<commit_message>
Publish privacy-safe request status v9
</commit_message>
<xml_diff>
--- a/site/downloads/pixan-bank-deck-large-en.pptx
+++ b/site/downloads/pixan-bank-deck-large-en.pptx
@@ -2,42 +2,42 @@
 <file path=ppt/presentation.xml><?xml version="1.0" encoding="utf-8"?>
 <p:presentation xmlns:p="http://schemas.openxmlformats.org/presentationml/2006/main">
   <p:sldMasterIdLst>
-    <p:sldMasterId xmlns:r="http://schemas.openxmlformats.org/officeDocument/2006/relationships" id="2147483648" r:id="Rce368825e36b4fd9"/>
+    <p:sldMasterId xmlns:r="http://schemas.openxmlformats.org/officeDocument/2006/relationships" id="2147483648" r:id="R934fdd0391f64ef5"/>
   </p:sldMasterIdLst>
   <p:notesMasterIdLst>
-    <p:notesMasterId xmlns:r="http://schemas.openxmlformats.org/officeDocument/2006/relationships" r:id="R4b9fc06309fc4204"/>
+    <p:notesMasterId xmlns:r="http://schemas.openxmlformats.org/officeDocument/2006/relationships" r:id="Raefbd3c6b7bb4c49"/>
   </p:notesMasterIdLst>
   <p:sldIdLst>
-    <p:sldId xmlns:r="http://schemas.openxmlformats.org/officeDocument/2006/relationships" id="256" r:id="R5819343070634cef"/>
-    <p:sldId xmlns:r="http://schemas.openxmlformats.org/officeDocument/2006/relationships" id="257" r:id="R9d432ab0e0034038"/>
-    <p:sldId xmlns:r="http://schemas.openxmlformats.org/officeDocument/2006/relationships" id="258" r:id="R8d478dd64edb40da"/>
-    <p:sldId xmlns:r="http://schemas.openxmlformats.org/officeDocument/2006/relationships" id="259" r:id="R87025964a6a24a7d"/>
-    <p:sldId xmlns:r="http://schemas.openxmlformats.org/officeDocument/2006/relationships" id="260" r:id="R72441db936224662"/>
-    <p:sldId xmlns:r="http://schemas.openxmlformats.org/officeDocument/2006/relationships" id="261" r:id="Raa617ee634394417"/>
-    <p:sldId xmlns:r="http://schemas.openxmlformats.org/officeDocument/2006/relationships" id="262" r:id="R89eb1c3f3db24944"/>
-    <p:sldId xmlns:r="http://schemas.openxmlformats.org/officeDocument/2006/relationships" id="263" r:id="Rb235f95d3c2948f6"/>
-    <p:sldId xmlns:r="http://schemas.openxmlformats.org/officeDocument/2006/relationships" id="264" r:id="Rdf5f42d5f0e7480f"/>
-    <p:sldId xmlns:r="http://schemas.openxmlformats.org/officeDocument/2006/relationships" id="265" r:id="R6d1bc062ed034f8a"/>
-    <p:sldId xmlns:r="http://schemas.openxmlformats.org/officeDocument/2006/relationships" id="266" r:id="Rf8d60cb95d594bb1"/>
-    <p:sldId xmlns:r="http://schemas.openxmlformats.org/officeDocument/2006/relationships" id="267" r:id="R5e56c8370c5645ea"/>
-    <p:sldId xmlns:r="http://schemas.openxmlformats.org/officeDocument/2006/relationships" id="268" r:id="R47dd90e9007f47ac"/>
-    <p:sldId xmlns:r="http://schemas.openxmlformats.org/officeDocument/2006/relationships" id="269" r:id="Rd1fb6aafd1d8430f"/>
-    <p:sldId xmlns:r="http://schemas.openxmlformats.org/officeDocument/2006/relationships" id="270" r:id="R584ac5112598460f"/>
-    <p:sldId xmlns:r="http://schemas.openxmlformats.org/officeDocument/2006/relationships" id="271" r:id="Re001857d585044f2"/>
-    <p:sldId xmlns:r="http://schemas.openxmlformats.org/officeDocument/2006/relationships" id="272" r:id="Rc0cc41df25304854"/>
-    <p:sldId xmlns:r="http://schemas.openxmlformats.org/officeDocument/2006/relationships" id="273" r:id="Rb9ef766d173f49c4"/>
-    <p:sldId xmlns:r="http://schemas.openxmlformats.org/officeDocument/2006/relationships" id="274" r:id="R82891c044bb6447e"/>
-    <p:sldId xmlns:r="http://schemas.openxmlformats.org/officeDocument/2006/relationships" id="275" r:id="R61c24c2cb01a42f4"/>
-    <p:sldId xmlns:r="http://schemas.openxmlformats.org/officeDocument/2006/relationships" id="276" r:id="R841b2a2999df4b53"/>
-    <p:sldId xmlns:r="http://schemas.openxmlformats.org/officeDocument/2006/relationships" id="277" r:id="Raed329f1439a4e4f"/>
-    <p:sldId xmlns:r="http://schemas.openxmlformats.org/officeDocument/2006/relationships" id="278" r:id="Ra49e624f541f4eed"/>
-    <p:sldId xmlns:r="http://schemas.openxmlformats.org/officeDocument/2006/relationships" id="279" r:id="R8e793e9cb4ec43fe"/>
-    <p:sldId xmlns:r="http://schemas.openxmlformats.org/officeDocument/2006/relationships" id="280" r:id="Rb47d13aec2e245ff"/>
-    <p:sldId xmlns:r="http://schemas.openxmlformats.org/officeDocument/2006/relationships" id="281" r:id="R0a79524b069e40fc"/>
-    <p:sldId xmlns:r="http://schemas.openxmlformats.org/officeDocument/2006/relationships" id="282" r:id="Rd96bf982a48d4e2f"/>
-    <p:sldId xmlns:r="http://schemas.openxmlformats.org/officeDocument/2006/relationships" id="283" r:id="R02697207f4724baa"/>
-    <p:sldId xmlns:r="http://schemas.openxmlformats.org/officeDocument/2006/relationships" id="284" r:id="R719193222f574680"/>
-    <p:sldId xmlns:r="http://schemas.openxmlformats.org/officeDocument/2006/relationships" id="285" r:id="Rc49b7ce462f249db"/>
+    <p:sldId xmlns:r="http://schemas.openxmlformats.org/officeDocument/2006/relationships" id="256" r:id="Rb90a8255385041cf"/>
+    <p:sldId xmlns:r="http://schemas.openxmlformats.org/officeDocument/2006/relationships" id="257" r:id="R960a9e4bfee94ab4"/>
+    <p:sldId xmlns:r="http://schemas.openxmlformats.org/officeDocument/2006/relationships" id="258" r:id="R4365f1d8579a4ed2"/>
+    <p:sldId xmlns:r="http://schemas.openxmlformats.org/officeDocument/2006/relationships" id="259" r:id="Rae19a14838a8425d"/>
+    <p:sldId xmlns:r="http://schemas.openxmlformats.org/officeDocument/2006/relationships" id="260" r:id="R916b6352b3844a09"/>
+    <p:sldId xmlns:r="http://schemas.openxmlformats.org/officeDocument/2006/relationships" id="261" r:id="R42c73f003df84fcc"/>
+    <p:sldId xmlns:r="http://schemas.openxmlformats.org/officeDocument/2006/relationships" id="262" r:id="R4f332eb4d5fc48f7"/>
+    <p:sldId xmlns:r="http://schemas.openxmlformats.org/officeDocument/2006/relationships" id="263" r:id="R5a4dba89fdd647ca"/>
+    <p:sldId xmlns:r="http://schemas.openxmlformats.org/officeDocument/2006/relationships" id="264" r:id="R98c5a7c62e8c4d47"/>
+    <p:sldId xmlns:r="http://schemas.openxmlformats.org/officeDocument/2006/relationships" id="265" r:id="Rbeb5902f404f4c63"/>
+    <p:sldId xmlns:r="http://schemas.openxmlformats.org/officeDocument/2006/relationships" id="266" r:id="R992e5e54bc2c40ef"/>
+    <p:sldId xmlns:r="http://schemas.openxmlformats.org/officeDocument/2006/relationships" id="267" r:id="R9858e480e79e46e3"/>
+    <p:sldId xmlns:r="http://schemas.openxmlformats.org/officeDocument/2006/relationships" id="268" r:id="Ra0a39da0385c4e33"/>
+    <p:sldId xmlns:r="http://schemas.openxmlformats.org/officeDocument/2006/relationships" id="269" r:id="R8b570191b160452b"/>
+    <p:sldId xmlns:r="http://schemas.openxmlformats.org/officeDocument/2006/relationships" id="270" r:id="R21d14bfa8de04832"/>
+    <p:sldId xmlns:r="http://schemas.openxmlformats.org/officeDocument/2006/relationships" id="271" r:id="R0deb1fdf4b5141b0"/>
+    <p:sldId xmlns:r="http://schemas.openxmlformats.org/officeDocument/2006/relationships" id="272" r:id="Rc4f608e3b9eb46e4"/>
+    <p:sldId xmlns:r="http://schemas.openxmlformats.org/officeDocument/2006/relationships" id="273" r:id="R2f72d6c2b44a42d6"/>
+    <p:sldId xmlns:r="http://schemas.openxmlformats.org/officeDocument/2006/relationships" id="274" r:id="R40f0e9cec5b64662"/>
+    <p:sldId xmlns:r="http://schemas.openxmlformats.org/officeDocument/2006/relationships" id="275" r:id="Rdfe50698937944b5"/>
+    <p:sldId xmlns:r="http://schemas.openxmlformats.org/officeDocument/2006/relationships" id="276" r:id="Rc7c6a81c3d2b413c"/>
+    <p:sldId xmlns:r="http://schemas.openxmlformats.org/officeDocument/2006/relationships" id="277" r:id="R4a813ee71939451a"/>
+    <p:sldId xmlns:r="http://schemas.openxmlformats.org/officeDocument/2006/relationships" id="278" r:id="R21afbe3c14434469"/>
+    <p:sldId xmlns:r="http://schemas.openxmlformats.org/officeDocument/2006/relationships" id="279" r:id="R67720dc0e87a4f64"/>
+    <p:sldId xmlns:r="http://schemas.openxmlformats.org/officeDocument/2006/relationships" id="280" r:id="Rae0a33b17a3f4df4"/>
+    <p:sldId xmlns:r="http://schemas.openxmlformats.org/officeDocument/2006/relationships" id="281" r:id="Rb25bc321e1ba43ed"/>
+    <p:sldId xmlns:r="http://schemas.openxmlformats.org/officeDocument/2006/relationships" id="282" r:id="R6e158a59bb424704"/>
+    <p:sldId xmlns:r="http://schemas.openxmlformats.org/officeDocument/2006/relationships" id="283" r:id="R4b21a3f5baab4981"/>
+    <p:sldId xmlns:r="http://schemas.openxmlformats.org/officeDocument/2006/relationships" id="284" r:id="Rc3d3a762a9024402"/>
+    <p:sldId xmlns:r="http://schemas.openxmlformats.org/officeDocument/2006/relationships" id="285" r:id="Rf697e9cf6c3e4f34"/>
   </p:sldIdLst>
   <p:sldSz cx="12191999" cy="6858000"/>
   <p:notesSz cx="6858000" cy="9144000"/>
@@ -2546,7 +2546,7 @@
           <p:cNvPr id="2" name="Title 1">
             <a:extLst xmlns:a="http://schemas.openxmlformats.org/drawingml/2006/main">
               <a:ext uri="{FF2B5EF4-FFF2-40B4-BE49-F238E27FC236}">
-                <a16:creationId xmlns:a16="http://schemas.microsoft.com/office/drawing/2014/main" id="{AB2B498F-C8F5-40F2-8817-89594F8B0B1F}"/>
+                <a16:creationId xmlns:a16="http://schemas.microsoft.com/office/drawing/2014/main" id="{F3436E2D-E1C1-48F8-9197-85806D748C89}"/>
               </a:ext>
             </a:extLst>
           </p:cNvPr>
@@ -2578,7 +2578,7 @@
           <p:cNvPr id="3" name="Subtitle 2">
             <a:extLst xmlns:a="http://schemas.openxmlformats.org/drawingml/2006/main">
               <a:ext uri="{FF2B5EF4-FFF2-40B4-BE49-F238E27FC236}">
-                <a16:creationId xmlns:a16="http://schemas.microsoft.com/office/drawing/2014/main" id="{BC1D041E-B309-4935-A433-51313FA49CD0}"/>
+                <a16:creationId xmlns:a16="http://schemas.microsoft.com/office/drawing/2014/main" id="{62B16E96-B168-49C7-A598-9CF616815311}"/>
               </a:ext>
             </a:extLst>
           </p:cNvPr>
@@ -2701,7 +2701,7 @@
           <p:cNvPr id="4" name="Date Placeholder 3">
             <a:extLst xmlns:a="http://schemas.openxmlformats.org/drawingml/2006/main">
               <a:ext uri="{FF2B5EF4-FFF2-40B4-BE49-F238E27FC236}">
-                <a16:creationId xmlns:a16="http://schemas.microsoft.com/office/drawing/2014/main" id="{09ACBE5B-6F51-48A2-A75A-2C2D4C1D91A5}"/>
+                <a16:creationId xmlns:a16="http://schemas.microsoft.com/office/drawing/2014/main" id="{E02447EA-F21A-4FCE-93BF-83319C5F99A9}"/>
               </a:ext>
             </a:extLst>
           </p:cNvPr>
@@ -2728,7 +2728,7 @@
           <p:cNvPr id="5" name="Footer Placeholder 4">
             <a:extLst xmlns:a="http://schemas.openxmlformats.org/drawingml/2006/main">
               <a:ext uri="{FF2B5EF4-FFF2-40B4-BE49-F238E27FC236}">
-                <a16:creationId xmlns:a16="http://schemas.microsoft.com/office/drawing/2014/main" id="{6611E20A-C95B-42F0-897B-F886F7D99376}"/>
+                <a16:creationId xmlns:a16="http://schemas.microsoft.com/office/drawing/2014/main" id="{12513908-F315-46CE-A1CC-00E9FD3C54AC}"/>
               </a:ext>
             </a:extLst>
           </p:cNvPr>
@@ -2751,7 +2751,7 @@
           <p:cNvPr id="6" name="Slide Number Placeholder 5">
             <a:extLst xmlns:a="http://schemas.openxmlformats.org/drawingml/2006/main">
               <a:ext uri="{FF2B5EF4-FFF2-40B4-BE49-F238E27FC236}">
-                <a16:creationId xmlns:a16="http://schemas.microsoft.com/office/drawing/2014/main" id="{EFF0B808-1A19-4D0C-B679-9C7F4935F005}"/>
+                <a16:creationId xmlns:a16="http://schemas.microsoft.com/office/drawing/2014/main" id="{239F615F-3E32-440F-9629-6EAE999D7021}"/>
               </a:ext>
             </a:extLst>
           </p:cNvPr>
@@ -2795,7 +2795,7 @@
           <p:cNvPr id="2" name="Title 1">
             <a:extLst xmlns:a="http://schemas.openxmlformats.org/drawingml/2006/main">
               <a:ext uri="{FF2B5EF4-FFF2-40B4-BE49-F238E27FC236}">
-                <a16:creationId xmlns:a16="http://schemas.microsoft.com/office/drawing/2014/main" id="{12CE4B95-2B64-4D7A-8907-870990D7C7A9}"/>
+                <a16:creationId xmlns:a16="http://schemas.microsoft.com/office/drawing/2014/main" id="{89FD243A-6CAA-4913-923B-A5345D6D622C}"/>
               </a:ext>
             </a:extLst>
           </p:cNvPr>
@@ -2822,7 +2822,7 @@
           <p:cNvPr id="3" name="Vertical Text Placeholder 2">
             <a:extLst xmlns:a="http://schemas.openxmlformats.org/drawingml/2006/main">
               <a:ext uri="{FF2B5EF4-FFF2-40B4-BE49-F238E27FC236}">
-                <a16:creationId xmlns:a16="http://schemas.microsoft.com/office/drawing/2014/main" id="{6AC5D85F-FF13-43C5-A26C-70183439E851}"/>
+                <a16:creationId xmlns:a16="http://schemas.microsoft.com/office/drawing/2014/main" id="{C239DBDF-4F3A-4DCA-A0B2-ABCDB27C67A5}"/>
               </a:ext>
             </a:extLst>
           </p:cNvPr>
@@ -2884,7 +2884,7 @@
           <p:cNvPr id="4" name="Date Placeholder 3">
             <a:extLst xmlns:a="http://schemas.openxmlformats.org/drawingml/2006/main">
               <a:ext uri="{FF2B5EF4-FFF2-40B4-BE49-F238E27FC236}">
-                <a16:creationId xmlns:a16="http://schemas.microsoft.com/office/drawing/2014/main" id="{1D85B98D-A421-4953-942A-3F88591E2FA4}"/>
+                <a16:creationId xmlns:a16="http://schemas.microsoft.com/office/drawing/2014/main" id="{46FFBFA1-4FEA-4BDF-A8A9-987002A20BF0}"/>
               </a:ext>
             </a:extLst>
           </p:cNvPr>
@@ -2911,7 +2911,7 @@
           <p:cNvPr id="5" name="Footer Placeholder 4">
             <a:extLst xmlns:a="http://schemas.openxmlformats.org/drawingml/2006/main">
               <a:ext uri="{FF2B5EF4-FFF2-40B4-BE49-F238E27FC236}">
-                <a16:creationId xmlns:a16="http://schemas.microsoft.com/office/drawing/2014/main" id="{387DE992-2165-4085-A16F-3B26B421A7B8}"/>
+                <a16:creationId xmlns:a16="http://schemas.microsoft.com/office/drawing/2014/main" id="{6C745F40-C9B3-445B-9CA8-FCDF87B7917D}"/>
               </a:ext>
             </a:extLst>
           </p:cNvPr>
@@ -2934,7 +2934,7 @@
           <p:cNvPr id="6" name="Slide Number Placeholder 5">
             <a:extLst xmlns:a="http://schemas.openxmlformats.org/drawingml/2006/main">
               <a:ext uri="{FF2B5EF4-FFF2-40B4-BE49-F238E27FC236}">
-                <a16:creationId xmlns:a16="http://schemas.microsoft.com/office/drawing/2014/main" id="{46FA4924-71D7-4358-A986-17050009B224}"/>
+                <a16:creationId xmlns:a16="http://schemas.microsoft.com/office/drawing/2014/main" id="{5594C023-5908-4B1A-B1EA-84359181F922}"/>
               </a:ext>
             </a:extLst>
           </p:cNvPr>
@@ -2978,7 +2978,7 @@
           <p:cNvPr id="2" name="Vertical Title 1">
             <a:extLst xmlns:a="http://schemas.openxmlformats.org/drawingml/2006/main">
               <a:ext uri="{FF2B5EF4-FFF2-40B4-BE49-F238E27FC236}">
-                <a16:creationId xmlns:a16="http://schemas.microsoft.com/office/drawing/2014/main" id="{DF46077C-E8A1-4F20-A66C-58465938AF05}"/>
+                <a16:creationId xmlns:a16="http://schemas.microsoft.com/office/drawing/2014/main" id="{3DDAAF3A-5834-414F-962E-06DCE1000473}"/>
               </a:ext>
             </a:extLst>
           </p:cNvPr>
@@ -3010,7 +3010,7 @@
           <p:cNvPr id="3" name="Vertical Text Placeholder 2">
             <a:extLst xmlns:a="http://schemas.openxmlformats.org/drawingml/2006/main">
               <a:ext uri="{FF2B5EF4-FFF2-40B4-BE49-F238E27FC236}">
-                <a16:creationId xmlns:a16="http://schemas.microsoft.com/office/drawing/2014/main" id="{87676CFC-4027-4C7A-AB7A-3F2D5DD65793}"/>
+                <a16:creationId xmlns:a16="http://schemas.microsoft.com/office/drawing/2014/main" id="{7013BCE6-FFD4-4B59-AB1F-12C5EA045F0D}"/>
               </a:ext>
             </a:extLst>
           </p:cNvPr>
@@ -3077,7 +3077,7 @@
           <p:cNvPr id="4" name="Date Placeholder 3">
             <a:extLst xmlns:a="http://schemas.openxmlformats.org/drawingml/2006/main">
               <a:ext uri="{FF2B5EF4-FFF2-40B4-BE49-F238E27FC236}">
-                <a16:creationId xmlns:a16="http://schemas.microsoft.com/office/drawing/2014/main" id="{31184D48-B98B-43AC-A701-220C52AF19A5}"/>
+                <a16:creationId xmlns:a16="http://schemas.microsoft.com/office/drawing/2014/main" id="{A7EEF051-262B-4E4B-ADB0-24779627AA5E}"/>
               </a:ext>
             </a:extLst>
           </p:cNvPr>
@@ -3104,7 +3104,7 @@
           <p:cNvPr id="5" name="Footer Placeholder 4">
             <a:extLst xmlns:a="http://schemas.openxmlformats.org/drawingml/2006/main">
               <a:ext uri="{FF2B5EF4-FFF2-40B4-BE49-F238E27FC236}">
-                <a16:creationId xmlns:a16="http://schemas.microsoft.com/office/drawing/2014/main" id="{1F028F9D-DD50-4739-999A-C742F06C705B}"/>
+                <a16:creationId xmlns:a16="http://schemas.microsoft.com/office/drawing/2014/main" id="{5EAA2759-142E-46CE-9777-3E934F614A55}"/>
               </a:ext>
             </a:extLst>
           </p:cNvPr>
@@ -3127,7 +3127,7 @@
           <p:cNvPr id="6" name="Slide Number Placeholder 5">
             <a:extLst xmlns:a="http://schemas.openxmlformats.org/drawingml/2006/main">
               <a:ext uri="{FF2B5EF4-FFF2-40B4-BE49-F238E27FC236}">
-                <a16:creationId xmlns:a16="http://schemas.microsoft.com/office/drawing/2014/main" id="{66BE7AB0-A249-4409-87EB-AC123689ABF1}"/>
+                <a16:creationId xmlns:a16="http://schemas.microsoft.com/office/drawing/2014/main" id="{CA18648B-47EC-4B15-83E6-C4B0024A997E}"/>
               </a:ext>
             </a:extLst>
           </p:cNvPr>
@@ -3171,7 +3171,7 @@
           <p:cNvPr id="2" name="Title 1">
             <a:extLst xmlns:a="http://schemas.openxmlformats.org/drawingml/2006/main">
               <a:ext uri="{FF2B5EF4-FFF2-40B4-BE49-F238E27FC236}">
-                <a16:creationId xmlns:a16="http://schemas.microsoft.com/office/drawing/2014/main" id="{7B4A62BD-86ED-4F8C-985E-B6A14FE00A00}"/>
+                <a16:creationId xmlns:a16="http://schemas.microsoft.com/office/drawing/2014/main" id="{765A7553-220F-4CDF-8251-AF14311B9589}"/>
               </a:ext>
             </a:extLst>
           </p:cNvPr>
@@ -3198,7 +3198,7 @@
           <p:cNvPr id="3" name="Content Placeholder 2">
             <a:extLst xmlns:a="http://schemas.openxmlformats.org/drawingml/2006/main">
               <a:ext uri="{FF2B5EF4-FFF2-40B4-BE49-F238E27FC236}">
-                <a16:creationId xmlns:a16="http://schemas.microsoft.com/office/drawing/2014/main" id="{D44C21F2-2083-4189-AE68-4FD75AF957E0}"/>
+                <a16:creationId xmlns:a16="http://schemas.microsoft.com/office/drawing/2014/main" id="{6748F28A-2112-48E5-9FC8-1E0AA4A8FC18}"/>
               </a:ext>
             </a:extLst>
           </p:cNvPr>
@@ -3260,7 +3260,7 @@
           <p:cNvPr id="4" name="Date Placeholder 3">
             <a:extLst xmlns:a="http://schemas.openxmlformats.org/drawingml/2006/main">
               <a:ext uri="{FF2B5EF4-FFF2-40B4-BE49-F238E27FC236}">
-                <a16:creationId xmlns:a16="http://schemas.microsoft.com/office/drawing/2014/main" id="{C35D2667-7AE5-49B2-9B2E-413CF5F950BE}"/>
+                <a16:creationId xmlns:a16="http://schemas.microsoft.com/office/drawing/2014/main" id="{DC1F3072-69D6-4D58-B937-5A4A9732AF6F}"/>
               </a:ext>
             </a:extLst>
           </p:cNvPr>
@@ -3287,7 +3287,7 @@
           <p:cNvPr id="5" name="Footer Placeholder 4">
             <a:extLst xmlns:a="http://schemas.openxmlformats.org/drawingml/2006/main">
               <a:ext uri="{FF2B5EF4-FFF2-40B4-BE49-F238E27FC236}">
-                <a16:creationId xmlns:a16="http://schemas.microsoft.com/office/drawing/2014/main" id="{0C441044-0EE1-4520-989B-C5C9253BFBA7}"/>
+                <a16:creationId xmlns:a16="http://schemas.microsoft.com/office/drawing/2014/main" id="{AB8B7EBD-716B-4029-963F-285A5DDE8B00}"/>
               </a:ext>
             </a:extLst>
           </p:cNvPr>
@@ -3310,7 +3310,7 @@
           <p:cNvPr id="6" name="Slide Number Placeholder 5">
             <a:extLst xmlns:a="http://schemas.openxmlformats.org/drawingml/2006/main">
               <a:ext uri="{FF2B5EF4-FFF2-40B4-BE49-F238E27FC236}">
-                <a16:creationId xmlns:a16="http://schemas.microsoft.com/office/drawing/2014/main" id="{BBBEF862-173E-4274-92D9-D0CBED0A9671}"/>
+                <a16:creationId xmlns:a16="http://schemas.microsoft.com/office/drawing/2014/main" id="{6DCEC666-C6C4-4FE9-B007-7B98042EABD4}"/>
               </a:ext>
             </a:extLst>
           </p:cNvPr>
@@ -3354,7 +3354,7 @@
           <p:cNvPr id="2" name="Title 1">
             <a:extLst xmlns:a="http://schemas.openxmlformats.org/drawingml/2006/main">
               <a:ext uri="{FF2B5EF4-FFF2-40B4-BE49-F238E27FC236}">
-                <a16:creationId xmlns:a16="http://schemas.microsoft.com/office/drawing/2014/main" id="{54CCB851-1801-416E-B7AC-417D4BCE3A09}"/>
+                <a16:creationId xmlns:a16="http://schemas.microsoft.com/office/drawing/2014/main" id="{C2A6CAAD-3C8C-412B-A83A-D7248E899DF9}"/>
               </a:ext>
             </a:extLst>
           </p:cNvPr>
@@ -3391,7 +3391,7 @@
           <p:cNvPr id="3" name="Text Placeholder 2">
             <a:extLst xmlns:a="http://schemas.openxmlformats.org/drawingml/2006/main">
               <a:ext uri="{FF2B5EF4-FFF2-40B4-BE49-F238E27FC236}">
-                <a16:creationId xmlns:a16="http://schemas.microsoft.com/office/drawing/2014/main" id="{EE0FCE41-1382-44A1-8EB6-732069269058}"/>
+                <a16:creationId xmlns:a16="http://schemas.microsoft.com/office/drawing/2014/main" id="{64C4EE91-145B-48E1-9CE8-225B99A929D9}"/>
               </a:ext>
             </a:extLst>
           </p:cNvPr>
@@ -3517,7 +3517,7 @@
           <p:cNvPr id="4" name="Date Placeholder 3">
             <a:extLst xmlns:a="http://schemas.openxmlformats.org/drawingml/2006/main">
               <a:ext uri="{FF2B5EF4-FFF2-40B4-BE49-F238E27FC236}">
-                <a16:creationId xmlns:a16="http://schemas.microsoft.com/office/drawing/2014/main" id="{7D1BBCAF-B5CB-4C91-B0A4-415D3E336E27}"/>
+                <a16:creationId xmlns:a16="http://schemas.microsoft.com/office/drawing/2014/main" id="{37DACD32-8B94-4A16-B1C0-9D27BCBC5577}"/>
               </a:ext>
             </a:extLst>
           </p:cNvPr>
@@ -3544,7 +3544,7 @@
           <p:cNvPr id="5" name="Footer Placeholder 4">
             <a:extLst xmlns:a="http://schemas.openxmlformats.org/drawingml/2006/main">
               <a:ext uri="{FF2B5EF4-FFF2-40B4-BE49-F238E27FC236}">
-                <a16:creationId xmlns:a16="http://schemas.microsoft.com/office/drawing/2014/main" id="{6D5D1573-9EDA-4072-A63A-55415C814814}"/>
+                <a16:creationId xmlns:a16="http://schemas.microsoft.com/office/drawing/2014/main" id="{D779F11F-F402-470D-94C9-8AC10D2E30A9}"/>
               </a:ext>
             </a:extLst>
           </p:cNvPr>
@@ -3567,7 +3567,7 @@
           <p:cNvPr id="6" name="Slide Number Placeholder 5">
             <a:extLst xmlns:a="http://schemas.openxmlformats.org/drawingml/2006/main">
               <a:ext uri="{FF2B5EF4-FFF2-40B4-BE49-F238E27FC236}">
-                <a16:creationId xmlns:a16="http://schemas.microsoft.com/office/drawing/2014/main" id="{BB9CD300-961C-426F-B85C-03EBEC6E05DB}"/>
+                <a16:creationId xmlns:a16="http://schemas.microsoft.com/office/drawing/2014/main" id="{79F9D546-DA84-44F8-8955-8796D7CABD60}"/>
               </a:ext>
             </a:extLst>
           </p:cNvPr>
@@ -3611,7 +3611,7 @@
           <p:cNvPr id="2" name="Title 1">
             <a:extLst xmlns:a="http://schemas.openxmlformats.org/drawingml/2006/main">
               <a:ext uri="{FF2B5EF4-FFF2-40B4-BE49-F238E27FC236}">
-                <a16:creationId xmlns:a16="http://schemas.microsoft.com/office/drawing/2014/main" id="{3AF360B6-5637-461F-A0A2-AE90D2389812}"/>
+                <a16:creationId xmlns:a16="http://schemas.microsoft.com/office/drawing/2014/main" id="{8018B09E-F6A1-4E9E-B4CE-4512C59D595F}"/>
               </a:ext>
             </a:extLst>
           </p:cNvPr>
@@ -3638,7 +3638,7 @@
           <p:cNvPr id="3" name="Content Placeholder 2">
             <a:extLst xmlns:a="http://schemas.openxmlformats.org/drawingml/2006/main">
               <a:ext uri="{FF2B5EF4-FFF2-40B4-BE49-F238E27FC236}">
-                <a16:creationId xmlns:a16="http://schemas.microsoft.com/office/drawing/2014/main" id="{8041805B-72CC-4D97-B4F4-9D19974C1719}"/>
+                <a16:creationId xmlns:a16="http://schemas.microsoft.com/office/drawing/2014/main" id="{AAA90FAE-06A9-4CDE-9628-BC7A990741B9}"/>
               </a:ext>
             </a:extLst>
           </p:cNvPr>
@@ -3742,7 +3742,7 @@
           <p:cNvPr id="4" name="Content Placeholder 3">
             <a:extLst xmlns:a="http://schemas.openxmlformats.org/drawingml/2006/main">
               <a:ext uri="{FF2B5EF4-FFF2-40B4-BE49-F238E27FC236}">
-                <a16:creationId xmlns:a16="http://schemas.microsoft.com/office/drawing/2014/main" id="{73B71B21-D5BA-4913-83A6-03406A863B84}"/>
+                <a16:creationId xmlns:a16="http://schemas.microsoft.com/office/drawing/2014/main" id="{61F6A098-5781-4739-AD0B-46563D0B9F21}"/>
               </a:ext>
             </a:extLst>
           </p:cNvPr>
@@ -3846,7 +3846,7 @@
           <p:cNvPr id="5" name="Date Placeholder 4">
             <a:extLst xmlns:a="http://schemas.openxmlformats.org/drawingml/2006/main">
               <a:ext uri="{FF2B5EF4-FFF2-40B4-BE49-F238E27FC236}">
-                <a16:creationId xmlns:a16="http://schemas.microsoft.com/office/drawing/2014/main" id="{C364A685-3879-40D1-91C4-73FFA0F26097}"/>
+                <a16:creationId xmlns:a16="http://schemas.microsoft.com/office/drawing/2014/main" id="{FDC7A8EE-D37B-4F14-A224-85C0556166E2}"/>
               </a:ext>
             </a:extLst>
           </p:cNvPr>
@@ -3873,7 +3873,7 @@
           <p:cNvPr id="6" name="Footer Placeholder 5">
             <a:extLst xmlns:a="http://schemas.openxmlformats.org/drawingml/2006/main">
               <a:ext uri="{FF2B5EF4-FFF2-40B4-BE49-F238E27FC236}">
-                <a16:creationId xmlns:a16="http://schemas.microsoft.com/office/drawing/2014/main" id="{4E8500F8-521A-47EB-AADF-E4FDD2014045}"/>
+                <a16:creationId xmlns:a16="http://schemas.microsoft.com/office/drawing/2014/main" id="{0C21F815-FDF6-4301-A7B8-0D4BD3369376}"/>
               </a:ext>
             </a:extLst>
           </p:cNvPr>
@@ -3896,7 +3896,7 @@
           <p:cNvPr id="7" name="Slide Number Placeholder 6">
             <a:extLst xmlns:a="http://schemas.openxmlformats.org/drawingml/2006/main">
               <a:ext uri="{FF2B5EF4-FFF2-40B4-BE49-F238E27FC236}">
-                <a16:creationId xmlns:a16="http://schemas.microsoft.com/office/drawing/2014/main" id="{BF9C0102-EB42-460A-8B03-1EBEA004D605}"/>
+                <a16:creationId xmlns:a16="http://schemas.microsoft.com/office/drawing/2014/main" id="{38AFDFCA-F708-4C0B-8E92-4947617D6C61}"/>
               </a:ext>
             </a:extLst>
           </p:cNvPr>
@@ -3940,7 +3940,7 @@
           <p:cNvPr id="2" name="Title 1">
             <a:extLst xmlns:a="http://schemas.openxmlformats.org/drawingml/2006/main">
               <a:ext uri="{FF2B5EF4-FFF2-40B4-BE49-F238E27FC236}">
-                <a16:creationId xmlns:a16="http://schemas.microsoft.com/office/drawing/2014/main" id="{F0178986-0670-4175-8FAB-CDD1B91C2D3E}"/>
+                <a16:creationId xmlns:a16="http://schemas.microsoft.com/office/drawing/2014/main" id="{1AB61278-1AD1-4008-B826-D2FCBD94D4A7}"/>
               </a:ext>
             </a:extLst>
           </p:cNvPr>
@@ -3972,7 +3972,7 @@
           <p:cNvPr id="3" name="Text Placeholder 2">
             <a:extLst xmlns:a="http://schemas.openxmlformats.org/drawingml/2006/main">
               <a:ext uri="{FF2B5EF4-FFF2-40B4-BE49-F238E27FC236}">
-                <a16:creationId xmlns:a16="http://schemas.microsoft.com/office/drawing/2014/main" id="{4D4BEB0C-54DD-4B44-904E-EC2E9BCC68D5}"/>
+                <a16:creationId xmlns:a16="http://schemas.microsoft.com/office/drawing/2014/main" id="{83B9E49E-E07B-4101-8CA3-C72C8F13EE20}"/>
               </a:ext>
             </a:extLst>
           </p:cNvPr>
@@ -4044,7 +4044,7 @@
           <p:cNvPr id="4" name="Content Placeholder 3">
             <a:extLst xmlns:a="http://schemas.openxmlformats.org/drawingml/2006/main">
               <a:ext uri="{FF2B5EF4-FFF2-40B4-BE49-F238E27FC236}">
-                <a16:creationId xmlns:a16="http://schemas.microsoft.com/office/drawing/2014/main" id="{AB162B1A-DD94-480B-83C2-63383DF21A60}"/>
+                <a16:creationId xmlns:a16="http://schemas.microsoft.com/office/drawing/2014/main" id="{D81CA610-36BC-462B-AA50-68DE1572CDEE}"/>
               </a:ext>
             </a:extLst>
           </p:cNvPr>
@@ -4148,7 +4148,7 @@
           <p:cNvPr id="5" name="Text Placeholder 4">
             <a:extLst xmlns:a="http://schemas.openxmlformats.org/drawingml/2006/main">
               <a:ext uri="{FF2B5EF4-FFF2-40B4-BE49-F238E27FC236}">
-                <a16:creationId xmlns:a16="http://schemas.microsoft.com/office/drawing/2014/main" id="{FD9BADA5-B6E6-412C-8C31-F618A0AE900E}"/>
+                <a16:creationId xmlns:a16="http://schemas.microsoft.com/office/drawing/2014/main" id="{8D417C4C-A5F4-4095-A9E6-F63D0D1B9C5C}"/>
               </a:ext>
             </a:extLst>
           </p:cNvPr>
@@ -4220,7 +4220,7 @@
           <p:cNvPr id="6" name="Content Placeholder 5">
             <a:extLst xmlns:a="http://schemas.openxmlformats.org/drawingml/2006/main">
               <a:ext uri="{FF2B5EF4-FFF2-40B4-BE49-F238E27FC236}">
-                <a16:creationId xmlns:a16="http://schemas.microsoft.com/office/drawing/2014/main" id="{360BC57E-83C8-4488-8F6D-E12A2C741747}"/>
+                <a16:creationId xmlns:a16="http://schemas.microsoft.com/office/drawing/2014/main" id="{29651AAE-A7EA-4274-884B-2D2CE1C6F5FB}"/>
               </a:ext>
             </a:extLst>
           </p:cNvPr>
@@ -4324,7 +4324,7 @@
           <p:cNvPr id="7" name="Date Placeholder 6">
             <a:extLst xmlns:a="http://schemas.openxmlformats.org/drawingml/2006/main">
               <a:ext uri="{FF2B5EF4-FFF2-40B4-BE49-F238E27FC236}">
-                <a16:creationId xmlns:a16="http://schemas.microsoft.com/office/drawing/2014/main" id="{36BD92F1-2855-4D32-A1A2-2DA6F1B4782A}"/>
+                <a16:creationId xmlns:a16="http://schemas.microsoft.com/office/drawing/2014/main" id="{AA292D49-F29C-4175-AB96-F05ED92C7EC7}"/>
               </a:ext>
             </a:extLst>
           </p:cNvPr>
@@ -4351,7 +4351,7 @@
           <p:cNvPr id="8" name="Footer Placeholder 7">
             <a:extLst xmlns:a="http://schemas.openxmlformats.org/drawingml/2006/main">
               <a:ext uri="{FF2B5EF4-FFF2-40B4-BE49-F238E27FC236}">
-                <a16:creationId xmlns:a16="http://schemas.microsoft.com/office/drawing/2014/main" id="{4AB70325-27D8-4567-9A37-A1387F4B27FA}"/>
+                <a16:creationId xmlns:a16="http://schemas.microsoft.com/office/drawing/2014/main" id="{81C95902-48B3-4E56-AC01-853516DF64B5}"/>
               </a:ext>
             </a:extLst>
           </p:cNvPr>
@@ -4374,7 +4374,7 @@
           <p:cNvPr id="9" name="Slide Number Placeholder 8">
             <a:extLst xmlns:a="http://schemas.openxmlformats.org/drawingml/2006/main">
               <a:ext uri="{FF2B5EF4-FFF2-40B4-BE49-F238E27FC236}">
-                <a16:creationId xmlns:a16="http://schemas.microsoft.com/office/drawing/2014/main" id="{F32778FB-4639-43ED-BEE0-1C9928EF333D}"/>
+                <a16:creationId xmlns:a16="http://schemas.microsoft.com/office/drawing/2014/main" id="{64B77271-500A-43B0-AEB6-427B36D92859}"/>
               </a:ext>
             </a:extLst>
           </p:cNvPr>
@@ -4418,7 +4418,7 @@
           <p:cNvPr id="2" name="Title 1">
             <a:extLst xmlns:a="http://schemas.openxmlformats.org/drawingml/2006/main">
               <a:ext uri="{FF2B5EF4-FFF2-40B4-BE49-F238E27FC236}">
-                <a16:creationId xmlns:a16="http://schemas.microsoft.com/office/drawing/2014/main" id="{6C6C24D9-B103-43EE-B444-D1259E30B14B}"/>
+                <a16:creationId xmlns:a16="http://schemas.microsoft.com/office/drawing/2014/main" id="{EB0D13B2-B442-4600-B4E7-AE087E56D815}"/>
               </a:ext>
             </a:extLst>
           </p:cNvPr>
@@ -4445,7 +4445,7 @@
           <p:cNvPr id="3" name="Date Placeholder 2">
             <a:extLst xmlns:a="http://schemas.openxmlformats.org/drawingml/2006/main">
               <a:ext uri="{FF2B5EF4-FFF2-40B4-BE49-F238E27FC236}">
-                <a16:creationId xmlns:a16="http://schemas.microsoft.com/office/drawing/2014/main" id="{5856551E-CBD2-454A-B1BE-3BD3B4727235}"/>
+                <a16:creationId xmlns:a16="http://schemas.microsoft.com/office/drawing/2014/main" id="{755734FE-A4A2-4791-A6B0-A52B722B4CA7}"/>
               </a:ext>
             </a:extLst>
           </p:cNvPr>
@@ -4472,7 +4472,7 @@
           <p:cNvPr id="4" name="Footer Placeholder 3">
             <a:extLst xmlns:a="http://schemas.openxmlformats.org/drawingml/2006/main">
               <a:ext uri="{FF2B5EF4-FFF2-40B4-BE49-F238E27FC236}">
-                <a16:creationId xmlns:a16="http://schemas.microsoft.com/office/drawing/2014/main" id="{AAA97748-BCF4-44F5-A6C8-4CBC951A787E}"/>
+                <a16:creationId xmlns:a16="http://schemas.microsoft.com/office/drawing/2014/main" id="{96E8902B-3E6E-4504-A558-03CA968A51BA}"/>
               </a:ext>
             </a:extLst>
           </p:cNvPr>
@@ -4495,7 +4495,7 @@
           <p:cNvPr id="5" name="Slide Number Placeholder 4">
             <a:extLst xmlns:a="http://schemas.openxmlformats.org/drawingml/2006/main">
               <a:ext uri="{FF2B5EF4-FFF2-40B4-BE49-F238E27FC236}">
-                <a16:creationId xmlns:a16="http://schemas.microsoft.com/office/drawing/2014/main" id="{483B9CF2-2D12-4AA5-87E7-F8CE0787262D}"/>
+                <a16:creationId xmlns:a16="http://schemas.microsoft.com/office/drawing/2014/main" id="{4F46550D-B380-41CD-B109-1374699733D1}"/>
               </a:ext>
             </a:extLst>
           </p:cNvPr>
@@ -4539,7 +4539,7 @@
           <p:cNvPr id="2" name="Date Placeholder 1">
             <a:extLst xmlns:a="http://schemas.openxmlformats.org/drawingml/2006/main">
               <a:ext uri="{FF2B5EF4-FFF2-40B4-BE49-F238E27FC236}">
-                <a16:creationId xmlns:a16="http://schemas.microsoft.com/office/drawing/2014/main" id="{6F499B53-BF1E-4A8E-A0F1-8139BE046CF6}"/>
+                <a16:creationId xmlns:a16="http://schemas.microsoft.com/office/drawing/2014/main" id="{B2EC543A-7899-4CF4-953C-7652D53BC30D}"/>
               </a:ext>
             </a:extLst>
           </p:cNvPr>
@@ -4566,7 +4566,7 @@
           <p:cNvPr id="3" name="Footer Placeholder 2">
             <a:extLst xmlns:a="http://schemas.openxmlformats.org/drawingml/2006/main">
               <a:ext uri="{FF2B5EF4-FFF2-40B4-BE49-F238E27FC236}">
-                <a16:creationId xmlns:a16="http://schemas.microsoft.com/office/drawing/2014/main" id="{9874C5E9-8459-4C45-B3DC-6B20534D06E0}"/>
+                <a16:creationId xmlns:a16="http://schemas.microsoft.com/office/drawing/2014/main" id="{7FB35ADF-4FE8-4944-8247-32EE1D748DB5}"/>
               </a:ext>
             </a:extLst>
           </p:cNvPr>
@@ -4589,7 +4589,7 @@
           <p:cNvPr id="4" name="Slide Number Placeholder 3">
             <a:extLst xmlns:a="http://schemas.openxmlformats.org/drawingml/2006/main">
               <a:ext uri="{FF2B5EF4-FFF2-40B4-BE49-F238E27FC236}">
-                <a16:creationId xmlns:a16="http://schemas.microsoft.com/office/drawing/2014/main" id="{3E569568-FE13-42CA-8289-FCF0D11C9B1C}"/>
+                <a16:creationId xmlns:a16="http://schemas.microsoft.com/office/drawing/2014/main" id="{22B00982-1B6E-442F-BA1A-D0BDD439E460}"/>
               </a:ext>
             </a:extLst>
           </p:cNvPr>
@@ -4633,7 +4633,7 @@
           <p:cNvPr id="2" name="Title 1">
             <a:extLst xmlns:a="http://schemas.openxmlformats.org/drawingml/2006/main">
               <a:ext uri="{FF2B5EF4-FFF2-40B4-BE49-F238E27FC236}">
-                <a16:creationId xmlns:a16="http://schemas.microsoft.com/office/drawing/2014/main" id="{60E64830-6404-4302-9414-EB451EB943CF}"/>
+                <a16:creationId xmlns:a16="http://schemas.microsoft.com/office/drawing/2014/main" id="{A2A6C3E8-C5EB-429B-ACF4-1C9132DF9F2B}"/>
               </a:ext>
             </a:extLst>
           </p:cNvPr>
@@ -4670,7 +4670,7 @@
           <p:cNvPr id="3" name="Content Placeholder 2">
             <a:extLst xmlns:a="http://schemas.openxmlformats.org/drawingml/2006/main">
               <a:ext uri="{FF2B5EF4-FFF2-40B4-BE49-F238E27FC236}">
-                <a16:creationId xmlns:a16="http://schemas.microsoft.com/office/drawing/2014/main" id="{549C431E-2565-4672-AC36-A5EDCA0F1F66}"/>
+                <a16:creationId xmlns:a16="http://schemas.microsoft.com/office/drawing/2014/main" id="{D04772B8-82A0-4110-8038-822FD70FBE3D}"/>
               </a:ext>
             </a:extLst>
           </p:cNvPr>
@@ -4774,7 +4774,7 @@
           <p:cNvPr id="4" name="Text Placeholder 3">
             <a:extLst xmlns:a="http://schemas.openxmlformats.org/drawingml/2006/main">
               <a:ext uri="{FF2B5EF4-FFF2-40B4-BE49-F238E27FC236}">
-                <a16:creationId xmlns:a16="http://schemas.microsoft.com/office/drawing/2014/main" id="{407CA220-25ED-4348-A0E4-3E1FFC2DCE83}"/>
+                <a16:creationId xmlns:a16="http://schemas.microsoft.com/office/drawing/2014/main" id="{E8AF4A4D-8D1E-43AA-9AF9-AD6BAD00A2D5}"/>
               </a:ext>
             </a:extLst>
           </p:cNvPr>
@@ -4846,7 +4846,7 @@
           <p:cNvPr id="5" name="Date Placeholder 4">
             <a:extLst xmlns:a="http://schemas.openxmlformats.org/drawingml/2006/main">
               <a:ext uri="{FF2B5EF4-FFF2-40B4-BE49-F238E27FC236}">
-                <a16:creationId xmlns:a16="http://schemas.microsoft.com/office/drawing/2014/main" id="{461EFB20-9C02-4922-B46D-C7C28141C710}"/>
+                <a16:creationId xmlns:a16="http://schemas.microsoft.com/office/drawing/2014/main" id="{5444D9EB-2FDF-4BF1-996D-CF16F3FDD6B4}"/>
               </a:ext>
             </a:extLst>
           </p:cNvPr>
@@ -4873,7 +4873,7 @@
           <p:cNvPr id="6" name="Footer Placeholder 5">
             <a:extLst xmlns:a="http://schemas.openxmlformats.org/drawingml/2006/main">
               <a:ext uri="{FF2B5EF4-FFF2-40B4-BE49-F238E27FC236}">
-                <a16:creationId xmlns:a16="http://schemas.microsoft.com/office/drawing/2014/main" id="{B0EF1C33-F4D6-45E4-B3AE-FE8834B94CF6}"/>
+                <a16:creationId xmlns:a16="http://schemas.microsoft.com/office/drawing/2014/main" id="{63B17912-9466-45EE-BF59-CE5C2804388D}"/>
               </a:ext>
             </a:extLst>
           </p:cNvPr>
@@ -4896,7 +4896,7 @@
           <p:cNvPr id="7" name="Slide Number Placeholder 6">
             <a:extLst xmlns:a="http://schemas.openxmlformats.org/drawingml/2006/main">
               <a:ext uri="{FF2B5EF4-FFF2-40B4-BE49-F238E27FC236}">
-                <a16:creationId xmlns:a16="http://schemas.microsoft.com/office/drawing/2014/main" id="{7B273C38-FBE6-4644-A151-608DE6C7C322}"/>
+                <a16:creationId xmlns:a16="http://schemas.microsoft.com/office/drawing/2014/main" id="{5CA971E6-70DB-4F5A-872F-025C9C6BE865}"/>
               </a:ext>
             </a:extLst>
           </p:cNvPr>
@@ -4940,7 +4940,7 @@
           <p:cNvPr id="2" name="Title 1">
             <a:extLst xmlns:a="http://schemas.openxmlformats.org/drawingml/2006/main">
               <a:ext uri="{FF2B5EF4-FFF2-40B4-BE49-F238E27FC236}">
-                <a16:creationId xmlns:a16="http://schemas.microsoft.com/office/drawing/2014/main" id="{269F0477-BC24-4934-8FDC-CC003220F24B}"/>
+                <a16:creationId xmlns:a16="http://schemas.microsoft.com/office/drawing/2014/main" id="{5A825230-A94B-4F59-A71C-6CEF3C60BF07}"/>
               </a:ext>
             </a:extLst>
           </p:cNvPr>
@@ -4977,7 +4977,7 @@
           <p:cNvPr id="3" name="Picture Placeholder 2">
             <a:extLst xmlns:a="http://schemas.openxmlformats.org/drawingml/2006/main">
               <a:ext uri="{FF2B5EF4-FFF2-40B4-BE49-F238E27FC236}">
-                <a16:creationId xmlns:a16="http://schemas.microsoft.com/office/drawing/2014/main" id="{2EEAA784-6F00-4E5F-B5D6-961C9A92BC5B}"/>
+                <a16:creationId xmlns:a16="http://schemas.microsoft.com/office/drawing/2014/main" id="{B0AFABCC-CBF0-4914-B015-912DD7B2D8E7}"/>
               </a:ext>
             </a:extLst>
           </p:cNvPr>
@@ -5042,7 +5042,7 @@
           <p:cNvPr id="4" name="Text Placeholder 3">
             <a:extLst xmlns:a="http://schemas.openxmlformats.org/drawingml/2006/main">
               <a:ext uri="{FF2B5EF4-FFF2-40B4-BE49-F238E27FC236}">
-                <a16:creationId xmlns:a16="http://schemas.microsoft.com/office/drawing/2014/main" id="{8AAFB2E4-9B93-41A7-866B-9BA49BB9D501}"/>
+                <a16:creationId xmlns:a16="http://schemas.microsoft.com/office/drawing/2014/main" id="{6B5E0EDD-ADB7-4320-9805-E0F8ADDFF2BB}"/>
               </a:ext>
             </a:extLst>
           </p:cNvPr>
@@ -5114,7 +5114,7 @@
           <p:cNvPr id="5" name="Date Placeholder 4">
             <a:extLst xmlns:a="http://schemas.openxmlformats.org/drawingml/2006/main">
               <a:ext uri="{FF2B5EF4-FFF2-40B4-BE49-F238E27FC236}">
-                <a16:creationId xmlns:a16="http://schemas.microsoft.com/office/drawing/2014/main" id="{00A893AE-F857-4153-9E5D-8C4211A6F501}"/>
+                <a16:creationId xmlns:a16="http://schemas.microsoft.com/office/drawing/2014/main" id="{DE7F61AC-0B0C-4367-9B2A-56315A0754EA}"/>
               </a:ext>
             </a:extLst>
           </p:cNvPr>
@@ -5141,7 +5141,7 @@
           <p:cNvPr id="6" name="Footer Placeholder 5">
             <a:extLst xmlns:a="http://schemas.openxmlformats.org/drawingml/2006/main">
               <a:ext uri="{FF2B5EF4-FFF2-40B4-BE49-F238E27FC236}">
-                <a16:creationId xmlns:a16="http://schemas.microsoft.com/office/drawing/2014/main" id="{B88D231C-2876-44DC-B0EA-13F9E96748B8}"/>
+                <a16:creationId xmlns:a16="http://schemas.microsoft.com/office/drawing/2014/main" id="{1CBFDCF0-1971-49AD-966B-817B9CFB6327}"/>
               </a:ext>
             </a:extLst>
           </p:cNvPr>
@@ -5164,7 +5164,7 @@
           <p:cNvPr id="7" name="Slide Number Placeholder 6">
             <a:extLst xmlns:a="http://schemas.openxmlformats.org/drawingml/2006/main">
               <a:ext uri="{FF2B5EF4-FFF2-40B4-BE49-F238E27FC236}">
-                <a16:creationId xmlns:a16="http://schemas.microsoft.com/office/drawing/2014/main" id="{7885D03C-2787-4568-96BF-BE5882C99F01}"/>
+                <a16:creationId xmlns:a16="http://schemas.microsoft.com/office/drawing/2014/main" id="{693D7C15-D71F-4FE8-BAA1-E2C025B1696E}"/>
               </a:ext>
             </a:extLst>
           </p:cNvPr>
@@ -5213,7 +5213,7 @@
           <p:cNvPr id="2" name="Title Placeholder 1">
             <a:extLst xmlns:a="http://schemas.openxmlformats.org/drawingml/2006/main">
               <a:ext uri="{FF2B5EF4-FFF2-40B4-BE49-F238E27FC236}">
-                <a16:creationId xmlns:a16="http://schemas.microsoft.com/office/drawing/2014/main" id="{36925245-E049-4EA6-8448-E77C9A03B201}"/>
+                <a16:creationId xmlns:a16="http://schemas.microsoft.com/office/drawing/2014/main" id="{2533FD76-40B2-48DE-98EC-F923AEE61A2A}"/>
               </a:ext>
             </a:extLst>
           </p:cNvPr>
@@ -5250,7 +5250,7 @@
           <p:cNvPr id="3" name="Text Placeholder 2">
             <a:extLst xmlns:a="http://schemas.openxmlformats.org/drawingml/2006/main">
               <a:ext uri="{FF2B5EF4-FFF2-40B4-BE49-F238E27FC236}">
-                <a16:creationId xmlns:a16="http://schemas.microsoft.com/office/drawing/2014/main" id="{4A68FDDC-AAEB-4AD3-ACDD-A7D1FB9C7557}"/>
+                <a16:creationId xmlns:a16="http://schemas.microsoft.com/office/drawing/2014/main" id="{17DA4F07-D25D-4AA8-9481-A0ACB31923CC}"/>
               </a:ext>
             </a:extLst>
           </p:cNvPr>
@@ -5322,7 +5322,7 @@
           <p:cNvPr id="4" name="Date Placeholder 3">
             <a:extLst xmlns:a="http://schemas.openxmlformats.org/drawingml/2006/main">
               <a:ext uri="{FF2B5EF4-FFF2-40B4-BE49-F238E27FC236}">
-                <a16:creationId xmlns:a16="http://schemas.microsoft.com/office/drawing/2014/main" id="{D5681373-3E9F-4ED8-92B3-207312A35029}"/>
+                <a16:creationId xmlns:a16="http://schemas.microsoft.com/office/drawing/2014/main" id="{BF69093B-2894-49BD-BC77-111048F7EE2F}"/>
               </a:ext>
             </a:extLst>
           </p:cNvPr>
@@ -5368,7 +5368,7 @@
           <p:cNvPr id="5" name="Footer Placeholder 4">
             <a:extLst xmlns:a="http://schemas.openxmlformats.org/drawingml/2006/main">
               <a:ext uri="{FF2B5EF4-FFF2-40B4-BE49-F238E27FC236}">
-                <a16:creationId xmlns:a16="http://schemas.microsoft.com/office/drawing/2014/main" id="{3B8D44A7-42C8-4025-8579-BC1FA9292813}"/>
+                <a16:creationId xmlns:a16="http://schemas.microsoft.com/office/drawing/2014/main" id="{A564FA4C-9B8E-4F8E-AC58-9B83F9203499}"/>
               </a:ext>
             </a:extLst>
           </p:cNvPr>
@@ -5410,7 +5410,7 @@
           <p:cNvPr id="6" name="Slide Number Placeholder 5">
             <a:extLst xmlns:a="http://schemas.openxmlformats.org/drawingml/2006/main">
               <a:ext uri="{FF2B5EF4-FFF2-40B4-BE49-F238E27FC236}">
-                <a16:creationId xmlns:a16="http://schemas.microsoft.com/office/drawing/2014/main" id="{2F0A2098-0853-47C4-BD4E-0D05CF9558CA}"/>
+                <a16:creationId xmlns:a16="http://schemas.microsoft.com/office/drawing/2014/main" id="{32EEB6E8-CD94-45F6-8CCA-096954F90977}"/>
               </a:ext>
             </a:extLst>
           </p:cNvPr>
@@ -5455,17 +5455,17 @@
   </p:cSld>
   <p:clrMap bg1="lt1" tx1="dk1" bg2="lt2" tx2="dk2" accent1="accent1" accent2="accent2" accent3="accent3" accent4="accent4" accent5="accent5" accent6="accent6" hlink="hlink" folHlink="folHlink"/>
   <p:sldLayoutIdLst>
-    <p:sldLayoutId xmlns:r="http://schemas.openxmlformats.org/officeDocument/2006/relationships" id="2147483649" r:id="R155d5e078f5041c8"/>
-    <p:sldLayoutId xmlns:r="http://schemas.openxmlformats.org/officeDocument/2006/relationships" id="2147483650" r:id="Rfceffbe568ad4021"/>
-    <p:sldLayoutId xmlns:r="http://schemas.openxmlformats.org/officeDocument/2006/relationships" id="2147483651" r:id="R81f394d44b364983"/>
-    <p:sldLayoutId xmlns:r="http://schemas.openxmlformats.org/officeDocument/2006/relationships" id="2147483652" r:id="R6dd83de2137241d2"/>
-    <p:sldLayoutId xmlns:r="http://schemas.openxmlformats.org/officeDocument/2006/relationships" id="2147483653" r:id="R05009a37861a461e"/>
-    <p:sldLayoutId xmlns:r="http://schemas.openxmlformats.org/officeDocument/2006/relationships" id="2147483654" r:id="Rc6511cc0fbae4e26"/>
-    <p:sldLayoutId xmlns:r="http://schemas.openxmlformats.org/officeDocument/2006/relationships" id="2147483655" r:id="Rb7ec10971e724373"/>
-    <p:sldLayoutId xmlns:r="http://schemas.openxmlformats.org/officeDocument/2006/relationships" id="2147483656" r:id="R464ed4f1fc3c424f"/>
-    <p:sldLayoutId xmlns:r="http://schemas.openxmlformats.org/officeDocument/2006/relationships" id="2147483657" r:id="Rbb05dd0c94bb412e"/>
-    <p:sldLayoutId xmlns:r="http://schemas.openxmlformats.org/officeDocument/2006/relationships" id="2147483658" r:id="R88efe05268784aed"/>
-    <p:sldLayoutId xmlns:r="http://schemas.openxmlformats.org/officeDocument/2006/relationships" id="2147483659" r:id="Ra780f3f56c4a475f"/>
+    <p:sldLayoutId xmlns:r="http://schemas.openxmlformats.org/officeDocument/2006/relationships" id="2147483649" r:id="R81a9e77a20944906"/>
+    <p:sldLayoutId xmlns:r="http://schemas.openxmlformats.org/officeDocument/2006/relationships" id="2147483650" r:id="Rba0146680ebf4aff"/>
+    <p:sldLayoutId xmlns:r="http://schemas.openxmlformats.org/officeDocument/2006/relationships" id="2147483651" r:id="R0e6cc09eca7b4837"/>
+    <p:sldLayoutId xmlns:r="http://schemas.openxmlformats.org/officeDocument/2006/relationships" id="2147483652" r:id="R31f34ca51b0148c5"/>
+    <p:sldLayoutId xmlns:r="http://schemas.openxmlformats.org/officeDocument/2006/relationships" id="2147483653" r:id="R15240216081946f0"/>
+    <p:sldLayoutId xmlns:r="http://schemas.openxmlformats.org/officeDocument/2006/relationships" id="2147483654" r:id="R965693c872f648d3"/>
+    <p:sldLayoutId xmlns:r="http://schemas.openxmlformats.org/officeDocument/2006/relationships" id="2147483655" r:id="R633aa97895434760"/>
+    <p:sldLayoutId xmlns:r="http://schemas.openxmlformats.org/officeDocument/2006/relationships" id="2147483656" r:id="Re010475ec9d641f8"/>
+    <p:sldLayoutId xmlns:r="http://schemas.openxmlformats.org/officeDocument/2006/relationships" id="2147483657" r:id="R81c6e35e28074cb0"/>
+    <p:sldLayoutId xmlns:r="http://schemas.openxmlformats.org/officeDocument/2006/relationships" id="2147483658" r:id="Rf26d059145e3479b"/>
+    <p:sldLayoutId xmlns:r="http://schemas.openxmlformats.org/officeDocument/2006/relationships" id="2147483659" r:id="Rbcb97eb59bcd4e5a"/>
   </p:sldLayoutIdLst>
   <p:txStyles>
     <p:titleStyle>
@@ -6018,7 +6018,7 @@
           <p:cNvPr id="2" name="Rectangle 1">
             <a:extLst xmlns:a="http://schemas.openxmlformats.org/drawingml/2006/main">
               <a:ext uri="{FF2B5EF4-FFF2-40B4-BE49-F238E27FC236}">
-                <a16:creationId xmlns:a16="http://schemas.microsoft.com/office/drawing/2014/main" id="{6D503E17-79D3-4B5A-B27B-C579E48FE1F4}"/>
+                <a16:creationId xmlns:a16="http://schemas.microsoft.com/office/drawing/2014/main" id="{DD954622-B252-4BB6-9886-4862C11F4918}"/>
               </a:ext>
             </a:extLst>
           </p:cNvPr>
@@ -6073,7 +6073,7 @@
           <p:cNvPr id="3" name="TextBox 2">
             <a:extLst xmlns:a="http://schemas.openxmlformats.org/drawingml/2006/main">
               <a:ext uri="{FF2B5EF4-FFF2-40B4-BE49-F238E27FC236}">
-                <a16:creationId xmlns:a16="http://schemas.microsoft.com/office/drawing/2014/main" id="{DBCAC493-BAF1-40AF-938F-47205524ADA4}"/>
+                <a16:creationId xmlns:a16="http://schemas.microsoft.com/office/drawing/2014/main" id="{5D4FDF2D-12BC-41D4-A640-52547C9C4E06}"/>
               </a:ext>
             </a:extLst>
           </p:cNvPr>
@@ -6120,7 +6120,7 @@
           <p:cNvPr id="4" name="TextBox 3">
             <a:extLst xmlns:a="http://schemas.openxmlformats.org/drawingml/2006/main">
               <a:ext uri="{FF2B5EF4-FFF2-40B4-BE49-F238E27FC236}">
-                <a16:creationId xmlns:a16="http://schemas.microsoft.com/office/drawing/2014/main" id="{5ABBC59F-0684-4A01-A24A-176E47F963F4}"/>
+                <a16:creationId xmlns:a16="http://schemas.microsoft.com/office/drawing/2014/main" id="{792C2E5B-4A03-44EA-BA40-33FF8B9D56D3}"/>
               </a:ext>
             </a:extLst>
           </p:cNvPr>
@@ -6188,7 +6188,7 @@
           <p:cNvPr id="5" name="TextBox 4">
             <a:extLst xmlns:a="http://schemas.openxmlformats.org/drawingml/2006/main">
               <a:ext uri="{FF2B5EF4-FFF2-40B4-BE49-F238E27FC236}">
-                <a16:creationId xmlns:a16="http://schemas.microsoft.com/office/drawing/2014/main" id="{A4D6E15A-247D-4891-B3E0-E72189176EDF}"/>
+                <a16:creationId xmlns:a16="http://schemas.microsoft.com/office/drawing/2014/main" id="{C75286D3-3980-42E7-8CE4-5A705207FF8B}"/>
               </a:ext>
             </a:extLst>
           </p:cNvPr>
@@ -6235,7 +6235,7 @@
           <p:cNvPr id="6" name="Rectangle 5">
             <a:extLst xmlns:a="http://schemas.openxmlformats.org/drawingml/2006/main">
               <a:ext uri="{FF2B5EF4-FFF2-40B4-BE49-F238E27FC236}">
-                <a16:creationId xmlns:a16="http://schemas.microsoft.com/office/drawing/2014/main" id="{6032E93A-832A-4E89-A460-529F837E6831}"/>
+                <a16:creationId xmlns:a16="http://schemas.microsoft.com/office/drawing/2014/main" id="{7C2874BB-028E-4BFF-B725-72D1F43974A0}"/>
               </a:ext>
             </a:extLst>
           </p:cNvPr>
@@ -6290,7 +6290,7 @@
           <p:cNvPr id="7" name="TextBox 6">
             <a:extLst xmlns:a="http://schemas.openxmlformats.org/drawingml/2006/main">
               <a:ext uri="{FF2B5EF4-FFF2-40B4-BE49-F238E27FC236}">
-                <a16:creationId xmlns:a16="http://schemas.microsoft.com/office/drawing/2014/main" id="{B9EF7646-FF06-407B-9375-295FD11E28F7}"/>
+                <a16:creationId xmlns:a16="http://schemas.microsoft.com/office/drawing/2014/main" id="{12D623E3-273C-4C66-9547-83DD023D1E67}"/>
               </a:ext>
             </a:extLst>
           </p:cNvPr>
@@ -6337,7 +6337,7 @@
           <p:cNvPr id="8" name="TextBox 7">
             <a:extLst xmlns:a="http://schemas.openxmlformats.org/drawingml/2006/main">
               <a:ext uri="{FF2B5EF4-FFF2-40B4-BE49-F238E27FC236}">
-                <a16:creationId xmlns:a16="http://schemas.microsoft.com/office/drawing/2014/main" id="{9B8DBE83-FE04-42C1-A432-5FD464A57C21}"/>
+                <a16:creationId xmlns:a16="http://schemas.microsoft.com/office/drawing/2014/main" id="{B830A4CD-4C82-4CF3-A914-F4C4AFD8AFCB}"/>
               </a:ext>
             </a:extLst>
           </p:cNvPr>
@@ -6374,7 +6374,7 @@
                 <a:ea typeface="Aptos"/>
                 <a:cs typeface="Aptos"/>
               </a:rPr>
-              <a:t>2026.07.22-8</a:t>
+              <a:t>2026.07.22-9</a:t>
             </a:r>
           </a:p>
         </p:txBody>
@@ -6384,7 +6384,7 @@
           <p:cNvPr id="9" name="TextBox 8">
             <a:extLst xmlns:a="http://schemas.openxmlformats.org/drawingml/2006/main">
               <a:ext uri="{FF2B5EF4-FFF2-40B4-BE49-F238E27FC236}">
-                <a16:creationId xmlns:a16="http://schemas.microsoft.com/office/drawing/2014/main" id="{2D609DB8-5CF7-4F45-B697-B1066B85441E}"/>
+                <a16:creationId xmlns:a16="http://schemas.microsoft.com/office/drawing/2014/main" id="{583B0AD9-62B5-4E9A-B59C-B3DF1665A79B}"/>
               </a:ext>
             </a:extLst>
           </p:cNvPr>
@@ -6452,7 +6452,7 @@
           <p:cNvPr id="10" name="TextBox 9">
             <a:extLst xmlns:a="http://schemas.openxmlformats.org/drawingml/2006/main">
               <a:ext uri="{FF2B5EF4-FFF2-40B4-BE49-F238E27FC236}">
-                <a16:creationId xmlns:a16="http://schemas.microsoft.com/office/drawing/2014/main" id="{A150DE0A-4BBF-4175-AB59-FB865EA96356}"/>
+                <a16:creationId xmlns:a16="http://schemas.microsoft.com/office/drawing/2014/main" id="{6DDC634D-1984-4241-B506-3B4DD7DA4F4E}"/>
               </a:ext>
             </a:extLst>
           </p:cNvPr>
@@ -6499,7 +6499,7 @@
           <p:cNvPr id="11" name="TextBox 10">
             <a:extLst xmlns:a="http://schemas.openxmlformats.org/drawingml/2006/main">
               <a:ext uri="{FF2B5EF4-FFF2-40B4-BE49-F238E27FC236}">
-                <a16:creationId xmlns:a16="http://schemas.microsoft.com/office/drawing/2014/main" id="{B3FBF516-5785-4B31-87C8-80BE94E3D96D}"/>
+                <a16:creationId xmlns:a16="http://schemas.microsoft.com/office/drawing/2014/main" id="{4BD4CBCF-ACD6-47E6-AD4C-F62FFAE120A5}"/>
               </a:ext>
             </a:extLst>
           </p:cNvPr>
@@ -6546,7 +6546,7 @@
           <p:cNvPr id="12" name="TextBox 11">
             <a:extLst xmlns:a="http://schemas.openxmlformats.org/drawingml/2006/main">
               <a:ext uri="{FF2B5EF4-FFF2-40B4-BE49-F238E27FC236}">
-                <a16:creationId xmlns:a16="http://schemas.microsoft.com/office/drawing/2014/main" id="{E804C718-3A1D-4E29-A11A-3C568BD6B98C}"/>
+                <a16:creationId xmlns:a16="http://schemas.microsoft.com/office/drawing/2014/main" id="{D6DA264B-2DC6-4EF5-BFD6-DF2BF6D90D34}"/>
               </a:ext>
             </a:extLst>
           </p:cNvPr>
@@ -6591,7 +6591,7 @@
     </p:spTree>
     <p:extLst>
       <p:ext uri="{BB962C8B-B14F-4D97-AF65-F5344CB8AC3E}">
-        <p14:creationId xmlns:p14="http://schemas.microsoft.com/office/powerpoint/2010/main" val="768524673"/>
+        <p14:creationId xmlns:p14="http://schemas.microsoft.com/office/powerpoint/2010/main" val="740424126"/>
       </p:ext>
     </p:extLst>
   </p:cSld>
@@ -6615,7 +6615,7 @@
           <p:cNvPr id="2" name="TextBox 1">
             <a:extLst xmlns:a="http://schemas.openxmlformats.org/drawingml/2006/main">
               <a:ext uri="{FF2B5EF4-FFF2-40B4-BE49-F238E27FC236}">
-                <a16:creationId xmlns:a16="http://schemas.microsoft.com/office/drawing/2014/main" id="{59C45BB6-D56E-48F8-A679-651379D82ACC}"/>
+                <a16:creationId xmlns:a16="http://schemas.microsoft.com/office/drawing/2014/main" id="{D268E322-EDD7-4B18-9AEA-77ABB93B604C}"/>
               </a:ext>
             </a:extLst>
           </p:cNvPr>
@@ -6662,7 +6662,7 @@
           <p:cNvPr id="3" name="TextBox 2">
             <a:extLst xmlns:a="http://schemas.openxmlformats.org/drawingml/2006/main">
               <a:ext uri="{FF2B5EF4-FFF2-40B4-BE49-F238E27FC236}">
-                <a16:creationId xmlns:a16="http://schemas.microsoft.com/office/drawing/2014/main" id="{D3177054-5663-4F90-B0E9-99E70D4072BB}"/>
+                <a16:creationId xmlns:a16="http://schemas.microsoft.com/office/drawing/2014/main" id="{3265EDCF-C001-4662-9C33-EF329B166CEF}"/>
               </a:ext>
             </a:extLst>
           </p:cNvPr>
@@ -6709,7 +6709,7 @@
           <p:cNvPr id="4" name="Rectangle 3">
             <a:extLst xmlns:a="http://schemas.openxmlformats.org/drawingml/2006/main">
               <a:ext uri="{FF2B5EF4-FFF2-40B4-BE49-F238E27FC236}">
-                <a16:creationId xmlns:a16="http://schemas.microsoft.com/office/drawing/2014/main" id="{CB564E50-B3B1-4A5D-871F-5989D8C6CAB2}"/>
+                <a16:creationId xmlns:a16="http://schemas.microsoft.com/office/drawing/2014/main" id="{039BC21F-7DD1-4F28-A336-CC1F0BBB7F16}"/>
               </a:ext>
             </a:extLst>
           </p:cNvPr>
@@ -6764,7 +6764,7 @@
           <p:cNvPr id="5" name="Rectangle 4">
             <a:extLst xmlns:a="http://schemas.openxmlformats.org/drawingml/2006/main">
               <a:ext uri="{FF2B5EF4-FFF2-40B4-BE49-F238E27FC236}">
-                <a16:creationId xmlns:a16="http://schemas.microsoft.com/office/drawing/2014/main" id="{20FB9A5F-FA91-49FD-8BC3-B9CBCFC005DD}"/>
+                <a16:creationId xmlns:a16="http://schemas.microsoft.com/office/drawing/2014/main" id="{24A40B15-2E87-43CD-BD70-026406062D3E}"/>
               </a:ext>
             </a:extLst>
           </p:cNvPr>
@@ -6819,7 +6819,7 @@
           <p:cNvPr id="6" name="TextBox 5">
             <a:extLst xmlns:a="http://schemas.openxmlformats.org/drawingml/2006/main">
               <a:ext uri="{FF2B5EF4-FFF2-40B4-BE49-F238E27FC236}">
-                <a16:creationId xmlns:a16="http://schemas.microsoft.com/office/drawing/2014/main" id="{0EB67338-D202-4893-98FE-E5DE28315BE9}"/>
+                <a16:creationId xmlns:a16="http://schemas.microsoft.com/office/drawing/2014/main" id="{0A1141D7-3E13-43F4-B6DB-EC2E58B84785}"/>
               </a:ext>
             </a:extLst>
           </p:cNvPr>
@@ -6856,7 +6856,7 @@
                 <a:ea typeface="Aptos"/>
                 <a:cs typeface="Aptos"/>
               </a:rPr>
-              <a:t>Independent public evidence summary · 2026.07.22-8 · 2026-07-22 · Sources: RPX; CNIPA guidance; EPO family</a:t>
+              <a:t>Independent public evidence summary · 2026.07.22-9 · 2026-07-22 · Sources: RPX; CNIPA guidance; EPO family</a:t>
             </a:r>
           </a:p>
         </p:txBody>
@@ -6866,7 +6866,7 @@
           <p:cNvPr id="7" name="TextBox 6">
             <a:extLst xmlns:a="http://schemas.openxmlformats.org/drawingml/2006/main">
               <a:ext uri="{FF2B5EF4-FFF2-40B4-BE49-F238E27FC236}">
-                <a16:creationId xmlns:a16="http://schemas.microsoft.com/office/drawing/2014/main" id="{487364A2-EE86-4D6B-B6E8-68C216013DAD}"/>
+                <a16:creationId xmlns:a16="http://schemas.microsoft.com/office/drawing/2014/main" id="{6326962D-FBED-4D6F-A996-5973E274A00E}"/>
               </a:ext>
             </a:extLst>
           </p:cNvPr>
@@ -6913,7 +6913,7 @@
           <p:cNvPr id="8" name="TextBox 7">
             <a:extLst xmlns:a="http://schemas.openxmlformats.org/drawingml/2006/main">
               <a:ext uri="{FF2B5EF4-FFF2-40B4-BE49-F238E27FC236}">
-                <a16:creationId xmlns:a16="http://schemas.microsoft.com/office/drawing/2014/main" id="{A4F1E488-D5F7-4EA2-BE7B-4C60A42461E7}"/>
+                <a16:creationId xmlns:a16="http://schemas.microsoft.com/office/drawing/2014/main" id="{ACD0CBEA-0DDC-41D1-9A14-14CB66082468}"/>
               </a:ext>
             </a:extLst>
           </p:cNvPr>
@@ -6960,7 +6960,7 @@
           <p:cNvPr id="9" name="TextBox 8">
             <a:extLst xmlns:a="http://schemas.openxmlformats.org/drawingml/2006/main">
               <a:ext uri="{FF2B5EF4-FFF2-40B4-BE49-F238E27FC236}">
-                <a16:creationId xmlns:a16="http://schemas.microsoft.com/office/drawing/2014/main" id="{E56B9AAD-2D05-4A43-9C98-073FEDD6F154}"/>
+                <a16:creationId xmlns:a16="http://schemas.microsoft.com/office/drawing/2014/main" id="{6C0F58FB-2CA0-49EE-AA2E-691F7847C05F}"/>
               </a:ext>
             </a:extLst>
           </p:cNvPr>
@@ -7057,7 +7057,7 @@
           <p:cNvPr id="10" name="Rounded Rectangle 9">
             <a:extLst xmlns:a="http://schemas.openxmlformats.org/drawingml/2006/main">
               <a:ext uri="{FF2B5EF4-FFF2-40B4-BE49-F238E27FC236}">
-                <a16:creationId xmlns:a16="http://schemas.microsoft.com/office/drawing/2014/main" id="{E38C0B5C-0A08-4C5A-B60B-412FFA1BDD7B}"/>
+                <a16:creationId xmlns:a16="http://schemas.microsoft.com/office/drawing/2014/main" id="{E8AEEFEC-61EF-4F64-BC01-3A754B9AC943}"/>
               </a:ext>
             </a:extLst>
           </p:cNvPr>
@@ -7114,7 +7114,7 @@
           <p:cNvPr id="11" name="TextBox 10">
             <a:extLst xmlns:a="http://schemas.openxmlformats.org/drawingml/2006/main">
               <a:ext uri="{FF2B5EF4-FFF2-40B4-BE49-F238E27FC236}">
-                <a16:creationId xmlns:a16="http://schemas.microsoft.com/office/drawing/2014/main" id="{44B629AA-2AE5-4770-A396-59EA3914D52D}"/>
+                <a16:creationId xmlns:a16="http://schemas.microsoft.com/office/drawing/2014/main" id="{9E551C28-2294-49AD-842D-184107772AB5}"/>
               </a:ext>
             </a:extLst>
           </p:cNvPr>
@@ -7161,7 +7161,7 @@
           <p:cNvPr id="12" name="TextBox 11">
             <a:extLst xmlns:a="http://schemas.openxmlformats.org/drawingml/2006/main">
               <a:ext uri="{FF2B5EF4-FFF2-40B4-BE49-F238E27FC236}">
-                <a16:creationId xmlns:a16="http://schemas.microsoft.com/office/drawing/2014/main" id="{881E536E-D9D1-40FA-B95C-8830CB8D0AA5}"/>
+                <a16:creationId xmlns:a16="http://schemas.microsoft.com/office/drawing/2014/main" id="{262C9C30-379F-4B90-B6B6-1892A4AA693E}"/>
               </a:ext>
             </a:extLst>
           </p:cNvPr>
@@ -7206,7 +7206,7 @@
     </p:spTree>
     <p:extLst>
       <p:ext uri="{BB962C8B-B14F-4D97-AF65-F5344CB8AC3E}">
-        <p14:creationId xmlns:p14="http://schemas.microsoft.com/office/powerpoint/2010/main" val="467708196"/>
+        <p14:creationId xmlns:p14="http://schemas.microsoft.com/office/powerpoint/2010/main" val="2007796088"/>
       </p:ext>
     </p:extLst>
   </p:cSld>
@@ -7230,7 +7230,7 @@
           <p:cNvPr id="2" name="TextBox 1">
             <a:extLst xmlns:a="http://schemas.openxmlformats.org/drawingml/2006/main">
               <a:ext uri="{FF2B5EF4-FFF2-40B4-BE49-F238E27FC236}">
-                <a16:creationId xmlns:a16="http://schemas.microsoft.com/office/drawing/2014/main" id="{0BAF5A30-829A-474A-A55A-7CFCBEDB79DA}"/>
+                <a16:creationId xmlns:a16="http://schemas.microsoft.com/office/drawing/2014/main" id="{B6AF9ACC-9A10-488D-8332-C6C0D934CC62}"/>
               </a:ext>
             </a:extLst>
           </p:cNvPr>
@@ -7277,7 +7277,7 @@
           <p:cNvPr id="3" name="TextBox 2">
             <a:extLst xmlns:a="http://schemas.openxmlformats.org/drawingml/2006/main">
               <a:ext uri="{FF2B5EF4-FFF2-40B4-BE49-F238E27FC236}">
-                <a16:creationId xmlns:a16="http://schemas.microsoft.com/office/drawing/2014/main" id="{CCBD63AA-E924-46CF-807C-2BCFB6C83AD2}"/>
+                <a16:creationId xmlns:a16="http://schemas.microsoft.com/office/drawing/2014/main" id="{90BFEDF8-C461-47BE-BC5D-CF4F1AE631A2}"/>
               </a:ext>
             </a:extLst>
           </p:cNvPr>
@@ -7324,7 +7324,7 @@
           <p:cNvPr id="4" name="Rectangle 3">
             <a:extLst xmlns:a="http://schemas.openxmlformats.org/drawingml/2006/main">
               <a:ext uri="{FF2B5EF4-FFF2-40B4-BE49-F238E27FC236}">
-                <a16:creationId xmlns:a16="http://schemas.microsoft.com/office/drawing/2014/main" id="{FA9CA240-9B4B-425F-8FF6-AC05AE974E93}"/>
+                <a16:creationId xmlns:a16="http://schemas.microsoft.com/office/drawing/2014/main" id="{A7A5D4EB-80E0-4991-AAFB-6242914E08DE}"/>
               </a:ext>
             </a:extLst>
           </p:cNvPr>
@@ -7379,7 +7379,7 @@
           <p:cNvPr id="5" name="Rectangle 4">
             <a:extLst xmlns:a="http://schemas.openxmlformats.org/drawingml/2006/main">
               <a:ext uri="{FF2B5EF4-FFF2-40B4-BE49-F238E27FC236}">
-                <a16:creationId xmlns:a16="http://schemas.microsoft.com/office/drawing/2014/main" id="{A859EDF8-EE1A-45D8-80A7-9FAB85476A95}"/>
+                <a16:creationId xmlns:a16="http://schemas.microsoft.com/office/drawing/2014/main" id="{8FE3D0F6-1CD9-417F-AE6C-EADEA96F28C5}"/>
               </a:ext>
             </a:extLst>
           </p:cNvPr>
@@ -7434,7 +7434,7 @@
           <p:cNvPr id="6" name="TextBox 5">
             <a:extLst xmlns:a="http://schemas.openxmlformats.org/drawingml/2006/main">
               <a:ext uri="{FF2B5EF4-FFF2-40B4-BE49-F238E27FC236}">
-                <a16:creationId xmlns:a16="http://schemas.microsoft.com/office/drawing/2014/main" id="{3B4A108F-59BA-4DEB-9F13-611321A5B929}"/>
+                <a16:creationId xmlns:a16="http://schemas.microsoft.com/office/drawing/2014/main" id="{B04B292D-9C96-4D89-A6F9-183D4A72DD72}"/>
               </a:ext>
             </a:extLst>
           </p:cNvPr>
@@ -7471,7 +7471,7 @@
                 <a:ea typeface="Aptos"/>
                 <a:cs typeface="Aptos"/>
               </a:rPr>
-              <a:t>Independent public evidence summary · 2026.07.22-8 · 2026-07-22 · Sources: IP Australia; PRH; EPO; EPO / UPC; USPTO</a:t>
+              <a:t>Independent public evidence summary · 2026.07.22-9 · 2026-07-22 · Sources: IP Australia; PRH; EPO; EPO / UPC; USPTO</a:t>
             </a:r>
           </a:p>
         </p:txBody>
@@ -7481,7 +7481,7 @@
           <p:cNvPr id="7" name="TextBox 6">
             <a:extLst xmlns:a="http://schemas.openxmlformats.org/drawingml/2006/main">
               <a:ext uri="{FF2B5EF4-FFF2-40B4-BE49-F238E27FC236}">
-                <a16:creationId xmlns:a16="http://schemas.microsoft.com/office/drawing/2014/main" id="{BCAE9A08-19FA-4203-B17A-9A811CC26FE7}"/>
+                <a16:creationId xmlns:a16="http://schemas.microsoft.com/office/drawing/2014/main" id="{B0F0E5FA-069C-4BDF-AAB8-8C6817FA5FEB}"/>
               </a:ext>
             </a:extLst>
           </p:cNvPr>
@@ -7968,7 +7968,7 @@
           <p:cNvPr id="9" name="TextBox 8">
             <a:extLst xmlns:a="http://schemas.openxmlformats.org/drawingml/2006/main">
               <a:ext uri="{FF2B5EF4-FFF2-40B4-BE49-F238E27FC236}">
-                <a16:creationId xmlns:a16="http://schemas.microsoft.com/office/drawing/2014/main" id="{12973C98-F6E0-4933-835C-BD0323C04C43}"/>
+                <a16:creationId xmlns:a16="http://schemas.microsoft.com/office/drawing/2014/main" id="{01F8A7B3-4815-4C6E-AE6A-D26A0228EDFF}"/>
               </a:ext>
             </a:extLst>
           </p:cNvPr>
@@ -8013,7 +8013,7 @@
     </p:spTree>
     <p:extLst>
       <p:ext uri="{BB962C8B-B14F-4D97-AF65-F5344CB8AC3E}">
-        <p14:creationId xmlns:p14="http://schemas.microsoft.com/office/powerpoint/2010/main" val="2024552900"/>
+        <p14:creationId xmlns:p14="http://schemas.microsoft.com/office/powerpoint/2010/main" val="1771571262"/>
       </p:ext>
     </p:extLst>
   </p:cSld>
@@ -8037,7 +8037,7 @@
           <p:cNvPr id="2" name="TextBox 1">
             <a:extLst xmlns:a="http://schemas.openxmlformats.org/drawingml/2006/main">
               <a:ext uri="{FF2B5EF4-FFF2-40B4-BE49-F238E27FC236}">
-                <a16:creationId xmlns:a16="http://schemas.microsoft.com/office/drawing/2014/main" id="{E29E634A-8FF3-4D93-867C-10F1FB658659}"/>
+                <a16:creationId xmlns:a16="http://schemas.microsoft.com/office/drawing/2014/main" id="{1B848FBE-732B-4C9F-A0E1-5EE818656414}"/>
               </a:ext>
             </a:extLst>
           </p:cNvPr>
@@ -8084,7 +8084,7 @@
           <p:cNvPr id="3" name="TextBox 2">
             <a:extLst xmlns:a="http://schemas.openxmlformats.org/drawingml/2006/main">
               <a:ext uri="{FF2B5EF4-FFF2-40B4-BE49-F238E27FC236}">
-                <a16:creationId xmlns:a16="http://schemas.microsoft.com/office/drawing/2014/main" id="{5EC08E6A-6165-4F61-BDCB-CE9692AB14D3}"/>
+                <a16:creationId xmlns:a16="http://schemas.microsoft.com/office/drawing/2014/main" id="{4F94AF81-1AB6-4EB5-9235-C85BBFF7D007}"/>
               </a:ext>
             </a:extLst>
           </p:cNvPr>
@@ -8131,7 +8131,7 @@
           <p:cNvPr id="4" name="Rectangle 3">
             <a:extLst xmlns:a="http://schemas.openxmlformats.org/drawingml/2006/main">
               <a:ext uri="{FF2B5EF4-FFF2-40B4-BE49-F238E27FC236}">
-                <a16:creationId xmlns:a16="http://schemas.microsoft.com/office/drawing/2014/main" id="{787EC350-3FA8-4709-BED9-6C0A67A14248}"/>
+                <a16:creationId xmlns:a16="http://schemas.microsoft.com/office/drawing/2014/main" id="{FC4BD03F-6AB8-4339-8822-A32241C9E9D5}"/>
               </a:ext>
             </a:extLst>
           </p:cNvPr>
@@ -8186,7 +8186,7 @@
           <p:cNvPr id="5" name="Rectangle 4">
             <a:extLst xmlns:a="http://schemas.openxmlformats.org/drawingml/2006/main">
               <a:ext uri="{FF2B5EF4-FFF2-40B4-BE49-F238E27FC236}">
-                <a16:creationId xmlns:a16="http://schemas.microsoft.com/office/drawing/2014/main" id="{FB63E2C3-FA1A-4F6B-8CDE-1C02F1AA59D3}"/>
+                <a16:creationId xmlns:a16="http://schemas.microsoft.com/office/drawing/2014/main" id="{D46CDFFC-86CC-4130-838E-65EDAD4393CE}"/>
               </a:ext>
             </a:extLst>
           </p:cNvPr>
@@ -8241,7 +8241,7 @@
           <p:cNvPr id="6" name="TextBox 5">
             <a:extLst xmlns:a="http://schemas.openxmlformats.org/drawingml/2006/main">
               <a:ext uri="{FF2B5EF4-FFF2-40B4-BE49-F238E27FC236}">
-                <a16:creationId xmlns:a16="http://schemas.microsoft.com/office/drawing/2014/main" id="{E327AFEC-974D-4468-9AAB-4579713EBCE3}"/>
+                <a16:creationId xmlns:a16="http://schemas.microsoft.com/office/drawing/2014/main" id="{F61BB9C8-86C2-412F-94C5-D9276D1B8531}"/>
               </a:ext>
             </a:extLst>
           </p:cNvPr>
@@ -8278,7 +8278,7 @@
                 <a:ea typeface="Aptos"/>
                 <a:cs typeface="Aptos"/>
               </a:rPr>
-              <a:t>Independent public evidence summary · 2026.07.22-8 · 2026-07-22 · Sources: UN; Atlas</a:t>
+              <a:t>Independent public evidence summary · 2026.07.22-9 · 2026-07-22 · Sources: UN; Atlas</a:t>
             </a:r>
           </a:p>
         </p:txBody>
@@ -8288,7 +8288,7 @@
           <p:cNvPr id="7" name="TextBox 6">
             <a:extLst xmlns:a="http://schemas.openxmlformats.org/drawingml/2006/main">
               <a:ext uri="{FF2B5EF4-FFF2-40B4-BE49-F238E27FC236}">
-                <a16:creationId xmlns:a16="http://schemas.microsoft.com/office/drawing/2014/main" id="{D0FE06E3-41B4-4891-A25B-62A933492E66}"/>
+                <a16:creationId xmlns:a16="http://schemas.microsoft.com/office/drawing/2014/main" id="{35F21FE3-C3CD-42FC-A3E0-AF12F30741B8}"/>
               </a:ext>
             </a:extLst>
           </p:cNvPr>
@@ -8335,7 +8335,7 @@
           <p:cNvPr id="8" name="Rounded Rectangle 7">
             <a:extLst xmlns:a="http://schemas.openxmlformats.org/drawingml/2006/main">
               <a:ext uri="{FF2B5EF4-FFF2-40B4-BE49-F238E27FC236}">
-                <a16:creationId xmlns:a16="http://schemas.microsoft.com/office/drawing/2014/main" id="{E41E4915-B188-4BF6-B59A-71174674A8D7}"/>
+                <a16:creationId xmlns:a16="http://schemas.microsoft.com/office/drawing/2014/main" id="{7C8E7FD7-6C4A-4AF2-B2D9-C013C5669F2B}"/>
               </a:ext>
             </a:extLst>
           </p:cNvPr>
@@ -8392,7 +8392,7 @@
           <p:cNvPr id="9" name="TextBox 8">
             <a:extLst xmlns:a="http://schemas.openxmlformats.org/drawingml/2006/main">
               <a:ext uri="{FF2B5EF4-FFF2-40B4-BE49-F238E27FC236}">
-                <a16:creationId xmlns:a16="http://schemas.microsoft.com/office/drawing/2014/main" id="{B1120C88-F2C0-47FB-A0FF-A14770A50B68}"/>
+                <a16:creationId xmlns:a16="http://schemas.microsoft.com/office/drawing/2014/main" id="{C8579EB4-EA27-47F3-8747-DA0792F1CE81}"/>
               </a:ext>
             </a:extLst>
           </p:cNvPr>
@@ -8439,7 +8439,7 @@
           <p:cNvPr id="10" name="TextBox 9">
             <a:extLst xmlns:a="http://schemas.openxmlformats.org/drawingml/2006/main">
               <a:ext uri="{FF2B5EF4-FFF2-40B4-BE49-F238E27FC236}">
-                <a16:creationId xmlns:a16="http://schemas.microsoft.com/office/drawing/2014/main" id="{8AF6AD5A-FF74-4410-863F-9EA83CBAD0D2}"/>
+                <a16:creationId xmlns:a16="http://schemas.microsoft.com/office/drawing/2014/main" id="{17BE9D3B-B4A6-44D2-80A7-7491C695FBC0}"/>
               </a:ext>
             </a:extLst>
           </p:cNvPr>
@@ -8486,7 +8486,7 @@
           <p:cNvPr id="11" name="Rounded Rectangle 10">
             <a:extLst xmlns:a="http://schemas.openxmlformats.org/drawingml/2006/main">
               <a:ext uri="{FF2B5EF4-FFF2-40B4-BE49-F238E27FC236}">
-                <a16:creationId xmlns:a16="http://schemas.microsoft.com/office/drawing/2014/main" id="{AEF62206-73E4-4BA7-90BE-BE92023DF294}"/>
+                <a16:creationId xmlns:a16="http://schemas.microsoft.com/office/drawing/2014/main" id="{74D1EC7B-2587-4CDB-9C69-5CAA92EFC1DF}"/>
               </a:ext>
             </a:extLst>
           </p:cNvPr>
@@ -8543,7 +8543,7 @@
           <p:cNvPr id="12" name="TextBox 11">
             <a:extLst xmlns:a="http://schemas.openxmlformats.org/drawingml/2006/main">
               <a:ext uri="{FF2B5EF4-FFF2-40B4-BE49-F238E27FC236}">
-                <a16:creationId xmlns:a16="http://schemas.microsoft.com/office/drawing/2014/main" id="{6EC09B54-C26A-4476-A522-017D6FFE98D8}"/>
+                <a16:creationId xmlns:a16="http://schemas.microsoft.com/office/drawing/2014/main" id="{BC275A3F-A3F7-4E7A-94F5-C60FF570D8A9}"/>
               </a:ext>
             </a:extLst>
           </p:cNvPr>
@@ -8590,7 +8590,7 @@
           <p:cNvPr id="13" name="TextBox 12">
             <a:extLst xmlns:a="http://schemas.openxmlformats.org/drawingml/2006/main">
               <a:ext uri="{FF2B5EF4-FFF2-40B4-BE49-F238E27FC236}">
-                <a16:creationId xmlns:a16="http://schemas.microsoft.com/office/drawing/2014/main" id="{02CAD627-1C50-42B7-B72F-29BAF4AE29B6}"/>
+                <a16:creationId xmlns:a16="http://schemas.microsoft.com/office/drawing/2014/main" id="{BFCBABE1-97BE-4097-9FA5-24CF92AE5813}"/>
               </a:ext>
             </a:extLst>
           </p:cNvPr>
@@ -8637,7 +8637,7 @@
           <p:cNvPr id="14" name="Rounded Rectangle 13">
             <a:extLst xmlns:a="http://schemas.openxmlformats.org/drawingml/2006/main">
               <a:ext uri="{FF2B5EF4-FFF2-40B4-BE49-F238E27FC236}">
-                <a16:creationId xmlns:a16="http://schemas.microsoft.com/office/drawing/2014/main" id="{291B8B7E-62B2-4E01-811E-F168CDF0545E}"/>
+                <a16:creationId xmlns:a16="http://schemas.microsoft.com/office/drawing/2014/main" id="{F77C224F-1C07-4799-965D-0915124B1052}"/>
               </a:ext>
             </a:extLst>
           </p:cNvPr>
@@ -8694,7 +8694,7 @@
           <p:cNvPr id="15" name="TextBox 14">
             <a:extLst xmlns:a="http://schemas.openxmlformats.org/drawingml/2006/main">
               <a:ext uri="{FF2B5EF4-FFF2-40B4-BE49-F238E27FC236}">
-                <a16:creationId xmlns:a16="http://schemas.microsoft.com/office/drawing/2014/main" id="{A7C87468-64E7-427C-8556-C0D6040C1306}"/>
+                <a16:creationId xmlns:a16="http://schemas.microsoft.com/office/drawing/2014/main" id="{D4486C71-C47C-476D-9F89-23CB44770ABC}"/>
               </a:ext>
             </a:extLst>
           </p:cNvPr>
@@ -8741,7 +8741,7 @@
           <p:cNvPr id="16" name="TextBox 15">
             <a:extLst xmlns:a="http://schemas.openxmlformats.org/drawingml/2006/main">
               <a:ext uri="{FF2B5EF4-FFF2-40B4-BE49-F238E27FC236}">
-                <a16:creationId xmlns:a16="http://schemas.microsoft.com/office/drawing/2014/main" id="{4DA49FD2-F046-4E09-AE82-ABCAAD363821}"/>
+                <a16:creationId xmlns:a16="http://schemas.microsoft.com/office/drawing/2014/main" id="{527BD842-379E-418D-9C6A-EB4AE5CD5B94}"/>
               </a:ext>
             </a:extLst>
           </p:cNvPr>
@@ -8788,7 +8788,7 @@
           <p:cNvPr id="17" name="Rounded Rectangle 16">
             <a:extLst xmlns:a="http://schemas.openxmlformats.org/drawingml/2006/main">
               <a:ext uri="{FF2B5EF4-FFF2-40B4-BE49-F238E27FC236}">
-                <a16:creationId xmlns:a16="http://schemas.microsoft.com/office/drawing/2014/main" id="{42AEE45A-9019-45EE-AC25-8099A072A933}"/>
+                <a16:creationId xmlns:a16="http://schemas.microsoft.com/office/drawing/2014/main" id="{662168AA-21E6-4F50-B55A-FEED54F92F41}"/>
               </a:ext>
             </a:extLst>
           </p:cNvPr>
@@ -8845,7 +8845,7 @@
           <p:cNvPr id="18" name="TextBox 17">
             <a:extLst xmlns:a="http://schemas.openxmlformats.org/drawingml/2006/main">
               <a:ext uri="{FF2B5EF4-FFF2-40B4-BE49-F238E27FC236}">
-                <a16:creationId xmlns:a16="http://schemas.microsoft.com/office/drawing/2014/main" id="{B2A9619E-D287-4E33-9DA8-9E7FB398FC2B}"/>
+                <a16:creationId xmlns:a16="http://schemas.microsoft.com/office/drawing/2014/main" id="{8BF0CFF4-92D9-4DEA-9649-8C2323FF9D78}"/>
               </a:ext>
             </a:extLst>
           </p:cNvPr>
@@ -8892,7 +8892,7 @@
           <p:cNvPr id="19" name="TextBox 18">
             <a:extLst xmlns:a="http://schemas.openxmlformats.org/drawingml/2006/main">
               <a:ext uri="{FF2B5EF4-FFF2-40B4-BE49-F238E27FC236}">
-                <a16:creationId xmlns:a16="http://schemas.microsoft.com/office/drawing/2014/main" id="{2A6D844D-8773-4313-B01A-25849387A584}"/>
+                <a16:creationId xmlns:a16="http://schemas.microsoft.com/office/drawing/2014/main" id="{59D499BE-DACA-408E-AF32-2945FEAE138D}"/>
               </a:ext>
             </a:extLst>
           </p:cNvPr>
@@ -8939,7 +8939,7 @@
           <p:cNvPr id="20" name="TextBox 19">
             <a:extLst xmlns:a="http://schemas.openxmlformats.org/drawingml/2006/main">
               <a:ext uri="{FF2B5EF4-FFF2-40B4-BE49-F238E27FC236}">
-                <a16:creationId xmlns:a16="http://schemas.microsoft.com/office/drawing/2014/main" id="{EE07C1F4-F115-4C80-9D84-27807D5CC2C4}"/>
+                <a16:creationId xmlns:a16="http://schemas.microsoft.com/office/drawing/2014/main" id="{C4653E20-4299-43C9-9AC3-8EAC0E9DD444}"/>
               </a:ext>
             </a:extLst>
           </p:cNvPr>
@@ -8986,7 +8986,7 @@
           <p:cNvPr id="21" name="Rounded Rectangle 20">
             <a:extLst xmlns:a="http://schemas.openxmlformats.org/drawingml/2006/main">
               <a:ext uri="{FF2B5EF4-FFF2-40B4-BE49-F238E27FC236}">
-                <a16:creationId xmlns:a16="http://schemas.microsoft.com/office/drawing/2014/main" id="{702813B9-F700-497C-AE86-C36B8D71CFBD}"/>
+                <a16:creationId xmlns:a16="http://schemas.microsoft.com/office/drawing/2014/main" id="{3DCE39FF-28F1-49E3-81C0-D6079E4C23D3}"/>
               </a:ext>
             </a:extLst>
           </p:cNvPr>
@@ -9043,7 +9043,7 @@
           <p:cNvPr id="22" name="TextBox 21">
             <a:extLst xmlns:a="http://schemas.openxmlformats.org/drawingml/2006/main">
               <a:ext uri="{FF2B5EF4-FFF2-40B4-BE49-F238E27FC236}">
-                <a16:creationId xmlns:a16="http://schemas.microsoft.com/office/drawing/2014/main" id="{741580E1-1B20-434C-AB50-A179AAC4EFCB}"/>
+                <a16:creationId xmlns:a16="http://schemas.microsoft.com/office/drawing/2014/main" id="{CB803758-96F7-405F-B8A1-9EC442B8AE34}"/>
               </a:ext>
             </a:extLst>
           </p:cNvPr>
@@ -9090,7 +9090,7 @@
           <p:cNvPr id="23" name="TextBox 22">
             <a:extLst xmlns:a="http://schemas.openxmlformats.org/drawingml/2006/main">
               <a:ext uri="{FF2B5EF4-FFF2-40B4-BE49-F238E27FC236}">
-                <a16:creationId xmlns:a16="http://schemas.microsoft.com/office/drawing/2014/main" id="{68750209-D14D-4A97-B578-43B5EF362A9A}"/>
+                <a16:creationId xmlns:a16="http://schemas.microsoft.com/office/drawing/2014/main" id="{13824250-3ED0-4407-BBA9-7BA67AC54706}"/>
               </a:ext>
             </a:extLst>
           </p:cNvPr>
@@ -9135,7 +9135,7 @@
     </p:spTree>
     <p:extLst>
       <p:ext uri="{BB962C8B-B14F-4D97-AF65-F5344CB8AC3E}">
-        <p14:creationId xmlns:p14="http://schemas.microsoft.com/office/powerpoint/2010/main" val="859576736"/>
+        <p14:creationId xmlns:p14="http://schemas.microsoft.com/office/powerpoint/2010/main" val="1053656129"/>
       </p:ext>
     </p:extLst>
   </p:cSld>
@@ -9159,7 +9159,7 @@
           <p:cNvPr id="2" name="TextBox 1">
             <a:extLst xmlns:a="http://schemas.openxmlformats.org/drawingml/2006/main">
               <a:ext uri="{FF2B5EF4-FFF2-40B4-BE49-F238E27FC236}">
-                <a16:creationId xmlns:a16="http://schemas.microsoft.com/office/drawing/2014/main" id="{DC644FF1-3637-4EBE-A9D6-317484E82B9E}"/>
+                <a16:creationId xmlns:a16="http://schemas.microsoft.com/office/drawing/2014/main" id="{75AAC6CF-403D-4C9D-A753-445C2170F6C5}"/>
               </a:ext>
             </a:extLst>
           </p:cNvPr>
@@ -9206,7 +9206,7 @@
           <p:cNvPr id="3" name="TextBox 2">
             <a:extLst xmlns:a="http://schemas.openxmlformats.org/drawingml/2006/main">
               <a:ext uri="{FF2B5EF4-FFF2-40B4-BE49-F238E27FC236}">
-                <a16:creationId xmlns:a16="http://schemas.microsoft.com/office/drawing/2014/main" id="{26EC65B9-E1F3-4887-A1AC-37B4707CC441}"/>
+                <a16:creationId xmlns:a16="http://schemas.microsoft.com/office/drawing/2014/main" id="{079AF131-9B87-4F01-9CB8-5DB3649A5335}"/>
               </a:ext>
             </a:extLst>
           </p:cNvPr>
@@ -9253,7 +9253,7 @@
           <p:cNvPr id="4" name="Rectangle 3">
             <a:extLst xmlns:a="http://schemas.openxmlformats.org/drawingml/2006/main">
               <a:ext uri="{FF2B5EF4-FFF2-40B4-BE49-F238E27FC236}">
-                <a16:creationId xmlns:a16="http://schemas.microsoft.com/office/drawing/2014/main" id="{094626DE-42B9-47AC-A4C1-E4B7CDAAB386}"/>
+                <a16:creationId xmlns:a16="http://schemas.microsoft.com/office/drawing/2014/main" id="{982F86DB-9B24-4FF4-B81D-3BA6229E51E8}"/>
               </a:ext>
             </a:extLst>
           </p:cNvPr>
@@ -9308,7 +9308,7 @@
           <p:cNvPr id="5" name="Rectangle 4">
             <a:extLst xmlns:a="http://schemas.openxmlformats.org/drawingml/2006/main">
               <a:ext uri="{FF2B5EF4-FFF2-40B4-BE49-F238E27FC236}">
-                <a16:creationId xmlns:a16="http://schemas.microsoft.com/office/drawing/2014/main" id="{EE0109BD-7762-4574-8965-AC2747629BE4}"/>
+                <a16:creationId xmlns:a16="http://schemas.microsoft.com/office/drawing/2014/main" id="{20DAE225-6A75-4ECE-8B9C-9FDEE2D69F3C}"/>
               </a:ext>
             </a:extLst>
           </p:cNvPr>
@@ -9363,7 +9363,7 @@
           <p:cNvPr id="6" name="TextBox 5">
             <a:extLst xmlns:a="http://schemas.openxmlformats.org/drawingml/2006/main">
               <a:ext uri="{FF2B5EF4-FFF2-40B4-BE49-F238E27FC236}">
-                <a16:creationId xmlns:a16="http://schemas.microsoft.com/office/drawing/2014/main" id="{B75BB7DC-02B8-4035-895D-380A71368D26}"/>
+                <a16:creationId xmlns:a16="http://schemas.microsoft.com/office/drawing/2014/main" id="{7D3D3FEC-C9E1-486A-AA99-3A91D513726C}"/>
               </a:ext>
             </a:extLst>
           </p:cNvPr>
@@ -9400,7 +9400,7 @@
                 <a:ea typeface="Aptos"/>
                 <a:cs typeface="Aptos"/>
               </a:rPr>
-              <a:t>Independent public evidence summary · 2026.07.22-8 · 2026-07-22 · Sources: Health Canada; Destatis; Vero; Sejm; Swedish Government</a:t>
+              <a:t>Independent public evidence summary · 2026.07.22-9 · 2026-07-22 · Sources: Health Canada; Destatis; Vero; Sejm; Swedish Government</a:t>
             </a:r>
           </a:p>
         </p:txBody>
@@ -9410,7 +9410,7 @@
           <p:cNvPr id="7" name="TextBox 6">
             <a:extLst xmlns:a="http://schemas.openxmlformats.org/drawingml/2006/main">
               <a:ext uri="{FF2B5EF4-FFF2-40B4-BE49-F238E27FC236}">
-                <a16:creationId xmlns:a16="http://schemas.microsoft.com/office/drawing/2014/main" id="{7D96D0A8-69FF-434E-AED6-763007A72837}"/>
+                <a16:creationId xmlns:a16="http://schemas.microsoft.com/office/drawing/2014/main" id="{FF9D7F3D-D30C-4435-A1B4-E2A91708EB88}"/>
               </a:ext>
             </a:extLst>
           </p:cNvPr>
@@ -9980,7 +9980,7 @@
           <p:cNvPr id="9" name="TextBox 8">
             <a:extLst xmlns:a="http://schemas.openxmlformats.org/drawingml/2006/main">
               <a:ext uri="{FF2B5EF4-FFF2-40B4-BE49-F238E27FC236}">
-                <a16:creationId xmlns:a16="http://schemas.microsoft.com/office/drawing/2014/main" id="{638F06E5-36DB-4065-AA18-96BA1103821B}"/>
+                <a16:creationId xmlns:a16="http://schemas.microsoft.com/office/drawing/2014/main" id="{82143438-2D76-40AA-9B4F-ACB8737B1C16}"/>
               </a:ext>
             </a:extLst>
           </p:cNvPr>
@@ -10025,7 +10025,7 @@
     </p:spTree>
     <p:extLst>
       <p:ext uri="{BB962C8B-B14F-4D97-AF65-F5344CB8AC3E}">
-        <p14:creationId xmlns:p14="http://schemas.microsoft.com/office/powerpoint/2010/main" val="1088600854"/>
+        <p14:creationId xmlns:p14="http://schemas.microsoft.com/office/powerpoint/2010/main" val="908447170"/>
       </p:ext>
     </p:extLst>
   </p:cSld>
@@ -10049,7 +10049,7 @@
           <p:cNvPr id="2" name="TextBox 1">
             <a:extLst xmlns:a="http://schemas.openxmlformats.org/drawingml/2006/main">
               <a:ext uri="{FF2B5EF4-FFF2-40B4-BE49-F238E27FC236}">
-                <a16:creationId xmlns:a16="http://schemas.microsoft.com/office/drawing/2014/main" id="{E3400B25-E7F3-475B-BC10-BC8D8E6E94A5}"/>
+                <a16:creationId xmlns:a16="http://schemas.microsoft.com/office/drawing/2014/main" id="{C75E4BFB-5ADD-4646-BDA0-0072CD4CACD3}"/>
               </a:ext>
             </a:extLst>
           </p:cNvPr>
@@ -10096,7 +10096,7 @@
           <p:cNvPr id="3" name="TextBox 2">
             <a:extLst xmlns:a="http://schemas.openxmlformats.org/drawingml/2006/main">
               <a:ext uri="{FF2B5EF4-FFF2-40B4-BE49-F238E27FC236}">
-                <a16:creationId xmlns:a16="http://schemas.microsoft.com/office/drawing/2014/main" id="{1F7AB691-D315-47F1-BCA1-44AD25474823}"/>
+                <a16:creationId xmlns:a16="http://schemas.microsoft.com/office/drawing/2014/main" id="{059BB44C-CE6A-469F-9979-FDA2C47DF7C4}"/>
               </a:ext>
             </a:extLst>
           </p:cNvPr>
@@ -10143,7 +10143,7 @@
           <p:cNvPr id="4" name="Rectangle 3">
             <a:extLst xmlns:a="http://schemas.openxmlformats.org/drawingml/2006/main">
               <a:ext uri="{FF2B5EF4-FFF2-40B4-BE49-F238E27FC236}">
-                <a16:creationId xmlns:a16="http://schemas.microsoft.com/office/drawing/2014/main" id="{00EC5417-42B7-424F-9085-73E28137A80E}"/>
+                <a16:creationId xmlns:a16="http://schemas.microsoft.com/office/drawing/2014/main" id="{D13330CB-AA6B-41B2-8300-468989448B93}"/>
               </a:ext>
             </a:extLst>
           </p:cNvPr>
@@ -10198,7 +10198,7 @@
           <p:cNvPr id="5" name="Rectangle 4">
             <a:extLst xmlns:a="http://schemas.openxmlformats.org/drawingml/2006/main">
               <a:ext uri="{FF2B5EF4-FFF2-40B4-BE49-F238E27FC236}">
-                <a16:creationId xmlns:a16="http://schemas.microsoft.com/office/drawing/2014/main" id="{B20735F7-F679-4F96-B9F5-5210082BBC79}"/>
+                <a16:creationId xmlns:a16="http://schemas.microsoft.com/office/drawing/2014/main" id="{50EFEF3F-6194-48E7-841A-E9EC75F74893}"/>
               </a:ext>
             </a:extLst>
           </p:cNvPr>
@@ -10253,7 +10253,7 @@
           <p:cNvPr id="6" name="TextBox 5">
             <a:extLst xmlns:a="http://schemas.openxmlformats.org/drawingml/2006/main">
               <a:ext uri="{FF2B5EF4-FFF2-40B4-BE49-F238E27FC236}">
-                <a16:creationId xmlns:a16="http://schemas.microsoft.com/office/drawing/2014/main" id="{3314CD34-1D95-4BDE-A8D5-1BA729E4D814}"/>
+                <a16:creationId xmlns:a16="http://schemas.microsoft.com/office/drawing/2014/main" id="{B4A9EE12-0994-4AAF-A622-39C6403B4B87}"/>
               </a:ext>
             </a:extLst>
           </p:cNvPr>
@@ -10290,7 +10290,7 @@
                 <a:ea typeface="Aptos"/>
                 <a:cs typeface="Aptos"/>
               </a:rPr>
-              <a:t>Independent public evidence summary · 2026.07.22-8 · 2026-07-22 · Sources: Health Canada 2024</a:t>
+              <a:t>Independent public evidence summary · 2026.07.22-9 · 2026-07-22 · Sources: Health Canada 2024</a:t>
             </a:r>
           </a:p>
         </p:txBody>
@@ -10300,7 +10300,7 @@
           <p:cNvPr id="7" name="TextBox 6">
             <a:extLst xmlns:a="http://schemas.openxmlformats.org/drawingml/2006/main">
               <a:ext uri="{FF2B5EF4-FFF2-40B4-BE49-F238E27FC236}">
-                <a16:creationId xmlns:a16="http://schemas.microsoft.com/office/drawing/2014/main" id="{3AFB3341-83F7-430F-98AE-15248F8AB0CA}"/>
+                <a16:creationId xmlns:a16="http://schemas.microsoft.com/office/drawing/2014/main" id="{EAE534A5-4A89-4498-8BBB-C85FA4DA731E}"/>
               </a:ext>
             </a:extLst>
           </p:cNvPr>
@@ -10347,7 +10347,7 @@
           <p:cNvPr id="8" name="Rounded Rectangle 7">
             <a:extLst xmlns:a="http://schemas.openxmlformats.org/drawingml/2006/main">
               <a:ext uri="{FF2B5EF4-FFF2-40B4-BE49-F238E27FC236}">
-                <a16:creationId xmlns:a16="http://schemas.microsoft.com/office/drawing/2014/main" id="{36BC302F-F48E-49EA-89D4-DBC55FA77BFC}"/>
+                <a16:creationId xmlns:a16="http://schemas.microsoft.com/office/drawing/2014/main" id="{112A39CE-FC67-43B8-BF28-1CCDFF378542}"/>
               </a:ext>
             </a:extLst>
           </p:cNvPr>
@@ -10404,7 +10404,7 @@
           <p:cNvPr id="9" name="TextBox 8">
             <a:extLst xmlns:a="http://schemas.openxmlformats.org/drawingml/2006/main">
               <a:ext uri="{FF2B5EF4-FFF2-40B4-BE49-F238E27FC236}">
-                <a16:creationId xmlns:a16="http://schemas.microsoft.com/office/drawing/2014/main" id="{0E3D4A28-1C17-482A-9581-AD7BED2A5763}"/>
+                <a16:creationId xmlns:a16="http://schemas.microsoft.com/office/drawing/2014/main" id="{2A68605A-3654-4D8C-ACC3-68E68591E851}"/>
               </a:ext>
             </a:extLst>
           </p:cNvPr>
@@ -10451,7 +10451,7 @@
           <p:cNvPr id="10" name="TextBox 9">
             <a:extLst xmlns:a="http://schemas.openxmlformats.org/drawingml/2006/main">
               <a:ext uri="{FF2B5EF4-FFF2-40B4-BE49-F238E27FC236}">
-                <a16:creationId xmlns:a16="http://schemas.microsoft.com/office/drawing/2014/main" id="{F5AA6257-A2D3-4C66-9AFB-D1E4D4B8BB6D}"/>
+                <a16:creationId xmlns:a16="http://schemas.microsoft.com/office/drawing/2014/main" id="{F97F40E1-9603-4390-8E2A-94FDFC16E39C}"/>
               </a:ext>
             </a:extLst>
           </p:cNvPr>
@@ -10498,7 +10498,7 @@
           <p:cNvPr id="11" name="Rounded Rectangle 10">
             <a:extLst xmlns:a="http://schemas.openxmlformats.org/drawingml/2006/main">
               <a:ext uri="{FF2B5EF4-FFF2-40B4-BE49-F238E27FC236}">
-                <a16:creationId xmlns:a16="http://schemas.microsoft.com/office/drawing/2014/main" id="{E035AB71-60BC-476F-8376-01E48E7C009E}"/>
+                <a16:creationId xmlns:a16="http://schemas.microsoft.com/office/drawing/2014/main" id="{22DD5251-6816-4609-97D2-C6A3E8C98DF9}"/>
               </a:ext>
             </a:extLst>
           </p:cNvPr>
@@ -10555,7 +10555,7 @@
           <p:cNvPr id="12" name="TextBox 11">
             <a:extLst xmlns:a="http://schemas.openxmlformats.org/drawingml/2006/main">
               <a:ext uri="{FF2B5EF4-FFF2-40B4-BE49-F238E27FC236}">
-                <a16:creationId xmlns:a16="http://schemas.microsoft.com/office/drawing/2014/main" id="{D79033EC-FB40-4A20-8260-7817F89DCD8F}"/>
+                <a16:creationId xmlns:a16="http://schemas.microsoft.com/office/drawing/2014/main" id="{056FF869-041A-41FC-8D56-F63A9C3474AA}"/>
               </a:ext>
             </a:extLst>
           </p:cNvPr>
@@ -10602,7 +10602,7 @@
           <p:cNvPr id="13" name="TextBox 12">
             <a:extLst xmlns:a="http://schemas.openxmlformats.org/drawingml/2006/main">
               <a:ext uri="{FF2B5EF4-FFF2-40B4-BE49-F238E27FC236}">
-                <a16:creationId xmlns:a16="http://schemas.microsoft.com/office/drawing/2014/main" id="{B47F955F-767F-4D0D-BC31-8EF3AB08EF61}"/>
+                <a16:creationId xmlns:a16="http://schemas.microsoft.com/office/drawing/2014/main" id="{4BF31271-41D3-4D5E-AF58-F02A0F5D425F}"/>
               </a:ext>
             </a:extLst>
           </p:cNvPr>
@@ -10649,7 +10649,7 @@
           <p:cNvPr id="14" name="Rounded Rectangle 13">
             <a:extLst xmlns:a="http://schemas.openxmlformats.org/drawingml/2006/main">
               <a:ext uri="{FF2B5EF4-FFF2-40B4-BE49-F238E27FC236}">
-                <a16:creationId xmlns:a16="http://schemas.microsoft.com/office/drawing/2014/main" id="{734EC2F7-12E0-48CA-B1E5-049763CA380E}"/>
+                <a16:creationId xmlns:a16="http://schemas.microsoft.com/office/drawing/2014/main" id="{56921BA5-C4D8-40A4-9695-35B28057D27C}"/>
               </a:ext>
             </a:extLst>
           </p:cNvPr>
@@ -10706,7 +10706,7 @@
           <p:cNvPr id="15" name="TextBox 14">
             <a:extLst xmlns:a="http://schemas.openxmlformats.org/drawingml/2006/main">
               <a:ext uri="{FF2B5EF4-FFF2-40B4-BE49-F238E27FC236}">
-                <a16:creationId xmlns:a16="http://schemas.microsoft.com/office/drawing/2014/main" id="{1FA36C9F-A367-4123-8E3D-10B9F03C8F98}"/>
+                <a16:creationId xmlns:a16="http://schemas.microsoft.com/office/drawing/2014/main" id="{340DBA46-11F1-42E2-B8CA-A5FFECFEEA5A}"/>
               </a:ext>
             </a:extLst>
           </p:cNvPr>
@@ -10753,7 +10753,7 @@
           <p:cNvPr id="16" name="TextBox 15">
             <a:extLst xmlns:a="http://schemas.openxmlformats.org/drawingml/2006/main">
               <a:ext uri="{FF2B5EF4-FFF2-40B4-BE49-F238E27FC236}">
-                <a16:creationId xmlns:a16="http://schemas.microsoft.com/office/drawing/2014/main" id="{5659C3F4-926E-444C-9144-42ED2131E524}"/>
+                <a16:creationId xmlns:a16="http://schemas.microsoft.com/office/drawing/2014/main" id="{773DEFD7-79BD-4275-A420-CAB80D0C37DB}"/>
               </a:ext>
             </a:extLst>
           </p:cNvPr>
@@ -10800,7 +10800,7 @@
           <p:cNvPr id="17" name="TextBox 16">
             <a:extLst xmlns:a="http://schemas.openxmlformats.org/drawingml/2006/main">
               <a:ext uri="{FF2B5EF4-FFF2-40B4-BE49-F238E27FC236}">
-                <a16:creationId xmlns:a16="http://schemas.microsoft.com/office/drawing/2014/main" id="{BEEA54E1-B608-4911-8A46-E596BA6492C1}"/>
+                <a16:creationId xmlns:a16="http://schemas.microsoft.com/office/drawing/2014/main" id="{95519D40-B48E-48FE-B8CB-3D34AFD4D829}"/>
               </a:ext>
             </a:extLst>
           </p:cNvPr>
@@ -10847,7 +10847,7 @@
           <p:cNvPr id="18" name="Rounded Rectangle 17">
             <a:extLst xmlns:a="http://schemas.openxmlformats.org/drawingml/2006/main">
               <a:ext uri="{FF2B5EF4-FFF2-40B4-BE49-F238E27FC236}">
-                <a16:creationId xmlns:a16="http://schemas.microsoft.com/office/drawing/2014/main" id="{BE6E6E95-3CE6-44DA-8BC7-D0081529D4DC}"/>
+                <a16:creationId xmlns:a16="http://schemas.microsoft.com/office/drawing/2014/main" id="{853198C0-409A-4AD0-BA0B-F56507DFD919}"/>
               </a:ext>
             </a:extLst>
           </p:cNvPr>
@@ -10904,7 +10904,7 @@
           <p:cNvPr id="19" name="TextBox 18">
             <a:extLst xmlns:a="http://schemas.openxmlformats.org/drawingml/2006/main">
               <a:ext uri="{FF2B5EF4-FFF2-40B4-BE49-F238E27FC236}">
-                <a16:creationId xmlns:a16="http://schemas.microsoft.com/office/drawing/2014/main" id="{900DCFD4-FE90-421E-9528-B06026AB9C9F}"/>
+                <a16:creationId xmlns:a16="http://schemas.microsoft.com/office/drawing/2014/main" id="{D30D8E8A-3384-4F8F-8088-9352D11E2CC9}"/>
               </a:ext>
             </a:extLst>
           </p:cNvPr>
@@ -10951,7 +10951,7 @@
           <p:cNvPr id="20" name="TextBox 19">
             <a:extLst xmlns:a="http://schemas.openxmlformats.org/drawingml/2006/main">
               <a:ext uri="{FF2B5EF4-FFF2-40B4-BE49-F238E27FC236}">
-                <a16:creationId xmlns:a16="http://schemas.microsoft.com/office/drawing/2014/main" id="{AF36E921-80B0-4546-86C1-3DBA8598532A}"/>
+                <a16:creationId xmlns:a16="http://schemas.microsoft.com/office/drawing/2014/main" id="{6F05FA5E-16B9-4085-875D-03453B6D93A5}"/>
               </a:ext>
             </a:extLst>
           </p:cNvPr>
@@ -10996,7 +10996,7 @@
     </p:spTree>
     <p:extLst>
       <p:ext uri="{BB962C8B-B14F-4D97-AF65-F5344CB8AC3E}">
-        <p14:creationId xmlns:p14="http://schemas.microsoft.com/office/powerpoint/2010/main" val="1866733624"/>
+        <p14:creationId xmlns:p14="http://schemas.microsoft.com/office/powerpoint/2010/main" val="1896385266"/>
       </p:ext>
     </p:extLst>
   </p:cSld>
@@ -11020,7 +11020,7 @@
           <p:cNvPr id="2" name="TextBox 1">
             <a:extLst xmlns:a="http://schemas.openxmlformats.org/drawingml/2006/main">
               <a:ext uri="{FF2B5EF4-FFF2-40B4-BE49-F238E27FC236}">
-                <a16:creationId xmlns:a16="http://schemas.microsoft.com/office/drawing/2014/main" id="{CB244F35-37E9-4363-8B41-486451F94982}"/>
+                <a16:creationId xmlns:a16="http://schemas.microsoft.com/office/drawing/2014/main" id="{A700B5B6-5290-46D0-B2D7-C864FF31B02D}"/>
               </a:ext>
             </a:extLst>
           </p:cNvPr>
@@ -11067,7 +11067,7 @@
           <p:cNvPr id="3" name="TextBox 2">
             <a:extLst xmlns:a="http://schemas.openxmlformats.org/drawingml/2006/main">
               <a:ext uri="{FF2B5EF4-FFF2-40B4-BE49-F238E27FC236}">
-                <a16:creationId xmlns:a16="http://schemas.microsoft.com/office/drawing/2014/main" id="{4253F181-D724-46A2-897D-24011A36DF86}"/>
+                <a16:creationId xmlns:a16="http://schemas.microsoft.com/office/drawing/2014/main" id="{0893CBF7-4192-4413-AA9E-090AAB9DAD1D}"/>
               </a:ext>
             </a:extLst>
           </p:cNvPr>
@@ -11114,7 +11114,7 @@
           <p:cNvPr id="4" name="Rectangle 3">
             <a:extLst xmlns:a="http://schemas.openxmlformats.org/drawingml/2006/main">
               <a:ext uri="{FF2B5EF4-FFF2-40B4-BE49-F238E27FC236}">
-                <a16:creationId xmlns:a16="http://schemas.microsoft.com/office/drawing/2014/main" id="{4C147DF7-CEBC-468E-ACD1-12C0D50F0BC8}"/>
+                <a16:creationId xmlns:a16="http://schemas.microsoft.com/office/drawing/2014/main" id="{F4C6BCEB-DF66-4359-A276-332CDFB34C04}"/>
               </a:ext>
             </a:extLst>
           </p:cNvPr>
@@ -11169,7 +11169,7 @@
           <p:cNvPr id="5" name="Rectangle 4">
             <a:extLst xmlns:a="http://schemas.openxmlformats.org/drawingml/2006/main">
               <a:ext uri="{FF2B5EF4-FFF2-40B4-BE49-F238E27FC236}">
-                <a16:creationId xmlns:a16="http://schemas.microsoft.com/office/drawing/2014/main" id="{98410586-7D1D-4F59-8AA5-BDEA738B1FDE}"/>
+                <a16:creationId xmlns:a16="http://schemas.microsoft.com/office/drawing/2014/main" id="{2F0C490A-4747-4D94-8AC1-8AC6D963335F}"/>
               </a:ext>
             </a:extLst>
           </p:cNvPr>
@@ -11224,7 +11224,7 @@
           <p:cNvPr id="6" name="TextBox 5">
             <a:extLst xmlns:a="http://schemas.openxmlformats.org/drawingml/2006/main">
               <a:ext uri="{FF2B5EF4-FFF2-40B4-BE49-F238E27FC236}">
-                <a16:creationId xmlns:a16="http://schemas.microsoft.com/office/drawing/2014/main" id="{1AAD36F7-6AEA-4F61-9E68-A233F1D471AD}"/>
+                <a16:creationId xmlns:a16="http://schemas.microsoft.com/office/drawing/2014/main" id="{165155F5-57CF-4019-977E-A7D168B5E3B3}"/>
               </a:ext>
             </a:extLst>
           </p:cNvPr>
@@ -11261,7 +11261,7 @@
                 <a:ea typeface="Aptos"/>
                 <a:cs typeface="Aptos"/>
               </a:rPr>
-              <a:t>Independent public evidence summary · 2026.07.22-8 · 2026-07-22 · Sources: Destatis</a:t>
+              <a:t>Independent public evidence summary · 2026.07.22-9 · 2026-07-22 · Sources: Destatis</a:t>
             </a:r>
           </a:p>
         </p:txBody>
@@ -11271,7 +11271,7 @@
           <p:cNvPr id="7" name="TextBox 6">
             <a:extLst xmlns:a="http://schemas.openxmlformats.org/drawingml/2006/main">
               <a:ext uri="{FF2B5EF4-FFF2-40B4-BE49-F238E27FC236}">
-                <a16:creationId xmlns:a16="http://schemas.microsoft.com/office/drawing/2014/main" id="{EB69FAA5-7F12-4B1D-AE07-F19E67F6D49B}"/>
+                <a16:creationId xmlns:a16="http://schemas.microsoft.com/office/drawing/2014/main" id="{B396B180-7561-4E20-9557-8148F3098490}"/>
               </a:ext>
             </a:extLst>
           </p:cNvPr>
@@ -11784,7 +11784,7 @@
           <p:cNvPr id="9" name="TextBox 8">
             <a:extLst xmlns:a="http://schemas.openxmlformats.org/drawingml/2006/main">
               <a:ext uri="{FF2B5EF4-FFF2-40B4-BE49-F238E27FC236}">
-                <a16:creationId xmlns:a16="http://schemas.microsoft.com/office/drawing/2014/main" id="{362FB58A-E2E7-4660-96B1-67737CE4BCFC}"/>
+                <a16:creationId xmlns:a16="http://schemas.microsoft.com/office/drawing/2014/main" id="{EFC502E7-0171-47DD-9FB5-81F137FD8199}"/>
               </a:ext>
             </a:extLst>
           </p:cNvPr>
@@ -11829,7 +11829,7 @@
     </p:spTree>
     <p:extLst>
       <p:ext uri="{BB962C8B-B14F-4D97-AF65-F5344CB8AC3E}">
-        <p14:creationId xmlns:p14="http://schemas.microsoft.com/office/powerpoint/2010/main" val="1460392944"/>
+        <p14:creationId xmlns:p14="http://schemas.microsoft.com/office/powerpoint/2010/main" val="1205900801"/>
       </p:ext>
     </p:extLst>
   </p:cSld>
@@ -11853,7 +11853,7 @@
           <p:cNvPr id="2" name="TextBox 1">
             <a:extLst xmlns:a="http://schemas.openxmlformats.org/drawingml/2006/main">
               <a:ext uri="{FF2B5EF4-FFF2-40B4-BE49-F238E27FC236}">
-                <a16:creationId xmlns:a16="http://schemas.microsoft.com/office/drawing/2014/main" id="{CD215898-9589-46F1-99E5-A90FA6256975}"/>
+                <a16:creationId xmlns:a16="http://schemas.microsoft.com/office/drawing/2014/main" id="{E0266EB8-106E-4494-8F5B-A61A58AA2689}"/>
               </a:ext>
             </a:extLst>
           </p:cNvPr>
@@ -11900,7 +11900,7 @@
           <p:cNvPr id="3" name="TextBox 2">
             <a:extLst xmlns:a="http://schemas.openxmlformats.org/drawingml/2006/main">
               <a:ext uri="{FF2B5EF4-FFF2-40B4-BE49-F238E27FC236}">
-                <a16:creationId xmlns:a16="http://schemas.microsoft.com/office/drawing/2014/main" id="{FA787C59-B95A-48AF-8BF9-8DDB3E2E18A4}"/>
+                <a16:creationId xmlns:a16="http://schemas.microsoft.com/office/drawing/2014/main" id="{B0D7C854-DB79-49CE-8BF0-A882E8C2696B}"/>
               </a:ext>
             </a:extLst>
           </p:cNvPr>
@@ -11947,7 +11947,7 @@
           <p:cNvPr id="4" name="Rectangle 3">
             <a:extLst xmlns:a="http://schemas.openxmlformats.org/drawingml/2006/main">
               <a:ext uri="{FF2B5EF4-FFF2-40B4-BE49-F238E27FC236}">
-                <a16:creationId xmlns:a16="http://schemas.microsoft.com/office/drawing/2014/main" id="{6572BB9E-35E0-430D-BB32-7170414087D9}"/>
+                <a16:creationId xmlns:a16="http://schemas.microsoft.com/office/drawing/2014/main" id="{50490857-390B-4F5E-B660-D50F1F36F625}"/>
               </a:ext>
             </a:extLst>
           </p:cNvPr>
@@ -12002,7 +12002,7 @@
           <p:cNvPr id="5" name="Rectangle 4">
             <a:extLst xmlns:a="http://schemas.openxmlformats.org/drawingml/2006/main">
               <a:ext uri="{FF2B5EF4-FFF2-40B4-BE49-F238E27FC236}">
-                <a16:creationId xmlns:a16="http://schemas.microsoft.com/office/drawing/2014/main" id="{44FBF207-D5A1-4236-9758-2FEA01DCACF0}"/>
+                <a16:creationId xmlns:a16="http://schemas.microsoft.com/office/drawing/2014/main" id="{8DF2CC33-8D36-4F05-AEDD-B75E7FC4FFEE}"/>
               </a:ext>
             </a:extLst>
           </p:cNvPr>
@@ -12057,7 +12057,7 @@
           <p:cNvPr id="6" name="TextBox 5">
             <a:extLst xmlns:a="http://schemas.openxmlformats.org/drawingml/2006/main">
               <a:ext uri="{FF2B5EF4-FFF2-40B4-BE49-F238E27FC236}">
-                <a16:creationId xmlns:a16="http://schemas.microsoft.com/office/drawing/2014/main" id="{CCD82362-7F0C-403E-BF4B-FA77E86675F6}"/>
+                <a16:creationId xmlns:a16="http://schemas.microsoft.com/office/drawing/2014/main" id="{D8578790-4140-4CC3-B0F3-F7D4B6C00EBF}"/>
               </a:ext>
             </a:extLst>
           </p:cNvPr>
@@ -12094,7 +12094,7 @@
                 <a:ea typeface="Aptos"/>
                 <a:cs typeface="Aptos"/>
               </a:rPr>
-              <a:t>Independent public evidence summary · 2026.07.22-8 · 2026-07-22 · Sources: Destatis; inTaste.de</a:t>
+              <a:t>Independent public evidence summary · 2026.07.22-9 · 2026-07-22 · Sources: Destatis; inTaste.de</a:t>
             </a:r>
           </a:p>
         </p:txBody>
@@ -12104,7 +12104,7 @@
           <p:cNvPr id="7" name="TextBox 6">
             <a:extLst xmlns:a="http://schemas.openxmlformats.org/drawingml/2006/main">
               <a:ext uri="{FF2B5EF4-FFF2-40B4-BE49-F238E27FC236}">
-                <a16:creationId xmlns:a16="http://schemas.microsoft.com/office/drawing/2014/main" id="{D8920B37-19FB-4B35-AB96-1F979FA4BA1A}"/>
+                <a16:creationId xmlns:a16="http://schemas.microsoft.com/office/drawing/2014/main" id="{177F31AF-48BB-45BD-82CF-6F2FDF77EAB5}"/>
               </a:ext>
             </a:extLst>
           </p:cNvPr>
@@ -12151,7 +12151,7 @@
           <p:cNvPr id="8" name="Rounded Rectangle 7">
             <a:extLst xmlns:a="http://schemas.openxmlformats.org/drawingml/2006/main">
               <a:ext uri="{FF2B5EF4-FFF2-40B4-BE49-F238E27FC236}">
-                <a16:creationId xmlns:a16="http://schemas.microsoft.com/office/drawing/2014/main" id="{23D430B2-AE33-4BB5-81BB-691D28545851}"/>
+                <a16:creationId xmlns:a16="http://schemas.microsoft.com/office/drawing/2014/main" id="{CC7C4343-28C7-4FA7-A18F-CB50ED73CC96}"/>
               </a:ext>
             </a:extLst>
           </p:cNvPr>
@@ -12208,7 +12208,7 @@
           <p:cNvPr id="9" name="TextBox 8">
             <a:extLst xmlns:a="http://schemas.openxmlformats.org/drawingml/2006/main">
               <a:ext uri="{FF2B5EF4-FFF2-40B4-BE49-F238E27FC236}">
-                <a16:creationId xmlns:a16="http://schemas.microsoft.com/office/drawing/2014/main" id="{583EBDDD-1624-4A9C-8232-121D367B5F93}"/>
+                <a16:creationId xmlns:a16="http://schemas.microsoft.com/office/drawing/2014/main" id="{28814392-5355-4240-9E60-E4DED7D08AA0}"/>
               </a:ext>
             </a:extLst>
           </p:cNvPr>
@@ -12255,7 +12255,7 @@
           <p:cNvPr id="10" name="TextBox 9">
             <a:extLst xmlns:a="http://schemas.openxmlformats.org/drawingml/2006/main">
               <a:ext uri="{FF2B5EF4-FFF2-40B4-BE49-F238E27FC236}">
-                <a16:creationId xmlns:a16="http://schemas.microsoft.com/office/drawing/2014/main" id="{3386FDA5-1AE6-4E87-9FB5-962C4D2FDEF4}"/>
+                <a16:creationId xmlns:a16="http://schemas.microsoft.com/office/drawing/2014/main" id="{DDEEA3CB-5689-49E9-82EF-43931A8EF33E}"/>
               </a:ext>
             </a:extLst>
           </p:cNvPr>
@@ -12302,7 +12302,7 @@
           <p:cNvPr id="11" name="Rounded Rectangle 10">
             <a:extLst xmlns:a="http://schemas.openxmlformats.org/drawingml/2006/main">
               <a:ext uri="{FF2B5EF4-FFF2-40B4-BE49-F238E27FC236}">
-                <a16:creationId xmlns:a16="http://schemas.microsoft.com/office/drawing/2014/main" id="{C78E46C7-C008-431B-A378-CC05A983C3FB}"/>
+                <a16:creationId xmlns:a16="http://schemas.microsoft.com/office/drawing/2014/main" id="{0647806E-A2E3-4929-B88B-4C7B4851F061}"/>
               </a:ext>
             </a:extLst>
           </p:cNvPr>
@@ -12359,7 +12359,7 @@
           <p:cNvPr id="12" name="TextBox 11">
             <a:extLst xmlns:a="http://schemas.openxmlformats.org/drawingml/2006/main">
               <a:ext uri="{FF2B5EF4-FFF2-40B4-BE49-F238E27FC236}">
-                <a16:creationId xmlns:a16="http://schemas.microsoft.com/office/drawing/2014/main" id="{D5A53ED6-B274-4F8D-A0F4-ED2E5819D40E}"/>
+                <a16:creationId xmlns:a16="http://schemas.microsoft.com/office/drawing/2014/main" id="{58E6A19F-A16B-418C-9349-B202DD3F6066}"/>
               </a:ext>
             </a:extLst>
           </p:cNvPr>
@@ -12406,7 +12406,7 @@
           <p:cNvPr id="13" name="TextBox 12">
             <a:extLst xmlns:a="http://schemas.openxmlformats.org/drawingml/2006/main">
               <a:ext uri="{FF2B5EF4-FFF2-40B4-BE49-F238E27FC236}">
-                <a16:creationId xmlns:a16="http://schemas.microsoft.com/office/drawing/2014/main" id="{4AF69404-EC1D-444C-A82D-AFDF91A93A56}"/>
+                <a16:creationId xmlns:a16="http://schemas.microsoft.com/office/drawing/2014/main" id="{46C764FB-B959-4307-948A-7C1484CFFBC1}"/>
               </a:ext>
             </a:extLst>
           </p:cNvPr>
@@ -12453,7 +12453,7 @@
           <p:cNvPr id="14" name="Rounded Rectangle 13">
             <a:extLst xmlns:a="http://schemas.openxmlformats.org/drawingml/2006/main">
               <a:ext uri="{FF2B5EF4-FFF2-40B4-BE49-F238E27FC236}">
-                <a16:creationId xmlns:a16="http://schemas.microsoft.com/office/drawing/2014/main" id="{3102459C-DE5F-4134-9E3D-AD6188407D04}"/>
+                <a16:creationId xmlns:a16="http://schemas.microsoft.com/office/drawing/2014/main" id="{3E047904-6F34-41C2-8AA2-9B880E36754C}"/>
               </a:ext>
             </a:extLst>
           </p:cNvPr>
@@ -12510,7 +12510,7 @@
           <p:cNvPr id="15" name="TextBox 14">
             <a:extLst xmlns:a="http://schemas.openxmlformats.org/drawingml/2006/main">
               <a:ext uri="{FF2B5EF4-FFF2-40B4-BE49-F238E27FC236}">
-                <a16:creationId xmlns:a16="http://schemas.microsoft.com/office/drawing/2014/main" id="{0F9AAF1E-5928-4A70-817C-C4DBC5078840}"/>
+                <a16:creationId xmlns:a16="http://schemas.microsoft.com/office/drawing/2014/main" id="{850ABC25-24F8-4CB8-8DAD-A19B8531512F}"/>
               </a:ext>
             </a:extLst>
           </p:cNvPr>
@@ -12557,7 +12557,7 @@
           <p:cNvPr id="16" name="TextBox 15">
             <a:extLst xmlns:a="http://schemas.openxmlformats.org/drawingml/2006/main">
               <a:ext uri="{FF2B5EF4-FFF2-40B4-BE49-F238E27FC236}">
-                <a16:creationId xmlns:a16="http://schemas.microsoft.com/office/drawing/2014/main" id="{E2C3E49C-5E11-4ECF-AE9B-5E2EE352E44A}"/>
+                <a16:creationId xmlns:a16="http://schemas.microsoft.com/office/drawing/2014/main" id="{52CD0FC0-7129-487B-BCF8-EEBF7430EB50}"/>
               </a:ext>
             </a:extLst>
           </p:cNvPr>
@@ -12604,7 +12604,7 @@
           <p:cNvPr id="17" name="TextBox 16">
             <a:extLst xmlns:a="http://schemas.openxmlformats.org/drawingml/2006/main">
               <a:ext uri="{FF2B5EF4-FFF2-40B4-BE49-F238E27FC236}">
-                <a16:creationId xmlns:a16="http://schemas.microsoft.com/office/drawing/2014/main" id="{31A35529-5F92-47B9-9187-60242E8E1AE4}"/>
+                <a16:creationId xmlns:a16="http://schemas.microsoft.com/office/drawing/2014/main" id="{869F35DA-87C0-4667-9670-FE35E6112A7C}"/>
               </a:ext>
             </a:extLst>
           </p:cNvPr>
@@ -12651,7 +12651,7 @@
           <p:cNvPr id="18" name="Rounded Rectangle 17">
             <a:extLst xmlns:a="http://schemas.openxmlformats.org/drawingml/2006/main">
               <a:ext uri="{FF2B5EF4-FFF2-40B4-BE49-F238E27FC236}">
-                <a16:creationId xmlns:a16="http://schemas.microsoft.com/office/drawing/2014/main" id="{325EBFD0-61B7-438A-8B87-749409828D5C}"/>
+                <a16:creationId xmlns:a16="http://schemas.microsoft.com/office/drawing/2014/main" id="{26111FC8-D795-4B83-8826-6913A533DA9D}"/>
               </a:ext>
             </a:extLst>
           </p:cNvPr>
@@ -12708,7 +12708,7 @@
           <p:cNvPr id="19" name="TextBox 18">
             <a:extLst xmlns:a="http://schemas.openxmlformats.org/drawingml/2006/main">
               <a:ext uri="{FF2B5EF4-FFF2-40B4-BE49-F238E27FC236}">
-                <a16:creationId xmlns:a16="http://schemas.microsoft.com/office/drawing/2014/main" id="{05E8EA21-151B-490A-9968-7DF7D90C9BC2}"/>
+                <a16:creationId xmlns:a16="http://schemas.microsoft.com/office/drawing/2014/main" id="{B86C0D5A-C8AA-46A4-BAE2-9622739FA2F7}"/>
               </a:ext>
             </a:extLst>
           </p:cNvPr>
@@ -12755,7 +12755,7 @@
           <p:cNvPr id="20" name="TextBox 19">
             <a:extLst xmlns:a="http://schemas.openxmlformats.org/drawingml/2006/main">
               <a:ext uri="{FF2B5EF4-FFF2-40B4-BE49-F238E27FC236}">
-                <a16:creationId xmlns:a16="http://schemas.microsoft.com/office/drawing/2014/main" id="{772941C7-D573-4EFA-8645-DC50C2A5BAB1}"/>
+                <a16:creationId xmlns:a16="http://schemas.microsoft.com/office/drawing/2014/main" id="{8F2C4628-2A03-4E1B-B695-C45CB95F6E61}"/>
               </a:ext>
             </a:extLst>
           </p:cNvPr>
@@ -12800,7 +12800,7 @@
     </p:spTree>
     <p:extLst>
       <p:ext uri="{BB962C8B-B14F-4D97-AF65-F5344CB8AC3E}">
-        <p14:creationId xmlns:p14="http://schemas.microsoft.com/office/powerpoint/2010/main" val="185071542"/>
+        <p14:creationId xmlns:p14="http://schemas.microsoft.com/office/powerpoint/2010/main" val="1271372671"/>
       </p:ext>
     </p:extLst>
   </p:cSld>
@@ -12824,7 +12824,7 @@
           <p:cNvPr id="2" name="TextBox 1">
             <a:extLst xmlns:a="http://schemas.openxmlformats.org/drawingml/2006/main">
               <a:ext uri="{FF2B5EF4-FFF2-40B4-BE49-F238E27FC236}">
-                <a16:creationId xmlns:a16="http://schemas.microsoft.com/office/drawing/2014/main" id="{0F409980-77AB-4F06-9C74-4022B8663E07}"/>
+                <a16:creationId xmlns:a16="http://schemas.microsoft.com/office/drawing/2014/main" id="{C229B36F-ADD8-448A-A132-96B9F4601926}"/>
               </a:ext>
             </a:extLst>
           </p:cNvPr>
@@ -12871,7 +12871,7 @@
           <p:cNvPr id="3" name="TextBox 2">
             <a:extLst xmlns:a="http://schemas.openxmlformats.org/drawingml/2006/main">
               <a:ext uri="{FF2B5EF4-FFF2-40B4-BE49-F238E27FC236}">
-                <a16:creationId xmlns:a16="http://schemas.microsoft.com/office/drawing/2014/main" id="{D20F98C2-2A22-4FE0-BA32-E240ACC488C5}"/>
+                <a16:creationId xmlns:a16="http://schemas.microsoft.com/office/drawing/2014/main" id="{431A3CDD-6D82-4663-BD7C-DECE72B8E945}"/>
               </a:ext>
             </a:extLst>
           </p:cNvPr>
@@ -12918,7 +12918,7 @@
           <p:cNvPr id="4" name="Rectangle 3">
             <a:extLst xmlns:a="http://schemas.openxmlformats.org/drawingml/2006/main">
               <a:ext uri="{FF2B5EF4-FFF2-40B4-BE49-F238E27FC236}">
-                <a16:creationId xmlns:a16="http://schemas.microsoft.com/office/drawing/2014/main" id="{9C25CBA6-60A5-42C4-99E7-8EE1E2E82F59}"/>
+                <a16:creationId xmlns:a16="http://schemas.microsoft.com/office/drawing/2014/main" id="{3CF9ED73-4A90-40CD-B104-A47B95F2DABD}"/>
               </a:ext>
             </a:extLst>
           </p:cNvPr>
@@ -12973,7 +12973,7 @@
           <p:cNvPr id="5" name="Rectangle 4">
             <a:extLst xmlns:a="http://schemas.openxmlformats.org/drawingml/2006/main">
               <a:ext uri="{FF2B5EF4-FFF2-40B4-BE49-F238E27FC236}">
-                <a16:creationId xmlns:a16="http://schemas.microsoft.com/office/drawing/2014/main" id="{E8211843-2945-4A5F-B6A2-3B9157022337}"/>
+                <a16:creationId xmlns:a16="http://schemas.microsoft.com/office/drawing/2014/main" id="{E3D23BC4-7C61-4C4E-893A-2C61B47E6118}"/>
               </a:ext>
             </a:extLst>
           </p:cNvPr>
@@ -13028,7 +13028,7 @@
           <p:cNvPr id="6" name="TextBox 5">
             <a:extLst xmlns:a="http://schemas.openxmlformats.org/drawingml/2006/main">
               <a:ext uri="{FF2B5EF4-FFF2-40B4-BE49-F238E27FC236}">
-                <a16:creationId xmlns:a16="http://schemas.microsoft.com/office/drawing/2014/main" id="{9DF44FD1-9E12-4E33-B4DD-E14C2E288CF8}"/>
+                <a16:creationId xmlns:a16="http://schemas.microsoft.com/office/drawing/2014/main" id="{C58C4548-3DFD-49CC-8425-5D7627122317}"/>
               </a:ext>
             </a:extLst>
           </p:cNvPr>
@@ -13065,7 +13065,7 @@
                 <a:ea typeface="Aptos"/>
                 <a:cs typeface="Aptos"/>
               </a:rPr>
-              <a:t>Independent public evidence summary · 2026.07.22-8 · 2026-07-22 · Sources: IMARC; GVR; Fortune</a:t>
+              <a:t>Independent public evidence summary · 2026.07.22-9 · 2026-07-22 · Sources: IMARC; GVR; Fortune</a:t>
             </a:r>
           </a:p>
         </p:txBody>
@@ -13075,7 +13075,7 @@
           <p:cNvPr id="7" name="TextBox 6">
             <a:extLst xmlns:a="http://schemas.openxmlformats.org/drawingml/2006/main">
               <a:ext uri="{FF2B5EF4-FFF2-40B4-BE49-F238E27FC236}">
-                <a16:creationId xmlns:a16="http://schemas.microsoft.com/office/drawing/2014/main" id="{1C75185C-D340-4540-84BE-8495EF6A9C5C}"/>
+                <a16:creationId xmlns:a16="http://schemas.microsoft.com/office/drawing/2014/main" id="{2281D780-4AE8-4221-90AF-9EB2D3B8C6CF}"/>
               </a:ext>
             </a:extLst>
           </p:cNvPr>
@@ -13122,7 +13122,7 @@
           <p:cNvPr id="8" name="Rounded Rectangle 7">
             <a:extLst xmlns:a="http://schemas.openxmlformats.org/drawingml/2006/main">
               <a:ext uri="{FF2B5EF4-FFF2-40B4-BE49-F238E27FC236}">
-                <a16:creationId xmlns:a16="http://schemas.microsoft.com/office/drawing/2014/main" id="{8D2A497D-4C71-44AE-AAEE-3ACA57038DFE}"/>
+                <a16:creationId xmlns:a16="http://schemas.microsoft.com/office/drawing/2014/main" id="{2B25AD0D-711B-4DB8-96F3-21597C0B1EF6}"/>
               </a:ext>
             </a:extLst>
           </p:cNvPr>
@@ -13179,7 +13179,7 @@
           <p:cNvPr id="9" name="TextBox 8">
             <a:extLst xmlns:a="http://schemas.openxmlformats.org/drawingml/2006/main">
               <a:ext uri="{FF2B5EF4-FFF2-40B4-BE49-F238E27FC236}">
-                <a16:creationId xmlns:a16="http://schemas.microsoft.com/office/drawing/2014/main" id="{59DB865A-E978-4C57-95E5-7203DBA20519}"/>
+                <a16:creationId xmlns:a16="http://schemas.microsoft.com/office/drawing/2014/main" id="{6AC812A5-3882-44E0-8BF5-6FD7A5D6E753}"/>
               </a:ext>
             </a:extLst>
           </p:cNvPr>
@@ -13226,7 +13226,7 @@
           <p:cNvPr id="10" name="TextBox 9">
             <a:extLst xmlns:a="http://schemas.openxmlformats.org/drawingml/2006/main">
               <a:ext uri="{FF2B5EF4-FFF2-40B4-BE49-F238E27FC236}">
-                <a16:creationId xmlns:a16="http://schemas.microsoft.com/office/drawing/2014/main" id="{39B35ADB-EDA5-4ABB-8532-88D21A3FCF43}"/>
+                <a16:creationId xmlns:a16="http://schemas.microsoft.com/office/drawing/2014/main" id="{93AD0DFA-41AE-45D1-9FFD-3878EA029822}"/>
               </a:ext>
             </a:extLst>
           </p:cNvPr>
@@ -13273,7 +13273,7 @@
           <p:cNvPr id="11" name="Rounded Rectangle 10">
             <a:extLst xmlns:a="http://schemas.openxmlformats.org/drawingml/2006/main">
               <a:ext uri="{FF2B5EF4-FFF2-40B4-BE49-F238E27FC236}">
-                <a16:creationId xmlns:a16="http://schemas.microsoft.com/office/drawing/2014/main" id="{825A5264-240A-46EB-A6C9-2036E30DAADE}"/>
+                <a16:creationId xmlns:a16="http://schemas.microsoft.com/office/drawing/2014/main" id="{363B09AB-D724-47F5-9A98-FDAFDC8F6B2F}"/>
               </a:ext>
             </a:extLst>
           </p:cNvPr>
@@ -13330,7 +13330,7 @@
           <p:cNvPr id="12" name="TextBox 11">
             <a:extLst xmlns:a="http://schemas.openxmlformats.org/drawingml/2006/main">
               <a:ext uri="{FF2B5EF4-FFF2-40B4-BE49-F238E27FC236}">
-                <a16:creationId xmlns:a16="http://schemas.microsoft.com/office/drawing/2014/main" id="{AF1549BC-8A32-4FCD-836C-E474B6CEA073}"/>
+                <a16:creationId xmlns:a16="http://schemas.microsoft.com/office/drawing/2014/main" id="{BEE580FC-3BE2-41CB-80BA-EA7BBB6A113E}"/>
               </a:ext>
             </a:extLst>
           </p:cNvPr>
@@ -13377,7 +13377,7 @@
           <p:cNvPr id="13" name="TextBox 12">
             <a:extLst xmlns:a="http://schemas.openxmlformats.org/drawingml/2006/main">
               <a:ext uri="{FF2B5EF4-FFF2-40B4-BE49-F238E27FC236}">
-                <a16:creationId xmlns:a16="http://schemas.microsoft.com/office/drawing/2014/main" id="{F6482E0E-FB44-43E6-931F-C2BBC196101D}"/>
+                <a16:creationId xmlns:a16="http://schemas.microsoft.com/office/drawing/2014/main" id="{C987D544-558B-4239-944D-3CBB53C5A73F}"/>
               </a:ext>
             </a:extLst>
           </p:cNvPr>
@@ -13424,7 +13424,7 @@
           <p:cNvPr id="14" name="Rounded Rectangle 13">
             <a:extLst xmlns:a="http://schemas.openxmlformats.org/drawingml/2006/main">
               <a:ext uri="{FF2B5EF4-FFF2-40B4-BE49-F238E27FC236}">
-                <a16:creationId xmlns:a16="http://schemas.microsoft.com/office/drawing/2014/main" id="{AAF5AE85-8196-494D-8D7E-15DD66957517}"/>
+                <a16:creationId xmlns:a16="http://schemas.microsoft.com/office/drawing/2014/main" id="{151FEDD6-FBE1-4637-8A26-C86EAAF81675}"/>
               </a:ext>
             </a:extLst>
           </p:cNvPr>
@@ -13481,7 +13481,7 @@
           <p:cNvPr id="15" name="TextBox 14">
             <a:extLst xmlns:a="http://schemas.openxmlformats.org/drawingml/2006/main">
               <a:ext uri="{FF2B5EF4-FFF2-40B4-BE49-F238E27FC236}">
-                <a16:creationId xmlns:a16="http://schemas.microsoft.com/office/drawing/2014/main" id="{A7611A24-5B1E-410F-820F-9064B1D09399}"/>
+                <a16:creationId xmlns:a16="http://schemas.microsoft.com/office/drawing/2014/main" id="{6F7BCBAA-4A86-4410-868C-DFB317B33810}"/>
               </a:ext>
             </a:extLst>
           </p:cNvPr>
@@ -13528,7 +13528,7 @@
           <p:cNvPr id="16" name="TextBox 15">
             <a:extLst xmlns:a="http://schemas.openxmlformats.org/drawingml/2006/main">
               <a:ext uri="{FF2B5EF4-FFF2-40B4-BE49-F238E27FC236}">
-                <a16:creationId xmlns:a16="http://schemas.microsoft.com/office/drawing/2014/main" id="{1B3810FA-E989-4FCE-A46B-07F4FD6B007F}"/>
+                <a16:creationId xmlns:a16="http://schemas.microsoft.com/office/drawing/2014/main" id="{9732CA8D-9729-48CD-B0C2-DF7445909630}"/>
               </a:ext>
             </a:extLst>
           </p:cNvPr>
@@ -13575,7 +13575,7 @@
           <p:cNvPr id="17" name="TextBox 16">
             <a:extLst xmlns:a="http://schemas.openxmlformats.org/drawingml/2006/main">
               <a:ext uri="{FF2B5EF4-FFF2-40B4-BE49-F238E27FC236}">
-                <a16:creationId xmlns:a16="http://schemas.microsoft.com/office/drawing/2014/main" id="{E9CA7405-9A67-4C49-8EC5-1369F732682F}"/>
+                <a16:creationId xmlns:a16="http://schemas.microsoft.com/office/drawing/2014/main" id="{BE0146A5-8DE9-45C4-81A8-494057C0817B}"/>
               </a:ext>
             </a:extLst>
           </p:cNvPr>
@@ -13622,7 +13622,7 @@
           <p:cNvPr id="18" name="Rounded Rectangle 17">
             <a:extLst xmlns:a="http://schemas.openxmlformats.org/drawingml/2006/main">
               <a:ext uri="{FF2B5EF4-FFF2-40B4-BE49-F238E27FC236}">
-                <a16:creationId xmlns:a16="http://schemas.microsoft.com/office/drawing/2014/main" id="{A283E2F2-705D-4958-8457-880F1D9716DB}"/>
+                <a16:creationId xmlns:a16="http://schemas.microsoft.com/office/drawing/2014/main" id="{27C64C26-A5FD-48CB-A1B6-AF131505DB20}"/>
               </a:ext>
             </a:extLst>
           </p:cNvPr>
@@ -13679,7 +13679,7 @@
           <p:cNvPr id="19" name="TextBox 18">
             <a:extLst xmlns:a="http://schemas.openxmlformats.org/drawingml/2006/main">
               <a:ext uri="{FF2B5EF4-FFF2-40B4-BE49-F238E27FC236}">
-                <a16:creationId xmlns:a16="http://schemas.microsoft.com/office/drawing/2014/main" id="{D8FF71C3-13C7-4ACC-ABE1-388C7AA9800B}"/>
+                <a16:creationId xmlns:a16="http://schemas.microsoft.com/office/drawing/2014/main" id="{5A981EE0-44D7-4586-A798-348C3254D1A2}"/>
               </a:ext>
             </a:extLst>
           </p:cNvPr>
@@ -13726,7 +13726,7 @@
           <p:cNvPr id="20" name="TextBox 19">
             <a:extLst xmlns:a="http://schemas.openxmlformats.org/drawingml/2006/main">
               <a:ext uri="{FF2B5EF4-FFF2-40B4-BE49-F238E27FC236}">
-                <a16:creationId xmlns:a16="http://schemas.microsoft.com/office/drawing/2014/main" id="{C806BF32-D3AF-4D43-B620-DF25284DDF10}"/>
+                <a16:creationId xmlns:a16="http://schemas.microsoft.com/office/drawing/2014/main" id="{815DE90E-B6CF-44AE-BB9B-85BB44E90294}"/>
               </a:ext>
             </a:extLst>
           </p:cNvPr>
@@ -13771,7 +13771,7 @@
     </p:spTree>
     <p:extLst>
       <p:ext uri="{BB962C8B-B14F-4D97-AF65-F5344CB8AC3E}">
-        <p14:creationId xmlns:p14="http://schemas.microsoft.com/office/powerpoint/2010/main" val="1658045330"/>
+        <p14:creationId xmlns:p14="http://schemas.microsoft.com/office/powerpoint/2010/main" val="1895678815"/>
       </p:ext>
     </p:extLst>
   </p:cSld>
@@ -13795,7 +13795,7 @@
           <p:cNvPr id="2" name="TextBox 1">
             <a:extLst xmlns:a="http://schemas.openxmlformats.org/drawingml/2006/main">
               <a:ext uri="{FF2B5EF4-FFF2-40B4-BE49-F238E27FC236}">
-                <a16:creationId xmlns:a16="http://schemas.microsoft.com/office/drawing/2014/main" id="{43E0C3FF-0188-4E10-9697-05512FEA374B}"/>
+                <a16:creationId xmlns:a16="http://schemas.microsoft.com/office/drawing/2014/main" id="{1F831B8E-E069-4611-AD04-D221DC648A91}"/>
               </a:ext>
             </a:extLst>
           </p:cNvPr>
@@ -13842,7 +13842,7 @@
           <p:cNvPr id="3" name="TextBox 2">
             <a:extLst xmlns:a="http://schemas.openxmlformats.org/drawingml/2006/main">
               <a:ext uri="{FF2B5EF4-FFF2-40B4-BE49-F238E27FC236}">
-                <a16:creationId xmlns:a16="http://schemas.microsoft.com/office/drawing/2014/main" id="{15D4C97B-A469-4CAC-9E05-FDCA299C7F5A}"/>
+                <a16:creationId xmlns:a16="http://schemas.microsoft.com/office/drawing/2014/main" id="{3BCD15DD-51C6-4CA5-8D4A-0429095160D3}"/>
               </a:ext>
             </a:extLst>
           </p:cNvPr>
@@ -13889,7 +13889,7 @@
           <p:cNvPr id="4" name="Rectangle 3">
             <a:extLst xmlns:a="http://schemas.openxmlformats.org/drawingml/2006/main">
               <a:ext uri="{FF2B5EF4-FFF2-40B4-BE49-F238E27FC236}">
-                <a16:creationId xmlns:a16="http://schemas.microsoft.com/office/drawing/2014/main" id="{1806BFF2-0EBD-489F-B597-9EF11798C589}"/>
+                <a16:creationId xmlns:a16="http://schemas.microsoft.com/office/drawing/2014/main" id="{D0B202DD-88BF-4FC3-8B8A-FF6A3AB9DCDB}"/>
               </a:ext>
             </a:extLst>
           </p:cNvPr>
@@ -13944,7 +13944,7 @@
           <p:cNvPr id="5" name="Rectangle 4">
             <a:extLst xmlns:a="http://schemas.openxmlformats.org/drawingml/2006/main">
               <a:ext uri="{FF2B5EF4-FFF2-40B4-BE49-F238E27FC236}">
-                <a16:creationId xmlns:a16="http://schemas.microsoft.com/office/drawing/2014/main" id="{43E8E249-0D2D-4DFE-B6EB-EAB7C1405CAD}"/>
+                <a16:creationId xmlns:a16="http://schemas.microsoft.com/office/drawing/2014/main" id="{F9D2F74B-D744-4CAE-AAF6-1DAA04808FA0}"/>
               </a:ext>
             </a:extLst>
           </p:cNvPr>
@@ -13999,7 +13999,7 @@
           <p:cNvPr id="6" name="TextBox 5">
             <a:extLst xmlns:a="http://schemas.openxmlformats.org/drawingml/2006/main">
               <a:ext uri="{FF2B5EF4-FFF2-40B4-BE49-F238E27FC236}">
-                <a16:creationId xmlns:a16="http://schemas.microsoft.com/office/drawing/2014/main" id="{1AB4B6F6-D07B-4351-A6B6-3820F2A379DB}"/>
+                <a16:creationId xmlns:a16="http://schemas.microsoft.com/office/drawing/2014/main" id="{CCB28205-8763-462C-A07F-A7FD543B09DF}"/>
               </a:ext>
             </a:extLst>
           </p:cNvPr>
@@ -14036,7 +14036,7 @@
                 <a:ea typeface="Aptos"/>
                 <a:cs typeface="Aptos"/>
               </a:rPr>
-              <a:t>Independent public evidence summary · 2026.07.22-8 · 2026-07-22 · Sources: Market-values model; Readiness</a:t>
+              <a:t>Independent public evidence summary · 2026.07.22-9 · 2026-07-22 · Sources: Market-values model; Readiness</a:t>
             </a:r>
           </a:p>
         </p:txBody>
@@ -14046,7 +14046,7 @@
           <p:cNvPr id="7" name="TextBox 6">
             <a:extLst xmlns:a="http://schemas.openxmlformats.org/drawingml/2006/main">
               <a:ext uri="{FF2B5EF4-FFF2-40B4-BE49-F238E27FC236}">
-                <a16:creationId xmlns:a16="http://schemas.microsoft.com/office/drawing/2014/main" id="{13211F6C-2F27-4A62-A259-A91FBE0C6E0C}"/>
+                <a16:creationId xmlns:a16="http://schemas.microsoft.com/office/drawing/2014/main" id="{0401AC9C-3941-491F-95DE-87580D8DB315}"/>
               </a:ext>
             </a:extLst>
           </p:cNvPr>
@@ -14093,7 +14093,7 @@
           <p:cNvPr id="8" name="TextBox 7">
             <a:extLst xmlns:a="http://schemas.openxmlformats.org/drawingml/2006/main">
               <a:ext uri="{FF2B5EF4-FFF2-40B4-BE49-F238E27FC236}">
-                <a16:creationId xmlns:a16="http://schemas.microsoft.com/office/drawing/2014/main" id="{40C0FB65-E50D-43D8-97E7-138C27FD15ED}"/>
+                <a16:creationId xmlns:a16="http://schemas.microsoft.com/office/drawing/2014/main" id="{88748D64-7F67-41A5-8A0E-553CB57C7F0B}"/>
               </a:ext>
             </a:extLst>
           </p:cNvPr>
@@ -14140,7 +14140,7 @@
           <p:cNvPr id="9" name="TextBox 8">
             <a:extLst xmlns:a="http://schemas.openxmlformats.org/drawingml/2006/main">
               <a:ext uri="{FF2B5EF4-FFF2-40B4-BE49-F238E27FC236}">
-                <a16:creationId xmlns:a16="http://schemas.microsoft.com/office/drawing/2014/main" id="{809DCC38-796D-4BA7-96E3-FFD9B60AF935}"/>
+                <a16:creationId xmlns:a16="http://schemas.microsoft.com/office/drawing/2014/main" id="{03E2C2D2-4656-4191-814B-55BD3542E2B7}"/>
               </a:ext>
             </a:extLst>
           </p:cNvPr>
@@ -14237,7 +14237,7 @@
           <p:cNvPr id="10" name="Rounded Rectangle 9">
             <a:extLst xmlns:a="http://schemas.openxmlformats.org/drawingml/2006/main">
               <a:ext uri="{FF2B5EF4-FFF2-40B4-BE49-F238E27FC236}">
-                <a16:creationId xmlns:a16="http://schemas.microsoft.com/office/drawing/2014/main" id="{29392533-9426-4B32-BC3B-73738243DD62}"/>
+                <a16:creationId xmlns:a16="http://schemas.microsoft.com/office/drawing/2014/main" id="{2C6EFA9B-D7E2-45F5-B863-CE4333356FE2}"/>
               </a:ext>
             </a:extLst>
           </p:cNvPr>
@@ -14294,7 +14294,7 @@
           <p:cNvPr id="11" name="TextBox 10">
             <a:extLst xmlns:a="http://schemas.openxmlformats.org/drawingml/2006/main">
               <a:ext uri="{FF2B5EF4-FFF2-40B4-BE49-F238E27FC236}">
-                <a16:creationId xmlns:a16="http://schemas.microsoft.com/office/drawing/2014/main" id="{D5BA3090-2D70-4D8F-9E47-F3CD842238CB}"/>
+                <a16:creationId xmlns:a16="http://schemas.microsoft.com/office/drawing/2014/main" id="{F12B3CAF-6D23-43A6-B492-7C2B68EFF10F}"/>
               </a:ext>
             </a:extLst>
           </p:cNvPr>
@@ -14341,7 +14341,7 @@
           <p:cNvPr id="12" name="TextBox 11">
             <a:extLst xmlns:a="http://schemas.openxmlformats.org/drawingml/2006/main">
               <a:ext uri="{FF2B5EF4-FFF2-40B4-BE49-F238E27FC236}">
-                <a16:creationId xmlns:a16="http://schemas.microsoft.com/office/drawing/2014/main" id="{5CE716EA-1C69-451C-B1A1-1F1D34023EAF}"/>
+                <a16:creationId xmlns:a16="http://schemas.microsoft.com/office/drawing/2014/main" id="{9E38F901-F568-47CE-8998-4437DB276547}"/>
               </a:ext>
             </a:extLst>
           </p:cNvPr>
@@ -14386,7 +14386,7 @@
     </p:spTree>
     <p:extLst>
       <p:ext uri="{BB962C8B-B14F-4D97-AF65-F5344CB8AC3E}">
-        <p14:creationId xmlns:p14="http://schemas.microsoft.com/office/powerpoint/2010/main" val="2099950377"/>
+        <p14:creationId xmlns:p14="http://schemas.microsoft.com/office/powerpoint/2010/main" val="1580677065"/>
       </p:ext>
     </p:extLst>
   </p:cSld>
@@ -14410,7 +14410,7 @@
           <p:cNvPr id="2" name="TextBox 1">
             <a:extLst xmlns:a="http://schemas.openxmlformats.org/drawingml/2006/main">
               <a:ext uri="{FF2B5EF4-FFF2-40B4-BE49-F238E27FC236}">
-                <a16:creationId xmlns:a16="http://schemas.microsoft.com/office/drawing/2014/main" id="{D7FCC518-4625-4E78-9207-A79A30943E0D}"/>
+                <a16:creationId xmlns:a16="http://schemas.microsoft.com/office/drawing/2014/main" id="{2A5B3AA2-A87C-4ACC-A10C-3A4329CD4ED2}"/>
               </a:ext>
             </a:extLst>
           </p:cNvPr>
@@ -14457,7 +14457,7 @@
           <p:cNvPr id="3" name="TextBox 2">
             <a:extLst xmlns:a="http://schemas.openxmlformats.org/drawingml/2006/main">
               <a:ext uri="{FF2B5EF4-FFF2-40B4-BE49-F238E27FC236}">
-                <a16:creationId xmlns:a16="http://schemas.microsoft.com/office/drawing/2014/main" id="{8DCF82FE-8751-43AB-B7F9-97A883BD9FC2}"/>
+                <a16:creationId xmlns:a16="http://schemas.microsoft.com/office/drawing/2014/main" id="{9511DD69-22BC-4A78-99A5-701262F17E00}"/>
               </a:ext>
             </a:extLst>
           </p:cNvPr>
@@ -14504,7 +14504,7 @@
           <p:cNvPr id="4" name="Rectangle 3">
             <a:extLst xmlns:a="http://schemas.openxmlformats.org/drawingml/2006/main">
               <a:ext uri="{FF2B5EF4-FFF2-40B4-BE49-F238E27FC236}">
-                <a16:creationId xmlns:a16="http://schemas.microsoft.com/office/drawing/2014/main" id="{94A63E86-7C35-4EC0-AC7A-1FA08FF6F0B2}"/>
+                <a16:creationId xmlns:a16="http://schemas.microsoft.com/office/drawing/2014/main" id="{15EC310A-1BCF-41DA-9A5A-08506308C2AF}"/>
               </a:ext>
             </a:extLst>
           </p:cNvPr>
@@ -14559,7 +14559,7 @@
           <p:cNvPr id="5" name="Rectangle 4">
             <a:extLst xmlns:a="http://schemas.openxmlformats.org/drawingml/2006/main">
               <a:ext uri="{FF2B5EF4-FFF2-40B4-BE49-F238E27FC236}">
-                <a16:creationId xmlns:a16="http://schemas.microsoft.com/office/drawing/2014/main" id="{B6F3F080-EFDA-4DE4-BF86-DC2DE0191F60}"/>
+                <a16:creationId xmlns:a16="http://schemas.microsoft.com/office/drawing/2014/main" id="{74FD007A-F5A1-4410-B085-08B7210C1501}"/>
               </a:ext>
             </a:extLst>
           </p:cNvPr>
@@ -14614,7 +14614,7 @@
           <p:cNvPr id="6" name="TextBox 5">
             <a:extLst xmlns:a="http://schemas.openxmlformats.org/drawingml/2006/main">
               <a:ext uri="{FF2B5EF4-FFF2-40B4-BE49-F238E27FC236}">
-                <a16:creationId xmlns:a16="http://schemas.microsoft.com/office/drawing/2014/main" id="{A2F904BA-FAF9-4F78-B2F7-05AA493CD8C2}"/>
+                <a16:creationId xmlns:a16="http://schemas.microsoft.com/office/drawing/2014/main" id="{2AFF42F9-239E-4E74-895A-201218BC4EA3}"/>
               </a:ext>
             </a:extLst>
           </p:cNvPr>
@@ -14651,7 +14651,7 @@
                 <a:ea typeface="Aptos"/>
                 <a:cs typeface="Aptos"/>
               </a:rPr>
-              <a:t>Independent public evidence summary · 2026.07.22-8 · 2026-07-22 · Sources: WIPO valuation; Evidence Register</a:t>
+              <a:t>Independent public evidence summary · 2026.07.22-9 · 2026-07-22 · Sources: WIPO valuation; Evidence Register</a:t>
             </a:r>
           </a:p>
         </p:txBody>
@@ -14661,7 +14661,7 @@
           <p:cNvPr id="7" name="TextBox 6">
             <a:extLst xmlns:a="http://schemas.openxmlformats.org/drawingml/2006/main">
               <a:ext uri="{FF2B5EF4-FFF2-40B4-BE49-F238E27FC236}">
-                <a16:creationId xmlns:a16="http://schemas.microsoft.com/office/drawing/2014/main" id="{F044E94F-CAD8-4C2B-8774-FD963192A956}"/>
+                <a16:creationId xmlns:a16="http://schemas.microsoft.com/office/drawing/2014/main" id="{27BD48C3-50F6-49A6-9117-3013839647D1}"/>
               </a:ext>
             </a:extLst>
           </p:cNvPr>
@@ -15231,7 +15231,7 @@
           <p:cNvPr id="9" name="TextBox 8">
             <a:extLst xmlns:a="http://schemas.openxmlformats.org/drawingml/2006/main">
               <a:ext uri="{FF2B5EF4-FFF2-40B4-BE49-F238E27FC236}">
-                <a16:creationId xmlns:a16="http://schemas.microsoft.com/office/drawing/2014/main" id="{C7A5DB2E-7EE4-4F34-A286-3CB9B9F44188}"/>
+                <a16:creationId xmlns:a16="http://schemas.microsoft.com/office/drawing/2014/main" id="{77EF4077-30F4-459E-A417-B46ED985223A}"/>
               </a:ext>
             </a:extLst>
           </p:cNvPr>
@@ -15276,7 +15276,7 @@
     </p:spTree>
     <p:extLst>
       <p:ext uri="{BB962C8B-B14F-4D97-AF65-F5344CB8AC3E}">
-        <p14:creationId xmlns:p14="http://schemas.microsoft.com/office/powerpoint/2010/main" val="1041845827"/>
+        <p14:creationId xmlns:p14="http://schemas.microsoft.com/office/powerpoint/2010/main" val="794536450"/>
       </p:ext>
     </p:extLst>
   </p:cSld>
@@ -15300,7 +15300,7 @@
           <p:cNvPr id="2" name="TextBox 1">
             <a:extLst xmlns:a="http://schemas.openxmlformats.org/drawingml/2006/main">
               <a:ext uri="{FF2B5EF4-FFF2-40B4-BE49-F238E27FC236}">
-                <a16:creationId xmlns:a16="http://schemas.microsoft.com/office/drawing/2014/main" id="{BB98C20B-8300-46FE-95D0-DEF3B16C4083}"/>
+                <a16:creationId xmlns:a16="http://schemas.microsoft.com/office/drawing/2014/main" id="{C8BF708A-6AB5-4B48-AD32-E938D4806647}"/>
               </a:ext>
             </a:extLst>
           </p:cNvPr>
@@ -15347,7 +15347,7 @@
           <p:cNvPr id="3" name="TextBox 2">
             <a:extLst xmlns:a="http://schemas.openxmlformats.org/drawingml/2006/main">
               <a:ext uri="{FF2B5EF4-FFF2-40B4-BE49-F238E27FC236}">
-                <a16:creationId xmlns:a16="http://schemas.microsoft.com/office/drawing/2014/main" id="{CAF260AB-6F63-423B-8829-E7C79992166D}"/>
+                <a16:creationId xmlns:a16="http://schemas.microsoft.com/office/drawing/2014/main" id="{039C45E1-6C21-47AD-A1C3-5122F19354EA}"/>
               </a:ext>
             </a:extLst>
           </p:cNvPr>
@@ -15394,7 +15394,7 @@
           <p:cNvPr id="4" name="Rectangle 3">
             <a:extLst xmlns:a="http://schemas.openxmlformats.org/drawingml/2006/main">
               <a:ext uri="{FF2B5EF4-FFF2-40B4-BE49-F238E27FC236}">
-                <a16:creationId xmlns:a16="http://schemas.microsoft.com/office/drawing/2014/main" id="{F0F1127A-93D1-43F6-8B4D-DD63E6E14DD5}"/>
+                <a16:creationId xmlns:a16="http://schemas.microsoft.com/office/drawing/2014/main" id="{840B5AF4-9F53-4FDC-B047-458C80F0DD45}"/>
               </a:ext>
             </a:extLst>
           </p:cNvPr>
@@ -15449,7 +15449,7 @@
           <p:cNvPr id="5" name="Rectangle 4">
             <a:extLst xmlns:a="http://schemas.openxmlformats.org/drawingml/2006/main">
               <a:ext uri="{FF2B5EF4-FFF2-40B4-BE49-F238E27FC236}">
-                <a16:creationId xmlns:a16="http://schemas.microsoft.com/office/drawing/2014/main" id="{4337D148-F506-4A55-81A0-F638B0E3A788}"/>
+                <a16:creationId xmlns:a16="http://schemas.microsoft.com/office/drawing/2014/main" id="{6A4302CE-C91C-434B-8AF2-F0A8848A70F5}"/>
               </a:ext>
             </a:extLst>
           </p:cNvPr>
@@ -15504,7 +15504,7 @@
           <p:cNvPr id="6" name="TextBox 5">
             <a:extLst xmlns:a="http://schemas.openxmlformats.org/drawingml/2006/main">
               <a:ext uri="{FF2B5EF4-FFF2-40B4-BE49-F238E27FC236}">
-                <a16:creationId xmlns:a16="http://schemas.microsoft.com/office/drawing/2014/main" id="{3568EF28-9BE0-4528-9AB3-9523A97C12E5}"/>
+                <a16:creationId xmlns:a16="http://schemas.microsoft.com/office/drawing/2014/main" id="{2703433C-8A53-4E93-86E4-1AA8F94952DB}"/>
               </a:ext>
             </a:extLst>
           </p:cNvPr>
@@ -15541,7 +15541,7 @@
                 <a:ea typeface="Aptos"/>
                 <a:cs typeface="Aptos"/>
               </a:rPr>
-              <a:t>Independent public evidence summary · 2026.07.22-8 · 2026-07-22 · Sources: EPO; Germany — official judgments; WIPO</a:t>
+              <a:t>Independent public evidence summary · 2026.07.22-9 · 2026-07-22 · Sources: EPO; Germany — official judgments; WIPO</a:t>
             </a:r>
           </a:p>
         </p:txBody>
@@ -15551,7 +15551,7 @@
           <p:cNvPr id="7" name="TextBox 6">
             <a:extLst xmlns:a="http://schemas.openxmlformats.org/drawingml/2006/main">
               <a:ext uri="{FF2B5EF4-FFF2-40B4-BE49-F238E27FC236}">
-                <a16:creationId xmlns:a16="http://schemas.microsoft.com/office/drawing/2014/main" id="{00898CBC-5EF7-43E1-9BA0-100298E3E555}"/>
+                <a16:creationId xmlns:a16="http://schemas.microsoft.com/office/drawing/2014/main" id="{7301BED8-8D2A-4958-B4A3-76BE48D437A0}"/>
               </a:ext>
             </a:extLst>
           </p:cNvPr>
@@ -15598,7 +15598,7 @@
           <p:cNvPr id="8" name="TextBox 7">
             <a:extLst xmlns:a="http://schemas.openxmlformats.org/drawingml/2006/main">
               <a:ext uri="{FF2B5EF4-FFF2-40B4-BE49-F238E27FC236}">
-                <a16:creationId xmlns:a16="http://schemas.microsoft.com/office/drawing/2014/main" id="{5616CF06-0529-4AF5-95B7-33ED3AEB4EA8}"/>
+                <a16:creationId xmlns:a16="http://schemas.microsoft.com/office/drawing/2014/main" id="{AD9BDBCE-B023-4571-A1F5-DE579B0927AF}"/>
               </a:ext>
             </a:extLst>
           </p:cNvPr>
@@ -15645,7 +15645,7 @@
           <p:cNvPr id="9" name="TextBox 8">
             <a:extLst xmlns:a="http://schemas.openxmlformats.org/drawingml/2006/main">
               <a:ext uri="{FF2B5EF4-FFF2-40B4-BE49-F238E27FC236}">
-                <a16:creationId xmlns:a16="http://schemas.microsoft.com/office/drawing/2014/main" id="{2FCD49B8-409F-493B-8DAB-EC2799EEA6FA}"/>
+                <a16:creationId xmlns:a16="http://schemas.microsoft.com/office/drawing/2014/main" id="{7A5B8A30-2FEF-4FD8-8FD4-FEE81E3D0559}"/>
               </a:ext>
             </a:extLst>
           </p:cNvPr>
@@ -15742,7 +15742,7 @@
           <p:cNvPr id="10" name="Rounded Rectangle 9">
             <a:extLst xmlns:a="http://schemas.openxmlformats.org/drawingml/2006/main">
               <a:ext uri="{FF2B5EF4-FFF2-40B4-BE49-F238E27FC236}">
-                <a16:creationId xmlns:a16="http://schemas.microsoft.com/office/drawing/2014/main" id="{61D519DA-A338-45A0-8B1C-C29BA5973638}"/>
+                <a16:creationId xmlns:a16="http://schemas.microsoft.com/office/drawing/2014/main" id="{FE6A8CC8-C75C-439B-806D-352FBBC56840}"/>
               </a:ext>
             </a:extLst>
           </p:cNvPr>
@@ -15799,7 +15799,7 @@
           <p:cNvPr id="11" name="TextBox 10">
             <a:extLst xmlns:a="http://schemas.openxmlformats.org/drawingml/2006/main">
               <a:ext uri="{FF2B5EF4-FFF2-40B4-BE49-F238E27FC236}">
-                <a16:creationId xmlns:a16="http://schemas.microsoft.com/office/drawing/2014/main" id="{C5CFD7D2-40CA-4D62-8B49-3EFAEE2AE0CC}"/>
+                <a16:creationId xmlns:a16="http://schemas.microsoft.com/office/drawing/2014/main" id="{506900D2-EBA4-4DC5-B9AE-7DEE2DDE9CAE}"/>
               </a:ext>
             </a:extLst>
           </p:cNvPr>
@@ -15846,7 +15846,7 @@
           <p:cNvPr id="12" name="TextBox 11">
             <a:extLst xmlns:a="http://schemas.openxmlformats.org/drawingml/2006/main">
               <a:ext uri="{FF2B5EF4-FFF2-40B4-BE49-F238E27FC236}">
-                <a16:creationId xmlns:a16="http://schemas.microsoft.com/office/drawing/2014/main" id="{71016661-D977-4CFC-8E5B-B271753F793D}"/>
+                <a16:creationId xmlns:a16="http://schemas.microsoft.com/office/drawing/2014/main" id="{B4FCA79C-A4CA-4243-B17C-DE26DD323BED}"/>
               </a:ext>
             </a:extLst>
           </p:cNvPr>
@@ -15891,7 +15891,7 @@
     </p:spTree>
     <p:extLst>
       <p:ext uri="{BB962C8B-B14F-4D97-AF65-F5344CB8AC3E}">
-        <p14:creationId xmlns:p14="http://schemas.microsoft.com/office/powerpoint/2010/main" val="1410185387"/>
+        <p14:creationId xmlns:p14="http://schemas.microsoft.com/office/powerpoint/2010/main" val="1870272871"/>
       </p:ext>
     </p:extLst>
   </p:cSld>
@@ -15915,7 +15915,7 @@
           <p:cNvPr id="2" name="TextBox 1">
             <a:extLst xmlns:a="http://schemas.openxmlformats.org/drawingml/2006/main">
               <a:ext uri="{FF2B5EF4-FFF2-40B4-BE49-F238E27FC236}">
-                <a16:creationId xmlns:a16="http://schemas.microsoft.com/office/drawing/2014/main" id="{9BC684A8-B9ED-4B33-A1FB-41F9755C5CE1}"/>
+                <a16:creationId xmlns:a16="http://schemas.microsoft.com/office/drawing/2014/main" id="{85A7B432-AB71-4CEB-A856-964BB465E839}"/>
               </a:ext>
             </a:extLst>
           </p:cNvPr>
@@ -15962,7 +15962,7 @@
           <p:cNvPr id="3" name="TextBox 2">
             <a:extLst xmlns:a="http://schemas.openxmlformats.org/drawingml/2006/main">
               <a:ext uri="{FF2B5EF4-FFF2-40B4-BE49-F238E27FC236}">
-                <a16:creationId xmlns:a16="http://schemas.microsoft.com/office/drawing/2014/main" id="{C5F8D3D0-2C8D-4B53-8F4A-3F5A907D505E}"/>
+                <a16:creationId xmlns:a16="http://schemas.microsoft.com/office/drawing/2014/main" id="{658D9CB7-60D7-48A3-B946-DD67A414BB7B}"/>
               </a:ext>
             </a:extLst>
           </p:cNvPr>
@@ -16009,7 +16009,7 @@
           <p:cNvPr id="4" name="Rectangle 3">
             <a:extLst xmlns:a="http://schemas.openxmlformats.org/drawingml/2006/main">
               <a:ext uri="{FF2B5EF4-FFF2-40B4-BE49-F238E27FC236}">
-                <a16:creationId xmlns:a16="http://schemas.microsoft.com/office/drawing/2014/main" id="{5759277A-CAA9-4DEB-BB64-E6CD35B7ECC9}"/>
+                <a16:creationId xmlns:a16="http://schemas.microsoft.com/office/drawing/2014/main" id="{B74B47CE-4EF1-45B5-8DEE-BDCCA3AA91F3}"/>
               </a:ext>
             </a:extLst>
           </p:cNvPr>
@@ -16064,7 +16064,7 @@
           <p:cNvPr id="5" name="Rectangle 4">
             <a:extLst xmlns:a="http://schemas.openxmlformats.org/drawingml/2006/main">
               <a:ext uri="{FF2B5EF4-FFF2-40B4-BE49-F238E27FC236}">
-                <a16:creationId xmlns:a16="http://schemas.microsoft.com/office/drawing/2014/main" id="{90BE8294-7DAD-4770-BAA0-374E3A710D22}"/>
+                <a16:creationId xmlns:a16="http://schemas.microsoft.com/office/drawing/2014/main" id="{659BFD51-0C1E-4D75-8D38-4EC1ED3C6717}"/>
               </a:ext>
             </a:extLst>
           </p:cNvPr>
@@ -16119,7 +16119,7 @@
           <p:cNvPr id="6" name="TextBox 5">
             <a:extLst xmlns:a="http://schemas.openxmlformats.org/drawingml/2006/main">
               <a:ext uri="{FF2B5EF4-FFF2-40B4-BE49-F238E27FC236}">
-                <a16:creationId xmlns:a16="http://schemas.microsoft.com/office/drawing/2014/main" id="{2ADB7E52-220C-4EB3-9802-99A378E9F0B4}"/>
+                <a16:creationId xmlns:a16="http://schemas.microsoft.com/office/drawing/2014/main" id="{EAB1AF26-1A24-41C1-8640-530A49816AAA}"/>
               </a:ext>
             </a:extLst>
           </p:cNvPr>
@@ -16156,7 +16156,7 @@
                 <a:ea typeface="Aptos"/>
                 <a:cs typeface="Aptos"/>
               </a:rPr>
-              <a:t>Independent public evidence summary · 2026.07.22-8 · 2026-07-22 · Sources: WIPO licensing; IP Finance</a:t>
+              <a:t>Independent public evidence summary · 2026.07.22-9 · 2026-07-22 · Sources: WIPO licensing; IP Finance</a:t>
             </a:r>
           </a:p>
         </p:txBody>
@@ -16166,7 +16166,7 @@
           <p:cNvPr id="7" name="TextBox 6">
             <a:extLst xmlns:a="http://schemas.openxmlformats.org/drawingml/2006/main">
               <a:ext uri="{FF2B5EF4-FFF2-40B4-BE49-F238E27FC236}">
-                <a16:creationId xmlns:a16="http://schemas.microsoft.com/office/drawing/2014/main" id="{03A52631-3B07-4567-8D89-F2CAE38178F7}"/>
+                <a16:creationId xmlns:a16="http://schemas.microsoft.com/office/drawing/2014/main" id="{49CCDE48-5046-41D4-BE2B-486605C4794C}"/>
               </a:ext>
             </a:extLst>
           </p:cNvPr>
@@ -16213,7 +16213,7 @@
           <p:cNvPr id="8" name="TextBox 7">
             <a:extLst xmlns:a="http://schemas.openxmlformats.org/drawingml/2006/main">
               <a:ext uri="{FF2B5EF4-FFF2-40B4-BE49-F238E27FC236}">
-                <a16:creationId xmlns:a16="http://schemas.microsoft.com/office/drawing/2014/main" id="{50140370-D140-413B-978F-44F78E8AC21D}"/>
+                <a16:creationId xmlns:a16="http://schemas.microsoft.com/office/drawing/2014/main" id="{77CACC44-5B69-4085-AEC1-736E00C9D3D1}"/>
               </a:ext>
             </a:extLst>
           </p:cNvPr>
@@ -16260,7 +16260,7 @@
           <p:cNvPr id="9" name="TextBox 8">
             <a:extLst xmlns:a="http://schemas.openxmlformats.org/drawingml/2006/main">
               <a:ext uri="{FF2B5EF4-FFF2-40B4-BE49-F238E27FC236}">
-                <a16:creationId xmlns:a16="http://schemas.microsoft.com/office/drawing/2014/main" id="{E97E0E92-A99A-4FB6-8FDE-1CE15BF2F537}"/>
+                <a16:creationId xmlns:a16="http://schemas.microsoft.com/office/drawing/2014/main" id="{55627811-2E94-4D54-86DD-CDF36C6DF116}"/>
               </a:ext>
             </a:extLst>
           </p:cNvPr>
@@ -16357,7 +16357,7 @@
           <p:cNvPr id="10" name="Rounded Rectangle 9">
             <a:extLst xmlns:a="http://schemas.openxmlformats.org/drawingml/2006/main">
               <a:ext uri="{FF2B5EF4-FFF2-40B4-BE49-F238E27FC236}">
-                <a16:creationId xmlns:a16="http://schemas.microsoft.com/office/drawing/2014/main" id="{8092EAC2-9C13-40E8-ACE0-D335DFB50950}"/>
+                <a16:creationId xmlns:a16="http://schemas.microsoft.com/office/drawing/2014/main" id="{51209ECF-F186-4DF0-884E-5547CDE3365A}"/>
               </a:ext>
             </a:extLst>
           </p:cNvPr>
@@ -16414,7 +16414,7 @@
           <p:cNvPr id="11" name="TextBox 10">
             <a:extLst xmlns:a="http://schemas.openxmlformats.org/drawingml/2006/main">
               <a:ext uri="{FF2B5EF4-FFF2-40B4-BE49-F238E27FC236}">
-                <a16:creationId xmlns:a16="http://schemas.microsoft.com/office/drawing/2014/main" id="{88B03450-CC1C-4AB3-B3F1-D7C92231CA62}"/>
+                <a16:creationId xmlns:a16="http://schemas.microsoft.com/office/drawing/2014/main" id="{D8D4ECBB-053D-4FD8-8F0F-0125426EF464}"/>
               </a:ext>
             </a:extLst>
           </p:cNvPr>
@@ -16461,7 +16461,7 @@
           <p:cNvPr id="12" name="TextBox 11">
             <a:extLst xmlns:a="http://schemas.openxmlformats.org/drawingml/2006/main">
               <a:ext uri="{FF2B5EF4-FFF2-40B4-BE49-F238E27FC236}">
-                <a16:creationId xmlns:a16="http://schemas.microsoft.com/office/drawing/2014/main" id="{0F370F3D-A567-42FD-BB37-6C6711D24EC2}"/>
+                <a16:creationId xmlns:a16="http://schemas.microsoft.com/office/drawing/2014/main" id="{596BFF5A-4468-4543-AC42-6E54F65D580B}"/>
               </a:ext>
             </a:extLst>
           </p:cNvPr>
@@ -16506,7 +16506,7 @@
     </p:spTree>
     <p:extLst>
       <p:ext uri="{BB962C8B-B14F-4D97-AF65-F5344CB8AC3E}">
-        <p14:creationId xmlns:p14="http://schemas.microsoft.com/office/powerpoint/2010/main" val="567224517"/>
+        <p14:creationId xmlns:p14="http://schemas.microsoft.com/office/powerpoint/2010/main" val="1155978858"/>
       </p:ext>
     </p:extLst>
   </p:cSld>
@@ -16530,7 +16530,7 @@
           <p:cNvPr id="2" name="TextBox 1">
             <a:extLst xmlns:a="http://schemas.openxmlformats.org/drawingml/2006/main">
               <a:ext uri="{FF2B5EF4-FFF2-40B4-BE49-F238E27FC236}">
-                <a16:creationId xmlns:a16="http://schemas.microsoft.com/office/drawing/2014/main" id="{CB3D6D7B-9BF3-46EE-AFC5-4C7990D634E3}"/>
+                <a16:creationId xmlns:a16="http://schemas.microsoft.com/office/drawing/2014/main" id="{D03DA760-0984-499B-AD2E-6BBB9AC1E0A2}"/>
               </a:ext>
             </a:extLst>
           </p:cNvPr>
@@ -16577,7 +16577,7 @@
           <p:cNvPr id="3" name="TextBox 2">
             <a:extLst xmlns:a="http://schemas.openxmlformats.org/drawingml/2006/main">
               <a:ext uri="{FF2B5EF4-FFF2-40B4-BE49-F238E27FC236}">
-                <a16:creationId xmlns:a16="http://schemas.microsoft.com/office/drawing/2014/main" id="{A32DDCAC-22DC-470A-A0E2-8140CC19EB34}"/>
+                <a16:creationId xmlns:a16="http://schemas.microsoft.com/office/drawing/2014/main" id="{4C6CEC90-BB31-49C8-A4A0-18A4D5395B6A}"/>
               </a:ext>
             </a:extLst>
           </p:cNvPr>
@@ -16624,7 +16624,7 @@
           <p:cNvPr id="4" name="Rectangle 3">
             <a:extLst xmlns:a="http://schemas.openxmlformats.org/drawingml/2006/main">
               <a:ext uri="{FF2B5EF4-FFF2-40B4-BE49-F238E27FC236}">
-                <a16:creationId xmlns:a16="http://schemas.microsoft.com/office/drawing/2014/main" id="{DCC61226-432E-40A9-A79C-D874ED48895E}"/>
+                <a16:creationId xmlns:a16="http://schemas.microsoft.com/office/drawing/2014/main" id="{DD73F3FB-ED1C-4FC7-A201-41AFB50B31F8}"/>
               </a:ext>
             </a:extLst>
           </p:cNvPr>
@@ -16679,7 +16679,7 @@
           <p:cNvPr id="5" name="Rectangle 4">
             <a:extLst xmlns:a="http://schemas.openxmlformats.org/drawingml/2006/main">
               <a:ext uri="{FF2B5EF4-FFF2-40B4-BE49-F238E27FC236}">
-                <a16:creationId xmlns:a16="http://schemas.microsoft.com/office/drawing/2014/main" id="{0EF742D0-3CBF-4536-B3A0-3BF669EDA0D8}"/>
+                <a16:creationId xmlns:a16="http://schemas.microsoft.com/office/drawing/2014/main" id="{2D46930E-332C-4E19-A969-087A95F452E6}"/>
               </a:ext>
             </a:extLst>
           </p:cNvPr>
@@ -16734,7 +16734,7 @@
           <p:cNvPr id="6" name="TextBox 5">
             <a:extLst xmlns:a="http://schemas.openxmlformats.org/drawingml/2006/main">
               <a:ext uri="{FF2B5EF4-FFF2-40B4-BE49-F238E27FC236}">
-                <a16:creationId xmlns:a16="http://schemas.microsoft.com/office/drawing/2014/main" id="{0F2248A0-5645-41D8-9480-65A97EC29754}"/>
+                <a16:creationId xmlns:a16="http://schemas.microsoft.com/office/drawing/2014/main" id="{9EB8F954-47AA-41EE-AC76-D2FBC5927E85}"/>
               </a:ext>
             </a:extLst>
           </p:cNvPr>
@@ -16771,7 +16771,7 @@
                 <a:ea typeface="Aptos"/>
                 <a:cs typeface="Aptos"/>
               </a:rPr>
-              <a:t>Independent public evidence summary · 2026.07.22-8 · 2026-07-22 · Sources: Evidence Register; EPO</a:t>
+              <a:t>Independent public evidence summary · 2026.07.22-9 · 2026-07-22 · Sources: Evidence Register; EPO</a:t>
             </a:r>
           </a:p>
         </p:txBody>
@@ -16781,7 +16781,7 @@
           <p:cNvPr id="7" name="TextBox 6">
             <a:extLst xmlns:a="http://schemas.openxmlformats.org/drawingml/2006/main">
               <a:ext uri="{FF2B5EF4-FFF2-40B4-BE49-F238E27FC236}">
-                <a16:creationId xmlns:a16="http://schemas.microsoft.com/office/drawing/2014/main" id="{75879735-5B1E-495F-92B5-912939C28B4A}"/>
+                <a16:creationId xmlns:a16="http://schemas.microsoft.com/office/drawing/2014/main" id="{F5487946-D63A-44FB-8C8A-A27D0155D61E}"/>
               </a:ext>
             </a:extLst>
           </p:cNvPr>
@@ -17268,7 +17268,7 @@
           <p:cNvPr id="9" name="TextBox 8">
             <a:extLst xmlns:a="http://schemas.openxmlformats.org/drawingml/2006/main">
               <a:ext uri="{FF2B5EF4-FFF2-40B4-BE49-F238E27FC236}">
-                <a16:creationId xmlns:a16="http://schemas.microsoft.com/office/drawing/2014/main" id="{6F0FB373-22B2-488C-98C7-A09593A1CB28}"/>
+                <a16:creationId xmlns:a16="http://schemas.microsoft.com/office/drawing/2014/main" id="{11138F25-A2D8-431A-81B8-8A9DD1539BE1}"/>
               </a:ext>
             </a:extLst>
           </p:cNvPr>
@@ -17313,7 +17313,7 @@
     </p:spTree>
     <p:extLst>
       <p:ext uri="{BB962C8B-B14F-4D97-AF65-F5344CB8AC3E}">
-        <p14:creationId xmlns:p14="http://schemas.microsoft.com/office/powerpoint/2010/main" val="525930496"/>
+        <p14:creationId xmlns:p14="http://schemas.microsoft.com/office/powerpoint/2010/main" val="1240088644"/>
       </p:ext>
     </p:extLst>
   </p:cSld>
@@ -17337,7 +17337,7 @@
           <p:cNvPr id="2" name="TextBox 1">
             <a:extLst xmlns:a="http://schemas.openxmlformats.org/drawingml/2006/main">
               <a:ext uri="{FF2B5EF4-FFF2-40B4-BE49-F238E27FC236}">
-                <a16:creationId xmlns:a16="http://schemas.microsoft.com/office/drawing/2014/main" id="{E8C1AE68-4E43-4D1A-96A3-F8FCBC31D792}"/>
+                <a16:creationId xmlns:a16="http://schemas.microsoft.com/office/drawing/2014/main" id="{E8D75A87-E60A-40A8-863D-3FC88E05E2F2}"/>
               </a:ext>
             </a:extLst>
           </p:cNvPr>
@@ -17384,7 +17384,7 @@
           <p:cNvPr id="3" name="TextBox 2">
             <a:extLst xmlns:a="http://schemas.openxmlformats.org/drawingml/2006/main">
               <a:ext uri="{FF2B5EF4-FFF2-40B4-BE49-F238E27FC236}">
-                <a16:creationId xmlns:a16="http://schemas.microsoft.com/office/drawing/2014/main" id="{52E8D07E-9805-4A1C-AD49-2A2168943634}"/>
+                <a16:creationId xmlns:a16="http://schemas.microsoft.com/office/drawing/2014/main" id="{3A5F2887-7033-41C3-BA75-6874578B8A9A}"/>
               </a:ext>
             </a:extLst>
           </p:cNvPr>
@@ -17431,7 +17431,7 @@
           <p:cNvPr id="4" name="Rectangle 3">
             <a:extLst xmlns:a="http://schemas.openxmlformats.org/drawingml/2006/main">
               <a:ext uri="{FF2B5EF4-FFF2-40B4-BE49-F238E27FC236}">
-                <a16:creationId xmlns:a16="http://schemas.microsoft.com/office/drawing/2014/main" id="{E2A6AA89-BA3C-45FF-9C40-244AF73570D8}"/>
+                <a16:creationId xmlns:a16="http://schemas.microsoft.com/office/drawing/2014/main" id="{51229D39-7823-4082-B0BF-B4B5031AAB32}"/>
               </a:ext>
             </a:extLst>
           </p:cNvPr>
@@ -17486,7 +17486,7 @@
           <p:cNvPr id="5" name="Rectangle 4">
             <a:extLst xmlns:a="http://schemas.openxmlformats.org/drawingml/2006/main">
               <a:ext uri="{FF2B5EF4-FFF2-40B4-BE49-F238E27FC236}">
-                <a16:creationId xmlns:a16="http://schemas.microsoft.com/office/drawing/2014/main" id="{5EFF69BA-2B45-49E0-8399-D458803BB3BA}"/>
+                <a16:creationId xmlns:a16="http://schemas.microsoft.com/office/drawing/2014/main" id="{E50E1835-613B-416C-BC7B-48190EF1C24A}"/>
               </a:ext>
             </a:extLst>
           </p:cNvPr>
@@ -17541,7 +17541,7 @@
           <p:cNvPr id="6" name="TextBox 5">
             <a:extLst xmlns:a="http://schemas.openxmlformats.org/drawingml/2006/main">
               <a:ext uri="{FF2B5EF4-FFF2-40B4-BE49-F238E27FC236}">
-                <a16:creationId xmlns:a16="http://schemas.microsoft.com/office/drawing/2014/main" id="{CEBEFADF-1524-4584-857C-A7F5E0209338}"/>
+                <a16:creationId xmlns:a16="http://schemas.microsoft.com/office/drawing/2014/main" id="{A454BFF3-9B91-4865-8F6C-A85BFD51816E}"/>
               </a:ext>
             </a:extLst>
           </p:cNvPr>
@@ -17578,7 +17578,7 @@
                 <a:ea typeface="Aptos"/>
                 <a:cs typeface="Aptos"/>
               </a:rPr>
-              <a:t>Independent public evidence summary · 2026.07.22-8 · 2026-07-22 · Sources: EP3032975B2; 7 O 3341/24</a:t>
+              <a:t>Independent public evidence summary · 2026.07.22-9 · 2026-07-22 · Sources: EP3032975B2; 7 O 3341/24</a:t>
             </a:r>
           </a:p>
         </p:txBody>
@@ -17588,7 +17588,7 @@
           <p:cNvPr id="7" name="TextBox 6">
             <a:extLst xmlns:a="http://schemas.openxmlformats.org/drawingml/2006/main">
               <a:ext uri="{FF2B5EF4-FFF2-40B4-BE49-F238E27FC236}">
-                <a16:creationId xmlns:a16="http://schemas.microsoft.com/office/drawing/2014/main" id="{675C4238-DE6F-4C6A-A1B7-9FA7AAC36863}"/>
+                <a16:creationId xmlns:a16="http://schemas.microsoft.com/office/drawing/2014/main" id="{6E931DB9-A87D-49CE-BA4A-1714BD9C50AB}"/>
               </a:ext>
             </a:extLst>
           </p:cNvPr>
@@ -17635,7 +17635,7 @@
           <p:cNvPr id="8" name="Rounded Rectangle 7">
             <a:extLst xmlns:a="http://schemas.openxmlformats.org/drawingml/2006/main">
               <a:ext uri="{FF2B5EF4-FFF2-40B4-BE49-F238E27FC236}">
-                <a16:creationId xmlns:a16="http://schemas.microsoft.com/office/drawing/2014/main" id="{EA98660C-C734-440B-9B59-58508D5BF6A7}"/>
+                <a16:creationId xmlns:a16="http://schemas.microsoft.com/office/drawing/2014/main" id="{03160B88-B59F-4BB8-A89A-DBCFD40E9348}"/>
               </a:ext>
             </a:extLst>
           </p:cNvPr>
@@ -17692,7 +17692,7 @@
           <p:cNvPr id="9" name="TextBox 8">
             <a:extLst xmlns:a="http://schemas.openxmlformats.org/drawingml/2006/main">
               <a:ext uri="{FF2B5EF4-FFF2-40B4-BE49-F238E27FC236}">
-                <a16:creationId xmlns:a16="http://schemas.microsoft.com/office/drawing/2014/main" id="{560609DB-7064-4513-AD50-D73CBEECEAB1}"/>
+                <a16:creationId xmlns:a16="http://schemas.microsoft.com/office/drawing/2014/main" id="{5A00457D-CE7C-44FB-847A-85E06200B06F}"/>
               </a:ext>
             </a:extLst>
           </p:cNvPr>
@@ -17739,7 +17739,7 @@
           <p:cNvPr id="10" name="TextBox 9">
             <a:extLst xmlns:a="http://schemas.openxmlformats.org/drawingml/2006/main">
               <a:ext uri="{FF2B5EF4-FFF2-40B4-BE49-F238E27FC236}">
-                <a16:creationId xmlns:a16="http://schemas.microsoft.com/office/drawing/2014/main" id="{00D56DF5-556C-4891-994E-72F15F94C21C}"/>
+                <a16:creationId xmlns:a16="http://schemas.microsoft.com/office/drawing/2014/main" id="{DADDD63B-2A19-48CD-951A-7805C9FDBB58}"/>
               </a:ext>
             </a:extLst>
           </p:cNvPr>
@@ -17786,7 +17786,7 @@
           <p:cNvPr id="11" name="TextBox 10">
             <a:extLst xmlns:a="http://schemas.openxmlformats.org/drawingml/2006/main">
               <a:ext uri="{FF2B5EF4-FFF2-40B4-BE49-F238E27FC236}">
-                <a16:creationId xmlns:a16="http://schemas.microsoft.com/office/drawing/2014/main" id="{10A7032C-9D01-4C5F-B892-76BAF78793D8}"/>
+                <a16:creationId xmlns:a16="http://schemas.microsoft.com/office/drawing/2014/main" id="{5015F019-8087-442A-BBAD-5CD167F57991}"/>
               </a:ext>
             </a:extLst>
           </p:cNvPr>
@@ -17833,7 +17833,7 @@
           <p:cNvPr id="12" name="Rounded Rectangle 11">
             <a:extLst xmlns:a="http://schemas.openxmlformats.org/drawingml/2006/main">
               <a:ext uri="{FF2B5EF4-FFF2-40B4-BE49-F238E27FC236}">
-                <a16:creationId xmlns:a16="http://schemas.microsoft.com/office/drawing/2014/main" id="{CB4A20B6-462A-4B83-8929-AA734EEEE3F5}"/>
+                <a16:creationId xmlns:a16="http://schemas.microsoft.com/office/drawing/2014/main" id="{4A815717-894A-4C12-834F-9291A24896BF}"/>
               </a:ext>
             </a:extLst>
           </p:cNvPr>
@@ -17890,7 +17890,7 @@
           <p:cNvPr id="13" name="TextBox 12">
             <a:extLst xmlns:a="http://schemas.openxmlformats.org/drawingml/2006/main">
               <a:ext uri="{FF2B5EF4-FFF2-40B4-BE49-F238E27FC236}">
-                <a16:creationId xmlns:a16="http://schemas.microsoft.com/office/drawing/2014/main" id="{08A0660F-3CAE-4313-83A8-5CD8DA16A369}"/>
+                <a16:creationId xmlns:a16="http://schemas.microsoft.com/office/drawing/2014/main" id="{1B2FF549-C939-4FEF-BF83-7701C0F9E5B6}"/>
               </a:ext>
             </a:extLst>
           </p:cNvPr>
@@ -17937,7 +17937,7 @@
           <p:cNvPr id="14" name="TextBox 13">
             <a:extLst xmlns:a="http://schemas.openxmlformats.org/drawingml/2006/main">
               <a:ext uri="{FF2B5EF4-FFF2-40B4-BE49-F238E27FC236}">
-                <a16:creationId xmlns:a16="http://schemas.microsoft.com/office/drawing/2014/main" id="{6D889CCE-86B1-4DFA-AB54-3D89245BACC9}"/>
+                <a16:creationId xmlns:a16="http://schemas.microsoft.com/office/drawing/2014/main" id="{4F9A56E8-0DE4-412E-B00A-20446FCC24D1}"/>
               </a:ext>
             </a:extLst>
           </p:cNvPr>
@@ -17984,7 +17984,7 @@
           <p:cNvPr id="15" name="TextBox 14">
             <a:extLst xmlns:a="http://schemas.openxmlformats.org/drawingml/2006/main">
               <a:ext uri="{FF2B5EF4-FFF2-40B4-BE49-F238E27FC236}">
-                <a16:creationId xmlns:a16="http://schemas.microsoft.com/office/drawing/2014/main" id="{2D21E898-0159-487D-811F-C3DAC2A2ABB8}"/>
+                <a16:creationId xmlns:a16="http://schemas.microsoft.com/office/drawing/2014/main" id="{451863E0-9137-4E73-A868-407823AD13BA}"/>
               </a:ext>
             </a:extLst>
           </p:cNvPr>
@@ -18031,7 +18031,7 @@
           <p:cNvPr id="16" name="Rounded Rectangle 15">
             <a:extLst xmlns:a="http://schemas.openxmlformats.org/drawingml/2006/main">
               <a:ext uri="{FF2B5EF4-FFF2-40B4-BE49-F238E27FC236}">
-                <a16:creationId xmlns:a16="http://schemas.microsoft.com/office/drawing/2014/main" id="{F924260B-AB61-4E69-A05B-438708919285}"/>
+                <a16:creationId xmlns:a16="http://schemas.microsoft.com/office/drawing/2014/main" id="{AB60F21B-7613-4F7A-8BE4-0209FA846135}"/>
               </a:ext>
             </a:extLst>
           </p:cNvPr>
@@ -18088,7 +18088,7 @@
           <p:cNvPr id="17" name="TextBox 16">
             <a:extLst xmlns:a="http://schemas.openxmlformats.org/drawingml/2006/main">
               <a:ext uri="{FF2B5EF4-FFF2-40B4-BE49-F238E27FC236}">
-                <a16:creationId xmlns:a16="http://schemas.microsoft.com/office/drawing/2014/main" id="{8B0E105B-EC1A-492E-8F5D-A6E9A4FFB4F4}"/>
+                <a16:creationId xmlns:a16="http://schemas.microsoft.com/office/drawing/2014/main" id="{9A1F3B46-46C6-48DC-A545-6176E8E50308}"/>
               </a:ext>
             </a:extLst>
           </p:cNvPr>
@@ -18135,7 +18135,7 @@
           <p:cNvPr id="18" name="TextBox 17">
             <a:extLst xmlns:a="http://schemas.openxmlformats.org/drawingml/2006/main">
               <a:ext uri="{FF2B5EF4-FFF2-40B4-BE49-F238E27FC236}">
-                <a16:creationId xmlns:a16="http://schemas.microsoft.com/office/drawing/2014/main" id="{621D6859-87D8-4B21-A524-5A5AA5DD35DB}"/>
+                <a16:creationId xmlns:a16="http://schemas.microsoft.com/office/drawing/2014/main" id="{0E8818AE-E36A-4BCE-8B60-BD7518EBB529}"/>
               </a:ext>
             </a:extLst>
           </p:cNvPr>
@@ -18182,7 +18182,7 @@
           <p:cNvPr id="19" name="TextBox 18">
             <a:extLst xmlns:a="http://schemas.openxmlformats.org/drawingml/2006/main">
               <a:ext uri="{FF2B5EF4-FFF2-40B4-BE49-F238E27FC236}">
-                <a16:creationId xmlns:a16="http://schemas.microsoft.com/office/drawing/2014/main" id="{DBA79293-7144-4553-A2B9-4693155D2034}"/>
+                <a16:creationId xmlns:a16="http://schemas.microsoft.com/office/drawing/2014/main" id="{20BD3A17-44B8-42EA-9B2C-249CFDFC23CC}"/>
               </a:ext>
             </a:extLst>
           </p:cNvPr>
@@ -18229,7 +18229,7 @@
           <p:cNvPr id="20" name="Rounded Rectangle 19">
             <a:extLst xmlns:a="http://schemas.openxmlformats.org/drawingml/2006/main">
               <a:ext uri="{FF2B5EF4-FFF2-40B4-BE49-F238E27FC236}">
-                <a16:creationId xmlns:a16="http://schemas.microsoft.com/office/drawing/2014/main" id="{C2FC7A2F-67C1-4559-85B0-5710F6FFB5DE}"/>
+                <a16:creationId xmlns:a16="http://schemas.microsoft.com/office/drawing/2014/main" id="{AFE5E6C1-6216-490A-87D3-7605C9F071A4}"/>
               </a:ext>
             </a:extLst>
           </p:cNvPr>
@@ -18286,7 +18286,7 @@
           <p:cNvPr id="21" name="TextBox 20">
             <a:extLst xmlns:a="http://schemas.openxmlformats.org/drawingml/2006/main">
               <a:ext uri="{FF2B5EF4-FFF2-40B4-BE49-F238E27FC236}">
-                <a16:creationId xmlns:a16="http://schemas.microsoft.com/office/drawing/2014/main" id="{84C0E70A-5D00-45E2-AF00-D6FC58B38849}"/>
+                <a16:creationId xmlns:a16="http://schemas.microsoft.com/office/drawing/2014/main" id="{C6628B6A-2405-4AE7-993D-0709CD6F06B4}"/>
               </a:ext>
             </a:extLst>
           </p:cNvPr>
@@ -18333,7 +18333,7 @@
           <p:cNvPr id="22" name="TextBox 21">
             <a:extLst xmlns:a="http://schemas.openxmlformats.org/drawingml/2006/main">
               <a:ext uri="{FF2B5EF4-FFF2-40B4-BE49-F238E27FC236}">
-                <a16:creationId xmlns:a16="http://schemas.microsoft.com/office/drawing/2014/main" id="{AE73A95D-DEA6-4ABA-8AB3-3055BD52937F}"/>
+                <a16:creationId xmlns:a16="http://schemas.microsoft.com/office/drawing/2014/main" id="{78CB31B6-3C24-454B-BCB0-242972C2583A}"/>
               </a:ext>
             </a:extLst>
           </p:cNvPr>
@@ -18380,7 +18380,7 @@
           <p:cNvPr id="23" name="TextBox 22">
             <a:extLst xmlns:a="http://schemas.openxmlformats.org/drawingml/2006/main">
               <a:ext uri="{FF2B5EF4-FFF2-40B4-BE49-F238E27FC236}">
-                <a16:creationId xmlns:a16="http://schemas.microsoft.com/office/drawing/2014/main" id="{E51A791A-BC29-4A94-BF42-132266538FC5}"/>
+                <a16:creationId xmlns:a16="http://schemas.microsoft.com/office/drawing/2014/main" id="{5C3E021B-E459-46E5-866F-A7EE1C8E6B61}"/>
               </a:ext>
             </a:extLst>
           </p:cNvPr>
@@ -18427,7 +18427,7 @@
           <p:cNvPr id="24" name="TextBox 23">
             <a:extLst xmlns:a="http://schemas.openxmlformats.org/drawingml/2006/main">
               <a:ext uri="{FF2B5EF4-FFF2-40B4-BE49-F238E27FC236}">
-                <a16:creationId xmlns:a16="http://schemas.microsoft.com/office/drawing/2014/main" id="{7430E9FC-6B87-474D-B163-FB10AF7DE064}"/>
+                <a16:creationId xmlns:a16="http://schemas.microsoft.com/office/drawing/2014/main" id="{2881B841-623D-42CB-B52D-6BAA8B0A9AC3}"/>
               </a:ext>
             </a:extLst>
           </p:cNvPr>
@@ -18472,7 +18472,7 @@
     </p:spTree>
     <p:extLst>
       <p:ext uri="{BB962C8B-B14F-4D97-AF65-F5344CB8AC3E}">
-        <p14:creationId xmlns:p14="http://schemas.microsoft.com/office/powerpoint/2010/main" val="1344514780"/>
+        <p14:creationId xmlns:p14="http://schemas.microsoft.com/office/powerpoint/2010/main" val="1540590765"/>
       </p:ext>
     </p:extLst>
   </p:cSld>
@@ -18496,7 +18496,7 @@
           <p:cNvPr id="2" name="TextBox 1">
             <a:extLst xmlns:a="http://schemas.openxmlformats.org/drawingml/2006/main">
               <a:ext uri="{FF2B5EF4-FFF2-40B4-BE49-F238E27FC236}">
-                <a16:creationId xmlns:a16="http://schemas.microsoft.com/office/drawing/2014/main" id="{52CF3436-1928-4EF4-8D16-4824357F2779}"/>
+                <a16:creationId xmlns:a16="http://schemas.microsoft.com/office/drawing/2014/main" id="{6006C4E8-B78E-474D-A7C6-9AB15900715D}"/>
               </a:ext>
             </a:extLst>
           </p:cNvPr>
@@ -18543,7 +18543,7 @@
           <p:cNvPr id="3" name="TextBox 2">
             <a:extLst xmlns:a="http://schemas.openxmlformats.org/drawingml/2006/main">
               <a:ext uri="{FF2B5EF4-FFF2-40B4-BE49-F238E27FC236}">
-                <a16:creationId xmlns:a16="http://schemas.microsoft.com/office/drawing/2014/main" id="{9883DD90-B2C3-4E3E-84E8-F6BF1328237D}"/>
+                <a16:creationId xmlns:a16="http://schemas.microsoft.com/office/drawing/2014/main" id="{761CA223-E18E-4892-AAB2-12240B210DC5}"/>
               </a:ext>
             </a:extLst>
           </p:cNvPr>
@@ -18590,7 +18590,7 @@
           <p:cNvPr id="4" name="Rectangle 3">
             <a:extLst xmlns:a="http://schemas.openxmlformats.org/drawingml/2006/main">
               <a:ext uri="{FF2B5EF4-FFF2-40B4-BE49-F238E27FC236}">
-                <a16:creationId xmlns:a16="http://schemas.microsoft.com/office/drawing/2014/main" id="{64DEC27A-4AF7-4CE9-B5E9-5582D0F1C469}"/>
+                <a16:creationId xmlns:a16="http://schemas.microsoft.com/office/drawing/2014/main" id="{E285A37D-1E96-4E10-8B28-2BC93FDD17ED}"/>
               </a:ext>
             </a:extLst>
           </p:cNvPr>
@@ -18645,7 +18645,7 @@
           <p:cNvPr id="5" name="Rectangle 4">
             <a:extLst xmlns:a="http://schemas.openxmlformats.org/drawingml/2006/main">
               <a:ext uri="{FF2B5EF4-FFF2-40B4-BE49-F238E27FC236}">
-                <a16:creationId xmlns:a16="http://schemas.microsoft.com/office/drawing/2014/main" id="{E91DBDA0-B8EA-4096-984C-151DD72CD213}"/>
+                <a16:creationId xmlns:a16="http://schemas.microsoft.com/office/drawing/2014/main" id="{E6744067-E5D3-406A-ACED-6654EFED4797}"/>
               </a:ext>
             </a:extLst>
           </p:cNvPr>
@@ -18700,7 +18700,7 @@
           <p:cNvPr id="6" name="TextBox 5">
             <a:extLst xmlns:a="http://schemas.openxmlformats.org/drawingml/2006/main">
               <a:ext uri="{FF2B5EF4-FFF2-40B4-BE49-F238E27FC236}">
-                <a16:creationId xmlns:a16="http://schemas.microsoft.com/office/drawing/2014/main" id="{928AEB55-BEFD-415A-AF4D-4DD2A2FE1AF7}"/>
+                <a16:creationId xmlns:a16="http://schemas.microsoft.com/office/drawing/2014/main" id="{D0FBEEA0-01A4-4426-8E06-A16F809A0E38}"/>
               </a:ext>
             </a:extLst>
           </p:cNvPr>
@@ -18737,7 +18737,7 @@
                 <a:ea typeface="Aptos"/>
                 <a:cs typeface="Aptos"/>
               </a:rPr>
-              <a:t>Independent public evidence summary · 2026.07.22-8 · 2026-07-22 · Sources: WIPO dispute resolution; EPO IPscore</a:t>
+              <a:t>Independent public evidence summary · 2026.07.22-9 · 2026-07-22 · Sources: WIPO dispute resolution; EPO IPscore</a:t>
             </a:r>
           </a:p>
         </p:txBody>
@@ -18747,7 +18747,7 @@
           <p:cNvPr id="7" name="TextBox 6">
             <a:extLst xmlns:a="http://schemas.openxmlformats.org/drawingml/2006/main">
               <a:ext uri="{FF2B5EF4-FFF2-40B4-BE49-F238E27FC236}">
-                <a16:creationId xmlns:a16="http://schemas.microsoft.com/office/drawing/2014/main" id="{FA6152FB-1213-4505-A2E6-B5802178B306}"/>
+                <a16:creationId xmlns:a16="http://schemas.microsoft.com/office/drawing/2014/main" id="{96CF3C17-8E54-4F52-B92E-CA155913C110}"/>
               </a:ext>
             </a:extLst>
           </p:cNvPr>
@@ -18794,7 +18794,7 @@
           <p:cNvPr id="8" name="Rounded Rectangle 7">
             <a:extLst xmlns:a="http://schemas.openxmlformats.org/drawingml/2006/main">
               <a:ext uri="{FF2B5EF4-FFF2-40B4-BE49-F238E27FC236}">
-                <a16:creationId xmlns:a16="http://schemas.microsoft.com/office/drawing/2014/main" id="{CDA29974-1ED8-4873-868F-04DCCA539D45}"/>
+                <a16:creationId xmlns:a16="http://schemas.microsoft.com/office/drawing/2014/main" id="{0FB95883-4349-43E1-B772-D7F6167CB408}"/>
               </a:ext>
             </a:extLst>
           </p:cNvPr>
@@ -18851,7 +18851,7 @@
           <p:cNvPr id="9" name="TextBox 8">
             <a:extLst xmlns:a="http://schemas.openxmlformats.org/drawingml/2006/main">
               <a:ext uri="{FF2B5EF4-FFF2-40B4-BE49-F238E27FC236}">
-                <a16:creationId xmlns:a16="http://schemas.microsoft.com/office/drawing/2014/main" id="{E8BFA89F-D9BE-4248-BEEB-57241453928E}"/>
+                <a16:creationId xmlns:a16="http://schemas.microsoft.com/office/drawing/2014/main" id="{FB9890FB-1F91-4B59-977C-1F6B018B219E}"/>
               </a:ext>
             </a:extLst>
           </p:cNvPr>
@@ -18898,7 +18898,7 @@
           <p:cNvPr id="10" name="TextBox 9">
             <a:extLst xmlns:a="http://schemas.openxmlformats.org/drawingml/2006/main">
               <a:ext uri="{FF2B5EF4-FFF2-40B4-BE49-F238E27FC236}">
-                <a16:creationId xmlns:a16="http://schemas.microsoft.com/office/drawing/2014/main" id="{933807F1-866D-47AF-98A6-934C41D030FB}"/>
+                <a16:creationId xmlns:a16="http://schemas.microsoft.com/office/drawing/2014/main" id="{55CD40FB-48AC-493B-8B8D-A8A87585EC4C}"/>
               </a:ext>
             </a:extLst>
           </p:cNvPr>
@@ -18945,7 +18945,7 @@
           <p:cNvPr id="11" name="TextBox 10">
             <a:extLst xmlns:a="http://schemas.openxmlformats.org/drawingml/2006/main">
               <a:ext uri="{FF2B5EF4-FFF2-40B4-BE49-F238E27FC236}">
-                <a16:creationId xmlns:a16="http://schemas.microsoft.com/office/drawing/2014/main" id="{8B07D76C-5590-4C27-9C23-C55C2BD3CFC9}"/>
+                <a16:creationId xmlns:a16="http://schemas.microsoft.com/office/drawing/2014/main" id="{9533DB97-B3F5-4DEE-8ACC-565693A68F43}"/>
               </a:ext>
             </a:extLst>
           </p:cNvPr>
@@ -18992,7 +18992,7 @@
           <p:cNvPr id="12" name="Rounded Rectangle 11">
             <a:extLst xmlns:a="http://schemas.openxmlformats.org/drawingml/2006/main">
               <a:ext uri="{FF2B5EF4-FFF2-40B4-BE49-F238E27FC236}">
-                <a16:creationId xmlns:a16="http://schemas.microsoft.com/office/drawing/2014/main" id="{C4EB9FAB-4F69-463C-8793-BDA37CF103E3}"/>
+                <a16:creationId xmlns:a16="http://schemas.microsoft.com/office/drawing/2014/main" id="{C7B6FA47-0A7A-44A9-8487-675A994299C1}"/>
               </a:ext>
             </a:extLst>
           </p:cNvPr>
@@ -19049,7 +19049,7 @@
           <p:cNvPr id="13" name="TextBox 12">
             <a:extLst xmlns:a="http://schemas.openxmlformats.org/drawingml/2006/main">
               <a:ext uri="{FF2B5EF4-FFF2-40B4-BE49-F238E27FC236}">
-                <a16:creationId xmlns:a16="http://schemas.microsoft.com/office/drawing/2014/main" id="{5DB80B56-F7D4-438C-8D08-E3158BCBF9C0}"/>
+                <a16:creationId xmlns:a16="http://schemas.microsoft.com/office/drawing/2014/main" id="{C651A65E-E926-4FDA-B9BF-5E5DC3145237}"/>
               </a:ext>
             </a:extLst>
           </p:cNvPr>
@@ -19096,7 +19096,7 @@
           <p:cNvPr id="14" name="TextBox 13">
             <a:extLst xmlns:a="http://schemas.openxmlformats.org/drawingml/2006/main">
               <a:ext uri="{FF2B5EF4-FFF2-40B4-BE49-F238E27FC236}">
-                <a16:creationId xmlns:a16="http://schemas.microsoft.com/office/drawing/2014/main" id="{F43A6C73-14BD-428D-8BEB-83B6F498340B}"/>
+                <a16:creationId xmlns:a16="http://schemas.microsoft.com/office/drawing/2014/main" id="{01A10754-59B5-48B0-A23D-7220B16BD5A1}"/>
               </a:ext>
             </a:extLst>
           </p:cNvPr>
@@ -19143,7 +19143,7 @@
           <p:cNvPr id="15" name="TextBox 14">
             <a:extLst xmlns:a="http://schemas.openxmlformats.org/drawingml/2006/main">
               <a:ext uri="{FF2B5EF4-FFF2-40B4-BE49-F238E27FC236}">
-                <a16:creationId xmlns:a16="http://schemas.microsoft.com/office/drawing/2014/main" id="{C9340BB2-4E23-4080-A01B-EDAAE10AE046}"/>
+                <a16:creationId xmlns:a16="http://schemas.microsoft.com/office/drawing/2014/main" id="{0E47101D-7AF9-4F30-B81B-B5319BDBD370}"/>
               </a:ext>
             </a:extLst>
           </p:cNvPr>
@@ -19190,7 +19190,7 @@
           <p:cNvPr id="16" name="Rounded Rectangle 15">
             <a:extLst xmlns:a="http://schemas.openxmlformats.org/drawingml/2006/main">
               <a:ext uri="{FF2B5EF4-FFF2-40B4-BE49-F238E27FC236}">
-                <a16:creationId xmlns:a16="http://schemas.microsoft.com/office/drawing/2014/main" id="{CEF390C3-446F-41C2-82C6-07D0BEDF54C3}"/>
+                <a16:creationId xmlns:a16="http://schemas.microsoft.com/office/drawing/2014/main" id="{83DDF465-966F-42C8-A212-F05648A1F74B}"/>
               </a:ext>
             </a:extLst>
           </p:cNvPr>
@@ -19247,7 +19247,7 @@
           <p:cNvPr id="17" name="TextBox 16">
             <a:extLst xmlns:a="http://schemas.openxmlformats.org/drawingml/2006/main">
               <a:ext uri="{FF2B5EF4-FFF2-40B4-BE49-F238E27FC236}">
-                <a16:creationId xmlns:a16="http://schemas.microsoft.com/office/drawing/2014/main" id="{326575A5-A4FD-40FD-8895-C2F786EA922B}"/>
+                <a16:creationId xmlns:a16="http://schemas.microsoft.com/office/drawing/2014/main" id="{7DF1812A-E692-4B32-A053-7A40546F14A9}"/>
               </a:ext>
             </a:extLst>
           </p:cNvPr>
@@ -19294,7 +19294,7 @@
           <p:cNvPr id="18" name="TextBox 17">
             <a:extLst xmlns:a="http://schemas.openxmlformats.org/drawingml/2006/main">
               <a:ext uri="{FF2B5EF4-FFF2-40B4-BE49-F238E27FC236}">
-                <a16:creationId xmlns:a16="http://schemas.microsoft.com/office/drawing/2014/main" id="{74F2AE71-3F5B-4EF2-BCA8-D570DB51E43A}"/>
+                <a16:creationId xmlns:a16="http://schemas.microsoft.com/office/drawing/2014/main" id="{0E180A76-B1EA-4651-B686-31A97EC0A4A7}"/>
               </a:ext>
             </a:extLst>
           </p:cNvPr>
@@ -19341,7 +19341,7 @@
           <p:cNvPr id="19" name="TextBox 18">
             <a:extLst xmlns:a="http://schemas.openxmlformats.org/drawingml/2006/main">
               <a:ext uri="{FF2B5EF4-FFF2-40B4-BE49-F238E27FC236}">
-                <a16:creationId xmlns:a16="http://schemas.microsoft.com/office/drawing/2014/main" id="{7E45EB32-FFB3-47C6-8C9C-C5D8F82E89EA}"/>
+                <a16:creationId xmlns:a16="http://schemas.microsoft.com/office/drawing/2014/main" id="{3129954E-B4DC-4B27-A880-9FEB1D0C52F7}"/>
               </a:ext>
             </a:extLst>
           </p:cNvPr>
@@ -19388,7 +19388,7 @@
           <p:cNvPr id="20" name="Rounded Rectangle 19">
             <a:extLst xmlns:a="http://schemas.openxmlformats.org/drawingml/2006/main">
               <a:ext uri="{FF2B5EF4-FFF2-40B4-BE49-F238E27FC236}">
-                <a16:creationId xmlns:a16="http://schemas.microsoft.com/office/drawing/2014/main" id="{B2A9EEC1-AF11-4031-B903-98FD6F78E479}"/>
+                <a16:creationId xmlns:a16="http://schemas.microsoft.com/office/drawing/2014/main" id="{976229AF-CDFE-437B-B7A4-E967449C6029}"/>
               </a:ext>
             </a:extLst>
           </p:cNvPr>
@@ -19445,7 +19445,7 @@
           <p:cNvPr id="21" name="TextBox 20">
             <a:extLst xmlns:a="http://schemas.openxmlformats.org/drawingml/2006/main">
               <a:ext uri="{FF2B5EF4-FFF2-40B4-BE49-F238E27FC236}">
-                <a16:creationId xmlns:a16="http://schemas.microsoft.com/office/drawing/2014/main" id="{8017A1D8-3FAA-40F2-93D4-1C881A6433D0}"/>
+                <a16:creationId xmlns:a16="http://schemas.microsoft.com/office/drawing/2014/main" id="{B2FC2DC8-E230-47A1-A90B-60D7A91307BF}"/>
               </a:ext>
             </a:extLst>
           </p:cNvPr>
@@ -19492,7 +19492,7 @@
           <p:cNvPr id="22" name="TextBox 21">
             <a:extLst xmlns:a="http://schemas.openxmlformats.org/drawingml/2006/main">
               <a:ext uri="{FF2B5EF4-FFF2-40B4-BE49-F238E27FC236}">
-                <a16:creationId xmlns:a16="http://schemas.microsoft.com/office/drawing/2014/main" id="{BB53DF6D-BB7D-4C35-99C1-03B7F28F41C6}"/>
+                <a16:creationId xmlns:a16="http://schemas.microsoft.com/office/drawing/2014/main" id="{2ADE84F0-6FD7-42C7-A06F-25FCCA5D25D7}"/>
               </a:ext>
             </a:extLst>
           </p:cNvPr>
@@ -19539,7 +19539,7 @@
           <p:cNvPr id="23" name="TextBox 22">
             <a:extLst xmlns:a="http://schemas.openxmlformats.org/drawingml/2006/main">
               <a:ext uri="{FF2B5EF4-FFF2-40B4-BE49-F238E27FC236}">
-                <a16:creationId xmlns:a16="http://schemas.microsoft.com/office/drawing/2014/main" id="{AE2AAC0E-5FE1-4F05-80A7-77E33F57FD7E}"/>
+                <a16:creationId xmlns:a16="http://schemas.microsoft.com/office/drawing/2014/main" id="{0F632556-65EA-4E3F-B4C6-77732E2526CA}"/>
               </a:ext>
             </a:extLst>
           </p:cNvPr>
@@ -19586,7 +19586,7 @@
           <p:cNvPr id="24" name="TextBox 23">
             <a:extLst xmlns:a="http://schemas.openxmlformats.org/drawingml/2006/main">
               <a:ext uri="{FF2B5EF4-FFF2-40B4-BE49-F238E27FC236}">
-                <a16:creationId xmlns:a16="http://schemas.microsoft.com/office/drawing/2014/main" id="{A1254B59-2F0C-4F6E-B6BC-5402F3395945}"/>
+                <a16:creationId xmlns:a16="http://schemas.microsoft.com/office/drawing/2014/main" id="{FB992DC0-8797-4350-B09E-AE47828A9392}"/>
               </a:ext>
             </a:extLst>
           </p:cNvPr>
@@ -19631,7 +19631,7 @@
     </p:spTree>
     <p:extLst>
       <p:ext uri="{BB962C8B-B14F-4D97-AF65-F5344CB8AC3E}">
-        <p14:creationId xmlns:p14="http://schemas.microsoft.com/office/powerpoint/2010/main" val="1725309266"/>
+        <p14:creationId xmlns:p14="http://schemas.microsoft.com/office/powerpoint/2010/main" val="859806017"/>
       </p:ext>
     </p:extLst>
   </p:cSld>
@@ -19655,7 +19655,7 @@
           <p:cNvPr id="2" name="TextBox 1">
             <a:extLst xmlns:a="http://schemas.openxmlformats.org/drawingml/2006/main">
               <a:ext uri="{FF2B5EF4-FFF2-40B4-BE49-F238E27FC236}">
-                <a16:creationId xmlns:a16="http://schemas.microsoft.com/office/drawing/2014/main" id="{1E47A91F-50F1-46C9-B34C-D557686933C8}"/>
+                <a16:creationId xmlns:a16="http://schemas.microsoft.com/office/drawing/2014/main" id="{71838222-A282-41FD-9B12-E064A020DA47}"/>
               </a:ext>
             </a:extLst>
           </p:cNvPr>
@@ -19702,7 +19702,7 @@
           <p:cNvPr id="3" name="TextBox 2">
             <a:extLst xmlns:a="http://schemas.openxmlformats.org/drawingml/2006/main">
               <a:ext uri="{FF2B5EF4-FFF2-40B4-BE49-F238E27FC236}">
-                <a16:creationId xmlns:a16="http://schemas.microsoft.com/office/drawing/2014/main" id="{42588564-6686-4811-A73E-C7F807DBA1FC}"/>
+                <a16:creationId xmlns:a16="http://schemas.microsoft.com/office/drawing/2014/main" id="{FF8FDAD1-FD54-42B8-A083-1A78415FC562}"/>
               </a:ext>
             </a:extLst>
           </p:cNvPr>
@@ -19749,7 +19749,7 @@
           <p:cNvPr id="4" name="Rectangle 3">
             <a:extLst xmlns:a="http://schemas.openxmlformats.org/drawingml/2006/main">
               <a:ext uri="{FF2B5EF4-FFF2-40B4-BE49-F238E27FC236}">
-                <a16:creationId xmlns:a16="http://schemas.microsoft.com/office/drawing/2014/main" id="{6FF4F7B9-0B16-4E59-81BC-3A451277243A}"/>
+                <a16:creationId xmlns:a16="http://schemas.microsoft.com/office/drawing/2014/main" id="{48BEE886-3729-4673-86C6-568C0EBA437C}"/>
               </a:ext>
             </a:extLst>
           </p:cNvPr>
@@ -19804,7 +19804,7 @@
           <p:cNvPr id="5" name="Rectangle 4">
             <a:extLst xmlns:a="http://schemas.openxmlformats.org/drawingml/2006/main">
               <a:ext uri="{FF2B5EF4-FFF2-40B4-BE49-F238E27FC236}">
-                <a16:creationId xmlns:a16="http://schemas.microsoft.com/office/drawing/2014/main" id="{D7A3B97F-3E52-433F-A2C9-DB17FC3C5985}"/>
+                <a16:creationId xmlns:a16="http://schemas.microsoft.com/office/drawing/2014/main" id="{B3AD91A6-E772-41C2-BD2D-02F501FCBC54}"/>
               </a:ext>
             </a:extLst>
           </p:cNvPr>
@@ -19859,7 +19859,7 @@
           <p:cNvPr id="6" name="TextBox 5">
             <a:extLst xmlns:a="http://schemas.openxmlformats.org/drawingml/2006/main">
               <a:ext uri="{FF2B5EF4-FFF2-40B4-BE49-F238E27FC236}">
-                <a16:creationId xmlns:a16="http://schemas.microsoft.com/office/drawing/2014/main" id="{3BA35E34-DF02-4B4B-998D-E002193FE9CB}"/>
+                <a16:creationId xmlns:a16="http://schemas.microsoft.com/office/drawing/2014/main" id="{61AE0A7A-7FD6-40C4-BFEA-C974C5EEFB40}"/>
               </a:ext>
             </a:extLst>
           </p:cNvPr>
@@ -19896,7 +19896,7 @@
                 <a:ea typeface="Aptos"/>
                 <a:cs typeface="Aptos"/>
               </a:rPr>
-              <a:t>Independent public evidence summary · 2026.07.22-8 · 2026-07-22 · Sources: WIPO licensing; IP Finance; TPLF mapping</a:t>
+              <a:t>Independent public evidence summary · 2026.07.22-9 · 2026-07-22 · Sources: WIPO licensing; IP Finance; TPLF mapping</a:t>
             </a:r>
           </a:p>
         </p:txBody>
@@ -19906,7 +19906,7 @@
           <p:cNvPr id="7" name="TextBox 6">
             <a:extLst xmlns:a="http://schemas.openxmlformats.org/drawingml/2006/main">
               <a:ext uri="{FF2B5EF4-FFF2-40B4-BE49-F238E27FC236}">
-                <a16:creationId xmlns:a16="http://schemas.microsoft.com/office/drawing/2014/main" id="{97C8AEA2-BE51-4360-A005-10FB753EE881}"/>
+                <a16:creationId xmlns:a16="http://schemas.microsoft.com/office/drawing/2014/main" id="{DAF7A2C1-663E-48B1-B7E6-A68AAE40D78C}"/>
               </a:ext>
             </a:extLst>
           </p:cNvPr>
@@ -20476,7 +20476,7 @@
           <p:cNvPr id="9" name="TextBox 8">
             <a:extLst xmlns:a="http://schemas.openxmlformats.org/drawingml/2006/main">
               <a:ext uri="{FF2B5EF4-FFF2-40B4-BE49-F238E27FC236}">
-                <a16:creationId xmlns:a16="http://schemas.microsoft.com/office/drawing/2014/main" id="{2519DC55-D22A-4D25-899E-944905969630}"/>
+                <a16:creationId xmlns:a16="http://schemas.microsoft.com/office/drawing/2014/main" id="{5F1A5A2C-E11F-4A67-BEE5-BE868D525B57}"/>
               </a:ext>
             </a:extLst>
           </p:cNvPr>
@@ -20521,7 +20521,7 @@
     </p:spTree>
     <p:extLst>
       <p:ext uri="{BB962C8B-B14F-4D97-AF65-F5344CB8AC3E}">
-        <p14:creationId xmlns:p14="http://schemas.microsoft.com/office/powerpoint/2010/main" val="1158020839"/>
+        <p14:creationId xmlns:p14="http://schemas.microsoft.com/office/powerpoint/2010/main" val="1079105360"/>
       </p:ext>
     </p:extLst>
   </p:cSld>
@@ -20545,7 +20545,7 @@
           <p:cNvPr id="2" name="TextBox 1">
             <a:extLst xmlns:a="http://schemas.openxmlformats.org/drawingml/2006/main">
               <a:ext uri="{FF2B5EF4-FFF2-40B4-BE49-F238E27FC236}">
-                <a16:creationId xmlns:a16="http://schemas.microsoft.com/office/drawing/2014/main" id="{CEC203A3-994D-4218-9534-2A174DFF4AC8}"/>
+                <a16:creationId xmlns:a16="http://schemas.microsoft.com/office/drawing/2014/main" id="{25F13E3D-FA26-4DDB-9E23-F34CB15AFE54}"/>
               </a:ext>
             </a:extLst>
           </p:cNvPr>
@@ -20592,7 +20592,7 @@
           <p:cNvPr id="3" name="TextBox 2">
             <a:extLst xmlns:a="http://schemas.openxmlformats.org/drawingml/2006/main">
               <a:ext uri="{FF2B5EF4-FFF2-40B4-BE49-F238E27FC236}">
-                <a16:creationId xmlns:a16="http://schemas.microsoft.com/office/drawing/2014/main" id="{56BF3B91-10DB-48B6-8876-42A1AF48E155}"/>
+                <a16:creationId xmlns:a16="http://schemas.microsoft.com/office/drawing/2014/main" id="{F58939F6-6EC0-4F64-9CD3-94CD78E10222}"/>
               </a:ext>
             </a:extLst>
           </p:cNvPr>
@@ -20639,7 +20639,7 @@
           <p:cNvPr id="4" name="Rectangle 3">
             <a:extLst xmlns:a="http://schemas.openxmlformats.org/drawingml/2006/main">
               <a:ext uri="{FF2B5EF4-FFF2-40B4-BE49-F238E27FC236}">
-                <a16:creationId xmlns:a16="http://schemas.microsoft.com/office/drawing/2014/main" id="{565685BB-4B49-4B39-8725-8A36662D68CC}"/>
+                <a16:creationId xmlns:a16="http://schemas.microsoft.com/office/drawing/2014/main" id="{61FB9D3B-DEA3-4340-B365-3E2375E0A6E9}"/>
               </a:ext>
             </a:extLst>
           </p:cNvPr>
@@ -20694,7 +20694,7 @@
           <p:cNvPr id="5" name="Rectangle 4">
             <a:extLst xmlns:a="http://schemas.openxmlformats.org/drawingml/2006/main">
               <a:ext uri="{FF2B5EF4-FFF2-40B4-BE49-F238E27FC236}">
-                <a16:creationId xmlns:a16="http://schemas.microsoft.com/office/drawing/2014/main" id="{536D7E78-51D4-4B67-BDC4-ACA200DC2163}"/>
+                <a16:creationId xmlns:a16="http://schemas.microsoft.com/office/drawing/2014/main" id="{288C1931-650F-4C77-A5CC-8B3876C33763}"/>
               </a:ext>
             </a:extLst>
           </p:cNvPr>
@@ -20749,7 +20749,7 @@
           <p:cNvPr id="6" name="TextBox 5">
             <a:extLst xmlns:a="http://schemas.openxmlformats.org/drawingml/2006/main">
               <a:ext uri="{FF2B5EF4-FFF2-40B4-BE49-F238E27FC236}">
-                <a16:creationId xmlns:a16="http://schemas.microsoft.com/office/drawing/2014/main" id="{F3E0936C-E652-41A6-AA24-CEAFCA2801BD}"/>
+                <a16:creationId xmlns:a16="http://schemas.microsoft.com/office/drawing/2014/main" id="{4F3403B6-D0FB-4126-B951-95A4D3E5BB4B}"/>
               </a:ext>
             </a:extLst>
           </p:cNvPr>
@@ -20786,7 +20786,7 @@
                 <a:ea typeface="Aptos"/>
                 <a:cs typeface="Aptos"/>
               </a:rPr>
-              <a:t>Independent public evidence summary · 2026.07.22-8 · 2026-07-22 · Sources: Evidence Register; WIPO valuation</a:t>
+              <a:t>Independent public evidence summary · 2026.07.22-9 · 2026-07-22 · Sources: Evidence Register; WIPO valuation</a:t>
             </a:r>
           </a:p>
         </p:txBody>
@@ -20796,7 +20796,7 @@
           <p:cNvPr id="7" name="TextBox 6">
             <a:extLst xmlns:a="http://schemas.openxmlformats.org/drawingml/2006/main">
               <a:ext uri="{FF2B5EF4-FFF2-40B4-BE49-F238E27FC236}">
-                <a16:creationId xmlns:a16="http://schemas.microsoft.com/office/drawing/2014/main" id="{CE983800-8081-4B11-A272-74E1EF41EA1C}"/>
+                <a16:creationId xmlns:a16="http://schemas.microsoft.com/office/drawing/2014/main" id="{6DAC56FE-A8E1-4F11-B610-7840E739A8E6}"/>
               </a:ext>
             </a:extLst>
           </p:cNvPr>
@@ -21449,7 +21449,7 @@
           <p:cNvPr id="9" name="TextBox 8">
             <a:extLst xmlns:a="http://schemas.openxmlformats.org/drawingml/2006/main">
               <a:ext uri="{FF2B5EF4-FFF2-40B4-BE49-F238E27FC236}">
-                <a16:creationId xmlns:a16="http://schemas.microsoft.com/office/drawing/2014/main" id="{A16590F4-6B56-4047-979F-38D0D80108C0}"/>
+                <a16:creationId xmlns:a16="http://schemas.microsoft.com/office/drawing/2014/main" id="{392FDC02-EB16-4547-B8F1-4C3795FA63AC}"/>
               </a:ext>
             </a:extLst>
           </p:cNvPr>
@@ -21494,7 +21494,7 @@
     </p:spTree>
     <p:extLst>
       <p:ext uri="{BB962C8B-B14F-4D97-AF65-F5344CB8AC3E}">
-        <p14:creationId xmlns:p14="http://schemas.microsoft.com/office/powerpoint/2010/main" val="2118078650"/>
+        <p14:creationId xmlns:p14="http://schemas.microsoft.com/office/powerpoint/2010/main" val="1707387436"/>
       </p:ext>
     </p:extLst>
   </p:cSld>
@@ -21518,7 +21518,7 @@
           <p:cNvPr id="2" name="TextBox 1">
             <a:extLst xmlns:a="http://schemas.openxmlformats.org/drawingml/2006/main">
               <a:ext uri="{FF2B5EF4-FFF2-40B4-BE49-F238E27FC236}">
-                <a16:creationId xmlns:a16="http://schemas.microsoft.com/office/drawing/2014/main" id="{EBD46AAE-CA64-4DA8-A4C6-6F48D3448342}"/>
+                <a16:creationId xmlns:a16="http://schemas.microsoft.com/office/drawing/2014/main" id="{5FD9C22E-0936-4183-A433-3FCF7175B311}"/>
               </a:ext>
             </a:extLst>
           </p:cNvPr>
@@ -21565,7 +21565,7 @@
           <p:cNvPr id="3" name="TextBox 2">
             <a:extLst xmlns:a="http://schemas.openxmlformats.org/drawingml/2006/main">
               <a:ext uri="{FF2B5EF4-FFF2-40B4-BE49-F238E27FC236}">
-                <a16:creationId xmlns:a16="http://schemas.microsoft.com/office/drawing/2014/main" id="{8A45EFC9-94DE-4108-97AC-21AED5D6749F}"/>
+                <a16:creationId xmlns:a16="http://schemas.microsoft.com/office/drawing/2014/main" id="{87F18902-FB7F-4468-9236-AC4DB5FA606F}"/>
               </a:ext>
             </a:extLst>
           </p:cNvPr>
@@ -21612,7 +21612,7 @@
           <p:cNvPr id="4" name="Rectangle 3">
             <a:extLst xmlns:a="http://schemas.openxmlformats.org/drawingml/2006/main">
               <a:ext uri="{FF2B5EF4-FFF2-40B4-BE49-F238E27FC236}">
-                <a16:creationId xmlns:a16="http://schemas.microsoft.com/office/drawing/2014/main" id="{D5E44FD3-197D-4B36-9885-04AAAF9DD852}"/>
+                <a16:creationId xmlns:a16="http://schemas.microsoft.com/office/drawing/2014/main" id="{6B6A6BCF-E493-4970-904A-6BC94F636FDE}"/>
               </a:ext>
             </a:extLst>
           </p:cNvPr>
@@ -21667,7 +21667,7 @@
           <p:cNvPr id="5" name="Rectangle 4">
             <a:extLst xmlns:a="http://schemas.openxmlformats.org/drawingml/2006/main">
               <a:ext uri="{FF2B5EF4-FFF2-40B4-BE49-F238E27FC236}">
-                <a16:creationId xmlns:a16="http://schemas.microsoft.com/office/drawing/2014/main" id="{EF27C09D-97FC-4D99-AE63-8F0032171DCB}"/>
+                <a16:creationId xmlns:a16="http://schemas.microsoft.com/office/drawing/2014/main" id="{2E25D073-19E2-4E5F-9B91-200B012056D6}"/>
               </a:ext>
             </a:extLst>
           </p:cNvPr>
@@ -21722,7 +21722,7 @@
           <p:cNvPr id="6" name="TextBox 5">
             <a:extLst xmlns:a="http://schemas.openxmlformats.org/drawingml/2006/main">
               <a:ext uri="{FF2B5EF4-FFF2-40B4-BE49-F238E27FC236}">
-                <a16:creationId xmlns:a16="http://schemas.microsoft.com/office/drawing/2014/main" id="{3B84D5CB-05C4-4C63-AD67-2B3EE5D0DF53}"/>
+                <a16:creationId xmlns:a16="http://schemas.microsoft.com/office/drawing/2014/main" id="{325CFED0-7FDD-4872-8379-9A6BA5533A0F}"/>
               </a:ext>
             </a:extLst>
           </p:cNvPr>
@@ -21759,7 +21759,7 @@
                 <a:ea typeface="Aptos"/>
                 <a:cs typeface="Aptos"/>
               </a:rPr>
-              <a:t>Independent public evidence summary · 2026.07.22-8 · 2026-07-22 · Sources: WIPO valuation</a:t>
+              <a:t>Independent public evidence summary · 2026.07.22-9 · 2026-07-22 · Sources: WIPO valuation</a:t>
             </a:r>
           </a:p>
         </p:txBody>
@@ -21769,7 +21769,7 @@
           <p:cNvPr id="7" name="TextBox 6">
             <a:extLst xmlns:a="http://schemas.openxmlformats.org/drawingml/2006/main">
               <a:ext uri="{FF2B5EF4-FFF2-40B4-BE49-F238E27FC236}">
-                <a16:creationId xmlns:a16="http://schemas.microsoft.com/office/drawing/2014/main" id="{ACF2D1DF-756F-4A8F-83A0-23B1A2A1E634}"/>
+                <a16:creationId xmlns:a16="http://schemas.microsoft.com/office/drawing/2014/main" id="{8AC4850B-48C1-4AF0-A7D7-C0EA57F5AA94}"/>
               </a:ext>
             </a:extLst>
           </p:cNvPr>
@@ -22502,7 +22502,7 @@
           <p:cNvPr id="9" name="TextBox 8">
             <a:extLst xmlns:a="http://schemas.openxmlformats.org/drawingml/2006/main">
               <a:ext uri="{FF2B5EF4-FFF2-40B4-BE49-F238E27FC236}">
-                <a16:creationId xmlns:a16="http://schemas.microsoft.com/office/drawing/2014/main" id="{14F9D4A4-D60F-4722-8FAB-154E7B1E56B7}"/>
+                <a16:creationId xmlns:a16="http://schemas.microsoft.com/office/drawing/2014/main" id="{4E5CF8AB-6039-4F8E-BB41-CF294BF05485}"/>
               </a:ext>
             </a:extLst>
           </p:cNvPr>
@@ -22547,7 +22547,7 @@
     </p:spTree>
     <p:extLst>
       <p:ext uri="{BB962C8B-B14F-4D97-AF65-F5344CB8AC3E}">
-        <p14:creationId xmlns:p14="http://schemas.microsoft.com/office/powerpoint/2010/main" val="2092916366"/>
+        <p14:creationId xmlns:p14="http://schemas.microsoft.com/office/powerpoint/2010/main" val="53254733"/>
       </p:ext>
     </p:extLst>
   </p:cSld>
@@ -22571,7 +22571,7 @@
           <p:cNvPr id="2" name="TextBox 1">
             <a:extLst xmlns:a="http://schemas.openxmlformats.org/drawingml/2006/main">
               <a:ext uri="{FF2B5EF4-FFF2-40B4-BE49-F238E27FC236}">
-                <a16:creationId xmlns:a16="http://schemas.microsoft.com/office/drawing/2014/main" id="{94BCBD1E-0492-4D76-9295-F2BA07598361}"/>
+                <a16:creationId xmlns:a16="http://schemas.microsoft.com/office/drawing/2014/main" id="{FDA63CFE-2427-48EE-B5AB-B5243B9B8DDD}"/>
               </a:ext>
             </a:extLst>
           </p:cNvPr>
@@ -22618,7 +22618,7 @@
           <p:cNvPr id="3" name="TextBox 2">
             <a:extLst xmlns:a="http://schemas.openxmlformats.org/drawingml/2006/main">
               <a:ext uri="{FF2B5EF4-FFF2-40B4-BE49-F238E27FC236}">
-                <a16:creationId xmlns:a16="http://schemas.microsoft.com/office/drawing/2014/main" id="{2F728EFA-3062-4FEB-9542-30D747781768}"/>
+                <a16:creationId xmlns:a16="http://schemas.microsoft.com/office/drawing/2014/main" id="{03B93B61-C5AE-473B-BFF6-C6EA195A30AD}"/>
               </a:ext>
             </a:extLst>
           </p:cNvPr>
@@ -22665,7 +22665,7 @@
           <p:cNvPr id="4" name="Rectangle 3">
             <a:extLst xmlns:a="http://schemas.openxmlformats.org/drawingml/2006/main">
               <a:ext uri="{FF2B5EF4-FFF2-40B4-BE49-F238E27FC236}">
-                <a16:creationId xmlns:a16="http://schemas.microsoft.com/office/drawing/2014/main" id="{77AB192F-0EC6-4015-BA8C-040F4E44397B}"/>
+                <a16:creationId xmlns:a16="http://schemas.microsoft.com/office/drawing/2014/main" id="{15A32B4B-B3D7-4083-8B32-D6C8C9A5B4C2}"/>
               </a:ext>
             </a:extLst>
           </p:cNvPr>
@@ -22720,7 +22720,7 @@
           <p:cNvPr id="5" name="Rectangle 4">
             <a:extLst xmlns:a="http://schemas.openxmlformats.org/drawingml/2006/main">
               <a:ext uri="{FF2B5EF4-FFF2-40B4-BE49-F238E27FC236}">
-                <a16:creationId xmlns:a16="http://schemas.microsoft.com/office/drawing/2014/main" id="{4B03CFBE-BC44-4E98-9147-E0BD3D734D00}"/>
+                <a16:creationId xmlns:a16="http://schemas.microsoft.com/office/drawing/2014/main" id="{6A3F3C49-526C-4917-B375-4E090959114C}"/>
               </a:ext>
             </a:extLst>
           </p:cNvPr>
@@ -22775,7 +22775,7 @@
           <p:cNvPr id="6" name="TextBox 5">
             <a:extLst xmlns:a="http://schemas.openxmlformats.org/drawingml/2006/main">
               <a:ext uri="{FF2B5EF4-FFF2-40B4-BE49-F238E27FC236}">
-                <a16:creationId xmlns:a16="http://schemas.microsoft.com/office/drawing/2014/main" id="{5A03CEDD-8AA3-4A8F-8DB8-A5E54ECE41FE}"/>
+                <a16:creationId xmlns:a16="http://schemas.microsoft.com/office/drawing/2014/main" id="{6C7FF603-B003-492E-A5EC-3AE2B6E15EC1}"/>
               </a:ext>
             </a:extLst>
           </p:cNvPr>
@@ -22812,7 +22812,7 @@
                 <a:ea typeface="Aptos"/>
                 <a:cs typeface="Aptos"/>
               </a:rPr>
-              <a:t>Independent public evidence summary · 2026.07.22-8 · 2026-07-22 · Sources: Evidence Register</a:t>
+              <a:t>Independent public evidence summary · 2026.07.22-9 · 2026-07-22 · Sources: Evidence Register</a:t>
             </a:r>
           </a:p>
         </p:txBody>
@@ -22822,7 +22822,7 @@
           <p:cNvPr id="7" name="TextBox 6">
             <a:extLst xmlns:a="http://schemas.openxmlformats.org/drawingml/2006/main">
               <a:ext uri="{FF2B5EF4-FFF2-40B4-BE49-F238E27FC236}">
-                <a16:creationId xmlns:a16="http://schemas.microsoft.com/office/drawing/2014/main" id="{F30E3E05-EE87-483C-A2DD-A2B7D2AEC18A}"/>
+                <a16:creationId xmlns:a16="http://schemas.microsoft.com/office/drawing/2014/main" id="{80DB0655-A2BB-4C54-BC7C-D60DA44498A5}"/>
               </a:ext>
             </a:extLst>
           </p:cNvPr>
@@ -23392,7 +23392,7 @@
           <p:cNvPr id="9" name="TextBox 8">
             <a:extLst xmlns:a="http://schemas.openxmlformats.org/drawingml/2006/main">
               <a:ext uri="{FF2B5EF4-FFF2-40B4-BE49-F238E27FC236}">
-                <a16:creationId xmlns:a16="http://schemas.microsoft.com/office/drawing/2014/main" id="{3DE247A5-AAE5-4631-9A74-33EC50F1E2D1}"/>
+                <a16:creationId xmlns:a16="http://schemas.microsoft.com/office/drawing/2014/main" id="{3C0A7508-93B6-45B7-93F0-A33E091F3D79}"/>
               </a:ext>
             </a:extLst>
           </p:cNvPr>
@@ -23437,7 +23437,7 @@
     </p:spTree>
     <p:extLst>
       <p:ext uri="{BB962C8B-B14F-4D97-AF65-F5344CB8AC3E}">
-        <p14:creationId xmlns:p14="http://schemas.microsoft.com/office/powerpoint/2010/main" val="1942760929"/>
+        <p14:creationId xmlns:p14="http://schemas.microsoft.com/office/powerpoint/2010/main" val="1746787613"/>
       </p:ext>
     </p:extLst>
   </p:cSld>
@@ -23461,7 +23461,7 @@
           <p:cNvPr id="2" name="TextBox 1">
             <a:extLst xmlns:a="http://schemas.openxmlformats.org/drawingml/2006/main">
               <a:ext uri="{FF2B5EF4-FFF2-40B4-BE49-F238E27FC236}">
-                <a16:creationId xmlns:a16="http://schemas.microsoft.com/office/drawing/2014/main" id="{4B40A477-15AD-4313-AA40-A43F1781A692}"/>
+                <a16:creationId xmlns:a16="http://schemas.microsoft.com/office/drawing/2014/main" id="{B3B0AC0D-8E1B-4616-8FB6-AAA7CE986AB3}"/>
               </a:ext>
             </a:extLst>
           </p:cNvPr>
@@ -23508,7 +23508,7 @@
           <p:cNvPr id="3" name="TextBox 2">
             <a:extLst xmlns:a="http://schemas.openxmlformats.org/drawingml/2006/main">
               <a:ext uri="{FF2B5EF4-FFF2-40B4-BE49-F238E27FC236}">
-                <a16:creationId xmlns:a16="http://schemas.microsoft.com/office/drawing/2014/main" id="{0014F240-C6FB-481C-9DE3-DC1938602913}"/>
+                <a16:creationId xmlns:a16="http://schemas.microsoft.com/office/drawing/2014/main" id="{BE166885-1780-4BE6-8334-E6DAC006528A}"/>
               </a:ext>
             </a:extLst>
           </p:cNvPr>
@@ -23555,7 +23555,7 @@
           <p:cNvPr id="4" name="Rectangle 3">
             <a:extLst xmlns:a="http://schemas.openxmlformats.org/drawingml/2006/main">
               <a:ext uri="{FF2B5EF4-FFF2-40B4-BE49-F238E27FC236}">
-                <a16:creationId xmlns:a16="http://schemas.microsoft.com/office/drawing/2014/main" id="{3E8CF239-D61B-4E10-B284-7ED41D88FC3B}"/>
+                <a16:creationId xmlns:a16="http://schemas.microsoft.com/office/drawing/2014/main" id="{DB0101B4-A009-4437-9ACA-F206464300CB}"/>
               </a:ext>
             </a:extLst>
           </p:cNvPr>
@@ -23610,7 +23610,7 @@
           <p:cNvPr id="5" name="Rectangle 4">
             <a:extLst xmlns:a="http://schemas.openxmlformats.org/drawingml/2006/main">
               <a:ext uri="{FF2B5EF4-FFF2-40B4-BE49-F238E27FC236}">
-                <a16:creationId xmlns:a16="http://schemas.microsoft.com/office/drawing/2014/main" id="{6CB1E7CD-9455-4BA9-A4C8-02D28A636B42}"/>
+                <a16:creationId xmlns:a16="http://schemas.microsoft.com/office/drawing/2014/main" id="{31BFCC2D-11BA-4D9D-8C14-742D04F5A275}"/>
               </a:ext>
             </a:extLst>
           </p:cNvPr>
@@ -23665,7 +23665,7 @@
           <p:cNvPr id="6" name="TextBox 5">
             <a:extLst xmlns:a="http://schemas.openxmlformats.org/drawingml/2006/main">
               <a:ext uri="{FF2B5EF4-FFF2-40B4-BE49-F238E27FC236}">
-                <a16:creationId xmlns:a16="http://schemas.microsoft.com/office/drawing/2014/main" id="{328A300C-216F-4D08-9236-AFD4BDD61CE7}"/>
+                <a16:creationId xmlns:a16="http://schemas.microsoft.com/office/drawing/2014/main" id="{0231597F-B7B1-43E9-BEC9-7877405CB2F0}"/>
               </a:ext>
             </a:extLst>
           </p:cNvPr>
@@ -23702,7 +23702,7 @@
                 <a:ea typeface="Aptos"/>
                 <a:cs typeface="Aptos"/>
               </a:rPr>
-              <a:t>Independent public evidence summary · 2026.07.22-8 · 2026-07-22 · Sources: Evidence Register</a:t>
+              <a:t>Independent public evidence summary · 2026.07.22-9 · 2026-07-22 · Sources: Evidence Register</a:t>
             </a:r>
           </a:p>
         </p:txBody>
@@ -23712,7 +23712,7 @@
           <p:cNvPr id="7" name="TextBox 6">
             <a:extLst xmlns:a="http://schemas.openxmlformats.org/drawingml/2006/main">
               <a:ext uri="{FF2B5EF4-FFF2-40B4-BE49-F238E27FC236}">
-                <a16:creationId xmlns:a16="http://schemas.microsoft.com/office/drawing/2014/main" id="{9854C5B4-8C71-44AB-BE6A-4BA18DB62051}"/>
+                <a16:creationId xmlns:a16="http://schemas.microsoft.com/office/drawing/2014/main" id="{14D217F7-7B5B-423B-ADB7-8A44CCC90FDE}"/>
               </a:ext>
             </a:extLst>
           </p:cNvPr>
@@ -24365,7 +24365,7 @@
           <p:cNvPr id="9" name="TextBox 8">
             <a:extLst xmlns:a="http://schemas.openxmlformats.org/drawingml/2006/main">
               <a:ext uri="{FF2B5EF4-FFF2-40B4-BE49-F238E27FC236}">
-                <a16:creationId xmlns:a16="http://schemas.microsoft.com/office/drawing/2014/main" id="{6FEC0802-9D51-4133-83AB-E518599D43B5}"/>
+                <a16:creationId xmlns:a16="http://schemas.microsoft.com/office/drawing/2014/main" id="{76316B92-0CB8-4DA8-A5C0-CD7687C09989}"/>
               </a:ext>
             </a:extLst>
           </p:cNvPr>
@@ -24410,7 +24410,7 @@
     </p:spTree>
     <p:extLst>
       <p:ext uri="{BB962C8B-B14F-4D97-AF65-F5344CB8AC3E}">
-        <p14:creationId xmlns:p14="http://schemas.microsoft.com/office/powerpoint/2010/main" val="1110109338"/>
+        <p14:creationId xmlns:p14="http://schemas.microsoft.com/office/powerpoint/2010/main" val="1660671506"/>
       </p:ext>
     </p:extLst>
   </p:cSld>
@@ -24434,7 +24434,7 @@
           <p:cNvPr id="2" name="TextBox 1">
             <a:extLst xmlns:a="http://schemas.openxmlformats.org/drawingml/2006/main">
               <a:ext uri="{FF2B5EF4-FFF2-40B4-BE49-F238E27FC236}">
-                <a16:creationId xmlns:a16="http://schemas.microsoft.com/office/drawing/2014/main" id="{AFBB895E-8DDB-4D79-839D-67640AD9DAEA}"/>
+                <a16:creationId xmlns:a16="http://schemas.microsoft.com/office/drawing/2014/main" id="{738B1D29-447A-484B-96B3-6D66E1726268}"/>
               </a:ext>
             </a:extLst>
           </p:cNvPr>
@@ -24481,7 +24481,7 @@
           <p:cNvPr id="3" name="TextBox 2">
             <a:extLst xmlns:a="http://schemas.openxmlformats.org/drawingml/2006/main">
               <a:ext uri="{FF2B5EF4-FFF2-40B4-BE49-F238E27FC236}">
-                <a16:creationId xmlns:a16="http://schemas.microsoft.com/office/drawing/2014/main" id="{9DA5AD96-D6EB-43E5-BC75-318A31B30A0D}"/>
+                <a16:creationId xmlns:a16="http://schemas.microsoft.com/office/drawing/2014/main" id="{921574DC-07D3-48AE-A35A-D5ECC19CCB3B}"/>
               </a:ext>
             </a:extLst>
           </p:cNvPr>
@@ -24528,7 +24528,7 @@
           <p:cNvPr id="4" name="Rectangle 3">
             <a:extLst xmlns:a="http://schemas.openxmlformats.org/drawingml/2006/main">
               <a:ext uri="{FF2B5EF4-FFF2-40B4-BE49-F238E27FC236}">
-                <a16:creationId xmlns:a16="http://schemas.microsoft.com/office/drawing/2014/main" id="{2714C374-7F39-4CAB-8431-8C541FF8BDB8}"/>
+                <a16:creationId xmlns:a16="http://schemas.microsoft.com/office/drawing/2014/main" id="{B8C9040A-E790-452E-ADD3-918E62FD3F9E}"/>
               </a:ext>
             </a:extLst>
           </p:cNvPr>
@@ -24583,7 +24583,7 @@
           <p:cNvPr id="5" name="Rectangle 4">
             <a:extLst xmlns:a="http://schemas.openxmlformats.org/drawingml/2006/main">
               <a:ext uri="{FF2B5EF4-FFF2-40B4-BE49-F238E27FC236}">
-                <a16:creationId xmlns:a16="http://schemas.microsoft.com/office/drawing/2014/main" id="{0E6E40CD-35C4-4E98-87DC-DF3BD35A3B28}"/>
+                <a16:creationId xmlns:a16="http://schemas.microsoft.com/office/drawing/2014/main" id="{508EC97A-7AD8-4FBB-BC5E-5A91B5ED8AF0}"/>
               </a:ext>
             </a:extLst>
           </p:cNvPr>
@@ -24638,7 +24638,7 @@
           <p:cNvPr id="6" name="TextBox 5">
             <a:extLst xmlns:a="http://schemas.openxmlformats.org/drawingml/2006/main">
               <a:ext uri="{FF2B5EF4-FFF2-40B4-BE49-F238E27FC236}">
-                <a16:creationId xmlns:a16="http://schemas.microsoft.com/office/drawing/2014/main" id="{F678CF8F-7C47-487B-8530-9D89DBF961DA}"/>
+                <a16:creationId xmlns:a16="http://schemas.microsoft.com/office/drawing/2014/main" id="{DCD307B9-18E9-497D-973C-78CDF45EAFAD}"/>
               </a:ext>
             </a:extLst>
           </p:cNvPr>
@@ -24675,7 +24675,7 @@
                 <a:ea typeface="Aptos"/>
                 <a:cs typeface="Aptos"/>
               </a:rPr>
-              <a:t>Independent public evidence summary · 2026.07.22-8 · 2026-07-22 · Sources: Evidence Register; changelog</a:t>
+              <a:t>Independent public evidence summary · 2026.07.22-9 · 2026-07-22 · Sources: Evidence Register; changelog</a:t>
             </a:r>
           </a:p>
         </p:txBody>
@@ -24685,7 +24685,7 @@
           <p:cNvPr id="7" name="TextBox 6">
             <a:extLst xmlns:a="http://schemas.openxmlformats.org/drawingml/2006/main">
               <a:ext uri="{FF2B5EF4-FFF2-40B4-BE49-F238E27FC236}">
-                <a16:creationId xmlns:a16="http://schemas.microsoft.com/office/drawing/2014/main" id="{88C33C93-7ACF-474D-98D1-52E1BE73FCD7}"/>
+                <a16:creationId xmlns:a16="http://schemas.microsoft.com/office/drawing/2014/main" id="{E1CFA685-250F-42A4-87C6-553C495CA4CB}"/>
               </a:ext>
             </a:extLst>
           </p:cNvPr>
@@ -24732,7 +24732,7 @@
           <p:cNvPr id="8" name="Rounded Rectangle 7">
             <a:extLst xmlns:a="http://schemas.openxmlformats.org/drawingml/2006/main">
               <a:ext uri="{FF2B5EF4-FFF2-40B4-BE49-F238E27FC236}">
-                <a16:creationId xmlns:a16="http://schemas.microsoft.com/office/drawing/2014/main" id="{E3ECA411-4401-4EF3-A718-181780C99A0A}"/>
+                <a16:creationId xmlns:a16="http://schemas.microsoft.com/office/drawing/2014/main" id="{A22079C8-4DA4-4600-927C-009924C1FBC3}"/>
               </a:ext>
             </a:extLst>
           </p:cNvPr>
@@ -24789,7 +24789,7 @@
           <p:cNvPr id="9" name="TextBox 8">
             <a:extLst xmlns:a="http://schemas.openxmlformats.org/drawingml/2006/main">
               <a:ext uri="{FF2B5EF4-FFF2-40B4-BE49-F238E27FC236}">
-                <a16:creationId xmlns:a16="http://schemas.microsoft.com/office/drawing/2014/main" id="{D3180229-F2E2-4B85-83F4-08F620F46B65}"/>
+                <a16:creationId xmlns:a16="http://schemas.microsoft.com/office/drawing/2014/main" id="{4B9CD6EC-AC04-447B-8FC7-7F0249F7BC38}"/>
               </a:ext>
             </a:extLst>
           </p:cNvPr>
@@ -24836,7 +24836,7 @@
           <p:cNvPr id="10" name="TextBox 9">
             <a:extLst xmlns:a="http://schemas.openxmlformats.org/drawingml/2006/main">
               <a:ext uri="{FF2B5EF4-FFF2-40B4-BE49-F238E27FC236}">
-                <a16:creationId xmlns:a16="http://schemas.microsoft.com/office/drawing/2014/main" id="{DFAC7313-C4F7-4D1F-A9D0-DAC3C00B544B}"/>
+                <a16:creationId xmlns:a16="http://schemas.microsoft.com/office/drawing/2014/main" id="{583B4150-2D37-4F31-8AFE-C1F14E99EC0E}"/>
               </a:ext>
             </a:extLst>
           </p:cNvPr>
@@ -24883,7 +24883,7 @@
           <p:cNvPr id="11" name="TextBox 10">
             <a:extLst xmlns:a="http://schemas.openxmlformats.org/drawingml/2006/main">
               <a:ext uri="{FF2B5EF4-FFF2-40B4-BE49-F238E27FC236}">
-                <a16:creationId xmlns:a16="http://schemas.microsoft.com/office/drawing/2014/main" id="{989DDA47-68E9-4E59-8487-67F31ADB3985}"/>
+                <a16:creationId xmlns:a16="http://schemas.microsoft.com/office/drawing/2014/main" id="{A778ED5C-1EBA-4A46-B04F-09C19F771BBB}"/>
               </a:ext>
             </a:extLst>
           </p:cNvPr>
@@ -24930,7 +24930,7 @@
           <p:cNvPr id="12" name="Rounded Rectangle 11">
             <a:extLst xmlns:a="http://schemas.openxmlformats.org/drawingml/2006/main">
               <a:ext uri="{FF2B5EF4-FFF2-40B4-BE49-F238E27FC236}">
-                <a16:creationId xmlns:a16="http://schemas.microsoft.com/office/drawing/2014/main" id="{492E9AC5-39BB-43C5-AEFC-C3B65D75AADF}"/>
+                <a16:creationId xmlns:a16="http://schemas.microsoft.com/office/drawing/2014/main" id="{79B26E7D-2A9D-42AA-B851-1A2D2CB7AE86}"/>
               </a:ext>
             </a:extLst>
           </p:cNvPr>
@@ -24987,7 +24987,7 @@
           <p:cNvPr id="13" name="TextBox 12">
             <a:extLst xmlns:a="http://schemas.openxmlformats.org/drawingml/2006/main">
               <a:ext uri="{FF2B5EF4-FFF2-40B4-BE49-F238E27FC236}">
-                <a16:creationId xmlns:a16="http://schemas.microsoft.com/office/drawing/2014/main" id="{0C841C9B-DB62-48D3-9A46-E6CEE2722DB6}"/>
+                <a16:creationId xmlns:a16="http://schemas.microsoft.com/office/drawing/2014/main" id="{1BA9958D-22B8-4758-95B0-AFBF3F4BC2D2}"/>
               </a:ext>
             </a:extLst>
           </p:cNvPr>
@@ -25034,7 +25034,7 @@
           <p:cNvPr id="14" name="TextBox 13">
             <a:extLst xmlns:a="http://schemas.openxmlformats.org/drawingml/2006/main">
               <a:ext uri="{FF2B5EF4-FFF2-40B4-BE49-F238E27FC236}">
-                <a16:creationId xmlns:a16="http://schemas.microsoft.com/office/drawing/2014/main" id="{330F5BF1-B1EB-4818-B559-4E39D3F40468}"/>
+                <a16:creationId xmlns:a16="http://schemas.microsoft.com/office/drawing/2014/main" id="{7B9DA7EA-C817-46B5-99D4-C192E02112F6}"/>
               </a:ext>
             </a:extLst>
           </p:cNvPr>
@@ -25081,7 +25081,7 @@
           <p:cNvPr id="15" name="TextBox 14">
             <a:extLst xmlns:a="http://schemas.openxmlformats.org/drawingml/2006/main">
               <a:ext uri="{FF2B5EF4-FFF2-40B4-BE49-F238E27FC236}">
-                <a16:creationId xmlns:a16="http://schemas.microsoft.com/office/drawing/2014/main" id="{7554236E-305B-4FE6-A640-2CE0B9252D97}"/>
+                <a16:creationId xmlns:a16="http://schemas.microsoft.com/office/drawing/2014/main" id="{2A365AA1-F463-4C81-A8E3-7ACBD469D273}"/>
               </a:ext>
             </a:extLst>
           </p:cNvPr>
@@ -25128,7 +25128,7 @@
           <p:cNvPr id="16" name="Rounded Rectangle 15">
             <a:extLst xmlns:a="http://schemas.openxmlformats.org/drawingml/2006/main">
               <a:ext uri="{FF2B5EF4-FFF2-40B4-BE49-F238E27FC236}">
-                <a16:creationId xmlns:a16="http://schemas.microsoft.com/office/drawing/2014/main" id="{519F0A05-A819-46C3-8A5F-9859A46A0292}"/>
+                <a16:creationId xmlns:a16="http://schemas.microsoft.com/office/drawing/2014/main" id="{026A4820-1AEB-40AF-A75A-63E101128F1A}"/>
               </a:ext>
             </a:extLst>
           </p:cNvPr>
@@ -25185,7 +25185,7 @@
           <p:cNvPr id="17" name="TextBox 16">
             <a:extLst xmlns:a="http://schemas.openxmlformats.org/drawingml/2006/main">
               <a:ext uri="{FF2B5EF4-FFF2-40B4-BE49-F238E27FC236}">
-                <a16:creationId xmlns:a16="http://schemas.microsoft.com/office/drawing/2014/main" id="{EB6A7004-1D98-48B6-9B40-D10F6A34FCFD}"/>
+                <a16:creationId xmlns:a16="http://schemas.microsoft.com/office/drawing/2014/main" id="{E210E917-A93A-4C7C-9C94-1DF2FE5DDAE9}"/>
               </a:ext>
             </a:extLst>
           </p:cNvPr>
@@ -25232,7 +25232,7 @@
           <p:cNvPr id="18" name="TextBox 17">
             <a:extLst xmlns:a="http://schemas.openxmlformats.org/drawingml/2006/main">
               <a:ext uri="{FF2B5EF4-FFF2-40B4-BE49-F238E27FC236}">
-                <a16:creationId xmlns:a16="http://schemas.microsoft.com/office/drawing/2014/main" id="{D501D4BE-0692-4E77-86EF-64E36346E029}"/>
+                <a16:creationId xmlns:a16="http://schemas.microsoft.com/office/drawing/2014/main" id="{C730F891-4159-4EF6-9F13-31175D5440D9}"/>
               </a:ext>
             </a:extLst>
           </p:cNvPr>
@@ -25279,7 +25279,7 @@
           <p:cNvPr id="19" name="TextBox 18">
             <a:extLst xmlns:a="http://schemas.openxmlformats.org/drawingml/2006/main">
               <a:ext uri="{FF2B5EF4-FFF2-40B4-BE49-F238E27FC236}">
-                <a16:creationId xmlns:a16="http://schemas.microsoft.com/office/drawing/2014/main" id="{737F6FC5-16A5-47D8-B2B1-CE09767C8F0E}"/>
+                <a16:creationId xmlns:a16="http://schemas.microsoft.com/office/drawing/2014/main" id="{3EB40D68-916A-47E4-AD11-E07DDF1F7766}"/>
               </a:ext>
             </a:extLst>
           </p:cNvPr>
@@ -25326,7 +25326,7 @@
           <p:cNvPr id="20" name="Rounded Rectangle 19">
             <a:extLst xmlns:a="http://schemas.openxmlformats.org/drawingml/2006/main">
               <a:ext uri="{FF2B5EF4-FFF2-40B4-BE49-F238E27FC236}">
-                <a16:creationId xmlns:a16="http://schemas.microsoft.com/office/drawing/2014/main" id="{0F230AB3-9729-4978-9F11-CBA777846373}"/>
+                <a16:creationId xmlns:a16="http://schemas.microsoft.com/office/drawing/2014/main" id="{130B32E7-0603-49D1-A571-B44A9C3B3820}"/>
               </a:ext>
             </a:extLst>
           </p:cNvPr>
@@ -25383,7 +25383,7 @@
           <p:cNvPr id="21" name="TextBox 20">
             <a:extLst xmlns:a="http://schemas.openxmlformats.org/drawingml/2006/main">
               <a:ext uri="{FF2B5EF4-FFF2-40B4-BE49-F238E27FC236}">
-                <a16:creationId xmlns:a16="http://schemas.microsoft.com/office/drawing/2014/main" id="{4C36A3D4-3486-403B-A584-DC825779F0C6}"/>
+                <a16:creationId xmlns:a16="http://schemas.microsoft.com/office/drawing/2014/main" id="{882EDC1C-6920-4C1F-9491-D648952B248E}"/>
               </a:ext>
             </a:extLst>
           </p:cNvPr>
@@ -25430,7 +25430,7 @@
           <p:cNvPr id="22" name="TextBox 21">
             <a:extLst xmlns:a="http://schemas.openxmlformats.org/drawingml/2006/main">
               <a:ext uri="{FF2B5EF4-FFF2-40B4-BE49-F238E27FC236}">
-                <a16:creationId xmlns:a16="http://schemas.microsoft.com/office/drawing/2014/main" id="{1E3E6DEA-A694-44FB-AFD4-E5939E02586F}"/>
+                <a16:creationId xmlns:a16="http://schemas.microsoft.com/office/drawing/2014/main" id="{D97ED6F2-AEDF-4DE4-8EC7-1BB3FF8D0F3B}"/>
               </a:ext>
             </a:extLst>
           </p:cNvPr>
@@ -25477,7 +25477,7 @@
           <p:cNvPr id="23" name="TextBox 22">
             <a:extLst xmlns:a="http://schemas.openxmlformats.org/drawingml/2006/main">
               <a:ext uri="{FF2B5EF4-FFF2-40B4-BE49-F238E27FC236}">
-                <a16:creationId xmlns:a16="http://schemas.microsoft.com/office/drawing/2014/main" id="{7AD8C80F-398F-49EE-AA93-C04A05991239}"/>
+                <a16:creationId xmlns:a16="http://schemas.microsoft.com/office/drawing/2014/main" id="{8B693996-F9ED-4A77-9337-4CC7415575A1}"/>
               </a:ext>
             </a:extLst>
           </p:cNvPr>
@@ -25524,7 +25524,7 @@
           <p:cNvPr id="24" name="TextBox 23">
             <a:extLst xmlns:a="http://schemas.openxmlformats.org/drawingml/2006/main">
               <a:ext uri="{FF2B5EF4-FFF2-40B4-BE49-F238E27FC236}">
-                <a16:creationId xmlns:a16="http://schemas.microsoft.com/office/drawing/2014/main" id="{D87C5874-AE54-44B4-AD51-24DD69FCC92B}"/>
+                <a16:creationId xmlns:a16="http://schemas.microsoft.com/office/drawing/2014/main" id="{42529BC9-58C2-414F-9273-77732735316C}"/>
               </a:ext>
             </a:extLst>
           </p:cNvPr>
@@ -25569,7 +25569,7 @@
     </p:spTree>
     <p:extLst>
       <p:ext uri="{BB962C8B-B14F-4D97-AF65-F5344CB8AC3E}">
-        <p14:creationId xmlns:p14="http://schemas.microsoft.com/office/powerpoint/2010/main" val="562993184"/>
+        <p14:creationId xmlns:p14="http://schemas.microsoft.com/office/powerpoint/2010/main" val="92321566"/>
       </p:ext>
     </p:extLst>
   </p:cSld>
@@ -25593,7 +25593,7 @@
           <p:cNvPr id="2" name="TextBox 1">
             <a:extLst xmlns:a="http://schemas.openxmlformats.org/drawingml/2006/main">
               <a:ext uri="{FF2B5EF4-FFF2-40B4-BE49-F238E27FC236}">
-                <a16:creationId xmlns:a16="http://schemas.microsoft.com/office/drawing/2014/main" id="{8FA16BA5-657E-4D1C-9C46-FBC6B765EB1B}"/>
+                <a16:creationId xmlns:a16="http://schemas.microsoft.com/office/drawing/2014/main" id="{579AC010-F3B8-4B79-AE8B-802D8F87309E}"/>
               </a:ext>
             </a:extLst>
           </p:cNvPr>
@@ -25640,7 +25640,7 @@
           <p:cNvPr id="3" name="TextBox 2">
             <a:extLst xmlns:a="http://schemas.openxmlformats.org/drawingml/2006/main">
               <a:ext uri="{FF2B5EF4-FFF2-40B4-BE49-F238E27FC236}">
-                <a16:creationId xmlns:a16="http://schemas.microsoft.com/office/drawing/2014/main" id="{0F229E67-CF59-47D1-8174-C8B5014DCDB5}"/>
+                <a16:creationId xmlns:a16="http://schemas.microsoft.com/office/drawing/2014/main" id="{DDCB1B9C-52F5-4FC7-B4EA-C8F20A2171B7}"/>
               </a:ext>
             </a:extLst>
           </p:cNvPr>
@@ -25687,7 +25687,7 @@
           <p:cNvPr id="4" name="Rectangle 3">
             <a:extLst xmlns:a="http://schemas.openxmlformats.org/drawingml/2006/main">
               <a:ext uri="{FF2B5EF4-FFF2-40B4-BE49-F238E27FC236}">
-                <a16:creationId xmlns:a16="http://schemas.microsoft.com/office/drawing/2014/main" id="{ABCE1930-8787-42A3-858B-D39811DB6A93}"/>
+                <a16:creationId xmlns:a16="http://schemas.microsoft.com/office/drawing/2014/main" id="{B712BD54-C6F5-4056-88D6-69F50254092E}"/>
               </a:ext>
             </a:extLst>
           </p:cNvPr>
@@ -25742,7 +25742,7 @@
           <p:cNvPr id="5" name="Rectangle 4">
             <a:extLst xmlns:a="http://schemas.openxmlformats.org/drawingml/2006/main">
               <a:ext uri="{FF2B5EF4-FFF2-40B4-BE49-F238E27FC236}">
-                <a16:creationId xmlns:a16="http://schemas.microsoft.com/office/drawing/2014/main" id="{55F2595C-4786-4EA4-98D0-C6CC94AF224D}"/>
+                <a16:creationId xmlns:a16="http://schemas.microsoft.com/office/drawing/2014/main" id="{FE25D6B4-B553-4C89-957F-6FDE67291137}"/>
               </a:ext>
             </a:extLst>
           </p:cNvPr>
@@ -25797,7 +25797,7 @@
           <p:cNvPr id="6" name="TextBox 5">
             <a:extLst xmlns:a="http://schemas.openxmlformats.org/drawingml/2006/main">
               <a:ext uri="{FF2B5EF4-FFF2-40B4-BE49-F238E27FC236}">
-                <a16:creationId xmlns:a16="http://schemas.microsoft.com/office/drawing/2014/main" id="{8AC3C739-479D-43F3-A6C3-D79F67329805}"/>
+                <a16:creationId xmlns:a16="http://schemas.microsoft.com/office/drawing/2014/main" id="{51853347-E45C-449C-8652-73E58012513C}"/>
               </a:ext>
             </a:extLst>
           </p:cNvPr>
@@ -25834,7 +25834,7 @@
                 <a:ea typeface="Aptos"/>
                 <a:cs typeface="Aptos"/>
               </a:rPr>
-              <a:t>Independent public evidence summary · 2026.07.22-8 · 2026-07-22 · Sources: EPO; 8 Ni 18/24 (EP); 7 O 3341/24</a:t>
+              <a:t>Independent public evidence summary · 2026.07.22-9 · 2026-07-22 · Sources: EPO; 8 Ni 18/24 (EP); 7 O 3341/24</a:t>
             </a:r>
           </a:p>
         </p:txBody>
@@ -25844,7 +25844,7 @@
           <p:cNvPr id="7" name="TextBox 6">
             <a:extLst xmlns:a="http://schemas.openxmlformats.org/drawingml/2006/main">
               <a:ext uri="{FF2B5EF4-FFF2-40B4-BE49-F238E27FC236}">
-                <a16:creationId xmlns:a16="http://schemas.microsoft.com/office/drawing/2014/main" id="{6493A345-A91F-4CA9-8B1E-F685447F5CCF}"/>
+                <a16:creationId xmlns:a16="http://schemas.microsoft.com/office/drawing/2014/main" id="{6DD99515-C4C9-433B-A530-27F2A57B94E4}"/>
               </a:ext>
             </a:extLst>
           </p:cNvPr>
@@ -26248,7 +26248,7 @@
           <p:cNvPr id="9" name="TextBox 8">
             <a:extLst xmlns:a="http://schemas.openxmlformats.org/drawingml/2006/main">
               <a:ext uri="{FF2B5EF4-FFF2-40B4-BE49-F238E27FC236}">
-                <a16:creationId xmlns:a16="http://schemas.microsoft.com/office/drawing/2014/main" id="{FEE9BAFA-8DA0-474A-879C-8A4E90774424}"/>
+                <a16:creationId xmlns:a16="http://schemas.microsoft.com/office/drawing/2014/main" id="{F1D39DB8-3582-4D2C-BFE4-A7F2E9E68B95}"/>
               </a:ext>
             </a:extLst>
           </p:cNvPr>
@@ -26293,7 +26293,7 @@
     </p:spTree>
     <p:extLst>
       <p:ext uri="{BB962C8B-B14F-4D97-AF65-F5344CB8AC3E}">
-        <p14:creationId xmlns:p14="http://schemas.microsoft.com/office/powerpoint/2010/main" val="196157156"/>
+        <p14:creationId xmlns:p14="http://schemas.microsoft.com/office/powerpoint/2010/main" val="1288151326"/>
       </p:ext>
     </p:extLst>
   </p:cSld>
@@ -26324,7 +26324,7 @@
           <p:cNvPr id="2" name="TextBox 1">
             <a:extLst xmlns:a="http://schemas.openxmlformats.org/drawingml/2006/main">
               <a:ext uri="{FF2B5EF4-FFF2-40B4-BE49-F238E27FC236}">
-                <a16:creationId xmlns:a16="http://schemas.microsoft.com/office/drawing/2014/main" id="{29160436-3A70-4D7E-B326-E54C5EC381A0}"/>
+                <a16:creationId xmlns:a16="http://schemas.microsoft.com/office/drawing/2014/main" id="{F983CE36-95D3-4520-BAF4-031689D5E41B}"/>
               </a:ext>
             </a:extLst>
           </p:cNvPr>
@@ -26371,7 +26371,7 @@
           <p:cNvPr id="3" name="TextBox 2">
             <a:extLst xmlns:a="http://schemas.openxmlformats.org/drawingml/2006/main">
               <a:ext uri="{FF2B5EF4-FFF2-40B4-BE49-F238E27FC236}">
-                <a16:creationId xmlns:a16="http://schemas.microsoft.com/office/drawing/2014/main" id="{2CBD78B8-07D1-437D-B78A-A86C9F67B2CE}"/>
+                <a16:creationId xmlns:a16="http://schemas.microsoft.com/office/drawing/2014/main" id="{CCB56563-454C-4968-AD50-34B6664A46BA}"/>
               </a:ext>
             </a:extLst>
           </p:cNvPr>
@@ -26418,7 +26418,7 @@
           <p:cNvPr id="4" name="TextBox 3">
             <a:extLst xmlns:a="http://schemas.openxmlformats.org/drawingml/2006/main">
               <a:ext uri="{FF2B5EF4-FFF2-40B4-BE49-F238E27FC236}">
-                <a16:creationId xmlns:a16="http://schemas.microsoft.com/office/drawing/2014/main" id="{F4C656FF-F531-4CC9-9533-03E0316D60BF}"/>
+                <a16:creationId xmlns:a16="http://schemas.microsoft.com/office/drawing/2014/main" id="{01BABAD7-212C-4123-B693-6BBC0BEA6876}"/>
               </a:ext>
             </a:extLst>
           </p:cNvPr>
@@ -26537,7 +26537,7 @@
           <p:cNvPr id="5" name="TextBox 4">
             <a:extLst xmlns:a="http://schemas.openxmlformats.org/drawingml/2006/main">
               <a:ext uri="{FF2B5EF4-FFF2-40B4-BE49-F238E27FC236}">
-                <a16:creationId xmlns:a16="http://schemas.microsoft.com/office/drawing/2014/main" id="{51AA2B48-8A8C-4DA4-A627-B92AEE475D99}"/>
+                <a16:creationId xmlns:a16="http://schemas.microsoft.com/office/drawing/2014/main" id="{ADD564C1-AB61-4336-A3F8-24E54EC10613}"/>
               </a:ext>
             </a:extLst>
           </p:cNvPr>
@@ -26574,7 +26574,7 @@
                 <a:ea typeface="Aptos"/>
                 <a:cs typeface="Aptos"/>
               </a:rPr>
-              <a:t>Version 2026.07.22-8 · 2026-07-22 · 30 / 30</a:t>
+              <a:t>Version 2026.07.22-9 · 2026-07-22 · 30 / 30</a:t>
             </a:r>
           </a:p>
         </p:txBody>
@@ -26582,7 +26582,7 @@
     </p:spTree>
     <p:extLst>
       <p:ext uri="{BB962C8B-B14F-4D97-AF65-F5344CB8AC3E}">
-        <p14:creationId xmlns:p14="http://schemas.microsoft.com/office/powerpoint/2010/main" val="559323013"/>
+        <p14:creationId xmlns:p14="http://schemas.microsoft.com/office/powerpoint/2010/main" val="556422540"/>
       </p:ext>
     </p:extLst>
   </p:cSld>
@@ -26606,7 +26606,7 @@
           <p:cNvPr id="2" name="TextBox 1">
             <a:extLst xmlns:a="http://schemas.openxmlformats.org/drawingml/2006/main">
               <a:ext uri="{FF2B5EF4-FFF2-40B4-BE49-F238E27FC236}">
-                <a16:creationId xmlns:a16="http://schemas.microsoft.com/office/drawing/2014/main" id="{DD5D8A54-63FA-4E60-A789-9B52FF7DDC05}"/>
+                <a16:creationId xmlns:a16="http://schemas.microsoft.com/office/drawing/2014/main" id="{23F78842-F31D-4BCA-A6BB-5EA12A03B320}"/>
               </a:ext>
             </a:extLst>
           </p:cNvPr>
@@ -26653,7 +26653,7 @@
           <p:cNvPr id="3" name="TextBox 2">
             <a:extLst xmlns:a="http://schemas.openxmlformats.org/drawingml/2006/main">
               <a:ext uri="{FF2B5EF4-FFF2-40B4-BE49-F238E27FC236}">
-                <a16:creationId xmlns:a16="http://schemas.microsoft.com/office/drawing/2014/main" id="{699089B8-8057-4D56-BCB4-EDD3AFC0E4DA}"/>
+                <a16:creationId xmlns:a16="http://schemas.microsoft.com/office/drawing/2014/main" id="{D8FC01DC-76AF-447B-BA62-D2B82BE9380B}"/>
               </a:ext>
             </a:extLst>
           </p:cNvPr>
@@ -26700,7 +26700,7 @@
           <p:cNvPr id="4" name="Rectangle 3">
             <a:extLst xmlns:a="http://schemas.openxmlformats.org/drawingml/2006/main">
               <a:ext uri="{FF2B5EF4-FFF2-40B4-BE49-F238E27FC236}">
-                <a16:creationId xmlns:a16="http://schemas.microsoft.com/office/drawing/2014/main" id="{050C2726-EF55-4AC2-A0B6-372B0C0F4585}"/>
+                <a16:creationId xmlns:a16="http://schemas.microsoft.com/office/drawing/2014/main" id="{E7EBB987-37AD-4869-B075-9B18876817E2}"/>
               </a:ext>
             </a:extLst>
           </p:cNvPr>
@@ -26755,7 +26755,7 @@
           <p:cNvPr id="5" name="Rectangle 4">
             <a:extLst xmlns:a="http://schemas.openxmlformats.org/drawingml/2006/main">
               <a:ext uri="{FF2B5EF4-FFF2-40B4-BE49-F238E27FC236}">
-                <a16:creationId xmlns:a16="http://schemas.microsoft.com/office/drawing/2014/main" id="{B26FCD45-A7A6-413A-8280-2A5290CE9484}"/>
+                <a16:creationId xmlns:a16="http://schemas.microsoft.com/office/drawing/2014/main" id="{355BE1A0-4A21-4B2D-BA2E-5B304B9A08E2}"/>
               </a:ext>
             </a:extLst>
           </p:cNvPr>
@@ -26810,7 +26810,7 @@
           <p:cNvPr id="6" name="TextBox 5">
             <a:extLst xmlns:a="http://schemas.openxmlformats.org/drawingml/2006/main">
               <a:ext uri="{FF2B5EF4-FFF2-40B4-BE49-F238E27FC236}">
-                <a16:creationId xmlns:a16="http://schemas.microsoft.com/office/drawing/2014/main" id="{697A8A1E-F087-4E89-8590-A039A9C1C9A5}"/>
+                <a16:creationId xmlns:a16="http://schemas.microsoft.com/office/drawing/2014/main" id="{E93F9AD1-E09D-4424-8457-D8F1B258BC9C}"/>
               </a:ext>
             </a:extLst>
           </p:cNvPr>
@@ -26847,7 +26847,7 @@
                 <a:ea typeface="Aptos"/>
                 <a:cs typeface="Aptos"/>
               </a:rPr>
-              <a:t>Independent public evidence summary · 2026.07.22-8 · 2026-07-22 · Sources: Evidence Register; WIPO</a:t>
+              <a:t>Independent public evidence summary · 2026.07.22-9 · 2026-07-22 · Sources: Evidence Register; WIPO</a:t>
             </a:r>
           </a:p>
         </p:txBody>
@@ -26857,7 +26857,7 @@
           <p:cNvPr id="7" name="TextBox 6">
             <a:extLst xmlns:a="http://schemas.openxmlformats.org/drawingml/2006/main">
               <a:ext uri="{FF2B5EF4-FFF2-40B4-BE49-F238E27FC236}">
-                <a16:creationId xmlns:a16="http://schemas.microsoft.com/office/drawing/2014/main" id="{1F32B6A1-2C88-4F3E-BFAC-FD45E31B1CB1}"/>
+                <a16:creationId xmlns:a16="http://schemas.microsoft.com/office/drawing/2014/main" id="{8D7206DC-AA3D-4387-A8FD-D031C396210B}"/>
               </a:ext>
             </a:extLst>
           </p:cNvPr>
@@ -26904,7 +26904,7 @@
           <p:cNvPr id="8" name="TextBox 7">
             <a:extLst xmlns:a="http://schemas.openxmlformats.org/drawingml/2006/main">
               <a:ext uri="{FF2B5EF4-FFF2-40B4-BE49-F238E27FC236}">
-                <a16:creationId xmlns:a16="http://schemas.microsoft.com/office/drawing/2014/main" id="{8848A425-A76F-4A7D-AE69-2C06A062B2F3}"/>
+                <a16:creationId xmlns:a16="http://schemas.microsoft.com/office/drawing/2014/main" id="{04ADFDA8-7320-483C-AFE8-997B243CD786}"/>
               </a:ext>
             </a:extLst>
           </p:cNvPr>
@@ -26951,7 +26951,7 @@
           <p:cNvPr id="9" name="TextBox 8">
             <a:extLst xmlns:a="http://schemas.openxmlformats.org/drawingml/2006/main">
               <a:ext uri="{FF2B5EF4-FFF2-40B4-BE49-F238E27FC236}">
-                <a16:creationId xmlns:a16="http://schemas.microsoft.com/office/drawing/2014/main" id="{4C2371DC-0C0E-4053-9F1D-40F2C1198B6D}"/>
+                <a16:creationId xmlns:a16="http://schemas.microsoft.com/office/drawing/2014/main" id="{2A0F79FF-F678-42AB-ABA9-AC95D5C8B4B9}"/>
               </a:ext>
             </a:extLst>
           </p:cNvPr>
@@ -27048,7 +27048,7 @@
           <p:cNvPr id="10" name="Rounded Rectangle 9">
             <a:extLst xmlns:a="http://schemas.openxmlformats.org/drawingml/2006/main">
               <a:ext uri="{FF2B5EF4-FFF2-40B4-BE49-F238E27FC236}">
-                <a16:creationId xmlns:a16="http://schemas.microsoft.com/office/drawing/2014/main" id="{42C19195-8D90-4E41-B84A-507A7253DF03}"/>
+                <a16:creationId xmlns:a16="http://schemas.microsoft.com/office/drawing/2014/main" id="{014BDCFF-2E00-4194-B5A0-F222F526FAC2}"/>
               </a:ext>
             </a:extLst>
           </p:cNvPr>
@@ -27105,7 +27105,7 @@
           <p:cNvPr id="11" name="TextBox 10">
             <a:extLst xmlns:a="http://schemas.openxmlformats.org/drawingml/2006/main">
               <a:ext uri="{FF2B5EF4-FFF2-40B4-BE49-F238E27FC236}">
-                <a16:creationId xmlns:a16="http://schemas.microsoft.com/office/drawing/2014/main" id="{E2822808-359D-48BA-B312-028990D67908}"/>
+                <a16:creationId xmlns:a16="http://schemas.microsoft.com/office/drawing/2014/main" id="{13EF9BBC-5C74-401C-8F66-AF29D4359149}"/>
               </a:ext>
             </a:extLst>
           </p:cNvPr>
@@ -27152,7 +27152,7 @@
           <p:cNvPr id="12" name="TextBox 11">
             <a:extLst xmlns:a="http://schemas.openxmlformats.org/drawingml/2006/main">
               <a:ext uri="{FF2B5EF4-FFF2-40B4-BE49-F238E27FC236}">
-                <a16:creationId xmlns:a16="http://schemas.microsoft.com/office/drawing/2014/main" id="{E04A6B22-2B82-4E60-A607-6C2E7229664E}"/>
+                <a16:creationId xmlns:a16="http://schemas.microsoft.com/office/drawing/2014/main" id="{827F02F9-789A-4AED-BCE4-289A1844E477}"/>
               </a:ext>
             </a:extLst>
           </p:cNvPr>
@@ -27197,7 +27197,7 @@
     </p:spTree>
     <p:extLst>
       <p:ext uri="{BB962C8B-B14F-4D97-AF65-F5344CB8AC3E}">
-        <p14:creationId xmlns:p14="http://schemas.microsoft.com/office/powerpoint/2010/main" val="894064853"/>
+        <p14:creationId xmlns:p14="http://schemas.microsoft.com/office/powerpoint/2010/main" val="1619892357"/>
       </p:ext>
     </p:extLst>
   </p:cSld>
@@ -27221,7 +27221,7 @@
           <p:cNvPr id="2" name="TextBox 1">
             <a:extLst xmlns:a="http://schemas.openxmlformats.org/drawingml/2006/main">
               <a:ext uri="{FF2B5EF4-FFF2-40B4-BE49-F238E27FC236}">
-                <a16:creationId xmlns:a16="http://schemas.microsoft.com/office/drawing/2014/main" id="{2FB7B651-1020-41E9-91CE-0FE90FC52E62}"/>
+                <a16:creationId xmlns:a16="http://schemas.microsoft.com/office/drawing/2014/main" id="{E2C60E80-6F04-43E4-83E6-CBB525FF80C4}"/>
               </a:ext>
             </a:extLst>
           </p:cNvPr>
@@ -27268,7 +27268,7 @@
           <p:cNvPr id="3" name="TextBox 2">
             <a:extLst xmlns:a="http://schemas.openxmlformats.org/drawingml/2006/main">
               <a:ext uri="{FF2B5EF4-FFF2-40B4-BE49-F238E27FC236}">
-                <a16:creationId xmlns:a16="http://schemas.microsoft.com/office/drawing/2014/main" id="{F214A4FB-446E-43C0-BA22-1487A2BB6E04}"/>
+                <a16:creationId xmlns:a16="http://schemas.microsoft.com/office/drawing/2014/main" id="{5ACE98B9-4016-4C2B-9B05-B7C39337E8A2}"/>
               </a:ext>
             </a:extLst>
           </p:cNvPr>
@@ -27315,7 +27315,7 @@
           <p:cNvPr id="4" name="Rectangle 3">
             <a:extLst xmlns:a="http://schemas.openxmlformats.org/drawingml/2006/main">
               <a:ext uri="{FF2B5EF4-FFF2-40B4-BE49-F238E27FC236}">
-                <a16:creationId xmlns:a16="http://schemas.microsoft.com/office/drawing/2014/main" id="{2F5F6A12-C56C-4F04-9374-25BCEA2B17A5}"/>
+                <a16:creationId xmlns:a16="http://schemas.microsoft.com/office/drawing/2014/main" id="{73D715AA-D4B1-4791-AC38-1A3D5778CB41}"/>
               </a:ext>
             </a:extLst>
           </p:cNvPr>
@@ -27370,7 +27370,7 @@
           <p:cNvPr id="5" name="Rectangle 4">
             <a:extLst xmlns:a="http://schemas.openxmlformats.org/drawingml/2006/main">
               <a:ext uri="{FF2B5EF4-FFF2-40B4-BE49-F238E27FC236}">
-                <a16:creationId xmlns:a16="http://schemas.microsoft.com/office/drawing/2014/main" id="{D662D643-90D7-40E5-97EA-4260B64A490A}"/>
+                <a16:creationId xmlns:a16="http://schemas.microsoft.com/office/drawing/2014/main" id="{EAE76652-6AA8-40C8-AC6B-213CEC1398F9}"/>
               </a:ext>
             </a:extLst>
           </p:cNvPr>
@@ -27425,7 +27425,7 @@
           <p:cNvPr id="6" name="TextBox 5">
             <a:extLst xmlns:a="http://schemas.openxmlformats.org/drawingml/2006/main">
               <a:ext uri="{FF2B5EF4-FFF2-40B4-BE49-F238E27FC236}">
-                <a16:creationId xmlns:a16="http://schemas.microsoft.com/office/drawing/2014/main" id="{B4067EC8-2395-47A3-82B5-B338937A1367}"/>
+                <a16:creationId xmlns:a16="http://schemas.microsoft.com/office/drawing/2014/main" id="{A9DD5EDA-AEFF-483D-8B88-72843F8A593C}"/>
               </a:ext>
             </a:extLst>
           </p:cNvPr>
@@ -27462,7 +27462,7 @@
                 <a:ea typeface="Aptos"/>
                 <a:cs typeface="Aptos"/>
               </a:rPr>
-              <a:t>Independent public evidence summary · 2026.07.22-8 · 2026-07-22 · Sources: EP3032975B2</a:t>
+              <a:t>Independent public evidence summary · 2026.07.22-9 · 2026-07-22 · Sources: EP3032975B2</a:t>
             </a:r>
           </a:p>
         </p:txBody>
@@ -27472,7 +27472,7 @@
           <p:cNvPr id="7" name="TextBox 6">
             <a:extLst xmlns:a="http://schemas.openxmlformats.org/drawingml/2006/main">
               <a:ext uri="{FF2B5EF4-FFF2-40B4-BE49-F238E27FC236}">
-                <a16:creationId xmlns:a16="http://schemas.microsoft.com/office/drawing/2014/main" id="{3B7AD425-CF41-4C54-AB36-AEE2B527F594}"/>
+                <a16:creationId xmlns:a16="http://schemas.microsoft.com/office/drawing/2014/main" id="{36641539-268B-4B36-AA60-8F2E7EC77B31}"/>
               </a:ext>
             </a:extLst>
           </p:cNvPr>
@@ -27519,7 +27519,7 @@
           <p:cNvPr id="8" name="TextBox 7">
             <a:extLst xmlns:a="http://schemas.openxmlformats.org/drawingml/2006/main">
               <a:ext uri="{FF2B5EF4-FFF2-40B4-BE49-F238E27FC236}">
-                <a16:creationId xmlns:a16="http://schemas.microsoft.com/office/drawing/2014/main" id="{813AD58E-B12E-4DF8-9BF2-9C2D001FE57B}"/>
+                <a16:creationId xmlns:a16="http://schemas.microsoft.com/office/drawing/2014/main" id="{4925BA15-DA98-4F04-BE7F-7E7173CBDEB3}"/>
               </a:ext>
             </a:extLst>
           </p:cNvPr>
@@ -27566,7 +27566,7 @@
           <p:cNvPr id="9" name="TextBox 8">
             <a:extLst xmlns:a="http://schemas.openxmlformats.org/drawingml/2006/main">
               <a:ext uri="{FF2B5EF4-FFF2-40B4-BE49-F238E27FC236}">
-                <a16:creationId xmlns:a16="http://schemas.microsoft.com/office/drawing/2014/main" id="{C5543AFB-39A2-467F-B91F-4BB345B81245}"/>
+                <a16:creationId xmlns:a16="http://schemas.microsoft.com/office/drawing/2014/main" id="{3FFA6CC8-8790-4A11-939C-AEA994886250}"/>
               </a:ext>
             </a:extLst>
           </p:cNvPr>
@@ -27663,7 +27663,7 @@
           <p:cNvPr id="10" name="Rounded Rectangle 9">
             <a:extLst xmlns:a="http://schemas.openxmlformats.org/drawingml/2006/main">
               <a:ext uri="{FF2B5EF4-FFF2-40B4-BE49-F238E27FC236}">
-                <a16:creationId xmlns:a16="http://schemas.microsoft.com/office/drawing/2014/main" id="{3071DA8E-5599-4DD2-937F-AD5E7D0C328B}"/>
+                <a16:creationId xmlns:a16="http://schemas.microsoft.com/office/drawing/2014/main" id="{C08CDB56-E939-4BF9-8555-EA0BC1556929}"/>
               </a:ext>
             </a:extLst>
           </p:cNvPr>
@@ -27720,7 +27720,7 @@
           <p:cNvPr id="11" name="TextBox 10">
             <a:extLst xmlns:a="http://schemas.openxmlformats.org/drawingml/2006/main">
               <a:ext uri="{FF2B5EF4-FFF2-40B4-BE49-F238E27FC236}">
-                <a16:creationId xmlns:a16="http://schemas.microsoft.com/office/drawing/2014/main" id="{EBF92752-A926-49A5-BB23-EFD232464CA9}"/>
+                <a16:creationId xmlns:a16="http://schemas.microsoft.com/office/drawing/2014/main" id="{1C344D4D-296E-432E-BBA2-03F99C3011D7}"/>
               </a:ext>
             </a:extLst>
           </p:cNvPr>
@@ -27767,7 +27767,7 @@
           <p:cNvPr id="12" name="TextBox 11">
             <a:extLst xmlns:a="http://schemas.openxmlformats.org/drawingml/2006/main">
               <a:ext uri="{FF2B5EF4-FFF2-40B4-BE49-F238E27FC236}">
-                <a16:creationId xmlns:a16="http://schemas.microsoft.com/office/drawing/2014/main" id="{A75C6931-EE28-4B6D-B4FC-49FD8D55296E}"/>
+                <a16:creationId xmlns:a16="http://schemas.microsoft.com/office/drawing/2014/main" id="{7AC936B5-CB92-49D9-A5D9-6090423D9FF0}"/>
               </a:ext>
             </a:extLst>
           </p:cNvPr>
@@ -27812,7 +27812,7 @@
     </p:spTree>
     <p:extLst>
       <p:ext uri="{BB962C8B-B14F-4D97-AF65-F5344CB8AC3E}">
-        <p14:creationId xmlns:p14="http://schemas.microsoft.com/office/powerpoint/2010/main" val="328853594"/>
+        <p14:creationId xmlns:p14="http://schemas.microsoft.com/office/powerpoint/2010/main" val="1511580907"/>
       </p:ext>
     </p:extLst>
   </p:cSld>
@@ -27836,7 +27836,7 @@
           <p:cNvPr id="2" name="TextBox 1">
             <a:extLst xmlns:a="http://schemas.openxmlformats.org/drawingml/2006/main">
               <a:ext uri="{FF2B5EF4-FFF2-40B4-BE49-F238E27FC236}">
-                <a16:creationId xmlns:a16="http://schemas.microsoft.com/office/drawing/2014/main" id="{F7B7248C-A747-4BAE-AE2D-DCA6EBFE8524}"/>
+                <a16:creationId xmlns:a16="http://schemas.microsoft.com/office/drawing/2014/main" id="{3281E17B-9B76-4F46-8F4E-3288172D998A}"/>
               </a:ext>
             </a:extLst>
           </p:cNvPr>
@@ -27883,7 +27883,7 @@
           <p:cNvPr id="3" name="TextBox 2">
             <a:extLst xmlns:a="http://schemas.openxmlformats.org/drawingml/2006/main">
               <a:ext uri="{FF2B5EF4-FFF2-40B4-BE49-F238E27FC236}">
-                <a16:creationId xmlns:a16="http://schemas.microsoft.com/office/drawing/2014/main" id="{D4189F40-93D1-425C-B384-3EAC6DC36091}"/>
+                <a16:creationId xmlns:a16="http://schemas.microsoft.com/office/drawing/2014/main" id="{02D5FA6C-B583-4E10-9ADF-222623D40754}"/>
               </a:ext>
             </a:extLst>
           </p:cNvPr>
@@ -27930,7 +27930,7 @@
           <p:cNvPr id="4" name="Rectangle 3">
             <a:extLst xmlns:a="http://schemas.openxmlformats.org/drawingml/2006/main">
               <a:ext uri="{FF2B5EF4-FFF2-40B4-BE49-F238E27FC236}">
-                <a16:creationId xmlns:a16="http://schemas.microsoft.com/office/drawing/2014/main" id="{6CD0C8D4-C87C-4561-A685-C06F682F9180}"/>
+                <a16:creationId xmlns:a16="http://schemas.microsoft.com/office/drawing/2014/main" id="{276B9391-C8E3-452D-BD11-727FF1A5DA0F}"/>
               </a:ext>
             </a:extLst>
           </p:cNvPr>
@@ -27985,7 +27985,7 @@
           <p:cNvPr id="5" name="Rectangle 4">
             <a:extLst xmlns:a="http://schemas.openxmlformats.org/drawingml/2006/main">
               <a:ext uri="{FF2B5EF4-FFF2-40B4-BE49-F238E27FC236}">
-                <a16:creationId xmlns:a16="http://schemas.microsoft.com/office/drawing/2014/main" id="{6FEBEA15-89B8-4EBC-8333-CF9243C7C737}"/>
+                <a16:creationId xmlns:a16="http://schemas.microsoft.com/office/drawing/2014/main" id="{BE818B6A-536B-445F-B103-DA7DD47FE2C2}"/>
               </a:ext>
             </a:extLst>
           </p:cNvPr>
@@ -28040,7 +28040,7 @@
           <p:cNvPr id="6" name="TextBox 5">
             <a:extLst xmlns:a="http://schemas.openxmlformats.org/drawingml/2006/main">
               <a:ext uri="{FF2B5EF4-FFF2-40B4-BE49-F238E27FC236}">
-                <a16:creationId xmlns:a16="http://schemas.microsoft.com/office/drawing/2014/main" id="{68A5A2D8-2684-470A-8BC8-FE7153928DB3}"/>
+                <a16:creationId xmlns:a16="http://schemas.microsoft.com/office/drawing/2014/main" id="{01AFCE20-A5F5-4206-9377-C90EE873E025}"/>
               </a:ext>
             </a:extLst>
           </p:cNvPr>
@@ -28077,7 +28077,7 @@
                 <a:ea typeface="Aptos"/>
                 <a:cs typeface="Aptos"/>
               </a:rPr>
-              <a:t>Independent public evidence summary · 2026.07.22-8 · 2026-07-22 · Sources: EP3032975B2</a:t>
+              <a:t>Independent public evidence summary · 2026.07.22-9 · 2026-07-22 · Sources: EP3032975B2</a:t>
             </a:r>
           </a:p>
         </p:txBody>
@@ -28087,7 +28087,7 @@
           <p:cNvPr id="7" name="TextBox 6">
             <a:extLst xmlns:a="http://schemas.openxmlformats.org/drawingml/2006/main">
               <a:ext uri="{FF2B5EF4-FFF2-40B4-BE49-F238E27FC236}">
-                <a16:creationId xmlns:a16="http://schemas.microsoft.com/office/drawing/2014/main" id="{E941D4CC-3F37-420C-AB1E-DE4C55CAC788}"/>
+                <a16:creationId xmlns:a16="http://schemas.microsoft.com/office/drawing/2014/main" id="{8F40E579-2118-4AE1-B5B6-C0653EA82460}"/>
               </a:ext>
             </a:extLst>
           </p:cNvPr>
@@ -28657,7 +28657,7 @@
           <p:cNvPr id="9" name="TextBox 8">
             <a:extLst xmlns:a="http://schemas.openxmlformats.org/drawingml/2006/main">
               <a:ext uri="{FF2B5EF4-FFF2-40B4-BE49-F238E27FC236}">
-                <a16:creationId xmlns:a16="http://schemas.microsoft.com/office/drawing/2014/main" id="{C3F68360-DFC5-46BB-816A-FA12A3166C92}"/>
+                <a16:creationId xmlns:a16="http://schemas.microsoft.com/office/drawing/2014/main" id="{2FDB45C9-76B8-47F7-BDA0-AE76C75DF389}"/>
               </a:ext>
             </a:extLst>
           </p:cNvPr>
@@ -28702,7 +28702,7 @@
     </p:spTree>
     <p:extLst>
       <p:ext uri="{BB962C8B-B14F-4D97-AF65-F5344CB8AC3E}">
-        <p14:creationId xmlns:p14="http://schemas.microsoft.com/office/powerpoint/2010/main" val="1019217459"/>
+        <p14:creationId xmlns:p14="http://schemas.microsoft.com/office/powerpoint/2010/main" val="191392355"/>
       </p:ext>
     </p:extLst>
   </p:cSld>
@@ -28726,7 +28726,7 @@
           <p:cNvPr id="2" name="TextBox 1">
             <a:extLst xmlns:a="http://schemas.openxmlformats.org/drawingml/2006/main">
               <a:ext uri="{FF2B5EF4-FFF2-40B4-BE49-F238E27FC236}">
-                <a16:creationId xmlns:a16="http://schemas.microsoft.com/office/drawing/2014/main" id="{68FB185D-3D88-4F05-B803-00E18BFC63EC}"/>
+                <a16:creationId xmlns:a16="http://schemas.microsoft.com/office/drawing/2014/main" id="{4B463AD2-7E2E-4157-ADFD-F299D24D7188}"/>
               </a:ext>
             </a:extLst>
           </p:cNvPr>
@@ -28773,7 +28773,7 @@
           <p:cNvPr id="3" name="TextBox 2">
             <a:extLst xmlns:a="http://schemas.openxmlformats.org/drawingml/2006/main">
               <a:ext uri="{FF2B5EF4-FFF2-40B4-BE49-F238E27FC236}">
-                <a16:creationId xmlns:a16="http://schemas.microsoft.com/office/drawing/2014/main" id="{5C467872-A2FE-47D2-9B01-80E1C9EA1AD6}"/>
+                <a16:creationId xmlns:a16="http://schemas.microsoft.com/office/drawing/2014/main" id="{070B91EC-48D3-406A-A910-727B9B2C5EB2}"/>
               </a:ext>
             </a:extLst>
           </p:cNvPr>
@@ -28820,7 +28820,7 @@
           <p:cNvPr id="4" name="Rectangle 3">
             <a:extLst xmlns:a="http://schemas.openxmlformats.org/drawingml/2006/main">
               <a:ext uri="{FF2B5EF4-FFF2-40B4-BE49-F238E27FC236}">
-                <a16:creationId xmlns:a16="http://schemas.microsoft.com/office/drawing/2014/main" id="{7E5C6F3D-68C8-42D0-9EFC-CF296B2B6B7F}"/>
+                <a16:creationId xmlns:a16="http://schemas.microsoft.com/office/drawing/2014/main" id="{F21AF8F7-985C-4394-8C56-E0A07AD8C7A0}"/>
               </a:ext>
             </a:extLst>
           </p:cNvPr>
@@ -28875,7 +28875,7 @@
           <p:cNvPr id="5" name="Rectangle 4">
             <a:extLst xmlns:a="http://schemas.openxmlformats.org/drawingml/2006/main">
               <a:ext uri="{FF2B5EF4-FFF2-40B4-BE49-F238E27FC236}">
-                <a16:creationId xmlns:a16="http://schemas.microsoft.com/office/drawing/2014/main" id="{9A66CDA3-1792-40E6-80C3-9967BB59D45F}"/>
+                <a16:creationId xmlns:a16="http://schemas.microsoft.com/office/drawing/2014/main" id="{7E4098A7-BA03-4FA5-A052-F2C59E9BB68A}"/>
               </a:ext>
             </a:extLst>
           </p:cNvPr>
@@ -28930,7 +28930,7 @@
           <p:cNvPr id="6" name="TextBox 5">
             <a:extLst xmlns:a="http://schemas.openxmlformats.org/drawingml/2006/main">
               <a:ext uri="{FF2B5EF4-FFF2-40B4-BE49-F238E27FC236}">
-                <a16:creationId xmlns:a16="http://schemas.microsoft.com/office/drawing/2014/main" id="{0DD6EBBC-ACA5-4E0A-BA27-FB0B8B8E9121}"/>
+                <a16:creationId xmlns:a16="http://schemas.microsoft.com/office/drawing/2014/main" id="{4B7D0F1D-7E41-44DC-BBD0-17C20A46FB77}"/>
               </a:ext>
             </a:extLst>
           </p:cNvPr>
@@ -28967,7 +28967,7 @@
                 <a:ea typeface="Aptos"/>
                 <a:cs typeface="Aptos"/>
               </a:rPr>
-              <a:t>Independent public evidence summary · 2026.07.22-8 · 2026-07-22 · Sources: EPO Register; B2</a:t>
+              <a:t>Independent public evidence summary · 2026.07.22-9 · 2026-07-22 · Sources: EPO Register; B2</a:t>
             </a:r>
           </a:p>
         </p:txBody>
@@ -28977,7 +28977,7 @@
           <p:cNvPr id="7" name="TextBox 6">
             <a:extLst xmlns:a="http://schemas.openxmlformats.org/drawingml/2006/main">
               <a:ext uri="{FF2B5EF4-FFF2-40B4-BE49-F238E27FC236}">
-                <a16:creationId xmlns:a16="http://schemas.microsoft.com/office/drawing/2014/main" id="{72A78975-7507-48FB-AAFA-00913B362FF7}"/>
+                <a16:creationId xmlns:a16="http://schemas.microsoft.com/office/drawing/2014/main" id="{F4B02055-68FF-44C5-BCFC-4A5C5348702A}"/>
               </a:ext>
             </a:extLst>
           </p:cNvPr>
@@ -29024,7 +29024,7 @@
           <p:cNvPr id="8" name="Rounded Rectangle 7">
             <a:extLst xmlns:a="http://schemas.openxmlformats.org/drawingml/2006/main">
               <a:ext uri="{FF2B5EF4-FFF2-40B4-BE49-F238E27FC236}">
-                <a16:creationId xmlns:a16="http://schemas.microsoft.com/office/drawing/2014/main" id="{0D1FF03D-325A-44A9-80E8-E45EA86416BF}"/>
+                <a16:creationId xmlns:a16="http://schemas.microsoft.com/office/drawing/2014/main" id="{E5FF2D78-BE65-4960-9FEE-BE04CAD85056}"/>
               </a:ext>
             </a:extLst>
           </p:cNvPr>
@@ -29081,7 +29081,7 @@
           <p:cNvPr id="9" name="TextBox 8">
             <a:extLst xmlns:a="http://schemas.openxmlformats.org/drawingml/2006/main">
               <a:ext uri="{FF2B5EF4-FFF2-40B4-BE49-F238E27FC236}">
-                <a16:creationId xmlns:a16="http://schemas.microsoft.com/office/drawing/2014/main" id="{D6458468-F078-44E4-BC8C-AD902E79063D}"/>
+                <a16:creationId xmlns:a16="http://schemas.microsoft.com/office/drawing/2014/main" id="{F79D9F95-1EA6-4217-8D7A-2808CAE3B93C}"/>
               </a:ext>
             </a:extLst>
           </p:cNvPr>
@@ -29128,7 +29128,7 @@
           <p:cNvPr id="10" name="TextBox 9">
             <a:extLst xmlns:a="http://schemas.openxmlformats.org/drawingml/2006/main">
               <a:ext uri="{FF2B5EF4-FFF2-40B4-BE49-F238E27FC236}">
-                <a16:creationId xmlns:a16="http://schemas.microsoft.com/office/drawing/2014/main" id="{B1E04001-B602-49EB-AA8A-AB3BF6CA2EE7}"/>
+                <a16:creationId xmlns:a16="http://schemas.microsoft.com/office/drawing/2014/main" id="{D41BF304-D417-42CE-8DE8-0EAC2898CD83}"/>
               </a:ext>
             </a:extLst>
           </p:cNvPr>
@@ -29175,7 +29175,7 @@
           <p:cNvPr id="11" name="Rounded Rectangle 10">
             <a:extLst xmlns:a="http://schemas.openxmlformats.org/drawingml/2006/main">
               <a:ext uri="{FF2B5EF4-FFF2-40B4-BE49-F238E27FC236}">
-                <a16:creationId xmlns:a16="http://schemas.microsoft.com/office/drawing/2014/main" id="{CD97C715-1712-4108-ACB4-8DE4F68A9A56}"/>
+                <a16:creationId xmlns:a16="http://schemas.microsoft.com/office/drawing/2014/main" id="{9723800E-07FE-4864-8BB9-F6D32CBBFA30}"/>
               </a:ext>
             </a:extLst>
           </p:cNvPr>
@@ -29232,7 +29232,7 @@
           <p:cNvPr id="12" name="TextBox 11">
             <a:extLst xmlns:a="http://schemas.openxmlformats.org/drawingml/2006/main">
               <a:ext uri="{FF2B5EF4-FFF2-40B4-BE49-F238E27FC236}">
-                <a16:creationId xmlns:a16="http://schemas.microsoft.com/office/drawing/2014/main" id="{18ACADBA-0C55-4EE0-ABA7-94C6502BF0C2}"/>
+                <a16:creationId xmlns:a16="http://schemas.microsoft.com/office/drawing/2014/main" id="{7D511301-AB35-49B9-9E6E-CF261081D997}"/>
               </a:ext>
             </a:extLst>
           </p:cNvPr>
@@ -29279,7 +29279,7 @@
           <p:cNvPr id="13" name="TextBox 12">
             <a:extLst xmlns:a="http://schemas.openxmlformats.org/drawingml/2006/main">
               <a:ext uri="{FF2B5EF4-FFF2-40B4-BE49-F238E27FC236}">
-                <a16:creationId xmlns:a16="http://schemas.microsoft.com/office/drawing/2014/main" id="{1BD3C2EE-EA55-4A38-82D2-DB74E52D2C03}"/>
+                <a16:creationId xmlns:a16="http://schemas.microsoft.com/office/drawing/2014/main" id="{2FC34DF0-D788-419E-BFF2-41BFE59DAD24}"/>
               </a:ext>
             </a:extLst>
           </p:cNvPr>
@@ -29326,7 +29326,7 @@
           <p:cNvPr id="14" name="Rounded Rectangle 13">
             <a:extLst xmlns:a="http://schemas.openxmlformats.org/drawingml/2006/main">
               <a:ext uri="{FF2B5EF4-FFF2-40B4-BE49-F238E27FC236}">
-                <a16:creationId xmlns:a16="http://schemas.microsoft.com/office/drawing/2014/main" id="{A75D936A-061F-48AE-B339-3B9352A48A0C}"/>
+                <a16:creationId xmlns:a16="http://schemas.microsoft.com/office/drawing/2014/main" id="{67E3D468-32BE-4054-AD7A-9FE70008FEF4}"/>
               </a:ext>
             </a:extLst>
           </p:cNvPr>
@@ -29383,7 +29383,7 @@
           <p:cNvPr id="15" name="TextBox 14">
             <a:extLst xmlns:a="http://schemas.openxmlformats.org/drawingml/2006/main">
               <a:ext uri="{FF2B5EF4-FFF2-40B4-BE49-F238E27FC236}">
-                <a16:creationId xmlns:a16="http://schemas.microsoft.com/office/drawing/2014/main" id="{1FABE12B-D7C1-4ACB-9F92-16C428326F2F}"/>
+                <a16:creationId xmlns:a16="http://schemas.microsoft.com/office/drawing/2014/main" id="{4465B154-EC09-4284-9B02-7227BF456F39}"/>
               </a:ext>
             </a:extLst>
           </p:cNvPr>
@@ -29430,7 +29430,7 @@
           <p:cNvPr id="16" name="TextBox 15">
             <a:extLst xmlns:a="http://schemas.openxmlformats.org/drawingml/2006/main">
               <a:ext uri="{FF2B5EF4-FFF2-40B4-BE49-F238E27FC236}">
-                <a16:creationId xmlns:a16="http://schemas.microsoft.com/office/drawing/2014/main" id="{8685AE99-3B7D-432E-BFBA-EB43010B0FC5}"/>
+                <a16:creationId xmlns:a16="http://schemas.microsoft.com/office/drawing/2014/main" id="{5A943CF4-476B-45C0-A5C5-AA841F28722E}"/>
               </a:ext>
             </a:extLst>
           </p:cNvPr>
@@ -29477,7 +29477,7 @@
           <p:cNvPr id="17" name="TextBox 16">
             <a:extLst xmlns:a="http://schemas.openxmlformats.org/drawingml/2006/main">
               <a:ext uri="{FF2B5EF4-FFF2-40B4-BE49-F238E27FC236}">
-                <a16:creationId xmlns:a16="http://schemas.microsoft.com/office/drawing/2014/main" id="{CA244EEA-8A33-4DFB-9697-5A957206984D}"/>
+                <a16:creationId xmlns:a16="http://schemas.microsoft.com/office/drawing/2014/main" id="{1CDA29A9-0755-4767-8098-AA218A3A9EA1}"/>
               </a:ext>
             </a:extLst>
           </p:cNvPr>
@@ -29524,7 +29524,7 @@
           <p:cNvPr id="18" name="Rounded Rectangle 17">
             <a:extLst xmlns:a="http://schemas.openxmlformats.org/drawingml/2006/main">
               <a:ext uri="{FF2B5EF4-FFF2-40B4-BE49-F238E27FC236}">
-                <a16:creationId xmlns:a16="http://schemas.microsoft.com/office/drawing/2014/main" id="{279B632A-A8B1-4B38-A344-B69935ED46EE}"/>
+                <a16:creationId xmlns:a16="http://schemas.microsoft.com/office/drawing/2014/main" id="{03E3708C-C153-45E3-9BFF-39E9A3A632F9}"/>
               </a:ext>
             </a:extLst>
           </p:cNvPr>
@@ -29581,7 +29581,7 @@
           <p:cNvPr id="19" name="TextBox 18">
             <a:extLst xmlns:a="http://schemas.openxmlformats.org/drawingml/2006/main">
               <a:ext uri="{FF2B5EF4-FFF2-40B4-BE49-F238E27FC236}">
-                <a16:creationId xmlns:a16="http://schemas.microsoft.com/office/drawing/2014/main" id="{FCAB1C89-C141-4273-BC1E-38B919B2E2EF}"/>
+                <a16:creationId xmlns:a16="http://schemas.microsoft.com/office/drawing/2014/main" id="{CA51478F-2DFC-435F-B782-260D0A219B32}"/>
               </a:ext>
             </a:extLst>
           </p:cNvPr>
@@ -29628,7 +29628,7 @@
           <p:cNvPr id="20" name="TextBox 19">
             <a:extLst xmlns:a="http://schemas.openxmlformats.org/drawingml/2006/main">
               <a:ext uri="{FF2B5EF4-FFF2-40B4-BE49-F238E27FC236}">
-                <a16:creationId xmlns:a16="http://schemas.microsoft.com/office/drawing/2014/main" id="{C1F2D772-82B4-444E-841F-8F15C3C1E23C}"/>
+                <a16:creationId xmlns:a16="http://schemas.microsoft.com/office/drawing/2014/main" id="{6EFD916A-A32F-4A83-98CD-7F95741E66B1}"/>
               </a:ext>
             </a:extLst>
           </p:cNvPr>
@@ -29673,7 +29673,7 @@
     </p:spTree>
     <p:extLst>
       <p:ext uri="{BB962C8B-B14F-4D97-AF65-F5344CB8AC3E}">
-        <p14:creationId xmlns:p14="http://schemas.microsoft.com/office/powerpoint/2010/main" val="1775246988"/>
+        <p14:creationId xmlns:p14="http://schemas.microsoft.com/office/powerpoint/2010/main" val="1502881297"/>
       </p:ext>
     </p:extLst>
   </p:cSld>
@@ -29697,7 +29697,7 @@
           <p:cNvPr id="2" name="TextBox 1">
             <a:extLst xmlns:a="http://schemas.openxmlformats.org/drawingml/2006/main">
               <a:ext uri="{FF2B5EF4-FFF2-40B4-BE49-F238E27FC236}">
-                <a16:creationId xmlns:a16="http://schemas.microsoft.com/office/drawing/2014/main" id="{DBCDC484-70BA-44F4-9663-BB0941872737}"/>
+                <a16:creationId xmlns:a16="http://schemas.microsoft.com/office/drawing/2014/main" id="{1F85C460-0FC9-475A-BEFD-91CDFEE6C42C}"/>
               </a:ext>
             </a:extLst>
           </p:cNvPr>
@@ -29744,7 +29744,7 @@
           <p:cNvPr id="3" name="TextBox 2">
             <a:extLst xmlns:a="http://schemas.openxmlformats.org/drawingml/2006/main">
               <a:ext uri="{FF2B5EF4-FFF2-40B4-BE49-F238E27FC236}">
-                <a16:creationId xmlns:a16="http://schemas.microsoft.com/office/drawing/2014/main" id="{FD2C593D-62C5-482E-B406-27876913224D}"/>
+                <a16:creationId xmlns:a16="http://schemas.microsoft.com/office/drawing/2014/main" id="{5BACA264-B47E-46A4-8E7A-42B53BD30190}"/>
               </a:ext>
             </a:extLst>
           </p:cNvPr>
@@ -29791,7 +29791,7 @@
           <p:cNvPr id="4" name="Rectangle 3">
             <a:extLst xmlns:a="http://schemas.openxmlformats.org/drawingml/2006/main">
               <a:ext uri="{FF2B5EF4-FFF2-40B4-BE49-F238E27FC236}">
-                <a16:creationId xmlns:a16="http://schemas.microsoft.com/office/drawing/2014/main" id="{DF10CF91-9B9C-4CED-B24B-4F18B495975A}"/>
+                <a16:creationId xmlns:a16="http://schemas.microsoft.com/office/drawing/2014/main" id="{3D986817-AC15-4D81-9DA2-BCE9D737EA68}"/>
               </a:ext>
             </a:extLst>
           </p:cNvPr>
@@ -29846,7 +29846,7 @@
           <p:cNvPr id="5" name="Rectangle 4">
             <a:extLst xmlns:a="http://schemas.openxmlformats.org/drawingml/2006/main">
               <a:ext uri="{FF2B5EF4-FFF2-40B4-BE49-F238E27FC236}">
-                <a16:creationId xmlns:a16="http://schemas.microsoft.com/office/drawing/2014/main" id="{DDCBE4A4-F9A0-4C2C-8E5E-31BCB05BA2A5}"/>
+                <a16:creationId xmlns:a16="http://schemas.microsoft.com/office/drawing/2014/main" id="{1FA7DF14-4866-409B-BA7C-CFAA47207720}"/>
               </a:ext>
             </a:extLst>
           </p:cNvPr>
@@ -29901,7 +29901,7 @@
           <p:cNvPr id="6" name="TextBox 5">
             <a:extLst xmlns:a="http://schemas.openxmlformats.org/drawingml/2006/main">
               <a:ext uri="{FF2B5EF4-FFF2-40B4-BE49-F238E27FC236}">
-                <a16:creationId xmlns:a16="http://schemas.microsoft.com/office/drawing/2014/main" id="{26C6F1A0-8497-4FBF-A0FB-E290E8407AFE}"/>
+                <a16:creationId xmlns:a16="http://schemas.microsoft.com/office/drawing/2014/main" id="{BCB5B9D5-AACA-4CB7-9B53-5F6DF15E1756}"/>
               </a:ext>
             </a:extLst>
           </p:cNvPr>
@@ -29938,7 +29938,7 @@
                 <a:ea typeface="Aptos"/>
                 <a:cs typeface="Aptos"/>
               </a:rPr>
-              <a:t>Independent public evidence summary · 2026.07.22-8 · 2026-07-22 · Sources: EPO family; national registers</a:t>
+              <a:t>Independent public evidence summary · 2026.07.22-9 · 2026-07-22 · Sources: EPO family; national registers</a:t>
             </a:r>
           </a:p>
         </p:txBody>
@@ -29948,7 +29948,7 @@
           <p:cNvPr id="7" name="TextBox 6">
             <a:extLst xmlns:a="http://schemas.openxmlformats.org/drawingml/2006/main">
               <a:ext uri="{FF2B5EF4-FFF2-40B4-BE49-F238E27FC236}">
-                <a16:creationId xmlns:a16="http://schemas.microsoft.com/office/drawing/2014/main" id="{35CD3847-85D5-4AB7-AE48-D300E45A6CAB}"/>
+                <a16:creationId xmlns:a16="http://schemas.microsoft.com/office/drawing/2014/main" id="{CF3E946A-196F-466F-A998-DAE328B13429}"/>
               </a:ext>
             </a:extLst>
           </p:cNvPr>
@@ -29995,7 +29995,7 @@
           <p:cNvPr id="8" name="Rounded Rectangle 7">
             <a:extLst xmlns:a="http://schemas.openxmlformats.org/drawingml/2006/main">
               <a:ext uri="{FF2B5EF4-FFF2-40B4-BE49-F238E27FC236}">
-                <a16:creationId xmlns:a16="http://schemas.microsoft.com/office/drawing/2014/main" id="{1DF988E0-E9C9-4F20-9DA7-EB42927C4836}"/>
+                <a16:creationId xmlns:a16="http://schemas.microsoft.com/office/drawing/2014/main" id="{E354748C-E401-4C4A-B5EA-CB8CA8020DF0}"/>
               </a:ext>
             </a:extLst>
           </p:cNvPr>
@@ -30052,7 +30052,7 @@
           <p:cNvPr id="9" name="TextBox 8">
             <a:extLst xmlns:a="http://schemas.openxmlformats.org/drawingml/2006/main">
               <a:ext uri="{FF2B5EF4-FFF2-40B4-BE49-F238E27FC236}">
-                <a16:creationId xmlns:a16="http://schemas.microsoft.com/office/drawing/2014/main" id="{6D987DC6-76C2-48C2-B6DF-F26D0F040A3E}"/>
+                <a16:creationId xmlns:a16="http://schemas.microsoft.com/office/drawing/2014/main" id="{8DBA2817-ABED-43F2-ADBA-5C0C61DD282D}"/>
               </a:ext>
             </a:extLst>
           </p:cNvPr>
@@ -30099,7 +30099,7 @@
           <p:cNvPr id="10" name="TextBox 9">
             <a:extLst xmlns:a="http://schemas.openxmlformats.org/drawingml/2006/main">
               <a:ext uri="{FF2B5EF4-FFF2-40B4-BE49-F238E27FC236}">
-                <a16:creationId xmlns:a16="http://schemas.microsoft.com/office/drawing/2014/main" id="{F9800A12-319C-4962-9D0B-C4BF9F71CAB8}"/>
+                <a16:creationId xmlns:a16="http://schemas.microsoft.com/office/drawing/2014/main" id="{9A634BB8-385E-4C34-84D7-51654DE3A28A}"/>
               </a:ext>
             </a:extLst>
           </p:cNvPr>
@@ -30146,7 +30146,7 @@
           <p:cNvPr id="11" name="Rounded Rectangle 10">
             <a:extLst xmlns:a="http://schemas.openxmlformats.org/drawingml/2006/main">
               <a:ext uri="{FF2B5EF4-FFF2-40B4-BE49-F238E27FC236}">
-                <a16:creationId xmlns:a16="http://schemas.microsoft.com/office/drawing/2014/main" id="{767896F4-8F73-462A-83AB-B885421A3FF2}"/>
+                <a16:creationId xmlns:a16="http://schemas.microsoft.com/office/drawing/2014/main" id="{B9A6829C-4527-4493-9820-8293EFE1AEAC}"/>
               </a:ext>
             </a:extLst>
           </p:cNvPr>
@@ -30203,7 +30203,7 @@
           <p:cNvPr id="12" name="TextBox 11">
             <a:extLst xmlns:a="http://schemas.openxmlformats.org/drawingml/2006/main">
               <a:ext uri="{FF2B5EF4-FFF2-40B4-BE49-F238E27FC236}">
-                <a16:creationId xmlns:a16="http://schemas.microsoft.com/office/drawing/2014/main" id="{1254FA05-BABB-44BF-88F9-E5B213F05633}"/>
+                <a16:creationId xmlns:a16="http://schemas.microsoft.com/office/drawing/2014/main" id="{83EBC911-5509-483F-B4A0-FAF788BFCBDA}"/>
               </a:ext>
             </a:extLst>
           </p:cNvPr>
@@ -30250,7 +30250,7 @@
           <p:cNvPr id="13" name="TextBox 12">
             <a:extLst xmlns:a="http://schemas.openxmlformats.org/drawingml/2006/main">
               <a:ext uri="{FF2B5EF4-FFF2-40B4-BE49-F238E27FC236}">
-                <a16:creationId xmlns:a16="http://schemas.microsoft.com/office/drawing/2014/main" id="{AFB0541B-5F4E-43D0-B2B7-1C2D9F80E981}"/>
+                <a16:creationId xmlns:a16="http://schemas.microsoft.com/office/drawing/2014/main" id="{6EC47865-5C1B-432A-B2F8-CEBBE7EEB769}"/>
               </a:ext>
             </a:extLst>
           </p:cNvPr>
@@ -30297,7 +30297,7 @@
           <p:cNvPr id="14" name="Rounded Rectangle 13">
             <a:extLst xmlns:a="http://schemas.openxmlformats.org/drawingml/2006/main">
               <a:ext uri="{FF2B5EF4-FFF2-40B4-BE49-F238E27FC236}">
-                <a16:creationId xmlns:a16="http://schemas.microsoft.com/office/drawing/2014/main" id="{4391C445-6853-4211-98CE-2213D9A73320}"/>
+                <a16:creationId xmlns:a16="http://schemas.microsoft.com/office/drawing/2014/main" id="{E3155377-721A-4F72-A364-E1ED4F598827}"/>
               </a:ext>
             </a:extLst>
           </p:cNvPr>
@@ -30354,7 +30354,7 @@
           <p:cNvPr id="15" name="TextBox 14">
             <a:extLst xmlns:a="http://schemas.openxmlformats.org/drawingml/2006/main">
               <a:ext uri="{FF2B5EF4-FFF2-40B4-BE49-F238E27FC236}">
-                <a16:creationId xmlns:a16="http://schemas.microsoft.com/office/drawing/2014/main" id="{758F9BB8-D578-41A8-97CA-683AA9EDCE8A}"/>
+                <a16:creationId xmlns:a16="http://schemas.microsoft.com/office/drawing/2014/main" id="{4EBB0956-E332-47B8-A852-B92019A56E3A}"/>
               </a:ext>
             </a:extLst>
           </p:cNvPr>
@@ -30401,7 +30401,7 @@
           <p:cNvPr id="16" name="TextBox 15">
             <a:extLst xmlns:a="http://schemas.openxmlformats.org/drawingml/2006/main">
               <a:ext uri="{FF2B5EF4-FFF2-40B4-BE49-F238E27FC236}">
-                <a16:creationId xmlns:a16="http://schemas.microsoft.com/office/drawing/2014/main" id="{6C7B955E-5AC3-45BD-839E-2D40A80E1849}"/>
+                <a16:creationId xmlns:a16="http://schemas.microsoft.com/office/drawing/2014/main" id="{B607D192-AFFC-45DF-9D0C-9F31FB11F4AA}"/>
               </a:ext>
             </a:extLst>
           </p:cNvPr>
@@ -30448,7 +30448,7 @@
           <p:cNvPr id="17" name="Rounded Rectangle 16">
             <a:extLst xmlns:a="http://schemas.openxmlformats.org/drawingml/2006/main">
               <a:ext uri="{FF2B5EF4-FFF2-40B4-BE49-F238E27FC236}">
-                <a16:creationId xmlns:a16="http://schemas.microsoft.com/office/drawing/2014/main" id="{21712B5A-3125-45A9-BE59-E6CCD65ABA54}"/>
+                <a16:creationId xmlns:a16="http://schemas.microsoft.com/office/drawing/2014/main" id="{1B352597-ADE2-4DE7-A6E2-C9096A1FC01B}"/>
               </a:ext>
             </a:extLst>
           </p:cNvPr>
@@ -30505,7 +30505,7 @@
           <p:cNvPr id="18" name="TextBox 17">
             <a:extLst xmlns:a="http://schemas.openxmlformats.org/drawingml/2006/main">
               <a:ext uri="{FF2B5EF4-FFF2-40B4-BE49-F238E27FC236}">
-                <a16:creationId xmlns:a16="http://schemas.microsoft.com/office/drawing/2014/main" id="{D2576BA8-6B35-4A51-BBDA-CBA1F43A3400}"/>
+                <a16:creationId xmlns:a16="http://schemas.microsoft.com/office/drawing/2014/main" id="{6BD6BCEB-C4A1-474E-AA68-DBA0E1E82D25}"/>
               </a:ext>
             </a:extLst>
           </p:cNvPr>
@@ -30552,7 +30552,7 @@
           <p:cNvPr id="19" name="TextBox 18">
             <a:extLst xmlns:a="http://schemas.openxmlformats.org/drawingml/2006/main">
               <a:ext uri="{FF2B5EF4-FFF2-40B4-BE49-F238E27FC236}">
-                <a16:creationId xmlns:a16="http://schemas.microsoft.com/office/drawing/2014/main" id="{0EB42671-6489-4B20-ADA9-44C8FED829FB}"/>
+                <a16:creationId xmlns:a16="http://schemas.microsoft.com/office/drawing/2014/main" id="{77469775-6D7C-4887-A3EA-4C561081403F}"/>
               </a:ext>
             </a:extLst>
           </p:cNvPr>
@@ -30599,7 +30599,7 @@
           <p:cNvPr id="20" name="TextBox 19">
             <a:extLst xmlns:a="http://schemas.openxmlformats.org/drawingml/2006/main">
               <a:ext uri="{FF2B5EF4-FFF2-40B4-BE49-F238E27FC236}">
-                <a16:creationId xmlns:a16="http://schemas.microsoft.com/office/drawing/2014/main" id="{5B906517-CBE3-445A-A3D0-DA19142B5F03}"/>
+                <a16:creationId xmlns:a16="http://schemas.microsoft.com/office/drawing/2014/main" id="{98BC8E10-5F47-433F-91BE-166F28150D6B}"/>
               </a:ext>
             </a:extLst>
           </p:cNvPr>
@@ -30646,7 +30646,7 @@
           <p:cNvPr id="21" name="Rounded Rectangle 20">
             <a:extLst xmlns:a="http://schemas.openxmlformats.org/drawingml/2006/main">
               <a:ext uri="{FF2B5EF4-FFF2-40B4-BE49-F238E27FC236}">
-                <a16:creationId xmlns:a16="http://schemas.microsoft.com/office/drawing/2014/main" id="{65818A31-2EA0-47FB-AE33-0AFC178E6858}"/>
+                <a16:creationId xmlns:a16="http://schemas.microsoft.com/office/drawing/2014/main" id="{3B4C493A-6A11-4625-A17E-B8E064D9B594}"/>
               </a:ext>
             </a:extLst>
           </p:cNvPr>
@@ -30703,7 +30703,7 @@
           <p:cNvPr id="22" name="TextBox 21">
             <a:extLst xmlns:a="http://schemas.openxmlformats.org/drawingml/2006/main">
               <a:ext uri="{FF2B5EF4-FFF2-40B4-BE49-F238E27FC236}">
-                <a16:creationId xmlns:a16="http://schemas.microsoft.com/office/drawing/2014/main" id="{218D366B-9DBA-4178-B263-3A1EFA657A2C}"/>
+                <a16:creationId xmlns:a16="http://schemas.microsoft.com/office/drawing/2014/main" id="{64119EA7-164B-4C27-8B57-E68D6C572BDE}"/>
               </a:ext>
             </a:extLst>
           </p:cNvPr>
@@ -30750,7 +30750,7 @@
           <p:cNvPr id="23" name="TextBox 22">
             <a:extLst xmlns:a="http://schemas.openxmlformats.org/drawingml/2006/main">
               <a:ext uri="{FF2B5EF4-FFF2-40B4-BE49-F238E27FC236}">
-                <a16:creationId xmlns:a16="http://schemas.microsoft.com/office/drawing/2014/main" id="{AF24983B-244D-4F61-8BA2-7CA29988D386}"/>
+                <a16:creationId xmlns:a16="http://schemas.microsoft.com/office/drawing/2014/main" id="{75D54E7B-E8F0-41AD-9015-67888E8C0F3C}"/>
               </a:ext>
             </a:extLst>
           </p:cNvPr>
@@ -30795,7 +30795,7 @@
     </p:spTree>
     <p:extLst>
       <p:ext uri="{BB962C8B-B14F-4D97-AF65-F5344CB8AC3E}">
-        <p14:creationId xmlns:p14="http://schemas.microsoft.com/office/powerpoint/2010/main" val="140360122"/>
+        <p14:creationId xmlns:p14="http://schemas.microsoft.com/office/powerpoint/2010/main" val="1254853679"/>
       </p:ext>
     </p:extLst>
   </p:cSld>
@@ -30819,7 +30819,7 @@
           <p:cNvPr id="2" name="TextBox 1">
             <a:extLst xmlns:a="http://schemas.openxmlformats.org/drawingml/2006/main">
               <a:ext uri="{FF2B5EF4-FFF2-40B4-BE49-F238E27FC236}">
-                <a16:creationId xmlns:a16="http://schemas.microsoft.com/office/drawing/2014/main" id="{B0922B50-4DAC-4D18-8F3E-490A7536DB9B}"/>
+                <a16:creationId xmlns:a16="http://schemas.microsoft.com/office/drawing/2014/main" id="{1F86B18E-D37E-42D5-939C-C13C68556CC6}"/>
               </a:ext>
             </a:extLst>
           </p:cNvPr>
@@ -30866,7 +30866,7 @@
           <p:cNvPr id="3" name="TextBox 2">
             <a:extLst xmlns:a="http://schemas.openxmlformats.org/drawingml/2006/main">
               <a:ext uri="{FF2B5EF4-FFF2-40B4-BE49-F238E27FC236}">
-                <a16:creationId xmlns:a16="http://schemas.microsoft.com/office/drawing/2014/main" id="{C0382A01-B6F7-4475-9343-871181C8787B}"/>
+                <a16:creationId xmlns:a16="http://schemas.microsoft.com/office/drawing/2014/main" id="{12FC2B2F-A43C-453C-963A-6A9219B30281}"/>
               </a:ext>
             </a:extLst>
           </p:cNvPr>
@@ -30913,7 +30913,7 @@
           <p:cNvPr id="4" name="Rectangle 3">
             <a:extLst xmlns:a="http://schemas.openxmlformats.org/drawingml/2006/main">
               <a:ext uri="{FF2B5EF4-FFF2-40B4-BE49-F238E27FC236}">
-                <a16:creationId xmlns:a16="http://schemas.microsoft.com/office/drawing/2014/main" id="{E1D95E78-9CAB-4AEA-BE34-C3E085CEC1EA}"/>
+                <a16:creationId xmlns:a16="http://schemas.microsoft.com/office/drawing/2014/main" id="{4DC40BD4-F3E4-4F7C-BA26-75C97201CDD4}"/>
               </a:ext>
             </a:extLst>
           </p:cNvPr>
@@ -30968,7 +30968,7 @@
           <p:cNvPr id="5" name="Rectangle 4">
             <a:extLst xmlns:a="http://schemas.openxmlformats.org/drawingml/2006/main">
               <a:ext uri="{FF2B5EF4-FFF2-40B4-BE49-F238E27FC236}">
-                <a16:creationId xmlns:a16="http://schemas.microsoft.com/office/drawing/2014/main" id="{0B8B0468-F97E-4662-BDD0-19FA95FCEC3D}"/>
+                <a16:creationId xmlns:a16="http://schemas.microsoft.com/office/drawing/2014/main" id="{1330912F-99CD-4DAC-BF5C-14877D4F6433}"/>
               </a:ext>
             </a:extLst>
           </p:cNvPr>
@@ -31023,7 +31023,7 @@
           <p:cNvPr id="6" name="TextBox 5">
             <a:extLst xmlns:a="http://schemas.openxmlformats.org/drawingml/2006/main">
               <a:ext uri="{FF2B5EF4-FFF2-40B4-BE49-F238E27FC236}">
-                <a16:creationId xmlns:a16="http://schemas.microsoft.com/office/drawing/2014/main" id="{F2C20B36-22B2-4E63-95E4-40CBC166D8DD}"/>
+                <a16:creationId xmlns:a16="http://schemas.microsoft.com/office/drawing/2014/main" id="{C61978B0-8184-4DCC-93D1-648DC06E2D36}"/>
               </a:ext>
             </a:extLst>
           </p:cNvPr>
@@ -31060,7 +31060,7 @@
                 <a:ea typeface="Aptos"/>
                 <a:cs typeface="Aptos"/>
               </a:rPr>
-              <a:t>Independent public evidence summary · 2026.07.22-8 · 2026-07-22 · Sources: Official judgments: 8 Ni 18/24 (EP); 7 O 3341/24</a:t>
+              <a:t>Independent public evidence summary · 2026.07.22-9 · 2026-07-22 · Sources: Official judgments: 8 Ni 18/24 (EP); 7 O 3341/24</a:t>
             </a:r>
           </a:p>
         </p:txBody>
@@ -31070,7 +31070,7 @@
           <p:cNvPr id="7" name="TextBox 6">
             <a:extLst xmlns:a="http://schemas.openxmlformats.org/drawingml/2006/main">
               <a:ext uri="{FF2B5EF4-FFF2-40B4-BE49-F238E27FC236}">
-                <a16:creationId xmlns:a16="http://schemas.microsoft.com/office/drawing/2014/main" id="{2B5B9497-CACC-42B6-B012-561416600D9E}"/>
+                <a16:creationId xmlns:a16="http://schemas.microsoft.com/office/drawing/2014/main" id="{4F05FD3F-8F5E-4D4F-BD11-CCD845CB45DF}"/>
               </a:ext>
             </a:extLst>
           </p:cNvPr>
@@ -31391,7 +31391,7 @@
           <p:cNvPr id="9" name="TextBox 8">
             <a:extLst xmlns:a="http://schemas.openxmlformats.org/drawingml/2006/main">
               <a:ext uri="{FF2B5EF4-FFF2-40B4-BE49-F238E27FC236}">
-                <a16:creationId xmlns:a16="http://schemas.microsoft.com/office/drawing/2014/main" id="{B221A6FC-3B7F-4206-A2AC-2386CE3C7412}"/>
+                <a16:creationId xmlns:a16="http://schemas.microsoft.com/office/drawing/2014/main" id="{3764FEA9-9D11-4EB7-AD70-AC9C542928DB}"/>
               </a:ext>
             </a:extLst>
           </p:cNvPr>
@@ -31436,7 +31436,7 @@
     </p:spTree>
     <p:extLst>
       <p:ext uri="{BB962C8B-B14F-4D97-AF65-F5344CB8AC3E}">
-        <p14:creationId xmlns:p14="http://schemas.microsoft.com/office/powerpoint/2010/main" val="33034432"/>
+        <p14:creationId xmlns:p14="http://schemas.microsoft.com/office/powerpoint/2010/main" val="26098725"/>
       </p:ext>
     </p:extLst>
   </p:cSld>

</xml_diff>

<commit_message>
Publish privacy-safe request status v9 (#7)
Publish the privacy-safe three-sent/seventeen-draft ledger, refresh all FI/EN lender downloads, and enforce deterministic public-boundary checks.
</commit_message>
<xml_diff>
--- a/site/downloads/pixan-bank-deck-large-en.pptx
+++ b/site/downloads/pixan-bank-deck-large-en.pptx
@@ -2,42 +2,42 @@
 <file path=ppt/presentation.xml><?xml version="1.0" encoding="utf-8"?>
 <p:presentation xmlns:p="http://schemas.openxmlformats.org/presentationml/2006/main">
   <p:sldMasterIdLst>
-    <p:sldMasterId xmlns:r="http://schemas.openxmlformats.org/officeDocument/2006/relationships" id="2147483648" r:id="Rce368825e36b4fd9"/>
+    <p:sldMasterId xmlns:r="http://schemas.openxmlformats.org/officeDocument/2006/relationships" id="2147483648" r:id="R934fdd0391f64ef5"/>
   </p:sldMasterIdLst>
   <p:notesMasterIdLst>
-    <p:notesMasterId xmlns:r="http://schemas.openxmlformats.org/officeDocument/2006/relationships" r:id="R4b9fc06309fc4204"/>
+    <p:notesMasterId xmlns:r="http://schemas.openxmlformats.org/officeDocument/2006/relationships" r:id="Raefbd3c6b7bb4c49"/>
   </p:notesMasterIdLst>
   <p:sldIdLst>
-    <p:sldId xmlns:r="http://schemas.openxmlformats.org/officeDocument/2006/relationships" id="256" r:id="R5819343070634cef"/>
-    <p:sldId xmlns:r="http://schemas.openxmlformats.org/officeDocument/2006/relationships" id="257" r:id="R9d432ab0e0034038"/>
-    <p:sldId xmlns:r="http://schemas.openxmlformats.org/officeDocument/2006/relationships" id="258" r:id="R8d478dd64edb40da"/>
-    <p:sldId xmlns:r="http://schemas.openxmlformats.org/officeDocument/2006/relationships" id="259" r:id="R87025964a6a24a7d"/>
-    <p:sldId xmlns:r="http://schemas.openxmlformats.org/officeDocument/2006/relationships" id="260" r:id="R72441db936224662"/>
-    <p:sldId xmlns:r="http://schemas.openxmlformats.org/officeDocument/2006/relationships" id="261" r:id="Raa617ee634394417"/>
-    <p:sldId xmlns:r="http://schemas.openxmlformats.org/officeDocument/2006/relationships" id="262" r:id="R89eb1c3f3db24944"/>
-    <p:sldId xmlns:r="http://schemas.openxmlformats.org/officeDocument/2006/relationships" id="263" r:id="Rb235f95d3c2948f6"/>
-    <p:sldId xmlns:r="http://schemas.openxmlformats.org/officeDocument/2006/relationships" id="264" r:id="Rdf5f42d5f0e7480f"/>
-    <p:sldId xmlns:r="http://schemas.openxmlformats.org/officeDocument/2006/relationships" id="265" r:id="R6d1bc062ed034f8a"/>
-    <p:sldId xmlns:r="http://schemas.openxmlformats.org/officeDocument/2006/relationships" id="266" r:id="Rf8d60cb95d594bb1"/>
-    <p:sldId xmlns:r="http://schemas.openxmlformats.org/officeDocument/2006/relationships" id="267" r:id="R5e56c8370c5645ea"/>
-    <p:sldId xmlns:r="http://schemas.openxmlformats.org/officeDocument/2006/relationships" id="268" r:id="R47dd90e9007f47ac"/>
-    <p:sldId xmlns:r="http://schemas.openxmlformats.org/officeDocument/2006/relationships" id="269" r:id="Rd1fb6aafd1d8430f"/>
-    <p:sldId xmlns:r="http://schemas.openxmlformats.org/officeDocument/2006/relationships" id="270" r:id="R584ac5112598460f"/>
-    <p:sldId xmlns:r="http://schemas.openxmlformats.org/officeDocument/2006/relationships" id="271" r:id="Re001857d585044f2"/>
-    <p:sldId xmlns:r="http://schemas.openxmlformats.org/officeDocument/2006/relationships" id="272" r:id="Rc0cc41df25304854"/>
-    <p:sldId xmlns:r="http://schemas.openxmlformats.org/officeDocument/2006/relationships" id="273" r:id="Rb9ef766d173f49c4"/>
-    <p:sldId xmlns:r="http://schemas.openxmlformats.org/officeDocument/2006/relationships" id="274" r:id="R82891c044bb6447e"/>
-    <p:sldId xmlns:r="http://schemas.openxmlformats.org/officeDocument/2006/relationships" id="275" r:id="R61c24c2cb01a42f4"/>
-    <p:sldId xmlns:r="http://schemas.openxmlformats.org/officeDocument/2006/relationships" id="276" r:id="R841b2a2999df4b53"/>
-    <p:sldId xmlns:r="http://schemas.openxmlformats.org/officeDocument/2006/relationships" id="277" r:id="Raed329f1439a4e4f"/>
-    <p:sldId xmlns:r="http://schemas.openxmlformats.org/officeDocument/2006/relationships" id="278" r:id="Ra49e624f541f4eed"/>
-    <p:sldId xmlns:r="http://schemas.openxmlformats.org/officeDocument/2006/relationships" id="279" r:id="R8e793e9cb4ec43fe"/>
-    <p:sldId xmlns:r="http://schemas.openxmlformats.org/officeDocument/2006/relationships" id="280" r:id="Rb47d13aec2e245ff"/>
-    <p:sldId xmlns:r="http://schemas.openxmlformats.org/officeDocument/2006/relationships" id="281" r:id="R0a79524b069e40fc"/>
-    <p:sldId xmlns:r="http://schemas.openxmlformats.org/officeDocument/2006/relationships" id="282" r:id="Rd96bf982a48d4e2f"/>
-    <p:sldId xmlns:r="http://schemas.openxmlformats.org/officeDocument/2006/relationships" id="283" r:id="R02697207f4724baa"/>
-    <p:sldId xmlns:r="http://schemas.openxmlformats.org/officeDocument/2006/relationships" id="284" r:id="R719193222f574680"/>
-    <p:sldId xmlns:r="http://schemas.openxmlformats.org/officeDocument/2006/relationships" id="285" r:id="Rc49b7ce462f249db"/>
+    <p:sldId xmlns:r="http://schemas.openxmlformats.org/officeDocument/2006/relationships" id="256" r:id="Rb90a8255385041cf"/>
+    <p:sldId xmlns:r="http://schemas.openxmlformats.org/officeDocument/2006/relationships" id="257" r:id="R960a9e4bfee94ab4"/>
+    <p:sldId xmlns:r="http://schemas.openxmlformats.org/officeDocument/2006/relationships" id="258" r:id="R4365f1d8579a4ed2"/>
+    <p:sldId xmlns:r="http://schemas.openxmlformats.org/officeDocument/2006/relationships" id="259" r:id="Rae19a14838a8425d"/>
+    <p:sldId xmlns:r="http://schemas.openxmlformats.org/officeDocument/2006/relationships" id="260" r:id="R916b6352b3844a09"/>
+    <p:sldId xmlns:r="http://schemas.openxmlformats.org/officeDocument/2006/relationships" id="261" r:id="R42c73f003df84fcc"/>
+    <p:sldId xmlns:r="http://schemas.openxmlformats.org/officeDocument/2006/relationships" id="262" r:id="R4f332eb4d5fc48f7"/>
+    <p:sldId xmlns:r="http://schemas.openxmlformats.org/officeDocument/2006/relationships" id="263" r:id="R5a4dba89fdd647ca"/>
+    <p:sldId xmlns:r="http://schemas.openxmlformats.org/officeDocument/2006/relationships" id="264" r:id="R98c5a7c62e8c4d47"/>
+    <p:sldId xmlns:r="http://schemas.openxmlformats.org/officeDocument/2006/relationships" id="265" r:id="Rbeb5902f404f4c63"/>
+    <p:sldId xmlns:r="http://schemas.openxmlformats.org/officeDocument/2006/relationships" id="266" r:id="R992e5e54bc2c40ef"/>
+    <p:sldId xmlns:r="http://schemas.openxmlformats.org/officeDocument/2006/relationships" id="267" r:id="R9858e480e79e46e3"/>
+    <p:sldId xmlns:r="http://schemas.openxmlformats.org/officeDocument/2006/relationships" id="268" r:id="Ra0a39da0385c4e33"/>
+    <p:sldId xmlns:r="http://schemas.openxmlformats.org/officeDocument/2006/relationships" id="269" r:id="R8b570191b160452b"/>
+    <p:sldId xmlns:r="http://schemas.openxmlformats.org/officeDocument/2006/relationships" id="270" r:id="R21d14bfa8de04832"/>
+    <p:sldId xmlns:r="http://schemas.openxmlformats.org/officeDocument/2006/relationships" id="271" r:id="R0deb1fdf4b5141b0"/>
+    <p:sldId xmlns:r="http://schemas.openxmlformats.org/officeDocument/2006/relationships" id="272" r:id="Rc4f608e3b9eb46e4"/>
+    <p:sldId xmlns:r="http://schemas.openxmlformats.org/officeDocument/2006/relationships" id="273" r:id="R2f72d6c2b44a42d6"/>
+    <p:sldId xmlns:r="http://schemas.openxmlformats.org/officeDocument/2006/relationships" id="274" r:id="R40f0e9cec5b64662"/>
+    <p:sldId xmlns:r="http://schemas.openxmlformats.org/officeDocument/2006/relationships" id="275" r:id="Rdfe50698937944b5"/>
+    <p:sldId xmlns:r="http://schemas.openxmlformats.org/officeDocument/2006/relationships" id="276" r:id="Rc7c6a81c3d2b413c"/>
+    <p:sldId xmlns:r="http://schemas.openxmlformats.org/officeDocument/2006/relationships" id="277" r:id="R4a813ee71939451a"/>
+    <p:sldId xmlns:r="http://schemas.openxmlformats.org/officeDocument/2006/relationships" id="278" r:id="R21afbe3c14434469"/>
+    <p:sldId xmlns:r="http://schemas.openxmlformats.org/officeDocument/2006/relationships" id="279" r:id="R67720dc0e87a4f64"/>
+    <p:sldId xmlns:r="http://schemas.openxmlformats.org/officeDocument/2006/relationships" id="280" r:id="Rae0a33b17a3f4df4"/>
+    <p:sldId xmlns:r="http://schemas.openxmlformats.org/officeDocument/2006/relationships" id="281" r:id="Rb25bc321e1ba43ed"/>
+    <p:sldId xmlns:r="http://schemas.openxmlformats.org/officeDocument/2006/relationships" id="282" r:id="R6e158a59bb424704"/>
+    <p:sldId xmlns:r="http://schemas.openxmlformats.org/officeDocument/2006/relationships" id="283" r:id="R4b21a3f5baab4981"/>
+    <p:sldId xmlns:r="http://schemas.openxmlformats.org/officeDocument/2006/relationships" id="284" r:id="Rc3d3a762a9024402"/>
+    <p:sldId xmlns:r="http://schemas.openxmlformats.org/officeDocument/2006/relationships" id="285" r:id="Rf697e9cf6c3e4f34"/>
   </p:sldIdLst>
   <p:sldSz cx="12191999" cy="6858000"/>
   <p:notesSz cx="6858000" cy="9144000"/>
@@ -2546,7 +2546,7 @@
           <p:cNvPr id="2" name="Title 1">
             <a:extLst xmlns:a="http://schemas.openxmlformats.org/drawingml/2006/main">
               <a:ext uri="{FF2B5EF4-FFF2-40B4-BE49-F238E27FC236}">
-                <a16:creationId xmlns:a16="http://schemas.microsoft.com/office/drawing/2014/main" id="{AB2B498F-C8F5-40F2-8817-89594F8B0B1F}"/>
+                <a16:creationId xmlns:a16="http://schemas.microsoft.com/office/drawing/2014/main" id="{F3436E2D-E1C1-48F8-9197-85806D748C89}"/>
               </a:ext>
             </a:extLst>
           </p:cNvPr>
@@ -2578,7 +2578,7 @@
           <p:cNvPr id="3" name="Subtitle 2">
             <a:extLst xmlns:a="http://schemas.openxmlformats.org/drawingml/2006/main">
               <a:ext uri="{FF2B5EF4-FFF2-40B4-BE49-F238E27FC236}">
-                <a16:creationId xmlns:a16="http://schemas.microsoft.com/office/drawing/2014/main" id="{BC1D041E-B309-4935-A433-51313FA49CD0}"/>
+                <a16:creationId xmlns:a16="http://schemas.microsoft.com/office/drawing/2014/main" id="{62B16E96-B168-49C7-A598-9CF616815311}"/>
               </a:ext>
             </a:extLst>
           </p:cNvPr>
@@ -2701,7 +2701,7 @@
           <p:cNvPr id="4" name="Date Placeholder 3">
             <a:extLst xmlns:a="http://schemas.openxmlformats.org/drawingml/2006/main">
               <a:ext uri="{FF2B5EF4-FFF2-40B4-BE49-F238E27FC236}">
-                <a16:creationId xmlns:a16="http://schemas.microsoft.com/office/drawing/2014/main" id="{09ACBE5B-6F51-48A2-A75A-2C2D4C1D91A5}"/>
+                <a16:creationId xmlns:a16="http://schemas.microsoft.com/office/drawing/2014/main" id="{E02447EA-F21A-4FCE-93BF-83319C5F99A9}"/>
               </a:ext>
             </a:extLst>
           </p:cNvPr>
@@ -2728,7 +2728,7 @@
           <p:cNvPr id="5" name="Footer Placeholder 4">
             <a:extLst xmlns:a="http://schemas.openxmlformats.org/drawingml/2006/main">
               <a:ext uri="{FF2B5EF4-FFF2-40B4-BE49-F238E27FC236}">
-                <a16:creationId xmlns:a16="http://schemas.microsoft.com/office/drawing/2014/main" id="{6611E20A-C95B-42F0-897B-F886F7D99376}"/>
+                <a16:creationId xmlns:a16="http://schemas.microsoft.com/office/drawing/2014/main" id="{12513908-F315-46CE-A1CC-00E9FD3C54AC}"/>
               </a:ext>
             </a:extLst>
           </p:cNvPr>
@@ -2751,7 +2751,7 @@
           <p:cNvPr id="6" name="Slide Number Placeholder 5">
             <a:extLst xmlns:a="http://schemas.openxmlformats.org/drawingml/2006/main">
               <a:ext uri="{FF2B5EF4-FFF2-40B4-BE49-F238E27FC236}">
-                <a16:creationId xmlns:a16="http://schemas.microsoft.com/office/drawing/2014/main" id="{EFF0B808-1A19-4D0C-B679-9C7F4935F005}"/>
+                <a16:creationId xmlns:a16="http://schemas.microsoft.com/office/drawing/2014/main" id="{239F615F-3E32-440F-9629-6EAE999D7021}"/>
               </a:ext>
             </a:extLst>
           </p:cNvPr>
@@ -2795,7 +2795,7 @@
           <p:cNvPr id="2" name="Title 1">
             <a:extLst xmlns:a="http://schemas.openxmlformats.org/drawingml/2006/main">
               <a:ext uri="{FF2B5EF4-FFF2-40B4-BE49-F238E27FC236}">
-                <a16:creationId xmlns:a16="http://schemas.microsoft.com/office/drawing/2014/main" id="{12CE4B95-2B64-4D7A-8907-870990D7C7A9}"/>
+                <a16:creationId xmlns:a16="http://schemas.microsoft.com/office/drawing/2014/main" id="{89FD243A-6CAA-4913-923B-A5345D6D622C}"/>
               </a:ext>
             </a:extLst>
           </p:cNvPr>
@@ -2822,7 +2822,7 @@
           <p:cNvPr id="3" name="Vertical Text Placeholder 2">
             <a:extLst xmlns:a="http://schemas.openxmlformats.org/drawingml/2006/main">
               <a:ext uri="{FF2B5EF4-FFF2-40B4-BE49-F238E27FC236}">
-                <a16:creationId xmlns:a16="http://schemas.microsoft.com/office/drawing/2014/main" id="{6AC5D85F-FF13-43C5-A26C-70183439E851}"/>
+                <a16:creationId xmlns:a16="http://schemas.microsoft.com/office/drawing/2014/main" id="{C239DBDF-4F3A-4DCA-A0B2-ABCDB27C67A5}"/>
               </a:ext>
             </a:extLst>
           </p:cNvPr>
@@ -2884,7 +2884,7 @@
           <p:cNvPr id="4" name="Date Placeholder 3">
             <a:extLst xmlns:a="http://schemas.openxmlformats.org/drawingml/2006/main">
               <a:ext uri="{FF2B5EF4-FFF2-40B4-BE49-F238E27FC236}">
-                <a16:creationId xmlns:a16="http://schemas.microsoft.com/office/drawing/2014/main" id="{1D85B98D-A421-4953-942A-3F88591E2FA4}"/>
+                <a16:creationId xmlns:a16="http://schemas.microsoft.com/office/drawing/2014/main" id="{46FFBFA1-4FEA-4BDF-A8A9-987002A20BF0}"/>
               </a:ext>
             </a:extLst>
           </p:cNvPr>
@@ -2911,7 +2911,7 @@
           <p:cNvPr id="5" name="Footer Placeholder 4">
             <a:extLst xmlns:a="http://schemas.openxmlformats.org/drawingml/2006/main">
               <a:ext uri="{FF2B5EF4-FFF2-40B4-BE49-F238E27FC236}">
-                <a16:creationId xmlns:a16="http://schemas.microsoft.com/office/drawing/2014/main" id="{387DE992-2165-4085-A16F-3B26B421A7B8}"/>
+                <a16:creationId xmlns:a16="http://schemas.microsoft.com/office/drawing/2014/main" id="{6C745F40-C9B3-445B-9CA8-FCDF87B7917D}"/>
               </a:ext>
             </a:extLst>
           </p:cNvPr>
@@ -2934,7 +2934,7 @@
           <p:cNvPr id="6" name="Slide Number Placeholder 5">
             <a:extLst xmlns:a="http://schemas.openxmlformats.org/drawingml/2006/main">
               <a:ext uri="{FF2B5EF4-FFF2-40B4-BE49-F238E27FC236}">
-                <a16:creationId xmlns:a16="http://schemas.microsoft.com/office/drawing/2014/main" id="{46FA4924-71D7-4358-A986-17050009B224}"/>
+                <a16:creationId xmlns:a16="http://schemas.microsoft.com/office/drawing/2014/main" id="{5594C023-5908-4B1A-B1EA-84359181F922}"/>
               </a:ext>
             </a:extLst>
           </p:cNvPr>
@@ -2978,7 +2978,7 @@
           <p:cNvPr id="2" name="Vertical Title 1">
             <a:extLst xmlns:a="http://schemas.openxmlformats.org/drawingml/2006/main">
               <a:ext uri="{FF2B5EF4-FFF2-40B4-BE49-F238E27FC236}">
-                <a16:creationId xmlns:a16="http://schemas.microsoft.com/office/drawing/2014/main" id="{DF46077C-E8A1-4F20-A66C-58465938AF05}"/>
+                <a16:creationId xmlns:a16="http://schemas.microsoft.com/office/drawing/2014/main" id="{3DDAAF3A-5834-414F-962E-06DCE1000473}"/>
               </a:ext>
             </a:extLst>
           </p:cNvPr>
@@ -3010,7 +3010,7 @@
           <p:cNvPr id="3" name="Vertical Text Placeholder 2">
             <a:extLst xmlns:a="http://schemas.openxmlformats.org/drawingml/2006/main">
               <a:ext uri="{FF2B5EF4-FFF2-40B4-BE49-F238E27FC236}">
-                <a16:creationId xmlns:a16="http://schemas.microsoft.com/office/drawing/2014/main" id="{87676CFC-4027-4C7A-AB7A-3F2D5DD65793}"/>
+                <a16:creationId xmlns:a16="http://schemas.microsoft.com/office/drawing/2014/main" id="{7013BCE6-FFD4-4B59-AB1F-12C5EA045F0D}"/>
               </a:ext>
             </a:extLst>
           </p:cNvPr>
@@ -3077,7 +3077,7 @@
           <p:cNvPr id="4" name="Date Placeholder 3">
             <a:extLst xmlns:a="http://schemas.openxmlformats.org/drawingml/2006/main">
               <a:ext uri="{FF2B5EF4-FFF2-40B4-BE49-F238E27FC236}">
-                <a16:creationId xmlns:a16="http://schemas.microsoft.com/office/drawing/2014/main" id="{31184D48-B98B-43AC-A701-220C52AF19A5}"/>
+                <a16:creationId xmlns:a16="http://schemas.microsoft.com/office/drawing/2014/main" id="{A7EEF051-262B-4E4B-ADB0-24779627AA5E}"/>
               </a:ext>
             </a:extLst>
           </p:cNvPr>
@@ -3104,7 +3104,7 @@
           <p:cNvPr id="5" name="Footer Placeholder 4">
             <a:extLst xmlns:a="http://schemas.openxmlformats.org/drawingml/2006/main">
               <a:ext uri="{FF2B5EF4-FFF2-40B4-BE49-F238E27FC236}">
-                <a16:creationId xmlns:a16="http://schemas.microsoft.com/office/drawing/2014/main" id="{1F028F9D-DD50-4739-999A-C742F06C705B}"/>
+                <a16:creationId xmlns:a16="http://schemas.microsoft.com/office/drawing/2014/main" id="{5EAA2759-142E-46CE-9777-3E934F614A55}"/>
               </a:ext>
             </a:extLst>
           </p:cNvPr>
@@ -3127,7 +3127,7 @@
           <p:cNvPr id="6" name="Slide Number Placeholder 5">
             <a:extLst xmlns:a="http://schemas.openxmlformats.org/drawingml/2006/main">
               <a:ext uri="{FF2B5EF4-FFF2-40B4-BE49-F238E27FC236}">
-                <a16:creationId xmlns:a16="http://schemas.microsoft.com/office/drawing/2014/main" id="{66BE7AB0-A249-4409-87EB-AC123689ABF1}"/>
+                <a16:creationId xmlns:a16="http://schemas.microsoft.com/office/drawing/2014/main" id="{CA18648B-47EC-4B15-83E6-C4B0024A997E}"/>
               </a:ext>
             </a:extLst>
           </p:cNvPr>
@@ -3171,7 +3171,7 @@
           <p:cNvPr id="2" name="Title 1">
             <a:extLst xmlns:a="http://schemas.openxmlformats.org/drawingml/2006/main">
               <a:ext uri="{FF2B5EF4-FFF2-40B4-BE49-F238E27FC236}">
-                <a16:creationId xmlns:a16="http://schemas.microsoft.com/office/drawing/2014/main" id="{7B4A62BD-86ED-4F8C-985E-B6A14FE00A00}"/>
+                <a16:creationId xmlns:a16="http://schemas.microsoft.com/office/drawing/2014/main" id="{765A7553-220F-4CDF-8251-AF14311B9589}"/>
               </a:ext>
             </a:extLst>
           </p:cNvPr>
@@ -3198,7 +3198,7 @@
           <p:cNvPr id="3" name="Content Placeholder 2">
             <a:extLst xmlns:a="http://schemas.openxmlformats.org/drawingml/2006/main">
               <a:ext uri="{FF2B5EF4-FFF2-40B4-BE49-F238E27FC236}">
-                <a16:creationId xmlns:a16="http://schemas.microsoft.com/office/drawing/2014/main" id="{D44C21F2-2083-4189-AE68-4FD75AF957E0}"/>
+                <a16:creationId xmlns:a16="http://schemas.microsoft.com/office/drawing/2014/main" id="{6748F28A-2112-48E5-9FC8-1E0AA4A8FC18}"/>
               </a:ext>
             </a:extLst>
           </p:cNvPr>
@@ -3260,7 +3260,7 @@
           <p:cNvPr id="4" name="Date Placeholder 3">
             <a:extLst xmlns:a="http://schemas.openxmlformats.org/drawingml/2006/main">
               <a:ext uri="{FF2B5EF4-FFF2-40B4-BE49-F238E27FC236}">
-                <a16:creationId xmlns:a16="http://schemas.microsoft.com/office/drawing/2014/main" id="{C35D2667-7AE5-49B2-9B2E-413CF5F950BE}"/>
+                <a16:creationId xmlns:a16="http://schemas.microsoft.com/office/drawing/2014/main" id="{DC1F3072-69D6-4D58-B937-5A4A9732AF6F}"/>
               </a:ext>
             </a:extLst>
           </p:cNvPr>
@@ -3287,7 +3287,7 @@
           <p:cNvPr id="5" name="Footer Placeholder 4">
             <a:extLst xmlns:a="http://schemas.openxmlformats.org/drawingml/2006/main">
               <a:ext uri="{FF2B5EF4-FFF2-40B4-BE49-F238E27FC236}">
-                <a16:creationId xmlns:a16="http://schemas.microsoft.com/office/drawing/2014/main" id="{0C441044-0EE1-4520-989B-C5C9253BFBA7}"/>
+                <a16:creationId xmlns:a16="http://schemas.microsoft.com/office/drawing/2014/main" id="{AB8B7EBD-716B-4029-963F-285A5DDE8B00}"/>
               </a:ext>
             </a:extLst>
           </p:cNvPr>
@@ -3310,7 +3310,7 @@
           <p:cNvPr id="6" name="Slide Number Placeholder 5">
             <a:extLst xmlns:a="http://schemas.openxmlformats.org/drawingml/2006/main">
               <a:ext uri="{FF2B5EF4-FFF2-40B4-BE49-F238E27FC236}">
-                <a16:creationId xmlns:a16="http://schemas.microsoft.com/office/drawing/2014/main" id="{BBBEF862-173E-4274-92D9-D0CBED0A9671}"/>
+                <a16:creationId xmlns:a16="http://schemas.microsoft.com/office/drawing/2014/main" id="{6DCEC666-C6C4-4FE9-B007-7B98042EABD4}"/>
               </a:ext>
             </a:extLst>
           </p:cNvPr>
@@ -3354,7 +3354,7 @@
           <p:cNvPr id="2" name="Title 1">
             <a:extLst xmlns:a="http://schemas.openxmlformats.org/drawingml/2006/main">
               <a:ext uri="{FF2B5EF4-FFF2-40B4-BE49-F238E27FC236}">
-                <a16:creationId xmlns:a16="http://schemas.microsoft.com/office/drawing/2014/main" id="{54CCB851-1801-416E-B7AC-417D4BCE3A09}"/>
+                <a16:creationId xmlns:a16="http://schemas.microsoft.com/office/drawing/2014/main" id="{C2A6CAAD-3C8C-412B-A83A-D7248E899DF9}"/>
               </a:ext>
             </a:extLst>
           </p:cNvPr>
@@ -3391,7 +3391,7 @@
           <p:cNvPr id="3" name="Text Placeholder 2">
             <a:extLst xmlns:a="http://schemas.openxmlformats.org/drawingml/2006/main">
               <a:ext uri="{FF2B5EF4-FFF2-40B4-BE49-F238E27FC236}">
-                <a16:creationId xmlns:a16="http://schemas.microsoft.com/office/drawing/2014/main" id="{EE0FCE41-1382-44A1-8EB6-732069269058}"/>
+                <a16:creationId xmlns:a16="http://schemas.microsoft.com/office/drawing/2014/main" id="{64C4EE91-145B-48E1-9CE8-225B99A929D9}"/>
               </a:ext>
             </a:extLst>
           </p:cNvPr>
@@ -3517,7 +3517,7 @@
           <p:cNvPr id="4" name="Date Placeholder 3">
             <a:extLst xmlns:a="http://schemas.openxmlformats.org/drawingml/2006/main">
               <a:ext uri="{FF2B5EF4-FFF2-40B4-BE49-F238E27FC236}">
-                <a16:creationId xmlns:a16="http://schemas.microsoft.com/office/drawing/2014/main" id="{7D1BBCAF-B5CB-4C91-B0A4-415D3E336E27}"/>
+                <a16:creationId xmlns:a16="http://schemas.microsoft.com/office/drawing/2014/main" id="{37DACD32-8B94-4A16-B1C0-9D27BCBC5577}"/>
               </a:ext>
             </a:extLst>
           </p:cNvPr>
@@ -3544,7 +3544,7 @@
           <p:cNvPr id="5" name="Footer Placeholder 4">
             <a:extLst xmlns:a="http://schemas.openxmlformats.org/drawingml/2006/main">
               <a:ext uri="{FF2B5EF4-FFF2-40B4-BE49-F238E27FC236}">
-                <a16:creationId xmlns:a16="http://schemas.microsoft.com/office/drawing/2014/main" id="{6D5D1573-9EDA-4072-A63A-55415C814814}"/>
+                <a16:creationId xmlns:a16="http://schemas.microsoft.com/office/drawing/2014/main" id="{D779F11F-F402-470D-94C9-8AC10D2E30A9}"/>
               </a:ext>
             </a:extLst>
           </p:cNvPr>
@@ -3567,7 +3567,7 @@
           <p:cNvPr id="6" name="Slide Number Placeholder 5">
             <a:extLst xmlns:a="http://schemas.openxmlformats.org/drawingml/2006/main">
               <a:ext uri="{FF2B5EF4-FFF2-40B4-BE49-F238E27FC236}">
-                <a16:creationId xmlns:a16="http://schemas.microsoft.com/office/drawing/2014/main" id="{BB9CD300-961C-426F-B85C-03EBEC6E05DB}"/>
+                <a16:creationId xmlns:a16="http://schemas.microsoft.com/office/drawing/2014/main" id="{79F9D546-DA84-44F8-8955-8796D7CABD60}"/>
               </a:ext>
             </a:extLst>
           </p:cNvPr>
@@ -3611,7 +3611,7 @@
           <p:cNvPr id="2" name="Title 1">
             <a:extLst xmlns:a="http://schemas.openxmlformats.org/drawingml/2006/main">
               <a:ext uri="{FF2B5EF4-FFF2-40B4-BE49-F238E27FC236}">
-                <a16:creationId xmlns:a16="http://schemas.microsoft.com/office/drawing/2014/main" id="{3AF360B6-5637-461F-A0A2-AE90D2389812}"/>
+                <a16:creationId xmlns:a16="http://schemas.microsoft.com/office/drawing/2014/main" id="{8018B09E-F6A1-4E9E-B4CE-4512C59D595F}"/>
               </a:ext>
             </a:extLst>
           </p:cNvPr>
@@ -3638,7 +3638,7 @@
           <p:cNvPr id="3" name="Content Placeholder 2">
             <a:extLst xmlns:a="http://schemas.openxmlformats.org/drawingml/2006/main">
               <a:ext uri="{FF2B5EF4-FFF2-40B4-BE49-F238E27FC236}">
-                <a16:creationId xmlns:a16="http://schemas.microsoft.com/office/drawing/2014/main" id="{8041805B-72CC-4D97-B4F4-9D19974C1719}"/>
+                <a16:creationId xmlns:a16="http://schemas.microsoft.com/office/drawing/2014/main" id="{AAA90FAE-06A9-4CDE-9628-BC7A990741B9}"/>
               </a:ext>
             </a:extLst>
           </p:cNvPr>
@@ -3742,7 +3742,7 @@
           <p:cNvPr id="4" name="Content Placeholder 3">
             <a:extLst xmlns:a="http://schemas.openxmlformats.org/drawingml/2006/main">
               <a:ext uri="{FF2B5EF4-FFF2-40B4-BE49-F238E27FC236}">
-                <a16:creationId xmlns:a16="http://schemas.microsoft.com/office/drawing/2014/main" id="{73B71B21-D5BA-4913-83A6-03406A863B84}"/>
+                <a16:creationId xmlns:a16="http://schemas.microsoft.com/office/drawing/2014/main" id="{61F6A098-5781-4739-AD0B-46563D0B9F21}"/>
               </a:ext>
             </a:extLst>
           </p:cNvPr>
@@ -3846,7 +3846,7 @@
           <p:cNvPr id="5" name="Date Placeholder 4">
             <a:extLst xmlns:a="http://schemas.openxmlformats.org/drawingml/2006/main">
               <a:ext uri="{FF2B5EF4-FFF2-40B4-BE49-F238E27FC236}">
-                <a16:creationId xmlns:a16="http://schemas.microsoft.com/office/drawing/2014/main" id="{C364A685-3879-40D1-91C4-73FFA0F26097}"/>
+                <a16:creationId xmlns:a16="http://schemas.microsoft.com/office/drawing/2014/main" id="{FDC7A8EE-D37B-4F14-A224-85C0556166E2}"/>
               </a:ext>
             </a:extLst>
           </p:cNvPr>
@@ -3873,7 +3873,7 @@
           <p:cNvPr id="6" name="Footer Placeholder 5">
             <a:extLst xmlns:a="http://schemas.openxmlformats.org/drawingml/2006/main">
               <a:ext uri="{FF2B5EF4-FFF2-40B4-BE49-F238E27FC236}">
-                <a16:creationId xmlns:a16="http://schemas.microsoft.com/office/drawing/2014/main" id="{4E8500F8-521A-47EB-AADF-E4FDD2014045}"/>
+                <a16:creationId xmlns:a16="http://schemas.microsoft.com/office/drawing/2014/main" id="{0C21F815-FDF6-4301-A7B8-0D4BD3369376}"/>
               </a:ext>
             </a:extLst>
           </p:cNvPr>
@@ -3896,7 +3896,7 @@
           <p:cNvPr id="7" name="Slide Number Placeholder 6">
             <a:extLst xmlns:a="http://schemas.openxmlformats.org/drawingml/2006/main">
               <a:ext uri="{FF2B5EF4-FFF2-40B4-BE49-F238E27FC236}">
-                <a16:creationId xmlns:a16="http://schemas.microsoft.com/office/drawing/2014/main" id="{BF9C0102-EB42-460A-8B03-1EBEA004D605}"/>
+                <a16:creationId xmlns:a16="http://schemas.microsoft.com/office/drawing/2014/main" id="{38AFDFCA-F708-4C0B-8E92-4947617D6C61}"/>
               </a:ext>
             </a:extLst>
           </p:cNvPr>
@@ -3940,7 +3940,7 @@
           <p:cNvPr id="2" name="Title 1">
             <a:extLst xmlns:a="http://schemas.openxmlformats.org/drawingml/2006/main">
               <a:ext uri="{FF2B5EF4-FFF2-40B4-BE49-F238E27FC236}">
-                <a16:creationId xmlns:a16="http://schemas.microsoft.com/office/drawing/2014/main" id="{F0178986-0670-4175-8FAB-CDD1B91C2D3E}"/>
+                <a16:creationId xmlns:a16="http://schemas.microsoft.com/office/drawing/2014/main" id="{1AB61278-1AD1-4008-B826-D2FCBD94D4A7}"/>
               </a:ext>
             </a:extLst>
           </p:cNvPr>
@@ -3972,7 +3972,7 @@
           <p:cNvPr id="3" name="Text Placeholder 2">
             <a:extLst xmlns:a="http://schemas.openxmlformats.org/drawingml/2006/main">
               <a:ext uri="{FF2B5EF4-FFF2-40B4-BE49-F238E27FC236}">
-                <a16:creationId xmlns:a16="http://schemas.microsoft.com/office/drawing/2014/main" id="{4D4BEB0C-54DD-4B44-904E-EC2E9BCC68D5}"/>
+                <a16:creationId xmlns:a16="http://schemas.microsoft.com/office/drawing/2014/main" id="{83B9E49E-E07B-4101-8CA3-C72C8F13EE20}"/>
               </a:ext>
             </a:extLst>
           </p:cNvPr>
@@ -4044,7 +4044,7 @@
           <p:cNvPr id="4" name="Content Placeholder 3">
             <a:extLst xmlns:a="http://schemas.openxmlformats.org/drawingml/2006/main">
               <a:ext uri="{FF2B5EF4-FFF2-40B4-BE49-F238E27FC236}">
-                <a16:creationId xmlns:a16="http://schemas.microsoft.com/office/drawing/2014/main" id="{AB162B1A-DD94-480B-83C2-63383DF21A60}"/>
+                <a16:creationId xmlns:a16="http://schemas.microsoft.com/office/drawing/2014/main" id="{D81CA610-36BC-462B-AA50-68DE1572CDEE}"/>
               </a:ext>
             </a:extLst>
           </p:cNvPr>
@@ -4148,7 +4148,7 @@
           <p:cNvPr id="5" name="Text Placeholder 4">
             <a:extLst xmlns:a="http://schemas.openxmlformats.org/drawingml/2006/main">
               <a:ext uri="{FF2B5EF4-FFF2-40B4-BE49-F238E27FC236}">
-                <a16:creationId xmlns:a16="http://schemas.microsoft.com/office/drawing/2014/main" id="{FD9BADA5-B6E6-412C-8C31-F618A0AE900E}"/>
+                <a16:creationId xmlns:a16="http://schemas.microsoft.com/office/drawing/2014/main" id="{8D417C4C-A5F4-4095-A9E6-F63D0D1B9C5C}"/>
               </a:ext>
             </a:extLst>
           </p:cNvPr>
@@ -4220,7 +4220,7 @@
           <p:cNvPr id="6" name="Content Placeholder 5">
             <a:extLst xmlns:a="http://schemas.openxmlformats.org/drawingml/2006/main">
               <a:ext uri="{FF2B5EF4-FFF2-40B4-BE49-F238E27FC236}">
-                <a16:creationId xmlns:a16="http://schemas.microsoft.com/office/drawing/2014/main" id="{360BC57E-83C8-4488-8F6D-E12A2C741747}"/>
+                <a16:creationId xmlns:a16="http://schemas.microsoft.com/office/drawing/2014/main" id="{29651AAE-A7EA-4274-884B-2D2CE1C6F5FB}"/>
               </a:ext>
             </a:extLst>
           </p:cNvPr>
@@ -4324,7 +4324,7 @@
           <p:cNvPr id="7" name="Date Placeholder 6">
             <a:extLst xmlns:a="http://schemas.openxmlformats.org/drawingml/2006/main">
               <a:ext uri="{FF2B5EF4-FFF2-40B4-BE49-F238E27FC236}">
-                <a16:creationId xmlns:a16="http://schemas.microsoft.com/office/drawing/2014/main" id="{36BD92F1-2855-4D32-A1A2-2DA6F1B4782A}"/>
+                <a16:creationId xmlns:a16="http://schemas.microsoft.com/office/drawing/2014/main" id="{AA292D49-F29C-4175-AB96-F05ED92C7EC7}"/>
               </a:ext>
             </a:extLst>
           </p:cNvPr>
@@ -4351,7 +4351,7 @@
           <p:cNvPr id="8" name="Footer Placeholder 7">
             <a:extLst xmlns:a="http://schemas.openxmlformats.org/drawingml/2006/main">
               <a:ext uri="{FF2B5EF4-FFF2-40B4-BE49-F238E27FC236}">
-                <a16:creationId xmlns:a16="http://schemas.microsoft.com/office/drawing/2014/main" id="{4AB70325-27D8-4567-9A37-A1387F4B27FA}"/>
+                <a16:creationId xmlns:a16="http://schemas.microsoft.com/office/drawing/2014/main" id="{81C95902-48B3-4E56-AC01-853516DF64B5}"/>
               </a:ext>
             </a:extLst>
           </p:cNvPr>
@@ -4374,7 +4374,7 @@
           <p:cNvPr id="9" name="Slide Number Placeholder 8">
             <a:extLst xmlns:a="http://schemas.openxmlformats.org/drawingml/2006/main">
               <a:ext uri="{FF2B5EF4-FFF2-40B4-BE49-F238E27FC236}">
-                <a16:creationId xmlns:a16="http://schemas.microsoft.com/office/drawing/2014/main" id="{F32778FB-4639-43ED-BEE0-1C9928EF333D}"/>
+                <a16:creationId xmlns:a16="http://schemas.microsoft.com/office/drawing/2014/main" id="{64B77271-500A-43B0-AEB6-427B36D92859}"/>
               </a:ext>
             </a:extLst>
           </p:cNvPr>
@@ -4418,7 +4418,7 @@
           <p:cNvPr id="2" name="Title 1">
             <a:extLst xmlns:a="http://schemas.openxmlformats.org/drawingml/2006/main">
               <a:ext uri="{FF2B5EF4-FFF2-40B4-BE49-F238E27FC236}">
-                <a16:creationId xmlns:a16="http://schemas.microsoft.com/office/drawing/2014/main" id="{6C6C24D9-B103-43EE-B444-D1259E30B14B}"/>
+                <a16:creationId xmlns:a16="http://schemas.microsoft.com/office/drawing/2014/main" id="{EB0D13B2-B442-4600-B4E7-AE087E56D815}"/>
               </a:ext>
             </a:extLst>
           </p:cNvPr>
@@ -4445,7 +4445,7 @@
           <p:cNvPr id="3" name="Date Placeholder 2">
             <a:extLst xmlns:a="http://schemas.openxmlformats.org/drawingml/2006/main">
               <a:ext uri="{FF2B5EF4-FFF2-40B4-BE49-F238E27FC236}">
-                <a16:creationId xmlns:a16="http://schemas.microsoft.com/office/drawing/2014/main" id="{5856551E-CBD2-454A-B1BE-3BD3B4727235}"/>
+                <a16:creationId xmlns:a16="http://schemas.microsoft.com/office/drawing/2014/main" id="{755734FE-A4A2-4791-A6B0-A52B722B4CA7}"/>
               </a:ext>
             </a:extLst>
           </p:cNvPr>
@@ -4472,7 +4472,7 @@
           <p:cNvPr id="4" name="Footer Placeholder 3">
             <a:extLst xmlns:a="http://schemas.openxmlformats.org/drawingml/2006/main">
               <a:ext uri="{FF2B5EF4-FFF2-40B4-BE49-F238E27FC236}">
-                <a16:creationId xmlns:a16="http://schemas.microsoft.com/office/drawing/2014/main" id="{AAA97748-BCF4-44F5-A6C8-4CBC951A787E}"/>
+                <a16:creationId xmlns:a16="http://schemas.microsoft.com/office/drawing/2014/main" id="{96E8902B-3E6E-4504-A558-03CA968A51BA}"/>
               </a:ext>
             </a:extLst>
           </p:cNvPr>
@@ -4495,7 +4495,7 @@
           <p:cNvPr id="5" name="Slide Number Placeholder 4">
             <a:extLst xmlns:a="http://schemas.openxmlformats.org/drawingml/2006/main">
               <a:ext uri="{FF2B5EF4-FFF2-40B4-BE49-F238E27FC236}">
-                <a16:creationId xmlns:a16="http://schemas.microsoft.com/office/drawing/2014/main" id="{483B9CF2-2D12-4AA5-87E7-F8CE0787262D}"/>
+                <a16:creationId xmlns:a16="http://schemas.microsoft.com/office/drawing/2014/main" id="{4F46550D-B380-41CD-B109-1374699733D1}"/>
               </a:ext>
             </a:extLst>
           </p:cNvPr>
@@ -4539,7 +4539,7 @@
           <p:cNvPr id="2" name="Date Placeholder 1">
             <a:extLst xmlns:a="http://schemas.openxmlformats.org/drawingml/2006/main">
               <a:ext uri="{FF2B5EF4-FFF2-40B4-BE49-F238E27FC236}">
-                <a16:creationId xmlns:a16="http://schemas.microsoft.com/office/drawing/2014/main" id="{6F499B53-BF1E-4A8E-A0F1-8139BE046CF6}"/>
+                <a16:creationId xmlns:a16="http://schemas.microsoft.com/office/drawing/2014/main" id="{B2EC543A-7899-4CF4-953C-7652D53BC30D}"/>
               </a:ext>
             </a:extLst>
           </p:cNvPr>
@@ -4566,7 +4566,7 @@
           <p:cNvPr id="3" name="Footer Placeholder 2">
             <a:extLst xmlns:a="http://schemas.openxmlformats.org/drawingml/2006/main">
               <a:ext uri="{FF2B5EF4-FFF2-40B4-BE49-F238E27FC236}">
-                <a16:creationId xmlns:a16="http://schemas.microsoft.com/office/drawing/2014/main" id="{9874C5E9-8459-4C45-B3DC-6B20534D06E0}"/>
+                <a16:creationId xmlns:a16="http://schemas.microsoft.com/office/drawing/2014/main" id="{7FB35ADF-4FE8-4944-8247-32EE1D748DB5}"/>
               </a:ext>
             </a:extLst>
           </p:cNvPr>
@@ -4589,7 +4589,7 @@
           <p:cNvPr id="4" name="Slide Number Placeholder 3">
             <a:extLst xmlns:a="http://schemas.openxmlformats.org/drawingml/2006/main">
               <a:ext uri="{FF2B5EF4-FFF2-40B4-BE49-F238E27FC236}">
-                <a16:creationId xmlns:a16="http://schemas.microsoft.com/office/drawing/2014/main" id="{3E569568-FE13-42CA-8289-FCF0D11C9B1C}"/>
+                <a16:creationId xmlns:a16="http://schemas.microsoft.com/office/drawing/2014/main" id="{22B00982-1B6E-442F-BA1A-D0BDD439E460}"/>
               </a:ext>
             </a:extLst>
           </p:cNvPr>
@@ -4633,7 +4633,7 @@
           <p:cNvPr id="2" name="Title 1">
             <a:extLst xmlns:a="http://schemas.openxmlformats.org/drawingml/2006/main">
               <a:ext uri="{FF2B5EF4-FFF2-40B4-BE49-F238E27FC236}">
-                <a16:creationId xmlns:a16="http://schemas.microsoft.com/office/drawing/2014/main" id="{60E64830-6404-4302-9414-EB451EB943CF}"/>
+                <a16:creationId xmlns:a16="http://schemas.microsoft.com/office/drawing/2014/main" id="{A2A6C3E8-C5EB-429B-ACF4-1C9132DF9F2B}"/>
               </a:ext>
             </a:extLst>
           </p:cNvPr>
@@ -4670,7 +4670,7 @@
           <p:cNvPr id="3" name="Content Placeholder 2">
             <a:extLst xmlns:a="http://schemas.openxmlformats.org/drawingml/2006/main">
               <a:ext uri="{FF2B5EF4-FFF2-40B4-BE49-F238E27FC236}">
-                <a16:creationId xmlns:a16="http://schemas.microsoft.com/office/drawing/2014/main" id="{549C431E-2565-4672-AC36-A5EDCA0F1F66}"/>
+                <a16:creationId xmlns:a16="http://schemas.microsoft.com/office/drawing/2014/main" id="{D04772B8-82A0-4110-8038-822FD70FBE3D}"/>
               </a:ext>
             </a:extLst>
           </p:cNvPr>
@@ -4774,7 +4774,7 @@
           <p:cNvPr id="4" name="Text Placeholder 3">
             <a:extLst xmlns:a="http://schemas.openxmlformats.org/drawingml/2006/main">
               <a:ext uri="{FF2B5EF4-FFF2-40B4-BE49-F238E27FC236}">
-                <a16:creationId xmlns:a16="http://schemas.microsoft.com/office/drawing/2014/main" id="{407CA220-25ED-4348-A0E4-3E1FFC2DCE83}"/>
+                <a16:creationId xmlns:a16="http://schemas.microsoft.com/office/drawing/2014/main" id="{E8AF4A4D-8D1E-43AA-9AF9-AD6BAD00A2D5}"/>
               </a:ext>
             </a:extLst>
           </p:cNvPr>
@@ -4846,7 +4846,7 @@
           <p:cNvPr id="5" name="Date Placeholder 4">
             <a:extLst xmlns:a="http://schemas.openxmlformats.org/drawingml/2006/main">
               <a:ext uri="{FF2B5EF4-FFF2-40B4-BE49-F238E27FC236}">
-                <a16:creationId xmlns:a16="http://schemas.microsoft.com/office/drawing/2014/main" id="{461EFB20-9C02-4922-B46D-C7C28141C710}"/>
+                <a16:creationId xmlns:a16="http://schemas.microsoft.com/office/drawing/2014/main" id="{5444D9EB-2FDF-4BF1-996D-CF16F3FDD6B4}"/>
               </a:ext>
             </a:extLst>
           </p:cNvPr>
@@ -4873,7 +4873,7 @@
           <p:cNvPr id="6" name="Footer Placeholder 5">
             <a:extLst xmlns:a="http://schemas.openxmlformats.org/drawingml/2006/main">
               <a:ext uri="{FF2B5EF4-FFF2-40B4-BE49-F238E27FC236}">
-                <a16:creationId xmlns:a16="http://schemas.microsoft.com/office/drawing/2014/main" id="{B0EF1C33-F4D6-45E4-B3AE-FE8834B94CF6}"/>
+                <a16:creationId xmlns:a16="http://schemas.microsoft.com/office/drawing/2014/main" id="{63B17912-9466-45EE-BF59-CE5C2804388D}"/>
               </a:ext>
             </a:extLst>
           </p:cNvPr>
@@ -4896,7 +4896,7 @@
           <p:cNvPr id="7" name="Slide Number Placeholder 6">
             <a:extLst xmlns:a="http://schemas.openxmlformats.org/drawingml/2006/main">
               <a:ext uri="{FF2B5EF4-FFF2-40B4-BE49-F238E27FC236}">
-                <a16:creationId xmlns:a16="http://schemas.microsoft.com/office/drawing/2014/main" id="{7B273C38-FBE6-4644-A151-608DE6C7C322}"/>
+                <a16:creationId xmlns:a16="http://schemas.microsoft.com/office/drawing/2014/main" id="{5CA971E6-70DB-4F5A-872F-025C9C6BE865}"/>
               </a:ext>
             </a:extLst>
           </p:cNvPr>
@@ -4940,7 +4940,7 @@
           <p:cNvPr id="2" name="Title 1">
             <a:extLst xmlns:a="http://schemas.openxmlformats.org/drawingml/2006/main">
               <a:ext uri="{FF2B5EF4-FFF2-40B4-BE49-F238E27FC236}">
-                <a16:creationId xmlns:a16="http://schemas.microsoft.com/office/drawing/2014/main" id="{269F0477-BC24-4934-8FDC-CC003220F24B}"/>
+                <a16:creationId xmlns:a16="http://schemas.microsoft.com/office/drawing/2014/main" id="{5A825230-A94B-4F59-A71C-6CEF3C60BF07}"/>
               </a:ext>
             </a:extLst>
           </p:cNvPr>
@@ -4977,7 +4977,7 @@
           <p:cNvPr id="3" name="Picture Placeholder 2">
             <a:extLst xmlns:a="http://schemas.openxmlformats.org/drawingml/2006/main">
               <a:ext uri="{FF2B5EF4-FFF2-40B4-BE49-F238E27FC236}">
-                <a16:creationId xmlns:a16="http://schemas.microsoft.com/office/drawing/2014/main" id="{2EEAA784-6F00-4E5F-B5D6-961C9A92BC5B}"/>
+                <a16:creationId xmlns:a16="http://schemas.microsoft.com/office/drawing/2014/main" id="{B0AFABCC-CBF0-4914-B015-912DD7B2D8E7}"/>
               </a:ext>
             </a:extLst>
           </p:cNvPr>
@@ -5042,7 +5042,7 @@
           <p:cNvPr id="4" name="Text Placeholder 3">
             <a:extLst xmlns:a="http://schemas.openxmlformats.org/drawingml/2006/main">
               <a:ext uri="{FF2B5EF4-FFF2-40B4-BE49-F238E27FC236}">
-                <a16:creationId xmlns:a16="http://schemas.microsoft.com/office/drawing/2014/main" id="{8AAFB2E4-9B93-41A7-866B-9BA49BB9D501}"/>
+                <a16:creationId xmlns:a16="http://schemas.microsoft.com/office/drawing/2014/main" id="{6B5E0EDD-ADB7-4320-9805-E0F8ADDFF2BB}"/>
               </a:ext>
             </a:extLst>
           </p:cNvPr>
@@ -5114,7 +5114,7 @@
           <p:cNvPr id="5" name="Date Placeholder 4">
             <a:extLst xmlns:a="http://schemas.openxmlformats.org/drawingml/2006/main">
               <a:ext uri="{FF2B5EF4-FFF2-40B4-BE49-F238E27FC236}">
-                <a16:creationId xmlns:a16="http://schemas.microsoft.com/office/drawing/2014/main" id="{00A893AE-F857-4153-9E5D-8C4211A6F501}"/>
+                <a16:creationId xmlns:a16="http://schemas.microsoft.com/office/drawing/2014/main" id="{DE7F61AC-0B0C-4367-9B2A-56315A0754EA}"/>
               </a:ext>
             </a:extLst>
           </p:cNvPr>
@@ -5141,7 +5141,7 @@
           <p:cNvPr id="6" name="Footer Placeholder 5">
             <a:extLst xmlns:a="http://schemas.openxmlformats.org/drawingml/2006/main">
               <a:ext uri="{FF2B5EF4-FFF2-40B4-BE49-F238E27FC236}">
-                <a16:creationId xmlns:a16="http://schemas.microsoft.com/office/drawing/2014/main" id="{B88D231C-2876-44DC-B0EA-13F9E96748B8}"/>
+                <a16:creationId xmlns:a16="http://schemas.microsoft.com/office/drawing/2014/main" id="{1CBFDCF0-1971-49AD-966B-817B9CFB6327}"/>
               </a:ext>
             </a:extLst>
           </p:cNvPr>
@@ -5164,7 +5164,7 @@
           <p:cNvPr id="7" name="Slide Number Placeholder 6">
             <a:extLst xmlns:a="http://schemas.openxmlformats.org/drawingml/2006/main">
               <a:ext uri="{FF2B5EF4-FFF2-40B4-BE49-F238E27FC236}">
-                <a16:creationId xmlns:a16="http://schemas.microsoft.com/office/drawing/2014/main" id="{7885D03C-2787-4568-96BF-BE5882C99F01}"/>
+                <a16:creationId xmlns:a16="http://schemas.microsoft.com/office/drawing/2014/main" id="{693D7C15-D71F-4FE8-BAA1-E2C025B1696E}"/>
               </a:ext>
             </a:extLst>
           </p:cNvPr>
@@ -5213,7 +5213,7 @@
           <p:cNvPr id="2" name="Title Placeholder 1">
             <a:extLst xmlns:a="http://schemas.openxmlformats.org/drawingml/2006/main">
               <a:ext uri="{FF2B5EF4-FFF2-40B4-BE49-F238E27FC236}">
-                <a16:creationId xmlns:a16="http://schemas.microsoft.com/office/drawing/2014/main" id="{36925245-E049-4EA6-8448-E77C9A03B201}"/>
+                <a16:creationId xmlns:a16="http://schemas.microsoft.com/office/drawing/2014/main" id="{2533FD76-40B2-48DE-98EC-F923AEE61A2A}"/>
               </a:ext>
             </a:extLst>
           </p:cNvPr>
@@ -5250,7 +5250,7 @@
           <p:cNvPr id="3" name="Text Placeholder 2">
             <a:extLst xmlns:a="http://schemas.openxmlformats.org/drawingml/2006/main">
               <a:ext uri="{FF2B5EF4-FFF2-40B4-BE49-F238E27FC236}">
-                <a16:creationId xmlns:a16="http://schemas.microsoft.com/office/drawing/2014/main" id="{4A68FDDC-AAEB-4AD3-ACDD-A7D1FB9C7557}"/>
+                <a16:creationId xmlns:a16="http://schemas.microsoft.com/office/drawing/2014/main" id="{17DA4F07-D25D-4AA8-9481-A0ACB31923CC}"/>
               </a:ext>
             </a:extLst>
           </p:cNvPr>
@@ -5322,7 +5322,7 @@
           <p:cNvPr id="4" name="Date Placeholder 3">
             <a:extLst xmlns:a="http://schemas.openxmlformats.org/drawingml/2006/main">
               <a:ext uri="{FF2B5EF4-FFF2-40B4-BE49-F238E27FC236}">
-                <a16:creationId xmlns:a16="http://schemas.microsoft.com/office/drawing/2014/main" id="{D5681373-3E9F-4ED8-92B3-207312A35029}"/>
+                <a16:creationId xmlns:a16="http://schemas.microsoft.com/office/drawing/2014/main" id="{BF69093B-2894-49BD-BC77-111048F7EE2F}"/>
               </a:ext>
             </a:extLst>
           </p:cNvPr>
@@ -5368,7 +5368,7 @@
           <p:cNvPr id="5" name="Footer Placeholder 4">
             <a:extLst xmlns:a="http://schemas.openxmlformats.org/drawingml/2006/main">
               <a:ext uri="{FF2B5EF4-FFF2-40B4-BE49-F238E27FC236}">
-                <a16:creationId xmlns:a16="http://schemas.microsoft.com/office/drawing/2014/main" id="{3B8D44A7-42C8-4025-8579-BC1FA9292813}"/>
+                <a16:creationId xmlns:a16="http://schemas.microsoft.com/office/drawing/2014/main" id="{A564FA4C-9B8E-4F8E-AC58-9B83F9203499}"/>
               </a:ext>
             </a:extLst>
           </p:cNvPr>
@@ -5410,7 +5410,7 @@
           <p:cNvPr id="6" name="Slide Number Placeholder 5">
             <a:extLst xmlns:a="http://schemas.openxmlformats.org/drawingml/2006/main">
               <a:ext uri="{FF2B5EF4-FFF2-40B4-BE49-F238E27FC236}">
-                <a16:creationId xmlns:a16="http://schemas.microsoft.com/office/drawing/2014/main" id="{2F0A2098-0853-47C4-BD4E-0D05CF9558CA}"/>
+                <a16:creationId xmlns:a16="http://schemas.microsoft.com/office/drawing/2014/main" id="{32EEB6E8-CD94-45F6-8CCA-096954F90977}"/>
               </a:ext>
             </a:extLst>
           </p:cNvPr>
@@ -5455,17 +5455,17 @@
   </p:cSld>
   <p:clrMap bg1="lt1" tx1="dk1" bg2="lt2" tx2="dk2" accent1="accent1" accent2="accent2" accent3="accent3" accent4="accent4" accent5="accent5" accent6="accent6" hlink="hlink" folHlink="folHlink"/>
   <p:sldLayoutIdLst>
-    <p:sldLayoutId xmlns:r="http://schemas.openxmlformats.org/officeDocument/2006/relationships" id="2147483649" r:id="R155d5e078f5041c8"/>
-    <p:sldLayoutId xmlns:r="http://schemas.openxmlformats.org/officeDocument/2006/relationships" id="2147483650" r:id="Rfceffbe568ad4021"/>
-    <p:sldLayoutId xmlns:r="http://schemas.openxmlformats.org/officeDocument/2006/relationships" id="2147483651" r:id="R81f394d44b364983"/>
-    <p:sldLayoutId xmlns:r="http://schemas.openxmlformats.org/officeDocument/2006/relationships" id="2147483652" r:id="R6dd83de2137241d2"/>
-    <p:sldLayoutId xmlns:r="http://schemas.openxmlformats.org/officeDocument/2006/relationships" id="2147483653" r:id="R05009a37861a461e"/>
-    <p:sldLayoutId xmlns:r="http://schemas.openxmlformats.org/officeDocument/2006/relationships" id="2147483654" r:id="Rc6511cc0fbae4e26"/>
-    <p:sldLayoutId xmlns:r="http://schemas.openxmlformats.org/officeDocument/2006/relationships" id="2147483655" r:id="Rb7ec10971e724373"/>
-    <p:sldLayoutId xmlns:r="http://schemas.openxmlformats.org/officeDocument/2006/relationships" id="2147483656" r:id="R464ed4f1fc3c424f"/>
-    <p:sldLayoutId xmlns:r="http://schemas.openxmlformats.org/officeDocument/2006/relationships" id="2147483657" r:id="Rbb05dd0c94bb412e"/>
-    <p:sldLayoutId xmlns:r="http://schemas.openxmlformats.org/officeDocument/2006/relationships" id="2147483658" r:id="R88efe05268784aed"/>
-    <p:sldLayoutId xmlns:r="http://schemas.openxmlformats.org/officeDocument/2006/relationships" id="2147483659" r:id="Ra780f3f56c4a475f"/>
+    <p:sldLayoutId xmlns:r="http://schemas.openxmlformats.org/officeDocument/2006/relationships" id="2147483649" r:id="R81a9e77a20944906"/>
+    <p:sldLayoutId xmlns:r="http://schemas.openxmlformats.org/officeDocument/2006/relationships" id="2147483650" r:id="Rba0146680ebf4aff"/>
+    <p:sldLayoutId xmlns:r="http://schemas.openxmlformats.org/officeDocument/2006/relationships" id="2147483651" r:id="R0e6cc09eca7b4837"/>
+    <p:sldLayoutId xmlns:r="http://schemas.openxmlformats.org/officeDocument/2006/relationships" id="2147483652" r:id="R31f34ca51b0148c5"/>
+    <p:sldLayoutId xmlns:r="http://schemas.openxmlformats.org/officeDocument/2006/relationships" id="2147483653" r:id="R15240216081946f0"/>
+    <p:sldLayoutId xmlns:r="http://schemas.openxmlformats.org/officeDocument/2006/relationships" id="2147483654" r:id="R965693c872f648d3"/>
+    <p:sldLayoutId xmlns:r="http://schemas.openxmlformats.org/officeDocument/2006/relationships" id="2147483655" r:id="R633aa97895434760"/>
+    <p:sldLayoutId xmlns:r="http://schemas.openxmlformats.org/officeDocument/2006/relationships" id="2147483656" r:id="Re010475ec9d641f8"/>
+    <p:sldLayoutId xmlns:r="http://schemas.openxmlformats.org/officeDocument/2006/relationships" id="2147483657" r:id="R81c6e35e28074cb0"/>
+    <p:sldLayoutId xmlns:r="http://schemas.openxmlformats.org/officeDocument/2006/relationships" id="2147483658" r:id="Rf26d059145e3479b"/>
+    <p:sldLayoutId xmlns:r="http://schemas.openxmlformats.org/officeDocument/2006/relationships" id="2147483659" r:id="Rbcb97eb59bcd4e5a"/>
   </p:sldLayoutIdLst>
   <p:txStyles>
     <p:titleStyle>
@@ -6018,7 +6018,7 @@
           <p:cNvPr id="2" name="Rectangle 1">
             <a:extLst xmlns:a="http://schemas.openxmlformats.org/drawingml/2006/main">
               <a:ext uri="{FF2B5EF4-FFF2-40B4-BE49-F238E27FC236}">
-                <a16:creationId xmlns:a16="http://schemas.microsoft.com/office/drawing/2014/main" id="{6D503E17-79D3-4B5A-B27B-C579E48FE1F4}"/>
+                <a16:creationId xmlns:a16="http://schemas.microsoft.com/office/drawing/2014/main" id="{DD954622-B252-4BB6-9886-4862C11F4918}"/>
               </a:ext>
             </a:extLst>
           </p:cNvPr>
@@ -6073,7 +6073,7 @@
           <p:cNvPr id="3" name="TextBox 2">
             <a:extLst xmlns:a="http://schemas.openxmlformats.org/drawingml/2006/main">
               <a:ext uri="{FF2B5EF4-FFF2-40B4-BE49-F238E27FC236}">
-                <a16:creationId xmlns:a16="http://schemas.microsoft.com/office/drawing/2014/main" id="{DBCAC493-BAF1-40AF-938F-47205524ADA4}"/>
+                <a16:creationId xmlns:a16="http://schemas.microsoft.com/office/drawing/2014/main" id="{5D4FDF2D-12BC-41D4-A640-52547C9C4E06}"/>
               </a:ext>
             </a:extLst>
           </p:cNvPr>
@@ -6120,7 +6120,7 @@
           <p:cNvPr id="4" name="TextBox 3">
             <a:extLst xmlns:a="http://schemas.openxmlformats.org/drawingml/2006/main">
               <a:ext uri="{FF2B5EF4-FFF2-40B4-BE49-F238E27FC236}">
-                <a16:creationId xmlns:a16="http://schemas.microsoft.com/office/drawing/2014/main" id="{5ABBC59F-0684-4A01-A24A-176E47F963F4}"/>
+                <a16:creationId xmlns:a16="http://schemas.microsoft.com/office/drawing/2014/main" id="{792C2E5B-4A03-44EA-BA40-33FF8B9D56D3}"/>
               </a:ext>
             </a:extLst>
           </p:cNvPr>
@@ -6188,7 +6188,7 @@
           <p:cNvPr id="5" name="TextBox 4">
             <a:extLst xmlns:a="http://schemas.openxmlformats.org/drawingml/2006/main">
               <a:ext uri="{FF2B5EF4-FFF2-40B4-BE49-F238E27FC236}">
-                <a16:creationId xmlns:a16="http://schemas.microsoft.com/office/drawing/2014/main" id="{A4D6E15A-247D-4891-B3E0-E72189176EDF}"/>
+                <a16:creationId xmlns:a16="http://schemas.microsoft.com/office/drawing/2014/main" id="{C75286D3-3980-42E7-8CE4-5A705207FF8B}"/>
               </a:ext>
             </a:extLst>
           </p:cNvPr>
@@ -6235,7 +6235,7 @@
           <p:cNvPr id="6" name="Rectangle 5">
             <a:extLst xmlns:a="http://schemas.openxmlformats.org/drawingml/2006/main">
               <a:ext uri="{FF2B5EF4-FFF2-40B4-BE49-F238E27FC236}">
-                <a16:creationId xmlns:a16="http://schemas.microsoft.com/office/drawing/2014/main" id="{6032E93A-832A-4E89-A460-529F837E6831}"/>
+                <a16:creationId xmlns:a16="http://schemas.microsoft.com/office/drawing/2014/main" id="{7C2874BB-028E-4BFF-B725-72D1F43974A0}"/>
               </a:ext>
             </a:extLst>
           </p:cNvPr>
@@ -6290,7 +6290,7 @@
           <p:cNvPr id="7" name="TextBox 6">
             <a:extLst xmlns:a="http://schemas.openxmlformats.org/drawingml/2006/main">
               <a:ext uri="{FF2B5EF4-FFF2-40B4-BE49-F238E27FC236}">
-                <a16:creationId xmlns:a16="http://schemas.microsoft.com/office/drawing/2014/main" id="{B9EF7646-FF06-407B-9375-295FD11E28F7}"/>
+                <a16:creationId xmlns:a16="http://schemas.microsoft.com/office/drawing/2014/main" id="{12D623E3-273C-4C66-9547-83DD023D1E67}"/>
               </a:ext>
             </a:extLst>
           </p:cNvPr>
@@ -6337,7 +6337,7 @@
           <p:cNvPr id="8" name="TextBox 7">
             <a:extLst xmlns:a="http://schemas.openxmlformats.org/drawingml/2006/main">
               <a:ext uri="{FF2B5EF4-FFF2-40B4-BE49-F238E27FC236}">
-                <a16:creationId xmlns:a16="http://schemas.microsoft.com/office/drawing/2014/main" id="{9B8DBE83-FE04-42C1-A432-5FD464A57C21}"/>
+                <a16:creationId xmlns:a16="http://schemas.microsoft.com/office/drawing/2014/main" id="{B830A4CD-4C82-4CF3-A914-F4C4AFD8AFCB}"/>
               </a:ext>
             </a:extLst>
           </p:cNvPr>
@@ -6374,7 +6374,7 @@
                 <a:ea typeface="Aptos"/>
                 <a:cs typeface="Aptos"/>
               </a:rPr>
-              <a:t>2026.07.22-8</a:t>
+              <a:t>2026.07.22-9</a:t>
             </a:r>
           </a:p>
         </p:txBody>
@@ -6384,7 +6384,7 @@
           <p:cNvPr id="9" name="TextBox 8">
             <a:extLst xmlns:a="http://schemas.openxmlformats.org/drawingml/2006/main">
               <a:ext uri="{FF2B5EF4-FFF2-40B4-BE49-F238E27FC236}">
-                <a16:creationId xmlns:a16="http://schemas.microsoft.com/office/drawing/2014/main" id="{2D609DB8-5CF7-4F45-B697-B1066B85441E}"/>
+                <a16:creationId xmlns:a16="http://schemas.microsoft.com/office/drawing/2014/main" id="{583B0AD9-62B5-4E9A-B59C-B3DF1665A79B}"/>
               </a:ext>
             </a:extLst>
           </p:cNvPr>
@@ -6452,7 +6452,7 @@
           <p:cNvPr id="10" name="TextBox 9">
             <a:extLst xmlns:a="http://schemas.openxmlformats.org/drawingml/2006/main">
               <a:ext uri="{FF2B5EF4-FFF2-40B4-BE49-F238E27FC236}">
-                <a16:creationId xmlns:a16="http://schemas.microsoft.com/office/drawing/2014/main" id="{A150DE0A-4BBF-4175-AB59-FB865EA96356}"/>
+                <a16:creationId xmlns:a16="http://schemas.microsoft.com/office/drawing/2014/main" id="{6DDC634D-1984-4241-B506-3B4DD7DA4F4E}"/>
               </a:ext>
             </a:extLst>
           </p:cNvPr>
@@ -6499,7 +6499,7 @@
           <p:cNvPr id="11" name="TextBox 10">
             <a:extLst xmlns:a="http://schemas.openxmlformats.org/drawingml/2006/main">
               <a:ext uri="{FF2B5EF4-FFF2-40B4-BE49-F238E27FC236}">
-                <a16:creationId xmlns:a16="http://schemas.microsoft.com/office/drawing/2014/main" id="{B3FBF516-5785-4B31-87C8-80BE94E3D96D}"/>
+                <a16:creationId xmlns:a16="http://schemas.microsoft.com/office/drawing/2014/main" id="{4BD4CBCF-ACD6-47E6-AD4C-F62FFAE120A5}"/>
               </a:ext>
             </a:extLst>
           </p:cNvPr>
@@ -6546,7 +6546,7 @@
           <p:cNvPr id="12" name="TextBox 11">
             <a:extLst xmlns:a="http://schemas.openxmlformats.org/drawingml/2006/main">
               <a:ext uri="{FF2B5EF4-FFF2-40B4-BE49-F238E27FC236}">
-                <a16:creationId xmlns:a16="http://schemas.microsoft.com/office/drawing/2014/main" id="{E804C718-3A1D-4E29-A11A-3C568BD6B98C}"/>
+                <a16:creationId xmlns:a16="http://schemas.microsoft.com/office/drawing/2014/main" id="{D6DA264B-2DC6-4EF5-BFD6-DF2BF6D90D34}"/>
               </a:ext>
             </a:extLst>
           </p:cNvPr>
@@ -6591,7 +6591,7 @@
     </p:spTree>
     <p:extLst>
       <p:ext uri="{BB962C8B-B14F-4D97-AF65-F5344CB8AC3E}">
-        <p14:creationId xmlns:p14="http://schemas.microsoft.com/office/powerpoint/2010/main" val="768524673"/>
+        <p14:creationId xmlns:p14="http://schemas.microsoft.com/office/powerpoint/2010/main" val="740424126"/>
       </p:ext>
     </p:extLst>
   </p:cSld>
@@ -6615,7 +6615,7 @@
           <p:cNvPr id="2" name="TextBox 1">
             <a:extLst xmlns:a="http://schemas.openxmlformats.org/drawingml/2006/main">
               <a:ext uri="{FF2B5EF4-FFF2-40B4-BE49-F238E27FC236}">
-                <a16:creationId xmlns:a16="http://schemas.microsoft.com/office/drawing/2014/main" id="{59C45BB6-D56E-48F8-A679-651379D82ACC}"/>
+                <a16:creationId xmlns:a16="http://schemas.microsoft.com/office/drawing/2014/main" id="{D268E322-EDD7-4B18-9AEA-77ABB93B604C}"/>
               </a:ext>
             </a:extLst>
           </p:cNvPr>
@@ -6662,7 +6662,7 @@
           <p:cNvPr id="3" name="TextBox 2">
             <a:extLst xmlns:a="http://schemas.openxmlformats.org/drawingml/2006/main">
               <a:ext uri="{FF2B5EF4-FFF2-40B4-BE49-F238E27FC236}">
-                <a16:creationId xmlns:a16="http://schemas.microsoft.com/office/drawing/2014/main" id="{D3177054-5663-4F90-B0E9-99E70D4072BB}"/>
+                <a16:creationId xmlns:a16="http://schemas.microsoft.com/office/drawing/2014/main" id="{3265EDCF-C001-4662-9C33-EF329B166CEF}"/>
               </a:ext>
             </a:extLst>
           </p:cNvPr>
@@ -6709,7 +6709,7 @@
           <p:cNvPr id="4" name="Rectangle 3">
             <a:extLst xmlns:a="http://schemas.openxmlformats.org/drawingml/2006/main">
               <a:ext uri="{FF2B5EF4-FFF2-40B4-BE49-F238E27FC236}">
-                <a16:creationId xmlns:a16="http://schemas.microsoft.com/office/drawing/2014/main" id="{CB564E50-B3B1-4A5D-871F-5989D8C6CAB2}"/>
+                <a16:creationId xmlns:a16="http://schemas.microsoft.com/office/drawing/2014/main" id="{039BC21F-7DD1-4F28-A336-CC1F0BBB7F16}"/>
               </a:ext>
             </a:extLst>
           </p:cNvPr>
@@ -6764,7 +6764,7 @@
           <p:cNvPr id="5" name="Rectangle 4">
             <a:extLst xmlns:a="http://schemas.openxmlformats.org/drawingml/2006/main">
               <a:ext uri="{FF2B5EF4-FFF2-40B4-BE49-F238E27FC236}">
-                <a16:creationId xmlns:a16="http://schemas.microsoft.com/office/drawing/2014/main" id="{20FB9A5F-FA91-49FD-8BC3-B9CBCFC005DD}"/>
+                <a16:creationId xmlns:a16="http://schemas.microsoft.com/office/drawing/2014/main" id="{24A40B15-2E87-43CD-BD70-026406062D3E}"/>
               </a:ext>
             </a:extLst>
           </p:cNvPr>
@@ -6819,7 +6819,7 @@
           <p:cNvPr id="6" name="TextBox 5">
             <a:extLst xmlns:a="http://schemas.openxmlformats.org/drawingml/2006/main">
               <a:ext uri="{FF2B5EF4-FFF2-40B4-BE49-F238E27FC236}">
-                <a16:creationId xmlns:a16="http://schemas.microsoft.com/office/drawing/2014/main" id="{0EB67338-D202-4893-98FE-E5DE28315BE9}"/>
+                <a16:creationId xmlns:a16="http://schemas.microsoft.com/office/drawing/2014/main" id="{0A1141D7-3E13-43F4-B6DB-EC2E58B84785}"/>
               </a:ext>
             </a:extLst>
           </p:cNvPr>
@@ -6856,7 +6856,7 @@
                 <a:ea typeface="Aptos"/>
                 <a:cs typeface="Aptos"/>
               </a:rPr>
-              <a:t>Independent public evidence summary · 2026.07.22-8 · 2026-07-22 · Sources: RPX; CNIPA guidance; EPO family</a:t>
+              <a:t>Independent public evidence summary · 2026.07.22-9 · 2026-07-22 · Sources: RPX; CNIPA guidance; EPO family</a:t>
             </a:r>
           </a:p>
         </p:txBody>
@@ -6866,7 +6866,7 @@
           <p:cNvPr id="7" name="TextBox 6">
             <a:extLst xmlns:a="http://schemas.openxmlformats.org/drawingml/2006/main">
               <a:ext uri="{FF2B5EF4-FFF2-40B4-BE49-F238E27FC236}">
-                <a16:creationId xmlns:a16="http://schemas.microsoft.com/office/drawing/2014/main" id="{487364A2-EE86-4D6B-B6E8-68C216013DAD}"/>
+                <a16:creationId xmlns:a16="http://schemas.microsoft.com/office/drawing/2014/main" id="{6326962D-FBED-4D6F-A996-5973E274A00E}"/>
               </a:ext>
             </a:extLst>
           </p:cNvPr>
@@ -6913,7 +6913,7 @@
           <p:cNvPr id="8" name="TextBox 7">
             <a:extLst xmlns:a="http://schemas.openxmlformats.org/drawingml/2006/main">
               <a:ext uri="{FF2B5EF4-FFF2-40B4-BE49-F238E27FC236}">
-                <a16:creationId xmlns:a16="http://schemas.microsoft.com/office/drawing/2014/main" id="{A4F1E488-D5F7-4EA2-BE7B-4C60A42461E7}"/>
+                <a16:creationId xmlns:a16="http://schemas.microsoft.com/office/drawing/2014/main" id="{ACD0CBEA-0DDC-41D1-9A14-14CB66082468}"/>
               </a:ext>
             </a:extLst>
           </p:cNvPr>
@@ -6960,7 +6960,7 @@
           <p:cNvPr id="9" name="TextBox 8">
             <a:extLst xmlns:a="http://schemas.openxmlformats.org/drawingml/2006/main">
               <a:ext uri="{FF2B5EF4-FFF2-40B4-BE49-F238E27FC236}">
-                <a16:creationId xmlns:a16="http://schemas.microsoft.com/office/drawing/2014/main" id="{E56B9AAD-2D05-4A43-9C98-073FEDD6F154}"/>
+                <a16:creationId xmlns:a16="http://schemas.microsoft.com/office/drawing/2014/main" id="{6C0F58FB-2CA0-49EE-AA2E-691F7847C05F}"/>
               </a:ext>
             </a:extLst>
           </p:cNvPr>
@@ -7057,7 +7057,7 @@
           <p:cNvPr id="10" name="Rounded Rectangle 9">
             <a:extLst xmlns:a="http://schemas.openxmlformats.org/drawingml/2006/main">
               <a:ext uri="{FF2B5EF4-FFF2-40B4-BE49-F238E27FC236}">
-                <a16:creationId xmlns:a16="http://schemas.microsoft.com/office/drawing/2014/main" id="{E38C0B5C-0A08-4C5A-B60B-412FFA1BDD7B}"/>
+                <a16:creationId xmlns:a16="http://schemas.microsoft.com/office/drawing/2014/main" id="{E8AEEFEC-61EF-4F64-BC01-3A754B9AC943}"/>
               </a:ext>
             </a:extLst>
           </p:cNvPr>
@@ -7114,7 +7114,7 @@
           <p:cNvPr id="11" name="TextBox 10">
             <a:extLst xmlns:a="http://schemas.openxmlformats.org/drawingml/2006/main">
               <a:ext uri="{FF2B5EF4-FFF2-40B4-BE49-F238E27FC236}">
-                <a16:creationId xmlns:a16="http://schemas.microsoft.com/office/drawing/2014/main" id="{44B629AA-2AE5-4770-A396-59EA3914D52D}"/>
+                <a16:creationId xmlns:a16="http://schemas.microsoft.com/office/drawing/2014/main" id="{9E551C28-2294-49AD-842D-184107772AB5}"/>
               </a:ext>
             </a:extLst>
           </p:cNvPr>
@@ -7161,7 +7161,7 @@
           <p:cNvPr id="12" name="TextBox 11">
             <a:extLst xmlns:a="http://schemas.openxmlformats.org/drawingml/2006/main">
               <a:ext uri="{FF2B5EF4-FFF2-40B4-BE49-F238E27FC236}">
-                <a16:creationId xmlns:a16="http://schemas.microsoft.com/office/drawing/2014/main" id="{881E536E-D9D1-40FA-B95C-8830CB8D0AA5}"/>
+                <a16:creationId xmlns:a16="http://schemas.microsoft.com/office/drawing/2014/main" id="{262C9C30-379F-4B90-B6B6-1892A4AA693E}"/>
               </a:ext>
             </a:extLst>
           </p:cNvPr>
@@ -7206,7 +7206,7 @@
     </p:spTree>
     <p:extLst>
       <p:ext uri="{BB962C8B-B14F-4D97-AF65-F5344CB8AC3E}">
-        <p14:creationId xmlns:p14="http://schemas.microsoft.com/office/powerpoint/2010/main" val="467708196"/>
+        <p14:creationId xmlns:p14="http://schemas.microsoft.com/office/powerpoint/2010/main" val="2007796088"/>
       </p:ext>
     </p:extLst>
   </p:cSld>
@@ -7230,7 +7230,7 @@
           <p:cNvPr id="2" name="TextBox 1">
             <a:extLst xmlns:a="http://schemas.openxmlformats.org/drawingml/2006/main">
               <a:ext uri="{FF2B5EF4-FFF2-40B4-BE49-F238E27FC236}">
-                <a16:creationId xmlns:a16="http://schemas.microsoft.com/office/drawing/2014/main" id="{0BAF5A30-829A-474A-A55A-7CFCBEDB79DA}"/>
+                <a16:creationId xmlns:a16="http://schemas.microsoft.com/office/drawing/2014/main" id="{B6AF9ACC-9A10-488D-8332-C6C0D934CC62}"/>
               </a:ext>
             </a:extLst>
           </p:cNvPr>
@@ -7277,7 +7277,7 @@
           <p:cNvPr id="3" name="TextBox 2">
             <a:extLst xmlns:a="http://schemas.openxmlformats.org/drawingml/2006/main">
               <a:ext uri="{FF2B5EF4-FFF2-40B4-BE49-F238E27FC236}">
-                <a16:creationId xmlns:a16="http://schemas.microsoft.com/office/drawing/2014/main" id="{CCBD63AA-E924-46CF-807C-2BCFB6C83AD2}"/>
+                <a16:creationId xmlns:a16="http://schemas.microsoft.com/office/drawing/2014/main" id="{90BFEDF8-C461-47BE-BC5D-CF4F1AE631A2}"/>
               </a:ext>
             </a:extLst>
           </p:cNvPr>
@@ -7324,7 +7324,7 @@
           <p:cNvPr id="4" name="Rectangle 3">
             <a:extLst xmlns:a="http://schemas.openxmlformats.org/drawingml/2006/main">
               <a:ext uri="{FF2B5EF4-FFF2-40B4-BE49-F238E27FC236}">
-                <a16:creationId xmlns:a16="http://schemas.microsoft.com/office/drawing/2014/main" id="{FA9CA240-9B4B-425F-8FF6-AC05AE974E93}"/>
+                <a16:creationId xmlns:a16="http://schemas.microsoft.com/office/drawing/2014/main" id="{A7A5D4EB-80E0-4991-AAFB-6242914E08DE}"/>
               </a:ext>
             </a:extLst>
           </p:cNvPr>
@@ -7379,7 +7379,7 @@
           <p:cNvPr id="5" name="Rectangle 4">
             <a:extLst xmlns:a="http://schemas.openxmlformats.org/drawingml/2006/main">
               <a:ext uri="{FF2B5EF4-FFF2-40B4-BE49-F238E27FC236}">
-                <a16:creationId xmlns:a16="http://schemas.microsoft.com/office/drawing/2014/main" id="{A859EDF8-EE1A-45D8-80A7-9FAB85476A95}"/>
+                <a16:creationId xmlns:a16="http://schemas.microsoft.com/office/drawing/2014/main" id="{8FE3D0F6-1CD9-417F-AE6C-EADEA96F28C5}"/>
               </a:ext>
             </a:extLst>
           </p:cNvPr>
@@ -7434,7 +7434,7 @@
           <p:cNvPr id="6" name="TextBox 5">
             <a:extLst xmlns:a="http://schemas.openxmlformats.org/drawingml/2006/main">
               <a:ext uri="{FF2B5EF4-FFF2-40B4-BE49-F238E27FC236}">
-                <a16:creationId xmlns:a16="http://schemas.microsoft.com/office/drawing/2014/main" id="{3B4A108F-59BA-4DEB-9F13-611321A5B929}"/>
+                <a16:creationId xmlns:a16="http://schemas.microsoft.com/office/drawing/2014/main" id="{B04B292D-9C96-4D89-A6F9-183D4A72DD72}"/>
               </a:ext>
             </a:extLst>
           </p:cNvPr>
@@ -7471,7 +7471,7 @@
                 <a:ea typeface="Aptos"/>
                 <a:cs typeface="Aptos"/>
               </a:rPr>
-              <a:t>Independent public evidence summary · 2026.07.22-8 · 2026-07-22 · Sources: IP Australia; PRH; EPO; EPO / UPC; USPTO</a:t>
+              <a:t>Independent public evidence summary · 2026.07.22-9 · 2026-07-22 · Sources: IP Australia; PRH; EPO; EPO / UPC; USPTO</a:t>
             </a:r>
           </a:p>
         </p:txBody>
@@ -7481,7 +7481,7 @@
           <p:cNvPr id="7" name="TextBox 6">
             <a:extLst xmlns:a="http://schemas.openxmlformats.org/drawingml/2006/main">
               <a:ext uri="{FF2B5EF4-FFF2-40B4-BE49-F238E27FC236}">
-                <a16:creationId xmlns:a16="http://schemas.microsoft.com/office/drawing/2014/main" id="{BCAE9A08-19FA-4203-B17A-9A811CC26FE7}"/>
+                <a16:creationId xmlns:a16="http://schemas.microsoft.com/office/drawing/2014/main" id="{B0F0E5FA-069C-4BDF-AAB8-8C6817FA5FEB}"/>
               </a:ext>
             </a:extLst>
           </p:cNvPr>
@@ -7968,7 +7968,7 @@
           <p:cNvPr id="9" name="TextBox 8">
             <a:extLst xmlns:a="http://schemas.openxmlformats.org/drawingml/2006/main">
               <a:ext uri="{FF2B5EF4-FFF2-40B4-BE49-F238E27FC236}">
-                <a16:creationId xmlns:a16="http://schemas.microsoft.com/office/drawing/2014/main" id="{12973C98-F6E0-4933-835C-BD0323C04C43}"/>
+                <a16:creationId xmlns:a16="http://schemas.microsoft.com/office/drawing/2014/main" id="{01F8A7B3-4815-4C6E-AE6A-D26A0228EDFF}"/>
               </a:ext>
             </a:extLst>
           </p:cNvPr>
@@ -8013,7 +8013,7 @@
     </p:spTree>
     <p:extLst>
       <p:ext uri="{BB962C8B-B14F-4D97-AF65-F5344CB8AC3E}">
-        <p14:creationId xmlns:p14="http://schemas.microsoft.com/office/powerpoint/2010/main" val="2024552900"/>
+        <p14:creationId xmlns:p14="http://schemas.microsoft.com/office/powerpoint/2010/main" val="1771571262"/>
       </p:ext>
     </p:extLst>
   </p:cSld>
@@ -8037,7 +8037,7 @@
           <p:cNvPr id="2" name="TextBox 1">
             <a:extLst xmlns:a="http://schemas.openxmlformats.org/drawingml/2006/main">
               <a:ext uri="{FF2B5EF4-FFF2-40B4-BE49-F238E27FC236}">
-                <a16:creationId xmlns:a16="http://schemas.microsoft.com/office/drawing/2014/main" id="{E29E634A-8FF3-4D93-867C-10F1FB658659}"/>
+                <a16:creationId xmlns:a16="http://schemas.microsoft.com/office/drawing/2014/main" id="{1B848FBE-732B-4C9F-A0E1-5EE818656414}"/>
               </a:ext>
             </a:extLst>
           </p:cNvPr>
@@ -8084,7 +8084,7 @@
           <p:cNvPr id="3" name="TextBox 2">
             <a:extLst xmlns:a="http://schemas.openxmlformats.org/drawingml/2006/main">
               <a:ext uri="{FF2B5EF4-FFF2-40B4-BE49-F238E27FC236}">
-                <a16:creationId xmlns:a16="http://schemas.microsoft.com/office/drawing/2014/main" id="{5EC08E6A-6165-4F61-BDCB-CE9692AB14D3}"/>
+                <a16:creationId xmlns:a16="http://schemas.microsoft.com/office/drawing/2014/main" id="{4F94AF81-1AB6-4EB5-9235-C85BBFF7D007}"/>
               </a:ext>
             </a:extLst>
           </p:cNvPr>
@@ -8131,7 +8131,7 @@
           <p:cNvPr id="4" name="Rectangle 3">
             <a:extLst xmlns:a="http://schemas.openxmlformats.org/drawingml/2006/main">
               <a:ext uri="{FF2B5EF4-FFF2-40B4-BE49-F238E27FC236}">
-                <a16:creationId xmlns:a16="http://schemas.microsoft.com/office/drawing/2014/main" id="{787EC350-3FA8-4709-BED9-6C0A67A14248}"/>
+                <a16:creationId xmlns:a16="http://schemas.microsoft.com/office/drawing/2014/main" id="{FC4BD03F-6AB8-4339-8822-A32241C9E9D5}"/>
               </a:ext>
             </a:extLst>
           </p:cNvPr>
@@ -8186,7 +8186,7 @@
           <p:cNvPr id="5" name="Rectangle 4">
             <a:extLst xmlns:a="http://schemas.openxmlformats.org/drawingml/2006/main">
               <a:ext uri="{FF2B5EF4-FFF2-40B4-BE49-F238E27FC236}">
-                <a16:creationId xmlns:a16="http://schemas.microsoft.com/office/drawing/2014/main" id="{FB63E2C3-FA1A-4F6B-8CDE-1C02F1AA59D3}"/>
+                <a16:creationId xmlns:a16="http://schemas.microsoft.com/office/drawing/2014/main" id="{D46CDFFC-86CC-4130-838E-65EDAD4393CE}"/>
               </a:ext>
             </a:extLst>
           </p:cNvPr>
@@ -8241,7 +8241,7 @@
           <p:cNvPr id="6" name="TextBox 5">
             <a:extLst xmlns:a="http://schemas.openxmlformats.org/drawingml/2006/main">
               <a:ext uri="{FF2B5EF4-FFF2-40B4-BE49-F238E27FC236}">
-                <a16:creationId xmlns:a16="http://schemas.microsoft.com/office/drawing/2014/main" id="{E327AFEC-974D-4468-9AAB-4579713EBCE3}"/>
+                <a16:creationId xmlns:a16="http://schemas.microsoft.com/office/drawing/2014/main" id="{F61BB9C8-86C2-412F-94C5-D9276D1B8531}"/>
               </a:ext>
             </a:extLst>
           </p:cNvPr>
@@ -8278,7 +8278,7 @@
                 <a:ea typeface="Aptos"/>
                 <a:cs typeface="Aptos"/>
               </a:rPr>
-              <a:t>Independent public evidence summary · 2026.07.22-8 · 2026-07-22 · Sources: UN; Atlas</a:t>
+              <a:t>Independent public evidence summary · 2026.07.22-9 · 2026-07-22 · Sources: UN; Atlas</a:t>
             </a:r>
           </a:p>
         </p:txBody>
@@ -8288,7 +8288,7 @@
           <p:cNvPr id="7" name="TextBox 6">
             <a:extLst xmlns:a="http://schemas.openxmlformats.org/drawingml/2006/main">
               <a:ext uri="{FF2B5EF4-FFF2-40B4-BE49-F238E27FC236}">
-                <a16:creationId xmlns:a16="http://schemas.microsoft.com/office/drawing/2014/main" id="{D0FE06E3-41B4-4891-A25B-62A933492E66}"/>
+                <a16:creationId xmlns:a16="http://schemas.microsoft.com/office/drawing/2014/main" id="{35F21FE3-C3CD-42FC-A3E0-AF12F30741B8}"/>
               </a:ext>
             </a:extLst>
           </p:cNvPr>
@@ -8335,7 +8335,7 @@
           <p:cNvPr id="8" name="Rounded Rectangle 7">
             <a:extLst xmlns:a="http://schemas.openxmlformats.org/drawingml/2006/main">
               <a:ext uri="{FF2B5EF4-FFF2-40B4-BE49-F238E27FC236}">
-                <a16:creationId xmlns:a16="http://schemas.microsoft.com/office/drawing/2014/main" id="{E41E4915-B188-4BF6-B59A-71174674A8D7}"/>
+                <a16:creationId xmlns:a16="http://schemas.microsoft.com/office/drawing/2014/main" id="{7C8E7FD7-6C4A-4AF2-B2D9-C013C5669F2B}"/>
               </a:ext>
             </a:extLst>
           </p:cNvPr>
@@ -8392,7 +8392,7 @@
           <p:cNvPr id="9" name="TextBox 8">
             <a:extLst xmlns:a="http://schemas.openxmlformats.org/drawingml/2006/main">
               <a:ext uri="{FF2B5EF4-FFF2-40B4-BE49-F238E27FC236}">
-                <a16:creationId xmlns:a16="http://schemas.microsoft.com/office/drawing/2014/main" id="{B1120C88-F2C0-47FB-A0FF-A14770A50B68}"/>
+                <a16:creationId xmlns:a16="http://schemas.microsoft.com/office/drawing/2014/main" id="{C8579EB4-EA27-47F3-8747-DA0792F1CE81}"/>
               </a:ext>
             </a:extLst>
           </p:cNvPr>
@@ -8439,7 +8439,7 @@
           <p:cNvPr id="10" name="TextBox 9">
             <a:extLst xmlns:a="http://schemas.openxmlformats.org/drawingml/2006/main">
               <a:ext uri="{FF2B5EF4-FFF2-40B4-BE49-F238E27FC236}">
-                <a16:creationId xmlns:a16="http://schemas.microsoft.com/office/drawing/2014/main" id="{8AF6AD5A-FF74-4410-863F-9EA83CBAD0D2}"/>
+                <a16:creationId xmlns:a16="http://schemas.microsoft.com/office/drawing/2014/main" id="{17BE9D3B-B4A6-44D2-80A7-7491C695FBC0}"/>
               </a:ext>
             </a:extLst>
           </p:cNvPr>
@@ -8486,7 +8486,7 @@
           <p:cNvPr id="11" name="Rounded Rectangle 10">
             <a:extLst xmlns:a="http://schemas.openxmlformats.org/drawingml/2006/main">
               <a:ext uri="{FF2B5EF4-FFF2-40B4-BE49-F238E27FC236}">
-                <a16:creationId xmlns:a16="http://schemas.microsoft.com/office/drawing/2014/main" id="{AEF62206-73E4-4BA7-90BE-BE92023DF294}"/>
+                <a16:creationId xmlns:a16="http://schemas.microsoft.com/office/drawing/2014/main" id="{74D1EC7B-2587-4CDB-9C69-5CAA92EFC1DF}"/>
               </a:ext>
             </a:extLst>
           </p:cNvPr>
@@ -8543,7 +8543,7 @@
           <p:cNvPr id="12" name="TextBox 11">
             <a:extLst xmlns:a="http://schemas.openxmlformats.org/drawingml/2006/main">
               <a:ext uri="{FF2B5EF4-FFF2-40B4-BE49-F238E27FC236}">
-                <a16:creationId xmlns:a16="http://schemas.microsoft.com/office/drawing/2014/main" id="{6EC09B54-C26A-4476-A522-017D6FFE98D8}"/>
+                <a16:creationId xmlns:a16="http://schemas.microsoft.com/office/drawing/2014/main" id="{BC275A3F-A3F7-4E7A-94F5-C60FF570D8A9}"/>
               </a:ext>
             </a:extLst>
           </p:cNvPr>
@@ -8590,7 +8590,7 @@
           <p:cNvPr id="13" name="TextBox 12">
             <a:extLst xmlns:a="http://schemas.openxmlformats.org/drawingml/2006/main">
               <a:ext uri="{FF2B5EF4-FFF2-40B4-BE49-F238E27FC236}">
-                <a16:creationId xmlns:a16="http://schemas.microsoft.com/office/drawing/2014/main" id="{02CAD627-1C50-42B7-B72F-29BAF4AE29B6}"/>
+                <a16:creationId xmlns:a16="http://schemas.microsoft.com/office/drawing/2014/main" id="{BFCBABE1-97BE-4097-9FA5-24CF92AE5813}"/>
               </a:ext>
             </a:extLst>
           </p:cNvPr>
@@ -8637,7 +8637,7 @@
           <p:cNvPr id="14" name="Rounded Rectangle 13">
             <a:extLst xmlns:a="http://schemas.openxmlformats.org/drawingml/2006/main">
               <a:ext uri="{FF2B5EF4-FFF2-40B4-BE49-F238E27FC236}">
-                <a16:creationId xmlns:a16="http://schemas.microsoft.com/office/drawing/2014/main" id="{291B8B7E-62B2-4E01-811E-F168CDF0545E}"/>
+                <a16:creationId xmlns:a16="http://schemas.microsoft.com/office/drawing/2014/main" id="{F77C224F-1C07-4799-965D-0915124B1052}"/>
               </a:ext>
             </a:extLst>
           </p:cNvPr>
@@ -8694,7 +8694,7 @@
           <p:cNvPr id="15" name="TextBox 14">
             <a:extLst xmlns:a="http://schemas.openxmlformats.org/drawingml/2006/main">
               <a:ext uri="{FF2B5EF4-FFF2-40B4-BE49-F238E27FC236}">
-                <a16:creationId xmlns:a16="http://schemas.microsoft.com/office/drawing/2014/main" id="{A7C87468-64E7-427C-8556-C0D6040C1306}"/>
+                <a16:creationId xmlns:a16="http://schemas.microsoft.com/office/drawing/2014/main" id="{D4486C71-C47C-476D-9F89-23CB44770ABC}"/>
               </a:ext>
             </a:extLst>
           </p:cNvPr>
@@ -8741,7 +8741,7 @@
           <p:cNvPr id="16" name="TextBox 15">
             <a:extLst xmlns:a="http://schemas.openxmlformats.org/drawingml/2006/main">
               <a:ext uri="{FF2B5EF4-FFF2-40B4-BE49-F238E27FC236}">
-                <a16:creationId xmlns:a16="http://schemas.microsoft.com/office/drawing/2014/main" id="{4DA49FD2-F046-4E09-AE82-ABCAAD363821}"/>
+                <a16:creationId xmlns:a16="http://schemas.microsoft.com/office/drawing/2014/main" id="{527BD842-379E-418D-9C6A-EB4AE5CD5B94}"/>
               </a:ext>
             </a:extLst>
           </p:cNvPr>
@@ -8788,7 +8788,7 @@
           <p:cNvPr id="17" name="Rounded Rectangle 16">
             <a:extLst xmlns:a="http://schemas.openxmlformats.org/drawingml/2006/main">
               <a:ext uri="{FF2B5EF4-FFF2-40B4-BE49-F238E27FC236}">
-                <a16:creationId xmlns:a16="http://schemas.microsoft.com/office/drawing/2014/main" id="{42AEE45A-9019-45EE-AC25-8099A072A933}"/>
+                <a16:creationId xmlns:a16="http://schemas.microsoft.com/office/drawing/2014/main" id="{662168AA-21E6-4F50-B55A-FEED54F92F41}"/>
               </a:ext>
             </a:extLst>
           </p:cNvPr>
@@ -8845,7 +8845,7 @@
           <p:cNvPr id="18" name="TextBox 17">
             <a:extLst xmlns:a="http://schemas.openxmlformats.org/drawingml/2006/main">
               <a:ext uri="{FF2B5EF4-FFF2-40B4-BE49-F238E27FC236}">
-                <a16:creationId xmlns:a16="http://schemas.microsoft.com/office/drawing/2014/main" id="{B2A9619E-D287-4E33-9DA8-9E7FB398FC2B}"/>
+                <a16:creationId xmlns:a16="http://schemas.microsoft.com/office/drawing/2014/main" id="{8BF0CFF4-92D9-4DEA-9649-8C2323FF9D78}"/>
               </a:ext>
             </a:extLst>
           </p:cNvPr>
@@ -8892,7 +8892,7 @@
           <p:cNvPr id="19" name="TextBox 18">
             <a:extLst xmlns:a="http://schemas.openxmlformats.org/drawingml/2006/main">
               <a:ext uri="{FF2B5EF4-FFF2-40B4-BE49-F238E27FC236}">
-                <a16:creationId xmlns:a16="http://schemas.microsoft.com/office/drawing/2014/main" id="{2A6D844D-8773-4313-B01A-25849387A584}"/>
+                <a16:creationId xmlns:a16="http://schemas.microsoft.com/office/drawing/2014/main" id="{59D499BE-DACA-408E-AF32-2945FEAE138D}"/>
               </a:ext>
             </a:extLst>
           </p:cNvPr>
@@ -8939,7 +8939,7 @@
           <p:cNvPr id="20" name="TextBox 19">
             <a:extLst xmlns:a="http://schemas.openxmlformats.org/drawingml/2006/main">
               <a:ext uri="{FF2B5EF4-FFF2-40B4-BE49-F238E27FC236}">
-                <a16:creationId xmlns:a16="http://schemas.microsoft.com/office/drawing/2014/main" id="{EE07C1F4-F115-4C80-9D84-27807D5CC2C4}"/>
+                <a16:creationId xmlns:a16="http://schemas.microsoft.com/office/drawing/2014/main" id="{C4653E20-4299-43C9-9AC3-8EAC0E9DD444}"/>
               </a:ext>
             </a:extLst>
           </p:cNvPr>
@@ -8986,7 +8986,7 @@
           <p:cNvPr id="21" name="Rounded Rectangle 20">
             <a:extLst xmlns:a="http://schemas.openxmlformats.org/drawingml/2006/main">
               <a:ext uri="{FF2B5EF4-FFF2-40B4-BE49-F238E27FC236}">
-                <a16:creationId xmlns:a16="http://schemas.microsoft.com/office/drawing/2014/main" id="{702813B9-F700-497C-AE86-C36B8D71CFBD}"/>
+                <a16:creationId xmlns:a16="http://schemas.microsoft.com/office/drawing/2014/main" id="{3DCE39FF-28F1-49E3-81C0-D6079E4C23D3}"/>
               </a:ext>
             </a:extLst>
           </p:cNvPr>
@@ -9043,7 +9043,7 @@
           <p:cNvPr id="22" name="TextBox 21">
             <a:extLst xmlns:a="http://schemas.openxmlformats.org/drawingml/2006/main">
               <a:ext uri="{FF2B5EF4-FFF2-40B4-BE49-F238E27FC236}">
-                <a16:creationId xmlns:a16="http://schemas.microsoft.com/office/drawing/2014/main" id="{741580E1-1B20-434C-AB50-A179AAC4EFCB}"/>
+                <a16:creationId xmlns:a16="http://schemas.microsoft.com/office/drawing/2014/main" id="{CB803758-96F7-405F-B8A1-9EC442B8AE34}"/>
               </a:ext>
             </a:extLst>
           </p:cNvPr>
@@ -9090,7 +9090,7 @@
           <p:cNvPr id="23" name="TextBox 22">
             <a:extLst xmlns:a="http://schemas.openxmlformats.org/drawingml/2006/main">
               <a:ext uri="{FF2B5EF4-FFF2-40B4-BE49-F238E27FC236}">
-                <a16:creationId xmlns:a16="http://schemas.microsoft.com/office/drawing/2014/main" id="{68750209-D14D-4A97-B578-43B5EF362A9A}"/>
+                <a16:creationId xmlns:a16="http://schemas.microsoft.com/office/drawing/2014/main" id="{13824250-3ED0-4407-BBA9-7BA67AC54706}"/>
               </a:ext>
             </a:extLst>
           </p:cNvPr>
@@ -9135,7 +9135,7 @@
     </p:spTree>
     <p:extLst>
       <p:ext uri="{BB962C8B-B14F-4D97-AF65-F5344CB8AC3E}">
-        <p14:creationId xmlns:p14="http://schemas.microsoft.com/office/powerpoint/2010/main" val="859576736"/>
+        <p14:creationId xmlns:p14="http://schemas.microsoft.com/office/powerpoint/2010/main" val="1053656129"/>
       </p:ext>
     </p:extLst>
   </p:cSld>
@@ -9159,7 +9159,7 @@
           <p:cNvPr id="2" name="TextBox 1">
             <a:extLst xmlns:a="http://schemas.openxmlformats.org/drawingml/2006/main">
               <a:ext uri="{FF2B5EF4-FFF2-40B4-BE49-F238E27FC236}">
-                <a16:creationId xmlns:a16="http://schemas.microsoft.com/office/drawing/2014/main" id="{DC644FF1-3637-4EBE-A9D6-317484E82B9E}"/>
+                <a16:creationId xmlns:a16="http://schemas.microsoft.com/office/drawing/2014/main" id="{75AAC6CF-403D-4C9D-A753-445C2170F6C5}"/>
               </a:ext>
             </a:extLst>
           </p:cNvPr>
@@ -9206,7 +9206,7 @@
           <p:cNvPr id="3" name="TextBox 2">
             <a:extLst xmlns:a="http://schemas.openxmlformats.org/drawingml/2006/main">
               <a:ext uri="{FF2B5EF4-FFF2-40B4-BE49-F238E27FC236}">
-                <a16:creationId xmlns:a16="http://schemas.microsoft.com/office/drawing/2014/main" id="{26EC65B9-E1F3-4887-A1AC-37B4707CC441}"/>
+                <a16:creationId xmlns:a16="http://schemas.microsoft.com/office/drawing/2014/main" id="{079AF131-9B87-4F01-9CB8-5DB3649A5335}"/>
               </a:ext>
             </a:extLst>
           </p:cNvPr>
@@ -9253,7 +9253,7 @@
           <p:cNvPr id="4" name="Rectangle 3">
             <a:extLst xmlns:a="http://schemas.openxmlformats.org/drawingml/2006/main">
               <a:ext uri="{FF2B5EF4-FFF2-40B4-BE49-F238E27FC236}">
-                <a16:creationId xmlns:a16="http://schemas.microsoft.com/office/drawing/2014/main" id="{094626DE-42B9-47AC-A4C1-E4B7CDAAB386}"/>
+                <a16:creationId xmlns:a16="http://schemas.microsoft.com/office/drawing/2014/main" id="{982F86DB-9B24-4FF4-B81D-3BA6229E51E8}"/>
               </a:ext>
             </a:extLst>
           </p:cNvPr>
@@ -9308,7 +9308,7 @@
           <p:cNvPr id="5" name="Rectangle 4">
             <a:extLst xmlns:a="http://schemas.openxmlformats.org/drawingml/2006/main">
               <a:ext uri="{FF2B5EF4-FFF2-40B4-BE49-F238E27FC236}">
-                <a16:creationId xmlns:a16="http://schemas.microsoft.com/office/drawing/2014/main" id="{EE0109BD-7762-4574-8965-AC2747629BE4}"/>
+                <a16:creationId xmlns:a16="http://schemas.microsoft.com/office/drawing/2014/main" id="{20DAE225-6A75-4ECE-8B9C-9FDEE2D69F3C}"/>
               </a:ext>
             </a:extLst>
           </p:cNvPr>
@@ -9363,7 +9363,7 @@
           <p:cNvPr id="6" name="TextBox 5">
             <a:extLst xmlns:a="http://schemas.openxmlformats.org/drawingml/2006/main">
               <a:ext uri="{FF2B5EF4-FFF2-40B4-BE49-F238E27FC236}">
-                <a16:creationId xmlns:a16="http://schemas.microsoft.com/office/drawing/2014/main" id="{B75BB7DC-02B8-4035-895D-380A71368D26}"/>
+                <a16:creationId xmlns:a16="http://schemas.microsoft.com/office/drawing/2014/main" id="{7D3D3FEC-C9E1-486A-AA99-3A91D513726C}"/>
               </a:ext>
             </a:extLst>
           </p:cNvPr>
@@ -9400,7 +9400,7 @@
                 <a:ea typeface="Aptos"/>
                 <a:cs typeface="Aptos"/>
               </a:rPr>
-              <a:t>Independent public evidence summary · 2026.07.22-8 · 2026-07-22 · Sources: Health Canada; Destatis; Vero; Sejm; Swedish Government</a:t>
+              <a:t>Independent public evidence summary · 2026.07.22-9 · 2026-07-22 · Sources: Health Canada; Destatis; Vero; Sejm; Swedish Government</a:t>
             </a:r>
           </a:p>
         </p:txBody>
@@ -9410,7 +9410,7 @@
           <p:cNvPr id="7" name="TextBox 6">
             <a:extLst xmlns:a="http://schemas.openxmlformats.org/drawingml/2006/main">
               <a:ext uri="{FF2B5EF4-FFF2-40B4-BE49-F238E27FC236}">
-                <a16:creationId xmlns:a16="http://schemas.microsoft.com/office/drawing/2014/main" id="{7D96D0A8-69FF-434E-AED6-763007A72837}"/>
+                <a16:creationId xmlns:a16="http://schemas.microsoft.com/office/drawing/2014/main" id="{FF9D7F3D-D30C-4435-A1B4-E2A91708EB88}"/>
               </a:ext>
             </a:extLst>
           </p:cNvPr>
@@ -9980,7 +9980,7 @@
           <p:cNvPr id="9" name="TextBox 8">
             <a:extLst xmlns:a="http://schemas.openxmlformats.org/drawingml/2006/main">
               <a:ext uri="{FF2B5EF4-FFF2-40B4-BE49-F238E27FC236}">
-                <a16:creationId xmlns:a16="http://schemas.microsoft.com/office/drawing/2014/main" id="{638F06E5-36DB-4065-AA18-96BA1103821B}"/>
+                <a16:creationId xmlns:a16="http://schemas.microsoft.com/office/drawing/2014/main" id="{82143438-2D76-40AA-9B4F-ACB8737B1C16}"/>
               </a:ext>
             </a:extLst>
           </p:cNvPr>
@@ -10025,7 +10025,7 @@
     </p:spTree>
     <p:extLst>
       <p:ext uri="{BB962C8B-B14F-4D97-AF65-F5344CB8AC3E}">
-        <p14:creationId xmlns:p14="http://schemas.microsoft.com/office/powerpoint/2010/main" val="1088600854"/>
+        <p14:creationId xmlns:p14="http://schemas.microsoft.com/office/powerpoint/2010/main" val="908447170"/>
       </p:ext>
     </p:extLst>
   </p:cSld>
@@ -10049,7 +10049,7 @@
           <p:cNvPr id="2" name="TextBox 1">
             <a:extLst xmlns:a="http://schemas.openxmlformats.org/drawingml/2006/main">
               <a:ext uri="{FF2B5EF4-FFF2-40B4-BE49-F238E27FC236}">
-                <a16:creationId xmlns:a16="http://schemas.microsoft.com/office/drawing/2014/main" id="{E3400B25-E7F3-475B-BC10-BC8D8E6E94A5}"/>
+                <a16:creationId xmlns:a16="http://schemas.microsoft.com/office/drawing/2014/main" id="{C75E4BFB-5ADD-4646-BDA0-0072CD4CACD3}"/>
               </a:ext>
             </a:extLst>
           </p:cNvPr>
@@ -10096,7 +10096,7 @@
           <p:cNvPr id="3" name="TextBox 2">
             <a:extLst xmlns:a="http://schemas.openxmlformats.org/drawingml/2006/main">
               <a:ext uri="{FF2B5EF4-FFF2-40B4-BE49-F238E27FC236}">
-                <a16:creationId xmlns:a16="http://schemas.microsoft.com/office/drawing/2014/main" id="{1F7AB691-D315-47F1-BCA1-44AD25474823}"/>
+                <a16:creationId xmlns:a16="http://schemas.microsoft.com/office/drawing/2014/main" id="{059BB44C-CE6A-469F-9979-FDA2C47DF7C4}"/>
               </a:ext>
             </a:extLst>
           </p:cNvPr>
@@ -10143,7 +10143,7 @@
           <p:cNvPr id="4" name="Rectangle 3">
             <a:extLst xmlns:a="http://schemas.openxmlformats.org/drawingml/2006/main">
               <a:ext uri="{FF2B5EF4-FFF2-40B4-BE49-F238E27FC236}">
-                <a16:creationId xmlns:a16="http://schemas.microsoft.com/office/drawing/2014/main" id="{00EC5417-42B7-424F-9085-73E28137A80E}"/>
+                <a16:creationId xmlns:a16="http://schemas.microsoft.com/office/drawing/2014/main" id="{D13330CB-AA6B-41B2-8300-468989448B93}"/>
               </a:ext>
             </a:extLst>
           </p:cNvPr>
@@ -10198,7 +10198,7 @@
           <p:cNvPr id="5" name="Rectangle 4">
             <a:extLst xmlns:a="http://schemas.openxmlformats.org/drawingml/2006/main">
               <a:ext uri="{FF2B5EF4-FFF2-40B4-BE49-F238E27FC236}">
-                <a16:creationId xmlns:a16="http://schemas.microsoft.com/office/drawing/2014/main" id="{B20735F7-F679-4F96-B9F5-5210082BBC79}"/>
+                <a16:creationId xmlns:a16="http://schemas.microsoft.com/office/drawing/2014/main" id="{50EFEF3F-6194-48E7-841A-E9EC75F74893}"/>
               </a:ext>
             </a:extLst>
           </p:cNvPr>
@@ -10253,7 +10253,7 @@
           <p:cNvPr id="6" name="TextBox 5">
             <a:extLst xmlns:a="http://schemas.openxmlformats.org/drawingml/2006/main">
               <a:ext uri="{FF2B5EF4-FFF2-40B4-BE49-F238E27FC236}">
-                <a16:creationId xmlns:a16="http://schemas.microsoft.com/office/drawing/2014/main" id="{3314CD34-1D95-4BDE-A8D5-1BA729E4D814}"/>
+                <a16:creationId xmlns:a16="http://schemas.microsoft.com/office/drawing/2014/main" id="{B4A9EE12-0994-4AAF-A622-39C6403B4B87}"/>
               </a:ext>
             </a:extLst>
           </p:cNvPr>
@@ -10290,7 +10290,7 @@
                 <a:ea typeface="Aptos"/>
                 <a:cs typeface="Aptos"/>
               </a:rPr>
-              <a:t>Independent public evidence summary · 2026.07.22-8 · 2026-07-22 · Sources: Health Canada 2024</a:t>
+              <a:t>Independent public evidence summary · 2026.07.22-9 · 2026-07-22 · Sources: Health Canada 2024</a:t>
             </a:r>
           </a:p>
         </p:txBody>
@@ -10300,7 +10300,7 @@
           <p:cNvPr id="7" name="TextBox 6">
             <a:extLst xmlns:a="http://schemas.openxmlformats.org/drawingml/2006/main">
               <a:ext uri="{FF2B5EF4-FFF2-40B4-BE49-F238E27FC236}">
-                <a16:creationId xmlns:a16="http://schemas.microsoft.com/office/drawing/2014/main" id="{3AFB3341-83F7-430F-98AE-15248F8AB0CA}"/>
+                <a16:creationId xmlns:a16="http://schemas.microsoft.com/office/drawing/2014/main" id="{EAE534A5-4A89-4498-8BBB-C85FA4DA731E}"/>
               </a:ext>
             </a:extLst>
           </p:cNvPr>
@@ -10347,7 +10347,7 @@
           <p:cNvPr id="8" name="Rounded Rectangle 7">
             <a:extLst xmlns:a="http://schemas.openxmlformats.org/drawingml/2006/main">
               <a:ext uri="{FF2B5EF4-FFF2-40B4-BE49-F238E27FC236}">
-                <a16:creationId xmlns:a16="http://schemas.microsoft.com/office/drawing/2014/main" id="{36BC302F-F48E-49EA-89D4-DBC55FA77BFC}"/>
+                <a16:creationId xmlns:a16="http://schemas.microsoft.com/office/drawing/2014/main" id="{112A39CE-FC67-43B8-BF28-1CCDFF378542}"/>
               </a:ext>
             </a:extLst>
           </p:cNvPr>
@@ -10404,7 +10404,7 @@
           <p:cNvPr id="9" name="TextBox 8">
             <a:extLst xmlns:a="http://schemas.openxmlformats.org/drawingml/2006/main">
               <a:ext uri="{FF2B5EF4-FFF2-40B4-BE49-F238E27FC236}">
-                <a16:creationId xmlns:a16="http://schemas.microsoft.com/office/drawing/2014/main" id="{0E3D4A28-1C17-482A-9581-AD7BED2A5763}"/>
+                <a16:creationId xmlns:a16="http://schemas.microsoft.com/office/drawing/2014/main" id="{2A68605A-3654-4D8C-ACC3-68E68591E851}"/>
               </a:ext>
             </a:extLst>
           </p:cNvPr>
@@ -10451,7 +10451,7 @@
           <p:cNvPr id="10" name="TextBox 9">
             <a:extLst xmlns:a="http://schemas.openxmlformats.org/drawingml/2006/main">
               <a:ext uri="{FF2B5EF4-FFF2-40B4-BE49-F238E27FC236}">
-                <a16:creationId xmlns:a16="http://schemas.microsoft.com/office/drawing/2014/main" id="{F5AA6257-A2D3-4C66-9AFB-D1E4D4B8BB6D}"/>
+                <a16:creationId xmlns:a16="http://schemas.microsoft.com/office/drawing/2014/main" id="{F97F40E1-9603-4390-8E2A-94FDFC16E39C}"/>
               </a:ext>
             </a:extLst>
           </p:cNvPr>
@@ -10498,7 +10498,7 @@
           <p:cNvPr id="11" name="Rounded Rectangle 10">
             <a:extLst xmlns:a="http://schemas.openxmlformats.org/drawingml/2006/main">
               <a:ext uri="{FF2B5EF4-FFF2-40B4-BE49-F238E27FC236}">
-                <a16:creationId xmlns:a16="http://schemas.microsoft.com/office/drawing/2014/main" id="{E035AB71-60BC-476F-8376-01E48E7C009E}"/>
+                <a16:creationId xmlns:a16="http://schemas.microsoft.com/office/drawing/2014/main" id="{22DD5251-6816-4609-97D2-C6A3E8C98DF9}"/>
               </a:ext>
             </a:extLst>
           </p:cNvPr>
@@ -10555,7 +10555,7 @@
           <p:cNvPr id="12" name="TextBox 11">
             <a:extLst xmlns:a="http://schemas.openxmlformats.org/drawingml/2006/main">
               <a:ext uri="{FF2B5EF4-FFF2-40B4-BE49-F238E27FC236}">
-                <a16:creationId xmlns:a16="http://schemas.microsoft.com/office/drawing/2014/main" id="{D79033EC-FB40-4A20-8260-7817F89DCD8F}"/>
+                <a16:creationId xmlns:a16="http://schemas.microsoft.com/office/drawing/2014/main" id="{056FF869-041A-41FC-8D56-F63A9C3474AA}"/>
               </a:ext>
             </a:extLst>
           </p:cNvPr>
@@ -10602,7 +10602,7 @@
           <p:cNvPr id="13" name="TextBox 12">
             <a:extLst xmlns:a="http://schemas.openxmlformats.org/drawingml/2006/main">
               <a:ext uri="{FF2B5EF4-FFF2-40B4-BE49-F238E27FC236}">
-                <a16:creationId xmlns:a16="http://schemas.microsoft.com/office/drawing/2014/main" id="{B47F955F-767F-4D0D-BC31-8EF3AB08EF61}"/>
+                <a16:creationId xmlns:a16="http://schemas.microsoft.com/office/drawing/2014/main" id="{4BF31271-41D3-4D5E-AF58-F02A0F5D425F}"/>
               </a:ext>
             </a:extLst>
           </p:cNvPr>
@@ -10649,7 +10649,7 @@
           <p:cNvPr id="14" name="Rounded Rectangle 13">
             <a:extLst xmlns:a="http://schemas.openxmlformats.org/drawingml/2006/main">
               <a:ext uri="{FF2B5EF4-FFF2-40B4-BE49-F238E27FC236}">
-                <a16:creationId xmlns:a16="http://schemas.microsoft.com/office/drawing/2014/main" id="{734EC2F7-12E0-48CA-B1E5-049763CA380E}"/>
+                <a16:creationId xmlns:a16="http://schemas.microsoft.com/office/drawing/2014/main" id="{56921BA5-C4D8-40A4-9695-35B28057D27C}"/>
               </a:ext>
             </a:extLst>
           </p:cNvPr>
@@ -10706,7 +10706,7 @@
           <p:cNvPr id="15" name="TextBox 14">
             <a:extLst xmlns:a="http://schemas.openxmlformats.org/drawingml/2006/main">
               <a:ext uri="{FF2B5EF4-FFF2-40B4-BE49-F238E27FC236}">
-                <a16:creationId xmlns:a16="http://schemas.microsoft.com/office/drawing/2014/main" id="{1FA36C9F-A367-4123-8E3D-10B9F03C8F98}"/>
+                <a16:creationId xmlns:a16="http://schemas.microsoft.com/office/drawing/2014/main" id="{340DBA46-11F1-42E2-B8CA-A5FFECFEEA5A}"/>
               </a:ext>
             </a:extLst>
           </p:cNvPr>
@@ -10753,7 +10753,7 @@
           <p:cNvPr id="16" name="TextBox 15">
             <a:extLst xmlns:a="http://schemas.openxmlformats.org/drawingml/2006/main">
               <a:ext uri="{FF2B5EF4-FFF2-40B4-BE49-F238E27FC236}">
-                <a16:creationId xmlns:a16="http://schemas.microsoft.com/office/drawing/2014/main" id="{5659C3F4-926E-444C-9144-42ED2131E524}"/>
+                <a16:creationId xmlns:a16="http://schemas.microsoft.com/office/drawing/2014/main" id="{773DEFD7-79BD-4275-A420-CAB80D0C37DB}"/>
               </a:ext>
             </a:extLst>
           </p:cNvPr>
@@ -10800,7 +10800,7 @@
           <p:cNvPr id="17" name="TextBox 16">
             <a:extLst xmlns:a="http://schemas.openxmlformats.org/drawingml/2006/main">
               <a:ext uri="{FF2B5EF4-FFF2-40B4-BE49-F238E27FC236}">
-                <a16:creationId xmlns:a16="http://schemas.microsoft.com/office/drawing/2014/main" id="{BEEA54E1-B608-4911-8A46-E596BA6492C1}"/>
+                <a16:creationId xmlns:a16="http://schemas.microsoft.com/office/drawing/2014/main" id="{95519D40-B48E-48FE-B8CB-3D34AFD4D829}"/>
               </a:ext>
             </a:extLst>
           </p:cNvPr>
@@ -10847,7 +10847,7 @@
           <p:cNvPr id="18" name="Rounded Rectangle 17">
             <a:extLst xmlns:a="http://schemas.openxmlformats.org/drawingml/2006/main">
               <a:ext uri="{FF2B5EF4-FFF2-40B4-BE49-F238E27FC236}">
-                <a16:creationId xmlns:a16="http://schemas.microsoft.com/office/drawing/2014/main" id="{BE6E6E95-3CE6-44DA-8BC7-D0081529D4DC}"/>
+                <a16:creationId xmlns:a16="http://schemas.microsoft.com/office/drawing/2014/main" id="{853198C0-409A-4AD0-BA0B-F56507DFD919}"/>
               </a:ext>
             </a:extLst>
           </p:cNvPr>
@@ -10904,7 +10904,7 @@
           <p:cNvPr id="19" name="TextBox 18">
             <a:extLst xmlns:a="http://schemas.openxmlformats.org/drawingml/2006/main">
               <a:ext uri="{FF2B5EF4-FFF2-40B4-BE49-F238E27FC236}">
-                <a16:creationId xmlns:a16="http://schemas.microsoft.com/office/drawing/2014/main" id="{900DCFD4-FE90-421E-9528-B06026AB9C9F}"/>
+                <a16:creationId xmlns:a16="http://schemas.microsoft.com/office/drawing/2014/main" id="{D30D8E8A-3384-4F8F-8088-9352D11E2CC9}"/>
               </a:ext>
             </a:extLst>
           </p:cNvPr>
@@ -10951,7 +10951,7 @@
           <p:cNvPr id="20" name="TextBox 19">
             <a:extLst xmlns:a="http://schemas.openxmlformats.org/drawingml/2006/main">
               <a:ext uri="{FF2B5EF4-FFF2-40B4-BE49-F238E27FC236}">
-                <a16:creationId xmlns:a16="http://schemas.microsoft.com/office/drawing/2014/main" id="{AF36E921-80B0-4546-86C1-3DBA8598532A}"/>
+                <a16:creationId xmlns:a16="http://schemas.microsoft.com/office/drawing/2014/main" id="{6F05FA5E-16B9-4085-875D-03453B6D93A5}"/>
               </a:ext>
             </a:extLst>
           </p:cNvPr>
@@ -10996,7 +10996,7 @@
     </p:spTree>
     <p:extLst>
       <p:ext uri="{BB962C8B-B14F-4D97-AF65-F5344CB8AC3E}">
-        <p14:creationId xmlns:p14="http://schemas.microsoft.com/office/powerpoint/2010/main" val="1866733624"/>
+        <p14:creationId xmlns:p14="http://schemas.microsoft.com/office/powerpoint/2010/main" val="1896385266"/>
       </p:ext>
     </p:extLst>
   </p:cSld>
@@ -11020,7 +11020,7 @@
           <p:cNvPr id="2" name="TextBox 1">
             <a:extLst xmlns:a="http://schemas.openxmlformats.org/drawingml/2006/main">
               <a:ext uri="{FF2B5EF4-FFF2-40B4-BE49-F238E27FC236}">
-                <a16:creationId xmlns:a16="http://schemas.microsoft.com/office/drawing/2014/main" id="{CB244F35-37E9-4363-8B41-486451F94982}"/>
+                <a16:creationId xmlns:a16="http://schemas.microsoft.com/office/drawing/2014/main" id="{A700B5B6-5290-46D0-B2D7-C864FF31B02D}"/>
               </a:ext>
             </a:extLst>
           </p:cNvPr>
@@ -11067,7 +11067,7 @@
           <p:cNvPr id="3" name="TextBox 2">
             <a:extLst xmlns:a="http://schemas.openxmlformats.org/drawingml/2006/main">
               <a:ext uri="{FF2B5EF4-FFF2-40B4-BE49-F238E27FC236}">
-                <a16:creationId xmlns:a16="http://schemas.microsoft.com/office/drawing/2014/main" id="{4253F181-D724-46A2-897D-24011A36DF86}"/>
+                <a16:creationId xmlns:a16="http://schemas.microsoft.com/office/drawing/2014/main" id="{0893CBF7-4192-4413-AA9E-090AAB9DAD1D}"/>
               </a:ext>
             </a:extLst>
           </p:cNvPr>
@@ -11114,7 +11114,7 @@
           <p:cNvPr id="4" name="Rectangle 3">
             <a:extLst xmlns:a="http://schemas.openxmlformats.org/drawingml/2006/main">
               <a:ext uri="{FF2B5EF4-FFF2-40B4-BE49-F238E27FC236}">
-                <a16:creationId xmlns:a16="http://schemas.microsoft.com/office/drawing/2014/main" id="{4C147DF7-CEBC-468E-ACD1-12C0D50F0BC8}"/>
+                <a16:creationId xmlns:a16="http://schemas.microsoft.com/office/drawing/2014/main" id="{F4C6BCEB-DF66-4359-A276-332CDFB34C04}"/>
               </a:ext>
             </a:extLst>
           </p:cNvPr>
@@ -11169,7 +11169,7 @@
           <p:cNvPr id="5" name="Rectangle 4">
             <a:extLst xmlns:a="http://schemas.openxmlformats.org/drawingml/2006/main">
               <a:ext uri="{FF2B5EF4-FFF2-40B4-BE49-F238E27FC236}">
-                <a16:creationId xmlns:a16="http://schemas.microsoft.com/office/drawing/2014/main" id="{98410586-7D1D-4F59-8AA5-BDEA738B1FDE}"/>
+                <a16:creationId xmlns:a16="http://schemas.microsoft.com/office/drawing/2014/main" id="{2F0C490A-4747-4D94-8AC1-8AC6D963335F}"/>
               </a:ext>
             </a:extLst>
           </p:cNvPr>
@@ -11224,7 +11224,7 @@
           <p:cNvPr id="6" name="TextBox 5">
             <a:extLst xmlns:a="http://schemas.openxmlformats.org/drawingml/2006/main">
               <a:ext uri="{FF2B5EF4-FFF2-40B4-BE49-F238E27FC236}">
-                <a16:creationId xmlns:a16="http://schemas.microsoft.com/office/drawing/2014/main" id="{1AAD36F7-6AEA-4F61-9E68-A233F1D471AD}"/>
+                <a16:creationId xmlns:a16="http://schemas.microsoft.com/office/drawing/2014/main" id="{165155F5-57CF-4019-977E-A7D168B5E3B3}"/>
               </a:ext>
             </a:extLst>
           </p:cNvPr>
@@ -11261,7 +11261,7 @@
                 <a:ea typeface="Aptos"/>
                 <a:cs typeface="Aptos"/>
               </a:rPr>
-              <a:t>Independent public evidence summary · 2026.07.22-8 · 2026-07-22 · Sources: Destatis</a:t>
+              <a:t>Independent public evidence summary · 2026.07.22-9 · 2026-07-22 · Sources: Destatis</a:t>
             </a:r>
           </a:p>
         </p:txBody>
@@ -11271,7 +11271,7 @@
           <p:cNvPr id="7" name="TextBox 6">
             <a:extLst xmlns:a="http://schemas.openxmlformats.org/drawingml/2006/main">
               <a:ext uri="{FF2B5EF4-FFF2-40B4-BE49-F238E27FC236}">
-                <a16:creationId xmlns:a16="http://schemas.microsoft.com/office/drawing/2014/main" id="{EB69FAA5-7F12-4B1D-AE07-F19E67F6D49B}"/>
+                <a16:creationId xmlns:a16="http://schemas.microsoft.com/office/drawing/2014/main" id="{B396B180-7561-4E20-9557-8148F3098490}"/>
               </a:ext>
             </a:extLst>
           </p:cNvPr>
@@ -11784,7 +11784,7 @@
           <p:cNvPr id="9" name="TextBox 8">
             <a:extLst xmlns:a="http://schemas.openxmlformats.org/drawingml/2006/main">
               <a:ext uri="{FF2B5EF4-FFF2-40B4-BE49-F238E27FC236}">
-                <a16:creationId xmlns:a16="http://schemas.microsoft.com/office/drawing/2014/main" id="{362FB58A-E2E7-4660-96B1-67737CE4BCFC}"/>
+                <a16:creationId xmlns:a16="http://schemas.microsoft.com/office/drawing/2014/main" id="{EFC502E7-0171-47DD-9FB5-81F137FD8199}"/>
               </a:ext>
             </a:extLst>
           </p:cNvPr>
@@ -11829,7 +11829,7 @@
     </p:spTree>
     <p:extLst>
       <p:ext uri="{BB962C8B-B14F-4D97-AF65-F5344CB8AC3E}">
-        <p14:creationId xmlns:p14="http://schemas.microsoft.com/office/powerpoint/2010/main" val="1460392944"/>
+        <p14:creationId xmlns:p14="http://schemas.microsoft.com/office/powerpoint/2010/main" val="1205900801"/>
       </p:ext>
     </p:extLst>
   </p:cSld>
@@ -11853,7 +11853,7 @@
           <p:cNvPr id="2" name="TextBox 1">
             <a:extLst xmlns:a="http://schemas.openxmlformats.org/drawingml/2006/main">
               <a:ext uri="{FF2B5EF4-FFF2-40B4-BE49-F238E27FC236}">
-                <a16:creationId xmlns:a16="http://schemas.microsoft.com/office/drawing/2014/main" id="{CD215898-9589-46F1-99E5-A90FA6256975}"/>
+                <a16:creationId xmlns:a16="http://schemas.microsoft.com/office/drawing/2014/main" id="{E0266EB8-106E-4494-8F5B-A61A58AA2689}"/>
               </a:ext>
             </a:extLst>
           </p:cNvPr>
@@ -11900,7 +11900,7 @@
           <p:cNvPr id="3" name="TextBox 2">
             <a:extLst xmlns:a="http://schemas.openxmlformats.org/drawingml/2006/main">
               <a:ext uri="{FF2B5EF4-FFF2-40B4-BE49-F238E27FC236}">
-                <a16:creationId xmlns:a16="http://schemas.microsoft.com/office/drawing/2014/main" id="{FA787C59-B95A-48AF-8BF9-8DDB3E2E18A4}"/>
+                <a16:creationId xmlns:a16="http://schemas.microsoft.com/office/drawing/2014/main" id="{B0D7C854-DB79-49CE-8BF0-A882E8C2696B}"/>
               </a:ext>
             </a:extLst>
           </p:cNvPr>
@@ -11947,7 +11947,7 @@
           <p:cNvPr id="4" name="Rectangle 3">
             <a:extLst xmlns:a="http://schemas.openxmlformats.org/drawingml/2006/main">
               <a:ext uri="{FF2B5EF4-FFF2-40B4-BE49-F238E27FC236}">
-                <a16:creationId xmlns:a16="http://schemas.microsoft.com/office/drawing/2014/main" id="{6572BB9E-35E0-430D-BB32-7170414087D9}"/>
+                <a16:creationId xmlns:a16="http://schemas.microsoft.com/office/drawing/2014/main" id="{50490857-390B-4F5E-B660-D50F1F36F625}"/>
               </a:ext>
             </a:extLst>
           </p:cNvPr>
@@ -12002,7 +12002,7 @@
           <p:cNvPr id="5" name="Rectangle 4">
             <a:extLst xmlns:a="http://schemas.openxmlformats.org/drawingml/2006/main">
               <a:ext uri="{FF2B5EF4-FFF2-40B4-BE49-F238E27FC236}">
-                <a16:creationId xmlns:a16="http://schemas.microsoft.com/office/drawing/2014/main" id="{44FBF207-D5A1-4236-9758-2FEA01DCACF0}"/>
+                <a16:creationId xmlns:a16="http://schemas.microsoft.com/office/drawing/2014/main" id="{8DF2CC33-8D36-4F05-AEDD-B75E7FC4FFEE}"/>
               </a:ext>
             </a:extLst>
           </p:cNvPr>
@@ -12057,7 +12057,7 @@
           <p:cNvPr id="6" name="TextBox 5">
             <a:extLst xmlns:a="http://schemas.openxmlformats.org/drawingml/2006/main">
               <a:ext uri="{FF2B5EF4-FFF2-40B4-BE49-F238E27FC236}">
-                <a16:creationId xmlns:a16="http://schemas.microsoft.com/office/drawing/2014/main" id="{CCD82362-7F0C-403E-BF4B-FA77E86675F6}"/>
+                <a16:creationId xmlns:a16="http://schemas.microsoft.com/office/drawing/2014/main" id="{D8578790-4140-4CC3-B0F3-F7D4B6C00EBF}"/>
               </a:ext>
             </a:extLst>
           </p:cNvPr>
@@ -12094,7 +12094,7 @@
                 <a:ea typeface="Aptos"/>
                 <a:cs typeface="Aptos"/>
               </a:rPr>
-              <a:t>Independent public evidence summary · 2026.07.22-8 · 2026-07-22 · Sources: Destatis; inTaste.de</a:t>
+              <a:t>Independent public evidence summary · 2026.07.22-9 · 2026-07-22 · Sources: Destatis; inTaste.de</a:t>
             </a:r>
           </a:p>
         </p:txBody>
@@ -12104,7 +12104,7 @@
           <p:cNvPr id="7" name="TextBox 6">
             <a:extLst xmlns:a="http://schemas.openxmlformats.org/drawingml/2006/main">
               <a:ext uri="{FF2B5EF4-FFF2-40B4-BE49-F238E27FC236}">
-                <a16:creationId xmlns:a16="http://schemas.microsoft.com/office/drawing/2014/main" id="{D8920B37-19FB-4B35-AB96-1F979FA4BA1A}"/>
+                <a16:creationId xmlns:a16="http://schemas.microsoft.com/office/drawing/2014/main" id="{177F31AF-48BB-45BD-82CF-6F2FDF77EAB5}"/>
               </a:ext>
             </a:extLst>
           </p:cNvPr>
@@ -12151,7 +12151,7 @@
           <p:cNvPr id="8" name="Rounded Rectangle 7">
             <a:extLst xmlns:a="http://schemas.openxmlformats.org/drawingml/2006/main">
               <a:ext uri="{FF2B5EF4-FFF2-40B4-BE49-F238E27FC236}">
-                <a16:creationId xmlns:a16="http://schemas.microsoft.com/office/drawing/2014/main" id="{23D430B2-AE33-4BB5-81BB-691D28545851}"/>
+                <a16:creationId xmlns:a16="http://schemas.microsoft.com/office/drawing/2014/main" id="{CC7C4343-28C7-4FA7-A18F-CB50ED73CC96}"/>
               </a:ext>
             </a:extLst>
           </p:cNvPr>
@@ -12208,7 +12208,7 @@
           <p:cNvPr id="9" name="TextBox 8">
             <a:extLst xmlns:a="http://schemas.openxmlformats.org/drawingml/2006/main">
               <a:ext uri="{FF2B5EF4-FFF2-40B4-BE49-F238E27FC236}">
-                <a16:creationId xmlns:a16="http://schemas.microsoft.com/office/drawing/2014/main" id="{583EBDDD-1624-4A9C-8232-121D367B5F93}"/>
+                <a16:creationId xmlns:a16="http://schemas.microsoft.com/office/drawing/2014/main" id="{28814392-5355-4240-9E60-E4DED7D08AA0}"/>
               </a:ext>
             </a:extLst>
           </p:cNvPr>
@@ -12255,7 +12255,7 @@
           <p:cNvPr id="10" name="TextBox 9">
             <a:extLst xmlns:a="http://schemas.openxmlformats.org/drawingml/2006/main">
               <a:ext uri="{FF2B5EF4-FFF2-40B4-BE49-F238E27FC236}">
-                <a16:creationId xmlns:a16="http://schemas.microsoft.com/office/drawing/2014/main" id="{3386FDA5-1AE6-4E87-9FB5-962C4D2FDEF4}"/>
+                <a16:creationId xmlns:a16="http://schemas.microsoft.com/office/drawing/2014/main" id="{DDEEA3CB-5689-49E9-82EF-43931A8EF33E}"/>
               </a:ext>
             </a:extLst>
           </p:cNvPr>
@@ -12302,7 +12302,7 @@
           <p:cNvPr id="11" name="Rounded Rectangle 10">
             <a:extLst xmlns:a="http://schemas.openxmlformats.org/drawingml/2006/main">
               <a:ext uri="{FF2B5EF4-FFF2-40B4-BE49-F238E27FC236}">
-                <a16:creationId xmlns:a16="http://schemas.microsoft.com/office/drawing/2014/main" id="{C78E46C7-C008-431B-A378-CC05A983C3FB}"/>
+                <a16:creationId xmlns:a16="http://schemas.microsoft.com/office/drawing/2014/main" id="{0647806E-A2E3-4929-B88B-4C7B4851F061}"/>
               </a:ext>
             </a:extLst>
           </p:cNvPr>
@@ -12359,7 +12359,7 @@
           <p:cNvPr id="12" name="TextBox 11">
             <a:extLst xmlns:a="http://schemas.openxmlformats.org/drawingml/2006/main">
               <a:ext uri="{FF2B5EF4-FFF2-40B4-BE49-F238E27FC236}">
-                <a16:creationId xmlns:a16="http://schemas.microsoft.com/office/drawing/2014/main" id="{D5A53ED6-B274-4F8D-A0F4-ED2E5819D40E}"/>
+                <a16:creationId xmlns:a16="http://schemas.microsoft.com/office/drawing/2014/main" id="{58E6A19F-A16B-418C-9349-B202DD3F6066}"/>
               </a:ext>
             </a:extLst>
           </p:cNvPr>
@@ -12406,7 +12406,7 @@
           <p:cNvPr id="13" name="TextBox 12">
             <a:extLst xmlns:a="http://schemas.openxmlformats.org/drawingml/2006/main">
               <a:ext uri="{FF2B5EF4-FFF2-40B4-BE49-F238E27FC236}">
-                <a16:creationId xmlns:a16="http://schemas.microsoft.com/office/drawing/2014/main" id="{4AF69404-EC1D-444C-A82D-AFDF91A93A56}"/>
+                <a16:creationId xmlns:a16="http://schemas.microsoft.com/office/drawing/2014/main" id="{46C764FB-B959-4307-948A-7C1484CFFBC1}"/>
               </a:ext>
             </a:extLst>
           </p:cNvPr>
@@ -12453,7 +12453,7 @@
           <p:cNvPr id="14" name="Rounded Rectangle 13">
             <a:extLst xmlns:a="http://schemas.openxmlformats.org/drawingml/2006/main">
               <a:ext uri="{FF2B5EF4-FFF2-40B4-BE49-F238E27FC236}">
-                <a16:creationId xmlns:a16="http://schemas.microsoft.com/office/drawing/2014/main" id="{3102459C-DE5F-4134-9E3D-AD6188407D04}"/>
+                <a16:creationId xmlns:a16="http://schemas.microsoft.com/office/drawing/2014/main" id="{3E047904-6F34-41C2-8AA2-9B880E36754C}"/>
               </a:ext>
             </a:extLst>
           </p:cNvPr>
@@ -12510,7 +12510,7 @@
           <p:cNvPr id="15" name="TextBox 14">
             <a:extLst xmlns:a="http://schemas.openxmlformats.org/drawingml/2006/main">
               <a:ext uri="{FF2B5EF4-FFF2-40B4-BE49-F238E27FC236}">
-                <a16:creationId xmlns:a16="http://schemas.microsoft.com/office/drawing/2014/main" id="{0F9AAF1E-5928-4A70-817C-C4DBC5078840}"/>
+                <a16:creationId xmlns:a16="http://schemas.microsoft.com/office/drawing/2014/main" id="{850ABC25-24F8-4CB8-8DAD-A19B8531512F}"/>
               </a:ext>
             </a:extLst>
           </p:cNvPr>
@@ -12557,7 +12557,7 @@
           <p:cNvPr id="16" name="TextBox 15">
             <a:extLst xmlns:a="http://schemas.openxmlformats.org/drawingml/2006/main">
               <a:ext uri="{FF2B5EF4-FFF2-40B4-BE49-F238E27FC236}">
-                <a16:creationId xmlns:a16="http://schemas.microsoft.com/office/drawing/2014/main" id="{E2C3E49C-5E11-4ECF-AE9B-5E2EE352E44A}"/>
+                <a16:creationId xmlns:a16="http://schemas.microsoft.com/office/drawing/2014/main" id="{52CD0FC0-7129-487B-BCF8-EEBF7430EB50}"/>
               </a:ext>
             </a:extLst>
           </p:cNvPr>
@@ -12604,7 +12604,7 @@
           <p:cNvPr id="17" name="TextBox 16">
             <a:extLst xmlns:a="http://schemas.openxmlformats.org/drawingml/2006/main">
               <a:ext uri="{FF2B5EF4-FFF2-40B4-BE49-F238E27FC236}">
-                <a16:creationId xmlns:a16="http://schemas.microsoft.com/office/drawing/2014/main" id="{31A35529-5F92-47B9-9187-60242E8E1AE4}"/>
+                <a16:creationId xmlns:a16="http://schemas.microsoft.com/office/drawing/2014/main" id="{869F35DA-87C0-4667-9670-FE35E6112A7C}"/>
               </a:ext>
             </a:extLst>
           </p:cNvPr>
@@ -12651,7 +12651,7 @@
           <p:cNvPr id="18" name="Rounded Rectangle 17">
             <a:extLst xmlns:a="http://schemas.openxmlformats.org/drawingml/2006/main">
               <a:ext uri="{FF2B5EF4-FFF2-40B4-BE49-F238E27FC236}">
-                <a16:creationId xmlns:a16="http://schemas.microsoft.com/office/drawing/2014/main" id="{325EBFD0-61B7-438A-8B87-749409828D5C}"/>
+                <a16:creationId xmlns:a16="http://schemas.microsoft.com/office/drawing/2014/main" id="{26111FC8-D795-4B83-8826-6913A533DA9D}"/>
               </a:ext>
             </a:extLst>
           </p:cNvPr>
@@ -12708,7 +12708,7 @@
           <p:cNvPr id="19" name="TextBox 18">
             <a:extLst xmlns:a="http://schemas.openxmlformats.org/drawingml/2006/main">
               <a:ext uri="{FF2B5EF4-FFF2-40B4-BE49-F238E27FC236}">
-                <a16:creationId xmlns:a16="http://schemas.microsoft.com/office/drawing/2014/main" id="{05E8EA21-151B-490A-9968-7DF7D90C9BC2}"/>
+                <a16:creationId xmlns:a16="http://schemas.microsoft.com/office/drawing/2014/main" id="{B86C0D5A-C8AA-46A4-BAE2-9622739FA2F7}"/>
               </a:ext>
             </a:extLst>
           </p:cNvPr>
@@ -12755,7 +12755,7 @@
           <p:cNvPr id="20" name="TextBox 19">
             <a:extLst xmlns:a="http://schemas.openxmlformats.org/drawingml/2006/main">
               <a:ext uri="{FF2B5EF4-FFF2-40B4-BE49-F238E27FC236}">
-                <a16:creationId xmlns:a16="http://schemas.microsoft.com/office/drawing/2014/main" id="{772941C7-D573-4EFA-8645-DC50C2A5BAB1}"/>
+                <a16:creationId xmlns:a16="http://schemas.microsoft.com/office/drawing/2014/main" id="{8F2C4628-2A03-4E1B-B695-C45CB95F6E61}"/>
               </a:ext>
             </a:extLst>
           </p:cNvPr>
@@ -12800,7 +12800,7 @@
     </p:spTree>
     <p:extLst>
       <p:ext uri="{BB962C8B-B14F-4D97-AF65-F5344CB8AC3E}">
-        <p14:creationId xmlns:p14="http://schemas.microsoft.com/office/powerpoint/2010/main" val="185071542"/>
+        <p14:creationId xmlns:p14="http://schemas.microsoft.com/office/powerpoint/2010/main" val="1271372671"/>
       </p:ext>
     </p:extLst>
   </p:cSld>
@@ -12824,7 +12824,7 @@
           <p:cNvPr id="2" name="TextBox 1">
             <a:extLst xmlns:a="http://schemas.openxmlformats.org/drawingml/2006/main">
               <a:ext uri="{FF2B5EF4-FFF2-40B4-BE49-F238E27FC236}">
-                <a16:creationId xmlns:a16="http://schemas.microsoft.com/office/drawing/2014/main" id="{0F409980-77AB-4F06-9C74-4022B8663E07}"/>
+                <a16:creationId xmlns:a16="http://schemas.microsoft.com/office/drawing/2014/main" id="{C229B36F-ADD8-448A-A132-96B9F4601926}"/>
               </a:ext>
             </a:extLst>
           </p:cNvPr>
@@ -12871,7 +12871,7 @@
           <p:cNvPr id="3" name="TextBox 2">
             <a:extLst xmlns:a="http://schemas.openxmlformats.org/drawingml/2006/main">
               <a:ext uri="{FF2B5EF4-FFF2-40B4-BE49-F238E27FC236}">
-                <a16:creationId xmlns:a16="http://schemas.microsoft.com/office/drawing/2014/main" id="{D20F98C2-2A22-4FE0-BA32-E240ACC488C5}"/>
+                <a16:creationId xmlns:a16="http://schemas.microsoft.com/office/drawing/2014/main" id="{431A3CDD-6D82-4663-BD7C-DECE72B8E945}"/>
               </a:ext>
             </a:extLst>
           </p:cNvPr>
@@ -12918,7 +12918,7 @@
           <p:cNvPr id="4" name="Rectangle 3">
             <a:extLst xmlns:a="http://schemas.openxmlformats.org/drawingml/2006/main">
               <a:ext uri="{FF2B5EF4-FFF2-40B4-BE49-F238E27FC236}">
-                <a16:creationId xmlns:a16="http://schemas.microsoft.com/office/drawing/2014/main" id="{9C25CBA6-60A5-42C4-99E7-8EE1E2E82F59}"/>
+                <a16:creationId xmlns:a16="http://schemas.microsoft.com/office/drawing/2014/main" id="{3CF9ED73-4A90-40CD-B104-A47B95F2DABD}"/>
               </a:ext>
             </a:extLst>
           </p:cNvPr>
@@ -12973,7 +12973,7 @@
           <p:cNvPr id="5" name="Rectangle 4">
             <a:extLst xmlns:a="http://schemas.openxmlformats.org/drawingml/2006/main">
               <a:ext uri="{FF2B5EF4-FFF2-40B4-BE49-F238E27FC236}">
-                <a16:creationId xmlns:a16="http://schemas.microsoft.com/office/drawing/2014/main" id="{E8211843-2945-4A5F-B6A2-3B9157022337}"/>
+                <a16:creationId xmlns:a16="http://schemas.microsoft.com/office/drawing/2014/main" id="{E3D23BC4-7C61-4C4E-893A-2C61B47E6118}"/>
               </a:ext>
             </a:extLst>
           </p:cNvPr>
@@ -13028,7 +13028,7 @@
           <p:cNvPr id="6" name="TextBox 5">
             <a:extLst xmlns:a="http://schemas.openxmlformats.org/drawingml/2006/main">
               <a:ext uri="{FF2B5EF4-FFF2-40B4-BE49-F238E27FC236}">
-                <a16:creationId xmlns:a16="http://schemas.microsoft.com/office/drawing/2014/main" id="{9DF44FD1-9E12-4E33-B4DD-E14C2E288CF8}"/>
+                <a16:creationId xmlns:a16="http://schemas.microsoft.com/office/drawing/2014/main" id="{C58C4548-3DFD-49CC-8425-5D7627122317}"/>
               </a:ext>
             </a:extLst>
           </p:cNvPr>
@@ -13065,7 +13065,7 @@
                 <a:ea typeface="Aptos"/>
                 <a:cs typeface="Aptos"/>
               </a:rPr>
-              <a:t>Independent public evidence summary · 2026.07.22-8 · 2026-07-22 · Sources: IMARC; GVR; Fortune</a:t>
+              <a:t>Independent public evidence summary · 2026.07.22-9 · 2026-07-22 · Sources: IMARC; GVR; Fortune</a:t>
             </a:r>
           </a:p>
         </p:txBody>
@@ -13075,7 +13075,7 @@
           <p:cNvPr id="7" name="TextBox 6">
             <a:extLst xmlns:a="http://schemas.openxmlformats.org/drawingml/2006/main">
               <a:ext uri="{FF2B5EF4-FFF2-40B4-BE49-F238E27FC236}">
-                <a16:creationId xmlns:a16="http://schemas.microsoft.com/office/drawing/2014/main" id="{1C75185C-D340-4540-84BE-8495EF6A9C5C}"/>
+                <a16:creationId xmlns:a16="http://schemas.microsoft.com/office/drawing/2014/main" id="{2281D780-4AE8-4221-90AF-9EB2D3B8C6CF}"/>
               </a:ext>
             </a:extLst>
           </p:cNvPr>
@@ -13122,7 +13122,7 @@
           <p:cNvPr id="8" name="Rounded Rectangle 7">
             <a:extLst xmlns:a="http://schemas.openxmlformats.org/drawingml/2006/main">
               <a:ext uri="{FF2B5EF4-FFF2-40B4-BE49-F238E27FC236}">
-                <a16:creationId xmlns:a16="http://schemas.microsoft.com/office/drawing/2014/main" id="{8D2A497D-4C71-44AE-AAEE-3ACA57038DFE}"/>
+                <a16:creationId xmlns:a16="http://schemas.microsoft.com/office/drawing/2014/main" id="{2B25AD0D-711B-4DB8-96F3-21597C0B1EF6}"/>
               </a:ext>
             </a:extLst>
           </p:cNvPr>
@@ -13179,7 +13179,7 @@
           <p:cNvPr id="9" name="TextBox 8">
             <a:extLst xmlns:a="http://schemas.openxmlformats.org/drawingml/2006/main">
               <a:ext uri="{FF2B5EF4-FFF2-40B4-BE49-F238E27FC236}">
-                <a16:creationId xmlns:a16="http://schemas.microsoft.com/office/drawing/2014/main" id="{59DB865A-E978-4C57-95E5-7203DBA20519}"/>
+                <a16:creationId xmlns:a16="http://schemas.microsoft.com/office/drawing/2014/main" id="{6AC812A5-3882-44E0-8BF5-6FD7A5D6E753}"/>
               </a:ext>
             </a:extLst>
           </p:cNvPr>
@@ -13226,7 +13226,7 @@
           <p:cNvPr id="10" name="TextBox 9">
             <a:extLst xmlns:a="http://schemas.openxmlformats.org/drawingml/2006/main">
               <a:ext uri="{FF2B5EF4-FFF2-40B4-BE49-F238E27FC236}">
-                <a16:creationId xmlns:a16="http://schemas.microsoft.com/office/drawing/2014/main" id="{39B35ADB-EDA5-4ABB-8532-88D21A3FCF43}"/>
+                <a16:creationId xmlns:a16="http://schemas.microsoft.com/office/drawing/2014/main" id="{93AD0DFA-41AE-45D1-9FFD-3878EA029822}"/>
               </a:ext>
             </a:extLst>
           </p:cNvPr>
@@ -13273,7 +13273,7 @@
           <p:cNvPr id="11" name="Rounded Rectangle 10">
             <a:extLst xmlns:a="http://schemas.openxmlformats.org/drawingml/2006/main">
               <a:ext uri="{FF2B5EF4-FFF2-40B4-BE49-F238E27FC236}">
-                <a16:creationId xmlns:a16="http://schemas.microsoft.com/office/drawing/2014/main" id="{825A5264-240A-46EB-A6C9-2036E30DAADE}"/>
+                <a16:creationId xmlns:a16="http://schemas.microsoft.com/office/drawing/2014/main" id="{363B09AB-D724-47F5-9A98-FDAFDC8F6B2F}"/>
               </a:ext>
             </a:extLst>
           </p:cNvPr>
@@ -13330,7 +13330,7 @@
           <p:cNvPr id="12" name="TextBox 11">
             <a:extLst xmlns:a="http://schemas.openxmlformats.org/drawingml/2006/main">
               <a:ext uri="{FF2B5EF4-FFF2-40B4-BE49-F238E27FC236}">
-                <a16:creationId xmlns:a16="http://schemas.microsoft.com/office/drawing/2014/main" id="{AF1549BC-8A32-4FCD-836C-E474B6CEA073}"/>
+                <a16:creationId xmlns:a16="http://schemas.microsoft.com/office/drawing/2014/main" id="{BEE580FC-3BE2-41CB-80BA-EA7BBB6A113E}"/>
               </a:ext>
             </a:extLst>
           </p:cNvPr>
@@ -13377,7 +13377,7 @@
           <p:cNvPr id="13" name="TextBox 12">
             <a:extLst xmlns:a="http://schemas.openxmlformats.org/drawingml/2006/main">
               <a:ext uri="{FF2B5EF4-FFF2-40B4-BE49-F238E27FC236}">
-                <a16:creationId xmlns:a16="http://schemas.microsoft.com/office/drawing/2014/main" id="{F6482E0E-FB44-43E6-931F-C2BBC196101D}"/>
+                <a16:creationId xmlns:a16="http://schemas.microsoft.com/office/drawing/2014/main" id="{C987D544-558B-4239-944D-3CBB53C5A73F}"/>
               </a:ext>
             </a:extLst>
           </p:cNvPr>
@@ -13424,7 +13424,7 @@
           <p:cNvPr id="14" name="Rounded Rectangle 13">
             <a:extLst xmlns:a="http://schemas.openxmlformats.org/drawingml/2006/main">
               <a:ext uri="{FF2B5EF4-FFF2-40B4-BE49-F238E27FC236}">
-                <a16:creationId xmlns:a16="http://schemas.microsoft.com/office/drawing/2014/main" id="{AAF5AE85-8196-494D-8D7E-15DD66957517}"/>
+                <a16:creationId xmlns:a16="http://schemas.microsoft.com/office/drawing/2014/main" id="{151FEDD6-FBE1-4637-8A26-C86EAAF81675}"/>
               </a:ext>
             </a:extLst>
           </p:cNvPr>
@@ -13481,7 +13481,7 @@
           <p:cNvPr id="15" name="TextBox 14">
             <a:extLst xmlns:a="http://schemas.openxmlformats.org/drawingml/2006/main">
               <a:ext uri="{FF2B5EF4-FFF2-40B4-BE49-F238E27FC236}">
-                <a16:creationId xmlns:a16="http://schemas.microsoft.com/office/drawing/2014/main" id="{A7611A24-5B1E-410F-820F-9064B1D09399}"/>
+                <a16:creationId xmlns:a16="http://schemas.microsoft.com/office/drawing/2014/main" id="{6F7BCBAA-4A86-4410-868C-DFB317B33810}"/>
               </a:ext>
             </a:extLst>
           </p:cNvPr>
@@ -13528,7 +13528,7 @@
           <p:cNvPr id="16" name="TextBox 15">
             <a:extLst xmlns:a="http://schemas.openxmlformats.org/drawingml/2006/main">
               <a:ext uri="{FF2B5EF4-FFF2-40B4-BE49-F238E27FC236}">
-                <a16:creationId xmlns:a16="http://schemas.microsoft.com/office/drawing/2014/main" id="{1B3810FA-E989-4FCE-A46B-07F4FD6B007F}"/>
+                <a16:creationId xmlns:a16="http://schemas.microsoft.com/office/drawing/2014/main" id="{9732CA8D-9729-48CD-B0C2-DF7445909630}"/>
               </a:ext>
             </a:extLst>
           </p:cNvPr>
@@ -13575,7 +13575,7 @@
           <p:cNvPr id="17" name="TextBox 16">
             <a:extLst xmlns:a="http://schemas.openxmlformats.org/drawingml/2006/main">
               <a:ext uri="{FF2B5EF4-FFF2-40B4-BE49-F238E27FC236}">
-                <a16:creationId xmlns:a16="http://schemas.microsoft.com/office/drawing/2014/main" id="{E9CA7405-9A67-4C49-8EC5-1369F732682F}"/>
+                <a16:creationId xmlns:a16="http://schemas.microsoft.com/office/drawing/2014/main" id="{BE0146A5-8DE9-45C4-81A8-494057C0817B}"/>
               </a:ext>
             </a:extLst>
           </p:cNvPr>
@@ -13622,7 +13622,7 @@
           <p:cNvPr id="18" name="Rounded Rectangle 17">
             <a:extLst xmlns:a="http://schemas.openxmlformats.org/drawingml/2006/main">
               <a:ext uri="{FF2B5EF4-FFF2-40B4-BE49-F238E27FC236}">
-                <a16:creationId xmlns:a16="http://schemas.microsoft.com/office/drawing/2014/main" id="{A283E2F2-705D-4958-8457-880F1D9716DB}"/>
+                <a16:creationId xmlns:a16="http://schemas.microsoft.com/office/drawing/2014/main" id="{27C64C26-A5FD-48CB-A1B6-AF131505DB20}"/>
               </a:ext>
             </a:extLst>
           </p:cNvPr>
@@ -13679,7 +13679,7 @@
           <p:cNvPr id="19" name="TextBox 18">
             <a:extLst xmlns:a="http://schemas.openxmlformats.org/drawingml/2006/main">
               <a:ext uri="{FF2B5EF4-FFF2-40B4-BE49-F238E27FC236}">
-                <a16:creationId xmlns:a16="http://schemas.microsoft.com/office/drawing/2014/main" id="{D8FF71C3-13C7-4ACC-ABE1-388C7AA9800B}"/>
+                <a16:creationId xmlns:a16="http://schemas.microsoft.com/office/drawing/2014/main" id="{5A981EE0-44D7-4586-A798-348C3254D1A2}"/>
               </a:ext>
             </a:extLst>
           </p:cNvPr>
@@ -13726,7 +13726,7 @@
           <p:cNvPr id="20" name="TextBox 19">
             <a:extLst xmlns:a="http://schemas.openxmlformats.org/drawingml/2006/main">
               <a:ext uri="{FF2B5EF4-FFF2-40B4-BE49-F238E27FC236}">
-                <a16:creationId xmlns:a16="http://schemas.microsoft.com/office/drawing/2014/main" id="{C806BF32-D3AF-4D43-B620-DF25284DDF10}"/>
+                <a16:creationId xmlns:a16="http://schemas.microsoft.com/office/drawing/2014/main" id="{815DE90E-B6CF-44AE-BB9B-85BB44E90294}"/>
               </a:ext>
             </a:extLst>
           </p:cNvPr>
@@ -13771,7 +13771,7 @@
     </p:spTree>
     <p:extLst>
       <p:ext uri="{BB962C8B-B14F-4D97-AF65-F5344CB8AC3E}">
-        <p14:creationId xmlns:p14="http://schemas.microsoft.com/office/powerpoint/2010/main" val="1658045330"/>
+        <p14:creationId xmlns:p14="http://schemas.microsoft.com/office/powerpoint/2010/main" val="1895678815"/>
       </p:ext>
     </p:extLst>
   </p:cSld>
@@ -13795,7 +13795,7 @@
           <p:cNvPr id="2" name="TextBox 1">
             <a:extLst xmlns:a="http://schemas.openxmlformats.org/drawingml/2006/main">
               <a:ext uri="{FF2B5EF4-FFF2-40B4-BE49-F238E27FC236}">
-                <a16:creationId xmlns:a16="http://schemas.microsoft.com/office/drawing/2014/main" id="{43E0C3FF-0188-4E10-9697-05512FEA374B}"/>
+                <a16:creationId xmlns:a16="http://schemas.microsoft.com/office/drawing/2014/main" id="{1F831B8E-E069-4611-AD04-D221DC648A91}"/>
               </a:ext>
             </a:extLst>
           </p:cNvPr>
@@ -13842,7 +13842,7 @@
           <p:cNvPr id="3" name="TextBox 2">
             <a:extLst xmlns:a="http://schemas.openxmlformats.org/drawingml/2006/main">
               <a:ext uri="{FF2B5EF4-FFF2-40B4-BE49-F238E27FC236}">
-                <a16:creationId xmlns:a16="http://schemas.microsoft.com/office/drawing/2014/main" id="{15D4C97B-A469-4CAC-9E05-FDCA299C7F5A}"/>
+                <a16:creationId xmlns:a16="http://schemas.microsoft.com/office/drawing/2014/main" id="{3BCD15DD-51C6-4CA5-8D4A-0429095160D3}"/>
               </a:ext>
             </a:extLst>
           </p:cNvPr>
@@ -13889,7 +13889,7 @@
           <p:cNvPr id="4" name="Rectangle 3">
             <a:extLst xmlns:a="http://schemas.openxmlformats.org/drawingml/2006/main">
               <a:ext uri="{FF2B5EF4-FFF2-40B4-BE49-F238E27FC236}">
-                <a16:creationId xmlns:a16="http://schemas.microsoft.com/office/drawing/2014/main" id="{1806BFF2-0EBD-489F-B597-9EF11798C589}"/>
+                <a16:creationId xmlns:a16="http://schemas.microsoft.com/office/drawing/2014/main" id="{D0B202DD-88BF-4FC3-8B8A-FF6A3AB9DCDB}"/>
               </a:ext>
             </a:extLst>
           </p:cNvPr>
@@ -13944,7 +13944,7 @@
           <p:cNvPr id="5" name="Rectangle 4">
             <a:extLst xmlns:a="http://schemas.openxmlformats.org/drawingml/2006/main">
               <a:ext uri="{FF2B5EF4-FFF2-40B4-BE49-F238E27FC236}">
-                <a16:creationId xmlns:a16="http://schemas.microsoft.com/office/drawing/2014/main" id="{43E8E249-0D2D-4DFE-B6EB-EAB7C1405CAD}"/>
+                <a16:creationId xmlns:a16="http://schemas.microsoft.com/office/drawing/2014/main" id="{F9D2F74B-D744-4CAE-AAF6-1DAA04808FA0}"/>
               </a:ext>
             </a:extLst>
           </p:cNvPr>
@@ -13999,7 +13999,7 @@
           <p:cNvPr id="6" name="TextBox 5">
             <a:extLst xmlns:a="http://schemas.openxmlformats.org/drawingml/2006/main">
               <a:ext uri="{FF2B5EF4-FFF2-40B4-BE49-F238E27FC236}">
-                <a16:creationId xmlns:a16="http://schemas.microsoft.com/office/drawing/2014/main" id="{1AB4B6F6-D07B-4351-A6B6-3820F2A379DB}"/>
+                <a16:creationId xmlns:a16="http://schemas.microsoft.com/office/drawing/2014/main" id="{CCB28205-8763-462C-A07F-A7FD543B09DF}"/>
               </a:ext>
             </a:extLst>
           </p:cNvPr>
@@ -14036,7 +14036,7 @@
                 <a:ea typeface="Aptos"/>
                 <a:cs typeface="Aptos"/>
               </a:rPr>
-              <a:t>Independent public evidence summary · 2026.07.22-8 · 2026-07-22 · Sources: Market-values model; Readiness</a:t>
+              <a:t>Independent public evidence summary · 2026.07.22-9 · 2026-07-22 · Sources: Market-values model; Readiness</a:t>
             </a:r>
           </a:p>
         </p:txBody>
@@ -14046,7 +14046,7 @@
           <p:cNvPr id="7" name="TextBox 6">
             <a:extLst xmlns:a="http://schemas.openxmlformats.org/drawingml/2006/main">
               <a:ext uri="{FF2B5EF4-FFF2-40B4-BE49-F238E27FC236}">
-                <a16:creationId xmlns:a16="http://schemas.microsoft.com/office/drawing/2014/main" id="{13211F6C-2F27-4A62-A259-A91FBE0C6E0C}"/>
+                <a16:creationId xmlns:a16="http://schemas.microsoft.com/office/drawing/2014/main" id="{0401AC9C-3941-491F-95DE-87580D8DB315}"/>
               </a:ext>
             </a:extLst>
           </p:cNvPr>
@@ -14093,7 +14093,7 @@
           <p:cNvPr id="8" name="TextBox 7">
             <a:extLst xmlns:a="http://schemas.openxmlformats.org/drawingml/2006/main">
               <a:ext uri="{FF2B5EF4-FFF2-40B4-BE49-F238E27FC236}">
-                <a16:creationId xmlns:a16="http://schemas.microsoft.com/office/drawing/2014/main" id="{40C0FB65-E50D-43D8-97E7-138C27FD15ED}"/>
+                <a16:creationId xmlns:a16="http://schemas.microsoft.com/office/drawing/2014/main" id="{88748D64-7F67-41A5-8A0E-553CB57C7F0B}"/>
               </a:ext>
             </a:extLst>
           </p:cNvPr>
@@ -14140,7 +14140,7 @@
           <p:cNvPr id="9" name="TextBox 8">
             <a:extLst xmlns:a="http://schemas.openxmlformats.org/drawingml/2006/main">
               <a:ext uri="{FF2B5EF4-FFF2-40B4-BE49-F238E27FC236}">
-                <a16:creationId xmlns:a16="http://schemas.microsoft.com/office/drawing/2014/main" id="{809DCC38-796D-4BA7-96E3-FFD9B60AF935}"/>
+                <a16:creationId xmlns:a16="http://schemas.microsoft.com/office/drawing/2014/main" id="{03E2C2D2-4656-4191-814B-55BD3542E2B7}"/>
               </a:ext>
             </a:extLst>
           </p:cNvPr>
@@ -14237,7 +14237,7 @@
           <p:cNvPr id="10" name="Rounded Rectangle 9">
             <a:extLst xmlns:a="http://schemas.openxmlformats.org/drawingml/2006/main">
               <a:ext uri="{FF2B5EF4-FFF2-40B4-BE49-F238E27FC236}">
-                <a16:creationId xmlns:a16="http://schemas.microsoft.com/office/drawing/2014/main" id="{29392533-9426-4B32-BC3B-73738243DD62}"/>
+                <a16:creationId xmlns:a16="http://schemas.microsoft.com/office/drawing/2014/main" id="{2C6EFA9B-D7E2-45F5-B863-CE4333356FE2}"/>
               </a:ext>
             </a:extLst>
           </p:cNvPr>
@@ -14294,7 +14294,7 @@
           <p:cNvPr id="11" name="TextBox 10">
             <a:extLst xmlns:a="http://schemas.openxmlformats.org/drawingml/2006/main">
               <a:ext uri="{FF2B5EF4-FFF2-40B4-BE49-F238E27FC236}">
-                <a16:creationId xmlns:a16="http://schemas.microsoft.com/office/drawing/2014/main" id="{D5BA3090-2D70-4D8F-9E47-F3CD842238CB}"/>
+                <a16:creationId xmlns:a16="http://schemas.microsoft.com/office/drawing/2014/main" id="{F12B3CAF-6D23-43A6-B492-7C2B68EFF10F}"/>
               </a:ext>
             </a:extLst>
           </p:cNvPr>
@@ -14341,7 +14341,7 @@
           <p:cNvPr id="12" name="TextBox 11">
             <a:extLst xmlns:a="http://schemas.openxmlformats.org/drawingml/2006/main">
               <a:ext uri="{FF2B5EF4-FFF2-40B4-BE49-F238E27FC236}">
-                <a16:creationId xmlns:a16="http://schemas.microsoft.com/office/drawing/2014/main" id="{5CE716EA-1C69-451C-B1A1-1F1D34023EAF}"/>
+                <a16:creationId xmlns:a16="http://schemas.microsoft.com/office/drawing/2014/main" id="{9E38F901-F568-47CE-8998-4437DB276547}"/>
               </a:ext>
             </a:extLst>
           </p:cNvPr>
@@ -14386,7 +14386,7 @@
     </p:spTree>
     <p:extLst>
       <p:ext uri="{BB962C8B-B14F-4D97-AF65-F5344CB8AC3E}">
-        <p14:creationId xmlns:p14="http://schemas.microsoft.com/office/powerpoint/2010/main" val="2099950377"/>
+        <p14:creationId xmlns:p14="http://schemas.microsoft.com/office/powerpoint/2010/main" val="1580677065"/>
       </p:ext>
     </p:extLst>
   </p:cSld>
@@ -14410,7 +14410,7 @@
           <p:cNvPr id="2" name="TextBox 1">
             <a:extLst xmlns:a="http://schemas.openxmlformats.org/drawingml/2006/main">
               <a:ext uri="{FF2B5EF4-FFF2-40B4-BE49-F238E27FC236}">
-                <a16:creationId xmlns:a16="http://schemas.microsoft.com/office/drawing/2014/main" id="{D7FCC518-4625-4E78-9207-A79A30943E0D}"/>
+                <a16:creationId xmlns:a16="http://schemas.microsoft.com/office/drawing/2014/main" id="{2A5B3AA2-A87C-4ACC-A10C-3A4329CD4ED2}"/>
               </a:ext>
             </a:extLst>
           </p:cNvPr>
@@ -14457,7 +14457,7 @@
           <p:cNvPr id="3" name="TextBox 2">
             <a:extLst xmlns:a="http://schemas.openxmlformats.org/drawingml/2006/main">
               <a:ext uri="{FF2B5EF4-FFF2-40B4-BE49-F238E27FC236}">
-                <a16:creationId xmlns:a16="http://schemas.microsoft.com/office/drawing/2014/main" id="{8DCF82FE-8751-43AB-B7F9-97A883BD9FC2}"/>
+                <a16:creationId xmlns:a16="http://schemas.microsoft.com/office/drawing/2014/main" id="{9511DD69-22BC-4A78-99A5-701262F17E00}"/>
               </a:ext>
             </a:extLst>
           </p:cNvPr>
@@ -14504,7 +14504,7 @@
           <p:cNvPr id="4" name="Rectangle 3">
             <a:extLst xmlns:a="http://schemas.openxmlformats.org/drawingml/2006/main">
               <a:ext uri="{FF2B5EF4-FFF2-40B4-BE49-F238E27FC236}">
-                <a16:creationId xmlns:a16="http://schemas.microsoft.com/office/drawing/2014/main" id="{94A63E86-7C35-4EC0-AC7A-1FA08FF6F0B2}"/>
+                <a16:creationId xmlns:a16="http://schemas.microsoft.com/office/drawing/2014/main" id="{15EC310A-1BCF-41DA-9A5A-08506308C2AF}"/>
               </a:ext>
             </a:extLst>
           </p:cNvPr>
@@ -14559,7 +14559,7 @@
           <p:cNvPr id="5" name="Rectangle 4">
             <a:extLst xmlns:a="http://schemas.openxmlformats.org/drawingml/2006/main">
               <a:ext uri="{FF2B5EF4-FFF2-40B4-BE49-F238E27FC236}">
-                <a16:creationId xmlns:a16="http://schemas.microsoft.com/office/drawing/2014/main" id="{B6F3F080-EFDA-4DE4-BF86-DC2DE0191F60}"/>
+                <a16:creationId xmlns:a16="http://schemas.microsoft.com/office/drawing/2014/main" id="{74FD007A-F5A1-4410-B085-08B7210C1501}"/>
               </a:ext>
             </a:extLst>
           </p:cNvPr>
@@ -14614,7 +14614,7 @@
           <p:cNvPr id="6" name="TextBox 5">
             <a:extLst xmlns:a="http://schemas.openxmlformats.org/drawingml/2006/main">
               <a:ext uri="{FF2B5EF4-FFF2-40B4-BE49-F238E27FC236}">
-                <a16:creationId xmlns:a16="http://schemas.microsoft.com/office/drawing/2014/main" id="{A2F904BA-FAF9-4F78-B2F7-05AA493CD8C2}"/>
+                <a16:creationId xmlns:a16="http://schemas.microsoft.com/office/drawing/2014/main" id="{2AFF42F9-239E-4E74-895A-201218BC4EA3}"/>
               </a:ext>
             </a:extLst>
           </p:cNvPr>
@@ -14651,7 +14651,7 @@
                 <a:ea typeface="Aptos"/>
                 <a:cs typeface="Aptos"/>
               </a:rPr>
-              <a:t>Independent public evidence summary · 2026.07.22-8 · 2026-07-22 · Sources: WIPO valuation; Evidence Register</a:t>
+              <a:t>Independent public evidence summary · 2026.07.22-9 · 2026-07-22 · Sources: WIPO valuation; Evidence Register</a:t>
             </a:r>
           </a:p>
         </p:txBody>
@@ -14661,7 +14661,7 @@
           <p:cNvPr id="7" name="TextBox 6">
             <a:extLst xmlns:a="http://schemas.openxmlformats.org/drawingml/2006/main">
               <a:ext uri="{FF2B5EF4-FFF2-40B4-BE49-F238E27FC236}">
-                <a16:creationId xmlns:a16="http://schemas.microsoft.com/office/drawing/2014/main" id="{F044E94F-CAD8-4C2B-8774-FD963192A956}"/>
+                <a16:creationId xmlns:a16="http://schemas.microsoft.com/office/drawing/2014/main" id="{27BD48C3-50F6-49A6-9117-3013839647D1}"/>
               </a:ext>
             </a:extLst>
           </p:cNvPr>
@@ -15231,7 +15231,7 @@
           <p:cNvPr id="9" name="TextBox 8">
             <a:extLst xmlns:a="http://schemas.openxmlformats.org/drawingml/2006/main">
               <a:ext uri="{FF2B5EF4-FFF2-40B4-BE49-F238E27FC236}">
-                <a16:creationId xmlns:a16="http://schemas.microsoft.com/office/drawing/2014/main" id="{C7A5DB2E-7EE4-4F34-A286-3CB9B9F44188}"/>
+                <a16:creationId xmlns:a16="http://schemas.microsoft.com/office/drawing/2014/main" id="{77EF4077-30F4-459E-A417-B46ED985223A}"/>
               </a:ext>
             </a:extLst>
           </p:cNvPr>
@@ -15276,7 +15276,7 @@
     </p:spTree>
     <p:extLst>
       <p:ext uri="{BB962C8B-B14F-4D97-AF65-F5344CB8AC3E}">
-        <p14:creationId xmlns:p14="http://schemas.microsoft.com/office/powerpoint/2010/main" val="1041845827"/>
+        <p14:creationId xmlns:p14="http://schemas.microsoft.com/office/powerpoint/2010/main" val="794536450"/>
       </p:ext>
     </p:extLst>
   </p:cSld>
@@ -15300,7 +15300,7 @@
           <p:cNvPr id="2" name="TextBox 1">
             <a:extLst xmlns:a="http://schemas.openxmlformats.org/drawingml/2006/main">
               <a:ext uri="{FF2B5EF4-FFF2-40B4-BE49-F238E27FC236}">
-                <a16:creationId xmlns:a16="http://schemas.microsoft.com/office/drawing/2014/main" id="{BB98C20B-8300-46FE-95D0-DEF3B16C4083}"/>
+                <a16:creationId xmlns:a16="http://schemas.microsoft.com/office/drawing/2014/main" id="{C8BF708A-6AB5-4B48-AD32-E938D4806647}"/>
               </a:ext>
             </a:extLst>
           </p:cNvPr>
@@ -15347,7 +15347,7 @@
           <p:cNvPr id="3" name="TextBox 2">
             <a:extLst xmlns:a="http://schemas.openxmlformats.org/drawingml/2006/main">
               <a:ext uri="{FF2B5EF4-FFF2-40B4-BE49-F238E27FC236}">
-                <a16:creationId xmlns:a16="http://schemas.microsoft.com/office/drawing/2014/main" id="{CAF260AB-6F63-423B-8829-E7C79992166D}"/>
+                <a16:creationId xmlns:a16="http://schemas.microsoft.com/office/drawing/2014/main" id="{039C45E1-6C21-47AD-A1C3-5122F19354EA}"/>
               </a:ext>
             </a:extLst>
           </p:cNvPr>
@@ -15394,7 +15394,7 @@
           <p:cNvPr id="4" name="Rectangle 3">
             <a:extLst xmlns:a="http://schemas.openxmlformats.org/drawingml/2006/main">
               <a:ext uri="{FF2B5EF4-FFF2-40B4-BE49-F238E27FC236}">
-                <a16:creationId xmlns:a16="http://schemas.microsoft.com/office/drawing/2014/main" id="{F0F1127A-93D1-43F6-8B4D-DD63E6E14DD5}"/>
+                <a16:creationId xmlns:a16="http://schemas.microsoft.com/office/drawing/2014/main" id="{840B5AF4-9F53-4FDC-B047-458C80F0DD45}"/>
               </a:ext>
             </a:extLst>
           </p:cNvPr>
@@ -15449,7 +15449,7 @@
           <p:cNvPr id="5" name="Rectangle 4">
             <a:extLst xmlns:a="http://schemas.openxmlformats.org/drawingml/2006/main">
               <a:ext uri="{FF2B5EF4-FFF2-40B4-BE49-F238E27FC236}">
-                <a16:creationId xmlns:a16="http://schemas.microsoft.com/office/drawing/2014/main" id="{4337D148-F506-4A55-81A0-F638B0E3A788}"/>
+                <a16:creationId xmlns:a16="http://schemas.microsoft.com/office/drawing/2014/main" id="{6A4302CE-C91C-434B-8AF2-F0A8848A70F5}"/>
               </a:ext>
             </a:extLst>
           </p:cNvPr>
@@ -15504,7 +15504,7 @@
           <p:cNvPr id="6" name="TextBox 5">
             <a:extLst xmlns:a="http://schemas.openxmlformats.org/drawingml/2006/main">
               <a:ext uri="{FF2B5EF4-FFF2-40B4-BE49-F238E27FC236}">
-                <a16:creationId xmlns:a16="http://schemas.microsoft.com/office/drawing/2014/main" id="{3568EF28-9BE0-4528-9AB3-9523A97C12E5}"/>
+                <a16:creationId xmlns:a16="http://schemas.microsoft.com/office/drawing/2014/main" id="{2703433C-8A53-4E93-86E4-1AA8F94952DB}"/>
               </a:ext>
             </a:extLst>
           </p:cNvPr>
@@ -15541,7 +15541,7 @@
                 <a:ea typeface="Aptos"/>
                 <a:cs typeface="Aptos"/>
               </a:rPr>
-              <a:t>Independent public evidence summary · 2026.07.22-8 · 2026-07-22 · Sources: EPO; Germany — official judgments; WIPO</a:t>
+              <a:t>Independent public evidence summary · 2026.07.22-9 · 2026-07-22 · Sources: EPO; Germany — official judgments; WIPO</a:t>
             </a:r>
           </a:p>
         </p:txBody>
@@ -15551,7 +15551,7 @@
           <p:cNvPr id="7" name="TextBox 6">
             <a:extLst xmlns:a="http://schemas.openxmlformats.org/drawingml/2006/main">
               <a:ext uri="{FF2B5EF4-FFF2-40B4-BE49-F238E27FC236}">
-                <a16:creationId xmlns:a16="http://schemas.microsoft.com/office/drawing/2014/main" id="{00898CBC-5EF7-43E1-9BA0-100298E3E555}"/>
+                <a16:creationId xmlns:a16="http://schemas.microsoft.com/office/drawing/2014/main" id="{7301BED8-8D2A-4958-B4A3-76BE48D437A0}"/>
               </a:ext>
             </a:extLst>
           </p:cNvPr>
@@ -15598,7 +15598,7 @@
           <p:cNvPr id="8" name="TextBox 7">
             <a:extLst xmlns:a="http://schemas.openxmlformats.org/drawingml/2006/main">
               <a:ext uri="{FF2B5EF4-FFF2-40B4-BE49-F238E27FC236}">
-                <a16:creationId xmlns:a16="http://schemas.microsoft.com/office/drawing/2014/main" id="{5616CF06-0529-4AF5-95B7-33ED3AEB4EA8}"/>
+                <a16:creationId xmlns:a16="http://schemas.microsoft.com/office/drawing/2014/main" id="{AD9BDBCE-B023-4571-A1F5-DE579B0927AF}"/>
               </a:ext>
             </a:extLst>
           </p:cNvPr>
@@ -15645,7 +15645,7 @@
           <p:cNvPr id="9" name="TextBox 8">
             <a:extLst xmlns:a="http://schemas.openxmlformats.org/drawingml/2006/main">
               <a:ext uri="{FF2B5EF4-FFF2-40B4-BE49-F238E27FC236}">
-                <a16:creationId xmlns:a16="http://schemas.microsoft.com/office/drawing/2014/main" id="{2FCD49B8-409F-493B-8DAB-EC2799EEA6FA}"/>
+                <a16:creationId xmlns:a16="http://schemas.microsoft.com/office/drawing/2014/main" id="{7A5B8A30-2FEF-4FD8-8FD4-FEE81E3D0559}"/>
               </a:ext>
             </a:extLst>
           </p:cNvPr>
@@ -15742,7 +15742,7 @@
           <p:cNvPr id="10" name="Rounded Rectangle 9">
             <a:extLst xmlns:a="http://schemas.openxmlformats.org/drawingml/2006/main">
               <a:ext uri="{FF2B5EF4-FFF2-40B4-BE49-F238E27FC236}">
-                <a16:creationId xmlns:a16="http://schemas.microsoft.com/office/drawing/2014/main" id="{61D519DA-A338-45A0-8B1C-C29BA5973638}"/>
+                <a16:creationId xmlns:a16="http://schemas.microsoft.com/office/drawing/2014/main" id="{FE6A8CC8-C75C-439B-806D-352FBBC56840}"/>
               </a:ext>
             </a:extLst>
           </p:cNvPr>
@@ -15799,7 +15799,7 @@
           <p:cNvPr id="11" name="TextBox 10">
             <a:extLst xmlns:a="http://schemas.openxmlformats.org/drawingml/2006/main">
               <a:ext uri="{FF2B5EF4-FFF2-40B4-BE49-F238E27FC236}">
-                <a16:creationId xmlns:a16="http://schemas.microsoft.com/office/drawing/2014/main" id="{C5CFD7D2-40CA-4D62-8B49-3EFAEE2AE0CC}"/>
+                <a16:creationId xmlns:a16="http://schemas.microsoft.com/office/drawing/2014/main" id="{506900D2-EBA4-4DC5-B9AE-7DEE2DDE9CAE}"/>
               </a:ext>
             </a:extLst>
           </p:cNvPr>
@@ -15846,7 +15846,7 @@
           <p:cNvPr id="12" name="TextBox 11">
             <a:extLst xmlns:a="http://schemas.openxmlformats.org/drawingml/2006/main">
               <a:ext uri="{FF2B5EF4-FFF2-40B4-BE49-F238E27FC236}">
-                <a16:creationId xmlns:a16="http://schemas.microsoft.com/office/drawing/2014/main" id="{71016661-D977-4CFC-8E5B-B271753F793D}"/>
+                <a16:creationId xmlns:a16="http://schemas.microsoft.com/office/drawing/2014/main" id="{B4FCA79C-A4CA-4243-B17C-DE26DD323BED}"/>
               </a:ext>
             </a:extLst>
           </p:cNvPr>
@@ -15891,7 +15891,7 @@
     </p:spTree>
     <p:extLst>
       <p:ext uri="{BB962C8B-B14F-4D97-AF65-F5344CB8AC3E}">
-        <p14:creationId xmlns:p14="http://schemas.microsoft.com/office/powerpoint/2010/main" val="1410185387"/>
+        <p14:creationId xmlns:p14="http://schemas.microsoft.com/office/powerpoint/2010/main" val="1870272871"/>
       </p:ext>
     </p:extLst>
   </p:cSld>
@@ -15915,7 +15915,7 @@
           <p:cNvPr id="2" name="TextBox 1">
             <a:extLst xmlns:a="http://schemas.openxmlformats.org/drawingml/2006/main">
               <a:ext uri="{FF2B5EF4-FFF2-40B4-BE49-F238E27FC236}">
-                <a16:creationId xmlns:a16="http://schemas.microsoft.com/office/drawing/2014/main" id="{9BC684A8-B9ED-4B33-A1FB-41F9755C5CE1}"/>
+                <a16:creationId xmlns:a16="http://schemas.microsoft.com/office/drawing/2014/main" id="{85A7B432-AB71-4CEB-A856-964BB465E839}"/>
               </a:ext>
             </a:extLst>
           </p:cNvPr>
@@ -15962,7 +15962,7 @@
           <p:cNvPr id="3" name="TextBox 2">
             <a:extLst xmlns:a="http://schemas.openxmlformats.org/drawingml/2006/main">
               <a:ext uri="{FF2B5EF4-FFF2-40B4-BE49-F238E27FC236}">
-                <a16:creationId xmlns:a16="http://schemas.microsoft.com/office/drawing/2014/main" id="{C5F8D3D0-2C8D-4B53-8F4A-3F5A907D505E}"/>
+                <a16:creationId xmlns:a16="http://schemas.microsoft.com/office/drawing/2014/main" id="{658D9CB7-60D7-48A3-B946-DD67A414BB7B}"/>
               </a:ext>
             </a:extLst>
           </p:cNvPr>
@@ -16009,7 +16009,7 @@
           <p:cNvPr id="4" name="Rectangle 3">
             <a:extLst xmlns:a="http://schemas.openxmlformats.org/drawingml/2006/main">
               <a:ext uri="{FF2B5EF4-FFF2-40B4-BE49-F238E27FC236}">
-                <a16:creationId xmlns:a16="http://schemas.microsoft.com/office/drawing/2014/main" id="{5759277A-CAA9-4DEB-BB64-E6CD35B7ECC9}"/>
+                <a16:creationId xmlns:a16="http://schemas.microsoft.com/office/drawing/2014/main" id="{B74B47CE-4EF1-45B5-8DEE-BDCCA3AA91F3}"/>
               </a:ext>
             </a:extLst>
           </p:cNvPr>
@@ -16064,7 +16064,7 @@
           <p:cNvPr id="5" name="Rectangle 4">
             <a:extLst xmlns:a="http://schemas.openxmlformats.org/drawingml/2006/main">
               <a:ext uri="{FF2B5EF4-FFF2-40B4-BE49-F238E27FC236}">
-                <a16:creationId xmlns:a16="http://schemas.microsoft.com/office/drawing/2014/main" id="{90BE8294-7DAD-4770-BAA0-374E3A710D22}"/>
+                <a16:creationId xmlns:a16="http://schemas.microsoft.com/office/drawing/2014/main" id="{659BFD51-0C1E-4D75-8D38-4EC1ED3C6717}"/>
               </a:ext>
             </a:extLst>
           </p:cNvPr>
@@ -16119,7 +16119,7 @@
           <p:cNvPr id="6" name="TextBox 5">
             <a:extLst xmlns:a="http://schemas.openxmlformats.org/drawingml/2006/main">
               <a:ext uri="{FF2B5EF4-FFF2-40B4-BE49-F238E27FC236}">
-                <a16:creationId xmlns:a16="http://schemas.microsoft.com/office/drawing/2014/main" id="{2ADB7E52-220C-4EB3-9802-99A378E9F0B4}"/>
+                <a16:creationId xmlns:a16="http://schemas.microsoft.com/office/drawing/2014/main" id="{EAB1AF26-1A24-41C1-8640-530A49816AAA}"/>
               </a:ext>
             </a:extLst>
           </p:cNvPr>
@@ -16156,7 +16156,7 @@
                 <a:ea typeface="Aptos"/>
                 <a:cs typeface="Aptos"/>
               </a:rPr>
-              <a:t>Independent public evidence summary · 2026.07.22-8 · 2026-07-22 · Sources: WIPO licensing; IP Finance</a:t>
+              <a:t>Independent public evidence summary · 2026.07.22-9 · 2026-07-22 · Sources: WIPO licensing; IP Finance</a:t>
             </a:r>
           </a:p>
         </p:txBody>
@@ -16166,7 +16166,7 @@
           <p:cNvPr id="7" name="TextBox 6">
             <a:extLst xmlns:a="http://schemas.openxmlformats.org/drawingml/2006/main">
               <a:ext uri="{FF2B5EF4-FFF2-40B4-BE49-F238E27FC236}">
-                <a16:creationId xmlns:a16="http://schemas.microsoft.com/office/drawing/2014/main" id="{03A52631-3B07-4567-8D89-F2CAE38178F7}"/>
+                <a16:creationId xmlns:a16="http://schemas.microsoft.com/office/drawing/2014/main" id="{49CCDE48-5046-41D4-BE2B-486605C4794C}"/>
               </a:ext>
             </a:extLst>
           </p:cNvPr>
@@ -16213,7 +16213,7 @@
           <p:cNvPr id="8" name="TextBox 7">
             <a:extLst xmlns:a="http://schemas.openxmlformats.org/drawingml/2006/main">
               <a:ext uri="{FF2B5EF4-FFF2-40B4-BE49-F238E27FC236}">
-                <a16:creationId xmlns:a16="http://schemas.microsoft.com/office/drawing/2014/main" id="{50140370-D140-413B-978F-44F78E8AC21D}"/>
+                <a16:creationId xmlns:a16="http://schemas.microsoft.com/office/drawing/2014/main" id="{77CACC44-5B69-4085-AEC1-736E00C9D3D1}"/>
               </a:ext>
             </a:extLst>
           </p:cNvPr>
@@ -16260,7 +16260,7 @@
           <p:cNvPr id="9" name="TextBox 8">
             <a:extLst xmlns:a="http://schemas.openxmlformats.org/drawingml/2006/main">
               <a:ext uri="{FF2B5EF4-FFF2-40B4-BE49-F238E27FC236}">
-                <a16:creationId xmlns:a16="http://schemas.microsoft.com/office/drawing/2014/main" id="{E97E0E92-A99A-4FB6-8FDE-1CE15BF2F537}"/>
+                <a16:creationId xmlns:a16="http://schemas.microsoft.com/office/drawing/2014/main" id="{55627811-2E94-4D54-86DD-CDF36C6DF116}"/>
               </a:ext>
             </a:extLst>
           </p:cNvPr>
@@ -16357,7 +16357,7 @@
           <p:cNvPr id="10" name="Rounded Rectangle 9">
             <a:extLst xmlns:a="http://schemas.openxmlformats.org/drawingml/2006/main">
               <a:ext uri="{FF2B5EF4-FFF2-40B4-BE49-F238E27FC236}">
-                <a16:creationId xmlns:a16="http://schemas.microsoft.com/office/drawing/2014/main" id="{8092EAC2-9C13-40E8-ACE0-D335DFB50950}"/>
+                <a16:creationId xmlns:a16="http://schemas.microsoft.com/office/drawing/2014/main" id="{51209ECF-F186-4DF0-884E-5547CDE3365A}"/>
               </a:ext>
             </a:extLst>
           </p:cNvPr>
@@ -16414,7 +16414,7 @@
           <p:cNvPr id="11" name="TextBox 10">
             <a:extLst xmlns:a="http://schemas.openxmlformats.org/drawingml/2006/main">
               <a:ext uri="{FF2B5EF4-FFF2-40B4-BE49-F238E27FC236}">
-                <a16:creationId xmlns:a16="http://schemas.microsoft.com/office/drawing/2014/main" id="{88B03450-CC1C-4AB3-B3F1-D7C92231CA62}"/>
+                <a16:creationId xmlns:a16="http://schemas.microsoft.com/office/drawing/2014/main" id="{D8D4ECBB-053D-4FD8-8F0F-0125426EF464}"/>
               </a:ext>
             </a:extLst>
           </p:cNvPr>
@@ -16461,7 +16461,7 @@
           <p:cNvPr id="12" name="TextBox 11">
             <a:extLst xmlns:a="http://schemas.openxmlformats.org/drawingml/2006/main">
               <a:ext uri="{FF2B5EF4-FFF2-40B4-BE49-F238E27FC236}">
-                <a16:creationId xmlns:a16="http://schemas.microsoft.com/office/drawing/2014/main" id="{0F370F3D-A567-42FD-BB37-6C6711D24EC2}"/>
+                <a16:creationId xmlns:a16="http://schemas.microsoft.com/office/drawing/2014/main" id="{596BFF5A-4468-4543-AC42-6E54F65D580B}"/>
               </a:ext>
             </a:extLst>
           </p:cNvPr>
@@ -16506,7 +16506,7 @@
     </p:spTree>
     <p:extLst>
       <p:ext uri="{BB962C8B-B14F-4D97-AF65-F5344CB8AC3E}">
-        <p14:creationId xmlns:p14="http://schemas.microsoft.com/office/powerpoint/2010/main" val="567224517"/>
+        <p14:creationId xmlns:p14="http://schemas.microsoft.com/office/powerpoint/2010/main" val="1155978858"/>
       </p:ext>
     </p:extLst>
   </p:cSld>
@@ -16530,7 +16530,7 @@
           <p:cNvPr id="2" name="TextBox 1">
             <a:extLst xmlns:a="http://schemas.openxmlformats.org/drawingml/2006/main">
               <a:ext uri="{FF2B5EF4-FFF2-40B4-BE49-F238E27FC236}">
-                <a16:creationId xmlns:a16="http://schemas.microsoft.com/office/drawing/2014/main" id="{CB3D6D7B-9BF3-46EE-AFC5-4C7990D634E3}"/>
+                <a16:creationId xmlns:a16="http://schemas.microsoft.com/office/drawing/2014/main" id="{D03DA760-0984-499B-AD2E-6BBB9AC1E0A2}"/>
               </a:ext>
             </a:extLst>
           </p:cNvPr>
@@ -16577,7 +16577,7 @@
           <p:cNvPr id="3" name="TextBox 2">
             <a:extLst xmlns:a="http://schemas.openxmlformats.org/drawingml/2006/main">
               <a:ext uri="{FF2B5EF4-FFF2-40B4-BE49-F238E27FC236}">
-                <a16:creationId xmlns:a16="http://schemas.microsoft.com/office/drawing/2014/main" id="{A32DDCAC-22DC-470A-A0E2-8140CC19EB34}"/>
+                <a16:creationId xmlns:a16="http://schemas.microsoft.com/office/drawing/2014/main" id="{4C6CEC90-BB31-49C8-A4A0-18A4D5395B6A}"/>
               </a:ext>
             </a:extLst>
           </p:cNvPr>
@@ -16624,7 +16624,7 @@
           <p:cNvPr id="4" name="Rectangle 3">
             <a:extLst xmlns:a="http://schemas.openxmlformats.org/drawingml/2006/main">
               <a:ext uri="{FF2B5EF4-FFF2-40B4-BE49-F238E27FC236}">
-                <a16:creationId xmlns:a16="http://schemas.microsoft.com/office/drawing/2014/main" id="{DCC61226-432E-40A9-A79C-D874ED48895E}"/>
+                <a16:creationId xmlns:a16="http://schemas.microsoft.com/office/drawing/2014/main" id="{DD73F3FB-ED1C-4FC7-A201-41AFB50B31F8}"/>
               </a:ext>
             </a:extLst>
           </p:cNvPr>
@@ -16679,7 +16679,7 @@
           <p:cNvPr id="5" name="Rectangle 4">
             <a:extLst xmlns:a="http://schemas.openxmlformats.org/drawingml/2006/main">
               <a:ext uri="{FF2B5EF4-FFF2-40B4-BE49-F238E27FC236}">
-                <a16:creationId xmlns:a16="http://schemas.microsoft.com/office/drawing/2014/main" id="{0EF742D0-3CBF-4536-B3A0-3BF669EDA0D8}"/>
+                <a16:creationId xmlns:a16="http://schemas.microsoft.com/office/drawing/2014/main" id="{2D46930E-332C-4E19-A969-087A95F452E6}"/>
               </a:ext>
             </a:extLst>
           </p:cNvPr>
@@ -16734,7 +16734,7 @@
           <p:cNvPr id="6" name="TextBox 5">
             <a:extLst xmlns:a="http://schemas.openxmlformats.org/drawingml/2006/main">
               <a:ext uri="{FF2B5EF4-FFF2-40B4-BE49-F238E27FC236}">
-                <a16:creationId xmlns:a16="http://schemas.microsoft.com/office/drawing/2014/main" id="{0F2248A0-5645-41D8-9480-65A97EC29754}"/>
+                <a16:creationId xmlns:a16="http://schemas.microsoft.com/office/drawing/2014/main" id="{9EB8F954-47AA-41EE-AC76-D2FBC5927E85}"/>
               </a:ext>
             </a:extLst>
           </p:cNvPr>
@@ -16771,7 +16771,7 @@
                 <a:ea typeface="Aptos"/>
                 <a:cs typeface="Aptos"/>
               </a:rPr>
-              <a:t>Independent public evidence summary · 2026.07.22-8 · 2026-07-22 · Sources: Evidence Register; EPO</a:t>
+              <a:t>Independent public evidence summary · 2026.07.22-9 · 2026-07-22 · Sources: Evidence Register; EPO</a:t>
             </a:r>
           </a:p>
         </p:txBody>
@@ -16781,7 +16781,7 @@
           <p:cNvPr id="7" name="TextBox 6">
             <a:extLst xmlns:a="http://schemas.openxmlformats.org/drawingml/2006/main">
               <a:ext uri="{FF2B5EF4-FFF2-40B4-BE49-F238E27FC236}">
-                <a16:creationId xmlns:a16="http://schemas.microsoft.com/office/drawing/2014/main" id="{75879735-5B1E-495F-92B5-912939C28B4A}"/>
+                <a16:creationId xmlns:a16="http://schemas.microsoft.com/office/drawing/2014/main" id="{F5487946-D63A-44FB-8C8A-A27D0155D61E}"/>
               </a:ext>
             </a:extLst>
           </p:cNvPr>
@@ -17268,7 +17268,7 @@
           <p:cNvPr id="9" name="TextBox 8">
             <a:extLst xmlns:a="http://schemas.openxmlformats.org/drawingml/2006/main">
               <a:ext uri="{FF2B5EF4-FFF2-40B4-BE49-F238E27FC236}">
-                <a16:creationId xmlns:a16="http://schemas.microsoft.com/office/drawing/2014/main" id="{6F0FB373-22B2-488C-98C7-A09593A1CB28}"/>
+                <a16:creationId xmlns:a16="http://schemas.microsoft.com/office/drawing/2014/main" id="{11138F25-A2D8-431A-81B8-8A9DD1539BE1}"/>
               </a:ext>
             </a:extLst>
           </p:cNvPr>
@@ -17313,7 +17313,7 @@
     </p:spTree>
     <p:extLst>
       <p:ext uri="{BB962C8B-B14F-4D97-AF65-F5344CB8AC3E}">
-        <p14:creationId xmlns:p14="http://schemas.microsoft.com/office/powerpoint/2010/main" val="525930496"/>
+        <p14:creationId xmlns:p14="http://schemas.microsoft.com/office/powerpoint/2010/main" val="1240088644"/>
       </p:ext>
     </p:extLst>
   </p:cSld>
@@ -17337,7 +17337,7 @@
           <p:cNvPr id="2" name="TextBox 1">
             <a:extLst xmlns:a="http://schemas.openxmlformats.org/drawingml/2006/main">
               <a:ext uri="{FF2B5EF4-FFF2-40B4-BE49-F238E27FC236}">
-                <a16:creationId xmlns:a16="http://schemas.microsoft.com/office/drawing/2014/main" id="{E8C1AE68-4E43-4D1A-96A3-F8FCBC31D792}"/>
+                <a16:creationId xmlns:a16="http://schemas.microsoft.com/office/drawing/2014/main" id="{E8D75A87-E60A-40A8-863D-3FC88E05E2F2}"/>
               </a:ext>
             </a:extLst>
           </p:cNvPr>
@@ -17384,7 +17384,7 @@
           <p:cNvPr id="3" name="TextBox 2">
             <a:extLst xmlns:a="http://schemas.openxmlformats.org/drawingml/2006/main">
               <a:ext uri="{FF2B5EF4-FFF2-40B4-BE49-F238E27FC236}">
-                <a16:creationId xmlns:a16="http://schemas.microsoft.com/office/drawing/2014/main" id="{52E8D07E-9805-4A1C-AD49-2A2168943634}"/>
+                <a16:creationId xmlns:a16="http://schemas.microsoft.com/office/drawing/2014/main" id="{3A5F2887-7033-41C3-BA75-6874578B8A9A}"/>
               </a:ext>
             </a:extLst>
           </p:cNvPr>
@@ -17431,7 +17431,7 @@
           <p:cNvPr id="4" name="Rectangle 3">
             <a:extLst xmlns:a="http://schemas.openxmlformats.org/drawingml/2006/main">
               <a:ext uri="{FF2B5EF4-FFF2-40B4-BE49-F238E27FC236}">
-                <a16:creationId xmlns:a16="http://schemas.microsoft.com/office/drawing/2014/main" id="{E2A6AA89-BA3C-45FF-9C40-244AF73570D8}"/>
+                <a16:creationId xmlns:a16="http://schemas.microsoft.com/office/drawing/2014/main" id="{51229D39-7823-4082-B0BF-B4B5031AAB32}"/>
               </a:ext>
             </a:extLst>
           </p:cNvPr>
@@ -17486,7 +17486,7 @@
           <p:cNvPr id="5" name="Rectangle 4">
             <a:extLst xmlns:a="http://schemas.openxmlformats.org/drawingml/2006/main">
               <a:ext uri="{FF2B5EF4-FFF2-40B4-BE49-F238E27FC236}">
-                <a16:creationId xmlns:a16="http://schemas.microsoft.com/office/drawing/2014/main" id="{5EFF69BA-2B45-49E0-8399-D458803BB3BA}"/>
+                <a16:creationId xmlns:a16="http://schemas.microsoft.com/office/drawing/2014/main" id="{E50E1835-613B-416C-BC7B-48190EF1C24A}"/>
               </a:ext>
             </a:extLst>
           </p:cNvPr>
@@ -17541,7 +17541,7 @@
           <p:cNvPr id="6" name="TextBox 5">
             <a:extLst xmlns:a="http://schemas.openxmlformats.org/drawingml/2006/main">
               <a:ext uri="{FF2B5EF4-FFF2-40B4-BE49-F238E27FC236}">
-                <a16:creationId xmlns:a16="http://schemas.microsoft.com/office/drawing/2014/main" id="{CEBEFADF-1524-4584-857C-A7F5E0209338}"/>
+                <a16:creationId xmlns:a16="http://schemas.microsoft.com/office/drawing/2014/main" id="{A454BFF3-9B91-4865-8F6C-A85BFD51816E}"/>
               </a:ext>
             </a:extLst>
           </p:cNvPr>
@@ -17578,7 +17578,7 @@
                 <a:ea typeface="Aptos"/>
                 <a:cs typeface="Aptos"/>
               </a:rPr>
-              <a:t>Independent public evidence summary · 2026.07.22-8 · 2026-07-22 · Sources: EP3032975B2; 7 O 3341/24</a:t>
+              <a:t>Independent public evidence summary · 2026.07.22-9 · 2026-07-22 · Sources: EP3032975B2; 7 O 3341/24</a:t>
             </a:r>
           </a:p>
         </p:txBody>
@@ -17588,7 +17588,7 @@
           <p:cNvPr id="7" name="TextBox 6">
             <a:extLst xmlns:a="http://schemas.openxmlformats.org/drawingml/2006/main">
               <a:ext uri="{FF2B5EF4-FFF2-40B4-BE49-F238E27FC236}">
-                <a16:creationId xmlns:a16="http://schemas.microsoft.com/office/drawing/2014/main" id="{675C4238-DE6F-4C6A-A1B7-9FA7AAC36863}"/>
+                <a16:creationId xmlns:a16="http://schemas.microsoft.com/office/drawing/2014/main" id="{6E931DB9-A87D-49CE-BA4A-1714BD9C50AB}"/>
               </a:ext>
             </a:extLst>
           </p:cNvPr>
@@ -17635,7 +17635,7 @@
           <p:cNvPr id="8" name="Rounded Rectangle 7">
             <a:extLst xmlns:a="http://schemas.openxmlformats.org/drawingml/2006/main">
               <a:ext uri="{FF2B5EF4-FFF2-40B4-BE49-F238E27FC236}">
-                <a16:creationId xmlns:a16="http://schemas.microsoft.com/office/drawing/2014/main" id="{EA98660C-C734-440B-9B59-58508D5BF6A7}"/>
+                <a16:creationId xmlns:a16="http://schemas.microsoft.com/office/drawing/2014/main" id="{03160B88-B59F-4BB8-A89A-DBCFD40E9348}"/>
               </a:ext>
             </a:extLst>
           </p:cNvPr>
@@ -17692,7 +17692,7 @@
           <p:cNvPr id="9" name="TextBox 8">
             <a:extLst xmlns:a="http://schemas.openxmlformats.org/drawingml/2006/main">
               <a:ext uri="{FF2B5EF4-FFF2-40B4-BE49-F238E27FC236}">
-                <a16:creationId xmlns:a16="http://schemas.microsoft.com/office/drawing/2014/main" id="{560609DB-7064-4513-AD50-D73CBEECEAB1}"/>
+                <a16:creationId xmlns:a16="http://schemas.microsoft.com/office/drawing/2014/main" id="{5A00457D-CE7C-44FB-847A-85E06200B06F}"/>
               </a:ext>
             </a:extLst>
           </p:cNvPr>
@@ -17739,7 +17739,7 @@
           <p:cNvPr id="10" name="TextBox 9">
             <a:extLst xmlns:a="http://schemas.openxmlformats.org/drawingml/2006/main">
               <a:ext uri="{FF2B5EF4-FFF2-40B4-BE49-F238E27FC236}">
-                <a16:creationId xmlns:a16="http://schemas.microsoft.com/office/drawing/2014/main" id="{00D56DF5-556C-4891-994E-72F15F94C21C}"/>
+                <a16:creationId xmlns:a16="http://schemas.microsoft.com/office/drawing/2014/main" id="{DADDD63B-2A19-48CD-951A-7805C9FDBB58}"/>
               </a:ext>
             </a:extLst>
           </p:cNvPr>
@@ -17786,7 +17786,7 @@
           <p:cNvPr id="11" name="TextBox 10">
             <a:extLst xmlns:a="http://schemas.openxmlformats.org/drawingml/2006/main">
               <a:ext uri="{FF2B5EF4-FFF2-40B4-BE49-F238E27FC236}">
-                <a16:creationId xmlns:a16="http://schemas.microsoft.com/office/drawing/2014/main" id="{10A7032C-9D01-4C5F-B892-76BAF78793D8}"/>
+                <a16:creationId xmlns:a16="http://schemas.microsoft.com/office/drawing/2014/main" id="{5015F019-8087-442A-BBAD-5CD167F57991}"/>
               </a:ext>
             </a:extLst>
           </p:cNvPr>
@@ -17833,7 +17833,7 @@
           <p:cNvPr id="12" name="Rounded Rectangle 11">
             <a:extLst xmlns:a="http://schemas.openxmlformats.org/drawingml/2006/main">
               <a:ext uri="{FF2B5EF4-FFF2-40B4-BE49-F238E27FC236}">
-                <a16:creationId xmlns:a16="http://schemas.microsoft.com/office/drawing/2014/main" id="{CB4A20B6-462A-4B83-8929-AA734EEEE3F5}"/>
+                <a16:creationId xmlns:a16="http://schemas.microsoft.com/office/drawing/2014/main" id="{4A815717-894A-4C12-834F-9291A24896BF}"/>
               </a:ext>
             </a:extLst>
           </p:cNvPr>
@@ -17890,7 +17890,7 @@
           <p:cNvPr id="13" name="TextBox 12">
             <a:extLst xmlns:a="http://schemas.openxmlformats.org/drawingml/2006/main">
               <a:ext uri="{FF2B5EF4-FFF2-40B4-BE49-F238E27FC236}">
-                <a16:creationId xmlns:a16="http://schemas.microsoft.com/office/drawing/2014/main" id="{08A0660F-3CAE-4313-83A8-5CD8DA16A369}"/>
+                <a16:creationId xmlns:a16="http://schemas.microsoft.com/office/drawing/2014/main" id="{1B2FF549-C939-4FEF-BF83-7701C0F9E5B6}"/>
               </a:ext>
             </a:extLst>
           </p:cNvPr>
@@ -17937,7 +17937,7 @@
           <p:cNvPr id="14" name="TextBox 13">
             <a:extLst xmlns:a="http://schemas.openxmlformats.org/drawingml/2006/main">
               <a:ext uri="{FF2B5EF4-FFF2-40B4-BE49-F238E27FC236}">
-                <a16:creationId xmlns:a16="http://schemas.microsoft.com/office/drawing/2014/main" id="{6D889CCE-86B1-4DFA-AB54-3D89245BACC9}"/>
+                <a16:creationId xmlns:a16="http://schemas.microsoft.com/office/drawing/2014/main" id="{4F9A56E8-0DE4-412E-B00A-20446FCC24D1}"/>
               </a:ext>
             </a:extLst>
           </p:cNvPr>
@@ -17984,7 +17984,7 @@
           <p:cNvPr id="15" name="TextBox 14">
             <a:extLst xmlns:a="http://schemas.openxmlformats.org/drawingml/2006/main">
               <a:ext uri="{FF2B5EF4-FFF2-40B4-BE49-F238E27FC236}">
-                <a16:creationId xmlns:a16="http://schemas.microsoft.com/office/drawing/2014/main" id="{2D21E898-0159-487D-811F-C3DAC2A2ABB8}"/>
+                <a16:creationId xmlns:a16="http://schemas.microsoft.com/office/drawing/2014/main" id="{451863E0-9137-4E73-A868-407823AD13BA}"/>
               </a:ext>
             </a:extLst>
           </p:cNvPr>
@@ -18031,7 +18031,7 @@
           <p:cNvPr id="16" name="Rounded Rectangle 15">
             <a:extLst xmlns:a="http://schemas.openxmlformats.org/drawingml/2006/main">
               <a:ext uri="{FF2B5EF4-FFF2-40B4-BE49-F238E27FC236}">
-                <a16:creationId xmlns:a16="http://schemas.microsoft.com/office/drawing/2014/main" id="{F924260B-AB61-4E69-A05B-438708919285}"/>
+                <a16:creationId xmlns:a16="http://schemas.microsoft.com/office/drawing/2014/main" id="{AB60F21B-7613-4F7A-8BE4-0209FA846135}"/>
               </a:ext>
             </a:extLst>
           </p:cNvPr>
@@ -18088,7 +18088,7 @@
           <p:cNvPr id="17" name="TextBox 16">
             <a:extLst xmlns:a="http://schemas.openxmlformats.org/drawingml/2006/main">
               <a:ext uri="{FF2B5EF4-FFF2-40B4-BE49-F238E27FC236}">
-                <a16:creationId xmlns:a16="http://schemas.microsoft.com/office/drawing/2014/main" id="{8B0E105B-EC1A-492E-8F5D-A6E9A4FFB4F4}"/>
+                <a16:creationId xmlns:a16="http://schemas.microsoft.com/office/drawing/2014/main" id="{9A1F3B46-46C6-48DC-A545-6176E8E50308}"/>
               </a:ext>
             </a:extLst>
           </p:cNvPr>
@@ -18135,7 +18135,7 @@
           <p:cNvPr id="18" name="TextBox 17">
             <a:extLst xmlns:a="http://schemas.openxmlformats.org/drawingml/2006/main">
               <a:ext uri="{FF2B5EF4-FFF2-40B4-BE49-F238E27FC236}">
-                <a16:creationId xmlns:a16="http://schemas.microsoft.com/office/drawing/2014/main" id="{621D6859-87D8-4B21-A524-5A5AA5DD35DB}"/>
+                <a16:creationId xmlns:a16="http://schemas.microsoft.com/office/drawing/2014/main" id="{0E8818AE-E36A-4BCE-8B60-BD7518EBB529}"/>
               </a:ext>
             </a:extLst>
           </p:cNvPr>
@@ -18182,7 +18182,7 @@
           <p:cNvPr id="19" name="TextBox 18">
             <a:extLst xmlns:a="http://schemas.openxmlformats.org/drawingml/2006/main">
               <a:ext uri="{FF2B5EF4-FFF2-40B4-BE49-F238E27FC236}">
-                <a16:creationId xmlns:a16="http://schemas.microsoft.com/office/drawing/2014/main" id="{DBA79293-7144-4553-A2B9-4693155D2034}"/>
+                <a16:creationId xmlns:a16="http://schemas.microsoft.com/office/drawing/2014/main" id="{20BD3A17-44B8-42EA-9B2C-249CFDFC23CC}"/>
               </a:ext>
             </a:extLst>
           </p:cNvPr>
@@ -18229,7 +18229,7 @@
           <p:cNvPr id="20" name="Rounded Rectangle 19">
             <a:extLst xmlns:a="http://schemas.openxmlformats.org/drawingml/2006/main">
               <a:ext uri="{FF2B5EF4-FFF2-40B4-BE49-F238E27FC236}">
-                <a16:creationId xmlns:a16="http://schemas.microsoft.com/office/drawing/2014/main" id="{C2FC7A2F-67C1-4559-85B0-5710F6FFB5DE}"/>
+                <a16:creationId xmlns:a16="http://schemas.microsoft.com/office/drawing/2014/main" id="{AFE5E6C1-6216-490A-87D3-7605C9F071A4}"/>
               </a:ext>
             </a:extLst>
           </p:cNvPr>
@@ -18286,7 +18286,7 @@
           <p:cNvPr id="21" name="TextBox 20">
             <a:extLst xmlns:a="http://schemas.openxmlformats.org/drawingml/2006/main">
               <a:ext uri="{FF2B5EF4-FFF2-40B4-BE49-F238E27FC236}">
-                <a16:creationId xmlns:a16="http://schemas.microsoft.com/office/drawing/2014/main" id="{84C0E70A-5D00-45E2-AF00-D6FC58B38849}"/>
+                <a16:creationId xmlns:a16="http://schemas.microsoft.com/office/drawing/2014/main" id="{C6628B6A-2405-4AE7-993D-0709CD6F06B4}"/>
               </a:ext>
             </a:extLst>
           </p:cNvPr>
@@ -18333,7 +18333,7 @@
           <p:cNvPr id="22" name="TextBox 21">
             <a:extLst xmlns:a="http://schemas.openxmlformats.org/drawingml/2006/main">
               <a:ext uri="{FF2B5EF4-FFF2-40B4-BE49-F238E27FC236}">
-                <a16:creationId xmlns:a16="http://schemas.microsoft.com/office/drawing/2014/main" id="{AE73A95D-DEA6-4ABA-8AB3-3055BD52937F}"/>
+                <a16:creationId xmlns:a16="http://schemas.microsoft.com/office/drawing/2014/main" id="{78CB31B6-3C24-454B-BCB0-242972C2583A}"/>
               </a:ext>
             </a:extLst>
           </p:cNvPr>
@@ -18380,7 +18380,7 @@
           <p:cNvPr id="23" name="TextBox 22">
             <a:extLst xmlns:a="http://schemas.openxmlformats.org/drawingml/2006/main">
               <a:ext uri="{FF2B5EF4-FFF2-40B4-BE49-F238E27FC236}">
-                <a16:creationId xmlns:a16="http://schemas.microsoft.com/office/drawing/2014/main" id="{E51A791A-BC29-4A94-BF42-132266538FC5}"/>
+                <a16:creationId xmlns:a16="http://schemas.microsoft.com/office/drawing/2014/main" id="{5C3E021B-E459-46E5-866F-A7EE1C8E6B61}"/>
               </a:ext>
             </a:extLst>
           </p:cNvPr>
@@ -18427,7 +18427,7 @@
           <p:cNvPr id="24" name="TextBox 23">
             <a:extLst xmlns:a="http://schemas.openxmlformats.org/drawingml/2006/main">
               <a:ext uri="{FF2B5EF4-FFF2-40B4-BE49-F238E27FC236}">
-                <a16:creationId xmlns:a16="http://schemas.microsoft.com/office/drawing/2014/main" id="{7430E9FC-6B87-474D-B163-FB10AF7DE064}"/>
+                <a16:creationId xmlns:a16="http://schemas.microsoft.com/office/drawing/2014/main" id="{2881B841-623D-42CB-B52D-6BAA8B0A9AC3}"/>
               </a:ext>
             </a:extLst>
           </p:cNvPr>
@@ -18472,7 +18472,7 @@
     </p:spTree>
     <p:extLst>
       <p:ext uri="{BB962C8B-B14F-4D97-AF65-F5344CB8AC3E}">
-        <p14:creationId xmlns:p14="http://schemas.microsoft.com/office/powerpoint/2010/main" val="1344514780"/>
+        <p14:creationId xmlns:p14="http://schemas.microsoft.com/office/powerpoint/2010/main" val="1540590765"/>
       </p:ext>
     </p:extLst>
   </p:cSld>
@@ -18496,7 +18496,7 @@
           <p:cNvPr id="2" name="TextBox 1">
             <a:extLst xmlns:a="http://schemas.openxmlformats.org/drawingml/2006/main">
               <a:ext uri="{FF2B5EF4-FFF2-40B4-BE49-F238E27FC236}">
-                <a16:creationId xmlns:a16="http://schemas.microsoft.com/office/drawing/2014/main" id="{52CF3436-1928-4EF4-8D16-4824357F2779}"/>
+                <a16:creationId xmlns:a16="http://schemas.microsoft.com/office/drawing/2014/main" id="{6006C4E8-B78E-474D-A7C6-9AB15900715D}"/>
               </a:ext>
             </a:extLst>
           </p:cNvPr>
@@ -18543,7 +18543,7 @@
           <p:cNvPr id="3" name="TextBox 2">
             <a:extLst xmlns:a="http://schemas.openxmlformats.org/drawingml/2006/main">
               <a:ext uri="{FF2B5EF4-FFF2-40B4-BE49-F238E27FC236}">
-                <a16:creationId xmlns:a16="http://schemas.microsoft.com/office/drawing/2014/main" id="{9883DD90-B2C3-4E3E-84E8-F6BF1328237D}"/>
+                <a16:creationId xmlns:a16="http://schemas.microsoft.com/office/drawing/2014/main" id="{761CA223-E18E-4892-AAB2-12240B210DC5}"/>
               </a:ext>
             </a:extLst>
           </p:cNvPr>
@@ -18590,7 +18590,7 @@
           <p:cNvPr id="4" name="Rectangle 3">
             <a:extLst xmlns:a="http://schemas.openxmlformats.org/drawingml/2006/main">
               <a:ext uri="{FF2B5EF4-FFF2-40B4-BE49-F238E27FC236}">
-                <a16:creationId xmlns:a16="http://schemas.microsoft.com/office/drawing/2014/main" id="{64DEC27A-4AF7-4CE9-B5E9-5582D0F1C469}"/>
+                <a16:creationId xmlns:a16="http://schemas.microsoft.com/office/drawing/2014/main" id="{E285A37D-1E96-4E10-8B28-2BC93FDD17ED}"/>
               </a:ext>
             </a:extLst>
           </p:cNvPr>
@@ -18645,7 +18645,7 @@
           <p:cNvPr id="5" name="Rectangle 4">
             <a:extLst xmlns:a="http://schemas.openxmlformats.org/drawingml/2006/main">
               <a:ext uri="{FF2B5EF4-FFF2-40B4-BE49-F238E27FC236}">
-                <a16:creationId xmlns:a16="http://schemas.microsoft.com/office/drawing/2014/main" id="{E91DBDA0-B8EA-4096-984C-151DD72CD213}"/>
+                <a16:creationId xmlns:a16="http://schemas.microsoft.com/office/drawing/2014/main" id="{E6744067-E5D3-406A-ACED-6654EFED4797}"/>
               </a:ext>
             </a:extLst>
           </p:cNvPr>
@@ -18700,7 +18700,7 @@
           <p:cNvPr id="6" name="TextBox 5">
             <a:extLst xmlns:a="http://schemas.openxmlformats.org/drawingml/2006/main">
               <a:ext uri="{FF2B5EF4-FFF2-40B4-BE49-F238E27FC236}">
-                <a16:creationId xmlns:a16="http://schemas.microsoft.com/office/drawing/2014/main" id="{928AEB55-BEFD-415A-AF4D-4DD2A2FE1AF7}"/>
+                <a16:creationId xmlns:a16="http://schemas.microsoft.com/office/drawing/2014/main" id="{D0FBEEA0-01A4-4426-8E06-A16F809A0E38}"/>
               </a:ext>
             </a:extLst>
           </p:cNvPr>
@@ -18737,7 +18737,7 @@
                 <a:ea typeface="Aptos"/>
                 <a:cs typeface="Aptos"/>
               </a:rPr>
-              <a:t>Independent public evidence summary · 2026.07.22-8 · 2026-07-22 · Sources: WIPO dispute resolution; EPO IPscore</a:t>
+              <a:t>Independent public evidence summary · 2026.07.22-9 · 2026-07-22 · Sources: WIPO dispute resolution; EPO IPscore</a:t>
             </a:r>
           </a:p>
         </p:txBody>
@@ -18747,7 +18747,7 @@
           <p:cNvPr id="7" name="TextBox 6">
             <a:extLst xmlns:a="http://schemas.openxmlformats.org/drawingml/2006/main">
               <a:ext uri="{FF2B5EF4-FFF2-40B4-BE49-F238E27FC236}">
-                <a16:creationId xmlns:a16="http://schemas.microsoft.com/office/drawing/2014/main" id="{FA6152FB-1213-4505-A2E6-B5802178B306}"/>
+                <a16:creationId xmlns:a16="http://schemas.microsoft.com/office/drawing/2014/main" id="{96CF3C17-8E54-4F52-B92E-CA155913C110}"/>
               </a:ext>
             </a:extLst>
           </p:cNvPr>
@@ -18794,7 +18794,7 @@
           <p:cNvPr id="8" name="Rounded Rectangle 7">
             <a:extLst xmlns:a="http://schemas.openxmlformats.org/drawingml/2006/main">
               <a:ext uri="{FF2B5EF4-FFF2-40B4-BE49-F238E27FC236}">
-                <a16:creationId xmlns:a16="http://schemas.microsoft.com/office/drawing/2014/main" id="{CDA29974-1ED8-4873-868F-04DCCA539D45}"/>
+                <a16:creationId xmlns:a16="http://schemas.microsoft.com/office/drawing/2014/main" id="{0FB95883-4349-43E1-B772-D7F6167CB408}"/>
               </a:ext>
             </a:extLst>
           </p:cNvPr>
@@ -18851,7 +18851,7 @@
           <p:cNvPr id="9" name="TextBox 8">
             <a:extLst xmlns:a="http://schemas.openxmlformats.org/drawingml/2006/main">
               <a:ext uri="{FF2B5EF4-FFF2-40B4-BE49-F238E27FC236}">
-                <a16:creationId xmlns:a16="http://schemas.microsoft.com/office/drawing/2014/main" id="{E8BFA89F-D9BE-4248-BEEB-57241453928E}"/>
+                <a16:creationId xmlns:a16="http://schemas.microsoft.com/office/drawing/2014/main" id="{FB9890FB-1F91-4B59-977C-1F6B018B219E}"/>
               </a:ext>
             </a:extLst>
           </p:cNvPr>
@@ -18898,7 +18898,7 @@
           <p:cNvPr id="10" name="TextBox 9">
             <a:extLst xmlns:a="http://schemas.openxmlformats.org/drawingml/2006/main">
               <a:ext uri="{FF2B5EF4-FFF2-40B4-BE49-F238E27FC236}">
-                <a16:creationId xmlns:a16="http://schemas.microsoft.com/office/drawing/2014/main" id="{933807F1-866D-47AF-98A6-934C41D030FB}"/>
+                <a16:creationId xmlns:a16="http://schemas.microsoft.com/office/drawing/2014/main" id="{55CD40FB-48AC-493B-8B8D-A8A87585EC4C}"/>
               </a:ext>
             </a:extLst>
           </p:cNvPr>
@@ -18945,7 +18945,7 @@
           <p:cNvPr id="11" name="TextBox 10">
             <a:extLst xmlns:a="http://schemas.openxmlformats.org/drawingml/2006/main">
               <a:ext uri="{FF2B5EF4-FFF2-40B4-BE49-F238E27FC236}">
-                <a16:creationId xmlns:a16="http://schemas.microsoft.com/office/drawing/2014/main" id="{8B07D76C-5590-4C27-9C23-C55C2BD3CFC9}"/>
+                <a16:creationId xmlns:a16="http://schemas.microsoft.com/office/drawing/2014/main" id="{9533DB97-B3F5-4DEE-8ACC-565693A68F43}"/>
               </a:ext>
             </a:extLst>
           </p:cNvPr>
@@ -18992,7 +18992,7 @@
           <p:cNvPr id="12" name="Rounded Rectangle 11">
             <a:extLst xmlns:a="http://schemas.openxmlformats.org/drawingml/2006/main">
               <a:ext uri="{FF2B5EF4-FFF2-40B4-BE49-F238E27FC236}">
-                <a16:creationId xmlns:a16="http://schemas.microsoft.com/office/drawing/2014/main" id="{C4EB9FAB-4F69-463C-8793-BDA37CF103E3}"/>
+                <a16:creationId xmlns:a16="http://schemas.microsoft.com/office/drawing/2014/main" id="{C7B6FA47-0A7A-44A9-8487-675A994299C1}"/>
               </a:ext>
             </a:extLst>
           </p:cNvPr>
@@ -19049,7 +19049,7 @@
           <p:cNvPr id="13" name="TextBox 12">
             <a:extLst xmlns:a="http://schemas.openxmlformats.org/drawingml/2006/main">
               <a:ext uri="{FF2B5EF4-FFF2-40B4-BE49-F238E27FC236}">
-                <a16:creationId xmlns:a16="http://schemas.microsoft.com/office/drawing/2014/main" id="{5DB80B56-F7D4-438C-8D08-E3158BCBF9C0}"/>
+                <a16:creationId xmlns:a16="http://schemas.microsoft.com/office/drawing/2014/main" id="{C651A65E-E926-4FDA-B9BF-5E5DC3145237}"/>
               </a:ext>
             </a:extLst>
           </p:cNvPr>
@@ -19096,7 +19096,7 @@
           <p:cNvPr id="14" name="TextBox 13">
             <a:extLst xmlns:a="http://schemas.openxmlformats.org/drawingml/2006/main">
               <a:ext uri="{FF2B5EF4-FFF2-40B4-BE49-F238E27FC236}">
-                <a16:creationId xmlns:a16="http://schemas.microsoft.com/office/drawing/2014/main" id="{F43A6C73-14BD-428D-8BEB-83B6F498340B}"/>
+                <a16:creationId xmlns:a16="http://schemas.microsoft.com/office/drawing/2014/main" id="{01A10754-59B5-48B0-A23D-7220B16BD5A1}"/>
               </a:ext>
             </a:extLst>
           </p:cNvPr>
@@ -19143,7 +19143,7 @@
           <p:cNvPr id="15" name="TextBox 14">
             <a:extLst xmlns:a="http://schemas.openxmlformats.org/drawingml/2006/main">
               <a:ext uri="{FF2B5EF4-FFF2-40B4-BE49-F238E27FC236}">
-                <a16:creationId xmlns:a16="http://schemas.microsoft.com/office/drawing/2014/main" id="{C9340BB2-4E23-4080-A01B-EDAAE10AE046}"/>
+                <a16:creationId xmlns:a16="http://schemas.microsoft.com/office/drawing/2014/main" id="{0E47101D-7AF9-4F30-B81B-B5319BDBD370}"/>
               </a:ext>
             </a:extLst>
           </p:cNvPr>
@@ -19190,7 +19190,7 @@
           <p:cNvPr id="16" name="Rounded Rectangle 15">
             <a:extLst xmlns:a="http://schemas.openxmlformats.org/drawingml/2006/main">
               <a:ext uri="{FF2B5EF4-FFF2-40B4-BE49-F238E27FC236}">
-                <a16:creationId xmlns:a16="http://schemas.microsoft.com/office/drawing/2014/main" id="{CEF390C3-446F-41C2-82C6-07D0BEDF54C3}"/>
+                <a16:creationId xmlns:a16="http://schemas.microsoft.com/office/drawing/2014/main" id="{83DDF465-966F-42C8-A212-F05648A1F74B}"/>
               </a:ext>
             </a:extLst>
           </p:cNvPr>
@@ -19247,7 +19247,7 @@
           <p:cNvPr id="17" name="TextBox 16">
             <a:extLst xmlns:a="http://schemas.openxmlformats.org/drawingml/2006/main">
               <a:ext uri="{FF2B5EF4-FFF2-40B4-BE49-F238E27FC236}">
-                <a16:creationId xmlns:a16="http://schemas.microsoft.com/office/drawing/2014/main" id="{326575A5-A4FD-40FD-8895-C2F786EA922B}"/>
+                <a16:creationId xmlns:a16="http://schemas.microsoft.com/office/drawing/2014/main" id="{7DF1812A-E692-4B32-A053-7A40546F14A9}"/>
               </a:ext>
             </a:extLst>
           </p:cNvPr>
@@ -19294,7 +19294,7 @@
           <p:cNvPr id="18" name="TextBox 17">
             <a:extLst xmlns:a="http://schemas.openxmlformats.org/drawingml/2006/main">
               <a:ext uri="{FF2B5EF4-FFF2-40B4-BE49-F238E27FC236}">
-                <a16:creationId xmlns:a16="http://schemas.microsoft.com/office/drawing/2014/main" id="{74F2AE71-3F5B-4EF2-BCA8-D570DB51E43A}"/>
+                <a16:creationId xmlns:a16="http://schemas.microsoft.com/office/drawing/2014/main" id="{0E180A76-B1EA-4651-B686-31A97EC0A4A7}"/>
               </a:ext>
             </a:extLst>
           </p:cNvPr>
@@ -19341,7 +19341,7 @@
           <p:cNvPr id="19" name="TextBox 18">
             <a:extLst xmlns:a="http://schemas.openxmlformats.org/drawingml/2006/main">
               <a:ext uri="{FF2B5EF4-FFF2-40B4-BE49-F238E27FC236}">
-                <a16:creationId xmlns:a16="http://schemas.microsoft.com/office/drawing/2014/main" id="{7E45EB32-FFB3-47C6-8C9C-C5D8F82E89EA}"/>
+                <a16:creationId xmlns:a16="http://schemas.microsoft.com/office/drawing/2014/main" id="{3129954E-B4DC-4B27-A880-9FEB1D0C52F7}"/>
               </a:ext>
             </a:extLst>
           </p:cNvPr>
@@ -19388,7 +19388,7 @@
           <p:cNvPr id="20" name="Rounded Rectangle 19">
             <a:extLst xmlns:a="http://schemas.openxmlformats.org/drawingml/2006/main">
               <a:ext uri="{FF2B5EF4-FFF2-40B4-BE49-F238E27FC236}">
-                <a16:creationId xmlns:a16="http://schemas.microsoft.com/office/drawing/2014/main" id="{B2A9EEC1-AF11-4031-B903-98FD6F78E479}"/>
+                <a16:creationId xmlns:a16="http://schemas.microsoft.com/office/drawing/2014/main" id="{976229AF-CDFE-437B-B7A4-E967449C6029}"/>
               </a:ext>
             </a:extLst>
           </p:cNvPr>
@@ -19445,7 +19445,7 @@
           <p:cNvPr id="21" name="TextBox 20">
             <a:extLst xmlns:a="http://schemas.openxmlformats.org/drawingml/2006/main">
               <a:ext uri="{FF2B5EF4-FFF2-40B4-BE49-F238E27FC236}">
-                <a16:creationId xmlns:a16="http://schemas.microsoft.com/office/drawing/2014/main" id="{8017A1D8-3FAA-40F2-93D4-1C881A6433D0}"/>
+                <a16:creationId xmlns:a16="http://schemas.microsoft.com/office/drawing/2014/main" id="{B2FC2DC8-E230-47A1-A90B-60D7A91307BF}"/>
               </a:ext>
             </a:extLst>
           </p:cNvPr>
@@ -19492,7 +19492,7 @@
           <p:cNvPr id="22" name="TextBox 21">
             <a:extLst xmlns:a="http://schemas.openxmlformats.org/drawingml/2006/main">
               <a:ext uri="{FF2B5EF4-FFF2-40B4-BE49-F238E27FC236}">
-                <a16:creationId xmlns:a16="http://schemas.microsoft.com/office/drawing/2014/main" id="{BB53DF6D-BB7D-4C35-99C1-03B7F28F41C6}"/>
+                <a16:creationId xmlns:a16="http://schemas.microsoft.com/office/drawing/2014/main" id="{2ADE84F0-6FD7-42C7-A06F-25FCCA5D25D7}"/>
               </a:ext>
             </a:extLst>
           </p:cNvPr>
@@ -19539,7 +19539,7 @@
           <p:cNvPr id="23" name="TextBox 22">
             <a:extLst xmlns:a="http://schemas.openxmlformats.org/drawingml/2006/main">
               <a:ext uri="{FF2B5EF4-FFF2-40B4-BE49-F238E27FC236}">
-                <a16:creationId xmlns:a16="http://schemas.microsoft.com/office/drawing/2014/main" id="{AE2AAC0E-5FE1-4F05-80A7-77E33F57FD7E}"/>
+                <a16:creationId xmlns:a16="http://schemas.microsoft.com/office/drawing/2014/main" id="{0F632556-65EA-4E3F-B4C6-77732E2526CA}"/>
               </a:ext>
             </a:extLst>
           </p:cNvPr>
@@ -19586,7 +19586,7 @@
           <p:cNvPr id="24" name="TextBox 23">
             <a:extLst xmlns:a="http://schemas.openxmlformats.org/drawingml/2006/main">
               <a:ext uri="{FF2B5EF4-FFF2-40B4-BE49-F238E27FC236}">
-                <a16:creationId xmlns:a16="http://schemas.microsoft.com/office/drawing/2014/main" id="{A1254B59-2F0C-4F6E-B6BC-5402F3395945}"/>
+                <a16:creationId xmlns:a16="http://schemas.microsoft.com/office/drawing/2014/main" id="{FB992DC0-8797-4350-B09E-AE47828A9392}"/>
               </a:ext>
             </a:extLst>
           </p:cNvPr>
@@ -19631,7 +19631,7 @@
     </p:spTree>
     <p:extLst>
       <p:ext uri="{BB962C8B-B14F-4D97-AF65-F5344CB8AC3E}">
-        <p14:creationId xmlns:p14="http://schemas.microsoft.com/office/powerpoint/2010/main" val="1725309266"/>
+        <p14:creationId xmlns:p14="http://schemas.microsoft.com/office/powerpoint/2010/main" val="859806017"/>
       </p:ext>
     </p:extLst>
   </p:cSld>
@@ -19655,7 +19655,7 @@
           <p:cNvPr id="2" name="TextBox 1">
             <a:extLst xmlns:a="http://schemas.openxmlformats.org/drawingml/2006/main">
               <a:ext uri="{FF2B5EF4-FFF2-40B4-BE49-F238E27FC236}">
-                <a16:creationId xmlns:a16="http://schemas.microsoft.com/office/drawing/2014/main" id="{1E47A91F-50F1-46C9-B34C-D557686933C8}"/>
+                <a16:creationId xmlns:a16="http://schemas.microsoft.com/office/drawing/2014/main" id="{71838222-A282-41FD-9B12-E064A020DA47}"/>
               </a:ext>
             </a:extLst>
           </p:cNvPr>
@@ -19702,7 +19702,7 @@
           <p:cNvPr id="3" name="TextBox 2">
             <a:extLst xmlns:a="http://schemas.openxmlformats.org/drawingml/2006/main">
               <a:ext uri="{FF2B5EF4-FFF2-40B4-BE49-F238E27FC236}">
-                <a16:creationId xmlns:a16="http://schemas.microsoft.com/office/drawing/2014/main" id="{42588564-6686-4811-A73E-C7F807DBA1FC}"/>
+                <a16:creationId xmlns:a16="http://schemas.microsoft.com/office/drawing/2014/main" id="{FF8FDAD1-FD54-42B8-A083-1A78415FC562}"/>
               </a:ext>
             </a:extLst>
           </p:cNvPr>
@@ -19749,7 +19749,7 @@
           <p:cNvPr id="4" name="Rectangle 3">
             <a:extLst xmlns:a="http://schemas.openxmlformats.org/drawingml/2006/main">
               <a:ext uri="{FF2B5EF4-FFF2-40B4-BE49-F238E27FC236}">
-                <a16:creationId xmlns:a16="http://schemas.microsoft.com/office/drawing/2014/main" id="{6FF4F7B9-0B16-4E59-81BC-3A451277243A}"/>
+                <a16:creationId xmlns:a16="http://schemas.microsoft.com/office/drawing/2014/main" id="{48BEE886-3729-4673-86C6-568C0EBA437C}"/>
               </a:ext>
             </a:extLst>
           </p:cNvPr>
@@ -19804,7 +19804,7 @@
           <p:cNvPr id="5" name="Rectangle 4">
             <a:extLst xmlns:a="http://schemas.openxmlformats.org/drawingml/2006/main">
               <a:ext uri="{FF2B5EF4-FFF2-40B4-BE49-F238E27FC236}">
-                <a16:creationId xmlns:a16="http://schemas.microsoft.com/office/drawing/2014/main" id="{D7A3B97F-3E52-433F-A2C9-DB17FC3C5985}"/>
+                <a16:creationId xmlns:a16="http://schemas.microsoft.com/office/drawing/2014/main" id="{B3AD91A6-E772-41C2-BD2D-02F501FCBC54}"/>
               </a:ext>
             </a:extLst>
           </p:cNvPr>
@@ -19859,7 +19859,7 @@
           <p:cNvPr id="6" name="TextBox 5">
             <a:extLst xmlns:a="http://schemas.openxmlformats.org/drawingml/2006/main">
               <a:ext uri="{FF2B5EF4-FFF2-40B4-BE49-F238E27FC236}">
-                <a16:creationId xmlns:a16="http://schemas.microsoft.com/office/drawing/2014/main" id="{3BA35E34-DF02-4B4B-998D-E002193FE9CB}"/>
+                <a16:creationId xmlns:a16="http://schemas.microsoft.com/office/drawing/2014/main" id="{61AE0A7A-7FD6-40C4-BFEA-C974C5EEFB40}"/>
               </a:ext>
             </a:extLst>
           </p:cNvPr>
@@ -19896,7 +19896,7 @@
                 <a:ea typeface="Aptos"/>
                 <a:cs typeface="Aptos"/>
               </a:rPr>
-              <a:t>Independent public evidence summary · 2026.07.22-8 · 2026-07-22 · Sources: WIPO licensing; IP Finance; TPLF mapping</a:t>
+              <a:t>Independent public evidence summary · 2026.07.22-9 · 2026-07-22 · Sources: WIPO licensing; IP Finance; TPLF mapping</a:t>
             </a:r>
           </a:p>
         </p:txBody>
@@ -19906,7 +19906,7 @@
           <p:cNvPr id="7" name="TextBox 6">
             <a:extLst xmlns:a="http://schemas.openxmlformats.org/drawingml/2006/main">
               <a:ext uri="{FF2B5EF4-FFF2-40B4-BE49-F238E27FC236}">
-                <a16:creationId xmlns:a16="http://schemas.microsoft.com/office/drawing/2014/main" id="{97C8AEA2-BE51-4360-A005-10FB753EE881}"/>
+                <a16:creationId xmlns:a16="http://schemas.microsoft.com/office/drawing/2014/main" id="{DAF7A2C1-663E-48B1-B7E6-A68AAE40D78C}"/>
               </a:ext>
             </a:extLst>
           </p:cNvPr>
@@ -20476,7 +20476,7 @@
           <p:cNvPr id="9" name="TextBox 8">
             <a:extLst xmlns:a="http://schemas.openxmlformats.org/drawingml/2006/main">
               <a:ext uri="{FF2B5EF4-FFF2-40B4-BE49-F238E27FC236}">
-                <a16:creationId xmlns:a16="http://schemas.microsoft.com/office/drawing/2014/main" id="{2519DC55-D22A-4D25-899E-944905969630}"/>
+                <a16:creationId xmlns:a16="http://schemas.microsoft.com/office/drawing/2014/main" id="{5F1A5A2C-E11F-4A67-BEE5-BE868D525B57}"/>
               </a:ext>
             </a:extLst>
           </p:cNvPr>
@@ -20521,7 +20521,7 @@
     </p:spTree>
     <p:extLst>
       <p:ext uri="{BB962C8B-B14F-4D97-AF65-F5344CB8AC3E}">
-        <p14:creationId xmlns:p14="http://schemas.microsoft.com/office/powerpoint/2010/main" val="1158020839"/>
+        <p14:creationId xmlns:p14="http://schemas.microsoft.com/office/powerpoint/2010/main" val="1079105360"/>
       </p:ext>
     </p:extLst>
   </p:cSld>
@@ -20545,7 +20545,7 @@
           <p:cNvPr id="2" name="TextBox 1">
             <a:extLst xmlns:a="http://schemas.openxmlformats.org/drawingml/2006/main">
               <a:ext uri="{FF2B5EF4-FFF2-40B4-BE49-F238E27FC236}">
-                <a16:creationId xmlns:a16="http://schemas.microsoft.com/office/drawing/2014/main" id="{CEC203A3-994D-4218-9534-2A174DFF4AC8}"/>
+                <a16:creationId xmlns:a16="http://schemas.microsoft.com/office/drawing/2014/main" id="{25F13E3D-FA26-4DDB-9E23-F34CB15AFE54}"/>
               </a:ext>
             </a:extLst>
           </p:cNvPr>
@@ -20592,7 +20592,7 @@
           <p:cNvPr id="3" name="TextBox 2">
             <a:extLst xmlns:a="http://schemas.openxmlformats.org/drawingml/2006/main">
               <a:ext uri="{FF2B5EF4-FFF2-40B4-BE49-F238E27FC236}">
-                <a16:creationId xmlns:a16="http://schemas.microsoft.com/office/drawing/2014/main" id="{56BF3B91-10DB-48B6-8876-42A1AF48E155}"/>
+                <a16:creationId xmlns:a16="http://schemas.microsoft.com/office/drawing/2014/main" id="{F58939F6-6EC0-4F64-9CD3-94CD78E10222}"/>
               </a:ext>
             </a:extLst>
           </p:cNvPr>
@@ -20639,7 +20639,7 @@
           <p:cNvPr id="4" name="Rectangle 3">
             <a:extLst xmlns:a="http://schemas.openxmlformats.org/drawingml/2006/main">
               <a:ext uri="{FF2B5EF4-FFF2-40B4-BE49-F238E27FC236}">
-                <a16:creationId xmlns:a16="http://schemas.microsoft.com/office/drawing/2014/main" id="{565685BB-4B49-4B39-8725-8A36662D68CC}"/>
+                <a16:creationId xmlns:a16="http://schemas.microsoft.com/office/drawing/2014/main" id="{61FB9D3B-DEA3-4340-B365-3E2375E0A6E9}"/>
               </a:ext>
             </a:extLst>
           </p:cNvPr>
@@ -20694,7 +20694,7 @@
           <p:cNvPr id="5" name="Rectangle 4">
             <a:extLst xmlns:a="http://schemas.openxmlformats.org/drawingml/2006/main">
               <a:ext uri="{FF2B5EF4-FFF2-40B4-BE49-F238E27FC236}">
-                <a16:creationId xmlns:a16="http://schemas.microsoft.com/office/drawing/2014/main" id="{536D7E78-51D4-4B67-BDC4-ACA200DC2163}"/>
+                <a16:creationId xmlns:a16="http://schemas.microsoft.com/office/drawing/2014/main" id="{288C1931-650F-4C77-A5CC-8B3876C33763}"/>
               </a:ext>
             </a:extLst>
           </p:cNvPr>
@@ -20749,7 +20749,7 @@
           <p:cNvPr id="6" name="TextBox 5">
             <a:extLst xmlns:a="http://schemas.openxmlformats.org/drawingml/2006/main">
               <a:ext uri="{FF2B5EF4-FFF2-40B4-BE49-F238E27FC236}">
-                <a16:creationId xmlns:a16="http://schemas.microsoft.com/office/drawing/2014/main" id="{F3E0936C-E652-41A6-AA24-CEAFCA2801BD}"/>
+                <a16:creationId xmlns:a16="http://schemas.microsoft.com/office/drawing/2014/main" id="{4F3403B6-D0FB-4126-B951-95A4D3E5BB4B}"/>
               </a:ext>
             </a:extLst>
           </p:cNvPr>
@@ -20786,7 +20786,7 @@
                 <a:ea typeface="Aptos"/>
                 <a:cs typeface="Aptos"/>
               </a:rPr>
-              <a:t>Independent public evidence summary · 2026.07.22-8 · 2026-07-22 · Sources: Evidence Register; WIPO valuation</a:t>
+              <a:t>Independent public evidence summary · 2026.07.22-9 · 2026-07-22 · Sources: Evidence Register; WIPO valuation</a:t>
             </a:r>
           </a:p>
         </p:txBody>
@@ -20796,7 +20796,7 @@
           <p:cNvPr id="7" name="TextBox 6">
             <a:extLst xmlns:a="http://schemas.openxmlformats.org/drawingml/2006/main">
               <a:ext uri="{FF2B5EF4-FFF2-40B4-BE49-F238E27FC236}">
-                <a16:creationId xmlns:a16="http://schemas.microsoft.com/office/drawing/2014/main" id="{CE983800-8081-4B11-A272-74E1EF41EA1C}"/>
+                <a16:creationId xmlns:a16="http://schemas.microsoft.com/office/drawing/2014/main" id="{6DAC56FE-A8E1-4F11-B610-7840E739A8E6}"/>
               </a:ext>
             </a:extLst>
           </p:cNvPr>
@@ -21449,7 +21449,7 @@
           <p:cNvPr id="9" name="TextBox 8">
             <a:extLst xmlns:a="http://schemas.openxmlformats.org/drawingml/2006/main">
               <a:ext uri="{FF2B5EF4-FFF2-40B4-BE49-F238E27FC236}">
-                <a16:creationId xmlns:a16="http://schemas.microsoft.com/office/drawing/2014/main" id="{A16590F4-6B56-4047-979F-38D0D80108C0}"/>
+                <a16:creationId xmlns:a16="http://schemas.microsoft.com/office/drawing/2014/main" id="{392FDC02-EB16-4547-B8F1-4C3795FA63AC}"/>
               </a:ext>
             </a:extLst>
           </p:cNvPr>
@@ -21494,7 +21494,7 @@
     </p:spTree>
     <p:extLst>
       <p:ext uri="{BB962C8B-B14F-4D97-AF65-F5344CB8AC3E}">
-        <p14:creationId xmlns:p14="http://schemas.microsoft.com/office/powerpoint/2010/main" val="2118078650"/>
+        <p14:creationId xmlns:p14="http://schemas.microsoft.com/office/powerpoint/2010/main" val="1707387436"/>
       </p:ext>
     </p:extLst>
   </p:cSld>
@@ -21518,7 +21518,7 @@
           <p:cNvPr id="2" name="TextBox 1">
             <a:extLst xmlns:a="http://schemas.openxmlformats.org/drawingml/2006/main">
               <a:ext uri="{FF2B5EF4-FFF2-40B4-BE49-F238E27FC236}">
-                <a16:creationId xmlns:a16="http://schemas.microsoft.com/office/drawing/2014/main" id="{EBD46AAE-CA64-4DA8-A4C6-6F48D3448342}"/>
+                <a16:creationId xmlns:a16="http://schemas.microsoft.com/office/drawing/2014/main" id="{5FD9C22E-0936-4183-A433-3FCF7175B311}"/>
               </a:ext>
             </a:extLst>
           </p:cNvPr>
@@ -21565,7 +21565,7 @@
           <p:cNvPr id="3" name="TextBox 2">
             <a:extLst xmlns:a="http://schemas.openxmlformats.org/drawingml/2006/main">
               <a:ext uri="{FF2B5EF4-FFF2-40B4-BE49-F238E27FC236}">
-                <a16:creationId xmlns:a16="http://schemas.microsoft.com/office/drawing/2014/main" id="{8A45EFC9-94DE-4108-97AC-21AED5D6749F}"/>
+                <a16:creationId xmlns:a16="http://schemas.microsoft.com/office/drawing/2014/main" id="{87F18902-FB7F-4468-9236-AC4DB5FA606F}"/>
               </a:ext>
             </a:extLst>
           </p:cNvPr>
@@ -21612,7 +21612,7 @@
           <p:cNvPr id="4" name="Rectangle 3">
             <a:extLst xmlns:a="http://schemas.openxmlformats.org/drawingml/2006/main">
               <a:ext uri="{FF2B5EF4-FFF2-40B4-BE49-F238E27FC236}">
-                <a16:creationId xmlns:a16="http://schemas.microsoft.com/office/drawing/2014/main" id="{D5E44FD3-197D-4B36-9885-04AAAF9DD852}"/>
+                <a16:creationId xmlns:a16="http://schemas.microsoft.com/office/drawing/2014/main" id="{6B6A6BCF-E493-4970-904A-6BC94F636FDE}"/>
               </a:ext>
             </a:extLst>
           </p:cNvPr>
@@ -21667,7 +21667,7 @@
           <p:cNvPr id="5" name="Rectangle 4">
             <a:extLst xmlns:a="http://schemas.openxmlformats.org/drawingml/2006/main">
               <a:ext uri="{FF2B5EF4-FFF2-40B4-BE49-F238E27FC236}">
-                <a16:creationId xmlns:a16="http://schemas.microsoft.com/office/drawing/2014/main" id="{EF27C09D-97FC-4D99-AE63-8F0032171DCB}"/>
+                <a16:creationId xmlns:a16="http://schemas.microsoft.com/office/drawing/2014/main" id="{2E25D073-19E2-4E5F-9B91-200B012056D6}"/>
               </a:ext>
             </a:extLst>
           </p:cNvPr>
@@ -21722,7 +21722,7 @@
           <p:cNvPr id="6" name="TextBox 5">
             <a:extLst xmlns:a="http://schemas.openxmlformats.org/drawingml/2006/main">
               <a:ext uri="{FF2B5EF4-FFF2-40B4-BE49-F238E27FC236}">
-                <a16:creationId xmlns:a16="http://schemas.microsoft.com/office/drawing/2014/main" id="{3B84D5CB-05C4-4C63-AD67-2B3EE5D0DF53}"/>
+                <a16:creationId xmlns:a16="http://schemas.microsoft.com/office/drawing/2014/main" id="{325CFED0-7FDD-4872-8379-9A6BA5533A0F}"/>
               </a:ext>
             </a:extLst>
           </p:cNvPr>
@@ -21759,7 +21759,7 @@
                 <a:ea typeface="Aptos"/>
                 <a:cs typeface="Aptos"/>
               </a:rPr>
-              <a:t>Independent public evidence summary · 2026.07.22-8 · 2026-07-22 · Sources: WIPO valuation</a:t>
+              <a:t>Independent public evidence summary · 2026.07.22-9 · 2026-07-22 · Sources: WIPO valuation</a:t>
             </a:r>
           </a:p>
         </p:txBody>
@@ -21769,7 +21769,7 @@
           <p:cNvPr id="7" name="TextBox 6">
             <a:extLst xmlns:a="http://schemas.openxmlformats.org/drawingml/2006/main">
               <a:ext uri="{FF2B5EF4-FFF2-40B4-BE49-F238E27FC236}">
-                <a16:creationId xmlns:a16="http://schemas.microsoft.com/office/drawing/2014/main" id="{ACF2D1DF-756F-4A8F-83A0-23B1A2A1E634}"/>
+                <a16:creationId xmlns:a16="http://schemas.microsoft.com/office/drawing/2014/main" id="{8AC4850B-48C1-4AF0-A7D7-C0EA57F5AA94}"/>
               </a:ext>
             </a:extLst>
           </p:cNvPr>
@@ -22502,7 +22502,7 @@
           <p:cNvPr id="9" name="TextBox 8">
             <a:extLst xmlns:a="http://schemas.openxmlformats.org/drawingml/2006/main">
               <a:ext uri="{FF2B5EF4-FFF2-40B4-BE49-F238E27FC236}">
-                <a16:creationId xmlns:a16="http://schemas.microsoft.com/office/drawing/2014/main" id="{14F9D4A4-D60F-4722-8FAB-154E7B1E56B7}"/>
+                <a16:creationId xmlns:a16="http://schemas.microsoft.com/office/drawing/2014/main" id="{4E5CF8AB-6039-4F8E-BB41-CF294BF05485}"/>
               </a:ext>
             </a:extLst>
           </p:cNvPr>
@@ -22547,7 +22547,7 @@
     </p:spTree>
     <p:extLst>
       <p:ext uri="{BB962C8B-B14F-4D97-AF65-F5344CB8AC3E}">
-        <p14:creationId xmlns:p14="http://schemas.microsoft.com/office/powerpoint/2010/main" val="2092916366"/>
+        <p14:creationId xmlns:p14="http://schemas.microsoft.com/office/powerpoint/2010/main" val="53254733"/>
       </p:ext>
     </p:extLst>
   </p:cSld>
@@ -22571,7 +22571,7 @@
           <p:cNvPr id="2" name="TextBox 1">
             <a:extLst xmlns:a="http://schemas.openxmlformats.org/drawingml/2006/main">
               <a:ext uri="{FF2B5EF4-FFF2-40B4-BE49-F238E27FC236}">
-                <a16:creationId xmlns:a16="http://schemas.microsoft.com/office/drawing/2014/main" id="{94BCBD1E-0492-4D76-9295-F2BA07598361}"/>
+                <a16:creationId xmlns:a16="http://schemas.microsoft.com/office/drawing/2014/main" id="{FDA63CFE-2427-48EE-B5AB-B5243B9B8DDD}"/>
               </a:ext>
             </a:extLst>
           </p:cNvPr>
@@ -22618,7 +22618,7 @@
           <p:cNvPr id="3" name="TextBox 2">
             <a:extLst xmlns:a="http://schemas.openxmlformats.org/drawingml/2006/main">
               <a:ext uri="{FF2B5EF4-FFF2-40B4-BE49-F238E27FC236}">
-                <a16:creationId xmlns:a16="http://schemas.microsoft.com/office/drawing/2014/main" id="{2F728EFA-3062-4FEB-9542-30D747781768}"/>
+                <a16:creationId xmlns:a16="http://schemas.microsoft.com/office/drawing/2014/main" id="{03B93B61-C5AE-473B-BFF6-C6EA195A30AD}"/>
               </a:ext>
             </a:extLst>
           </p:cNvPr>
@@ -22665,7 +22665,7 @@
           <p:cNvPr id="4" name="Rectangle 3">
             <a:extLst xmlns:a="http://schemas.openxmlformats.org/drawingml/2006/main">
               <a:ext uri="{FF2B5EF4-FFF2-40B4-BE49-F238E27FC236}">
-                <a16:creationId xmlns:a16="http://schemas.microsoft.com/office/drawing/2014/main" id="{77AB192F-0EC6-4015-BA8C-040F4E44397B}"/>
+                <a16:creationId xmlns:a16="http://schemas.microsoft.com/office/drawing/2014/main" id="{15A32B4B-B3D7-4083-8B32-D6C8C9A5B4C2}"/>
               </a:ext>
             </a:extLst>
           </p:cNvPr>
@@ -22720,7 +22720,7 @@
           <p:cNvPr id="5" name="Rectangle 4">
             <a:extLst xmlns:a="http://schemas.openxmlformats.org/drawingml/2006/main">
               <a:ext uri="{FF2B5EF4-FFF2-40B4-BE49-F238E27FC236}">
-                <a16:creationId xmlns:a16="http://schemas.microsoft.com/office/drawing/2014/main" id="{4B03CFBE-BC44-4E98-9147-E0BD3D734D00}"/>
+                <a16:creationId xmlns:a16="http://schemas.microsoft.com/office/drawing/2014/main" id="{6A3F3C49-526C-4917-B375-4E090959114C}"/>
               </a:ext>
             </a:extLst>
           </p:cNvPr>
@@ -22775,7 +22775,7 @@
           <p:cNvPr id="6" name="TextBox 5">
             <a:extLst xmlns:a="http://schemas.openxmlformats.org/drawingml/2006/main">
               <a:ext uri="{FF2B5EF4-FFF2-40B4-BE49-F238E27FC236}">
-                <a16:creationId xmlns:a16="http://schemas.microsoft.com/office/drawing/2014/main" id="{5A03CEDD-8AA3-4A8F-8DB8-A5E54ECE41FE}"/>
+                <a16:creationId xmlns:a16="http://schemas.microsoft.com/office/drawing/2014/main" id="{6C7FF603-B003-492E-A5EC-3AE2B6E15EC1}"/>
               </a:ext>
             </a:extLst>
           </p:cNvPr>
@@ -22812,7 +22812,7 @@
                 <a:ea typeface="Aptos"/>
                 <a:cs typeface="Aptos"/>
               </a:rPr>
-              <a:t>Independent public evidence summary · 2026.07.22-8 · 2026-07-22 · Sources: Evidence Register</a:t>
+              <a:t>Independent public evidence summary · 2026.07.22-9 · 2026-07-22 · Sources: Evidence Register</a:t>
             </a:r>
           </a:p>
         </p:txBody>
@@ -22822,7 +22822,7 @@
           <p:cNvPr id="7" name="TextBox 6">
             <a:extLst xmlns:a="http://schemas.openxmlformats.org/drawingml/2006/main">
               <a:ext uri="{FF2B5EF4-FFF2-40B4-BE49-F238E27FC236}">
-                <a16:creationId xmlns:a16="http://schemas.microsoft.com/office/drawing/2014/main" id="{F30E3E05-EE87-483C-A2DD-A2B7D2AEC18A}"/>
+                <a16:creationId xmlns:a16="http://schemas.microsoft.com/office/drawing/2014/main" id="{80DB0655-A2BB-4C54-BC7C-D60DA44498A5}"/>
               </a:ext>
             </a:extLst>
           </p:cNvPr>
@@ -23392,7 +23392,7 @@
           <p:cNvPr id="9" name="TextBox 8">
             <a:extLst xmlns:a="http://schemas.openxmlformats.org/drawingml/2006/main">
               <a:ext uri="{FF2B5EF4-FFF2-40B4-BE49-F238E27FC236}">
-                <a16:creationId xmlns:a16="http://schemas.microsoft.com/office/drawing/2014/main" id="{3DE247A5-AAE5-4631-9A74-33EC50F1E2D1}"/>
+                <a16:creationId xmlns:a16="http://schemas.microsoft.com/office/drawing/2014/main" id="{3C0A7508-93B6-45B7-93F0-A33E091F3D79}"/>
               </a:ext>
             </a:extLst>
           </p:cNvPr>
@@ -23437,7 +23437,7 @@
     </p:spTree>
     <p:extLst>
       <p:ext uri="{BB962C8B-B14F-4D97-AF65-F5344CB8AC3E}">
-        <p14:creationId xmlns:p14="http://schemas.microsoft.com/office/powerpoint/2010/main" val="1942760929"/>
+        <p14:creationId xmlns:p14="http://schemas.microsoft.com/office/powerpoint/2010/main" val="1746787613"/>
       </p:ext>
     </p:extLst>
   </p:cSld>
@@ -23461,7 +23461,7 @@
           <p:cNvPr id="2" name="TextBox 1">
             <a:extLst xmlns:a="http://schemas.openxmlformats.org/drawingml/2006/main">
               <a:ext uri="{FF2B5EF4-FFF2-40B4-BE49-F238E27FC236}">
-                <a16:creationId xmlns:a16="http://schemas.microsoft.com/office/drawing/2014/main" id="{4B40A477-15AD-4313-AA40-A43F1781A692}"/>
+                <a16:creationId xmlns:a16="http://schemas.microsoft.com/office/drawing/2014/main" id="{B3B0AC0D-8E1B-4616-8FB6-AAA7CE986AB3}"/>
               </a:ext>
             </a:extLst>
           </p:cNvPr>
@@ -23508,7 +23508,7 @@
           <p:cNvPr id="3" name="TextBox 2">
             <a:extLst xmlns:a="http://schemas.openxmlformats.org/drawingml/2006/main">
               <a:ext uri="{FF2B5EF4-FFF2-40B4-BE49-F238E27FC236}">
-                <a16:creationId xmlns:a16="http://schemas.microsoft.com/office/drawing/2014/main" id="{0014F240-C6FB-481C-9DE3-DC1938602913}"/>
+                <a16:creationId xmlns:a16="http://schemas.microsoft.com/office/drawing/2014/main" id="{BE166885-1780-4BE6-8334-E6DAC006528A}"/>
               </a:ext>
             </a:extLst>
           </p:cNvPr>
@@ -23555,7 +23555,7 @@
           <p:cNvPr id="4" name="Rectangle 3">
             <a:extLst xmlns:a="http://schemas.openxmlformats.org/drawingml/2006/main">
               <a:ext uri="{FF2B5EF4-FFF2-40B4-BE49-F238E27FC236}">
-                <a16:creationId xmlns:a16="http://schemas.microsoft.com/office/drawing/2014/main" id="{3E8CF239-D61B-4E10-B284-7ED41D88FC3B}"/>
+                <a16:creationId xmlns:a16="http://schemas.microsoft.com/office/drawing/2014/main" id="{DB0101B4-A009-4437-9ACA-F206464300CB}"/>
               </a:ext>
             </a:extLst>
           </p:cNvPr>
@@ -23610,7 +23610,7 @@
           <p:cNvPr id="5" name="Rectangle 4">
             <a:extLst xmlns:a="http://schemas.openxmlformats.org/drawingml/2006/main">
               <a:ext uri="{FF2B5EF4-FFF2-40B4-BE49-F238E27FC236}">
-                <a16:creationId xmlns:a16="http://schemas.microsoft.com/office/drawing/2014/main" id="{6CB1E7CD-9455-4BA9-A4C8-02D28A636B42}"/>
+                <a16:creationId xmlns:a16="http://schemas.microsoft.com/office/drawing/2014/main" id="{31BFCC2D-11BA-4D9D-8C14-742D04F5A275}"/>
               </a:ext>
             </a:extLst>
           </p:cNvPr>
@@ -23665,7 +23665,7 @@
           <p:cNvPr id="6" name="TextBox 5">
             <a:extLst xmlns:a="http://schemas.openxmlformats.org/drawingml/2006/main">
               <a:ext uri="{FF2B5EF4-FFF2-40B4-BE49-F238E27FC236}">
-                <a16:creationId xmlns:a16="http://schemas.microsoft.com/office/drawing/2014/main" id="{328A300C-216F-4D08-9236-AFD4BDD61CE7}"/>
+                <a16:creationId xmlns:a16="http://schemas.microsoft.com/office/drawing/2014/main" id="{0231597F-B7B1-43E9-BEC9-7877405CB2F0}"/>
               </a:ext>
             </a:extLst>
           </p:cNvPr>
@@ -23702,7 +23702,7 @@
                 <a:ea typeface="Aptos"/>
                 <a:cs typeface="Aptos"/>
               </a:rPr>
-              <a:t>Independent public evidence summary · 2026.07.22-8 · 2026-07-22 · Sources: Evidence Register</a:t>
+              <a:t>Independent public evidence summary · 2026.07.22-9 · 2026-07-22 · Sources: Evidence Register</a:t>
             </a:r>
           </a:p>
         </p:txBody>
@@ -23712,7 +23712,7 @@
           <p:cNvPr id="7" name="TextBox 6">
             <a:extLst xmlns:a="http://schemas.openxmlformats.org/drawingml/2006/main">
               <a:ext uri="{FF2B5EF4-FFF2-40B4-BE49-F238E27FC236}">
-                <a16:creationId xmlns:a16="http://schemas.microsoft.com/office/drawing/2014/main" id="{9854C5B4-8C71-44AB-BE6A-4BA18DB62051}"/>
+                <a16:creationId xmlns:a16="http://schemas.microsoft.com/office/drawing/2014/main" id="{14D217F7-7B5B-423B-ADB7-8A44CCC90FDE}"/>
               </a:ext>
             </a:extLst>
           </p:cNvPr>
@@ -24365,7 +24365,7 @@
           <p:cNvPr id="9" name="TextBox 8">
             <a:extLst xmlns:a="http://schemas.openxmlformats.org/drawingml/2006/main">
               <a:ext uri="{FF2B5EF4-FFF2-40B4-BE49-F238E27FC236}">
-                <a16:creationId xmlns:a16="http://schemas.microsoft.com/office/drawing/2014/main" id="{6FEC0802-9D51-4133-83AB-E518599D43B5}"/>
+                <a16:creationId xmlns:a16="http://schemas.microsoft.com/office/drawing/2014/main" id="{76316B92-0CB8-4DA8-A5C0-CD7687C09989}"/>
               </a:ext>
             </a:extLst>
           </p:cNvPr>
@@ -24410,7 +24410,7 @@
     </p:spTree>
     <p:extLst>
       <p:ext uri="{BB962C8B-B14F-4D97-AF65-F5344CB8AC3E}">
-        <p14:creationId xmlns:p14="http://schemas.microsoft.com/office/powerpoint/2010/main" val="1110109338"/>
+        <p14:creationId xmlns:p14="http://schemas.microsoft.com/office/powerpoint/2010/main" val="1660671506"/>
       </p:ext>
     </p:extLst>
   </p:cSld>
@@ -24434,7 +24434,7 @@
           <p:cNvPr id="2" name="TextBox 1">
             <a:extLst xmlns:a="http://schemas.openxmlformats.org/drawingml/2006/main">
               <a:ext uri="{FF2B5EF4-FFF2-40B4-BE49-F238E27FC236}">
-                <a16:creationId xmlns:a16="http://schemas.microsoft.com/office/drawing/2014/main" id="{AFBB895E-8DDB-4D79-839D-67640AD9DAEA}"/>
+                <a16:creationId xmlns:a16="http://schemas.microsoft.com/office/drawing/2014/main" id="{738B1D29-447A-484B-96B3-6D66E1726268}"/>
               </a:ext>
             </a:extLst>
           </p:cNvPr>
@@ -24481,7 +24481,7 @@
           <p:cNvPr id="3" name="TextBox 2">
             <a:extLst xmlns:a="http://schemas.openxmlformats.org/drawingml/2006/main">
               <a:ext uri="{FF2B5EF4-FFF2-40B4-BE49-F238E27FC236}">
-                <a16:creationId xmlns:a16="http://schemas.microsoft.com/office/drawing/2014/main" id="{9DA5AD96-D6EB-43E5-BC75-318A31B30A0D}"/>
+                <a16:creationId xmlns:a16="http://schemas.microsoft.com/office/drawing/2014/main" id="{921574DC-07D3-48AE-A35A-D5ECC19CCB3B}"/>
               </a:ext>
             </a:extLst>
           </p:cNvPr>
@@ -24528,7 +24528,7 @@
           <p:cNvPr id="4" name="Rectangle 3">
             <a:extLst xmlns:a="http://schemas.openxmlformats.org/drawingml/2006/main">
               <a:ext uri="{FF2B5EF4-FFF2-40B4-BE49-F238E27FC236}">
-                <a16:creationId xmlns:a16="http://schemas.microsoft.com/office/drawing/2014/main" id="{2714C374-7F39-4CAB-8431-8C541FF8BDB8}"/>
+                <a16:creationId xmlns:a16="http://schemas.microsoft.com/office/drawing/2014/main" id="{B8C9040A-E790-452E-ADD3-918E62FD3F9E}"/>
               </a:ext>
             </a:extLst>
           </p:cNvPr>
@@ -24583,7 +24583,7 @@
           <p:cNvPr id="5" name="Rectangle 4">
             <a:extLst xmlns:a="http://schemas.openxmlformats.org/drawingml/2006/main">
               <a:ext uri="{FF2B5EF4-FFF2-40B4-BE49-F238E27FC236}">
-                <a16:creationId xmlns:a16="http://schemas.microsoft.com/office/drawing/2014/main" id="{0E6E40CD-35C4-4E98-87DC-DF3BD35A3B28}"/>
+                <a16:creationId xmlns:a16="http://schemas.microsoft.com/office/drawing/2014/main" id="{508EC97A-7AD8-4FBB-BC5E-5A91B5ED8AF0}"/>
               </a:ext>
             </a:extLst>
           </p:cNvPr>
@@ -24638,7 +24638,7 @@
           <p:cNvPr id="6" name="TextBox 5">
             <a:extLst xmlns:a="http://schemas.openxmlformats.org/drawingml/2006/main">
               <a:ext uri="{FF2B5EF4-FFF2-40B4-BE49-F238E27FC236}">
-                <a16:creationId xmlns:a16="http://schemas.microsoft.com/office/drawing/2014/main" id="{F678CF8F-7C47-487B-8530-9D89DBF961DA}"/>
+                <a16:creationId xmlns:a16="http://schemas.microsoft.com/office/drawing/2014/main" id="{DCD307B9-18E9-497D-973C-78CDF45EAFAD}"/>
               </a:ext>
             </a:extLst>
           </p:cNvPr>
@@ -24675,7 +24675,7 @@
                 <a:ea typeface="Aptos"/>
                 <a:cs typeface="Aptos"/>
               </a:rPr>
-              <a:t>Independent public evidence summary · 2026.07.22-8 · 2026-07-22 · Sources: Evidence Register; changelog</a:t>
+              <a:t>Independent public evidence summary · 2026.07.22-9 · 2026-07-22 · Sources: Evidence Register; changelog</a:t>
             </a:r>
           </a:p>
         </p:txBody>
@@ -24685,7 +24685,7 @@
           <p:cNvPr id="7" name="TextBox 6">
             <a:extLst xmlns:a="http://schemas.openxmlformats.org/drawingml/2006/main">
               <a:ext uri="{FF2B5EF4-FFF2-40B4-BE49-F238E27FC236}">
-                <a16:creationId xmlns:a16="http://schemas.microsoft.com/office/drawing/2014/main" id="{88C33C93-7ACF-474D-98D1-52E1BE73FCD7}"/>
+                <a16:creationId xmlns:a16="http://schemas.microsoft.com/office/drawing/2014/main" id="{E1CFA685-250F-42A4-87C6-553C495CA4CB}"/>
               </a:ext>
             </a:extLst>
           </p:cNvPr>
@@ -24732,7 +24732,7 @@
           <p:cNvPr id="8" name="Rounded Rectangle 7">
             <a:extLst xmlns:a="http://schemas.openxmlformats.org/drawingml/2006/main">
               <a:ext uri="{FF2B5EF4-FFF2-40B4-BE49-F238E27FC236}">
-                <a16:creationId xmlns:a16="http://schemas.microsoft.com/office/drawing/2014/main" id="{E3ECA411-4401-4EF3-A718-181780C99A0A}"/>
+                <a16:creationId xmlns:a16="http://schemas.microsoft.com/office/drawing/2014/main" id="{A22079C8-4DA4-4600-927C-009924C1FBC3}"/>
               </a:ext>
             </a:extLst>
           </p:cNvPr>
@@ -24789,7 +24789,7 @@
           <p:cNvPr id="9" name="TextBox 8">
             <a:extLst xmlns:a="http://schemas.openxmlformats.org/drawingml/2006/main">
               <a:ext uri="{FF2B5EF4-FFF2-40B4-BE49-F238E27FC236}">
-                <a16:creationId xmlns:a16="http://schemas.microsoft.com/office/drawing/2014/main" id="{D3180229-F2E2-4B85-83F4-08F620F46B65}"/>
+                <a16:creationId xmlns:a16="http://schemas.microsoft.com/office/drawing/2014/main" id="{4B9CD6EC-AC04-447B-8FC7-7F0249F7BC38}"/>
               </a:ext>
             </a:extLst>
           </p:cNvPr>
@@ -24836,7 +24836,7 @@
           <p:cNvPr id="10" name="TextBox 9">
             <a:extLst xmlns:a="http://schemas.openxmlformats.org/drawingml/2006/main">
               <a:ext uri="{FF2B5EF4-FFF2-40B4-BE49-F238E27FC236}">
-                <a16:creationId xmlns:a16="http://schemas.microsoft.com/office/drawing/2014/main" id="{DFAC7313-C4F7-4D1F-A9D0-DAC3C00B544B}"/>
+                <a16:creationId xmlns:a16="http://schemas.microsoft.com/office/drawing/2014/main" id="{583B4150-2D37-4F31-8AFE-C1F14E99EC0E}"/>
               </a:ext>
             </a:extLst>
           </p:cNvPr>
@@ -24883,7 +24883,7 @@
           <p:cNvPr id="11" name="TextBox 10">
             <a:extLst xmlns:a="http://schemas.openxmlformats.org/drawingml/2006/main">
               <a:ext uri="{FF2B5EF4-FFF2-40B4-BE49-F238E27FC236}">
-                <a16:creationId xmlns:a16="http://schemas.microsoft.com/office/drawing/2014/main" id="{989DDA47-68E9-4E59-8487-67F31ADB3985}"/>
+                <a16:creationId xmlns:a16="http://schemas.microsoft.com/office/drawing/2014/main" id="{A778ED5C-1EBA-4A46-B04F-09C19F771BBB}"/>
               </a:ext>
             </a:extLst>
           </p:cNvPr>
@@ -24930,7 +24930,7 @@
           <p:cNvPr id="12" name="Rounded Rectangle 11">
             <a:extLst xmlns:a="http://schemas.openxmlformats.org/drawingml/2006/main">
               <a:ext uri="{FF2B5EF4-FFF2-40B4-BE49-F238E27FC236}">
-                <a16:creationId xmlns:a16="http://schemas.microsoft.com/office/drawing/2014/main" id="{492E9AC5-39BB-43C5-AEFC-C3B65D75AADF}"/>
+                <a16:creationId xmlns:a16="http://schemas.microsoft.com/office/drawing/2014/main" id="{79B26E7D-2A9D-42AA-B851-1A2D2CB7AE86}"/>
               </a:ext>
             </a:extLst>
           </p:cNvPr>
@@ -24987,7 +24987,7 @@
           <p:cNvPr id="13" name="TextBox 12">
             <a:extLst xmlns:a="http://schemas.openxmlformats.org/drawingml/2006/main">
               <a:ext uri="{FF2B5EF4-FFF2-40B4-BE49-F238E27FC236}">
-                <a16:creationId xmlns:a16="http://schemas.microsoft.com/office/drawing/2014/main" id="{0C841C9B-DB62-48D3-9A46-E6CEE2722DB6}"/>
+                <a16:creationId xmlns:a16="http://schemas.microsoft.com/office/drawing/2014/main" id="{1BA9958D-22B8-4758-95B0-AFBF3F4BC2D2}"/>
               </a:ext>
             </a:extLst>
           </p:cNvPr>
@@ -25034,7 +25034,7 @@
           <p:cNvPr id="14" name="TextBox 13">
             <a:extLst xmlns:a="http://schemas.openxmlformats.org/drawingml/2006/main">
               <a:ext uri="{FF2B5EF4-FFF2-40B4-BE49-F238E27FC236}">
-                <a16:creationId xmlns:a16="http://schemas.microsoft.com/office/drawing/2014/main" id="{330F5BF1-B1EB-4818-B559-4E39D3F40468}"/>
+                <a16:creationId xmlns:a16="http://schemas.microsoft.com/office/drawing/2014/main" id="{7B9DA7EA-C817-46B5-99D4-C192E02112F6}"/>
               </a:ext>
             </a:extLst>
           </p:cNvPr>
@@ -25081,7 +25081,7 @@
           <p:cNvPr id="15" name="TextBox 14">
             <a:extLst xmlns:a="http://schemas.openxmlformats.org/drawingml/2006/main">
               <a:ext uri="{FF2B5EF4-FFF2-40B4-BE49-F238E27FC236}">
-                <a16:creationId xmlns:a16="http://schemas.microsoft.com/office/drawing/2014/main" id="{7554236E-305B-4FE6-A640-2CE0B9252D97}"/>
+                <a16:creationId xmlns:a16="http://schemas.microsoft.com/office/drawing/2014/main" id="{2A365AA1-F463-4C81-A8E3-7ACBD469D273}"/>
               </a:ext>
             </a:extLst>
           </p:cNvPr>
@@ -25128,7 +25128,7 @@
           <p:cNvPr id="16" name="Rounded Rectangle 15">
             <a:extLst xmlns:a="http://schemas.openxmlformats.org/drawingml/2006/main">
               <a:ext uri="{FF2B5EF4-FFF2-40B4-BE49-F238E27FC236}">
-                <a16:creationId xmlns:a16="http://schemas.microsoft.com/office/drawing/2014/main" id="{519F0A05-A819-46C3-8A5F-9859A46A0292}"/>
+                <a16:creationId xmlns:a16="http://schemas.microsoft.com/office/drawing/2014/main" id="{026A4820-1AEB-40AF-A75A-63E101128F1A}"/>
               </a:ext>
             </a:extLst>
           </p:cNvPr>
@@ -25185,7 +25185,7 @@
           <p:cNvPr id="17" name="TextBox 16">
             <a:extLst xmlns:a="http://schemas.openxmlformats.org/drawingml/2006/main">
               <a:ext uri="{FF2B5EF4-FFF2-40B4-BE49-F238E27FC236}">
-                <a16:creationId xmlns:a16="http://schemas.microsoft.com/office/drawing/2014/main" id="{EB6A7004-1D98-48B6-9B40-D10F6A34FCFD}"/>
+                <a16:creationId xmlns:a16="http://schemas.microsoft.com/office/drawing/2014/main" id="{E210E917-A93A-4C7C-9C94-1DF2FE5DDAE9}"/>
               </a:ext>
             </a:extLst>
           </p:cNvPr>
@@ -25232,7 +25232,7 @@
           <p:cNvPr id="18" name="TextBox 17">
             <a:extLst xmlns:a="http://schemas.openxmlformats.org/drawingml/2006/main">
               <a:ext uri="{FF2B5EF4-FFF2-40B4-BE49-F238E27FC236}">
-                <a16:creationId xmlns:a16="http://schemas.microsoft.com/office/drawing/2014/main" id="{D501D4BE-0692-4E77-86EF-64E36346E029}"/>
+                <a16:creationId xmlns:a16="http://schemas.microsoft.com/office/drawing/2014/main" id="{C730F891-4159-4EF6-9F13-31175D5440D9}"/>
               </a:ext>
             </a:extLst>
           </p:cNvPr>
@@ -25279,7 +25279,7 @@
           <p:cNvPr id="19" name="TextBox 18">
             <a:extLst xmlns:a="http://schemas.openxmlformats.org/drawingml/2006/main">
               <a:ext uri="{FF2B5EF4-FFF2-40B4-BE49-F238E27FC236}">
-                <a16:creationId xmlns:a16="http://schemas.microsoft.com/office/drawing/2014/main" id="{737F6FC5-16A5-47D8-B2B1-CE09767C8F0E}"/>
+                <a16:creationId xmlns:a16="http://schemas.microsoft.com/office/drawing/2014/main" id="{3EB40D68-916A-47E4-AD11-E07DDF1F7766}"/>
               </a:ext>
             </a:extLst>
           </p:cNvPr>
@@ -25326,7 +25326,7 @@
           <p:cNvPr id="20" name="Rounded Rectangle 19">
             <a:extLst xmlns:a="http://schemas.openxmlformats.org/drawingml/2006/main">
               <a:ext uri="{FF2B5EF4-FFF2-40B4-BE49-F238E27FC236}">
-                <a16:creationId xmlns:a16="http://schemas.microsoft.com/office/drawing/2014/main" id="{0F230AB3-9729-4978-9F11-CBA777846373}"/>
+                <a16:creationId xmlns:a16="http://schemas.microsoft.com/office/drawing/2014/main" id="{130B32E7-0603-49D1-A571-B44A9C3B3820}"/>
               </a:ext>
             </a:extLst>
           </p:cNvPr>
@@ -25383,7 +25383,7 @@
           <p:cNvPr id="21" name="TextBox 20">
             <a:extLst xmlns:a="http://schemas.openxmlformats.org/drawingml/2006/main">
               <a:ext uri="{FF2B5EF4-FFF2-40B4-BE49-F238E27FC236}">
-                <a16:creationId xmlns:a16="http://schemas.microsoft.com/office/drawing/2014/main" id="{4C36A3D4-3486-403B-A584-DC825779F0C6}"/>
+                <a16:creationId xmlns:a16="http://schemas.microsoft.com/office/drawing/2014/main" id="{882EDC1C-6920-4C1F-9491-D648952B248E}"/>
               </a:ext>
             </a:extLst>
           </p:cNvPr>
@@ -25430,7 +25430,7 @@
           <p:cNvPr id="22" name="TextBox 21">
             <a:extLst xmlns:a="http://schemas.openxmlformats.org/drawingml/2006/main">
               <a:ext uri="{FF2B5EF4-FFF2-40B4-BE49-F238E27FC236}">
-                <a16:creationId xmlns:a16="http://schemas.microsoft.com/office/drawing/2014/main" id="{1E3E6DEA-A694-44FB-AFD4-E5939E02586F}"/>
+                <a16:creationId xmlns:a16="http://schemas.microsoft.com/office/drawing/2014/main" id="{D97ED6F2-AEDF-4DE4-8EC7-1BB3FF8D0F3B}"/>
               </a:ext>
             </a:extLst>
           </p:cNvPr>
@@ -25477,7 +25477,7 @@
           <p:cNvPr id="23" name="TextBox 22">
             <a:extLst xmlns:a="http://schemas.openxmlformats.org/drawingml/2006/main">
               <a:ext uri="{FF2B5EF4-FFF2-40B4-BE49-F238E27FC236}">
-                <a16:creationId xmlns:a16="http://schemas.microsoft.com/office/drawing/2014/main" id="{7AD8C80F-398F-49EE-AA93-C04A05991239}"/>
+                <a16:creationId xmlns:a16="http://schemas.microsoft.com/office/drawing/2014/main" id="{8B693996-F9ED-4A77-9337-4CC7415575A1}"/>
               </a:ext>
             </a:extLst>
           </p:cNvPr>
@@ -25524,7 +25524,7 @@
           <p:cNvPr id="24" name="TextBox 23">
             <a:extLst xmlns:a="http://schemas.openxmlformats.org/drawingml/2006/main">
               <a:ext uri="{FF2B5EF4-FFF2-40B4-BE49-F238E27FC236}">
-                <a16:creationId xmlns:a16="http://schemas.microsoft.com/office/drawing/2014/main" id="{D87C5874-AE54-44B4-AD51-24DD69FCC92B}"/>
+                <a16:creationId xmlns:a16="http://schemas.microsoft.com/office/drawing/2014/main" id="{42529BC9-58C2-414F-9273-77732735316C}"/>
               </a:ext>
             </a:extLst>
           </p:cNvPr>
@@ -25569,7 +25569,7 @@
     </p:spTree>
     <p:extLst>
       <p:ext uri="{BB962C8B-B14F-4D97-AF65-F5344CB8AC3E}">
-        <p14:creationId xmlns:p14="http://schemas.microsoft.com/office/powerpoint/2010/main" val="562993184"/>
+        <p14:creationId xmlns:p14="http://schemas.microsoft.com/office/powerpoint/2010/main" val="92321566"/>
       </p:ext>
     </p:extLst>
   </p:cSld>
@@ -25593,7 +25593,7 @@
           <p:cNvPr id="2" name="TextBox 1">
             <a:extLst xmlns:a="http://schemas.openxmlformats.org/drawingml/2006/main">
               <a:ext uri="{FF2B5EF4-FFF2-40B4-BE49-F238E27FC236}">
-                <a16:creationId xmlns:a16="http://schemas.microsoft.com/office/drawing/2014/main" id="{8FA16BA5-657E-4D1C-9C46-FBC6B765EB1B}"/>
+                <a16:creationId xmlns:a16="http://schemas.microsoft.com/office/drawing/2014/main" id="{579AC010-F3B8-4B79-AE8B-802D8F87309E}"/>
               </a:ext>
             </a:extLst>
           </p:cNvPr>
@@ -25640,7 +25640,7 @@
           <p:cNvPr id="3" name="TextBox 2">
             <a:extLst xmlns:a="http://schemas.openxmlformats.org/drawingml/2006/main">
               <a:ext uri="{FF2B5EF4-FFF2-40B4-BE49-F238E27FC236}">
-                <a16:creationId xmlns:a16="http://schemas.microsoft.com/office/drawing/2014/main" id="{0F229E67-CF59-47D1-8174-C8B5014DCDB5}"/>
+                <a16:creationId xmlns:a16="http://schemas.microsoft.com/office/drawing/2014/main" id="{DDCB1B9C-52F5-4FC7-B4EA-C8F20A2171B7}"/>
               </a:ext>
             </a:extLst>
           </p:cNvPr>
@@ -25687,7 +25687,7 @@
           <p:cNvPr id="4" name="Rectangle 3">
             <a:extLst xmlns:a="http://schemas.openxmlformats.org/drawingml/2006/main">
               <a:ext uri="{FF2B5EF4-FFF2-40B4-BE49-F238E27FC236}">
-                <a16:creationId xmlns:a16="http://schemas.microsoft.com/office/drawing/2014/main" id="{ABCE1930-8787-42A3-858B-D39811DB6A93}"/>
+                <a16:creationId xmlns:a16="http://schemas.microsoft.com/office/drawing/2014/main" id="{B712BD54-C6F5-4056-88D6-69F50254092E}"/>
               </a:ext>
             </a:extLst>
           </p:cNvPr>
@@ -25742,7 +25742,7 @@
           <p:cNvPr id="5" name="Rectangle 4">
             <a:extLst xmlns:a="http://schemas.openxmlformats.org/drawingml/2006/main">
               <a:ext uri="{FF2B5EF4-FFF2-40B4-BE49-F238E27FC236}">
-                <a16:creationId xmlns:a16="http://schemas.microsoft.com/office/drawing/2014/main" id="{55F2595C-4786-4EA4-98D0-C6CC94AF224D}"/>
+                <a16:creationId xmlns:a16="http://schemas.microsoft.com/office/drawing/2014/main" id="{FE25D6B4-B553-4C89-957F-6FDE67291137}"/>
               </a:ext>
             </a:extLst>
           </p:cNvPr>
@@ -25797,7 +25797,7 @@
           <p:cNvPr id="6" name="TextBox 5">
             <a:extLst xmlns:a="http://schemas.openxmlformats.org/drawingml/2006/main">
               <a:ext uri="{FF2B5EF4-FFF2-40B4-BE49-F238E27FC236}">
-                <a16:creationId xmlns:a16="http://schemas.microsoft.com/office/drawing/2014/main" id="{8AC3C739-479D-43F3-A6C3-D79F67329805}"/>
+                <a16:creationId xmlns:a16="http://schemas.microsoft.com/office/drawing/2014/main" id="{51853347-E45C-449C-8652-73E58012513C}"/>
               </a:ext>
             </a:extLst>
           </p:cNvPr>
@@ -25834,7 +25834,7 @@
                 <a:ea typeface="Aptos"/>
                 <a:cs typeface="Aptos"/>
               </a:rPr>
-              <a:t>Independent public evidence summary · 2026.07.22-8 · 2026-07-22 · Sources: EPO; 8 Ni 18/24 (EP); 7 O 3341/24</a:t>
+              <a:t>Independent public evidence summary · 2026.07.22-9 · 2026-07-22 · Sources: EPO; 8 Ni 18/24 (EP); 7 O 3341/24</a:t>
             </a:r>
           </a:p>
         </p:txBody>
@@ -25844,7 +25844,7 @@
           <p:cNvPr id="7" name="TextBox 6">
             <a:extLst xmlns:a="http://schemas.openxmlformats.org/drawingml/2006/main">
               <a:ext uri="{FF2B5EF4-FFF2-40B4-BE49-F238E27FC236}">
-                <a16:creationId xmlns:a16="http://schemas.microsoft.com/office/drawing/2014/main" id="{6493A345-A91F-4CA9-8B1E-F685447F5CCF}"/>
+                <a16:creationId xmlns:a16="http://schemas.microsoft.com/office/drawing/2014/main" id="{6DD99515-C4C9-433B-A530-27F2A57B94E4}"/>
               </a:ext>
             </a:extLst>
           </p:cNvPr>
@@ -26248,7 +26248,7 @@
           <p:cNvPr id="9" name="TextBox 8">
             <a:extLst xmlns:a="http://schemas.openxmlformats.org/drawingml/2006/main">
               <a:ext uri="{FF2B5EF4-FFF2-40B4-BE49-F238E27FC236}">
-                <a16:creationId xmlns:a16="http://schemas.microsoft.com/office/drawing/2014/main" id="{FEE9BAFA-8DA0-474A-879C-8A4E90774424}"/>
+                <a16:creationId xmlns:a16="http://schemas.microsoft.com/office/drawing/2014/main" id="{F1D39DB8-3582-4D2C-BFE4-A7F2E9E68B95}"/>
               </a:ext>
             </a:extLst>
           </p:cNvPr>
@@ -26293,7 +26293,7 @@
     </p:spTree>
     <p:extLst>
       <p:ext uri="{BB962C8B-B14F-4D97-AF65-F5344CB8AC3E}">
-        <p14:creationId xmlns:p14="http://schemas.microsoft.com/office/powerpoint/2010/main" val="196157156"/>
+        <p14:creationId xmlns:p14="http://schemas.microsoft.com/office/powerpoint/2010/main" val="1288151326"/>
       </p:ext>
     </p:extLst>
   </p:cSld>
@@ -26324,7 +26324,7 @@
           <p:cNvPr id="2" name="TextBox 1">
             <a:extLst xmlns:a="http://schemas.openxmlformats.org/drawingml/2006/main">
               <a:ext uri="{FF2B5EF4-FFF2-40B4-BE49-F238E27FC236}">
-                <a16:creationId xmlns:a16="http://schemas.microsoft.com/office/drawing/2014/main" id="{29160436-3A70-4D7E-B326-E54C5EC381A0}"/>
+                <a16:creationId xmlns:a16="http://schemas.microsoft.com/office/drawing/2014/main" id="{F983CE36-95D3-4520-BAF4-031689D5E41B}"/>
               </a:ext>
             </a:extLst>
           </p:cNvPr>
@@ -26371,7 +26371,7 @@
           <p:cNvPr id="3" name="TextBox 2">
             <a:extLst xmlns:a="http://schemas.openxmlformats.org/drawingml/2006/main">
               <a:ext uri="{FF2B5EF4-FFF2-40B4-BE49-F238E27FC236}">
-                <a16:creationId xmlns:a16="http://schemas.microsoft.com/office/drawing/2014/main" id="{2CBD78B8-07D1-437D-B78A-A86C9F67B2CE}"/>
+                <a16:creationId xmlns:a16="http://schemas.microsoft.com/office/drawing/2014/main" id="{CCB56563-454C-4968-AD50-34B6664A46BA}"/>
               </a:ext>
             </a:extLst>
           </p:cNvPr>
@@ -26418,7 +26418,7 @@
           <p:cNvPr id="4" name="TextBox 3">
             <a:extLst xmlns:a="http://schemas.openxmlformats.org/drawingml/2006/main">
               <a:ext uri="{FF2B5EF4-FFF2-40B4-BE49-F238E27FC236}">
-                <a16:creationId xmlns:a16="http://schemas.microsoft.com/office/drawing/2014/main" id="{F4C656FF-F531-4CC9-9533-03E0316D60BF}"/>
+                <a16:creationId xmlns:a16="http://schemas.microsoft.com/office/drawing/2014/main" id="{01BABAD7-212C-4123-B693-6BBC0BEA6876}"/>
               </a:ext>
             </a:extLst>
           </p:cNvPr>
@@ -26537,7 +26537,7 @@
           <p:cNvPr id="5" name="TextBox 4">
             <a:extLst xmlns:a="http://schemas.openxmlformats.org/drawingml/2006/main">
               <a:ext uri="{FF2B5EF4-FFF2-40B4-BE49-F238E27FC236}">
-                <a16:creationId xmlns:a16="http://schemas.microsoft.com/office/drawing/2014/main" id="{51AA2B48-8A8C-4DA4-A627-B92AEE475D99}"/>
+                <a16:creationId xmlns:a16="http://schemas.microsoft.com/office/drawing/2014/main" id="{ADD564C1-AB61-4336-A3F8-24E54EC10613}"/>
               </a:ext>
             </a:extLst>
           </p:cNvPr>
@@ -26574,7 +26574,7 @@
                 <a:ea typeface="Aptos"/>
                 <a:cs typeface="Aptos"/>
               </a:rPr>
-              <a:t>Version 2026.07.22-8 · 2026-07-22 · 30 / 30</a:t>
+              <a:t>Version 2026.07.22-9 · 2026-07-22 · 30 / 30</a:t>
             </a:r>
           </a:p>
         </p:txBody>
@@ -26582,7 +26582,7 @@
     </p:spTree>
     <p:extLst>
       <p:ext uri="{BB962C8B-B14F-4D97-AF65-F5344CB8AC3E}">
-        <p14:creationId xmlns:p14="http://schemas.microsoft.com/office/powerpoint/2010/main" val="559323013"/>
+        <p14:creationId xmlns:p14="http://schemas.microsoft.com/office/powerpoint/2010/main" val="556422540"/>
       </p:ext>
     </p:extLst>
   </p:cSld>
@@ -26606,7 +26606,7 @@
           <p:cNvPr id="2" name="TextBox 1">
             <a:extLst xmlns:a="http://schemas.openxmlformats.org/drawingml/2006/main">
               <a:ext uri="{FF2B5EF4-FFF2-40B4-BE49-F238E27FC236}">
-                <a16:creationId xmlns:a16="http://schemas.microsoft.com/office/drawing/2014/main" id="{DD5D8A54-63FA-4E60-A789-9B52FF7DDC05}"/>
+                <a16:creationId xmlns:a16="http://schemas.microsoft.com/office/drawing/2014/main" id="{23F78842-F31D-4BCA-A6BB-5EA12A03B320}"/>
               </a:ext>
             </a:extLst>
           </p:cNvPr>
@@ -26653,7 +26653,7 @@
           <p:cNvPr id="3" name="TextBox 2">
             <a:extLst xmlns:a="http://schemas.openxmlformats.org/drawingml/2006/main">
               <a:ext uri="{FF2B5EF4-FFF2-40B4-BE49-F238E27FC236}">
-                <a16:creationId xmlns:a16="http://schemas.microsoft.com/office/drawing/2014/main" id="{699089B8-8057-4D56-BCB4-EDD3AFC0E4DA}"/>
+                <a16:creationId xmlns:a16="http://schemas.microsoft.com/office/drawing/2014/main" id="{D8FC01DC-76AF-447B-BA62-D2B82BE9380B}"/>
               </a:ext>
             </a:extLst>
           </p:cNvPr>
@@ -26700,7 +26700,7 @@
           <p:cNvPr id="4" name="Rectangle 3">
             <a:extLst xmlns:a="http://schemas.openxmlformats.org/drawingml/2006/main">
               <a:ext uri="{FF2B5EF4-FFF2-40B4-BE49-F238E27FC236}">
-                <a16:creationId xmlns:a16="http://schemas.microsoft.com/office/drawing/2014/main" id="{050C2726-EF55-4AC2-A0B6-372B0C0F4585}"/>
+                <a16:creationId xmlns:a16="http://schemas.microsoft.com/office/drawing/2014/main" id="{E7EBB987-37AD-4869-B075-9B18876817E2}"/>
               </a:ext>
             </a:extLst>
           </p:cNvPr>
@@ -26755,7 +26755,7 @@
           <p:cNvPr id="5" name="Rectangle 4">
             <a:extLst xmlns:a="http://schemas.openxmlformats.org/drawingml/2006/main">
               <a:ext uri="{FF2B5EF4-FFF2-40B4-BE49-F238E27FC236}">
-                <a16:creationId xmlns:a16="http://schemas.microsoft.com/office/drawing/2014/main" id="{B26FCD45-A7A6-413A-8280-2A5290CE9484}"/>
+                <a16:creationId xmlns:a16="http://schemas.microsoft.com/office/drawing/2014/main" id="{355BE1A0-4A21-4B2D-BA2E-5B304B9A08E2}"/>
               </a:ext>
             </a:extLst>
           </p:cNvPr>
@@ -26810,7 +26810,7 @@
           <p:cNvPr id="6" name="TextBox 5">
             <a:extLst xmlns:a="http://schemas.openxmlformats.org/drawingml/2006/main">
               <a:ext uri="{FF2B5EF4-FFF2-40B4-BE49-F238E27FC236}">
-                <a16:creationId xmlns:a16="http://schemas.microsoft.com/office/drawing/2014/main" id="{697A8A1E-F087-4E89-8590-A039A9C1C9A5}"/>
+                <a16:creationId xmlns:a16="http://schemas.microsoft.com/office/drawing/2014/main" id="{E93F9AD1-E09D-4424-8457-D8F1B258BC9C}"/>
               </a:ext>
             </a:extLst>
           </p:cNvPr>
@@ -26847,7 +26847,7 @@
                 <a:ea typeface="Aptos"/>
                 <a:cs typeface="Aptos"/>
               </a:rPr>
-              <a:t>Independent public evidence summary · 2026.07.22-8 · 2026-07-22 · Sources: Evidence Register; WIPO</a:t>
+              <a:t>Independent public evidence summary · 2026.07.22-9 · 2026-07-22 · Sources: Evidence Register; WIPO</a:t>
             </a:r>
           </a:p>
         </p:txBody>
@@ -26857,7 +26857,7 @@
           <p:cNvPr id="7" name="TextBox 6">
             <a:extLst xmlns:a="http://schemas.openxmlformats.org/drawingml/2006/main">
               <a:ext uri="{FF2B5EF4-FFF2-40B4-BE49-F238E27FC236}">
-                <a16:creationId xmlns:a16="http://schemas.microsoft.com/office/drawing/2014/main" id="{1F32B6A1-2C88-4F3E-BFAC-FD45E31B1CB1}"/>
+                <a16:creationId xmlns:a16="http://schemas.microsoft.com/office/drawing/2014/main" id="{8D7206DC-AA3D-4387-A8FD-D031C396210B}"/>
               </a:ext>
             </a:extLst>
           </p:cNvPr>
@@ -26904,7 +26904,7 @@
           <p:cNvPr id="8" name="TextBox 7">
             <a:extLst xmlns:a="http://schemas.openxmlformats.org/drawingml/2006/main">
               <a:ext uri="{FF2B5EF4-FFF2-40B4-BE49-F238E27FC236}">
-                <a16:creationId xmlns:a16="http://schemas.microsoft.com/office/drawing/2014/main" id="{8848A425-A76F-4A7D-AE69-2C06A062B2F3}"/>
+                <a16:creationId xmlns:a16="http://schemas.microsoft.com/office/drawing/2014/main" id="{04ADFDA8-7320-483C-AFE8-997B243CD786}"/>
               </a:ext>
             </a:extLst>
           </p:cNvPr>
@@ -26951,7 +26951,7 @@
           <p:cNvPr id="9" name="TextBox 8">
             <a:extLst xmlns:a="http://schemas.openxmlformats.org/drawingml/2006/main">
               <a:ext uri="{FF2B5EF4-FFF2-40B4-BE49-F238E27FC236}">
-                <a16:creationId xmlns:a16="http://schemas.microsoft.com/office/drawing/2014/main" id="{4C2371DC-0C0E-4053-9F1D-40F2C1198B6D}"/>
+                <a16:creationId xmlns:a16="http://schemas.microsoft.com/office/drawing/2014/main" id="{2A0F79FF-F678-42AB-ABA9-AC95D5C8B4B9}"/>
               </a:ext>
             </a:extLst>
           </p:cNvPr>
@@ -27048,7 +27048,7 @@
           <p:cNvPr id="10" name="Rounded Rectangle 9">
             <a:extLst xmlns:a="http://schemas.openxmlformats.org/drawingml/2006/main">
               <a:ext uri="{FF2B5EF4-FFF2-40B4-BE49-F238E27FC236}">
-                <a16:creationId xmlns:a16="http://schemas.microsoft.com/office/drawing/2014/main" id="{42C19195-8D90-4E41-B84A-507A7253DF03}"/>
+                <a16:creationId xmlns:a16="http://schemas.microsoft.com/office/drawing/2014/main" id="{014BDCFF-2E00-4194-B5A0-F222F526FAC2}"/>
               </a:ext>
             </a:extLst>
           </p:cNvPr>
@@ -27105,7 +27105,7 @@
           <p:cNvPr id="11" name="TextBox 10">
             <a:extLst xmlns:a="http://schemas.openxmlformats.org/drawingml/2006/main">
               <a:ext uri="{FF2B5EF4-FFF2-40B4-BE49-F238E27FC236}">
-                <a16:creationId xmlns:a16="http://schemas.microsoft.com/office/drawing/2014/main" id="{E2822808-359D-48BA-B312-028990D67908}"/>
+                <a16:creationId xmlns:a16="http://schemas.microsoft.com/office/drawing/2014/main" id="{13EF9BBC-5C74-401C-8F66-AF29D4359149}"/>
               </a:ext>
             </a:extLst>
           </p:cNvPr>
@@ -27152,7 +27152,7 @@
           <p:cNvPr id="12" name="TextBox 11">
             <a:extLst xmlns:a="http://schemas.openxmlformats.org/drawingml/2006/main">
               <a:ext uri="{FF2B5EF4-FFF2-40B4-BE49-F238E27FC236}">
-                <a16:creationId xmlns:a16="http://schemas.microsoft.com/office/drawing/2014/main" id="{E04A6B22-2B82-4E60-A607-6C2E7229664E}"/>
+                <a16:creationId xmlns:a16="http://schemas.microsoft.com/office/drawing/2014/main" id="{827F02F9-789A-4AED-BCE4-289A1844E477}"/>
               </a:ext>
             </a:extLst>
           </p:cNvPr>
@@ -27197,7 +27197,7 @@
     </p:spTree>
     <p:extLst>
       <p:ext uri="{BB962C8B-B14F-4D97-AF65-F5344CB8AC3E}">
-        <p14:creationId xmlns:p14="http://schemas.microsoft.com/office/powerpoint/2010/main" val="894064853"/>
+        <p14:creationId xmlns:p14="http://schemas.microsoft.com/office/powerpoint/2010/main" val="1619892357"/>
       </p:ext>
     </p:extLst>
   </p:cSld>
@@ -27221,7 +27221,7 @@
           <p:cNvPr id="2" name="TextBox 1">
             <a:extLst xmlns:a="http://schemas.openxmlformats.org/drawingml/2006/main">
               <a:ext uri="{FF2B5EF4-FFF2-40B4-BE49-F238E27FC236}">
-                <a16:creationId xmlns:a16="http://schemas.microsoft.com/office/drawing/2014/main" id="{2FB7B651-1020-41E9-91CE-0FE90FC52E62}"/>
+                <a16:creationId xmlns:a16="http://schemas.microsoft.com/office/drawing/2014/main" id="{E2C60E80-6F04-43E4-83E6-CBB525FF80C4}"/>
               </a:ext>
             </a:extLst>
           </p:cNvPr>
@@ -27268,7 +27268,7 @@
           <p:cNvPr id="3" name="TextBox 2">
             <a:extLst xmlns:a="http://schemas.openxmlformats.org/drawingml/2006/main">
               <a:ext uri="{FF2B5EF4-FFF2-40B4-BE49-F238E27FC236}">
-                <a16:creationId xmlns:a16="http://schemas.microsoft.com/office/drawing/2014/main" id="{F214A4FB-446E-43C0-BA22-1487A2BB6E04}"/>
+                <a16:creationId xmlns:a16="http://schemas.microsoft.com/office/drawing/2014/main" id="{5ACE98B9-4016-4C2B-9B05-B7C39337E8A2}"/>
               </a:ext>
             </a:extLst>
           </p:cNvPr>
@@ -27315,7 +27315,7 @@
           <p:cNvPr id="4" name="Rectangle 3">
             <a:extLst xmlns:a="http://schemas.openxmlformats.org/drawingml/2006/main">
               <a:ext uri="{FF2B5EF4-FFF2-40B4-BE49-F238E27FC236}">
-                <a16:creationId xmlns:a16="http://schemas.microsoft.com/office/drawing/2014/main" id="{2F5F6A12-C56C-4F04-9374-25BCEA2B17A5}"/>
+                <a16:creationId xmlns:a16="http://schemas.microsoft.com/office/drawing/2014/main" id="{73D715AA-D4B1-4791-AC38-1A3D5778CB41}"/>
               </a:ext>
             </a:extLst>
           </p:cNvPr>
@@ -27370,7 +27370,7 @@
           <p:cNvPr id="5" name="Rectangle 4">
             <a:extLst xmlns:a="http://schemas.openxmlformats.org/drawingml/2006/main">
               <a:ext uri="{FF2B5EF4-FFF2-40B4-BE49-F238E27FC236}">
-                <a16:creationId xmlns:a16="http://schemas.microsoft.com/office/drawing/2014/main" id="{D662D643-90D7-40E5-97EA-4260B64A490A}"/>
+                <a16:creationId xmlns:a16="http://schemas.microsoft.com/office/drawing/2014/main" id="{EAE76652-6AA8-40C8-AC6B-213CEC1398F9}"/>
               </a:ext>
             </a:extLst>
           </p:cNvPr>
@@ -27425,7 +27425,7 @@
           <p:cNvPr id="6" name="TextBox 5">
             <a:extLst xmlns:a="http://schemas.openxmlformats.org/drawingml/2006/main">
               <a:ext uri="{FF2B5EF4-FFF2-40B4-BE49-F238E27FC236}">
-                <a16:creationId xmlns:a16="http://schemas.microsoft.com/office/drawing/2014/main" id="{B4067EC8-2395-47A3-82B5-B338937A1367}"/>
+                <a16:creationId xmlns:a16="http://schemas.microsoft.com/office/drawing/2014/main" id="{A9DD5EDA-AEFF-483D-8B88-72843F8A593C}"/>
               </a:ext>
             </a:extLst>
           </p:cNvPr>
@@ -27462,7 +27462,7 @@
                 <a:ea typeface="Aptos"/>
                 <a:cs typeface="Aptos"/>
               </a:rPr>
-              <a:t>Independent public evidence summary · 2026.07.22-8 · 2026-07-22 · Sources: EP3032975B2</a:t>
+              <a:t>Independent public evidence summary · 2026.07.22-9 · 2026-07-22 · Sources: EP3032975B2</a:t>
             </a:r>
           </a:p>
         </p:txBody>
@@ -27472,7 +27472,7 @@
           <p:cNvPr id="7" name="TextBox 6">
             <a:extLst xmlns:a="http://schemas.openxmlformats.org/drawingml/2006/main">
               <a:ext uri="{FF2B5EF4-FFF2-40B4-BE49-F238E27FC236}">
-                <a16:creationId xmlns:a16="http://schemas.microsoft.com/office/drawing/2014/main" id="{3B7AD425-CF41-4C54-AB36-AEE2B527F594}"/>
+                <a16:creationId xmlns:a16="http://schemas.microsoft.com/office/drawing/2014/main" id="{36641539-268B-4B36-AA60-8F2E7EC77B31}"/>
               </a:ext>
             </a:extLst>
           </p:cNvPr>
@@ -27519,7 +27519,7 @@
           <p:cNvPr id="8" name="TextBox 7">
             <a:extLst xmlns:a="http://schemas.openxmlformats.org/drawingml/2006/main">
               <a:ext uri="{FF2B5EF4-FFF2-40B4-BE49-F238E27FC236}">
-                <a16:creationId xmlns:a16="http://schemas.microsoft.com/office/drawing/2014/main" id="{813AD58E-B12E-4DF8-9BF2-9C2D001FE57B}"/>
+                <a16:creationId xmlns:a16="http://schemas.microsoft.com/office/drawing/2014/main" id="{4925BA15-DA98-4F04-BE7F-7E7173CBDEB3}"/>
               </a:ext>
             </a:extLst>
           </p:cNvPr>
@@ -27566,7 +27566,7 @@
           <p:cNvPr id="9" name="TextBox 8">
             <a:extLst xmlns:a="http://schemas.openxmlformats.org/drawingml/2006/main">
               <a:ext uri="{FF2B5EF4-FFF2-40B4-BE49-F238E27FC236}">
-                <a16:creationId xmlns:a16="http://schemas.microsoft.com/office/drawing/2014/main" id="{C5543AFB-39A2-467F-B91F-4BB345B81245}"/>
+                <a16:creationId xmlns:a16="http://schemas.microsoft.com/office/drawing/2014/main" id="{3FFA6CC8-8790-4A11-939C-AEA994886250}"/>
               </a:ext>
             </a:extLst>
           </p:cNvPr>
@@ -27663,7 +27663,7 @@
           <p:cNvPr id="10" name="Rounded Rectangle 9">
             <a:extLst xmlns:a="http://schemas.openxmlformats.org/drawingml/2006/main">
               <a:ext uri="{FF2B5EF4-FFF2-40B4-BE49-F238E27FC236}">
-                <a16:creationId xmlns:a16="http://schemas.microsoft.com/office/drawing/2014/main" id="{3071DA8E-5599-4DD2-937F-AD5E7D0C328B}"/>
+                <a16:creationId xmlns:a16="http://schemas.microsoft.com/office/drawing/2014/main" id="{C08CDB56-E939-4BF9-8555-EA0BC1556929}"/>
               </a:ext>
             </a:extLst>
           </p:cNvPr>
@@ -27720,7 +27720,7 @@
           <p:cNvPr id="11" name="TextBox 10">
             <a:extLst xmlns:a="http://schemas.openxmlformats.org/drawingml/2006/main">
               <a:ext uri="{FF2B5EF4-FFF2-40B4-BE49-F238E27FC236}">
-                <a16:creationId xmlns:a16="http://schemas.microsoft.com/office/drawing/2014/main" id="{EBF92752-A926-49A5-BB23-EFD232464CA9}"/>
+                <a16:creationId xmlns:a16="http://schemas.microsoft.com/office/drawing/2014/main" id="{1C344D4D-296E-432E-BBA2-03F99C3011D7}"/>
               </a:ext>
             </a:extLst>
           </p:cNvPr>
@@ -27767,7 +27767,7 @@
           <p:cNvPr id="12" name="TextBox 11">
             <a:extLst xmlns:a="http://schemas.openxmlformats.org/drawingml/2006/main">
               <a:ext uri="{FF2B5EF4-FFF2-40B4-BE49-F238E27FC236}">
-                <a16:creationId xmlns:a16="http://schemas.microsoft.com/office/drawing/2014/main" id="{A75C6931-EE28-4B6D-B4FC-49FD8D55296E}"/>
+                <a16:creationId xmlns:a16="http://schemas.microsoft.com/office/drawing/2014/main" id="{7AC936B5-CB92-49D9-A5D9-6090423D9FF0}"/>
               </a:ext>
             </a:extLst>
           </p:cNvPr>
@@ -27812,7 +27812,7 @@
     </p:spTree>
     <p:extLst>
       <p:ext uri="{BB962C8B-B14F-4D97-AF65-F5344CB8AC3E}">
-        <p14:creationId xmlns:p14="http://schemas.microsoft.com/office/powerpoint/2010/main" val="328853594"/>
+        <p14:creationId xmlns:p14="http://schemas.microsoft.com/office/powerpoint/2010/main" val="1511580907"/>
       </p:ext>
     </p:extLst>
   </p:cSld>
@@ -27836,7 +27836,7 @@
           <p:cNvPr id="2" name="TextBox 1">
             <a:extLst xmlns:a="http://schemas.openxmlformats.org/drawingml/2006/main">
               <a:ext uri="{FF2B5EF4-FFF2-40B4-BE49-F238E27FC236}">
-                <a16:creationId xmlns:a16="http://schemas.microsoft.com/office/drawing/2014/main" id="{F7B7248C-A747-4BAE-AE2D-DCA6EBFE8524}"/>
+                <a16:creationId xmlns:a16="http://schemas.microsoft.com/office/drawing/2014/main" id="{3281E17B-9B76-4F46-8F4E-3288172D998A}"/>
               </a:ext>
             </a:extLst>
           </p:cNvPr>
@@ -27883,7 +27883,7 @@
           <p:cNvPr id="3" name="TextBox 2">
             <a:extLst xmlns:a="http://schemas.openxmlformats.org/drawingml/2006/main">
               <a:ext uri="{FF2B5EF4-FFF2-40B4-BE49-F238E27FC236}">
-                <a16:creationId xmlns:a16="http://schemas.microsoft.com/office/drawing/2014/main" id="{D4189F40-93D1-425C-B384-3EAC6DC36091}"/>
+                <a16:creationId xmlns:a16="http://schemas.microsoft.com/office/drawing/2014/main" id="{02D5FA6C-B583-4E10-9ADF-222623D40754}"/>
               </a:ext>
             </a:extLst>
           </p:cNvPr>
@@ -27930,7 +27930,7 @@
           <p:cNvPr id="4" name="Rectangle 3">
             <a:extLst xmlns:a="http://schemas.openxmlformats.org/drawingml/2006/main">
               <a:ext uri="{FF2B5EF4-FFF2-40B4-BE49-F238E27FC236}">
-                <a16:creationId xmlns:a16="http://schemas.microsoft.com/office/drawing/2014/main" id="{6CD0C8D4-C87C-4561-A685-C06F682F9180}"/>
+                <a16:creationId xmlns:a16="http://schemas.microsoft.com/office/drawing/2014/main" id="{276B9391-C8E3-452D-BD11-727FF1A5DA0F}"/>
               </a:ext>
             </a:extLst>
           </p:cNvPr>
@@ -27985,7 +27985,7 @@
           <p:cNvPr id="5" name="Rectangle 4">
             <a:extLst xmlns:a="http://schemas.openxmlformats.org/drawingml/2006/main">
               <a:ext uri="{FF2B5EF4-FFF2-40B4-BE49-F238E27FC236}">
-                <a16:creationId xmlns:a16="http://schemas.microsoft.com/office/drawing/2014/main" id="{6FEBEA15-89B8-4EBC-8333-CF9243C7C737}"/>
+                <a16:creationId xmlns:a16="http://schemas.microsoft.com/office/drawing/2014/main" id="{BE818B6A-536B-445F-B103-DA7DD47FE2C2}"/>
               </a:ext>
             </a:extLst>
           </p:cNvPr>
@@ -28040,7 +28040,7 @@
           <p:cNvPr id="6" name="TextBox 5">
             <a:extLst xmlns:a="http://schemas.openxmlformats.org/drawingml/2006/main">
               <a:ext uri="{FF2B5EF4-FFF2-40B4-BE49-F238E27FC236}">
-                <a16:creationId xmlns:a16="http://schemas.microsoft.com/office/drawing/2014/main" id="{68A5A2D8-2684-470A-8BC8-FE7153928DB3}"/>
+                <a16:creationId xmlns:a16="http://schemas.microsoft.com/office/drawing/2014/main" id="{01AFCE20-A5F5-4206-9377-C90EE873E025}"/>
               </a:ext>
             </a:extLst>
           </p:cNvPr>
@@ -28077,7 +28077,7 @@
                 <a:ea typeface="Aptos"/>
                 <a:cs typeface="Aptos"/>
               </a:rPr>
-              <a:t>Independent public evidence summary · 2026.07.22-8 · 2026-07-22 · Sources: EP3032975B2</a:t>
+              <a:t>Independent public evidence summary · 2026.07.22-9 · 2026-07-22 · Sources: EP3032975B2</a:t>
             </a:r>
           </a:p>
         </p:txBody>
@@ -28087,7 +28087,7 @@
           <p:cNvPr id="7" name="TextBox 6">
             <a:extLst xmlns:a="http://schemas.openxmlformats.org/drawingml/2006/main">
               <a:ext uri="{FF2B5EF4-FFF2-40B4-BE49-F238E27FC236}">
-                <a16:creationId xmlns:a16="http://schemas.microsoft.com/office/drawing/2014/main" id="{E941D4CC-3F37-420C-AB1E-DE4C55CAC788}"/>
+                <a16:creationId xmlns:a16="http://schemas.microsoft.com/office/drawing/2014/main" id="{8F40E579-2118-4AE1-B5B6-C0653EA82460}"/>
               </a:ext>
             </a:extLst>
           </p:cNvPr>
@@ -28657,7 +28657,7 @@
           <p:cNvPr id="9" name="TextBox 8">
             <a:extLst xmlns:a="http://schemas.openxmlformats.org/drawingml/2006/main">
               <a:ext uri="{FF2B5EF4-FFF2-40B4-BE49-F238E27FC236}">
-                <a16:creationId xmlns:a16="http://schemas.microsoft.com/office/drawing/2014/main" id="{C3F68360-DFC5-46BB-816A-FA12A3166C92}"/>
+                <a16:creationId xmlns:a16="http://schemas.microsoft.com/office/drawing/2014/main" id="{2FDB45C9-76B8-47F7-BDA0-AE76C75DF389}"/>
               </a:ext>
             </a:extLst>
           </p:cNvPr>
@@ -28702,7 +28702,7 @@
     </p:spTree>
     <p:extLst>
       <p:ext uri="{BB962C8B-B14F-4D97-AF65-F5344CB8AC3E}">
-        <p14:creationId xmlns:p14="http://schemas.microsoft.com/office/powerpoint/2010/main" val="1019217459"/>
+        <p14:creationId xmlns:p14="http://schemas.microsoft.com/office/powerpoint/2010/main" val="191392355"/>
       </p:ext>
     </p:extLst>
   </p:cSld>
@@ -28726,7 +28726,7 @@
           <p:cNvPr id="2" name="TextBox 1">
             <a:extLst xmlns:a="http://schemas.openxmlformats.org/drawingml/2006/main">
               <a:ext uri="{FF2B5EF4-FFF2-40B4-BE49-F238E27FC236}">
-                <a16:creationId xmlns:a16="http://schemas.microsoft.com/office/drawing/2014/main" id="{68FB185D-3D88-4F05-B803-00E18BFC63EC}"/>
+                <a16:creationId xmlns:a16="http://schemas.microsoft.com/office/drawing/2014/main" id="{4B463AD2-7E2E-4157-ADFD-F299D24D7188}"/>
               </a:ext>
             </a:extLst>
           </p:cNvPr>
@@ -28773,7 +28773,7 @@
           <p:cNvPr id="3" name="TextBox 2">
             <a:extLst xmlns:a="http://schemas.openxmlformats.org/drawingml/2006/main">
               <a:ext uri="{FF2B5EF4-FFF2-40B4-BE49-F238E27FC236}">
-                <a16:creationId xmlns:a16="http://schemas.microsoft.com/office/drawing/2014/main" id="{5C467872-A2FE-47D2-9B01-80E1C9EA1AD6}"/>
+                <a16:creationId xmlns:a16="http://schemas.microsoft.com/office/drawing/2014/main" id="{070B91EC-48D3-406A-A910-727B9B2C5EB2}"/>
               </a:ext>
             </a:extLst>
           </p:cNvPr>
@@ -28820,7 +28820,7 @@
           <p:cNvPr id="4" name="Rectangle 3">
             <a:extLst xmlns:a="http://schemas.openxmlformats.org/drawingml/2006/main">
               <a:ext uri="{FF2B5EF4-FFF2-40B4-BE49-F238E27FC236}">
-                <a16:creationId xmlns:a16="http://schemas.microsoft.com/office/drawing/2014/main" id="{7E5C6F3D-68C8-42D0-9EFC-CF296B2B6B7F}"/>
+                <a16:creationId xmlns:a16="http://schemas.microsoft.com/office/drawing/2014/main" id="{F21AF8F7-985C-4394-8C56-E0A07AD8C7A0}"/>
               </a:ext>
             </a:extLst>
           </p:cNvPr>
@@ -28875,7 +28875,7 @@
           <p:cNvPr id="5" name="Rectangle 4">
             <a:extLst xmlns:a="http://schemas.openxmlformats.org/drawingml/2006/main">
               <a:ext uri="{FF2B5EF4-FFF2-40B4-BE49-F238E27FC236}">
-                <a16:creationId xmlns:a16="http://schemas.microsoft.com/office/drawing/2014/main" id="{9A66CDA3-1792-40E6-80C3-9967BB59D45F}"/>
+                <a16:creationId xmlns:a16="http://schemas.microsoft.com/office/drawing/2014/main" id="{7E4098A7-BA03-4FA5-A052-F2C59E9BB68A}"/>
               </a:ext>
             </a:extLst>
           </p:cNvPr>
@@ -28930,7 +28930,7 @@
           <p:cNvPr id="6" name="TextBox 5">
             <a:extLst xmlns:a="http://schemas.openxmlformats.org/drawingml/2006/main">
               <a:ext uri="{FF2B5EF4-FFF2-40B4-BE49-F238E27FC236}">
-                <a16:creationId xmlns:a16="http://schemas.microsoft.com/office/drawing/2014/main" id="{0DD6EBBC-ACA5-4E0A-BA27-FB0B8B8E9121}"/>
+                <a16:creationId xmlns:a16="http://schemas.microsoft.com/office/drawing/2014/main" id="{4B7D0F1D-7E41-44DC-BBD0-17C20A46FB77}"/>
               </a:ext>
             </a:extLst>
           </p:cNvPr>
@@ -28967,7 +28967,7 @@
                 <a:ea typeface="Aptos"/>
                 <a:cs typeface="Aptos"/>
               </a:rPr>
-              <a:t>Independent public evidence summary · 2026.07.22-8 · 2026-07-22 · Sources: EPO Register; B2</a:t>
+              <a:t>Independent public evidence summary · 2026.07.22-9 · 2026-07-22 · Sources: EPO Register; B2</a:t>
             </a:r>
           </a:p>
         </p:txBody>
@@ -28977,7 +28977,7 @@
           <p:cNvPr id="7" name="TextBox 6">
             <a:extLst xmlns:a="http://schemas.openxmlformats.org/drawingml/2006/main">
               <a:ext uri="{FF2B5EF4-FFF2-40B4-BE49-F238E27FC236}">
-                <a16:creationId xmlns:a16="http://schemas.microsoft.com/office/drawing/2014/main" id="{72A78975-7507-48FB-AAFA-00913B362FF7}"/>
+                <a16:creationId xmlns:a16="http://schemas.microsoft.com/office/drawing/2014/main" id="{F4B02055-68FF-44C5-BCFC-4A5C5348702A}"/>
               </a:ext>
             </a:extLst>
           </p:cNvPr>
@@ -29024,7 +29024,7 @@
           <p:cNvPr id="8" name="Rounded Rectangle 7">
             <a:extLst xmlns:a="http://schemas.openxmlformats.org/drawingml/2006/main">
               <a:ext uri="{FF2B5EF4-FFF2-40B4-BE49-F238E27FC236}">
-                <a16:creationId xmlns:a16="http://schemas.microsoft.com/office/drawing/2014/main" id="{0D1FF03D-325A-44A9-80E8-E45EA86416BF}"/>
+                <a16:creationId xmlns:a16="http://schemas.microsoft.com/office/drawing/2014/main" id="{E5FF2D78-BE65-4960-9FEE-BE04CAD85056}"/>
               </a:ext>
             </a:extLst>
           </p:cNvPr>
@@ -29081,7 +29081,7 @@
           <p:cNvPr id="9" name="TextBox 8">
             <a:extLst xmlns:a="http://schemas.openxmlformats.org/drawingml/2006/main">
               <a:ext uri="{FF2B5EF4-FFF2-40B4-BE49-F238E27FC236}">
-                <a16:creationId xmlns:a16="http://schemas.microsoft.com/office/drawing/2014/main" id="{D6458468-F078-44E4-BC8C-AD902E79063D}"/>
+                <a16:creationId xmlns:a16="http://schemas.microsoft.com/office/drawing/2014/main" id="{F79D9F95-1EA6-4217-8D7A-2808CAE3B93C}"/>
               </a:ext>
             </a:extLst>
           </p:cNvPr>
@@ -29128,7 +29128,7 @@
           <p:cNvPr id="10" name="TextBox 9">
             <a:extLst xmlns:a="http://schemas.openxmlformats.org/drawingml/2006/main">
               <a:ext uri="{FF2B5EF4-FFF2-40B4-BE49-F238E27FC236}">
-                <a16:creationId xmlns:a16="http://schemas.microsoft.com/office/drawing/2014/main" id="{B1E04001-B602-49EB-AA8A-AB3BF6CA2EE7}"/>
+                <a16:creationId xmlns:a16="http://schemas.microsoft.com/office/drawing/2014/main" id="{D41BF304-D417-42CE-8DE8-0EAC2898CD83}"/>
               </a:ext>
             </a:extLst>
           </p:cNvPr>
@@ -29175,7 +29175,7 @@
           <p:cNvPr id="11" name="Rounded Rectangle 10">
             <a:extLst xmlns:a="http://schemas.openxmlformats.org/drawingml/2006/main">
               <a:ext uri="{FF2B5EF4-FFF2-40B4-BE49-F238E27FC236}">
-                <a16:creationId xmlns:a16="http://schemas.microsoft.com/office/drawing/2014/main" id="{CD97C715-1712-4108-ACB4-8DE4F68A9A56}"/>
+                <a16:creationId xmlns:a16="http://schemas.microsoft.com/office/drawing/2014/main" id="{9723800E-07FE-4864-8BB9-F6D32CBBFA30}"/>
               </a:ext>
             </a:extLst>
           </p:cNvPr>
@@ -29232,7 +29232,7 @@
           <p:cNvPr id="12" name="TextBox 11">
             <a:extLst xmlns:a="http://schemas.openxmlformats.org/drawingml/2006/main">
               <a:ext uri="{FF2B5EF4-FFF2-40B4-BE49-F238E27FC236}">
-                <a16:creationId xmlns:a16="http://schemas.microsoft.com/office/drawing/2014/main" id="{18ACADBA-0C55-4EE0-ABA7-94C6502BF0C2}"/>
+                <a16:creationId xmlns:a16="http://schemas.microsoft.com/office/drawing/2014/main" id="{7D511301-AB35-49B9-9E6E-CF261081D997}"/>
               </a:ext>
             </a:extLst>
           </p:cNvPr>
@@ -29279,7 +29279,7 @@
           <p:cNvPr id="13" name="TextBox 12">
             <a:extLst xmlns:a="http://schemas.openxmlformats.org/drawingml/2006/main">
               <a:ext uri="{FF2B5EF4-FFF2-40B4-BE49-F238E27FC236}">
-                <a16:creationId xmlns:a16="http://schemas.microsoft.com/office/drawing/2014/main" id="{1BD3C2EE-EA55-4A38-82D2-DB74E52D2C03}"/>
+                <a16:creationId xmlns:a16="http://schemas.microsoft.com/office/drawing/2014/main" id="{2FC34DF0-D788-419E-BFF2-41BFE59DAD24}"/>
               </a:ext>
             </a:extLst>
           </p:cNvPr>
@@ -29326,7 +29326,7 @@
           <p:cNvPr id="14" name="Rounded Rectangle 13">
             <a:extLst xmlns:a="http://schemas.openxmlformats.org/drawingml/2006/main">
               <a:ext uri="{FF2B5EF4-FFF2-40B4-BE49-F238E27FC236}">
-                <a16:creationId xmlns:a16="http://schemas.microsoft.com/office/drawing/2014/main" id="{A75D936A-061F-48AE-B339-3B9352A48A0C}"/>
+                <a16:creationId xmlns:a16="http://schemas.microsoft.com/office/drawing/2014/main" id="{67E3D468-32BE-4054-AD7A-9FE70008FEF4}"/>
               </a:ext>
             </a:extLst>
           </p:cNvPr>
@@ -29383,7 +29383,7 @@
           <p:cNvPr id="15" name="TextBox 14">
             <a:extLst xmlns:a="http://schemas.openxmlformats.org/drawingml/2006/main">
               <a:ext uri="{FF2B5EF4-FFF2-40B4-BE49-F238E27FC236}">
-                <a16:creationId xmlns:a16="http://schemas.microsoft.com/office/drawing/2014/main" id="{1FABE12B-D7C1-4ACB-9F92-16C428326F2F}"/>
+                <a16:creationId xmlns:a16="http://schemas.microsoft.com/office/drawing/2014/main" id="{4465B154-EC09-4284-9B02-7227BF456F39}"/>
               </a:ext>
             </a:extLst>
           </p:cNvPr>
@@ -29430,7 +29430,7 @@
           <p:cNvPr id="16" name="TextBox 15">
             <a:extLst xmlns:a="http://schemas.openxmlformats.org/drawingml/2006/main">
               <a:ext uri="{FF2B5EF4-FFF2-40B4-BE49-F238E27FC236}">
-                <a16:creationId xmlns:a16="http://schemas.microsoft.com/office/drawing/2014/main" id="{8685AE99-3B7D-432E-BFBA-EB43010B0FC5}"/>
+                <a16:creationId xmlns:a16="http://schemas.microsoft.com/office/drawing/2014/main" id="{5A943CF4-476B-45C0-A5C5-AA841F28722E}"/>
               </a:ext>
             </a:extLst>
           </p:cNvPr>
@@ -29477,7 +29477,7 @@
           <p:cNvPr id="17" name="TextBox 16">
             <a:extLst xmlns:a="http://schemas.openxmlformats.org/drawingml/2006/main">
               <a:ext uri="{FF2B5EF4-FFF2-40B4-BE49-F238E27FC236}">
-                <a16:creationId xmlns:a16="http://schemas.microsoft.com/office/drawing/2014/main" id="{CA244EEA-8A33-4DFB-9697-5A957206984D}"/>
+                <a16:creationId xmlns:a16="http://schemas.microsoft.com/office/drawing/2014/main" id="{1CDA29A9-0755-4767-8098-AA218A3A9EA1}"/>
               </a:ext>
             </a:extLst>
           </p:cNvPr>
@@ -29524,7 +29524,7 @@
           <p:cNvPr id="18" name="Rounded Rectangle 17">
             <a:extLst xmlns:a="http://schemas.openxmlformats.org/drawingml/2006/main">
               <a:ext uri="{FF2B5EF4-FFF2-40B4-BE49-F238E27FC236}">
-                <a16:creationId xmlns:a16="http://schemas.microsoft.com/office/drawing/2014/main" id="{279B632A-A8B1-4B38-A344-B69935ED46EE}"/>
+                <a16:creationId xmlns:a16="http://schemas.microsoft.com/office/drawing/2014/main" id="{03E3708C-C153-45E3-9BFF-39E9A3A632F9}"/>
               </a:ext>
             </a:extLst>
           </p:cNvPr>
@@ -29581,7 +29581,7 @@
           <p:cNvPr id="19" name="TextBox 18">
             <a:extLst xmlns:a="http://schemas.openxmlformats.org/drawingml/2006/main">
               <a:ext uri="{FF2B5EF4-FFF2-40B4-BE49-F238E27FC236}">
-                <a16:creationId xmlns:a16="http://schemas.microsoft.com/office/drawing/2014/main" id="{FCAB1C89-C141-4273-BC1E-38B919B2E2EF}"/>
+                <a16:creationId xmlns:a16="http://schemas.microsoft.com/office/drawing/2014/main" id="{CA51478F-2DFC-435F-B782-260D0A219B32}"/>
               </a:ext>
             </a:extLst>
           </p:cNvPr>
@@ -29628,7 +29628,7 @@
           <p:cNvPr id="20" name="TextBox 19">
             <a:extLst xmlns:a="http://schemas.openxmlformats.org/drawingml/2006/main">
               <a:ext uri="{FF2B5EF4-FFF2-40B4-BE49-F238E27FC236}">
-                <a16:creationId xmlns:a16="http://schemas.microsoft.com/office/drawing/2014/main" id="{C1F2D772-82B4-444E-841F-8F15C3C1E23C}"/>
+                <a16:creationId xmlns:a16="http://schemas.microsoft.com/office/drawing/2014/main" id="{6EFD916A-A32F-4A83-98CD-7F95741E66B1}"/>
               </a:ext>
             </a:extLst>
           </p:cNvPr>
@@ -29673,7 +29673,7 @@
     </p:spTree>
     <p:extLst>
       <p:ext uri="{BB962C8B-B14F-4D97-AF65-F5344CB8AC3E}">
-        <p14:creationId xmlns:p14="http://schemas.microsoft.com/office/powerpoint/2010/main" val="1775246988"/>
+        <p14:creationId xmlns:p14="http://schemas.microsoft.com/office/powerpoint/2010/main" val="1502881297"/>
       </p:ext>
     </p:extLst>
   </p:cSld>
@@ -29697,7 +29697,7 @@
           <p:cNvPr id="2" name="TextBox 1">
             <a:extLst xmlns:a="http://schemas.openxmlformats.org/drawingml/2006/main">
               <a:ext uri="{FF2B5EF4-FFF2-40B4-BE49-F238E27FC236}">
-                <a16:creationId xmlns:a16="http://schemas.microsoft.com/office/drawing/2014/main" id="{DBCDC484-70BA-44F4-9663-BB0941872737}"/>
+                <a16:creationId xmlns:a16="http://schemas.microsoft.com/office/drawing/2014/main" id="{1F85C460-0FC9-475A-BEFD-91CDFEE6C42C}"/>
               </a:ext>
             </a:extLst>
           </p:cNvPr>
@@ -29744,7 +29744,7 @@
           <p:cNvPr id="3" name="TextBox 2">
             <a:extLst xmlns:a="http://schemas.openxmlformats.org/drawingml/2006/main">
               <a:ext uri="{FF2B5EF4-FFF2-40B4-BE49-F238E27FC236}">
-                <a16:creationId xmlns:a16="http://schemas.microsoft.com/office/drawing/2014/main" id="{FD2C593D-62C5-482E-B406-27876913224D}"/>
+                <a16:creationId xmlns:a16="http://schemas.microsoft.com/office/drawing/2014/main" id="{5BACA264-B47E-46A4-8E7A-42B53BD30190}"/>
               </a:ext>
             </a:extLst>
           </p:cNvPr>
@@ -29791,7 +29791,7 @@
           <p:cNvPr id="4" name="Rectangle 3">
             <a:extLst xmlns:a="http://schemas.openxmlformats.org/drawingml/2006/main">
               <a:ext uri="{FF2B5EF4-FFF2-40B4-BE49-F238E27FC236}">
-                <a16:creationId xmlns:a16="http://schemas.microsoft.com/office/drawing/2014/main" id="{DF10CF91-9B9C-4CED-B24B-4F18B495975A}"/>
+                <a16:creationId xmlns:a16="http://schemas.microsoft.com/office/drawing/2014/main" id="{3D986817-AC15-4D81-9DA2-BCE9D737EA68}"/>
               </a:ext>
             </a:extLst>
           </p:cNvPr>
@@ -29846,7 +29846,7 @@
           <p:cNvPr id="5" name="Rectangle 4">
             <a:extLst xmlns:a="http://schemas.openxmlformats.org/drawingml/2006/main">
               <a:ext uri="{FF2B5EF4-FFF2-40B4-BE49-F238E27FC236}">
-                <a16:creationId xmlns:a16="http://schemas.microsoft.com/office/drawing/2014/main" id="{DDCBE4A4-F9A0-4C2C-8E5E-31BCB05BA2A5}"/>
+                <a16:creationId xmlns:a16="http://schemas.microsoft.com/office/drawing/2014/main" id="{1FA7DF14-4866-409B-BA7C-CFAA47207720}"/>
               </a:ext>
             </a:extLst>
           </p:cNvPr>
@@ -29901,7 +29901,7 @@
           <p:cNvPr id="6" name="TextBox 5">
             <a:extLst xmlns:a="http://schemas.openxmlformats.org/drawingml/2006/main">
               <a:ext uri="{FF2B5EF4-FFF2-40B4-BE49-F238E27FC236}">
-                <a16:creationId xmlns:a16="http://schemas.microsoft.com/office/drawing/2014/main" id="{26C6F1A0-8497-4FBF-A0FB-E290E8407AFE}"/>
+                <a16:creationId xmlns:a16="http://schemas.microsoft.com/office/drawing/2014/main" id="{BCB5B9D5-AACA-4CB7-9B53-5F6DF15E1756}"/>
               </a:ext>
             </a:extLst>
           </p:cNvPr>
@@ -29938,7 +29938,7 @@
                 <a:ea typeface="Aptos"/>
                 <a:cs typeface="Aptos"/>
               </a:rPr>
-              <a:t>Independent public evidence summary · 2026.07.22-8 · 2026-07-22 · Sources: EPO family; national registers</a:t>
+              <a:t>Independent public evidence summary · 2026.07.22-9 · 2026-07-22 · Sources: EPO family; national registers</a:t>
             </a:r>
           </a:p>
         </p:txBody>
@@ -29948,7 +29948,7 @@
           <p:cNvPr id="7" name="TextBox 6">
             <a:extLst xmlns:a="http://schemas.openxmlformats.org/drawingml/2006/main">
               <a:ext uri="{FF2B5EF4-FFF2-40B4-BE49-F238E27FC236}">
-                <a16:creationId xmlns:a16="http://schemas.microsoft.com/office/drawing/2014/main" id="{35CD3847-85D5-4AB7-AE48-D300E45A6CAB}"/>
+                <a16:creationId xmlns:a16="http://schemas.microsoft.com/office/drawing/2014/main" id="{CF3E946A-196F-466F-A998-DAE328B13429}"/>
               </a:ext>
             </a:extLst>
           </p:cNvPr>
@@ -29995,7 +29995,7 @@
           <p:cNvPr id="8" name="Rounded Rectangle 7">
             <a:extLst xmlns:a="http://schemas.openxmlformats.org/drawingml/2006/main">
               <a:ext uri="{FF2B5EF4-FFF2-40B4-BE49-F238E27FC236}">
-                <a16:creationId xmlns:a16="http://schemas.microsoft.com/office/drawing/2014/main" id="{1DF988E0-E9C9-4F20-9DA7-EB42927C4836}"/>
+                <a16:creationId xmlns:a16="http://schemas.microsoft.com/office/drawing/2014/main" id="{E354748C-E401-4C4A-B5EA-CB8CA8020DF0}"/>
               </a:ext>
             </a:extLst>
           </p:cNvPr>
@@ -30052,7 +30052,7 @@
           <p:cNvPr id="9" name="TextBox 8">
             <a:extLst xmlns:a="http://schemas.openxmlformats.org/drawingml/2006/main">
               <a:ext uri="{FF2B5EF4-FFF2-40B4-BE49-F238E27FC236}">
-                <a16:creationId xmlns:a16="http://schemas.microsoft.com/office/drawing/2014/main" id="{6D987DC6-76C2-48C2-B6DF-F26D0F040A3E}"/>
+                <a16:creationId xmlns:a16="http://schemas.microsoft.com/office/drawing/2014/main" id="{8DBA2817-ABED-43F2-ADBA-5C0C61DD282D}"/>
               </a:ext>
             </a:extLst>
           </p:cNvPr>
@@ -30099,7 +30099,7 @@
           <p:cNvPr id="10" name="TextBox 9">
             <a:extLst xmlns:a="http://schemas.openxmlformats.org/drawingml/2006/main">
               <a:ext uri="{FF2B5EF4-FFF2-40B4-BE49-F238E27FC236}">
-                <a16:creationId xmlns:a16="http://schemas.microsoft.com/office/drawing/2014/main" id="{F9800A12-319C-4962-9D0B-C4BF9F71CAB8}"/>
+                <a16:creationId xmlns:a16="http://schemas.microsoft.com/office/drawing/2014/main" id="{9A634BB8-385E-4C34-84D7-51654DE3A28A}"/>
               </a:ext>
             </a:extLst>
           </p:cNvPr>
@@ -30146,7 +30146,7 @@
           <p:cNvPr id="11" name="Rounded Rectangle 10">
             <a:extLst xmlns:a="http://schemas.openxmlformats.org/drawingml/2006/main">
               <a:ext uri="{FF2B5EF4-FFF2-40B4-BE49-F238E27FC236}">
-                <a16:creationId xmlns:a16="http://schemas.microsoft.com/office/drawing/2014/main" id="{767896F4-8F73-462A-83AB-B885421A3FF2}"/>
+                <a16:creationId xmlns:a16="http://schemas.microsoft.com/office/drawing/2014/main" id="{B9A6829C-4527-4493-9820-8293EFE1AEAC}"/>
               </a:ext>
             </a:extLst>
           </p:cNvPr>
@@ -30203,7 +30203,7 @@
           <p:cNvPr id="12" name="TextBox 11">
             <a:extLst xmlns:a="http://schemas.openxmlformats.org/drawingml/2006/main">
               <a:ext uri="{FF2B5EF4-FFF2-40B4-BE49-F238E27FC236}">
-                <a16:creationId xmlns:a16="http://schemas.microsoft.com/office/drawing/2014/main" id="{1254FA05-BABB-44BF-88F9-E5B213F05633}"/>
+                <a16:creationId xmlns:a16="http://schemas.microsoft.com/office/drawing/2014/main" id="{83EBC911-5509-483F-B4A0-FAF788BFCBDA}"/>
               </a:ext>
             </a:extLst>
           </p:cNvPr>
@@ -30250,7 +30250,7 @@
           <p:cNvPr id="13" name="TextBox 12">
             <a:extLst xmlns:a="http://schemas.openxmlformats.org/drawingml/2006/main">
               <a:ext uri="{FF2B5EF4-FFF2-40B4-BE49-F238E27FC236}">
-                <a16:creationId xmlns:a16="http://schemas.microsoft.com/office/drawing/2014/main" id="{AFB0541B-5F4E-43D0-B2B7-1C2D9F80E981}"/>
+                <a16:creationId xmlns:a16="http://schemas.microsoft.com/office/drawing/2014/main" id="{6EC47865-5C1B-432A-B2F8-CEBBE7EEB769}"/>
               </a:ext>
             </a:extLst>
           </p:cNvPr>
@@ -30297,7 +30297,7 @@
           <p:cNvPr id="14" name="Rounded Rectangle 13">
             <a:extLst xmlns:a="http://schemas.openxmlformats.org/drawingml/2006/main">
               <a:ext uri="{FF2B5EF4-FFF2-40B4-BE49-F238E27FC236}">
-                <a16:creationId xmlns:a16="http://schemas.microsoft.com/office/drawing/2014/main" id="{4391C445-6853-4211-98CE-2213D9A73320}"/>
+                <a16:creationId xmlns:a16="http://schemas.microsoft.com/office/drawing/2014/main" id="{E3155377-721A-4F72-A364-E1ED4F598827}"/>
               </a:ext>
             </a:extLst>
           </p:cNvPr>
@@ -30354,7 +30354,7 @@
           <p:cNvPr id="15" name="TextBox 14">
             <a:extLst xmlns:a="http://schemas.openxmlformats.org/drawingml/2006/main">
               <a:ext uri="{FF2B5EF4-FFF2-40B4-BE49-F238E27FC236}">
-                <a16:creationId xmlns:a16="http://schemas.microsoft.com/office/drawing/2014/main" id="{758F9BB8-D578-41A8-97CA-683AA9EDCE8A}"/>
+                <a16:creationId xmlns:a16="http://schemas.microsoft.com/office/drawing/2014/main" id="{4EBB0956-E332-47B8-A852-B92019A56E3A}"/>
               </a:ext>
             </a:extLst>
           </p:cNvPr>
@@ -30401,7 +30401,7 @@
           <p:cNvPr id="16" name="TextBox 15">
             <a:extLst xmlns:a="http://schemas.openxmlformats.org/drawingml/2006/main">
               <a:ext uri="{FF2B5EF4-FFF2-40B4-BE49-F238E27FC236}">
-                <a16:creationId xmlns:a16="http://schemas.microsoft.com/office/drawing/2014/main" id="{6C7B955E-5AC3-45BD-839E-2D40A80E1849}"/>
+                <a16:creationId xmlns:a16="http://schemas.microsoft.com/office/drawing/2014/main" id="{B607D192-AFFC-45DF-9D0C-9F31FB11F4AA}"/>
               </a:ext>
             </a:extLst>
           </p:cNvPr>
@@ -30448,7 +30448,7 @@
           <p:cNvPr id="17" name="Rounded Rectangle 16">
             <a:extLst xmlns:a="http://schemas.openxmlformats.org/drawingml/2006/main">
               <a:ext uri="{FF2B5EF4-FFF2-40B4-BE49-F238E27FC236}">
-                <a16:creationId xmlns:a16="http://schemas.microsoft.com/office/drawing/2014/main" id="{21712B5A-3125-45A9-BE59-E6CCD65ABA54}"/>
+                <a16:creationId xmlns:a16="http://schemas.microsoft.com/office/drawing/2014/main" id="{1B352597-ADE2-4DE7-A6E2-C9096A1FC01B}"/>
               </a:ext>
             </a:extLst>
           </p:cNvPr>
@@ -30505,7 +30505,7 @@
           <p:cNvPr id="18" name="TextBox 17">
             <a:extLst xmlns:a="http://schemas.openxmlformats.org/drawingml/2006/main">
               <a:ext uri="{FF2B5EF4-FFF2-40B4-BE49-F238E27FC236}">
-                <a16:creationId xmlns:a16="http://schemas.microsoft.com/office/drawing/2014/main" id="{D2576BA8-6B35-4A51-BBDA-CBA1F43A3400}"/>
+                <a16:creationId xmlns:a16="http://schemas.microsoft.com/office/drawing/2014/main" id="{6BD6BCEB-C4A1-474E-AA68-DBA0E1E82D25}"/>
               </a:ext>
             </a:extLst>
           </p:cNvPr>
@@ -30552,7 +30552,7 @@
           <p:cNvPr id="19" name="TextBox 18">
             <a:extLst xmlns:a="http://schemas.openxmlformats.org/drawingml/2006/main">
               <a:ext uri="{FF2B5EF4-FFF2-40B4-BE49-F238E27FC236}">
-                <a16:creationId xmlns:a16="http://schemas.microsoft.com/office/drawing/2014/main" id="{0EB42671-6489-4B20-ADA9-44C8FED829FB}"/>
+                <a16:creationId xmlns:a16="http://schemas.microsoft.com/office/drawing/2014/main" id="{77469775-6D7C-4887-A3EA-4C561081403F}"/>
               </a:ext>
             </a:extLst>
           </p:cNvPr>
@@ -30599,7 +30599,7 @@
           <p:cNvPr id="20" name="TextBox 19">
             <a:extLst xmlns:a="http://schemas.openxmlformats.org/drawingml/2006/main">
               <a:ext uri="{FF2B5EF4-FFF2-40B4-BE49-F238E27FC236}">
-                <a16:creationId xmlns:a16="http://schemas.microsoft.com/office/drawing/2014/main" id="{5B906517-CBE3-445A-A3D0-DA19142B5F03}"/>
+                <a16:creationId xmlns:a16="http://schemas.microsoft.com/office/drawing/2014/main" id="{98BC8E10-5F47-433F-91BE-166F28150D6B}"/>
               </a:ext>
             </a:extLst>
           </p:cNvPr>
@@ -30646,7 +30646,7 @@
           <p:cNvPr id="21" name="Rounded Rectangle 20">
             <a:extLst xmlns:a="http://schemas.openxmlformats.org/drawingml/2006/main">
               <a:ext uri="{FF2B5EF4-FFF2-40B4-BE49-F238E27FC236}">
-                <a16:creationId xmlns:a16="http://schemas.microsoft.com/office/drawing/2014/main" id="{65818A31-2EA0-47FB-AE33-0AFC178E6858}"/>
+                <a16:creationId xmlns:a16="http://schemas.microsoft.com/office/drawing/2014/main" id="{3B4C493A-6A11-4625-A17E-B8E064D9B594}"/>
               </a:ext>
             </a:extLst>
           </p:cNvPr>
@@ -30703,7 +30703,7 @@
           <p:cNvPr id="22" name="TextBox 21">
             <a:extLst xmlns:a="http://schemas.openxmlformats.org/drawingml/2006/main">
               <a:ext uri="{FF2B5EF4-FFF2-40B4-BE49-F238E27FC236}">
-                <a16:creationId xmlns:a16="http://schemas.microsoft.com/office/drawing/2014/main" id="{218D366B-9DBA-4178-B263-3A1EFA657A2C}"/>
+                <a16:creationId xmlns:a16="http://schemas.microsoft.com/office/drawing/2014/main" id="{64119EA7-164B-4C27-8B57-E68D6C572BDE}"/>
               </a:ext>
             </a:extLst>
           </p:cNvPr>
@@ -30750,7 +30750,7 @@
           <p:cNvPr id="23" name="TextBox 22">
             <a:extLst xmlns:a="http://schemas.openxmlformats.org/drawingml/2006/main">
               <a:ext uri="{FF2B5EF4-FFF2-40B4-BE49-F238E27FC236}">
-                <a16:creationId xmlns:a16="http://schemas.microsoft.com/office/drawing/2014/main" id="{AF24983B-244D-4F61-8BA2-7CA29988D386}"/>
+                <a16:creationId xmlns:a16="http://schemas.microsoft.com/office/drawing/2014/main" id="{75D54E7B-E8F0-41AD-9015-67888E8C0F3C}"/>
               </a:ext>
             </a:extLst>
           </p:cNvPr>
@@ -30795,7 +30795,7 @@
     </p:spTree>
     <p:extLst>
       <p:ext uri="{BB962C8B-B14F-4D97-AF65-F5344CB8AC3E}">
-        <p14:creationId xmlns:p14="http://schemas.microsoft.com/office/powerpoint/2010/main" val="140360122"/>
+        <p14:creationId xmlns:p14="http://schemas.microsoft.com/office/powerpoint/2010/main" val="1254853679"/>
       </p:ext>
     </p:extLst>
   </p:cSld>
@@ -30819,7 +30819,7 @@
           <p:cNvPr id="2" name="TextBox 1">
             <a:extLst xmlns:a="http://schemas.openxmlformats.org/drawingml/2006/main">
               <a:ext uri="{FF2B5EF4-FFF2-40B4-BE49-F238E27FC236}">
-                <a16:creationId xmlns:a16="http://schemas.microsoft.com/office/drawing/2014/main" id="{B0922B50-4DAC-4D18-8F3E-490A7536DB9B}"/>
+                <a16:creationId xmlns:a16="http://schemas.microsoft.com/office/drawing/2014/main" id="{1F86B18E-D37E-42D5-939C-C13C68556CC6}"/>
               </a:ext>
             </a:extLst>
           </p:cNvPr>
@@ -30866,7 +30866,7 @@
           <p:cNvPr id="3" name="TextBox 2">
             <a:extLst xmlns:a="http://schemas.openxmlformats.org/drawingml/2006/main">
               <a:ext uri="{FF2B5EF4-FFF2-40B4-BE49-F238E27FC236}">
-                <a16:creationId xmlns:a16="http://schemas.microsoft.com/office/drawing/2014/main" id="{C0382A01-B6F7-4475-9343-871181C8787B}"/>
+                <a16:creationId xmlns:a16="http://schemas.microsoft.com/office/drawing/2014/main" id="{12FC2B2F-A43C-453C-963A-6A9219B30281}"/>
               </a:ext>
             </a:extLst>
           </p:cNvPr>
@@ -30913,7 +30913,7 @@
           <p:cNvPr id="4" name="Rectangle 3">
             <a:extLst xmlns:a="http://schemas.openxmlformats.org/drawingml/2006/main">
               <a:ext uri="{FF2B5EF4-FFF2-40B4-BE49-F238E27FC236}">
-                <a16:creationId xmlns:a16="http://schemas.microsoft.com/office/drawing/2014/main" id="{E1D95E78-9CAB-4AEA-BE34-C3E085CEC1EA}"/>
+                <a16:creationId xmlns:a16="http://schemas.microsoft.com/office/drawing/2014/main" id="{4DC40BD4-F3E4-4F7C-BA26-75C97201CDD4}"/>
               </a:ext>
             </a:extLst>
           </p:cNvPr>
@@ -30968,7 +30968,7 @@
           <p:cNvPr id="5" name="Rectangle 4">
             <a:extLst xmlns:a="http://schemas.openxmlformats.org/drawingml/2006/main">
               <a:ext uri="{FF2B5EF4-FFF2-40B4-BE49-F238E27FC236}">
-                <a16:creationId xmlns:a16="http://schemas.microsoft.com/office/drawing/2014/main" id="{0B8B0468-F97E-4662-BDD0-19FA95FCEC3D}"/>
+                <a16:creationId xmlns:a16="http://schemas.microsoft.com/office/drawing/2014/main" id="{1330912F-99CD-4DAC-BF5C-14877D4F6433}"/>
               </a:ext>
             </a:extLst>
           </p:cNvPr>
@@ -31023,7 +31023,7 @@
           <p:cNvPr id="6" name="TextBox 5">
             <a:extLst xmlns:a="http://schemas.openxmlformats.org/drawingml/2006/main">
               <a:ext uri="{FF2B5EF4-FFF2-40B4-BE49-F238E27FC236}">
-                <a16:creationId xmlns:a16="http://schemas.microsoft.com/office/drawing/2014/main" id="{F2C20B36-22B2-4E63-95E4-40CBC166D8DD}"/>
+                <a16:creationId xmlns:a16="http://schemas.microsoft.com/office/drawing/2014/main" id="{C61978B0-8184-4DCC-93D1-648DC06E2D36}"/>
               </a:ext>
             </a:extLst>
           </p:cNvPr>
@@ -31060,7 +31060,7 @@
                 <a:ea typeface="Aptos"/>
                 <a:cs typeface="Aptos"/>
               </a:rPr>
-              <a:t>Independent public evidence summary · 2026.07.22-8 · 2026-07-22 · Sources: Official judgments: 8 Ni 18/24 (EP); 7 O 3341/24</a:t>
+              <a:t>Independent public evidence summary · 2026.07.22-9 · 2026-07-22 · Sources: Official judgments: 8 Ni 18/24 (EP); 7 O 3341/24</a:t>
             </a:r>
           </a:p>
         </p:txBody>
@@ -31070,7 +31070,7 @@
           <p:cNvPr id="7" name="TextBox 6">
             <a:extLst xmlns:a="http://schemas.openxmlformats.org/drawingml/2006/main">
               <a:ext uri="{FF2B5EF4-FFF2-40B4-BE49-F238E27FC236}">
-                <a16:creationId xmlns:a16="http://schemas.microsoft.com/office/drawing/2014/main" id="{2B5B9497-CACC-42B6-B012-561416600D9E}"/>
+                <a16:creationId xmlns:a16="http://schemas.microsoft.com/office/drawing/2014/main" id="{4F05FD3F-8F5E-4D4F-BD11-CCD845CB45DF}"/>
               </a:ext>
             </a:extLst>
           </p:cNvPr>
@@ -31391,7 +31391,7 @@
           <p:cNvPr id="9" name="TextBox 8">
             <a:extLst xmlns:a="http://schemas.openxmlformats.org/drawingml/2006/main">
               <a:ext uri="{FF2B5EF4-FFF2-40B4-BE49-F238E27FC236}">
-                <a16:creationId xmlns:a16="http://schemas.microsoft.com/office/drawing/2014/main" id="{B221A6FC-3B7F-4206-A2AC-2386CE3C7412}"/>
+                <a16:creationId xmlns:a16="http://schemas.microsoft.com/office/drawing/2014/main" id="{3764FEA9-9D11-4EB7-AD70-AC9C542928DB}"/>
               </a:ext>
             </a:extLst>
           </p:cNvPr>
@@ -31436,7 +31436,7 @@
     </p:spTree>
     <p:extLst>
       <p:ext uri="{BB962C8B-B14F-4D97-AF65-F5344CB8AC3E}">
-        <p14:creationId xmlns:p14="http://schemas.microsoft.com/office/powerpoint/2010/main" val="33034432"/>
+        <p14:creationId xmlns:p14="http://schemas.microsoft.com/office/powerpoint/2010/main" val="26098725"/>
       </p:ext>
     </p:extLst>
   </p:cSld>

</xml_diff>

<commit_message>
Publish bankability gates and Top 10 matrix v10
</commit_message>
<xml_diff>
--- a/site/downloads/pixan-bank-deck-large-en.pptx
+++ b/site/downloads/pixan-bank-deck-large-en.pptx
@@ -2,42 +2,42 @@
 <file path=ppt/presentation.xml><?xml version="1.0" encoding="utf-8"?>
 <p:presentation xmlns:p="http://schemas.openxmlformats.org/presentationml/2006/main">
   <p:sldMasterIdLst>
-    <p:sldMasterId xmlns:r="http://schemas.openxmlformats.org/officeDocument/2006/relationships" id="2147483648" r:id="R934fdd0391f64ef5"/>
+    <p:sldMasterId xmlns:r="http://schemas.openxmlformats.org/officeDocument/2006/relationships" id="2147483648" r:id="Ref5a49b8e33444ee"/>
   </p:sldMasterIdLst>
   <p:notesMasterIdLst>
-    <p:notesMasterId xmlns:r="http://schemas.openxmlformats.org/officeDocument/2006/relationships" r:id="Raefbd3c6b7bb4c49"/>
+    <p:notesMasterId xmlns:r="http://schemas.openxmlformats.org/officeDocument/2006/relationships" r:id="R5c967f926b054948"/>
   </p:notesMasterIdLst>
   <p:sldIdLst>
-    <p:sldId xmlns:r="http://schemas.openxmlformats.org/officeDocument/2006/relationships" id="256" r:id="Rb90a8255385041cf"/>
-    <p:sldId xmlns:r="http://schemas.openxmlformats.org/officeDocument/2006/relationships" id="257" r:id="R960a9e4bfee94ab4"/>
-    <p:sldId xmlns:r="http://schemas.openxmlformats.org/officeDocument/2006/relationships" id="258" r:id="R4365f1d8579a4ed2"/>
-    <p:sldId xmlns:r="http://schemas.openxmlformats.org/officeDocument/2006/relationships" id="259" r:id="Rae19a14838a8425d"/>
-    <p:sldId xmlns:r="http://schemas.openxmlformats.org/officeDocument/2006/relationships" id="260" r:id="R916b6352b3844a09"/>
-    <p:sldId xmlns:r="http://schemas.openxmlformats.org/officeDocument/2006/relationships" id="261" r:id="R42c73f003df84fcc"/>
-    <p:sldId xmlns:r="http://schemas.openxmlformats.org/officeDocument/2006/relationships" id="262" r:id="R4f332eb4d5fc48f7"/>
-    <p:sldId xmlns:r="http://schemas.openxmlformats.org/officeDocument/2006/relationships" id="263" r:id="R5a4dba89fdd647ca"/>
-    <p:sldId xmlns:r="http://schemas.openxmlformats.org/officeDocument/2006/relationships" id="264" r:id="R98c5a7c62e8c4d47"/>
-    <p:sldId xmlns:r="http://schemas.openxmlformats.org/officeDocument/2006/relationships" id="265" r:id="Rbeb5902f404f4c63"/>
-    <p:sldId xmlns:r="http://schemas.openxmlformats.org/officeDocument/2006/relationships" id="266" r:id="R992e5e54bc2c40ef"/>
-    <p:sldId xmlns:r="http://schemas.openxmlformats.org/officeDocument/2006/relationships" id="267" r:id="R9858e480e79e46e3"/>
-    <p:sldId xmlns:r="http://schemas.openxmlformats.org/officeDocument/2006/relationships" id="268" r:id="Ra0a39da0385c4e33"/>
-    <p:sldId xmlns:r="http://schemas.openxmlformats.org/officeDocument/2006/relationships" id="269" r:id="R8b570191b160452b"/>
-    <p:sldId xmlns:r="http://schemas.openxmlformats.org/officeDocument/2006/relationships" id="270" r:id="R21d14bfa8de04832"/>
-    <p:sldId xmlns:r="http://schemas.openxmlformats.org/officeDocument/2006/relationships" id="271" r:id="R0deb1fdf4b5141b0"/>
-    <p:sldId xmlns:r="http://schemas.openxmlformats.org/officeDocument/2006/relationships" id="272" r:id="Rc4f608e3b9eb46e4"/>
-    <p:sldId xmlns:r="http://schemas.openxmlformats.org/officeDocument/2006/relationships" id="273" r:id="R2f72d6c2b44a42d6"/>
-    <p:sldId xmlns:r="http://schemas.openxmlformats.org/officeDocument/2006/relationships" id="274" r:id="R40f0e9cec5b64662"/>
-    <p:sldId xmlns:r="http://schemas.openxmlformats.org/officeDocument/2006/relationships" id="275" r:id="Rdfe50698937944b5"/>
-    <p:sldId xmlns:r="http://schemas.openxmlformats.org/officeDocument/2006/relationships" id="276" r:id="Rc7c6a81c3d2b413c"/>
-    <p:sldId xmlns:r="http://schemas.openxmlformats.org/officeDocument/2006/relationships" id="277" r:id="R4a813ee71939451a"/>
-    <p:sldId xmlns:r="http://schemas.openxmlformats.org/officeDocument/2006/relationships" id="278" r:id="R21afbe3c14434469"/>
-    <p:sldId xmlns:r="http://schemas.openxmlformats.org/officeDocument/2006/relationships" id="279" r:id="R67720dc0e87a4f64"/>
-    <p:sldId xmlns:r="http://schemas.openxmlformats.org/officeDocument/2006/relationships" id="280" r:id="Rae0a33b17a3f4df4"/>
-    <p:sldId xmlns:r="http://schemas.openxmlformats.org/officeDocument/2006/relationships" id="281" r:id="Rb25bc321e1ba43ed"/>
-    <p:sldId xmlns:r="http://schemas.openxmlformats.org/officeDocument/2006/relationships" id="282" r:id="R6e158a59bb424704"/>
-    <p:sldId xmlns:r="http://schemas.openxmlformats.org/officeDocument/2006/relationships" id="283" r:id="R4b21a3f5baab4981"/>
-    <p:sldId xmlns:r="http://schemas.openxmlformats.org/officeDocument/2006/relationships" id="284" r:id="Rc3d3a762a9024402"/>
-    <p:sldId xmlns:r="http://schemas.openxmlformats.org/officeDocument/2006/relationships" id="285" r:id="Rf697e9cf6c3e4f34"/>
+    <p:sldId xmlns:r="http://schemas.openxmlformats.org/officeDocument/2006/relationships" id="256" r:id="R51f76c2c33d54ebc"/>
+    <p:sldId xmlns:r="http://schemas.openxmlformats.org/officeDocument/2006/relationships" id="257" r:id="Rb6ca7651245e44bd"/>
+    <p:sldId xmlns:r="http://schemas.openxmlformats.org/officeDocument/2006/relationships" id="258" r:id="R728d3864eea54789"/>
+    <p:sldId xmlns:r="http://schemas.openxmlformats.org/officeDocument/2006/relationships" id="259" r:id="R887296ef3e5c41bd"/>
+    <p:sldId xmlns:r="http://schemas.openxmlformats.org/officeDocument/2006/relationships" id="260" r:id="R0964266d23544227"/>
+    <p:sldId xmlns:r="http://schemas.openxmlformats.org/officeDocument/2006/relationships" id="261" r:id="Rfcff9a4ef5ff4ae7"/>
+    <p:sldId xmlns:r="http://schemas.openxmlformats.org/officeDocument/2006/relationships" id="262" r:id="R7112d5d98d4a4983"/>
+    <p:sldId xmlns:r="http://schemas.openxmlformats.org/officeDocument/2006/relationships" id="263" r:id="R42a42d6de41544ae"/>
+    <p:sldId xmlns:r="http://schemas.openxmlformats.org/officeDocument/2006/relationships" id="264" r:id="R37a99e70731e41fe"/>
+    <p:sldId xmlns:r="http://schemas.openxmlformats.org/officeDocument/2006/relationships" id="265" r:id="R65afc73da1a34c04"/>
+    <p:sldId xmlns:r="http://schemas.openxmlformats.org/officeDocument/2006/relationships" id="266" r:id="R90d189aa4f134a19"/>
+    <p:sldId xmlns:r="http://schemas.openxmlformats.org/officeDocument/2006/relationships" id="267" r:id="Rd493ce9875fb40ad"/>
+    <p:sldId xmlns:r="http://schemas.openxmlformats.org/officeDocument/2006/relationships" id="268" r:id="R7b6d40e79ba44233"/>
+    <p:sldId xmlns:r="http://schemas.openxmlformats.org/officeDocument/2006/relationships" id="269" r:id="R39b5bfeb317b4cbd"/>
+    <p:sldId xmlns:r="http://schemas.openxmlformats.org/officeDocument/2006/relationships" id="270" r:id="R755731d64aa34ddc"/>
+    <p:sldId xmlns:r="http://schemas.openxmlformats.org/officeDocument/2006/relationships" id="271" r:id="Rfdf723c821904929"/>
+    <p:sldId xmlns:r="http://schemas.openxmlformats.org/officeDocument/2006/relationships" id="272" r:id="R7be044c8e0c74838"/>
+    <p:sldId xmlns:r="http://schemas.openxmlformats.org/officeDocument/2006/relationships" id="273" r:id="Raadd97d2e8a242cf"/>
+    <p:sldId xmlns:r="http://schemas.openxmlformats.org/officeDocument/2006/relationships" id="274" r:id="R7381ce146e4b478b"/>
+    <p:sldId xmlns:r="http://schemas.openxmlformats.org/officeDocument/2006/relationships" id="275" r:id="Rfe0fae9fe1c1489a"/>
+    <p:sldId xmlns:r="http://schemas.openxmlformats.org/officeDocument/2006/relationships" id="276" r:id="Rf9b199648b494dbb"/>
+    <p:sldId xmlns:r="http://schemas.openxmlformats.org/officeDocument/2006/relationships" id="277" r:id="R4873d6082fbc4c82"/>
+    <p:sldId xmlns:r="http://schemas.openxmlformats.org/officeDocument/2006/relationships" id="278" r:id="R4547eb5e8aa84604"/>
+    <p:sldId xmlns:r="http://schemas.openxmlformats.org/officeDocument/2006/relationships" id="279" r:id="R611b8110eafe4209"/>
+    <p:sldId xmlns:r="http://schemas.openxmlformats.org/officeDocument/2006/relationships" id="280" r:id="R15e9dc2682cf4158"/>
+    <p:sldId xmlns:r="http://schemas.openxmlformats.org/officeDocument/2006/relationships" id="281" r:id="Re5f890118f864b93"/>
+    <p:sldId xmlns:r="http://schemas.openxmlformats.org/officeDocument/2006/relationships" id="282" r:id="Rc21c7b9bc13842d6"/>
+    <p:sldId xmlns:r="http://schemas.openxmlformats.org/officeDocument/2006/relationships" id="283" r:id="R6bdca5e15de544ac"/>
+    <p:sldId xmlns:r="http://schemas.openxmlformats.org/officeDocument/2006/relationships" id="284" r:id="R57e2f9a531fe42da"/>
+    <p:sldId xmlns:r="http://schemas.openxmlformats.org/officeDocument/2006/relationships" id="285" r:id="Ra2cb064421854e20"/>
   </p:sldIdLst>
   <p:sldSz cx="12191999" cy="6858000"/>
   <p:notesSz cx="6858000" cy="9144000"/>
@@ -2546,7 +2546,7 @@
           <p:cNvPr id="2" name="Title 1">
             <a:extLst xmlns:a="http://schemas.openxmlformats.org/drawingml/2006/main">
               <a:ext uri="{FF2B5EF4-FFF2-40B4-BE49-F238E27FC236}">
-                <a16:creationId xmlns:a16="http://schemas.microsoft.com/office/drawing/2014/main" id="{F3436E2D-E1C1-48F8-9197-85806D748C89}"/>
+                <a16:creationId xmlns:a16="http://schemas.microsoft.com/office/drawing/2014/main" id="{0F263D0A-7A17-49AF-9E15-8C9B81D8EDAD}"/>
               </a:ext>
             </a:extLst>
           </p:cNvPr>
@@ -2578,7 +2578,7 @@
           <p:cNvPr id="3" name="Subtitle 2">
             <a:extLst xmlns:a="http://schemas.openxmlformats.org/drawingml/2006/main">
               <a:ext uri="{FF2B5EF4-FFF2-40B4-BE49-F238E27FC236}">
-                <a16:creationId xmlns:a16="http://schemas.microsoft.com/office/drawing/2014/main" id="{62B16E96-B168-49C7-A598-9CF616815311}"/>
+                <a16:creationId xmlns:a16="http://schemas.microsoft.com/office/drawing/2014/main" id="{33CE651E-9356-4C9A-AE02-68CA21CFDEA0}"/>
               </a:ext>
             </a:extLst>
           </p:cNvPr>
@@ -2701,7 +2701,7 @@
           <p:cNvPr id="4" name="Date Placeholder 3">
             <a:extLst xmlns:a="http://schemas.openxmlformats.org/drawingml/2006/main">
               <a:ext uri="{FF2B5EF4-FFF2-40B4-BE49-F238E27FC236}">
-                <a16:creationId xmlns:a16="http://schemas.microsoft.com/office/drawing/2014/main" id="{E02447EA-F21A-4FCE-93BF-83319C5F99A9}"/>
+                <a16:creationId xmlns:a16="http://schemas.microsoft.com/office/drawing/2014/main" id="{139E1B8C-5293-4AA1-A733-6EE5675CCF10}"/>
               </a:ext>
             </a:extLst>
           </p:cNvPr>
@@ -2728,7 +2728,7 @@
           <p:cNvPr id="5" name="Footer Placeholder 4">
             <a:extLst xmlns:a="http://schemas.openxmlformats.org/drawingml/2006/main">
               <a:ext uri="{FF2B5EF4-FFF2-40B4-BE49-F238E27FC236}">
-                <a16:creationId xmlns:a16="http://schemas.microsoft.com/office/drawing/2014/main" id="{12513908-F315-46CE-A1CC-00E9FD3C54AC}"/>
+                <a16:creationId xmlns:a16="http://schemas.microsoft.com/office/drawing/2014/main" id="{5EB15239-356B-425E-AD3A-159BABF8D12D}"/>
               </a:ext>
             </a:extLst>
           </p:cNvPr>
@@ -2751,7 +2751,7 @@
           <p:cNvPr id="6" name="Slide Number Placeholder 5">
             <a:extLst xmlns:a="http://schemas.openxmlformats.org/drawingml/2006/main">
               <a:ext uri="{FF2B5EF4-FFF2-40B4-BE49-F238E27FC236}">
-                <a16:creationId xmlns:a16="http://schemas.microsoft.com/office/drawing/2014/main" id="{239F615F-3E32-440F-9629-6EAE999D7021}"/>
+                <a16:creationId xmlns:a16="http://schemas.microsoft.com/office/drawing/2014/main" id="{07C81122-C1FB-48A1-A053-C2A4BF2B0A55}"/>
               </a:ext>
             </a:extLst>
           </p:cNvPr>
@@ -2795,7 +2795,7 @@
           <p:cNvPr id="2" name="Title 1">
             <a:extLst xmlns:a="http://schemas.openxmlformats.org/drawingml/2006/main">
               <a:ext uri="{FF2B5EF4-FFF2-40B4-BE49-F238E27FC236}">
-                <a16:creationId xmlns:a16="http://schemas.microsoft.com/office/drawing/2014/main" id="{89FD243A-6CAA-4913-923B-A5345D6D622C}"/>
+                <a16:creationId xmlns:a16="http://schemas.microsoft.com/office/drawing/2014/main" id="{88689F9D-D90E-4212-AF5D-4DC3A778E3F9}"/>
               </a:ext>
             </a:extLst>
           </p:cNvPr>
@@ -2822,7 +2822,7 @@
           <p:cNvPr id="3" name="Vertical Text Placeholder 2">
             <a:extLst xmlns:a="http://schemas.openxmlformats.org/drawingml/2006/main">
               <a:ext uri="{FF2B5EF4-FFF2-40B4-BE49-F238E27FC236}">
-                <a16:creationId xmlns:a16="http://schemas.microsoft.com/office/drawing/2014/main" id="{C239DBDF-4F3A-4DCA-A0B2-ABCDB27C67A5}"/>
+                <a16:creationId xmlns:a16="http://schemas.microsoft.com/office/drawing/2014/main" id="{10EF1C08-EF34-466C-8BA3-229CBCF1C108}"/>
               </a:ext>
             </a:extLst>
           </p:cNvPr>
@@ -2884,7 +2884,7 @@
           <p:cNvPr id="4" name="Date Placeholder 3">
             <a:extLst xmlns:a="http://schemas.openxmlformats.org/drawingml/2006/main">
               <a:ext uri="{FF2B5EF4-FFF2-40B4-BE49-F238E27FC236}">
-                <a16:creationId xmlns:a16="http://schemas.microsoft.com/office/drawing/2014/main" id="{46FFBFA1-4FEA-4BDF-A8A9-987002A20BF0}"/>
+                <a16:creationId xmlns:a16="http://schemas.microsoft.com/office/drawing/2014/main" id="{97929792-CE4E-40B1-AF2B-1A5516E363D7}"/>
               </a:ext>
             </a:extLst>
           </p:cNvPr>
@@ -2911,7 +2911,7 @@
           <p:cNvPr id="5" name="Footer Placeholder 4">
             <a:extLst xmlns:a="http://schemas.openxmlformats.org/drawingml/2006/main">
               <a:ext uri="{FF2B5EF4-FFF2-40B4-BE49-F238E27FC236}">
-                <a16:creationId xmlns:a16="http://schemas.microsoft.com/office/drawing/2014/main" id="{6C745F40-C9B3-445B-9CA8-FCDF87B7917D}"/>
+                <a16:creationId xmlns:a16="http://schemas.microsoft.com/office/drawing/2014/main" id="{CD88F3ED-EA7D-467A-9C52-05D50D443BD0}"/>
               </a:ext>
             </a:extLst>
           </p:cNvPr>
@@ -2934,7 +2934,7 @@
           <p:cNvPr id="6" name="Slide Number Placeholder 5">
             <a:extLst xmlns:a="http://schemas.openxmlformats.org/drawingml/2006/main">
               <a:ext uri="{FF2B5EF4-FFF2-40B4-BE49-F238E27FC236}">
-                <a16:creationId xmlns:a16="http://schemas.microsoft.com/office/drawing/2014/main" id="{5594C023-5908-4B1A-B1EA-84359181F922}"/>
+                <a16:creationId xmlns:a16="http://schemas.microsoft.com/office/drawing/2014/main" id="{D107801E-00F9-487D-94DA-370DA0E5094D}"/>
               </a:ext>
             </a:extLst>
           </p:cNvPr>
@@ -2978,7 +2978,7 @@
           <p:cNvPr id="2" name="Vertical Title 1">
             <a:extLst xmlns:a="http://schemas.openxmlformats.org/drawingml/2006/main">
               <a:ext uri="{FF2B5EF4-FFF2-40B4-BE49-F238E27FC236}">
-                <a16:creationId xmlns:a16="http://schemas.microsoft.com/office/drawing/2014/main" id="{3DDAAF3A-5834-414F-962E-06DCE1000473}"/>
+                <a16:creationId xmlns:a16="http://schemas.microsoft.com/office/drawing/2014/main" id="{96E88F34-EAB4-4595-A3D2-175AC418DD28}"/>
               </a:ext>
             </a:extLst>
           </p:cNvPr>
@@ -3010,7 +3010,7 @@
           <p:cNvPr id="3" name="Vertical Text Placeholder 2">
             <a:extLst xmlns:a="http://schemas.openxmlformats.org/drawingml/2006/main">
               <a:ext uri="{FF2B5EF4-FFF2-40B4-BE49-F238E27FC236}">
-                <a16:creationId xmlns:a16="http://schemas.microsoft.com/office/drawing/2014/main" id="{7013BCE6-FFD4-4B59-AB1F-12C5EA045F0D}"/>
+                <a16:creationId xmlns:a16="http://schemas.microsoft.com/office/drawing/2014/main" id="{D4F7F1DB-FE5D-4823-A3CD-C7F0D2237EC5}"/>
               </a:ext>
             </a:extLst>
           </p:cNvPr>
@@ -3077,7 +3077,7 @@
           <p:cNvPr id="4" name="Date Placeholder 3">
             <a:extLst xmlns:a="http://schemas.openxmlformats.org/drawingml/2006/main">
               <a:ext uri="{FF2B5EF4-FFF2-40B4-BE49-F238E27FC236}">
-                <a16:creationId xmlns:a16="http://schemas.microsoft.com/office/drawing/2014/main" id="{A7EEF051-262B-4E4B-ADB0-24779627AA5E}"/>
+                <a16:creationId xmlns:a16="http://schemas.microsoft.com/office/drawing/2014/main" id="{BC986B05-E101-4360-BC00-B898A475169A}"/>
               </a:ext>
             </a:extLst>
           </p:cNvPr>
@@ -3104,7 +3104,7 @@
           <p:cNvPr id="5" name="Footer Placeholder 4">
             <a:extLst xmlns:a="http://schemas.openxmlformats.org/drawingml/2006/main">
               <a:ext uri="{FF2B5EF4-FFF2-40B4-BE49-F238E27FC236}">
-                <a16:creationId xmlns:a16="http://schemas.microsoft.com/office/drawing/2014/main" id="{5EAA2759-142E-46CE-9777-3E934F614A55}"/>
+                <a16:creationId xmlns:a16="http://schemas.microsoft.com/office/drawing/2014/main" id="{20101DBA-9678-48FE-A7BE-E91B5FEBDA48}"/>
               </a:ext>
             </a:extLst>
           </p:cNvPr>
@@ -3127,7 +3127,7 @@
           <p:cNvPr id="6" name="Slide Number Placeholder 5">
             <a:extLst xmlns:a="http://schemas.openxmlformats.org/drawingml/2006/main">
               <a:ext uri="{FF2B5EF4-FFF2-40B4-BE49-F238E27FC236}">
-                <a16:creationId xmlns:a16="http://schemas.microsoft.com/office/drawing/2014/main" id="{CA18648B-47EC-4B15-83E6-C4B0024A997E}"/>
+                <a16:creationId xmlns:a16="http://schemas.microsoft.com/office/drawing/2014/main" id="{4350D0D1-EA30-4033-B43D-62E0C7DB2B20}"/>
               </a:ext>
             </a:extLst>
           </p:cNvPr>
@@ -3171,7 +3171,7 @@
           <p:cNvPr id="2" name="Title 1">
             <a:extLst xmlns:a="http://schemas.openxmlformats.org/drawingml/2006/main">
               <a:ext uri="{FF2B5EF4-FFF2-40B4-BE49-F238E27FC236}">
-                <a16:creationId xmlns:a16="http://schemas.microsoft.com/office/drawing/2014/main" id="{765A7553-220F-4CDF-8251-AF14311B9589}"/>
+                <a16:creationId xmlns:a16="http://schemas.microsoft.com/office/drawing/2014/main" id="{78915B9A-5B8F-4426-A131-2263FBEF2242}"/>
               </a:ext>
             </a:extLst>
           </p:cNvPr>
@@ -3198,7 +3198,7 @@
           <p:cNvPr id="3" name="Content Placeholder 2">
             <a:extLst xmlns:a="http://schemas.openxmlformats.org/drawingml/2006/main">
               <a:ext uri="{FF2B5EF4-FFF2-40B4-BE49-F238E27FC236}">
-                <a16:creationId xmlns:a16="http://schemas.microsoft.com/office/drawing/2014/main" id="{6748F28A-2112-48E5-9FC8-1E0AA4A8FC18}"/>
+                <a16:creationId xmlns:a16="http://schemas.microsoft.com/office/drawing/2014/main" id="{DB859555-37FA-4076-A123-CF1CAAEBD1A5}"/>
               </a:ext>
             </a:extLst>
           </p:cNvPr>
@@ -3260,7 +3260,7 @@
           <p:cNvPr id="4" name="Date Placeholder 3">
             <a:extLst xmlns:a="http://schemas.openxmlformats.org/drawingml/2006/main">
               <a:ext uri="{FF2B5EF4-FFF2-40B4-BE49-F238E27FC236}">
-                <a16:creationId xmlns:a16="http://schemas.microsoft.com/office/drawing/2014/main" id="{DC1F3072-69D6-4D58-B937-5A4A9732AF6F}"/>
+                <a16:creationId xmlns:a16="http://schemas.microsoft.com/office/drawing/2014/main" id="{73905BC6-6270-4C51-AC51-A676D02873EE}"/>
               </a:ext>
             </a:extLst>
           </p:cNvPr>
@@ -3287,7 +3287,7 @@
           <p:cNvPr id="5" name="Footer Placeholder 4">
             <a:extLst xmlns:a="http://schemas.openxmlformats.org/drawingml/2006/main">
               <a:ext uri="{FF2B5EF4-FFF2-40B4-BE49-F238E27FC236}">
-                <a16:creationId xmlns:a16="http://schemas.microsoft.com/office/drawing/2014/main" id="{AB8B7EBD-716B-4029-963F-285A5DDE8B00}"/>
+                <a16:creationId xmlns:a16="http://schemas.microsoft.com/office/drawing/2014/main" id="{54270016-0440-4A18-AAE4-04EC40CED869}"/>
               </a:ext>
             </a:extLst>
           </p:cNvPr>
@@ -3310,7 +3310,7 @@
           <p:cNvPr id="6" name="Slide Number Placeholder 5">
             <a:extLst xmlns:a="http://schemas.openxmlformats.org/drawingml/2006/main">
               <a:ext uri="{FF2B5EF4-FFF2-40B4-BE49-F238E27FC236}">
-                <a16:creationId xmlns:a16="http://schemas.microsoft.com/office/drawing/2014/main" id="{6DCEC666-C6C4-4FE9-B007-7B98042EABD4}"/>
+                <a16:creationId xmlns:a16="http://schemas.microsoft.com/office/drawing/2014/main" id="{F224D988-3792-4FC3-AFB4-435F28FC17CB}"/>
               </a:ext>
             </a:extLst>
           </p:cNvPr>
@@ -3354,7 +3354,7 @@
           <p:cNvPr id="2" name="Title 1">
             <a:extLst xmlns:a="http://schemas.openxmlformats.org/drawingml/2006/main">
               <a:ext uri="{FF2B5EF4-FFF2-40B4-BE49-F238E27FC236}">
-                <a16:creationId xmlns:a16="http://schemas.microsoft.com/office/drawing/2014/main" id="{C2A6CAAD-3C8C-412B-A83A-D7248E899DF9}"/>
+                <a16:creationId xmlns:a16="http://schemas.microsoft.com/office/drawing/2014/main" id="{7C70C37A-113E-4478-861B-6C022C934A82}"/>
               </a:ext>
             </a:extLst>
           </p:cNvPr>
@@ -3391,7 +3391,7 @@
           <p:cNvPr id="3" name="Text Placeholder 2">
             <a:extLst xmlns:a="http://schemas.openxmlformats.org/drawingml/2006/main">
               <a:ext uri="{FF2B5EF4-FFF2-40B4-BE49-F238E27FC236}">
-                <a16:creationId xmlns:a16="http://schemas.microsoft.com/office/drawing/2014/main" id="{64C4EE91-145B-48E1-9CE8-225B99A929D9}"/>
+                <a16:creationId xmlns:a16="http://schemas.microsoft.com/office/drawing/2014/main" id="{029024FB-EAF3-428F-99D8-573CA3B883D2}"/>
               </a:ext>
             </a:extLst>
           </p:cNvPr>
@@ -3517,7 +3517,7 @@
           <p:cNvPr id="4" name="Date Placeholder 3">
             <a:extLst xmlns:a="http://schemas.openxmlformats.org/drawingml/2006/main">
               <a:ext uri="{FF2B5EF4-FFF2-40B4-BE49-F238E27FC236}">
-                <a16:creationId xmlns:a16="http://schemas.microsoft.com/office/drawing/2014/main" id="{37DACD32-8B94-4A16-B1C0-9D27BCBC5577}"/>
+                <a16:creationId xmlns:a16="http://schemas.microsoft.com/office/drawing/2014/main" id="{B4784A54-132F-4BAA-ADE7-9A012AB0FC77}"/>
               </a:ext>
             </a:extLst>
           </p:cNvPr>
@@ -3544,7 +3544,7 @@
           <p:cNvPr id="5" name="Footer Placeholder 4">
             <a:extLst xmlns:a="http://schemas.openxmlformats.org/drawingml/2006/main">
               <a:ext uri="{FF2B5EF4-FFF2-40B4-BE49-F238E27FC236}">
-                <a16:creationId xmlns:a16="http://schemas.microsoft.com/office/drawing/2014/main" id="{D779F11F-F402-470D-94C9-8AC10D2E30A9}"/>
+                <a16:creationId xmlns:a16="http://schemas.microsoft.com/office/drawing/2014/main" id="{E7A92AA5-15CB-4453-9380-1BBCDAE2F967}"/>
               </a:ext>
             </a:extLst>
           </p:cNvPr>
@@ -3567,7 +3567,7 @@
           <p:cNvPr id="6" name="Slide Number Placeholder 5">
             <a:extLst xmlns:a="http://schemas.openxmlformats.org/drawingml/2006/main">
               <a:ext uri="{FF2B5EF4-FFF2-40B4-BE49-F238E27FC236}">
-                <a16:creationId xmlns:a16="http://schemas.microsoft.com/office/drawing/2014/main" id="{79F9D546-DA84-44F8-8955-8796D7CABD60}"/>
+                <a16:creationId xmlns:a16="http://schemas.microsoft.com/office/drawing/2014/main" id="{C948D2C8-4A9E-4C34-A100-10773340F2C9}"/>
               </a:ext>
             </a:extLst>
           </p:cNvPr>
@@ -3611,7 +3611,7 @@
           <p:cNvPr id="2" name="Title 1">
             <a:extLst xmlns:a="http://schemas.openxmlformats.org/drawingml/2006/main">
               <a:ext uri="{FF2B5EF4-FFF2-40B4-BE49-F238E27FC236}">
-                <a16:creationId xmlns:a16="http://schemas.microsoft.com/office/drawing/2014/main" id="{8018B09E-F6A1-4E9E-B4CE-4512C59D595F}"/>
+                <a16:creationId xmlns:a16="http://schemas.microsoft.com/office/drawing/2014/main" id="{9EA6BBD2-43A6-448B-A057-94DF852F13EF}"/>
               </a:ext>
             </a:extLst>
           </p:cNvPr>
@@ -3638,7 +3638,7 @@
           <p:cNvPr id="3" name="Content Placeholder 2">
             <a:extLst xmlns:a="http://schemas.openxmlformats.org/drawingml/2006/main">
               <a:ext uri="{FF2B5EF4-FFF2-40B4-BE49-F238E27FC236}">
-                <a16:creationId xmlns:a16="http://schemas.microsoft.com/office/drawing/2014/main" id="{AAA90FAE-06A9-4CDE-9628-BC7A990741B9}"/>
+                <a16:creationId xmlns:a16="http://schemas.microsoft.com/office/drawing/2014/main" id="{B8BAD046-C4F7-4286-BD9E-F4678B331633}"/>
               </a:ext>
             </a:extLst>
           </p:cNvPr>
@@ -3742,7 +3742,7 @@
           <p:cNvPr id="4" name="Content Placeholder 3">
             <a:extLst xmlns:a="http://schemas.openxmlformats.org/drawingml/2006/main">
               <a:ext uri="{FF2B5EF4-FFF2-40B4-BE49-F238E27FC236}">
-                <a16:creationId xmlns:a16="http://schemas.microsoft.com/office/drawing/2014/main" id="{61F6A098-5781-4739-AD0B-46563D0B9F21}"/>
+                <a16:creationId xmlns:a16="http://schemas.microsoft.com/office/drawing/2014/main" id="{F3F3D957-4722-4869-8930-2C210E53DC37}"/>
               </a:ext>
             </a:extLst>
           </p:cNvPr>
@@ -3846,7 +3846,7 @@
           <p:cNvPr id="5" name="Date Placeholder 4">
             <a:extLst xmlns:a="http://schemas.openxmlformats.org/drawingml/2006/main">
               <a:ext uri="{FF2B5EF4-FFF2-40B4-BE49-F238E27FC236}">
-                <a16:creationId xmlns:a16="http://schemas.microsoft.com/office/drawing/2014/main" id="{FDC7A8EE-D37B-4F14-A224-85C0556166E2}"/>
+                <a16:creationId xmlns:a16="http://schemas.microsoft.com/office/drawing/2014/main" id="{174BD042-E1C6-4CD0-A52E-115606AEFDD1}"/>
               </a:ext>
             </a:extLst>
           </p:cNvPr>
@@ -3873,7 +3873,7 @@
           <p:cNvPr id="6" name="Footer Placeholder 5">
             <a:extLst xmlns:a="http://schemas.openxmlformats.org/drawingml/2006/main">
               <a:ext uri="{FF2B5EF4-FFF2-40B4-BE49-F238E27FC236}">
-                <a16:creationId xmlns:a16="http://schemas.microsoft.com/office/drawing/2014/main" id="{0C21F815-FDF6-4301-A7B8-0D4BD3369376}"/>
+                <a16:creationId xmlns:a16="http://schemas.microsoft.com/office/drawing/2014/main" id="{B8F2FB94-44FA-4539-8BE4-4EC66539DA6E}"/>
               </a:ext>
             </a:extLst>
           </p:cNvPr>
@@ -3896,7 +3896,7 @@
           <p:cNvPr id="7" name="Slide Number Placeholder 6">
             <a:extLst xmlns:a="http://schemas.openxmlformats.org/drawingml/2006/main">
               <a:ext uri="{FF2B5EF4-FFF2-40B4-BE49-F238E27FC236}">
-                <a16:creationId xmlns:a16="http://schemas.microsoft.com/office/drawing/2014/main" id="{38AFDFCA-F708-4C0B-8E92-4947617D6C61}"/>
+                <a16:creationId xmlns:a16="http://schemas.microsoft.com/office/drawing/2014/main" id="{9797166E-D51E-4B2C-B722-FD88F7951815}"/>
               </a:ext>
             </a:extLst>
           </p:cNvPr>
@@ -3940,7 +3940,7 @@
           <p:cNvPr id="2" name="Title 1">
             <a:extLst xmlns:a="http://schemas.openxmlformats.org/drawingml/2006/main">
               <a:ext uri="{FF2B5EF4-FFF2-40B4-BE49-F238E27FC236}">
-                <a16:creationId xmlns:a16="http://schemas.microsoft.com/office/drawing/2014/main" id="{1AB61278-1AD1-4008-B826-D2FCBD94D4A7}"/>
+                <a16:creationId xmlns:a16="http://schemas.microsoft.com/office/drawing/2014/main" id="{6B9BA5E1-0E66-430E-9CCD-704FEB0AB8E5}"/>
               </a:ext>
             </a:extLst>
           </p:cNvPr>
@@ -3972,7 +3972,7 @@
           <p:cNvPr id="3" name="Text Placeholder 2">
             <a:extLst xmlns:a="http://schemas.openxmlformats.org/drawingml/2006/main">
               <a:ext uri="{FF2B5EF4-FFF2-40B4-BE49-F238E27FC236}">
-                <a16:creationId xmlns:a16="http://schemas.microsoft.com/office/drawing/2014/main" id="{83B9E49E-E07B-4101-8CA3-C72C8F13EE20}"/>
+                <a16:creationId xmlns:a16="http://schemas.microsoft.com/office/drawing/2014/main" id="{2CAE8D6F-5965-444E-B665-B343993EE8D6}"/>
               </a:ext>
             </a:extLst>
           </p:cNvPr>
@@ -4044,7 +4044,7 @@
           <p:cNvPr id="4" name="Content Placeholder 3">
             <a:extLst xmlns:a="http://schemas.openxmlformats.org/drawingml/2006/main">
               <a:ext uri="{FF2B5EF4-FFF2-40B4-BE49-F238E27FC236}">
-                <a16:creationId xmlns:a16="http://schemas.microsoft.com/office/drawing/2014/main" id="{D81CA610-36BC-462B-AA50-68DE1572CDEE}"/>
+                <a16:creationId xmlns:a16="http://schemas.microsoft.com/office/drawing/2014/main" id="{C49BF9C6-8D66-418B-A74C-E45D962AC523}"/>
               </a:ext>
             </a:extLst>
           </p:cNvPr>
@@ -4148,7 +4148,7 @@
           <p:cNvPr id="5" name="Text Placeholder 4">
             <a:extLst xmlns:a="http://schemas.openxmlformats.org/drawingml/2006/main">
               <a:ext uri="{FF2B5EF4-FFF2-40B4-BE49-F238E27FC236}">
-                <a16:creationId xmlns:a16="http://schemas.microsoft.com/office/drawing/2014/main" id="{8D417C4C-A5F4-4095-A9E6-F63D0D1B9C5C}"/>
+                <a16:creationId xmlns:a16="http://schemas.microsoft.com/office/drawing/2014/main" id="{978AEB07-D4EA-4219-94F1-F5BE92F2E676}"/>
               </a:ext>
             </a:extLst>
           </p:cNvPr>
@@ -4220,7 +4220,7 @@
           <p:cNvPr id="6" name="Content Placeholder 5">
             <a:extLst xmlns:a="http://schemas.openxmlformats.org/drawingml/2006/main">
               <a:ext uri="{FF2B5EF4-FFF2-40B4-BE49-F238E27FC236}">
-                <a16:creationId xmlns:a16="http://schemas.microsoft.com/office/drawing/2014/main" id="{29651AAE-A7EA-4274-884B-2D2CE1C6F5FB}"/>
+                <a16:creationId xmlns:a16="http://schemas.microsoft.com/office/drawing/2014/main" id="{CA1E7A3D-0AFC-4153-BFE4-4C3D11BCF572}"/>
               </a:ext>
             </a:extLst>
           </p:cNvPr>
@@ -4324,7 +4324,7 @@
           <p:cNvPr id="7" name="Date Placeholder 6">
             <a:extLst xmlns:a="http://schemas.openxmlformats.org/drawingml/2006/main">
               <a:ext uri="{FF2B5EF4-FFF2-40B4-BE49-F238E27FC236}">
-                <a16:creationId xmlns:a16="http://schemas.microsoft.com/office/drawing/2014/main" id="{AA292D49-F29C-4175-AB96-F05ED92C7EC7}"/>
+                <a16:creationId xmlns:a16="http://schemas.microsoft.com/office/drawing/2014/main" id="{6383AAEA-26D6-4793-816A-C43A919A3088}"/>
               </a:ext>
             </a:extLst>
           </p:cNvPr>
@@ -4351,7 +4351,7 @@
           <p:cNvPr id="8" name="Footer Placeholder 7">
             <a:extLst xmlns:a="http://schemas.openxmlformats.org/drawingml/2006/main">
               <a:ext uri="{FF2B5EF4-FFF2-40B4-BE49-F238E27FC236}">
-                <a16:creationId xmlns:a16="http://schemas.microsoft.com/office/drawing/2014/main" id="{81C95902-48B3-4E56-AC01-853516DF64B5}"/>
+                <a16:creationId xmlns:a16="http://schemas.microsoft.com/office/drawing/2014/main" id="{6FE6737F-C44E-47D6-AECA-D384ADA5BE62}"/>
               </a:ext>
             </a:extLst>
           </p:cNvPr>
@@ -4374,7 +4374,7 @@
           <p:cNvPr id="9" name="Slide Number Placeholder 8">
             <a:extLst xmlns:a="http://schemas.openxmlformats.org/drawingml/2006/main">
               <a:ext uri="{FF2B5EF4-FFF2-40B4-BE49-F238E27FC236}">
-                <a16:creationId xmlns:a16="http://schemas.microsoft.com/office/drawing/2014/main" id="{64B77271-500A-43B0-AEB6-427B36D92859}"/>
+                <a16:creationId xmlns:a16="http://schemas.microsoft.com/office/drawing/2014/main" id="{679C330B-86CF-479F-B11D-E4713087AA18}"/>
               </a:ext>
             </a:extLst>
           </p:cNvPr>
@@ -4418,7 +4418,7 @@
           <p:cNvPr id="2" name="Title 1">
             <a:extLst xmlns:a="http://schemas.openxmlformats.org/drawingml/2006/main">
               <a:ext uri="{FF2B5EF4-FFF2-40B4-BE49-F238E27FC236}">
-                <a16:creationId xmlns:a16="http://schemas.microsoft.com/office/drawing/2014/main" id="{EB0D13B2-B442-4600-B4E7-AE087E56D815}"/>
+                <a16:creationId xmlns:a16="http://schemas.microsoft.com/office/drawing/2014/main" id="{617EB283-14FE-49CF-B9C3-382299EAD206}"/>
               </a:ext>
             </a:extLst>
           </p:cNvPr>
@@ -4445,7 +4445,7 @@
           <p:cNvPr id="3" name="Date Placeholder 2">
             <a:extLst xmlns:a="http://schemas.openxmlformats.org/drawingml/2006/main">
               <a:ext uri="{FF2B5EF4-FFF2-40B4-BE49-F238E27FC236}">
-                <a16:creationId xmlns:a16="http://schemas.microsoft.com/office/drawing/2014/main" id="{755734FE-A4A2-4791-A6B0-A52B722B4CA7}"/>
+                <a16:creationId xmlns:a16="http://schemas.microsoft.com/office/drawing/2014/main" id="{971F5DAF-344A-4419-9465-0CDF80DBA1B0}"/>
               </a:ext>
             </a:extLst>
           </p:cNvPr>
@@ -4472,7 +4472,7 @@
           <p:cNvPr id="4" name="Footer Placeholder 3">
             <a:extLst xmlns:a="http://schemas.openxmlformats.org/drawingml/2006/main">
               <a:ext uri="{FF2B5EF4-FFF2-40B4-BE49-F238E27FC236}">
-                <a16:creationId xmlns:a16="http://schemas.microsoft.com/office/drawing/2014/main" id="{96E8902B-3E6E-4504-A558-03CA968A51BA}"/>
+                <a16:creationId xmlns:a16="http://schemas.microsoft.com/office/drawing/2014/main" id="{39FDCE2D-AD13-4718-B32D-0C14CB5A9937}"/>
               </a:ext>
             </a:extLst>
           </p:cNvPr>
@@ -4495,7 +4495,7 @@
           <p:cNvPr id="5" name="Slide Number Placeholder 4">
             <a:extLst xmlns:a="http://schemas.openxmlformats.org/drawingml/2006/main">
               <a:ext uri="{FF2B5EF4-FFF2-40B4-BE49-F238E27FC236}">
-                <a16:creationId xmlns:a16="http://schemas.microsoft.com/office/drawing/2014/main" id="{4F46550D-B380-41CD-B109-1374699733D1}"/>
+                <a16:creationId xmlns:a16="http://schemas.microsoft.com/office/drawing/2014/main" id="{AAF7C8FB-7CBF-4F2E-AA77-143D1A6FDFAB}"/>
               </a:ext>
             </a:extLst>
           </p:cNvPr>
@@ -4539,7 +4539,7 @@
           <p:cNvPr id="2" name="Date Placeholder 1">
             <a:extLst xmlns:a="http://schemas.openxmlformats.org/drawingml/2006/main">
               <a:ext uri="{FF2B5EF4-FFF2-40B4-BE49-F238E27FC236}">
-                <a16:creationId xmlns:a16="http://schemas.microsoft.com/office/drawing/2014/main" id="{B2EC543A-7899-4CF4-953C-7652D53BC30D}"/>
+                <a16:creationId xmlns:a16="http://schemas.microsoft.com/office/drawing/2014/main" id="{C88D538D-8F02-49CE-A904-1105D9F508A3}"/>
               </a:ext>
             </a:extLst>
           </p:cNvPr>
@@ -4566,7 +4566,7 @@
           <p:cNvPr id="3" name="Footer Placeholder 2">
             <a:extLst xmlns:a="http://schemas.openxmlformats.org/drawingml/2006/main">
               <a:ext uri="{FF2B5EF4-FFF2-40B4-BE49-F238E27FC236}">
-                <a16:creationId xmlns:a16="http://schemas.microsoft.com/office/drawing/2014/main" id="{7FB35ADF-4FE8-4944-8247-32EE1D748DB5}"/>
+                <a16:creationId xmlns:a16="http://schemas.microsoft.com/office/drawing/2014/main" id="{20788487-46A8-47E7-B013-EAA8E0E1984E}"/>
               </a:ext>
             </a:extLst>
           </p:cNvPr>
@@ -4589,7 +4589,7 @@
           <p:cNvPr id="4" name="Slide Number Placeholder 3">
             <a:extLst xmlns:a="http://schemas.openxmlformats.org/drawingml/2006/main">
               <a:ext uri="{FF2B5EF4-FFF2-40B4-BE49-F238E27FC236}">
-                <a16:creationId xmlns:a16="http://schemas.microsoft.com/office/drawing/2014/main" id="{22B00982-1B6E-442F-BA1A-D0BDD439E460}"/>
+                <a16:creationId xmlns:a16="http://schemas.microsoft.com/office/drawing/2014/main" id="{43AAB4AB-3067-43EB-A029-D8A19003CB37}"/>
               </a:ext>
             </a:extLst>
           </p:cNvPr>
@@ -4633,7 +4633,7 @@
           <p:cNvPr id="2" name="Title 1">
             <a:extLst xmlns:a="http://schemas.openxmlformats.org/drawingml/2006/main">
               <a:ext uri="{FF2B5EF4-FFF2-40B4-BE49-F238E27FC236}">
-                <a16:creationId xmlns:a16="http://schemas.microsoft.com/office/drawing/2014/main" id="{A2A6C3E8-C5EB-429B-ACF4-1C9132DF9F2B}"/>
+                <a16:creationId xmlns:a16="http://schemas.microsoft.com/office/drawing/2014/main" id="{1403FC27-5849-49AD-BD37-E590D56A6C45}"/>
               </a:ext>
             </a:extLst>
           </p:cNvPr>
@@ -4670,7 +4670,7 @@
           <p:cNvPr id="3" name="Content Placeholder 2">
             <a:extLst xmlns:a="http://schemas.openxmlformats.org/drawingml/2006/main">
               <a:ext uri="{FF2B5EF4-FFF2-40B4-BE49-F238E27FC236}">
-                <a16:creationId xmlns:a16="http://schemas.microsoft.com/office/drawing/2014/main" id="{D04772B8-82A0-4110-8038-822FD70FBE3D}"/>
+                <a16:creationId xmlns:a16="http://schemas.microsoft.com/office/drawing/2014/main" id="{35964B7B-34D8-4E30-AD13-335AAABFA326}"/>
               </a:ext>
             </a:extLst>
           </p:cNvPr>
@@ -4774,7 +4774,7 @@
           <p:cNvPr id="4" name="Text Placeholder 3">
             <a:extLst xmlns:a="http://schemas.openxmlformats.org/drawingml/2006/main">
               <a:ext uri="{FF2B5EF4-FFF2-40B4-BE49-F238E27FC236}">
-                <a16:creationId xmlns:a16="http://schemas.microsoft.com/office/drawing/2014/main" id="{E8AF4A4D-8D1E-43AA-9AF9-AD6BAD00A2D5}"/>
+                <a16:creationId xmlns:a16="http://schemas.microsoft.com/office/drawing/2014/main" id="{AFE8C344-AAF9-415C-9106-50AE06A9EC4F}"/>
               </a:ext>
             </a:extLst>
           </p:cNvPr>
@@ -4846,7 +4846,7 @@
           <p:cNvPr id="5" name="Date Placeholder 4">
             <a:extLst xmlns:a="http://schemas.openxmlformats.org/drawingml/2006/main">
               <a:ext uri="{FF2B5EF4-FFF2-40B4-BE49-F238E27FC236}">
-                <a16:creationId xmlns:a16="http://schemas.microsoft.com/office/drawing/2014/main" id="{5444D9EB-2FDF-4BF1-996D-CF16F3FDD6B4}"/>
+                <a16:creationId xmlns:a16="http://schemas.microsoft.com/office/drawing/2014/main" id="{18EBE7C5-9683-41A8-90A4-EFE3AA8D1011}"/>
               </a:ext>
             </a:extLst>
           </p:cNvPr>
@@ -4873,7 +4873,7 @@
           <p:cNvPr id="6" name="Footer Placeholder 5">
             <a:extLst xmlns:a="http://schemas.openxmlformats.org/drawingml/2006/main">
               <a:ext uri="{FF2B5EF4-FFF2-40B4-BE49-F238E27FC236}">
-                <a16:creationId xmlns:a16="http://schemas.microsoft.com/office/drawing/2014/main" id="{63B17912-9466-45EE-BF59-CE5C2804388D}"/>
+                <a16:creationId xmlns:a16="http://schemas.microsoft.com/office/drawing/2014/main" id="{007F7533-68C4-4547-B66C-E9B8DF0E327B}"/>
               </a:ext>
             </a:extLst>
           </p:cNvPr>
@@ -4896,7 +4896,7 @@
           <p:cNvPr id="7" name="Slide Number Placeholder 6">
             <a:extLst xmlns:a="http://schemas.openxmlformats.org/drawingml/2006/main">
               <a:ext uri="{FF2B5EF4-FFF2-40B4-BE49-F238E27FC236}">
-                <a16:creationId xmlns:a16="http://schemas.microsoft.com/office/drawing/2014/main" id="{5CA971E6-70DB-4F5A-872F-025C9C6BE865}"/>
+                <a16:creationId xmlns:a16="http://schemas.microsoft.com/office/drawing/2014/main" id="{3F2286C8-DCC5-4251-AF4B-50B5AAED4908}"/>
               </a:ext>
             </a:extLst>
           </p:cNvPr>
@@ -4940,7 +4940,7 @@
           <p:cNvPr id="2" name="Title 1">
             <a:extLst xmlns:a="http://schemas.openxmlformats.org/drawingml/2006/main">
               <a:ext uri="{FF2B5EF4-FFF2-40B4-BE49-F238E27FC236}">
-                <a16:creationId xmlns:a16="http://schemas.microsoft.com/office/drawing/2014/main" id="{5A825230-A94B-4F59-A71C-6CEF3C60BF07}"/>
+                <a16:creationId xmlns:a16="http://schemas.microsoft.com/office/drawing/2014/main" id="{D9F0FFE5-D0B7-46D0-9ADB-BA4C143DD9F7}"/>
               </a:ext>
             </a:extLst>
           </p:cNvPr>
@@ -4977,7 +4977,7 @@
           <p:cNvPr id="3" name="Picture Placeholder 2">
             <a:extLst xmlns:a="http://schemas.openxmlformats.org/drawingml/2006/main">
               <a:ext uri="{FF2B5EF4-FFF2-40B4-BE49-F238E27FC236}">
-                <a16:creationId xmlns:a16="http://schemas.microsoft.com/office/drawing/2014/main" id="{B0AFABCC-CBF0-4914-B015-912DD7B2D8E7}"/>
+                <a16:creationId xmlns:a16="http://schemas.microsoft.com/office/drawing/2014/main" id="{CACD5425-F6F3-4B80-8F57-465096722C47}"/>
               </a:ext>
             </a:extLst>
           </p:cNvPr>
@@ -5042,7 +5042,7 @@
           <p:cNvPr id="4" name="Text Placeholder 3">
             <a:extLst xmlns:a="http://schemas.openxmlformats.org/drawingml/2006/main">
               <a:ext uri="{FF2B5EF4-FFF2-40B4-BE49-F238E27FC236}">
-                <a16:creationId xmlns:a16="http://schemas.microsoft.com/office/drawing/2014/main" id="{6B5E0EDD-ADB7-4320-9805-E0F8ADDFF2BB}"/>
+                <a16:creationId xmlns:a16="http://schemas.microsoft.com/office/drawing/2014/main" id="{06760891-4FBC-4104-AF3D-EFDAAF37FBCA}"/>
               </a:ext>
             </a:extLst>
           </p:cNvPr>
@@ -5114,7 +5114,7 @@
           <p:cNvPr id="5" name="Date Placeholder 4">
             <a:extLst xmlns:a="http://schemas.openxmlformats.org/drawingml/2006/main">
               <a:ext uri="{FF2B5EF4-FFF2-40B4-BE49-F238E27FC236}">
-                <a16:creationId xmlns:a16="http://schemas.microsoft.com/office/drawing/2014/main" id="{DE7F61AC-0B0C-4367-9B2A-56315A0754EA}"/>
+                <a16:creationId xmlns:a16="http://schemas.microsoft.com/office/drawing/2014/main" id="{C1716BC2-9F89-4096-87D8-652A0E1A1A9A}"/>
               </a:ext>
             </a:extLst>
           </p:cNvPr>
@@ -5141,7 +5141,7 @@
           <p:cNvPr id="6" name="Footer Placeholder 5">
             <a:extLst xmlns:a="http://schemas.openxmlformats.org/drawingml/2006/main">
               <a:ext uri="{FF2B5EF4-FFF2-40B4-BE49-F238E27FC236}">
-                <a16:creationId xmlns:a16="http://schemas.microsoft.com/office/drawing/2014/main" id="{1CBFDCF0-1971-49AD-966B-817B9CFB6327}"/>
+                <a16:creationId xmlns:a16="http://schemas.microsoft.com/office/drawing/2014/main" id="{859DBE2F-E295-439B-9610-717C1190B1B1}"/>
               </a:ext>
             </a:extLst>
           </p:cNvPr>
@@ -5164,7 +5164,7 @@
           <p:cNvPr id="7" name="Slide Number Placeholder 6">
             <a:extLst xmlns:a="http://schemas.openxmlformats.org/drawingml/2006/main">
               <a:ext uri="{FF2B5EF4-FFF2-40B4-BE49-F238E27FC236}">
-                <a16:creationId xmlns:a16="http://schemas.microsoft.com/office/drawing/2014/main" id="{693D7C15-D71F-4FE8-BAA1-E2C025B1696E}"/>
+                <a16:creationId xmlns:a16="http://schemas.microsoft.com/office/drawing/2014/main" id="{099E4239-91CF-4BCF-AC3C-723CA6038650}"/>
               </a:ext>
             </a:extLst>
           </p:cNvPr>
@@ -5213,7 +5213,7 @@
           <p:cNvPr id="2" name="Title Placeholder 1">
             <a:extLst xmlns:a="http://schemas.openxmlformats.org/drawingml/2006/main">
               <a:ext uri="{FF2B5EF4-FFF2-40B4-BE49-F238E27FC236}">
-                <a16:creationId xmlns:a16="http://schemas.microsoft.com/office/drawing/2014/main" id="{2533FD76-40B2-48DE-98EC-F923AEE61A2A}"/>
+                <a16:creationId xmlns:a16="http://schemas.microsoft.com/office/drawing/2014/main" id="{B2378F9C-5DE4-47C7-AA10-5EADBAA3D026}"/>
               </a:ext>
             </a:extLst>
           </p:cNvPr>
@@ -5250,7 +5250,7 @@
           <p:cNvPr id="3" name="Text Placeholder 2">
             <a:extLst xmlns:a="http://schemas.openxmlformats.org/drawingml/2006/main">
               <a:ext uri="{FF2B5EF4-FFF2-40B4-BE49-F238E27FC236}">
-                <a16:creationId xmlns:a16="http://schemas.microsoft.com/office/drawing/2014/main" id="{17DA4F07-D25D-4AA8-9481-A0ACB31923CC}"/>
+                <a16:creationId xmlns:a16="http://schemas.microsoft.com/office/drawing/2014/main" id="{30708D96-FDE4-4ACE-B1C1-7CB896C5BB93}"/>
               </a:ext>
             </a:extLst>
           </p:cNvPr>
@@ -5322,7 +5322,7 @@
           <p:cNvPr id="4" name="Date Placeholder 3">
             <a:extLst xmlns:a="http://schemas.openxmlformats.org/drawingml/2006/main">
               <a:ext uri="{FF2B5EF4-FFF2-40B4-BE49-F238E27FC236}">
-                <a16:creationId xmlns:a16="http://schemas.microsoft.com/office/drawing/2014/main" id="{BF69093B-2894-49BD-BC77-111048F7EE2F}"/>
+                <a16:creationId xmlns:a16="http://schemas.microsoft.com/office/drawing/2014/main" id="{55C08E49-67E6-471D-BF64-2B0C9FBE4D83}"/>
               </a:ext>
             </a:extLst>
           </p:cNvPr>
@@ -5368,7 +5368,7 @@
           <p:cNvPr id="5" name="Footer Placeholder 4">
             <a:extLst xmlns:a="http://schemas.openxmlformats.org/drawingml/2006/main">
               <a:ext uri="{FF2B5EF4-FFF2-40B4-BE49-F238E27FC236}">
-                <a16:creationId xmlns:a16="http://schemas.microsoft.com/office/drawing/2014/main" id="{A564FA4C-9B8E-4F8E-AC58-9B83F9203499}"/>
+                <a16:creationId xmlns:a16="http://schemas.microsoft.com/office/drawing/2014/main" id="{3D3FD9DC-B4BC-4F05-8ABE-62ABB23B0EB5}"/>
               </a:ext>
             </a:extLst>
           </p:cNvPr>
@@ -5410,7 +5410,7 @@
           <p:cNvPr id="6" name="Slide Number Placeholder 5">
             <a:extLst xmlns:a="http://schemas.openxmlformats.org/drawingml/2006/main">
               <a:ext uri="{FF2B5EF4-FFF2-40B4-BE49-F238E27FC236}">
-                <a16:creationId xmlns:a16="http://schemas.microsoft.com/office/drawing/2014/main" id="{32EEB6E8-CD94-45F6-8CCA-096954F90977}"/>
+                <a16:creationId xmlns:a16="http://schemas.microsoft.com/office/drawing/2014/main" id="{52D2F26B-CEB1-4A59-8D9D-0848C7AB5A7F}"/>
               </a:ext>
             </a:extLst>
           </p:cNvPr>
@@ -5455,17 +5455,17 @@
   </p:cSld>
   <p:clrMap bg1="lt1" tx1="dk1" bg2="lt2" tx2="dk2" accent1="accent1" accent2="accent2" accent3="accent3" accent4="accent4" accent5="accent5" accent6="accent6" hlink="hlink" folHlink="folHlink"/>
   <p:sldLayoutIdLst>
-    <p:sldLayoutId xmlns:r="http://schemas.openxmlformats.org/officeDocument/2006/relationships" id="2147483649" r:id="R81a9e77a20944906"/>
-    <p:sldLayoutId xmlns:r="http://schemas.openxmlformats.org/officeDocument/2006/relationships" id="2147483650" r:id="Rba0146680ebf4aff"/>
-    <p:sldLayoutId xmlns:r="http://schemas.openxmlformats.org/officeDocument/2006/relationships" id="2147483651" r:id="R0e6cc09eca7b4837"/>
-    <p:sldLayoutId xmlns:r="http://schemas.openxmlformats.org/officeDocument/2006/relationships" id="2147483652" r:id="R31f34ca51b0148c5"/>
-    <p:sldLayoutId xmlns:r="http://schemas.openxmlformats.org/officeDocument/2006/relationships" id="2147483653" r:id="R15240216081946f0"/>
-    <p:sldLayoutId xmlns:r="http://schemas.openxmlformats.org/officeDocument/2006/relationships" id="2147483654" r:id="R965693c872f648d3"/>
-    <p:sldLayoutId xmlns:r="http://schemas.openxmlformats.org/officeDocument/2006/relationships" id="2147483655" r:id="R633aa97895434760"/>
-    <p:sldLayoutId xmlns:r="http://schemas.openxmlformats.org/officeDocument/2006/relationships" id="2147483656" r:id="Re010475ec9d641f8"/>
-    <p:sldLayoutId xmlns:r="http://schemas.openxmlformats.org/officeDocument/2006/relationships" id="2147483657" r:id="R81c6e35e28074cb0"/>
-    <p:sldLayoutId xmlns:r="http://schemas.openxmlformats.org/officeDocument/2006/relationships" id="2147483658" r:id="Rf26d059145e3479b"/>
-    <p:sldLayoutId xmlns:r="http://schemas.openxmlformats.org/officeDocument/2006/relationships" id="2147483659" r:id="Rbcb97eb59bcd4e5a"/>
+    <p:sldLayoutId xmlns:r="http://schemas.openxmlformats.org/officeDocument/2006/relationships" id="2147483649" r:id="R9c2041b055bf4bf9"/>
+    <p:sldLayoutId xmlns:r="http://schemas.openxmlformats.org/officeDocument/2006/relationships" id="2147483650" r:id="R7762f4e8ba84402d"/>
+    <p:sldLayoutId xmlns:r="http://schemas.openxmlformats.org/officeDocument/2006/relationships" id="2147483651" r:id="R2d55390f407b4ec5"/>
+    <p:sldLayoutId xmlns:r="http://schemas.openxmlformats.org/officeDocument/2006/relationships" id="2147483652" r:id="Ref003b474c40494d"/>
+    <p:sldLayoutId xmlns:r="http://schemas.openxmlformats.org/officeDocument/2006/relationships" id="2147483653" r:id="R02d0080b4e3a44da"/>
+    <p:sldLayoutId xmlns:r="http://schemas.openxmlformats.org/officeDocument/2006/relationships" id="2147483654" r:id="R7682c04accc74ed3"/>
+    <p:sldLayoutId xmlns:r="http://schemas.openxmlformats.org/officeDocument/2006/relationships" id="2147483655" r:id="R45fa51f2dbc247ad"/>
+    <p:sldLayoutId xmlns:r="http://schemas.openxmlformats.org/officeDocument/2006/relationships" id="2147483656" r:id="R11240eba189e476c"/>
+    <p:sldLayoutId xmlns:r="http://schemas.openxmlformats.org/officeDocument/2006/relationships" id="2147483657" r:id="R5eb33d82e1d64afa"/>
+    <p:sldLayoutId xmlns:r="http://schemas.openxmlformats.org/officeDocument/2006/relationships" id="2147483658" r:id="R2d195a1861e24e12"/>
+    <p:sldLayoutId xmlns:r="http://schemas.openxmlformats.org/officeDocument/2006/relationships" id="2147483659" r:id="R2f5a25d831e04374"/>
   </p:sldLayoutIdLst>
   <p:txStyles>
     <p:titleStyle>
@@ -6018,7 +6018,7 @@
           <p:cNvPr id="2" name="Rectangle 1">
             <a:extLst xmlns:a="http://schemas.openxmlformats.org/drawingml/2006/main">
               <a:ext uri="{FF2B5EF4-FFF2-40B4-BE49-F238E27FC236}">
-                <a16:creationId xmlns:a16="http://schemas.microsoft.com/office/drawing/2014/main" id="{DD954622-B252-4BB6-9886-4862C11F4918}"/>
+                <a16:creationId xmlns:a16="http://schemas.microsoft.com/office/drawing/2014/main" id="{9E2B5B22-D2D3-4E82-87B7-5695F50283DF}"/>
               </a:ext>
             </a:extLst>
           </p:cNvPr>
@@ -6073,7 +6073,7 @@
           <p:cNvPr id="3" name="TextBox 2">
             <a:extLst xmlns:a="http://schemas.openxmlformats.org/drawingml/2006/main">
               <a:ext uri="{FF2B5EF4-FFF2-40B4-BE49-F238E27FC236}">
-                <a16:creationId xmlns:a16="http://schemas.microsoft.com/office/drawing/2014/main" id="{5D4FDF2D-12BC-41D4-A640-52547C9C4E06}"/>
+                <a16:creationId xmlns:a16="http://schemas.microsoft.com/office/drawing/2014/main" id="{FD4F55F9-F735-46AC-AC6C-8DEA1559C741}"/>
               </a:ext>
             </a:extLst>
           </p:cNvPr>
@@ -6120,7 +6120,7 @@
           <p:cNvPr id="4" name="TextBox 3">
             <a:extLst xmlns:a="http://schemas.openxmlformats.org/drawingml/2006/main">
               <a:ext uri="{FF2B5EF4-FFF2-40B4-BE49-F238E27FC236}">
-                <a16:creationId xmlns:a16="http://schemas.microsoft.com/office/drawing/2014/main" id="{792C2E5B-4A03-44EA-BA40-33FF8B9D56D3}"/>
+                <a16:creationId xmlns:a16="http://schemas.microsoft.com/office/drawing/2014/main" id="{B5C20824-512E-4E3F-9099-2C91F5E4D418}"/>
               </a:ext>
             </a:extLst>
           </p:cNvPr>
@@ -6188,7 +6188,7 @@
           <p:cNvPr id="5" name="TextBox 4">
             <a:extLst xmlns:a="http://schemas.openxmlformats.org/drawingml/2006/main">
               <a:ext uri="{FF2B5EF4-FFF2-40B4-BE49-F238E27FC236}">
-                <a16:creationId xmlns:a16="http://schemas.microsoft.com/office/drawing/2014/main" id="{C75286D3-3980-42E7-8CE4-5A705207FF8B}"/>
+                <a16:creationId xmlns:a16="http://schemas.microsoft.com/office/drawing/2014/main" id="{DA0AF32A-72B8-44C6-803C-2F01A879B27F}"/>
               </a:ext>
             </a:extLst>
           </p:cNvPr>
@@ -6235,7 +6235,7 @@
           <p:cNvPr id="6" name="Rectangle 5">
             <a:extLst xmlns:a="http://schemas.openxmlformats.org/drawingml/2006/main">
               <a:ext uri="{FF2B5EF4-FFF2-40B4-BE49-F238E27FC236}">
-                <a16:creationId xmlns:a16="http://schemas.microsoft.com/office/drawing/2014/main" id="{7C2874BB-028E-4BFF-B725-72D1F43974A0}"/>
+                <a16:creationId xmlns:a16="http://schemas.microsoft.com/office/drawing/2014/main" id="{A50C0CE6-E0A9-4BD4-BF35-064EAC559991}"/>
               </a:ext>
             </a:extLst>
           </p:cNvPr>
@@ -6290,7 +6290,7 @@
           <p:cNvPr id="7" name="TextBox 6">
             <a:extLst xmlns:a="http://schemas.openxmlformats.org/drawingml/2006/main">
               <a:ext uri="{FF2B5EF4-FFF2-40B4-BE49-F238E27FC236}">
-                <a16:creationId xmlns:a16="http://schemas.microsoft.com/office/drawing/2014/main" id="{12D623E3-273C-4C66-9547-83DD023D1E67}"/>
+                <a16:creationId xmlns:a16="http://schemas.microsoft.com/office/drawing/2014/main" id="{9A23C6E0-F272-46FA-A221-C8F907B6BC8D}"/>
               </a:ext>
             </a:extLst>
           </p:cNvPr>
@@ -6337,7 +6337,7 @@
           <p:cNvPr id="8" name="TextBox 7">
             <a:extLst xmlns:a="http://schemas.openxmlformats.org/drawingml/2006/main">
               <a:ext uri="{FF2B5EF4-FFF2-40B4-BE49-F238E27FC236}">
-                <a16:creationId xmlns:a16="http://schemas.microsoft.com/office/drawing/2014/main" id="{B830A4CD-4C82-4CF3-A914-F4C4AFD8AFCB}"/>
+                <a16:creationId xmlns:a16="http://schemas.microsoft.com/office/drawing/2014/main" id="{0B246F5F-495B-489F-9040-71A1FA5414AB}"/>
               </a:ext>
             </a:extLst>
           </p:cNvPr>
@@ -6374,7 +6374,7 @@
                 <a:ea typeface="Aptos"/>
                 <a:cs typeface="Aptos"/>
               </a:rPr>
-              <a:t>2026.07.22-9</a:t>
+              <a:t>2026.07.23-10</a:t>
             </a:r>
           </a:p>
         </p:txBody>
@@ -6384,7 +6384,7 @@
           <p:cNvPr id="9" name="TextBox 8">
             <a:extLst xmlns:a="http://schemas.openxmlformats.org/drawingml/2006/main">
               <a:ext uri="{FF2B5EF4-FFF2-40B4-BE49-F238E27FC236}">
-                <a16:creationId xmlns:a16="http://schemas.microsoft.com/office/drawing/2014/main" id="{583B0AD9-62B5-4E9A-B59C-B3DF1665A79B}"/>
+                <a16:creationId xmlns:a16="http://schemas.microsoft.com/office/drawing/2014/main" id="{2163055A-5966-438D-AD7A-F63AFEB5095A}"/>
               </a:ext>
             </a:extLst>
           </p:cNvPr>
@@ -6452,7 +6452,7 @@
           <p:cNvPr id="10" name="TextBox 9">
             <a:extLst xmlns:a="http://schemas.openxmlformats.org/drawingml/2006/main">
               <a:ext uri="{FF2B5EF4-FFF2-40B4-BE49-F238E27FC236}">
-                <a16:creationId xmlns:a16="http://schemas.microsoft.com/office/drawing/2014/main" id="{6DDC634D-1984-4241-B506-3B4DD7DA4F4E}"/>
+                <a16:creationId xmlns:a16="http://schemas.microsoft.com/office/drawing/2014/main" id="{900FCFE4-5286-4C8A-86C6-8FB7345B3D0D}"/>
               </a:ext>
             </a:extLst>
           </p:cNvPr>
@@ -6499,7 +6499,7 @@
           <p:cNvPr id="11" name="TextBox 10">
             <a:extLst xmlns:a="http://schemas.openxmlformats.org/drawingml/2006/main">
               <a:ext uri="{FF2B5EF4-FFF2-40B4-BE49-F238E27FC236}">
-                <a16:creationId xmlns:a16="http://schemas.microsoft.com/office/drawing/2014/main" id="{4BD4CBCF-ACD6-47E6-AD4C-F62FFAE120A5}"/>
+                <a16:creationId xmlns:a16="http://schemas.microsoft.com/office/drawing/2014/main" id="{E4C64B53-B84C-45F3-9D6E-1400D98379AE}"/>
               </a:ext>
             </a:extLst>
           </p:cNvPr>
@@ -6546,7 +6546,7 @@
           <p:cNvPr id="12" name="TextBox 11">
             <a:extLst xmlns:a="http://schemas.openxmlformats.org/drawingml/2006/main">
               <a:ext uri="{FF2B5EF4-FFF2-40B4-BE49-F238E27FC236}">
-                <a16:creationId xmlns:a16="http://schemas.microsoft.com/office/drawing/2014/main" id="{D6DA264B-2DC6-4EF5-BFD6-DF2BF6D90D34}"/>
+                <a16:creationId xmlns:a16="http://schemas.microsoft.com/office/drawing/2014/main" id="{D617E42B-B813-4CB0-8A67-8DE55FF000B9}"/>
               </a:ext>
             </a:extLst>
           </p:cNvPr>
@@ -6591,7 +6591,7 @@
     </p:spTree>
     <p:extLst>
       <p:ext uri="{BB962C8B-B14F-4D97-AF65-F5344CB8AC3E}">
-        <p14:creationId xmlns:p14="http://schemas.microsoft.com/office/powerpoint/2010/main" val="740424126"/>
+        <p14:creationId xmlns:p14="http://schemas.microsoft.com/office/powerpoint/2010/main" val="321935706"/>
       </p:ext>
     </p:extLst>
   </p:cSld>
@@ -6615,7 +6615,7 @@
           <p:cNvPr id="2" name="TextBox 1">
             <a:extLst xmlns:a="http://schemas.openxmlformats.org/drawingml/2006/main">
               <a:ext uri="{FF2B5EF4-FFF2-40B4-BE49-F238E27FC236}">
-                <a16:creationId xmlns:a16="http://schemas.microsoft.com/office/drawing/2014/main" id="{D268E322-EDD7-4B18-9AEA-77ABB93B604C}"/>
+                <a16:creationId xmlns:a16="http://schemas.microsoft.com/office/drawing/2014/main" id="{016CB0BF-1804-4583-A352-E14493D099B8}"/>
               </a:ext>
             </a:extLst>
           </p:cNvPr>
@@ -6662,7 +6662,7 @@
           <p:cNvPr id="3" name="TextBox 2">
             <a:extLst xmlns:a="http://schemas.openxmlformats.org/drawingml/2006/main">
               <a:ext uri="{FF2B5EF4-FFF2-40B4-BE49-F238E27FC236}">
-                <a16:creationId xmlns:a16="http://schemas.microsoft.com/office/drawing/2014/main" id="{3265EDCF-C001-4662-9C33-EF329B166CEF}"/>
+                <a16:creationId xmlns:a16="http://schemas.microsoft.com/office/drawing/2014/main" id="{3D149D78-E08E-48BB-8146-D628B0943E97}"/>
               </a:ext>
             </a:extLst>
           </p:cNvPr>
@@ -6709,7 +6709,7 @@
           <p:cNvPr id="4" name="Rectangle 3">
             <a:extLst xmlns:a="http://schemas.openxmlformats.org/drawingml/2006/main">
               <a:ext uri="{FF2B5EF4-FFF2-40B4-BE49-F238E27FC236}">
-                <a16:creationId xmlns:a16="http://schemas.microsoft.com/office/drawing/2014/main" id="{039BC21F-7DD1-4F28-A336-CC1F0BBB7F16}"/>
+                <a16:creationId xmlns:a16="http://schemas.microsoft.com/office/drawing/2014/main" id="{446BD7A7-F55B-4227-84AE-0F498A589876}"/>
               </a:ext>
             </a:extLst>
           </p:cNvPr>
@@ -6764,7 +6764,7 @@
           <p:cNvPr id="5" name="Rectangle 4">
             <a:extLst xmlns:a="http://schemas.openxmlformats.org/drawingml/2006/main">
               <a:ext uri="{FF2B5EF4-FFF2-40B4-BE49-F238E27FC236}">
-                <a16:creationId xmlns:a16="http://schemas.microsoft.com/office/drawing/2014/main" id="{24A40B15-2E87-43CD-BD70-026406062D3E}"/>
+                <a16:creationId xmlns:a16="http://schemas.microsoft.com/office/drawing/2014/main" id="{6F224D52-DA09-4E6D-9AA8-65EEF62B565A}"/>
               </a:ext>
             </a:extLst>
           </p:cNvPr>
@@ -6819,7 +6819,7 @@
           <p:cNvPr id="6" name="TextBox 5">
             <a:extLst xmlns:a="http://schemas.openxmlformats.org/drawingml/2006/main">
               <a:ext uri="{FF2B5EF4-FFF2-40B4-BE49-F238E27FC236}">
-                <a16:creationId xmlns:a16="http://schemas.microsoft.com/office/drawing/2014/main" id="{0A1141D7-3E13-43F4-B6DB-EC2E58B84785}"/>
+                <a16:creationId xmlns:a16="http://schemas.microsoft.com/office/drawing/2014/main" id="{714ED097-94A9-4A17-A03F-E642611606E5}"/>
               </a:ext>
             </a:extLst>
           </p:cNvPr>
@@ -6856,7 +6856,7 @@
                 <a:ea typeface="Aptos"/>
                 <a:cs typeface="Aptos"/>
               </a:rPr>
-              <a:t>Independent public evidence summary · 2026.07.22-9 · 2026-07-22 · Sources: RPX; CNIPA guidance; EPO family</a:t>
+              <a:t>Independent public evidence summary · 2026.07.23-10 · 2026-07-22 · Sources: RPX; CNIPA guidance; EPO family</a:t>
             </a:r>
           </a:p>
         </p:txBody>
@@ -6866,7 +6866,7 @@
           <p:cNvPr id="7" name="TextBox 6">
             <a:extLst xmlns:a="http://schemas.openxmlformats.org/drawingml/2006/main">
               <a:ext uri="{FF2B5EF4-FFF2-40B4-BE49-F238E27FC236}">
-                <a16:creationId xmlns:a16="http://schemas.microsoft.com/office/drawing/2014/main" id="{6326962D-FBED-4D6F-A996-5973E274A00E}"/>
+                <a16:creationId xmlns:a16="http://schemas.microsoft.com/office/drawing/2014/main" id="{A4EF41D1-F973-4FDF-BF0F-E87516BBCC7D}"/>
               </a:ext>
             </a:extLst>
           </p:cNvPr>
@@ -6913,7 +6913,7 @@
           <p:cNvPr id="8" name="TextBox 7">
             <a:extLst xmlns:a="http://schemas.openxmlformats.org/drawingml/2006/main">
               <a:ext uri="{FF2B5EF4-FFF2-40B4-BE49-F238E27FC236}">
-                <a16:creationId xmlns:a16="http://schemas.microsoft.com/office/drawing/2014/main" id="{ACD0CBEA-0DDC-41D1-9A14-14CB66082468}"/>
+                <a16:creationId xmlns:a16="http://schemas.microsoft.com/office/drawing/2014/main" id="{E118C154-0A7A-4E73-B795-89A8A079EEE2}"/>
               </a:ext>
             </a:extLst>
           </p:cNvPr>
@@ -6960,7 +6960,7 @@
           <p:cNvPr id="9" name="TextBox 8">
             <a:extLst xmlns:a="http://schemas.openxmlformats.org/drawingml/2006/main">
               <a:ext uri="{FF2B5EF4-FFF2-40B4-BE49-F238E27FC236}">
-                <a16:creationId xmlns:a16="http://schemas.microsoft.com/office/drawing/2014/main" id="{6C0F58FB-2CA0-49EE-AA2E-691F7847C05F}"/>
+                <a16:creationId xmlns:a16="http://schemas.microsoft.com/office/drawing/2014/main" id="{15799F9A-72F7-46A8-B0F6-4773C423605A}"/>
               </a:ext>
             </a:extLst>
           </p:cNvPr>
@@ -7057,7 +7057,7 @@
           <p:cNvPr id="10" name="Rounded Rectangle 9">
             <a:extLst xmlns:a="http://schemas.openxmlformats.org/drawingml/2006/main">
               <a:ext uri="{FF2B5EF4-FFF2-40B4-BE49-F238E27FC236}">
-                <a16:creationId xmlns:a16="http://schemas.microsoft.com/office/drawing/2014/main" id="{E8AEEFEC-61EF-4F64-BC01-3A754B9AC943}"/>
+                <a16:creationId xmlns:a16="http://schemas.microsoft.com/office/drawing/2014/main" id="{F69ABE7E-D7E0-4FF6-AEB4-450AAE63316A}"/>
               </a:ext>
             </a:extLst>
           </p:cNvPr>
@@ -7114,7 +7114,7 @@
           <p:cNvPr id="11" name="TextBox 10">
             <a:extLst xmlns:a="http://schemas.openxmlformats.org/drawingml/2006/main">
               <a:ext uri="{FF2B5EF4-FFF2-40B4-BE49-F238E27FC236}">
-                <a16:creationId xmlns:a16="http://schemas.microsoft.com/office/drawing/2014/main" id="{9E551C28-2294-49AD-842D-184107772AB5}"/>
+                <a16:creationId xmlns:a16="http://schemas.microsoft.com/office/drawing/2014/main" id="{963DF681-B4C9-407D-B3FB-56C19A97D68A}"/>
               </a:ext>
             </a:extLst>
           </p:cNvPr>
@@ -7161,7 +7161,7 @@
           <p:cNvPr id="12" name="TextBox 11">
             <a:extLst xmlns:a="http://schemas.openxmlformats.org/drawingml/2006/main">
               <a:ext uri="{FF2B5EF4-FFF2-40B4-BE49-F238E27FC236}">
-                <a16:creationId xmlns:a16="http://schemas.microsoft.com/office/drawing/2014/main" id="{262C9C30-379F-4B90-B6B6-1892A4AA693E}"/>
+                <a16:creationId xmlns:a16="http://schemas.microsoft.com/office/drawing/2014/main" id="{D556769B-98C6-4568-AFA0-B10F2440902A}"/>
               </a:ext>
             </a:extLst>
           </p:cNvPr>
@@ -7206,7 +7206,7 @@
     </p:spTree>
     <p:extLst>
       <p:ext uri="{BB962C8B-B14F-4D97-AF65-F5344CB8AC3E}">
-        <p14:creationId xmlns:p14="http://schemas.microsoft.com/office/powerpoint/2010/main" val="2007796088"/>
+        <p14:creationId xmlns:p14="http://schemas.microsoft.com/office/powerpoint/2010/main" val="2146159874"/>
       </p:ext>
     </p:extLst>
   </p:cSld>
@@ -7230,7 +7230,7 @@
           <p:cNvPr id="2" name="TextBox 1">
             <a:extLst xmlns:a="http://schemas.openxmlformats.org/drawingml/2006/main">
               <a:ext uri="{FF2B5EF4-FFF2-40B4-BE49-F238E27FC236}">
-                <a16:creationId xmlns:a16="http://schemas.microsoft.com/office/drawing/2014/main" id="{B6AF9ACC-9A10-488D-8332-C6C0D934CC62}"/>
+                <a16:creationId xmlns:a16="http://schemas.microsoft.com/office/drawing/2014/main" id="{C0BAFD7D-1DF4-4F6D-BCFA-6E5507F4B58E}"/>
               </a:ext>
             </a:extLst>
           </p:cNvPr>
@@ -7277,7 +7277,7 @@
           <p:cNvPr id="3" name="TextBox 2">
             <a:extLst xmlns:a="http://schemas.openxmlformats.org/drawingml/2006/main">
               <a:ext uri="{FF2B5EF4-FFF2-40B4-BE49-F238E27FC236}">
-                <a16:creationId xmlns:a16="http://schemas.microsoft.com/office/drawing/2014/main" id="{90BFEDF8-C461-47BE-BC5D-CF4F1AE631A2}"/>
+                <a16:creationId xmlns:a16="http://schemas.microsoft.com/office/drawing/2014/main" id="{86CADCE5-E55E-4AC4-AE22-16512253DE75}"/>
               </a:ext>
             </a:extLst>
           </p:cNvPr>
@@ -7324,7 +7324,7 @@
           <p:cNvPr id="4" name="Rectangle 3">
             <a:extLst xmlns:a="http://schemas.openxmlformats.org/drawingml/2006/main">
               <a:ext uri="{FF2B5EF4-FFF2-40B4-BE49-F238E27FC236}">
-                <a16:creationId xmlns:a16="http://schemas.microsoft.com/office/drawing/2014/main" id="{A7A5D4EB-80E0-4991-AAFB-6242914E08DE}"/>
+                <a16:creationId xmlns:a16="http://schemas.microsoft.com/office/drawing/2014/main" id="{4EC112B1-D206-488F-A6E0-9F5DE091D30C}"/>
               </a:ext>
             </a:extLst>
           </p:cNvPr>
@@ -7379,7 +7379,7 @@
           <p:cNvPr id="5" name="Rectangle 4">
             <a:extLst xmlns:a="http://schemas.openxmlformats.org/drawingml/2006/main">
               <a:ext uri="{FF2B5EF4-FFF2-40B4-BE49-F238E27FC236}">
-                <a16:creationId xmlns:a16="http://schemas.microsoft.com/office/drawing/2014/main" id="{8FE3D0F6-1CD9-417F-AE6C-EADEA96F28C5}"/>
+                <a16:creationId xmlns:a16="http://schemas.microsoft.com/office/drawing/2014/main" id="{78F2E461-8B92-46CC-9ACC-E74FEA5862B5}"/>
               </a:ext>
             </a:extLst>
           </p:cNvPr>
@@ -7434,7 +7434,7 @@
           <p:cNvPr id="6" name="TextBox 5">
             <a:extLst xmlns:a="http://schemas.openxmlformats.org/drawingml/2006/main">
               <a:ext uri="{FF2B5EF4-FFF2-40B4-BE49-F238E27FC236}">
-                <a16:creationId xmlns:a16="http://schemas.microsoft.com/office/drawing/2014/main" id="{B04B292D-9C96-4D89-A6F9-183D4A72DD72}"/>
+                <a16:creationId xmlns:a16="http://schemas.microsoft.com/office/drawing/2014/main" id="{4DE3B5DB-8A1B-4BC2-8EAE-41D11C7F1284}"/>
               </a:ext>
             </a:extLst>
           </p:cNvPr>
@@ -7471,7 +7471,7 @@
                 <a:ea typeface="Aptos"/>
                 <a:cs typeface="Aptos"/>
               </a:rPr>
-              <a:t>Independent public evidence summary · 2026.07.22-9 · 2026-07-22 · Sources: IP Australia; PRH; EPO; EPO / UPC; USPTO</a:t>
+              <a:t>Independent public evidence summary · 2026.07.23-10 · 2026-07-22 · Sources: IP Australia; PRH; EPO; EPO / UPC; USPTO</a:t>
             </a:r>
           </a:p>
         </p:txBody>
@@ -7481,7 +7481,7 @@
           <p:cNvPr id="7" name="TextBox 6">
             <a:extLst xmlns:a="http://schemas.openxmlformats.org/drawingml/2006/main">
               <a:ext uri="{FF2B5EF4-FFF2-40B4-BE49-F238E27FC236}">
-                <a16:creationId xmlns:a16="http://schemas.microsoft.com/office/drawing/2014/main" id="{B0F0E5FA-069C-4BDF-AAB8-8C6817FA5FEB}"/>
+                <a16:creationId xmlns:a16="http://schemas.microsoft.com/office/drawing/2014/main" id="{0F2CB7C4-B5F6-47B3-91C5-51BC92B8352A}"/>
               </a:ext>
             </a:extLst>
           </p:cNvPr>
@@ -7968,7 +7968,7 @@
           <p:cNvPr id="9" name="TextBox 8">
             <a:extLst xmlns:a="http://schemas.openxmlformats.org/drawingml/2006/main">
               <a:ext uri="{FF2B5EF4-FFF2-40B4-BE49-F238E27FC236}">
-                <a16:creationId xmlns:a16="http://schemas.microsoft.com/office/drawing/2014/main" id="{01F8A7B3-4815-4C6E-AE6A-D26A0228EDFF}"/>
+                <a16:creationId xmlns:a16="http://schemas.microsoft.com/office/drawing/2014/main" id="{2B734C01-0BCE-460B-A160-62949DC64C53}"/>
               </a:ext>
             </a:extLst>
           </p:cNvPr>
@@ -8013,7 +8013,7 @@
     </p:spTree>
     <p:extLst>
       <p:ext uri="{BB962C8B-B14F-4D97-AF65-F5344CB8AC3E}">
-        <p14:creationId xmlns:p14="http://schemas.microsoft.com/office/powerpoint/2010/main" val="1771571262"/>
+        <p14:creationId xmlns:p14="http://schemas.microsoft.com/office/powerpoint/2010/main" val="1554783275"/>
       </p:ext>
     </p:extLst>
   </p:cSld>
@@ -8037,7 +8037,7 @@
           <p:cNvPr id="2" name="TextBox 1">
             <a:extLst xmlns:a="http://schemas.openxmlformats.org/drawingml/2006/main">
               <a:ext uri="{FF2B5EF4-FFF2-40B4-BE49-F238E27FC236}">
-                <a16:creationId xmlns:a16="http://schemas.microsoft.com/office/drawing/2014/main" id="{1B848FBE-732B-4C9F-A0E1-5EE818656414}"/>
+                <a16:creationId xmlns:a16="http://schemas.microsoft.com/office/drawing/2014/main" id="{01F5128A-9F1B-4FD9-8F59-E8B752DE52B2}"/>
               </a:ext>
             </a:extLst>
           </p:cNvPr>
@@ -8084,7 +8084,7 @@
           <p:cNvPr id="3" name="TextBox 2">
             <a:extLst xmlns:a="http://schemas.openxmlformats.org/drawingml/2006/main">
               <a:ext uri="{FF2B5EF4-FFF2-40B4-BE49-F238E27FC236}">
-                <a16:creationId xmlns:a16="http://schemas.microsoft.com/office/drawing/2014/main" id="{4F94AF81-1AB6-4EB5-9235-C85BBFF7D007}"/>
+                <a16:creationId xmlns:a16="http://schemas.microsoft.com/office/drawing/2014/main" id="{4600043F-FCB6-4CC6-A5BA-DEA3EC000F96}"/>
               </a:ext>
             </a:extLst>
           </p:cNvPr>
@@ -8131,7 +8131,7 @@
           <p:cNvPr id="4" name="Rectangle 3">
             <a:extLst xmlns:a="http://schemas.openxmlformats.org/drawingml/2006/main">
               <a:ext uri="{FF2B5EF4-FFF2-40B4-BE49-F238E27FC236}">
-                <a16:creationId xmlns:a16="http://schemas.microsoft.com/office/drawing/2014/main" id="{FC4BD03F-6AB8-4339-8822-A32241C9E9D5}"/>
+                <a16:creationId xmlns:a16="http://schemas.microsoft.com/office/drawing/2014/main" id="{465CD8EE-1F32-47AF-AB28-6BB1E72487A7}"/>
               </a:ext>
             </a:extLst>
           </p:cNvPr>
@@ -8186,7 +8186,7 @@
           <p:cNvPr id="5" name="Rectangle 4">
             <a:extLst xmlns:a="http://schemas.openxmlformats.org/drawingml/2006/main">
               <a:ext uri="{FF2B5EF4-FFF2-40B4-BE49-F238E27FC236}">
-                <a16:creationId xmlns:a16="http://schemas.microsoft.com/office/drawing/2014/main" id="{D46CDFFC-86CC-4130-838E-65EDAD4393CE}"/>
+                <a16:creationId xmlns:a16="http://schemas.microsoft.com/office/drawing/2014/main" id="{CCD56968-0781-4DD2-95F6-AB80988D6AB5}"/>
               </a:ext>
             </a:extLst>
           </p:cNvPr>
@@ -8241,7 +8241,7 @@
           <p:cNvPr id="6" name="TextBox 5">
             <a:extLst xmlns:a="http://schemas.openxmlformats.org/drawingml/2006/main">
               <a:ext uri="{FF2B5EF4-FFF2-40B4-BE49-F238E27FC236}">
-                <a16:creationId xmlns:a16="http://schemas.microsoft.com/office/drawing/2014/main" id="{F61BB9C8-86C2-412F-94C5-D9276D1B8531}"/>
+                <a16:creationId xmlns:a16="http://schemas.microsoft.com/office/drawing/2014/main" id="{CD87C2AA-C221-48FC-8FDE-7D464D36C0EC}"/>
               </a:ext>
             </a:extLst>
           </p:cNvPr>
@@ -8278,7 +8278,7 @@
                 <a:ea typeface="Aptos"/>
                 <a:cs typeface="Aptos"/>
               </a:rPr>
-              <a:t>Independent public evidence summary · 2026.07.22-9 · 2026-07-22 · Sources: UN; Atlas</a:t>
+              <a:t>Independent public evidence summary · 2026.07.23-10 · 2026-07-22 · Sources: UN; Atlas</a:t>
             </a:r>
           </a:p>
         </p:txBody>
@@ -8288,7 +8288,7 @@
           <p:cNvPr id="7" name="TextBox 6">
             <a:extLst xmlns:a="http://schemas.openxmlformats.org/drawingml/2006/main">
               <a:ext uri="{FF2B5EF4-FFF2-40B4-BE49-F238E27FC236}">
-                <a16:creationId xmlns:a16="http://schemas.microsoft.com/office/drawing/2014/main" id="{35F21FE3-C3CD-42FC-A3E0-AF12F30741B8}"/>
+                <a16:creationId xmlns:a16="http://schemas.microsoft.com/office/drawing/2014/main" id="{00507115-1232-47A8-A180-90E4C78D674F}"/>
               </a:ext>
             </a:extLst>
           </p:cNvPr>
@@ -8335,7 +8335,7 @@
           <p:cNvPr id="8" name="Rounded Rectangle 7">
             <a:extLst xmlns:a="http://schemas.openxmlformats.org/drawingml/2006/main">
               <a:ext uri="{FF2B5EF4-FFF2-40B4-BE49-F238E27FC236}">
-                <a16:creationId xmlns:a16="http://schemas.microsoft.com/office/drawing/2014/main" id="{7C8E7FD7-6C4A-4AF2-B2D9-C013C5669F2B}"/>
+                <a16:creationId xmlns:a16="http://schemas.microsoft.com/office/drawing/2014/main" id="{1C7BF45D-F3D5-4DF8-A8EC-014574D2DEC0}"/>
               </a:ext>
             </a:extLst>
           </p:cNvPr>
@@ -8392,7 +8392,7 @@
           <p:cNvPr id="9" name="TextBox 8">
             <a:extLst xmlns:a="http://schemas.openxmlformats.org/drawingml/2006/main">
               <a:ext uri="{FF2B5EF4-FFF2-40B4-BE49-F238E27FC236}">
-                <a16:creationId xmlns:a16="http://schemas.microsoft.com/office/drawing/2014/main" id="{C8579EB4-EA27-47F3-8747-DA0792F1CE81}"/>
+                <a16:creationId xmlns:a16="http://schemas.microsoft.com/office/drawing/2014/main" id="{6393BA34-1E00-405B-93C3-CFFBB9E37F66}"/>
               </a:ext>
             </a:extLst>
           </p:cNvPr>
@@ -8439,7 +8439,7 @@
           <p:cNvPr id="10" name="TextBox 9">
             <a:extLst xmlns:a="http://schemas.openxmlformats.org/drawingml/2006/main">
               <a:ext uri="{FF2B5EF4-FFF2-40B4-BE49-F238E27FC236}">
-                <a16:creationId xmlns:a16="http://schemas.microsoft.com/office/drawing/2014/main" id="{17BE9D3B-B4A6-44D2-80A7-7491C695FBC0}"/>
+                <a16:creationId xmlns:a16="http://schemas.microsoft.com/office/drawing/2014/main" id="{58E4F7F1-68B9-4F2C-B3F9-3A46191335F4}"/>
               </a:ext>
             </a:extLst>
           </p:cNvPr>
@@ -8486,7 +8486,7 @@
           <p:cNvPr id="11" name="Rounded Rectangle 10">
             <a:extLst xmlns:a="http://schemas.openxmlformats.org/drawingml/2006/main">
               <a:ext uri="{FF2B5EF4-FFF2-40B4-BE49-F238E27FC236}">
-                <a16:creationId xmlns:a16="http://schemas.microsoft.com/office/drawing/2014/main" id="{74D1EC7B-2587-4CDB-9C69-5CAA92EFC1DF}"/>
+                <a16:creationId xmlns:a16="http://schemas.microsoft.com/office/drawing/2014/main" id="{3FD45B9A-5D8A-4BA4-A8B1-385F4DE842AE}"/>
               </a:ext>
             </a:extLst>
           </p:cNvPr>
@@ -8543,7 +8543,7 @@
           <p:cNvPr id="12" name="TextBox 11">
             <a:extLst xmlns:a="http://schemas.openxmlformats.org/drawingml/2006/main">
               <a:ext uri="{FF2B5EF4-FFF2-40B4-BE49-F238E27FC236}">
-                <a16:creationId xmlns:a16="http://schemas.microsoft.com/office/drawing/2014/main" id="{BC275A3F-A3F7-4E7A-94F5-C60FF570D8A9}"/>
+                <a16:creationId xmlns:a16="http://schemas.microsoft.com/office/drawing/2014/main" id="{C5E00E6C-424F-46B8-A2F3-AC2D9C3737F2}"/>
               </a:ext>
             </a:extLst>
           </p:cNvPr>
@@ -8590,7 +8590,7 @@
           <p:cNvPr id="13" name="TextBox 12">
             <a:extLst xmlns:a="http://schemas.openxmlformats.org/drawingml/2006/main">
               <a:ext uri="{FF2B5EF4-FFF2-40B4-BE49-F238E27FC236}">
-                <a16:creationId xmlns:a16="http://schemas.microsoft.com/office/drawing/2014/main" id="{BFCBABE1-97BE-4097-9FA5-24CF92AE5813}"/>
+                <a16:creationId xmlns:a16="http://schemas.microsoft.com/office/drawing/2014/main" id="{A034897B-2891-4886-812A-CB1F234242FA}"/>
               </a:ext>
             </a:extLst>
           </p:cNvPr>
@@ -8637,7 +8637,7 @@
           <p:cNvPr id="14" name="Rounded Rectangle 13">
             <a:extLst xmlns:a="http://schemas.openxmlformats.org/drawingml/2006/main">
               <a:ext uri="{FF2B5EF4-FFF2-40B4-BE49-F238E27FC236}">
-                <a16:creationId xmlns:a16="http://schemas.microsoft.com/office/drawing/2014/main" id="{F77C224F-1C07-4799-965D-0915124B1052}"/>
+                <a16:creationId xmlns:a16="http://schemas.microsoft.com/office/drawing/2014/main" id="{41CDDCFE-121C-4CC5-B6D6-13B20620FA0B}"/>
               </a:ext>
             </a:extLst>
           </p:cNvPr>
@@ -8694,7 +8694,7 @@
           <p:cNvPr id="15" name="TextBox 14">
             <a:extLst xmlns:a="http://schemas.openxmlformats.org/drawingml/2006/main">
               <a:ext uri="{FF2B5EF4-FFF2-40B4-BE49-F238E27FC236}">
-                <a16:creationId xmlns:a16="http://schemas.microsoft.com/office/drawing/2014/main" id="{D4486C71-C47C-476D-9F89-23CB44770ABC}"/>
+                <a16:creationId xmlns:a16="http://schemas.microsoft.com/office/drawing/2014/main" id="{EEDEE866-2DA3-4B55-B6D4-536D73593A92}"/>
               </a:ext>
             </a:extLst>
           </p:cNvPr>
@@ -8741,7 +8741,7 @@
           <p:cNvPr id="16" name="TextBox 15">
             <a:extLst xmlns:a="http://schemas.openxmlformats.org/drawingml/2006/main">
               <a:ext uri="{FF2B5EF4-FFF2-40B4-BE49-F238E27FC236}">
-                <a16:creationId xmlns:a16="http://schemas.microsoft.com/office/drawing/2014/main" id="{527BD842-379E-418D-9C6A-EB4AE5CD5B94}"/>
+                <a16:creationId xmlns:a16="http://schemas.microsoft.com/office/drawing/2014/main" id="{DC5674DE-00DD-440C-9071-36074FA182BA}"/>
               </a:ext>
             </a:extLst>
           </p:cNvPr>
@@ -8788,7 +8788,7 @@
           <p:cNvPr id="17" name="Rounded Rectangle 16">
             <a:extLst xmlns:a="http://schemas.openxmlformats.org/drawingml/2006/main">
               <a:ext uri="{FF2B5EF4-FFF2-40B4-BE49-F238E27FC236}">
-                <a16:creationId xmlns:a16="http://schemas.microsoft.com/office/drawing/2014/main" id="{662168AA-21E6-4F50-B55A-FEED54F92F41}"/>
+                <a16:creationId xmlns:a16="http://schemas.microsoft.com/office/drawing/2014/main" id="{930395C4-6CF3-4207-843B-1AACA53F0AD1}"/>
               </a:ext>
             </a:extLst>
           </p:cNvPr>
@@ -8845,7 +8845,7 @@
           <p:cNvPr id="18" name="TextBox 17">
             <a:extLst xmlns:a="http://schemas.openxmlformats.org/drawingml/2006/main">
               <a:ext uri="{FF2B5EF4-FFF2-40B4-BE49-F238E27FC236}">
-                <a16:creationId xmlns:a16="http://schemas.microsoft.com/office/drawing/2014/main" id="{8BF0CFF4-92D9-4DEA-9649-8C2323FF9D78}"/>
+                <a16:creationId xmlns:a16="http://schemas.microsoft.com/office/drawing/2014/main" id="{943A8013-8CAE-4E29-BE5D-BF4968626082}"/>
               </a:ext>
             </a:extLst>
           </p:cNvPr>
@@ -8892,7 +8892,7 @@
           <p:cNvPr id="19" name="TextBox 18">
             <a:extLst xmlns:a="http://schemas.openxmlformats.org/drawingml/2006/main">
               <a:ext uri="{FF2B5EF4-FFF2-40B4-BE49-F238E27FC236}">
-                <a16:creationId xmlns:a16="http://schemas.microsoft.com/office/drawing/2014/main" id="{59D499BE-DACA-408E-AF32-2945FEAE138D}"/>
+                <a16:creationId xmlns:a16="http://schemas.microsoft.com/office/drawing/2014/main" id="{9C5C1E66-9998-4536-A68D-39F1C3900013}"/>
               </a:ext>
             </a:extLst>
           </p:cNvPr>
@@ -8939,7 +8939,7 @@
           <p:cNvPr id="20" name="TextBox 19">
             <a:extLst xmlns:a="http://schemas.openxmlformats.org/drawingml/2006/main">
               <a:ext uri="{FF2B5EF4-FFF2-40B4-BE49-F238E27FC236}">
-                <a16:creationId xmlns:a16="http://schemas.microsoft.com/office/drawing/2014/main" id="{C4653E20-4299-43C9-9AC3-8EAC0E9DD444}"/>
+                <a16:creationId xmlns:a16="http://schemas.microsoft.com/office/drawing/2014/main" id="{F1602CFB-8D4A-4541-9763-EAFA7BF87A0B}"/>
               </a:ext>
             </a:extLst>
           </p:cNvPr>
@@ -8986,7 +8986,7 @@
           <p:cNvPr id="21" name="Rounded Rectangle 20">
             <a:extLst xmlns:a="http://schemas.openxmlformats.org/drawingml/2006/main">
               <a:ext uri="{FF2B5EF4-FFF2-40B4-BE49-F238E27FC236}">
-                <a16:creationId xmlns:a16="http://schemas.microsoft.com/office/drawing/2014/main" id="{3DCE39FF-28F1-49E3-81C0-D6079E4C23D3}"/>
+                <a16:creationId xmlns:a16="http://schemas.microsoft.com/office/drawing/2014/main" id="{3559C327-1CC5-467E-8A54-595398B2FF24}"/>
               </a:ext>
             </a:extLst>
           </p:cNvPr>
@@ -9043,7 +9043,7 @@
           <p:cNvPr id="22" name="TextBox 21">
             <a:extLst xmlns:a="http://schemas.openxmlformats.org/drawingml/2006/main">
               <a:ext uri="{FF2B5EF4-FFF2-40B4-BE49-F238E27FC236}">
-                <a16:creationId xmlns:a16="http://schemas.microsoft.com/office/drawing/2014/main" id="{CB803758-96F7-405F-B8A1-9EC442B8AE34}"/>
+                <a16:creationId xmlns:a16="http://schemas.microsoft.com/office/drawing/2014/main" id="{650FA5CC-38D3-4652-8A91-27CD5669672B}"/>
               </a:ext>
             </a:extLst>
           </p:cNvPr>
@@ -9090,7 +9090,7 @@
           <p:cNvPr id="23" name="TextBox 22">
             <a:extLst xmlns:a="http://schemas.openxmlformats.org/drawingml/2006/main">
               <a:ext uri="{FF2B5EF4-FFF2-40B4-BE49-F238E27FC236}">
-                <a16:creationId xmlns:a16="http://schemas.microsoft.com/office/drawing/2014/main" id="{13824250-3ED0-4407-BBA9-7BA67AC54706}"/>
+                <a16:creationId xmlns:a16="http://schemas.microsoft.com/office/drawing/2014/main" id="{120A75D5-8DBC-4B00-8737-466ED44EF430}"/>
               </a:ext>
             </a:extLst>
           </p:cNvPr>
@@ -9135,7 +9135,7 @@
     </p:spTree>
     <p:extLst>
       <p:ext uri="{BB962C8B-B14F-4D97-AF65-F5344CB8AC3E}">
-        <p14:creationId xmlns:p14="http://schemas.microsoft.com/office/powerpoint/2010/main" val="1053656129"/>
+        <p14:creationId xmlns:p14="http://schemas.microsoft.com/office/powerpoint/2010/main" val="1205908936"/>
       </p:ext>
     </p:extLst>
   </p:cSld>
@@ -9159,7 +9159,7 @@
           <p:cNvPr id="2" name="TextBox 1">
             <a:extLst xmlns:a="http://schemas.openxmlformats.org/drawingml/2006/main">
               <a:ext uri="{FF2B5EF4-FFF2-40B4-BE49-F238E27FC236}">
-                <a16:creationId xmlns:a16="http://schemas.microsoft.com/office/drawing/2014/main" id="{75AAC6CF-403D-4C9D-A753-445C2170F6C5}"/>
+                <a16:creationId xmlns:a16="http://schemas.microsoft.com/office/drawing/2014/main" id="{3446BB4B-87DC-4D69-8866-7C5CD7CA036D}"/>
               </a:ext>
             </a:extLst>
           </p:cNvPr>
@@ -9206,7 +9206,7 @@
           <p:cNvPr id="3" name="TextBox 2">
             <a:extLst xmlns:a="http://schemas.openxmlformats.org/drawingml/2006/main">
               <a:ext uri="{FF2B5EF4-FFF2-40B4-BE49-F238E27FC236}">
-                <a16:creationId xmlns:a16="http://schemas.microsoft.com/office/drawing/2014/main" id="{079AF131-9B87-4F01-9CB8-5DB3649A5335}"/>
+                <a16:creationId xmlns:a16="http://schemas.microsoft.com/office/drawing/2014/main" id="{AF221798-0F9E-4742-BE56-2012A3EA8ADC}"/>
               </a:ext>
             </a:extLst>
           </p:cNvPr>
@@ -9253,7 +9253,7 @@
           <p:cNvPr id="4" name="Rectangle 3">
             <a:extLst xmlns:a="http://schemas.openxmlformats.org/drawingml/2006/main">
               <a:ext uri="{FF2B5EF4-FFF2-40B4-BE49-F238E27FC236}">
-                <a16:creationId xmlns:a16="http://schemas.microsoft.com/office/drawing/2014/main" id="{982F86DB-9B24-4FF4-B81D-3BA6229E51E8}"/>
+                <a16:creationId xmlns:a16="http://schemas.microsoft.com/office/drawing/2014/main" id="{36F6812B-039B-4E70-9931-A4E51A49366F}"/>
               </a:ext>
             </a:extLst>
           </p:cNvPr>
@@ -9308,7 +9308,7 @@
           <p:cNvPr id="5" name="Rectangle 4">
             <a:extLst xmlns:a="http://schemas.openxmlformats.org/drawingml/2006/main">
               <a:ext uri="{FF2B5EF4-FFF2-40B4-BE49-F238E27FC236}">
-                <a16:creationId xmlns:a16="http://schemas.microsoft.com/office/drawing/2014/main" id="{20DAE225-6A75-4ECE-8B9C-9FDEE2D69F3C}"/>
+                <a16:creationId xmlns:a16="http://schemas.microsoft.com/office/drawing/2014/main" id="{6CCFFA52-28CC-4A52-864E-8C538B95C1FF}"/>
               </a:ext>
             </a:extLst>
           </p:cNvPr>
@@ -9363,7 +9363,7 @@
           <p:cNvPr id="6" name="TextBox 5">
             <a:extLst xmlns:a="http://schemas.openxmlformats.org/drawingml/2006/main">
               <a:ext uri="{FF2B5EF4-FFF2-40B4-BE49-F238E27FC236}">
-                <a16:creationId xmlns:a16="http://schemas.microsoft.com/office/drawing/2014/main" id="{7D3D3FEC-C9E1-486A-AA99-3A91D513726C}"/>
+                <a16:creationId xmlns:a16="http://schemas.microsoft.com/office/drawing/2014/main" id="{895AC9D5-81EC-40E1-922E-6DA29BABEF3A}"/>
               </a:ext>
             </a:extLst>
           </p:cNvPr>
@@ -9400,7 +9400,7 @@
                 <a:ea typeface="Aptos"/>
                 <a:cs typeface="Aptos"/>
               </a:rPr>
-              <a:t>Independent public evidence summary · 2026.07.22-9 · 2026-07-22 · Sources: Health Canada; Destatis; Vero; Sejm; Swedish Government</a:t>
+              <a:t>Independent public evidence summary · 2026.07.23-10 · 2026-07-22 · Sources: Health Canada; Destatis; Vero; Sejm; Swedish Government</a:t>
             </a:r>
           </a:p>
         </p:txBody>
@@ -9410,7 +9410,7 @@
           <p:cNvPr id="7" name="TextBox 6">
             <a:extLst xmlns:a="http://schemas.openxmlformats.org/drawingml/2006/main">
               <a:ext uri="{FF2B5EF4-FFF2-40B4-BE49-F238E27FC236}">
-                <a16:creationId xmlns:a16="http://schemas.microsoft.com/office/drawing/2014/main" id="{FF9D7F3D-D30C-4435-A1B4-E2A91708EB88}"/>
+                <a16:creationId xmlns:a16="http://schemas.microsoft.com/office/drawing/2014/main" id="{5A584F06-12B9-4F93-AB34-37758934DBC1}"/>
               </a:ext>
             </a:extLst>
           </p:cNvPr>
@@ -9980,7 +9980,7 @@
           <p:cNvPr id="9" name="TextBox 8">
             <a:extLst xmlns:a="http://schemas.openxmlformats.org/drawingml/2006/main">
               <a:ext uri="{FF2B5EF4-FFF2-40B4-BE49-F238E27FC236}">
-                <a16:creationId xmlns:a16="http://schemas.microsoft.com/office/drawing/2014/main" id="{82143438-2D76-40AA-9B4F-ACB8737B1C16}"/>
+                <a16:creationId xmlns:a16="http://schemas.microsoft.com/office/drawing/2014/main" id="{B798AAB0-958A-4597-A4FA-F87AE8B97482}"/>
               </a:ext>
             </a:extLst>
           </p:cNvPr>
@@ -10025,7 +10025,7 @@
     </p:spTree>
     <p:extLst>
       <p:ext uri="{BB962C8B-B14F-4D97-AF65-F5344CB8AC3E}">
-        <p14:creationId xmlns:p14="http://schemas.microsoft.com/office/powerpoint/2010/main" val="908447170"/>
+        <p14:creationId xmlns:p14="http://schemas.microsoft.com/office/powerpoint/2010/main" val="1906912212"/>
       </p:ext>
     </p:extLst>
   </p:cSld>
@@ -10049,7 +10049,7 @@
           <p:cNvPr id="2" name="TextBox 1">
             <a:extLst xmlns:a="http://schemas.openxmlformats.org/drawingml/2006/main">
               <a:ext uri="{FF2B5EF4-FFF2-40B4-BE49-F238E27FC236}">
-                <a16:creationId xmlns:a16="http://schemas.microsoft.com/office/drawing/2014/main" id="{C75E4BFB-5ADD-4646-BDA0-0072CD4CACD3}"/>
+                <a16:creationId xmlns:a16="http://schemas.microsoft.com/office/drawing/2014/main" id="{CBA9A255-F567-4C86-8F86-EE77A4ECF8B3}"/>
               </a:ext>
             </a:extLst>
           </p:cNvPr>
@@ -10096,7 +10096,7 @@
           <p:cNvPr id="3" name="TextBox 2">
             <a:extLst xmlns:a="http://schemas.openxmlformats.org/drawingml/2006/main">
               <a:ext uri="{FF2B5EF4-FFF2-40B4-BE49-F238E27FC236}">
-                <a16:creationId xmlns:a16="http://schemas.microsoft.com/office/drawing/2014/main" id="{059BB44C-CE6A-469F-9979-FDA2C47DF7C4}"/>
+                <a16:creationId xmlns:a16="http://schemas.microsoft.com/office/drawing/2014/main" id="{46CFEED9-AB91-4779-ABEC-4B44E6BF63B6}"/>
               </a:ext>
             </a:extLst>
           </p:cNvPr>
@@ -10143,7 +10143,7 @@
           <p:cNvPr id="4" name="Rectangle 3">
             <a:extLst xmlns:a="http://schemas.openxmlformats.org/drawingml/2006/main">
               <a:ext uri="{FF2B5EF4-FFF2-40B4-BE49-F238E27FC236}">
-                <a16:creationId xmlns:a16="http://schemas.microsoft.com/office/drawing/2014/main" id="{D13330CB-AA6B-41B2-8300-468989448B93}"/>
+                <a16:creationId xmlns:a16="http://schemas.microsoft.com/office/drawing/2014/main" id="{675D6ED0-D671-4D21-B75E-FB87D003F7F9}"/>
               </a:ext>
             </a:extLst>
           </p:cNvPr>
@@ -10198,7 +10198,7 @@
           <p:cNvPr id="5" name="Rectangle 4">
             <a:extLst xmlns:a="http://schemas.openxmlformats.org/drawingml/2006/main">
               <a:ext uri="{FF2B5EF4-FFF2-40B4-BE49-F238E27FC236}">
-                <a16:creationId xmlns:a16="http://schemas.microsoft.com/office/drawing/2014/main" id="{50EFEF3F-6194-48E7-841A-E9EC75F74893}"/>
+                <a16:creationId xmlns:a16="http://schemas.microsoft.com/office/drawing/2014/main" id="{E32EC7C8-B234-47A8-B4A0-A632AA44DE05}"/>
               </a:ext>
             </a:extLst>
           </p:cNvPr>
@@ -10253,7 +10253,7 @@
           <p:cNvPr id="6" name="TextBox 5">
             <a:extLst xmlns:a="http://schemas.openxmlformats.org/drawingml/2006/main">
               <a:ext uri="{FF2B5EF4-FFF2-40B4-BE49-F238E27FC236}">
-                <a16:creationId xmlns:a16="http://schemas.microsoft.com/office/drawing/2014/main" id="{B4A9EE12-0994-4AAF-A622-39C6403B4B87}"/>
+                <a16:creationId xmlns:a16="http://schemas.microsoft.com/office/drawing/2014/main" id="{C551D6E2-1A4A-42F8-A0E6-78D1920C0740}"/>
               </a:ext>
             </a:extLst>
           </p:cNvPr>
@@ -10290,7 +10290,7 @@
                 <a:ea typeface="Aptos"/>
                 <a:cs typeface="Aptos"/>
               </a:rPr>
-              <a:t>Independent public evidence summary · 2026.07.22-9 · 2026-07-22 · Sources: Health Canada 2024</a:t>
+              <a:t>Independent public evidence summary · 2026.07.23-10 · 2026-07-22 · Sources: Health Canada 2024</a:t>
             </a:r>
           </a:p>
         </p:txBody>
@@ -10300,7 +10300,7 @@
           <p:cNvPr id="7" name="TextBox 6">
             <a:extLst xmlns:a="http://schemas.openxmlformats.org/drawingml/2006/main">
               <a:ext uri="{FF2B5EF4-FFF2-40B4-BE49-F238E27FC236}">
-                <a16:creationId xmlns:a16="http://schemas.microsoft.com/office/drawing/2014/main" id="{EAE534A5-4A89-4498-8BBB-C85FA4DA731E}"/>
+                <a16:creationId xmlns:a16="http://schemas.microsoft.com/office/drawing/2014/main" id="{33EC497C-04F6-436E-8251-A691CE59500C}"/>
               </a:ext>
             </a:extLst>
           </p:cNvPr>
@@ -10347,7 +10347,7 @@
           <p:cNvPr id="8" name="Rounded Rectangle 7">
             <a:extLst xmlns:a="http://schemas.openxmlformats.org/drawingml/2006/main">
               <a:ext uri="{FF2B5EF4-FFF2-40B4-BE49-F238E27FC236}">
-                <a16:creationId xmlns:a16="http://schemas.microsoft.com/office/drawing/2014/main" id="{112A39CE-FC67-43B8-BF28-1CCDFF378542}"/>
+                <a16:creationId xmlns:a16="http://schemas.microsoft.com/office/drawing/2014/main" id="{5E7EF6F6-0AD5-41D4-99D3-AB82E6DC0412}"/>
               </a:ext>
             </a:extLst>
           </p:cNvPr>
@@ -10404,7 +10404,7 @@
           <p:cNvPr id="9" name="TextBox 8">
             <a:extLst xmlns:a="http://schemas.openxmlformats.org/drawingml/2006/main">
               <a:ext uri="{FF2B5EF4-FFF2-40B4-BE49-F238E27FC236}">
-                <a16:creationId xmlns:a16="http://schemas.microsoft.com/office/drawing/2014/main" id="{2A68605A-3654-4D8C-ACC3-68E68591E851}"/>
+                <a16:creationId xmlns:a16="http://schemas.microsoft.com/office/drawing/2014/main" id="{2882B370-C28A-49C6-819C-ADFECABBC90A}"/>
               </a:ext>
             </a:extLst>
           </p:cNvPr>
@@ -10451,7 +10451,7 @@
           <p:cNvPr id="10" name="TextBox 9">
             <a:extLst xmlns:a="http://schemas.openxmlformats.org/drawingml/2006/main">
               <a:ext uri="{FF2B5EF4-FFF2-40B4-BE49-F238E27FC236}">
-                <a16:creationId xmlns:a16="http://schemas.microsoft.com/office/drawing/2014/main" id="{F97F40E1-9603-4390-8E2A-94FDFC16E39C}"/>
+                <a16:creationId xmlns:a16="http://schemas.microsoft.com/office/drawing/2014/main" id="{908F1E6B-4C81-4847-99DF-A31BD8EA5ED4}"/>
               </a:ext>
             </a:extLst>
           </p:cNvPr>
@@ -10498,7 +10498,7 @@
           <p:cNvPr id="11" name="Rounded Rectangle 10">
             <a:extLst xmlns:a="http://schemas.openxmlformats.org/drawingml/2006/main">
               <a:ext uri="{FF2B5EF4-FFF2-40B4-BE49-F238E27FC236}">
-                <a16:creationId xmlns:a16="http://schemas.microsoft.com/office/drawing/2014/main" id="{22DD5251-6816-4609-97D2-C6A3E8C98DF9}"/>
+                <a16:creationId xmlns:a16="http://schemas.microsoft.com/office/drawing/2014/main" id="{5EF39D58-FB87-4CDD-9708-A98AF57E17D7}"/>
               </a:ext>
             </a:extLst>
           </p:cNvPr>
@@ -10555,7 +10555,7 @@
           <p:cNvPr id="12" name="TextBox 11">
             <a:extLst xmlns:a="http://schemas.openxmlformats.org/drawingml/2006/main">
               <a:ext uri="{FF2B5EF4-FFF2-40B4-BE49-F238E27FC236}">
-                <a16:creationId xmlns:a16="http://schemas.microsoft.com/office/drawing/2014/main" id="{056FF869-041A-41FC-8D56-F63A9C3474AA}"/>
+                <a16:creationId xmlns:a16="http://schemas.microsoft.com/office/drawing/2014/main" id="{1B17487D-2D5B-41A4-8AC7-C8E6843FA255}"/>
               </a:ext>
             </a:extLst>
           </p:cNvPr>
@@ -10602,7 +10602,7 @@
           <p:cNvPr id="13" name="TextBox 12">
             <a:extLst xmlns:a="http://schemas.openxmlformats.org/drawingml/2006/main">
               <a:ext uri="{FF2B5EF4-FFF2-40B4-BE49-F238E27FC236}">
-                <a16:creationId xmlns:a16="http://schemas.microsoft.com/office/drawing/2014/main" id="{4BF31271-41D3-4D5E-AF58-F02A0F5D425F}"/>
+                <a16:creationId xmlns:a16="http://schemas.microsoft.com/office/drawing/2014/main" id="{826F62F3-75D5-4448-B92B-11D6E54EC3DC}"/>
               </a:ext>
             </a:extLst>
           </p:cNvPr>
@@ -10649,7 +10649,7 @@
           <p:cNvPr id="14" name="Rounded Rectangle 13">
             <a:extLst xmlns:a="http://schemas.openxmlformats.org/drawingml/2006/main">
               <a:ext uri="{FF2B5EF4-FFF2-40B4-BE49-F238E27FC236}">
-                <a16:creationId xmlns:a16="http://schemas.microsoft.com/office/drawing/2014/main" id="{56921BA5-C4D8-40A4-9695-35B28057D27C}"/>
+                <a16:creationId xmlns:a16="http://schemas.microsoft.com/office/drawing/2014/main" id="{150B46A4-C5F4-4D00-B217-6C97C1974476}"/>
               </a:ext>
             </a:extLst>
           </p:cNvPr>
@@ -10706,7 +10706,7 @@
           <p:cNvPr id="15" name="TextBox 14">
             <a:extLst xmlns:a="http://schemas.openxmlformats.org/drawingml/2006/main">
               <a:ext uri="{FF2B5EF4-FFF2-40B4-BE49-F238E27FC236}">
-                <a16:creationId xmlns:a16="http://schemas.microsoft.com/office/drawing/2014/main" id="{340DBA46-11F1-42E2-B8CA-A5FFECFEEA5A}"/>
+                <a16:creationId xmlns:a16="http://schemas.microsoft.com/office/drawing/2014/main" id="{CB3FD990-1303-4C4E-9A9B-4CD033EE5030}"/>
               </a:ext>
             </a:extLst>
           </p:cNvPr>
@@ -10753,7 +10753,7 @@
           <p:cNvPr id="16" name="TextBox 15">
             <a:extLst xmlns:a="http://schemas.openxmlformats.org/drawingml/2006/main">
               <a:ext uri="{FF2B5EF4-FFF2-40B4-BE49-F238E27FC236}">
-                <a16:creationId xmlns:a16="http://schemas.microsoft.com/office/drawing/2014/main" id="{773DEFD7-79BD-4275-A420-CAB80D0C37DB}"/>
+                <a16:creationId xmlns:a16="http://schemas.microsoft.com/office/drawing/2014/main" id="{FA72A65B-626E-43C9-B1CC-C79589CDFA6C}"/>
               </a:ext>
             </a:extLst>
           </p:cNvPr>
@@ -10800,7 +10800,7 @@
           <p:cNvPr id="17" name="TextBox 16">
             <a:extLst xmlns:a="http://schemas.openxmlformats.org/drawingml/2006/main">
               <a:ext uri="{FF2B5EF4-FFF2-40B4-BE49-F238E27FC236}">
-                <a16:creationId xmlns:a16="http://schemas.microsoft.com/office/drawing/2014/main" id="{95519D40-B48E-48FE-B8CB-3D34AFD4D829}"/>
+                <a16:creationId xmlns:a16="http://schemas.microsoft.com/office/drawing/2014/main" id="{3184535B-CB25-49F7-BA0A-5A104BDE5BC7}"/>
               </a:ext>
             </a:extLst>
           </p:cNvPr>
@@ -10847,7 +10847,7 @@
           <p:cNvPr id="18" name="Rounded Rectangle 17">
             <a:extLst xmlns:a="http://schemas.openxmlformats.org/drawingml/2006/main">
               <a:ext uri="{FF2B5EF4-FFF2-40B4-BE49-F238E27FC236}">
-                <a16:creationId xmlns:a16="http://schemas.microsoft.com/office/drawing/2014/main" id="{853198C0-409A-4AD0-BA0B-F56507DFD919}"/>
+                <a16:creationId xmlns:a16="http://schemas.microsoft.com/office/drawing/2014/main" id="{3B3677E6-7D7E-4293-A40C-205D94005CA1}"/>
               </a:ext>
             </a:extLst>
           </p:cNvPr>
@@ -10904,7 +10904,7 @@
           <p:cNvPr id="19" name="TextBox 18">
             <a:extLst xmlns:a="http://schemas.openxmlformats.org/drawingml/2006/main">
               <a:ext uri="{FF2B5EF4-FFF2-40B4-BE49-F238E27FC236}">
-                <a16:creationId xmlns:a16="http://schemas.microsoft.com/office/drawing/2014/main" id="{D30D8E8A-3384-4F8F-8088-9352D11E2CC9}"/>
+                <a16:creationId xmlns:a16="http://schemas.microsoft.com/office/drawing/2014/main" id="{0EF10DF8-F91C-4CED-9C18-6193E54F907D}"/>
               </a:ext>
             </a:extLst>
           </p:cNvPr>
@@ -10951,7 +10951,7 @@
           <p:cNvPr id="20" name="TextBox 19">
             <a:extLst xmlns:a="http://schemas.openxmlformats.org/drawingml/2006/main">
               <a:ext uri="{FF2B5EF4-FFF2-40B4-BE49-F238E27FC236}">
-                <a16:creationId xmlns:a16="http://schemas.microsoft.com/office/drawing/2014/main" id="{6F05FA5E-16B9-4085-875D-03453B6D93A5}"/>
+                <a16:creationId xmlns:a16="http://schemas.microsoft.com/office/drawing/2014/main" id="{1CAF6494-62CC-4671-A91B-E16AC3C7B373}"/>
               </a:ext>
             </a:extLst>
           </p:cNvPr>
@@ -10996,7 +10996,7 @@
     </p:spTree>
     <p:extLst>
       <p:ext uri="{BB962C8B-B14F-4D97-AF65-F5344CB8AC3E}">
-        <p14:creationId xmlns:p14="http://schemas.microsoft.com/office/powerpoint/2010/main" val="1896385266"/>
+        <p14:creationId xmlns:p14="http://schemas.microsoft.com/office/powerpoint/2010/main" val="1983239040"/>
       </p:ext>
     </p:extLst>
   </p:cSld>
@@ -11020,7 +11020,7 @@
           <p:cNvPr id="2" name="TextBox 1">
             <a:extLst xmlns:a="http://schemas.openxmlformats.org/drawingml/2006/main">
               <a:ext uri="{FF2B5EF4-FFF2-40B4-BE49-F238E27FC236}">
-                <a16:creationId xmlns:a16="http://schemas.microsoft.com/office/drawing/2014/main" id="{A700B5B6-5290-46D0-B2D7-C864FF31B02D}"/>
+                <a16:creationId xmlns:a16="http://schemas.microsoft.com/office/drawing/2014/main" id="{33C749A4-E1A4-4123-A4FF-6EC7C0509571}"/>
               </a:ext>
             </a:extLst>
           </p:cNvPr>
@@ -11067,7 +11067,7 @@
           <p:cNvPr id="3" name="TextBox 2">
             <a:extLst xmlns:a="http://schemas.openxmlformats.org/drawingml/2006/main">
               <a:ext uri="{FF2B5EF4-FFF2-40B4-BE49-F238E27FC236}">
-                <a16:creationId xmlns:a16="http://schemas.microsoft.com/office/drawing/2014/main" id="{0893CBF7-4192-4413-AA9E-090AAB9DAD1D}"/>
+                <a16:creationId xmlns:a16="http://schemas.microsoft.com/office/drawing/2014/main" id="{85C9BEBB-7786-4FEE-8D98-059A3D5E1F47}"/>
               </a:ext>
             </a:extLst>
           </p:cNvPr>
@@ -11114,7 +11114,7 @@
           <p:cNvPr id="4" name="Rectangle 3">
             <a:extLst xmlns:a="http://schemas.openxmlformats.org/drawingml/2006/main">
               <a:ext uri="{FF2B5EF4-FFF2-40B4-BE49-F238E27FC236}">
-                <a16:creationId xmlns:a16="http://schemas.microsoft.com/office/drawing/2014/main" id="{F4C6BCEB-DF66-4359-A276-332CDFB34C04}"/>
+                <a16:creationId xmlns:a16="http://schemas.microsoft.com/office/drawing/2014/main" id="{361E1FF1-D90F-46BA-BD89-610AAF011B2B}"/>
               </a:ext>
             </a:extLst>
           </p:cNvPr>
@@ -11169,7 +11169,7 @@
           <p:cNvPr id="5" name="Rectangle 4">
             <a:extLst xmlns:a="http://schemas.openxmlformats.org/drawingml/2006/main">
               <a:ext uri="{FF2B5EF4-FFF2-40B4-BE49-F238E27FC236}">
-                <a16:creationId xmlns:a16="http://schemas.microsoft.com/office/drawing/2014/main" id="{2F0C490A-4747-4D94-8AC1-8AC6D963335F}"/>
+                <a16:creationId xmlns:a16="http://schemas.microsoft.com/office/drawing/2014/main" id="{9AFD24CA-5AFB-46A0-A9F8-2FF13490391A}"/>
               </a:ext>
             </a:extLst>
           </p:cNvPr>
@@ -11224,7 +11224,7 @@
           <p:cNvPr id="6" name="TextBox 5">
             <a:extLst xmlns:a="http://schemas.openxmlformats.org/drawingml/2006/main">
               <a:ext uri="{FF2B5EF4-FFF2-40B4-BE49-F238E27FC236}">
-                <a16:creationId xmlns:a16="http://schemas.microsoft.com/office/drawing/2014/main" id="{165155F5-57CF-4019-977E-A7D168B5E3B3}"/>
+                <a16:creationId xmlns:a16="http://schemas.microsoft.com/office/drawing/2014/main" id="{D7574163-0C7D-43E4-9569-74C34881B341}"/>
               </a:ext>
             </a:extLst>
           </p:cNvPr>
@@ -11261,7 +11261,7 @@
                 <a:ea typeface="Aptos"/>
                 <a:cs typeface="Aptos"/>
               </a:rPr>
-              <a:t>Independent public evidence summary · 2026.07.22-9 · 2026-07-22 · Sources: Destatis</a:t>
+              <a:t>Independent public evidence summary · 2026.07.23-10 · 2026-07-22 · Sources: Destatis</a:t>
             </a:r>
           </a:p>
         </p:txBody>
@@ -11271,7 +11271,7 @@
           <p:cNvPr id="7" name="TextBox 6">
             <a:extLst xmlns:a="http://schemas.openxmlformats.org/drawingml/2006/main">
               <a:ext uri="{FF2B5EF4-FFF2-40B4-BE49-F238E27FC236}">
-                <a16:creationId xmlns:a16="http://schemas.microsoft.com/office/drawing/2014/main" id="{B396B180-7561-4E20-9557-8148F3098490}"/>
+                <a16:creationId xmlns:a16="http://schemas.microsoft.com/office/drawing/2014/main" id="{E58C4FE3-8895-414E-9036-0013E8E9DD8F}"/>
               </a:ext>
             </a:extLst>
           </p:cNvPr>
@@ -11784,7 +11784,7 @@
           <p:cNvPr id="9" name="TextBox 8">
             <a:extLst xmlns:a="http://schemas.openxmlformats.org/drawingml/2006/main">
               <a:ext uri="{FF2B5EF4-FFF2-40B4-BE49-F238E27FC236}">
-                <a16:creationId xmlns:a16="http://schemas.microsoft.com/office/drawing/2014/main" id="{EFC502E7-0171-47DD-9FB5-81F137FD8199}"/>
+                <a16:creationId xmlns:a16="http://schemas.microsoft.com/office/drawing/2014/main" id="{37036FF8-A56A-4B1D-AC26-3EFE6A224643}"/>
               </a:ext>
             </a:extLst>
           </p:cNvPr>
@@ -11829,7 +11829,7 @@
     </p:spTree>
     <p:extLst>
       <p:ext uri="{BB962C8B-B14F-4D97-AF65-F5344CB8AC3E}">
-        <p14:creationId xmlns:p14="http://schemas.microsoft.com/office/powerpoint/2010/main" val="1205900801"/>
+        <p14:creationId xmlns:p14="http://schemas.microsoft.com/office/powerpoint/2010/main" val="893745509"/>
       </p:ext>
     </p:extLst>
   </p:cSld>
@@ -11853,7 +11853,7 @@
           <p:cNvPr id="2" name="TextBox 1">
             <a:extLst xmlns:a="http://schemas.openxmlformats.org/drawingml/2006/main">
               <a:ext uri="{FF2B5EF4-FFF2-40B4-BE49-F238E27FC236}">
-                <a16:creationId xmlns:a16="http://schemas.microsoft.com/office/drawing/2014/main" id="{E0266EB8-106E-4494-8F5B-A61A58AA2689}"/>
+                <a16:creationId xmlns:a16="http://schemas.microsoft.com/office/drawing/2014/main" id="{B73D9614-05BB-4372-8F1E-13A649F4216A}"/>
               </a:ext>
             </a:extLst>
           </p:cNvPr>
@@ -11900,7 +11900,7 @@
           <p:cNvPr id="3" name="TextBox 2">
             <a:extLst xmlns:a="http://schemas.openxmlformats.org/drawingml/2006/main">
               <a:ext uri="{FF2B5EF4-FFF2-40B4-BE49-F238E27FC236}">
-                <a16:creationId xmlns:a16="http://schemas.microsoft.com/office/drawing/2014/main" id="{B0D7C854-DB79-49CE-8BF0-A882E8C2696B}"/>
+                <a16:creationId xmlns:a16="http://schemas.microsoft.com/office/drawing/2014/main" id="{EB3AF31A-1025-4FF8-B824-2B681D44D3EE}"/>
               </a:ext>
             </a:extLst>
           </p:cNvPr>
@@ -11947,7 +11947,7 @@
           <p:cNvPr id="4" name="Rectangle 3">
             <a:extLst xmlns:a="http://schemas.openxmlformats.org/drawingml/2006/main">
               <a:ext uri="{FF2B5EF4-FFF2-40B4-BE49-F238E27FC236}">
-                <a16:creationId xmlns:a16="http://schemas.microsoft.com/office/drawing/2014/main" id="{50490857-390B-4F5E-B660-D50F1F36F625}"/>
+                <a16:creationId xmlns:a16="http://schemas.microsoft.com/office/drawing/2014/main" id="{E7DB1783-6A69-4409-B1BF-2ED104D20EC1}"/>
               </a:ext>
             </a:extLst>
           </p:cNvPr>
@@ -12002,7 +12002,7 @@
           <p:cNvPr id="5" name="Rectangle 4">
             <a:extLst xmlns:a="http://schemas.openxmlformats.org/drawingml/2006/main">
               <a:ext uri="{FF2B5EF4-FFF2-40B4-BE49-F238E27FC236}">
-                <a16:creationId xmlns:a16="http://schemas.microsoft.com/office/drawing/2014/main" id="{8DF2CC33-8D36-4F05-AEDD-B75E7FC4FFEE}"/>
+                <a16:creationId xmlns:a16="http://schemas.microsoft.com/office/drawing/2014/main" id="{7506F975-860D-40D2-B10C-6612F3AF9B06}"/>
               </a:ext>
             </a:extLst>
           </p:cNvPr>
@@ -12057,7 +12057,7 @@
           <p:cNvPr id="6" name="TextBox 5">
             <a:extLst xmlns:a="http://schemas.openxmlformats.org/drawingml/2006/main">
               <a:ext uri="{FF2B5EF4-FFF2-40B4-BE49-F238E27FC236}">
-                <a16:creationId xmlns:a16="http://schemas.microsoft.com/office/drawing/2014/main" id="{D8578790-4140-4CC3-B0F3-F7D4B6C00EBF}"/>
+                <a16:creationId xmlns:a16="http://schemas.microsoft.com/office/drawing/2014/main" id="{4A13526F-53DE-4F03-8114-A16A60266B60}"/>
               </a:ext>
             </a:extLst>
           </p:cNvPr>
@@ -12094,7 +12094,7 @@
                 <a:ea typeface="Aptos"/>
                 <a:cs typeface="Aptos"/>
               </a:rPr>
-              <a:t>Independent public evidence summary · 2026.07.22-9 · 2026-07-22 · Sources: Destatis; inTaste.de</a:t>
+              <a:t>Independent public evidence summary · 2026.07.23-10 · 2026-07-22 · Sources: Destatis; inTaste.de</a:t>
             </a:r>
           </a:p>
         </p:txBody>
@@ -12104,7 +12104,7 @@
           <p:cNvPr id="7" name="TextBox 6">
             <a:extLst xmlns:a="http://schemas.openxmlformats.org/drawingml/2006/main">
               <a:ext uri="{FF2B5EF4-FFF2-40B4-BE49-F238E27FC236}">
-                <a16:creationId xmlns:a16="http://schemas.microsoft.com/office/drawing/2014/main" id="{177F31AF-48BB-45BD-82CF-6F2FDF77EAB5}"/>
+                <a16:creationId xmlns:a16="http://schemas.microsoft.com/office/drawing/2014/main" id="{694C6EA5-06DD-40EA-AA31-A397C912E94D}"/>
               </a:ext>
             </a:extLst>
           </p:cNvPr>
@@ -12151,7 +12151,7 @@
           <p:cNvPr id="8" name="Rounded Rectangle 7">
             <a:extLst xmlns:a="http://schemas.openxmlformats.org/drawingml/2006/main">
               <a:ext uri="{FF2B5EF4-FFF2-40B4-BE49-F238E27FC236}">
-                <a16:creationId xmlns:a16="http://schemas.microsoft.com/office/drawing/2014/main" id="{CC7C4343-28C7-4FA7-A18F-CB50ED73CC96}"/>
+                <a16:creationId xmlns:a16="http://schemas.microsoft.com/office/drawing/2014/main" id="{86679CB8-CFC3-4E87-A1A0-F0DB9F02326F}"/>
               </a:ext>
             </a:extLst>
           </p:cNvPr>
@@ -12208,7 +12208,7 @@
           <p:cNvPr id="9" name="TextBox 8">
             <a:extLst xmlns:a="http://schemas.openxmlformats.org/drawingml/2006/main">
               <a:ext uri="{FF2B5EF4-FFF2-40B4-BE49-F238E27FC236}">
-                <a16:creationId xmlns:a16="http://schemas.microsoft.com/office/drawing/2014/main" id="{28814392-5355-4240-9E60-E4DED7D08AA0}"/>
+                <a16:creationId xmlns:a16="http://schemas.microsoft.com/office/drawing/2014/main" id="{12D0AB7B-CD18-482E-95B6-F686C21DE0E7}"/>
               </a:ext>
             </a:extLst>
           </p:cNvPr>
@@ -12255,7 +12255,7 @@
           <p:cNvPr id="10" name="TextBox 9">
             <a:extLst xmlns:a="http://schemas.openxmlformats.org/drawingml/2006/main">
               <a:ext uri="{FF2B5EF4-FFF2-40B4-BE49-F238E27FC236}">
-                <a16:creationId xmlns:a16="http://schemas.microsoft.com/office/drawing/2014/main" id="{DDEEA3CB-5689-49E9-82EF-43931A8EF33E}"/>
+                <a16:creationId xmlns:a16="http://schemas.microsoft.com/office/drawing/2014/main" id="{2FF12385-8CAC-4D79-A15F-9B4EBEAC02C6}"/>
               </a:ext>
             </a:extLst>
           </p:cNvPr>
@@ -12302,7 +12302,7 @@
           <p:cNvPr id="11" name="Rounded Rectangle 10">
             <a:extLst xmlns:a="http://schemas.openxmlformats.org/drawingml/2006/main">
               <a:ext uri="{FF2B5EF4-FFF2-40B4-BE49-F238E27FC236}">
-                <a16:creationId xmlns:a16="http://schemas.microsoft.com/office/drawing/2014/main" id="{0647806E-A2E3-4929-B88B-4C7B4851F061}"/>
+                <a16:creationId xmlns:a16="http://schemas.microsoft.com/office/drawing/2014/main" id="{31A37C56-90D2-41DB-A216-3B81227058E6}"/>
               </a:ext>
             </a:extLst>
           </p:cNvPr>
@@ -12359,7 +12359,7 @@
           <p:cNvPr id="12" name="TextBox 11">
             <a:extLst xmlns:a="http://schemas.openxmlformats.org/drawingml/2006/main">
               <a:ext uri="{FF2B5EF4-FFF2-40B4-BE49-F238E27FC236}">
-                <a16:creationId xmlns:a16="http://schemas.microsoft.com/office/drawing/2014/main" id="{58E6A19F-A16B-418C-9349-B202DD3F6066}"/>
+                <a16:creationId xmlns:a16="http://schemas.microsoft.com/office/drawing/2014/main" id="{2EBE9969-8D55-47CB-8635-E3AFA6C63DE9}"/>
               </a:ext>
             </a:extLst>
           </p:cNvPr>
@@ -12406,7 +12406,7 @@
           <p:cNvPr id="13" name="TextBox 12">
             <a:extLst xmlns:a="http://schemas.openxmlformats.org/drawingml/2006/main">
               <a:ext uri="{FF2B5EF4-FFF2-40B4-BE49-F238E27FC236}">
-                <a16:creationId xmlns:a16="http://schemas.microsoft.com/office/drawing/2014/main" id="{46C764FB-B959-4307-948A-7C1484CFFBC1}"/>
+                <a16:creationId xmlns:a16="http://schemas.microsoft.com/office/drawing/2014/main" id="{397C6EFB-3222-4513-AD56-B834959D97ED}"/>
               </a:ext>
             </a:extLst>
           </p:cNvPr>
@@ -12453,7 +12453,7 @@
           <p:cNvPr id="14" name="Rounded Rectangle 13">
             <a:extLst xmlns:a="http://schemas.openxmlformats.org/drawingml/2006/main">
               <a:ext uri="{FF2B5EF4-FFF2-40B4-BE49-F238E27FC236}">
-                <a16:creationId xmlns:a16="http://schemas.microsoft.com/office/drawing/2014/main" id="{3E047904-6F34-41C2-8AA2-9B880E36754C}"/>
+                <a16:creationId xmlns:a16="http://schemas.microsoft.com/office/drawing/2014/main" id="{D02D8AC3-878C-4BA6-AE96-794098F96A83}"/>
               </a:ext>
             </a:extLst>
           </p:cNvPr>
@@ -12510,7 +12510,7 @@
           <p:cNvPr id="15" name="TextBox 14">
             <a:extLst xmlns:a="http://schemas.openxmlformats.org/drawingml/2006/main">
               <a:ext uri="{FF2B5EF4-FFF2-40B4-BE49-F238E27FC236}">
-                <a16:creationId xmlns:a16="http://schemas.microsoft.com/office/drawing/2014/main" id="{850ABC25-24F8-4CB8-8DAD-A19B8531512F}"/>
+                <a16:creationId xmlns:a16="http://schemas.microsoft.com/office/drawing/2014/main" id="{40BA0B04-93C7-4E78-BAD3-098920B7F8D4}"/>
               </a:ext>
             </a:extLst>
           </p:cNvPr>
@@ -12557,7 +12557,7 @@
           <p:cNvPr id="16" name="TextBox 15">
             <a:extLst xmlns:a="http://schemas.openxmlformats.org/drawingml/2006/main">
               <a:ext uri="{FF2B5EF4-FFF2-40B4-BE49-F238E27FC236}">
-                <a16:creationId xmlns:a16="http://schemas.microsoft.com/office/drawing/2014/main" id="{52CD0FC0-7129-487B-BCF8-EEBF7430EB50}"/>
+                <a16:creationId xmlns:a16="http://schemas.microsoft.com/office/drawing/2014/main" id="{32F2D01B-62D5-4E0F-918C-D6EC1EE9F58F}"/>
               </a:ext>
             </a:extLst>
           </p:cNvPr>
@@ -12604,7 +12604,7 @@
           <p:cNvPr id="17" name="TextBox 16">
             <a:extLst xmlns:a="http://schemas.openxmlformats.org/drawingml/2006/main">
               <a:ext uri="{FF2B5EF4-FFF2-40B4-BE49-F238E27FC236}">
-                <a16:creationId xmlns:a16="http://schemas.microsoft.com/office/drawing/2014/main" id="{869F35DA-87C0-4667-9670-FE35E6112A7C}"/>
+                <a16:creationId xmlns:a16="http://schemas.microsoft.com/office/drawing/2014/main" id="{3B401416-7017-4B48-9D97-127BF86D87C1}"/>
               </a:ext>
             </a:extLst>
           </p:cNvPr>
@@ -12651,7 +12651,7 @@
           <p:cNvPr id="18" name="Rounded Rectangle 17">
             <a:extLst xmlns:a="http://schemas.openxmlformats.org/drawingml/2006/main">
               <a:ext uri="{FF2B5EF4-FFF2-40B4-BE49-F238E27FC236}">
-                <a16:creationId xmlns:a16="http://schemas.microsoft.com/office/drawing/2014/main" id="{26111FC8-D795-4B83-8826-6913A533DA9D}"/>
+                <a16:creationId xmlns:a16="http://schemas.microsoft.com/office/drawing/2014/main" id="{96AA97BB-C316-49B9-9D3E-4D3BE0F37440}"/>
               </a:ext>
             </a:extLst>
           </p:cNvPr>
@@ -12708,7 +12708,7 @@
           <p:cNvPr id="19" name="TextBox 18">
             <a:extLst xmlns:a="http://schemas.openxmlformats.org/drawingml/2006/main">
               <a:ext uri="{FF2B5EF4-FFF2-40B4-BE49-F238E27FC236}">
-                <a16:creationId xmlns:a16="http://schemas.microsoft.com/office/drawing/2014/main" id="{B86C0D5A-C8AA-46A4-BAE2-9622739FA2F7}"/>
+                <a16:creationId xmlns:a16="http://schemas.microsoft.com/office/drawing/2014/main" id="{C827DCE2-8D3A-4399-B793-10CC928074FA}"/>
               </a:ext>
             </a:extLst>
           </p:cNvPr>
@@ -12755,7 +12755,7 @@
           <p:cNvPr id="20" name="TextBox 19">
             <a:extLst xmlns:a="http://schemas.openxmlformats.org/drawingml/2006/main">
               <a:ext uri="{FF2B5EF4-FFF2-40B4-BE49-F238E27FC236}">
-                <a16:creationId xmlns:a16="http://schemas.microsoft.com/office/drawing/2014/main" id="{8F2C4628-2A03-4E1B-B695-C45CB95F6E61}"/>
+                <a16:creationId xmlns:a16="http://schemas.microsoft.com/office/drawing/2014/main" id="{910C61FB-76AC-422C-961F-1D6D000EB342}"/>
               </a:ext>
             </a:extLst>
           </p:cNvPr>
@@ -12800,7 +12800,7 @@
     </p:spTree>
     <p:extLst>
       <p:ext uri="{BB962C8B-B14F-4D97-AF65-F5344CB8AC3E}">
-        <p14:creationId xmlns:p14="http://schemas.microsoft.com/office/powerpoint/2010/main" val="1271372671"/>
+        <p14:creationId xmlns:p14="http://schemas.microsoft.com/office/powerpoint/2010/main" val="1430062123"/>
       </p:ext>
     </p:extLst>
   </p:cSld>
@@ -12824,7 +12824,7 @@
           <p:cNvPr id="2" name="TextBox 1">
             <a:extLst xmlns:a="http://schemas.openxmlformats.org/drawingml/2006/main">
               <a:ext uri="{FF2B5EF4-FFF2-40B4-BE49-F238E27FC236}">
-                <a16:creationId xmlns:a16="http://schemas.microsoft.com/office/drawing/2014/main" id="{C229B36F-ADD8-448A-A132-96B9F4601926}"/>
+                <a16:creationId xmlns:a16="http://schemas.microsoft.com/office/drawing/2014/main" id="{FD217578-01DA-4DE8-8C33-2D283584B851}"/>
               </a:ext>
             </a:extLst>
           </p:cNvPr>
@@ -12871,7 +12871,7 @@
           <p:cNvPr id="3" name="TextBox 2">
             <a:extLst xmlns:a="http://schemas.openxmlformats.org/drawingml/2006/main">
               <a:ext uri="{FF2B5EF4-FFF2-40B4-BE49-F238E27FC236}">
-                <a16:creationId xmlns:a16="http://schemas.microsoft.com/office/drawing/2014/main" id="{431A3CDD-6D82-4663-BD7C-DECE72B8E945}"/>
+                <a16:creationId xmlns:a16="http://schemas.microsoft.com/office/drawing/2014/main" id="{50ABDEF3-4CD1-4C6D-B5C9-041006B43356}"/>
               </a:ext>
             </a:extLst>
           </p:cNvPr>
@@ -12918,7 +12918,7 @@
           <p:cNvPr id="4" name="Rectangle 3">
             <a:extLst xmlns:a="http://schemas.openxmlformats.org/drawingml/2006/main">
               <a:ext uri="{FF2B5EF4-FFF2-40B4-BE49-F238E27FC236}">
-                <a16:creationId xmlns:a16="http://schemas.microsoft.com/office/drawing/2014/main" id="{3CF9ED73-4A90-40CD-B104-A47B95F2DABD}"/>
+                <a16:creationId xmlns:a16="http://schemas.microsoft.com/office/drawing/2014/main" id="{794D1202-4482-4E7A-BCDF-AB1FFE49BFF8}"/>
               </a:ext>
             </a:extLst>
           </p:cNvPr>
@@ -12973,7 +12973,7 @@
           <p:cNvPr id="5" name="Rectangle 4">
             <a:extLst xmlns:a="http://schemas.openxmlformats.org/drawingml/2006/main">
               <a:ext uri="{FF2B5EF4-FFF2-40B4-BE49-F238E27FC236}">
-                <a16:creationId xmlns:a16="http://schemas.microsoft.com/office/drawing/2014/main" id="{E3D23BC4-7C61-4C4E-893A-2C61B47E6118}"/>
+                <a16:creationId xmlns:a16="http://schemas.microsoft.com/office/drawing/2014/main" id="{44CD4CC4-424E-4495-B4AA-44F2CC52A199}"/>
               </a:ext>
             </a:extLst>
           </p:cNvPr>
@@ -13028,7 +13028,7 @@
           <p:cNvPr id="6" name="TextBox 5">
             <a:extLst xmlns:a="http://schemas.openxmlformats.org/drawingml/2006/main">
               <a:ext uri="{FF2B5EF4-FFF2-40B4-BE49-F238E27FC236}">
-                <a16:creationId xmlns:a16="http://schemas.microsoft.com/office/drawing/2014/main" id="{C58C4548-3DFD-49CC-8425-5D7627122317}"/>
+                <a16:creationId xmlns:a16="http://schemas.microsoft.com/office/drawing/2014/main" id="{F1C91BB2-610C-4C21-A498-3AE2F4C26B88}"/>
               </a:ext>
             </a:extLst>
           </p:cNvPr>
@@ -13065,7 +13065,7 @@
                 <a:ea typeface="Aptos"/>
                 <a:cs typeface="Aptos"/>
               </a:rPr>
-              <a:t>Independent public evidence summary · 2026.07.22-9 · 2026-07-22 · Sources: IMARC; GVR; Fortune</a:t>
+              <a:t>Independent public evidence summary · 2026.07.23-10 · 2026-07-22 · Sources: IMARC; GVR; Fortune</a:t>
             </a:r>
           </a:p>
         </p:txBody>
@@ -13075,7 +13075,7 @@
           <p:cNvPr id="7" name="TextBox 6">
             <a:extLst xmlns:a="http://schemas.openxmlformats.org/drawingml/2006/main">
               <a:ext uri="{FF2B5EF4-FFF2-40B4-BE49-F238E27FC236}">
-                <a16:creationId xmlns:a16="http://schemas.microsoft.com/office/drawing/2014/main" id="{2281D780-4AE8-4221-90AF-9EB2D3B8C6CF}"/>
+                <a16:creationId xmlns:a16="http://schemas.microsoft.com/office/drawing/2014/main" id="{739C2251-77E1-41F1-96D5-E647CAF920BC}"/>
               </a:ext>
             </a:extLst>
           </p:cNvPr>
@@ -13122,7 +13122,7 @@
           <p:cNvPr id="8" name="Rounded Rectangle 7">
             <a:extLst xmlns:a="http://schemas.openxmlformats.org/drawingml/2006/main">
               <a:ext uri="{FF2B5EF4-FFF2-40B4-BE49-F238E27FC236}">
-                <a16:creationId xmlns:a16="http://schemas.microsoft.com/office/drawing/2014/main" id="{2B25AD0D-711B-4DB8-96F3-21597C0B1EF6}"/>
+                <a16:creationId xmlns:a16="http://schemas.microsoft.com/office/drawing/2014/main" id="{470B9D91-512A-40A7-9D2D-940FFB61BDF8}"/>
               </a:ext>
             </a:extLst>
           </p:cNvPr>
@@ -13179,7 +13179,7 @@
           <p:cNvPr id="9" name="TextBox 8">
             <a:extLst xmlns:a="http://schemas.openxmlformats.org/drawingml/2006/main">
               <a:ext uri="{FF2B5EF4-FFF2-40B4-BE49-F238E27FC236}">
-                <a16:creationId xmlns:a16="http://schemas.microsoft.com/office/drawing/2014/main" id="{6AC812A5-3882-44E0-8BF5-6FD7A5D6E753}"/>
+                <a16:creationId xmlns:a16="http://schemas.microsoft.com/office/drawing/2014/main" id="{E473EE61-65BA-4D6F-9CCC-4063E5E63963}"/>
               </a:ext>
             </a:extLst>
           </p:cNvPr>
@@ -13226,7 +13226,7 @@
           <p:cNvPr id="10" name="TextBox 9">
             <a:extLst xmlns:a="http://schemas.openxmlformats.org/drawingml/2006/main">
               <a:ext uri="{FF2B5EF4-FFF2-40B4-BE49-F238E27FC236}">
-                <a16:creationId xmlns:a16="http://schemas.microsoft.com/office/drawing/2014/main" id="{93AD0DFA-41AE-45D1-9FFD-3878EA029822}"/>
+                <a16:creationId xmlns:a16="http://schemas.microsoft.com/office/drawing/2014/main" id="{D93C8705-2BE4-4B41-8D2D-6C445BBF6C0E}"/>
               </a:ext>
             </a:extLst>
           </p:cNvPr>
@@ -13273,7 +13273,7 @@
           <p:cNvPr id="11" name="Rounded Rectangle 10">
             <a:extLst xmlns:a="http://schemas.openxmlformats.org/drawingml/2006/main">
               <a:ext uri="{FF2B5EF4-FFF2-40B4-BE49-F238E27FC236}">
-                <a16:creationId xmlns:a16="http://schemas.microsoft.com/office/drawing/2014/main" id="{363B09AB-D724-47F5-9A98-FDAFDC8F6B2F}"/>
+                <a16:creationId xmlns:a16="http://schemas.microsoft.com/office/drawing/2014/main" id="{F131B95F-772B-49F8-90F4-CBA5F011397C}"/>
               </a:ext>
             </a:extLst>
           </p:cNvPr>
@@ -13330,7 +13330,7 @@
           <p:cNvPr id="12" name="TextBox 11">
             <a:extLst xmlns:a="http://schemas.openxmlformats.org/drawingml/2006/main">
               <a:ext uri="{FF2B5EF4-FFF2-40B4-BE49-F238E27FC236}">
-                <a16:creationId xmlns:a16="http://schemas.microsoft.com/office/drawing/2014/main" id="{BEE580FC-3BE2-41CB-80BA-EA7BBB6A113E}"/>
+                <a16:creationId xmlns:a16="http://schemas.microsoft.com/office/drawing/2014/main" id="{1FFB7506-7E83-4184-8DC0-E3219C8D1F15}"/>
               </a:ext>
             </a:extLst>
           </p:cNvPr>
@@ -13377,7 +13377,7 @@
           <p:cNvPr id="13" name="TextBox 12">
             <a:extLst xmlns:a="http://schemas.openxmlformats.org/drawingml/2006/main">
               <a:ext uri="{FF2B5EF4-FFF2-40B4-BE49-F238E27FC236}">
-                <a16:creationId xmlns:a16="http://schemas.microsoft.com/office/drawing/2014/main" id="{C987D544-558B-4239-944D-3CBB53C5A73F}"/>
+                <a16:creationId xmlns:a16="http://schemas.microsoft.com/office/drawing/2014/main" id="{52A8C069-8589-4907-B994-F8C7FD23B959}"/>
               </a:ext>
             </a:extLst>
           </p:cNvPr>
@@ -13424,7 +13424,7 @@
           <p:cNvPr id="14" name="Rounded Rectangle 13">
             <a:extLst xmlns:a="http://schemas.openxmlformats.org/drawingml/2006/main">
               <a:ext uri="{FF2B5EF4-FFF2-40B4-BE49-F238E27FC236}">
-                <a16:creationId xmlns:a16="http://schemas.microsoft.com/office/drawing/2014/main" id="{151FEDD6-FBE1-4637-8A26-C86EAAF81675}"/>
+                <a16:creationId xmlns:a16="http://schemas.microsoft.com/office/drawing/2014/main" id="{A76AFE75-A97A-46DC-B124-07395D3F678B}"/>
               </a:ext>
             </a:extLst>
           </p:cNvPr>
@@ -13481,7 +13481,7 @@
           <p:cNvPr id="15" name="TextBox 14">
             <a:extLst xmlns:a="http://schemas.openxmlformats.org/drawingml/2006/main">
               <a:ext uri="{FF2B5EF4-FFF2-40B4-BE49-F238E27FC236}">
-                <a16:creationId xmlns:a16="http://schemas.microsoft.com/office/drawing/2014/main" id="{6F7BCBAA-4A86-4410-868C-DFB317B33810}"/>
+                <a16:creationId xmlns:a16="http://schemas.microsoft.com/office/drawing/2014/main" id="{96767EF8-6653-4628-B8C3-6829045EDAEF}"/>
               </a:ext>
             </a:extLst>
           </p:cNvPr>
@@ -13528,7 +13528,7 @@
           <p:cNvPr id="16" name="TextBox 15">
             <a:extLst xmlns:a="http://schemas.openxmlformats.org/drawingml/2006/main">
               <a:ext uri="{FF2B5EF4-FFF2-40B4-BE49-F238E27FC236}">
-                <a16:creationId xmlns:a16="http://schemas.microsoft.com/office/drawing/2014/main" id="{9732CA8D-9729-48CD-B0C2-DF7445909630}"/>
+                <a16:creationId xmlns:a16="http://schemas.microsoft.com/office/drawing/2014/main" id="{C8E0F251-10E6-4041-B9D2-C18D3E4BEED6}"/>
               </a:ext>
             </a:extLst>
           </p:cNvPr>
@@ -13575,7 +13575,7 @@
           <p:cNvPr id="17" name="TextBox 16">
             <a:extLst xmlns:a="http://schemas.openxmlformats.org/drawingml/2006/main">
               <a:ext uri="{FF2B5EF4-FFF2-40B4-BE49-F238E27FC236}">
-                <a16:creationId xmlns:a16="http://schemas.microsoft.com/office/drawing/2014/main" id="{BE0146A5-8DE9-45C4-81A8-494057C0817B}"/>
+                <a16:creationId xmlns:a16="http://schemas.microsoft.com/office/drawing/2014/main" id="{F5F1C193-8FEB-4CB0-A30C-9B6DE69AAB3A}"/>
               </a:ext>
             </a:extLst>
           </p:cNvPr>
@@ -13622,7 +13622,7 @@
           <p:cNvPr id="18" name="Rounded Rectangle 17">
             <a:extLst xmlns:a="http://schemas.openxmlformats.org/drawingml/2006/main">
               <a:ext uri="{FF2B5EF4-FFF2-40B4-BE49-F238E27FC236}">
-                <a16:creationId xmlns:a16="http://schemas.microsoft.com/office/drawing/2014/main" id="{27C64C26-A5FD-48CB-A1B6-AF131505DB20}"/>
+                <a16:creationId xmlns:a16="http://schemas.microsoft.com/office/drawing/2014/main" id="{08527326-9664-44DF-8B2F-ED17B458533E}"/>
               </a:ext>
             </a:extLst>
           </p:cNvPr>
@@ -13679,7 +13679,7 @@
           <p:cNvPr id="19" name="TextBox 18">
             <a:extLst xmlns:a="http://schemas.openxmlformats.org/drawingml/2006/main">
               <a:ext uri="{FF2B5EF4-FFF2-40B4-BE49-F238E27FC236}">
-                <a16:creationId xmlns:a16="http://schemas.microsoft.com/office/drawing/2014/main" id="{5A981EE0-44D7-4586-A798-348C3254D1A2}"/>
+                <a16:creationId xmlns:a16="http://schemas.microsoft.com/office/drawing/2014/main" id="{88A574FC-A8D5-43DA-ADDB-4C6F9C92967F}"/>
               </a:ext>
             </a:extLst>
           </p:cNvPr>
@@ -13726,7 +13726,7 @@
           <p:cNvPr id="20" name="TextBox 19">
             <a:extLst xmlns:a="http://schemas.openxmlformats.org/drawingml/2006/main">
               <a:ext uri="{FF2B5EF4-FFF2-40B4-BE49-F238E27FC236}">
-                <a16:creationId xmlns:a16="http://schemas.microsoft.com/office/drawing/2014/main" id="{815DE90E-B6CF-44AE-BB9B-85BB44E90294}"/>
+                <a16:creationId xmlns:a16="http://schemas.microsoft.com/office/drawing/2014/main" id="{BA18639B-EE8B-497E-A0D5-ACBA4173CD7C}"/>
               </a:ext>
             </a:extLst>
           </p:cNvPr>
@@ -13771,7 +13771,7 @@
     </p:spTree>
     <p:extLst>
       <p:ext uri="{BB962C8B-B14F-4D97-AF65-F5344CB8AC3E}">
-        <p14:creationId xmlns:p14="http://schemas.microsoft.com/office/powerpoint/2010/main" val="1895678815"/>
+        <p14:creationId xmlns:p14="http://schemas.microsoft.com/office/powerpoint/2010/main" val="1433827433"/>
       </p:ext>
     </p:extLst>
   </p:cSld>
@@ -13795,7 +13795,7 @@
           <p:cNvPr id="2" name="TextBox 1">
             <a:extLst xmlns:a="http://schemas.openxmlformats.org/drawingml/2006/main">
               <a:ext uri="{FF2B5EF4-FFF2-40B4-BE49-F238E27FC236}">
-                <a16:creationId xmlns:a16="http://schemas.microsoft.com/office/drawing/2014/main" id="{1F831B8E-E069-4611-AD04-D221DC648A91}"/>
+                <a16:creationId xmlns:a16="http://schemas.microsoft.com/office/drawing/2014/main" id="{6C4BA9EF-103C-4E31-991C-1E52B5DF366B}"/>
               </a:ext>
             </a:extLst>
           </p:cNvPr>
@@ -13842,7 +13842,7 @@
           <p:cNvPr id="3" name="TextBox 2">
             <a:extLst xmlns:a="http://schemas.openxmlformats.org/drawingml/2006/main">
               <a:ext uri="{FF2B5EF4-FFF2-40B4-BE49-F238E27FC236}">
-                <a16:creationId xmlns:a16="http://schemas.microsoft.com/office/drawing/2014/main" id="{3BCD15DD-51C6-4CA5-8D4A-0429095160D3}"/>
+                <a16:creationId xmlns:a16="http://schemas.microsoft.com/office/drawing/2014/main" id="{EB0F104D-F8B5-49E1-9957-CC27123FCBAD}"/>
               </a:ext>
             </a:extLst>
           </p:cNvPr>
@@ -13889,7 +13889,7 @@
           <p:cNvPr id="4" name="Rectangle 3">
             <a:extLst xmlns:a="http://schemas.openxmlformats.org/drawingml/2006/main">
               <a:ext uri="{FF2B5EF4-FFF2-40B4-BE49-F238E27FC236}">
-                <a16:creationId xmlns:a16="http://schemas.microsoft.com/office/drawing/2014/main" id="{D0B202DD-88BF-4FC3-8B8A-FF6A3AB9DCDB}"/>
+                <a16:creationId xmlns:a16="http://schemas.microsoft.com/office/drawing/2014/main" id="{946DCCDC-CBA5-416E-8DDC-CC87CE9B1EA9}"/>
               </a:ext>
             </a:extLst>
           </p:cNvPr>
@@ -13944,7 +13944,7 @@
           <p:cNvPr id="5" name="Rectangle 4">
             <a:extLst xmlns:a="http://schemas.openxmlformats.org/drawingml/2006/main">
               <a:ext uri="{FF2B5EF4-FFF2-40B4-BE49-F238E27FC236}">
-                <a16:creationId xmlns:a16="http://schemas.microsoft.com/office/drawing/2014/main" id="{F9D2F74B-D744-4CAE-AAF6-1DAA04808FA0}"/>
+                <a16:creationId xmlns:a16="http://schemas.microsoft.com/office/drawing/2014/main" id="{B714FBA5-B69A-45B9-8410-070166C55A94}"/>
               </a:ext>
             </a:extLst>
           </p:cNvPr>
@@ -13999,7 +13999,7 @@
           <p:cNvPr id="6" name="TextBox 5">
             <a:extLst xmlns:a="http://schemas.openxmlformats.org/drawingml/2006/main">
               <a:ext uri="{FF2B5EF4-FFF2-40B4-BE49-F238E27FC236}">
-                <a16:creationId xmlns:a16="http://schemas.microsoft.com/office/drawing/2014/main" id="{CCB28205-8763-462C-A07F-A7FD543B09DF}"/>
+                <a16:creationId xmlns:a16="http://schemas.microsoft.com/office/drawing/2014/main" id="{140472B7-7607-48AE-8B31-D16481EFADC9}"/>
               </a:ext>
             </a:extLst>
           </p:cNvPr>
@@ -14036,7 +14036,7 @@
                 <a:ea typeface="Aptos"/>
                 <a:cs typeface="Aptos"/>
               </a:rPr>
-              <a:t>Independent public evidence summary · 2026.07.22-9 · 2026-07-22 · Sources: Market-values model; Readiness</a:t>
+              <a:t>Independent public evidence summary · 2026.07.23-10 · 2026-07-22 · Sources: Market-values model; Readiness</a:t>
             </a:r>
           </a:p>
         </p:txBody>
@@ -14046,7 +14046,7 @@
           <p:cNvPr id="7" name="TextBox 6">
             <a:extLst xmlns:a="http://schemas.openxmlformats.org/drawingml/2006/main">
               <a:ext uri="{FF2B5EF4-FFF2-40B4-BE49-F238E27FC236}">
-                <a16:creationId xmlns:a16="http://schemas.microsoft.com/office/drawing/2014/main" id="{0401AC9C-3941-491F-95DE-87580D8DB315}"/>
+                <a16:creationId xmlns:a16="http://schemas.microsoft.com/office/drawing/2014/main" id="{30D373F4-E33C-4B49-9730-B559981EB31B}"/>
               </a:ext>
             </a:extLst>
           </p:cNvPr>
@@ -14093,7 +14093,7 @@
           <p:cNvPr id="8" name="TextBox 7">
             <a:extLst xmlns:a="http://schemas.openxmlformats.org/drawingml/2006/main">
               <a:ext uri="{FF2B5EF4-FFF2-40B4-BE49-F238E27FC236}">
-                <a16:creationId xmlns:a16="http://schemas.microsoft.com/office/drawing/2014/main" id="{88748D64-7F67-41A5-8A0E-553CB57C7F0B}"/>
+                <a16:creationId xmlns:a16="http://schemas.microsoft.com/office/drawing/2014/main" id="{82EA0CF3-19D1-43EE-9A4E-DF5764CDF7B5}"/>
               </a:ext>
             </a:extLst>
           </p:cNvPr>
@@ -14140,7 +14140,7 @@
           <p:cNvPr id="9" name="TextBox 8">
             <a:extLst xmlns:a="http://schemas.openxmlformats.org/drawingml/2006/main">
               <a:ext uri="{FF2B5EF4-FFF2-40B4-BE49-F238E27FC236}">
-                <a16:creationId xmlns:a16="http://schemas.microsoft.com/office/drawing/2014/main" id="{03E2C2D2-4656-4191-814B-55BD3542E2B7}"/>
+                <a16:creationId xmlns:a16="http://schemas.microsoft.com/office/drawing/2014/main" id="{5BC97264-EE73-4ED2-9C7E-DFD89D021994}"/>
               </a:ext>
             </a:extLst>
           </p:cNvPr>
@@ -14237,7 +14237,7 @@
           <p:cNvPr id="10" name="Rounded Rectangle 9">
             <a:extLst xmlns:a="http://schemas.openxmlformats.org/drawingml/2006/main">
               <a:ext uri="{FF2B5EF4-FFF2-40B4-BE49-F238E27FC236}">
-                <a16:creationId xmlns:a16="http://schemas.microsoft.com/office/drawing/2014/main" id="{2C6EFA9B-D7E2-45F5-B863-CE4333356FE2}"/>
+                <a16:creationId xmlns:a16="http://schemas.microsoft.com/office/drawing/2014/main" id="{885825C2-4F03-4E84-ABAE-13959A01456E}"/>
               </a:ext>
             </a:extLst>
           </p:cNvPr>
@@ -14294,7 +14294,7 @@
           <p:cNvPr id="11" name="TextBox 10">
             <a:extLst xmlns:a="http://schemas.openxmlformats.org/drawingml/2006/main">
               <a:ext uri="{FF2B5EF4-FFF2-40B4-BE49-F238E27FC236}">
-                <a16:creationId xmlns:a16="http://schemas.microsoft.com/office/drawing/2014/main" id="{F12B3CAF-6D23-43A6-B492-7C2B68EFF10F}"/>
+                <a16:creationId xmlns:a16="http://schemas.microsoft.com/office/drawing/2014/main" id="{6EF8DCBA-1F4A-4C84-B805-49B12D3DEF60}"/>
               </a:ext>
             </a:extLst>
           </p:cNvPr>
@@ -14341,7 +14341,7 @@
           <p:cNvPr id="12" name="TextBox 11">
             <a:extLst xmlns:a="http://schemas.openxmlformats.org/drawingml/2006/main">
               <a:ext uri="{FF2B5EF4-FFF2-40B4-BE49-F238E27FC236}">
-                <a16:creationId xmlns:a16="http://schemas.microsoft.com/office/drawing/2014/main" id="{9E38F901-F568-47CE-8998-4437DB276547}"/>
+                <a16:creationId xmlns:a16="http://schemas.microsoft.com/office/drawing/2014/main" id="{6F182AFF-4BD3-4CF7-A62A-2DF26FB55273}"/>
               </a:ext>
             </a:extLst>
           </p:cNvPr>
@@ -14386,7 +14386,7 @@
     </p:spTree>
     <p:extLst>
       <p:ext uri="{BB962C8B-B14F-4D97-AF65-F5344CB8AC3E}">
-        <p14:creationId xmlns:p14="http://schemas.microsoft.com/office/powerpoint/2010/main" val="1580677065"/>
+        <p14:creationId xmlns:p14="http://schemas.microsoft.com/office/powerpoint/2010/main" val="1242436755"/>
       </p:ext>
     </p:extLst>
   </p:cSld>
@@ -14410,7 +14410,7 @@
           <p:cNvPr id="2" name="TextBox 1">
             <a:extLst xmlns:a="http://schemas.openxmlformats.org/drawingml/2006/main">
               <a:ext uri="{FF2B5EF4-FFF2-40B4-BE49-F238E27FC236}">
-                <a16:creationId xmlns:a16="http://schemas.microsoft.com/office/drawing/2014/main" id="{2A5B3AA2-A87C-4ACC-A10C-3A4329CD4ED2}"/>
+                <a16:creationId xmlns:a16="http://schemas.microsoft.com/office/drawing/2014/main" id="{8F4EBEC0-55CC-4675-B63B-34BAAF0D0EFD}"/>
               </a:ext>
             </a:extLst>
           </p:cNvPr>
@@ -14457,7 +14457,7 @@
           <p:cNvPr id="3" name="TextBox 2">
             <a:extLst xmlns:a="http://schemas.openxmlformats.org/drawingml/2006/main">
               <a:ext uri="{FF2B5EF4-FFF2-40B4-BE49-F238E27FC236}">
-                <a16:creationId xmlns:a16="http://schemas.microsoft.com/office/drawing/2014/main" id="{9511DD69-22BC-4A78-99A5-701262F17E00}"/>
+                <a16:creationId xmlns:a16="http://schemas.microsoft.com/office/drawing/2014/main" id="{F18EEF3B-CF7D-4FBD-870F-013E0F6D9489}"/>
               </a:ext>
             </a:extLst>
           </p:cNvPr>
@@ -14504,7 +14504,7 @@
           <p:cNvPr id="4" name="Rectangle 3">
             <a:extLst xmlns:a="http://schemas.openxmlformats.org/drawingml/2006/main">
               <a:ext uri="{FF2B5EF4-FFF2-40B4-BE49-F238E27FC236}">
-                <a16:creationId xmlns:a16="http://schemas.microsoft.com/office/drawing/2014/main" id="{15EC310A-1BCF-41DA-9A5A-08506308C2AF}"/>
+                <a16:creationId xmlns:a16="http://schemas.microsoft.com/office/drawing/2014/main" id="{08995396-9A8D-4922-8283-6C7482765D6F}"/>
               </a:ext>
             </a:extLst>
           </p:cNvPr>
@@ -14559,7 +14559,7 @@
           <p:cNvPr id="5" name="Rectangle 4">
             <a:extLst xmlns:a="http://schemas.openxmlformats.org/drawingml/2006/main">
               <a:ext uri="{FF2B5EF4-FFF2-40B4-BE49-F238E27FC236}">
-                <a16:creationId xmlns:a16="http://schemas.microsoft.com/office/drawing/2014/main" id="{74FD007A-F5A1-4410-B085-08B7210C1501}"/>
+                <a16:creationId xmlns:a16="http://schemas.microsoft.com/office/drawing/2014/main" id="{0756A4A4-F326-4BFD-9C14-6CF1B2330F29}"/>
               </a:ext>
             </a:extLst>
           </p:cNvPr>
@@ -14614,7 +14614,7 @@
           <p:cNvPr id="6" name="TextBox 5">
             <a:extLst xmlns:a="http://schemas.openxmlformats.org/drawingml/2006/main">
               <a:ext uri="{FF2B5EF4-FFF2-40B4-BE49-F238E27FC236}">
-                <a16:creationId xmlns:a16="http://schemas.microsoft.com/office/drawing/2014/main" id="{2AFF42F9-239E-4E74-895A-201218BC4EA3}"/>
+                <a16:creationId xmlns:a16="http://schemas.microsoft.com/office/drawing/2014/main" id="{2767A7B3-C055-4F10-BEB6-A6EA6E25C310}"/>
               </a:ext>
             </a:extLst>
           </p:cNvPr>
@@ -14651,7 +14651,7 @@
                 <a:ea typeface="Aptos"/>
                 <a:cs typeface="Aptos"/>
               </a:rPr>
-              <a:t>Independent public evidence summary · 2026.07.22-9 · 2026-07-22 · Sources: WIPO valuation; Evidence Register</a:t>
+              <a:t>Independent public evidence summary · 2026.07.23-10 · 2026-07-22 · Sources: WIPO valuation; Evidence Register</a:t>
             </a:r>
           </a:p>
         </p:txBody>
@@ -14661,7 +14661,7 @@
           <p:cNvPr id="7" name="TextBox 6">
             <a:extLst xmlns:a="http://schemas.openxmlformats.org/drawingml/2006/main">
               <a:ext uri="{FF2B5EF4-FFF2-40B4-BE49-F238E27FC236}">
-                <a16:creationId xmlns:a16="http://schemas.microsoft.com/office/drawing/2014/main" id="{27BD48C3-50F6-49A6-9117-3013839647D1}"/>
+                <a16:creationId xmlns:a16="http://schemas.microsoft.com/office/drawing/2014/main" id="{1EB2D229-CC61-436F-9CBD-168C2AEB57F5}"/>
               </a:ext>
             </a:extLst>
           </p:cNvPr>
@@ -15231,7 +15231,7 @@
           <p:cNvPr id="9" name="TextBox 8">
             <a:extLst xmlns:a="http://schemas.openxmlformats.org/drawingml/2006/main">
               <a:ext uri="{FF2B5EF4-FFF2-40B4-BE49-F238E27FC236}">
-                <a16:creationId xmlns:a16="http://schemas.microsoft.com/office/drawing/2014/main" id="{77EF4077-30F4-459E-A417-B46ED985223A}"/>
+                <a16:creationId xmlns:a16="http://schemas.microsoft.com/office/drawing/2014/main" id="{039F17CC-9FF2-4693-8D2A-673C46E161B2}"/>
               </a:ext>
             </a:extLst>
           </p:cNvPr>
@@ -15276,7 +15276,7 @@
     </p:spTree>
     <p:extLst>
       <p:ext uri="{BB962C8B-B14F-4D97-AF65-F5344CB8AC3E}">
-        <p14:creationId xmlns:p14="http://schemas.microsoft.com/office/powerpoint/2010/main" val="794536450"/>
+        <p14:creationId xmlns:p14="http://schemas.microsoft.com/office/powerpoint/2010/main" val="250185763"/>
       </p:ext>
     </p:extLst>
   </p:cSld>
@@ -15300,7 +15300,7 @@
           <p:cNvPr id="2" name="TextBox 1">
             <a:extLst xmlns:a="http://schemas.openxmlformats.org/drawingml/2006/main">
               <a:ext uri="{FF2B5EF4-FFF2-40B4-BE49-F238E27FC236}">
-                <a16:creationId xmlns:a16="http://schemas.microsoft.com/office/drawing/2014/main" id="{C8BF708A-6AB5-4B48-AD32-E938D4806647}"/>
+                <a16:creationId xmlns:a16="http://schemas.microsoft.com/office/drawing/2014/main" id="{F7C8FF39-751A-4200-9F16-20B0BC90328E}"/>
               </a:ext>
             </a:extLst>
           </p:cNvPr>
@@ -15347,7 +15347,7 @@
           <p:cNvPr id="3" name="TextBox 2">
             <a:extLst xmlns:a="http://schemas.openxmlformats.org/drawingml/2006/main">
               <a:ext uri="{FF2B5EF4-FFF2-40B4-BE49-F238E27FC236}">
-                <a16:creationId xmlns:a16="http://schemas.microsoft.com/office/drawing/2014/main" id="{039C45E1-6C21-47AD-A1C3-5122F19354EA}"/>
+                <a16:creationId xmlns:a16="http://schemas.microsoft.com/office/drawing/2014/main" id="{9DA8EA9C-3A11-42CD-B3FC-508113312D87}"/>
               </a:ext>
             </a:extLst>
           </p:cNvPr>
@@ -15394,7 +15394,7 @@
           <p:cNvPr id="4" name="Rectangle 3">
             <a:extLst xmlns:a="http://schemas.openxmlformats.org/drawingml/2006/main">
               <a:ext uri="{FF2B5EF4-FFF2-40B4-BE49-F238E27FC236}">
-                <a16:creationId xmlns:a16="http://schemas.microsoft.com/office/drawing/2014/main" id="{840B5AF4-9F53-4FDC-B047-458C80F0DD45}"/>
+                <a16:creationId xmlns:a16="http://schemas.microsoft.com/office/drawing/2014/main" id="{119D40D6-A876-4FE0-85A8-AD7B0834378B}"/>
               </a:ext>
             </a:extLst>
           </p:cNvPr>
@@ -15449,7 +15449,7 @@
           <p:cNvPr id="5" name="Rectangle 4">
             <a:extLst xmlns:a="http://schemas.openxmlformats.org/drawingml/2006/main">
               <a:ext uri="{FF2B5EF4-FFF2-40B4-BE49-F238E27FC236}">
-                <a16:creationId xmlns:a16="http://schemas.microsoft.com/office/drawing/2014/main" id="{6A4302CE-C91C-434B-8AF2-F0A8848A70F5}"/>
+                <a16:creationId xmlns:a16="http://schemas.microsoft.com/office/drawing/2014/main" id="{E77C1875-5E33-414C-8E75-4066E26F92A4}"/>
               </a:ext>
             </a:extLst>
           </p:cNvPr>
@@ -15504,7 +15504,7 @@
           <p:cNvPr id="6" name="TextBox 5">
             <a:extLst xmlns:a="http://schemas.openxmlformats.org/drawingml/2006/main">
               <a:ext uri="{FF2B5EF4-FFF2-40B4-BE49-F238E27FC236}">
-                <a16:creationId xmlns:a16="http://schemas.microsoft.com/office/drawing/2014/main" id="{2703433C-8A53-4E93-86E4-1AA8F94952DB}"/>
+                <a16:creationId xmlns:a16="http://schemas.microsoft.com/office/drawing/2014/main" id="{35BA8125-2460-4189-AF49-9D6BC9F21EBA}"/>
               </a:ext>
             </a:extLst>
           </p:cNvPr>
@@ -15541,7 +15541,7 @@
                 <a:ea typeface="Aptos"/>
                 <a:cs typeface="Aptos"/>
               </a:rPr>
-              <a:t>Independent public evidence summary · 2026.07.22-9 · 2026-07-22 · Sources: EPO; Germany — official judgments; WIPO</a:t>
+              <a:t>Independent public evidence summary · 2026.07.23-10 · 2026-07-22 · Sources: EPO; Germany — official judgments; WIPO</a:t>
             </a:r>
           </a:p>
         </p:txBody>
@@ -15551,7 +15551,7 @@
           <p:cNvPr id="7" name="TextBox 6">
             <a:extLst xmlns:a="http://schemas.openxmlformats.org/drawingml/2006/main">
               <a:ext uri="{FF2B5EF4-FFF2-40B4-BE49-F238E27FC236}">
-                <a16:creationId xmlns:a16="http://schemas.microsoft.com/office/drawing/2014/main" id="{7301BED8-8D2A-4958-B4A3-76BE48D437A0}"/>
+                <a16:creationId xmlns:a16="http://schemas.microsoft.com/office/drawing/2014/main" id="{1AB3C04B-B18A-426A-8D04-F660D7F5C6D5}"/>
               </a:ext>
             </a:extLst>
           </p:cNvPr>
@@ -15598,7 +15598,7 @@
           <p:cNvPr id="8" name="TextBox 7">
             <a:extLst xmlns:a="http://schemas.openxmlformats.org/drawingml/2006/main">
               <a:ext uri="{FF2B5EF4-FFF2-40B4-BE49-F238E27FC236}">
-                <a16:creationId xmlns:a16="http://schemas.microsoft.com/office/drawing/2014/main" id="{AD9BDBCE-B023-4571-A1F5-DE579B0927AF}"/>
+                <a16:creationId xmlns:a16="http://schemas.microsoft.com/office/drawing/2014/main" id="{797A5EB9-D2EB-4BFB-B336-463DD496A796}"/>
               </a:ext>
             </a:extLst>
           </p:cNvPr>
@@ -15645,7 +15645,7 @@
           <p:cNvPr id="9" name="TextBox 8">
             <a:extLst xmlns:a="http://schemas.openxmlformats.org/drawingml/2006/main">
               <a:ext uri="{FF2B5EF4-FFF2-40B4-BE49-F238E27FC236}">
-                <a16:creationId xmlns:a16="http://schemas.microsoft.com/office/drawing/2014/main" id="{7A5B8A30-2FEF-4FD8-8FD4-FEE81E3D0559}"/>
+                <a16:creationId xmlns:a16="http://schemas.microsoft.com/office/drawing/2014/main" id="{E9F5887E-580F-4DA5-91A5-D59C6B138570}"/>
               </a:ext>
             </a:extLst>
           </p:cNvPr>
@@ -15742,7 +15742,7 @@
           <p:cNvPr id="10" name="Rounded Rectangle 9">
             <a:extLst xmlns:a="http://schemas.openxmlformats.org/drawingml/2006/main">
               <a:ext uri="{FF2B5EF4-FFF2-40B4-BE49-F238E27FC236}">
-                <a16:creationId xmlns:a16="http://schemas.microsoft.com/office/drawing/2014/main" id="{FE6A8CC8-C75C-439B-806D-352FBBC56840}"/>
+                <a16:creationId xmlns:a16="http://schemas.microsoft.com/office/drawing/2014/main" id="{E40EA0A7-0A11-4F33-8F7D-32FAAE28928F}"/>
               </a:ext>
             </a:extLst>
           </p:cNvPr>
@@ -15799,7 +15799,7 @@
           <p:cNvPr id="11" name="TextBox 10">
             <a:extLst xmlns:a="http://schemas.openxmlformats.org/drawingml/2006/main">
               <a:ext uri="{FF2B5EF4-FFF2-40B4-BE49-F238E27FC236}">
-                <a16:creationId xmlns:a16="http://schemas.microsoft.com/office/drawing/2014/main" id="{506900D2-EBA4-4DC5-B9AE-7DEE2DDE9CAE}"/>
+                <a16:creationId xmlns:a16="http://schemas.microsoft.com/office/drawing/2014/main" id="{788B25CA-DD4F-4577-96E3-1F9771818447}"/>
               </a:ext>
             </a:extLst>
           </p:cNvPr>
@@ -15846,7 +15846,7 @@
           <p:cNvPr id="12" name="TextBox 11">
             <a:extLst xmlns:a="http://schemas.openxmlformats.org/drawingml/2006/main">
               <a:ext uri="{FF2B5EF4-FFF2-40B4-BE49-F238E27FC236}">
-                <a16:creationId xmlns:a16="http://schemas.microsoft.com/office/drawing/2014/main" id="{B4FCA79C-A4CA-4243-B17C-DE26DD323BED}"/>
+                <a16:creationId xmlns:a16="http://schemas.microsoft.com/office/drawing/2014/main" id="{3444F3AF-B0AA-4BAB-A5C0-F858C4F66FE9}"/>
               </a:ext>
             </a:extLst>
           </p:cNvPr>
@@ -15891,7 +15891,7 @@
     </p:spTree>
     <p:extLst>
       <p:ext uri="{BB962C8B-B14F-4D97-AF65-F5344CB8AC3E}">
-        <p14:creationId xmlns:p14="http://schemas.microsoft.com/office/powerpoint/2010/main" val="1870272871"/>
+        <p14:creationId xmlns:p14="http://schemas.microsoft.com/office/powerpoint/2010/main" val="747547884"/>
       </p:ext>
     </p:extLst>
   </p:cSld>
@@ -15915,7 +15915,7 @@
           <p:cNvPr id="2" name="TextBox 1">
             <a:extLst xmlns:a="http://schemas.openxmlformats.org/drawingml/2006/main">
               <a:ext uri="{FF2B5EF4-FFF2-40B4-BE49-F238E27FC236}">
-                <a16:creationId xmlns:a16="http://schemas.microsoft.com/office/drawing/2014/main" id="{85A7B432-AB71-4CEB-A856-964BB465E839}"/>
+                <a16:creationId xmlns:a16="http://schemas.microsoft.com/office/drawing/2014/main" id="{07A2C05D-C3EE-45E7-8365-5DE2A1EF6010}"/>
               </a:ext>
             </a:extLst>
           </p:cNvPr>
@@ -15962,7 +15962,7 @@
           <p:cNvPr id="3" name="TextBox 2">
             <a:extLst xmlns:a="http://schemas.openxmlformats.org/drawingml/2006/main">
               <a:ext uri="{FF2B5EF4-FFF2-40B4-BE49-F238E27FC236}">
-                <a16:creationId xmlns:a16="http://schemas.microsoft.com/office/drawing/2014/main" id="{658D9CB7-60D7-48A3-B946-DD67A414BB7B}"/>
+                <a16:creationId xmlns:a16="http://schemas.microsoft.com/office/drawing/2014/main" id="{D3D4D502-F878-4CA1-A23C-260ED1E9098F}"/>
               </a:ext>
             </a:extLst>
           </p:cNvPr>
@@ -16009,7 +16009,7 @@
           <p:cNvPr id="4" name="Rectangle 3">
             <a:extLst xmlns:a="http://schemas.openxmlformats.org/drawingml/2006/main">
               <a:ext uri="{FF2B5EF4-FFF2-40B4-BE49-F238E27FC236}">
-                <a16:creationId xmlns:a16="http://schemas.microsoft.com/office/drawing/2014/main" id="{B74B47CE-4EF1-45B5-8DEE-BDCCA3AA91F3}"/>
+                <a16:creationId xmlns:a16="http://schemas.microsoft.com/office/drawing/2014/main" id="{3152E449-4F22-4530-A574-113F42C76211}"/>
               </a:ext>
             </a:extLst>
           </p:cNvPr>
@@ -16064,7 +16064,7 @@
           <p:cNvPr id="5" name="Rectangle 4">
             <a:extLst xmlns:a="http://schemas.openxmlformats.org/drawingml/2006/main">
               <a:ext uri="{FF2B5EF4-FFF2-40B4-BE49-F238E27FC236}">
-                <a16:creationId xmlns:a16="http://schemas.microsoft.com/office/drawing/2014/main" id="{659BFD51-0C1E-4D75-8D38-4EC1ED3C6717}"/>
+                <a16:creationId xmlns:a16="http://schemas.microsoft.com/office/drawing/2014/main" id="{22ACCDD4-9D76-41D8-88B3-2D43521B18B8}"/>
               </a:ext>
             </a:extLst>
           </p:cNvPr>
@@ -16119,7 +16119,7 @@
           <p:cNvPr id="6" name="TextBox 5">
             <a:extLst xmlns:a="http://schemas.openxmlformats.org/drawingml/2006/main">
               <a:ext uri="{FF2B5EF4-FFF2-40B4-BE49-F238E27FC236}">
-                <a16:creationId xmlns:a16="http://schemas.microsoft.com/office/drawing/2014/main" id="{EAB1AF26-1A24-41C1-8640-530A49816AAA}"/>
+                <a16:creationId xmlns:a16="http://schemas.microsoft.com/office/drawing/2014/main" id="{3839196C-5325-4302-8319-C4793D8E4748}"/>
               </a:ext>
             </a:extLst>
           </p:cNvPr>
@@ -16156,7 +16156,7 @@
                 <a:ea typeface="Aptos"/>
                 <a:cs typeface="Aptos"/>
               </a:rPr>
-              <a:t>Independent public evidence summary · 2026.07.22-9 · 2026-07-22 · Sources: WIPO licensing; IP Finance</a:t>
+              <a:t>Independent public evidence summary · 2026.07.23-10 · 2026-07-22 · Sources: WIPO licensing; IP Finance</a:t>
             </a:r>
           </a:p>
         </p:txBody>
@@ -16166,7 +16166,7 @@
           <p:cNvPr id="7" name="TextBox 6">
             <a:extLst xmlns:a="http://schemas.openxmlformats.org/drawingml/2006/main">
               <a:ext uri="{FF2B5EF4-FFF2-40B4-BE49-F238E27FC236}">
-                <a16:creationId xmlns:a16="http://schemas.microsoft.com/office/drawing/2014/main" id="{49CCDE48-5046-41D4-BE2B-486605C4794C}"/>
+                <a16:creationId xmlns:a16="http://schemas.microsoft.com/office/drawing/2014/main" id="{38E14C2D-E997-463D-B76D-9D87CFAD5481}"/>
               </a:ext>
             </a:extLst>
           </p:cNvPr>
@@ -16213,7 +16213,7 @@
           <p:cNvPr id="8" name="TextBox 7">
             <a:extLst xmlns:a="http://schemas.openxmlformats.org/drawingml/2006/main">
               <a:ext uri="{FF2B5EF4-FFF2-40B4-BE49-F238E27FC236}">
-                <a16:creationId xmlns:a16="http://schemas.microsoft.com/office/drawing/2014/main" id="{77CACC44-5B69-4085-AEC1-736E00C9D3D1}"/>
+                <a16:creationId xmlns:a16="http://schemas.microsoft.com/office/drawing/2014/main" id="{CAC157B8-059B-4A0E-95CD-904E5FCE6020}"/>
               </a:ext>
             </a:extLst>
           </p:cNvPr>
@@ -16260,7 +16260,7 @@
           <p:cNvPr id="9" name="TextBox 8">
             <a:extLst xmlns:a="http://schemas.openxmlformats.org/drawingml/2006/main">
               <a:ext uri="{FF2B5EF4-FFF2-40B4-BE49-F238E27FC236}">
-                <a16:creationId xmlns:a16="http://schemas.microsoft.com/office/drawing/2014/main" id="{55627811-2E94-4D54-86DD-CDF36C6DF116}"/>
+                <a16:creationId xmlns:a16="http://schemas.microsoft.com/office/drawing/2014/main" id="{679B823A-ECFD-4425-8C14-156F04359FDA}"/>
               </a:ext>
             </a:extLst>
           </p:cNvPr>
@@ -16357,7 +16357,7 @@
           <p:cNvPr id="10" name="Rounded Rectangle 9">
             <a:extLst xmlns:a="http://schemas.openxmlformats.org/drawingml/2006/main">
               <a:ext uri="{FF2B5EF4-FFF2-40B4-BE49-F238E27FC236}">
-                <a16:creationId xmlns:a16="http://schemas.microsoft.com/office/drawing/2014/main" id="{51209ECF-F186-4DF0-884E-5547CDE3365A}"/>
+                <a16:creationId xmlns:a16="http://schemas.microsoft.com/office/drawing/2014/main" id="{96070D32-7C94-422E-86BA-950E0EACA540}"/>
               </a:ext>
             </a:extLst>
           </p:cNvPr>
@@ -16414,7 +16414,7 @@
           <p:cNvPr id="11" name="TextBox 10">
             <a:extLst xmlns:a="http://schemas.openxmlformats.org/drawingml/2006/main">
               <a:ext uri="{FF2B5EF4-FFF2-40B4-BE49-F238E27FC236}">
-                <a16:creationId xmlns:a16="http://schemas.microsoft.com/office/drawing/2014/main" id="{D8D4ECBB-053D-4FD8-8F0F-0125426EF464}"/>
+                <a16:creationId xmlns:a16="http://schemas.microsoft.com/office/drawing/2014/main" id="{07DC9485-DCD5-4CC6-8894-DF83246778DB}"/>
               </a:ext>
             </a:extLst>
           </p:cNvPr>
@@ -16461,7 +16461,7 @@
           <p:cNvPr id="12" name="TextBox 11">
             <a:extLst xmlns:a="http://schemas.openxmlformats.org/drawingml/2006/main">
               <a:ext uri="{FF2B5EF4-FFF2-40B4-BE49-F238E27FC236}">
-                <a16:creationId xmlns:a16="http://schemas.microsoft.com/office/drawing/2014/main" id="{596BFF5A-4468-4543-AC42-6E54F65D580B}"/>
+                <a16:creationId xmlns:a16="http://schemas.microsoft.com/office/drawing/2014/main" id="{C806F569-CDFD-4E86-9B34-AC639FB33DF7}"/>
               </a:ext>
             </a:extLst>
           </p:cNvPr>
@@ -16506,7 +16506,7 @@
     </p:spTree>
     <p:extLst>
       <p:ext uri="{BB962C8B-B14F-4D97-AF65-F5344CB8AC3E}">
-        <p14:creationId xmlns:p14="http://schemas.microsoft.com/office/powerpoint/2010/main" val="1155978858"/>
+        <p14:creationId xmlns:p14="http://schemas.microsoft.com/office/powerpoint/2010/main" val="340262305"/>
       </p:ext>
     </p:extLst>
   </p:cSld>
@@ -16530,7 +16530,7 @@
           <p:cNvPr id="2" name="TextBox 1">
             <a:extLst xmlns:a="http://schemas.openxmlformats.org/drawingml/2006/main">
               <a:ext uri="{FF2B5EF4-FFF2-40B4-BE49-F238E27FC236}">
-                <a16:creationId xmlns:a16="http://schemas.microsoft.com/office/drawing/2014/main" id="{D03DA760-0984-499B-AD2E-6BBB9AC1E0A2}"/>
+                <a16:creationId xmlns:a16="http://schemas.microsoft.com/office/drawing/2014/main" id="{9980A7FC-AFB6-499A-B2EE-81ACF6127133}"/>
               </a:ext>
             </a:extLst>
           </p:cNvPr>
@@ -16577,7 +16577,7 @@
           <p:cNvPr id="3" name="TextBox 2">
             <a:extLst xmlns:a="http://schemas.openxmlformats.org/drawingml/2006/main">
               <a:ext uri="{FF2B5EF4-FFF2-40B4-BE49-F238E27FC236}">
-                <a16:creationId xmlns:a16="http://schemas.microsoft.com/office/drawing/2014/main" id="{4C6CEC90-BB31-49C8-A4A0-18A4D5395B6A}"/>
+                <a16:creationId xmlns:a16="http://schemas.microsoft.com/office/drawing/2014/main" id="{9E885DB2-4366-47ED-AC0C-3BC2831E63EF}"/>
               </a:ext>
             </a:extLst>
           </p:cNvPr>
@@ -16624,7 +16624,7 @@
           <p:cNvPr id="4" name="Rectangle 3">
             <a:extLst xmlns:a="http://schemas.openxmlformats.org/drawingml/2006/main">
               <a:ext uri="{FF2B5EF4-FFF2-40B4-BE49-F238E27FC236}">
-                <a16:creationId xmlns:a16="http://schemas.microsoft.com/office/drawing/2014/main" id="{DD73F3FB-ED1C-4FC7-A201-41AFB50B31F8}"/>
+                <a16:creationId xmlns:a16="http://schemas.microsoft.com/office/drawing/2014/main" id="{D2FA1E60-FC1A-42C8-B038-F80520340511}"/>
               </a:ext>
             </a:extLst>
           </p:cNvPr>
@@ -16679,7 +16679,7 @@
           <p:cNvPr id="5" name="Rectangle 4">
             <a:extLst xmlns:a="http://schemas.openxmlformats.org/drawingml/2006/main">
               <a:ext uri="{FF2B5EF4-FFF2-40B4-BE49-F238E27FC236}">
-                <a16:creationId xmlns:a16="http://schemas.microsoft.com/office/drawing/2014/main" id="{2D46930E-332C-4E19-A969-087A95F452E6}"/>
+                <a16:creationId xmlns:a16="http://schemas.microsoft.com/office/drawing/2014/main" id="{1894D294-EBCE-4963-95B6-C41EBF848E94}"/>
               </a:ext>
             </a:extLst>
           </p:cNvPr>
@@ -16734,7 +16734,7 @@
           <p:cNvPr id="6" name="TextBox 5">
             <a:extLst xmlns:a="http://schemas.openxmlformats.org/drawingml/2006/main">
               <a:ext uri="{FF2B5EF4-FFF2-40B4-BE49-F238E27FC236}">
-                <a16:creationId xmlns:a16="http://schemas.microsoft.com/office/drawing/2014/main" id="{9EB8F954-47AA-41EE-AC76-D2FBC5927E85}"/>
+                <a16:creationId xmlns:a16="http://schemas.microsoft.com/office/drawing/2014/main" id="{01F90638-F82C-45A0-B8A2-8C3466490182}"/>
               </a:ext>
             </a:extLst>
           </p:cNvPr>
@@ -16771,7 +16771,7 @@
                 <a:ea typeface="Aptos"/>
                 <a:cs typeface="Aptos"/>
               </a:rPr>
-              <a:t>Independent public evidence summary · 2026.07.22-9 · 2026-07-22 · Sources: Evidence Register; EPO</a:t>
+              <a:t>Independent public evidence summary · 2026.07.23-10 · 2026-07-22 · Sources: Evidence Register; EPO</a:t>
             </a:r>
           </a:p>
         </p:txBody>
@@ -16781,7 +16781,7 @@
           <p:cNvPr id="7" name="TextBox 6">
             <a:extLst xmlns:a="http://schemas.openxmlformats.org/drawingml/2006/main">
               <a:ext uri="{FF2B5EF4-FFF2-40B4-BE49-F238E27FC236}">
-                <a16:creationId xmlns:a16="http://schemas.microsoft.com/office/drawing/2014/main" id="{F5487946-D63A-44FB-8C8A-A27D0155D61E}"/>
+                <a16:creationId xmlns:a16="http://schemas.microsoft.com/office/drawing/2014/main" id="{C330DD02-22D6-4CDA-B680-4CE6F7FE15B0}"/>
               </a:ext>
             </a:extLst>
           </p:cNvPr>
@@ -17268,7 +17268,7 @@
           <p:cNvPr id="9" name="TextBox 8">
             <a:extLst xmlns:a="http://schemas.openxmlformats.org/drawingml/2006/main">
               <a:ext uri="{FF2B5EF4-FFF2-40B4-BE49-F238E27FC236}">
-                <a16:creationId xmlns:a16="http://schemas.microsoft.com/office/drawing/2014/main" id="{11138F25-A2D8-431A-81B8-8A9DD1539BE1}"/>
+                <a16:creationId xmlns:a16="http://schemas.microsoft.com/office/drawing/2014/main" id="{542CF62A-A755-4022-BAAB-024BBA495F4B}"/>
               </a:ext>
             </a:extLst>
           </p:cNvPr>
@@ -17313,7 +17313,7 @@
     </p:spTree>
     <p:extLst>
       <p:ext uri="{BB962C8B-B14F-4D97-AF65-F5344CB8AC3E}">
-        <p14:creationId xmlns:p14="http://schemas.microsoft.com/office/powerpoint/2010/main" val="1240088644"/>
+        <p14:creationId xmlns:p14="http://schemas.microsoft.com/office/powerpoint/2010/main" val="729815906"/>
       </p:ext>
     </p:extLst>
   </p:cSld>
@@ -17337,7 +17337,7 @@
           <p:cNvPr id="2" name="TextBox 1">
             <a:extLst xmlns:a="http://schemas.openxmlformats.org/drawingml/2006/main">
               <a:ext uri="{FF2B5EF4-FFF2-40B4-BE49-F238E27FC236}">
-                <a16:creationId xmlns:a16="http://schemas.microsoft.com/office/drawing/2014/main" id="{E8D75A87-E60A-40A8-863D-3FC88E05E2F2}"/>
+                <a16:creationId xmlns:a16="http://schemas.microsoft.com/office/drawing/2014/main" id="{F211D6FB-AEDC-417F-8C07-0B8FD3C97F8C}"/>
               </a:ext>
             </a:extLst>
           </p:cNvPr>
@@ -17384,7 +17384,7 @@
           <p:cNvPr id="3" name="TextBox 2">
             <a:extLst xmlns:a="http://schemas.openxmlformats.org/drawingml/2006/main">
               <a:ext uri="{FF2B5EF4-FFF2-40B4-BE49-F238E27FC236}">
-                <a16:creationId xmlns:a16="http://schemas.microsoft.com/office/drawing/2014/main" id="{3A5F2887-7033-41C3-BA75-6874578B8A9A}"/>
+                <a16:creationId xmlns:a16="http://schemas.microsoft.com/office/drawing/2014/main" id="{288FB995-2DD6-4117-A2A0-FF5CF5F80574}"/>
               </a:ext>
             </a:extLst>
           </p:cNvPr>
@@ -17431,7 +17431,7 @@
           <p:cNvPr id="4" name="Rectangle 3">
             <a:extLst xmlns:a="http://schemas.openxmlformats.org/drawingml/2006/main">
               <a:ext uri="{FF2B5EF4-FFF2-40B4-BE49-F238E27FC236}">
-                <a16:creationId xmlns:a16="http://schemas.microsoft.com/office/drawing/2014/main" id="{51229D39-7823-4082-B0BF-B4B5031AAB32}"/>
+                <a16:creationId xmlns:a16="http://schemas.microsoft.com/office/drawing/2014/main" id="{CBCEA591-F028-4BA8-B5E9-A4DDD5FDE1E5}"/>
               </a:ext>
             </a:extLst>
           </p:cNvPr>
@@ -17486,7 +17486,7 @@
           <p:cNvPr id="5" name="Rectangle 4">
             <a:extLst xmlns:a="http://schemas.openxmlformats.org/drawingml/2006/main">
               <a:ext uri="{FF2B5EF4-FFF2-40B4-BE49-F238E27FC236}">
-                <a16:creationId xmlns:a16="http://schemas.microsoft.com/office/drawing/2014/main" id="{E50E1835-613B-416C-BC7B-48190EF1C24A}"/>
+                <a16:creationId xmlns:a16="http://schemas.microsoft.com/office/drawing/2014/main" id="{47D29226-2141-4087-8921-86F3B9D8615C}"/>
               </a:ext>
             </a:extLst>
           </p:cNvPr>
@@ -17541,7 +17541,7 @@
           <p:cNvPr id="6" name="TextBox 5">
             <a:extLst xmlns:a="http://schemas.openxmlformats.org/drawingml/2006/main">
               <a:ext uri="{FF2B5EF4-FFF2-40B4-BE49-F238E27FC236}">
-                <a16:creationId xmlns:a16="http://schemas.microsoft.com/office/drawing/2014/main" id="{A454BFF3-9B91-4865-8F6C-A85BFD51816E}"/>
+                <a16:creationId xmlns:a16="http://schemas.microsoft.com/office/drawing/2014/main" id="{B3E413BF-9D22-455E-AB23-723C4B21B13C}"/>
               </a:ext>
             </a:extLst>
           </p:cNvPr>
@@ -17578,7 +17578,7 @@
                 <a:ea typeface="Aptos"/>
                 <a:cs typeface="Aptos"/>
               </a:rPr>
-              <a:t>Independent public evidence summary · 2026.07.22-9 · 2026-07-22 · Sources: EP3032975B2; 7 O 3341/24</a:t>
+              <a:t>Independent public evidence summary · 2026.07.23-10 · 2026-07-22 · Sources: EP3032975B2; 7 O 3341/24</a:t>
             </a:r>
           </a:p>
         </p:txBody>
@@ -17588,7 +17588,7 @@
           <p:cNvPr id="7" name="TextBox 6">
             <a:extLst xmlns:a="http://schemas.openxmlformats.org/drawingml/2006/main">
               <a:ext uri="{FF2B5EF4-FFF2-40B4-BE49-F238E27FC236}">
-                <a16:creationId xmlns:a16="http://schemas.microsoft.com/office/drawing/2014/main" id="{6E931DB9-A87D-49CE-BA4A-1714BD9C50AB}"/>
+                <a16:creationId xmlns:a16="http://schemas.microsoft.com/office/drawing/2014/main" id="{EF92FF94-FD40-4922-9233-3D61DACE9B7D}"/>
               </a:ext>
             </a:extLst>
           </p:cNvPr>
@@ -17635,7 +17635,7 @@
           <p:cNvPr id="8" name="Rounded Rectangle 7">
             <a:extLst xmlns:a="http://schemas.openxmlformats.org/drawingml/2006/main">
               <a:ext uri="{FF2B5EF4-FFF2-40B4-BE49-F238E27FC236}">
-                <a16:creationId xmlns:a16="http://schemas.microsoft.com/office/drawing/2014/main" id="{03160B88-B59F-4BB8-A89A-DBCFD40E9348}"/>
+                <a16:creationId xmlns:a16="http://schemas.microsoft.com/office/drawing/2014/main" id="{9B914660-52AA-46DE-A118-4B900FFDE37E}"/>
               </a:ext>
             </a:extLst>
           </p:cNvPr>
@@ -17692,7 +17692,7 @@
           <p:cNvPr id="9" name="TextBox 8">
             <a:extLst xmlns:a="http://schemas.openxmlformats.org/drawingml/2006/main">
               <a:ext uri="{FF2B5EF4-FFF2-40B4-BE49-F238E27FC236}">
-                <a16:creationId xmlns:a16="http://schemas.microsoft.com/office/drawing/2014/main" id="{5A00457D-CE7C-44FB-847A-85E06200B06F}"/>
+                <a16:creationId xmlns:a16="http://schemas.microsoft.com/office/drawing/2014/main" id="{9D56DB96-49AA-4FFF-9BC0-EF1DEFC428E7}"/>
               </a:ext>
             </a:extLst>
           </p:cNvPr>
@@ -17739,7 +17739,7 @@
           <p:cNvPr id="10" name="TextBox 9">
             <a:extLst xmlns:a="http://schemas.openxmlformats.org/drawingml/2006/main">
               <a:ext uri="{FF2B5EF4-FFF2-40B4-BE49-F238E27FC236}">
-                <a16:creationId xmlns:a16="http://schemas.microsoft.com/office/drawing/2014/main" id="{DADDD63B-2A19-48CD-951A-7805C9FDBB58}"/>
+                <a16:creationId xmlns:a16="http://schemas.microsoft.com/office/drawing/2014/main" id="{8179FF3E-3A1C-4C34-B0B8-E00EECEB77CB}"/>
               </a:ext>
             </a:extLst>
           </p:cNvPr>
@@ -17786,7 +17786,7 @@
           <p:cNvPr id="11" name="TextBox 10">
             <a:extLst xmlns:a="http://schemas.openxmlformats.org/drawingml/2006/main">
               <a:ext uri="{FF2B5EF4-FFF2-40B4-BE49-F238E27FC236}">
-                <a16:creationId xmlns:a16="http://schemas.microsoft.com/office/drawing/2014/main" id="{5015F019-8087-442A-BBAD-5CD167F57991}"/>
+                <a16:creationId xmlns:a16="http://schemas.microsoft.com/office/drawing/2014/main" id="{AE46ED1A-4DDF-40A2-903F-8A17B84725A4}"/>
               </a:ext>
             </a:extLst>
           </p:cNvPr>
@@ -17833,7 +17833,7 @@
           <p:cNvPr id="12" name="Rounded Rectangle 11">
             <a:extLst xmlns:a="http://schemas.openxmlformats.org/drawingml/2006/main">
               <a:ext uri="{FF2B5EF4-FFF2-40B4-BE49-F238E27FC236}">
-                <a16:creationId xmlns:a16="http://schemas.microsoft.com/office/drawing/2014/main" id="{4A815717-894A-4C12-834F-9291A24896BF}"/>
+                <a16:creationId xmlns:a16="http://schemas.microsoft.com/office/drawing/2014/main" id="{F2448030-76EE-414F-8C86-25A07A09B75C}"/>
               </a:ext>
             </a:extLst>
           </p:cNvPr>
@@ -17890,7 +17890,7 @@
           <p:cNvPr id="13" name="TextBox 12">
             <a:extLst xmlns:a="http://schemas.openxmlformats.org/drawingml/2006/main">
               <a:ext uri="{FF2B5EF4-FFF2-40B4-BE49-F238E27FC236}">
-                <a16:creationId xmlns:a16="http://schemas.microsoft.com/office/drawing/2014/main" id="{1B2FF549-C939-4FEF-BF83-7701C0F9E5B6}"/>
+                <a16:creationId xmlns:a16="http://schemas.microsoft.com/office/drawing/2014/main" id="{62869C3A-2558-408C-BD6B-1D80CAC1F1D0}"/>
               </a:ext>
             </a:extLst>
           </p:cNvPr>
@@ -17937,7 +17937,7 @@
           <p:cNvPr id="14" name="TextBox 13">
             <a:extLst xmlns:a="http://schemas.openxmlformats.org/drawingml/2006/main">
               <a:ext uri="{FF2B5EF4-FFF2-40B4-BE49-F238E27FC236}">
-                <a16:creationId xmlns:a16="http://schemas.microsoft.com/office/drawing/2014/main" id="{4F9A56E8-0DE4-412E-B00A-20446FCC24D1}"/>
+                <a16:creationId xmlns:a16="http://schemas.microsoft.com/office/drawing/2014/main" id="{608D1C0D-7891-468A-B3CF-BD152FF7104F}"/>
               </a:ext>
             </a:extLst>
           </p:cNvPr>
@@ -17984,7 +17984,7 @@
           <p:cNvPr id="15" name="TextBox 14">
             <a:extLst xmlns:a="http://schemas.openxmlformats.org/drawingml/2006/main">
               <a:ext uri="{FF2B5EF4-FFF2-40B4-BE49-F238E27FC236}">
-                <a16:creationId xmlns:a16="http://schemas.microsoft.com/office/drawing/2014/main" id="{451863E0-9137-4E73-A868-407823AD13BA}"/>
+                <a16:creationId xmlns:a16="http://schemas.microsoft.com/office/drawing/2014/main" id="{9A3A09B7-6088-4468-B821-48C4CF757B70}"/>
               </a:ext>
             </a:extLst>
           </p:cNvPr>
@@ -18031,7 +18031,7 @@
           <p:cNvPr id="16" name="Rounded Rectangle 15">
             <a:extLst xmlns:a="http://schemas.openxmlformats.org/drawingml/2006/main">
               <a:ext uri="{FF2B5EF4-FFF2-40B4-BE49-F238E27FC236}">
-                <a16:creationId xmlns:a16="http://schemas.microsoft.com/office/drawing/2014/main" id="{AB60F21B-7613-4F7A-8BE4-0209FA846135}"/>
+                <a16:creationId xmlns:a16="http://schemas.microsoft.com/office/drawing/2014/main" id="{EDD116F9-824E-4DAE-8A57-50F10E4F2FC4}"/>
               </a:ext>
             </a:extLst>
           </p:cNvPr>
@@ -18088,7 +18088,7 @@
           <p:cNvPr id="17" name="TextBox 16">
             <a:extLst xmlns:a="http://schemas.openxmlformats.org/drawingml/2006/main">
               <a:ext uri="{FF2B5EF4-FFF2-40B4-BE49-F238E27FC236}">
-                <a16:creationId xmlns:a16="http://schemas.microsoft.com/office/drawing/2014/main" id="{9A1F3B46-46C6-48DC-A545-6176E8E50308}"/>
+                <a16:creationId xmlns:a16="http://schemas.microsoft.com/office/drawing/2014/main" id="{454BD2CB-CFFB-4FF0-9E9A-870B696830E4}"/>
               </a:ext>
             </a:extLst>
           </p:cNvPr>
@@ -18135,7 +18135,7 @@
           <p:cNvPr id="18" name="TextBox 17">
             <a:extLst xmlns:a="http://schemas.openxmlformats.org/drawingml/2006/main">
               <a:ext uri="{FF2B5EF4-FFF2-40B4-BE49-F238E27FC236}">
-                <a16:creationId xmlns:a16="http://schemas.microsoft.com/office/drawing/2014/main" id="{0E8818AE-E36A-4BCE-8B60-BD7518EBB529}"/>
+                <a16:creationId xmlns:a16="http://schemas.microsoft.com/office/drawing/2014/main" id="{07FEC64A-9CE7-4294-9D18-966ACD1AB1E3}"/>
               </a:ext>
             </a:extLst>
           </p:cNvPr>
@@ -18182,7 +18182,7 @@
           <p:cNvPr id="19" name="TextBox 18">
             <a:extLst xmlns:a="http://schemas.openxmlformats.org/drawingml/2006/main">
               <a:ext uri="{FF2B5EF4-FFF2-40B4-BE49-F238E27FC236}">
-                <a16:creationId xmlns:a16="http://schemas.microsoft.com/office/drawing/2014/main" id="{20BD3A17-44B8-42EA-9B2C-249CFDFC23CC}"/>
+                <a16:creationId xmlns:a16="http://schemas.microsoft.com/office/drawing/2014/main" id="{10171992-BF37-4642-80BF-AD829711EF53}"/>
               </a:ext>
             </a:extLst>
           </p:cNvPr>
@@ -18229,7 +18229,7 @@
           <p:cNvPr id="20" name="Rounded Rectangle 19">
             <a:extLst xmlns:a="http://schemas.openxmlformats.org/drawingml/2006/main">
               <a:ext uri="{FF2B5EF4-FFF2-40B4-BE49-F238E27FC236}">
-                <a16:creationId xmlns:a16="http://schemas.microsoft.com/office/drawing/2014/main" id="{AFE5E6C1-6216-490A-87D3-7605C9F071A4}"/>
+                <a16:creationId xmlns:a16="http://schemas.microsoft.com/office/drawing/2014/main" id="{C9370CB4-DD46-415F-A8A6-FCEE4143A35F}"/>
               </a:ext>
             </a:extLst>
           </p:cNvPr>
@@ -18286,7 +18286,7 @@
           <p:cNvPr id="21" name="TextBox 20">
             <a:extLst xmlns:a="http://schemas.openxmlformats.org/drawingml/2006/main">
               <a:ext uri="{FF2B5EF4-FFF2-40B4-BE49-F238E27FC236}">
-                <a16:creationId xmlns:a16="http://schemas.microsoft.com/office/drawing/2014/main" id="{C6628B6A-2405-4AE7-993D-0709CD6F06B4}"/>
+                <a16:creationId xmlns:a16="http://schemas.microsoft.com/office/drawing/2014/main" id="{1E20B19F-5618-41DF-8BBD-FE01CD94FF48}"/>
               </a:ext>
             </a:extLst>
           </p:cNvPr>
@@ -18333,7 +18333,7 @@
           <p:cNvPr id="22" name="TextBox 21">
             <a:extLst xmlns:a="http://schemas.openxmlformats.org/drawingml/2006/main">
               <a:ext uri="{FF2B5EF4-FFF2-40B4-BE49-F238E27FC236}">
-                <a16:creationId xmlns:a16="http://schemas.microsoft.com/office/drawing/2014/main" id="{78CB31B6-3C24-454B-BCB0-242972C2583A}"/>
+                <a16:creationId xmlns:a16="http://schemas.microsoft.com/office/drawing/2014/main" id="{881D8A73-35EF-405F-A065-14B3A183705B}"/>
               </a:ext>
             </a:extLst>
           </p:cNvPr>
@@ -18380,7 +18380,7 @@
           <p:cNvPr id="23" name="TextBox 22">
             <a:extLst xmlns:a="http://schemas.openxmlformats.org/drawingml/2006/main">
               <a:ext uri="{FF2B5EF4-FFF2-40B4-BE49-F238E27FC236}">
-                <a16:creationId xmlns:a16="http://schemas.microsoft.com/office/drawing/2014/main" id="{5C3E021B-E459-46E5-866F-A7EE1C8E6B61}"/>
+                <a16:creationId xmlns:a16="http://schemas.microsoft.com/office/drawing/2014/main" id="{7ABEBF89-28A0-4B8A-9DF2-B9D2C9D62322}"/>
               </a:ext>
             </a:extLst>
           </p:cNvPr>
@@ -18427,7 +18427,7 @@
           <p:cNvPr id="24" name="TextBox 23">
             <a:extLst xmlns:a="http://schemas.openxmlformats.org/drawingml/2006/main">
               <a:ext uri="{FF2B5EF4-FFF2-40B4-BE49-F238E27FC236}">
-                <a16:creationId xmlns:a16="http://schemas.microsoft.com/office/drawing/2014/main" id="{2881B841-623D-42CB-B52D-6BAA8B0A9AC3}"/>
+                <a16:creationId xmlns:a16="http://schemas.microsoft.com/office/drawing/2014/main" id="{D1A515DC-75CA-44A4-83FA-91C839C79D4A}"/>
               </a:ext>
             </a:extLst>
           </p:cNvPr>
@@ -18472,7 +18472,7 @@
     </p:spTree>
     <p:extLst>
       <p:ext uri="{BB962C8B-B14F-4D97-AF65-F5344CB8AC3E}">
-        <p14:creationId xmlns:p14="http://schemas.microsoft.com/office/powerpoint/2010/main" val="1540590765"/>
+        <p14:creationId xmlns:p14="http://schemas.microsoft.com/office/powerpoint/2010/main" val="917983250"/>
       </p:ext>
     </p:extLst>
   </p:cSld>
@@ -18496,7 +18496,7 @@
           <p:cNvPr id="2" name="TextBox 1">
             <a:extLst xmlns:a="http://schemas.openxmlformats.org/drawingml/2006/main">
               <a:ext uri="{FF2B5EF4-FFF2-40B4-BE49-F238E27FC236}">
-                <a16:creationId xmlns:a16="http://schemas.microsoft.com/office/drawing/2014/main" id="{6006C4E8-B78E-474D-A7C6-9AB15900715D}"/>
+                <a16:creationId xmlns:a16="http://schemas.microsoft.com/office/drawing/2014/main" id="{5767BC29-4602-4D16-9A51-F04B1FB3DEF6}"/>
               </a:ext>
             </a:extLst>
           </p:cNvPr>
@@ -18543,7 +18543,7 @@
           <p:cNvPr id="3" name="TextBox 2">
             <a:extLst xmlns:a="http://schemas.openxmlformats.org/drawingml/2006/main">
               <a:ext uri="{FF2B5EF4-FFF2-40B4-BE49-F238E27FC236}">
-                <a16:creationId xmlns:a16="http://schemas.microsoft.com/office/drawing/2014/main" id="{761CA223-E18E-4892-AAB2-12240B210DC5}"/>
+                <a16:creationId xmlns:a16="http://schemas.microsoft.com/office/drawing/2014/main" id="{13B89AEC-D60D-4E70-8300-A6613FAFC26E}"/>
               </a:ext>
             </a:extLst>
           </p:cNvPr>
@@ -18590,7 +18590,7 @@
           <p:cNvPr id="4" name="Rectangle 3">
             <a:extLst xmlns:a="http://schemas.openxmlformats.org/drawingml/2006/main">
               <a:ext uri="{FF2B5EF4-FFF2-40B4-BE49-F238E27FC236}">
-                <a16:creationId xmlns:a16="http://schemas.microsoft.com/office/drawing/2014/main" id="{E285A37D-1E96-4E10-8B28-2BC93FDD17ED}"/>
+                <a16:creationId xmlns:a16="http://schemas.microsoft.com/office/drawing/2014/main" id="{218AAA1C-F2B6-4CB0-A3ED-1237583BEA0E}"/>
               </a:ext>
             </a:extLst>
           </p:cNvPr>
@@ -18645,7 +18645,7 @@
           <p:cNvPr id="5" name="Rectangle 4">
             <a:extLst xmlns:a="http://schemas.openxmlformats.org/drawingml/2006/main">
               <a:ext uri="{FF2B5EF4-FFF2-40B4-BE49-F238E27FC236}">
-                <a16:creationId xmlns:a16="http://schemas.microsoft.com/office/drawing/2014/main" id="{E6744067-E5D3-406A-ACED-6654EFED4797}"/>
+                <a16:creationId xmlns:a16="http://schemas.microsoft.com/office/drawing/2014/main" id="{D549CF2B-3E7D-41A4-85A8-D48655DBC43A}"/>
               </a:ext>
             </a:extLst>
           </p:cNvPr>
@@ -18700,7 +18700,7 @@
           <p:cNvPr id="6" name="TextBox 5">
             <a:extLst xmlns:a="http://schemas.openxmlformats.org/drawingml/2006/main">
               <a:ext uri="{FF2B5EF4-FFF2-40B4-BE49-F238E27FC236}">
-                <a16:creationId xmlns:a16="http://schemas.microsoft.com/office/drawing/2014/main" id="{D0FBEEA0-01A4-4426-8E06-A16F809A0E38}"/>
+                <a16:creationId xmlns:a16="http://schemas.microsoft.com/office/drawing/2014/main" id="{C8CB780B-C0BD-472C-90F3-50FD5766F8D8}"/>
               </a:ext>
             </a:extLst>
           </p:cNvPr>
@@ -18737,7 +18737,7 @@
                 <a:ea typeface="Aptos"/>
                 <a:cs typeface="Aptos"/>
               </a:rPr>
-              <a:t>Independent public evidence summary · 2026.07.22-9 · 2026-07-22 · Sources: WIPO dispute resolution; EPO IPscore</a:t>
+              <a:t>Independent public evidence summary · 2026.07.23-10 · 2026-07-22 · Sources: WIPO dispute resolution; EPO IPscore</a:t>
             </a:r>
           </a:p>
         </p:txBody>
@@ -18747,7 +18747,7 @@
           <p:cNvPr id="7" name="TextBox 6">
             <a:extLst xmlns:a="http://schemas.openxmlformats.org/drawingml/2006/main">
               <a:ext uri="{FF2B5EF4-FFF2-40B4-BE49-F238E27FC236}">
-                <a16:creationId xmlns:a16="http://schemas.microsoft.com/office/drawing/2014/main" id="{96CF3C17-8E54-4F52-B92E-CA155913C110}"/>
+                <a16:creationId xmlns:a16="http://schemas.microsoft.com/office/drawing/2014/main" id="{D5A566C2-B712-41DE-BB52-F4EC35474259}"/>
               </a:ext>
             </a:extLst>
           </p:cNvPr>
@@ -18794,7 +18794,7 @@
           <p:cNvPr id="8" name="Rounded Rectangle 7">
             <a:extLst xmlns:a="http://schemas.openxmlformats.org/drawingml/2006/main">
               <a:ext uri="{FF2B5EF4-FFF2-40B4-BE49-F238E27FC236}">
-                <a16:creationId xmlns:a16="http://schemas.microsoft.com/office/drawing/2014/main" id="{0FB95883-4349-43E1-B772-D7F6167CB408}"/>
+                <a16:creationId xmlns:a16="http://schemas.microsoft.com/office/drawing/2014/main" id="{F00C757F-740D-43DE-9BAF-D639DE606369}"/>
               </a:ext>
             </a:extLst>
           </p:cNvPr>
@@ -18851,7 +18851,7 @@
           <p:cNvPr id="9" name="TextBox 8">
             <a:extLst xmlns:a="http://schemas.openxmlformats.org/drawingml/2006/main">
               <a:ext uri="{FF2B5EF4-FFF2-40B4-BE49-F238E27FC236}">
-                <a16:creationId xmlns:a16="http://schemas.microsoft.com/office/drawing/2014/main" id="{FB9890FB-1F91-4B59-977C-1F6B018B219E}"/>
+                <a16:creationId xmlns:a16="http://schemas.microsoft.com/office/drawing/2014/main" id="{F6E40714-6C6B-4895-B135-18A644D435FA}"/>
               </a:ext>
             </a:extLst>
           </p:cNvPr>
@@ -18898,7 +18898,7 @@
           <p:cNvPr id="10" name="TextBox 9">
             <a:extLst xmlns:a="http://schemas.openxmlformats.org/drawingml/2006/main">
               <a:ext uri="{FF2B5EF4-FFF2-40B4-BE49-F238E27FC236}">
-                <a16:creationId xmlns:a16="http://schemas.microsoft.com/office/drawing/2014/main" id="{55CD40FB-48AC-493B-8B8D-A8A87585EC4C}"/>
+                <a16:creationId xmlns:a16="http://schemas.microsoft.com/office/drawing/2014/main" id="{AFFF1FFB-F068-4A5B-BB18-CD9CF8AC91B2}"/>
               </a:ext>
             </a:extLst>
           </p:cNvPr>
@@ -18945,7 +18945,7 @@
           <p:cNvPr id="11" name="TextBox 10">
             <a:extLst xmlns:a="http://schemas.openxmlformats.org/drawingml/2006/main">
               <a:ext uri="{FF2B5EF4-FFF2-40B4-BE49-F238E27FC236}">
-                <a16:creationId xmlns:a16="http://schemas.microsoft.com/office/drawing/2014/main" id="{9533DB97-B3F5-4DEE-8ACC-565693A68F43}"/>
+                <a16:creationId xmlns:a16="http://schemas.microsoft.com/office/drawing/2014/main" id="{C08DDD2D-C31A-44BD-BCAE-D55E4634C6B5}"/>
               </a:ext>
             </a:extLst>
           </p:cNvPr>
@@ -18992,7 +18992,7 @@
           <p:cNvPr id="12" name="Rounded Rectangle 11">
             <a:extLst xmlns:a="http://schemas.openxmlformats.org/drawingml/2006/main">
               <a:ext uri="{FF2B5EF4-FFF2-40B4-BE49-F238E27FC236}">
-                <a16:creationId xmlns:a16="http://schemas.microsoft.com/office/drawing/2014/main" id="{C7B6FA47-0A7A-44A9-8487-675A994299C1}"/>
+                <a16:creationId xmlns:a16="http://schemas.microsoft.com/office/drawing/2014/main" id="{9468DD32-4EF7-4C13-929E-A926F1B7511B}"/>
               </a:ext>
             </a:extLst>
           </p:cNvPr>
@@ -19049,7 +19049,7 @@
           <p:cNvPr id="13" name="TextBox 12">
             <a:extLst xmlns:a="http://schemas.openxmlformats.org/drawingml/2006/main">
               <a:ext uri="{FF2B5EF4-FFF2-40B4-BE49-F238E27FC236}">
-                <a16:creationId xmlns:a16="http://schemas.microsoft.com/office/drawing/2014/main" id="{C651A65E-E926-4FDA-B9BF-5E5DC3145237}"/>
+                <a16:creationId xmlns:a16="http://schemas.microsoft.com/office/drawing/2014/main" id="{D8A376C3-9FFB-4682-A020-BB13B4555242}"/>
               </a:ext>
             </a:extLst>
           </p:cNvPr>
@@ -19096,7 +19096,7 @@
           <p:cNvPr id="14" name="TextBox 13">
             <a:extLst xmlns:a="http://schemas.openxmlformats.org/drawingml/2006/main">
               <a:ext uri="{FF2B5EF4-FFF2-40B4-BE49-F238E27FC236}">
-                <a16:creationId xmlns:a16="http://schemas.microsoft.com/office/drawing/2014/main" id="{01A10754-59B5-48B0-A23D-7220B16BD5A1}"/>
+                <a16:creationId xmlns:a16="http://schemas.microsoft.com/office/drawing/2014/main" id="{8CCCBF04-777D-43F7-8203-6E75581A0429}"/>
               </a:ext>
             </a:extLst>
           </p:cNvPr>
@@ -19143,7 +19143,7 @@
           <p:cNvPr id="15" name="TextBox 14">
             <a:extLst xmlns:a="http://schemas.openxmlformats.org/drawingml/2006/main">
               <a:ext uri="{FF2B5EF4-FFF2-40B4-BE49-F238E27FC236}">
-                <a16:creationId xmlns:a16="http://schemas.microsoft.com/office/drawing/2014/main" id="{0E47101D-7AF9-4F30-B81B-B5319BDBD370}"/>
+                <a16:creationId xmlns:a16="http://schemas.microsoft.com/office/drawing/2014/main" id="{00459F79-8175-4ACD-8B24-91E241ED8B12}"/>
               </a:ext>
             </a:extLst>
           </p:cNvPr>
@@ -19190,7 +19190,7 @@
           <p:cNvPr id="16" name="Rounded Rectangle 15">
             <a:extLst xmlns:a="http://schemas.openxmlformats.org/drawingml/2006/main">
               <a:ext uri="{FF2B5EF4-FFF2-40B4-BE49-F238E27FC236}">
-                <a16:creationId xmlns:a16="http://schemas.microsoft.com/office/drawing/2014/main" id="{83DDF465-966F-42C8-A212-F05648A1F74B}"/>
+                <a16:creationId xmlns:a16="http://schemas.microsoft.com/office/drawing/2014/main" id="{394754CA-D8EC-440F-BB89-C9110C9EFF2A}"/>
               </a:ext>
             </a:extLst>
           </p:cNvPr>
@@ -19247,7 +19247,7 @@
           <p:cNvPr id="17" name="TextBox 16">
             <a:extLst xmlns:a="http://schemas.openxmlformats.org/drawingml/2006/main">
               <a:ext uri="{FF2B5EF4-FFF2-40B4-BE49-F238E27FC236}">
-                <a16:creationId xmlns:a16="http://schemas.microsoft.com/office/drawing/2014/main" id="{7DF1812A-E692-4B32-A053-7A40546F14A9}"/>
+                <a16:creationId xmlns:a16="http://schemas.microsoft.com/office/drawing/2014/main" id="{9F036AFC-547E-48C9-96CC-556E56298DE1}"/>
               </a:ext>
             </a:extLst>
           </p:cNvPr>
@@ -19294,7 +19294,7 @@
           <p:cNvPr id="18" name="TextBox 17">
             <a:extLst xmlns:a="http://schemas.openxmlformats.org/drawingml/2006/main">
               <a:ext uri="{FF2B5EF4-FFF2-40B4-BE49-F238E27FC236}">
-                <a16:creationId xmlns:a16="http://schemas.microsoft.com/office/drawing/2014/main" id="{0E180A76-B1EA-4651-B686-31A97EC0A4A7}"/>
+                <a16:creationId xmlns:a16="http://schemas.microsoft.com/office/drawing/2014/main" id="{D676F299-9373-4548-8D9A-8C55B9AEE8C2}"/>
               </a:ext>
             </a:extLst>
           </p:cNvPr>
@@ -19341,7 +19341,7 @@
           <p:cNvPr id="19" name="TextBox 18">
             <a:extLst xmlns:a="http://schemas.openxmlformats.org/drawingml/2006/main">
               <a:ext uri="{FF2B5EF4-FFF2-40B4-BE49-F238E27FC236}">
-                <a16:creationId xmlns:a16="http://schemas.microsoft.com/office/drawing/2014/main" id="{3129954E-B4DC-4B27-A880-9FEB1D0C52F7}"/>
+                <a16:creationId xmlns:a16="http://schemas.microsoft.com/office/drawing/2014/main" id="{7DB08B5B-8FAB-4482-BFA8-487FBE382697}"/>
               </a:ext>
             </a:extLst>
           </p:cNvPr>
@@ -19388,7 +19388,7 @@
           <p:cNvPr id="20" name="Rounded Rectangle 19">
             <a:extLst xmlns:a="http://schemas.openxmlformats.org/drawingml/2006/main">
               <a:ext uri="{FF2B5EF4-FFF2-40B4-BE49-F238E27FC236}">
-                <a16:creationId xmlns:a16="http://schemas.microsoft.com/office/drawing/2014/main" id="{976229AF-CDFE-437B-B7A4-E967449C6029}"/>
+                <a16:creationId xmlns:a16="http://schemas.microsoft.com/office/drawing/2014/main" id="{33F3FD50-1ABB-4BCB-B6D6-3D117712676C}"/>
               </a:ext>
             </a:extLst>
           </p:cNvPr>
@@ -19445,7 +19445,7 @@
           <p:cNvPr id="21" name="TextBox 20">
             <a:extLst xmlns:a="http://schemas.openxmlformats.org/drawingml/2006/main">
               <a:ext uri="{FF2B5EF4-FFF2-40B4-BE49-F238E27FC236}">
-                <a16:creationId xmlns:a16="http://schemas.microsoft.com/office/drawing/2014/main" id="{B2FC2DC8-E230-47A1-A90B-60D7A91307BF}"/>
+                <a16:creationId xmlns:a16="http://schemas.microsoft.com/office/drawing/2014/main" id="{384AEB7A-5688-4EDC-BF83-F864B3581923}"/>
               </a:ext>
             </a:extLst>
           </p:cNvPr>
@@ -19492,7 +19492,7 @@
           <p:cNvPr id="22" name="TextBox 21">
             <a:extLst xmlns:a="http://schemas.openxmlformats.org/drawingml/2006/main">
               <a:ext uri="{FF2B5EF4-FFF2-40B4-BE49-F238E27FC236}">
-                <a16:creationId xmlns:a16="http://schemas.microsoft.com/office/drawing/2014/main" id="{2ADE84F0-6FD7-42C7-A06F-25FCCA5D25D7}"/>
+                <a16:creationId xmlns:a16="http://schemas.microsoft.com/office/drawing/2014/main" id="{099BAFAA-F7D8-43D1-B6A2-6E81555A122F}"/>
               </a:ext>
             </a:extLst>
           </p:cNvPr>
@@ -19539,7 +19539,7 @@
           <p:cNvPr id="23" name="TextBox 22">
             <a:extLst xmlns:a="http://schemas.openxmlformats.org/drawingml/2006/main">
               <a:ext uri="{FF2B5EF4-FFF2-40B4-BE49-F238E27FC236}">
-                <a16:creationId xmlns:a16="http://schemas.microsoft.com/office/drawing/2014/main" id="{0F632556-65EA-4E3F-B4C6-77732E2526CA}"/>
+                <a16:creationId xmlns:a16="http://schemas.microsoft.com/office/drawing/2014/main" id="{EAD9BB6F-D748-4F0B-A855-DD240AA01F48}"/>
               </a:ext>
             </a:extLst>
           </p:cNvPr>
@@ -19586,7 +19586,7 @@
           <p:cNvPr id="24" name="TextBox 23">
             <a:extLst xmlns:a="http://schemas.openxmlformats.org/drawingml/2006/main">
               <a:ext uri="{FF2B5EF4-FFF2-40B4-BE49-F238E27FC236}">
-                <a16:creationId xmlns:a16="http://schemas.microsoft.com/office/drawing/2014/main" id="{FB992DC0-8797-4350-B09E-AE47828A9392}"/>
+                <a16:creationId xmlns:a16="http://schemas.microsoft.com/office/drawing/2014/main" id="{DAF44827-F65D-4EFA-B816-B8A698ADB25E}"/>
               </a:ext>
             </a:extLst>
           </p:cNvPr>
@@ -19631,7 +19631,7 @@
     </p:spTree>
     <p:extLst>
       <p:ext uri="{BB962C8B-B14F-4D97-AF65-F5344CB8AC3E}">
-        <p14:creationId xmlns:p14="http://schemas.microsoft.com/office/powerpoint/2010/main" val="859806017"/>
+        <p14:creationId xmlns:p14="http://schemas.microsoft.com/office/powerpoint/2010/main" val="2087689409"/>
       </p:ext>
     </p:extLst>
   </p:cSld>
@@ -19655,7 +19655,7 @@
           <p:cNvPr id="2" name="TextBox 1">
             <a:extLst xmlns:a="http://schemas.openxmlformats.org/drawingml/2006/main">
               <a:ext uri="{FF2B5EF4-FFF2-40B4-BE49-F238E27FC236}">
-                <a16:creationId xmlns:a16="http://schemas.microsoft.com/office/drawing/2014/main" id="{71838222-A282-41FD-9B12-E064A020DA47}"/>
+                <a16:creationId xmlns:a16="http://schemas.microsoft.com/office/drawing/2014/main" id="{6A3401B0-FF00-4EB1-B2DD-16FEE9B7E236}"/>
               </a:ext>
             </a:extLst>
           </p:cNvPr>
@@ -19702,7 +19702,7 @@
           <p:cNvPr id="3" name="TextBox 2">
             <a:extLst xmlns:a="http://schemas.openxmlformats.org/drawingml/2006/main">
               <a:ext uri="{FF2B5EF4-FFF2-40B4-BE49-F238E27FC236}">
-                <a16:creationId xmlns:a16="http://schemas.microsoft.com/office/drawing/2014/main" id="{FF8FDAD1-FD54-42B8-A083-1A78415FC562}"/>
+                <a16:creationId xmlns:a16="http://schemas.microsoft.com/office/drawing/2014/main" id="{34573C6B-E0DE-4D04-8E97-3DCB860837E5}"/>
               </a:ext>
             </a:extLst>
           </p:cNvPr>
@@ -19749,7 +19749,7 @@
           <p:cNvPr id="4" name="Rectangle 3">
             <a:extLst xmlns:a="http://schemas.openxmlformats.org/drawingml/2006/main">
               <a:ext uri="{FF2B5EF4-FFF2-40B4-BE49-F238E27FC236}">
-                <a16:creationId xmlns:a16="http://schemas.microsoft.com/office/drawing/2014/main" id="{48BEE886-3729-4673-86C6-568C0EBA437C}"/>
+                <a16:creationId xmlns:a16="http://schemas.microsoft.com/office/drawing/2014/main" id="{4112A014-A753-4D0B-BDC2-A27700528009}"/>
               </a:ext>
             </a:extLst>
           </p:cNvPr>
@@ -19804,7 +19804,7 @@
           <p:cNvPr id="5" name="Rectangle 4">
             <a:extLst xmlns:a="http://schemas.openxmlformats.org/drawingml/2006/main">
               <a:ext uri="{FF2B5EF4-FFF2-40B4-BE49-F238E27FC236}">
-                <a16:creationId xmlns:a16="http://schemas.microsoft.com/office/drawing/2014/main" id="{B3AD91A6-E772-41C2-BD2D-02F501FCBC54}"/>
+                <a16:creationId xmlns:a16="http://schemas.microsoft.com/office/drawing/2014/main" id="{E47336BF-A4CB-4753-92E2-64A64E9FB342}"/>
               </a:ext>
             </a:extLst>
           </p:cNvPr>
@@ -19859,7 +19859,7 @@
           <p:cNvPr id="6" name="TextBox 5">
             <a:extLst xmlns:a="http://schemas.openxmlformats.org/drawingml/2006/main">
               <a:ext uri="{FF2B5EF4-FFF2-40B4-BE49-F238E27FC236}">
-                <a16:creationId xmlns:a16="http://schemas.microsoft.com/office/drawing/2014/main" id="{61AE0A7A-7FD6-40C4-BFEA-C974C5EEFB40}"/>
+                <a16:creationId xmlns:a16="http://schemas.microsoft.com/office/drawing/2014/main" id="{6C2907CA-1F51-4D16-8752-D5DD94BB99C3}"/>
               </a:ext>
             </a:extLst>
           </p:cNvPr>
@@ -19896,7 +19896,7 @@
                 <a:ea typeface="Aptos"/>
                 <a:cs typeface="Aptos"/>
               </a:rPr>
-              <a:t>Independent public evidence summary · 2026.07.22-9 · 2026-07-22 · Sources: WIPO licensing; IP Finance; TPLF mapping</a:t>
+              <a:t>Independent public evidence summary · 2026.07.23-10 · 2026-07-22 · Sources: WIPO licensing; IP Finance; TPLF mapping</a:t>
             </a:r>
           </a:p>
         </p:txBody>
@@ -19906,7 +19906,7 @@
           <p:cNvPr id="7" name="TextBox 6">
             <a:extLst xmlns:a="http://schemas.openxmlformats.org/drawingml/2006/main">
               <a:ext uri="{FF2B5EF4-FFF2-40B4-BE49-F238E27FC236}">
-                <a16:creationId xmlns:a16="http://schemas.microsoft.com/office/drawing/2014/main" id="{DAF7A2C1-663E-48B1-B7E6-A68AAE40D78C}"/>
+                <a16:creationId xmlns:a16="http://schemas.microsoft.com/office/drawing/2014/main" id="{81ABA7E3-650D-43BE-8AC5-4B743E47758C}"/>
               </a:ext>
             </a:extLst>
           </p:cNvPr>
@@ -20476,7 +20476,7 @@
           <p:cNvPr id="9" name="TextBox 8">
             <a:extLst xmlns:a="http://schemas.openxmlformats.org/drawingml/2006/main">
               <a:ext uri="{FF2B5EF4-FFF2-40B4-BE49-F238E27FC236}">
-                <a16:creationId xmlns:a16="http://schemas.microsoft.com/office/drawing/2014/main" id="{5F1A5A2C-E11F-4A67-BEE5-BE868D525B57}"/>
+                <a16:creationId xmlns:a16="http://schemas.microsoft.com/office/drawing/2014/main" id="{BD9749BA-0425-4F36-B462-F647472C01EE}"/>
               </a:ext>
             </a:extLst>
           </p:cNvPr>
@@ -20521,7 +20521,7 @@
     </p:spTree>
     <p:extLst>
       <p:ext uri="{BB962C8B-B14F-4D97-AF65-F5344CB8AC3E}">
-        <p14:creationId xmlns:p14="http://schemas.microsoft.com/office/powerpoint/2010/main" val="1079105360"/>
+        <p14:creationId xmlns:p14="http://schemas.microsoft.com/office/powerpoint/2010/main" val="1055359720"/>
       </p:ext>
     </p:extLst>
   </p:cSld>
@@ -20545,7 +20545,7 @@
           <p:cNvPr id="2" name="TextBox 1">
             <a:extLst xmlns:a="http://schemas.openxmlformats.org/drawingml/2006/main">
               <a:ext uri="{FF2B5EF4-FFF2-40B4-BE49-F238E27FC236}">
-                <a16:creationId xmlns:a16="http://schemas.microsoft.com/office/drawing/2014/main" id="{25F13E3D-FA26-4DDB-9E23-F34CB15AFE54}"/>
+                <a16:creationId xmlns:a16="http://schemas.microsoft.com/office/drawing/2014/main" id="{719DFD49-53E7-4A74-BE3A-6D796F6DE2A4}"/>
               </a:ext>
             </a:extLst>
           </p:cNvPr>
@@ -20592,7 +20592,7 @@
           <p:cNvPr id="3" name="TextBox 2">
             <a:extLst xmlns:a="http://schemas.openxmlformats.org/drawingml/2006/main">
               <a:ext uri="{FF2B5EF4-FFF2-40B4-BE49-F238E27FC236}">
-                <a16:creationId xmlns:a16="http://schemas.microsoft.com/office/drawing/2014/main" id="{F58939F6-6EC0-4F64-9CD3-94CD78E10222}"/>
+                <a16:creationId xmlns:a16="http://schemas.microsoft.com/office/drawing/2014/main" id="{0BB451CD-BBC6-4032-B687-7A4DCA4B4058}"/>
               </a:ext>
             </a:extLst>
           </p:cNvPr>
@@ -20639,7 +20639,7 @@
           <p:cNvPr id="4" name="Rectangle 3">
             <a:extLst xmlns:a="http://schemas.openxmlformats.org/drawingml/2006/main">
               <a:ext uri="{FF2B5EF4-FFF2-40B4-BE49-F238E27FC236}">
-                <a16:creationId xmlns:a16="http://schemas.microsoft.com/office/drawing/2014/main" id="{61FB9D3B-DEA3-4340-B365-3E2375E0A6E9}"/>
+                <a16:creationId xmlns:a16="http://schemas.microsoft.com/office/drawing/2014/main" id="{81E7987D-513A-4FCB-BD7E-165FFD36DA7F}"/>
               </a:ext>
             </a:extLst>
           </p:cNvPr>
@@ -20694,7 +20694,7 @@
           <p:cNvPr id="5" name="Rectangle 4">
             <a:extLst xmlns:a="http://schemas.openxmlformats.org/drawingml/2006/main">
               <a:ext uri="{FF2B5EF4-FFF2-40B4-BE49-F238E27FC236}">
-                <a16:creationId xmlns:a16="http://schemas.microsoft.com/office/drawing/2014/main" id="{288C1931-650F-4C77-A5CC-8B3876C33763}"/>
+                <a16:creationId xmlns:a16="http://schemas.microsoft.com/office/drawing/2014/main" id="{A50181CF-28F9-4A21-A74F-65DD492AF1B3}"/>
               </a:ext>
             </a:extLst>
           </p:cNvPr>
@@ -20749,7 +20749,7 @@
           <p:cNvPr id="6" name="TextBox 5">
             <a:extLst xmlns:a="http://schemas.openxmlformats.org/drawingml/2006/main">
               <a:ext uri="{FF2B5EF4-FFF2-40B4-BE49-F238E27FC236}">
-                <a16:creationId xmlns:a16="http://schemas.microsoft.com/office/drawing/2014/main" id="{4F3403B6-D0FB-4126-B951-95A4D3E5BB4B}"/>
+                <a16:creationId xmlns:a16="http://schemas.microsoft.com/office/drawing/2014/main" id="{FDECAD9F-7859-4A4E-B336-CD11B6697AE0}"/>
               </a:ext>
             </a:extLst>
           </p:cNvPr>
@@ -20786,7 +20786,7 @@
                 <a:ea typeface="Aptos"/>
                 <a:cs typeface="Aptos"/>
               </a:rPr>
-              <a:t>Independent public evidence summary · 2026.07.22-9 · 2026-07-22 · Sources: Evidence Register; WIPO valuation</a:t>
+              <a:t>Independent public evidence summary · 2026.07.23-10 · 2026-07-22 · Sources: Evidence Register; WIPO valuation</a:t>
             </a:r>
           </a:p>
         </p:txBody>
@@ -20796,7 +20796,7 @@
           <p:cNvPr id="7" name="TextBox 6">
             <a:extLst xmlns:a="http://schemas.openxmlformats.org/drawingml/2006/main">
               <a:ext uri="{FF2B5EF4-FFF2-40B4-BE49-F238E27FC236}">
-                <a16:creationId xmlns:a16="http://schemas.microsoft.com/office/drawing/2014/main" id="{6DAC56FE-A8E1-4F11-B610-7840E739A8E6}"/>
+                <a16:creationId xmlns:a16="http://schemas.microsoft.com/office/drawing/2014/main" id="{ECD341ED-38BC-426E-B698-043DF39C62A0}"/>
               </a:ext>
             </a:extLst>
           </p:cNvPr>
@@ -21449,7 +21449,7 @@
           <p:cNvPr id="9" name="TextBox 8">
             <a:extLst xmlns:a="http://schemas.openxmlformats.org/drawingml/2006/main">
               <a:ext uri="{FF2B5EF4-FFF2-40B4-BE49-F238E27FC236}">
-                <a16:creationId xmlns:a16="http://schemas.microsoft.com/office/drawing/2014/main" id="{392FDC02-EB16-4547-B8F1-4C3795FA63AC}"/>
+                <a16:creationId xmlns:a16="http://schemas.microsoft.com/office/drawing/2014/main" id="{9E6BC743-41B8-4F96-8C2D-C95DF4834913}"/>
               </a:ext>
             </a:extLst>
           </p:cNvPr>
@@ -21494,7 +21494,7 @@
     </p:spTree>
     <p:extLst>
       <p:ext uri="{BB962C8B-B14F-4D97-AF65-F5344CB8AC3E}">
-        <p14:creationId xmlns:p14="http://schemas.microsoft.com/office/powerpoint/2010/main" val="1707387436"/>
+        <p14:creationId xmlns:p14="http://schemas.microsoft.com/office/powerpoint/2010/main" val="1178387720"/>
       </p:ext>
     </p:extLst>
   </p:cSld>
@@ -21518,7 +21518,7 @@
           <p:cNvPr id="2" name="TextBox 1">
             <a:extLst xmlns:a="http://schemas.openxmlformats.org/drawingml/2006/main">
               <a:ext uri="{FF2B5EF4-FFF2-40B4-BE49-F238E27FC236}">
-                <a16:creationId xmlns:a16="http://schemas.microsoft.com/office/drawing/2014/main" id="{5FD9C22E-0936-4183-A433-3FCF7175B311}"/>
+                <a16:creationId xmlns:a16="http://schemas.microsoft.com/office/drawing/2014/main" id="{BA0E0014-25AF-4EDD-A86F-8F4158FE753A}"/>
               </a:ext>
             </a:extLst>
           </p:cNvPr>
@@ -21565,7 +21565,7 @@
           <p:cNvPr id="3" name="TextBox 2">
             <a:extLst xmlns:a="http://schemas.openxmlformats.org/drawingml/2006/main">
               <a:ext uri="{FF2B5EF4-FFF2-40B4-BE49-F238E27FC236}">
-                <a16:creationId xmlns:a16="http://schemas.microsoft.com/office/drawing/2014/main" id="{87F18902-FB7F-4468-9236-AC4DB5FA606F}"/>
+                <a16:creationId xmlns:a16="http://schemas.microsoft.com/office/drawing/2014/main" id="{B523DA14-1708-48A0-AAF3-C79C19A28BFE}"/>
               </a:ext>
             </a:extLst>
           </p:cNvPr>
@@ -21612,7 +21612,7 @@
           <p:cNvPr id="4" name="Rectangle 3">
             <a:extLst xmlns:a="http://schemas.openxmlformats.org/drawingml/2006/main">
               <a:ext uri="{FF2B5EF4-FFF2-40B4-BE49-F238E27FC236}">
-                <a16:creationId xmlns:a16="http://schemas.microsoft.com/office/drawing/2014/main" id="{6B6A6BCF-E493-4970-904A-6BC94F636FDE}"/>
+                <a16:creationId xmlns:a16="http://schemas.microsoft.com/office/drawing/2014/main" id="{79C58AD9-952F-4B0D-87A1-037429A31B9F}"/>
               </a:ext>
             </a:extLst>
           </p:cNvPr>
@@ -21667,7 +21667,7 @@
           <p:cNvPr id="5" name="Rectangle 4">
             <a:extLst xmlns:a="http://schemas.openxmlformats.org/drawingml/2006/main">
               <a:ext uri="{FF2B5EF4-FFF2-40B4-BE49-F238E27FC236}">
-                <a16:creationId xmlns:a16="http://schemas.microsoft.com/office/drawing/2014/main" id="{2E25D073-19E2-4E5F-9B91-200B012056D6}"/>
+                <a16:creationId xmlns:a16="http://schemas.microsoft.com/office/drawing/2014/main" id="{65FE4F14-8E8C-4FAB-B774-DFCA84BD71F2}"/>
               </a:ext>
             </a:extLst>
           </p:cNvPr>
@@ -21722,7 +21722,7 @@
           <p:cNvPr id="6" name="TextBox 5">
             <a:extLst xmlns:a="http://schemas.openxmlformats.org/drawingml/2006/main">
               <a:ext uri="{FF2B5EF4-FFF2-40B4-BE49-F238E27FC236}">
-                <a16:creationId xmlns:a16="http://schemas.microsoft.com/office/drawing/2014/main" id="{325CFED0-7FDD-4872-8379-9A6BA5533A0F}"/>
+                <a16:creationId xmlns:a16="http://schemas.microsoft.com/office/drawing/2014/main" id="{98176D4F-6E17-4D73-BC84-FFB85AC8D6CC}"/>
               </a:ext>
             </a:extLst>
           </p:cNvPr>
@@ -21759,7 +21759,7 @@
                 <a:ea typeface="Aptos"/>
                 <a:cs typeface="Aptos"/>
               </a:rPr>
-              <a:t>Independent public evidence summary · 2026.07.22-9 · 2026-07-22 · Sources: WIPO valuation</a:t>
+              <a:t>Independent public evidence summary · 2026.07.23-10 · 2026-07-22 · Sources: WIPO valuation</a:t>
             </a:r>
           </a:p>
         </p:txBody>
@@ -21769,7 +21769,7 @@
           <p:cNvPr id="7" name="TextBox 6">
             <a:extLst xmlns:a="http://schemas.openxmlformats.org/drawingml/2006/main">
               <a:ext uri="{FF2B5EF4-FFF2-40B4-BE49-F238E27FC236}">
-                <a16:creationId xmlns:a16="http://schemas.microsoft.com/office/drawing/2014/main" id="{8AC4850B-48C1-4AF0-A7D7-C0EA57F5AA94}"/>
+                <a16:creationId xmlns:a16="http://schemas.microsoft.com/office/drawing/2014/main" id="{5DA579D6-1EE1-4D4A-9DF4-59C9FE3289E1}"/>
               </a:ext>
             </a:extLst>
           </p:cNvPr>
@@ -22502,7 +22502,7 @@
           <p:cNvPr id="9" name="TextBox 8">
             <a:extLst xmlns:a="http://schemas.openxmlformats.org/drawingml/2006/main">
               <a:ext uri="{FF2B5EF4-FFF2-40B4-BE49-F238E27FC236}">
-                <a16:creationId xmlns:a16="http://schemas.microsoft.com/office/drawing/2014/main" id="{4E5CF8AB-6039-4F8E-BB41-CF294BF05485}"/>
+                <a16:creationId xmlns:a16="http://schemas.microsoft.com/office/drawing/2014/main" id="{B42BCE63-1847-45C0-8BE5-F245557E685B}"/>
               </a:ext>
             </a:extLst>
           </p:cNvPr>
@@ -22547,7 +22547,7 @@
     </p:spTree>
     <p:extLst>
       <p:ext uri="{BB962C8B-B14F-4D97-AF65-F5344CB8AC3E}">
-        <p14:creationId xmlns:p14="http://schemas.microsoft.com/office/powerpoint/2010/main" val="53254733"/>
+        <p14:creationId xmlns:p14="http://schemas.microsoft.com/office/powerpoint/2010/main" val="1405375829"/>
       </p:ext>
     </p:extLst>
   </p:cSld>
@@ -22571,7 +22571,7 @@
           <p:cNvPr id="2" name="TextBox 1">
             <a:extLst xmlns:a="http://schemas.openxmlformats.org/drawingml/2006/main">
               <a:ext uri="{FF2B5EF4-FFF2-40B4-BE49-F238E27FC236}">
-                <a16:creationId xmlns:a16="http://schemas.microsoft.com/office/drawing/2014/main" id="{FDA63CFE-2427-48EE-B5AB-B5243B9B8DDD}"/>
+                <a16:creationId xmlns:a16="http://schemas.microsoft.com/office/drawing/2014/main" id="{CE739E78-52E5-4251-B279-2881146437B4}"/>
               </a:ext>
             </a:extLst>
           </p:cNvPr>
@@ -22618,7 +22618,7 @@
           <p:cNvPr id="3" name="TextBox 2">
             <a:extLst xmlns:a="http://schemas.openxmlformats.org/drawingml/2006/main">
               <a:ext uri="{FF2B5EF4-FFF2-40B4-BE49-F238E27FC236}">
-                <a16:creationId xmlns:a16="http://schemas.microsoft.com/office/drawing/2014/main" id="{03B93B61-C5AE-473B-BFF6-C6EA195A30AD}"/>
+                <a16:creationId xmlns:a16="http://schemas.microsoft.com/office/drawing/2014/main" id="{5C5FD976-EA75-468D-833F-477F5B1AF458}"/>
               </a:ext>
             </a:extLst>
           </p:cNvPr>
@@ -22665,7 +22665,7 @@
           <p:cNvPr id="4" name="Rectangle 3">
             <a:extLst xmlns:a="http://schemas.openxmlformats.org/drawingml/2006/main">
               <a:ext uri="{FF2B5EF4-FFF2-40B4-BE49-F238E27FC236}">
-                <a16:creationId xmlns:a16="http://schemas.microsoft.com/office/drawing/2014/main" id="{15A32B4B-B3D7-4083-8B32-D6C8C9A5B4C2}"/>
+                <a16:creationId xmlns:a16="http://schemas.microsoft.com/office/drawing/2014/main" id="{C623E92F-BCCE-4C09-B4BA-064921740286}"/>
               </a:ext>
             </a:extLst>
           </p:cNvPr>
@@ -22720,7 +22720,7 @@
           <p:cNvPr id="5" name="Rectangle 4">
             <a:extLst xmlns:a="http://schemas.openxmlformats.org/drawingml/2006/main">
               <a:ext uri="{FF2B5EF4-FFF2-40B4-BE49-F238E27FC236}">
-                <a16:creationId xmlns:a16="http://schemas.microsoft.com/office/drawing/2014/main" id="{6A3F3C49-526C-4917-B375-4E090959114C}"/>
+                <a16:creationId xmlns:a16="http://schemas.microsoft.com/office/drawing/2014/main" id="{0EE6075F-0159-42BD-8FB6-E1ED96D16E00}"/>
               </a:ext>
             </a:extLst>
           </p:cNvPr>
@@ -22775,7 +22775,7 @@
           <p:cNvPr id="6" name="TextBox 5">
             <a:extLst xmlns:a="http://schemas.openxmlformats.org/drawingml/2006/main">
               <a:ext uri="{FF2B5EF4-FFF2-40B4-BE49-F238E27FC236}">
-                <a16:creationId xmlns:a16="http://schemas.microsoft.com/office/drawing/2014/main" id="{6C7FF603-B003-492E-A5EC-3AE2B6E15EC1}"/>
+                <a16:creationId xmlns:a16="http://schemas.microsoft.com/office/drawing/2014/main" id="{6C2E195D-0BAE-4821-A054-A043CBE4AD7E}"/>
               </a:ext>
             </a:extLst>
           </p:cNvPr>
@@ -22812,7 +22812,7 @@
                 <a:ea typeface="Aptos"/>
                 <a:cs typeface="Aptos"/>
               </a:rPr>
-              <a:t>Independent public evidence summary · 2026.07.22-9 · 2026-07-22 · Sources: Evidence Register</a:t>
+              <a:t>Independent public evidence summary · 2026.07.23-10 · 2026-07-22 · Sources: Evidence Register</a:t>
             </a:r>
           </a:p>
         </p:txBody>
@@ -22822,7 +22822,7 @@
           <p:cNvPr id="7" name="TextBox 6">
             <a:extLst xmlns:a="http://schemas.openxmlformats.org/drawingml/2006/main">
               <a:ext uri="{FF2B5EF4-FFF2-40B4-BE49-F238E27FC236}">
-                <a16:creationId xmlns:a16="http://schemas.microsoft.com/office/drawing/2014/main" id="{80DB0655-A2BB-4C54-BC7C-D60DA44498A5}"/>
+                <a16:creationId xmlns:a16="http://schemas.microsoft.com/office/drawing/2014/main" id="{798243D3-46E4-4F6D-B6D0-DDE7AA9E137D}"/>
               </a:ext>
             </a:extLst>
           </p:cNvPr>
@@ -23392,7 +23392,7 @@
           <p:cNvPr id="9" name="TextBox 8">
             <a:extLst xmlns:a="http://schemas.openxmlformats.org/drawingml/2006/main">
               <a:ext uri="{FF2B5EF4-FFF2-40B4-BE49-F238E27FC236}">
-                <a16:creationId xmlns:a16="http://schemas.microsoft.com/office/drawing/2014/main" id="{3C0A7508-93B6-45B7-93F0-A33E091F3D79}"/>
+                <a16:creationId xmlns:a16="http://schemas.microsoft.com/office/drawing/2014/main" id="{68AB7D60-A601-41B5-B446-D8E3C23AF0AF}"/>
               </a:ext>
             </a:extLst>
           </p:cNvPr>
@@ -23437,7 +23437,7 @@
     </p:spTree>
     <p:extLst>
       <p:ext uri="{BB962C8B-B14F-4D97-AF65-F5344CB8AC3E}">
-        <p14:creationId xmlns:p14="http://schemas.microsoft.com/office/powerpoint/2010/main" val="1746787613"/>
+        <p14:creationId xmlns:p14="http://schemas.microsoft.com/office/powerpoint/2010/main" val="933218628"/>
       </p:ext>
     </p:extLst>
   </p:cSld>
@@ -23461,7 +23461,7 @@
           <p:cNvPr id="2" name="TextBox 1">
             <a:extLst xmlns:a="http://schemas.openxmlformats.org/drawingml/2006/main">
               <a:ext uri="{FF2B5EF4-FFF2-40B4-BE49-F238E27FC236}">
-                <a16:creationId xmlns:a16="http://schemas.microsoft.com/office/drawing/2014/main" id="{B3B0AC0D-8E1B-4616-8FB6-AAA7CE986AB3}"/>
+                <a16:creationId xmlns:a16="http://schemas.microsoft.com/office/drawing/2014/main" id="{E7B51426-E870-4728-9925-DEB716EE23CA}"/>
               </a:ext>
             </a:extLst>
           </p:cNvPr>
@@ -23508,7 +23508,7 @@
           <p:cNvPr id="3" name="TextBox 2">
             <a:extLst xmlns:a="http://schemas.openxmlformats.org/drawingml/2006/main">
               <a:ext uri="{FF2B5EF4-FFF2-40B4-BE49-F238E27FC236}">
-                <a16:creationId xmlns:a16="http://schemas.microsoft.com/office/drawing/2014/main" id="{BE166885-1780-4BE6-8334-E6DAC006528A}"/>
+                <a16:creationId xmlns:a16="http://schemas.microsoft.com/office/drawing/2014/main" id="{348C8034-912C-4B35-9751-B9432C2C913B}"/>
               </a:ext>
             </a:extLst>
           </p:cNvPr>
@@ -23555,7 +23555,7 @@
           <p:cNvPr id="4" name="Rectangle 3">
             <a:extLst xmlns:a="http://schemas.openxmlformats.org/drawingml/2006/main">
               <a:ext uri="{FF2B5EF4-FFF2-40B4-BE49-F238E27FC236}">
-                <a16:creationId xmlns:a16="http://schemas.microsoft.com/office/drawing/2014/main" id="{DB0101B4-A009-4437-9ACA-F206464300CB}"/>
+                <a16:creationId xmlns:a16="http://schemas.microsoft.com/office/drawing/2014/main" id="{1D9BCD7B-92EB-43DD-B7F4-FE967F5BE907}"/>
               </a:ext>
             </a:extLst>
           </p:cNvPr>
@@ -23610,7 +23610,7 @@
           <p:cNvPr id="5" name="Rectangle 4">
             <a:extLst xmlns:a="http://schemas.openxmlformats.org/drawingml/2006/main">
               <a:ext uri="{FF2B5EF4-FFF2-40B4-BE49-F238E27FC236}">
-                <a16:creationId xmlns:a16="http://schemas.microsoft.com/office/drawing/2014/main" id="{31BFCC2D-11BA-4D9D-8C14-742D04F5A275}"/>
+                <a16:creationId xmlns:a16="http://schemas.microsoft.com/office/drawing/2014/main" id="{AF1F63F0-1A48-432D-908D-3CDDEDB2BB76}"/>
               </a:ext>
             </a:extLst>
           </p:cNvPr>
@@ -23665,7 +23665,7 @@
           <p:cNvPr id="6" name="TextBox 5">
             <a:extLst xmlns:a="http://schemas.openxmlformats.org/drawingml/2006/main">
               <a:ext uri="{FF2B5EF4-FFF2-40B4-BE49-F238E27FC236}">
-                <a16:creationId xmlns:a16="http://schemas.microsoft.com/office/drawing/2014/main" id="{0231597F-B7B1-43E9-BEC9-7877405CB2F0}"/>
+                <a16:creationId xmlns:a16="http://schemas.microsoft.com/office/drawing/2014/main" id="{57C4E468-03ED-4E21-8154-A68DF39E17A9}"/>
               </a:ext>
             </a:extLst>
           </p:cNvPr>
@@ -23702,7 +23702,7 @@
                 <a:ea typeface="Aptos"/>
                 <a:cs typeface="Aptos"/>
               </a:rPr>
-              <a:t>Independent public evidence summary · 2026.07.22-9 · 2026-07-22 · Sources: Evidence Register</a:t>
+              <a:t>Independent public evidence summary · 2026.07.23-10 · 2026-07-22 · Sources: Evidence Register</a:t>
             </a:r>
           </a:p>
         </p:txBody>
@@ -23712,7 +23712,7 @@
           <p:cNvPr id="7" name="TextBox 6">
             <a:extLst xmlns:a="http://schemas.openxmlformats.org/drawingml/2006/main">
               <a:ext uri="{FF2B5EF4-FFF2-40B4-BE49-F238E27FC236}">
-                <a16:creationId xmlns:a16="http://schemas.microsoft.com/office/drawing/2014/main" id="{14D217F7-7B5B-423B-ADB7-8A44CCC90FDE}"/>
+                <a16:creationId xmlns:a16="http://schemas.microsoft.com/office/drawing/2014/main" id="{F62273F6-877F-4EE8-9F6F-33CA6710AE5E}"/>
               </a:ext>
             </a:extLst>
           </p:cNvPr>
@@ -24365,7 +24365,7 @@
           <p:cNvPr id="9" name="TextBox 8">
             <a:extLst xmlns:a="http://schemas.openxmlformats.org/drawingml/2006/main">
               <a:ext uri="{FF2B5EF4-FFF2-40B4-BE49-F238E27FC236}">
-                <a16:creationId xmlns:a16="http://schemas.microsoft.com/office/drawing/2014/main" id="{76316B92-0CB8-4DA8-A5C0-CD7687C09989}"/>
+                <a16:creationId xmlns:a16="http://schemas.microsoft.com/office/drawing/2014/main" id="{6F842D77-9A27-413A-8022-C7DA46E544BA}"/>
               </a:ext>
             </a:extLst>
           </p:cNvPr>
@@ -24410,7 +24410,7 @@
     </p:spTree>
     <p:extLst>
       <p:ext uri="{BB962C8B-B14F-4D97-AF65-F5344CB8AC3E}">
-        <p14:creationId xmlns:p14="http://schemas.microsoft.com/office/powerpoint/2010/main" val="1660671506"/>
+        <p14:creationId xmlns:p14="http://schemas.microsoft.com/office/powerpoint/2010/main" val="761923218"/>
       </p:ext>
     </p:extLst>
   </p:cSld>
@@ -24434,7 +24434,7 @@
           <p:cNvPr id="2" name="TextBox 1">
             <a:extLst xmlns:a="http://schemas.openxmlformats.org/drawingml/2006/main">
               <a:ext uri="{FF2B5EF4-FFF2-40B4-BE49-F238E27FC236}">
-                <a16:creationId xmlns:a16="http://schemas.microsoft.com/office/drawing/2014/main" id="{738B1D29-447A-484B-96B3-6D66E1726268}"/>
+                <a16:creationId xmlns:a16="http://schemas.microsoft.com/office/drawing/2014/main" id="{E931539C-865A-4AE2-A2A6-40AECF85EDAD}"/>
               </a:ext>
             </a:extLst>
           </p:cNvPr>
@@ -24481,7 +24481,7 @@
           <p:cNvPr id="3" name="TextBox 2">
             <a:extLst xmlns:a="http://schemas.openxmlformats.org/drawingml/2006/main">
               <a:ext uri="{FF2B5EF4-FFF2-40B4-BE49-F238E27FC236}">
-                <a16:creationId xmlns:a16="http://schemas.microsoft.com/office/drawing/2014/main" id="{921574DC-07D3-48AE-A35A-D5ECC19CCB3B}"/>
+                <a16:creationId xmlns:a16="http://schemas.microsoft.com/office/drawing/2014/main" id="{EC356DDA-5572-443C-90AE-E7B9F8EFE20C}"/>
               </a:ext>
             </a:extLst>
           </p:cNvPr>
@@ -24528,7 +24528,7 @@
           <p:cNvPr id="4" name="Rectangle 3">
             <a:extLst xmlns:a="http://schemas.openxmlformats.org/drawingml/2006/main">
               <a:ext uri="{FF2B5EF4-FFF2-40B4-BE49-F238E27FC236}">
-                <a16:creationId xmlns:a16="http://schemas.microsoft.com/office/drawing/2014/main" id="{B8C9040A-E790-452E-ADD3-918E62FD3F9E}"/>
+                <a16:creationId xmlns:a16="http://schemas.microsoft.com/office/drawing/2014/main" id="{A67D95BA-C8D0-4C0D-8A27-C58AB3305E41}"/>
               </a:ext>
             </a:extLst>
           </p:cNvPr>
@@ -24583,7 +24583,7 @@
           <p:cNvPr id="5" name="Rectangle 4">
             <a:extLst xmlns:a="http://schemas.openxmlformats.org/drawingml/2006/main">
               <a:ext uri="{FF2B5EF4-FFF2-40B4-BE49-F238E27FC236}">
-                <a16:creationId xmlns:a16="http://schemas.microsoft.com/office/drawing/2014/main" id="{508EC97A-7AD8-4FBB-BC5E-5A91B5ED8AF0}"/>
+                <a16:creationId xmlns:a16="http://schemas.microsoft.com/office/drawing/2014/main" id="{17C2568B-5B65-49EB-A10D-0E783A45490A}"/>
               </a:ext>
             </a:extLst>
           </p:cNvPr>
@@ -24638,7 +24638,7 @@
           <p:cNvPr id="6" name="TextBox 5">
             <a:extLst xmlns:a="http://schemas.openxmlformats.org/drawingml/2006/main">
               <a:ext uri="{FF2B5EF4-FFF2-40B4-BE49-F238E27FC236}">
-                <a16:creationId xmlns:a16="http://schemas.microsoft.com/office/drawing/2014/main" id="{DCD307B9-18E9-497D-973C-78CDF45EAFAD}"/>
+                <a16:creationId xmlns:a16="http://schemas.microsoft.com/office/drawing/2014/main" id="{61AC46D3-7578-4E6D-88DC-C0B3089CB2FC}"/>
               </a:ext>
             </a:extLst>
           </p:cNvPr>
@@ -24675,7 +24675,7 @@
                 <a:ea typeface="Aptos"/>
                 <a:cs typeface="Aptos"/>
               </a:rPr>
-              <a:t>Independent public evidence summary · 2026.07.22-9 · 2026-07-22 · Sources: Evidence Register; changelog</a:t>
+              <a:t>Independent public evidence summary · 2026.07.23-10 · 2026-07-22 · Sources: Evidence Register; changelog</a:t>
             </a:r>
           </a:p>
         </p:txBody>
@@ -24685,7 +24685,7 @@
           <p:cNvPr id="7" name="TextBox 6">
             <a:extLst xmlns:a="http://schemas.openxmlformats.org/drawingml/2006/main">
               <a:ext uri="{FF2B5EF4-FFF2-40B4-BE49-F238E27FC236}">
-                <a16:creationId xmlns:a16="http://schemas.microsoft.com/office/drawing/2014/main" id="{E1CFA685-250F-42A4-87C6-553C495CA4CB}"/>
+                <a16:creationId xmlns:a16="http://schemas.microsoft.com/office/drawing/2014/main" id="{A5C754B4-9B99-4E21-BFC1-E3256B11E71B}"/>
               </a:ext>
             </a:extLst>
           </p:cNvPr>
@@ -24732,7 +24732,7 @@
           <p:cNvPr id="8" name="Rounded Rectangle 7">
             <a:extLst xmlns:a="http://schemas.openxmlformats.org/drawingml/2006/main">
               <a:ext uri="{FF2B5EF4-FFF2-40B4-BE49-F238E27FC236}">
-                <a16:creationId xmlns:a16="http://schemas.microsoft.com/office/drawing/2014/main" id="{A22079C8-4DA4-4600-927C-009924C1FBC3}"/>
+                <a16:creationId xmlns:a16="http://schemas.microsoft.com/office/drawing/2014/main" id="{77A32934-8478-4732-97FD-3836F3209768}"/>
               </a:ext>
             </a:extLst>
           </p:cNvPr>
@@ -24789,7 +24789,7 @@
           <p:cNvPr id="9" name="TextBox 8">
             <a:extLst xmlns:a="http://schemas.openxmlformats.org/drawingml/2006/main">
               <a:ext uri="{FF2B5EF4-FFF2-40B4-BE49-F238E27FC236}">
-                <a16:creationId xmlns:a16="http://schemas.microsoft.com/office/drawing/2014/main" id="{4B9CD6EC-AC04-447B-8FC7-7F0249F7BC38}"/>
+                <a16:creationId xmlns:a16="http://schemas.microsoft.com/office/drawing/2014/main" id="{9101AB6F-703A-4D5C-90EA-D382780A6FA9}"/>
               </a:ext>
             </a:extLst>
           </p:cNvPr>
@@ -24836,7 +24836,7 @@
           <p:cNvPr id="10" name="TextBox 9">
             <a:extLst xmlns:a="http://schemas.openxmlformats.org/drawingml/2006/main">
               <a:ext uri="{FF2B5EF4-FFF2-40B4-BE49-F238E27FC236}">
-                <a16:creationId xmlns:a16="http://schemas.microsoft.com/office/drawing/2014/main" id="{583B4150-2D37-4F31-8AFE-C1F14E99EC0E}"/>
+                <a16:creationId xmlns:a16="http://schemas.microsoft.com/office/drawing/2014/main" id="{910751A1-7DC7-4D08-9084-B4FD379AD980}"/>
               </a:ext>
             </a:extLst>
           </p:cNvPr>
@@ -24883,7 +24883,7 @@
           <p:cNvPr id="11" name="TextBox 10">
             <a:extLst xmlns:a="http://schemas.openxmlformats.org/drawingml/2006/main">
               <a:ext uri="{FF2B5EF4-FFF2-40B4-BE49-F238E27FC236}">
-                <a16:creationId xmlns:a16="http://schemas.microsoft.com/office/drawing/2014/main" id="{A778ED5C-1EBA-4A46-B04F-09C19F771BBB}"/>
+                <a16:creationId xmlns:a16="http://schemas.microsoft.com/office/drawing/2014/main" id="{DC4282B3-B638-430E-B5B7-06917F72187E}"/>
               </a:ext>
             </a:extLst>
           </p:cNvPr>
@@ -24930,7 +24930,7 @@
           <p:cNvPr id="12" name="Rounded Rectangle 11">
             <a:extLst xmlns:a="http://schemas.openxmlformats.org/drawingml/2006/main">
               <a:ext uri="{FF2B5EF4-FFF2-40B4-BE49-F238E27FC236}">
-                <a16:creationId xmlns:a16="http://schemas.microsoft.com/office/drawing/2014/main" id="{79B26E7D-2A9D-42AA-B851-1A2D2CB7AE86}"/>
+                <a16:creationId xmlns:a16="http://schemas.microsoft.com/office/drawing/2014/main" id="{0F8F0269-6A2B-42F0-88FA-53F9E9A1A9DD}"/>
               </a:ext>
             </a:extLst>
           </p:cNvPr>
@@ -24987,7 +24987,7 @@
           <p:cNvPr id="13" name="TextBox 12">
             <a:extLst xmlns:a="http://schemas.openxmlformats.org/drawingml/2006/main">
               <a:ext uri="{FF2B5EF4-FFF2-40B4-BE49-F238E27FC236}">
-                <a16:creationId xmlns:a16="http://schemas.microsoft.com/office/drawing/2014/main" id="{1BA9958D-22B8-4758-95B0-AFBF3F4BC2D2}"/>
+                <a16:creationId xmlns:a16="http://schemas.microsoft.com/office/drawing/2014/main" id="{6178299B-6D0B-4500-A379-543E50F107F4}"/>
               </a:ext>
             </a:extLst>
           </p:cNvPr>
@@ -25034,7 +25034,7 @@
           <p:cNvPr id="14" name="TextBox 13">
             <a:extLst xmlns:a="http://schemas.openxmlformats.org/drawingml/2006/main">
               <a:ext uri="{FF2B5EF4-FFF2-40B4-BE49-F238E27FC236}">
-                <a16:creationId xmlns:a16="http://schemas.microsoft.com/office/drawing/2014/main" id="{7B9DA7EA-C817-46B5-99D4-C192E02112F6}"/>
+                <a16:creationId xmlns:a16="http://schemas.microsoft.com/office/drawing/2014/main" id="{399D9A65-C244-4D6C-8DEB-8639133D87FD}"/>
               </a:ext>
             </a:extLst>
           </p:cNvPr>
@@ -25081,7 +25081,7 @@
           <p:cNvPr id="15" name="TextBox 14">
             <a:extLst xmlns:a="http://schemas.openxmlformats.org/drawingml/2006/main">
               <a:ext uri="{FF2B5EF4-FFF2-40B4-BE49-F238E27FC236}">
-                <a16:creationId xmlns:a16="http://schemas.microsoft.com/office/drawing/2014/main" id="{2A365AA1-F463-4C81-A8E3-7ACBD469D273}"/>
+                <a16:creationId xmlns:a16="http://schemas.microsoft.com/office/drawing/2014/main" id="{F77D1CB0-3153-42F5-81BD-75C9C191E3EA}"/>
               </a:ext>
             </a:extLst>
           </p:cNvPr>
@@ -25128,7 +25128,7 @@
           <p:cNvPr id="16" name="Rounded Rectangle 15">
             <a:extLst xmlns:a="http://schemas.openxmlformats.org/drawingml/2006/main">
               <a:ext uri="{FF2B5EF4-FFF2-40B4-BE49-F238E27FC236}">
-                <a16:creationId xmlns:a16="http://schemas.microsoft.com/office/drawing/2014/main" id="{026A4820-1AEB-40AF-A75A-63E101128F1A}"/>
+                <a16:creationId xmlns:a16="http://schemas.microsoft.com/office/drawing/2014/main" id="{449E57A4-AFC9-44E9-9C00-EF0A5DE0E2DB}"/>
               </a:ext>
             </a:extLst>
           </p:cNvPr>
@@ -25185,7 +25185,7 @@
           <p:cNvPr id="17" name="TextBox 16">
             <a:extLst xmlns:a="http://schemas.openxmlformats.org/drawingml/2006/main">
               <a:ext uri="{FF2B5EF4-FFF2-40B4-BE49-F238E27FC236}">
-                <a16:creationId xmlns:a16="http://schemas.microsoft.com/office/drawing/2014/main" id="{E210E917-A93A-4C7C-9C94-1DF2FE5DDAE9}"/>
+                <a16:creationId xmlns:a16="http://schemas.microsoft.com/office/drawing/2014/main" id="{AFC6793B-69A5-46C0-B1C3-518840C7BA36}"/>
               </a:ext>
             </a:extLst>
           </p:cNvPr>
@@ -25232,7 +25232,7 @@
           <p:cNvPr id="18" name="TextBox 17">
             <a:extLst xmlns:a="http://schemas.openxmlformats.org/drawingml/2006/main">
               <a:ext uri="{FF2B5EF4-FFF2-40B4-BE49-F238E27FC236}">
-                <a16:creationId xmlns:a16="http://schemas.microsoft.com/office/drawing/2014/main" id="{C730F891-4159-4EF6-9F13-31175D5440D9}"/>
+                <a16:creationId xmlns:a16="http://schemas.microsoft.com/office/drawing/2014/main" id="{3369C1C1-76AF-497F-8E2B-68E913E0F6B7}"/>
               </a:ext>
             </a:extLst>
           </p:cNvPr>
@@ -25279,7 +25279,7 @@
           <p:cNvPr id="19" name="TextBox 18">
             <a:extLst xmlns:a="http://schemas.openxmlformats.org/drawingml/2006/main">
               <a:ext uri="{FF2B5EF4-FFF2-40B4-BE49-F238E27FC236}">
-                <a16:creationId xmlns:a16="http://schemas.microsoft.com/office/drawing/2014/main" id="{3EB40D68-916A-47E4-AD11-E07DDF1F7766}"/>
+                <a16:creationId xmlns:a16="http://schemas.microsoft.com/office/drawing/2014/main" id="{299BBD7E-5DEB-42B9-B730-4F4AA3D453A6}"/>
               </a:ext>
             </a:extLst>
           </p:cNvPr>
@@ -25326,7 +25326,7 @@
           <p:cNvPr id="20" name="Rounded Rectangle 19">
             <a:extLst xmlns:a="http://schemas.openxmlformats.org/drawingml/2006/main">
               <a:ext uri="{FF2B5EF4-FFF2-40B4-BE49-F238E27FC236}">
-                <a16:creationId xmlns:a16="http://schemas.microsoft.com/office/drawing/2014/main" id="{130B32E7-0603-49D1-A571-B44A9C3B3820}"/>
+                <a16:creationId xmlns:a16="http://schemas.microsoft.com/office/drawing/2014/main" id="{03E5F1DF-ECF4-416E-BADD-E9F18722A223}"/>
               </a:ext>
             </a:extLst>
           </p:cNvPr>
@@ -25383,7 +25383,7 @@
           <p:cNvPr id="21" name="TextBox 20">
             <a:extLst xmlns:a="http://schemas.openxmlformats.org/drawingml/2006/main">
               <a:ext uri="{FF2B5EF4-FFF2-40B4-BE49-F238E27FC236}">
-                <a16:creationId xmlns:a16="http://schemas.microsoft.com/office/drawing/2014/main" id="{882EDC1C-6920-4C1F-9491-D648952B248E}"/>
+                <a16:creationId xmlns:a16="http://schemas.microsoft.com/office/drawing/2014/main" id="{ECD7C601-3F12-46C2-8EC9-ABD7CC47B478}"/>
               </a:ext>
             </a:extLst>
           </p:cNvPr>
@@ -25430,7 +25430,7 @@
           <p:cNvPr id="22" name="TextBox 21">
             <a:extLst xmlns:a="http://schemas.openxmlformats.org/drawingml/2006/main">
               <a:ext uri="{FF2B5EF4-FFF2-40B4-BE49-F238E27FC236}">
-                <a16:creationId xmlns:a16="http://schemas.microsoft.com/office/drawing/2014/main" id="{D97ED6F2-AEDF-4DE4-8EC7-1BB3FF8D0F3B}"/>
+                <a16:creationId xmlns:a16="http://schemas.microsoft.com/office/drawing/2014/main" id="{DEBDE6D6-23C0-4484-BD56-C7E4E4BC25FC}"/>
               </a:ext>
             </a:extLst>
           </p:cNvPr>
@@ -25477,7 +25477,7 @@
           <p:cNvPr id="23" name="TextBox 22">
             <a:extLst xmlns:a="http://schemas.openxmlformats.org/drawingml/2006/main">
               <a:ext uri="{FF2B5EF4-FFF2-40B4-BE49-F238E27FC236}">
-                <a16:creationId xmlns:a16="http://schemas.microsoft.com/office/drawing/2014/main" id="{8B693996-F9ED-4A77-9337-4CC7415575A1}"/>
+                <a16:creationId xmlns:a16="http://schemas.microsoft.com/office/drawing/2014/main" id="{CAB7B1A1-A6B9-430F-AFA8-C2493BD754B6}"/>
               </a:ext>
             </a:extLst>
           </p:cNvPr>
@@ -25524,7 +25524,7 @@
           <p:cNvPr id="24" name="TextBox 23">
             <a:extLst xmlns:a="http://schemas.openxmlformats.org/drawingml/2006/main">
               <a:ext uri="{FF2B5EF4-FFF2-40B4-BE49-F238E27FC236}">
-                <a16:creationId xmlns:a16="http://schemas.microsoft.com/office/drawing/2014/main" id="{42529BC9-58C2-414F-9273-77732735316C}"/>
+                <a16:creationId xmlns:a16="http://schemas.microsoft.com/office/drawing/2014/main" id="{8234CC30-EF4B-4418-A8BE-68CE82B3D4FC}"/>
               </a:ext>
             </a:extLst>
           </p:cNvPr>
@@ -25569,7 +25569,7 @@
     </p:spTree>
     <p:extLst>
       <p:ext uri="{BB962C8B-B14F-4D97-AF65-F5344CB8AC3E}">
-        <p14:creationId xmlns:p14="http://schemas.microsoft.com/office/powerpoint/2010/main" val="92321566"/>
+        <p14:creationId xmlns:p14="http://schemas.microsoft.com/office/powerpoint/2010/main" val="1801416930"/>
       </p:ext>
     </p:extLst>
   </p:cSld>
@@ -25593,7 +25593,7 @@
           <p:cNvPr id="2" name="TextBox 1">
             <a:extLst xmlns:a="http://schemas.openxmlformats.org/drawingml/2006/main">
               <a:ext uri="{FF2B5EF4-FFF2-40B4-BE49-F238E27FC236}">
-                <a16:creationId xmlns:a16="http://schemas.microsoft.com/office/drawing/2014/main" id="{579AC010-F3B8-4B79-AE8B-802D8F87309E}"/>
+                <a16:creationId xmlns:a16="http://schemas.microsoft.com/office/drawing/2014/main" id="{DC39BE08-B519-44DD-A47D-4CA5CAC9A9CA}"/>
               </a:ext>
             </a:extLst>
           </p:cNvPr>
@@ -25640,7 +25640,7 @@
           <p:cNvPr id="3" name="TextBox 2">
             <a:extLst xmlns:a="http://schemas.openxmlformats.org/drawingml/2006/main">
               <a:ext uri="{FF2B5EF4-FFF2-40B4-BE49-F238E27FC236}">
-                <a16:creationId xmlns:a16="http://schemas.microsoft.com/office/drawing/2014/main" id="{DDCB1B9C-52F5-4FC7-B4EA-C8F20A2171B7}"/>
+                <a16:creationId xmlns:a16="http://schemas.microsoft.com/office/drawing/2014/main" id="{E5187957-0F8B-475D-828C-812872F405A4}"/>
               </a:ext>
             </a:extLst>
           </p:cNvPr>
@@ -25687,7 +25687,7 @@
           <p:cNvPr id="4" name="Rectangle 3">
             <a:extLst xmlns:a="http://schemas.openxmlformats.org/drawingml/2006/main">
               <a:ext uri="{FF2B5EF4-FFF2-40B4-BE49-F238E27FC236}">
-                <a16:creationId xmlns:a16="http://schemas.microsoft.com/office/drawing/2014/main" id="{B712BD54-C6F5-4056-88D6-69F50254092E}"/>
+                <a16:creationId xmlns:a16="http://schemas.microsoft.com/office/drawing/2014/main" id="{0CC31C4B-B453-429E-8A24-C588A437E82E}"/>
               </a:ext>
             </a:extLst>
           </p:cNvPr>
@@ -25742,7 +25742,7 @@
           <p:cNvPr id="5" name="Rectangle 4">
             <a:extLst xmlns:a="http://schemas.openxmlformats.org/drawingml/2006/main">
               <a:ext uri="{FF2B5EF4-FFF2-40B4-BE49-F238E27FC236}">
-                <a16:creationId xmlns:a16="http://schemas.microsoft.com/office/drawing/2014/main" id="{FE25D6B4-B553-4C89-957F-6FDE67291137}"/>
+                <a16:creationId xmlns:a16="http://schemas.microsoft.com/office/drawing/2014/main" id="{B69B8470-C7A9-433C-9010-4C4B79E30D1E}"/>
               </a:ext>
             </a:extLst>
           </p:cNvPr>
@@ -25797,7 +25797,7 @@
           <p:cNvPr id="6" name="TextBox 5">
             <a:extLst xmlns:a="http://schemas.openxmlformats.org/drawingml/2006/main">
               <a:ext uri="{FF2B5EF4-FFF2-40B4-BE49-F238E27FC236}">
-                <a16:creationId xmlns:a16="http://schemas.microsoft.com/office/drawing/2014/main" id="{51853347-E45C-449C-8652-73E58012513C}"/>
+                <a16:creationId xmlns:a16="http://schemas.microsoft.com/office/drawing/2014/main" id="{C06CCDDB-CB84-4A6D-B3DD-8A05A0E856D4}"/>
               </a:ext>
             </a:extLst>
           </p:cNvPr>
@@ -25834,7 +25834,7 @@
                 <a:ea typeface="Aptos"/>
                 <a:cs typeface="Aptos"/>
               </a:rPr>
-              <a:t>Independent public evidence summary · 2026.07.22-9 · 2026-07-22 · Sources: EPO; 8 Ni 18/24 (EP); 7 O 3341/24</a:t>
+              <a:t>Independent public evidence summary · 2026.07.23-10 · 2026-07-22 · Sources: EPO; 8 Ni 18/24 (EP); 7 O 3341/24</a:t>
             </a:r>
           </a:p>
         </p:txBody>
@@ -25844,7 +25844,7 @@
           <p:cNvPr id="7" name="TextBox 6">
             <a:extLst xmlns:a="http://schemas.openxmlformats.org/drawingml/2006/main">
               <a:ext uri="{FF2B5EF4-FFF2-40B4-BE49-F238E27FC236}">
-                <a16:creationId xmlns:a16="http://schemas.microsoft.com/office/drawing/2014/main" id="{6DD99515-C4C9-433B-A530-27F2A57B94E4}"/>
+                <a16:creationId xmlns:a16="http://schemas.microsoft.com/office/drawing/2014/main" id="{4192D5BE-BB41-451D-A629-B2996F631506}"/>
               </a:ext>
             </a:extLst>
           </p:cNvPr>
@@ -26248,7 +26248,7 @@
           <p:cNvPr id="9" name="TextBox 8">
             <a:extLst xmlns:a="http://schemas.openxmlformats.org/drawingml/2006/main">
               <a:ext uri="{FF2B5EF4-FFF2-40B4-BE49-F238E27FC236}">
-                <a16:creationId xmlns:a16="http://schemas.microsoft.com/office/drawing/2014/main" id="{F1D39DB8-3582-4D2C-BFE4-A7F2E9E68B95}"/>
+                <a16:creationId xmlns:a16="http://schemas.microsoft.com/office/drawing/2014/main" id="{55944AB8-4A44-4244-85D4-A73FE2CD687B}"/>
               </a:ext>
             </a:extLst>
           </p:cNvPr>
@@ -26293,7 +26293,7 @@
     </p:spTree>
     <p:extLst>
       <p:ext uri="{BB962C8B-B14F-4D97-AF65-F5344CB8AC3E}">
-        <p14:creationId xmlns:p14="http://schemas.microsoft.com/office/powerpoint/2010/main" val="1288151326"/>
+        <p14:creationId xmlns:p14="http://schemas.microsoft.com/office/powerpoint/2010/main" val="784500770"/>
       </p:ext>
     </p:extLst>
   </p:cSld>
@@ -26324,7 +26324,7 @@
           <p:cNvPr id="2" name="TextBox 1">
             <a:extLst xmlns:a="http://schemas.openxmlformats.org/drawingml/2006/main">
               <a:ext uri="{FF2B5EF4-FFF2-40B4-BE49-F238E27FC236}">
-                <a16:creationId xmlns:a16="http://schemas.microsoft.com/office/drawing/2014/main" id="{F983CE36-95D3-4520-BAF4-031689D5E41B}"/>
+                <a16:creationId xmlns:a16="http://schemas.microsoft.com/office/drawing/2014/main" id="{B5B2249B-2272-42D2-BCA8-B652BFB2C205}"/>
               </a:ext>
             </a:extLst>
           </p:cNvPr>
@@ -26371,7 +26371,7 @@
           <p:cNvPr id="3" name="TextBox 2">
             <a:extLst xmlns:a="http://schemas.openxmlformats.org/drawingml/2006/main">
               <a:ext uri="{FF2B5EF4-FFF2-40B4-BE49-F238E27FC236}">
-                <a16:creationId xmlns:a16="http://schemas.microsoft.com/office/drawing/2014/main" id="{CCB56563-454C-4968-AD50-34B6664A46BA}"/>
+                <a16:creationId xmlns:a16="http://schemas.microsoft.com/office/drawing/2014/main" id="{CC73BFCA-22C6-4D9C-B837-FDDC18A8E441}"/>
               </a:ext>
             </a:extLst>
           </p:cNvPr>
@@ -26418,7 +26418,7 @@
           <p:cNvPr id="4" name="TextBox 3">
             <a:extLst xmlns:a="http://schemas.openxmlformats.org/drawingml/2006/main">
               <a:ext uri="{FF2B5EF4-FFF2-40B4-BE49-F238E27FC236}">
-                <a16:creationId xmlns:a16="http://schemas.microsoft.com/office/drawing/2014/main" id="{01BABAD7-212C-4123-B693-6BBC0BEA6876}"/>
+                <a16:creationId xmlns:a16="http://schemas.microsoft.com/office/drawing/2014/main" id="{2BD646D0-2301-48CC-B199-BEDB02185563}"/>
               </a:ext>
             </a:extLst>
           </p:cNvPr>
@@ -26537,7 +26537,7 @@
           <p:cNvPr id="5" name="TextBox 4">
             <a:extLst xmlns:a="http://schemas.openxmlformats.org/drawingml/2006/main">
               <a:ext uri="{FF2B5EF4-FFF2-40B4-BE49-F238E27FC236}">
-                <a16:creationId xmlns:a16="http://schemas.microsoft.com/office/drawing/2014/main" id="{ADD564C1-AB61-4336-A3F8-24E54EC10613}"/>
+                <a16:creationId xmlns:a16="http://schemas.microsoft.com/office/drawing/2014/main" id="{9D441880-4F9A-4B1C-BE63-D0EB9F821E6D}"/>
               </a:ext>
             </a:extLst>
           </p:cNvPr>
@@ -26574,7 +26574,7 @@
                 <a:ea typeface="Aptos"/>
                 <a:cs typeface="Aptos"/>
               </a:rPr>
-              <a:t>Version 2026.07.22-9 · 2026-07-22 · 30 / 30</a:t>
+              <a:t>Version 2026.07.23-10 · 2026-07-22 · 30 / 30</a:t>
             </a:r>
           </a:p>
         </p:txBody>
@@ -26582,7 +26582,7 @@
     </p:spTree>
     <p:extLst>
       <p:ext uri="{BB962C8B-B14F-4D97-AF65-F5344CB8AC3E}">
-        <p14:creationId xmlns:p14="http://schemas.microsoft.com/office/powerpoint/2010/main" val="556422540"/>
+        <p14:creationId xmlns:p14="http://schemas.microsoft.com/office/powerpoint/2010/main" val="733978074"/>
       </p:ext>
     </p:extLst>
   </p:cSld>
@@ -26606,7 +26606,7 @@
           <p:cNvPr id="2" name="TextBox 1">
             <a:extLst xmlns:a="http://schemas.openxmlformats.org/drawingml/2006/main">
               <a:ext uri="{FF2B5EF4-FFF2-40B4-BE49-F238E27FC236}">
-                <a16:creationId xmlns:a16="http://schemas.microsoft.com/office/drawing/2014/main" id="{23F78842-F31D-4BCA-A6BB-5EA12A03B320}"/>
+                <a16:creationId xmlns:a16="http://schemas.microsoft.com/office/drawing/2014/main" id="{5FECF78C-1179-40F2-B719-C1D03A470910}"/>
               </a:ext>
             </a:extLst>
           </p:cNvPr>
@@ -26653,7 +26653,7 @@
           <p:cNvPr id="3" name="TextBox 2">
             <a:extLst xmlns:a="http://schemas.openxmlformats.org/drawingml/2006/main">
               <a:ext uri="{FF2B5EF4-FFF2-40B4-BE49-F238E27FC236}">
-                <a16:creationId xmlns:a16="http://schemas.microsoft.com/office/drawing/2014/main" id="{D8FC01DC-76AF-447B-BA62-D2B82BE9380B}"/>
+                <a16:creationId xmlns:a16="http://schemas.microsoft.com/office/drawing/2014/main" id="{6AD31A2B-F6FC-4AE8-A091-9C8AEDDBEFE7}"/>
               </a:ext>
             </a:extLst>
           </p:cNvPr>
@@ -26700,7 +26700,7 @@
           <p:cNvPr id="4" name="Rectangle 3">
             <a:extLst xmlns:a="http://schemas.openxmlformats.org/drawingml/2006/main">
               <a:ext uri="{FF2B5EF4-FFF2-40B4-BE49-F238E27FC236}">
-                <a16:creationId xmlns:a16="http://schemas.microsoft.com/office/drawing/2014/main" id="{E7EBB987-37AD-4869-B075-9B18876817E2}"/>
+                <a16:creationId xmlns:a16="http://schemas.microsoft.com/office/drawing/2014/main" id="{9A7563BD-49C0-40BE-922B-F42B247E79EF}"/>
               </a:ext>
             </a:extLst>
           </p:cNvPr>
@@ -26755,7 +26755,7 @@
           <p:cNvPr id="5" name="Rectangle 4">
             <a:extLst xmlns:a="http://schemas.openxmlformats.org/drawingml/2006/main">
               <a:ext uri="{FF2B5EF4-FFF2-40B4-BE49-F238E27FC236}">
-                <a16:creationId xmlns:a16="http://schemas.microsoft.com/office/drawing/2014/main" id="{355BE1A0-4A21-4B2D-BA2E-5B304B9A08E2}"/>
+                <a16:creationId xmlns:a16="http://schemas.microsoft.com/office/drawing/2014/main" id="{53246B55-0A5F-4593-B902-468A597EAB5C}"/>
               </a:ext>
             </a:extLst>
           </p:cNvPr>
@@ -26810,7 +26810,7 @@
           <p:cNvPr id="6" name="TextBox 5">
             <a:extLst xmlns:a="http://schemas.openxmlformats.org/drawingml/2006/main">
               <a:ext uri="{FF2B5EF4-FFF2-40B4-BE49-F238E27FC236}">
-                <a16:creationId xmlns:a16="http://schemas.microsoft.com/office/drawing/2014/main" id="{E93F9AD1-E09D-4424-8457-D8F1B258BC9C}"/>
+                <a16:creationId xmlns:a16="http://schemas.microsoft.com/office/drawing/2014/main" id="{75B78308-67CD-494B-B3C3-821875554D8B}"/>
               </a:ext>
             </a:extLst>
           </p:cNvPr>
@@ -26847,7 +26847,7 @@
                 <a:ea typeface="Aptos"/>
                 <a:cs typeface="Aptos"/>
               </a:rPr>
-              <a:t>Independent public evidence summary · 2026.07.22-9 · 2026-07-22 · Sources: Evidence Register; WIPO</a:t>
+              <a:t>Independent public evidence summary · 2026.07.23-10 · 2026-07-22 · Sources: Evidence Register; WIPO</a:t>
             </a:r>
           </a:p>
         </p:txBody>
@@ -26857,7 +26857,7 @@
           <p:cNvPr id="7" name="TextBox 6">
             <a:extLst xmlns:a="http://schemas.openxmlformats.org/drawingml/2006/main">
               <a:ext uri="{FF2B5EF4-FFF2-40B4-BE49-F238E27FC236}">
-                <a16:creationId xmlns:a16="http://schemas.microsoft.com/office/drawing/2014/main" id="{8D7206DC-AA3D-4387-A8FD-D031C396210B}"/>
+                <a16:creationId xmlns:a16="http://schemas.microsoft.com/office/drawing/2014/main" id="{493339A3-1E23-495C-B193-D4A359EB7FBF}"/>
               </a:ext>
             </a:extLst>
           </p:cNvPr>
@@ -26904,7 +26904,7 @@
           <p:cNvPr id="8" name="TextBox 7">
             <a:extLst xmlns:a="http://schemas.openxmlformats.org/drawingml/2006/main">
               <a:ext uri="{FF2B5EF4-FFF2-40B4-BE49-F238E27FC236}">
-                <a16:creationId xmlns:a16="http://schemas.microsoft.com/office/drawing/2014/main" id="{04ADFDA8-7320-483C-AFE8-997B243CD786}"/>
+                <a16:creationId xmlns:a16="http://schemas.microsoft.com/office/drawing/2014/main" id="{495FD5D9-0ABD-451D-8352-F79A243B69AE}"/>
               </a:ext>
             </a:extLst>
           </p:cNvPr>
@@ -26951,7 +26951,7 @@
           <p:cNvPr id="9" name="TextBox 8">
             <a:extLst xmlns:a="http://schemas.openxmlformats.org/drawingml/2006/main">
               <a:ext uri="{FF2B5EF4-FFF2-40B4-BE49-F238E27FC236}">
-                <a16:creationId xmlns:a16="http://schemas.microsoft.com/office/drawing/2014/main" id="{2A0F79FF-F678-42AB-ABA9-AC95D5C8B4B9}"/>
+                <a16:creationId xmlns:a16="http://schemas.microsoft.com/office/drawing/2014/main" id="{B907D7DC-BB2D-4460-A829-59073B7EE2B7}"/>
               </a:ext>
             </a:extLst>
           </p:cNvPr>
@@ -27048,7 +27048,7 @@
           <p:cNvPr id="10" name="Rounded Rectangle 9">
             <a:extLst xmlns:a="http://schemas.openxmlformats.org/drawingml/2006/main">
               <a:ext uri="{FF2B5EF4-FFF2-40B4-BE49-F238E27FC236}">
-                <a16:creationId xmlns:a16="http://schemas.microsoft.com/office/drawing/2014/main" id="{014BDCFF-2E00-4194-B5A0-F222F526FAC2}"/>
+                <a16:creationId xmlns:a16="http://schemas.microsoft.com/office/drawing/2014/main" id="{4105B759-5F80-4C27-B8D9-18903AAD65EF}"/>
               </a:ext>
             </a:extLst>
           </p:cNvPr>
@@ -27105,7 +27105,7 @@
           <p:cNvPr id="11" name="TextBox 10">
             <a:extLst xmlns:a="http://schemas.openxmlformats.org/drawingml/2006/main">
               <a:ext uri="{FF2B5EF4-FFF2-40B4-BE49-F238E27FC236}">
-                <a16:creationId xmlns:a16="http://schemas.microsoft.com/office/drawing/2014/main" id="{13EF9BBC-5C74-401C-8F66-AF29D4359149}"/>
+                <a16:creationId xmlns:a16="http://schemas.microsoft.com/office/drawing/2014/main" id="{22725A3C-5159-46E7-A117-676FF2941687}"/>
               </a:ext>
             </a:extLst>
           </p:cNvPr>
@@ -27152,7 +27152,7 @@
           <p:cNvPr id="12" name="TextBox 11">
             <a:extLst xmlns:a="http://schemas.openxmlformats.org/drawingml/2006/main">
               <a:ext uri="{FF2B5EF4-FFF2-40B4-BE49-F238E27FC236}">
-                <a16:creationId xmlns:a16="http://schemas.microsoft.com/office/drawing/2014/main" id="{827F02F9-789A-4AED-BCE4-289A1844E477}"/>
+                <a16:creationId xmlns:a16="http://schemas.microsoft.com/office/drawing/2014/main" id="{46C060C8-6E84-4A13-BA03-049B4EA4401F}"/>
               </a:ext>
             </a:extLst>
           </p:cNvPr>
@@ -27197,7 +27197,7 @@
     </p:spTree>
     <p:extLst>
       <p:ext uri="{BB962C8B-B14F-4D97-AF65-F5344CB8AC3E}">
-        <p14:creationId xmlns:p14="http://schemas.microsoft.com/office/powerpoint/2010/main" val="1619892357"/>
+        <p14:creationId xmlns:p14="http://schemas.microsoft.com/office/powerpoint/2010/main" val="602478147"/>
       </p:ext>
     </p:extLst>
   </p:cSld>
@@ -27221,7 +27221,7 @@
           <p:cNvPr id="2" name="TextBox 1">
             <a:extLst xmlns:a="http://schemas.openxmlformats.org/drawingml/2006/main">
               <a:ext uri="{FF2B5EF4-FFF2-40B4-BE49-F238E27FC236}">
-                <a16:creationId xmlns:a16="http://schemas.microsoft.com/office/drawing/2014/main" id="{E2C60E80-6F04-43E4-83E6-CBB525FF80C4}"/>
+                <a16:creationId xmlns:a16="http://schemas.microsoft.com/office/drawing/2014/main" id="{C5714E1E-0512-44CD-BF26-784B04CFE888}"/>
               </a:ext>
             </a:extLst>
           </p:cNvPr>
@@ -27268,7 +27268,7 @@
           <p:cNvPr id="3" name="TextBox 2">
             <a:extLst xmlns:a="http://schemas.openxmlformats.org/drawingml/2006/main">
               <a:ext uri="{FF2B5EF4-FFF2-40B4-BE49-F238E27FC236}">
-                <a16:creationId xmlns:a16="http://schemas.microsoft.com/office/drawing/2014/main" id="{5ACE98B9-4016-4C2B-9B05-B7C39337E8A2}"/>
+                <a16:creationId xmlns:a16="http://schemas.microsoft.com/office/drawing/2014/main" id="{63F41A78-85FD-4FE6-8014-CD73FD9A6598}"/>
               </a:ext>
             </a:extLst>
           </p:cNvPr>
@@ -27315,7 +27315,7 @@
           <p:cNvPr id="4" name="Rectangle 3">
             <a:extLst xmlns:a="http://schemas.openxmlformats.org/drawingml/2006/main">
               <a:ext uri="{FF2B5EF4-FFF2-40B4-BE49-F238E27FC236}">
-                <a16:creationId xmlns:a16="http://schemas.microsoft.com/office/drawing/2014/main" id="{73D715AA-D4B1-4791-AC38-1A3D5778CB41}"/>
+                <a16:creationId xmlns:a16="http://schemas.microsoft.com/office/drawing/2014/main" id="{9B113DC3-B82A-4218-B5F9-D986A39FA302}"/>
               </a:ext>
             </a:extLst>
           </p:cNvPr>
@@ -27370,7 +27370,7 @@
           <p:cNvPr id="5" name="Rectangle 4">
             <a:extLst xmlns:a="http://schemas.openxmlformats.org/drawingml/2006/main">
               <a:ext uri="{FF2B5EF4-FFF2-40B4-BE49-F238E27FC236}">
-                <a16:creationId xmlns:a16="http://schemas.microsoft.com/office/drawing/2014/main" id="{EAE76652-6AA8-40C8-AC6B-213CEC1398F9}"/>
+                <a16:creationId xmlns:a16="http://schemas.microsoft.com/office/drawing/2014/main" id="{629F77FC-796F-4D3F-A0CA-84CD24136EBD}"/>
               </a:ext>
             </a:extLst>
           </p:cNvPr>
@@ -27425,7 +27425,7 @@
           <p:cNvPr id="6" name="TextBox 5">
             <a:extLst xmlns:a="http://schemas.openxmlformats.org/drawingml/2006/main">
               <a:ext uri="{FF2B5EF4-FFF2-40B4-BE49-F238E27FC236}">
-                <a16:creationId xmlns:a16="http://schemas.microsoft.com/office/drawing/2014/main" id="{A9DD5EDA-AEFF-483D-8B88-72843F8A593C}"/>
+                <a16:creationId xmlns:a16="http://schemas.microsoft.com/office/drawing/2014/main" id="{67EE16FD-0BCF-4605-89E6-AF7029E830FE}"/>
               </a:ext>
             </a:extLst>
           </p:cNvPr>
@@ -27462,7 +27462,7 @@
                 <a:ea typeface="Aptos"/>
                 <a:cs typeface="Aptos"/>
               </a:rPr>
-              <a:t>Independent public evidence summary · 2026.07.22-9 · 2026-07-22 · Sources: EP3032975B2</a:t>
+              <a:t>Independent public evidence summary · 2026.07.23-10 · 2026-07-22 · Sources: EP3032975B2</a:t>
             </a:r>
           </a:p>
         </p:txBody>
@@ -27472,7 +27472,7 @@
           <p:cNvPr id="7" name="TextBox 6">
             <a:extLst xmlns:a="http://schemas.openxmlformats.org/drawingml/2006/main">
               <a:ext uri="{FF2B5EF4-FFF2-40B4-BE49-F238E27FC236}">
-                <a16:creationId xmlns:a16="http://schemas.microsoft.com/office/drawing/2014/main" id="{36641539-268B-4B36-AA60-8F2E7EC77B31}"/>
+                <a16:creationId xmlns:a16="http://schemas.microsoft.com/office/drawing/2014/main" id="{4296B138-DD66-4603-BD34-779DF6768E95}"/>
               </a:ext>
             </a:extLst>
           </p:cNvPr>
@@ -27519,7 +27519,7 @@
           <p:cNvPr id="8" name="TextBox 7">
             <a:extLst xmlns:a="http://schemas.openxmlformats.org/drawingml/2006/main">
               <a:ext uri="{FF2B5EF4-FFF2-40B4-BE49-F238E27FC236}">
-                <a16:creationId xmlns:a16="http://schemas.microsoft.com/office/drawing/2014/main" id="{4925BA15-DA98-4F04-BE7F-7E7173CBDEB3}"/>
+                <a16:creationId xmlns:a16="http://schemas.microsoft.com/office/drawing/2014/main" id="{EF8D3735-E8F6-44A8-AB31-79B7CD695B9E}"/>
               </a:ext>
             </a:extLst>
           </p:cNvPr>
@@ -27566,7 +27566,7 @@
           <p:cNvPr id="9" name="TextBox 8">
             <a:extLst xmlns:a="http://schemas.openxmlformats.org/drawingml/2006/main">
               <a:ext uri="{FF2B5EF4-FFF2-40B4-BE49-F238E27FC236}">
-                <a16:creationId xmlns:a16="http://schemas.microsoft.com/office/drawing/2014/main" id="{3FFA6CC8-8790-4A11-939C-AEA994886250}"/>
+                <a16:creationId xmlns:a16="http://schemas.microsoft.com/office/drawing/2014/main" id="{E5FAB211-24D3-4590-9A7A-677F0CDFC489}"/>
               </a:ext>
             </a:extLst>
           </p:cNvPr>
@@ -27663,7 +27663,7 @@
           <p:cNvPr id="10" name="Rounded Rectangle 9">
             <a:extLst xmlns:a="http://schemas.openxmlformats.org/drawingml/2006/main">
               <a:ext uri="{FF2B5EF4-FFF2-40B4-BE49-F238E27FC236}">
-                <a16:creationId xmlns:a16="http://schemas.microsoft.com/office/drawing/2014/main" id="{C08CDB56-E939-4BF9-8555-EA0BC1556929}"/>
+                <a16:creationId xmlns:a16="http://schemas.microsoft.com/office/drawing/2014/main" id="{59E28F05-1A72-47F8-9998-F2FEA83491AB}"/>
               </a:ext>
             </a:extLst>
           </p:cNvPr>
@@ -27720,7 +27720,7 @@
           <p:cNvPr id="11" name="TextBox 10">
             <a:extLst xmlns:a="http://schemas.openxmlformats.org/drawingml/2006/main">
               <a:ext uri="{FF2B5EF4-FFF2-40B4-BE49-F238E27FC236}">
-                <a16:creationId xmlns:a16="http://schemas.microsoft.com/office/drawing/2014/main" id="{1C344D4D-296E-432E-BBA2-03F99C3011D7}"/>
+                <a16:creationId xmlns:a16="http://schemas.microsoft.com/office/drawing/2014/main" id="{7BA7B35C-FC46-4474-B3D7-CA342C2702D6}"/>
               </a:ext>
             </a:extLst>
           </p:cNvPr>
@@ -27767,7 +27767,7 @@
           <p:cNvPr id="12" name="TextBox 11">
             <a:extLst xmlns:a="http://schemas.openxmlformats.org/drawingml/2006/main">
               <a:ext uri="{FF2B5EF4-FFF2-40B4-BE49-F238E27FC236}">
-                <a16:creationId xmlns:a16="http://schemas.microsoft.com/office/drawing/2014/main" id="{7AC936B5-CB92-49D9-A5D9-6090423D9FF0}"/>
+                <a16:creationId xmlns:a16="http://schemas.microsoft.com/office/drawing/2014/main" id="{E715A0C5-69E8-459D-99AB-7DF1EA734A9C}"/>
               </a:ext>
             </a:extLst>
           </p:cNvPr>
@@ -27812,7 +27812,7 @@
     </p:spTree>
     <p:extLst>
       <p:ext uri="{BB962C8B-B14F-4D97-AF65-F5344CB8AC3E}">
-        <p14:creationId xmlns:p14="http://schemas.microsoft.com/office/powerpoint/2010/main" val="1511580907"/>
+        <p14:creationId xmlns:p14="http://schemas.microsoft.com/office/powerpoint/2010/main" val="2012476660"/>
       </p:ext>
     </p:extLst>
   </p:cSld>
@@ -27836,7 +27836,7 @@
           <p:cNvPr id="2" name="TextBox 1">
             <a:extLst xmlns:a="http://schemas.openxmlformats.org/drawingml/2006/main">
               <a:ext uri="{FF2B5EF4-FFF2-40B4-BE49-F238E27FC236}">
-                <a16:creationId xmlns:a16="http://schemas.microsoft.com/office/drawing/2014/main" id="{3281E17B-9B76-4F46-8F4E-3288172D998A}"/>
+                <a16:creationId xmlns:a16="http://schemas.microsoft.com/office/drawing/2014/main" id="{F28AB2C8-9ADA-4AA3-9F9C-A5DD17EA28A7}"/>
               </a:ext>
             </a:extLst>
           </p:cNvPr>
@@ -27883,7 +27883,7 @@
           <p:cNvPr id="3" name="TextBox 2">
             <a:extLst xmlns:a="http://schemas.openxmlformats.org/drawingml/2006/main">
               <a:ext uri="{FF2B5EF4-FFF2-40B4-BE49-F238E27FC236}">
-                <a16:creationId xmlns:a16="http://schemas.microsoft.com/office/drawing/2014/main" id="{02D5FA6C-B583-4E10-9ADF-222623D40754}"/>
+                <a16:creationId xmlns:a16="http://schemas.microsoft.com/office/drawing/2014/main" id="{98136BB7-BC91-44C0-9E8C-4AEE74645792}"/>
               </a:ext>
             </a:extLst>
           </p:cNvPr>
@@ -27930,7 +27930,7 @@
           <p:cNvPr id="4" name="Rectangle 3">
             <a:extLst xmlns:a="http://schemas.openxmlformats.org/drawingml/2006/main">
               <a:ext uri="{FF2B5EF4-FFF2-40B4-BE49-F238E27FC236}">
-                <a16:creationId xmlns:a16="http://schemas.microsoft.com/office/drawing/2014/main" id="{276B9391-C8E3-452D-BD11-727FF1A5DA0F}"/>
+                <a16:creationId xmlns:a16="http://schemas.microsoft.com/office/drawing/2014/main" id="{049F2503-33D1-4461-94D1-14B3E64A88AE}"/>
               </a:ext>
             </a:extLst>
           </p:cNvPr>
@@ -27985,7 +27985,7 @@
           <p:cNvPr id="5" name="Rectangle 4">
             <a:extLst xmlns:a="http://schemas.openxmlformats.org/drawingml/2006/main">
               <a:ext uri="{FF2B5EF4-FFF2-40B4-BE49-F238E27FC236}">
-                <a16:creationId xmlns:a16="http://schemas.microsoft.com/office/drawing/2014/main" id="{BE818B6A-536B-445F-B103-DA7DD47FE2C2}"/>
+                <a16:creationId xmlns:a16="http://schemas.microsoft.com/office/drawing/2014/main" id="{36FB01EB-5D1F-4DA7-A9BC-B58329654CAA}"/>
               </a:ext>
             </a:extLst>
           </p:cNvPr>
@@ -28040,7 +28040,7 @@
           <p:cNvPr id="6" name="TextBox 5">
             <a:extLst xmlns:a="http://schemas.openxmlformats.org/drawingml/2006/main">
               <a:ext uri="{FF2B5EF4-FFF2-40B4-BE49-F238E27FC236}">
-                <a16:creationId xmlns:a16="http://schemas.microsoft.com/office/drawing/2014/main" id="{01AFCE20-A5F5-4206-9377-C90EE873E025}"/>
+                <a16:creationId xmlns:a16="http://schemas.microsoft.com/office/drawing/2014/main" id="{BD522210-83B8-4190-B1AE-BDD27040EA0D}"/>
               </a:ext>
             </a:extLst>
           </p:cNvPr>
@@ -28077,7 +28077,7 @@
                 <a:ea typeface="Aptos"/>
                 <a:cs typeface="Aptos"/>
               </a:rPr>
-              <a:t>Independent public evidence summary · 2026.07.22-9 · 2026-07-22 · Sources: EP3032975B2</a:t>
+              <a:t>Independent public evidence summary · 2026.07.23-10 · 2026-07-22 · Sources: EP3032975B2</a:t>
             </a:r>
           </a:p>
         </p:txBody>
@@ -28087,7 +28087,7 @@
           <p:cNvPr id="7" name="TextBox 6">
             <a:extLst xmlns:a="http://schemas.openxmlformats.org/drawingml/2006/main">
               <a:ext uri="{FF2B5EF4-FFF2-40B4-BE49-F238E27FC236}">
-                <a16:creationId xmlns:a16="http://schemas.microsoft.com/office/drawing/2014/main" id="{8F40E579-2118-4AE1-B5B6-C0653EA82460}"/>
+                <a16:creationId xmlns:a16="http://schemas.microsoft.com/office/drawing/2014/main" id="{E92DCBAD-BF08-4374-BD8C-43472C6A6C50}"/>
               </a:ext>
             </a:extLst>
           </p:cNvPr>
@@ -28657,7 +28657,7 @@
           <p:cNvPr id="9" name="TextBox 8">
             <a:extLst xmlns:a="http://schemas.openxmlformats.org/drawingml/2006/main">
               <a:ext uri="{FF2B5EF4-FFF2-40B4-BE49-F238E27FC236}">
-                <a16:creationId xmlns:a16="http://schemas.microsoft.com/office/drawing/2014/main" id="{2FDB45C9-76B8-47F7-BDA0-AE76C75DF389}"/>
+                <a16:creationId xmlns:a16="http://schemas.microsoft.com/office/drawing/2014/main" id="{4DBE734C-44D9-4BFF-8706-FBBA470B5396}"/>
               </a:ext>
             </a:extLst>
           </p:cNvPr>
@@ -28702,7 +28702,7 @@
     </p:spTree>
     <p:extLst>
       <p:ext uri="{BB962C8B-B14F-4D97-AF65-F5344CB8AC3E}">
-        <p14:creationId xmlns:p14="http://schemas.microsoft.com/office/powerpoint/2010/main" val="191392355"/>
+        <p14:creationId xmlns:p14="http://schemas.microsoft.com/office/powerpoint/2010/main" val="1357717513"/>
       </p:ext>
     </p:extLst>
   </p:cSld>
@@ -28726,7 +28726,7 @@
           <p:cNvPr id="2" name="TextBox 1">
             <a:extLst xmlns:a="http://schemas.openxmlformats.org/drawingml/2006/main">
               <a:ext uri="{FF2B5EF4-FFF2-40B4-BE49-F238E27FC236}">
-                <a16:creationId xmlns:a16="http://schemas.microsoft.com/office/drawing/2014/main" id="{4B463AD2-7E2E-4157-ADFD-F299D24D7188}"/>
+                <a16:creationId xmlns:a16="http://schemas.microsoft.com/office/drawing/2014/main" id="{C0F255FE-F014-4249-AC27-279019447F69}"/>
               </a:ext>
             </a:extLst>
           </p:cNvPr>
@@ -28773,7 +28773,7 @@
           <p:cNvPr id="3" name="TextBox 2">
             <a:extLst xmlns:a="http://schemas.openxmlformats.org/drawingml/2006/main">
               <a:ext uri="{FF2B5EF4-FFF2-40B4-BE49-F238E27FC236}">
-                <a16:creationId xmlns:a16="http://schemas.microsoft.com/office/drawing/2014/main" id="{070B91EC-48D3-406A-A910-727B9B2C5EB2}"/>
+                <a16:creationId xmlns:a16="http://schemas.microsoft.com/office/drawing/2014/main" id="{EF526671-8FE8-4179-B127-455CE2AA95C6}"/>
               </a:ext>
             </a:extLst>
           </p:cNvPr>
@@ -28820,7 +28820,7 @@
           <p:cNvPr id="4" name="Rectangle 3">
             <a:extLst xmlns:a="http://schemas.openxmlformats.org/drawingml/2006/main">
               <a:ext uri="{FF2B5EF4-FFF2-40B4-BE49-F238E27FC236}">
-                <a16:creationId xmlns:a16="http://schemas.microsoft.com/office/drawing/2014/main" id="{F21AF8F7-985C-4394-8C56-E0A07AD8C7A0}"/>
+                <a16:creationId xmlns:a16="http://schemas.microsoft.com/office/drawing/2014/main" id="{805F5BCA-46A6-4CB5-A930-4300494441BE}"/>
               </a:ext>
             </a:extLst>
           </p:cNvPr>
@@ -28875,7 +28875,7 @@
           <p:cNvPr id="5" name="Rectangle 4">
             <a:extLst xmlns:a="http://schemas.openxmlformats.org/drawingml/2006/main">
               <a:ext uri="{FF2B5EF4-FFF2-40B4-BE49-F238E27FC236}">
-                <a16:creationId xmlns:a16="http://schemas.microsoft.com/office/drawing/2014/main" id="{7E4098A7-BA03-4FA5-A052-F2C59E9BB68A}"/>
+                <a16:creationId xmlns:a16="http://schemas.microsoft.com/office/drawing/2014/main" id="{B9B83AC9-3D2F-4ADE-BBF6-53720778887A}"/>
               </a:ext>
             </a:extLst>
           </p:cNvPr>
@@ -28930,7 +28930,7 @@
           <p:cNvPr id="6" name="TextBox 5">
             <a:extLst xmlns:a="http://schemas.openxmlformats.org/drawingml/2006/main">
               <a:ext uri="{FF2B5EF4-FFF2-40B4-BE49-F238E27FC236}">
-                <a16:creationId xmlns:a16="http://schemas.microsoft.com/office/drawing/2014/main" id="{4B7D0F1D-7E41-44DC-BBD0-17C20A46FB77}"/>
+                <a16:creationId xmlns:a16="http://schemas.microsoft.com/office/drawing/2014/main" id="{2545413C-E3CE-4604-A5F2-A78B2E449305}"/>
               </a:ext>
             </a:extLst>
           </p:cNvPr>
@@ -28967,7 +28967,7 @@
                 <a:ea typeface="Aptos"/>
                 <a:cs typeface="Aptos"/>
               </a:rPr>
-              <a:t>Independent public evidence summary · 2026.07.22-9 · 2026-07-22 · Sources: EPO Register; B2</a:t>
+              <a:t>Independent public evidence summary · 2026.07.23-10 · 2026-07-22 · Sources: EPO Register; B2</a:t>
             </a:r>
           </a:p>
         </p:txBody>
@@ -28977,7 +28977,7 @@
           <p:cNvPr id="7" name="TextBox 6">
             <a:extLst xmlns:a="http://schemas.openxmlformats.org/drawingml/2006/main">
               <a:ext uri="{FF2B5EF4-FFF2-40B4-BE49-F238E27FC236}">
-                <a16:creationId xmlns:a16="http://schemas.microsoft.com/office/drawing/2014/main" id="{F4B02055-68FF-44C5-BCFC-4A5C5348702A}"/>
+                <a16:creationId xmlns:a16="http://schemas.microsoft.com/office/drawing/2014/main" id="{DEB769A1-C080-466F-BD0B-1D8B114610A4}"/>
               </a:ext>
             </a:extLst>
           </p:cNvPr>
@@ -29024,7 +29024,7 @@
           <p:cNvPr id="8" name="Rounded Rectangle 7">
             <a:extLst xmlns:a="http://schemas.openxmlformats.org/drawingml/2006/main">
               <a:ext uri="{FF2B5EF4-FFF2-40B4-BE49-F238E27FC236}">
-                <a16:creationId xmlns:a16="http://schemas.microsoft.com/office/drawing/2014/main" id="{E5FF2D78-BE65-4960-9FEE-BE04CAD85056}"/>
+                <a16:creationId xmlns:a16="http://schemas.microsoft.com/office/drawing/2014/main" id="{037AE4D6-D7F2-43B3-9FB7-B772ECE8E052}"/>
               </a:ext>
             </a:extLst>
           </p:cNvPr>
@@ -29081,7 +29081,7 @@
           <p:cNvPr id="9" name="TextBox 8">
             <a:extLst xmlns:a="http://schemas.openxmlformats.org/drawingml/2006/main">
               <a:ext uri="{FF2B5EF4-FFF2-40B4-BE49-F238E27FC236}">
-                <a16:creationId xmlns:a16="http://schemas.microsoft.com/office/drawing/2014/main" id="{F79D9F95-1EA6-4217-8D7A-2808CAE3B93C}"/>
+                <a16:creationId xmlns:a16="http://schemas.microsoft.com/office/drawing/2014/main" id="{12D6807D-D9AA-47AE-9535-A8259A255571}"/>
               </a:ext>
             </a:extLst>
           </p:cNvPr>
@@ -29128,7 +29128,7 @@
           <p:cNvPr id="10" name="TextBox 9">
             <a:extLst xmlns:a="http://schemas.openxmlformats.org/drawingml/2006/main">
               <a:ext uri="{FF2B5EF4-FFF2-40B4-BE49-F238E27FC236}">
-                <a16:creationId xmlns:a16="http://schemas.microsoft.com/office/drawing/2014/main" id="{D41BF304-D417-42CE-8DE8-0EAC2898CD83}"/>
+                <a16:creationId xmlns:a16="http://schemas.microsoft.com/office/drawing/2014/main" id="{B0FDAA0D-0B42-47AA-8DD5-72A9DE8C7C56}"/>
               </a:ext>
             </a:extLst>
           </p:cNvPr>
@@ -29175,7 +29175,7 @@
           <p:cNvPr id="11" name="Rounded Rectangle 10">
             <a:extLst xmlns:a="http://schemas.openxmlformats.org/drawingml/2006/main">
               <a:ext uri="{FF2B5EF4-FFF2-40B4-BE49-F238E27FC236}">
-                <a16:creationId xmlns:a16="http://schemas.microsoft.com/office/drawing/2014/main" id="{9723800E-07FE-4864-8BB9-F6D32CBBFA30}"/>
+                <a16:creationId xmlns:a16="http://schemas.microsoft.com/office/drawing/2014/main" id="{48787EE4-349E-4CF5-80DF-9C2393083967}"/>
               </a:ext>
             </a:extLst>
           </p:cNvPr>
@@ -29232,7 +29232,7 @@
           <p:cNvPr id="12" name="TextBox 11">
             <a:extLst xmlns:a="http://schemas.openxmlformats.org/drawingml/2006/main">
               <a:ext uri="{FF2B5EF4-FFF2-40B4-BE49-F238E27FC236}">
-                <a16:creationId xmlns:a16="http://schemas.microsoft.com/office/drawing/2014/main" id="{7D511301-AB35-49B9-9E6E-CF261081D997}"/>
+                <a16:creationId xmlns:a16="http://schemas.microsoft.com/office/drawing/2014/main" id="{EA4C6B9E-DFD0-4451-BA36-B65D00856C8C}"/>
               </a:ext>
             </a:extLst>
           </p:cNvPr>
@@ -29279,7 +29279,7 @@
           <p:cNvPr id="13" name="TextBox 12">
             <a:extLst xmlns:a="http://schemas.openxmlformats.org/drawingml/2006/main">
               <a:ext uri="{FF2B5EF4-FFF2-40B4-BE49-F238E27FC236}">
-                <a16:creationId xmlns:a16="http://schemas.microsoft.com/office/drawing/2014/main" id="{2FC34DF0-D788-419E-BFF2-41BFE59DAD24}"/>
+                <a16:creationId xmlns:a16="http://schemas.microsoft.com/office/drawing/2014/main" id="{CBBAA00B-DE80-4F1C-80C8-3F2B7CA7696F}"/>
               </a:ext>
             </a:extLst>
           </p:cNvPr>
@@ -29326,7 +29326,7 @@
           <p:cNvPr id="14" name="Rounded Rectangle 13">
             <a:extLst xmlns:a="http://schemas.openxmlformats.org/drawingml/2006/main">
               <a:ext uri="{FF2B5EF4-FFF2-40B4-BE49-F238E27FC236}">
-                <a16:creationId xmlns:a16="http://schemas.microsoft.com/office/drawing/2014/main" id="{67E3D468-32BE-4054-AD7A-9FE70008FEF4}"/>
+                <a16:creationId xmlns:a16="http://schemas.microsoft.com/office/drawing/2014/main" id="{E8970C3E-E2F9-41FE-8671-204838248CC7}"/>
               </a:ext>
             </a:extLst>
           </p:cNvPr>
@@ -29383,7 +29383,7 @@
           <p:cNvPr id="15" name="TextBox 14">
             <a:extLst xmlns:a="http://schemas.openxmlformats.org/drawingml/2006/main">
               <a:ext uri="{FF2B5EF4-FFF2-40B4-BE49-F238E27FC236}">
-                <a16:creationId xmlns:a16="http://schemas.microsoft.com/office/drawing/2014/main" id="{4465B154-EC09-4284-9B02-7227BF456F39}"/>
+                <a16:creationId xmlns:a16="http://schemas.microsoft.com/office/drawing/2014/main" id="{322CED65-3765-49B6-9101-9028434F08CA}"/>
               </a:ext>
             </a:extLst>
           </p:cNvPr>
@@ -29430,7 +29430,7 @@
           <p:cNvPr id="16" name="TextBox 15">
             <a:extLst xmlns:a="http://schemas.openxmlformats.org/drawingml/2006/main">
               <a:ext uri="{FF2B5EF4-FFF2-40B4-BE49-F238E27FC236}">
-                <a16:creationId xmlns:a16="http://schemas.microsoft.com/office/drawing/2014/main" id="{5A943CF4-476B-45C0-A5C5-AA841F28722E}"/>
+                <a16:creationId xmlns:a16="http://schemas.microsoft.com/office/drawing/2014/main" id="{BCC6A4DB-B63D-4F94-A13C-E87F7B541C33}"/>
               </a:ext>
             </a:extLst>
           </p:cNvPr>
@@ -29477,7 +29477,7 @@
           <p:cNvPr id="17" name="TextBox 16">
             <a:extLst xmlns:a="http://schemas.openxmlformats.org/drawingml/2006/main">
               <a:ext uri="{FF2B5EF4-FFF2-40B4-BE49-F238E27FC236}">
-                <a16:creationId xmlns:a16="http://schemas.microsoft.com/office/drawing/2014/main" id="{1CDA29A9-0755-4767-8098-AA218A3A9EA1}"/>
+                <a16:creationId xmlns:a16="http://schemas.microsoft.com/office/drawing/2014/main" id="{B6CB91B3-1C5A-4721-AC9D-01850DD30DDF}"/>
               </a:ext>
             </a:extLst>
           </p:cNvPr>
@@ -29524,7 +29524,7 @@
           <p:cNvPr id="18" name="Rounded Rectangle 17">
             <a:extLst xmlns:a="http://schemas.openxmlformats.org/drawingml/2006/main">
               <a:ext uri="{FF2B5EF4-FFF2-40B4-BE49-F238E27FC236}">
-                <a16:creationId xmlns:a16="http://schemas.microsoft.com/office/drawing/2014/main" id="{03E3708C-C153-45E3-9BFF-39E9A3A632F9}"/>
+                <a16:creationId xmlns:a16="http://schemas.microsoft.com/office/drawing/2014/main" id="{A0C41CE3-8C1F-4B7E-A8E7-A0A6627ABDC8}"/>
               </a:ext>
             </a:extLst>
           </p:cNvPr>
@@ -29581,7 +29581,7 @@
           <p:cNvPr id="19" name="TextBox 18">
             <a:extLst xmlns:a="http://schemas.openxmlformats.org/drawingml/2006/main">
               <a:ext uri="{FF2B5EF4-FFF2-40B4-BE49-F238E27FC236}">
-                <a16:creationId xmlns:a16="http://schemas.microsoft.com/office/drawing/2014/main" id="{CA51478F-2DFC-435F-B782-260D0A219B32}"/>
+                <a16:creationId xmlns:a16="http://schemas.microsoft.com/office/drawing/2014/main" id="{112C3525-E956-4425-B064-B0AC481D914F}"/>
               </a:ext>
             </a:extLst>
           </p:cNvPr>
@@ -29628,7 +29628,7 @@
           <p:cNvPr id="20" name="TextBox 19">
             <a:extLst xmlns:a="http://schemas.openxmlformats.org/drawingml/2006/main">
               <a:ext uri="{FF2B5EF4-FFF2-40B4-BE49-F238E27FC236}">
-                <a16:creationId xmlns:a16="http://schemas.microsoft.com/office/drawing/2014/main" id="{6EFD916A-A32F-4A83-98CD-7F95741E66B1}"/>
+                <a16:creationId xmlns:a16="http://schemas.microsoft.com/office/drawing/2014/main" id="{0E5E9028-5517-4A73-8E1F-73DB3C169A9D}"/>
               </a:ext>
             </a:extLst>
           </p:cNvPr>
@@ -29673,7 +29673,7 @@
     </p:spTree>
     <p:extLst>
       <p:ext uri="{BB962C8B-B14F-4D97-AF65-F5344CB8AC3E}">
-        <p14:creationId xmlns:p14="http://schemas.microsoft.com/office/powerpoint/2010/main" val="1502881297"/>
+        <p14:creationId xmlns:p14="http://schemas.microsoft.com/office/powerpoint/2010/main" val="664886785"/>
       </p:ext>
     </p:extLst>
   </p:cSld>
@@ -29697,7 +29697,7 @@
           <p:cNvPr id="2" name="TextBox 1">
             <a:extLst xmlns:a="http://schemas.openxmlformats.org/drawingml/2006/main">
               <a:ext uri="{FF2B5EF4-FFF2-40B4-BE49-F238E27FC236}">
-                <a16:creationId xmlns:a16="http://schemas.microsoft.com/office/drawing/2014/main" id="{1F85C460-0FC9-475A-BEFD-91CDFEE6C42C}"/>
+                <a16:creationId xmlns:a16="http://schemas.microsoft.com/office/drawing/2014/main" id="{D130B268-7874-432A-B9B8-478389B6B4B9}"/>
               </a:ext>
             </a:extLst>
           </p:cNvPr>
@@ -29744,7 +29744,7 @@
           <p:cNvPr id="3" name="TextBox 2">
             <a:extLst xmlns:a="http://schemas.openxmlformats.org/drawingml/2006/main">
               <a:ext uri="{FF2B5EF4-FFF2-40B4-BE49-F238E27FC236}">
-                <a16:creationId xmlns:a16="http://schemas.microsoft.com/office/drawing/2014/main" id="{5BACA264-B47E-46A4-8E7A-42B53BD30190}"/>
+                <a16:creationId xmlns:a16="http://schemas.microsoft.com/office/drawing/2014/main" id="{4748BDFF-E957-48B8-8811-C62AA0E5C3E4}"/>
               </a:ext>
             </a:extLst>
           </p:cNvPr>
@@ -29791,7 +29791,7 @@
           <p:cNvPr id="4" name="Rectangle 3">
             <a:extLst xmlns:a="http://schemas.openxmlformats.org/drawingml/2006/main">
               <a:ext uri="{FF2B5EF4-FFF2-40B4-BE49-F238E27FC236}">
-                <a16:creationId xmlns:a16="http://schemas.microsoft.com/office/drawing/2014/main" id="{3D986817-AC15-4D81-9DA2-BCE9D737EA68}"/>
+                <a16:creationId xmlns:a16="http://schemas.microsoft.com/office/drawing/2014/main" id="{3DE5A07B-154A-4BA3-BD48-6C55E6AFBC28}"/>
               </a:ext>
             </a:extLst>
           </p:cNvPr>
@@ -29846,7 +29846,7 @@
           <p:cNvPr id="5" name="Rectangle 4">
             <a:extLst xmlns:a="http://schemas.openxmlformats.org/drawingml/2006/main">
               <a:ext uri="{FF2B5EF4-FFF2-40B4-BE49-F238E27FC236}">
-                <a16:creationId xmlns:a16="http://schemas.microsoft.com/office/drawing/2014/main" id="{1FA7DF14-4866-409B-BA7C-CFAA47207720}"/>
+                <a16:creationId xmlns:a16="http://schemas.microsoft.com/office/drawing/2014/main" id="{70E12C48-1C6C-49D2-83A5-74445D4B3E97}"/>
               </a:ext>
             </a:extLst>
           </p:cNvPr>
@@ -29901,7 +29901,7 @@
           <p:cNvPr id="6" name="TextBox 5">
             <a:extLst xmlns:a="http://schemas.openxmlformats.org/drawingml/2006/main">
               <a:ext uri="{FF2B5EF4-FFF2-40B4-BE49-F238E27FC236}">
-                <a16:creationId xmlns:a16="http://schemas.microsoft.com/office/drawing/2014/main" id="{BCB5B9D5-AACA-4CB7-9B53-5F6DF15E1756}"/>
+                <a16:creationId xmlns:a16="http://schemas.microsoft.com/office/drawing/2014/main" id="{AC2483C3-9A64-4BDC-A229-6D8EA3316D0C}"/>
               </a:ext>
             </a:extLst>
           </p:cNvPr>
@@ -29938,7 +29938,7 @@
                 <a:ea typeface="Aptos"/>
                 <a:cs typeface="Aptos"/>
               </a:rPr>
-              <a:t>Independent public evidence summary · 2026.07.22-9 · 2026-07-22 · Sources: EPO family; national registers</a:t>
+              <a:t>Independent public evidence summary · 2026.07.23-10 · 2026-07-22 · Sources: EPO family; national registers</a:t>
             </a:r>
           </a:p>
         </p:txBody>
@@ -29948,7 +29948,7 @@
           <p:cNvPr id="7" name="TextBox 6">
             <a:extLst xmlns:a="http://schemas.openxmlformats.org/drawingml/2006/main">
               <a:ext uri="{FF2B5EF4-FFF2-40B4-BE49-F238E27FC236}">
-                <a16:creationId xmlns:a16="http://schemas.microsoft.com/office/drawing/2014/main" id="{CF3E946A-196F-466F-A998-DAE328B13429}"/>
+                <a16:creationId xmlns:a16="http://schemas.microsoft.com/office/drawing/2014/main" id="{E7EC4605-5EB3-4E9F-AE47-9388DE1FD6B5}"/>
               </a:ext>
             </a:extLst>
           </p:cNvPr>
@@ -29995,7 +29995,7 @@
           <p:cNvPr id="8" name="Rounded Rectangle 7">
             <a:extLst xmlns:a="http://schemas.openxmlformats.org/drawingml/2006/main">
               <a:ext uri="{FF2B5EF4-FFF2-40B4-BE49-F238E27FC236}">
-                <a16:creationId xmlns:a16="http://schemas.microsoft.com/office/drawing/2014/main" id="{E354748C-E401-4C4A-B5EA-CB8CA8020DF0}"/>
+                <a16:creationId xmlns:a16="http://schemas.microsoft.com/office/drawing/2014/main" id="{3DF2DAE6-6EA5-4179-A4D1-73865299DEAD}"/>
               </a:ext>
             </a:extLst>
           </p:cNvPr>
@@ -30052,7 +30052,7 @@
           <p:cNvPr id="9" name="TextBox 8">
             <a:extLst xmlns:a="http://schemas.openxmlformats.org/drawingml/2006/main">
               <a:ext uri="{FF2B5EF4-FFF2-40B4-BE49-F238E27FC236}">
-                <a16:creationId xmlns:a16="http://schemas.microsoft.com/office/drawing/2014/main" id="{8DBA2817-ABED-43F2-ADBA-5C0C61DD282D}"/>
+                <a16:creationId xmlns:a16="http://schemas.microsoft.com/office/drawing/2014/main" id="{E3543369-E835-405A-B058-090BC42938B1}"/>
               </a:ext>
             </a:extLst>
           </p:cNvPr>
@@ -30099,7 +30099,7 @@
           <p:cNvPr id="10" name="TextBox 9">
             <a:extLst xmlns:a="http://schemas.openxmlformats.org/drawingml/2006/main">
               <a:ext uri="{FF2B5EF4-FFF2-40B4-BE49-F238E27FC236}">
-                <a16:creationId xmlns:a16="http://schemas.microsoft.com/office/drawing/2014/main" id="{9A634BB8-385E-4C34-84D7-51654DE3A28A}"/>
+                <a16:creationId xmlns:a16="http://schemas.microsoft.com/office/drawing/2014/main" id="{8944A267-2CED-4DE8-8EBA-2684F0D44146}"/>
               </a:ext>
             </a:extLst>
           </p:cNvPr>
@@ -30146,7 +30146,7 @@
           <p:cNvPr id="11" name="Rounded Rectangle 10">
             <a:extLst xmlns:a="http://schemas.openxmlformats.org/drawingml/2006/main">
               <a:ext uri="{FF2B5EF4-FFF2-40B4-BE49-F238E27FC236}">
-                <a16:creationId xmlns:a16="http://schemas.microsoft.com/office/drawing/2014/main" id="{B9A6829C-4527-4493-9820-8293EFE1AEAC}"/>
+                <a16:creationId xmlns:a16="http://schemas.microsoft.com/office/drawing/2014/main" id="{C7ABFE91-7553-471D-90E1-F5BBDB048D7C}"/>
               </a:ext>
             </a:extLst>
           </p:cNvPr>
@@ -30203,7 +30203,7 @@
           <p:cNvPr id="12" name="TextBox 11">
             <a:extLst xmlns:a="http://schemas.openxmlformats.org/drawingml/2006/main">
               <a:ext uri="{FF2B5EF4-FFF2-40B4-BE49-F238E27FC236}">
-                <a16:creationId xmlns:a16="http://schemas.microsoft.com/office/drawing/2014/main" id="{83EBC911-5509-483F-B4A0-FAF788BFCBDA}"/>
+                <a16:creationId xmlns:a16="http://schemas.microsoft.com/office/drawing/2014/main" id="{97A90AF1-6F58-4057-B86A-3ACBC0881572}"/>
               </a:ext>
             </a:extLst>
           </p:cNvPr>
@@ -30250,7 +30250,7 @@
           <p:cNvPr id="13" name="TextBox 12">
             <a:extLst xmlns:a="http://schemas.openxmlformats.org/drawingml/2006/main">
               <a:ext uri="{FF2B5EF4-FFF2-40B4-BE49-F238E27FC236}">
-                <a16:creationId xmlns:a16="http://schemas.microsoft.com/office/drawing/2014/main" id="{6EC47865-5C1B-432A-B2F8-CEBBE7EEB769}"/>
+                <a16:creationId xmlns:a16="http://schemas.microsoft.com/office/drawing/2014/main" id="{8A376231-3268-4E4E-B8F5-E9768FFB8009}"/>
               </a:ext>
             </a:extLst>
           </p:cNvPr>
@@ -30297,7 +30297,7 @@
           <p:cNvPr id="14" name="Rounded Rectangle 13">
             <a:extLst xmlns:a="http://schemas.openxmlformats.org/drawingml/2006/main">
               <a:ext uri="{FF2B5EF4-FFF2-40B4-BE49-F238E27FC236}">
-                <a16:creationId xmlns:a16="http://schemas.microsoft.com/office/drawing/2014/main" id="{E3155377-721A-4F72-A364-E1ED4F598827}"/>
+                <a16:creationId xmlns:a16="http://schemas.microsoft.com/office/drawing/2014/main" id="{9FA7D0A0-2571-489A-B0F7-864CFA759E91}"/>
               </a:ext>
             </a:extLst>
           </p:cNvPr>
@@ -30354,7 +30354,7 @@
           <p:cNvPr id="15" name="TextBox 14">
             <a:extLst xmlns:a="http://schemas.openxmlformats.org/drawingml/2006/main">
               <a:ext uri="{FF2B5EF4-FFF2-40B4-BE49-F238E27FC236}">
-                <a16:creationId xmlns:a16="http://schemas.microsoft.com/office/drawing/2014/main" id="{4EBB0956-E332-47B8-A852-B92019A56E3A}"/>
+                <a16:creationId xmlns:a16="http://schemas.microsoft.com/office/drawing/2014/main" id="{C3E7F8CD-E972-4C9F-92BF-72DEC4E30C18}"/>
               </a:ext>
             </a:extLst>
           </p:cNvPr>
@@ -30401,7 +30401,7 @@
           <p:cNvPr id="16" name="TextBox 15">
             <a:extLst xmlns:a="http://schemas.openxmlformats.org/drawingml/2006/main">
               <a:ext uri="{FF2B5EF4-FFF2-40B4-BE49-F238E27FC236}">
-                <a16:creationId xmlns:a16="http://schemas.microsoft.com/office/drawing/2014/main" id="{B607D192-AFFC-45DF-9D0C-9F31FB11F4AA}"/>
+                <a16:creationId xmlns:a16="http://schemas.microsoft.com/office/drawing/2014/main" id="{9728CEC8-8AB9-44D3-8518-D4DE63B4ECAE}"/>
               </a:ext>
             </a:extLst>
           </p:cNvPr>
@@ -30448,7 +30448,7 @@
           <p:cNvPr id="17" name="Rounded Rectangle 16">
             <a:extLst xmlns:a="http://schemas.openxmlformats.org/drawingml/2006/main">
               <a:ext uri="{FF2B5EF4-FFF2-40B4-BE49-F238E27FC236}">
-                <a16:creationId xmlns:a16="http://schemas.microsoft.com/office/drawing/2014/main" id="{1B352597-ADE2-4DE7-A6E2-C9096A1FC01B}"/>
+                <a16:creationId xmlns:a16="http://schemas.microsoft.com/office/drawing/2014/main" id="{BC9A1E57-ADAB-4EE6-81B4-6DBC70E210B7}"/>
               </a:ext>
             </a:extLst>
           </p:cNvPr>
@@ -30505,7 +30505,7 @@
           <p:cNvPr id="18" name="TextBox 17">
             <a:extLst xmlns:a="http://schemas.openxmlformats.org/drawingml/2006/main">
               <a:ext uri="{FF2B5EF4-FFF2-40B4-BE49-F238E27FC236}">
-                <a16:creationId xmlns:a16="http://schemas.microsoft.com/office/drawing/2014/main" id="{6BD6BCEB-C4A1-474E-AA68-DBA0E1E82D25}"/>
+                <a16:creationId xmlns:a16="http://schemas.microsoft.com/office/drawing/2014/main" id="{87644F90-4C69-4017-9655-1E187BFF6811}"/>
               </a:ext>
             </a:extLst>
           </p:cNvPr>
@@ -30552,7 +30552,7 @@
           <p:cNvPr id="19" name="TextBox 18">
             <a:extLst xmlns:a="http://schemas.openxmlformats.org/drawingml/2006/main">
               <a:ext uri="{FF2B5EF4-FFF2-40B4-BE49-F238E27FC236}">
-                <a16:creationId xmlns:a16="http://schemas.microsoft.com/office/drawing/2014/main" id="{77469775-6D7C-4887-A3EA-4C561081403F}"/>
+                <a16:creationId xmlns:a16="http://schemas.microsoft.com/office/drawing/2014/main" id="{65C38000-1116-4459-943E-4B8D8B6438DC}"/>
               </a:ext>
             </a:extLst>
           </p:cNvPr>
@@ -30599,7 +30599,7 @@
           <p:cNvPr id="20" name="TextBox 19">
             <a:extLst xmlns:a="http://schemas.openxmlformats.org/drawingml/2006/main">
               <a:ext uri="{FF2B5EF4-FFF2-40B4-BE49-F238E27FC236}">
-                <a16:creationId xmlns:a16="http://schemas.microsoft.com/office/drawing/2014/main" id="{98BC8E10-5F47-433F-91BE-166F28150D6B}"/>
+                <a16:creationId xmlns:a16="http://schemas.microsoft.com/office/drawing/2014/main" id="{C5B2E74E-7488-4DA7-9012-F0BB59652F46}"/>
               </a:ext>
             </a:extLst>
           </p:cNvPr>
@@ -30646,7 +30646,7 @@
           <p:cNvPr id="21" name="Rounded Rectangle 20">
             <a:extLst xmlns:a="http://schemas.openxmlformats.org/drawingml/2006/main">
               <a:ext uri="{FF2B5EF4-FFF2-40B4-BE49-F238E27FC236}">
-                <a16:creationId xmlns:a16="http://schemas.microsoft.com/office/drawing/2014/main" id="{3B4C493A-6A11-4625-A17E-B8E064D9B594}"/>
+                <a16:creationId xmlns:a16="http://schemas.microsoft.com/office/drawing/2014/main" id="{6310FB59-988A-44AE-B323-973763CBAD1F}"/>
               </a:ext>
             </a:extLst>
           </p:cNvPr>
@@ -30703,7 +30703,7 @@
           <p:cNvPr id="22" name="TextBox 21">
             <a:extLst xmlns:a="http://schemas.openxmlformats.org/drawingml/2006/main">
               <a:ext uri="{FF2B5EF4-FFF2-40B4-BE49-F238E27FC236}">
-                <a16:creationId xmlns:a16="http://schemas.microsoft.com/office/drawing/2014/main" id="{64119EA7-164B-4C27-8B57-E68D6C572BDE}"/>
+                <a16:creationId xmlns:a16="http://schemas.microsoft.com/office/drawing/2014/main" id="{73C96886-655A-435E-93B3-CC1A6E0E89A4}"/>
               </a:ext>
             </a:extLst>
           </p:cNvPr>
@@ -30750,7 +30750,7 @@
           <p:cNvPr id="23" name="TextBox 22">
             <a:extLst xmlns:a="http://schemas.openxmlformats.org/drawingml/2006/main">
               <a:ext uri="{FF2B5EF4-FFF2-40B4-BE49-F238E27FC236}">
-                <a16:creationId xmlns:a16="http://schemas.microsoft.com/office/drawing/2014/main" id="{75D54E7B-E8F0-41AD-9015-67888E8C0F3C}"/>
+                <a16:creationId xmlns:a16="http://schemas.microsoft.com/office/drawing/2014/main" id="{F09E23F0-6FE5-4299-B663-5587186FE918}"/>
               </a:ext>
             </a:extLst>
           </p:cNvPr>
@@ -30795,7 +30795,7 @@
     </p:spTree>
     <p:extLst>
       <p:ext uri="{BB962C8B-B14F-4D97-AF65-F5344CB8AC3E}">
-        <p14:creationId xmlns:p14="http://schemas.microsoft.com/office/powerpoint/2010/main" val="1254853679"/>
+        <p14:creationId xmlns:p14="http://schemas.microsoft.com/office/powerpoint/2010/main" val="1262548599"/>
       </p:ext>
     </p:extLst>
   </p:cSld>
@@ -30819,7 +30819,7 @@
           <p:cNvPr id="2" name="TextBox 1">
             <a:extLst xmlns:a="http://schemas.openxmlformats.org/drawingml/2006/main">
               <a:ext uri="{FF2B5EF4-FFF2-40B4-BE49-F238E27FC236}">
-                <a16:creationId xmlns:a16="http://schemas.microsoft.com/office/drawing/2014/main" id="{1F86B18E-D37E-42D5-939C-C13C68556CC6}"/>
+                <a16:creationId xmlns:a16="http://schemas.microsoft.com/office/drawing/2014/main" id="{17928046-A228-4039-BA32-8FA77890F76C}"/>
               </a:ext>
             </a:extLst>
           </p:cNvPr>
@@ -30866,7 +30866,7 @@
           <p:cNvPr id="3" name="TextBox 2">
             <a:extLst xmlns:a="http://schemas.openxmlformats.org/drawingml/2006/main">
               <a:ext uri="{FF2B5EF4-FFF2-40B4-BE49-F238E27FC236}">
-                <a16:creationId xmlns:a16="http://schemas.microsoft.com/office/drawing/2014/main" id="{12FC2B2F-A43C-453C-963A-6A9219B30281}"/>
+                <a16:creationId xmlns:a16="http://schemas.microsoft.com/office/drawing/2014/main" id="{0759DE54-22C5-49E0-ABE5-58BBC77CA466}"/>
               </a:ext>
             </a:extLst>
           </p:cNvPr>
@@ -30913,7 +30913,7 @@
           <p:cNvPr id="4" name="Rectangle 3">
             <a:extLst xmlns:a="http://schemas.openxmlformats.org/drawingml/2006/main">
               <a:ext uri="{FF2B5EF4-FFF2-40B4-BE49-F238E27FC236}">
-                <a16:creationId xmlns:a16="http://schemas.microsoft.com/office/drawing/2014/main" id="{4DC40BD4-F3E4-4F7C-BA26-75C97201CDD4}"/>
+                <a16:creationId xmlns:a16="http://schemas.microsoft.com/office/drawing/2014/main" id="{8C8B38C9-A4FC-4EBD-BAF1-48531484F505}"/>
               </a:ext>
             </a:extLst>
           </p:cNvPr>
@@ -30968,7 +30968,7 @@
           <p:cNvPr id="5" name="Rectangle 4">
             <a:extLst xmlns:a="http://schemas.openxmlformats.org/drawingml/2006/main">
               <a:ext uri="{FF2B5EF4-FFF2-40B4-BE49-F238E27FC236}">
-                <a16:creationId xmlns:a16="http://schemas.microsoft.com/office/drawing/2014/main" id="{1330912F-99CD-4DAC-BF5C-14877D4F6433}"/>
+                <a16:creationId xmlns:a16="http://schemas.microsoft.com/office/drawing/2014/main" id="{DC2A18FB-C7F4-49F4-8738-23B3B8805B4F}"/>
               </a:ext>
             </a:extLst>
           </p:cNvPr>
@@ -31023,7 +31023,7 @@
           <p:cNvPr id="6" name="TextBox 5">
             <a:extLst xmlns:a="http://schemas.openxmlformats.org/drawingml/2006/main">
               <a:ext uri="{FF2B5EF4-FFF2-40B4-BE49-F238E27FC236}">
-                <a16:creationId xmlns:a16="http://schemas.microsoft.com/office/drawing/2014/main" id="{C61978B0-8184-4DCC-93D1-648DC06E2D36}"/>
+                <a16:creationId xmlns:a16="http://schemas.microsoft.com/office/drawing/2014/main" id="{B0BD5FE0-5A99-4118-AC99-ADACEED5B4E6}"/>
               </a:ext>
             </a:extLst>
           </p:cNvPr>
@@ -31060,7 +31060,7 @@
                 <a:ea typeface="Aptos"/>
                 <a:cs typeface="Aptos"/>
               </a:rPr>
-              <a:t>Independent public evidence summary · 2026.07.22-9 · 2026-07-22 · Sources: Official judgments: 8 Ni 18/24 (EP); 7 O 3341/24</a:t>
+              <a:t>Independent public evidence summary · 2026.07.23-10 · 2026-07-22 · Sources: Official judgments: 8 Ni 18/24 (EP); 7 O 3341/24</a:t>
             </a:r>
           </a:p>
         </p:txBody>
@@ -31070,7 +31070,7 @@
           <p:cNvPr id="7" name="TextBox 6">
             <a:extLst xmlns:a="http://schemas.openxmlformats.org/drawingml/2006/main">
               <a:ext uri="{FF2B5EF4-FFF2-40B4-BE49-F238E27FC236}">
-                <a16:creationId xmlns:a16="http://schemas.microsoft.com/office/drawing/2014/main" id="{4F05FD3F-8F5E-4D4F-BD11-CCD845CB45DF}"/>
+                <a16:creationId xmlns:a16="http://schemas.microsoft.com/office/drawing/2014/main" id="{77CEAACA-00B6-486A-B429-8A2B215F5660}"/>
               </a:ext>
             </a:extLst>
           </p:cNvPr>
@@ -31391,7 +31391,7 @@
           <p:cNvPr id="9" name="TextBox 8">
             <a:extLst xmlns:a="http://schemas.openxmlformats.org/drawingml/2006/main">
               <a:ext uri="{FF2B5EF4-FFF2-40B4-BE49-F238E27FC236}">
-                <a16:creationId xmlns:a16="http://schemas.microsoft.com/office/drawing/2014/main" id="{3764FEA9-9D11-4EB7-AD70-AC9C542928DB}"/>
+                <a16:creationId xmlns:a16="http://schemas.microsoft.com/office/drawing/2014/main" id="{08BB7F44-71E3-4CDB-8FA9-C9E12C934A70}"/>
               </a:ext>
             </a:extLst>
           </p:cNvPr>
@@ -31436,7 +31436,7 @@
     </p:spTree>
     <p:extLst>
       <p:ext uri="{BB962C8B-B14F-4D97-AF65-F5344CB8AC3E}">
-        <p14:creationId xmlns:p14="http://schemas.microsoft.com/office/powerpoint/2010/main" val="26098725"/>
+        <p14:creationId xmlns:p14="http://schemas.microsoft.com/office/powerpoint/2010/main" val="896396466"/>
       </p:ext>
     </p:extLst>
   </p:cSld>

</xml_diff>

<commit_message>
Publish Pixan bankability gates and Top 10 matrix v10
Adds the bilingual public HOLD/gate view, Top 10 market/right matrix, and release-locked v10 lender downloads after full validation.
</commit_message>
<xml_diff>
--- a/site/downloads/pixan-bank-deck-large-en.pptx
+++ b/site/downloads/pixan-bank-deck-large-en.pptx
@@ -2,42 +2,42 @@
 <file path=ppt/presentation.xml><?xml version="1.0" encoding="utf-8"?>
 <p:presentation xmlns:p="http://schemas.openxmlformats.org/presentationml/2006/main">
   <p:sldMasterIdLst>
-    <p:sldMasterId xmlns:r="http://schemas.openxmlformats.org/officeDocument/2006/relationships" id="2147483648" r:id="R934fdd0391f64ef5"/>
+    <p:sldMasterId xmlns:r="http://schemas.openxmlformats.org/officeDocument/2006/relationships" id="2147483648" r:id="Ref5a49b8e33444ee"/>
   </p:sldMasterIdLst>
   <p:notesMasterIdLst>
-    <p:notesMasterId xmlns:r="http://schemas.openxmlformats.org/officeDocument/2006/relationships" r:id="Raefbd3c6b7bb4c49"/>
+    <p:notesMasterId xmlns:r="http://schemas.openxmlformats.org/officeDocument/2006/relationships" r:id="R5c967f926b054948"/>
   </p:notesMasterIdLst>
   <p:sldIdLst>
-    <p:sldId xmlns:r="http://schemas.openxmlformats.org/officeDocument/2006/relationships" id="256" r:id="Rb90a8255385041cf"/>
-    <p:sldId xmlns:r="http://schemas.openxmlformats.org/officeDocument/2006/relationships" id="257" r:id="R960a9e4bfee94ab4"/>
-    <p:sldId xmlns:r="http://schemas.openxmlformats.org/officeDocument/2006/relationships" id="258" r:id="R4365f1d8579a4ed2"/>
-    <p:sldId xmlns:r="http://schemas.openxmlformats.org/officeDocument/2006/relationships" id="259" r:id="Rae19a14838a8425d"/>
-    <p:sldId xmlns:r="http://schemas.openxmlformats.org/officeDocument/2006/relationships" id="260" r:id="R916b6352b3844a09"/>
-    <p:sldId xmlns:r="http://schemas.openxmlformats.org/officeDocument/2006/relationships" id="261" r:id="R42c73f003df84fcc"/>
-    <p:sldId xmlns:r="http://schemas.openxmlformats.org/officeDocument/2006/relationships" id="262" r:id="R4f332eb4d5fc48f7"/>
-    <p:sldId xmlns:r="http://schemas.openxmlformats.org/officeDocument/2006/relationships" id="263" r:id="R5a4dba89fdd647ca"/>
-    <p:sldId xmlns:r="http://schemas.openxmlformats.org/officeDocument/2006/relationships" id="264" r:id="R98c5a7c62e8c4d47"/>
-    <p:sldId xmlns:r="http://schemas.openxmlformats.org/officeDocument/2006/relationships" id="265" r:id="Rbeb5902f404f4c63"/>
-    <p:sldId xmlns:r="http://schemas.openxmlformats.org/officeDocument/2006/relationships" id="266" r:id="R992e5e54bc2c40ef"/>
-    <p:sldId xmlns:r="http://schemas.openxmlformats.org/officeDocument/2006/relationships" id="267" r:id="R9858e480e79e46e3"/>
-    <p:sldId xmlns:r="http://schemas.openxmlformats.org/officeDocument/2006/relationships" id="268" r:id="Ra0a39da0385c4e33"/>
-    <p:sldId xmlns:r="http://schemas.openxmlformats.org/officeDocument/2006/relationships" id="269" r:id="R8b570191b160452b"/>
-    <p:sldId xmlns:r="http://schemas.openxmlformats.org/officeDocument/2006/relationships" id="270" r:id="R21d14bfa8de04832"/>
-    <p:sldId xmlns:r="http://schemas.openxmlformats.org/officeDocument/2006/relationships" id="271" r:id="R0deb1fdf4b5141b0"/>
-    <p:sldId xmlns:r="http://schemas.openxmlformats.org/officeDocument/2006/relationships" id="272" r:id="Rc4f608e3b9eb46e4"/>
-    <p:sldId xmlns:r="http://schemas.openxmlformats.org/officeDocument/2006/relationships" id="273" r:id="R2f72d6c2b44a42d6"/>
-    <p:sldId xmlns:r="http://schemas.openxmlformats.org/officeDocument/2006/relationships" id="274" r:id="R40f0e9cec5b64662"/>
-    <p:sldId xmlns:r="http://schemas.openxmlformats.org/officeDocument/2006/relationships" id="275" r:id="Rdfe50698937944b5"/>
-    <p:sldId xmlns:r="http://schemas.openxmlformats.org/officeDocument/2006/relationships" id="276" r:id="Rc7c6a81c3d2b413c"/>
-    <p:sldId xmlns:r="http://schemas.openxmlformats.org/officeDocument/2006/relationships" id="277" r:id="R4a813ee71939451a"/>
-    <p:sldId xmlns:r="http://schemas.openxmlformats.org/officeDocument/2006/relationships" id="278" r:id="R21afbe3c14434469"/>
-    <p:sldId xmlns:r="http://schemas.openxmlformats.org/officeDocument/2006/relationships" id="279" r:id="R67720dc0e87a4f64"/>
-    <p:sldId xmlns:r="http://schemas.openxmlformats.org/officeDocument/2006/relationships" id="280" r:id="Rae0a33b17a3f4df4"/>
-    <p:sldId xmlns:r="http://schemas.openxmlformats.org/officeDocument/2006/relationships" id="281" r:id="Rb25bc321e1ba43ed"/>
-    <p:sldId xmlns:r="http://schemas.openxmlformats.org/officeDocument/2006/relationships" id="282" r:id="R6e158a59bb424704"/>
-    <p:sldId xmlns:r="http://schemas.openxmlformats.org/officeDocument/2006/relationships" id="283" r:id="R4b21a3f5baab4981"/>
-    <p:sldId xmlns:r="http://schemas.openxmlformats.org/officeDocument/2006/relationships" id="284" r:id="Rc3d3a762a9024402"/>
-    <p:sldId xmlns:r="http://schemas.openxmlformats.org/officeDocument/2006/relationships" id="285" r:id="Rf697e9cf6c3e4f34"/>
+    <p:sldId xmlns:r="http://schemas.openxmlformats.org/officeDocument/2006/relationships" id="256" r:id="R51f76c2c33d54ebc"/>
+    <p:sldId xmlns:r="http://schemas.openxmlformats.org/officeDocument/2006/relationships" id="257" r:id="Rb6ca7651245e44bd"/>
+    <p:sldId xmlns:r="http://schemas.openxmlformats.org/officeDocument/2006/relationships" id="258" r:id="R728d3864eea54789"/>
+    <p:sldId xmlns:r="http://schemas.openxmlformats.org/officeDocument/2006/relationships" id="259" r:id="R887296ef3e5c41bd"/>
+    <p:sldId xmlns:r="http://schemas.openxmlformats.org/officeDocument/2006/relationships" id="260" r:id="R0964266d23544227"/>
+    <p:sldId xmlns:r="http://schemas.openxmlformats.org/officeDocument/2006/relationships" id="261" r:id="Rfcff9a4ef5ff4ae7"/>
+    <p:sldId xmlns:r="http://schemas.openxmlformats.org/officeDocument/2006/relationships" id="262" r:id="R7112d5d98d4a4983"/>
+    <p:sldId xmlns:r="http://schemas.openxmlformats.org/officeDocument/2006/relationships" id="263" r:id="R42a42d6de41544ae"/>
+    <p:sldId xmlns:r="http://schemas.openxmlformats.org/officeDocument/2006/relationships" id="264" r:id="R37a99e70731e41fe"/>
+    <p:sldId xmlns:r="http://schemas.openxmlformats.org/officeDocument/2006/relationships" id="265" r:id="R65afc73da1a34c04"/>
+    <p:sldId xmlns:r="http://schemas.openxmlformats.org/officeDocument/2006/relationships" id="266" r:id="R90d189aa4f134a19"/>
+    <p:sldId xmlns:r="http://schemas.openxmlformats.org/officeDocument/2006/relationships" id="267" r:id="Rd493ce9875fb40ad"/>
+    <p:sldId xmlns:r="http://schemas.openxmlformats.org/officeDocument/2006/relationships" id="268" r:id="R7b6d40e79ba44233"/>
+    <p:sldId xmlns:r="http://schemas.openxmlformats.org/officeDocument/2006/relationships" id="269" r:id="R39b5bfeb317b4cbd"/>
+    <p:sldId xmlns:r="http://schemas.openxmlformats.org/officeDocument/2006/relationships" id="270" r:id="R755731d64aa34ddc"/>
+    <p:sldId xmlns:r="http://schemas.openxmlformats.org/officeDocument/2006/relationships" id="271" r:id="Rfdf723c821904929"/>
+    <p:sldId xmlns:r="http://schemas.openxmlformats.org/officeDocument/2006/relationships" id="272" r:id="R7be044c8e0c74838"/>
+    <p:sldId xmlns:r="http://schemas.openxmlformats.org/officeDocument/2006/relationships" id="273" r:id="Raadd97d2e8a242cf"/>
+    <p:sldId xmlns:r="http://schemas.openxmlformats.org/officeDocument/2006/relationships" id="274" r:id="R7381ce146e4b478b"/>
+    <p:sldId xmlns:r="http://schemas.openxmlformats.org/officeDocument/2006/relationships" id="275" r:id="Rfe0fae9fe1c1489a"/>
+    <p:sldId xmlns:r="http://schemas.openxmlformats.org/officeDocument/2006/relationships" id="276" r:id="Rf9b199648b494dbb"/>
+    <p:sldId xmlns:r="http://schemas.openxmlformats.org/officeDocument/2006/relationships" id="277" r:id="R4873d6082fbc4c82"/>
+    <p:sldId xmlns:r="http://schemas.openxmlformats.org/officeDocument/2006/relationships" id="278" r:id="R4547eb5e8aa84604"/>
+    <p:sldId xmlns:r="http://schemas.openxmlformats.org/officeDocument/2006/relationships" id="279" r:id="R611b8110eafe4209"/>
+    <p:sldId xmlns:r="http://schemas.openxmlformats.org/officeDocument/2006/relationships" id="280" r:id="R15e9dc2682cf4158"/>
+    <p:sldId xmlns:r="http://schemas.openxmlformats.org/officeDocument/2006/relationships" id="281" r:id="Re5f890118f864b93"/>
+    <p:sldId xmlns:r="http://schemas.openxmlformats.org/officeDocument/2006/relationships" id="282" r:id="Rc21c7b9bc13842d6"/>
+    <p:sldId xmlns:r="http://schemas.openxmlformats.org/officeDocument/2006/relationships" id="283" r:id="R6bdca5e15de544ac"/>
+    <p:sldId xmlns:r="http://schemas.openxmlformats.org/officeDocument/2006/relationships" id="284" r:id="R57e2f9a531fe42da"/>
+    <p:sldId xmlns:r="http://schemas.openxmlformats.org/officeDocument/2006/relationships" id="285" r:id="Ra2cb064421854e20"/>
   </p:sldIdLst>
   <p:sldSz cx="12191999" cy="6858000"/>
   <p:notesSz cx="6858000" cy="9144000"/>
@@ -2546,7 +2546,7 @@
           <p:cNvPr id="2" name="Title 1">
             <a:extLst xmlns:a="http://schemas.openxmlformats.org/drawingml/2006/main">
               <a:ext uri="{FF2B5EF4-FFF2-40B4-BE49-F238E27FC236}">
-                <a16:creationId xmlns:a16="http://schemas.microsoft.com/office/drawing/2014/main" id="{F3436E2D-E1C1-48F8-9197-85806D748C89}"/>
+                <a16:creationId xmlns:a16="http://schemas.microsoft.com/office/drawing/2014/main" id="{0F263D0A-7A17-49AF-9E15-8C9B81D8EDAD}"/>
               </a:ext>
             </a:extLst>
           </p:cNvPr>
@@ -2578,7 +2578,7 @@
           <p:cNvPr id="3" name="Subtitle 2">
             <a:extLst xmlns:a="http://schemas.openxmlformats.org/drawingml/2006/main">
               <a:ext uri="{FF2B5EF4-FFF2-40B4-BE49-F238E27FC236}">
-                <a16:creationId xmlns:a16="http://schemas.microsoft.com/office/drawing/2014/main" id="{62B16E96-B168-49C7-A598-9CF616815311}"/>
+                <a16:creationId xmlns:a16="http://schemas.microsoft.com/office/drawing/2014/main" id="{33CE651E-9356-4C9A-AE02-68CA21CFDEA0}"/>
               </a:ext>
             </a:extLst>
           </p:cNvPr>
@@ -2701,7 +2701,7 @@
           <p:cNvPr id="4" name="Date Placeholder 3">
             <a:extLst xmlns:a="http://schemas.openxmlformats.org/drawingml/2006/main">
               <a:ext uri="{FF2B5EF4-FFF2-40B4-BE49-F238E27FC236}">
-                <a16:creationId xmlns:a16="http://schemas.microsoft.com/office/drawing/2014/main" id="{E02447EA-F21A-4FCE-93BF-83319C5F99A9}"/>
+                <a16:creationId xmlns:a16="http://schemas.microsoft.com/office/drawing/2014/main" id="{139E1B8C-5293-4AA1-A733-6EE5675CCF10}"/>
               </a:ext>
             </a:extLst>
           </p:cNvPr>
@@ -2728,7 +2728,7 @@
           <p:cNvPr id="5" name="Footer Placeholder 4">
             <a:extLst xmlns:a="http://schemas.openxmlformats.org/drawingml/2006/main">
               <a:ext uri="{FF2B5EF4-FFF2-40B4-BE49-F238E27FC236}">
-                <a16:creationId xmlns:a16="http://schemas.microsoft.com/office/drawing/2014/main" id="{12513908-F315-46CE-A1CC-00E9FD3C54AC}"/>
+                <a16:creationId xmlns:a16="http://schemas.microsoft.com/office/drawing/2014/main" id="{5EB15239-356B-425E-AD3A-159BABF8D12D}"/>
               </a:ext>
             </a:extLst>
           </p:cNvPr>
@@ -2751,7 +2751,7 @@
           <p:cNvPr id="6" name="Slide Number Placeholder 5">
             <a:extLst xmlns:a="http://schemas.openxmlformats.org/drawingml/2006/main">
               <a:ext uri="{FF2B5EF4-FFF2-40B4-BE49-F238E27FC236}">
-                <a16:creationId xmlns:a16="http://schemas.microsoft.com/office/drawing/2014/main" id="{239F615F-3E32-440F-9629-6EAE999D7021}"/>
+                <a16:creationId xmlns:a16="http://schemas.microsoft.com/office/drawing/2014/main" id="{07C81122-C1FB-48A1-A053-C2A4BF2B0A55}"/>
               </a:ext>
             </a:extLst>
           </p:cNvPr>
@@ -2795,7 +2795,7 @@
           <p:cNvPr id="2" name="Title 1">
             <a:extLst xmlns:a="http://schemas.openxmlformats.org/drawingml/2006/main">
               <a:ext uri="{FF2B5EF4-FFF2-40B4-BE49-F238E27FC236}">
-                <a16:creationId xmlns:a16="http://schemas.microsoft.com/office/drawing/2014/main" id="{89FD243A-6CAA-4913-923B-A5345D6D622C}"/>
+                <a16:creationId xmlns:a16="http://schemas.microsoft.com/office/drawing/2014/main" id="{88689F9D-D90E-4212-AF5D-4DC3A778E3F9}"/>
               </a:ext>
             </a:extLst>
           </p:cNvPr>
@@ -2822,7 +2822,7 @@
           <p:cNvPr id="3" name="Vertical Text Placeholder 2">
             <a:extLst xmlns:a="http://schemas.openxmlformats.org/drawingml/2006/main">
               <a:ext uri="{FF2B5EF4-FFF2-40B4-BE49-F238E27FC236}">
-                <a16:creationId xmlns:a16="http://schemas.microsoft.com/office/drawing/2014/main" id="{C239DBDF-4F3A-4DCA-A0B2-ABCDB27C67A5}"/>
+                <a16:creationId xmlns:a16="http://schemas.microsoft.com/office/drawing/2014/main" id="{10EF1C08-EF34-466C-8BA3-229CBCF1C108}"/>
               </a:ext>
             </a:extLst>
           </p:cNvPr>
@@ -2884,7 +2884,7 @@
           <p:cNvPr id="4" name="Date Placeholder 3">
             <a:extLst xmlns:a="http://schemas.openxmlformats.org/drawingml/2006/main">
               <a:ext uri="{FF2B5EF4-FFF2-40B4-BE49-F238E27FC236}">
-                <a16:creationId xmlns:a16="http://schemas.microsoft.com/office/drawing/2014/main" id="{46FFBFA1-4FEA-4BDF-A8A9-987002A20BF0}"/>
+                <a16:creationId xmlns:a16="http://schemas.microsoft.com/office/drawing/2014/main" id="{97929792-CE4E-40B1-AF2B-1A5516E363D7}"/>
               </a:ext>
             </a:extLst>
           </p:cNvPr>
@@ -2911,7 +2911,7 @@
           <p:cNvPr id="5" name="Footer Placeholder 4">
             <a:extLst xmlns:a="http://schemas.openxmlformats.org/drawingml/2006/main">
               <a:ext uri="{FF2B5EF4-FFF2-40B4-BE49-F238E27FC236}">
-                <a16:creationId xmlns:a16="http://schemas.microsoft.com/office/drawing/2014/main" id="{6C745F40-C9B3-445B-9CA8-FCDF87B7917D}"/>
+                <a16:creationId xmlns:a16="http://schemas.microsoft.com/office/drawing/2014/main" id="{CD88F3ED-EA7D-467A-9C52-05D50D443BD0}"/>
               </a:ext>
             </a:extLst>
           </p:cNvPr>
@@ -2934,7 +2934,7 @@
           <p:cNvPr id="6" name="Slide Number Placeholder 5">
             <a:extLst xmlns:a="http://schemas.openxmlformats.org/drawingml/2006/main">
               <a:ext uri="{FF2B5EF4-FFF2-40B4-BE49-F238E27FC236}">
-                <a16:creationId xmlns:a16="http://schemas.microsoft.com/office/drawing/2014/main" id="{5594C023-5908-4B1A-B1EA-84359181F922}"/>
+                <a16:creationId xmlns:a16="http://schemas.microsoft.com/office/drawing/2014/main" id="{D107801E-00F9-487D-94DA-370DA0E5094D}"/>
               </a:ext>
             </a:extLst>
           </p:cNvPr>
@@ -2978,7 +2978,7 @@
           <p:cNvPr id="2" name="Vertical Title 1">
             <a:extLst xmlns:a="http://schemas.openxmlformats.org/drawingml/2006/main">
               <a:ext uri="{FF2B5EF4-FFF2-40B4-BE49-F238E27FC236}">
-                <a16:creationId xmlns:a16="http://schemas.microsoft.com/office/drawing/2014/main" id="{3DDAAF3A-5834-414F-962E-06DCE1000473}"/>
+                <a16:creationId xmlns:a16="http://schemas.microsoft.com/office/drawing/2014/main" id="{96E88F34-EAB4-4595-A3D2-175AC418DD28}"/>
               </a:ext>
             </a:extLst>
           </p:cNvPr>
@@ -3010,7 +3010,7 @@
           <p:cNvPr id="3" name="Vertical Text Placeholder 2">
             <a:extLst xmlns:a="http://schemas.openxmlformats.org/drawingml/2006/main">
               <a:ext uri="{FF2B5EF4-FFF2-40B4-BE49-F238E27FC236}">
-                <a16:creationId xmlns:a16="http://schemas.microsoft.com/office/drawing/2014/main" id="{7013BCE6-FFD4-4B59-AB1F-12C5EA045F0D}"/>
+                <a16:creationId xmlns:a16="http://schemas.microsoft.com/office/drawing/2014/main" id="{D4F7F1DB-FE5D-4823-A3CD-C7F0D2237EC5}"/>
               </a:ext>
             </a:extLst>
           </p:cNvPr>
@@ -3077,7 +3077,7 @@
           <p:cNvPr id="4" name="Date Placeholder 3">
             <a:extLst xmlns:a="http://schemas.openxmlformats.org/drawingml/2006/main">
               <a:ext uri="{FF2B5EF4-FFF2-40B4-BE49-F238E27FC236}">
-                <a16:creationId xmlns:a16="http://schemas.microsoft.com/office/drawing/2014/main" id="{A7EEF051-262B-4E4B-ADB0-24779627AA5E}"/>
+                <a16:creationId xmlns:a16="http://schemas.microsoft.com/office/drawing/2014/main" id="{BC986B05-E101-4360-BC00-B898A475169A}"/>
               </a:ext>
             </a:extLst>
           </p:cNvPr>
@@ -3104,7 +3104,7 @@
           <p:cNvPr id="5" name="Footer Placeholder 4">
             <a:extLst xmlns:a="http://schemas.openxmlformats.org/drawingml/2006/main">
               <a:ext uri="{FF2B5EF4-FFF2-40B4-BE49-F238E27FC236}">
-                <a16:creationId xmlns:a16="http://schemas.microsoft.com/office/drawing/2014/main" id="{5EAA2759-142E-46CE-9777-3E934F614A55}"/>
+                <a16:creationId xmlns:a16="http://schemas.microsoft.com/office/drawing/2014/main" id="{20101DBA-9678-48FE-A7BE-E91B5FEBDA48}"/>
               </a:ext>
             </a:extLst>
           </p:cNvPr>
@@ -3127,7 +3127,7 @@
           <p:cNvPr id="6" name="Slide Number Placeholder 5">
             <a:extLst xmlns:a="http://schemas.openxmlformats.org/drawingml/2006/main">
               <a:ext uri="{FF2B5EF4-FFF2-40B4-BE49-F238E27FC236}">
-                <a16:creationId xmlns:a16="http://schemas.microsoft.com/office/drawing/2014/main" id="{CA18648B-47EC-4B15-83E6-C4B0024A997E}"/>
+                <a16:creationId xmlns:a16="http://schemas.microsoft.com/office/drawing/2014/main" id="{4350D0D1-EA30-4033-B43D-62E0C7DB2B20}"/>
               </a:ext>
             </a:extLst>
           </p:cNvPr>
@@ -3171,7 +3171,7 @@
           <p:cNvPr id="2" name="Title 1">
             <a:extLst xmlns:a="http://schemas.openxmlformats.org/drawingml/2006/main">
               <a:ext uri="{FF2B5EF4-FFF2-40B4-BE49-F238E27FC236}">
-                <a16:creationId xmlns:a16="http://schemas.microsoft.com/office/drawing/2014/main" id="{765A7553-220F-4CDF-8251-AF14311B9589}"/>
+                <a16:creationId xmlns:a16="http://schemas.microsoft.com/office/drawing/2014/main" id="{78915B9A-5B8F-4426-A131-2263FBEF2242}"/>
               </a:ext>
             </a:extLst>
           </p:cNvPr>
@@ -3198,7 +3198,7 @@
           <p:cNvPr id="3" name="Content Placeholder 2">
             <a:extLst xmlns:a="http://schemas.openxmlformats.org/drawingml/2006/main">
               <a:ext uri="{FF2B5EF4-FFF2-40B4-BE49-F238E27FC236}">
-                <a16:creationId xmlns:a16="http://schemas.microsoft.com/office/drawing/2014/main" id="{6748F28A-2112-48E5-9FC8-1E0AA4A8FC18}"/>
+                <a16:creationId xmlns:a16="http://schemas.microsoft.com/office/drawing/2014/main" id="{DB859555-37FA-4076-A123-CF1CAAEBD1A5}"/>
               </a:ext>
             </a:extLst>
           </p:cNvPr>
@@ -3260,7 +3260,7 @@
           <p:cNvPr id="4" name="Date Placeholder 3">
             <a:extLst xmlns:a="http://schemas.openxmlformats.org/drawingml/2006/main">
               <a:ext uri="{FF2B5EF4-FFF2-40B4-BE49-F238E27FC236}">
-                <a16:creationId xmlns:a16="http://schemas.microsoft.com/office/drawing/2014/main" id="{DC1F3072-69D6-4D58-B937-5A4A9732AF6F}"/>
+                <a16:creationId xmlns:a16="http://schemas.microsoft.com/office/drawing/2014/main" id="{73905BC6-6270-4C51-AC51-A676D02873EE}"/>
               </a:ext>
             </a:extLst>
           </p:cNvPr>
@@ -3287,7 +3287,7 @@
           <p:cNvPr id="5" name="Footer Placeholder 4">
             <a:extLst xmlns:a="http://schemas.openxmlformats.org/drawingml/2006/main">
               <a:ext uri="{FF2B5EF4-FFF2-40B4-BE49-F238E27FC236}">
-                <a16:creationId xmlns:a16="http://schemas.microsoft.com/office/drawing/2014/main" id="{AB8B7EBD-716B-4029-963F-285A5DDE8B00}"/>
+                <a16:creationId xmlns:a16="http://schemas.microsoft.com/office/drawing/2014/main" id="{54270016-0440-4A18-AAE4-04EC40CED869}"/>
               </a:ext>
             </a:extLst>
           </p:cNvPr>
@@ -3310,7 +3310,7 @@
           <p:cNvPr id="6" name="Slide Number Placeholder 5">
             <a:extLst xmlns:a="http://schemas.openxmlformats.org/drawingml/2006/main">
               <a:ext uri="{FF2B5EF4-FFF2-40B4-BE49-F238E27FC236}">
-                <a16:creationId xmlns:a16="http://schemas.microsoft.com/office/drawing/2014/main" id="{6DCEC666-C6C4-4FE9-B007-7B98042EABD4}"/>
+                <a16:creationId xmlns:a16="http://schemas.microsoft.com/office/drawing/2014/main" id="{F224D988-3792-4FC3-AFB4-435F28FC17CB}"/>
               </a:ext>
             </a:extLst>
           </p:cNvPr>
@@ -3354,7 +3354,7 @@
           <p:cNvPr id="2" name="Title 1">
             <a:extLst xmlns:a="http://schemas.openxmlformats.org/drawingml/2006/main">
               <a:ext uri="{FF2B5EF4-FFF2-40B4-BE49-F238E27FC236}">
-                <a16:creationId xmlns:a16="http://schemas.microsoft.com/office/drawing/2014/main" id="{C2A6CAAD-3C8C-412B-A83A-D7248E899DF9}"/>
+                <a16:creationId xmlns:a16="http://schemas.microsoft.com/office/drawing/2014/main" id="{7C70C37A-113E-4478-861B-6C022C934A82}"/>
               </a:ext>
             </a:extLst>
           </p:cNvPr>
@@ -3391,7 +3391,7 @@
           <p:cNvPr id="3" name="Text Placeholder 2">
             <a:extLst xmlns:a="http://schemas.openxmlformats.org/drawingml/2006/main">
               <a:ext uri="{FF2B5EF4-FFF2-40B4-BE49-F238E27FC236}">
-                <a16:creationId xmlns:a16="http://schemas.microsoft.com/office/drawing/2014/main" id="{64C4EE91-145B-48E1-9CE8-225B99A929D9}"/>
+                <a16:creationId xmlns:a16="http://schemas.microsoft.com/office/drawing/2014/main" id="{029024FB-EAF3-428F-99D8-573CA3B883D2}"/>
               </a:ext>
             </a:extLst>
           </p:cNvPr>
@@ -3517,7 +3517,7 @@
           <p:cNvPr id="4" name="Date Placeholder 3">
             <a:extLst xmlns:a="http://schemas.openxmlformats.org/drawingml/2006/main">
               <a:ext uri="{FF2B5EF4-FFF2-40B4-BE49-F238E27FC236}">
-                <a16:creationId xmlns:a16="http://schemas.microsoft.com/office/drawing/2014/main" id="{37DACD32-8B94-4A16-B1C0-9D27BCBC5577}"/>
+                <a16:creationId xmlns:a16="http://schemas.microsoft.com/office/drawing/2014/main" id="{B4784A54-132F-4BAA-ADE7-9A012AB0FC77}"/>
               </a:ext>
             </a:extLst>
           </p:cNvPr>
@@ -3544,7 +3544,7 @@
           <p:cNvPr id="5" name="Footer Placeholder 4">
             <a:extLst xmlns:a="http://schemas.openxmlformats.org/drawingml/2006/main">
               <a:ext uri="{FF2B5EF4-FFF2-40B4-BE49-F238E27FC236}">
-                <a16:creationId xmlns:a16="http://schemas.microsoft.com/office/drawing/2014/main" id="{D779F11F-F402-470D-94C9-8AC10D2E30A9}"/>
+                <a16:creationId xmlns:a16="http://schemas.microsoft.com/office/drawing/2014/main" id="{E7A92AA5-15CB-4453-9380-1BBCDAE2F967}"/>
               </a:ext>
             </a:extLst>
           </p:cNvPr>
@@ -3567,7 +3567,7 @@
           <p:cNvPr id="6" name="Slide Number Placeholder 5">
             <a:extLst xmlns:a="http://schemas.openxmlformats.org/drawingml/2006/main">
               <a:ext uri="{FF2B5EF4-FFF2-40B4-BE49-F238E27FC236}">
-                <a16:creationId xmlns:a16="http://schemas.microsoft.com/office/drawing/2014/main" id="{79F9D546-DA84-44F8-8955-8796D7CABD60}"/>
+                <a16:creationId xmlns:a16="http://schemas.microsoft.com/office/drawing/2014/main" id="{C948D2C8-4A9E-4C34-A100-10773340F2C9}"/>
               </a:ext>
             </a:extLst>
           </p:cNvPr>
@@ -3611,7 +3611,7 @@
           <p:cNvPr id="2" name="Title 1">
             <a:extLst xmlns:a="http://schemas.openxmlformats.org/drawingml/2006/main">
               <a:ext uri="{FF2B5EF4-FFF2-40B4-BE49-F238E27FC236}">
-                <a16:creationId xmlns:a16="http://schemas.microsoft.com/office/drawing/2014/main" id="{8018B09E-F6A1-4E9E-B4CE-4512C59D595F}"/>
+                <a16:creationId xmlns:a16="http://schemas.microsoft.com/office/drawing/2014/main" id="{9EA6BBD2-43A6-448B-A057-94DF852F13EF}"/>
               </a:ext>
             </a:extLst>
           </p:cNvPr>
@@ -3638,7 +3638,7 @@
           <p:cNvPr id="3" name="Content Placeholder 2">
             <a:extLst xmlns:a="http://schemas.openxmlformats.org/drawingml/2006/main">
               <a:ext uri="{FF2B5EF4-FFF2-40B4-BE49-F238E27FC236}">
-                <a16:creationId xmlns:a16="http://schemas.microsoft.com/office/drawing/2014/main" id="{AAA90FAE-06A9-4CDE-9628-BC7A990741B9}"/>
+                <a16:creationId xmlns:a16="http://schemas.microsoft.com/office/drawing/2014/main" id="{B8BAD046-C4F7-4286-BD9E-F4678B331633}"/>
               </a:ext>
             </a:extLst>
           </p:cNvPr>
@@ -3742,7 +3742,7 @@
           <p:cNvPr id="4" name="Content Placeholder 3">
             <a:extLst xmlns:a="http://schemas.openxmlformats.org/drawingml/2006/main">
               <a:ext uri="{FF2B5EF4-FFF2-40B4-BE49-F238E27FC236}">
-                <a16:creationId xmlns:a16="http://schemas.microsoft.com/office/drawing/2014/main" id="{61F6A098-5781-4739-AD0B-46563D0B9F21}"/>
+                <a16:creationId xmlns:a16="http://schemas.microsoft.com/office/drawing/2014/main" id="{F3F3D957-4722-4869-8930-2C210E53DC37}"/>
               </a:ext>
             </a:extLst>
           </p:cNvPr>
@@ -3846,7 +3846,7 @@
           <p:cNvPr id="5" name="Date Placeholder 4">
             <a:extLst xmlns:a="http://schemas.openxmlformats.org/drawingml/2006/main">
               <a:ext uri="{FF2B5EF4-FFF2-40B4-BE49-F238E27FC236}">
-                <a16:creationId xmlns:a16="http://schemas.microsoft.com/office/drawing/2014/main" id="{FDC7A8EE-D37B-4F14-A224-85C0556166E2}"/>
+                <a16:creationId xmlns:a16="http://schemas.microsoft.com/office/drawing/2014/main" id="{174BD042-E1C6-4CD0-A52E-115606AEFDD1}"/>
               </a:ext>
             </a:extLst>
           </p:cNvPr>
@@ -3873,7 +3873,7 @@
           <p:cNvPr id="6" name="Footer Placeholder 5">
             <a:extLst xmlns:a="http://schemas.openxmlformats.org/drawingml/2006/main">
               <a:ext uri="{FF2B5EF4-FFF2-40B4-BE49-F238E27FC236}">
-                <a16:creationId xmlns:a16="http://schemas.microsoft.com/office/drawing/2014/main" id="{0C21F815-FDF6-4301-A7B8-0D4BD3369376}"/>
+                <a16:creationId xmlns:a16="http://schemas.microsoft.com/office/drawing/2014/main" id="{B8F2FB94-44FA-4539-8BE4-4EC66539DA6E}"/>
               </a:ext>
             </a:extLst>
           </p:cNvPr>
@@ -3896,7 +3896,7 @@
           <p:cNvPr id="7" name="Slide Number Placeholder 6">
             <a:extLst xmlns:a="http://schemas.openxmlformats.org/drawingml/2006/main">
               <a:ext uri="{FF2B5EF4-FFF2-40B4-BE49-F238E27FC236}">
-                <a16:creationId xmlns:a16="http://schemas.microsoft.com/office/drawing/2014/main" id="{38AFDFCA-F708-4C0B-8E92-4947617D6C61}"/>
+                <a16:creationId xmlns:a16="http://schemas.microsoft.com/office/drawing/2014/main" id="{9797166E-D51E-4B2C-B722-FD88F7951815}"/>
               </a:ext>
             </a:extLst>
           </p:cNvPr>
@@ -3940,7 +3940,7 @@
           <p:cNvPr id="2" name="Title 1">
             <a:extLst xmlns:a="http://schemas.openxmlformats.org/drawingml/2006/main">
               <a:ext uri="{FF2B5EF4-FFF2-40B4-BE49-F238E27FC236}">
-                <a16:creationId xmlns:a16="http://schemas.microsoft.com/office/drawing/2014/main" id="{1AB61278-1AD1-4008-B826-D2FCBD94D4A7}"/>
+                <a16:creationId xmlns:a16="http://schemas.microsoft.com/office/drawing/2014/main" id="{6B9BA5E1-0E66-430E-9CCD-704FEB0AB8E5}"/>
               </a:ext>
             </a:extLst>
           </p:cNvPr>
@@ -3972,7 +3972,7 @@
           <p:cNvPr id="3" name="Text Placeholder 2">
             <a:extLst xmlns:a="http://schemas.openxmlformats.org/drawingml/2006/main">
               <a:ext uri="{FF2B5EF4-FFF2-40B4-BE49-F238E27FC236}">
-                <a16:creationId xmlns:a16="http://schemas.microsoft.com/office/drawing/2014/main" id="{83B9E49E-E07B-4101-8CA3-C72C8F13EE20}"/>
+                <a16:creationId xmlns:a16="http://schemas.microsoft.com/office/drawing/2014/main" id="{2CAE8D6F-5965-444E-B665-B343993EE8D6}"/>
               </a:ext>
             </a:extLst>
           </p:cNvPr>
@@ -4044,7 +4044,7 @@
           <p:cNvPr id="4" name="Content Placeholder 3">
             <a:extLst xmlns:a="http://schemas.openxmlformats.org/drawingml/2006/main">
               <a:ext uri="{FF2B5EF4-FFF2-40B4-BE49-F238E27FC236}">
-                <a16:creationId xmlns:a16="http://schemas.microsoft.com/office/drawing/2014/main" id="{D81CA610-36BC-462B-AA50-68DE1572CDEE}"/>
+                <a16:creationId xmlns:a16="http://schemas.microsoft.com/office/drawing/2014/main" id="{C49BF9C6-8D66-418B-A74C-E45D962AC523}"/>
               </a:ext>
             </a:extLst>
           </p:cNvPr>
@@ -4148,7 +4148,7 @@
           <p:cNvPr id="5" name="Text Placeholder 4">
             <a:extLst xmlns:a="http://schemas.openxmlformats.org/drawingml/2006/main">
               <a:ext uri="{FF2B5EF4-FFF2-40B4-BE49-F238E27FC236}">
-                <a16:creationId xmlns:a16="http://schemas.microsoft.com/office/drawing/2014/main" id="{8D417C4C-A5F4-4095-A9E6-F63D0D1B9C5C}"/>
+                <a16:creationId xmlns:a16="http://schemas.microsoft.com/office/drawing/2014/main" id="{978AEB07-D4EA-4219-94F1-F5BE92F2E676}"/>
               </a:ext>
             </a:extLst>
           </p:cNvPr>
@@ -4220,7 +4220,7 @@
           <p:cNvPr id="6" name="Content Placeholder 5">
             <a:extLst xmlns:a="http://schemas.openxmlformats.org/drawingml/2006/main">
               <a:ext uri="{FF2B5EF4-FFF2-40B4-BE49-F238E27FC236}">
-                <a16:creationId xmlns:a16="http://schemas.microsoft.com/office/drawing/2014/main" id="{29651AAE-A7EA-4274-884B-2D2CE1C6F5FB}"/>
+                <a16:creationId xmlns:a16="http://schemas.microsoft.com/office/drawing/2014/main" id="{CA1E7A3D-0AFC-4153-BFE4-4C3D11BCF572}"/>
               </a:ext>
             </a:extLst>
           </p:cNvPr>
@@ -4324,7 +4324,7 @@
           <p:cNvPr id="7" name="Date Placeholder 6">
             <a:extLst xmlns:a="http://schemas.openxmlformats.org/drawingml/2006/main">
               <a:ext uri="{FF2B5EF4-FFF2-40B4-BE49-F238E27FC236}">
-                <a16:creationId xmlns:a16="http://schemas.microsoft.com/office/drawing/2014/main" id="{AA292D49-F29C-4175-AB96-F05ED92C7EC7}"/>
+                <a16:creationId xmlns:a16="http://schemas.microsoft.com/office/drawing/2014/main" id="{6383AAEA-26D6-4793-816A-C43A919A3088}"/>
               </a:ext>
             </a:extLst>
           </p:cNvPr>
@@ -4351,7 +4351,7 @@
           <p:cNvPr id="8" name="Footer Placeholder 7">
             <a:extLst xmlns:a="http://schemas.openxmlformats.org/drawingml/2006/main">
               <a:ext uri="{FF2B5EF4-FFF2-40B4-BE49-F238E27FC236}">
-                <a16:creationId xmlns:a16="http://schemas.microsoft.com/office/drawing/2014/main" id="{81C95902-48B3-4E56-AC01-853516DF64B5}"/>
+                <a16:creationId xmlns:a16="http://schemas.microsoft.com/office/drawing/2014/main" id="{6FE6737F-C44E-47D6-AECA-D384ADA5BE62}"/>
               </a:ext>
             </a:extLst>
           </p:cNvPr>
@@ -4374,7 +4374,7 @@
           <p:cNvPr id="9" name="Slide Number Placeholder 8">
             <a:extLst xmlns:a="http://schemas.openxmlformats.org/drawingml/2006/main">
               <a:ext uri="{FF2B5EF4-FFF2-40B4-BE49-F238E27FC236}">
-                <a16:creationId xmlns:a16="http://schemas.microsoft.com/office/drawing/2014/main" id="{64B77271-500A-43B0-AEB6-427B36D92859}"/>
+                <a16:creationId xmlns:a16="http://schemas.microsoft.com/office/drawing/2014/main" id="{679C330B-86CF-479F-B11D-E4713087AA18}"/>
               </a:ext>
             </a:extLst>
           </p:cNvPr>
@@ -4418,7 +4418,7 @@
           <p:cNvPr id="2" name="Title 1">
             <a:extLst xmlns:a="http://schemas.openxmlformats.org/drawingml/2006/main">
               <a:ext uri="{FF2B5EF4-FFF2-40B4-BE49-F238E27FC236}">
-                <a16:creationId xmlns:a16="http://schemas.microsoft.com/office/drawing/2014/main" id="{EB0D13B2-B442-4600-B4E7-AE087E56D815}"/>
+                <a16:creationId xmlns:a16="http://schemas.microsoft.com/office/drawing/2014/main" id="{617EB283-14FE-49CF-B9C3-382299EAD206}"/>
               </a:ext>
             </a:extLst>
           </p:cNvPr>
@@ -4445,7 +4445,7 @@
           <p:cNvPr id="3" name="Date Placeholder 2">
             <a:extLst xmlns:a="http://schemas.openxmlformats.org/drawingml/2006/main">
               <a:ext uri="{FF2B5EF4-FFF2-40B4-BE49-F238E27FC236}">
-                <a16:creationId xmlns:a16="http://schemas.microsoft.com/office/drawing/2014/main" id="{755734FE-A4A2-4791-A6B0-A52B722B4CA7}"/>
+                <a16:creationId xmlns:a16="http://schemas.microsoft.com/office/drawing/2014/main" id="{971F5DAF-344A-4419-9465-0CDF80DBA1B0}"/>
               </a:ext>
             </a:extLst>
           </p:cNvPr>
@@ -4472,7 +4472,7 @@
           <p:cNvPr id="4" name="Footer Placeholder 3">
             <a:extLst xmlns:a="http://schemas.openxmlformats.org/drawingml/2006/main">
               <a:ext uri="{FF2B5EF4-FFF2-40B4-BE49-F238E27FC236}">
-                <a16:creationId xmlns:a16="http://schemas.microsoft.com/office/drawing/2014/main" id="{96E8902B-3E6E-4504-A558-03CA968A51BA}"/>
+                <a16:creationId xmlns:a16="http://schemas.microsoft.com/office/drawing/2014/main" id="{39FDCE2D-AD13-4718-B32D-0C14CB5A9937}"/>
               </a:ext>
             </a:extLst>
           </p:cNvPr>
@@ -4495,7 +4495,7 @@
           <p:cNvPr id="5" name="Slide Number Placeholder 4">
             <a:extLst xmlns:a="http://schemas.openxmlformats.org/drawingml/2006/main">
               <a:ext uri="{FF2B5EF4-FFF2-40B4-BE49-F238E27FC236}">
-                <a16:creationId xmlns:a16="http://schemas.microsoft.com/office/drawing/2014/main" id="{4F46550D-B380-41CD-B109-1374699733D1}"/>
+                <a16:creationId xmlns:a16="http://schemas.microsoft.com/office/drawing/2014/main" id="{AAF7C8FB-7CBF-4F2E-AA77-143D1A6FDFAB}"/>
               </a:ext>
             </a:extLst>
           </p:cNvPr>
@@ -4539,7 +4539,7 @@
           <p:cNvPr id="2" name="Date Placeholder 1">
             <a:extLst xmlns:a="http://schemas.openxmlformats.org/drawingml/2006/main">
               <a:ext uri="{FF2B5EF4-FFF2-40B4-BE49-F238E27FC236}">
-                <a16:creationId xmlns:a16="http://schemas.microsoft.com/office/drawing/2014/main" id="{B2EC543A-7899-4CF4-953C-7652D53BC30D}"/>
+                <a16:creationId xmlns:a16="http://schemas.microsoft.com/office/drawing/2014/main" id="{C88D538D-8F02-49CE-A904-1105D9F508A3}"/>
               </a:ext>
             </a:extLst>
           </p:cNvPr>
@@ -4566,7 +4566,7 @@
           <p:cNvPr id="3" name="Footer Placeholder 2">
             <a:extLst xmlns:a="http://schemas.openxmlformats.org/drawingml/2006/main">
               <a:ext uri="{FF2B5EF4-FFF2-40B4-BE49-F238E27FC236}">
-                <a16:creationId xmlns:a16="http://schemas.microsoft.com/office/drawing/2014/main" id="{7FB35ADF-4FE8-4944-8247-32EE1D748DB5}"/>
+                <a16:creationId xmlns:a16="http://schemas.microsoft.com/office/drawing/2014/main" id="{20788487-46A8-47E7-B013-EAA8E0E1984E}"/>
               </a:ext>
             </a:extLst>
           </p:cNvPr>
@@ -4589,7 +4589,7 @@
           <p:cNvPr id="4" name="Slide Number Placeholder 3">
             <a:extLst xmlns:a="http://schemas.openxmlformats.org/drawingml/2006/main">
               <a:ext uri="{FF2B5EF4-FFF2-40B4-BE49-F238E27FC236}">
-                <a16:creationId xmlns:a16="http://schemas.microsoft.com/office/drawing/2014/main" id="{22B00982-1B6E-442F-BA1A-D0BDD439E460}"/>
+                <a16:creationId xmlns:a16="http://schemas.microsoft.com/office/drawing/2014/main" id="{43AAB4AB-3067-43EB-A029-D8A19003CB37}"/>
               </a:ext>
             </a:extLst>
           </p:cNvPr>
@@ -4633,7 +4633,7 @@
           <p:cNvPr id="2" name="Title 1">
             <a:extLst xmlns:a="http://schemas.openxmlformats.org/drawingml/2006/main">
               <a:ext uri="{FF2B5EF4-FFF2-40B4-BE49-F238E27FC236}">
-                <a16:creationId xmlns:a16="http://schemas.microsoft.com/office/drawing/2014/main" id="{A2A6C3E8-C5EB-429B-ACF4-1C9132DF9F2B}"/>
+                <a16:creationId xmlns:a16="http://schemas.microsoft.com/office/drawing/2014/main" id="{1403FC27-5849-49AD-BD37-E590D56A6C45}"/>
               </a:ext>
             </a:extLst>
           </p:cNvPr>
@@ -4670,7 +4670,7 @@
           <p:cNvPr id="3" name="Content Placeholder 2">
             <a:extLst xmlns:a="http://schemas.openxmlformats.org/drawingml/2006/main">
               <a:ext uri="{FF2B5EF4-FFF2-40B4-BE49-F238E27FC236}">
-                <a16:creationId xmlns:a16="http://schemas.microsoft.com/office/drawing/2014/main" id="{D04772B8-82A0-4110-8038-822FD70FBE3D}"/>
+                <a16:creationId xmlns:a16="http://schemas.microsoft.com/office/drawing/2014/main" id="{35964B7B-34D8-4E30-AD13-335AAABFA326}"/>
               </a:ext>
             </a:extLst>
           </p:cNvPr>
@@ -4774,7 +4774,7 @@
           <p:cNvPr id="4" name="Text Placeholder 3">
             <a:extLst xmlns:a="http://schemas.openxmlformats.org/drawingml/2006/main">
               <a:ext uri="{FF2B5EF4-FFF2-40B4-BE49-F238E27FC236}">
-                <a16:creationId xmlns:a16="http://schemas.microsoft.com/office/drawing/2014/main" id="{E8AF4A4D-8D1E-43AA-9AF9-AD6BAD00A2D5}"/>
+                <a16:creationId xmlns:a16="http://schemas.microsoft.com/office/drawing/2014/main" id="{AFE8C344-AAF9-415C-9106-50AE06A9EC4F}"/>
               </a:ext>
             </a:extLst>
           </p:cNvPr>
@@ -4846,7 +4846,7 @@
           <p:cNvPr id="5" name="Date Placeholder 4">
             <a:extLst xmlns:a="http://schemas.openxmlformats.org/drawingml/2006/main">
               <a:ext uri="{FF2B5EF4-FFF2-40B4-BE49-F238E27FC236}">
-                <a16:creationId xmlns:a16="http://schemas.microsoft.com/office/drawing/2014/main" id="{5444D9EB-2FDF-4BF1-996D-CF16F3FDD6B4}"/>
+                <a16:creationId xmlns:a16="http://schemas.microsoft.com/office/drawing/2014/main" id="{18EBE7C5-9683-41A8-90A4-EFE3AA8D1011}"/>
               </a:ext>
             </a:extLst>
           </p:cNvPr>
@@ -4873,7 +4873,7 @@
           <p:cNvPr id="6" name="Footer Placeholder 5">
             <a:extLst xmlns:a="http://schemas.openxmlformats.org/drawingml/2006/main">
               <a:ext uri="{FF2B5EF4-FFF2-40B4-BE49-F238E27FC236}">
-                <a16:creationId xmlns:a16="http://schemas.microsoft.com/office/drawing/2014/main" id="{63B17912-9466-45EE-BF59-CE5C2804388D}"/>
+                <a16:creationId xmlns:a16="http://schemas.microsoft.com/office/drawing/2014/main" id="{007F7533-68C4-4547-B66C-E9B8DF0E327B}"/>
               </a:ext>
             </a:extLst>
           </p:cNvPr>
@@ -4896,7 +4896,7 @@
           <p:cNvPr id="7" name="Slide Number Placeholder 6">
             <a:extLst xmlns:a="http://schemas.openxmlformats.org/drawingml/2006/main">
               <a:ext uri="{FF2B5EF4-FFF2-40B4-BE49-F238E27FC236}">
-                <a16:creationId xmlns:a16="http://schemas.microsoft.com/office/drawing/2014/main" id="{5CA971E6-70DB-4F5A-872F-025C9C6BE865}"/>
+                <a16:creationId xmlns:a16="http://schemas.microsoft.com/office/drawing/2014/main" id="{3F2286C8-DCC5-4251-AF4B-50B5AAED4908}"/>
               </a:ext>
             </a:extLst>
           </p:cNvPr>
@@ -4940,7 +4940,7 @@
           <p:cNvPr id="2" name="Title 1">
             <a:extLst xmlns:a="http://schemas.openxmlformats.org/drawingml/2006/main">
               <a:ext uri="{FF2B5EF4-FFF2-40B4-BE49-F238E27FC236}">
-                <a16:creationId xmlns:a16="http://schemas.microsoft.com/office/drawing/2014/main" id="{5A825230-A94B-4F59-A71C-6CEF3C60BF07}"/>
+                <a16:creationId xmlns:a16="http://schemas.microsoft.com/office/drawing/2014/main" id="{D9F0FFE5-D0B7-46D0-9ADB-BA4C143DD9F7}"/>
               </a:ext>
             </a:extLst>
           </p:cNvPr>
@@ -4977,7 +4977,7 @@
           <p:cNvPr id="3" name="Picture Placeholder 2">
             <a:extLst xmlns:a="http://schemas.openxmlformats.org/drawingml/2006/main">
               <a:ext uri="{FF2B5EF4-FFF2-40B4-BE49-F238E27FC236}">
-                <a16:creationId xmlns:a16="http://schemas.microsoft.com/office/drawing/2014/main" id="{B0AFABCC-CBF0-4914-B015-912DD7B2D8E7}"/>
+                <a16:creationId xmlns:a16="http://schemas.microsoft.com/office/drawing/2014/main" id="{CACD5425-F6F3-4B80-8F57-465096722C47}"/>
               </a:ext>
             </a:extLst>
           </p:cNvPr>
@@ -5042,7 +5042,7 @@
           <p:cNvPr id="4" name="Text Placeholder 3">
             <a:extLst xmlns:a="http://schemas.openxmlformats.org/drawingml/2006/main">
               <a:ext uri="{FF2B5EF4-FFF2-40B4-BE49-F238E27FC236}">
-                <a16:creationId xmlns:a16="http://schemas.microsoft.com/office/drawing/2014/main" id="{6B5E0EDD-ADB7-4320-9805-E0F8ADDFF2BB}"/>
+                <a16:creationId xmlns:a16="http://schemas.microsoft.com/office/drawing/2014/main" id="{06760891-4FBC-4104-AF3D-EFDAAF37FBCA}"/>
               </a:ext>
             </a:extLst>
           </p:cNvPr>
@@ -5114,7 +5114,7 @@
           <p:cNvPr id="5" name="Date Placeholder 4">
             <a:extLst xmlns:a="http://schemas.openxmlformats.org/drawingml/2006/main">
               <a:ext uri="{FF2B5EF4-FFF2-40B4-BE49-F238E27FC236}">
-                <a16:creationId xmlns:a16="http://schemas.microsoft.com/office/drawing/2014/main" id="{DE7F61AC-0B0C-4367-9B2A-56315A0754EA}"/>
+                <a16:creationId xmlns:a16="http://schemas.microsoft.com/office/drawing/2014/main" id="{C1716BC2-9F89-4096-87D8-652A0E1A1A9A}"/>
               </a:ext>
             </a:extLst>
           </p:cNvPr>
@@ -5141,7 +5141,7 @@
           <p:cNvPr id="6" name="Footer Placeholder 5">
             <a:extLst xmlns:a="http://schemas.openxmlformats.org/drawingml/2006/main">
               <a:ext uri="{FF2B5EF4-FFF2-40B4-BE49-F238E27FC236}">
-                <a16:creationId xmlns:a16="http://schemas.microsoft.com/office/drawing/2014/main" id="{1CBFDCF0-1971-49AD-966B-817B9CFB6327}"/>
+                <a16:creationId xmlns:a16="http://schemas.microsoft.com/office/drawing/2014/main" id="{859DBE2F-E295-439B-9610-717C1190B1B1}"/>
               </a:ext>
             </a:extLst>
           </p:cNvPr>
@@ -5164,7 +5164,7 @@
           <p:cNvPr id="7" name="Slide Number Placeholder 6">
             <a:extLst xmlns:a="http://schemas.openxmlformats.org/drawingml/2006/main">
               <a:ext uri="{FF2B5EF4-FFF2-40B4-BE49-F238E27FC236}">
-                <a16:creationId xmlns:a16="http://schemas.microsoft.com/office/drawing/2014/main" id="{693D7C15-D71F-4FE8-BAA1-E2C025B1696E}"/>
+                <a16:creationId xmlns:a16="http://schemas.microsoft.com/office/drawing/2014/main" id="{099E4239-91CF-4BCF-AC3C-723CA6038650}"/>
               </a:ext>
             </a:extLst>
           </p:cNvPr>
@@ -5213,7 +5213,7 @@
           <p:cNvPr id="2" name="Title Placeholder 1">
             <a:extLst xmlns:a="http://schemas.openxmlformats.org/drawingml/2006/main">
               <a:ext uri="{FF2B5EF4-FFF2-40B4-BE49-F238E27FC236}">
-                <a16:creationId xmlns:a16="http://schemas.microsoft.com/office/drawing/2014/main" id="{2533FD76-40B2-48DE-98EC-F923AEE61A2A}"/>
+                <a16:creationId xmlns:a16="http://schemas.microsoft.com/office/drawing/2014/main" id="{B2378F9C-5DE4-47C7-AA10-5EADBAA3D026}"/>
               </a:ext>
             </a:extLst>
           </p:cNvPr>
@@ -5250,7 +5250,7 @@
           <p:cNvPr id="3" name="Text Placeholder 2">
             <a:extLst xmlns:a="http://schemas.openxmlformats.org/drawingml/2006/main">
               <a:ext uri="{FF2B5EF4-FFF2-40B4-BE49-F238E27FC236}">
-                <a16:creationId xmlns:a16="http://schemas.microsoft.com/office/drawing/2014/main" id="{17DA4F07-D25D-4AA8-9481-A0ACB31923CC}"/>
+                <a16:creationId xmlns:a16="http://schemas.microsoft.com/office/drawing/2014/main" id="{30708D96-FDE4-4ACE-B1C1-7CB896C5BB93}"/>
               </a:ext>
             </a:extLst>
           </p:cNvPr>
@@ -5322,7 +5322,7 @@
           <p:cNvPr id="4" name="Date Placeholder 3">
             <a:extLst xmlns:a="http://schemas.openxmlformats.org/drawingml/2006/main">
               <a:ext uri="{FF2B5EF4-FFF2-40B4-BE49-F238E27FC236}">
-                <a16:creationId xmlns:a16="http://schemas.microsoft.com/office/drawing/2014/main" id="{BF69093B-2894-49BD-BC77-111048F7EE2F}"/>
+                <a16:creationId xmlns:a16="http://schemas.microsoft.com/office/drawing/2014/main" id="{55C08E49-67E6-471D-BF64-2B0C9FBE4D83}"/>
               </a:ext>
             </a:extLst>
           </p:cNvPr>
@@ -5368,7 +5368,7 @@
           <p:cNvPr id="5" name="Footer Placeholder 4">
             <a:extLst xmlns:a="http://schemas.openxmlformats.org/drawingml/2006/main">
               <a:ext uri="{FF2B5EF4-FFF2-40B4-BE49-F238E27FC236}">
-                <a16:creationId xmlns:a16="http://schemas.microsoft.com/office/drawing/2014/main" id="{A564FA4C-9B8E-4F8E-AC58-9B83F9203499}"/>
+                <a16:creationId xmlns:a16="http://schemas.microsoft.com/office/drawing/2014/main" id="{3D3FD9DC-B4BC-4F05-8ABE-62ABB23B0EB5}"/>
               </a:ext>
             </a:extLst>
           </p:cNvPr>
@@ -5410,7 +5410,7 @@
           <p:cNvPr id="6" name="Slide Number Placeholder 5">
             <a:extLst xmlns:a="http://schemas.openxmlformats.org/drawingml/2006/main">
               <a:ext uri="{FF2B5EF4-FFF2-40B4-BE49-F238E27FC236}">
-                <a16:creationId xmlns:a16="http://schemas.microsoft.com/office/drawing/2014/main" id="{32EEB6E8-CD94-45F6-8CCA-096954F90977}"/>
+                <a16:creationId xmlns:a16="http://schemas.microsoft.com/office/drawing/2014/main" id="{52D2F26B-CEB1-4A59-8D9D-0848C7AB5A7F}"/>
               </a:ext>
             </a:extLst>
           </p:cNvPr>
@@ -5455,17 +5455,17 @@
   </p:cSld>
   <p:clrMap bg1="lt1" tx1="dk1" bg2="lt2" tx2="dk2" accent1="accent1" accent2="accent2" accent3="accent3" accent4="accent4" accent5="accent5" accent6="accent6" hlink="hlink" folHlink="folHlink"/>
   <p:sldLayoutIdLst>
-    <p:sldLayoutId xmlns:r="http://schemas.openxmlformats.org/officeDocument/2006/relationships" id="2147483649" r:id="R81a9e77a20944906"/>
-    <p:sldLayoutId xmlns:r="http://schemas.openxmlformats.org/officeDocument/2006/relationships" id="2147483650" r:id="Rba0146680ebf4aff"/>
-    <p:sldLayoutId xmlns:r="http://schemas.openxmlformats.org/officeDocument/2006/relationships" id="2147483651" r:id="R0e6cc09eca7b4837"/>
-    <p:sldLayoutId xmlns:r="http://schemas.openxmlformats.org/officeDocument/2006/relationships" id="2147483652" r:id="R31f34ca51b0148c5"/>
-    <p:sldLayoutId xmlns:r="http://schemas.openxmlformats.org/officeDocument/2006/relationships" id="2147483653" r:id="R15240216081946f0"/>
-    <p:sldLayoutId xmlns:r="http://schemas.openxmlformats.org/officeDocument/2006/relationships" id="2147483654" r:id="R965693c872f648d3"/>
-    <p:sldLayoutId xmlns:r="http://schemas.openxmlformats.org/officeDocument/2006/relationships" id="2147483655" r:id="R633aa97895434760"/>
-    <p:sldLayoutId xmlns:r="http://schemas.openxmlformats.org/officeDocument/2006/relationships" id="2147483656" r:id="Re010475ec9d641f8"/>
-    <p:sldLayoutId xmlns:r="http://schemas.openxmlformats.org/officeDocument/2006/relationships" id="2147483657" r:id="R81c6e35e28074cb0"/>
-    <p:sldLayoutId xmlns:r="http://schemas.openxmlformats.org/officeDocument/2006/relationships" id="2147483658" r:id="Rf26d059145e3479b"/>
-    <p:sldLayoutId xmlns:r="http://schemas.openxmlformats.org/officeDocument/2006/relationships" id="2147483659" r:id="Rbcb97eb59bcd4e5a"/>
+    <p:sldLayoutId xmlns:r="http://schemas.openxmlformats.org/officeDocument/2006/relationships" id="2147483649" r:id="R9c2041b055bf4bf9"/>
+    <p:sldLayoutId xmlns:r="http://schemas.openxmlformats.org/officeDocument/2006/relationships" id="2147483650" r:id="R7762f4e8ba84402d"/>
+    <p:sldLayoutId xmlns:r="http://schemas.openxmlformats.org/officeDocument/2006/relationships" id="2147483651" r:id="R2d55390f407b4ec5"/>
+    <p:sldLayoutId xmlns:r="http://schemas.openxmlformats.org/officeDocument/2006/relationships" id="2147483652" r:id="Ref003b474c40494d"/>
+    <p:sldLayoutId xmlns:r="http://schemas.openxmlformats.org/officeDocument/2006/relationships" id="2147483653" r:id="R02d0080b4e3a44da"/>
+    <p:sldLayoutId xmlns:r="http://schemas.openxmlformats.org/officeDocument/2006/relationships" id="2147483654" r:id="R7682c04accc74ed3"/>
+    <p:sldLayoutId xmlns:r="http://schemas.openxmlformats.org/officeDocument/2006/relationships" id="2147483655" r:id="R45fa51f2dbc247ad"/>
+    <p:sldLayoutId xmlns:r="http://schemas.openxmlformats.org/officeDocument/2006/relationships" id="2147483656" r:id="R11240eba189e476c"/>
+    <p:sldLayoutId xmlns:r="http://schemas.openxmlformats.org/officeDocument/2006/relationships" id="2147483657" r:id="R5eb33d82e1d64afa"/>
+    <p:sldLayoutId xmlns:r="http://schemas.openxmlformats.org/officeDocument/2006/relationships" id="2147483658" r:id="R2d195a1861e24e12"/>
+    <p:sldLayoutId xmlns:r="http://schemas.openxmlformats.org/officeDocument/2006/relationships" id="2147483659" r:id="R2f5a25d831e04374"/>
   </p:sldLayoutIdLst>
   <p:txStyles>
     <p:titleStyle>
@@ -6018,7 +6018,7 @@
           <p:cNvPr id="2" name="Rectangle 1">
             <a:extLst xmlns:a="http://schemas.openxmlformats.org/drawingml/2006/main">
               <a:ext uri="{FF2B5EF4-FFF2-40B4-BE49-F238E27FC236}">
-                <a16:creationId xmlns:a16="http://schemas.microsoft.com/office/drawing/2014/main" id="{DD954622-B252-4BB6-9886-4862C11F4918}"/>
+                <a16:creationId xmlns:a16="http://schemas.microsoft.com/office/drawing/2014/main" id="{9E2B5B22-D2D3-4E82-87B7-5695F50283DF}"/>
               </a:ext>
             </a:extLst>
           </p:cNvPr>
@@ -6073,7 +6073,7 @@
           <p:cNvPr id="3" name="TextBox 2">
             <a:extLst xmlns:a="http://schemas.openxmlformats.org/drawingml/2006/main">
               <a:ext uri="{FF2B5EF4-FFF2-40B4-BE49-F238E27FC236}">
-                <a16:creationId xmlns:a16="http://schemas.microsoft.com/office/drawing/2014/main" id="{5D4FDF2D-12BC-41D4-A640-52547C9C4E06}"/>
+                <a16:creationId xmlns:a16="http://schemas.microsoft.com/office/drawing/2014/main" id="{FD4F55F9-F735-46AC-AC6C-8DEA1559C741}"/>
               </a:ext>
             </a:extLst>
           </p:cNvPr>
@@ -6120,7 +6120,7 @@
           <p:cNvPr id="4" name="TextBox 3">
             <a:extLst xmlns:a="http://schemas.openxmlformats.org/drawingml/2006/main">
               <a:ext uri="{FF2B5EF4-FFF2-40B4-BE49-F238E27FC236}">
-                <a16:creationId xmlns:a16="http://schemas.microsoft.com/office/drawing/2014/main" id="{792C2E5B-4A03-44EA-BA40-33FF8B9D56D3}"/>
+                <a16:creationId xmlns:a16="http://schemas.microsoft.com/office/drawing/2014/main" id="{B5C20824-512E-4E3F-9099-2C91F5E4D418}"/>
               </a:ext>
             </a:extLst>
           </p:cNvPr>
@@ -6188,7 +6188,7 @@
           <p:cNvPr id="5" name="TextBox 4">
             <a:extLst xmlns:a="http://schemas.openxmlformats.org/drawingml/2006/main">
               <a:ext uri="{FF2B5EF4-FFF2-40B4-BE49-F238E27FC236}">
-                <a16:creationId xmlns:a16="http://schemas.microsoft.com/office/drawing/2014/main" id="{C75286D3-3980-42E7-8CE4-5A705207FF8B}"/>
+                <a16:creationId xmlns:a16="http://schemas.microsoft.com/office/drawing/2014/main" id="{DA0AF32A-72B8-44C6-803C-2F01A879B27F}"/>
               </a:ext>
             </a:extLst>
           </p:cNvPr>
@@ -6235,7 +6235,7 @@
           <p:cNvPr id="6" name="Rectangle 5">
             <a:extLst xmlns:a="http://schemas.openxmlformats.org/drawingml/2006/main">
               <a:ext uri="{FF2B5EF4-FFF2-40B4-BE49-F238E27FC236}">
-                <a16:creationId xmlns:a16="http://schemas.microsoft.com/office/drawing/2014/main" id="{7C2874BB-028E-4BFF-B725-72D1F43974A0}"/>
+                <a16:creationId xmlns:a16="http://schemas.microsoft.com/office/drawing/2014/main" id="{A50C0CE6-E0A9-4BD4-BF35-064EAC559991}"/>
               </a:ext>
             </a:extLst>
           </p:cNvPr>
@@ -6290,7 +6290,7 @@
           <p:cNvPr id="7" name="TextBox 6">
             <a:extLst xmlns:a="http://schemas.openxmlformats.org/drawingml/2006/main">
               <a:ext uri="{FF2B5EF4-FFF2-40B4-BE49-F238E27FC236}">
-                <a16:creationId xmlns:a16="http://schemas.microsoft.com/office/drawing/2014/main" id="{12D623E3-273C-4C66-9547-83DD023D1E67}"/>
+                <a16:creationId xmlns:a16="http://schemas.microsoft.com/office/drawing/2014/main" id="{9A23C6E0-F272-46FA-A221-C8F907B6BC8D}"/>
               </a:ext>
             </a:extLst>
           </p:cNvPr>
@@ -6337,7 +6337,7 @@
           <p:cNvPr id="8" name="TextBox 7">
             <a:extLst xmlns:a="http://schemas.openxmlformats.org/drawingml/2006/main">
               <a:ext uri="{FF2B5EF4-FFF2-40B4-BE49-F238E27FC236}">
-                <a16:creationId xmlns:a16="http://schemas.microsoft.com/office/drawing/2014/main" id="{B830A4CD-4C82-4CF3-A914-F4C4AFD8AFCB}"/>
+                <a16:creationId xmlns:a16="http://schemas.microsoft.com/office/drawing/2014/main" id="{0B246F5F-495B-489F-9040-71A1FA5414AB}"/>
               </a:ext>
             </a:extLst>
           </p:cNvPr>
@@ -6374,7 +6374,7 @@
                 <a:ea typeface="Aptos"/>
                 <a:cs typeface="Aptos"/>
               </a:rPr>
-              <a:t>2026.07.22-9</a:t>
+              <a:t>2026.07.23-10</a:t>
             </a:r>
           </a:p>
         </p:txBody>
@@ -6384,7 +6384,7 @@
           <p:cNvPr id="9" name="TextBox 8">
             <a:extLst xmlns:a="http://schemas.openxmlformats.org/drawingml/2006/main">
               <a:ext uri="{FF2B5EF4-FFF2-40B4-BE49-F238E27FC236}">
-                <a16:creationId xmlns:a16="http://schemas.microsoft.com/office/drawing/2014/main" id="{583B0AD9-62B5-4E9A-B59C-B3DF1665A79B}"/>
+                <a16:creationId xmlns:a16="http://schemas.microsoft.com/office/drawing/2014/main" id="{2163055A-5966-438D-AD7A-F63AFEB5095A}"/>
               </a:ext>
             </a:extLst>
           </p:cNvPr>
@@ -6452,7 +6452,7 @@
           <p:cNvPr id="10" name="TextBox 9">
             <a:extLst xmlns:a="http://schemas.openxmlformats.org/drawingml/2006/main">
               <a:ext uri="{FF2B5EF4-FFF2-40B4-BE49-F238E27FC236}">
-                <a16:creationId xmlns:a16="http://schemas.microsoft.com/office/drawing/2014/main" id="{6DDC634D-1984-4241-B506-3B4DD7DA4F4E}"/>
+                <a16:creationId xmlns:a16="http://schemas.microsoft.com/office/drawing/2014/main" id="{900FCFE4-5286-4C8A-86C6-8FB7345B3D0D}"/>
               </a:ext>
             </a:extLst>
           </p:cNvPr>
@@ -6499,7 +6499,7 @@
           <p:cNvPr id="11" name="TextBox 10">
             <a:extLst xmlns:a="http://schemas.openxmlformats.org/drawingml/2006/main">
               <a:ext uri="{FF2B5EF4-FFF2-40B4-BE49-F238E27FC236}">
-                <a16:creationId xmlns:a16="http://schemas.microsoft.com/office/drawing/2014/main" id="{4BD4CBCF-ACD6-47E6-AD4C-F62FFAE120A5}"/>
+                <a16:creationId xmlns:a16="http://schemas.microsoft.com/office/drawing/2014/main" id="{E4C64B53-B84C-45F3-9D6E-1400D98379AE}"/>
               </a:ext>
             </a:extLst>
           </p:cNvPr>
@@ -6546,7 +6546,7 @@
           <p:cNvPr id="12" name="TextBox 11">
             <a:extLst xmlns:a="http://schemas.openxmlformats.org/drawingml/2006/main">
               <a:ext uri="{FF2B5EF4-FFF2-40B4-BE49-F238E27FC236}">
-                <a16:creationId xmlns:a16="http://schemas.microsoft.com/office/drawing/2014/main" id="{D6DA264B-2DC6-4EF5-BFD6-DF2BF6D90D34}"/>
+                <a16:creationId xmlns:a16="http://schemas.microsoft.com/office/drawing/2014/main" id="{D617E42B-B813-4CB0-8A67-8DE55FF000B9}"/>
               </a:ext>
             </a:extLst>
           </p:cNvPr>
@@ -6591,7 +6591,7 @@
     </p:spTree>
     <p:extLst>
       <p:ext uri="{BB962C8B-B14F-4D97-AF65-F5344CB8AC3E}">
-        <p14:creationId xmlns:p14="http://schemas.microsoft.com/office/powerpoint/2010/main" val="740424126"/>
+        <p14:creationId xmlns:p14="http://schemas.microsoft.com/office/powerpoint/2010/main" val="321935706"/>
       </p:ext>
     </p:extLst>
   </p:cSld>
@@ -6615,7 +6615,7 @@
           <p:cNvPr id="2" name="TextBox 1">
             <a:extLst xmlns:a="http://schemas.openxmlformats.org/drawingml/2006/main">
               <a:ext uri="{FF2B5EF4-FFF2-40B4-BE49-F238E27FC236}">
-                <a16:creationId xmlns:a16="http://schemas.microsoft.com/office/drawing/2014/main" id="{D268E322-EDD7-4B18-9AEA-77ABB93B604C}"/>
+                <a16:creationId xmlns:a16="http://schemas.microsoft.com/office/drawing/2014/main" id="{016CB0BF-1804-4583-A352-E14493D099B8}"/>
               </a:ext>
             </a:extLst>
           </p:cNvPr>
@@ -6662,7 +6662,7 @@
           <p:cNvPr id="3" name="TextBox 2">
             <a:extLst xmlns:a="http://schemas.openxmlformats.org/drawingml/2006/main">
               <a:ext uri="{FF2B5EF4-FFF2-40B4-BE49-F238E27FC236}">
-                <a16:creationId xmlns:a16="http://schemas.microsoft.com/office/drawing/2014/main" id="{3265EDCF-C001-4662-9C33-EF329B166CEF}"/>
+                <a16:creationId xmlns:a16="http://schemas.microsoft.com/office/drawing/2014/main" id="{3D149D78-E08E-48BB-8146-D628B0943E97}"/>
               </a:ext>
             </a:extLst>
           </p:cNvPr>
@@ -6709,7 +6709,7 @@
           <p:cNvPr id="4" name="Rectangle 3">
             <a:extLst xmlns:a="http://schemas.openxmlformats.org/drawingml/2006/main">
               <a:ext uri="{FF2B5EF4-FFF2-40B4-BE49-F238E27FC236}">
-                <a16:creationId xmlns:a16="http://schemas.microsoft.com/office/drawing/2014/main" id="{039BC21F-7DD1-4F28-A336-CC1F0BBB7F16}"/>
+                <a16:creationId xmlns:a16="http://schemas.microsoft.com/office/drawing/2014/main" id="{446BD7A7-F55B-4227-84AE-0F498A589876}"/>
               </a:ext>
             </a:extLst>
           </p:cNvPr>
@@ -6764,7 +6764,7 @@
           <p:cNvPr id="5" name="Rectangle 4">
             <a:extLst xmlns:a="http://schemas.openxmlformats.org/drawingml/2006/main">
               <a:ext uri="{FF2B5EF4-FFF2-40B4-BE49-F238E27FC236}">
-                <a16:creationId xmlns:a16="http://schemas.microsoft.com/office/drawing/2014/main" id="{24A40B15-2E87-43CD-BD70-026406062D3E}"/>
+                <a16:creationId xmlns:a16="http://schemas.microsoft.com/office/drawing/2014/main" id="{6F224D52-DA09-4E6D-9AA8-65EEF62B565A}"/>
               </a:ext>
             </a:extLst>
           </p:cNvPr>
@@ -6819,7 +6819,7 @@
           <p:cNvPr id="6" name="TextBox 5">
             <a:extLst xmlns:a="http://schemas.openxmlformats.org/drawingml/2006/main">
               <a:ext uri="{FF2B5EF4-FFF2-40B4-BE49-F238E27FC236}">
-                <a16:creationId xmlns:a16="http://schemas.microsoft.com/office/drawing/2014/main" id="{0A1141D7-3E13-43F4-B6DB-EC2E58B84785}"/>
+                <a16:creationId xmlns:a16="http://schemas.microsoft.com/office/drawing/2014/main" id="{714ED097-94A9-4A17-A03F-E642611606E5}"/>
               </a:ext>
             </a:extLst>
           </p:cNvPr>
@@ -6856,7 +6856,7 @@
                 <a:ea typeface="Aptos"/>
                 <a:cs typeface="Aptos"/>
               </a:rPr>
-              <a:t>Independent public evidence summary · 2026.07.22-9 · 2026-07-22 · Sources: RPX; CNIPA guidance; EPO family</a:t>
+              <a:t>Independent public evidence summary · 2026.07.23-10 · 2026-07-22 · Sources: RPX; CNIPA guidance; EPO family</a:t>
             </a:r>
           </a:p>
         </p:txBody>
@@ -6866,7 +6866,7 @@
           <p:cNvPr id="7" name="TextBox 6">
             <a:extLst xmlns:a="http://schemas.openxmlformats.org/drawingml/2006/main">
               <a:ext uri="{FF2B5EF4-FFF2-40B4-BE49-F238E27FC236}">
-                <a16:creationId xmlns:a16="http://schemas.microsoft.com/office/drawing/2014/main" id="{6326962D-FBED-4D6F-A996-5973E274A00E}"/>
+                <a16:creationId xmlns:a16="http://schemas.microsoft.com/office/drawing/2014/main" id="{A4EF41D1-F973-4FDF-BF0F-E87516BBCC7D}"/>
               </a:ext>
             </a:extLst>
           </p:cNvPr>
@@ -6913,7 +6913,7 @@
           <p:cNvPr id="8" name="TextBox 7">
             <a:extLst xmlns:a="http://schemas.openxmlformats.org/drawingml/2006/main">
               <a:ext uri="{FF2B5EF4-FFF2-40B4-BE49-F238E27FC236}">
-                <a16:creationId xmlns:a16="http://schemas.microsoft.com/office/drawing/2014/main" id="{ACD0CBEA-0DDC-41D1-9A14-14CB66082468}"/>
+                <a16:creationId xmlns:a16="http://schemas.microsoft.com/office/drawing/2014/main" id="{E118C154-0A7A-4E73-B795-89A8A079EEE2}"/>
               </a:ext>
             </a:extLst>
           </p:cNvPr>
@@ -6960,7 +6960,7 @@
           <p:cNvPr id="9" name="TextBox 8">
             <a:extLst xmlns:a="http://schemas.openxmlformats.org/drawingml/2006/main">
               <a:ext uri="{FF2B5EF4-FFF2-40B4-BE49-F238E27FC236}">
-                <a16:creationId xmlns:a16="http://schemas.microsoft.com/office/drawing/2014/main" id="{6C0F58FB-2CA0-49EE-AA2E-691F7847C05F}"/>
+                <a16:creationId xmlns:a16="http://schemas.microsoft.com/office/drawing/2014/main" id="{15799F9A-72F7-46A8-B0F6-4773C423605A}"/>
               </a:ext>
             </a:extLst>
           </p:cNvPr>
@@ -7057,7 +7057,7 @@
           <p:cNvPr id="10" name="Rounded Rectangle 9">
             <a:extLst xmlns:a="http://schemas.openxmlformats.org/drawingml/2006/main">
               <a:ext uri="{FF2B5EF4-FFF2-40B4-BE49-F238E27FC236}">
-                <a16:creationId xmlns:a16="http://schemas.microsoft.com/office/drawing/2014/main" id="{E8AEEFEC-61EF-4F64-BC01-3A754B9AC943}"/>
+                <a16:creationId xmlns:a16="http://schemas.microsoft.com/office/drawing/2014/main" id="{F69ABE7E-D7E0-4FF6-AEB4-450AAE63316A}"/>
               </a:ext>
             </a:extLst>
           </p:cNvPr>
@@ -7114,7 +7114,7 @@
           <p:cNvPr id="11" name="TextBox 10">
             <a:extLst xmlns:a="http://schemas.openxmlformats.org/drawingml/2006/main">
               <a:ext uri="{FF2B5EF4-FFF2-40B4-BE49-F238E27FC236}">
-                <a16:creationId xmlns:a16="http://schemas.microsoft.com/office/drawing/2014/main" id="{9E551C28-2294-49AD-842D-184107772AB5}"/>
+                <a16:creationId xmlns:a16="http://schemas.microsoft.com/office/drawing/2014/main" id="{963DF681-B4C9-407D-B3FB-56C19A97D68A}"/>
               </a:ext>
             </a:extLst>
           </p:cNvPr>
@@ -7161,7 +7161,7 @@
           <p:cNvPr id="12" name="TextBox 11">
             <a:extLst xmlns:a="http://schemas.openxmlformats.org/drawingml/2006/main">
               <a:ext uri="{FF2B5EF4-FFF2-40B4-BE49-F238E27FC236}">
-                <a16:creationId xmlns:a16="http://schemas.microsoft.com/office/drawing/2014/main" id="{262C9C30-379F-4B90-B6B6-1892A4AA693E}"/>
+                <a16:creationId xmlns:a16="http://schemas.microsoft.com/office/drawing/2014/main" id="{D556769B-98C6-4568-AFA0-B10F2440902A}"/>
               </a:ext>
             </a:extLst>
           </p:cNvPr>
@@ -7206,7 +7206,7 @@
     </p:spTree>
     <p:extLst>
       <p:ext uri="{BB962C8B-B14F-4D97-AF65-F5344CB8AC3E}">
-        <p14:creationId xmlns:p14="http://schemas.microsoft.com/office/powerpoint/2010/main" val="2007796088"/>
+        <p14:creationId xmlns:p14="http://schemas.microsoft.com/office/powerpoint/2010/main" val="2146159874"/>
       </p:ext>
     </p:extLst>
   </p:cSld>
@@ -7230,7 +7230,7 @@
           <p:cNvPr id="2" name="TextBox 1">
             <a:extLst xmlns:a="http://schemas.openxmlformats.org/drawingml/2006/main">
               <a:ext uri="{FF2B5EF4-FFF2-40B4-BE49-F238E27FC236}">
-                <a16:creationId xmlns:a16="http://schemas.microsoft.com/office/drawing/2014/main" id="{B6AF9ACC-9A10-488D-8332-C6C0D934CC62}"/>
+                <a16:creationId xmlns:a16="http://schemas.microsoft.com/office/drawing/2014/main" id="{C0BAFD7D-1DF4-4F6D-BCFA-6E5507F4B58E}"/>
               </a:ext>
             </a:extLst>
           </p:cNvPr>
@@ -7277,7 +7277,7 @@
           <p:cNvPr id="3" name="TextBox 2">
             <a:extLst xmlns:a="http://schemas.openxmlformats.org/drawingml/2006/main">
               <a:ext uri="{FF2B5EF4-FFF2-40B4-BE49-F238E27FC236}">
-                <a16:creationId xmlns:a16="http://schemas.microsoft.com/office/drawing/2014/main" id="{90BFEDF8-C461-47BE-BC5D-CF4F1AE631A2}"/>
+                <a16:creationId xmlns:a16="http://schemas.microsoft.com/office/drawing/2014/main" id="{86CADCE5-E55E-4AC4-AE22-16512253DE75}"/>
               </a:ext>
             </a:extLst>
           </p:cNvPr>
@@ -7324,7 +7324,7 @@
           <p:cNvPr id="4" name="Rectangle 3">
             <a:extLst xmlns:a="http://schemas.openxmlformats.org/drawingml/2006/main">
               <a:ext uri="{FF2B5EF4-FFF2-40B4-BE49-F238E27FC236}">
-                <a16:creationId xmlns:a16="http://schemas.microsoft.com/office/drawing/2014/main" id="{A7A5D4EB-80E0-4991-AAFB-6242914E08DE}"/>
+                <a16:creationId xmlns:a16="http://schemas.microsoft.com/office/drawing/2014/main" id="{4EC112B1-D206-488F-A6E0-9F5DE091D30C}"/>
               </a:ext>
             </a:extLst>
           </p:cNvPr>
@@ -7379,7 +7379,7 @@
           <p:cNvPr id="5" name="Rectangle 4">
             <a:extLst xmlns:a="http://schemas.openxmlformats.org/drawingml/2006/main">
               <a:ext uri="{FF2B5EF4-FFF2-40B4-BE49-F238E27FC236}">
-                <a16:creationId xmlns:a16="http://schemas.microsoft.com/office/drawing/2014/main" id="{8FE3D0F6-1CD9-417F-AE6C-EADEA96F28C5}"/>
+                <a16:creationId xmlns:a16="http://schemas.microsoft.com/office/drawing/2014/main" id="{78F2E461-8B92-46CC-9ACC-E74FEA5862B5}"/>
               </a:ext>
             </a:extLst>
           </p:cNvPr>
@@ -7434,7 +7434,7 @@
           <p:cNvPr id="6" name="TextBox 5">
             <a:extLst xmlns:a="http://schemas.openxmlformats.org/drawingml/2006/main">
               <a:ext uri="{FF2B5EF4-FFF2-40B4-BE49-F238E27FC236}">
-                <a16:creationId xmlns:a16="http://schemas.microsoft.com/office/drawing/2014/main" id="{B04B292D-9C96-4D89-A6F9-183D4A72DD72}"/>
+                <a16:creationId xmlns:a16="http://schemas.microsoft.com/office/drawing/2014/main" id="{4DE3B5DB-8A1B-4BC2-8EAE-41D11C7F1284}"/>
               </a:ext>
             </a:extLst>
           </p:cNvPr>
@@ -7471,7 +7471,7 @@
                 <a:ea typeface="Aptos"/>
                 <a:cs typeface="Aptos"/>
               </a:rPr>
-              <a:t>Independent public evidence summary · 2026.07.22-9 · 2026-07-22 · Sources: IP Australia; PRH; EPO; EPO / UPC; USPTO</a:t>
+              <a:t>Independent public evidence summary · 2026.07.23-10 · 2026-07-22 · Sources: IP Australia; PRH; EPO; EPO / UPC; USPTO</a:t>
             </a:r>
           </a:p>
         </p:txBody>
@@ -7481,7 +7481,7 @@
           <p:cNvPr id="7" name="TextBox 6">
             <a:extLst xmlns:a="http://schemas.openxmlformats.org/drawingml/2006/main">
               <a:ext uri="{FF2B5EF4-FFF2-40B4-BE49-F238E27FC236}">
-                <a16:creationId xmlns:a16="http://schemas.microsoft.com/office/drawing/2014/main" id="{B0F0E5FA-069C-4BDF-AAB8-8C6817FA5FEB}"/>
+                <a16:creationId xmlns:a16="http://schemas.microsoft.com/office/drawing/2014/main" id="{0F2CB7C4-B5F6-47B3-91C5-51BC92B8352A}"/>
               </a:ext>
             </a:extLst>
           </p:cNvPr>
@@ -7968,7 +7968,7 @@
           <p:cNvPr id="9" name="TextBox 8">
             <a:extLst xmlns:a="http://schemas.openxmlformats.org/drawingml/2006/main">
               <a:ext uri="{FF2B5EF4-FFF2-40B4-BE49-F238E27FC236}">
-                <a16:creationId xmlns:a16="http://schemas.microsoft.com/office/drawing/2014/main" id="{01F8A7B3-4815-4C6E-AE6A-D26A0228EDFF}"/>
+                <a16:creationId xmlns:a16="http://schemas.microsoft.com/office/drawing/2014/main" id="{2B734C01-0BCE-460B-A160-62949DC64C53}"/>
               </a:ext>
             </a:extLst>
           </p:cNvPr>
@@ -8013,7 +8013,7 @@
     </p:spTree>
     <p:extLst>
       <p:ext uri="{BB962C8B-B14F-4D97-AF65-F5344CB8AC3E}">
-        <p14:creationId xmlns:p14="http://schemas.microsoft.com/office/powerpoint/2010/main" val="1771571262"/>
+        <p14:creationId xmlns:p14="http://schemas.microsoft.com/office/powerpoint/2010/main" val="1554783275"/>
       </p:ext>
     </p:extLst>
   </p:cSld>
@@ -8037,7 +8037,7 @@
           <p:cNvPr id="2" name="TextBox 1">
             <a:extLst xmlns:a="http://schemas.openxmlformats.org/drawingml/2006/main">
               <a:ext uri="{FF2B5EF4-FFF2-40B4-BE49-F238E27FC236}">
-                <a16:creationId xmlns:a16="http://schemas.microsoft.com/office/drawing/2014/main" id="{1B848FBE-732B-4C9F-A0E1-5EE818656414}"/>
+                <a16:creationId xmlns:a16="http://schemas.microsoft.com/office/drawing/2014/main" id="{01F5128A-9F1B-4FD9-8F59-E8B752DE52B2}"/>
               </a:ext>
             </a:extLst>
           </p:cNvPr>
@@ -8084,7 +8084,7 @@
           <p:cNvPr id="3" name="TextBox 2">
             <a:extLst xmlns:a="http://schemas.openxmlformats.org/drawingml/2006/main">
               <a:ext uri="{FF2B5EF4-FFF2-40B4-BE49-F238E27FC236}">
-                <a16:creationId xmlns:a16="http://schemas.microsoft.com/office/drawing/2014/main" id="{4F94AF81-1AB6-4EB5-9235-C85BBFF7D007}"/>
+                <a16:creationId xmlns:a16="http://schemas.microsoft.com/office/drawing/2014/main" id="{4600043F-FCB6-4CC6-A5BA-DEA3EC000F96}"/>
               </a:ext>
             </a:extLst>
           </p:cNvPr>
@@ -8131,7 +8131,7 @@
           <p:cNvPr id="4" name="Rectangle 3">
             <a:extLst xmlns:a="http://schemas.openxmlformats.org/drawingml/2006/main">
               <a:ext uri="{FF2B5EF4-FFF2-40B4-BE49-F238E27FC236}">
-                <a16:creationId xmlns:a16="http://schemas.microsoft.com/office/drawing/2014/main" id="{FC4BD03F-6AB8-4339-8822-A32241C9E9D5}"/>
+                <a16:creationId xmlns:a16="http://schemas.microsoft.com/office/drawing/2014/main" id="{465CD8EE-1F32-47AF-AB28-6BB1E72487A7}"/>
               </a:ext>
             </a:extLst>
           </p:cNvPr>
@@ -8186,7 +8186,7 @@
           <p:cNvPr id="5" name="Rectangle 4">
             <a:extLst xmlns:a="http://schemas.openxmlformats.org/drawingml/2006/main">
               <a:ext uri="{FF2B5EF4-FFF2-40B4-BE49-F238E27FC236}">
-                <a16:creationId xmlns:a16="http://schemas.microsoft.com/office/drawing/2014/main" id="{D46CDFFC-86CC-4130-838E-65EDAD4393CE}"/>
+                <a16:creationId xmlns:a16="http://schemas.microsoft.com/office/drawing/2014/main" id="{CCD56968-0781-4DD2-95F6-AB80988D6AB5}"/>
               </a:ext>
             </a:extLst>
           </p:cNvPr>
@@ -8241,7 +8241,7 @@
           <p:cNvPr id="6" name="TextBox 5">
             <a:extLst xmlns:a="http://schemas.openxmlformats.org/drawingml/2006/main">
               <a:ext uri="{FF2B5EF4-FFF2-40B4-BE49-F238E27FC236}">
-                <a16:creationId xmlns:a16="http://schemas.microsoft.com/office/drawing/2014/main" id="{F61BB9C8-86C2-412F-94C5-D9276D1B8531}"/>
+                <a16:creationId xmlns:a16="http://schemas.microsoft.com/office/drawing/2014/main" id="{CD87C2AA-C221-48FC-8FDE-7D464D36C0EC}"/>
               </a:ext>
             </a:extLst>
           </p:cNvPr>
@@ -8278,7 +8278,7 @@
                 <a:ea typeface="Aptos"/>
                 <a:cs typeface="Aptos"/>
               </a:rPr>
-              <a:t>Independent public evidence summary · 2026.07.22-9 · 2026-07-22 · Sources: UN; Atlas</a:t>
+              <a:t>Independent public evidence summary · 2026.07.23-10 · 2026-07-22 · Sources: UN; Atlas</a:t>
             </a:r>
           </a:p>
         </p:txBody>
@@ -8288,7 +8288,7 @@
           <p:cNvPr id="7" name="TextBox 6">
             <a:extLst xmlns:a="http://schemas.openxmlformats.org/drawingml/2006/main">
               <a:ext uri="{FF2B5EF4-FFF2-40B4-BE49-F238E27FC236}">
-                <a16:creationId xmlns:a16="http://schemas.microsoft.com/office/drawing/2014/main" id="{35F21FE3-C3CD-42FC-A3E0-AF12F30741B8}"/>
+                <a16:creationId xmlns:a16="http://schemas.microsoft.com/office/drawing/2014/main" id="{00507115-1232-47A8-A180-90E4C78D674F}"/>
               </a:ext>
             </a:extLst>
           </p:cNvPr>
@@ -8335,7 +8335,7 @@
           <p:cNvPr id="8" name="Rounded Rectangle 7">
             <a:extLst xmlns:a="http://schemas.openxmlformats.org/drawingml/2006/main">
               <a:ext uri="{FF2B5EF4-FFF2-40B4-BE49-F238E27FC236}">
-                <a16:creationId xmlns:a16="http://schemas.microsoft.com/office/drawing/2014/main" id="{7C8E7FD7-6C4A-4AF2-B2D9-C013C5669F2B}"/>
+                <a16:creationId xmlns:a16="http://schemas.microsoft.com/office/drawing/2014/main" id="{1C7BF45D-F3D5-4DF8-A8EC-014574D2DEC0}"/>
               </a:ext>
             </a:extLst>
           </p:cNvPr>
@@ -8392,7 +8392,7 @@
           <p:cNvPr id="9" name="TextBox 8">
             <a:extLst xmlns:a="http://schemas.openxmlformats.org/drawingml/2006/main">
               <a:ext uri="{FF2B5EF4-FFF2-40B4-BE49-F238E27FC236}">
-                <a16:creationId xmlns:a16="http://schemas.microsoft.com/office/drawing/2014/main" id="{C8579EB4-EA27-47F3-8747-DA0792F1CE81}"/>
+                <a16:creationId xmlns:a16="http://schemas.microsoft.com/office/drawing/2014/main" id="{6393BA34-1E00-405B-93C3-CFFBB9E37F66}"/>
               </a:ext>
             </a:extLst>
           </p:cNvPr>
@@ -8439,7 +8439,7 @@
           <p:cNvPr id="10" name="TextBox 9">
             <a:extLst xmlns:a="http://schemas.openxmlformats.org/drawingml/2006/main">
               <a:ext uri="{FF2B5EF4-FFF2-40B4-BE49-F238E27FC236}">
-                <a16:creationId xmlns:a16="http://schemas.microsoft.com/office/drawing/2014/main" id="{17BE9D3B-B4A6-44D2-80A7-7491C695FBC0}"/>
+                <a16:creationId xmlns:a16="http://schemas.microsoft.com/office/drawing/2014/main" id="{58E4F7F1-68B9-4F2C-B3F9-3A46191335F4}"/>
               </a:ext>
             </a:extLst>
           </p:cNvPr>
@@ -8486,7 +8486,7 @@
           <p:cNvPr id="11" name="Rounded Rectangle 10">
             <a:extLst xmlns:a="http://schemas.openxmlformats.org/drawingml/2006/main">
               <a:ext uri="{FF2B5EF4-FFF2-40B4-BE49-F238E27FC236}">
-                <a16:creationId xmlns:a16="http://schemas.microsoft.com/office/drawing/2014/main" id="{74D1EC7B-2587-4CDB-9C69-5CAA92EFC1DF}"/>
+                <a16:creationId xmlns:a16="http://schemas.microsoft.com/office/drawing/2014/main" id="{3FD45B9A-5D8A-4BA4-A8B1-385F4DE842AE}"/>
               </a:ext>
             </a:extLst>
           </p:cNvPr>
@@ -8543,7 +8543,7 @@
           <p:cNvPr id="12" name="TextBox 11">
             <a:extLst xmlns:a="http://schemas.openxmlformats.org/drawingml/2006/main">
               <a:ext uri="{FF2B5EF4-FFF2-40B4-BE49-F238E27FC236}">
-                <a16:creationId xmlns:a16="http://schemas.microsoft.com/office/drawing/2014/main" id="{BC275A3F-A3F7-4E7A-94F5-C60FF570D8A9}"/>
+                <a16:creationId xmlns:a16="http://schemas.microsoft.com/office/drawing/2014/main" id="{C5E00E6C-424F-46B8-A2F3-AC2D9C3737F2}"/>
               </a:ext>
             </a:extLst>
           </p:cNvPr>
@@ -8590,7 +8590,7 @@
           <p:cNvPr id="13" name="TextBox 12">
             <a:extLst xmlns:a="http://schemas.openxmlformats.org/drawingml/2006/main">
               <a:ext uri="{FF2B5EF4-FFF2-40B4-BE49-F238E27FC236}">
-                <a16:creationId xmlns:a16="http://schemas.microsoft.com/office/drawing/2014/main" id="{BFCBABE1-97BE-4097-9FA5-24CF92AE5813}"/>
+                <a16:creationId xmlns:a16="http://schemas.microsoft.com/office/drawing/2014/main" id="{A034897B-2891-4886-812A-CB1F234242FA}"/>
               </a:ext>
             </a:extLst>
           </p:cNvPr>
@@ -8637,7 +8637,7 @@
           <p:cNvPr id="14" name="Rounded Rectangle 13">
             <a:extLst xmlns:a="http://schemas.openxmlformats.org/drawingml/2006/main">
               <a:ext uri="{FF2B5EF4-FFF2-40B4-BE49-F238E27FC236}">
-                <a16:creationId xmlns:a16="http://schemas.microsoft.com/office/drawing/2014/main" id="{F77C224F-1C07-4799-965D-0915124B1052}"/>
+                <a16:creationId xmlns:a16="http://schemas.microsoft.com/office/drawing/2014/main" id="{41CDDCFE-121C-4CC5-B6D6-13B20620FA0B}"/>
               </a:ext>
             </a:extLst>
           </p:cNvPr>
@@ -8694,7 +8694,7 @@
           <p:cNvPr id="15" name="TextBox 14">
             <a:extLst xmlns:a="http://schemas.openxmlformats.org/drawingml/2006/main">
               <a:ext uri="{FF2B5EF4-FFF2-40B4-BE49-F238E27FC236}">
-                <a16:creationId xmlns:a16="http://schemas.microsoft.com/office/drawing/2014/main" id="{D4486C71-C47C-476D-9F89-23CB44770ABC}"/>
+                <a16:creationId xmlns:a16="http://schemas.microsoft.com/office/drawing/2014/main" id="{EEDEE866-2DA3-4B55-B6D4-536D73593A92}"/>
               </a:ext>
             </a:extLst>
           </p:cNvPr>
@@ -8741,7 +8741,7 @@
           <p:cNvPr id="16" name="TextBox 15">
             <a:extLst xmlns:a="http://schemas.openxmlformats.org/drawingml/2006/main">
               <a:ext uri="{FF2B5EF4-FFF2-40B4-BE49-F238E27FC236}">
-                <a16:creationId xmlns:a16="http://schemas.microsoft.com/office/drawing/2014/main" id="{527BD842-379E-418D-9C6A-EB4AE5CD5B94}"/>
+                <a16:creationId xmlns:a16="http://schemas.microsoft.com/office/drawing/2014/main" id="{DC5674DE-00DD-440C-9071-36074FA182BA}"/>
               </a:ext>
             </a:extLst>
           </p:cNvPr>
@@ -8788,7 +8788,7 @@
           <p:cNvPr id="17" name="Rounded Rectangle 16">
             <a:extLst xmlns:a="http://schemas.openxmlformats.org/drawingml/2006/main">
               <a:ext uri="{FF2B5EF4-FFF2-40B4-BE49-F238E27FC236}">
-                <a16:creationId xmlns:a16="http://schemas.microsoft.com/office/drawing/2014/main" id="{662168AA-21E6-4F50-B55A-FEED54F92F41}"/>
+                <a16:creationId xmlns:a16="http://schemas.microsoft.com/office/drawing/2014/main" id="{930395C4-6CF3-4207-843B-1AACA53F0AD1}"/>
               </a:ext>
             </a:extLst>
           </p:cNvPr>
@@ -8845,7 +8845,7 @@
           <p:cNvPr id="18" name="TextBox 17">
             <a:extLst xmlns:a="http://schemas.openxmlformats.org/drawingml/2006/main">
               <a:ext uri="{FF2B5EF4-FFF2-40B4-BE49-F238E27FC236}">
-                <a16:creationId xmlns:a16="http://schemas.microsoft.com/office/drawing/2014/main" id="{8BF0CFF4-92D9-4DEA-9649-8C2323FF9D78}"/>
+                <a16:creationId xmlns:a16="http://schemas.microsoft.com/office/drawing/2014/main" id="{943A8013-8CAE-4E29-BE5D-BF4968626082}"/>
               </a:ext>
             </a:extLst>
           </p:cNvPr>
@@ -8892,7 +8892,7 @@
           <p:cNvPr id="19" name="TextBox 18">
             <a:extLst xmlns:a="http://schemas.openxmlformats.org/drawingml/2006/main">
               <a:ext uri="{FF2B5EF4-FFF2-40B4-BE49-F238E27FC236}">
-                <a16:creationId xmlns:a16="http://schemas.microsoft.com/office/drawing/2014/main" id="{59D499BE-DACA-408E-AF32-2945FEAE138D}"/>
+                <a16:creationId xmlns:a16="http://schemas.microsoft.com/office/drawing/2014/main" id="{9C5C1E66-9998-4536-A68D-39F1C3900013}"/>
               </a:ext>
             </a:extLst>
           </p:cNvPr>
@@ -8939,7 +8939,7 @@
           <p:cNvPr id="20" name="TextBox 19">
             <a:extLst xmlns:a="http://schemas.openxmlformats.org/drawingml/2006/main">
               <a:ext uri="{FF2B5EF4-FFF2-40B4-BE49-F238E27FC236}">
-                <a16:creationId xmlns:a16="http://schemas.microsoft.com/office/drawing/2014/main" id="{C4653E20-4299-43C9-9AC3-8EAC0E9DD444}"/>
+                <a16:creationId xmlns:a16="http://schemas.microsoft.com/office/drawing/2014/main" id="{F1602CFB-8D4A-4541-9763-EAFA7BF87A0B}"/>
               </a:ext>
             </a:extLst>
           </p:cNvPr>
@@ -8986,7 +8986,7 @@
           <p:cNvPr id="21" name="Rounded Rectangle 20">
             <a:extLst xmlns:a="http://schemas.openxmlformats.org/drawingml/2006/main">
               <a:ext uri="{FF2B5EF4-FFF2-40B4-BE49-F238E27FC236}">
-                <a16:creationId xmlns:a16="http://schemas.microsoft.com/office/drawing/2014/main" id="{3DCE39FF-28F1-49E3-81C0-D6079E4C23D3}"/>
+                <a16:creationId xmlns:a16="http://schemas.microsoft.com/office/drawing/2014/main" id="{3559C327-1CC5-467E-8A54-595398B2FF24}"/>
               </a:ext>
             </a:extLst>
           </p:cNvPr>
@@ -9043,7 +9043,7 @@
           <p:cNvPr id="22" name="TextBox 21">
             <a:extLst xmlns:a="http://schemas.openxmlformats.org/drawingml/2006/main">
               <a:ext uri="{FF2B5EF4-FFF2-40B4-BE49-F238E27FC236}">
-                <a16:creationId xmlns:a16="http://schemas.microsoft.com/office/drawing/2014/main" id="{CB803758-96F7-405F-B8A1-9EC442B8AE34}"/>
+                <a16:creationId xmlns:a16="http://schemas.microsoft.com/office/drawing/2014/main" id="{650FA5CC-38D3-4652-8A91-27CD5669672B}"/>
               </a:ext>
             </a:extLst>
           </p:cNvPr>
@@ -9090,7 +9090,7 @@
           <p:cNvPr id="23" name="TextBox 22">
             <a:extLst xmlns:a="http://schemas.openxmlformats.org/drawingml/2006/main">
               <a:ext uri="{FF2B5EF4-FFF2-40B4-BE49-F238E27FC236}">
-                <a16:creationId xmlns:a16="http://schemas.microsoft.com/office/drawing/2014/main" id="{13824250-3ED0-4407-BBA9-7BA67AC54706}"/>
+                <a16:creationId xmlns:a16="http://schemas.microsoft.com/office/drawing/2014/main" id="{120A75D5-8DBC-4B00-8737-466ED44EF430}"/>
               </a:ext>
             </a:extLst>
           </p:cNvPr>
@@ -9135,7 +9135,7 @@
     </p:spTree>
     <p:extLst>
       <p:ext uri="{BB962C8B-B14F-4D97-AF65-F5344CB8AC3E}">
-        <p14:creationId xmlns:p14="http://schemas.microsoft.com/office/powerpoint/2010/main" val="1053656129"/>
+        <p14:creationId xmlns:p14="http://schemas.microsoft.com/office/powerpoint/2010/main" val="1205908936"/>
       </p:ext>
     </p:extLst>
   </p:cSld>
@@ -9159,7 +9159,7 @@
           <p:cNvPr id="2" name="TextBox 1">
             <a:extLst xmlns:a="http://schemas.openxmlformats.org/drawingml/2006/main">
               <a:ext uri="{FF2B5EF4-FFF2-40B4-BE49-F238E27FC236}">
-                <a16:creationId xmlns:a16="http://schemas.microsoft.com/office/drawing/2014/main" id="{75AAC6CF-403D-4C9D-A753-445C2170F6C5}"/>
+                <a16:creationId xmlns:a16="http://schemas.microsoft.com/office/drawing/2014/main" id="{3446BB4B-87DC-4D69-8866-7C5CD7CA036D}"/>
               </a:ext>
             </a:extLst>
           </p:cNvPr>
@@ -9206,7 +9206,7 @@
           <p:cNvPr id="3" name="TextBox 2">
             <a:extLst xmlns:a="http://schemas.openxmlformats.org/drawingml/2006/main">
               <a:ext uri="{FF2B5EF4-FFF2-40B4-BE49-F238E27FC236}">
-                <a16:creationId xmlns:a16="http://schemas.microsoft.com/office/drawing/2014/main" id="{079AF131-9B87-4F01-9CB8-5DB3649A5335}"/>
+                <a16:creationId xmlns:a16="http://schemas.microsoft.com/office/drawing/2014/main" id="{AF221798-0F9E-4742-BE56-2012A3EA8ADC}"/>
               </a:ext>
             </a:extLst>
           </p:cNvPr>
@@ -9253,7 +9253,7 @@
           <p:cNvPr id="4" name="Rectangle 3">
             <a:extLst xmlns:a="http://schemas.openxmlformats.org/drawingml/2006/main">
               <a:ext uri="{FF2B5EF4-FFF2-40B4-BE49-F238E27FC236}">
-                <a16:creationId xmlns:a16="http://schemas.microsoft.com/office/drawing/2014/main" id="{982F86DB-9B24-4FF4-B81D-3BA6229E51E8}"/>
+                <a16:creationId xmlns:a16="http://schemas.microsoft.com/office/drawing/2014/main" id="{36F6812B-039B-4E70-9931-A4E51A49366F}"/>
               </a:ext>
             </a:extLst>
           </p:cNvPr>
@@ -9308,7 +9308,7 @@
           <p:cNvPr id="5" name="Rectangle 4">
             <a:extLst xmlns:a="http://schemas.openxmlformats.org/drawingml/2006/main">
               <a:ext uri="{FF2B5EF4-FFF2-40B4-BE49-F238E27FC236}">
-                <a16:creationId xmlns:a16="http://schemas.microsoft.com/office/drawing/2014/main" id="{20DAE225-6A75-4ECE-8B9C-9FDEE2D69F3C}"/>
+                <a16:creationId xmlns:a16="http://schemas.microsoft.com/office/drawing/2014/main" id="{6CCFFA52-28CC-4A52-864E-8C538B95C1FF}"/>
               </a:ext>
             </a:extLst>
           </p:cNvPr>
@@ -9363,7 +9363,7 @@
           <p:cNvPr id="6" name="TextBox 5">
             <a:extLst xmlns:a="http://schemas.openxmlformats.org/drawingml/2006/main">
               <a:ext uri="{FF2B5EF4-FFF2-40B4-BE49-F238E27FC236}">
-                <a16:creationId xmlns:a16="http://schemas.microsoft.com/office/drawing/2014/main" id="{7D3D3FEC-C9E1-486A-AA99-3A91D513726C}"/>
+                <a16:creationId xmlns:a16="http://schemas.microsoft.com/office/drawing/2014/main" id="{895AC9D5-81EC-40E1-922E-6DA29BABEF3A}"/>
               </a:ext>
             </a:extLst>
           </p:cNvPr>
@@ -9400,7 +9400,7 @@
                 <a:ea typeface="Aptos"/>
                 <a:cs typeface="Aptos"/>
               </a:rPr>
-              <a:t>Independent public evidence summary · 2026.07.22-9 · 2026-07-22 · Sources: Health Canada; Destatis; Vero; Sejm; Swedish Government</a:t>
+              <a:t>Independent public evidence summary · 2026.07.23-10 · 2026-07-22 · Sources: Health Canada; Destatis; Vero; Sejm; Swedish Government</a:t>
             </a:r>
           </a:p>
         </p:txBody>
@@ -9410,7 +9410,7 @@
           <p:cNvPr id="7" name="TextBox 6">
             <a:extLst xmlns:a="http://schemas.openxmlformats.org/drawingml/2006/main">
               <a:ext uri="{FF2B5EF4-FFF2-40B4-BE49-F238E27FC236}">
-                <a16:creationId xmlns:a16="http://schemas.microsoft.com/office/drawing/2014/main" id="{FF9D7F3D-D30C-4435-A1B4-E2A91708EB88}"/>
+                <a16:creationId xmlns:a16="http://schemas.microsoft.com/office/drawing/2014/main" id="{5A584F06-12B9-4F93-AB34-37758934DBC1}"/>
               </a:ext>
             </a:extLst>
           </p:cNvPr>
@@ -9980,7 +9980,7 @@
           <p:cNvPr id="9" name="TextBox 8">
             <a:extLst xmlns:a="http://schemas.openxmlformats.org/drawingml/2006/main">
               <a:ext uri="{FF2B5EF4-FFF2-40B4-BE49-F238E27FC236}">
-                <a16:creationId xmlns:a16="http://schemas.microsoft.com/office/drawing/2014/main" id="{82143438-2D76-40AA-9B4F-ACB8737B1C16}"/>
+                <a16:creationId xmlns:a16="http://schemas.microsoft.com/office/drawing/2014/main" id="{B798AAB0-958A-4597-A4FA-F87AE8B97482}"/>
               </a:ext>
             </a:extLst>
           </p:cNvPr>
@@ -10025,7 +10025,7 @@
     </p:spTree>
     <p:extLst>
       <p:ext uri="{BB962C8B-B14F-4D97-AF65-F5344CB8AC3E}">
-        <p14:creationId xmlns:p14="http://schemas.microsoft.com/office/powerpoint/2010/main" val="908447170"/>
+        <p14:creationId xmlns:p14="http://schemas.microsoft.com/office/powerpoint/2010/main" val="1906912212"/>
       </p:ext>
     </p:extLst>
   </p:cSld>
@@ -10049,7 +10049,7 @@
           <p:cNvPr id="2" name="TextBox 1">
             <a:extLst xmlns:a="http://schemas.openxmlformats.org/drawingml/2006/main">
               <a:ext uri="{FF2B5EF4-FFF2-40B4-BE49-F238E27FC236}">
-                <a16:creationId xmlns:a16="http://schemas.microsoft.com/office/drawing/2014/main" id="{C75E4BFB-5ADD-4646-BDA0-0072CD4CACD3}"/>
+                <a16:creationId xmlns:a16="http://schemas.microsoft.com/office/drawing/2014/main" id="{CBA9A255-F567-4C86-8F86-EE77A4ECF8B3}"/>
               </a:ext>
             </a:extLst>
           </p:cNvPr>
@@ -10096,7 +10096,7 @@
           <p:cNvPr id="3" name="TextBox 2">
             <a:extLst xmlns:a="http://schemas.openxmlformats.org/drawingml/2006/main">
               <a:ext uri="{FF2B5EF4-FFF2-40B4-BE49-F238E27FC236}">
-                <a16:creationId xmlns:a16="http://schemas.microsoft.com/office/drawing/2014/main" id="{059BB44C-CE6A-469F-9979-FDA2C47DF7C4}"/>
+                <a16:creationId xmlns:a16="http://schemas.microsoft.com/office/drawing/2014/main" id="{46CFEED9-AB91-4779-ABEC-4B44E6BF63B6}"/>
               </a:ext>
             </a:extLst>
           </p:cNvPr>
@@ -10143,7 +10143,7 @@
           <p:cNvPr id="4" name="Rectangle 3">
             <a:extLst xmlns:a="http://schemas.openxmlformats.org/drawingml/2006/main">
               <a:ext uri="{FF2B5EF4-FFF2-40B4-BE49-F238E27FC236}">
-                <a16:creationId xmlns:a16="http://schemas.microsoft.com/office/drawing/2014/main" id="{D13330CB-AA6B-41B2-8300-468989448B93}"/>
+                <a16:creationId xmlns:a16="http://schemas.microsoft.com/office/drawing/2014/main" id="{675D6ED0-D671-4D21-B75E-FB87D003F7F9}"/>
               </a:ext>
             </a:extLst>
           </p:cNvPr>
@@ -10198,7 +10198,7 @@
           <p:cNvPr id="5" name="Rectangle 4">
             <a:extLst xmlns:a="http://schemas.openxmlformats.org/drawingml/2006/main">
               <a:ext uri="{FF2B5EF4-FFF2-40B4-BE49-F238E27FC236}">
-                <a16:creationId xmlns:a16="http://schemas.microsoft.com/office/drawing/2014/main" id="{50EFEF3F-6194-48E7-841A-E9EC75F74893}"/>
+                <a16:creationId xmlns:a16="http://schemas.microsoft.com/office/drawing/2014/main" id="{E32EC7C8-B234-47A8-B4A0-A632AA44DE05}"/>
               </a:ext>
             </a:extLst>
           </p:cNvPr>
@@ -10253,7 +10253,7 @@
           <p:cNvPr id="6" name="TextBox 5">
             <a:extLst xmlns:a="http://schemas.openxmlformats.org/drawingml/2006/main">
               <a:ext uri="{FF2B5EF4-FFF2-40B4-BE49-F238E27FC236}">
-                <a16:creationId xmlns:a16="http://schemas.microsoft.com/office/drawing/2014/main" id="{B4A9EE12-0994-4AAF-A622-39C6403B4B87}"/>
+                <a16:creationId xmlns:a16="http://schemas.microsoft.com/office/drawing/2014/main" id="{C551D6E2-1A4A-42F8-A0E6-78D1920C0740}"/>
               </a:ext>
             </a:extLst>
           </p:cNvPr>
@@ -10290,7 +10290,7 @@
                 <a:ea typeface="Aptos"/>
                 <a:cs typeface="Aptos"/>
               </a:rPr>
-              <a:t>Independent public evidence summary · 2026.07.22-9 · 2026-07-22 · Sources: Health Canada 2024</a:t>
+              <a:t>Independent public evidence summary · 2026.07.23-10 · 2026-07-22 · Sources: Health Canada 2024</a:t>
             </a:r>
           </a:p>
         </p:txBody>
@@ -10300,7 +10300,7 @@
           <p:cNvPr id="7" name="TextBox 6">
             <a:extLst xmlns:a="http://schemas.openxmlformats.org/drawingml/2006/main">
               <a:ext uri="{FF2B5EF4-FFF2-40B4-BE49-F238E27FC236}">
-                <a16:creationId xmlns:a16="http://schemas.microsoft.com/office/drawing/2014/main" id="{EAE534A5-4A89-4498-8BBB-C85FA4DA731E}"/>
+                <a16:creationId xmlns:a16="http://schemas.microsoft.com/office/drawing/2014/main" id="{33EC497C-04F6-436E-8251-A691CE59500C}"/>
               </a:ext>
             </a:extLst>
           </p:cNvPr>
@@ -10347,7 +10347,7 @@
           <p:cNvPr id="8" name="Rounded Rectangle 7">
             <a:extLst xmlns:a="http://schemas.openxmlformats.org/drawingml/2006/main">
               <a:ext uri="{FF2B5EF4-FFF2-40B4-BE49-F238E27FC236}">
-                <a16:creationId xmlns:a16="http://schemas.microsoft.com/office/drawing/2014/main" id="{112A39CE-FC67-43B8-BF28-1CCDFF378542}"/>
+                <a16:creationId xmlns:a16="http://schemas.microsoft.com/office/drawing/2014/main" id="{5E7EF6F6-0AD5-41D4-99D3-AB82E6DC0412}"/>
               </a:ext>
             </a:extLst>
           </p:cNvPr>
@@ -10404,7 +10404,7 @@
           <p:cNvPr id="9" name="TextBox 8">
             <a:extLst xmlns:a="http://schemas.openxmlformats.org/drawingml/2006/main">
               <a:ext uri="{FF2B5EF4-FFF2-40B4-BE49-F238E27FC236}">
-                <a16:creationId xmlns:a16="http://schemas.microsoft.com/office/drawing/2014/main" id="{2A68605A-3654-4D8C-ACC3-68E68591E851}"/>
+                <a16:creationId xmlns:a16="http://schemas.microsoft.com/office/drawing/2014/main" id="{2882B370-C28A-49C6-819C-ADFECABBC90A}"/>
               </a:ext>
             </a:extLst>
           </p:cNvPr>
@@ -10451,7 +10451,7 @@
           <p:cNvPr id="10" name="TextBox 9">
             <a:extLst xmlns:a="http://schemas.openxmlformats.org/drawingml/2006/main">
               <a:ext uri="{FF2B5EF4-FFF2-40B4-BE49-F238E27FC236}">
-                <a16:creationId xmlns:a16="http://schemas.microsoft.com/office/drawing/2014/main" id="{F97F40E1-9603-4390-8E2A-94FDFC16E39C}"/>
+                <a16:creationId xmlns:a16="http://schemas.microsoft.com/office/drawing/2014/main" id="{908F1E6B-4C81-4847-99DF-A31BD8EA5ED4}"/>
               </a:ext>
             </a:extLst>
           </p:cNvPr>
@@ -10498,7 +10498,7 @@
           <p:cNvPr id="11" name="Rounded Rectangle 10">
             <a:extLst xmlns:a="http://schemas.openxmlformats.org/drawingml/2006/main">
               <a:ext uri="{FF2B5EF4-FFF2-40B4-BE49-F238E27FC236}">
-                <a16:creationId xmlns:a16="http://schemas.microsoft.com/office/drawing/2014/main" id="{22DD5251-6816-4609-97D2-C6A3E8C98DF9}"/>
+                <a16:creationId xmlns:a16="http://schemas.microsoft.com/office/drawing/2014/main" id="{5EF39D58-FB87-4CDD-9708-A98AF57E17D7}"/>
               </a:ext>
             </a:extLst>
           </p:cNvPr>
@@ -10555,7 +10555,7 @@
           <p:cNvPr id="12" name="TextBox 11">
             <a:extLst xmlns:a="http://schemas.openxmlformats.org/drawingml/2006/main">
               <a:ext uri="{FF2B5EF4-FFF2-40B4-BE49-F238E27FC236}">
-                <a16:creationId xmlns:a16="http://schemas.microsoft.com/office/drawing/2014/main" id="{056FF869-041A-41FC-8D56-F63A9C3474AA}"/>
+                <a16:creationId xmlns:a16="http://schemas.microsoft.com/office/drawing/2014/main" id="{1B17487D-2D5B-41A4-8AC7-C8E6843FA255}"/>
               </a:ext>
             </a:extLst>
           </p:cNvPr>
@@ -10602,7 +10602,7 @@
           <p:cNvPr id="13" name="TextBox 12">
             <a:extLst xmlns:a="http://schemas.openxmlformats.org/drawingml/2006/main">
               <a:ext uri="{FF2B5EF4-FFF2-40B4-BE49-F238E27FC236}">
-                <a16:creationId xmlns:a16="http://schemas.microsoft.com/office/drawing/2014/main" id="{4BF31271-41D3-4D5E-AF58-F02A0F5D425F}"/>
+                <a16:creationId xmlns:a16="http://schemas.microsoft.com/office/drawing/2014/main" id="{826F62F3-75D5-4448-B92B-11D6E54EC3DC}"/>
               </a:ext>
             </a:extLst>
           </p:cNvPr>
@@ -10649,7 +10649,7 @@
           <p:cNvPr id="14" name="Rounded Rectangle 13">
             <a:extLst xmlns:a="http://schemas.openxmlformats.org/drawingml/2006/main">
               <a:ext uri="{FF2B5EF4-FFF2-40B4-BE49-F238E27FC236}">
-                <a16:creationId xmlns:a16="http://schemas.microsoft.com/office/drawing/2014/main" id="{56921BA5-C4D8-40A4-9695-35B28057D27C}"/>
+                <a16:creationId xmlns:a16="http://schemas.microsoft.com/office/drawing/2014/main" id="{150B46A4-C5F4-4D00-B217-6C97C1974476}"/>
               </a:ext>
             </a:extLst>
           </p:cNvPr>
@@ -10706,7 +10706,7 @@
           <p:cNvPr id="15" name="TextBox 14">
             <a:extLst xmlns:a="http://schemas.openxmlformats.org/drawingml/2006/main">
               <a:ext uri="{FF2B5EF4-FFF2-40B4-BE49-F238E27FC236}">
-                <a16:creationId xmlns:a16="http://schemas.microsoft.com/office/drawing/2014/main" id="{340DBA46-11F1-42E2-B8CA-A5FFECFEEA5A}"/>
+                <a16:creationId xmlns:a16="http://schemas.microsoft.com/office/drawing/2014/main" id="{CB3FD990-1303-4C4E-9A9B-4CD033EE5030}"/>
               </a:ext>
             </a:extLst>
           </p:cNvPr>
@@ -10753,7 +10753,7 @@
           <p:cNvPr id="16" name="TextBox 15">
             <a:extLst xmlns:a="http://schemas.openxmlformats.org/drawingml/2006/main">
               <a:ext uri="{FF2B5EF4-FFF2-40B4-BE49-F238E27FC236}">
-                <a16:creationId xmlns:a16="http://schemas.microsoft.com/office/drawing/2014/main" id="{773DEFD7-79BD-4275-A420-CAB80D0C37DB}"/>
+                <a16:creationId xmlns:a16="http://schemas.microsoft.com/office/drawing/2014/main" id="{FA72A65B-626E-43C9-B1CC-C79589CDFA6C}"/>
               </a:ext>
             </a:extLst>
           </p:cNvPr>
@@ -10800,7 +10800,7 @@
           <p:cNvPr id="17" name="TextBox 16">
             <a:extLst xmlns:a="http://schemas.openxmlformats.org/drawingml/2006/main">
               <a:ext uri="{FF2B5EF4-FFF2-40B4-BE49-F238E27FC236}">
-                <a16:creationId xmlns:a16="http://schemas.microsoft.com/office/drawing/2014/main" id="{95519D40-B48E-48FE-B8CB-3D34AFD4D829}"/>
+                <a16:creationId xmlns:a16="http://schemas.microsoft.com/office/drawing/2014/main" id="{3184535B-CB25-49F7-BA0A-5A104BDE5BC7}"/>
               </a:ext>
             </a:extLst>
           </p:cNvPr>
@@ -10847,7 +10847,7 @@
           <p:cNvPr id="18" name="Rounded Rectangle 17">
             <a:extLst xmlns:a="http://schemas.openxmlformats.org/drawingml/2006/main">
               <a:ext uri="{FF2B5EF4-FFF2-40B4-BE49-F238E27FC236}">
-                <a16:creationId xmlns:a16="http://schemas.microsoft.com/office/drawing/2014/main" id="{853198C0-409A-4AD0-BA0B-F56507DFD919}"/>
+                <a16:creationId xmlns:a16="http://schemas.microsoft.com/office/drawing/2014/main" id="{3B3677E6-7D7E-4293-A40C-205D94005CA1}"/>
               </a:ext>
             </a:extLst>
           </p:cNvPr>
@@ -10904,7 +10904,7 @@
           <p:cNvPr id="19" name="TextBox 18">
             <a:extLst xmlns:a="http://schemas.openxmlformats.org/drawingml/2006/main">
               <a:ext uri="{FF2B5EF4-FFF2-40B4-BE49-F238E27FC236}">
-                <a16:creationId xmlns:a16="http://schemas.microsoft.com/office/drawing/2014/main" id="{D30D8E8A-3384-4F8F-8088-9352D11E2CC9}"/>
+                <a16:creationId xmlns:a16="http://schemas.microsoft.com/office/drawing/2014/main" id="{0EF10DF8-F91C-4CED-9C18-6193E54F907D}"/>
               </a:ext>
             </a:extLst>
           </p:cNvPr>
@@ -10951,7 +10951,7 @@
           <p:cNvPr id="20" name="TextBox 19">
             <a:extLst xmlns:a="http://schemas.openxmlformats.org/drawingml/2006/main">
               <a:ext uri="{FF2B5EF4-FFF2-40B4-BE49-F238E27FC236}">
-                <a16:creationId xmlns:a16="http://schemas.microsoft.com/office/drawing/2014/main" id="{6F05FA5E-16B9-4085-875D-03453B6D93A5}"/>
+                <a16:creationId xmlns:a16="http://schemas.microsoft.com/office/drawing/2014/main" id="{1CAF6494-62CC-4671-A91B-E16AC3C7B373}"/>
               </a:ext>
             </a:extLst>
           </p:cNvPr>
@@ -10996,7 +10996,7 @@
     </p:spTree>
     <p:extLst>
       <p:ext uri="{BB962C8B-B14F-4D97-AF65-F5344CB8AC3E}">
-        <p14:creationId xmlns:p14="http://schemas.microsoft.com/office/powerpoint/2010/main" val="1896385266"/>
+        <p14:creationId xmlns:p14="http://schemas.microsoft.com/office/powerpoint/2010/main" val="1983239040"/>
       </p:ext>
     </p:extLst>
   </p:cSld>
@@ -11020,7 +11020,7 @@
           <p:cNvPr id="2" name="TextBox 1">
             <a:extLst xmlns:a="http://schemas.openxmlformats.org/drawingml/2006/main">
               <a:ext uri="{FF2B5EF4-FFF2-40B4-BE49-F238E27FC236}">
-                <a16:creationId xmlns:a16="http://schemas.microsoft.com/office/drawing/2014/main" id="{A700B5B6-5290-46D0-B2D7-C864FF31B02D}"/>
+                <a16:creationId xmlns:a16="http://schemas.microsoft.com/office/drawing/2014/main" id="{33C749A4-E1A4-4123-A4FF-6EC7C0509571}"/>
               </a:ext>
             </a:extLst>
           </p:cNvPr>
@@ -11067,7 +11067,7 @@
           <p:cNvPr id="3" name="TextBox 2">
             <a:extLst xmlns:a="http://schemas.openxmlformats.org/drawingml/2006/main">
               <a:ext uri="{FF2B5EF4-FFF2-40B4-BE49-F238E27FC236}">
-                <a16:creationId xmlns:a16="http://schemas.microsoft.com/office/drawing/2014/main" id="{0893CBF7-4192-4413-AA9E-090AAB9DAD1D}"/>
+                <a16:creationId xmlns:a16="http://schemas.microsoft.com/office/drawing/2014/main" id="{85C9BEBB-7786-4FEE-8D98-059A3D5E1F47}"/>
               </a:ext>
             </a:extLst>
           </p:cNvPr>
@@ -11114,7 +11114,7 @@
           <p:cNvPr id="4" name="Rectangle 3">
             <a:extLst xmlns:a="http://schemas.openxmlformats.org/drawingml/2006/main">
               <a:ext uri="{FF2B5EF4-FFF2-40B4-BE49-F238E27FC236}">
-                <a16:creationId xmlns:a16="http://schemas.microsoft.com/office/drawing/2014/main" id="{F4C6BCEB-DF66-4359-A276-332CDFB34C04}"/>
+                <a16:creationId xmlns:a16="http://schemas.microsoft.com/office/drawing/2014/main" id="{361E1FF1-D90F-46BA-BD89-610AAF011B2B}"/>
               </a:ext>
             </a:extLst>
           </p:cNvPr>
@@ -11169,7 +11169,7 @@
           <p:cNvPr id="5" name="Rectangle 4">
             <a:extLst xmlns:a="http://schemas.openxmlformats.org/drawingml/2006/main">
               <a:ext uri="{FF2B5EF4-FFF2-40B4-BE49-F238E27FC236}">
-                <a16:creationId xmlns:a16="http://schemas.microsoft.com/office/drawing/2014/main" id="{2F0C490A-4747-4D94-8AC1-8AC6D963335F}"/>
+                <a16:creationId xmlns:a16="http://schemas.microsoft.com/office/drawing/2014/main" id="{9AFD24CA-5AFB-46A0-A9F8-2FF13490391A}"/>
               </a:ext>
             </a:extLst>
           </p:cNvPr>
@@ -11224,7 +11224,7 @@
           <p:cNvPr id="6" name="TextBox 5">
             <a:extLst xmlns:a="http://schemas.openxmlformats.org/drawingml/2006/main">
               <a:ext uri="{FF2B5EF4-FFF2-40B4-BE49-F238E27FC236}">
-                <a16:creationId xmlns:a16="http://schemas.microsoft.com/office/drawing/2014/main" id="{165155F5-57CF-4019-977E-A7D168B5E3B3}"/>
+                <a16:creationId xmlns:a16="http://schemas.microsoft.com/office/drawing/2014/main" id="{D7574163-0C7D-43E4-9569-74C34881B341}"/>
               </a:ext>
             </a:extLst>
           </p:cNvPr>
@@ -11261,7 +11261,7 @@
                 <a:ea typeface="Aptos"/>
                 <a:cs typeface="Aptos"/>
               </a:rPr>
-              <a:t>Independent public evidence summary · 2026.07.22-9 · 2026-07-22 · Sources: Destatis</a:t>
+              <a:t>Independent public evidence summary · 2026.07.23-10 · 2026-07-22 · Sources: Destatis</a:t>
             </a:r>
           </a:p>
         </p:txBody>
@@ -11271,7 +11271,7 @@
           <p:cNvPr id="7" name="TextBox 6">
             <a:extLst xmlns:a="http://schemas.openxmlformats.org/drawingml/2006/main">
               <a:ext uri="{FF2B5EF4-FFF2-40B4-BE49-F238E27FC236}">
-                <a16:creationId xmlns:a16="http://schemas.microsoft.com/office/drawing/2014/main" id="{B396B180-7561-4E20-9557-8148F3098490}"/>
+                <a16:creationId xmlns:a16="http://schemas.microsoft.com/office/drawing/2014/main" id="{E58C4FE3-8895-414E-9036-0013E8E9DD8F}"/>
               </a:ext>
             </a:extLst>
           </p:cNvPr>
@@ -11784,7 +11784,7 @@
           <p:cNvPr id="9" name="TextBox 8">
             <a:extLst xmlns:a="http://schemas.openxmlformats.org/drawingml/2006/main">
               <a:ext uri="{FF2B5EF4-FFF2-40B4-BE49-F238E27FC236}">
-                <a16:creationId xmlns:a16="http://schemas.microsoft.com/office/drawing/2014/main" id="{EFC502E7-0171-47DD-9FB5-81F137FD8199}"/>
+                <a16:creationId xmlns:a16="http://schemas.microsoft.com/office/drawing/2014/main" id="{37036FF8-A56A-4B1D-AC26-3EFE6A224643}"/>
               </a:ext>
             </a:extLst>
           </p:cNvPr>
@@ -11829,7 +11829,7 @@
     </p:spTree>
     <p:extLst>
       <p:ext uri="{BB962C8B-B14F-4D97-AF65-F5344CB8AC3E}">
-        <p14:creationId xmlns:p14="http://schemas.microsoft.com/office/powerpoint/2010/main" val="1205900801"/>
+        <p14:creationId xmlns:p14="http://schemas.microsoft.com/office/powerpoint/2010/main" val="893745509"/>
       </p:ext>
     </p:extLst>
   </p:cSld>
@@ -11853,7 +11853,7 @@
           <p:cNvPr id="2" name="TextBox 1">
             <a:extLst xmlns:a="http://schemas.openxmlformats.org/drawingml/2006/main">
               <a:ext uri="{FF2B5EF4-FFF2-40B4-BE49-F238E27FC236}">
-                <a16:creationId xmlns:a16="http://schemas.microsoft.com/office/drawing/2014/main" id="{E0266EB8-106E-4494-8F5B-A61A58AA2689}"/>
+                <a16:creationId xmlns:a16="http://schemas.microsoft.com/office/drawing/2014/main" id="{B73D9614-05BB-4372-8F1E-13A649F4216A}"/>
               </a:ext>
             </a:extLst>
           </p:cNvPr>
@@ -11900,7 +11900,7 @@
           <p:cNvPr id="3" name="TextBox 2">
             <a:extLst xmlns:a="http://schemas.openxmlformats.org/drawingml/2006/main">
               <a:ext uri="{FF2B5EF4-FFF2-40B4-BE49-F238E27FC236}">
-                <a16:creationId xmlns:a16="http://schemas.microsoft.com/office/drawing/2014/main" id="{B0D7C854-DB79-49CE-8BF0-A882E8C2696B}"/>
+                <a16:creationId xmlns:a16="http://schemas.microsoft.com/office/drawing/2014/main" id="{EB3AF31A-1025-4FF8-B824-2B681D44D3EE}"/>
               </a:ext>
             </a:extLst>
           </p:cNvPr>
@@ -11947,7 +11947,7 @@
           <p:cNvPr id="4" name="Rectangle 3">
             <a:extLst xmlns:a="http://schemas.openxmlformats.org/drawingml/2006/main">
               <a:ext uri="{FF2B5EF4-FFF2-40B4-BE49-F238E27FC236}">
-                <a16:creationId xmlns:a16="http://schemas.microsoft.com/office/drawing/2014/main" id="{50490857-390B-4F5E-B660-D50F1F36F625}"/>
+                <a16:creationId xmlns:a16="http://schemas.microsoft.com/office/drawing/2014/main" id="{E7DB1783-6A69-4409-B1BF-2ED104D20EC1}"/>
               </a:ext>
             </a:extLst>
           </p:cNvPr>
@@ -12002,7 +12002,7 @@
           <p:cNvPr id="5" name="Rectangle 4">
             <a:extLst xmlns:a="http://schemas.openxmlformats.org/drawingml/2006/main">
               <a:ext uri="{FF2B5EF4-FFF2-40B4-BE49-F238E27FC236}">
-                <a16:creationId xmlns:a16="http://schemas.microsoft.com/office/drawing/2014/main" id="{8DF2CC33-8D36-4F05-AEDD-B75E7FC4FFEE}"/>
+                <a16:creationId xmlns:a16="http://schemas.microsoft.com/office/drawing/2014/main" id="{7506F975-860D-40D2-B10C-6612F3AF9B06}"/>
               </a:ext>
             </a:extLst>
           </p:cNvPr>
@@ -12057,7 +12057,7 @@
           <p:cNvPr id="6" name="TextBox 5">
             <a:extLst xmlns:a="http://schemas.openxmlformats.org/drawingml/2006/main">
               <a:ext uri="{FF2B5EF4-FFF2-40B4-BE49-F238E27FC236}">
-                <a16:creationId xmlns:a16="http://schemas.microsoft.com/office/drawing/2014/main" id="{D8578790-4140-4CC3-B0F3-F7D4B6C00EBF}"/>
+                <a16:creationId xmlns:a16="http://schemas.microsoft.com/office/drawing/2014/main" id="{4A13526F-53DE-4F03-8114-A16A60266B60}"/>
               </a:ext>
             </a:extLst>
           </p:cNvPr>
@@ -12094,7 +12094,7 @@
                 <a:ea typeface="Aptos"/>
                 <a:cs typeface="Aptos"/>
               </a:rPr>
-              <a:t>Independent public evidence summary · 2026.07.22-9 · 2026-07-22 · Sources: Destatis; inTaste.de</a:t>
+              <a:t>Independent public evidence summary · 2026.07.23-10 · 2026-07-22 · Sources: Destatis; inTaste.de</a:t>
             </a:r>
           </a:p>
         </p:txBody>
@@ -12104,7 +12104,7 @@
           <p:cNvPr id="7" name="TextBox 6">
             <a:extLst xmlns:a="http://schemas.openxmlformats.org/drawingml/2006/main">
               <a:ext uri="{FF2B5EF4-FFF2-40B4-BE49-F238E27FC236}">
-                <a16:creationId xmlns:a16="http://schemas.microsoft.com/office/drawing/2014/main" id="{177F31AF-48BB-45BD-82CF-6F2FDF77EAB5}"/>
+                <a16:creationId xmlns:a16="http://schemas.microsoft.com/office/drawing/2014/main" id="{694C6EA5-06DD-40EA-AA31-A397C912E94D}"/>
               </a:ext>
             </a:extLst>
           </p:cNvPr>
@@ -12151,7 +12151,7 @@
           <p:cNvPr id="8" name="Rounded Rectangle 7">
             <a:extLst xmlns:a="http://schemas.openxmlformats.org/drawingml/2006/main">
               <a:ext uri="{FF2B5EF4-FFF2-40B4-BE49-F238E27FC236}">
-                <a16:creationId xmlns:a16="http://schemas.microsoft.com/office/drawing/2014/main" id="{CC7C4343-28C7-4FA7-A18F-CB50ED73CC96}"/>
+                <a16:creationId xmlns:a16="http://schemas.microsoft.com/office/drawing/2014/main" id="{86679CB8-CFC3-4E87-A1A0-F0DB9F02326F}"/>
               </a:ext>
             </a:extLst>
           </p:cNvPr>
@@ -12208,7 +12208,7 @@
           <p:cNvPr id="9" name="TextBox 8">
             <a:extLst xmlns:a="http://schemas.openxmlformats.org/drawingml/2006/main">
               <a:ext uri="{FF2B5EF4-FFF2-40B4-BE49-F238E27FC236}">
-                <a16:creationId xmlns:a16="http://schemas.microsoft.com/office/drawing/2014/main" id="{28814392-5355-4240-9E60-E4DED7D08AA0}"/>
+                <a16:creationId xmlns:a16="http://schemas.microsoft.com/office/drawing/2014/main" id="{12D0AB7B-CD18-482E-95B6-F686C21DE0E7}"/>
               </a:ext>
             </a:extLst>
           </p:cNvPr>
@@ -12255,7 +12255,7 @@
           <p:cNvPr id="10" name="TextBox 9">
             <a:extLst xmlns:a="http://schemas.openxmlformats.org/drawingml/2006/main">
               <a:ext uri="{FF2B5EF4-FFF2-40B4-BE49-F238E27FC236}">
-                <a16:creationId xmlns:a16="http://schemas.microsoft.com/office/drawing/2014/main" id="{DDEEA3CB-5689-49E9-82EF-43931A8EF33E}"/>
+                <a16:creationId xmlns:a16="http://schemas.microsoft.com/office/drawing/2014/main" id="{2FF12385-8CAC-4D79-A15F-9B4EBEAC02C6}"/>
               </a:ext>
             </a:extLst>
           </p:cNvPr>
@@ -12302,7 +12302,7 @@
           <p:cNvPr id="11" name="Rounded Rectangle 10">
             <a:extLst xmlns:a="http://schemas.openxmlformats.org/drawingml/2006/main">
               <a:ext uri="{FF2B5EF4-FFF2-40B4-BE49-F238E27FC236}">
-                <a16:creationId xmlns:a16="http://schemas.microsoft.com/office/drawing/2014/main" id="{0647806E-A2E3-4929-B88B-4C7B4851F061}"/>
+                <a16:creationId xmlns:a16="http://schemas.microsoft.com/office/drawing/2014/main" id="{31A37C56-90D2-41DB-A216-3B81227058E6}"/>
               </a:ext>
             </a:extLst>
           </p:cNvPr>
@@ -12359,7 +12359,7 @@
           <p:cNvPr id="12" name="TextBox 11">
             <a:extLst xmlns:a="http://schemas.openxmlformats.org/drawingml/2006/main">
               <a:ext uri="{FF2B5EF4-FFF2-40B4-BE49-F238E27FC236}">
-                <a16:creationId xmlns:a16="http://schemas.microsoft.com/office/drawing/2014/main" id="{58E6A19F-A16B-418C-9349-B202DD3F6066}"/>
+                <a16:creationId xmlns:a16="http://schemas.microsoft.com/office/drawing/2014/main" id="{2EBE9969-8D55-47CB-8635-E3AFA6C63DE9}"/>
               </a:ext>
             </a:extLst>
           </p:cNvPr>
@@ -12406,7 +12406,7 @@
           <p:cNvPr id="13" name="TextBox 12">
             <a:extLst xmlns:a="http://schemas.openxmlformats.org/drawingml/2006/main">
               <a:ext uri="{FF2B5EF4-FFF2-40B4-BE49-F238E27FC236}">
-                <a16:creationId xmlns:a16="http://schemas.microsoft.com/office/drawing/2014/main" id="{46C764FB-B959-4307-948A-7C1484CFFBC1}"/>
+                <a16:creationId xmlns:a16="http://schemas.microsoft.com/office/drawing/2014/main" id="{397C6EFB-3222-4513-AD56-B834959D97ED}"/>
               </a:ext>
             </a:extLst>
           </p:cNvPr>
@@ -12453,7 +12453,7 @@
           <p:cNvPr id="14" name="Rounded Rectangle 13">
             <a:extLst xmlns:a="http://schemas.openxmlformats.org/drawingml/2006/main">
               <a:ext uri="{FF2B5EF4-FFF2-40B4-BE49-F238E27FC236}">
-                <a16:creationId xmlns:a16="http://schemas.microsoft.com/office/drawing/2014/main" id="{3E047904-6F34-41C2-8AA2-9B880E36754C}"/>
+                <a16:creationId xmlns:a16="http://schemas.microsoft.com/office/drawing/2014/main" id="{D02D8AC3-878C-4BA6-AE96-794098F96A83}"/>
               </a:ext>
             </a:extLst>
           </p:cNvPr>
@@ -12510,7 +12510,7 @@
           <p:cNvPr id="15" name="TextBox 14">
             <a:extLst xmlns:a="http://schemas.openxmlformats.org/drawingml/2006/main">
               <a:ext uri="{FF2B5EF4-FFF2-40B4-BE49-F238E27FC236}">
-                <a16:creationId xmlns:a16="http://schemas.microsoft.com/office/drawing/2014/main" id="{850ABC25-24F8-4CB8-8DAD-A19B8531512F}"/>
+                <a16:creationId xmlns:a16="http://schemas.microsoft.com/office/drawing/2014/main" id="{40BA0B04-93C7-4E78-BAD3-098920B7F8D4}"/>
               </a:ext>
             </a:extLst>
           </p:cNvPr>
@@ -12557,7 +12557,7 @@
           <p:cNvPr id="16" name="TextBox 15">
             <a:extLst xmlns:a="http://schemas.openxmlformats.org/drawingml/2006/main">
               <a:ext uri="{FF2B5EF4-FFF2-40B4-BE49-F238E27FC236}">
-                <a16:creationId xmlns:a16="http://schemas.microsoft.com/office/drawing/2014/main" id="{52CD0FC0-7129-487B-BCF8-EEBF7430EB50}"/>
+                <a16:creationId xmlns:a16="http://schemas.microsoft.com/office/drawing/2014/main" id="{32F2D01B-62D5-4E0F-918C-D6EC1EE9F58F}"/>
               </a:ext>
             </a:extLst>
           </p:cNvPr>
@@ -12604,7 +12604,7 @@
           <p:cNvPr id="17" name="TextBox 16">
             <a:extLst xmlns:a="http://schemas.openxmlformats.org/drawingml/2006/main">
               <a:ext uri="{FF2B5EF4-FFF2-40B4-BE49-F238E27FC236}">
-                <a16:creationId xmlns:a16="http://schemas.microsoft.com/office/drawing/2014/main" id="{869F35DA-87C0-4667-9670-FE35E6112A7C}"/>
+                <a16:creationId xmlns:a16="http://schemas.microsoft.com/office/drawing/2014/main" id="{3B401416-7017-4B48-9D97-127BF86D87C1}"/>
               </a:ext>
             </a:extLst>
           </p:cNvPr>
@@ -12651,7 +12651,7 @@
           <p:cNvPr id="18" name="Rounded Rectangle 17">
             <a:extLst xmlns:a="http://schemas.openxmlformats.org/drawingml/2006/main">
               <a:ext uri="{FF2B5EF4-FFF2-40B4-BE49-F238E27FC236}">
-                <a16:creationId xmlns:a16="http://schemas.microsoft.com/office/drawing/2014/main" id="{26111FC8-D795-4B83-8826-6913A533DA9D}"/>
+                <a16:creationId xmlns:a16="http://schemas.microsoft.com/office/drawing/2014/main" id="{96AA97BB-C316-49B9-9D3E-4D3BE0F37440}"/>
               </a:ext>
             </a:extLst>
           </p:cNvPr>
@@ -12708,7 +12708,7 @@
           <p:cNvPr id="19" name="TextBox 18">
             <a:extLst xmlns:a="http://schemas.openxmlformats.org/drawingml/2006/main">
               <a:ext uri="{FF2B5EF4-FFF2-40B4-BE49-F238E27FC236}">
-                <a16:creationId xmlns:a16="http://schemas.microsoft.com/office/drawing/2014/main" id="{B86C0D5A-C8AA-46A4-BAE2-9622739FA2F7}"/>
+                <a16:creationId xmlns:a16="http://schemas.microsoft.com/office/drawing/2014/main" id="{C827DCE2-8D3A-4399-B793-10CC928074FA}"/>
               </a:ext>
             </a:extLst>
           </p:cNvPr>
@@ -12755,7 +12755,7 @@
           <p:cNvPr id="20" name="TextBox 19">
             <a:extLst xmlns:a="http://schemas.openxmlformats.org/drawingml/2006/main">
               <a:ext uri="{FF2B5EF4-FFF2-40B4-BE49-F238E27FC236}">
-                <a16:creationId xmlns:a16="http://schemas.microsoft.com/office/drawing/2014/main" id="{8F2C4628-2A03-4E1B-B695-C45CB95F6E61}"/>
+                <a16:creationId xmlns:a16="http://schemas.microsoft.com/office/drawing/2014/main" id="{910C61FB-76AC-422C-961F-1D6D000EB342}"/>
               </a:ext>
             </a:extLst>
           </p:cNvPr>
@@ -12800,7 +12800,7 @@
     </p:spTree>
     <p:extLst>
       <p:ext uri="{BB962C8B-B14F-4D97-AF65-F5344CB8AC3E}">
-        <p14:creationId xmlns:p14="http://schemas.microsoft.com/office/powerpoint/2010/main" val="1271372671"/>
+        <p14:creationId xmlns:p14="http://schemas.microsoft.com/office/powerpoint/2010/main" val="1430062123"/>
       </p:ext>
     </p:extLst>
   </p:cSld>
@@ -12824,7 +12824,7 @@
           <p:cNvPr id="2" name="TextBox 1">
             <a:extLst xmlns:a="http://schemas.openxmlformats.org/drawingml/2006/main">
               <a:ext uri="{FF2B5EF4-FFF2-40B4-BE49-F238E27FC236}">
-                <a16:creationId xmlns:a16="http://schemas.microsoft.com/office/drawing/2014/main" id="{C229B36F-ADD8-448A-A132-96B9F4601926}"/>
+                <a16:creationId xmlns:a16="http://schemas.microsoft.com/office/drawing/2014/main" id="{FD217578-01DA-4DE8-8C33-2D283584B851}"/>
               </a:ext>
             </a:extLst>
           </p:cNvPr>
@@ -12871,7 +12871,7 @@
           <p:cNvPr id="3" name="TextBox 2">
             <a:extLst xmlns:a="http://schemas.openxmlformats.org/drawingml/2006/main">
               <a:ext uri="{FF2B5EF4-FFF2-40B4-BE49-F238E27FC236}">
-                <a16:creationId xmlns:a16="http://schemas.microsoft.com/office/drawing/2014/main" id="{431A3CDD-6D82-4663-BD7C-DECE72B8E945}"/>
+                <a16:creationId xmlns:a16="http://schemas.microsoft.com/office/drawing/2014/main" id="{50ABDEF3-4CD1-4C6D-B5C9-041006B43356}"/>
               </a:ext>
             </a:extLst>
           </p:cNvPr>
@@ -12918,7 +12918,7 @@
           <p:cNvPr id="4" name="Rectangle 3">
             <a:extLst xmlns:a="http://schemas.openxmlformats.org/drawingml/2006/main">
               <a:ext uri="{FF2B5EF4-FFF2-40B4-BE49-F238E27FC236}">
-                <a16:creationId xmlns:a16="http://schemas.microsoft.com/office/drawing/2014/main" id="{3CF9ED73-4A90-40CD-B104-A47B95F2DABD}"/>
+                <a16:creationId xmlns:a16="http://schemas.microsoft.com/office/drawing/2014/main" id="{794D1202-4482-4E7A-BCDF-AB1FFE49BFF8}"/>
               </a:ext>
             </a:extLst>
           </p:cNvPr>
@@ -12973,7 +12973,7 @@
           <p:cNvPr id="5" name="Rectangle 4">
             <a:extLst xmlns:a="http://schemas.openxmlformats.org/drawingml/2006/main">
               <a:ext uri="{FF2B5EF4-FFF2-40B4-BE49-F238E27FC236}">
-                <a16:creationId xmlns:a16="http://schemas.microsoft.com/office/drawing/2014/main" id="{E3D23BC4-7C61-4C4E-893A-2C61B47E6118}"/>
+                <a16:creationId xmlns:a16="http://schemas.microsoft.com/office/drawing/2014/main" id="{44CD4CC4-424E-4495-B4AA-44F2CC52A199}"/>
               </a:ext>
             </a:extLst>
           </p:cNvPr>
@@ -13028,7 +13028,7 @@
           <p:cNvPr id="6" name="TextBox 5">
             <a:extLst xmlns:a="http://schemas.openxmlformats.org/drawingml/2006/main">
               <a:ext uri="{FF2B5EF4-FFF2-40B4-BE49-F238E27FC236}">
-                <a16:creationId xmlns:a16="http://schemas.microsoft.com/office/drawing/2014/main" id="{C58C4548-3DFD-49CC-8425-5D7627122317}"/>
+                <a16:creationId xmlns:a16="http://schemas.microsoft.com/office/drawing/2014/main" id="{F1C91BB2-610C-4C21-A498-3AE2F4C26B88}"/>
               </a:ext>
             </a:extLst>
           </p:cNvPr>
@@ -13065,7 +13065,7 @@
                 <a:ea typeface="Aptos"/>
                 <a:cs typeface="Aptos"/>
               </a:rPr>
-              <a:t>Independent public evidence summary · 2026.07.22-9 · 2026-07-22 · Sources: IMARC; GVR; Fortune</a:t>
+              <a:t>Independent public evidence summary · 2026.07.23-10 · 2026-07-22 · Sources: IMARC; GVR; Fortune</a:t>
             </a:r>
           </a:p>
         </p:txBody>
@@ -13075,7 +13075,7 @@
           <p:cNvPr id="7" name="TextBox 6">
             <a:extLst xmlns:a="http://schemas.openxmlformats.org/drawingml/2006/main">
               <a:ext uri="{FF2B5EF4-FFF2-40B4-BE49-F238E27FC236}">
-                <a16:creationId xmlns:a16="http://schemas.microsoft.com/office/drawing/2014/main" id="{2281D780-4AE8-4221-90AF-9EB2D3B8C6CF}"/>
+                <a16:creationId xmlns:a16="http://schemas.microsoft.com/office/drawing/2014/main" id="{739C2251-77E1-41F1-96D5-E647CAF920BC}"/>
               </a:ext>
             </a:extLst>
           </p:cNvPr>
@@ -13122,7 +13122,7 @@
           <p:cNvPr id="8" name="Rounded Rectangle 7">
             <a:extLst xmlns:a="http://schemas.openxmlformats.org/drawingml/2006/main">
               <a:ext uri="{FF2B5EF4-FFF2-40B4-BE49-F238E27FC236}">
-                <a16:creationId xmlns:a16="http://schemas.microsoft.com/office/drawing/2014/main" id="{2B25AD0D-711B-4DB8-96F3-21597C0B1EF6}"/>
+                <a16:creationId xmlns:a16="http://schemas.microsoft.com/office/drawing/2014/main" id="{470B9D91-512A-40A7-9D2D-940FFB61BDF8}"/>
               </a:ext>
             </a:extLst>
           </p:cNvPr>
@@ -13179,7 +13179,7 @@
           <p:cNvPr id="9" name="TextBox 8">
             <a:extLst xmlns:a="http://schemas.openxmlformats.org/drawingml/2006/main">
               <a:ext uri="{FF2B5EF4-FFF2-40B4-BE49-F238E27FC236}">
-                <a16:creationId xmlns:a16="http://schemas.microsoft.com/office/drawing/2014/main" id="{6AC812A5-3882-44E0-8BF5-6FD7A5D6E753}"/>
+                <a16:creationId xmlns:a16="http://schemas.microsoft.com/office/drawing/2014/main" id="{E473EE61-65BA-4D6F-9CCC-4063E5E63963}"/>
               </a:ext>
             </a:extLst>
           </p:cNvPr>
@@ -13226,7 +13226,7 @@
           <p:cNvPr id="10" name="TextBox 9">
             <a:extLst xmlns:a="http://schemas.openxmlformats.org/drawingml/2006/main">
               <a:ext uri="{FF2B5EF4-FFF2-40B4-BE49-F238E27FC236}">
-                <a16:creationId xmlns:a16="http://schemas.microsoft.com/office/drawing/2014/main" id="{93AD0DFA-41AE-45D1-9FFD-3878EA029822}"/>
+                <a16:creationId xmlns:a16="http://schemas.microsoft.com/office/drawing/2014/main" id="{D93C8705-2BE4-4B41-8D2D-6C445BBF6C0E}"/>
               </a:ext>
             </a:extLst>
           </p:cNvPr>
@@ -13273,7 +13273,7 @@
           <p:cNvPr id="11" name="Rounded Rectangle 10">
             <a:extLst xmlns:a="http://schemas.openxmlformats.org/drawingml/2006/main">
               <a:ext uri="{FF2B5EF4-FFF2-40B4-BE49-F238E27FC236}">
-                <a16:creationId xmlns:a16="http://schemas.microsoft.com/office/drawing/2014/main" id="{363B09AB-D724-47F5-9A98-FDAFDC8F6B2F}"/>
+                <a16:creationId xmlns:a16="http://schemas.microsoft.com/office/drawing/2014/main" id="{F131B95F-772B-49F8-90F4-CBA5F011397C}"/>
               </a:ext>
             </a:extLst>
           </p:cNvPr>
@@ -13330,7 +13330,7 @@
           <p:cNvPr id="12" name="TextBox 11">
             <a:extLst xmlns:a="http://schemas.openxmlformats.org/drawingml/2006/main">
               <a:ext uri="{FF2B5EF4-FFF2-40B4-BE49-F238E27FC236}">
-                <a16:creationId xmlns:a16="http://schemas.microsoft.com/office/drawing/2014/main" id="{BEE580FC-3BE2-41CB-80BA-EA7BBB6A113E}"/>
+                <a16:creationId xmlns:a16="http://schemas.microsoft.com/office/drawing/2014/main" id="{1FFB7506-7E83-4184-8DC0-E3219C8D1F15}"/>
               </a:ext>
             </a:extLst>
           </p:cNvPr>
@@ -13377,7 +13377,7 @@
           <p:cNvPr id="13" name="TextBox 12">
             <a:extLst xmlns:a="http://schemas.openxmlformats.org/drawingml/2006/main">
               <a:ext uri="{FF2B5EF4-FFF2-40B4-BE49-F238E27FC236}">
-                <a16:creationId xmlns:a16="http://schemas.microsoft.com/office/drawing/2014/main" id="{C987D544-558B-4239-944D-3CBB53C5A73F}"/>
+                <a16:creationId xmlns:a16="http://schemas.microsoft.com/office/drawing/2014/main" id="{52A8C069-8589-4907-B994-F8C7FD23B959}"/>
               </a:ext>
             </a:extLst>
           </p:cNvPr>
@@ -13424,7 +13424,7 @@
           <p:cNvPr id="14" name="Rounded Rectangle 13">
             <a:extLst xmlns:a="http://schemas.openxmlformats.org/drawingml/2006/main">
               <a:ext uri="{FF2B5EF4-FFF2-40B4-BE49-F238E27FC236}">
-                <a16:creationId xmlns:a16="http://schemas.microsoft.com/office/drawing/2014/main" id="{151FEDD6-FBE1-4637-8A26-C86EAAF81675}"/>
+                <a16:creationId xmlns:a16="http://schemas.microsoft.com/office/drawing/2014/main" id="{A76AFE75-A97A-46DC-B124-07395D3F678B}"/>
               </a:ext>
             </a:extLst>
           </p:cNvPr>
@@ -13481,7 +13481,7 @@
           <p:cNvPr id="15" name="TextBox 14">
             <a:extLst xmlns:a="http://schemas.openxmlformats.org/drawingml/2006/main">
               <a:ext uri="{FF2B5EF4-FFF2-40B4-BE49-F238E27FC236}">
-                <a16:creationId xmlns:a16="http://schemas.microsoft.com/office/drawing/2014/main" id="{6F7BCBAA-4A86-4410-868C-DFB317B33810}"/>
+                <a16:creationId xmlns:a16="http://schemas.microsoft.com/office/drawing/2014/main" id="{96767EF8-6653-4628-B8C3-6829045EDAEF}"/>
               </a:ext>
             </a:extLst>
           </p:cNvPr>
@@ -13528,7 +13528,7 @@
           <p:cNvPr id="16" name="TextBox 15">
             <a:extLst xmlns:a="http://schemas.openxmlformats.org/drawingml/2006/main">
               <a:ext uri="{FF2B5EF4-FFF2-40B4-BE49-F238E27FC236}">
-                <a16:creationId xmlns:a16="http://schemas.microsoft.com/office/drawing/2014/main" id="{9732CA8D-9729-48CD-B0C2-DF7445909630}"/>
+                <a16:creationId xmlns:a16="http://schemas.microsoft.com/office/drawing/2014/main" id="{C8E0F251-10E6-4041-B9D2-C18D3E4BEED6}"/>
               </a:ext>
             </a:extLst>
           </p:cNvPr>
@@ -13575,7 +13575,7 @@
           <p:cNvPr id="17" name="TextBox 16">
             <a:extLst xmlns:a="http://schemas.openxmlformats.org/drawingml/2006/main">
               <a:ext uri="{FF2B5EF4-FFF2-40B4-BE49-F238E27FC236}">
-                <a16:creationId xmlns:a16="http://schemas.microsoft.com/office/drawing/2014/main" id="{BE0146A5-8DE9-45C4-81A8-494057C0817B}"/>
+                <a16:creationId xmlns:a16="http://schemas.microsoft.com/office/drawing/2014/main" id="{F5F1C193-8FEB-4CB0-A30C-9B6DE69AAB3A}"/>
               </a:ext>
             </a:extLst>
           </p:cNvPr>
@@ -13622,7 +13622,7 @@
           <p:cNvPr id="18" name="Rounded Rectangle 17">
             <a:extLst xmlns:a="http://schemas.openxmlformats.org/drawingml/2006/main">
               <a:ext uri="{FF2B5EF4-FFF2-40B4-BE49-F238E27FC236}">
-                <a16:creationId xmlns:a16="http://schemas.microsoft.com/office/drawing/2014/main" id="{27C64C26-A5FD-48CB-A1B6-AF131505DB20}"/>
+                <a16:creationId xmlns:a16="http://schemas.microsoft.com/office/drawing/2014/main" id="{08527326-9664-44DF-8B2F-ED17B458533E}"/>
               </a:ext>
             </a:extLst>
           </p:cNvPr>
@@ -13679,7 +13679,7 @@
           <p:cNvPr id="19" name="TextBox 18">
             <a:extLst xmlns:a="http://schemas.openxmlformats.org/drawingml/2006/main">
               <a:ext uri="{FF2B5EF4-FFF2-40B4-BE49-F238E27FC236}">
-                <a16:creationId xmlns:a16="http://schemas.microsoft.com/office/drawing/2014/main" id="{5A981EE0-44D7-4586-A798-348C3254D1A2}"/>
+                <a16:creationId xmlns:a16="http://schemas.microsoft.com/office/drawing/2014/main" id="{88A574FC-A8D5-43DA-ADDB-4C6F9C92967F}"/>
               </a:ext>
             </a:extLst>
           </p:cNvPr>
@@ -13726,7 +13726,7 @@
           <p:cNvPr id="20" name="TextBox 19">
             <a:extLst xmlns:a="http://schemas.openxmlformats.org/drawingml/2006/main">
               <a:ext uri="{FF2B5EF4-FFF2-40B4-BE49-F238E27FC236}">
-                <a16:creationId xmlns:a16="http://schemas.microsoft.com/office/drawing/2014/main" id="{815DE90E-B6CF-44AE-BB9B-85BB44E90294}"/>
+                <a16:creationId xmlns:a16="http://schemas.microsoft.com/office/drawing/2014/main" id="{BA18639B-EE8B-497E-A0D5-ACBA4173CD7C}"/>
               </a:ext>
             </a:extLst>
           </p:cNvPr>
@@ -13771,7 +13771,7 @@
     </p:spTree>
     <p:extLst>
       <p:ext uri="{BB962C8B-B14F-4D97-AF65-F5344CB8AC3E}">
-        <p14:creationId xmlns:p14="http://schemas.microsoft.com/office/powerpoint/2010/main" val="1895678815"/>
+        <p14:creationId xmlns:p14="http://schemas.microsoft.com/office/powerpoint/2010/main" val="1433827433"/>
       </p:ext>
     </p:extLst>
   </p:cSld>
@@ -13795,7 +13795,7 @@
           <p:cNvPr id="2" name="TextBox 1">
             <a:extLst xmlns:a="http://schemas.openxmlformats.org/drawingml/2006/main">
               <a:ext uri="{FF2B5EF4-FFF2-40B4-BE49-F238E27FC236}">
-                <a16:creationId xmlns:a16="http://schemas.microsoft.com/office/drawing/2014/main" id="{1F831B8E-E069-4611-AD04-D221DC648A91}"/>
+                <a16:creationId xmlns:a16="http://schemas.microsoft.com/office/drawing/2014/main" id="{6C4BA9EF-103C-4E31-991C-1E52B5DF366B}"/>
               </a:ext>
             </a:extLst>
           </p:cNvPr>
@@ -13842,7 +13842,7 @@
           <p:cNvPr id="3" name="TextBox 2">
             <a:extLst xmlns:a="http://schemas.openxmlformats.org/drawingml/2006/main">
               <a:ext uri="{FF2B5EF4-FFF2-40B4-BE49-F238E27FC236}">
-                <a16:creationId xmlns:a16="http://schemas.microsoft.com/office/drawing/2014/main" id="{3BCD15DD-51C6-4CA5-8D4A-0429095160D3}"/>
+                <a16:creationId xmlns:a16="http://schemas.microsoft.com/office/drawing/2014/main" id="{EB0F104D-F8B5-49E1-9957-CC27123FCBAD}"/>
               </a:ext>
             </a:extLst>
           </p:cNvPr>
@@ -13889,7 +13889,7 @@
           <p:cNvPr id="4" name="Rectangle 3">
             <a:extLst xmlns:a="http://schemas.openxmlformats.org/drawingml/2006/main">
               <a:ext uri="{FF2B5EF4-FFF2-40B4-BE49-F238E27FC236}">
-                <a16:creationId xmlns:a16="http://schemas.microsoft.com/office/drawing/2014/main" id="{D0B202DD-88BF-4FC3-8B8A-FF6A3AB9DCDB}"/>
+                <a16:creationId xmlns:a16="http://schemas.microsoft.com/office/drawing/2014/main" id="{946DCCDC-CBA5-416E-8DDC-CC87CE9B1EA9}"/>
               </a:ext>
             </a:extLst>
           </p:cNvPr>
@@ -13944,7 +13944,7 @@
           <p:cNvPr id="5" name="Rectangle 4">
             <a:extLst xmlns:a="http://schemas.openxmlformats.org/drawingml/2006/main">
               <a:ext uri="{FF2B5EF4-FFF2-40B4-BE49-F238E27FC236}">
-                <a16:creationId xmlns:a16="http://schemas.microsoft.com/office/drawing/2014/main" id="{F9D2F74B-D744-4CAE-AAF6-1DAA04808FA0}"/>
+                <a16:creationId xmlns:a16="http://schemas.microsoft.com/office/drawing/2014/main" id="{B714FBA5-B69A-45B9-8410-070166C55A94}"/>
               </a:ext>
             </a:extLst>
           </p:cNvPr>
@@ -13999,7 +13999,7 @@
           <p:cNvPr id="6" name="TextBox 5">
             <a:extLst xmlns:a="http://schemas.openxmlformats.org/drawingml/2006/main">
               <a:ext uri="{FF2B5EF4-FFF2-40B4-BE49-F238E27FC236}">
-                <a16:creationId xmlns:a16="http://schemas.microsoft.com/office/drawing/2014/main" id="{CCB28205-8763-462C-A07F-A7FD543B09DF}"/>
+                <a16:creationId xmlns:a16="http://schemas.microsoft.com/office/drawing/2014/main" id="{140472B7-7607-48AE-8B31-D16481EFADC9}"/>
               </a:ext>
             </a:extLst>
           </p:cNvPr>
@@ -14036,7 +14036,7 @@
                 <a:ea typeface="Aptos"/>
                 <a:cs typeface="Aptos"/>
               </a:rPr>
-              <a:t>Independent public evidence summary · 2026.07.22-9 · 2026-07-22 · Sources: Market-values model; Readiness</a:t>
+              <a:t>Independent public evidence summary · 2026.07.23-10 · 2026-07-22 · Sources: Market-values model; Readiness</a:t>
             </a:r>
           </a:p>
         </p:txBody>
@@ -14046,7 +14046,7 @@
           <p:cNvPr id="7" name="TextBox 6">
             <a:extLst xmlns:a="http://schemas.openxmlformats.org/drawingml/2006/main">
               <a:ext uri="{FF2B5EF4-FFF2-40B4-BE49-F238E27FC236}">
-                <a16:creationId xmlns:a16="http://schemas.microsoft.com/office/drawing/2014/main" id="{0401AC9C-3941-491F-95DE-87580D8DB315}"/>
+                <a16:creationId xmlns:a16="http://schemas.microsoft.com/office/drawing/2014/main" id="{30D373F4-E33C-4B49-9730-B559981EB31B}"/>
               </a:ext>
             </a:extLst>
           </p:cNvPr>
@@ -14093,7 +14093,7 @@
           <p:cNvPr id="8" name="TextBox 7">
             <a:extLst xmlns:a="http://schemas.openxmlformats.org/drawingml/2006/main">
               <a:ext uri="{FF2B5EF4-FFF2-40B4-BE49-F238E27FC236}">
-                <a16:creationId xmlns:a16="http://schemas.microsoft.com/office/drawing/2014/main" id="{88748D64-7F67-41A5-8A0E-553CB57C7F0B}"/>
+                <a16:creationId xmlns:a16="http://schemas.microsoft.com/office/drawing/2014/main" id="{82EA0CF3-19D1-43EE-9A4E-DF5764CDF7B5}"/>
               </a:ext>
             </a:extLst>
           </p:cNvPr>
@@ -14140,7 +14140,7 @@
           <p:cNvPr id="9" name="TextBox 8">
             <a:extLst xmlns:a="http://schemas.openxmlformats.org/drawingml/2006/main">
               <a:ext uri="{FF2B5EF4-FFF2-40B4-BE49-F238E27FC236}">
-                <a16:creationId xmlns:a16="http://schemas.microsoft.com/office/drawing/2014/main" id="{03E2C2D2-4656-4191-814B-55BD3542E2B7}"/>
+                <a16:creationId xmlns:a16="http://schemas.microsoft.com/office/drawing/2014/main" id="{5BC97264-EE73-4ED2-9C7E-DFD89D021994}"/>
               </a:ext>
             </a:extLst>
           </p:cNvPr>
@@ -14237,7 +14237,7 @@
           <p:cNvPr id="10" name="Rounded Rectangle 9">
             <a:extLst xmlns:a="http://schemas.openxmlformats.org/drawingml/2006/main">
               <a:ext uri="{FF2B5EF4-FFF2-40B4-BE49-F238E27FC236}">
-                <a16:creationId xmlns:a16="http://schemas.microsoft.com/office/drawing/2014/main" id="{2C6EFA9B-D7E2-45F5-B863-CE4333356FE2}"/>
+                <a16:creationId xmlns:a16="http://schemas.microsoft.com/office/drawing/2014/main" id="{885825C2-4F03-4E84-ABAE-13959A01456E}"/>
               </a:ext>
             </a:extLst>
           </p:cNvPr>
@@ -14294,7 +14294,7 @@
           <p:cNvPr id="11" name="TextBox 10">
             <a:extLst xmlns:a="http://schemas.openxmlformats.org/drawingml/2006/main">
               <a:ext uri="{FF2B5EF4-FFF2-40B4-BE49-F238E27FC236}">
-                <a16:creationId xmlns:a16="http://schemas.microsoft.com/office/drawing/2014/main" id="{F12B3CAF-6D23-43A6-B492-7C2B68EFF10F}"/>
+                <a16:creationId xmlns:a16="http://schemas.microsoft.com/office/drawing/2014/main" id="{6EF8DCBA-1F4A-4C84-B805-49B12D3DEF60}"/>
               </a:ext>
             </a:extLst>
           </p:cNvPr>
@@ -14341,7 +14341,7 @@
           <p:cNvPr id="12" name="TextBox 11">
             <a:extLst xmlns:a="http://schemas.openxmlformats.org/drawingml/2006/main">
               <a:ext uri="{FF2B5EF4-FFF2-40B4-BE49-F238E27FC236}">
-                <a16:creationId xmlns:a16="http://schemas.microsoft.com/office/drawing/2014/main" id="{9E38F901-F568-47CE-8998-4437DB276547}"/>
+                <a16:creationId xmlns:a16="http://schemas.microsoft.com/office/drawing/2014/main" id="{6F182AFF-4BD3-4CF7-A62A-2DF26FB55273}"/>
               </a:ext>
             </a:extLst>
           </p:cNvPr>
@@ -14386,7 +14386,7 @@
     </p:spTree>
     <p:extLst>
       <p:ext uri="{BB962C8B-B14F-4D97-AF65-F5344CB8AC3E}">
-        <p14:creationId xmlns:p14="http://schemas.microsoft.com/office/powerpoint/2010/main" val="1580677065"/>
+        <p14:creationId xmlns:p14="http://schemas.microsoft.com/office/powerpoint/2010/main" val="1242436755"/>
       </p:ext>
     </p:extLst>
   </p:cSld>
@@ -14410,7 +14410,7 @@
           <p:cNvPr id="2" name="TextBox 1">
             <a:extLst xmlns:a="http://schemas.openxmlformats.org/drawingml/2006/main">
               <a:ext uri="{FF2B5EF4-FFF2-40B4-BE49-F238E27FC236}">
-                <a16:creationId xmlns:a16="http://schemas.microsoft.com/office/drawing/2014/main" id="{2A5B3AA2-A87C-4ACC-A10C-3A4329CD4ED2}"/>
+                <a16:creationId xmlns:a16="http://schemas.microsoft.com/office/drawing/2014/main" id="{8F4EBEC0-55CC-4675-B63B-34BAAF0D0EFD}"/>
               </a:ext>
             </a:extLst>
           </p:cNvPr>
@@ -14457,7 +14457,7 @@
           <p:cNvPr id="3" name="TextBox 2">
             <a:extLst xmlns:a="http://schemas.openxmlformats.org/drawingml/2006/main">
               <a:ext uri="{FF2B5EF4-FFF2-40B4-BE49-F238E27FC236}">
-                <a16:creationId xmlns:a16="http://schemas.microsoft.com/office/drawing/2014/main" id="{9511DD69-22BC-4A78-99A5-701262F17E00}"/>
+                <a16:creationId xmlns:a16="http://schemas.microsoft.com/office/drawing/2014/main" id="{F18EEF3B-CF7D-4FBD-870F-013E0F6D9489}"/>
               </a:ext>
             </a:extLst>
           </p:cNvPr>
@@ -14504,7 +14504,7 @@
           <p:cNvPr id="4" name="Rectangle 3">
             <a:extLst xmlns:a="http://schemas.openxmlformats.org/drawingml/2006/main">
               <a:ext uri="{FF2B5EF4-FFF2-40B4-BE49-F238E27FC236}">
-                <a16:creationId xmlns:a16="http://schemas.microsoft.com/office/drawing/2014/main" id="{15EC310A-1BCF-41DA-9A5A-08506308C2AF}"/>
+                <a16:creationId xmlns:a16="http://schemas.microsoft.com/office/drawing/2014/main" id="{08995396-9A8D-4922-8283-6C7482765D6F}"/>
               </a:ext>
             </a:extLst>
           </p:cNvPr>
@@ -14559,7 +14559,7 @@
           <p:cNvPr id="5" name="Rectangle 4">
             <a:extLst xmlns:a="http://schemas.openxmlformats.org/drawingml/2006/main">
               <a:ext uri="{FF2B5EF4-FFF2-40B4-BE49-F238E27FC236}">
-                <a16:creationId xmlns:a16="http://schemas.microsoft.com/office/drawing/2014/main" id="{74FD007A-F5A1-4410-B085-08B7210C1501}"/>
+                <a16:creationId xmlns:a16="http://schemas.microsoft.com/office/drawing/2014/main" id="{0756A4A4-F326-4BFD-9C14-6CF1B2330F29}"/>
               </a:ext>
             </a:extLst>
           </p:cNvPr>
@@ -14614,7 +14614,7 @@
           <p:cNvPr id="6" name="TextBox 5">
             <a:extLst xmlns:a="http://schemas.openxmlformats.org/drawingml/2006/main">
               <a:ext uri="{FF2B5EF4-FFF2-40B4-BE49-F238E27FC236}">
-                <a16:creationId xmlns:a16="http://schemas.microsoft.com/office/drawing/2014/main" id="{2AFF42F9-239E-4E74-895A-201218BC4EA3}"/>
+                <a16:creationId xmlns:a16="http://schemas.microsoft.com/office/drawing/2014/main" id="{2767A7B3-C055-4F10-BEB6-A6EA6E25C310}"/>
               </a:ext>
             </a:extLst>
           </p:cNvPr>
@@ -14651,7 +14651,7 @@
                 <a:ea typeface="Aptos"/>
                 <a:cs typeface="Aptos"/>
               </a:rPr>
-              <a:t>Independent public evidence summary · 2026.07.22-9 · 2026-07-22 · Sources: WIPO valuation; Evidence Register</a:t>
+              <a:t>Independent public evidence summary · 2026.07.23-10 · 2026-07-22 · Sources: WIPO valuation; Evidence Register</a:t>
             </a:r>
           </a:p>
         </p:txBody>
@@ -14661,7 +14661,7 @@
           <p:cNvPr id="7" name="TextBox 6">
             <a:extLst xmlns:a="http://schemas.openxmlformats.org/drawingml/2006/main">
               <a:ext uri="{FF2B5EF4-FFF2-40B4-BE49-F238E27FC236}">
-                <a16:creationId xmlns:a16="http://schemas.microsoft.com/office/drawing/2014/main" id="{27BD48C3-50F6-49A6-9117-3013839647D1}"/>
+                <a16:creationId xmlns:a16="http://schemas.microsoft.com/office/drawing/2014/main" id="{1EB2D229-CC61-436F-9CBD-168C2AEB57F5}"/>
               </a:ext>
             </a:extLst>
           </p:cNvPr>
@@ -15231,7 +15231,7 @@
           <p:cNvPr id="9" name="TextBox 8">
             <a:extLst xmlns:a="http://schemas.openxmlformats.org/drawingml/2006/main">
               <a:ext uri="{FF2B5EF4-FFF2-40B4-BE49-F238E27FC236}">
-                <a16:creationId xmlns:a16="http://schemas.microsoft.com/office/drawing/2014/main" id="{77EF4077-30F4-459E-A417-B46ED985223A}"/>
+                <a16:creationId xmlns:a16="http://schemas.microsoft.com/office/drawing/2014/main" id="{039F17CC-9FF2-4693-8D2A-673C46E161B2}"/>
               </a:ext>
             </a:extLst>
           </p:cNvPr>
@@ -15276,7 +15276,7 @@
     </p:spTree>
     <p:extLst>
       <p:ext uri="{BB962C8B-B14F-4D97-AF65-F5344CB8AC3E}">
-        <p14:creationId xmlns:p14="http://schemas.microsoft.com/office/powerpoint/2010/main" val="794536450"/>
+        <p14:creationId xmlns:p14="http://schemas.microsoft.com/office/powerpoint/2010/main" val="250185763"/>
       </p:ext>
     </p:extLst>
   </p:cSld>
@@ -15300,7 +15300,7 @@
           <p:cNvPr id="2" name="TextBox 1">
             <a:extLst xmlns:a="http://schemas.openxmlformats.org/drawingml/2006/main">
               <a:ext uri="{FF2B5EF4-FFF2-40B4-BE49-F238E27FC236}">
-                <a16:creationId xmlns:a16="http://schemas.microsoft.com/office/drawing/2014/main" id="{C8BF708A-6AB5-4B48-AD32-E938D4806647}"/>
+                <a16:creationId xmlns:a16="http://schemas.microsoft.com/office/drawing/2014/main" id="{F7C8FF39-751A-4200-9F16-20B0BC90328E}"/>
               </a:ext>
             </a:extLst>
           </p:cNvPr>
@@ -15347,7 +15347,7 @@
           <p:cNvPr id="3" name="TextBox 2">
             <a:extLst xmlns:a="http://schemas.openxmlformats.org/drawingml/2006/main">
               <a:ext uri="{FF2B5EF4-FFF2-40B4-BE49-F238E27FC236}">
-                <a16:creationId xmlns:a16="http://schemas.microsoft.com/office/drawing/2014/main" id="{039C45E1-6C21-47AD-A1C3-5122F19354EA}"/>
+                <a16:creationId xmlns:a16="http://schemas.microsoft.com/office/drawing/2014/main" id="{9DA8EA9C-3A11-42CD-B3FC-508113312D87}"/>
               </a:ext>
             </a:extLst>
           </p:cNvPr>
@@ -15394,7 +15394,7 @@
           <p:cNvPr id="4" name="Rectangle 3">
             <a:extLst xmlns:a="http://schemas.openxmlformats.org/drawingml/2006/main">
               <a:ext uri="{FF2B5EF4-FFF2-40B4-BE49-F238E27FC236}">
-                <a16:creationId xmlns:a16="http://schemas.microsoft.com/office/drawing/2014/main" id="{840B5AF4-9F53-4FDC-B047-458C80F0DD45}"/>
+                <a16:creationId xmlns:a16="http://schemas.microsoft.com/office/drawing/2014/main" id="{119D40D6-A876-4FE0-85A8-AD7B0834378B}"/>
               </a:ext>
             </a:extLst>
           </p:cNvPr>
@@ -15449,7 +15449,7 @@
           <p:cNvPr id="5" name="Rectangle 4">
             <a:extLst xmlns:a="http://schemas.openxmlformats.org/drawingml/2006/main">
               <a:ext uri="{FF2B5EF4-FFF2-40B4-BE49-F238E27FC236}">
-                <a16:creationId xmlns:a16="http://schemas.microsoft.com/office/drawing/2014/main" id="{6A4302CE-C91C-434B-8AF2-F0A8848A70F5}"/>
+                <a16:creationId xmlns:a16="http://schemas.microsoft.com/office/drawing/2014/main" id="{E77C1875-5E33-414C-8E75-4066E26F92A4}"/>
               </a:ext>
             </a:extLst>
           </p:cNvPr>
@@ -15504,7 +15504,7 @@
           <p:cNvPr id="6" name="TextBox 5">
             <a:extLst xmlns:a="http://schemas.openxmlformats.org/drawingml/2006/main">
               <a:ext uri="{FF2B5EF4-FFF2-40B4-BE49-F238E27FC236}">
-                <a16:creationId xmlns:a16="http://schemas.microsoft.com/office/drawing/2014/main" id="{2703433C-8A53-4E93-86E4-1AA8F94952DB}"/>
+                <a16:creationId xmlns:a16="http://schemas.microsoft.com/office/drawing/2014/main" id="{35BA8125-2460-4189-AF49-9D6BC9F21EBA}"/>
               </a:ext>
             </a:extLst>
           </p:cNvPr>
@@ -15541,7 +15541,7 @@
                 <a:ea typeface="Aptos"/>
                 <a:cs typeface="Aptos"/>
               </a:rPr>
-              <a:t>Independent public evidence summary · 2026.07.22-9 · 2026-07-22 · Sources: EPO; Germany — official judgments; WIPO</a:t>
+              <a:t>Independent public evidence summary · 2026.07.23-10 · 2026-07-22 · Sources: EPO; Germany — official judgments; WIPO</a:t>
             </a:r>
           </a:p>
         </p:txBody>
@@ -15551,7 +15551,7 @@
           <p:cNvPr id="7" name="TextBox 6">
             <a:extLst xmlns:a="http://schemas.openxmlformats.org/drawingml/2006/main">
               <a:ext uri="{FF2B5EF4-FFF2-40B4-BE49-F238E27FC236}">
-                <a16:creationId xmlns:a16="http://schemas.microsoft.com/office/drawing/2014/main" id="{7301BED8-8D2A-4958-B4A3-76BE48D437A0}"/>
+                <a16:creationId xmlns:a16="http://schemas.microsoft.com/office/drawing/2014/main" id="{1AB3C04B-B18A-426A-8D04-F660D7F5C6D5}"/>
               </a:ext>
             </a:extLst>
           </p:cNvPr>
@@ -15598,7 +15598,7 @@
           <p:cNvPr id="8" name="TextBox 7">
             <a:extLst xmlns:a="http://schemas.openxmlformats.org/drawingml/2006/main">
               <a:ext uri="{FF2B5EF4-FFF2-40B4-BE49-F238E27FC236}">
-                <a16:creationId xmlns:a16="http://schemas.microsoft.com/office/drawing/2014/main" id="{AD9BDBCE-B023-4571-A1F5-DE579B0927AF}"/>
+                <a16:creationId xmlns:a16="http://schemas.microsoft.com/office/drawing/2014/main" id="{797A5EB9-D2EB-4BFB-B336-463DD496A796}"/>
               </a:ext>
             </a:extLst>
           </p:cNvPr>
@@ -15645,7 +15645,7 @@
           <p:cNvPr id="9" name="TextBox 8">
             <a:extLst xmlns:a="http://schemas.openxmlformats.org/drawingml/2006/main">
               <a:ext uri="{FF2B5EF4-FFF2-40B4-BE49-F238E27FC236}">
-                <a16:creationId xmlns:a16="http://schemas.microsoft.com/office/drawing/2014/main" id="{7A5B8A30-2FEF-4FD8-8FD4-FEE81E3D0559}"/>
+                <a16:creationId xmlns:a16="http://schemas.microsoft.com/office/drawing/2014/main" id="{E9F5887E-580F-4DA5-91A5-D59C6B138570}"/>
               </a:ext>
             </a:extLst>
           </p:cNvPr>
@@ -15742,7 +15742,7 @@
           <p:cNvPr id="10" name="Rounded Rectangle 9">
             <a:extLst xmlns:a="http://schemas.openxmlformats.org/drawingml/2006/main">
               <a:ext uri="{FF2B5EF4-FFF2-40B4-BE49-F238E27FC236}">
-                <a16:creationId xmlns:a16="http://schemas.microsoft.com/office/drawing/2014/main" id="{FE6A8CC8-C75C-439B-806D-352FBBC56840}"/>
+                <a16:creationId xmlns:a16="http://schemas.microsoft.com/office/drawing/2014/main" id="{E40EA0A7-0A11-4F33-8F7D-32FAAE28928F}"/>
               </a:ext>
             </a:extLst>
           </p:cNvPr>
@@ -15799,7 +15799,7 @@
           <p:cNvPr id="11" name="TextBox 10">
             <a:extLst xmlns:a="http://schemas.openxmlformats.org/drawingml/2006/main">
               <a:ext uri="{FF2B5EF4-FFF2-40B4-BE49-F238E27FC236}">
-                <a16:creationId xmlns:a16="http://schemas.microsoft.com/office/drawing/2014/main" id="{506900D2-EBA4-4DC5-B9AE-7DEE2DDE9CAE}"/>
+                <a16:creationId xmlns:a16="http://schemas.microsoft.com/office/drawing/2014/main" id="{788B25CA-DD4F-4577-96E3-1F9771818447}"/>
               </a:ext>
             </a:extLst>
           </p:cNvPr>
@@ -15846,7 +15846,7 @@
           <p:cNvPr id="12" name="TextBox 11">
             <a:extLst xmlns:a="http://schemas.openxmlformats.org/drawingml/2006/main">
               <a:ext uri="{FF2B5EF4-FFF2-40B4-BE49-F238E27FC236}">
-                <a16:creationId xmlns:a16="http://schemas.microsoft.com/office/drawing/2014/main" id="{B4FCA79C-A4CA-4243-B17C-DE26DD323BED}"/>
+                <a16:creationId xmlns:a16="http://schemas.microsoft.com/office/drawing/2014/main" id="{3444F3AF-B0AA-4BAB-A5C0-F858C4F66FE9}"/>
               </a:ext>
             </a:extLst>
           </p:cNvPr>
@@ -15891,7 +15891,7 @@
     </p:spTree>
     <p:extLst>
       <p:ext uri="{BB962C8B-B14F-4D97-AF65-F5344CB8AC3E}">
-        <p14:creationId xmlns:p14="http://schemas.microsoft.com/office/powerpoint/2010/main" val="1870272871"/>
+        <p14:creationId xmlns:p14="http://schemas.microsoft.com/office/powerpoint/2010/main" val="747547884"/>
       </p:ext>
     </p:extLst>
   </p:cSld>
@@ -15915,7 +15915,7 @@
           <p:cNvPr id="2" name="TextBox 1">
             <a:extLst xmlns:a="http://schemas.openxmlformats.org/drawingml/2006/main">
               <a:ext uri="{FF2B5EF4-FFF2-40B4-BE49-F238E27FC236}">
-                <a16:creationId xmlns:a16="http://schemas.microsoft.com/office/drawing/2014/main" id="{85A7B432-AB71-4CEB-A856-964BB465E839}"/>
+                <a16:creationId xmlns:a16="http://schemas.microsoft.com/office/drawing/2014/main" id="{07A2C05D-C3EE-45E7-8365-5DE2A1EF6010}"/>
               </a:ext>
             </a:extLst>
           </p:cNvPr>
@@ -15962,7 +15962,7 @@
           <p:cNvPr id="3" name="TextBox 2">
             <a:extLst xmlns:a="http://schemas.openxmlformats.org/drawingml/2006/main">
               <a:ext uri="{FF2B5EF4-FFF2-40B4-BE49-F238E27FC236}">
-                <a16:creationId xmlns:a16="http://schemas.microsoft.com/office/drawing/2014/main" id="{658D9CB7-60D7-48A3-B946-DD67A414BB7B}"/>
+                <a16:creationId xmlns:a16="http://schemas.microsoft.com/office/drawing/2014/main" id="{D3D4D502-F878-4CA1-A23C-260ED1E9098F}"/>
               </a:ext>
             </a:extLst>
           </p:cNvPr>
@@ -16009,7 +16009,7 @@
           <p:cNvPr id="4" name="Rectangle 3">
             <a:extLst xmlns:a="http://schemas.openxmlformats.org/drawingml/2006/main">
               <a:ext uri="{FF2B5EF4-FFF2-40B4-BE49-F238E27FC236}">
-                <a16:creationId xmlns:a16="http://schemas.microsoft.com/office/drawing/2014/main" id="{B74B47CE-4EF1-45B5-8DEE-BDCCA3AA91F3}"/>
+                <a16:creationId xmlns:a16="http://schemas.microsoft.com/office/drawing/2014/main" id="{3152E449-4F22-4530-A574-113F42C76211}"/>
               </a:ext>
             </a:extLst>
           </p:cNvPr>
@@ -16064,7 +16064,7 @@
           <p:cNvPr id="5" name="Rectangle 4">
             <a:extLst xmlns:a="http://schemas.openxmlformats.org/drawingml/2006/main">
               <a:ext uri="{FF2B5EF4-FFF2-40B4-BE49-F238E27FC236}">
-                <a16:creationId xmlns:a16="http://schemas.microsoft.com/office/drawing/2014/main" id="{659BFD51-0C1E-4D75-8D38-4EC1ED3C6717}"/>
+                <a16:creationId xmlns:a16="http://schemas.microsoft.com/office/drawing/2014/main" id="{22ACCDD4-9D76-41D8-88B3-2D43521B18B8}"/>
               </a:ext>
             </a:extLst>
           </p:cNvPr>
@@ -16119,7 +16119,7 @@
           <p:cNvPr id="6" name="TextBox 5">
             <a:extLst xmlns:a="http://schemas.openxmlformats.org/drawingml/2006/main">
               <a:ext uri="{FF2B5EF4-FFF2-40B4-BE49-F238E27FC236}">
-                <a16:creationId xmlns:a16="http://schemas.microsoft.com/office/drawing/2014/main" id="{EAB1AF26-1A24-41C1-8640-530A49816AAA}"/>
+                <a16:creationId xmlns:a16="http://schemas.microsoft.com/office/drawing/2014/main" id="{3839196C-5325-4302-8319-C4793D8E4748}"/>
               </a:ext>
             </a:extLst>
           </p:cNvPr>
@@ -16156,7 +16156,7 @@
                 <a:ea typeface="Aptos"/>
                 <a:cs typeface="Aptos"/>
               </a:rPr>
-              <a:t>Independent public evidence summary · 2026.07.22-9 · 2026-07-22 · Sources: WIPO licensing; IP Finance</a:t>
+              <a:t>Independent public evidence summary · 2026.07.23-10 · 2026-07-22 · Sources: WIPO licensing; IP Finance</a:t>
             </a:r>
           </a:p>
         </p:txBody>
@@ -16166,7 +16166,7 @@
           <p:cNvPr id="7" name="TextBox 6">
             <a:extLst xmlns:a="http://schemas.openxmlformats.org/drawingml/2006/main">
               <a:ext uri="{FF2B5EF4-FFF2-40B4-BE49-F238E27FC236}">
-                <a16:creationId xmlns:a16="http://schemas.microsoft.com/office/drawing/2014/main" id="{49CCDE48-5046-41D4-BE2B-486605C4794C}"/>
+                <a16:creationId xmlns:a16="http://schemas.microsoft.com/office/drawing/2014/main" id="{38E14C2D-E997-463D-B76D-9D87CFAD5481}"/>
               </a:ext>
             </a:extLst>
           </p:cNvPr>
@@ -16213,7 +16213,7 @@
           <p:cNvPr id="8" name="TextBox 7">
             <a:extLst xmlns:a="http://schemas.openxmlformats.org/drawingml/2006/main">
               <a:ext uri="{FF2B5EF4-FFF2-40B4-BE49-F238E27FC236}">
-                <a16:creationId xmlns:a16="http://schemas.microsoft.com/office/drawing/2014/main" id="{77CACC44-5B69-4085-AEC1-736E00C9D3D1}"/>
+                <a16:creationId xmlns:a16="http://schemas.microsoft.com/office/drawing/2014/main" id="{CAC157B8-059B-4A0E-95CD-904E5FCE6020}"/>
               </a:ext>
             </a:extLst>
           </p:cNvPr>
@@ -16260,7 +16260,7 @@
           <p:cNvPr id="9" name="TextBox 8">
             <a:extLst xmlns:a="http://schemas.openxmlformats.org/drawingml/2006/main">
               <a:ext uri="{FF2B5EF4-FFF2-40B4-BE49-F238E27FC236}">
-                <a16:creationId xmlns:a16="http://schemas.microsoft.com/office/drawing/2014/main" id="{55627811-2E94-4D54-86DD-CDF36C6DF116}"/>
+                <a16:creationId xmlns:a16="http://schemas.microsoft.com/office/drawing/2014/main" id="{679B823A-ECFD-4425-8C14-156F04359FDA}"/>
               </a:ext>
             </a:extLst>
           </p:cNvPr>
@@ -16357,7 +16357,7 @@
           <p:cNvPr id="10" name="Rounded Rectangle 9">
             <a:extLst xmlns:a="http://schemas.openxmlformats.org/drawingml/2006/main">
               <a:ext uri="{FF2B5EF4-FFF2-40B4-BE49-F238E27FC236}">
-                <a16:creationId xmlns:a16="http://schemas.microsoft.com/office/drawing/2014/main" id="{51209ECF-F186-4DF0-884E-5547CDE3365A}"/>
+                <a16:creationId xmlns:a16="http://schemas.microsoft.com/office/drawing/2014/main" id="{96070D32-7C94-422E-86BA-950E0EACA540}"/>
               </a:ext>
             </a:extLst>
           </p:cNvPr>
@@ -16414,7 +16414,7 @@
           <p:cNvPr id="11" name="TextBox 10">
             <a:extLst xmlns:a="http://schemas.openxmlformats.org/drawingml/2006/main">
               <a:ext uri="{FF2B5EF4-FFF2-40B4-BE49-F238E27FC236}">
-                <a16:creationId xmlns:a16="http://schemas.microsoft.com/office/drawing/2014/main" id="{D8D4ECBB-053D-4FD8-8F0F-0125426EF464}"/>
+                <a16:creationId xmlns:a16="http://schemas.microsoft.com/office/drawing/2014/main" id="{07DC9485-DCD5-4CC6-8894-DF83246778DB}"/>
               </a:ext>
             </a:extLst>
           </p:cNvPr>
@@ -16461,7 +16461,7 @@
           <p:cNvPr id="12" name="TextBox 11">
             <a:extLst xmlns:a="http://schemas.openxmlformats.org/drawingml/2006/main">
               <a:ext uri="{FF2B5EF4-FFF2-40B4-BE49-F238E27FC236}">
-                <a16:creationId xmlns:a16="http://schemas.microsoft.com/office/drawing/2014/main" id="{596BFF5A-4468-4543-AC42-6E54F65D580B}"/>
+                <a16:creationId xmlns:a16="http://schemas.microsoft.com/office/drawing/2014/main" id="{C806F569-CDFD-4E86-9B34-AC639FB33DF7}"/>
               </a:ext>
             </a:extLst>
           </p:cNvPr>
@@ -16506,7 +16506,7 @@
     </p:spTree>
     <p:extLst>
       <p:ext uri="{BB962C8B-B14F-4D97-AF65-F5344CB8AC3E}">
-        <p14:creationId xmlns:p14="http://schemas.microsoft.com/office/powerpoint/2010/main" val="1155978858"/>
+        <p14:creationId xmlns:p14="http://schemas.microsoft.com/office/powerpoint/2010/main" val="340262305"/>
       </p:ext>
     </p:extLst>
   </p:cSld>
@@ -16530,7 +16530,7 @@
           <p:cNvPr id="2" name="TextBox 1">
             <a:extLst xmlns:a="http://schemas.openxmlformats.org/drawingml/2006/main">
               <a:ext uri="{FF2B5EF4-FFF2-40B4-BE49-F238E27FC236}">
-                <a16:creationId xmlns:a16="http://schemas.microsoft.com/office/drawing/2014/main" id="{D03DA760-0984-499B-AD2E-6BBB9AC1E0A2}"/>
+                <a16:creationId xmlns:a16="http://schemas.microsoft.com/office/drawing/2014/main" id="{9980A7FC-AFB6-499A-B2EE-81ACF6127133}"/>
               </a:ext>
             </a:extLst>
           </p:cNvPr>
@@ -16577,7 +16577,7 @@
           <p:cNvPr id="3" name="TextBox 2">
             <a:extLst xmlns:a="http://schemas.openxmlformats.org/drawingml/2006/main">
               <a:ext uri="{FF2B5EF4-FFF2-40B4-BE49-F238E27FC236}">
-                <a16:creationId xmlns:a16="http://schemas.microsoft.com/office/drawing/2014/main" id="{4C6CEC90-BB31-49C8-A4A0-18A4D5395B6A}"/>
+                <a16:creationId xmlns:a16="http://schemas.microsoft.com/office/drawing/2014/main" id="{9E885DB2-4366-47ED-AC0C-3BC2831E63EF}"/>
               </a:ext>
             </a:extLst>
           </p:cNvPr>
@@ -16624,7 +16624,7 @@
           <p:cNvPr id="4" name="Rectangle 3">
             <a:extLst xmlns:a="http://schemas.openxmlformats.org/drawingml/2006/main">
               <a:ext uri="{FF2B5EF4-FFF2-40B4-BE49-F238E27FC236}">
-                <a16:creationId xmlns:a16="http://schemas.microsoft.com/office/drawing/2014/main" id="{DD73F3FB-ED1C-4FC7-A201-41AFB50B31F8}"/>
+                <a16:creationId xmlns:a16="http://schemas.microsoft.com/office/drawing/2014/main" id="{D2FA1E60-FC1A-42C8-B038-F80520340511}"/>
               </a:ext>
             </a:extLst>
           </p:cNvPr>
@@ -16679,7 +16679,7 @@
           <p:cNvPr id="5" name="Rectangle 4">
             <a:extLst xmlns:a="http://schemas.openxmlformats.org/drawingml/2006/main">
               <a:ext uri="{FF2B5EF4-FFF2-40B4-BE49-F238E27FC236}">
-                <a16:creationId xmlns:a16="http://schemas.microsoft.com/office/drawing/2014/main" id="{2D46930E-332C-4E19-A969-087A95F452E6}"/>
+                <a16:creationId xmlns:a16="http://schemas.microsoft.com/office/drawing/2014/main" id="{1894D294-EBCE-4963-95B6-C41EBF848E94}"/>
               </a:ext>
             </a:extLst>
           </p:cNvPr>
@@ -16734,7 +16734,7 @@
           <p:cNvPr id="6" name="TextBox 5">
             <a:extLst xmlns:a="http://schemas.openxmlformats.org/drawingml/2006/main">
               <a:ext uri="{FF2B5EF4-FFF2-40B4-BE49-F238E27FC236}">
-                <a16:creationId xmlns:a16="http://schemas.microsoft.com/office/drawing/2014/main" id="{9EB8F954-47AA-41EE-AC76-D2FBC5927E85}"/>
+                <a16:creationId xmlns:a16="http://schemas.microsoft.com/office/drawing/2014/main" id="{01F90638-F82C-45A0-B8A2-8C3466490182}"/>
               </a:ext>
             </a:extLst>
           </p:cNvPr>
@@ -16771,7 +16771,7 @@
                 <a:ea typeface="Aptos"/>
                 <a:cs typeface="Aptos"/>
               </a:rPr>
-              <a:t>Independent public evidence summary · 2026.07.22-9 · 2026-07-22 · Sources: Evidence Register; EPO</a:t>
+              <a:t>Independent public evidence summary · 2026.07.23-10 · 2026-07-22 · Sources: Evidence Register; EPO</a:t>
             </a:r>
           </a:p>
         </p:txBody>
@@ -16781,7 +16781,7 @@
           <p:cNvPr id="7" name="TextBox 6">
             <a:extLst xmlns:a="http://schemas.openxmlformats.org/drawingml/2006/main">
               <a:ext uri="{FF2B5EF4-FFF2-40B4-BE49-F238E27FC236}">
-                <a16:creationId xmlns:a16="http://schemas.microsoft.com/office/drawing/2014/main" id="{F5487946-D63A-44FB-8C8A-A27D0155D61E}"/>
+                <a16:creationId xmlns:a16="http://schemas.microsoft.com/office/drawing/2014/main" id="{C330DD02-22D6-4CDA-B680-4CE6F7FE15B0}"/>
               </a:ext>
             </a:extLst>
           </p:cNvPr>
@@ -17268,7 +17268,7 @@
           <p:cNvPr id="9" name="TextBox 8">
             <a:extLst xmlns:a="http://schemas.openxmlformats.org/drawingml/2006/main">
               <a:ext uri="{FF2B5EF4-FFF2-40B4-BE49-F238E27FC236}">
-                <a16:creationId xmlns:a16="http://schemas.microsoft.com/office/drawing/2014/main" id="{11138F25-A2D8-431A-81B8-8A9DD1539BE1}"/>
+                <a16:creationId xmlns:a16="http://schemas.microsoft.com/office/drawing/2014/main" id="{542CF62A-A755-4022-BAAB-024BBA495F4B}"/>
               </a:ext>
             </a:extLst>
           </p:cNvPr>
@@ -17313,7 +17313,7 @@
     </p:spTree>
     <p:extLst>
       <p:ext uri="{BB962C8B-B14F-4D97-AF65-F5344CB8AC3E}">
-        <p14:creationId xmlns:p14="http://schemas.microsoft.com/office/powerpoint/2010/main" val="1240088644"/>
+        <p14:creationId xmlns:p14="http://schemas.microsoft.com/office/powerpoint/2010/main" val="729815906"/>
       </p:ext>
     </p:extLst>
   </p:cSld>
@@ -17337,7 +17337,7 @@
           <p:cNvPr id="2" name="TextBox 1">
             <a:extLst xmlns:a="http://schemas.openxmlformats.org/drawingml/2006/main">
               <a:ext uri="{FF2B5EF4-FFF2-40B4-BE49-F238E27FC236}">
-                <a16:creationId xmlns:a16="http://schemas.microsoft.com/office/drawing/2014/main" id="{E8D75A87-E60A-40A8-863D-3FC88E05E2F2}"/>
+                <a16:creationId xmlns:a16="http://schemas.microsoft.com/office/drawing/2014/main" id="{F211D6FB-AEDC-417F-8C07-0B8FD3C97F8C}"/>
               </a:ext>
             </a:extLst>
           </p:cNvPr>
@@ -17384,7 +17384,7 @@
           <p:cNvPr id="3" name="TextBox 2">
             <a:extLst xmlns:a="http://schemas.openxmlformats.org/drawingml/2006/main">
               <a:ext uri="{FF2B5EF4-FFF2-40B4-BE49-F238E27FC236}">
-                <a16:creationId xmlns:a16="http://schemas.microsoft.com/office/drawing/2014/main" id="{3A5F2887-7033-41C3-BA75-6874578B8A9A}"/>
+                <a16:creationId xmlns:a16="http://schemas.microsoft.com/office/drawing/2014/main" id="{288FB995-2DD6-4117-A2A0-FF5CF5F80574}"/>
               </a:ext>
             </a:extLst>
           </p:cNvPr>
@@ -17431,7 +17431,7 @@
           <p:cNvPr id="4" name="Rectangle 3">
             <a:extLst xmlns:a="http://schemas.openxmlformats.org/drawingml/2006/main">
               <a:ext uri="{FF2B5EF4-FFF2-40B4-BE49-F238E27FC236}">
-                <a16:creationId xmlns:a16="http://schemas.microsoft.com/office/drawing/2014/main" id="{51229D39-7823-4082-B0BF-B4B5031AAB32}"/>
+                <a16:creationId xmlns:a16="http://schemas.microsoft.com/office/drawing/2014/main" id="{CBCEA591-F028-4BA8-B5E9-A4DDD5FDE1E5}"/>
               </a:ext>
             </a:extLst>
           </p:cNvPr>
@@ -17486,7 +17486,7 @@
           <p:cNvPr id="5" name="Rectangle 4">
             <a:extLst xmlns:a="http://schemas.openxmlformats.org/drawingml/2006/main">
               <a:ext uri="{FF2B5EF4-FFF2-40B4-BE49-F238E27FC236}">
-                <a16:creationId xmlns:a16="http://schemas.microsoft.com/office/drawing/2014/main" id="{E50E1835-613B-416C-BC7B-48190EF1C24A}"/>
+                <a16:creationId xmlns:a16="http://schemas.microsoft.com/office/drawing/2014/main" id="{47D29226-2141-4087-8921-86F3B9D8615C}"/>
               </a:ext>
             </a:extLst>
           </p:cNvPr>
@@ -17541,7 +17541,7 @@
           <p:cNvPr id="6" name="TextBox 5">
             <a:extLst xmlns:a="http://schemas.openxmlformats.org/drawingml/2006/main">
               <a:ext uri="{FF2B5EF4-FFF2-40B4-BE49-F238E27FC236}">
-                <a16:creationId xmlns:a16="http://schemas.microsoft.com/office/drawing/2014/main" id="{A454BFF3-9B91-4865-8F6C-A85BFD51816E}"/>
+                <a16:creationId xmlns:a16="http://schemas.microsoft.com/office/drawing/2014/main" id="{B3E413BF-9D22-455E-AB23-723C4B21B13C}"/>
               </a:ext>
             </a:extLst>
           </p:cNvPr>
@@ -17578,7 +17578,7 @@
                 <a:ea typeface="Aptos"/>
                 <a:cs typeface="Aptos"/>
               </a:rPr>
-              <a:t>Independent public evidence summary · 2026.07.22-9 · 2026-07-22 · Sources: EP3032975B2; 7 O 3341/24</a:t>
+              <a:t>Independent public evidence summary · 2026.07.23-10 · 2026-07-22 · Sources: EP3032975B2; 7 O 3341/24</a:t>
             </a:r>
           </a:p>
         </p:txBody>
@@ -17588,7 +17588,7 @@
           <p:cNvPr id="7" name="TextBox 6">
             <a:extLst xmlns:a="http://schemas.openxmlformats.org/drawingml/2006/main">
               <a:ext uri="{FF2B5EF4-FFF2-40B4-BE49-F238E27FC236}">
-                <a16:creationId xmlns:a16="http://schemas.microsoft.com/office/drawing/2014/main" id="{6E931DB9-A87D-49CE-BA4A-1714BD9C50AB}"/>
+                <a16:creationId xmlns:a16="http://schemas.microsoft.com/office/drawing/2014/main" id="{EF92FF94-FD40-4922-9233-3D61DACE9B7D}"/>
               </a:ext>
             </a:extLst>
           </p:cNvPr>
@@ -17635,7 +17635,7 @@
           <p:cNvPr id="8" name="Rounded Rectangle 7">
             <a:extLst xmlns:a="http://schemas.openxmlformats.org/drawingml/2006/main">
               <a:ext uri="{FF2B5EF4-FFF2-40B4-BE49-F238E27FC236}">
-                <a16:creationId xmlns:a16="http://schemas.microsoft.com/office/drawing/2014/main" id="{03160B88-B59F-4BB8-A89A-DBCFD40E9348}"/>
+                <a16:creationId xmlns:a16="http://schemas.microsoft.com/office/drawing/2014/main" id="{9B914660-52AA-46DE-A118-4B900FFDE37E}"/>
               </a:ext>
             </a:extLst>
           </p:cNvPr>
@@ -17692,7 +17692,7 @@
           <p:cNvPr id="9" name="TextBox 8">
             <a:extLst xmlns:a="http://schemas.openxmlformats.org/drawingml/2006/main">
               <a:ext uri="{FF2B5EF4-FFF2-40B4-BE49-F238E27FC236}">
-                <a16:creationId xmlns:a16="http://schemas.microsoft.com/office/drawing/2014/main" id="{5A00457D-CE7C-44FB-847A-85E06200B06F}"/>
+                <a16:creationId xmlns:a16="http://schemas.microsoft.com/office/drawing/2014/main" id="{9D56DB96-49AA-4FFF-9BC0-EF1DEFC428E7}"/>
               </a:ext>
             </a:extLst>
           </p:cNvPr>
@@ -17739,7 +17739,7 @@
           <p:cNvPr id="10" name="TextBox 9">
             <a:extLst xmlns:a="http://schemas.openxmlformats.org/drawingml/2006/main">
               <a:ext uri="{FF2B5EF4-FFF2-40B4-BE49-F238E27FC236}">
-                <a16:creationId xmlns:a16="http://schemas.microsoft.com/office/drawing/2014/main" id="{DADDD63B-2A19-48CD-951A-7805C9FDBB58}"/>
+                <a16:creationId xmlns:a16="http://schemas.microsoft.com/office/drawing/2014/main" id="{8179FF3E-3A1C-4C34-B0B8-E00EECEB77CB}"/>
               </a:ext>
             </a:extLst>
           </p:cNvPr>
@@ -17786,7 +17786,7 @@
           <p:cNvPr id="11" name="TextBox 10">
             <a:extLst xmlns:a="http://schemas.openxmlformats.org/drawingml/2006/main">
               <a:ext uri="{FF2B5EF4-FFF2-40B4-BE49-F238E27FC236}">
-                <a16:creationId xmlns:a16="http://schemas.microsoft.com/office/drawing/2014/main" id="{5015F019-8087-442A-BBAD-5CD167F57991}"/>
+                <a16:creationId xmlns:a16="http://schemas.microsoft.com/office/drawing/2014/main" id="{AE46ED1A-4DDF-40A2-903F-8A17B84725A4}"/>
               </a:ext>
             </a:extLst>
           </p:cNvPr>
@@ -17833,7 +17833,7 @@
           <p:cNvPr id="12" name="Rounded Rectangle 11">
             <a:extLst xmlns:a="http://schemas.openxmlformats.org/drawingml/2006/main">
               <a:ext uri="{FF2B5EF4-FFF2-40B4-BE49-F238E27FC236}">
-                <a16:creationId xmlns:a16="http://schemas.microsoft.com/office/drawing/2014/main" id="{4A815717-894A-4C12-834F-9291A24896BF}"/>
+                <a16:creationId xmlns:a16="http://schemas.microsoft.com/office/drawing/2014/main" id="{F2448030-76EE-414F-8C86-25A07A09B75C}"/>
               </a:ext>
             </a:extLst>
           </p:cNvPr>
@@ -17890,7 +17890,7 @@
           <p:cNvPr id="13" name="TextBox 12">
             <a:extLst xmlns:a="http://schemas.openxmlformats.org/drawingml/2006/main">
               <a:ext uri="{FF2B5EF4-FFF2-40B4-BE49-F238E27FC236}">
-                <a16:creationId xmlns:a16="http://schemas.microsoft.com/office/drawing/2014/main" id="{1B2FF549-C939-4FEF-BF83-7701C0F9E5B6}"/>
+                <a16:creationId xmlns:a16="http://schemas.microsoft.com/office/drawing/2014/main" id="{62869C3A-2558-408C-BD6B-1D80CAC1F1D0}"/>
               </a:ext>
             </a:extLst>
           </p:cNvPr>
@@ -17937,7 +17937,7 @@
           <p:cNvPr id="14" name="TextBox 13">
             <a:extLst xmlns:a="http://schemas.openxmlformats.org/drawingml/2006/main">
               <a:ext uri="{FF2B5EF4-FFF2-40B4-BE49-F238E27FC236}">
-                <a16:creationId xmlns:a16="http://schemas.microsoft.com/office/drawing/2014/main" id="{4F9A56E8-0DE4-412E-B00A-20446FCC24D1}"/>
+                <a16:creationId xmlns:a16="http://schemas.microsoft.com/office/drawing/2014/main" id="{608D1C0D-7891-468A-B3CF-BD152FF7104F}"/>
               </a:ext>
             </a:extLst>
           </p:cNvPr>
@@ -17984,7 +17984,7 @@
           <p:cNvPr id="15" name="TextBox 14">
             <a:extLst xmlns:a="http://schemas.openxmlformats.org/drawingml/2006/main">
               <a:ext uri="{FF2B5EF4-FFF2-40B4-BE49-F238E27FC236}">
-                <a16:creationId xmlns:a16="http://schemas.microsoft.com/office/drawing/2014/main" id="{451863E0-9137-4E73-A868-407823AD13BA}"/>
+                <a16:creationId xmlns:a16="http://schemas.microsoft.com/office/drawing/2014/main" id="{9A3A09B7-6088-4468-B821-48C4CF757B70}"/>
               </a:ext>
             </a:extLst>
           </p:cNvPr>
@@ -18031,7 +18031,7 @@
           <p:cNvPr id="16" name="Rounded Rectangle 15">
             <a:extLst xmlns:a="http://schemas.openxmlformats.org/drawingml/2006/main">
               <a:ext uri="{FF2B5EF4-FFF2-40B4-BE49-F238E27FC236}">
-                <a16:creationId xmlns:a16="http://schemas.microsoft.com/office/drawing/2014/main" id="{AB60F21B-7613-4F7A-8BE4-0209FA846135}"/>
+                <a16:creationId xmlns:a16="http://schemas.microsoft.com/office/drawing/2014/main" id="{EDD116F9-824E-4DAE-8A57-50F10E4F2FC4}"/>
               </a:ext>
             </a:extLst>
           </p:cNvPr>
@@ -18088,7 +18088,7 @@
           <p:cNvPr id="17" name="TextBox 16">
             <a:extLst xmlns:a="http://schemas.openxmlformats.org/drawingml/2006/main">
               <a:ext uri="{FF2B5EF4-FFF2-40B4-BE49-F238E27FC236}">
-                <a16:creationId xmlns:a16="http://schemas.microsoft.com/office/drawing/2014/main" id="{9A1F3B46-46C6-48DC-A545-6176E8E50308}"/>
+                <a16:creationId xmlns:a16="http://schemas.microsoft.com/office/drawing/2014/main" id="{454BD2CB-CFFB-4FF0-9E9A-870B696830E4}"/>
               </a:ext>
             </a:extLst>
           </p:cNvPr>
@@ -18135,7 +18135,7 @@
           <p:cNvPr id="18" name="TextBox 17">
             <a:extLst xmlns:a="http://schemas.openxmlformats.org/drawingml/2006/main">
               <a:ext uri="{FF2B5EF4-FFF2-40B4-BE49-F238E27FC236}">
-                <a16:creationId xmlns:a16="http://schemas.microsoft.com/office/drawing/2014/main" id="{0E8818AE-E36A-4BCE-8B60-BD7518EBB529}"/>
+                <a16:creationId xmlns:a16="http://schemas.microsoft.com/office/drawing/2014/main" id="{07FEC64A-9CE7-4294-9D18-966ACD1AB1E3}"/>
               </a:ext>
             </a:extLst>
           </p:cNvPr>
@@ -18182,7 +18182,7 @@
           <p:cNvPr id="19" name="TextBox 18">
             <a:extLst xmlns:a="http://schemas.openxmlformats.org/drawingml/2006/main">
               <a:ext uri="{FF2B5EF4-FFF2-40B4-BE49-F238E27FC236}">
-                <a16:creationId xmlns:a16="http://schemas.microsoft.com/office/drawing/2014/main" id="{20BD3A17-44B8-42EA-9B2C-249CFDFC23CC}"/>
+                <a16:creationId xmlns:a16="http://schemas.microsoft.com/office/drawing/2014/main" id="{10171992-BF37-4642-80BF-AD829711EF53}"/>
               </a:ext>
             </a:extLst>
           </p:cNvPr>
@@ -18229,7 +18229,7 @@
           <p:cNvPr id="20" name="Rounded Rectangle 19">
             <a:extLst xmlns:a="http://schemas.openxmlformats.org/drawingml/2006/main">
               <a:ext uri="{FF2B5EF4-FFF2-40B4-BE49-F238E27FC236}">
-                <a16:creationId xmlns:a16="http://schemas.microsoft.com/office/drawing/2014/main" id="{AFE5E6C1-6216-490A-87D3-7605C9F071A4}"/>
+                <a16:creationId xmlns:a16="http://schemas.microsoft.com/office/drawing/2014/main" id="{C9370CB4-DD46-415F-A8A6-FCEE4143A35F}"/>
               </a:ext>
             </a:extLst>
           </p:cNvPr>
@@ -18286,7 +18286,7 @@
           <p:cNvPr id="21" name="TextBox 20">
             <a:extLst xmlns:a="http://schemas.openxmlformats.org/drawingml/2006/main">
               <a:ext uri="{FF2B5EF4-FFF2-40B4-BE49-F238E27FC236}">
-                <a16:creationId xmlns:a16="http://schemas.microsoft.com/office/drawing/2014/main" id="{C6628B6A-2405-4AE7-993D-0709CD6F06B4}"/>
+                <a16:creationId xmlns:a16="http://schemas.microsoft.com/office/drawing/2014/main" id="{1E20B19F-5618-41DF-8BBD-FE01CD94FF48}"/>
               </a:ext>
             </a:extLst>
           </p:cNvPr>
@@ -18333,7 +18333,7 @@
           <p:cNvPr id="22" name="TextBox 21">
             <a:extLst xmlns:a="http://schemas.openxmlformats.org/drawingml/2006/main">
               <a:ext uri="{FF2B5EF4-FFF2-40B4-BE49-F238E27FC236}">
-                <a16:creationId xmlns:a16="http://schemas.microsoft.com/office/drawing/2014/main" id="{78CB31B6-3C24-454B-BCB0-242972C2583A}"/>
+                <a16:creationId xmlns:a16="http://schemas.microsoft.com/office/drawing/2014/main" id="{881D8A73-35EF-405F-A065-14B3A183705B}"/>
               </a:ext>
             </a:extLst>
           </p:cNvPr>
@@ -18380,7 +18380,7 @@
           <p:cNvPr id="23" name="TextBox 22">
             <a:extLst xmlns:a="http://schemas.openxmlformats.org/drawingml/2006/main">
               <a:ext uri="{FF2B5EF4-FFF2-40B4-BE49-F238E27FC236}">
-                <a16:creationId xmlns:a16="http://schemas.microsoft.com/office/drawing/2014/main" id="{5C3E021B-E459-46E5-866F-A7EE1C8E6B61}"/>
+                <a16:creationId xmlns:a16="http://schemas.microsoft.com/office/drawing/2014/main" id="{7ABEBF89-28A0-4B8A-9DF2-B9D2C9D62322}"/>
               </a:ext>
             </a:extLst>
           </p:cNvPr>
@@ -18427,7 +18427,7 @@
           <p:cNvPr id="24" name="TextBox 23">
             <a:extLst xmlns:a="http://schemas.openxmlformats.org/drawingml/2006/main">
               <a:ext uri="{FF2B5EF4-FFF2-40B4-BE49-F238E27FC236}">
-                <a16:creationId xmlns:a16="http://schemas.microsoft.com/office/drawing/2014/main" id="{2881B841-623D-42CB-B52D-6BAA8B0A9AC3}"/>
+                <a16:creationId xmlns:a16="http://schemas.microsoft.com/office/drawing/2014/main" id="{D1A515DC-75CA-44A4-83FA-91C839C79D4A}"/>
               </a:ext>
             </a:extLst>
           </p:cNvPr>
@@ -18472,7 +18472,7 @@
     </p:spTree>
     <p:extLst>
       <p:ext uri="{BB962C8B-B14F-4D97-AF65-F5344CB8AC3E}">
-        <p14:creationId xmlns:p14="http://schemas.microsoft.com/office/powerpoint/2010/main" val="1540590765"/>
+        <p14:creationId xmlns:p14="http://schemas.microsoft.com/office/powerpoint/2010/main" val="917983250"/>
       </p:ext>
     </p:extLst>
   </p:cSld>
@@ -18496,7 +18496,7 @@
           <p:cNvPr id="2" name="TextBox 1">
             <a:extLst xmlns:a="http://schemas.openxmlformats.org/drawingml/2006/main">
               <a:ext uri="{FF2B5EF4-FFF2-40B4-BE49-F238E27FC236}">
-                <a16:creationId xmlns:a16="http://schemas.microsoft.com/office/drawing/2014/main" id="{6006C4E8-B78E-474D-A7C6-9AB15900715D}"/>
+                <a16:creationId xmlns:a16="http://schemas.microsoft.com/office/drawing/2014/main" id="{5767BC29-4602-4D16-9A51-F04B1FB3DEF6}"/>
               </a:ext>
             </a:extLst>
           </p:cNvPr>
@@ -18543,7 +18543,7 @@
           <p:cNvPr id="3" name="TextBox 2">
             <a:extLst xmlns:a="http://schemas.openxmlformats.org/drawingml/2006/main">
               <a:ext uri="{FF2B5EF4-FFF2-40B4-BE49-F238E27FC236}">
-                <a16:creationId xmlns:a16="http://schemas.microsoft.com/office/drawing/2014/main" id="{761CA223-E18E-4892-AAB2-12240B210DC5}"/>
+                <a16:creationId xmlns:a16="http://schemas.microsoft.com/office/drawing/2014/main" id="{13B89AEC-D60D-4E70-8300-A6613FAFC26E}"/>
               </a:ext>
             </a:extLst>
           </p:cNvPr>
@@ -18590,7 +18590,7 @@
           <p:cNvPr id="4" name="Rectangle 3">
             <a:extLst xmlns:a="http://schemas.openxmlformats.org/drawingml/2006/main">
               <a:ext uri="{FF2B5EF4-FFF2-40B4-BE49-F238E27FC236}">
-                <a16:creationId xmlns:a16="http://schemas.microsoft.com/office/drawing/2014/main" id="{E285A37D-1E96-4E10-8B28-2BC93FDD17ED}"/>
+                <a16:creationId xmlns:a16="http://schemas.microsoft.com/office/drawing/2014/main" id="{218AAA1C-F2B6-4CB0-A3ED-1237583BEA0E}"/>
               </a:ext>
             </a:extLst>
           </p:cNvPr>
@@ -18645,7 +18645,7 @@
           <p:cNvPr id="5" name="Rectangle 4">
             <a:extLst xmlns:a="http://schemas.openxmlformats.org/drawingml/2006/main">
               <a:ext uri="{FF2B5EF4-FFF2-40B4-BE49-F238E27FC236}">
-                <a16:creationId xmlns:a16="http://schemas.microsoft.com/office/drawing/2014/main" id="{E6744067-E5D3-406A-ACED-6654EFED4797}"/>
+                <a16:creationId xmlns:a16="http://schemas.microsoft.com/office/drawing/2014/main" id="{D549CF2B-3E7D-41A4-85A8-D48655DBC43A}"/>
               </a:ext>
             </a:extLst>
           </p:cNvPr>
@@ -18700,7 +18700,7 @@
           <p:cNvPr id="6" name="TextBox 5">
             <a:extLst xmlns:a="http://schemas.openxmlformats.org/drawingml/2006/main">
               <a:ext uri="{FF2B5EF4-FFF2-40B4-BE49-F238E27FC236}">
-                <a16:creationId xmlns:a16="http://schemas.microsoft.com/office/drawing/2014/main" id="{D0FBEEA0-01A4-4426-8E06-A16F809A0E38}"/>
+                <a16:creationId xmlns:a16="http://schemas.microsoft.com/office/drawing/2014/main" id="{C8CB780B-C0BD-472C-90F3-50FD5766F8D8}"/>
               </a:ext>
             </a:extLst>
           </p:cNvPr>
@@ -18737,7 +18737,7 @@
                 <a:ea typeface="Aptos"/>
                 <a:cs typeface="Aptos"/>
               </a:rPr>
-              <a:t>Independent public evidence summary · 2026.07.22-9 · 2026-07-22 · Sources: WIPO dispute resolution; EPO IPscore</a:t>
+              <a:t>Independent public evidence summary · 2026.07.23-10 · 2026-07-22 · Sources: WIPO dispute resolution; EPO IPscore</a:t>
             </a:r>
           </a:p>
         </p:txBody>
@@ -18747,7 +18747,7 @@
           <p:cNvPr id="7" name="TextBox 6">
             <a:extLst xmlns:a="http://schemas.openxmlformats.org/drawingml/2006/main">
               <a:ext uri="{FF2B5EF4-FFF2-40B4-BE49-F238E27FC236}">
-                <a16:creationId xmlns:a16="http://schemas.microsoft.com/office/drawing/2014/main" id="{96CF3C17-8E54-4F52-B92E-CA155913C110}"/>
+                <a16:creationId xmlns:a16="http://schemas.microsoft.com/office/drawing/2014/main" id="{D5A566C2-B712-41DE-BB52-F4EC35474259}"/>
               </a:ext>
             </a:extLst>
           </p:cNvPr>
@@ -18794,7 +18794,7 @@
           <p:cNvPr id="8" name="Rounded Rectangle 7">
             <a:extLst xmlns:a="http://schemas.openxmlformats.org/drawingml/2006/main">
               <a:ext uri="{FF2B5EF4-FFF2-40B4-BE49-F238E27FC236}">
-                <a16:creationId xmlns:a16="http://schemas.microsoft.com/office/drawing/2014/main" id="{0FB95883-4349-43E1-B772-D7F6167CB408}"/>
+                <a16:creationId xmlns:a16="http://schemas.microsoft.com/office/drawing/2014/main" id="{F00C757F-740D-43DE-9BAF-D639DE606369}"/>
               </a:ext>
             </a:extLst>
           </p:cNvPr>
@@ -18851,7 +18851,7 @@
           <p:cNvPr id="9" name="TextBox 8">
             <a:extLst xmlns:a="http://schemas.openxmlformats.org/drawingml/2006/main">
               <a:ext uri="{FF2B5EF4-FFF2-40B4-BE49-F238E27FC236}">
-                <a16:creationId xmlns:a16="http://schemas.microsoft.com/office/drawing/2014/main" id="{FB9890FB-1F91-4B59-977C-1F6B018B219E}"/>
+                <a16:creationId xmlns:a16="http://schemas.microsoft.com/office/drawing/2014/main" id="{F6E40714-6C6B-4895-B135-18A644D435FA}"/>
               </a:ext>
             </a:extLst>
           </p:cNvPr>
@@ -18898,7 +18898,7 @@
           <p:cNvPr id="10" name="TextBox 9">
             <a:extLst xmlns:a="http://schemas.openxmlformats.org/drawingml/2006/main">
               <a:ext uri="{FF2B5EF4-FFF2-40B4-BE49-F238E27FC236}">
-                <a16:creationId xmlns:a16="http://schemas.microsoft.com/office/drawing/2014/main" id="{55CD40FB-48AC-493B-8B8D-A8A87585EC4C}"/>
+                <a16:creationId xmlns:a16="http://schemas.microsoft.com/office/drawing/2014/main" id="{AFFF1FFB-F068-4A5B-BB18-CD9CF8AC91B2}"/>
               </a:ext>
             </a:extLst>
           </p:cNvPr>
@@ -18945,7 +18945,7 @@
           <p:cNvPr id="11" name="TextBox 10">
             <a:extLst xmlns:a="http://schemas.openxmlformats.org/drawingml/2006/main">
               <a:ext uri="{FF2B5EF4-FFF2-40B4-BE49-F238E27FC236}">
-                <a16:creationId xmlns:a16="http://schemas.microsoft.com/office/drawing/2014/main" id="{9533DB97-B3F5-4DEE-8ACC-565693A68F43}"/>
+                <a16:creationId xmlns:a16="http://schemas.microsoft.com/office/drawing/2014/main" id="{C08DDD2D-C31A-44BD-BCAE-D55E4634C6B5}"/>
               </a:ext>
             </a:extLst>
           </p:cNvPr>
@@ -18992,7 +18992,7 @@
           <p:cNvPr id="12" name="Rounded Rectangle 11">
             <a:extLst xmlns:a="http://schemas.openxmlformats.org/drawingml/2006/main">
               <a:ext uri="{FF2B5EF4-FFF2-40B4-BE49-F238E27FC236}">
-                <a16:creationId xmlns:a16="http://schemas.microsoft.com/office/drawing/2014/main" id="{C7B6FA47-0A7A-44A9-8487-675A994299C1}"/>
+                <a16:creationId xmlns:a16="http://schemas.microsoft.com/office/drawing/2014/main" id="{9468DD32-4EF7-4C13-929E-A926F1B7511B}"/>
               </a:ext>
             </a:extLst>
           </p:cNvPr>
@@ -19049,7 +19049,7 @@
           <p:cNvPr id="13" name="TextBox 12">
             <a:extLst xmlns:a="http://schemas.openxmlformats.org/drawingml/2006/main">
               <a:ext uri="{FF2B5EF4-FFF2-40B4-BE49-F238E27FC236}">
-                <a16:creationId xmlns:a16="http://schemas.microsoft.com/office/drawing/2014/main" id="{C651A65E-E926-4FDA-B9BF-5E5DC3145237}"/>
+                <a16:creationId xmlns:a16="http://schemas.microsoft.com/office/drawing/2014/main" id="{D8A376C3-9FFB-4682-A020-BB13B4555242}"/>
               </a:ext>
             </a:extLst>
           </p:cNvPr>
@@ -19096,7 +19096,7 @@
           <p:cNvPr id="14" name="TextBox 13">
             <a:extLst xmlns:a="http://schemas.openxmlformats.org/drawingml/2006/main">
               <a:ext uri="{FF2B5EF4-FFF2-40B4-BE49-F238E27FC236}">
-                <a16:creationId xmlns:a16="http://schemas.microsoft.com/office/drawing/2014/main" id="{01A10754-59B5-48B0-A23D-7220B16BD5A1}"/>
+                <a16:creationId xmlns:a16="http://schemas.microsoft.com/office/drawing/2014/main" id="{8CCCBF04-777D-43F7-8203-6E75581A0429}"/>
               </a:ext>
             </a:extLst>
           </p:cNvPr>
@@ -19143,7 +19143,7 @@
           <p:cNvPr id="15" name="TextBox 14">
             <a:extLst xmlns:a="http://schemas.openxmlformats.org/drawingml/2006/main">
               <a:ext uri="{FF2B5EF4-FFF2-40B4-BE49-F238E27FC236}">
-                <a16:creationId xmlns:a16="http://schemas.microsoft.com/office/drawing/2014/main" id="{0E47101D-7AF9-4F30-B81B-B5319BDBD370}"/>
+                <a16:creationId xmlns:a16="http://schemas.microsoft.com/office/drawing/2014/main" id="{00459F79-8175-4ACD-8B24-91E241ED8B12}"/>
               </a:ext>
             </a:extLst>
           </p:cNvPr>
@@ -19190,7 +19190,7 @@
           <p:cNvPr id="16" name="Rounded Rectangle 15">
             <a:extLst xmlns:a="http://schemas.openxmlformats.org/drawingml/2006/main">
               <a:ext uri="{FF2B5EF4-FFF2-40B4-BE49-F238E27FC236}">
-                <a16:creationId xmlns:a16="http://schemas.microsoft.com/office/drawing/2014/main" id="{83DDF465-966F-42C8-A212-F05648A1F74B}"/>
+                <a16:creationId xmlns:a16="http://schemas.microsoft.com/office/drawing/2014/main" id="{394754CA-D8EC-440F-BB89-C9110C9EFF2A}"/>
               </a:ext>
             </a:extLst>
           </p:cNvPr>
@@ -19247,7 +19247,7 @@
           <p:cNvPr id="17" name="TextBox 16">
             <a:extLst xmlns:a="http://schemas.openxmlformats.org/drawingml/2006/main">
               <a:ext uri="{FF2B5EF4-FFF2-40B4-BE49-F238E27FC236}">
-                <a16:creationId xmlns:a16="http://schemas.microsoft.com/office/drawing/2014/main" id="{7DF1812A-E692-4B32-A053-7A40546F14A9}"/>
+                <a16:creationId xmlns:a16="http://schemas.microsoft.com/office/drawing/2014/main" id="{9F036AFC-547E-48C9-96CC-556E56298DE1}"/>
               </a:ext>
             </a:extLst>
           </p:cNvPr>
@@ -19294,7 +19294,7 @@
           <p:cNvPr id="18" name="TextBox 17">
             <a:extLst xmlns:a="http://schemas.openxmlformats.org/drawingml/2006/main">
               <a:ext uri="{FF2B5EF4-FFF2-40B4-BE49-F238E27FC236}">
-                <a16:creationId xmlns:a16="http://schemas.microsoft.com/office/drawing/2014/main" id="{0E180A76-B1EA-4651-B686-31A97EC0A4A7}"/>
+                <a16:creationId xmlns:a16="http://schemas.microsoft.com/office/drawing/2014/main" id="{D676F299-9373-4548-8D9A-8C55B9AEE8C2}"/>
               </a:ext>
             </a:extLst>
           </p:cNvPr>
@@ -19341,7 +19341,7 @@
           <p:cNvPr id="19" name="TextBox 18">
             <a:extLst xmlns:a="http://schemas.openxmlformats.org/drawingml/2006/main">
               <a:ext uri="{FF2B5EF4-FFF2-40B4-BE49-F238E27FC236}">
-                <a16:creationId xmlns:a16="http://schemas.microsoft.com/office/drawing/2014/main" id="{3129954E-B4DC-4B27-A880-9FEB1D0C52F7}"/>
+                <a16:creationId xmlns:a16="http://schemas.microsoft.com/office/drawing/2014/main" id="{7DB08B5B-8FAB-4482-BFA8-487FBE382697}"/>
               </a:ext>
             </a:extLst>
           </p:cNvPr>
@@ -19388,7 +19388,7 @@
           <p:cNvPr id="20" name="Rounded Rectangle 19">
             <a:extLst xmlns:a="http://schemas.openxmlformats.org/drawingml/2006/main">
               <a:ext uri="{FF2B5EF4-FFF2-40B4-BE49-F238E27FC236}">
-                <a16:creationId xmlns:a16="http://schemas.microsoft.com/office/drawing/2014/main" id="{976229AF-CDFE-437B-B7A4-E967449C6029}"/>
+                <a16:creationId xmlns:a16="http://schemas.microsoft.com/office/drawing/2014/main" id="{33F3FD50-1ABB-4BCB-B6D6-3D117712676C}"/>
               </a:ext>
             </a:extLst>
           </p:cNvPr>
@@ -19445,7 +19445,7 @@
           <p:cNvPr id="21" name="TextBox 20">
             <a:extLst xmlns:a="http://schemas.openxmlformats.org/drawingml/2006/main">
               <a:ext uri="{FF2B5EF4-FFF2-40B4-BE49-F238E27FC236}">
-                <a16:creationId xmlns:a16="http://schemas.microsoft.com/office/drawing/2014/main" id="{B2FC2DC8-E230-47A1-A90B-60D7A91307BF}"/>
+                <a16:creationId xmlns:a16="http://schemas.microsoft.com/office/drawing/2014/main" id="{384AEB7A-5688-4EDC-BF83-F864B3581923}"/>
               </a:ext>
             </a:extLst>
           </p:cNvPr>
@@ -19492,7 +19492,7 @@
           <p:cNvPr id="22" name="TextBox 21">
             <a:extLst xmlns:a="http://schemas.openxmlformats.org/drawingml/2006/main">
               <a:ext uri="{FF2B5EF4-FFF2-40B4-BE49-F238E27FC236}">
-                <a16:creationId xmlns:a16="http://schemas.microsoft.com/office/drawing/2014/main" id="{2ADE84F0-6FD7-42C7-A06F-25FCCA5D25D7}"/>
+                <a16:creationId xmlns:a16="http://schemas.microsoft.com/office/drawing/2014/main" id="{099BAFAA-F7D8-43D1-B6A2-6E81555A122F}"/>
               </a:ext>
             </a:extLst>
           </p:cNvPr>
@@ -19539,7 +19539,7 @@
           <p:cNvPr id="23" name="TextBox 22">
             <a:extLst xmlns:a="http://schemas.openxmlformats.org/drawingml/2006/main">
               <a:ext uri="{FF2B5EF4-FFF2-40B4-BE49-F238E27FC236}">
-                <a16:creationId xmlns:a16="http://schemas.microsoft.com/office/drawing/2014/main" id="{0F632556-65EA-4E3F-B4C6-77732E2526CA}"/>
+                <a16:creationId xmlns:a16="http://schemas.microsoft.com/office/drawing/2014/main" id="{EAD9BB6F-D748-4F0B-A855-DD240AA01F48}"/>
               </a:ext>
             </a:extLst>
           </p:cNvPr>
@@ -19586,7 +19586,7 @@
           <p:cNvPr id="24" name="TextBox 23">
             <a:extLst xmlns:a="http://schemas.openxmlformats.org/drawingml/2006/main">
               <a:ext uri="{FF2B5EF4-FFF2-40B4-BE49-F238E27FC236}">
-                <a16:creationId xmlns:a16="http://schemas.microsoft.com/office/drawing/2014/main" id="{FB992DC0-8797-4350-B09E-AE47828A9392}"/>
+                <a16:creationId xmlns:a16="http://schemas.microsoft.com/office/drawing/2014/main" id="{DAF44827-F65D-4EFA-B816-B8A698ADB25E}"/>
               </a:ext>
             </a:extLst>
           </p:cNvPr>
@@ -19631,7 +19631,7 @@
     </p:spTree>
     <p:extLst>
       <p:ext uri="{BB962C8B-B14F-4D97-AF65-F5344CB8AC3E}">
-        <p14:creationId xmlns:p14="http://schemas.microsoft.com/office/powerpoint/2010/main" val="859806017"/>
+        <p14:creationId xmlns:p14="http://schemas.microsoft.com/office/powerpoint/2010/main" val="2087689409"/>
       </p:ext>
     </p:extLst>
   </p:cSld>
@@ -19655,7 +19655,7 @@
           <p:cNvPr id="2" name="TextBox 1">
             <a:extLst xmlns:a="http://schemas.openxmlformats.org/drawingml/2006/main">
               <a:ext uri="{FF2B5EF4-FFF2-40B4-BE49-F238E27FC236}">
-                <a16:creationId xmlns:a16="http://schemas.microsoft.com/office/drawing/2014/main" id="{71838222-A282-41FD-9B12-E064A020DA47}"/>
+                <a16:creationId xmlns:a16="http://schemas.microsoft.com/office/drawing/2014/main" id="{6A3401B0-FF00-4EB1-B2DD-16FEE9B7E236}"/>
               </a:ext>
             </a:extLst>
           </p:cNvPr>
@@ -19702,7 +19702,7 @@
           <p:cNvPr id="3" name="TextBox 2">
             <a:extLst xmlns:a="http://schemas.openxmlformats.org/drawingml/2006/main">
               <a:ext uri="{FF2B5EF4-FFF2-40B4-BE49-F238E27FC236}">
-                <a16:creationId xmlns:a16="http://schemas.microsoft.com/office/drawing/2014/main" id="{FF8FDAD1-FD54-42B8-A083-1A78415FC562}"/>
+                <a16:creationId xmlns:a16="http://schemas.microsoft.com/office/drawing/2014/main" id="{34573C6B-E0DE-4D04-8E97-3DCB860837E5}"/>
               </a:ext>
             </a:extLst>
           </p:cNvPr>
@@ -19749,7 +19749,7 @@
           <p:cNvPr id="4" name="Rectangle 3">
             <a:extLst xmlns:a="http://schemas.openxmlformats.org/drawingml/2006/main">
               <a:ext uri="{FF2B5EF4-FFF2-40B4-BE49-F238E27FC236}">
-                <a16:creationId xmlns:a16="http://schemas.microsoft.com/office/drawing/2014/main" id="{48BEE886-3729-4673-86C6-568C0EBA437C}"/>
+                <a16:creationId xmlns:a16="http://schemas.microsoft.com/office/drawing/2014/main" id="{4112A014-A753-4D0B-BDC2-A27700528009}"/>
               </a:ext>
             </a:extLst>
           </p:cNvPr>
@@ -19804,7 +19804,7 @@
           <p:cNvPr id="5" name="Rectangle 4">
             <a:extLst xmlns:a="http://schemas.openxmlformats.org/drawingml/2006/main">
               <a:ext uri="{FF2B5EF4-FFF2-40B4-BE49-F238E27FC236}">
-                <a16:creationId xmlns:a16="http://schemas.microsoft.com/office/drawing/2014/main" id="{B3AD91A6-E772-41C2-BD2D-02F501FCBC54}"/>
+                <a16:creationId xmlns:a16="http://schemas.microsoft.com/office/drawing/2014/main" id="{E47336BF-A4CB-4753-92E2-64A64E9FB342}"/>
               </a:ext>
             </a:extLst>
           </p:cNvPr>
@@ -19859,7 +19859,7 @@
           <p:cNvPr id="6" name="TextBox 5">
             <a:extLst xmlns:a="http://schemas.openxmlformats.org/drawingml/2006/main">
               <a:ext uri="{FF2B5EF4-FFF2-40B4-BE49-F238E27FC236}">
-                <a16:creationId xmlns:a16="http://schemas.microsoft.com/office/drawing/2014/main" id="{61AE0A7A-7FD6-40C4-BFEA-C974C5EEFB40}"/>
+                <a16:creationId xmlns:a16="http://schemas.microsoft.com/office/drawing/2014/main" id="{6C2907CA-1F51-4D16-8752-D5DD94BB99C3}"/>
               </a:ext>
             </a:extLst>
           </p:cNvPr>
@@ -19896,7 +19896,7 @@
                 <a:ea typeface="Aptos"/>
                 <a:cs typeface="Aptos"/>
               </a:rPr>
-              <a:t>Independent public evidence summary · 2026.07.22-9 · 2026-07-22 · Sources: WIPO licensing; IP Finance; TPLF mapping</a:t>
+              <a:t>Independent public evidence summary · 2026.07.23-10 · 2026-07-22 · Sources: WIPO licensing; IP Finance; TPLF mapping</a:t>
             </a:r>
           </a:p>
         </p:txBody>
@@ -19906,7 +19906,7 @@
           <p:cNvPr id="7" name="TextBox 6">
             <a:extLst xmlns:a="http://schemas.openxmlformats.org/drawingml/2006/main">
               <a:ext uri="{FF2B5EF4-FFF2-40B4-BE49-F238E27FC236}">
-                <a16:creationId xmlns:a16="http://schemas.microsoft.com/office/drawing/2014/main" id="{DAF7A2C1-663E-48B1-B7E6-A68AAE40D78C}"/>
+                <a16:creationId xmlns:a16="http://schemas.microsoft.com/office/drawing/2014/main" id="{81ABA7E3-650D-43BE-8AC5-4B743E47758C}"/>
               </a:ext>
             </a:extLst>
           </p:cNvPr>
@@ -20476,7 +20476,7 @@
           <p:cNvPr id="9" name="TextBox 8">
             <a:extLst xmlns:a="http://schemas.openxmlformats.org/drawingml/2006/main">
               <a:ext uri="{FF2B5EF4-FFF2-40B4-BE49-F238E27FC236}">
-                <a16:creationId xmlns:a16="http://schemas.microsoft.com/office/drawing/2014/main" id="{5F1A5A2C-E11F-4A67-BEE5-BE868D525B57}"/>
+                <a16:creationId xmlns:a16="http://schemas.microsoft.com/office/drawing/2014/main" id="{BD9749BA-0425-4F36-B462-F647472C01EE}"/>
               </a:ext>
             </a:extLst>
           </p:cNvPr>
@@ -20521,7 +20521,7 @@
     </p:spTree>
     <p:extLst>
       <p:ext uri="{BB962C8B-B14F-4D97-AF65-F5344CB8AC3E}">
-        <p14:creationId xmlns:p14="http://schemas.microsoft.com/office/powerpoint/2010/main" val="1079105360"/>
+        <p14:creationId xmlns:p14="http://schemas.microsoft.com/office/powerpoint/2010/main" val="1055359720"/>
       </p:ext>
     </p:extLst>
   </p:cSld>
@@ -20545,7 +20545,7 @@
           <p:cNvPr id="2" name="TextBox 1">
             <a:extLst xmlns:a="http://schemas.openxmlformats.org/drawingml/2006/main">
               <a:ext uri="{FF2B5EF4-FFF2-40B4-BE49-F238E27FC236}">
-                <a16:creationId xmlns:a16="http://schemas.microsoft.com/office/drawing/2014/main" id="{25F13E3D-FA26-4DDB-9E23-F34CB15AFE54}"/>
+                <a16:creationId xmlns:a16="http://schemas.microsoft.com/office/drawing/2014/main" id="{719DFD49-53E7-4A74-BE3A-6D796F6DE2A4}"/>
               </a:ext>
             </a:extLst>
           </p:cNvPr>
@@ -20592,7 +20592,7 @@
           <p:cNvPr id="3" name="TextBox 2">
             <a:extLst xmlns:a="http://schemas.openxmlformats.org/drawingml/2006/main">
               <a:ext uri="{FF2B5EF4-FFF2-40B4-BE49-F238E27FC236}">
-                <a16:creationId xmlns:a16="http://schemas.microsoft.com/office/drawing/2014/main" id="{F58939F6-6EC0-4F64-9CD3-94CD78E10222}"/>
+                <a16:creationId xmlns:a16="http://schemas.microsoft.com/office/drawing/2014/main" id="{0BB451CD-BBC6-4032-B687-7A4DCA4B4058}"/>
               </a:ext>
             </a:extLst>
           </p:cNvPr>
@@ -20639,7 +20639,7 @@
           <p:cNvPr id="4" name="Rectangle 3">
             <a:extLst xmlns:a="http://schemas.openxmlformats.org/drawingml/2006/main">
               <a:ext uri="{FF2B5EF4-FFF2-40B4-BE49-F238E27FC236}">
-                <a16:creationId xmlns:a16="http://schemas.microsoft.com/office/drawing/2014/main" id="{61FB9D3B-DEA3-4340-B365-3E2375E0A6E9}"/>
+                <a16:creationId xmlns:a16="http://schemas.microsoft.com/office/drawing/2014/main" id="{81E7987D-513A-4FCB-BD7E-165FFD36DA7F}"/>
               </a:ext>
             </a:extLst>
           </p:cNvPr>
@@ -20694,7 +20694,7 @@
           <p:cNvPr id="5" name="Rectangle 4">
             <a:extLst xmlns:a="http://schemas.openxmlformats.org/drawingml/2006/main">
               <a:ext uri="{FF2B5EF4-FFF2-40B4-BE49-F238E27FC236}">
-                <a16:creationId xmlns:a16="http://schemas.microsoft.com/office/drawing/2014/main" id="{288C1931-650F-4C77-A5CC-8B3876C33763}"/>
+                <a16:creationId xmlns:a16="http://schemas.microsoft.com/office/drawing/2014/main" id="{A50181CF-28F9-4A21-A74F-65DD492AF1B3}"/>
               </a:ext>
             </a:extLst>
           </p:cNvPr>
@@ -20749,7 +20749,7 @@
           <p:cNvPr id="6" name="TextBox 5">
             <a:extLst xmlns:a="http://schemas.openxmlformats.org/drawingml/2006/main">
               <a:ext uri="{FF2B5EF4-FFF2-40B4-BE49-F238E27FC236}">
-                <a16:creationId xmlns:a16="http://schemas.microsoft.com/office/drawing/2014/main" id="{4F3403B6-D0FB-4126-B951-95A4D3E5BB4B}"/>
+                <a16:creationId xmlns:a16="http://schemas.microsoft.com/office/drawing/2014/main" id="{FDECAD9F-7859-4A4E-B336-CD11B6697AE0}"/>
               </a:ext>
             </a:extLst>
           </p:cNvPr>
@@ -20786,7 +20786,7 @@
                 <a:ea typeface="Aptos"/>
                 <a:cs typeface="Aptos"/>
               </a:rPr>
-              <a:t>Independent public evidence summary · 2026.07.22-9 · 2026-07-22 · Sources: Evidence Register; WIPO valuation</a:t>
+              <a:t>Independent public evidence summary · 2026.07.23-10 · 2026-07-22 · Sources: Evidence Register; WIPO valuation</a:t>
             </a:r>
           </a:p>
         </p:txBody>
@@ -20796,7 +20796,7 @@
           <p:cNvPr id="7" name="TextBox 6">
             <a:extLst xmlns:a="http://schemas.openxmlformats.org/drawingml/2006/main">
               <a:ext uri="{FF2B5EF4-FFF2-40B4-BE49-F238E27FC236}">
-                <a16:creationId xmlns:a16="http://schemas.microsoft.com/office/drawing/2014/main" id="{6DAC56FE-A8E1-4F11-B610-7840E739A8E6}"/>
+                <a16:creationId xmlns:a16="http://schemas.microsoft.com/office/drawing/2014/main" id="{ECD341ED-38BC-426E-B698-043DF39C62A0}"/>
               </a:ext>
             </a:extLst>
           </p:cNvPr>
@@ -21449,7 +21449,7 @@
           <p:cNvPr id="9" name="TextBox 8">
             <a:extLst xmlns:a="http://schemas.openxmlformats.org/drawingml/2006/main">
               <a:ext uri="{FF2B5EF4-FFF2-40B4-BE49-F238E27FC236}">
-                <a16:creationId xmlns:a16="http://schemas.microsoft.com/office/drawing/2014/main" id="{392FDC02-EB16-4547-B8F1-4C3795FA63AC}"/>
+                <a16:creationId xmlns:a16="http://schemas.microsoft.com/office/drawing/2014/main" id="{9E6BC743-41B8-4F96-8C2D-C95DF4834913}"/>
               </a:ext>
             </a:extLst>
           </p:cNvPr>
@@ -21494,7 +21494,7 @@
     </p:spTree>
     <p:extLst>
       <p:ext uri="{BB962C8B-B14F-4D97-AF65-F5344CB8AC3E}">
-        <p14:creationId xmlns:p14="http://schemas.microsoft.com/office/powerpoint/2010/main" val="1707387436"/>
+        <p14:creationId xmlns:p14="http://schemas.microsoft.com/office/powerpoint/2010/main" val="1178387720"/>
       </p:ext>
     </p:extLst>
   </p:cSld>
@@ -21518,7 +21518,7 @@
           <p:cNvPr id="2" name="TextBox 1">
             <a:extLst xmlns:a="http://schemas.openxmlformats.org/drawingml/2006/main">
               <a:ext uri="{FF2B5EF4-FFF2-40B4-BE49-F238E27FC236}">
-                <a16:creationId xmlns:a16="http://schemas.microsoft.com/office/drawing/2014/main" id="{5FD9C22E-0936-4183-A433-3FCF7175B311}"/>
+                <a16:creationId xmlns:a16="http://schemas.microsoft.com/office/drawing/2014/main" id="{BA0E0014-25AF-4EDD-A86F-8F4158FE753A}"/>
               </a:ext>
             </a:extLst>
           </p:cNvPr>
@@ -21565,7 +21565,7 @@
           <p:cNvPr id="3" name="TextBox 2">
             <a:extLst xmlns:a="http://schemas.openxmlformats.org/drawingml/2006/main">
               <a:ext uri="{FF2B5EF4-FFF2-40B4-BE49-F238E27FC236}">
-                <a16:creationId xmlns:a16="http://schemas.microsoft.com/office/drawing/2014/main" id="{87F18902-FB7F-4468-9236-AC4DB5FA606F}"/>
+                <a16:creationId xmlns:a16="http://schemas.microsoft.com/office/drawing/2014/main" id="{B523DA14-1708-48A0-AAF3-C79C19A28BFE}"/>
               </a:ext>
             </a:extLst>
           </p:cNvPr>
@@ -21612,7 +21612,7 @@
           <p:cNvPr id="4" name="Rectangle 3">
             <a:extLst xmlns:a="http://schemas.openxmlformats.org/drawingml/2006/main">
               <a:ext uri="{FF2B5EF4-FFF2-40B4-BE49-F238E27FC236}">
-                <a16:creationId xmlns:a16="http://schemas.microsoft.com/office/drawing/2014/main" id="{6B6A6BCF-E493-4970-904A-6BC94F636FDE}"/>
+                <a16:creationId xmlns:a16="http://schemas.microsoft.com/office/drawing/2014/main" id="{79C58AD9-952F-4B0D-87A1-037429A31B9F}"/>
               </a:ext>
             </a:extLst>
           </p:cNvPr>
@@ -21667,7 +21667,7 @@
           <p:cNvPr id="5" name="Rectangle 4">
             <a:extLst xmlns:a="http://schemas.openxmlformats.org/drawingml/2006/main">
               <a:ext uri="{FF2B5EF4-FFF2-40B4-BE49-F238E27FC236}">
-                <a16:creationId xmlns:a16="http://schemas.microsoft.com/office/drawing/2014/main" id="{2E25D073-19E2-4E5F-9B91-200B012056D6}"/>
+                <a16:creationId xmlns:a16="http://schemas.microsoft.com/office/drawing/2014/main" id="{65FE4F14-8E8C-4FAB-B774-DFCA84BD71F2}"/>
               </a:ext>
             </a:extLst>
           </p:cNvPr>
@@ -21722,7 +21722,7 @@
           <p:cNvPr id="6" name="TextBox 5">
             <a:extLst xmlns:a="http://schemas.openxmlformats.org/drawingml/2006/main">
               <a:ext uri="{FF2B5EF4-FFF2-40B4-BE49-F238E27FC236}">
-                <a16:creationId xmlns:a16="http://schemas.microsoft.com/office/drawing/2014/main" id="{325CFED0-7FDD-4872-8379-9A6BA5533A0F}"/>
+                <a16:creationId xmlns:a16="http://schemas.microsoft.com/office/drawing/2014/main" id="{98176D4F-6E17-4D73-BC84-FFB85AC8D6CC}"/>
               </a:ext>
             </a:extLst>
           </p:cNvPr>
@@ -21759,7 +21759,7 @@
                 <a:ea typeface="Aptos"/>
                 <a:cs typeface="Aptos"/>
               </a:rPr>
-              <a:t>Independent public evidence summary · 2026.07.22-9 · 2026-07-22 · Sources: WIPO valuation</a:t>
+              <a:t>Independent public evidence summary · 2026.07.23-10 · 2026-07-22 · Sources: WIPO valuation</a:t>
             </a:r>
           </a:p>
         </p:txBody>
@@ -21769,7 +21769,7 @@
           <p:cNvPr id="7" name="TextBox 6">
             <a:extLst xmlns:a="http://schemas.openxmlformats.org/drawingml/2006/main">
               <a:ext uri="{FF2B5EF4-FFF2-40B4-BE49-F238E27FC236}">
-                <a16:creationId xmlns:a16="http://schemas.microsoft.com/office/drawing/2014/main" id="{8AC4850B-48C1-4AF0-A7D7-C0EA57F5AA94}"/>
+                <a16:creationId xmlns:a16="http://schemas.microsoft.com/office/drawing/2014/main" id="{5DA579D6-1EE1-4D4A-9DF4-59C9FE3289E1}"/>
               </a:ext>
             </a:extLst>
           </p:cNvPr>
@@ -22502,7 +22502,7 @@
           <p:cNvPr id="9" name="TextBox 8">
             <a:extLst xmlns:a="http://schemas.openxmlformats.org/drawingml/2006/main">
               <a:ext uri="{FF2B5EF4-FFF2-40B4-BE49-F238E27FC236}">
-                <a16:creationId xmlns:a16="http://schemas.microsoft.com/office/drawing/2014/main" id="{4E5CF8AB-6039-4F8E-BB41-CF294BF05485}"/>
+                <a16:creationId xmlns:a16="http://schemas.microsoft.com/office/drawing/2014/main" id="{B42BCE63-1847-45C0-8BE5-F245557E685B}"/>
               </a:ext>
             </a:extLst>
           </p:cNvPr>
@@ -22547,7 +22547,7 @@
     </p:spTree>
     <p:extLst>
       <p:ext uri="{BB962C8B-B14F-4D97-AF65-F5344CB8AC3E}">
-        <p14:creationId xmlns:p14="http://schemas.microsoft.com/office/powerpoint/2010/main" val="53254733"/>
+        <p14:creationId xmlns:p14="http://schemas.microsoft.com/office/powerpoint/2010/main" val="1405375829"/>
       </p:ext>
     </p:extLst>
   </p:cSld>
@@ -22571,7 +22571,7 @@
           <p:cNvPr id="2" name="TextBox 1">
             <a:extLst xmlns:a="http://schemas.openxmlformats.org/drawingml/2006/main">
               <a:ext uri="{FF2B5EF4-FFF2-40B4-BE49-F238E27FC236}">
-                <a16:creationId xmlns:a16="http://schemas.microsoft.com/office/drawing/2014/main" id="{FDA63CFE-2427-48EE-B5AB-B5243B9B8DDD}"/>
+                <a16:creationId xmlns:a16="http://schemas.microsoft.com/office/drawing/2014/main" id="{CE739E78-52E5-4251-B279-2881146437B4}"/>
               </a:ext>
             </a:extLst>
           </p:cNvPr>
@@ -22618,7 +22618,7 @@
           <p:cNvPr id="3" name="TextBox 2">
             <a:extLst xmlns:a="http://schemas.openxmlformats.org/drawingml/2006/main">
               <a:ext uri="{FF2B5EF4-FFF2-40B4-BE49-F238E27FC236}">
-                <a16:creationId xmlns:a16="http://schemas.microsoft.com/office/drawing/2014/main" id="{03B93B61-C5AE-473B-BFF6-C6EA195A30AD}"/>
+                <a16:creationId xmlns:a16="http://schemas.microsoft.com/office/drawing/2014/main" id="{5C5FD976-EA75-468D-833F-477F5B1AF458}"/>
               </a:ext>
             </a:extLst>
           </p:cNvPr>
@@ -22665,7 +22665,7 @@
           <p:cNvPr id="4" name="Rectangle 3">
             <a:extLst xmlns:a="http://schemas.openxmlformats.org/drawingml/2006/main">
               <a:ext uri="{FF2B5EF4-FFF2-40B4-BE49-F238E27FC236}">
-                <a16:creationId xmlns:a16="http://schemas.microsoft.com/office/drawing/2014/main" id="{15A32B4B-B3D7-4083-8B32-D6C8C9A5B4C2}"/>
+                <a16:creationId xmlns:a16="http://schemas.microsoft.com/office/drawing/2014/main" id="{C623E92F-BCCE-4C09-B4BA-064921740286}"/>
               </a:ext>
             </a:extLst>
           </p:cNvPr>
@@ -22720,7 +22720,7 @@
           <p:cNvPr id="5" name="Rectangle 4">
             <a:extLst xmlns:a="http://schemas.openxmlformats.org/drawingml/2006/main">
               <a:ext uri="{FF2B5EF4-FFF2-40B4-BE49-F238E27FC236}">
-                <a16:creationId xmlns:a16="http://schemas.microsoft.com/office/drawing/2014/main" id="{6A3F3C49-526C-4917-B375-4E090959114C}"/>
+                <a16:creationId xmlns:a16="http://schemas.microsoft.com/office/drawing/2014/main" id="{0EE6075F-0159-42BD-8FB6-E1ED96D16E00}"/>
               </a:ext>
             </a:extLst>
           </p:cNvPr>
@@ -22775,7 +22775,7 @@
           <p:cNvPr id="6" name="TextBox 5">
             <a:extLst xmlns:a="http://schemas.openxmlformats.org/drawingml/2006/main">
               <a:ext uri="{FF2B5EF4-FFF2-40B4-BE49-F238E27FC236}">
-                <a16:creationId xmlns:a16="http://schemas.microsoft.com/office/drawing/2014/main" id="{6C7FF603-B003-492E-A5EC-3AE2B6E15EC1}"/>
+                <a16:creationId xmlns:a16="http://schemas.microsoft.com/office/drawing/2014/main" id="{6C2E195D-0BAE-4821-A054-A043CBE4AD7E}"/>
               </a:ext>
             </a:extLst>
           </p:cNvPr>
@@ -22812,7 +22812,7 @@
                 <a:ea typeface="Aptos"/>
                 <a:cs typeface="Aptos"/>
               </a:rPr>
-              <a:t>Independent public evidence summary · 2026.07.22-9 · 2026-07-22 · Sources: Evidence Register</a:t>
+              <a:t>Independent public evidence summary · 2026.07.23-10 · 2026-07-22 · Sources: Evidence Register</a:t>
             </a:r>
           </a:p>
         </p:txBody>
@@ -22822,7 +22822,7 @@
           <p:cNvPr id="7" name="TextBox 6">
             <a:extLst xmlns:a="http://schemas.openxmlformats.org/drawingml/2006/main">
               <a:ext uri="{FF2B5EF4-FFF2-40B4-BE49-F238E27FC236}">
-                <a16:creationId xmlns:a16="http://schemas.microsoft.com/office/drawing/2014/main" id="{80DB0655-A2BB-4C54-BC7C-D60DA44498A5}"/>
+                <a16:creationId xmlns:a16="http://schemas.microsoft.com/office/drawing/2014/main" id="{798243D3-46E4-4F6D-B6D0-DDE7AA9E137D}"/>
               </a:ext>
             </a:extLst>
           </p:cNvPr>
@@ -23392,7 +23392,7 @@
           <p:cNvPr id="9" name="TextBox 8">
             <a:extLst xmlns:a="http://schemas.openxmlformats.org/drawingml/2006/main">
               <a:ext uri="{FF2B5EF4-FFF2-40B4-BE49-F238E27FC236}">
-                <a16:creationId xmlns:a16="http://schemas.microsoft.com/office/drawing/2014/main" id="{3C0A7508-93B6-45B7-93F0-A33E091F3D79}"/>
+                <a16:creationId xmlns:a16="http://schemas.microsoft.com/office/drawing/2014/main" id="{68AB7D60-A601-41B5-B446-D8E3C23AF0AF}"/>
               </a:ext>
             </a:extLst>
           </p:cNvPr>
@@ -23437,7 +23437,7 @@
     </p:spTree>
     <p:extLst>
       <p:ext uri="{BB962C8B-B14F-4D97-AF65-F5344CB8AC3E}">
-        <p14:creationId xmlns:p14="http://schemas.microsoft.com/office/powerpoint/2010/main" val="1746787613"/>
+        <p14:creationId xmlns:p14="http://schemas.microsoft.com/office/powerpoint/2010/main" val="933218628"/>
       </p:ext>
     </p:extLst>
   </p:cSld>
@@ -23461,7 +23461,7 @@
           <p:cNvPr id="2" name="TextBox 1">
             <a:extLst xmlns:a="http://schemas.openxmlformats.org/drawingml/2006/main">
               <a:ext uri="{FF2B5EF4-FFF2-40B4-BE49-F238E27FC236}">
-                <a16:creationId xmlns:a16="http://schemas.microsoft.com/office/drawing/2014/main" id="{B3B0AC0D-8E1B-4616-8FB6-AAA7CE986AB3}"/>
+                <a16:creationId xmlns:a16="http://schemas.microsoft.com/office/drawing/2014/main" id="{E7B51426-E870-4728-9925-DEB716EE23CA}"/>
               </a:ext>
             </a:extLst>
           </p:cNvPr>
@@ -23508,7 +23508,7 @@
           <p:cNvPr id="3" name="TextBox 2">
             <a:extLst xmlns:a="http://schemas.openxmlformats.org/drawingml/2006/main">
               <a:ext uri="{FF2B5EF4-FFF2-40B4-BE49-F238E27FC236}">
-                <a16:creationId xmlns:a16="http://schemas.microsoft.com/office/drawing/2014/main" id="{BE166885-1780-4BE6-8334-E6DAC006528A}"/>
+                <a16:creationId xmlns:a16="http://schemas.microsoft.com/office/drawing/2014/main" id="{348C8034-912C-4B35-9751-B9432C2C913B}"/>
               </a:ext>
             </a:extLst>
           </p:cNvPr>
@@ -23555,7 +23555,7 @@
           <p:cNvPr id="4" name="Rectangle 3">
             <a:extLst xmlns:a="http://schemas.openxmlformats.org/drawingml/2006/main">
               <a:ext uri="{FF2B5EF4-FFF2-40B4-BE49-F238E27FC236}">
-                <a16:creationId xmlns:a16="http://schemas.microsoft.com/office/drawing/2014/main" id="{DB0101B4-A009-4437-9ACA-F206464300CB}"/>
+                <a16:creationId xmlns:a16="http://schemas.microsoft.com/office/drawing/2014/main" id="{1D9BCD7B-92EB-43DD-B7F4-FE967F5BE907}"/>
               </a:ext>
             </a:extLst>
           </p:cNvPr>
@@ -23610,7 +23610,7 @@
           <p:cNvPr id="5" name="Rectangle 4">
             <a:extLst xmlns:a="http://schemas.openxmlformats.org/drawingml/2006/main">
               <a:ext uri="{FF2B5EF4-FFF2-40B4-BE49-F238E27FC236}">
-                <a16:creationId xmlns:a16="http://schemas.microsoft.com/office/drawing/2014/main" id="{31BFCC2D-11BA-4D9D-8C14-742D04F5A275}"/>
+                <a16:creationId xmlns:a16="http://schemas.microsoft.com/office/drawing/2014/main" id="{AF1F63F0-1A48-432D-908D-3CDDEDB2BB76}"/>
               </a:ext>
             </a:extLst>
           </p:cNvPr>
@@ -23665,7 +23665,7 @@
           <p:cNvPr id="6" name="TextBox 5">
             <a:extLst xmlns:a="http://schemas.openxmlformats.org/drawingml/2006/main">
               <a:ext uri="{FF2B5EF4-FFF2-40B4-BE49-F238E27FC236}">
-                <a16:creationId xmlns:a16="http://schemas.microsoft.com/office/drawing/2014/main" id="{0231597F-B7B1-43E9-BEC9-7877405CB2F0}"/>
+                <a16:creationId xmlns:a16="http://schemas.microsoft.com/office/drawing/2014/main" id="{57C4E468-03ED-4E21-8154-A68DF39E17A9}"/>
               </a:ext>
             </a:extLst>
           </p:cNvPr>
@@ -23702,7 +23702,7 @@
                 <a:ea typeface="Aptos"/>
                 <a:cs typeface="Aptos"/>
               </a:rPr>
-              <a:t>Independent public evidence summary · 2026.07.22-9 · 2026-07-22 · Sources: Evidence Register</a:t>
+              <a:t>Independent public evidence summary · 2026.07.23-10 · 2026-07-22 · Sources: Evidence Register</a:t>
             </a:r>
           </a:p>
         </p:txBody>
@@ -23712,7 +23712,7 @@
           <p:cNvPr id="7" name="TextBox 6">
             <a:extLst xmlns:a="http://schemas.openxmlformats.org/drawingml/2006/main">
               <a:ext uri="{FF2B5EF4-FFF2-40B4-BE49-F238E27FC236}">
-                <a16:creationId xmlns:a16="http://schemas.microsoft.com/office/drawing/2014/main" id="{14D217F7-7B5B-423B-ADB7-8A44CCC90FDE}"/>
+                <a16:creationId xmlns:a16="http://schemas.microsoft.com/office/drawing/2014/main" id="{F62273F6-877F-4EE8-9F6F-33CA6710AE5E}"/>
               </a:ext>
             </a:extLst>
           </p:cNvPr>
@@ -24365,7 +24365,7 @@
           <p:cNvPr id="9" name="TextBox 8">
             <a:extLst xmlns:a="http://schemas.openxmlformats.org/drawingml/2006/main">
               <a:ext uri="{FF2B5EF4-FFF2-40B4-BE49-F238E27FC236}">
-                <a16:creationId xmlns:a16="http://schemas.microsoft.com/office/drawing/2014/main" id="{76316B92-0CB8-4DA8-A5C0-CD7687C09989}"/>
+                <a16:creationId xmlns:a16="http://schemas.microsoft.com/office/drawing/2014/main" id="{6F842D77-9A27-413A-8022-C7DA46E544BA}"/>
               </a:ext>
             </a:extLst>
           </p:cNvPr>
@@ -24410,7 +24410,7 @@
     </p:spTree>
     <p:extLst>
       <p:ext uri="{BB962C8B-B14F-4D97-AF65-F5344CB8AC3E}">
-        <p14:creationId xmlns:p14="http://schemas.microsoft.com/office/powerpoint/2010/main" val="1660671506"/>
+        <p14:creationId xmlns:p14="http://schemas.microsoft.com/office/powerpoint/2010/main" val="761923218"/>
       </p:ext>
     </p:extLst>
   </p:cSld>
@@ -24434,7 +24434,7 @@
           <p:cNvPr id="2" name="TextBox 1">
             <a:extLst xmlns:a="http://schemas.openxmlformats.org/drawingml/2006/main">
               <a:ext uri="{FF2B5EF4-FFF2-40B4-BE49-F238E27FC236}">
-                <a16:creationId xmlns:a16="http://schemas.microsoft.com/office/drawing/2014/main" id="{738B1D29-447A-484B-96B3-6D66E1726268}"/>
+                <a16:creationId xmlns:a16="http://schemas.microsoft.com/office/drawing/2014/main" id="{E931539C-865A-4AE2-A2A6-40AECF85EDAD}"/>
               </a:ext>
             </a:extLst>
           </p:cNvPr>
@@ -24481,7 +24481,7 @@
           <p:cNvPr id="3" name="TextBox 2">
             <a:extLst xmlns:a="http://schemas.openxmlformats.org/drawingml/2006/main">
               <a:ext uri="{FF2B5EF4-FFF2-40B4-BE49-F238E27FC236}">
-                <a16:creationId xmlns:a16="http://schemas.microsoft.com/office/drawing/2014/main" id="{921574DC-07D3-48AE-A35A-D5ECC19CCB3B}"/>
+                <a16:creationId xmlns:a16="http://schemas.microsoft.com/office/drawing/2014/main" id="{EC356DDA-5572-443C-90AE-E7B9F8EFE20C}"/>
               </a:ext>
             </a:extLst>
           </p:cNvPr>
@@ -24528,7 +24528,7 @@
           <p:cNvPr id="4" name="Rectangle 3">
             <a:extLst xmlns:a="http://schemas.openxmlformats.org/drawingml/2006/main">
               <a:ext uri="{FF2B5EF4-FFF2-40B4-BE49-F238E27FC236}">
-                <a16:creationId xmlns:a16="http://schemas.microsoft.com/office/drawing/2014/main" id="{B8C9040A-E790-452E-ADD3-918E62FD3F9E}"/>
+                <a16:creationId xmlns:a16="http://schemas.microsoft.com/office/drawing/2014/main" id="{A67D95BA-C8D0-4C0D-8A27-C58AB3305E41}"/>
               </a:ext>
             </a:extLst>
           </p:cNvPr>
@@ -24583,7 +24583,7 @@
           <p:cNvPr id="5" name="Rectangle 4">
             <a:extLst xmlns:a="http://schemas.openxmlformats.org/drawingml/2006/main">
               <a:ext uri="{FF2B5EF4-FFF2-40B4-BE49-F238E27FC236}">
-                <a16:creationId xmlns:a16="http://schemas.microsoft.com/office/drawing/2014/main" id="{508EC97A-7AD8-4FBB-BC5E-5A91B5ED8AF0}"/>
+                <a16:creationId xmlns:a16="http://schemas.microsoft.com/office/drawing/2014/main" id="{17C2568B-5B65-49EB-A10D-0E783A45490A}"/>
               </a:ext>
             </a:extLst>
           </p:cNvPr>
@@ -24638,7 +24638,7 @@
           <p:cNvPr id="6" name="TextBox 5">
             <a:extLst xmlns:a="http://schemas.openxmlformats.org/drawingml/2006/main">
               <a:ext uri="{FF2B5EF4-FFF2-40B4-BE49-F238E27FC236}">
-                <a16:creationId xmlns:a16="http://schemas.microsoft.com/office/drawing/2014/main" id="{DCD307B9-18E9-497D-973C-78CDF45EAFAD}"/>
+                <a16:creationId xmlns:a16="http://schemas.microsoft.com/office/drawing/2014/main" id="{61AC46D3-7578-4E6D-88DC-C0B3089CB2FC}"/>
               </a:ext>
             </a:extLst>
           </p:cNvPr>
@@ -24675,7 +24675,7 @@
                 <a:ea typeface="Aptos"/>
                 <a:cs typeface="Aptos"/>
               </a:rPr>
-              <a:t>Independent public evidence summary · 2026.07.22-9 · 2026-07-22 · Sources: Evidence Register; changelog</a:t>
+              <a:t>Independent public evidence summary · 2026.07.23-10 · 2026-07-22 · Sources: Evidence Register; changelog</a:t>
             </a:r>
           </a:p>
         </p:txBody>
@@ -24685,7 +24685,7 @@
           <p:cNvPr id="7" name="TextBox 6">
             <a:extLst xmlns:a="http://schemas.openxmlformats.org/drawingml/2006/main">
               <a:ext uri="{FF2B5EF4-FFF2-40B4-BE49-F238E27FC236}">
-                <a16:creationId xmlns:a16="http://schemas.microsoft.com/office/drawing/2014/main" id="{E1CFA685-250F-42A4-87C6-553C495CA4CB}"/>
+                <a16:creationId xmlns:a16="http://schemas.microsoft.com/office/drawing/2014/main" id="{A5C754B4-9B99-4E21-BFC1-E3256B11E71B}"/>
               </a:ext>
             </a:extLst>
           </p:cNvPr>
@@ -24732,7 +24732,7 @@
           <p:cNvPr id="8" name="Rounded Rectangle 7">
             <a:extLst xmlns:a="http://schemas.openxmlformats.org/drawingml/2006/main">
               <a:ext uri="{FF2B5EF4-FFF2-40B4-BE49-F238E27FC236}">
-                <a16:creationId xmlns:a16="http://schemas.microsoft.com/office/drawing/2014/main" id="{A22079C8-4DA4-4600-927C-009924C1FBC3}"/>
+                <a16:creationId xmlns:a16="http://schemas.microsoft.com/office/drawing/2014/main" id="{77A32934-8478-4732-97FD-3836F3209768}"/>
               </a:ext>
             </a:extLst>
           </p:cNvPr>
@@ -24789,7 +24789,7 @@
           <p:cNvPr id="9" name="TextBox 8">
             <a:extLst xmlns:a="http://schemas.openxmlformats.org/drawingml/2006/main">
               <a:ext uri="{FF2B5EF4-FFF2-40B4-BE49-F238E27FC236}">
-                <a16:creationId xmlns:a16="http://schemas.microsoft.com/office/drawing/2014/main" id="{4B9CD6EC-AC04-447B-8FC7-7F0249F7BC38}"/>
+                <a16:creationId xmlns:a16="http://schemas.microsoft.com/office/drawing/2014/main" id="{9101AB6F-703A-4D5C-90EA-D382780A6FA9}"/>
               </a:ext>
             </a:extLst>
           </p:cNvPr>
@@ -24836,7 +24836,7 @@
           <p:cNvPr id="10" name="TextBox 9">
             <a:extLst xmlns:a="http://schemas.openxmlformats.org/drawingml/2006/main">
               <a:ext uri="{FF2B5EF4-FFF2-40B4-BE49-F238E27FC236}">
-                <a16:creationId xmlns:a16="http://schemas.microsoft.com/office/drawing/2014/main" id="{583B4150-2D37-4F31-8AFE-C1F14E99EC0E}"/>
+                <a16:creationId xmlns:a16="http://schemas.microsoft.com/office/drawing/2014/main" id="{910751A1-7DC7-4D08-9084-B4FD379AD980}"/>
               </a:ext>
             </a:extLst>
           </p:cNvPr>
@@ -24883,7 +24883,7 @@
           <p:cNvPr id="11" name="TextBox 10">
             <a:extLst xmlns:a="http://schemas.openxmlformats.org/drawingml/2006/main">
               <a:ext uri="{FF2B5EF4-FFF2-40B4-BE49-F238E27FC236}">
-                <a16:creationId xmlns:a16="http://schemas.microsoft.com/office/drawing/2014/main" id="{A778ED5C-1EBA-4A46-B04F-09C19F771BBB}"/>
+                <a16:creationId xmlns:a16="http://schemas.microsoft.com/office/drawing/2014/main" id="{DC4282B3-B638-430E-B5B7-06917F72187E}"/>
               </a:ext>
             </a:extLst>
           </p:cNvPr>
@@ -24930,7 +24930,7 @@
           <p:cNvPr id="12" name="Rounded Rectangle 11">
             <a:extLst xmlns:a="http://schemas.openxmlformats.org/drawingml/2006/main">
               <a:ext uri="{FF2B5EF4-FFF2-40B4-BE49-F238E27FC236}">
-                <a16:creationId xmlns:a16="http://schemas.microsoft.com/office/drawing/2014/main" id="{79B26E7D-2A9D-42AA-B851-1A2D2CB7AE86}"/>
+                <a16:creationId xmlns:a16="http://schemas.microsoft.com/office/drawing/2014/main" id="{0F8F0269-6A2B-42F0-88FA-53F9E9A1A9DD}"/>
               </a:ext>
             </a:extLst>
           </p:cNvPr>
@@ -24987,7 +24987,7 @@
           <p:cNvPr id="13" name="TextBox 12">
             <a:extLst xmlns:a="http://schemas.openxmlformats.org/drawingml/2006/main">
               <a:ext uri="{FF2B5EF4-FFF2-40B4-BE49-F238E27FC236}">
-                <a16:creationId xmlns:a16="http://schemas.microsoft.com/office/drawing/2014/main" id="{1BA9958D-22B8-4758-95B0-AFBF3F4BC2D2}"/>
+                <a16:creationId xmlns:a16="http://schemas.microsoft.com/office/drawing/2014/main" id="{6178299B-6D0B-4500-A379-543E50F107F4}"/>
               </a:ext>
             </a:extLst>
           </p:cNvPr>
@@ -25034,7 +25034,7 @@
           <p:cNvPr id="14" name="TextBox 13">
             <a:extLst xmlns:a="http://schemas.openxmlformats.org/drawingml/2006/main">
               <a:ext uri="{FF2B5EF4-FFF2-40B4-BE49-F238E27FC236}">
-                <a16:creationId xmlns:a16="http://schemas.microsoft.com/office/drawing/2014/main" id="{7B9DA7EA-C817-46B5-99D4-C192E02112F6}"/>
+                <a16:creationId xmlns:a16="http://schemas.microsoft.com/office/drawing/2014/main" id="{399D9A65-C244-4D6C-8DEB-8639133D87FD}"/>
               </a:ext>
             </a:extLst>
           </p:cNvPr>
@@ -25081,7 +25081,7 @@
           <p:cNvPr id="15" name="TextBox 14">
             <a:extLst xmlns:a="http://schemas.openxmlformats.org/drawingml/2006/main">
               <a:ext uri="{FF2B5EF4-FFF2-40B4-BE49-F238E27FC236}">
-                <a16:creationId xmlns:a16="http://schemas.microsoft.com/office/drawing/2014/main" id="{2A365AA1-F463-4C81-A8E3-7ACBD469D273}"/>
+                <a16:creationId xmlns:a16="http://schemas.microsoft.com/office/drawing/2014/main" id="{F77D1CB0-3153-42F5-81BD-75C9C191E3EA}"/>
               </a:ext>
             </a:extLst>
           </p:cNvPr>
@@ -25128,7 +25128,7 @@
           <p:cNvPr id="16" name="Rounded Rectangle 15">
             <a:extLst xmlns:a="http://schemas.openxmlformats.org/drawingml/2006/main">
               <a:ext uri="{FF2B5EF4-FFF2-40B4-BE49-F238E27FC236}">
-                <a16:creationId xmlns:a16="http://schemas.microsoft.com/office/drawing/2014/main" id="{026A4820-1AEB-40AF-A75A-63E101128F1A}"/>
+                <a16:creationId xmlns:a16="http://schemas.microsoft.com/office/drawing/2014/main" id="{449E57A4-AFC9-44E9-9C00-EF0A5DE0E2DB}"/>
               </a:ext>
             </a:extLst>
           </p:cNvPr>
@@ -25185,7 +25185,7 @@
           <p:cNvPr id="17" name="TextBox 16">
             <a:extLst xmlns:a="http://schemas.openxmlformats.org/drawingml/2006/main">
               <a:ext uri="{FF2B5EF4-FFF2-40B4-BE49-F238E27FC236}">
-                <a16:creationId xmlns:a16="http://schemas.microsoft.com/office/drawing/2014/main" id="{E210E917-A93A-4C7C-9C94-1DF2FE5DDAE9}"/>
+                <a16:creationId xmlns:a16="http://schemas.microsoft.com/office/drawing/2014/main" id="{AFC6793B-69A5-46C0-B1C3-518840C7BA36}"/>
               </a:ext>
             </a:extLst>
           </p:cNvPr>
@@ -25232,7 +25232,7 @@
           <p:cNvPr id="18" name="TextBox 17">
             <a:extLst xmlns:a="http://schemas.openxmlformats.org/drawingml/2006/main">
               <a:ext uri="{FF2B5EF4-FFF2-40B4-BE49-F238E27FC236}">
-                <a16:creationId xmlns:a16="http://schemas.microsoft.com/office/drawing/2014/main" id="{C730F891-4159-4EF6-9F13-31175D5440D9}"/>
+                <a16:creationId xmlns:a16="http://schemas.microsoft.com/office/drawing/2014/main" id="{3369C1C1-76AF-497F-8E2B-68E913E0F6B7}"/>
               </a:ext>
             </a:extLst>
           </p:cNvPr>
@@ -25279,7 +25279,7 @@
           <p:cNvPr id="19" name="TextBox 18">
             <a:extLst xmlns:a="http://schemas.openxmlformats.org/drawingml/2006/main">
               <a:ext uri="{FF2B5EF4-FFF2-40B4-BE49-F238E27FC236}">
-                <a16:creationId xmlns:a16="http://schemas.microsoft.com/office/drawing/2014/main" id="{3EB40D68-916A-47E4-AD11-E07DDF1F7766}"/>
+                <a16:creationId xmlns:a16="http://schemas.microsoft.com/office/drawing/2014/main" id="{299BBD7E-5DEB-42B9-B730-4F4AA3D453A6}"/>
               </a:ext>
             </a:extLst>
           </p:cNvPr>
@@ -25326,7 +25326,7 @@
           <p:cNvPr id="20" name="Rounded Rectangle 19">
             <a:extLst xmlns:a="http://schemas.openxmlformats.org/drawingml/2006/main">
               <a:ext uri="{FF2B5EF4-FFF2-40B4-BE49-F238E27FC236}">
-                <a16:creationId xmlns:a16="http://schemas.microsoft.com/office/drawing/2014/main" id="{130B32E7-0603-49D1-A571-B44A9C3B3820}"/>
+                <a16:creationId xmlns:a16="http://schemas.microsoft.com/office/drawing/2014/main" id="{03E5F1DF-ECF4-416E-BADD-E9F18722A223}"/>
               </a:ext>
             </a:extLst>
           </p:cNvPr>
@@ -25383,7 +25383,7 @@
           <p:cNvPr id="21" name="TextBox 20">
             <a:extLst xmlns:a="http://schemas.openxmlformats.org/drawingml/2006/main">
               <a:ext uri="{FF2B5EF4-FFF2-40B4-BE49-F238E27FC236}">
-                <a16:creationId xmlns:a16="http://schemas.microsoft.com/office/drawing/2014/main" id="{882EDC1C-6920-4C1F-9491-D648952B248E}"/>
+                <a16:creationId xmlns:a16="http://schemas.microsoft.com/office/drawing/2014/main" id="{ECD7C601-3F12-46C2-8EC9-ABD7CC47B478}"/>
               </a:ext>
             </a:extLst>
           </p:cNvPr>
@@ -25430,7 +25430,7 @@
           <p:cNvPr id="22" name="TextBox 21">
             <a:extLst xmlns:a="http://schemas.openxmlformats.org/drawingml/2006/main">
               <a:ext uri="{FF2B5EF4-FFF2-40B4-BE49-F238E27FC236}">
-                <a16:creationId xmlns:a16="http://schemas.microsoft.com/office/drawing/2014/main" id="{D97ED6F2-AEDF-4DE4-8EC7-1BB3FF8D0F3B}"/>
+                <a16:creationId xmlns:a16="http://schemas.microsoft.com/office/drawing/2014/main" id="{DEBDE6D6-23C0-4484-BD56-C7E4E4BC25FC}"/>
               </a:ext>
             </a:extLst>
           </p:cNvPr>
@@ -25477,7 +25477,7 @@
           <p:cNvPr id="23" name="TextBox 22">
             <a:extLst xmlns:a="http://schemas.openxmlformats.org/drawingml/2006/main">
               <a:ext uri="{FF2B5EF4-FFF2-40B4-BE49-F238E27FC236}">
-                <a16:creationId xmlns:a16="http://schemas.microsoft.com/office/drawing/2014/main" id="{8B693996-F9ED-4A77-9337-4CC7415575A1}"/>
+                <a16:creationId xmlns:a16="http://schemas.microsoft.com/office/drawing/2014/main" id="{CAB7B1A1-A6B9-430F-AFA8-C2493BD754B6}"/>
               </a:ext>
             </a:extLst>
           </p:cNvPr>
@@ -25524,7 +25524,7 @@
           <p:cNvPr id="24" name="TextBox 23">
             <a:extLst xmlns:a="http://schemas.openxmlformats.org/drawingml/2006/main">
               <a:ext uri="{FF2B5EF4-FFF2-40B4-BE49-F238E27FC236}">
-                <a16:creationId xmlns:a16="http://schemas.microsoft.com/office/drawing/2014/main" id="{42529BC9-58C2-414F-9273-77732735316C}"/>
+                <a16:creationId xmlns:a16="http://schemas.microsoft.com/office/drawing/2014/main" id="{8234CC30-EF4B-4418-A8BE-68CE82B3D4FC}"/>
               </a:ext>
             </a:extLst>
           </p:cNvPr>
@@ -25569,7 +25569,7 @@
     </p:spTree>
     <p:extLst>
       <p:ext uri="{BB962C8B-B14F-4D97-AF65-F5344CB8AC3E}">
-        <p14:creationId xmlns:p14="http://schemas.microsoft.com/office/powerpoint/2010/main" val="92321566"/>
+        <p14:creationId xmlns:p14="http://schemas.microsoft.com/office/powerpoint/2010/main" val="1801416930"/>
       </p:ext>
     </p:extLst>
   </p:cSld>
@@ -25593,7 +25593,7 @@
           <p:cNvPr id="2" name="TextBox 1">
             <a:extLst xmlns:a="http://schemas.openxmlformats.org/drawingml/2006/main">
               <a:ext uri="{FF2B5EF4-FFF2-40B4-BE49-F238E27FC236}">
-                <a16:creationId xmlns:a16="http://schemas.microsoft.com/office/drawing/2014/main" id="{579AC010-F3B8-4B79-AE8B-802D8F87309E}"/>
+                <a16:creationId xmlns:a16="http://schemas.microsoft.com/office/drawing/2014/main" id="{DC39BE08-B519-44DD-A47D-4CA5CAC9A9CA}"/>
               </a:ext>
             </a:extLst>
           </p:cNvPr>
@@ -25640,7 +25640,7 @@
           <p:cNvPr id="3" name="TextBox 2">
             <a:extLst xmlns:a="http://schemas.openxmlformats.org/drawingml/2006/main">
               <a:ext uri="{FF2B5EF4-FFF2-40B4-BE49-F238E27FC236}">
-                <a16:creationId xmlns:a16="http://schemas.microsoft.com/office/drawing/2014/main" id="{DDCB1B9C-52F5-4FC7-B4EA-C8F20A2171B7}"/>
+                <a16:creationId xmlns:a16="http://schemas.microsoft.com/office/drawing/2014/main" id="{E5187957-0F8B-475D-828C-812872F405A4}"/>
               </a:ext>
             </a:extLst>
           </p:cNvPr>
@@ -25687,7 +25687,7 @@
           <p:cNvPr id="4" name="Rectangle 3">
             <a:extLst xmlns:a="http://schemas.openxmlformats.org/drawingml/2006/main">
               <a:ext uri="{FF2B5EF4-FFF2-40B4-BE49-F238E27FC236}">
-                <a16:creationId xmlns:a16="http://schemas.microsoft.com/office/drawing/2014/main" id="{B712BD54-C6F5-4056-88D6-69F50254092E}"/>
+                <a16:creationId xmlns:a16="http://schemas.microsoft.com/office/drawing/2014/main" id="{0CC31C4B-B453-429E-8A24-C588A437E82E}"/>
               </a:ext>
             </a:extLst>
           </p:cNvPr>
@@ -25742,7 +25742,7 @@
           <p:cNvPr id="5" name="Rectangle 4">
             <a:extLst xmlns:a="http://schemas.openxmlformats.org/drawingml/2006/main">
               <a:ext uri="{FF2B5EF4-FFF2-40B4-BE49-F238E27FC236}">
-                <a16:creationId xmlns:a16="http://schemas.microsoft.com/office/drawing/2014/main" id="{FE25D6B4-B553-4C89-957F-6FDE67291137}"/>
+                <a16:creationId xmlns:a16="http://schemas.microsoft.com/office/drawing/2014/main" id="{B69B8470-C7A9-433C-9010-4C4B79E30D1E}"/>
               </a:ext>
             </a:extLst>
           </p:cNvPr>
@@ -25797,7 +25797,7 @@
           <p:cNvPr id="6" name="TextBox 5">
             <a:extLst xmlns:a="http://schemas.openxmlformats.org/drawingml/2006/main">
               <a:ext uri="{FF2B5EF4-FFF2-40B4-BE49-F238E27FC236}">
-                <a16:creationId xmlns:a16="http://schemas.microsoft.com/office/drawing/2014/main" id="{51853347-E45C-449C-8652-73E58012513C}"/>
+                <a16:creationId xmlns:a16="http://schemas.microsoft.com/office/drawing/2014/main" id="{C06CCDDB-CB84-4A6D-B3DD-8A05A0E856D4}"/>
               </a:ext>
             </a:extLst>
           </p:cNvPr>
@@ -25834,7 +25834,7 @@
                 <a:ea typeface="Aptos"/>
                 <a:cs typeface="Aptos"/>
               </a:rPr>
-              <a:t>Independent public evidence summary · 2026.07.22-9 · 2026-07-22 · Sources: EPO; 8 Ni 18/24 (EP); 7 O 3341/24</a:t>
+              <a:t>Independent public evidence summary · 2026.07.23-10 · 2026-07-22 · Sources: EPO; 8 Ni 18/24 (EP); 7 O 3341/24</a:t>
             </a:r>
           </a:p>
         </p:txBody>
@@ -25844,7 +25844,7 @@
           <p:cNvPr id="7" name="TextBox 6">
             <a:extLst xmlns:a="http://schemas.openxmlformats.org/drawingml/2006/main">
               <a:ext uri="{FF2B5EF4-FFF2-40B4-BE49-F238E27FC236}">
-                <a16:creationId xmlns:a16="http://schemas.microsoft.com/office/drawing/2014/main" id="{6DD99515-C4C9-433B-A530-27F2A57B94E4}"/>
+                <a16:creationId xmlns:a16="http://schemas.microsoft.com/office/drawing/2014/main" id="{4192D5BE-BB41-451D-A629-B2996F631506}"/>
               </a:ext>
             </a:extLst>
           </p:cNvPr>
@@ -26248,7 +26248,7 @@
           <p:cNvPr id="9" name="TextBox 8">
             <a:extLst xmlns:a="http://schemas.openxmlformats.org/drawingml/2006/main">
               <a:ext uri="{FF2B5EF4-FFF2-40B4-BE49-F238E27FC236}">
-                <a16:creationId xmlns:a16="http://schemas.microsoft.com/office/drawing/2014/main" id="{F1D39DB8-3582-4D2C-BFE4-A7F2E9E68B95}"/>
+                <a16:creationId xmlns:a16="http://schemas.microsoft.com/office/drawing/2014/main" id="{55944AB8-4A44-4244-85D4-A73FE2CD687B}"/>
               </a:ext>
             </a:extLst>
           </p:cNvPr>
@@ -26293,7 +26293,7 @@
     </p:spTree>
     <p:extLst>
       <p:ext uri="{BB962C8B-B14F-4D97-AF65-F5344CB8AC3E}">
-        <p14:creationId xmlns:p14="http://schemas.microsoft.com/office/powerpoint/2010/main" val="1288151326"/>
+        <p14:creationId xmlns:p14="http://schemas.microsoft.com/office/powerpoint/2010/main" val="784500770"/>
       </p:ext>
     </p:extLst>
   </p:cSld>
@@ -26324,7 +26324,7 @@
           <p:cNvPr id="2" name="TextBox 1">
             <a:extLst xmlns:a="http://schemas.openxmlformats.org/drawingml/2006/main">
               <a:ext uri="{FF2B5EF4-FFF2-40B4-BE49-F238E27FC236}">
-                <a16:creationId xmlns:a16="http://schemas.microsoft.com/office/drawing/2014/main" id="{F983CE36-95D3-4520-BAF4-031689D5E41B}"/>
+                <a16:creationId xmlns:a16="http://schemas.microsoft.com/office/drawing/2014/main" id="{B5B2249B-2272-42D2-BCA8-B652BFB2C205}"/>
               </a:ext>
             </a:extLst>
           </p:cNvPr>
@@ -26371,7 +26371,7 @@
           <p:cNvPr id="3" name="TextBox 2">
             <a:extLst xmlns:a="http://schemas.openxmlformats.org/drawingml/2006/main">
               <a:ext uri="{FF2B5EF4-FFF2-40B4-BE49-F238E27FC236}">
-                <a16:creationId xmlns:a16="http://schemas.microsoft.com/office/drawing/2014/main" id="{CCB56563-454C-4968-AD50-34B6664A46BA}"/>
+                <a16:creationId xmlns:a16="http://schemas.microsoft.com/office/drawing/2014/main" id="{CC73BFCA-22C6-4D9C-B837-FDDC18A8E441}"/>
               </a:ext>
             </a:extLst>
           </p:cNvPr>
@@ -26418,7 +26418,7 @@
           <p:cNvPr id="4" name="TextBox 3">
             <a:extLst xmlns:a="http://schemas.openxmlformats.org/drawingml/2006/main">
               <a:ext uri="{FF2B5EF4-FFF2-40B4-BE49-F238E27FC236}">
-                <a16:creationId xmlns:a16="http://schemas.microsoft.com/office/drawing/2014/main" id="{01BABAD7-212C-4123-B693-6BBC0BEA6876}"/>
+                <a16:creationId xmlns:a16="http://schemas.microsoft.com/office/drawing/2014/main" id="{2BD646D0-2301-48CC-B199-BEDB02185563}"/>
               </a:ext>
             </a:extLst>
           </p:cNvPr>
@@ -26537,7 +26537,7 @@
           <p:cNvPr id="5" name="TextBox 4">
             <a:extLst xmlns:a="http://schemas.openxmlformats.org/drawingml/2006/main">
               <a:ext uri="{FF2B5EF4-FFF2-40B4-BE49-F238E27FC236}">
-                <a16:creationId xmlns:a16="http://schemas.microsoft.com/office/drawing/2014/main" id="{ADD564C1-AB61-4336-A3F8-24E54EC10613}"/>
+                <a16:creationId xmlns:a16="http://schemas.microsoft.com/office/drawing/2014/main" id="{9D441880-4F9A-4B1C-BE63-D0EB9F821E6D}"/>
               </a:ext>
             </a:extLst>
           </p:cNvPr>
@@ -26574,7 +26574,7 @@
                 <a:ea typeface="Aptos"/>
                 <a:cs typeface="Aptos"/>
               </a:rPr>
-              <a:t>Version 2026.07.22-9 · 2026-07-22 · 30 / 30</a:t>
+              <a:t>Version 2026.07.23-10 · 2026-07-22 · 30 / 30</a:t>
             </a:r>
           </a:p>
         </p:txBody>
@@ -26582,7 +26582,7 @@
     </p:spTree>
     <p:extLst>
       <p:ext uri="{BB962C8B-B14F-4D97-AF65-F5344CB8AC3E}">
-        <p14:creationId xmlns:p14="http://schemas.microsoft.com/office/powerpoint/2010/main" val="556422540"/>
+        <p14:creationId xmlns:p14="http://schemas.microsoft.com/office/powerpoint/2010/main" val="733978074"/>
       </p:ext>
     </p:extLst>
   </p:cSld>
@@ -26606,7 +26606,7 @@
           <p:cNvPr id="2" name="TextBox 1">
             <a:extLst xmlns:a="http://schemas.openxmlformats.org/drawingml/2006/main">
               <a:ext uri="{FF2B5EF4-FFF2-40B4-BE49-F238E27FC236}">
-                <a16:creationId xmlns:a16="http://schemas.microsoft.com/office/drawing/2014/main" id="{23F78842-F31D-4BCA-A6BB-5EA12A03B320}"/>
+                <a16:creationId xmlns:a16="http://schemas.microsoft.com/office/drawing/2014/main" id="{5FECF78C-1179-40F2-B719-C1D03A470910}"/>
               </a:ext>
             </a:extLst>
           </p:cNvPr>
@@ -26653,7 +26653,7 @@
           <p:cNvPr id="3" name="TextBox 2">
             <a:extLst xmlns:a="http://schemas.openxmlformats.org/drawingml/2006/main">
               <a:ext uri="{FF2B5EF4-FFF2-40B4-BE49-F238E27FC236}">
-                <a16:creationId xmlns:a16="http://schemas.microsoft.com/office/drawing/2014/main" id="{D8FC01DC-76AF-447B-BA62-D2B82BE9380B}"/>
+                <a16:creationId xmlns:a16="http://schemas.microsoft.com/office/drawing/2014/main" id="{6AD31A2B-F6FC-4AE8-A091-9C8AEDDBEFE7}"/>
               </a:ext>
             </a:extLst>
           </p:cNvPr>
@@ -26700,7 +26700,7 @@
           <p:cNvPr id="4" name="Rectangle 3">
             <a:extLst xmlns:a="http://schemas.openxmlformats.org/drawingml/2006/main">
               <a:ext uri="{FF2B5EF4-FFF2-40B4-BE49-F238E27FC236}">
-                <a16:creationId xmlns:a16="http://schemas.microsoft.com/office/drawing/2014/main" id="{E7EBB987-37AD-4869-B075-9B18876817E2}"/>
+                <a16:creationId xmlns:a16="http://schemas.microsoft.com/office/drawing/2014/main" id="{9A7563BD-49C0-40BE-922B-F42B247E79EF}"/>
               </a:ext>
             </a:extLst>
           </p:cNvPr>
@@ -26755,7 +26755,7 @@
           <p:cNvPr id="5" name="Rectangle 4">
             <a:extLst xmlns:a="http://schemas.openxmlformats.org/drawingml/2006/main">
               <a:ext uri="{FF2B5EF4-FFF2-40B4-BE49-F238E27FC236}">
-                <a16:creationId xmlns:a16="http://schemas.microsoft.com/office/drawing/2014/main" id="{355BE1A0-4A21-4B2D-BA2E-5B304B9A08E2}"/>
+                <a16:creationId xmlns:a16="http://schemas.microsoft.com/office/drawing/2014/main" id="{53246B55-0A5F-4593-B902-468A597EAB5C}"/>
               </a:ext>
             </a:extLst>
           </p:cNvPr>
@@ -26810,7 +26810,7 @@
           <p:cNvPr id="6" name="TextBox 5">
             <a:extLst xmlns:a="http://schemas.openxmlformats.org/drawingml/2006/main">
               <a:ext uri="{FF2B5EF4-FFF2-40B4-BE49-F238E27FC236}">
-                <a16:creationId xmlns:a16="http://schemas.microsoft.com/office/drawing/2014/main" id="{E93F9AD1-E09D-4424-8457-D8F1B258BC9C}"/>
+                <a16:creationId xmlns:a16="http://schemas.microsoft.com/office/drawing/2014/main" id="{75B78308-67CD-494B-B3C3-821875554D8B}"/>
               </a:ext>
             </a:extLst>
           </p:cNvPr>
@@ -26847,7 +26847,7 @@
                 <a:ea typeface="Aptos"/>
                 <a:cs typeface="Aptos"/>
               </a:rPr>
-              <a:t>Independent public evidence summary · 2026.07.22-9 · 2026-07-22 · Sources: Evidence Register; WIPO</a:t>
+              <a:t>Independent public evidence summary · 2026.07.23-10 · 2026-07-22 · Sources: Evidence Register; WIPO</a:t>
             </a:r>
           </a:p>
         </p:txBody>
@@ -26857,7 +26857,7 @@
           <p:cNvPr id="7" name="TextBox 6">
             <a:extLst xmlns:a="http://schemas.openxmlformats.org/drawingml/2006/main">
               <a:ext uri="{FF2B5EF4-FFF2-40B4-BE49-F238E27FC236}">
-                <a16:creationId xmlns:a16="http://schemas.microsoft.com/office/drawing/2014/main" id="{8D7206DC-AA3D-4387-A8FD-D031C396210B}"/>
+                <a16:creationId xmlns:a16="http://schemas.microsoft.com/office/drawing/2014/main" id="{493339A3-1E23-495C-B193-D4A359EB7FBF}"/>
               </a:ext>
             </a:extLst>
           </p:cNvPr>
@@ -26904,7 +26904,7 @@
           <p:cNvPr id="8" name="TextBox 7">
             <a:extLst xmlns:a="http://schemas.openxmlformats.org/drawingml/2006/main">
               <a:ext uri="{FF2B5EF4-FFF2-40B4-BE49-F238E27FC236}">
-                <a16:creationId xmlns:a16="http://schemas.microsoft.com/office/drawing/2014/main" id="{04ADFDA8-7320-483C-AFE8-997B243CD786}"/>
+                <a16:creationId xmlns:a16="http://schemas.microsoft.com/office/drawing/2014/main" id="{495FD5D9-0ABD-451D-8352-F79A243B69AE}"/>
               </a:ext>
             </a:extLst>
           </p:cNvPr>
@@ -26951,7 +26951,7 @@
           <p:cNvPr id="9" name="TextBox 8">
             <a:extLst xmlns:a="http://schemas.openxmlformats.org/drawingml/2006/main">
               <a:ext uri="{FF2B5EF4-FFF2-40B4-BE49-F238E27FC236}">
-                <a16:creationId xmlns:a16="http://schemas.microsoft.com/office/drawing/2014/main" id="{2A0F79FF-F678-42AB-ABA9-AC95D5C8B4B9}"/>
+                <a16:creationId xmlns:a16="http://schemas.microsoft.com/office/drawing/2014/main" id="{B907D7DC-BB2D-4460-A829-59073B7EE2B7}"/>
               </a:ext>
             </a:extLst>
           </p:cNvPr>
@@ -27048,7 +27048,7 @@
           <p:cNvPr id="10" name="Rounded Rectangle 9">
             <a:extLst xmlns:a="http://schemas.openxmlformats.org/drawingml/2006/main">
               <a:ext uri="{FF2B5EF4-FFF2-40B4-BE49-F238E27FC236}">
-                <a16:creationId xmlns:a16="http://schemas.microsoft.com/office/drawing/2014/main" id="{014BDCFF-2E00-4194-B5A0-F222F526FAC2}"/>
+                <a16:creationId xmlns:a16="http://schemas.microsoft.com/office/drawing/2014/main" id="{4105B759-5F80-4C27-B8D9-18903AAD65EF}"/>
               </a:ext>
             </a:extLst>
           </p:cNvPr>
@@ -27105,7 +27105,7 @@
           <p:cNvPr id="11" name="TextBox 10">
             <a:extLst xmlns:a="http://schemas.openxmlformats.org/drawingml/2006/main">
               <a:ext uri="{FF2B5EF4-FFF2-40B4-BE49-F238E27FC236}">
-                <a16:creationId xmlns:a16="http://schemas.microsoft.com/office/drawing/2014/main" id="{13EF9BBC-5C74-401C-8F66-AF29D4359149}"/>
+                <a16:creationId xmlns:a16="http://schemas.microsoft.com/office/drawing/2014/main" id="{22725A3C-5159-46E7-A117-676FF2941687}"/>
               </a:ext>
             </a:extLst>
           </p:cNvPr>
@@ -27152,7 +27152,7 @@
           <p:cNvPr id="12" name="TextBox 11">
             <a:extLst xmlns:a="http://schemas.openxmlformats.org/drawingml/2006/main">
               <a:ext uri="{FF2B5EF4-FFF2-40B4-BE49-F238E27FC236}">
-                <a16:creationId xmlns:a16="http://schemas.microsoft.com/office/drawing/2014/main" id="{827F02F9-789A-4AED-BCE4-289A1844E477}"/>
+                <a16:creationId xmlns:a16="http://schemas.microsoft.com/office/drawing/2014/main" id="{46C060C8-6E84-4A13-BA03-049B4EA4401F}"/>
               </a:ext>
             </a:extLst>
           </p:cNvPr>
@@ -27197,7 +27197,7 @@
     </p:spTree>
     <p:extLst>
       <p:ext uri="{BB962C8B-B14F-4D97-AF65-F5344CB8AC3E}">
-        <p14:creationId xmlns:p14="http://schemas.microsoft.com/office/powerpoint/2010/main" val="1619892357"/>
+        <p14:creationId xmlns:p14="http://schemas.microsoft.com/office/powerpoint/2010/main" val="602478147"/>
       </p:ext>
     </p:extLst>
   </p:cSld>
@@ -27221,7 +27221,7 @@
           <p:cNvPr id="2" name="TextBox 1">
             <a:extLst xmlns:a="http://schemas.openxmlformats.org/drawingml/2006/main">
               <a:ext uri="{FF2B5EF4-FFF2-40B4-BE49-F238E27FC236}">
-                <a16:creationId xmlns:a16="http://schemas.microsoft.com/office/drawing/2014/main" id="{E2C60E80-6F04-43E4-83E6-CBB525FF80C4}"/>
+                <a16:creationId xmlns:a16="http://schemas.microsoft.com/office/drawing/2014/main" id="{C5714E1E-0512-44CD-BF26-784B04CFE888}"/>
               </a:ext>
             </a:extLst>
           </p:cNvPr>
@@ -27268,7 +27268,7 @@
           <p:cNvPr id="3" name="TextBox 2">
             <a:extLst xmlns:a="http://schemas.openxmlformats.org/drawingml/2006/main">
               <a:ext uri="{FF2B5EF4-FFF2-40B4-BE49-F238E27FC236}">
-                <a16:creationId xmlns:a16="http://schemas.microsoft.com/office/drawing/2014/main" id="{5ACE98B9-4016-4C2B-9B05-B7C39337E8A2}"/>
+                <a16:creationId xmlns:a16="http://schemas.microsoft.com/office/drawing/2014/main" id="{63F41A78-85FD-4FE6-8014-CD73FD9A6598}"/>
               </a:ext>
             </a:extLst>
           </p:cNvPr>
@@ -27315,7 +27315,7 @@
           <p:cNvPr id="4" name="Rectangle 3">
             <a:extLst xmlns:a="http://schemas.openxmlformats.org/drawingml/2006/main">
               <a:ext uri="{FF2B5EF4-FFF2-40B4-BE49-F238E27FC236}">
-                <a16:creationId xmlns:a16="http://schemas.microsoft.com/office/drawing/2014/main" id="{73D715AA-D4B1-4791-AC38-1A3D5778CB41}"/>
+                <a16:creationId xmlns:a16="http://schemas.microsoft.com/office/drawing/2014/main" id="{9B113DC3-B82A-4218-B5F9-D986A39FA302}"/>
               </a:ext>
             </a:extLst>
           </p:cNvPr>
@@ -27370,7 +27370,7 @@
           <p:cNvPr id="5" name="Rectangle 4">
             <a:extLst xmlns:a="http://schemas.openxmlformats.org/drawingml/2006/main">
               <a:ext uri="{FF2B5EF4-FFF2-40B4-BE49-F238E27FC236}">
-                <a16:creationId xmlns:a16="http://schemas.microsoft.com/office/drawing/2014/main" id="{EAE76652-6AA8-40C8-AC6B-213CEC1398F9}"/>
+                <a16:creationId xmlns:a16="http://schemas.microsoft.com/office/drawing/2014/main" id="{629F77FC-796F-4D3F-A0CA-84CD24136EBD}"/>
               </a:ext>
             </a:extLst>
           </p:cNvPr>
@@ -27425,7 +27425,7 @@
           <p:cNvPr id="6" name="TextBox 5">
             <a:extLst xmlns:a="http://schemas.openxmlformats.org/drawingml/2006/main">
               <a:ext uri="{FF2B5EF4-FFF2-40B4-BE49-F238E27FC236}">
-                <a16:creationId xmlns:a16="http://schemas.microsoft.com/office/drawing/2014/main" id="{A9DD5EDA-AEFF-483D-8B88-72843F8A593C}"/>
+                <a16:creationId xmlns:a16="http://schemas.microsoft.com/office/drawing/2014/main" id="{67EE16FD-0BCF-4605-89E6-AF7029E830FE}"/>
               </a:ext>
             </a:extLst>
           </p:cNvPr>
@@ -27462,7 +27462,7 @@
                 <a:ea typeface="Aptos"/>
                 <a:cs typeface="Aptos"/>
               </a:rPr>
-              <a:t>Independent public evidence summary · 2026.07.22-9 · 2026-07-22 · Sources: EP3032975B2</a:t>
+              <a:t>Independent public evidence summary · 2026.07.23-10 · 2026-07-22 · Sources: EP3032975B2</a:t>
             </a:r>
           </a:p>
         </p:txBody>
@@ -27472,7 +27472,7 @@
           <p:cNvPr id="7" name="TextBox 6">
             <a:extLst xmlns:a="http://schemas.openxmlformats.org/drawingml/2006/main">
               <a:ext uri="{FF2B5EF4-FFF2-40B4-BE49-F238E27FC236}">
-                <a16:creationId xmlns:a16="http://schemas.microsoft.com/office/drawing/2014/main" id="{36641539-268B-4B36-AA60-8F2E7EC77B31}"/>
+                <a16:creationId xmlns:a16="http://schemas.microsoft.com/office/drawing/2014/main" id="{4296B138-DD66-4603-BD34-779DF6768E95}"/>
               </a:ext>
             </a:extLst>
           </p:cNvPr>
@@ -27519,7 +27519,7 @@
           <p:cNvPr id="8" name="TextBox 7">
             <a:extLst xmlns:a="http://schemas.openxmlformats.org/drawingml/2006/main">
               <a:ext uri="{FF2B5EF4-FFF2-40B4-BE49-F238E27FC236}">
-                <a16:creationId xmlns:a16="http://schemas.microsoft.com/office/drawing/2014/main" id="{4925BA15-DA98-4F04-BE7F-7E7173CBDEB3}"/>
+                <a16:creationId xmlns:a16="http://schemas.microsoft.com/office/drawing/2014/main" id="{EF8D3735-E8F6-44A8-AB31-79B7CD695B9E}"/>
               </a:ext>
             </a:extLst>
           </p:cNvPr>
@@ -27566,7 +27566,7 @@
           <p:cNvPr id="9" name="TextBox 8">
             <a:extLst xmlns:a="http://schemas.openxmlformats.org/drawingml/2006/main">
               <a:ext uri="{FF2B5EF4-FFF2-40B4-BE49-F238E27FC236}">
-                <a16:creationId xmlns:a16="http://schemas.microsoft.com/office/drawing/2014/main" id="{3FFA6CC8-8790-4A11-939C-AEA994886250}"/>
+                <a16:creationId xmlns:a16="http://schemas.microsoft.com/office/drawing/2014/main" id="{E5FAB211-24D3-4590-9A7A-677F0CDFC489}"/>
               </a:ext>
             </a:extLst>
           </p:cNvPr>
@@ -27663,7 +27663,7 @@
           <p:cNvPr id="10" name="Rounded Rectangle 9">
             <a:extLst xmlns:a="http://schemas.openxmlformats.org/drawingml/2006/main">
               <a:ext uri="{FF2B5EF4-FFF2-40B4-BE49-F238E27FC236}">
-                <a16:creationId xmlns:a16="http://schemas.microsoft.com/office/drawing/2014/main" id="{C08CDB56-E939-4BF9-8555-EA0BC1556929}"/>
+                <a16:creationId xmlns:a16="http://schemas.microsoft.com/office/drawing/2014/main" id="{59E28F05-1A72-47F8-9998-F2FEA83491AB}"/>
               </a:ext>
             </a:extLst>
           </p:cNvPr>
@@ -27720,7 +27720,7 @@
           <p:cNvPr id="11" name="TextBox 10">
             <a:extLst xmlns:a="http://schemas.openxmlformats.org/drawingml/2006/main">
               <a:ext uri="{FF2B5EF4-FFF2-40B4-BE49-F238E27FC236}">
-                <a16:creationId xmlns:a16="http://schemas.microsoft.com/office/drawing/2014/main" id="{1C344D4D-296E-432E-BBA2-03F99C3011D7}"/>
+                <a16:creationId xmlns:a16="http://schemas.microsoft.com/office/drawing/2014/main" id="{7BA7B35C-FC46-4474-B3D7-CA342C2702D6}"/>
               </a:ext>
             </a:extLst>
           </p:cNvPr>
@@ -27767,7 +27767,7 @@
           <p:cNvPr id="12" name="TextBox 11">
             <a:extLst xmlns:a="http://schemas.openxmlformats.org/drawingml/2006/main">
               <a:ext uri="{FF2B5EF4-FFF2-40B4-BE49-F238E27FC236}">
-                <a16:creationId xmlns:a16="http://schemas.microsoft.com/office/drawing/2014/main" id="{7AC936B5-CB92-49D9-A5D9-6090423D9FF0}"/>
+                <a16:creationId xmlns:a16="http://schemas.microsoft.com/office/drawing/2014/main" id="{E715A0C5-69E8-459D-99AB-7DF1EA734A9C}"/>
               </a:ext>
             </a:extLst>
           </p:cNvPr>
@@ -27812,7 +27812,7 @@
     </p:spTree>
     <p:extLst>
       <p:ext uri="{BB962C8B-B14F-4D97-AF65-F5344CB8AC3E}">
-        <p14:creationId xmlns:p14="http://schemas.microsoft.com/office/powerpoint/2010/main" val="1511580907"/>
+        <p14:creationId xmlns:p14="http://schemas.microsoft.com/office/powerpoint/2010/main" val="2012476660"/>
       </p:ext>
     </p:extLst>
   </p:cSld>
@@ -27836,7 +27836,7 @@
           <p:cNvPr id="2" name="TextBox 1">
             <a:extLst xmlns:a="http://schemas.openxmlformats.org/drawingml/2006/main">
               <a:ext uri="{FF2B5EF4-FFF2-40B4-BE49-F238E27FC236}">
-                <a16:creationId xmlns:a16="http://schemas.microsoft.com/office/drawing/2014/main" id="{3281E17B-9B76-4F46-8F4E-3288172D998A}"/>
+                <a16:creationId xmlns:a16="http://schemas.microsoft.com/office/drawing/2014/main" id="{F28AB2C8-9ADA-4AA3-9F9C-A5DD17EA28A7}"/>
               </a:ext>
             </a:extLst>
           </p:cNvPr>
@@ -27883,7 +27883,7 @@
           <p:cNvPr id="3" name="TextBox 2">
             <a:extLst xmlns:a="http://schemas.openxmlformats.org/drawingml/2006/main">
               <a:ext uri="{FF2B5EF4-FFF2-40B4-BE49-F238E27FC236}">
-                <a16:creationId xmlns:a16="http://schemas.microsoft.com/office/drawing/2014/main" id="{02D5FA6C-B583-4E10-9ADF-222623D40754}"/>
+                <a16:creationId xmlns:a16="http://schemas.microsoft.com/office/drawing/2014/main" id="{98136BB7-BC91-44C0-9E8C-4AEE74645792}"/>
               </a:ext>
             </a:extLst>
           </p:cNvPr>
@@ -27930,7 +27930,7 @@
           <p:cNvPr id="4" name="Rectangle 3">
             <a:extLst xmlns:a="http://schemas.openxmlformats.org/drawingml/2006/main">
               <a:ext uri="{FF2B5EF4-FFF2-40B4-BE49-F238E27FC236}">
-                <a16:creationId xmlns:a16="http://schemas.microsoft.com/office/drawing/2014/main" id="{276B9391-C8E3-452D-BD11-727FF1A5DA0F}"/>
+                <a16:creationId xmlns:a16="http://schemas.microsoft.com/office/drawing/2014/main" id="{049F2503-33D1-4461-94D1-14B3E64A88AE}"/>
               </a:ext>
             </a:extLst>
           </p:cNvPr>
@@ -27985,7 +27985,7 @@
           <p:cNvPr id="5" name="Rectangle 4">
             <a:extLst xmlns:a="http://schemas.openxmlformats.org/drawingml/2006/main">
               <a:ext uri="{FF2B5EF4-FFF2-40B4-BE49-F238E27FC236}">
-                <a16:creationId xmlns:a16="http://schemas.microsoft.com/office/drawing/2014/main" id="{BE818B6A-536B-445F-B103-DA7DD47FE2C2}"/>
+                <a16:creationId xmlns:a16="http://schemas.microsoft.com/office/drawing/2014/main" id="{36FB01EB-5D1F-4DA7-A9BC-B58329654CAA}"/>
               </a:ext>
             </a:extLst>
           </p:cNvPr>
@@ -28040,7 +28040,7 @@
           <p:cNvPr id="6" name="TextBox 5">
             <a:extLst xmlns:a="http://schemas.openxmlformats.org/drawingml/2006/main">
               <a:ext uri="{FF2B5EF4-FFF2-40B4-BE49-F238E27FC236}">
-                <a16:creationId xmlns:a16="http://schemas.microsoft.com/office/drawing/2014/main" id="{01AFCE20-A5F5-4206-9377-C90EE873E025}"/>
+                <a16:creationId xmlns:a16="http://schemas.microsoft.com/office/drawing/2014/main" id="{BD522210-83B8-4190-B1AE-BDD27040EA0D}"/>
               </a:ext>
             </a:extLst>
           </p:cNvPr>
@@ -28077,7 +28077,7 @@
                 <a:ea typeface="Aptos"/>
                 <a:cs typeface="Aptos"/>
               </a:rPr>
-              <a:t>Independent public evidence summary · 2026.07.22-9 · 2026-07-22 · Sources: EP3032975B2</a:t>
+              <a:t>Independent public evidence summary · 2026.07.23-10 · 2026-07-22 · Sources: EP3032975B2</a:t>
             </a:r>
           </a:p>
         </p:txBody>
@@ -28087,7 +28087,7 @@
           <p:cNvPr id="7" name="TextBox 6">
             <a:extLst xmlns:a="http://schemas.openxmlformats.org/drawingml/2006/main">
               <a:ext uri="{FF2B5EF4-FFF2-40B4-BE49-F238E27FC236}">
-                <a16:creationId xmlns:a16="http://schemas.microsoft.com/office/drawing/2014/main" id="{8F40E579-2118-4AE1-B5B6-C0653EA82460}"/>
+                <a16:creationId xmlns:a16="http://schemas.microsoft.com/office/drawing/2014/main" id="{E92DCBAD-BF08-4374-BD8C-43472C6A6C50}"/>
               </a:ext>
             </a:extLst>
           </p:cNvPr>
@@ -28657,7 +28657,7 @@
           <p:cNvPr id="9" name="TextBox 8">
             <a:extLst xmlns:a="http://schemas.openxmlformats.org/drawingml/2006/main">
               <a:ext uri="{FF2B5EF4-FFF2-40B4-BE49-F238E27FC236}">
-                <a16:creationId xmlns:a16="http://schemas.microsoft.com/office/drawing/2014/main" id="{2FDB45C9-76B8-47F7-BDA0-AE76C75DF389}"/>
+                <a16:creationId xmlns:a16="http://schemas.microsoft.com/office/drawing/2014/main" id="{4DBE734C-44D9-4BFF-8706-FBBA470B5396}"/>
               </a:ext>
             </a:extLst>
           </p:cNvPr>
@@ -28702,7 +28702,7 @@
     </p:spTree>
     <p:extLst>
       <p:ext uri="{BB962C8B-B14F-4D97-AF65-F5344CB8AC3E}">
-        <p14:creationId xmlns:p14="http://schemas.microsoft.com/office/powerpoint/2010/main" val="191392355"/>
+        <p14:creationId xmlns:p14="http://schemas.microsoft.com/office/powerpoint/2010/main" val="1357717513"/>
       </p:ext>
     </p:extLst>
   </p:cSld>
@@ -28726,7 +28726,7 @@
           <p:cNvPr id="2" name="TextBox 1">
             <a:extLst xmlns:a="http://schemas.openxmlformats.org/drawingml/2006/main">
               <a:ext uri="{FF2B5EF4-FFF2-40B4-BE49-F238E27FC236}">
-                <a16:creationId xmlns:a16="http://schemas.microsoft.com/office/drawing/2014/main" id="{4B463AD2-7E2E-4157-ADFD-F299D24D7188}"/>
+                <a16:creationId xmlns:a16="http://schemas.microsoft.com/office/drawing/2014/main" id="{C0F255FE-F014-4249-AC27-279019447F69}"/>
               </a:ext>
             </a:extLst>
           </p:cNvPr>
@@ -28773,7 +28773,7 @@
           <p:cNvPr id="3" name="TextBox 2">
             <a:extLst xmlns:a="http://schemas.openxmlformats.org/drawingml/2006/main">
               <a:ext uri="{FF2B5EF4-FFF2-40B4-BE49-F238E27FC236}">
-                <a16:creationId xmlns:a16="http://schemas.microsoft.com/office/drawing/2014/main" id="{070B91EC-48D3-406A-A910-727B9B2C5EB2}"/>
+                <a16:creationId xmlns:a16="http://schemas.microsoft.com/office/drawing/2014/main" id="{EF526671-8FE8-4179-B127-455CE2AA95C6}"/>
               </a:ext>
             </a:extLst>
           </p:cNvPr>
@@ -28820,7 +28820,7 @@
           <p:cNvPr id="4" name="Rectangle 3">
             <a:extLst xmlns:a="http://schemas.openxmlformats.org/drawingml/2006/main">
               <a:ext uri="{FF2B5EF4-FFF2-40B4-BE49-F238E27FC236}">
-                <a16:creationId xmlns:a16="http://schemas.microsoft.com/office/drawing/2014/main" id="{F21AF8F7-985C-4394-8C56-E0A07AD8C7A0}"/>
+                <a16:creationId xmlns:a16="http://schemas.microsoft.com/office/drawing/2014/main" id="{805F5BCA-46A6-4CB5-A930-4300494441BE}"/>
               </a:ext>
             </a:extLst>
           </p:cNvPr>
@@ -28875,7 +28875,7 @@
           <p:cNvPr id="5" name="Rectangle 4">
             <a:extLst xmlns:a="http://schemas.openxmlformats.org/drawingml/2006/main">
               <a:ext uri="{FF2B5EF4-FFF2-40B4-BE49-F238E27FC236}">
-                <a16:creationId xmlns:a16="http://schemas.microsoft.com/office/drawing/2014/main" id="{7E4098A7-BA03-4FA5-A052-F2C59E9BB68A}"/>
+                <a16:creationId xmlns:a16="http://schemas.microsoft.com/office/drawing/2014/main" id="{B9B83AC9-3D2F-4ADE-BBF6-53720778887A}"/>
               </a:ext>
             </a:extLst>
           </p:cNvPr>
@@ -28930,7 +28930,7 @@
           <p:cNvPr id="6" name="TextBox 5">
             <a:extLst xmlns:a="http://schemas.openxmlformats.org/drawingml/2006/main">
               <a:ext uri="{FF2B5EF4-FFF2-40B4-BE49-F238E27FC236}">
-                <a16:creationId xmlns:a16="http://schemas.microsoft.com/office/drawing/2014/main" id="{4B7D0F1D-7E41-44DC-BBD0-17C20A46FB77}"/>
+                <a16:creationId xmlns:a16="http://schemas.microsoft.com/office/drawing/2014/main" id="{2545413C-E3CE-4604-A5F2-A78B2E449305}"/>
               </a:ext>
             </a:extLst>
           </p:cNvPr>
@@ -28967,7 +28967,7 @@
                 <a:ea typeface="Aptos"/>
                 <a:cs typeface="Aptos"/>
               </a:rPr>
-              <a:t>Independent public evidence summary · 2026.07.22-9 · 2026-07-22 · Sources: EPO Register; B2</a:t>
+              <a:t>Independent public evidence summary · 2026.07.23-10 · 2026-07-22 · Sources: EPO Register; B2</a:t>
             </a:r>
           </a:p>
         </p:txBody>
@@ -28977,7 +28977,7 @@
           <p:cNvPr id="7" name="TextBox 6">
             <a:extLst xmlns:a="http://schemas.openxmlformats.org/drawingml/2006/main">
               <a:ext uri="{FF2B5EF4-FFF2-40B4-BE49-F238E27FC236}">
-                <a16:creationId xmlns:a16="http://schemas.microsoft.com/office/drawing/2014/main" id="{F4B02055-68FF-44C5-BCFC-4A5C5348702A}"/>
+                <a16:creationId xmlns:a16="http://schemas.microsoft.com/office/drawing/2014/main" id="{DEB769A1-C080-466F-BD0B-1D8B114610A4}"/>
               </a:ext>
             </a:extLst>
           </p:cNvPr>
@@ -29024,7 +29024,7 @@
           <p:cNvPr id="8" name="Rounded Rectangle 7">
             <a:extLst xmlns:a="http://schemas.openxmlformats.org/drawingml/2006/main">
               <a:ext uri="{FF2B5EF4-FFF2-40B4-BE49-F238E27FC236}">
-                <a16:creationId xmlns:a16="http://schemas.microsoft.com/office/drawing/2014/main" id="{E5FF2D78-BE65-4960-9FEE-BE04CAD85056}"/>
+                <a16:creationId xmlns:a16="http://schemas.microsoft.com/office/drawing/2014/main" id="{037AE4D6-D7F2-43B3-9FB7-B772ECE8E052}"/>
               </a:ext>
             </a:extLst>
           </p:cNvPr>
@@ -29081,7 +29081,7 @@
           <p:cNvPr id="9" name="TextBox 8">
             <a:extLst xmlns:a="http://schemas.openxmlformats.org/drawingml/2006/main">
               <a:ext uri="{FF2B5EF4-FFF2-40B4-BE49-F238E27FC236}">
-                <a16:creationId xmlns:a16="http://schemas.microsoft.com/office/drawing/2014/main" id="{F79D9F95-1EA6-4217-8D7A-2808CAE3B93C}"/>
+                <a16:creationId xmlns:a16="http://schemas.microsoft.com/office/drawing/2014/main" id="{12D6807D-D9AA-47AE-9535-A8259A255571}"/>
               </a:ext>
             </a:extLst>
           </p:cNvPr>
@@ -29128,7 +29128,7 @@
           <p:cNvPr id="10" name="TextBox 9">
             <a:extLst xmlns:a="http://schemas.openxmlformats.org/drawingml/2006/main">
               <a:ext uri="{FF2B5EF4-FFF2-40B4-BE49-F238E27FC236}">
-                <a16:creationId xmlns:a16="http://schemas.microsoft.com/office/drawing/2014/main" id="{D41BF304-D417-42CE-8DE8-0EAC2898CD83}"/>
+                <a16:creationId xmlns:a16="http://schemas.microsoft.com/office/drawing/2014/main" id="{B0FDAA0D-0B42-47AA-8DD5-72A9DE8C7C56}"/>
               </a:ext>
             </a:extLst>
           </p:cNvPr>
@@ -29175,7 +29175,7 @@
           <p:cNvPr id="11" name="Rounded Rectangle 10">
             <a:extLst xmlns:a="http://schemas.openxmlformats.org/drawingml/2006/main">
               <a:ext uri="{FF2B5EF4-FFF2-40B4-BE49-F238E27FC236}">
-                <a16:creationId xmlns:a16="http://schemas.microsoft.com/office/drawing/2014/main" id="{9723800E-07FE-4864-8BB9-F6D32CBBFA30}"/>
+                <a16:creationId xmlns:a16="http://schemas.microsoft.com/office/drawing/2014/main" id="{48787EE4-349E-4CF5-80DF-9C2393083967}"/>
               </a:ext>
             </a:extLst>
           </p:cNvPr>
@@ -29232,7 +29232,7 @@
           <p:cNvPr id="12" name="TextBox 11">
             <a:extLst xmlns:a="http://schemas.openxmlformats.org/drawingml/2006/main">
               <a:ext uri="{FF2B5EF4-FFF2-40B4-BE49-F238E27FC236}">
-                <a16:creationId xmlns:a16="http://schemas.microsoft.com/office/drawing/2014/main" id="{7D511301-AB35-49B9-9E6E-CF261081D997}"/>
+                <a16:creationId xmlns:a16="http://schemas.microsoft.com/office/drawing/2014/main" id="{EA4C6B9E-DFD0-4451-BA36-B65D00856C8C}"/>
               </a:ext>
             </a:extLst>
           </p:cNvPr>
@@ -29279,7 +29279,7 @@
           <p:cNvPr id="13" name="TextBox 12">
             <a:extLst xmlns:a="http://schemas.openxmlformats.org/drawingml/2006/main">
               <a:ext uri="{FF2B5EF4-FFF2-40B4-BE49-F238E27FC236}">
-                <a16:creationId xmlns:a16="http://schemas.microsoft.com/office/drawing/2014/main" id="{2FC34DF0-D788-419E-BFF2-41BFE59DAD24}"/>
+                <a16:creationId xmlns:a16="http://schemas.microsoft.com/office/drawing/2014/main" id="{CBBAA00B-DE80-4F1C-80C8-3F2B7CA7696F}"/>
               </a:ext>
             </a:extLst>
           </p:cNvPr>
@@ -29326,7 +29326,7 @@
           <p:cNvPr id="14" name="Rounded Rectangle 13">
             <a:extLst xmlns:a="http://schemas.openxmlformats.org/drawingml/2006/main">
               <a:ext uri="{FF2B5EF4-FFF2-40B4-BE49-F238E27FC236}">
-                <a16:creationId xmlns:a16="http://schemas.microsoft.com/office/drawing/2014/main" id="{67E3D468-32BE-4054-AD7A-9FE70008FEF4}"/>
+                <a16:creationId xmlns:a16="http://schemas.microsoft.com/office/drawing/2014/main" id="{E8970C3E-E2F9-41FE-8671-204838248CC7}"/>
               </a:ext>
             </a:extLst>
           </p:cNvPr>
@@ -29383,7 +29383,7 @@
           <p:cNvPr id="15" name="TextBox 14">
             <a:extLst xmlns:a="http://schemas.openxmlformats.org/drawingml/2006/main">
               <a:ext uri="{FF2B5EF4-FFF2-40B4-BE49-F238E27FC236}">
-                <a16:creationId xmlns:a16="http://schemas.microsoft.com/office/drawing/2014/main" id="{4465B154-EC09-4284-9B02-7227BF456F39}"/>
+                <a16:creationId xmlns:a16="http://schemas.microsoft.com/office/drawing/2014/main" id="{322CED65-3765-49B6-9101-9028434F08CA}"/>
               </a:ext>
             </a:extLst>
           </p:cNvPr>
@@ -29430,7 +29430,7 @@
           <p:cNvPr id="16" name="TextBox 15">
             <a:extLst xmlns:a="http://schemas.openxmlformats.org/drawingml/2006/main">
               <a:ext uri="{FF2B5EF4-FFF2-40B4-BE49-F238E27FC236}">
-                <a16:creationId xmlns:a16="http://schemas.microsoft.com/office/drawing/2014/main" id="{5A943CF4-476B-45C0-A5C5-AA841F28722E}"/>
+                <a16:creationId xmlns:a16="http://schemas.microsoft.com/office/drawing/2014/main" id="{BCC6A4DB-B63D-4F94-A13C-E87F7B541C33}"/>
               </a:ext>
             </a:extLst>
           </p:cNvPr>
@@ -29477,7 +29477,7 @@
           <p:cNvPr id="17" name="TextBox 16">
             <a:extLst xmlns:a="http://schemas.openxmlformats.org/drawingml/2006/main">
               <a:ext uri="{FF2B5EF4-FFF2-40B4-BE49-F238E27FC236}">
-                <a16:creationId xmlns:a16="http://schemas.microsoft.com/office/drawing/2014/main" id="{1CDA29A9-0755-4767-8098-AA218A3A9EA1}"/>
+                <a16:creationId xmlns:a16="http://schemas.microsoft.com/office/drawing/2014/main" id="{B6CB91B3-1C5A-4721-AC9D-01850DD30DDF}"/>
               </a:ext>
             </a:extLst>
           </p:cNvPr>
@@ -29524,7 +29524,7 @@
           <p:cNvPr id="18" name="Rounded Rectangle 17">
             <a:extLst xmlns:a="http://schemas.openxmlformats.org/drawingml/2006/main">
               <a:ext uri="{FF2B5EF4-FFF2-40B4-BE49-F238E27FC236}">
-                <a16:creationId xmlns:a16="http://schemas.microsoft.com/office/drawing/2014/main" id="{03E3708C-C153-45E3-9BFF-39E9A3A632F9}"/>
+                <a16:creationId xmlns:a16="http://schemas.microsoft.com/office/drawing/2014/main" id="{A0C41CE3-8C1F-4B7E-A8E7-A0A6627ABDC8}"/>
               </a:ext>
             </a:extLst>
           </p:cNvPr>
@@ -29581,7 +29581,7 @@
           <p:cNvPr id="19" name="TextBox 18">
             <a:extLst xmlns:a="http://schemas.openxmlformats.org/drawingml/2006/main">
               <a:ext uri="{FF2B5EF4-FFF2-40B4-BE49-F238E27FC236}">
-                <a16:creationId xmlns:a16="http://schemas.microsoft.com/office/drawing/2014/main" id="{CA51478F-2DFC-435F-B782-260D0A219B32}"/>
+                <a16:creationId xmlns:a16="http://schemas.microsoft.com/office/drawing/2014/main" id="{112C3525-E956-4425-B064-B0AC481D914F}"/>
               </a:ext>
             </a:extLst>
           </p:cNvPr>
@@ -29628,7 +29628,7 @@
           <p:cNvPr id="20" name="TextBox 19">
             <a:extLst xmlns:a="http://schemas.openxmlformats.org/drawingml/2006/main">
               <a:ext uri="{FF2B5EF4-FFF2-40B4-BE49-F238E27FC236}">
-                <a16:creationId xmlns:a16="http://schemas.microsoft.com/office/drawing/2014/main" id="{6EFD916A-A32F-4A83-98CD-7F95741E66B1}"/>
+                <a16:creationId xmlns:a16="http://schemas.microsoft.com/office/drawing/2014/main" id="{0E5E9028-5517-4A73-8E1F-73DB3C169A9D}"/>
               </a:ext>
             </a:extLst>
           </p:cNvPr>
@@ -29673,7 +29673,7 @@
     </p:spTree>
     <p:extLst>
       <p:ext uri="{BB962C8B-B14F-4D97-AF65-F5344CB8AC3E}">
-        <p14:creationId xmlns:p14="http://schemas.microsoft.com/office/powerpoint/2010/main" val="1502881297"/>
+        <p14:creationId xmlns:p14="http://schemas.microsoft.com/office/powerpoint/2010/main" val="664886785"/>
       </p:ext>
     </p:extLst>
   </p:cSld>
@@ -29697,7 +29697,7 @@
           <p:cNvPr id="2" name="TextBox 1">
             <a:extLst xmlns:a="http://schemas.openxmlformats.org/drawingml/2006/main">
               <a:ext uri="{FF2B5EF4-FFF2-40B4-BE49-F238E27FC236}">
-                <a16:creationId xmlns:a16="http://schemas.microsoft.com/office/drawing/2014/main" id="{1F85C460-0FC9-475A-BEFD-91CDFEE6C42C}"/>
+                <a16:creationId xmlns:a16="http://schemas.microsoft.com/office/drawing/2014/main" id="{D130B268-7874-432A-B9B8-478389B6B4B9}"/>
               </a:ext>
             </a:extLst>
           </p:cNvPr>
@@ -29744,7 +29744,7 @@
           <p:cNvPr id="3" name="TextBox 2">
             <a:extLst xmlns:a="http://schemas.openxmlformats.org/drawingml/2006/main">
               <a:ext uri="{FF2B5EF4-FFF2-40B4-BE49-F238E27FC236}">
-                <a16:creationId xmlns:a16="http://schemas.microsoft.com/office/drawing/2014/main" id="{5BACA264-B47E-46A4-8E7A-42B53BD30190}"/>
+                <a16:creationId xmlns:a16="http://schemas.microsoft.com/office/drawing/2014/main" id="{4748BDFF-E957-48B8-8811-C62AA0E5C3E4}"/>
               </a:ext>
             </a:extLst>
           </p:cNvPr>
@@ -29791,7 +29791,7 @@
           <p:cNvPr id="4" name="Rectangle 3">
             <a:extLst xmlns:a="http://schemas.openxmlformats.org/drawingml/2006/main">
               <a:ext uri="{FF2B5EF4-FFF2-40B4-BE49-F238E27FC236}">
-                <a16:creationId xmlns:a16="http://schemas.microsoft.com/office/drawing/2014/main" id="{3D986817-AC15-4D81-9DA2-BCE9D737EA68}"/>
+                <a16:creationId xmlns:a16="http://schemas.microsoft.com/office/drawing/2014/main" id="{3DE5A07B-154A-4BA3-BD48-6C55E6AFBC28}"/>
               </a:ext>
             </a:extLst>
           </p:cNvPr>
@@ -29846,7 +29846,7 @@
           <p:cNvPr id="5" name="Rectangle 4">
             <a:extLst xmlns:a="http://schemas.openxmlformats.org/drawingml/2006/main">
               <a:ext uri="{FF2B5EF4-FFF2-40B4-BE49-F238E27FC236}">
-                <a16:creationId xmlns:a16="http://schemas.microsoft.com/office/drawing/2014/main" id="{1FA7DF14-4866-409B-BA7C-CFAA47207720}"/>
+                <a16:creationId xmlns:a16="http://schemas.microsoft.com/office/drawing/2014/main" id="{70E12C48-1C6C-49D2-83A5-74445D4B3E97}"/>
               </a:ext>
             </a:extLst>
           </p:cNvPr>
@@ -29901,7 +29901,7 @@
           <p:cNvPr id="6" name="TextBox 5">
             <a:extLst xmlns:a="http://schemas.openxmlformats.org/drawingml/2006/main">
               <a:ext uri="{FF2B5EF4-FFF2-40B4-BE49-F238E27FC236}">
-                <a16:creationId xmlns:a16="http://schemas.microsoft.com/office/drawing/2014/main" id="{BCB5B9D5-AACA-4CB7-9B53-5F6DF15E1756}"/>
+                <a16:creationId xmlns:a16="http://schemas.microsoft.com/office/drawing/2014/main" id="{AC2483C3-9A64-4BDC-A229-6D8EA3316D0C}"/>
               </a:ext>
             </a:extLst>
           </p:cNvPr>
@@ -29938,7 +29938,7 @@
                 <a:ea typeface="Aptos"/>
                 <a:cs typeface="Aptos"/>
               </a:rPr>
-              <a:t>Independent public evidence summary · 2026.07.22-9 · 2026-07-22 · Sources: EPO family; national registers</a:t>
+              <a:t>Independent public evidence summary · 2026.07.23-10 · 2026-07-22 · Sources: EPO family; national registers</a:t>
             </a:r>
           </a:p>
         </p:txBody>
@@ -29948,7 +29948,7 @@
           <p:cNvPr id="7" name="TextBox 6">
             <a:extLst xmlns:a="http://schemas.openxmlformats.org/drawingml/2006/main">
               <a:ext uri="{FF2B5EF4-FFF2-40B4-BE49-F238E27FC236}">
-                <a16:creationId xmlns:a16="http://schemas.microsoft.com/office/drawing/2014/main" id="{CF3E946A-196F-466F-A998-DAE328B13429}"/>
+                <a16:creationId xmlns:a16="http://schemas.microsoft.com/office/drawing/2014/main" id="{E7EC4605-5EB3-4E9F-AE47-9388DE1FD6B5}"/>
               </a:ext>
             </a:extLst>
           </p:cNvPr>
@@ -29995,7 +29995,7 @@
           <p:cNvPr id="8" name="Rounded Rectangle 7">
             <a:extLst xmlns:a="http://schemas.openxmlformats.org/drawingml/2006/main">
               <a:ext uri="{FF2B5EF4-FFF2-40B4-BE49-F238E27FC236}">
-                <a16:creationId xmlns:a16="http://schemas.microsoft.com/office/drawing/2014/main" id="{E354748C-E401-4C4A-B5EA-CB8CA8020DF0}"/>
+                <a16:creationId xmlns:a16="http://schemas.microsoft.com/office/drawing/2014/main" id="{3DF2DAE6-6EA5-4179-A4D1-73865299DEAD}"/>
               </a:ext>
             </a:extLst>
           </p:cNvPr>
@@ -30052,7 +30052,7 @@
           <p:cNvPr id="9" name="TextBox 8">
             <a:extLst xmlns:a="http://schemas.openxmlformats.org/drawingml/2006/main">
               <a:ext uri="{FF2B5EF4-FFF2-40B4-BE49-F238E27FC236}">
-                <a16:creationId xmlns:a16="http://schemas.microsoft.com/office/drawing/2014/main" id="{8DBA2817-ABED-43F2-ADBA-5C0C61DD282D}"/>
+                <a16:creationId xmlns:a16="http://schemas.microsoft.com/office/drawing/2014/main" id="{E3543369-E835-405A-B058-090BC42938B1}"/>
               </a:ext>
             </a:extLst>
           </p:cNvPr>
@@ -30099,7 +30099,7 @@
           <p:cNvPr id="10" name="TextBox 9">
             <a:extLst xmlns:a="http://schemas.openxmlformats.org/drawingml/2006/main">
               <a:ext uri="{FF2B5EF4-FFF2-40B4-BE49-F238E27FC236}">
-                <a16:creationId xmlns:a16="http://schemas.microsoft.com/office/drawing/2014/main" id="{9A634BB8-385E-4C34-84D7-51654DE3A28A}"/>
+                <a16:creationId xmlns:a16="http://schemas.microsoft.com/office/drawing/2014/main" id="{8944A267-2CED-4DE8-8EBA-2684F0D44146}"/>
               </a:ext>
             </a:extLst>
           </p:cNvPr>
@@ -30146,7 +30146,7 @@
           <p:cNvPr id="11" name="Rounded Rectangle 10">
             <a:extLst xmlns:a="http://schemas.openxmlformats.org/drawingml/2006/main">
               <a:ext uri="{FF2B5EF4-FFF2-40B4-BE49-F238E27FC236}">
-                <a16:creationId xmlns:a16="http://schemas.microsoft.com/office/drawing/2014/main" id="{B9A6829C-4527-4493-9820-8293EFE1AEAC}"/>
+                <a16:creationId xmlns:a16="http://schemas.microsoft.com/office/drawing/2014/main" id="{C7ABFE91-7553-471D-90E1-F5BBDB048D7C}"/>
               </a:ext>
             </a:extLst>
           </p:cNvPr>
@@ -30203,7 +30203,7 @@
           <p:cNvPr id="12" name="TextBox 11">
             <a:extLst xmlns:a="http://schemas.openxmlformats.org/drawingml/2006/main">
               <a:ext uri="{FF2B5EF4-FFF2-40B4-BE49-F238E27FC236}">
-                <a16:creationId xmlns:a16="http://schemas.microsoft.com/office/drawing/2014/main" id="{83EBC911-5509-483F-B4A0-FAF788BFCBDA}"/>
+                <a16:creationId xmlns:a16="http://schemas.microsoft.com/office/drawing/2014/main" id="{97A90AF1-6F58-4057-B86A-3ACBC0881572}"/>
               </a:ext>
             </a:extLst>
           </p:cNvPr>
@@ -30250,7 +30250,7 @@
           <p:cNvPr id="13" name="TextBox 12">
             <a:extLst xmlns:a="http://schemas.openxmlformats.org/drawingml/2006/main">
               <a:ext uri="{FF2B5EF4-FFF2-40B4-BE49-F238E27FC236}">
-                <a16:creationId xmlns:a16="http://schemas.microsoft.com/office/drawing/2014/main" id="{6EC47865-5C1B-432A-B2F8-CEBBE7EEB769}"/>
+                <a16:creationId xmlns:a16="http://schemas.microsoft.com/office/drawing/2014/main" id="{8A376231-3268-4E4E-B8F5-E9768FFB8009}"/>
               </a:ext>
             </a:extLst>
           </p:cNvPr>
@@ -30297,7 +30297,7 @@
           <p:cNvPr id="14" name="Rounded Rectangle 13">
             <a:extLst xmlns:a="http://schemas.openxmlformats.org/drawingml/2006/main">
               <a:ext uri="{FF2B5EF4-FFF2-40B4-BE49-F238E27FC236}">
-                <a16:creationId xmlns:a16="http://schemas.microsoft.com/office/drawing/2014/main" id="{E3155377-721A-4F72-A364-E1ED4F598827}"/>
+                <a16:creationId xmlns:a16="http://schemas.microsoft.com/office/drawing/2014/main" id="{9FA7D0A0-2571-489A-B0F7-864CFA759E91}"/>
               </a:ext>
             </a:extLst>
           </p:cNvPr>
@@ -30354,7 +30354,7 @@
           <p:cNvPr id="15" name="TextBox 14">
             <a:extLst xmlns:a="http://schemas.openxmlformats.org/drawingml/2006/main">
               <a:ext uri="{FF2B5EF4-FFF2-40B4-BE49-F238E27FC236}">
-                <a16:creationId xmlns:a16="http://schemas.microsoft.com/office/drawing/2014/main" id="{4EBB0956-E332-47B8-A852-B92019A56E3A}"/>
+                <a16:creationId xmlns:a16="http://schemas.microsoft.com/office/drawing/2014/main" id="{C3E7F8CD-E972-4C9F-92BF-72DEC4E30C18}"/>
               </a:ext>
             </a:extLst>
           </p:cNvPr>
@@ -30401,7 +30401,7 @@
           <p:cNvPr id="16" name="TextBox 15">
             <a:extLst xmlns:a="http://schemas.openxmlformats.org/drawingml/2006/main">
               <a:ext uri="{FF2B5EF4-FFF2-40B4-BE49-F238E27FC236}">
-                <a16:creationId xmlns:a16="http://schemas.microsoft.com/office/drawing/2014/main" id="{B607D192-AFFC-45DF-9D0C-9F31FB11F4AA}"/>
+                <a16:creationId xmlns:a16="http://schemas.microsoft.com/office/drawing/2014/main" id="{9728CEC8-8AB9-44D3-8518-D4DE63B4ECAE}"/>
               </a:ext>
             </a:extLst>
           </p:cNvPr>
@@ -30448,7 +30448,7 @@
           <p:cNvPr id="17" name="Rounded Rectangle 16">
             <a:extLst xmlns:a="http://schemas.openxmlformats.org/drawingml/2006/main">
               <a:ext uri="{FF2B5EF4-FFF2-40B4-BE49-F238E27FC236}">
-                <a16:creationId xmlns:a16="http://schemas.microsoft.com/office/drawing/2014/main" id="{1B352597-ADE2-4DE7-A6E2-C9096A1FC01B}"/>
+                <a16:creationId xmlns:a16="http://schemas.microsoft.com/office/drawing/2014/main" id="{BC9A1E57-ADAB-4EE6-81B4-6DBC70E210B7}"/>
               </a:ext>
             </a:extLst>
           </p:cNvPr>
@@ -30505,7 +30505,7 @@
           <p:cNvPr id="18" name="TextBox 17">
             <a:extLst xmlns:a="http://schemas.openxmlformats.org/drawingml/2006/main">
               <a:ext uri="{FF2B5EF4-FFF2-40B4-BE49-F238E27FC236}">
-                <a16:creationId xmlns:a16="http://schemas.microsoft.com/office/drawing/2014/main" id="{6BD6BCEB-C4A1-474E-AA68-DBA0E1E82D25}"/>
+                <a16:creationId xmlns:a16="http://schemas.microsoft.com/office/drawing/2014/main" id="{87644F90-4C69-4017-9655-1E187BFF6811}"/>
               </a:ext>
             </a:extLst>
           </p:cNvPr>
@@ -30552,7 +30552,7 @@
           <p:cNvPr id="19" name="TextBox 18">
             <a:extLst xmlns:a="http://schemas.openxmlformats.org/drawingml/2006/main">
               <a:ext uri="{FF2B5EF4-FFF2-40B4-BE49-F238E27FC236}">
-                <a16:creationId xmlns:a16="http://schemas.microsoft.com/office/drawing/2014/main" id="{77469775-6D7C-4887-A3EA-4C561081403F}"/>
+                <a16:creationId xmlns:a16="http://schemas.microsoft.com/office/drawing/2014/main" id="{65C38000-1116-4459-943E-4B8D8B6438DC}"/>
               </a:ext>
             </a:extLst>
           </p:cNvPr>
@@ -30599,7 +30599,7 @@
           <p:cNvPr id="20" name="TextBox 19">
             <a:extLst xmlns:a="http://schemas.openxmlformats.org/drawingml/2006/main">
               <a:ext uri="{FF2B5EF4-FFF2-40B4-BE49-F238E27FC236}">
-                <a16:creationId xmlns:a16="http://schemas.microsoft.com/office/drawing/2014/main" id="{98BC8E10-5F47-433F-91BE-166F28150D6B}"/>
+                <a16:creationId xmlns:a16="http://schemas.microsoft.com/office/drawing/2014/main" id="{C5B2E74E-7488-4DA7-9012-F0BB59652F46}"/>
               </a:ext>
             </a:extLst>
           </p:cNvPr>
@@ -30646,7 +30646,7 @@
           <p:cNvPr id="21" name="Rounded Rectangle 20">
             <a:extLst xmlns:a="http://schemas.openxmlformats.org/drawingml/2006/main">
               <a:ext uri="{FF2B5EF4-FFF2-40B4-BE49-F238E27FC236}">
-                <a16:creationId xmlns:a16="http://schemas.microsoft.com/office/drawing/2014/main" id="{3B4C493A-6A11-4625-A17E-B8E064D9B594}"/>
+                <a16:creationId xmlns:a16="http://schemas.microsoft.com/office/drawing/2014/main" id="{6310FB59-988A-44AE-B323-973763CBAD1F}"/>
               </a:ext>
             </a:extLst>
           </p:cNvPr>
@@ -30703,7 +30703,7 @@
           <p:cNvPr id="22" name="TextBox 21">
             <a:extLst xmlns:a="http://schemas.openxmlformats.org/drawingml/2006/main">
               <a:ext uri="{FF2B5EF4-FFF2-40B4-BE49-F238E27FC236}">
-                <a16:creationId xmlns:a16="http://schemas.microsoft.com/office/drawing/2014/main" id="{64119EA7-164B-4C27-8B57-E68D6C572BDE}"/>
+                <a16:creationId xmlns:a16="http://schemas.microsoft.com/office/drawing/2014/main" id="{73C96886-655A-435E-93B3-CC1A6E0E89A4}"/>
               </a:ext>
             </a:extLst>
           </p:cNvPr>
@@ -30750,7 +30750,7 @@
           <p:cNvPr id="23" name="TextBox 22">
             <a:extLst xmlns:a="http://schemas.openxmlformats.org/drawingml/2006/main">
               <a:ext uri="{FF2B5EF4-FFF2-40B4-BE49-F238E27FC236}">
-                <a16:creationId xmlns:a16="http://schemas.microsoft.com/office/drawing/2014/main" id="{75D54E7B-E8F0-41AD-9015-67888E8C0F3C}"/>
+                <a16:creationId xmlns:a16="http://schemas.microsoft.com/office/drawing/2014/main" id="{F09E23F0-6FE5-4299-B663-5587186FE918}"/>
               </a:ext>
             </a:extLst>
           </p:cNvPr>
@@ -30795,7 +30795,7 @@
     </p:spTree>
     <p:extLst>
       <p:ext uri="{BB962C8B-B14F-4D97-AF65-F5344CB8AC3E}">
-        <p14:creationId xmlns:p14="http://schemas.microsoft.com/office/powerpoint/2010/main" val="1254853679"/>
+        <p14:creationId xmlns:p14="http://schemas.microsoft.com/office/powerpoint/2010/main" val="1262548599"/>
       </p:ext>
     </p:extLst>
   </p:cSld>
@@ -30819,7 +30819,7 @@
           <p:cNvPr id="2" name="TextBox 1">
             <a:extLst xmlns:a="http://schemas.openxmlformats.org/drawingml/2006/main">
               <a:ext uri="{FF2B5EF4-FFF2-40B4-BE49-F238E27FC236}">
-                <a16:creationId xmlns:a16="http://schemas.microsoft.com/office/drawing/2014/main" id="{1F86B18E-D37E-42D5-939C-C13C68556CC6}"/>
+                <a16:creationId xmlns:a16="http://schemas.microsoft.com/office/drawing/2014/main" id="{17928046-A228-4039-BA32-8FA77890F76C}"/>
               </a:ext>
             </a:extLst>
           </p:cNvPr>
@@ -30866,7 +30866,7 @@
           <p:cNvPr id="3" name="TextBox 2">
             <a:extLst xmlns:a="http://schemas.openxmlformats.org/drawingml/2006/main">
               <a:ext uri="{FF2B5EF4-FFF2-40B4-BE49-F238E27FC236}">
-                <a16:creationId xmlns:a16="http://schemas.microsoft.com/office/drawing/2014/main" id="{12FC2B2F-A43C-453C-963A-6A9219B30281}"/>
+                <a16:creationId xmlns:a16="http://schemas.microsoft.com/office/drawing/2014/main" id="{0759DE54-22C5-49E0-ABE5-58BBC77CA466}"/>
               </a:ext>
             </a:extLst>
           </p:cNvPr>
@@ -30913,7 +30913,7 @@
           <p:cNvPr id="4" name="Rectangle 3">
             <a:extLst xmlns:a="http://schemas.openxmlformats.org/drawingml/2006/main">
               <a:ext uri="{FF2B5EF4-FFF2-40B4-BE49-F238E27FC236}">
-                <a16:creationId xmlns:a16="http://schemas.microsoft.com/office/drawing/2014/main" id="{4DC40BD4-F3E4-4F7C-BA26-75C97201CDD4}"/>
+                <a16:creationId xmlns:a16="http://schemas.microsoft.com/office/drawing/2014/main" id="{8C8B38C9-A4FC-4EBD-BAF1-48531484F505}"/>
               </a:ext>
             </a:extLst>
           </p:cNvPr>
@@ -30968,7 +30968,7 @@
           <p:cNvPr id="5" name="Rectangle 4">
             <a:extLst xmlns:a="http://schemas.openxmlformats.org/drawingml/2006/main">
               <a:ext uri="{FF2B5EF4-FFF2-40B4-BE49-F238E27FC236}">
-                <a16:creationId xmlns:a16="http://schemas.microsoft.com/office/drawing/2014/main" id="{1330912F-99CD-4DAC-BF5C-14877D4F6433}"/>
+                <a16:creationId xmlns:a16="http://schemas.microsoft.com/office/drawing/2014/main" id="{DC2A18FB-C7F4-49F4-8738-23B3B8805B4F}"/>
               </a:ext>
             </a:extLst>
           </p:cNvPr>
@@ -31023,7 +31023,7 @@
           <p:cNvPr id="6" name="TextBox 5">
             <a:extLst xmlns:a="http://schemas.openxmlformats.org/drawingml/2006/main">
               <a:ext uri="{FF2B5EF4-FFF2-40B4-BE49-F238E27FC236}">
-                <a16:creationId xmlns:a16="http://schemas.microsoft.com/office/drawing/2014/main" id="{C61978B0-8184-4DCC-93D1-648DC06E2D36}"/>
+                <a16:creationId xmlns:a16="http://schemas.microsoft.com/office/drawing/2014/main" id="{B0BD5FE0-5A99-4118-AC99-ADACEED5B4E6}"/>
               </a:ext>
             </a:extLst>
           </p:cNvPr>
@@ -31060,7 +31060,7 @@
                 <a:ea typeface="Aptos"/>
                 <a:cs typeface="Aptos"/>
               </a:rPr>
-              <a:t>Independent public evidence summary · 2026.07.22-9 · 2026-07-22 · Sources: Official judgments: 8 Ni 18/24 (EP); 7 O 3341/24</a:t>
+              <a:t>Independent public evidence summary · 2026.07.23-10 · 2026-07-22 · Sources: Official judgments: 8 Ni 18/24 (EP); 7 O 3341/24</a:t>
             </a:r>
           </a:p>
         </p:txBody>
@@ -31070,7 +31070,7 @@
           <p:cNvPr id="7" name="TextBox 6">
             <a:extLst xmlns:a="http://schemas.openxmlformats.org/drawingml/2006/main">
               <a:ext uri="{FF2B5EF4-FFF2-40B4-BE49-F238E27FC236}">
-                <a16:creationId xmlns:a16="http://schemas.microsoft.com/office/drawing/2014/main" id="{4F05FD3F-8F5E-4D4F-BD11-CCD845CB45DF}"/>
+                <a16:creationId xmlns:a16="http://schemas.microsoft.com/office/drawing/2014/main" id="{77CEAACA-00B6-486A-B429-8A2B215F5660}"/>
               </a:ext>
             </a:extLst>
           </p:cNvPr>
@@ -31391,7 +31391,7 @@
           <p:cNvPr id="9" name="TextBox 8">
             <a:extLst xmlns:a="http://schemas.openxmlformats.org/drawingml/2006/main">
               <a:ext uri="{FF2B5EF4-FFF2-40B4-BE49-F238E27FC236}">
-                <a16:creationId xmlns:a16="http://schemas.microsoft.com/office/drawing/2014/main" id="{3764FEA9-9D11-4EB7-AD70-AC9C542928DB}"/>
+                <a16:creationId xmlns:a16="http://schemas.microsoft.com/office/drawing/2014/main" id="{08BB7F44-71E3-4CDB-8FA9-C9E12C934A70}"/>
               </a:ext>
             </a:extLst>
           </p:cNvPr>
@@ -31436,7 +31436,7 @@
     </p:spTree>
     <p:extLst>
       <p:ext uri="{BB962C8B-B14F-4D97-AF65-F5344CB8AC3E}">
-        <p14:creationId xmlns:p14="http://schemas.microsoft.com/office/powerpoint/2010/main" val="26098725"/>
+        <p14:creationId xmlns:p14="http://schemas.microsoft.com/office/powerpoint/2010/main" val="896396466"/>
       </p:ext>
     </p:extLst>
   </p:cSld>

</xml_diff>

<commit_message>
Publish paid data procurement shortlist v11
</commit_message>
<xml_diff>
--- a/site/downloads/pixan-bank-deck-large-en.pptx
+++ b/site/downloads/pixan-bank-deck-large-en.pptx
@@ -2,42 +2,42 @@
 <file path=ppt/presentation.xml><?xml version="1.0" encoding="utf-8"?>
 <p:presentation xmlns:p="http://schemas.openxmlformats.org/presentationml/2006/main">
   <p:sldMasterIdLst>
-    <p:sldMasterId xmlns:r="http://schemas.openxmlformats.org/officeDocument/2006/relationships" id="2147483648" r:id="Ref5a49b8e33444ee"/>
+    <p:sldMasterId xmlns:r="http://schemas.openxmlformats.org/officeDocument/2006/relationships" id="2147483648" r:id="Re7e2019882044e15"/>
   </p:sldMasterIdLst>
   <p:notesMasterIdLst>
-    <p:notesMasterId xmlns:r="http://schemas.openxmlformats.org/officeDocument/2006/relationships" r:id="R5c967f926b054948"/>
+    <p:notesMasterId xmlns:r="http://schemas.openxmlformats.org/officeDocument/2006/relationships" r:id="R802a4da9f6b44856"/>
   </p:notesMasterIdLst>
   <p:sldIdLst>
-    <p:sldId xmlns:r="http://schemas.openxmlformats.org/officeDocument/2006/relationships" id="256" r:id="R51f76c2c33d54ebc"/>
-    <p:sldId xmlns:r="http://schemas.openxmlformats.org/officeDocument/2006/relationships" id="257" r:id="Rb6ca7651245e44bd"/>
-    <p:sldId xmlns:r="http://schemas.openxmlformats.org/officeDocument/2006/relationships" id="258" r:id="R728d3864eea54789"/>
-    <p:sldId xmlns:r="http://schemas.openxmlformats.org/officeDocument/2006/relationships" id="259" r:id="R887296ef3e5c41bd"/>
-    <p:sldId xmlns:r="http://schemas.openxmlformats.org/officeDocument/2006/relationships" id="260" r:id="R0964266d23544227"/>
-    <p:sldId xmlns:r="http://schemas.openxmlformats.org/officeDocument/2006/relationships" id="261" r:id="Rfcff9a4ef5ff4ae7"/>
-    <p:sldId xmlns:r="http://schemas.openxmlformats.org/officeDocument/2006/relationships" id="262" r:id="R7112d5d98d4a4983"/>
-    <p:sldId xmlns:r="http://schemas.openxmlformats.org/officeDocument/2006/relationships" id="263" r:id="R42a42d6de41544ae"/>
-    <p:sldId xmlns:r="http://schemas.openxmlformats.org/officeDocument/2006/relationships" id="264" r:id="R37a99e70731e41fe"/>
-    <p:sldId xmlns:r="http://schemas.openxmlformats.org/officeDocument/2006/relationships" id="265" r:id="R65afc73da1a34c04"/>
-    <p:sldId xmlns:r="http://schemas.openxmlformats.org/officeDocument/2006/relationships" id="266" r:id="R90d189aa4f134a19"/>
-    <p:sldId xmlns:r="http://schemas.openxmlformats.org/officeDocument/2006/relationships" id="267" r:id="Rd493ce9875fb40ad"/>
-    <p:sldId xmlns:r="http://schemas.openxmlformats.org/officeDocument/2006/relationships" id="268" r:id="R7b6d40e79ba44233"/>
-    <p:sldId xmlns:r="http://schemas.openxmlformats.org/officeDocument/2006/relationships" id="269" r:id="R39b5bfeb317b4cbd"/>
-    <p:sldId xmlns:r="http://schemas.openxmlformats.org/officeDocument/2006/relationships" id="270" r:id="R755731d64aa34ddc"/>
-    <p:sldId xmlns:r="http://schemas.openxmlformats.org/officeDocument/2006/relationships" id="271" r:id="Rfdf723c821904929"/>
-    <p:sldId xmlns:r="http://schemas.openxmlformats.org/officeDocument/2006/relationships" id="272" r:id="R7be044c8e0c74838"/>
-    <p:sldId xmlns:r="http://schemas.openxmlformats.org/officeDocument/2006/relationships" id="273" r:id="Raadd97d2e8a242cf"/>
-    <p:sldId xmlns:r="http://schemas.openxmlformats.org/officeDocument/2006/relationships" id="274" r:id="R7381ce146e4b478b"/>
-    <p:sldId xmlns:r="http://schemas.openxmlformats.org/officeDocument/2006/relationships" id="275" r:id="Rfe0fae9fe1c1489a"/>
-    <p:sldId xmlns:r="http://schemas.openxmlformats.org/officeDocument/2006/relationships" id="276" r:id="Rf9b199648b494dbb"/>
-    <p:sldId xmlns:r="http://schemas.openxmlformats.org/officeDocument/2006/relationships" id="277" r:id="R4873d6082fbc4c82"/>
-    <p:sldId xmlns:r="http://schemas.openxmlformats.org/officeDocument/2006/relationships" id="278" r:id="R4547eb5e8aa84604"/>
-    <p:sldId xmlns:r="http://schemas.openxmlformats.org/officeDocument/2006/relationships" id="279" r:id="R611b8110eafe4209"/>
-    <p:sldId xmlns:r="http://schemas.openxmlformats.org/officeDocument/2006/relationships" id="280" r:id="R15e9dc2682cf4158"/>
-    <p:sldId xmlns:r="http://schemas.openxmlformats.org/officeDocument/2006/relationships" id="281" r:id="Re5f890118f864b93"/>
-    <p:sldId xmlns:r="http://schemas.openxmlformats.org/officeDocument/2006/relationships" id="282" r:id="Rc21c7b9bc13842d6"/>
-    <p:sldId xmlns:r="http://schemas.openxmlformats.org/officeDocument/2006/relationships" id="283" r:id="R6bdca5e15de544ac"/>
-    <p:sldId xmlns:r="http://schemas.openxmlformats.org/officeDocument/2006/relationships" id="284" r:id="R57e2f9a531fe42da"/>
-    <p:sldId xmlns:r="http://schemas.openxmlformats.org/officeDocument/2006/relationships" id="285" r:id="Ra2cb064421854e20"/>
+    <p:sldId xmlns:r="http://schemas.openxmlformats.org/officeDocument/2006/relationships" id="256" r:id="Rdbd15247a94a47c9"/>
+    <p:sldId xmlns:r="http://schemas.openxmlformats.org/officeDocument/2006/relationships" id="257" r:id="R802680e7c5454b62"/>
+    <p:sldId xmlns:r="http://schemas.openxmlformats.org/officeDocument/2006/relationships" id="258" r:id="R6a3b740eaf304d7e"/>
+    <p:sldId xmlns:r="http://schemas.openxmlformats.org/officeDocument/2006/relationships" id="259" r:id="Rf9e6902db2fb4af2"/>
+    <p:sldId xmlns:r="http://schemas.openxmlformats.org/officeDocument/2006/relationships" id="260" r:id="Rf24a7298b3c54671"/>
+    <p:sldId xmlns:r="http://schemas.openxmlformats.org/officeDocument/2006/relationships" id="261" r:id="R8e88cf1d30f94d03"/>
+    <p:sldId xmlns:r="http://schemas.openxmlformats.org/officeDocument/2006/relationships" id="262" r:id="Rdc6bff2d12d843c2"/>
+    <p:sldId xmlns:r="http://schemas.openxmlformats.org/officeDocument/2006/relationships" id="263" r:id="Rf9fc0559d19348b9"/>
+    <p:sldId xmlns:r="http://schemas.openxmlformats.org/officeDocument/2006/relationships" id="264" r:id="R3ab9a4e3a6694c58"/>
+    <p:sldId xmlns:r="http://schemas.openxmlformats.org/officeDocument/2006/relationships" id="265" r:id="R69c792d8e6cf4051"/>
+    <p:sldId xmlns:r="http://schemas.openxmlformats.org/officeDocument/2006/relationships" id="266" r:id="R3d78e3a944a34bfd"/>
+    <p:sldId xmlns:r="http://schemas.openxmlformats.org/officeDocument/2006/relationships" id="267" r:id="R16d05dcf2bda430a"/>
+    <p:sldId xmlns:r="http://schemas.openxmlformats.org/officeDocument/2006/relationships" id="268" r:id="R70c5d9cc9b0a4f9b"/>
+    <p:sldId xmlns:r="http://schemas.openxmlformats.org/officeDocument/2006/relationships" id="269" r:id="Ra951ebbdf946466c"/>
+    <p:sldId xmlns:r="http://schemas.openxmlformats.org/officeDocument/2006/relationships" id="270" r:id="R8dc1785b943e4640"/>
+    <p:sldId xmlns:r="http://schemas.openxmlformats.org/officeDocument/2006/relationships" id="271" r:id="Rde5e759cb18a42b2"/>
+    <p:sldId xmlns:r="http://schemas.openxmlformats.org/officeDocument/2006/relationships" id="272" r:id="R1737235b89ba458a"/>
+    <p:sldId xmlns:r="http://schemas.openxmlformats.org/officeDocument/2006/relationships" id="273" r:id="Ra10f2db6d21b44d5"/>
+    <p:sldId xmlns:r="http://schemas.openxmlformats.org/officeDocument/2006/relationships" id="274" r:id="Rc2ff847a2f634276"/>
+    <p:sldId xmlns:r="http://schemas.openxmlformats.org/officeDocument/2006/relationships" id="275" r:id="R9d4c8068f8e24008"/>
+    <p:sldId xmlns:r="http://schemas.openxmlformats.org/officeDocument/2006/relationships" id="276" r:id="R42003a71fd2449c4"/>
+    <p:sldId xmlns:r="http://schemas.openxmlformats.org/officeDocument/2006/relationships" id="277" r:id="Rcde60cb5432e4778"/>
+    <p:sldId xmlns:r="http://schemas.openxmlformats.org/officeDocument/2006/relationships" id="278" r:id="R89819fbbe5c74fe1"/>
+    <p:sldId xmlns:r="http://schemas.openxmlformats.org/officeDocument/2006/relationships" id="279" r:id="Rf955841f08cb474c"/>
+    <p:sldId xmlns:r="http://schemas.openxmlformats.org/officeDocument/2006/relationships" id="280" r:id="R840335f4bca249a9"/>
+    <p:sldId xmlns:r="http://schemas.openxmlformats.org/officeDocument/2006/relationships" id="281" r:id="Ra1af903b893b4d96"/>
+    <p:sldId xmlns:r="http://schemas.openxmlformats.org/officeDocument/2006/relationships" id="282" r:id="R852c1820c4d44844"/>
+    <p:sldId xmlns:r="http://schemas.openxmlformats.org/officeDocument/2006/relationships" id="283" r:id="R6e40e57a34284278"/>
+    <p:sldId xmlns:r="http://schemas.openxmlformats.org/officeDocument/2006/relationships" id="284" r:id="Rddecc54555734b2f"/>
+    <p:sldId xmlns:r="http://schemas.openxmlformats.org/officeDocument/2006/relationships" id="285" r:id="R8f28f120f45d4582"/>
   </p:sldIdLst>
   <p:sldSz cx="12191999" cy="6858000"/>
   <p:notesSz cx="6858000" cy="9144000"/>
@@ -2546,7 +2546,7 @@
           <p:cNvPr id="2" name="Title 1">
             <a:extLst xmlns:a="http://schemas.openxmlformats.org/drawingml/2006/main">
               <a:ext uri="{FF2B5EF4-FFF2-40B4-BE49-F238E27FC236}">
-                <a16:creationId xmlns:a16="http://schemas.microsoft.com/office/drawing/2014/main" id="{0F263D0A-7A17-49AF-9E15-8C9B81D8EDAD}"/>
+                <a16:creationId xmlns:a16="http://schemas.microsoft.com/office/drawing/2014/main" id="{F7809EC4-1F78-491A-AF12-7F3FE2CAA5B3}"/>
               </a:ext>
             </a:extLst>
           </p:cNvPr>
@@ -2578,7 +2578,7 @@
           <p:cNvPr id="3" name="Subtitle 2">
             <a:extLst xmlns:a="http://schemas.openxmlformats.org/drawingml/2006/main">
               <a:ext uri="{FF2B5EF4-FFF2-40B4-BE49-F238E27FC236}">
-                <a16:creationId xmlns:a16="http://schemas.microsoft.com/office/drawing/2014/main" id="{33CE651E-9356-4C9A-AE02-68CA21CFDEA0}"/>
+                <a16:creationId xmlns:a16="http://schemas.microsoft.com/office/drawing/2014/main" id="{CAEF7FD6-62F5-4688-A062-8EB20C9FC22F}"/>
               </a:ext>
             </a:extLst>
           </p:cNvPr>
@@ -2701,7 +2701,7 @@
           <p:cNvPr id="4" name="Date Placeholder 3">
             <a:extLst xmlns:a="http://schemas.openxmlformats.org/drawingml/2006/main">
               <a:ext uri="{FF2B5EF4-FFF2-40B4-BE49-F238E27FC236}">
-                <a16:creationId xmlns:a16="http://schemas.microsoft.com/office/drawing/2014/main" id="{139E1B8C-5293-4AA1-A733-6EE5675CCF10}"/>
+                <a16:creationId xmlns:a16="http://schemas.microsoft.com/office/drawing/2014/main" id="{1717D429-BDD1-412D-AD1C-B968E7E4E6D3}"/>
               </a:ext>
             </a:extLst>
           </p:cNvPr>
@@ -2728,7 +2728,7 @@
           <p:cNvPr id="5" name="Footer Placeholder 4">
             <a:extLst xmlns:a="http://schemas.openxmlformats.org/drawingml/2006/main">
               <a:ext uri="{FF2B5EF4-FFF2-40B4-BE49-F238E27FC236}">
-                <a16:creationId xmlns:a16="http://schemas.microsoft.com/office/drawing/2014/main" id="{5EB15239-356B-425E-AD3A-159BABF8D12D}"/>
+                <a16:creationId xmlns:a16="http://schemas.microsoft.com/office/drawing/2014/main" id="{5C8FEBEC-CD04-4E11-B74D-589655BD46E3}"/>
               </a:ext>
             </a:extLst>
           </p:cNvPr>
@@ -2751,7 +2751,7 @@
           <p:cNvPr id="6" name="Slide Number Placeholder 5">
             <a:extLst xmlns:a="http://schemas.openxmlformats.org/drawingml/2006/main">
               <a:ext uri="{FF2B5EF4-FFF2-40B4-BE49-F238E27FC236}">
-                <a16:creationId xmlns:a16="http://schemas.microsoft.com/office/drawing/2014/main" id="{07C81122-C1FB-48A1-A053-C2A4BF2B0A55}"/>
+                <a16:creationId xmlns:a16="http://schemas.microsoft.com/office/drawing/2014/main" id="{B617E9FC-5FD3-4A9A-93C5-78E344B8B68A}"/>
               </a:ext>
             </a:extLst>
           </p:cNvPr>
@@ -2795,7 +2795,7 @@
           <p:cNvPr id="2" name="Title 1">
             <a:extLst xmlns:a="http://schemas.openxmlformats.org/drawingml/2006/main">
               <a:ext uri="{FF2B5EF4-FFF2-40B4-BE49-F238E27FC236}">
-                <a16:creationId xmlns:a16="http://schemas.microsoft.com/office/drawing/2014/main" id="{88689F9D-D90E-4212-AF5D-4DC3A778E3F9}"/>
+                <a16:creationId xmlns:a16="http://schemas.microsoft.com/office/drawing/2014/main" id="{4F0BE108-02BC-4BE7-B4E8-730C0C756B65}"/>
               </a:ext>
             </a:extLst>
           </p:cNvPr>
@@ -2822,7 +2822,7 @@
           <p:cNvPr id="3" name="Vertical Text Placeholder 2">
             <a:extLst xmlns:a="http://schemas.openxmlformats.org/drawingml/2006/main">
               <a:ext uri="{FF2B5EF4-FFF2-40B4-BE49-F238E27FC236}">
-                <a16:creationId xmlns:a16="http://schemas.microsoft.com/office/drawing/2014/main" id="{10EF1C08-EF34-466C-8BA3-229CBCF1C108}"/>
+                <a16:creationId xmlns:a16="http://schemas.microsoft.com/office/drawing/2014/main" id="{EE79F35C-3D32-4F47-9FBA-9097CA82CB23}"/>
               </a:ext>
             </a:extLst>
           </p:cNvPr>
@@ -2884,7 +2884,7 @@
           <p:cNvPr id="4" name="Date Placeholder 3">
             <a:extLst xmlns:a="http://schemas.openxmlformats.org/drawingml/2006/main">
               <a:ext uri="{FF2B5EF4-FFF2-40B4-BE49-F238E27FC236}">
-                <a16:creationId xmlns:a16="http://schemas.microsoft.com/office/drawing/2014/main" id="{97929792-CE4E-40B1-AF2B-1A5516E363D7}"/>
+                <a16:creationId xmlns:a16="http://schemas.microsoft.com/office/drawing/2014/main" id="{5645855B-22BE-4720-AB75-F9E3CB80BDE5}"/>
               </a:ext>
             </a:extLst>
           </p:cNvPr>
@@ -2911,7 +2911,7 @@
           <p:cNvPr id="5" name="Footer Placeholder 4">
             <a:extLst xmlns:a="http://schemas.openxmlformats.org/drawingml/2006/main">
               <a:ext uri="{FF2B5EF4-FFF2-40B4-BE49-F238E27FC236}">
-                <a16:creationId xmlns:a16="http://schemas.microsoft.com/office/drawing/2014/main" id="{CD88F3ED-EA7D-467A-9C52-05D50D443BD0}"/>
+                <a16:creationId xmlns:a16="http://schemas.microsoft.com/office/drawing/2014/main" id="{612D3F85-D364-40F7-96B2-AA032F16DA5F}"/>
               </a:ext>
             </a:extLst>
           </p:cNvPr>
@@ -2934,7 +2934,7 @@
           <p:cNvPr id="6" name="Slide Number Placeholder 5">
             <a:extLst xmlns:a="http://schemas.openxmlformats.org/drawingml/2006/main">
               <a:ext uri="{FF2B5EF4-FFF2-40B4-BE49-F238E27FC236}">
-                <a16:creationId xmlns:a16="http://schemas.microsoft.com/office/drawing/2014/main" id="{D107801E-00F9-487D-94DA-370DA0E5094D}"/>
+                <a16:creationId xmlns:a16="http://schemas.microsoft.com/office/drawing/2014/main" id="{2494F1CA-EA7B-4905-B1C8-758D7A236FE8}"/>
               </a:ext>
             </a:extLst>
           </p:cNvPr>
@@ -2978,7 +2978,7 @@
           <p:cNvPr id="2" name="Vertical Title 1">
             <a:extLst xmlns:a="http://schemas.openxmlformats.org/drawingml/2006/main">
               <a:ext uri="{FF2B5EF4-FFF2-40B4-BE49-F238E27FC236}">
-                <a16:creationId xmlns:a16="http://schemas.microsoft.com/office/drawing/2014/main" id="{96E88F34-EAB4-4595-A3D2-175AC418DD28}"/>
+                <a16:creationId xmlns:a16="http://schemas.microsoft.com/office/drawing/2014/main" id="{D8624403-4E97-4391-8FE0-F217F20E636A}"/>
               </a:ext>
             </a:extLst>
           </p:cNvPr>
@@ -3010,7 +3010,7 @@
           <p:cNvPr id="3" name="Vertical Text Placeholder 2">
             <a:extLst xmlns:a="http://schemas.openxmlformats.org/drawingml/2006/main">
               <a:ext uri="{FF2B5EF4-FFF2-40B4-BE49-F238E27FC236}">
-                <a16:creationId xmlns:a16="http://schemas.microsoft.com/office/drawing/2014/main" id="{D4F7F1DB-FE5D-4823-A3CD-C7F0D2237EC5}"/>
+                <a16:creationId xmlns:a16="http://schemas.microsoft.com/office/drawing/2014/main" id="{4645BA77-FD9C-4B47-8ECD-8F35F37E42BF}"/>
               </a:ext>
             </a:extLst>
           </p:cNvPr>
@@ -3077,7 +3077,7 @@
           <p:cNvPr id="4" name="Date Placeholder 3">
             <a:extLst xmlns:a="http://schemas.openxmlformats.org/drawingml/2006/main">
               <a:ext uri="{FF2B5EF4-FFF2-40B4-BE49-F238E27FC236}">
-                <a16:creationId xmlns:a16="http://schemas.microsoft.com/office/drawing/2014/main" id="{BC986B05-E101-4360-BC00-B898A475169A}"/>
+                <a16:creationId xmlns:a16="http://schemas.microsoft.com/office/drawing/2014/main" id="{A90F3831-201B-48AA-BA53-7B69D200B3C2}"/>
               </a:ext>
             </a:extLst>
           </p:cNvPr>
@@ -3104,7 +3104,7 @@
           <p:cNvPr id="5" name="Footer Placeholder 4">
             <a:extLst xmlns:a="http://schemas.openxmlformats.org/drawingml/2006/main">
               <a:ext uri="{FF2B5EF4-FFF2-40B4-BE49-F238E27FC236}">
-                <a16:creationId xmlns:a16="http://schemas.microsoft.com/office/drawing/2014/main" id="{20101DBA-9678-48FE-A7BE-E91B5FEBDA48}"/>
+                <a16:creationId xmlns:a16="http://schemas.microsoft.com/office/drawing/2014/main" id="{A16A7CF0-5011-40CD-BB42-D2E86B51F4CC}"/>
               </a:ext>
             </a:extLst>
           </p:cNvPr>
@@ -3127,7 +3127,7 @@
           <p:cNvPr id="6" name="Slide Number Placeholder 5">
             <a:extLst xmlns:a="http://schemas.openxmlformats.org/drawingml/2006/main">
               <a:ext uri="{FF2B5EF4-FFF2-40B4-BE49-F238E27FC236}">
-                <a16:creationId xmlns:a16="http://schemas.microsoft.com/office/drawing/2014/main" id="{4350D0D1-EA30-4033-B43D-62E0C7DB2B20}"/>
+                <a16:creationId xmlns:a16="http://schemas.microsoft.com/office/drawing/2014/main" id="{6BC1D610-9494-4800-9188-3D5A9E49A19E}"/>
               </a:ext>
             </a:extLst>
           </p:cNvPr>
@@ -3171,7 +3171,7 @@
           <p:cNvPr id="2" name="Title 1">
             <a:extLst xmlns:a="http://schemas.openxmlformats.org/drawingml/2006/main">
               <a:ext uri="{FF2B5EF4-FFF2-40B4-BE49-F238E27FC236}">
-                <a16:creationId xmlns:a16="http://schemas.microsoft.com/office/drawing/2014/main" id="{78915B9A-5B8F-4426-A131-2263FBEF2242}"/>
+                <a16:creationId xmlns:a16="http://schemas.microsoft.com/office/drawing/2014/main" id="{E7DD1674-2CC6-4D95-A90D-5058F88EBDF6}"/>
               </a:ext>
             </a:extLst>
           </p:cNvPr>
@@ -3198,7 +3198,7 @@
           <p:cNvPr id="3" name="Content Placeholder 2">
             <a:extLst xmlns:a="http://schemas.openxmlformats.org/drawingml/2006/main">
               <a:ext uri="{FF2B5EF4-FFF2-40B4-BE49-F238E27FC236}">
-                <a16:creationId xmlns:a16="http://schemas.microsoft.com/office/drawing/2014/main" id="{DB859555-37FA-4076-A123-CF1CAAEBD1A5}"/>
+                <a16:creationId xmlns:a16="http://schemas.microsoft.com/office/drawing/2014/main" id="{FA7AB130-F27B-4213-BCF3-4BF73361BC04}"/>
               </a:ext>
             </a:extLst>
           </p:cNvPr>
@@ -3260,7 +3260,7 @@
           <p:cNvPr id="4" name="Date Placeholder 3">
             <a:extLst xmlns:a="http://schemas.openxmlformats.org/drawingml/2006/main">
               <a:ext uri="{FF2B5EF4-FFF2-40B4-BE49-F238E27FC236}">
-                <a16:creationId xmlns:a16="http://schemas.microsoft.com/office/drawing/2014/main" id="{73905BC6-6270-4C51-AC51-A676D02873EE}"/>
+                <a16:creationId xmlns:a16="http://schemas.microsoft.com/office/drawing/2014/main" id="{43FCC16E-437D-49CA-9272-EF238AB79849}"/>
               </a:ext>
             </a:extLst>
           </p:cNvPr>
@@ -3287,7 +3287,7 @@
           <p:cNvPr id="5" name="Footer Placeholder 4">
             <a:extLst xmlns:a="http://schemas.openxmlformats.org/drawingml/2006/main">
               <a:ext uri="{FF2B5EF4-FFF2-40B4-BE49-F238E27FC236}">
-                <a16:creationId xmlns:a16="http://schemas.microsoft.com/office/drawing/2014/main" id="{54270016-0440-4A18-AAE4-04EC40CED869}"/>
+                <a16:creationId xmlns:a16="http://schemas.microsoft.com/office/drawing/2014/main" id="{ED416D9B-4B77-416F-88D8-F2976A2F9DB5}"/>
               </a:ext>
             </a:extLst>
           </p:cNvPr>
@@ -3310,7 +3310,7 @@
           <p:cNvPr id="6" name="Slide Number Placeholder 5">
             <a:extLst xmlns:a="http://schemas.openxmlformats.org/drawingml/2006/main">
               <a:ext uri="{FF2B5EF4-FFF2-40B4-BE49-F238E27FC236}">
-                <a16:creationId xmlns:a16="http://schemas.microsoft.com/office/drawing/2014/main" id="{F224D988-3792-4FC3-AFB4-435F28FC17CB}"/>
+                <a16:creationId xmlns:a16="http://schemas.microsoft.com/office/drawing/2014/main" id="{3EF9937D-A620-4720-BBC6-A2F488E48C1E}"/>
               </a:ext>
             </a:extLst>
           </p:cNvPr>
@@ -3354,7 +3354,7 @@
           <p:cNvPr id="2" name="Title 1">
             <a:extLst xmlns:a="http://schemas.openxmlformats.org/drawingml/2006/main">
               <a:ext uri="{FF2B5EF4-FFF2-40B4-BE49-F238E27FC236}">
-                <a16:creationId xmlns:a16="http://schemas.microsoft.com/office/drawing/2014/main" id="{7C70C37A-113E-4478-861B-6C022C934A82}"/>
+                <a16:creationId xmlns:a16="http://schemas.microsoft.com/office/drawing/2014/main" id="{94E9EF8A-FC8B-46CE-962B-AD19D8581E71}"/>
               </a:ext>
             </a:extLst>
           </p:cNvPr>
@@ -3391,7 +3391,7 @@
           <p:cNvPr id="3" name="Text Placeholder 2">
             <a:extLst xmlns:a="http://schemas.openxmlformats.org/drawingml/2006/main">
               <a:ext uri="{FF2B5EF4-FFF2-40B4-BE49-F238E27FC236}">
-                <a16:creationId xmlns:a16="http://schemas.microsoft.com/office/drawing/2014/main" id="{029024FB-EAF3-428F-99D8-573CA3B883D2}"/>
+                <a16:creationId xmlns:a16="http://schemas.microsoft.com/office/drawing/2014/main" id="{513D9717-1828-49AD-9F8C-4FDAA641A6CC}"/>
               </a:ext>
             </a:extLst>
           </p:cNvPr>
@@ -3517,7 +3517,7 @@
           <p:cNvPr id="4" name="Date Placeholder 3">
             <a:extLst xmlns:a="http://schemas.openxmlformats.org/drawingml/2006/main">
               <a:ext uri="{FF2B5EF4-FFF2-40B4-BE49-F238E27FC236}">
-                <a16:creationId xmlns:a16="http://schemas.microsoft.com/office/drawing/2014/main" id="{B4784A54-132F-4BAA-ADE7-9A012AB0FC77}"/>
+                <a16:creationId xmlns:a16="http://schemas.microsoft.com/office/drawing/2014/main" id="{B578AB29-2FAD-4ECF-9BB8-99263C16D722}"/>
               </a:ext>
             </a:extLst>
           </p:cNvPr>
@@ -3544,7 +3544,7 @@
           <p:cNvPr id="5" name="Footer Placeholder 4">
             <a:extLst xmlns:a="http://schemas.openxmlformats.org/drawingml/2006/main">
               <a:ext uri="{FF2B5EF4-FFF2-40B4-BE49-F238E27FC236}">
-                <a16:creationId xmlns:a16="http://schemas.microsoft.com/office/drawing/2014/main" id="{E7A92AA5-15CB-4453-9380-1BBCDAE2F967}"/>
+                <a16:creationId xmlns:a16="http://schemas.microsoft.com/office/drawing/2014/main" id="{9A1760C3-2F0C-4B48-BA15-018AE0FDAF46}"/>
               </a:ext>
             </a:extLst>
           </p:cNvPr>
@@ -3567,7 +3567,7 @@
           <p:cNvPr id="6" name="Slide Number Placeholder 5">
             <a:extLst xmlns:a="http://schemas.openxmlformats.org/drawingml/2006/main">
               <a:ext uri="{FF2B5EF4-FFF2-40B4-BE49-F238E27FC236}">
-                <a16:creationId xmlns:a16="http://schemas.microsoft.com/office/drawing/2014/main" id="{C948D2C8-4A9E-4C34-A100-10773340F2C9}"/>
+                <a16:creationId xmlns:a16="http://schemas.microsoft.com/office/drawing/2014/main" id="{1C85D8CD-FD29-4DC1-86B1-749BF7E81972}"/>
               </a:ext>
             </a:extLst>
           </p:cNvPr>
@@ -3611,7 +3611,7 @@
           <p:cNvPr id="2" name="Title 1">
             <a:extLst xmlns:a="http://schemas.openxmlformats.org/drawingml/2006/main">
               <a:ext uri="{FF2B5EF4-FFF2-40B4-BE49-F238E27FC236}">
-                <a16:creationId xmlns:a16="http://schemas.microsoft.com/office/drawing/2014/main" id="{9EA6BBD2-43A6-448B-A057-94DF852F13EF}"/>
+                <a16:creationId xmlns:a16="http://schemas.microsoft.com/office/drawing/2014/main" id="{2BF5DFF3-EC5D-46C6-94AC-C6D84D3B6AAC}"/>
               </a:ext>
             </a:extLst>
           </p:cNvPr>
@@ -3638,7 +3638,7 @@
           <p:cNvPr id="3" name="Content Placeholder 2">
             <a:extLst xmlns:a="http://schemas.openxmlformats.org/drawingml/2006/main">
               <a:ext uri="{FF2B5EF4-FFF2-40B4-BE49-F238E27FC236}">
-                <a16:creationId xmlns:a16="http://schemas.microsoft.com/office/drawing/2014/main" id="{B8BAD046-C4F7-4286-BD9E-F4678B331633}"/>
+                <a16:creationId xmlns:a16="http://schemas.microsoft.com/office/drawing/2014/main" id="{F01F61E4-4662-4819-B1D1-1C90220B952E}"/>
               </a:ext>
             </a:extLst>
           </p:cNvPr>
@@ -3742,7 +3742,7 @@
           <p:cNvPr id="4" name="Content Placeholder 3">
             <a:extLst xmlns:a="http://schemas.openxmlformats.org/drawingml/2006/main">
               <a:ext uri="{FF2B5EF4-FFF2-40B4-BE49-F238E27FC236}">
-                <a16:creationId xmlns:a16="http://schemas.microsoft.com/office/drawing/2014/main" id="{F3F3D957-4722-4869-8930-2C210E53DC37}"/>
+                <a16:creationId xmlns:a16="http://schemas.microsoft.com/office/drawing/2014/main" id="{2DDF5A29-C6D5-4351-8284-82A93160589D}"/>
               </a:ext>
             </a:extLst>
           </p:cNvPr>
@@ -3846,7 +3846,7 @@
           <p:cNvPr id="5" name="Date Placeholder 4">
             <a:extLst xmlns:a="http://schemas.openxmlformats.org/drawingml/2006/main">
               <a:ext uri="{FF2B5EF4-FFF2-40B4-BE49-F238E27FC236}">
-                <a16:creationId xmlns:a16="http://schemas.microsoft.com/office/drawing/2014/main" id="{174BD042-E1C6-4CD0-A52E-115606AEFDD1}"/>
+                <a16:creationId xmlns:a16="http://schemas.microsoft.com/office/drawing/2014/main" id="{57588AA8-06C6-4FC7-9410-96411EA19D0E}"/>
               </a:ext>
             </a:extLst>
           </p:cNvPr>
@@ -3873,7 +3873,7 @@
           <p:cNvPr id="6" name="Footer Placeholder 5">
             <a:extLst xmlns:a="http://schemas.openxmlformats.org/drawingml/2006/main">
               <a:ext uri="{FF2B5EF4-FFF2-40B4-BE49-F238E27FC236}">
-                <a16:creationId xmlns:a16="http://schemas.microsoft.com/office/drawing/2014/main" id="{B8F2FB94-44FA-4539-8BE4-4EC66539DA6E}"/>
+                <a16:creationId xmlns:a16="http://schemas.microsoft.com/office/drawing/2014/main" id="{A9A066A5-69DE-4CFC-A9BB-A7E6CE5D583A}"/>
               </a:ext>
             </a:extLst>
           </p:cNvPr>
@@ -3896,7 +3896,7 @@
           <p:cNvPr id="7" name="Slide Number Placeholder 6">
             <a:extLst xmlns:a="http://schemas.openxmlformats.org/drawingml/2006/main">
               <a:ext uri="{FF2B5EF4-FFF2-40B4-BE49-F238E27FC236}">
-                <a16:creationId xmlns:a16="http://schemas.microsoft.com/office/drawing/2014/main" id="{9797166E-D51E-4B2C-B722-FD88F7951815}"/>
+                <a16:creationId xmlns:a16="http://schemas.microsoft.com/office/drawing/2014/main" id="{75451068-69CD-4064-A47D-4810E6053730}"/>
               </a:ext>
             </a:extLst>
           </p:cNvPr>
@@ -3940,7 +3940,7 @@
           <p:cNvPr id="2" name="Title 1">
             <a:extLst xmlns:a="http://schemas.openxmlformats.org/drawingml/2006/main">
               <a:ext uri="{FF2B5EF4-FFF2-40B4-BE49-F238E27FC236}">
-                <a16:creationId xmlns:a16="http://schemas.microsoft.com/office/drawing/2014/main" id="{6B9BA5E1-0E66-430E-9CCD-704FEB0AB8E5}"/>
+                <a16:creationId xmlns:a16="http://schemas.microsoft.com/office/drawing/2014/main" id="{157A8D42-2B93-4123-A4FB-9A0B190FAC51}"/>
               </a:ext>
             </a:extLst>
           </p:cNvPr>
@@ -3972,7 +3972,7 @@
           <p:cNvPr id="3" name="Text Placeholder 2">
             <a:extLst xmlns:a="http://schemas.openxmlformats.org/drawingml/2006/main">
               <a:ext uri="{FF2B5EF4-FFF2-40B4-BE49-F238E27FC236}">
-                <a16:creationId xmlns:a16="http://schemas.microsoft.com/office/drawing/2014/main" id="{2CAE8D6F-5965-444E-B665-B343993EE8D6}"/>
+                <a16:creationId xmlns:a16="http://schemas.microsoft.com/office/drawing/2014/main" id="{7D634F14-F18B-44CD-892F-41300D9A6374}"/>
               </a:ext>
             </a:extLst>
           </p:cNvPr>
@@ -4044,7 +4044,7 @@
           <p:cNvPr id="4" name="Content Placeholder 3">
             <a:extLst xmlns:a="http://schemas.openxmlformats.org/drawingml/2006/main">
               <a:ext uri="{FF2B5EF4-FFF2-40B4-BE49-F238E27FC236}">
-                <a16:creationId xmlns:a16="http://schemas.microsoft.com/office/drawing/2014/main" id="{C49BF9C6-8D66-418B-A74C-E45D962AC523}"/>
+                <a16:creationId xmlns:a16="http://schemas.microsoft.com/office/drawing/2014/main" id="{3DA1AC27-890F-488D-9713-513E10D3BB0C}"/>
               </a:ext>
             </a:extLst>
           </p:cNvPr>
@@ -4148,7 +4148,7 @@
           <p:cNvPr id="5" name="Text Placeholder 4">
             <a:extLst xmlns:a="http://schemas.openxmlformats.org/drawingml/2006/main">
               <a:ext uri="{FF2B5EF4-FFF2-40B4-BE49-F238E27FC236}">
-                <a16:creationId xmlns:a16="http://schemas.microsoft.com/office/drawing/2014/main" id="{978AEB07-D4EA-4219-94F1-F5BE92F2E676}"/>
+                <a16:creationId xmlns:a16="http://schemas.microsoft.com/office/drawing/2014/main" id="{C590CE0D-1888-408E-B60A-4D4A77DD51C5}"/>
               </a:ext>
             </a:extLst>
           </p:cNvPr>
@@ -4220,7 +4220,7 @@
           <p:cNvPr id="6" name="Content Placeholder 5">
             <a:extLst xmlns:a="http://schemas.openxmlformats.org/drawingml/2006/main">
               <a:ext uri="{FF2B5EF4-FFF2-40B4-BE49-F238E27FC236}">
-                <a16:creationId xmlns:a16="http://schemas.microsoft.com/office/drawing/2014/main" id="{CA1E7A3D-0AFC-4153-BFE4-4C3D11BCF572}"/>
+                <a16:creationId xmlns:a16="http://schemas.microsoft.com/office/drawing/2014/main" id="{CFA1A617-B61F-4F70-AFBA-FCE3FE3F6604}"/>
               </a:ext>
             </a:extLst>
           </p:cNvPr>
@@ -4324,7 +4324,7 @@
           <p:cNvPr id="7" name="Date Placeholder 6">
             <a:extLst xmlns:a="http://schemas.openxmlformats.org/drawingml/2006/main">
               <a:ext uri="{FF2B5EF4-FFF2-40B4-BE49-F238E27FC236}">
-                <a16:creationId xmlns:a16="http://schemas.microsoft.com/office/drawing/2014/main" id="{6383AAEA-26D6-4793-816A-C43A919A3088}"/>
+                <a16:creationId xmlns:a16="http://schemas.microsoft.com/office/drawing/2014/main" id="{66396BB1-BB12-4001-A4C8-535692CC8404}"/>
               </a:ext>
             </a:extLst>
           </p:cNvPr>
@@ -4351,7 +4351,7 @@
           <p:cNvPr id="8" name="Footer Placeholder 7">
             <a:extLst xmlns:a="http://schemas.openxmlformats.org/drawingml/2006/main">
               <a:ext uri="{FF2B5EF4-FFF2-40B4-BE49-F238E27FC236}">
-                <a16:creationId xmlns:a16="http://schemas.microsoft.com/office/drawing/2014/main" id="{6FE6737F-C44E-47D6-AECA-D384ADA5BE62}"/>
+                <a16:creationId xmlns:a16="http://schemas.microsoft.com/office/drawing/2014/main" id="{DC5767B0-0E48-4075-BBE6-EAB46F31812C}"/>
               </a:ext>
             </a:extLst>
           </p:cNvPr>
@@ -4374,7 +4374,7 @@
           <p:cNvPr id="9" name="Slide Number Placeholder 8">
             <a:extLst xmlns:a="http://schemas.openxmlformats.org/drawingml/2006/main">
               <a:ext uri="{FF2B5EF4-FFF2-40B4-BE49-F238E27FC236}">
-                <a16:creationId xmlns:a16="http://schemas.microsoft.com/office/drawing/2014/main" id="{679C330B-86CF-479F-B11D-E4713087AA18}"/>
+                <a16:creationId xmlns:a16="http://schemas.microsoft.com/office/drawing/2014/main" id="{7D602CE6-EA9D-4C19-B338-AE8A10FE565E}"/>
               </a:ext>
             </a:extLst>
           </p:cNvPr>
@@ -4418,7 +4418,7 @@
           <p:cNvPr id="2" name="Title 1">
             <a:extLst xmlns:a="http://schemas.openxmlformats.org/drawingml/2006/main">
               <a:ext uri="{FF2B5EF4-FFF2-40B4-BE49-F238E27FC236}">
-                <a16:creationId xmlns:a16="http://schemas.microsoft.com/office/drawing/2014/main" id="{617EB283-14FE-49CF-B9C3-382299EAD206}"/>
+                <a16:creationId xmlns:a16="http://schemas.microsoft.com/office/drawing/2014/main" id="{59A22DAB-8098-4848-BC18-4081ADAF6FC0}"/>
               </a:ext>
             </a:extLst>
           </p:cNvPr>
@@ -4445,7 +4445,7 @@
           <p:cNvPr id="3" name="Date Placeholder 2">
             <a:extLst xmlns:a="http://schemas.openxmlformats.org/drawingml/2006/main">
               <a:ext uri="{FF2B5EF4-FFF2-40B4-BE49-F238E27FC236}">
-                <a16:creationId xmlns:a16="http://schemas.microsoft.com/office/drawing/2014/main" id="{971F5DAF-344A-4419-9465-0CDF80DBA1B0}"/>
+                <a16:creationId xmlns:a16="http://schemas.microsoft.com/office/drawing/2014/main" id="{C11ADB71-6949-4161-8A20-0B8D9C8BB0D0}"/>
               </a:ext>
             </a:extLst>
           </p:cNvPr>
@@ -4472,7 +4472,7 @@
           <p:cNvPr id="4" name="Footer Placeholder 3">
             <a:extLst xmlns:a="http://schemas.openxmlformats.org/drawingml/2006/main">
               <a:ext uri="{FF2B5EF4-FFF2-40B4-BE49-F238E27FC236}">
-                <a16:creationId xmlns:a16="http://schemas.microsoft.com/office/drawing/2014/main" id="{39FDCE2D-AD13-4718-B32D-0C14CB5A9937}"/>
+                <a16:creationId xmlns:a16="http://schemas.microsoft.com/office/drawing/2014/main" id="{87FD76C8-280E-4AF0-8C7E-E82781F8ABC7}"/>
               </a:ext>
             </a:extLst>
           </p:cNvPr>
@@ -4495,7 +4495,7 @@
           <p:cNvPr id="5" name="Slide Number Placeholder 4">
             <a:extLst xmlns:a="http://schemas.openxmlformats.org/drawingml/2006/main">
               <a:ext uri="{FF2B5EF4-FFF2-40B4-BE49-F238E27FC236}">
-                <a16:creationId xmlns:a16="http://schemas.microsoft.com/office/drawing/2014/main" id="{AAF7C8FB-7CBF-4F2E-AA77-143D1A6FDFAB}"/>
+                <a16:creationId xmlns:a16="http://schemas.microsoft.com/office/drawing/2014/main" id="{1D658A89-06AD-4DA6-AF57-1972911E73AA}"/>
               </a:ext>
             </a:extLst>
           </p:cNvPr>
@@ -4539,7 +4539,7 @@
           <p:cNvPr id="2" name="Date Placeholder 1">
             <a:extLst xmlns:a="http://schemas.openxmlformats.org/drawingml/2006/main">
               <a:ext uri="{FF2B5EF4-FFF2-40B4-BE49-F238E27FC236}">
-                <a16:creationId xmlns:a16="http://schemas.microsoft.com/office/drawing/2014/main" id="{C88D538D-8F02-49CE-A904-1105D9F508A3}"/>
+                <a16:creationId xmlns:a16="http://schemas.microsoft.com/office/drawing/2014/main" id="{1930CD67-232B-45C9-87CA-2AC9394C1D65}"/>
               </a:ext>
             </a:extLst>
           </p:cNvPr>
@@ -4566,7 +4566,7 @@
           <p:cNvPr id="3" name="Footer Placeholder 2">
             <a:extLst xmlns:a="http://schemas.openxmlformats.org/drawingml/2006/main">
               <a:ext uri="{FF2B5EF4-FFF2-40B4-BE49-F238E27FC236}">
-                <a16:creationId xmlns:a16="http://schemas.microsoft.com/office/drawing/2014/main" id="{20788487-46A8-47E7-B013-EAA8E0E1984E}"/>
+                <a16:creationId xmlns:a16="http://schemas.microsoft.com/office/drawing/2014/main" id="{5E6CF2FC-3961-412D-AD17-1870A1C81AA9}"/>
               </a:ext>
             </a:extLst>
           </p:cNvPr>
@@ -4589,7 +4589,7 @@
           <p:cNvPr id="4" name="Slide Number Placeholder 3">
             <a:extLst xmlns:a="http://schemas.openxmlformats.org/drawingml/2006/main">
               <a:ext uri="{FF2B5EF4-FFF2-40B4-BE49-F238E27FC236}">
-                <a16:creationId xmlns:a16="http://schemas.microsoft.com/office/drawing/2014/main" id="{43AAB4AB-3067-43EB-A029-D8A19003CB37}"/>
+                <a16:creationId xmlns:a16="http://schemas.microsoft.com/office/drawing/2014/main" id="{F8BE0EA0-3BF2-474E-ACCD-BF9ADF6BBD2B}"/>
               </a:ext>
             </a:extLst>
           </p:cNvPr>
@@ -4633,7 +4633,7 @@
           <p:cNvPr id="2" name="Title 1">
             <a:extLst xmlns:a="http://schemas.openxmlformats.org/drawingml/2006/main">
               <a:ext uri="{FF2B5EF4-FFF2-40B4-BE49-F238E27FC236}">
-                <a16:creationId xmlns:a16="http://schemas.microsoft.com/office/drawing/2014/main" id="{1403FC27-5849-49AD-BD37-E590D56A6C45}"/>
+                <a16:creationId xmlns:a16="http://schemas.microsoft.com/office/drawing/2014/main" id="{11D19ECF-07D8-42C5-AF5D-D08A09FCA865}"/>
               </a:ext>
             </a:extLst>
           </p:cNvPr>
@@ -4670,7 +4670,7 @@
           <p:cNvPr id="3" name="Content Placeholder 2">
             <a:extLst xmlns:a="http://schemas.openxmlformats.org/drawingml/2006/main">
               <a:ext uri="{FF2B5EF4-FFF2-40B4-BE49-F238E27FC236}">
-                <a16:creationId xmlns:a16="http://schemas.microsoft.com/office/drawing/2014/main" id="{35964B7B-34D8-4E30-AD13-335AAABFA326}"/>
+                <a16:creationId xmlns:a16="http://schemas.microsoft.com/office/drawing/2014/main" id="{A8F8DC87-6295-466C-8AA4-6C9AAB2BB42F}"/>
               </a:ext>
             </a:extLst>
           </p:cNvPr>
@@ -4774,7 +4774,7 @@
           <p:cNvPr id="4" name="Text Placeholder 3">
             <a:extLst xmlns:a="http://schemas.openxmlformats.org/drawingml/2006/main">
               <a:ext uri="{FF2B5EF4-FFF2-40B4-BE49-F238E27FC236}">
-                <a16:creationId xmlns:a16="http://schemas.microsoft.com/office/drawing/2014/main" id="{AFE8C344-AAF9-415C-9106-50AE06A9EC4F}"/>
+                <a16:creationId xmlns:a16="http://schemas.microsoft.com/office/drawing/2014/main" id="{A3DF6698-2174-4CC6-919E-9D9F3AB10AB8}"/>
               </a:ext>
             </a:extLst>
           </p:cNvPr>
@@ -4846,7 +4846,7 @@
           <p:cNvPr id="5" name="Date Placeholder 4">
             <a:extLst xmlns:a="http://schemas.openxmlformats.org/drawingml/2006/main">
               <a:ext uri="{FF2B5EF4-FFF2-40B4-BE49-F238E27FC236}">
-                <a16:creationId xmlns:a16="http://schemas.microsoft.com/office/drawing/2014/main" id="{18EBE7C5-9683-41A8-90A4-EFE3AA8D1011}"/>
+                <a16:creationId xmlns:a16="http://schemas.microsoft.com/office/drawing/2014/main" id="{F8D5C5D3-FE37-42BF-8B11-66C39C4F7EB0}"/>
               </a:ext>
             </a:extLst>
           </p:cNvPr>
@@ -4873,7 +4873,7 @@
           <p:cNvPr id="6" name="Footer Placeholder 5">
             <a:extLst xmlns:a="http://schemas.openxmlformats.org/drawingml/2006/main">
               <a:ext uri="{FF2B5EF4-FFF2-40B4-BE49-F238E27FC236}">
-                <a16:creationId xmlns:a16="http://schemas.microsoft.com/office/drawing/2014/main" id="{007F7533-68C4-4547-B66C-E9B8DF0E327B}"/>
+                <a16:creationId xmlns:a16="http://schemas.microsoft.com/office/drawing/2014/main" id="{ACC099E8-7D2C-436C-9756-7F298A354871}"/>
               </a:ext>
             </a:extLst>
           </p:cNvPr>
@@ -4896,7 +4896,7 @@
           <p:cNvPr id="7" name="Slide Number Placeholder 6">
             <a:extLst xmlns:a="http://schemas.openxmlformats.org/drawingml/2006/main">
               <a:ext uri="{FF2B5EF4-FFF2-40B4-BE49-F238E27FC236}">
-                <a16:creationId xmlns:a16="http://schemas.microsoft.com/office/drawing/2014/main" id="{3F2286C8-DCC5-4251-AF4B-50B5AAED4908}"/>
+                <a16:creationId xmlns:a16="http://schemas.microsoft.com/office/drawing/2014/main" id="{275DC1BB-7E9C-4B5E-BEDE-CB063379CCAE}"/>
               </a:ext>
             </a:extLst>
           </p:cNvPr>
@@ -4940,7 +4940,7 @@
           <p:cNvPr id="2" name="Title 1">
             <a:extLst xmlns:a="http://schemas.openxmlformats.org/drawingml/2006/main">
               <a:ext uri="{FF2B5EF4-FFF2-40B4-BE49-F238E27FC236}">
-                <a16:creationId xmlns:a16="http://schemas.microsoft.com/office/drawing/2014/main" id="{D9F0FFE5-D0B7-46D0-9ADB-BA4C143DD9F7}"/>
+                <a16:creationId xmlns:a16="http://schemas.microsoft.com/office/drawing/2014/main" id="{30D6BAC2-A6EE-445B-867C-BA2E6F059142}"/>
               </a:ext>
             </a:extLst>
           </p:cNvPr>
@@ -4977,7 +4977,7 @@
           <p:cNvPr id="3" name="Picture Placeholder 2">
             <a:extLst xmlns:a="http://schemas.openxmlformats.org/drawingml/2006/main">
               <a:ext uri="{FF2B5EF4-FFF2-40B4-BE49-F238E27FC236}">
-                <a16:creationId xmlns:a16="http://schemas.microsoft.com/office/drawing/2014/main" id="{CACD5425-F6F3-4B80-8F57-465096722C47}"/>
+                <a16:creationId xmlns:a16="http://schemas.microsoft.com/office/drawing/2014/main" id="{7E645AB5-7E6A-4E4B-BB27-476B6408E817}"/>
               </a:ext>
             </a:extLst>
           </p:cNvPr>
@@ -5042,7 +5042,7 @@
           <p:cNvPr id="4" name="Text Placeholder 3">
             <a:extLst xmlns:a="http://schemas.openxmlformats.org/drawingml/2006/main">
               <a:ext uri="{FF2B5EF4-FFF2-40B4-BE49-F238E27FC236}">
-                <a16:creationId xmlns:a16="http://schemas.microsoft.com/office/drawing/2014/main" id="{06760891-4FBC-4104-AF3D-EFDAAF37FBCA}"/>
+                <a16:creationId xmlns:a16="http://schemas.microsoft.com/office/drawing/2014/main" id="{241B3D2E-249B-46D8-9A95-3B2CA4FE089F}"/>
               </a:ext>
             </a:extLst>
           </p:cNvPr>
@@ -5114,7 +5114,7 @@
           <p:cNvPr id="5" name="Date Placeholder 4">
             <a:extLst xmlns:a="http://schemas.openxmlformats.org/drawingml/2006/main">
               <a:ext uri="{FF2B5EF4-FFF2-40B4-BE49-F238E27FC236}">
-                <a16:creationId xmlns:a16="http://schemas.microsoft.com/office/drawing/2014/main" id="{C1716BC2-9F89-4096-87D8-652A0E1A1A9A}"/>
+                <a16:creationId xmlns:a16="http://schemas.microsoft.com/office/drawing/2014/main" id="{9780C79C-7EFA-4EE1-8C81-DF74397ABF66}"/>
               </a:ext>
             </a:extLst>
           </p:cNvPr>
@@ -5141,7 +5141,7 @@
           <p:cNvPr id="6" name="Footer Placeholder 5">
             <a:extLst xmlns:a="http://schemas.openxmlformats.org/drawingml/2006/main">
               <a:ext uri="{FF2B5EF4-FFF2-40B4-BE49-F238E27FC236}">
-                <a16:creationId xmlns:a16="http://schemas.microsoft.com/office/drawing/2014/main" id="{859DBE2F-E295-439B-9610-717C1190B1B1}"/>
+                <a16:creationId xmlns:a16="http://schemas.microsoft.com/office/drawing/2014/main" id="{D507E20D-4779-48A7-89F0-AAFC7046ACFA}"/>
               </a:ext>
             </a:extLst>
           </p:cNvPr>
@@ -5164,7 +5164,7 @@
           <p:cNvPr id="7" name="Slide Number Placeholder 6">
             <a:extLst xmlns:a="http://schemas.openxmlformats.org/drawingml/2006/main">
               <a:ext uri="{FF2B5EF4-FFF2-40B4-BE49-F238E27FC236}">
-                <a16:creationId xmlns:a16="http://schemas.microsoft.com/office/drawing/2014/main" id="{099E4239-91CF-4BCF-AC3C-723CA6038650}"/>
+                <a16:creationId xmlns:a16="http://schemas.microsoft.com/office/drawing/2014/main" id="{359645BD-EC64-4477-A588-1E4DDFED5D2F}"/>
               </a:ext>
             </a:extLst>
           </p:cNvPr>
@@ -5213,7 +5213,7 @@
           <p:cNvPr id="2" name="Title Placeholder 1">
             <a:extLst xmlns:a="http://schemas.openxmlformats.org/drawingml/2006/main">
               <a:ext uri="{FF2B5EF4-FFF2-40B4-BE49-F238E27FC236}">
-                <a16:creationId xmlns:a16="http://schemas.microsoft.com/office/drawing/2014/main" id="{B2378F9C-5DE4-47C7-AA10-5EADBAA3D026}"/>
+                <a16:creationId xmlns:a16="http://schemas.microsoft.com/office/drawing/2014/main" id="{463CE577-05E8-45FD-BFFA-4F3335D9EE12}"/>
               </a:ext>
             </a:extLst>
           </p:cNvPr>
@@ -5250,7 +5250,7 @@
           <p:cNvPr id="3" name="Text Placeholder 2">
             <a:extLst xmlns:a="http://schemas.openxmlformats.org/drawingml/2006/main">
               <a:ext uri="{FF2B5EF4-FFF2-40B4-BE49-F238E27FC236}">
-                <a16:creationId xmlns:a16="http://schemas.microsoft.com/office/drawing/2014/main" id="{30708D96-FDE4-4ACE-B1C1-7CB896C5BB93}"/>
+                <a16:creationId xmlns:a16="http://schemas.microsoft.com/office/drawing/2014/main" id="{06CAC898-4ABF-4288-8A80-FAD724649EAD}"/>
               </a:ext>
             </a:extLst>
           </p:cNvPr>
@@ -5322,7 +5322,7 @@
           <p:cNvPr id="4" name="Date Placeholder 3">
             <a:extLst xmlns:a="http://schemas.openxmlformats.org/drawingml/2006/main">
               <a:ext uri="{FF2B5EF4-FFF2-40B4-BE49-F238E27FC236}">
-                <a16:creationId xmlns:a16="http://schemas.microsoft.com/office/drawing/2014/main" id="{55C08E49-67E6-471D-BF64-2B0C9FBE4D83}"/>
+                <a16:creationId xmlns:a16="http://schemas.microsoft.com/office/drawing/2014/main" id="{7163F342-25EE-4651-A9CF-678F904BC2CC}"/>
               </a:ext>
             </a:extLst>
           </p:cNvPr>
@@ -5368,7 +5368,7 @@
           <p:cNvPr id="5" name="Footer Placeholder 4">
             <a:extLst xmlns:a="http://schemas.openxmlformats.org/drawingml/2006/main">
               <a:ext uri="{FF2B5EF4-FFF2-40B4-BE49-F238E27FC236}">
-                <a16:creationId xmlns:a16="http://schemas.microsoft.com/office/drawing/2014/main" id="{3D3FD9DC-B4BC-4F05-8ABE-62ABB23B0EB5}"/>
+                <a16:creationId xmlns:a16="http://schemas.microsoft.com/office/drawing/2014/main" id="{4783FBEE-2C4B-4D6C-A02D-958A6C686837}"/>
               </a:ext>
             </a:extLst>
           </p:cNvPr>
@@ -5410,7 +5410,7 @@
           <p:cNvPr id="6" name="Slide Number Placeholder 5">
             <a:extLst xmlns:a="http://schemas.openxmlformats.org/drawingml/2006/main">
               <a:ext uri="{FF2B5EF4-FFF2-40B4-BE49-F238E27FC236}">
-                <a16:creationId xmlns:a16="http://schemas.microsoft.com/office/drawing/2014/main" id="{52D2F26B-CEB1-4A59-8D9D-0848C7AB5A7F}"/>
+                <a16:creationId xmlns:a16="http://schemas.microsoft.com/office/drawing/2014/main" id="{31D2475F-7035-4E82-A172-65A0301E3756}"/>
               </a:ext>
             </a:extLst>
           </p:cNvPr>
@@ -5455,17 +5455,17 @@
   </p:cSld>
   <p:clrMap bg1="lt1" tx1="dk1" bg2="lt2" tx2="dk2" accent1="accent1" accent2="accent2" accent3="accent3" accent4="accent4" accent5="accent5" accent6="accent6" hlink="hlink" folHlink="folHlink"/>
   <p:sldLayoutIdLst>
-    <p:sldLayoutId xmlns:r="http://schemas.openxmlformats.org/officeDocument/2006/relationships" id="2147483649" r:id="R9c2041b055bf4bf9"/>
-    <p:sldLayoutId xmlns:r="http://schemas.openxmlformats.org/officeDocument/2006/relationships" id="2147483650" r:id="R7762f4e8ba84402d"/>
-    <p:sldLayoutId xmlns:r="http://schemas.openxmlformats.org/officeDocument/2006/relationships" id="2147483651" r:id="R2d55390f407b4ec5"/>
-    <p:sldLayoutId xmlns:r="http://schemas.openxmlformats.org/officeDocument/2006/relationships" id="2147483652" r:id="Ref003b474c40494d"/>
-    <p:sldLayoutId xmlns:r="http://schemas.openxmlformats.org/officeDocument/2006/relationships" id="2147483653" r:id="R02d0080b4e3a44da"/>
-    <p:sldLayoutId xmlns:r="http://schemas.openxmlformats.org/officeDocument/2006/relationships" id="2147483654" r:id="R7682c04accc74ed3"/>
-    <p:sldLayoutId xmlns:r="http://schemas.openxmlformats.org/officeDocument/2006/relationships" id="2147483655" r:id="R45fa51f2dbc247ad"/>
-    <p:sldLayoutId xmlns:r="http://schemas.openxmlformats.org/officeDocument/2006/relationships" id="2147483656" r:id="R11240eba189e476c"/>
-    <p:sldLayoutId xmlns:r="http://schemas.openxmlformats.org/officeDocument/2006/relationships" id="2147483657" r:id="R5eb33d82e1d64afa"/>
-    <p:sldLayoutId xmlns:r="http://schemas.openxmlformats.org/officeDocument/2006/relationships" id="2147483658" r:id="R2d195a1861e24e12"/>
-    <p:sldLayoutId xmlns:r="http://schemas.openxmlformats.org/officeDocument/2006/relationships" id="2147483659" r:id="R2f5a25d831e04374"/>
+    <p:sldLayoutId xmlns:r="http://schemas.openxmlformats.org/officeDocument/2006/relationships" id="2147483649" r:id="R5880d5992620492d"/>
+    <p:sldLayoutId xmlns:r="http://schemas.openxmlformats.org/officeDocument/2006/relationships" id="2147483650" r:id="R737bdcc11a1a4615"/>
+    <p:sldLayoutId xmlns:r="http://schemas.openxmlformats.org/officeDocument/2006/relationships" id="2147483651" r:id="R353bed9000a94343"/>
+    <p:sldLayoutId xmlns:r="http://schemas.openxmlformats.org/officeDocument/2006/relationships" id="2147483652" r:id="R65638369637b44a7"/>
+    <p:sldLayoutId xmlns:r="http://schemas.openxmlformats.org/officeDocument/2006/relationships" id="2147483653" r:id="Rf478e7b23b204987"/>
+    <p:sldLayoutId xmlns:r="http://schemas.openxmlformats.org/officeDocument/2006/relationships" id="2147483654" r:id="R2a2119097b6c4f86"/>
+    <p:sldLayoutId xmlns:r="http://schemas.openxmlformats.org/officeDocument/2006/relationships" id="2147483655" r:id="Rdc13873485f24a10"/>
+    <p:sldLayoutId xmlns:r="http://schemas.openxmlformats.org/officeDocument/2006/relationships" id="2147483656" r:id="Rf29e74eb6d9f4fc7"/>
+    <p:sldLayoutId xmlns:r="http://schemas.openxmlformats.org/officeDocument/2006/relationships" id="2147483657" r:id="R75a0c65fadd1467f"/>
+    <p:sldLayoutId xmlns:r="http://schemas.openxmlformats.org/officeDocument/2006/relationships" id="2147483658" r:id="R10caa8a27bde4399"/>
+    <p:sldLayoutId xmlns:r="http://schemas.openxmlformats.org/officeDocument/2006/relationships" id="2147483659" r:id="Rd83ce658582a4167"/>
   </p:sldLayoutIdLst>
   <p:txStyles>
     <p:titleStyle>
@@ -6018,7 +6018,7 @@
           <p:cNvPr id="2" name="Rectangle 1">
             <a:extLst xmlns:a="http://schemas.openxmlformats.org/drawingml/2006/main">
               <a:ext uri="{FF2B5EF4-FFF2-40B4-BE49-F238E27FC236}">
-                <a16:creationId xmlns:a16="http://schemas.microsoft.com/office/drawing/2014/main" id="{9E2B5B22-D2D3-4E82-87B7-5695F50283DF}"/>
+                <a16:creationId xmlns:a16="http://schemas.microsoft.com/office/drawing/2014/main" id="{B84B3351-8466-40AA-BC00-83C83F876BC2}"/>
               </a:ext>
             </a:extLst>
           </p:cNvPr>
@@ -6073,7 +6073,7 @@
           <p:cNvPr id="3" name="TextBox 2">
             <a:extLst xmlns:a="http://schemas.openxmlformats.org/drawingml/2006/main">
               <a:ext uri="{FF2B5EF4-FFF2-40B4-BE49-F238E27FC236}">
-                <a16:creationId xmlns:a16="http://schemas.microsoft.com/office/drawing/2014/main" id="{FD4F55F9-F735-46AC-AC6C-8DEA1559C741}"/>
+                <a16:creationId xmlns:a16="http://schemas.microsoft.com/office/drawing/2014/main" id="{55186D4C-04D6-426F-9E00-9C2D02DB9EFF}"/>
               </a:ext>
             </a:extLst>
           </p:cNvPr>
@@ -6120,7 +6120,7 @@
           <p:cNvPr id="4" name="TextBox 3">
             <a:extLst xmlns:a="http://schemas.openxmlformats.org/drawingml/2006/main">
               <a:ext uri="{FF2B5EF4-FFF2-40B4-BE49-F238E27FC236}">
-                <a16:creationId xmlns:a16="http://schemas.microsoft.com/office/drawing/2014/main" id="{B5C20824-512E-4E3F-9099-2C91F5E4D418}"/>
+                <a16:creationId xmlns:a16="http://schemas.microsoft.com/office/drawing/2014/main" id="{192657B6-E65C-4E41-96D1-2B75C39BFD2F}"/>
               </a:ext>
             </a:extLst>
           </p:cNvPr>
@@ -6188,7 +6188,7 @@
           <p:cNvPr id="5" name="TextBox 4">
             <a:extLst xmlns:a="http://schemas.openxmlformats.org/drawingml/2006/main">
               <a:ext uri="{FF2B5EF4-FFF2-40B4-BE49-F238E27FC236}">
-                <a16:creationId xmlns:a16="http://schemas.microsoft.com/office/drawing/2014/main" id="{DA0AF32A-72B8-44C6-803C-2F01A879B27F}"/>
+                <a16:creationId xmlns:a16="http://schemas.microsoft.com/office/drawing/2014/main" id="{630CD139-E274-413D-8C13-AB803A3DB5AA}"/>
               </a:ext>
             </a:extLst>
           </p:cNvPr>
@@ -6235,7 +6235,7 @@
           <p:cNvPr id="6" name="Rectangle 5">
             <a:extLst xmlns:a="http://schemas.openxmlformats.org/drawingml/2006/main">
               <a:ext uri="{FF2B5EF4-FFF2-40B4-BE49-F238E27FC236}">
-                <a16:creationId xmlns:a16="http://schemas.microsoft.com/office/drawing/2014/main" id="{A50C0CE6-E0A9-4BD4-BF35-064EAC559991}"/>
+                <a16:creationId xmlns:a16="http://schemas.microsoft.com/office/drawing/2014/main" id="{CDF288AB-4056-4C6F-8D41-06821AEA6953}"/>
               </a:ext>
             </a:extLst>
           </p:cNvPr>
@@ -6290,7 +6290,7 @@
           <p:cNvPr id="7" name="TextBox 6">
             <a:extLst xmlns:a="http://schemas.openxmlformats.org/drawingml/2006/main">
               <a:ext uri="{FF2B5EF4-FFF2-40B4-BE49-F238E27FC236}">
-                <a16:creationId xmlns:a16="http://schemas.microsoft.com/office/drawing/2014/main" id="{9A23C6E0-F272-46FA-A221-C8F907B6BC8D}"/>
+                <a16:creationId xmlns:a16="http://schemas.microsoft.com/office/drawing/2014/main" id="{08184345-7026-4804-A628-186038CBF1B1}"/>
               </a:ext>
             </a:extLst>
           </p:cNvPr>
@@ -6337,7 +6337,7 @@
           <p:cNvPr id="8" name="TextBox 7">
             <a:extLst xmlns:a="http://schemas.openxmlformats.org/drawingml/2006/main">
               <a:ext uri="{FF2B5EF4-FFF2-40B4-BE49-F238E27FC236}">
-                <a16:creationId xmlns:a16="http://schemas.microsoft.com/office/drawing/2014/main" id="{0B246F5F-495B-489F-9040-71A1FA5414AB}"/>
+                <a16:creationId xmlns:a16="http://schemas.microsoft.com/office/drawing/2014/main" id="{E0C3CA0E-6944-45CA-A613-5743844A9B22}"/>
               </a:ext>
             </a:extLst>
           </p:cNvPr>
@@ -6349,7 +6349,7 @@
         <p:spPr>
           <a:xfrm xmlns:a="http://schemas.openxmlformats.org/drawingml/2006/main">
             <a:off x="8732520" y="1700784"/>
-            <a:ext cx="2880360" cy="502920"/>
+            <a:ext cx="2880360" cy="515112"/>
           </a:xfrm>
           <a:prstGeom xmlns:a="http://schemas.openxmlformats.org/drawingml/2006/main" prst="rect">
             <a:avLst/>
@@ -6374,7 +6374,7 @@
                 <a:ea typeface="Aptos"/>
                 <a:cs typeface="Aptos"/>
               </a:rPr>
-              <a:t>2026.07.23-10</a:t>
+              <a:t>2026.07.23-11</a:t>
             </a:r>
           </a:p>
         </p:txBody>
@@ -6384,7 +6384,7 @@
           <p:cNvPr id="9" name="TextBox 8">
             <a:extLst xmlns:a="http://schemas.openxmlformats.org/drawingml/2006/main">
               <a:ext uri="{FF2B5EF4-FFF2-40B4-BE49-F238E27FC236}">
-                <a16:creationId xmlns:a16="http://schemas.microsoft.com/office/drawing/2014/main" id="{2163055A-5966-438D-AD7A-F63AFEB5095A}"/>
+                <a16:creationId xmlns:a16="http://schemas.microsoft.com/office/drawing/2014/main" id="{F9E43497-3EA1-4BB5-82B7-76473D2816E3}"/>
               </a:ext>
             </a:extLst>
           </p:cNvPr>
@@ -6452,7 +6452,7 @@
           <p:cNvPr id="10" name="TextBox 9">
             <a:extLst xmlns:a="http://schemas.openxmlformats.org/drawingml/2006/main">
               <a:ext uri="{FF2B5EF4-FFF2-40B4-BE49-F238E27FC236}">
-                <a16:creationId xmlns:a16="http://schemas.microsoft.com/office/drawing/2014/main" id="{900FCFE4-5286-4C8A-86C6-8FB7345B3D0D}"/>
+                <a16:creationId xmlns:a16="http://schemas.microsoft.com/office/drawing/2014/main" id="{8EC6B138-2AF1-4947-A8CC-2EE04DD23C8D}"/>
               </a:ext>
             </a:extLst>
           </p:cNvPr>
@@ -6499,7 +6499,7 @@
           <p:cNvPr id="11" name="TextBox 10">
             <a:extLst xmlns:a="http://schemas.openxmlformats.org/drawingml/2006/main">
               <a:ext uri="{FF2B5EF4-FFF2-40B4-BE49-F238E27FC236}">
-                <a16:creationId xmlns:a16="http://schemas.microsoft.com/office/drawing/2014/main" id="{E4C64B53-B84C-45F3-9D6E-1400D98379AE}"/>
+                <a16:creationId xmlns:a16="http://schemas.microsoft.com/office/drawing/2014/main" id="{F63E0A11-901A-46BC-BB76-E155BF0DC3B6}"/>
               </a:ext>
             </a:extLst>
           </p:cNvPr>
@@ -6546,7 +6546,7 @@
           <p:cNvPr id="12" name="TextBox 11">
             <a:extLst xmlns:a="http://schemas.openxmlformats.org/drawingml/2006/main">
               <a:ext uri="{FF2B5EF4-FFF2-40B4-BE49-F238E27FC236}">
-                <a16:creationId xmlns:a16="http://schemas.microsoft.com/office/drawing/2014/main" id="{D617E42B-B813-4CB0-8A67-8DE55FF000B9}"/>
+                <a16:creationId xmlns:a16="http://schemas.microsoft.com/office/drawing/2014/main" id="{73F29D8C-8AFC-403A-91A7-95C3EB168CF3}"/>
               </a:ext>
             </a:extLst>
           </p:cNvPr>
@@ -6591,7 +6591,7 @@
     </p:spTree>
     <p:extLst>
       <p:ext uri="{BB962C8B-B14F-4D97-AF65-F5344CB8AC3E}">
-        <p14:creationId xmlns:p14="http://schemas.microsoft.com/office/powerpoint/2010/main" val="321935706"/>
+        <p14:creationId xmlns:p14="http://schemas.microsoft.com/office/powerpoint/2010/main" val="1049812690"/>
       </p:ext>
     </p:extLst>
   </p:cSld>
@@ -6615,7 +6615,7 @@
           <p:cNvPr id="2" name="TextBox 1">
             <a:extLst xmlns:a="http://schemas.openxmlformats.org/drawingml/2006/main">
               <a:ext uri="{FF2B5EF4-FFF2-40B4-BE49-F238E27FC236}">
-                <a16:creationId xmlns:a16="http://schemas.microsoft.com/office/drawing/2014/main" id="{016CB0BF-1804-4583-A352-E14493D099B8}"/>
+                <a16:creationId xmlns:a16="http://schemas.microsoft.com/office/drawing/2014/main" id="{FB9D0F24-EAC5-40F3-8E3C-144A78F8CE2B}"/>
               </a:ext>
             </a:extLst>
           </p:cNvPr>
@@ -6662,7 +6662,7 @@
           <p:cNvPr id="3" name="TextBox 2">
             <a:extLst xmlns:a="http://schemas.openxmlformats.org/drawingml/2006/main">
               <a:ext uri="{FF2B5EF4-FFF2-40B4-BE49-F238E27FC236}">
-                <a16:creationId xmlns:a16="http://schemas.microsoft.com/office/drawing/2014/main" id="{3D149D78-E08E-48BB-8146-D628B0943E97}"/>
+                <a16:creationId xmlns:a16="http://schemas.microsoft.com/office/drawing/2014/main" id="{3570924F-5761-47C5-85D2-BAE3F0C1A1C4}"/>
               </a:ext>
             </a:extLst>
           </p:cNvPr>
@@ -6709,7 +6709,7 @@
           <p:cNvPr id="4" name="Rectangle 3">
             <a:extLst xmlns:a="http://schemas.openxmlformats.org/drawingml/2006/main">
               <a:ext uri="{FF2B5EF4-FFF2-40B4-BE49-F238E27FC236}">
-                <a16:creationId xmlns:a16="http://schemas.microsoft.com/office/drawing/2014/main" id="{446BD7A7-F55B-4227-84AE-0F498A589876}"/>
+                <a16:creationId xmlns:a16="http://schemas.microsoft.com/office/drawing/2014/main" id="{747797E3-C501-4B52-9CF0-C58E64A62DE6}"/>
               </a:ext>
             </a:extLst>
           </p:cNvPr>
@@ -6764,7 +6764,7 @@
           <p:cNvPr id="5" name="Rectangle 4">
             <a:extLst xmlns:a="http://schemas.openxmlformats.org/drawingml/2006/main">
               <a:ext uri="{FF2B5EF4-FFF2-40B4-BE49-F238E27FC236}">
-                <a16:creationId xmlns:a16="http://schemas.microsoft.com/office/drawing/2014/main" id="{6F224D52-DA09-4E6D-9AA8-65EEF62B565A}"/>
+                <a16:creationId xmlns:a16="http://schemas.microsoft.com/office/drawing/2014/main" id="{0C5AEEC3-A75F-4853-919E-7B1B622A3C58}"/>
               </a:ext>
             </a:extLst>
           </p:cNvPr>
@@ -6819,7 +6819,7 @@
           <p:cNvPr id="6" name="TextBox 5">
             <a:extLst xmlns:a="http://schemas.openxmlformats.org/drawingml/2006/main">
               <a:ext uri="{FF2B5EF4-FFF2-40B4-BE49-F238E27FC236}">
-                <a16:creationId xmlns:a16="http://schemas.microsoft.com/office/drawing/2014/main" id="{714ED097-94A9-4A17-A03F-E642611606E5}"/>
+                <a16:creationId xmlns:a16="http://schemas.microsoft.com/office/drawing/2014/main" id="{E6ECFFE6-0DAC-4AA2-9FD1-79C622D2F6E0}"/>
               </a:ext>
             </a:extLst>
           </p:cNvPr>
@@ -6856,7 +6856,7 @@
                 <a:ea typeface="Aptos"/>
                 <a:cs typeface="Aptos"/>
               </a:rPr>
-              <a:t>Independent public evidence summary · 2026.07.23-10 · 2026-07-22 · Sources: RPX; CNIPA guidance; EPO family</a:t>
+              <a:t>Independent public evidence summary · 2026.07.23-11 · 2026-07-22 · Sources: RPX; CNIPA guidance; EPO family</a:t>
             </a:r>
           </a:p>
         </p:txBody>
@@ -6866,7 +6866,7 @@
           <p:cNvPr id="7" name="TextBox 6">
             <a:extLst xmlns:a="http://schemas.openxmlformats.org/drawingml/2006/main">
               <a:ext uri="{FF2B5EF4-FFF2-40B4-BE49-F238E27FC236}">
-                <a16:creationId xmlns:a16="http://schemas.microsoft.com/office/drawing/2014/main" id="{A4EF41D1-F973-4FDF-BF0F-E87516BBCC7D}"/>
+                <a16:creationId xmlns:a16="http://schemas.microsoft.com/office/drawing/2014/main" id="{ACD52683-BA25-402A-83D5-630DC02AC1F5}"/>
               </a:ext>
             </a:extLst>
           </p:cNvPr>
@@ -6913,7 +6913,7 @@
           <p:cNvPr id="8" name="TextBox 7">
             <a:extLst xmlns:a="http://schemas.openxmlformats.org/drawingml/2006/main">
               <a:ext uri="{FF2B5EF4-FFF2-40B4-BE49-F238E27FC236}">
-                <a16:creationId xmlns:a16="http://schemas.microsoft.com/office/drawing/2014/main" id="{E118C154-0A7A-4E73-B795-89A8A079EEE2}"/>
+                <a16:creationId xmlns:a16="http://schemas.microsoft.com/office/drawing/2014/main" id="{791A2B7C-5A34-41AC-BCAE-91F1A0C9CA56}"/>
               </a:ext>
             </a:extLst>
           </p:cNvPr>
@@ -6960,7 +6960,7 @@
           <p:cNvPr id="9" name="TextBox 8">
             <a:extLst xmlns:a="http://schemas.openxmlformats.org/drawingml/2006/main">
               <a:ext uri="{FF2B5EF4-FFF2-40B4-BE49-F238E27FC236}">
-                <a16:creationId xmlns:a16="http://schemas.microsoft.com/office/drawing/2014/main" id="{15799F9A-72F7-46A8-B0F6-4773C423605A}"/>
+                <a16:creationId xmlns:a16="http://schemas.microsoft.com/office/drawing/2014/main" id="{D7DA377A-0968-4D6F-B5E6-DCB9346A85D4}"/>
               </a:ext>
             </a:extLst>
           </p:cNvPr>
@@ -7057,7 +7057,7 @@
           <p:cNvPr id="10" name="Rounded Rectangle 9">
             <a:extLst xmlns:a="http://schemas.openxmlformats.org/drawingml/2006/main">
               <a:ext uri="{FF2B5EF4-FFF2-40B4-BE49-F238E27FC236}">
-                <a16:creationId xmlns:a16="http://schemas.microsoft.com/office/drawing/2014/main" id="{F69ABE7E-D7E0-4FF6-AEB4-450AAE63316A}"/>
+                <a16:creationId xmlns:a16="http://schemas.microsoft.com/office/drawing/2014/main" id="{68E3CCC7-7E5A-48A4-88AB-EC1758E85907}"/>
               </a:ext>
             </a:extLst>
           </p:cNvPr>
@@ -7114,7 +7114,7 @@
           <p:cNvPr id="11" name="TextBox 10">
             <a:extLst xmlns:a="http://schemas.openxmlformats.org/drawingml/2006/main">
               <a:ext uri="{FF2B5EF4-FFF2-40B4-BE49-F238E27FC236}">
-                <a16:creationId xmlns:a16="http://schemas.microsoft.com/office/drawing/2014/main" id="{963DF681-B4C9-407D-B3FB-56C19A97D68A}"/>
+                <a16:creationId xmlns:a16="http://schemas.microsoft.com/office/drawing/2014/main" id="{C51FB831-FA6B-4073-BF7C-52E82EEE2CE4}"/>
               </a:ext>
             </a:extLst>
           </p:cNvPr>
@@ -7161,7 +7161,7 @@
           <p:cNvPr id="12" name="TextBox 11">
             <a:extLst xmlns:a="http://schemas.openxmlformats.org/drawingml/2006/main">
               <a:ext uri="{FF2B5EF4-FFF2-40B4-BE49-F238E27FC236}">
-                <a16:creationId xmlns:a16="http://schemas.microsoft.com/office/drawing/2014/main" id="{D556769B-98C6-4568-AFA0-B10F2440902A}"/>
+                <a16:creationId xmlns:a16="http://schemas.microsoft.com/office/drawing/2014/main" id="{2886A989-23DB-45DB-A944-2D76227A000E}"/>
               </a:ext>
             </a:extLst>
           </p:cNvPr>
@@ -7206,7 +7206,7 @@
     </p:spTree>
     <p:extLst>
       <p:ext uri="{BB962C8B-B14F-4D97-AF65-F5344CB8AC3E}">
-        <p14:creationId xmlns:p14="http://schemas.microsoft.com/office/powerpoint/2010/main" val="2146159874"/>
+        <p14:creationId xmlns:p14="http://schemas.microsoft.com/office/powerpoint/2010/main" val="1283933904"/>
       </p:ext>
     </p:extLst>
   </p:cSld>
@@ -7230,7 +7230,7 @@
           <p:cNvPr id="2" name="TextBox 1">
             <a:extLst xmlns:a="http://schemas.openxmlformats.org/drawingml/2006/main">
               <a:ext uri="{FF2B5EF4-FFF2-40B4-BE49-F238E27FC236}">
-                <a16:creationId xmlns:a16="http://schemas.microsoft.com/office/drawing/2014/main" id="{C0BAFD7D-1DF4-4F6D-BCFA-6E5507F4B58E}"/>
+                <a16:creationId xmlns:a16="http://schemas.microsoft.com/office/drawing/2014/main" id="{6BBE3564-E4A7-4B38-99B0-9A293E727DEF}"/>
               </a:ext>
             </a:extLst>
           </p:cNvPr>
@@ -7277,7 +7277,7 @@
           <p:cNvPr id="3" name="TextBox 2">
             <a:extLst xmlns:a="http://schemas.openxmlformats.org/drawingml/2006/main">
               <a:ext uri="{FF2B5EF4-FFF2-40B4-BE49-F238E27FC236}">
-                <a16:creationId xmlns:a16="http://schemas.microsoft.com/office/drawing/2014/main" id="{86CADCE5-E55E-4AC4-AE22-16512253DE75}"/>
+                <a16:creationId xmlns:a16="http://schemas.microsoft.com/office/drawing/2014/main" id="{0875BA64-0119-4842-A492-4AA3B4183D8A}"/>
               </a:ext>
             </a:extLst>
           </p:cNvPr>
@@ -7324,7 +7324,7 @@
           <p:cNvPr id="4" name="Rectangle 3">
             <a:extLst xmlns:a="http://schemas.openxmlformats.org/drawingml/2006/main">
               <a:ext uri="{FF2B5EF4-FFF2-40B4-BE49-F238E27FC236}">
-                <a16:creationId xmlns:a16="http://schemas.microsoft.com/office/drawing/2014/main" id="{4EC112B1-D206-488F-A6E0-9F5DE091D30C}"/>
+                <a16:creationId xmlns:a16="http://schemas.microsoft.com/office/drawing/2014/main" id="{B70C0224-B96E-4BCF-9B60-2C35F06ABD7F}"/>
               </a:ext>
             </a:extLst>
           </p:cNvPr>
@@ -7379,7 +7379,7 @@
           <p:cNvPr id="5" name="Rectangle 4">
             <a:extLst xmlns:a="http://schemas.openxmlformats.org/drawingml/2006/main">
               <a:ext uri="{FF2B5EF4-FFF2-40B4-BE49-F238E27FC236}">
-                <a16:creationId xmlns:a16="http://schemas.microsoft.com/office/drawing/2014/main" id="{78F2E461-8B92-46CC-9ACC-E74FEA5862B5}"/>
+                <a16:creationId xmlns:a16="http://schemas.microsoft.com/office/drawing/2014/main" id="{C21C2F0A-32AB-43BF-B93D-AD331F4C36C0}"/>
               </a:ext>
             </a:extLst>
           </p:cNvPr>
@@ -7434,7 +7434,7 @@
           <p:cNvPr id="6" name="TextBox 5">
             <a:extLst xmlns:a="http://schemas.openxmlformats.org/drawingml/2006/main">
               <a:ext uri="{FF2B5EF4-FFF2-40B4-BE49-F238E27FC236}">
-                <a16:creationId xmlns:a16="http://schemas.microsoft.com/office/drawing/2014/main" id="{4DE3B5DB-8A1B-4BC2-8EAE-41D11C7F1284}"/>
+                <a16:creationId xmlns:a16="http://schemas.microsoft.com/office/drawing/2014/main" id="{CFCF2316-FF3C-43E7-B080-7C0FA30C0164}"/>
               </a:ext>
             </a:extLst>
           </p:cNvPr>
@@ -7471,7 +7471,7 @@
                 <a:ea typeface="Aptos"/>
                 <a:cs typeface="Aptos"/>
               </a:rPr>
-              <a:t>Independent public evidence summary · 2026.07.23-10 · 2026-07-22 · Sources: IP Australia; PRH; EPO; EPO / UPC; USPTO</a:t>
+              <a:t>Independent public evidence summary · 2026.07.23-11 · 2026-07-22 · Sources: IP Australia; PRH; EPO; EPO / UPC; USPTO</a:t>
             </a:r>
           </a:p>
         </p:txBody>
@@ -7481,7 +7481,7 @@
           <p:cNvPr id="7" name="TextBox 6">
             <a:extLst xmlns:a="http://schemas.openxmlformats.org/drawingml/2006/main">
               <a:ext uri="{FF2B5EF4-FFF2-40B4-BE49-F238E27FC236}">
-                <a16:creationId xmlns:a16="http://schemas.microsoft.com/office/drawing/2014/main" id="{0F2CB7C4-B5F6-47B3-91C5-51BC92B8352A}"/>
+                <a16:creationId xmlns:a16="http://schemas.microsoft.com/office/drawing/2014/main" id="{EB74F2ED-5D48-4CFF-839D-FE798D95BBB7}"/>
               </a:ext>
             </a:extLst>
           </p:cNvPr>
@@ -7968,7 +7968,7 @@
           <p:cNvPr id="9" name="TextBox 8">
             <a:extLst xmlns:a="http://schemas.openxmlformats.org/drawingml/2006/main">
               <a:ext uri="{FF2B5EF4-FFF2-40B4-BE49-F238E27FC236}">
-                <a16:creationId xmlns:a16="http://schemas.microsoft.com/office/drawing/2014/main" id="{2B734C01-0BCE-460B-A160-62949DC64C53}"/>
+                <a16:creationId xmlns:a16="http://schemas.microsoft.com/office/drawing/2014/main" id="{9ADD5ED6-9731-493F-8AFC-E28D3CF886F4}"/>
               </a:ext>
             </a:extLst>
           </p:cNvPr>
@@ -8013,7 +8013,7 @@
     </p:spTree>
     <p:extLst>
       <p:ext uri="{BB962C8B-B14F-4D97-AF65-F5344CB8AC3E}">
-        <p14:creationId xmlns:p14="http://schemas.microsoft.com/office/powerpoint/2010/main" val="1554783275"/>
+        <p14:creationId xmlns:p14="http://schemas.microsoft.com/office/powerpoint/2010/main" val="813080793"/>
       </p:ext>
     </p:extLst>
   </p:cSld>
@@ -8037,7 +8037,7 @@
           <p:cNvPr id="2" name="TextBox 1">
             <a:extLst xmlns:a="http://schemas.openxmlformats.org/drawingml/2006/main">
               <a:ext uri="{FF2B5EF4-FFF2-40B4-BE49-F238E27FC236}">
-                <a16:creationId xmlns:a16="http://schemas.microsoft.com/office/drawing/2014/main" id="{01F5128A-9F1B-4FD9-8F59-E8B752DE52B2}"/>
+                <a16:creationId xmlns:a16="http://schemas.microsoft.com/office/drawing/2014/main" id="{83E7E9E7-A255-4CD5-A437-8281F8024E6B}"/>
               </a:ext>
             </a:extLst>
           </p:cNvPr>
@@ -8084,7 +8084,7 @@
           <p:cNvPr id="3" name="TextBox 2">
             <a:extLst xmlns:a="http://schemas.openxmlformats.org/drawingml/2006/main">
               <a:ext uri="{FF2B5EF4-FFF2-40B4-BE49-F238E27FC236}">
-                <a16:creationId xmlns:a16="http://schemas.microsoft.com/office/drawing/2014/main" id="{4600043F-FCB6-4CC6-A5BA-DEA3EC000F96}"/>
+                <a16:creationId xmlns:a16="http://schemas.microsoft.com/office/drawing/2014/main" id="{0E23D26C-1474-44A9-B037-D7811D8F97C8}"/>
               </a:ext>
             </a:extLst>
           </p:cNvPr>
@@ -8131,7 +8131,7 @@
           <p:cNvPr id="4" name="Rectangle 3">
             <a:extLst xmlns:a="http://schemas.openxmlformats.org/drawingml/2006/main">
               <a:ext uri="{FF2B5EF4-FFF2-40B4-BE49-F238E27FC236}">
-                <a16:creationId xmlns:a16="http://schemas.microsoft.com/office/drawing/2014/main" id="{465CD8EE-1F32-47AF-AB28-6BB1E72487A7}"/>
+                <a16:creationId xmlns:a16="http://schemas.microsoft.com/office/drawing/2014/main" id="{ADD958E2-9C75-4F7C-84DF-467870D8B136}"/>
               </a:ext>
             </a:extLst>
           </p:cNvPr>
@@ -8186,7 +8186,7 @@
           <p:cNvPr id="5" name="Rectangle 4">
             <a:extLst xmlns:a="http://schemas.openxmlformats.org/drawingml/2006/main">
               <a:ext uri="{FF2B5EF4-FFF2-40B4-BE49-F238E27FC236}">
-                <a16:creationId xmlns:a16="http://schemas.microsoft.com/office/drawing/2014/main" id="{CCD56968-0781-4DD2-95F6-AB80988D6AB5}"/>
+                <a16:creationId xmlns:a16="http://schemas.microsoft.com/office/drawing/2014/main" id="{EFA6400C-107D-4BBC-B295-F5733076AE5F}"/>
               </a:ext>
             </a:extLst>
           </p:cNvPr>
@@ -8241,7 +8241,7 @@
           <p:cNvPr id="6" name="TextBox 5">
             <a:extLst xmlns:a="http://schemas.openxmlformats.org/drawingml/2006/main">
               <a:ext uri="{FF2B5EF4-FFF2-40B4-BE49-F238E27FC236}">
-                <a16:creationId xmlns:a16="http://schemas.microsoft.com/office/drawing/2014/main" id="{CD87C2AA-C221-48FC-8FDE-7D464D36C0EC}"/>
+                <a16:creationId xmlns:a16="http://schemas.microsoft.com/office/drawing/2014/main" id="{D59947B2-BB7D-45EF-869D-837704F9FACE}"/>
               </a:ext>
             </a:extLst>
           </p:cNvPr>
@@ -8278,7 +8278,7 @@
                 <a:ea typeface="Aptos"/>
                 <a:cs typeface="Aptos"/>
               </a:rPr>
-              <a:t>Independent public evidence summary · 2026.07.23-10 · 2026-07-22 · Sources: UN; Atlas</a:t>
+              <a:t>Independent public evidence summary · 2026.07.23-11 · 2026-07-22 · Sources: UN; Atlas</a:t>
             </a:r>
           </a:p>
         </p:txBody>
@@ -8288,7 +8288,7 @@
           <p:cNvPr id="7" name="TextBox 6">
             <a:extLst xmlns:a="http://schemas.openxmlformats.org/drawingml/2006/main">
               <a:ext uri="{FF2B5EF4-FFF2-40B4-BE49-F238E27FC236}">
-                <a16:creationId xmlns:a16="http://schemas.microsoft.com/office/drawing/2014/main" id="{00507115-1232-47A8-A180-90E4C78D674F}"/>
+                <a16:creationId xmlns:a16="http://schemas.microsoft.com/office/drawing/2014/main" id="{8F247A69-64CD-49A5-B050-C8669BA7A936}"/>
               </a:ext>
             </a:extLst>
           </p:cNvPr>
@@ -8335,7 +8335,7 @@
           <p:cNvPr id="8" name="Rounded Rectangle 7">
             <a:extLst xmlns:a="http://schemas.openxmlformats.org/drawingml/2006/main">
               <a:ext uri="{FF2B5EF4-FFF2-40B4-BE49-F238E27FC236}">
-                <a16:creationId xmlns:a16="http://schemas.microsoft.com/office/drawing/2014/main" id="{1C7BF45D-F3D5-4DF8-A8EC-014574D2DEC0}"/>
+                <a16:creationId xmlns:a16="http://schemas.microsoft.com/office/drawing/2014/main" id="{65AD9409-DA7E-4B38-AA14-91314C3413AD}"/>
               </a:ext>
             </a:extLst>
           </p:cNvPr>
@@ -8392,7 +8392,7 @@
           <p:cNvPr id="9" name="TextBox 8">
             <a:extLst xmlns:a="http://schemas.openxmlformats.org/drawingml/2006/main">
               <a:ext uri="{FF2B5EF4-FFF2-40B4-BE49-F238E27FC236}">
-                <a16:creationId xmlns:a16="http://schemas.microsoft.com/office/drawing/2014/main" id="{6393BA34-1E00-405B-93C3-CFFBB9E37F66}"/>
+                <a16:creationId xmlns:a16="http://schemas.microsoft.com/office/drawing/2014/main" id="{B0275603-FE95-4480-913F-1CBF68E4D129}"/>
               </a:ext>
             </a:extLst>
           </p:cNvPr>
@@ -8439,7 +8439,7 @@
           <p:cNvPr id="10" name="TextBox 9">
             <a:extLst xmlns:a="http://schemas.openxmlformats.org/drawingml/2006/main">
               <a:ext uri="{FF2B5EF4-FFF2-40B4-BE49-F238E27FC236}">
-                <a16:creationId xmlns:a16="http://schemas.microsoft.com/office/drawing/2014/main" id="{58E4F7F1-68B9-4F2C-B3F9-3A46191335F4}"/>
+                <a16:creationId xmlns:a16="http://schemas.microsoft.com/office/drawing/2014/main" id="{34A753AE-92C9-444B-8DF7-F4C30A71106A}"/>
               </a:ext>
             </a:extLst>
           </p:cNvPr>
@@ -8486,7 +8486,7 @@
           <p:cNvPr id="11" name="Rounded Rectangle 10">
             <a:extLst xmlns:a="http://schemas.openxmlformats.org/drawingml/2006/main">
               <a:ext uri="{FF2B5EF4-FFF2-40B4-BE49-F238E27FC236}">
-                <a16:creationId xmlns:a16="http://schemas.microsoft.com/office/drawing/2014/main" id="{3FD45B9A-5D8A-4BA4-A8B1-385F4DE842AE}"/>
+                <a16:creationId xmlns:a16="http://schemas.microsoft.com/office/drawing/2014/main" id="{7B6CB931-B7DF-4002-B4BF-89415E28BC12}"/>
               </a:ext>
             </a:extLst>
           </p:cNvPr>
@@ -8543,7 +8543,7 @@
           <p:cNvPr id="12" name="TextBox 11">
             <a:extLst xmlns:a="http://schemas.openxmlformats.org/drawingml/2006/main">
               <a:ext uri="{FF2B5EF4-FFF2-40B4-BE49-F238E27FC236}">
-                <a16:creationId xmlns:a16="http://schemas.microsoft.com/office/drawing/2014/main" id="{C5E00E6C-424F-46B8-A2F3-AC2D9C3737F2}"/>
+                <a16:creationId xmlns:a16="http://schemas.microsoft.com/office/drawing/2014/main" id="{EAFB984C-A669-4C7E-B685-7B52C6AB3038}"/>
               </a:ext>
             </a:extLst>
           </p:cNvPr>
@@ -8590,7 +8590,7 @@
           <p:cNvPr id="13" name="TextBox 12">
             <a:extLst xmlns:a="http://schemas.openxmlformats.org/drawingml/2006/main">
               <a:ext uri="{FF2B5EF4-FFF2-40B4-BE49-F238E27FC236}">
-                <a16:creationId xmlns:a16="http://schemas.microsoft.com/office/drawing/2014/main" id="{A034897B-2891-4886-812A-CB1F234242FA}"/>
+                <a16:creationId xmlns:a16="http://schemas.microsoft.com/office/drawing/2014/main" id="{80E0438D-7F36-41AC-A2EA-ECC019B098D2}"/>
               </a:ext>
             </a:extLst>
           </p:cNvPr>
@@ -8637,7 +8637,7 @@
           <p:cNvPr id="14" name="Rounded Rectangle 13">
             <a:extLst xmlns:a="http://schemas.openxmlformats.org/drawingml/2006/main">
               <a:ext uri="{FF2B5EF4-FFF2-40B4-BE49-F238E27FC236}">
-                <a16:creationId xmlns:a16="http://schemas.microsoft.com/office/drawing/2014/main" id="{41CDDCFE-121C-4CC5-B6D6-13B20620FA0B}"/>
+                <a16:creationId xmlns:a16="http://schemas.microsoft.com/office/drawing/2014/main" id="{18E8B1C0-5E60-4B1D-8B0B-E8CA3840241D}"/>
               </a:ext>
             </a:extLst>
           </p:cNvPr>
@@ -8694,7 +8694,7 @@
           <p:cNvPr id="15" name="TextBox 14">
             <a:extLst xmlns:a="http://schemas.openxmlformats.org/drawingml/2006/main">
               <a:ext uri="{FF2B5EF4-FFF2-40B4-BE49-F238E27FC236}">
-                <a16:creationId xmlns:a16="http://schemas.microsoft.com/office/drawing/2014/main" id="{EEDEE866-2DA3-4B55-B6D4-536D73593A92}"/>
+                <a16:creationId xmlns:a16="http://schemas.microsoft.com/office/drawing/2014/main" id="{073B9E06-E0BC-4071-B5BF-E982053AA5D6}"/>
               </a:ext>
             </a:extLst>
           </p:cNvPr>
@@ -8741,7 +8741,7 @@
           <p:cNvPr id="16" name="TextBox 15">
             <a:extLst xmlns:a="http://schemas.openxmlformats.org/drawingml/2006/main">
               <a:ext uri="{FF2B5EF4-FFF2-40B4-BE49-F238E27FC236}">
-                <a16:creationId xmlns:a16="http://schemas.microsoft.com/office/drawing/2014/main" id="{DC5674DE-00DD-440C-9071-36074FA182BA}"/>
+                <a16:creationId xmlns:a16="http://schemas.microsoft.com/office/drawing/2014/main" id="{883DDB40-15C2-4BC3-8778-C34019F5E519}"/>
               </a:ext>
             </a:extLst>
           </p:cNvPr>
@@ -8788,7 +8788,7 @@
           <p:cNvPr id="17" name="Rounded Rectangle 16">
             <a:extLst xmlns:a="http://schemas.openxmlformats.org/drawingml/2006/main">
               <a:ext uri="{FF2B5EF4-FFF2-40B4-BE49-F238E27FC236}">
-                <a16:creationId xmlns:a16="http://schemas.microsoft.com/office/drawing/2014/main" id="{930395C4-6CF3-4207-843B-1AACA53F0AD1}"/>
+                <a16:creationId xmlns:a16="http://schemas.microsoft.com/office/drawing/2014/main" id="{5907A372-E6B0-4424-A49A-9E1401E9E795}"/>
               </a:ext>
             </a:extLst>
           </p:cNvPr>
@@ -8845,7 +8845,7 @@
           <p:cNvPr id="18" name="TextBox 17">
             <a:extLst xmlns:a="http://schemas.openxmlformats.org/drawingml/2006/main">
               <a:ext uri="{FF2B5EF4-FFF2-40B4-BE49-F238E27FC236}">
-                <a16:creationId xmlns:a16="http://schemas.microsoft.com/office/drawing/2014/main" id="{943A8013-8CAE-4E29-BE5D-BF4968626082}"/>
+                <a16:creationId xmlns:a16="http://schemas.microsoft.com/office/drawing/2014/main" id="{0F699235-730C-4A63-B615-9B15796D3EB6}"/>
               </a:ext>
             </a:extLst>
           </p:cNvPr>
@@ -8892,7 +8892,7 @@
           <p:cNvPr id="19" name="TextBox 18">
             <a:extLst xmlns:a="http://schemas.openxmlformats.org/drawingml/2006/main">
               <a:ext uri="{FF2B5EF4-FFF2-40B4-BE49-F238E27FC236}">
-                <a16:creationId xmlns:a16="http://schemas.microsoft.com/office/drawing/2014/main" id="{9C5C1E66-9998-4536-A68D-39F1C3900013}"/>
+                <a16:creationId xmlns:a16="http://schemas.microsoft.com/office/drawing/2014/main" id="{3CD87749-055B-4BE0-B323-60252D4A9525}"/>
               </a:ext>
             </a:extLst>
           </p:cNvPr>
@@ -8939,7 +8939,7 @@
           <p:cNvPr id="20" name="TextBox 19">
             <a:extLst xmlns:a="http://schemas.openxmlformats.org/drawingml/2006/main">
               <a:ext uri="{FF2B5EF4-FFF2-40B4-BE49-F238E27FC236}">
-                <a16:creationId xmlns:a16="http://schemas.microsoft.com/office/drawing/2014/main" id="{F1602CFB-8D4A-4541-9763-EAFA7BF87A0B}"/>
+                <a16:creationId xmlns:a16="http://schemas.microsoft.com/office/drawing/2014/main" id="{71D3152D-DE3C-46EC-BD73-D5AA45C414EA}"/>
               </a:ext>
             </a:extLst>
           </p:cNvPr>
@@ -8986,7 +8986,7 @@
           <p:cNvPr id="21" name="Rounded Rectangle 20">
             <a:extLst xmlns:a="http://schemas.openxmlformats.org/drawingml/2006/main">
               <a:ext uri="{FF2B5EF4-FFF2-40B4-BE49-F238E27FC236}">
-                <a16:creationId xmlns:a16="http://schemas.microsoft.com/office/drawing/2014/main" id="{3559C327-1CC5-467E-8A54-595398B2FF24}"/>
+                <a16:creationId xmlns:a16="http://schemas.microsoft.com/office/drawing/2014/main" id="{097FDE0C-8E62-40B6-BD95-5B9F11AAC2B1}"/>
               </a:ext>
             </a:extLst>
           </p:cNvPr>
@@ -9043,7 +9043,7 @@
           <p:cNvPr id="22" name="TextBox 21">
             <a:extLst xmlns:a="http://schemas.openxmlformats.org/drawingml/2006/main">
               <a:ext uri="{FF2B5EF4-FFF2-40B4-BE49-F238E27FC236}">
-                <a16:creationId xmlns:a16="http://schemas.microsoft.com/office/drawing/2014/main" id="{650FA5CC-38D3-4652-8A91-27CD5669672B}"/>
+                <a16:creationId xmlns:a16="http://schemas.microsoft.com/office/drawing/2014/main" id="{1CE2088F-C66A-4721-9A8E-6B6DCDCBD71D}"/>
               </a:ext>
             </a:extLst>
           </p:cNvPr>
@@ -9090,7 +9090,7 @@
           <p:cNvPr id="23" name="TextBox 22">
             <a:extLst xmlns:a="http://schemas.openxmlformats.org/drawingml/2006/main">
               <a:ext uri="{FF2B5EF4-FFF2-40B4-BE49-F238E27FC236}">
-                <a16:creationId xmlns:a16="http://schemas.microsoft.com/office/drawing/2014/main" id="{120A75D5-8DBC-4B00-8737-466ED44EF430}"/>
+                <a16:creationId xmlns:a16="http://schemas.microsoft.com/office/drawing/2014/main" id="{0428FB92-F183-409A-833F-DB035DFF9F45}"/>
               </a:ext>
             </a:extLst>
           </p:cNvPr>
@@ -9135,7 +9135,7 @@
     </p:spTree>
     <p:extLst>
       <p:ext uri="{BB962C8B-B14F-4D97-AF65-F5344CB8AC3E}">
-        <p14:creationId xmlns:p14="http://schemas.microsoft.com/office/powerpoint/2010/main" val="1205908936"/>
+        <p14:creationId xmlns:p14="http://schemas.microsoft.com/office/powerpoint/2010/main" val="2086873088"/>
       </p:ext>
     </p:extLst>
   </p:cSld>
@@ -9159,7 +9159,7 @@
           <p:cNvPr id="2" name="TextBox 1">
             <a:extLst xmlns:a="http://schemas.openxmlformats.org/drawingml/2006/main">
               <a:ext uri="{FF2B5EF4-FFF2-40B4-BE49-F238E27FC236}">
-                <a16:creationId xmlns:a16="http://schemas.microsoft.com/office/drawing/2014/main" id="{3446BB4B-87DC-4D69-8866-7C5CD7CA036D}"/>
+                <a16:creationId xmlns:a16="http://schemas.microsoft.com/office/drawing/2014/main" id="{B849AB76-DF25-4E77-9C53-6903765B64B6}"/>
               </a:ext>
             </a:extLst>
           </p:cNvPr>
@@ -9206,7 +9206,7 @@
           <p:cNvPr id="3" name="TextBox 2">
             <a:extLst xmlns:a="http://schemas.openxmlformats.org/drawingml/2006/main">
               <a:ext uri="{FF2B5EF4-FFF2-40B4-BE49-F238E27FC236}">
-                <a16:creationId xmlns:a16="http://schemas.microsoft.com/office/drawing/2014/main" id="{AF221798-0F9E-4742-BE56-2012A3EA8ADC}"/>
+                <a16:creationId xmlns:a16="http://schemas.microsoft.com/office/drawing/2014/main" id="{069F2A74-3E7C-4A6A-84ED-70809408F1F6}"/>
               </a:ext>
             </a:extLst>
           </p:cNvPr>
@@ -9253,7 +9253,7 @@
           <p:cNvPr id="4" name="Rectangle 3">
             <a:extLst xmlns:a="http://schemas.openxmlformats.org/drawingml/2006/main">
               <a:ext uri="{FF2B5EF4-FFF2-40B4-BE49-F238E27FC236}">
-                <a16:creationId xmlns:a16="http://schemas.microsoft.com/office/drawing/2014/main" id="{36F6812B-039B-4E70-9931-A4E51A49366F}"/>
+                <a16:creationId xmlns:a16="http://schemas.microsoft.com/office/drawing/2014/main" id="{09F2AA74-AFE8-46F4-A375-D40D8D91A3BC}"/>
               </a:ext>
             </a:extLst>
           </p:cNvPr>
@@ -9308,7 +9308,7 @@
           <p:cNvPr id="5" name="Rectangle 4">
             <a:extLst xmlns:a="http://schemas.openxmlformats.org/drawingml/2006/main">
               <a:ext uri="{FF2B5EF4-FFF2-40B4-BE49-F238E27FC236}">
-                <a16:creationId xmlns:a16="http://schemas.microsoft.com/office/drawing/2014/main" id="{6CCFFA52-28CC-4A52-864E-8C538B95C1FF}"/>
+                <a16:creationId xmlns:a16="http://schemas.microsoft.com/office/drawing/2014/main" id="{663CC336-7886-4105-BF68-1BBCCEB8E58F}"/>
               </a:ext>
             </a:extLst>
           </p:cNvPr>
@@ -9363,7 +9363,7 @@
           <p:cNvPr id="6" name="TextBox 5">
             <a:extLst xmlns:a="http://schemas.openxmlformats.org/drawingml/2006/main">
               <a:ext uri="{FF2B5EF4-FFF2-40B4-BE49-F238E27FC236}">
-                <a16:creationId xmlns:a16="http://schemas.microsoft.com/office/drawing/2014/main" id="{895AC9D5-81EC-40E1-922E-6DA29BABEF3A}"/>
+                <a16:creationId xmlns:a16="http://schemas.microsoft.com/office/drawing/2014/main" id="{D731022E-18BA-47CB-A341-94085A7D78E2}"/>
               </a:ext>
             </a:extLst>
           </p:cNvPr>
@@ -9400,7 +9400,7 @@
                 <a:ea typeface="Aptos"/>
                 <a:cs typeface="Aptos"/>
               </a:rPr>
-              <a:t>Independent public evidence summary · 2026.07.23-10 · 2026-07-22 · Sources: Health Canada; Destatis; Vero; Sejm; Swedish Government</a:t>
+              <a:t>Independent public evidence summary · 2026.07.23-11 · 2026-07-22 · Sources: Health Canada; Destatis; Vero; Sejm; Swedish Government</a:t>
             </a:r>
           </a:p>
         </p:txBody>
@@ -9410,7 +9410,7 @@
           <p:cNvPr id="7" name="TextBox 6">
             <a:extLst xmlns:a="http://schemas.openxmlformats.org/drawingml/2006/main">
               <a:ext uri="{FF2B5EF4-FFF2-40B4-BE49-F238E27FC236}">
-                <a16:creationId xmlns:a16="http://schemas.microsoft.com/office/drawing/2014/main" id="{5A584F06-12B9-4F93-AB34-37758934DBC1}"/>
+                <a16:creationId xmlns:a16="http://schemas.microsoft.com/office/drawing/2014/main" id="{5F2AE8CA-7B22-4CC2-A887-9E1E564E8E27}"/>
               </a:ext>
             </a:extLst>
           </p:cNvPr>
@@ -9980,7 +9980,7 @@
           <p:cNvPr id="9" name="TextBox 8">
             <a:extLst xmlns:a="http://schemas.openxmlformats.org/drawingml/2006/main">
               <a:ext uri="{FF2B5EF4-FFF2-40B4-BE49-F238E27FC236}">
-                <a16:creationId xmlns:a16="http://schemas.microsoft.com/office/drawing/2014/main" id="{B798AAB0-958A-4597-A4FA-F87AE8B97482}"/>
+                <a16:creationId xmlns:a16="http://schemas.microsoft.com/office/drawing/2014/main" id="{94E0904C-1306-4D46-B0DC-DCF02E519293}"/>
               </a:ext>
             </a:extLst>
           </p:cNvPr>
@@ -10025,7 +10025,7 @@
     </p:spTree>
     <p:extLst>
       <p:ext uri="{BB962C8B-B14F-4D97-AF65-F5344CB8AC3E}">
-        <p14:creationId xmlns:p14="http://schemas.microsoft.com/office/powerpoint/2010/main" val="1906912212"/>
+        <p14:creationId xmlns:p14="http://schemas.microsoft.com/office/powerpoint/2010/main" val="168174732"/>
       </p:ext>
     </p:extLst>
   </p:cSld>
@@ -10049,7 +10049,7 @@
           <p:cNvPr id="2" name="TextBox 1">
             <a:extLst xmlns:a="http://schemas.openxmlformats.org/drawingml/2006/main">
               <a:ext uri="{FF2B5EF4-FFF2-40B4-BE49-F238E27FC236}">
-                <a16:creationId xmlns:a16="http://schemas.microsoft.com/office/drawing/2014/main" id="{CBA9A255-F567-4C86-8F86-EE77A4ECF8B3}"/>
+                <a16:creationId xmlns:a16="http://schemas.microsoft.com/office/drawing/2014/main" id="{EC7DC5B3-54F2-495E-AC63-39EB7A3640F0}"/>
               </a:ext>
             </a:extLst>
           </p:cNvPr>
@@ -10096,7 +10096,7 @@
           <p:cNvPr id="3" name="TextBox 2">
             <a:extLst xmlns:a="http://schemas.openxmlformats.org/drawingml/2006/main">
               <a:ext uri="{FF2B5EF4-FFF2-40B4-BE49-F238E27FC236}">
-                <a16:creationId xmlns:a16="http://schemas.microsoft.com/office/drawing/2014/main" id="{46CFEED9-AB91-4779-ABEC-4B44E6BF63B6}"/>
+                <a16:creationId xmlns:a16="http://schemas.microsoft.com/office/drawing/2014/main" id="{845940B2-6493-4A78-9F91-48A4F0DDB6FF}"/>
               </a:ext>
             </a:extLst>
           </p:cNvPr>
@@ -10143,7 +10143,7 @@
           <p:cNvPr id="4" name="Rectangle 3">
             <a:extLst xmlns:a="http://schemas.openxmlformats.org/drawingml/2006/main">
               <a:ext uri="{FF2B5EF4-FFF2-40B4-BE49-F238E27FC236}">
-                <a16:creationId xmlns:a16="http://schemas.microsoft.com/office/drawing/2014/main" id="{675D6ED0-D671-4D21-B75E-FB87D003F7F9}"/>
+                <a16:creationId xmlns:a16="http://schemas.microsoft.com/office/drawing/2014/main" id="{105E3BF9-662A-4416-A99D-638867D88CAE}"/>
               </a:ext>
             </a:extLst>
           </p:cNvPr>
@@ -10198,7 +10198,7 @@
           <p:cNvPr id="5" name="Rectangle 4">
             <a:extLst xmlns:a="http://schemas.openxmlformats.org/drawingml/2006/main">
               <a:ext uri="{FF2B5EF4-FFF2-40B4-BE49-F238E27FC236}">
-                <a16:creationId xmlns:a16="http://schemas.microsoft.com/office/drawing/2014/main" id="{E32EC7C8-B234-47A8-B4A0-A632AA44DE05}"/>
+                <a16:creationId xmlns:a16="http://schemas.microsoft.com/office/drawing/2014/main" id="{8C9271E5-B4F0-4864-B516-9F3B22B5CAAD}"/>
               </a:ext>
             </a:extLst>
           </p:cNvPr>
@@ -10253,7 +10253,7 @@
           <p:cNvPr id="6" name="TextBox 5">
             <a:extLst xmlns:a="http://schemas.openxmlformats.org/drawingml/2006/main">
               <a:ext uri="{FF2B5EF4-FFF2-40B4-BE49-F238E27FC236}">
-                <a16:creationId xmlns:a16="http://schemas.microsoft.com/office/drawing/2014/main" id="{C551D6E2-1A4A-42F8-A0E6-78D1920C0740}"/>
+                <a16:creationId xmlns:a16="http://schemas.microsoft.com/office/drawing/2014/main" id="{553CAF99-F7B9-4F00-A44A-C8870FC45F53}"/>
               </a:ext>
             </a:extLst>
           </p:cNvPr>
@@ -10290,7 +10290,7 @@
                 <a:ea typeface="Aptos"/>
                 <a:cs typeface="Aptos"/>
               </a:rPr>
-              <a:t>Independent public evidence summary · 2026.07.23-10 · 2026-07-22 · Sources: Health Canada 2024</a:t>
+              <a:t>Independent public evidence summary · 2026.07.23-11 · 2026-07-22 · Sources: Health Canada 2024</a:t>
             </a:r>
           </a:p>
         </p:txBody>
@@ -10300,7 +10300,7 @@
           <p:cNvPr id="7" name="TextBox 6">
             <a:extLst xmlns:a="http://schemas.openxmlformats.org/drawingml/2006/main">
               <a:ext uri="{FF2B5EF4-FFF2-40B4-BE49-F238E27FC236}">
-                <a16:creationId xmlns:a16="http://schemas.microsoft.com/office/drawing/2014/main" id="{33EC497C-04F6-436E-8251-A691CE59500C}"/>
+                <a16:creationId xmlns:a16="http://schemas.microsoft.com/office/drawing/2014/main" id="{6BD1070D-36CA-4F04-8EF6-C51E14F29ADC}"/>
               </a:ext>
             </a:extLst>
           </p:cNvPr>
@@ -10347,7 +10347,7 @@
           <p:cNvPr id="8" name="Rounded Rectangle 7">
             <a:extLst xmlns:a="http://schemas.openxmlformats.org/drawingml/2006/main">
               <a:ext uri="{FF2B5EF4-FFF2-40B4-BE49-F238E27FC236}">
-                <a16:creationId xmlns:a16="http://schemas.microsoft.com/office/drawing/2014/main" id="{5E7EF6F6-0AD5-41D4-99D3-AB82E6DC0412}"/>
+                <a16:creationId xmlns:a16="http://schemas.microsoft.com/office/drawing/2014/main" id="{A3281213-3247-438D-A08C-6F30F13DA0D9}"/>
               </a:ext>
             </a:extLst>
           </p:cNvPr>
@@ -10404,7 +10404,7 @@
           <p:cNvPr id="9" name="TextBox 8">
             <a:extLst xmlns:a="http://schemas.openxmlformats.org/drawingml/2006/main">
               <a:ext uri="{FF2B5EF4-FFF2-40B4-BE49-F238E27FC236}">
-                <a16:creationId xmlns:a16="http://schemas.microsoft.com/office/drawing/2014/main" id="{2882B370-C28A-49C6-819C-ADFECABBC90A}"/>
+                <a16:creationId xmlns:a16="http://schemas.microsoft.com/office/drawing/2014/main" id="{BA14D461-DB82-42E4-BDB4-3E3A93E71920}"/>
               </a:ext>
             </a:extLst>
           </p:cNvPr>
@@ -10451,7 +10451,7 @@
           <p:cNvPr id="10" name="TextBox 9">
             <a:extLst xmlns:a="http://schemas.openxmlformats.org/drawingml/2006/main">
               <a:ext uri="{FF2B5EF4-FFF2-40B4-BE49-F238E27FC236}">
-                <a16:creationId xmlns:a16="http://schemas.microsoft.com/office/drawing/2014/main" id="{908F1E6B-4C81-4847-99DF-A31BD8EA5ED4}"/>
+                <a16:creationId xmlns:a16="http://schemas.microsoft.com/office/drawing/2014/main" id="{07B17D0B-ADE8-4EF8-BB70-F9BF3FE9A0A5}"/>
               </a:ext>
             </a:extLst>
           </p:cNvPr>
@@ -10498,7 +10498,7 @@
           <p:cNvPr id="11" name="Rounded Rectangle 10">
             <a:extLst xmlns:a="http://schemas.openxmlformats.org/drawingml/2006/main">
               <a:ext uri="{FF2B5EF4-FFF2-40B4-BE49-F238E27FC236}">
-                <a16:creationId xmlns:a16="http://schemas.microsoft.com/office/drawing/2014/main" id="{5EF39D58-FB87-4CDD-9708-A98AF57E17D7}"/>
+                <a16:creationId xmlns:a16="http://schemas.microsoft.com/office/drawing/2014/main" id="{3BCB83EF-078F-41EB-970E-78F589035981}"/>
               </a:ext>
             </a:extLst>
           </p:cNvPr>
@@ -10555,7 +10555,7 @@
           <p:cNvPr id="12" name="TextBox 11">
             <a:extLst xmlns:a="http://schemas.openxmlformats.org/drawingml/2006/main">
               <a:ext uri="{FF2B5EF4-FFF2-40B4-BE49-F238E27FC236}">
-                <a16:creationId xmlns:a16="http://schemas.microsoft.com/office/drawing/2014/main" id="{1B17487D-2D5B-41A4-8AC7-C8E6843FA255}"/>
+                <a16:creationId xmlns:a16="http://schemas.microsoft.com/office/drawing/2014/main" id="{DBC7B415-D97A-468E-96AB-364A6E4DFE7E}"/>
               </a:ext>
             </a:extLst>
           </p:cNvPr>
@@ -10602,7 +10602,7 @@
           <p:cNvPr id="13" name="TextBox 12">
             <a:extLst xmlns:a="http://schemas.openxmlformats.org/drawingml/2006/main">
               <a:ext uri="{FF2B5EF4-FFF2-40B4-BE49-F238E27FC236}">
-                <a16:creationId xmlns:a16="http://schemas.microsoft.com/office/drawing/2014/main" id="{826F62F3-75D5-4448-B92B-11D6E54EC3DC}"/>
+                <a16:creationId xmlns:a16="http://schemas.microsoft.com/office/drawing/2014/main" id="{47BE71CA-EC72-4F3E-8273-DD17AC13EEFB}"/>
               </a:ext>
             </a:extLst>
           </p:cNvPr>
@@ -10649,7 +10649,7 @@
           <p:cNvPr id="14" name="Rounded Rectangle 13">
             <a:extLst xmlns:a="http://schemas.openxmlformats.org/drawingml/2006/main">
               <a:ext uri="{FF2B5EF4-FFF2-40B4-BE49-F238E27FC236}">
-                <a16:creationId xmlns:a16="http://schemas.microsoft.com/office/drawing/2014/main" id="{150B46A4-C5F4-4D00-B217-6C97C1974476}"/>
+                <a16:creationId xmlns:a16="http://schemas.microsoft.com/office/drawing/2014/main" id="{413008A5-9E54-42E6-AF35-C845F2A447C4}"/>
               </a:ext>
             </a:extLst>
           </p:cNvPr>
@@ -10706,7 +10706,7 @@
           <p:cNvPr id="15" name="TextBox 14">
             <a:extLst xmlns:a="http://schemas.openxmlformats.org/drawingml/2006/main">
               <a:ext uri="{FF2B5EF4-FFF2-40B4-BE49-F238E27FC236}">
-                <a16:creationId xmlns:a16="http://schemas.microsoft.com/office/drawing/2014/main" id="{CB3FD990-1303-4C4E-9A9B-4CD033EE5030}"/>
+                <a16:creationId xmlns:a16="http://schemas.microsoft.com/office/drawing/2014/main" id="{B32DB0A2-FFC2-4354-8C17-B7474202A89B}"/>
               </a:ext>
             </a:extLst>
           </p:cNvPr>
@@ -10753,7 +10753,7 @@
           <p:cNvPr id="16" name="TextBox 15">
             <a:extLst xmlns:a="http://schemas.openxmlformats.org/drawingml/2006/main">
               <a:ext uri="{FF2B5EF4-FFF2-40B4-BE49-F238E27FC236}">
-                <a16:creationId xmlns:a16="http://schemas.microsoft.com/office/drawing/2014/main" id="{FA72A65B-626E-43C9-B1CC-C79589CDFA6C}"/>
+                <a16:creationId xmlns:a16="http://schemas.microsoft.com/office/drawing/2014/main" id="{6522A2C1-A84F-41CB-9ED5-8CCE9CD0DD74}"/>
               </a:ext>
             </a:extLst>
           </p:cNvPr>
@@ -10800,7 +10800,7 @@
           <p:cNvPr id="17" name="TextBox 16">
             <a:extLst xmlns:a="http://schemas.openxmlformats.org/drawingml/2006/main">
               <a:ext uri="{FF2B5EF4-FFF2-40B4-BE49-F238E27FC236}">
-                <a16:creationId xmlns:a16="http://schemas.microsoft.com/office/drawing/2014/main" id="{3184535B-CB25-49F7-BA0A-5A104BDE5BC7}"/>
+                <a16:creationId xmlns:a16="http://schemas.microsoft.com/office/drawing/2014/main" id="{08B12A30-4ADC-4871-8CAC-CD6CD05EA517}"/>
               </a:ext>
             </a:extLst>
           </p:cNvPr>
@@ -10847,7 +10847,7 @@
           <p:cNvPr id="18" name="Rounded Rectangle 17">
             <a:extLst xmlns:a="http://schemas.openxmlformats.org/drawingml/2006/main">
               <a:ext uri="{FF2B5EF4-FFF2-40B4-BE49-F238E27FC236}">
-                <a16:creationId xmlns:a16="http://schemas.microsoft.com/office/drawing/2014/main" id="{3B3677E6-7D7E-4293-A40C-205D94005CA1}"/>
+                <a16:creationId xmlns:a16="http://schemas.microsoft.com/office/drawing/2014/main" id="{6FC55814-8DF0-419E-A0C2-BAE42BA684D9}"/>
               </a:ext>
             </a:extLst>
           </p:cNvPr>
@@ -10904,7 +10904,7 @@
           <p:cNvPr id="19" name="TextBox 18">
             <a:extLst xmlns:a="http://schemas.openxmlformats.org/drawingml/2006/main">
               <a:ext uri="{FF2B5EF4-FFF2-40B4-BE49-F238E27FC236}">
-                <a16:creationId xmlns:a16="http://schemas.microsoft.com/office/drawing/2014/main" id="{0EF10DF8-F91C-4CED-9C18-6193E54F907D}"/>
+                <a16:creationId xmlns:a16="http://schemas.microsoft.com/office/drawing/2014/main" id="{E8A2B5B3-B5B5-475E-8B4E-BD958AD60EEE}"/>
               </a:ext>
             </a:extLst>
           </p:cNvPr>
@@ -10951,7 +10951,7 @@
           <p:cNvPr id="20" name="TextBox 19">
             <a:extLst xmlns:a="http://schemas.openxmlformats.org/drawingml/2006/main">
               <a:ext uri="{FF2B5EF4-FFF2-40B4-BE49-F238E27FC236}">
-                <a16:creationId xmlns:a16="http://schemas.microsoft.com/office/drawing/2014/main" id="{1CAF6494-62CC-4671-A91B-E16AC3C7B373}"/>
+                <a16:creationId xmlns:a16="http://schemas.microsoft.com/office/drawing/2014/main" id="{FD3B1E4A-7503-4F93-848B-D9C954B1AB3C}"/>
               </a:ext>
             </a:extLst>
           </p:cNvPr>
@@ -10996,7 +10996,7 @@
     </p:spTree>
     <p:extLst>
       <p:ext uri="{BB962C8B-B14F-4D97-AF65-F5344CB8AC3E}">
-        <p14:creationId xmlns:p14="http://schemas.microsoft.com/office/powerpoint/2010/main" val="1983239040"/>
+        <p14:creationId xmlns:p14="http://schemas.microsoft.com/office/powerpoint/2010/main" val="1563846229"/>
       </p:ext>
     </p:extLst>
   </p:cSld>
@@ -11020,7 +11020,7 @@
           <p:cNvPr id="2" name="TextBox 1">
             <a:extLst xmlns:a="http://schemas.openxmlformats.org/drawingml/2006/main">
               <a:ext uri="{FF2B5EF4-FFF2-40B4-BE49-F238E27FC236}">
-                <a16:creationId xmlns:a16="http://schemas.microsoft.com/office/drawing/2014/main" id="{33C749A4-E1A4-4123-A4FF-6EC7C0509571}"/>
+                <a16:creationId xmlns:a16="http://schemas.microsoft.com/office/drawing/2014/main" id="{25ECA68D-04B6-4D01-B053-2FDFF2D4E65F}"/>
               </a:ext>
             </a:extLst>
           </p:cNvPr>
@@ -11067,7 +11067,7 @@
           <p:cNvPr id="3" name="TextBox 2">
             <a:extLst xmlns:a="http://schemas.openxmlformats.org/drawingml/2006/main">
               <a:ext uri="{FF2B5EF4-FFF2-40B4-BE49-F238E27FC236}">
-                <a16:creationId xmlns:a16="http://schemas.microsoft.com/office/drawing/2014/main" id="{85C9BEBB-7786-4FEE-8D98-059A3D5E1F47}"/>
+                <a16:creationId xmlns:a16="http://schemas.microsoft.com/office/drawing/2014/main" id="{262286AE-C1C3-4E05-94E7-5FE48364081C}"/>
               </a:ext>
             </a:extLst>
           </p:cNvPr>
@@ -11114,7 +11114,7 @@
           <p:cNvPr id="4" name="Rectangle 3">
             <a:extLst xmlns:a="http://schemas.openxmlformats.org/drawingml/2006/main">
               <a:ext uri="{FF2B5EF4-FFF2-40B4-BE49-F238E27FC236}">
-                <a16:creationId xmlns:a16="http://schemas.microsoft.com/office/drawing/2014/main" id="{361E1FF1-D90F-46BA-BD89-610AAF011B2B}"/>
+                <a16:creationId xmlns:a16="http://schemas.microsoft.com/office/drawing/2014/main" id="{BFD5CF69-7EE1-467D-B105-243CB36A4E7B}"/>
               </a:ext>
             </a:extLst>
           </p:cNvPr>
@@ -11169,7 +11169,7 @@
           <p:cNvPr id="5" name="Rectangle 4">
             <a:extLst xmlns:a="http://schemas.openxmlformats.org/drawingml/2006/main">
               <a:ext uri="{FF2B5EF4-FFF2-40B4-BE49-F238E27FC236}">
-                <a16:creationId xmlns:a16="http://schemas.microsoft.com/office/drawing/2014/main" id="{9AFD24CA-5AFB-46A0-A9F8-2FF13490391A}"/>
+                <a16:creationId xmlns:a16="http://schemas.microsoft.com/office/drawing/2014/main" id="{CCBCEA1D-9FB4-4E69-89CC-FA97F0EE62D7}"/>
               </a:ext>
             </a:extLst>
           </p:cNvPr>
@@ -11224,7 +11224,7 @@
           <p:cNvPr id="6" name="TextBox 5">
             <a:extLst xmlns:a="http://schemas.openxmlformats.org/drawingml/2006/main">
               <a:ext uri="{FF2B5EF4-FFF2-40B4-BE49-F238E27FC236}">
-                <a16:creationId xmlns:a16="http://schemas.microsoft.com/office/drawing/2014/main" id="{D7574163-0C7D-43E4-9569-74C34881B341}"/>
+                <a16:creationId xmlns:a16="http://schemas.microsoft.com/office/drawing/2014/main" id="{20A08FDD-FFCD-4340-84A7-A485FE5AFB45}"/>
               </a:ext>
             </a:extLst>
           </p:cNvPr>
@@ -11261,7 +11261,7 @@
                 <a:ea typeface="Aptos"/>
                 <a:cs typeface="Aptos"/>
               </a:rPr>
-              <a:t>Independent public evidence summary · 2026.07.23-10 · 2026-07-22 · Sources: Destatis</a:t>
+              <a:t>Independent public evidence summary · 2026.07.23-11 · 2026-07-22 · Sources: Destatis</a:t>
             </a:r>
           </a:p>
         </p:txBody>
@@ -11271,7 +11271,7 @@
           <p:cNvPr id="7" name="TextBox 6">
             <a:extLst xmlns:a="http://schemas.openxmlformats.org/drawingml/2006/main">
               <a:ext uri="{FF2B5EF4-FFF2-40B4-BE49-F238E27FC236}">
-                <a16:creationId xmlns:a16="http://schemas.microsoft.com/office/drawing/2014/main" id="{E58C4FE3-8895-414E-9036-0013E8E9DD8F}"/>
+                <a16:creationId xmlns:a16="http://schemas.microsoft.com/office/drawing/2014/main" id="{A1D6F7B9-57CA-4A7C-8C11-29A658A93186}"/>
               </a:ext>
             </a:extLst>
           </p:cNvPr>
@@ -11784,7 +11784,7 @@
           <p:cNvPr id="9" name="TextBox 8">
             <a:extLst xmlns:a="http://schemas.openxmlformats.org/drawingml/2006/main">
               <a:ext uri="{FF2B5EF4-FFF2-40B4-BE49-F238E27FC236}">
-                <a16:creationId xmlns:a16="http://schemas.microsoft.com/office/drawing/2014/main" id="{37036FF8-A56A-4B1D-AC26-3EFE6A224643}"/>
+                <a16:creationId xmlns:a16="http://schemas.microsoft.com/office/drawing/2014/main" id="{1FDC591A-3A4A-4590-83B7-A920ABFAABF1}"/>
               </a:ext>
             </a:extLst>
           </p:cNvPr>
@@ -11829,7 +11829,7 @@
     </p:spTree>
     <p:extLst>
       <p:ext uri="{BB962C8B-B14F-4D97-AF65-F5344CB8AC3E}">
-        <p14:creationId xmlns:p14="http://schemas.microsoft.com/office/powerpoint/2010/main" val="893745509"/>
+        <p14:creationId xmlns:p14="http://schemas.microsoft.com/office/powerpoint/2010/main" val="1924246346"/>
       </p:ext>
     </p:extLst>
   </p:cSld>
@@ -11853,7 +11853,7 @@
           <p:cNvPr id="2" name="TextBox 1">
             <a:extLst xmlns:a="http://schemas.openxmlformats.org/drawingml/2006/main">
               <a:ext uri="{FF2B5EF4-FFF2-40B4-BE49-F238E27FC236}">
-                <a16:creationId xmlns:a16="http://schemas.microsoft.com/office/drawing/2014/main" id="{B73D9614-05BB-4372-8F1E-13A649F4216A}"/>
+                <a16:creationId xmlns:a16="http://schemas.microsoft.com/office/drawing/2014/main" id="{0C4E630C-F660-4F1E-B66D-D496C2E42377}"/>
               </a:ext>
             </a:extLst>
           </p:cNvPr>
@@ -11900,7 +11900,7 @@
           <p:cNvPr id="3" name="TextBox 2">
             <a:extLst xmlns:a="http://schemas.openxmlformats.org/drawingml/2006/main">
               <a:ext uri="{FF2B5EF4-FFF2-40B4-BE49-F238E27FC236}">
-                <a16:creationId xmlns:a16="http://schemas.microsoft.com/office/drawing/2014/main" id="{EB3AF31A-1025-4FF8-B824-2B681D44D3EE}"/>
+                <a16:creationId xmlns:a16="http://schemas.microsoft.com/office/drawing/2014/main" id="{2D401984-36B9-4291-B6A9-39388383DEE2}"/>
               </a:ext>
             </a:extLst>
           </p:cNvPr>
@@ -11947,7 +11947,7 @@
           <p:cNvPr id="4" name="Rectangle 3">
             <a:extLst xmlns:a="http://schemas.openxmlformats.org/drawingml/2006/main">
               <a:ext uri="{FF2B5EF4-FFF2-40B4-BE49-F238E27FC236}">
-                <a16:creationId xmlns:a16="http://schemas.microsoft.com/office/drawing/2014/main" id="{E7DB1783-6A69-4409-B1BF-2ED104D20EC1}"/>
+                <a16:creationId xmlns:a16="http://schemas.microsoft.com/office/drawing/2014/main" id="{DFAB0CDB-2EA2-4846-BD38-C5FBDCE16BC9}"/>
               </a:ext>
             </a:extLst>
           </p:cNvPr>
@@ -12002,7 +12002,7 @@
           <p:cNvPr id="5" name="Rectangle 4">
             <a:extLst xmlns:a="http://schemas.openxmlformats.org/drawingml/2006/main">
               <a:ext uri="{FF2B5EF4-FFF2-40B4-BE49-F238E27FC236}">
-                <a16:creationId xmlns:a16="http://schemas.microsoft.com/office/drawing/2014/main" id="{7506F975-860D-40D2-B10C-6612F3AF9B06}"/>
+                <a16:creationId xmlns:a16="http://schemas.microsoft.com/office/drawing/2014/main" id="{3D768825-C38A-4A59-90F4-11152AE86358}"/>
               </a:ext>
             </a:extLst>
           </p:cNvPr>
@@ -12057,7 +12057,7 @@
           <p:cNvPr id="6" name="TextBox 5">
             <a:extLst xmlns:a="http://schemas.openxmlformats.org/drawingml/2006/main">
               <a:ext uri="{FF2B5EF4-FFF2-40B4-BE49-F238E27FC236}">
-                <a16:creationId xmlns:a16="http://schemas.microsoft.com/office/drawing/2014/main" id="{4A13526F-53DE-4F03-8114-A16A60266B60}"/>
+                <a16:creationId xmlns:a16="http://schemas.microsoft.com/office/drawing/2014/main" id="{97AC2108-A160-4922-9796-91F5153A4E0E}"/>
               </a:ext>
             </a:extLst>
           </p:cNvPr>
@@ -12094,7 +12094,7 @@
                 <a:ea typeface="Aptos"/>
                 <a:cs typeface="Aptos"/>
               </a:rPr>
-              <a:t>Independent public evidence summary · 2026.07.23-10 · 2026-07-22 · Sources: Destatis; inTaste.de</a:t>
+              <a:t>Independent public evidence summary · 2026.07.23-11 · 2026-07-22 · Sources: Destatis; inTaste.de</a:t>
             </a:r>
           </a:p>
         </p:txBody>
@@ -12104,7 +12104,7 @@
           <p:cNvPr id="7" name="TextBox 6">
             <a:extLst xmlns:a="http://schemas.openxmlformats.org/drawingml/2006/main">
               <a:ext uri="{FF2B5EF4-FFF2-40B4-BE49-F238E27FC236}">
-                <a16:creationId xmlns:a16="http://schemas.microsoft.com/office/drawing/2014/main" id="{694C6EA5-06DD-40EA-AA31-A397C912E94D}"/>
+                <a16:creationId xmlns:a16="http://schemas.microsoft.com/office/drawing/2014/main" id="{E6A69BAF-44CB-4DA8-B583-B4EE36F800EB}"/>
               </a:ext>
             </a:extLst>
           </p:cNvPr>
@@ -12151,7 +12151,7 @@
           <p:cNvPr id="8" name="Rounded Rectangle 7">
             <a:extLst xmlns:a="http://schemas.openxmlformats.org/drawingml/2006/main">
               <a:ext uri="{FF2B5EF4-FFF2-40B4-BE49-F238E27FC236}">
-                <a16:creationId xmlns:a16="http://schemas.microsoft.com/office/drawing/2014/main" id="{86679CB8-CFC3-4E87-A1A0-F0DB9F02326F}"/>
+                <a16:creationId xmlns:a16="http://schemas.microsoft.com/office/drawing/2014/main" id="{EFD2C8A6-596C-43E8-847C-50607E188F45}"/>
               </a:ext>
             </a:extLst>
           </p:cNvPr>
@@ -12208,7 +12208,7 @@
           <p:cNvPr id="9" name="TextBox 8">
             <a:extLst xmlns:a="http://schemas.openxmlformats.org/drawingml/2006/main">
               <a:ext uri="{FF2B5EF4-FFF2-40B4-BE49-F238E27FC236}">
-                <a16:creationId xmlns:a16="http://schemas.microsoft.com/office/drawing/2014/main" id="{12D0AB7B-CD18-482E-95B6-F686C21DE0E7}"/>
+                <a16:creationId xmlns:a16="http://schemas.microsoft.com/office/drawing/2014/main" id="{61BD2918-5D6F-42F7-91E5-653F4A4F14C9}"/>
               </a:ext>
             </a:extLst>
           </p:cNvPr>
@@ -12255,7 +12255,7 @@
           <p:cNvPr id="10" name="TextBox 9">
             <a:extLst xmlns:a="http://schemas.openxmlformats.org/drawingml/2006/main">
               <a:ext uri="{FF2B5EF4-FFF2-40B4-BE49-F238E27FC236}">
-                <a16:creationId xmlns:a16="http://schemas.microsoft.com/office/drawing/2014/main" id="{2FF12385-8CAC-4D79-A15F-9B4EBEAC02C6}"/>
+                <a16:creationId xmlns:a16="http://schemas.microsoft.com/office/drawing/2014/main" id="{18EC659F-6F22-445E-A4C1-0514F6E1D837}"/>
               </a:ext>
             </a:extLst>
           </p:cNvPr>
@@ -12302,7 +12302,7 @@
           <p:cNvPr id="11" name="Rounded Rectangle 10">
             <a:extLst xmlns:a="http://schemas.openxmlformats.org/drawingml/2006/main">
               <a:ext uri="{FF2B5EF4-FFF2-40B4-BE49-F238E27FC236}">
-                <a16:creationId xmlns:a16="http://schemas.microsoft.com/office/drawing/2014/main" id="{31A37C56-90D2-41DB-A216-3B81227058E6}"/>
+                <a16:creationId xmlns:a16="http://schemas.microsoft.com/office/drawing/2014/main" id="{DDEFDA4C-65D0-4A03-8C87-E607B84537D3}"/>
               </a:ext>
             </a:extLst>
           </p:cNvPr>
@@ -12359,7 +12359,7 @@
           <p:cNvPr id="12" name="TextBox 11">
             <a:extLst xmlns:a="http://schemas.openxmlformats.org/drawingml/2006/main">
               <a:ext uri="{FF2B5EF4-FFF2-40B4-BE49-F238E27FC236}">
-                <a16:creationId xmlns:a16="http://schemas.microsoft.com/office/drawing/2014/main" id="{2EBE9969-8D55-47CB-8635-E3AFA6C63DE9}"/>
+                <a16:creationId xmlns:a16="http://schemas.microsoft.com/office/drawing/2014/main" id="{E4B84C38-2B00-4890-8D8D-27AB957874F7}"/>
               </a:ext>
             </a:extLst>
           </p:cNvPr>
@@ -12406,7 +12406,7 @@
           <p:cNvPr id="13" name="TextBox 12">
             <a:extLst xmlns:a="http://schemas.openxmlformats.org/drawingml/2006/main">
               <a:ext uri="{FF2B5EF4-FFF2-40B4-BE49-F238E27FC236}">
-                <a16:creationId xmlns:a16="http://schemas.microsoft.com/office/drawing/2014/main" id="{397C6EFB-3222-4513-AD56-B834959D97ED}"/>
+                <a16:creationId xmlns:a16="http://schemas.microsoft.com/office/drawing/2014/main" id="{C268DD0F-4AE1-470C-9E6C-D5FBABED8942}"/>
               </a:ext>
             </a:extLst>
           </p:cNvPr>
@@ -12453,7 +12453,7 @@
           <p:cNvPr id="14" name="Rounded Rectangle 13">
             <a:extLst xmlns:a="http://schemas.openxmlformats.org/drawingml/2006/main">
               <a:ext uri="{FF2B5EF4-FFF2-40B4-BE49-F238E27FC236}">
-                <a16:creationId xmlns:a16="http://schemas.microsoft.com/office/drawing/2014/main" id="{D02D8AC3-878C-4BA6-AE96-794098F96A83}"/>
+                <a16:creationId xmlns:a16="http://schemas.microsoft.com/office/drawing/2014/main" id="{BE6DA2FB-70B2-4D59-908A-A0B11455EFD3}"/>
               </a:ext>
             </a:extLst>
           </p:cNvPr>
@@ -12510,7 +12510,7 @@
           <p:cNvPr id="15" name="TextBox 14">
             <a:extLst xmlns:a="http://schemas.openxmlformats.org/drawingml/2006/main">
               <a:ext uri="{FF2B5EF4-FFF2-40B4-BE49-F238E27FC236}">
-                <a16:creationId xmlns:a16="http://schemas.microsoft.com/office/drawing/2014/main" id="{40BA0B04-93C7-4E78-BAD3-098920B7F8D4}"/>
+                <a16:creationId xmlns:a16="http://schemas.microsoft.com/office/drawing/2014/main" id="{1C6C824D-CA56-41F1-BFBB-CE7C790FA608}"/>
               </a:ext>
             </a:extLst>
           </p:cNvPr>
@@ -12557,7 +12557,7 @@
           <p:cNvPr id="16" name="TextBox 15">
             <a:extLst xmlns:a="http://schemas.openxmlformats.org/drawingml/2006/main">
               <a:ext uri="{FF2B5EF4-FFF2-40B4-BE49-F238E27FC236}">
-                <a16:creationId xmlns:a16="http://schemas.microsoft.com/office/drawing/2014/main" id="{32F2D01B-62D5-4E0F-918C-D6EC1EE9F58F}"/>
+                <a16:creationId xmlns:a16="http://schemas.microsoft.com/office/drawing/2014/main" id="{F752A6BA-A10E-4916-8124-9AB0E99306F7}"/>
               </a:ext>
             </a:extLst>
           </p:cNvPr>
@@ -12604,7 +12604,7 @@
           <p:cNvPr id="17" name="TextBox 16">
             <a:extLst xmlns:a="http://schemas.openxmlformats.org/drawingml/2006/main">
               <a:ext uri="{FF2B5EF4-FFF2-40B4-BE49-F238E27FC236}">
-                <a16:creationId xmlns:a16="http://schemas.microsoft.com/office/drawing/2014/main" id="{3B401416-7017-4B48-9D97-127BF86D87C1}"/>
+                <a16:creationId xmlns:a16="http://schemas.microsoft.com/office/drawing/2014/main" id="{FF22F3EA-88A7-4853-8AEB-AA224ACB921E}"/>
               </a:ext>
             </a:extLst>
           </p:cNvPr>
@@ -12651,7 +12651,7 @@
           <p:cNvPr id="18" name="Rounded Rectangle 17">
             <a:extLst xmlns:a="http://schemas.openxmlformats.org/drawingml/2006/main">
               <a:ext uri="{FF2B5EF4-FFF2-40B4-BE49-F238E27FC236}">
-                <a16:creationId xmlns:a16="http://schemas.microsoft.com/office/drawing/2014/main" id="{96AA97BB-C316-49B9-9D3E-4D3BE0F37440}"/>
+                <a16:creationId xmlns:a16="http://schemas.microsoft.com/office/drawing/2014/main" id="{A89146B7-9B41-45FF-933F-DE66381204D1}"/>
               </a:ext>
             </a:extLst>
           </p:cNvPr>
@@ -12708,7 +12708,7 @@
           <p:cNvPr id="19" name="TextBox 18">
             <a:extLst xmlns:a="http://schemas.openxmlformats.org/drawingml/2006/main">
               <a:ext uri="{FF2B5EF4-FFF2-40B4-BE49-F238E27FC236}">
-                <a16:creationId xmlns:a16="http://schemas.microsoft.com/office/drawing/2014/main" id="{C827DCE2-8D3A-4399-B793-10CC928074FA}"/>
+                <a16:creationId xmlns:a16="http://schemas.microsoft.com/office/drawing/2014/main" id="{3E3723D6-25F3-426B-A522-31C3375A654C}"/>
               </a:ext>
             </a:extLst>
           </p:cNvPr>
@@ -12755,7 +12755,7 @@
           <p:cNvPr id="20" name="TextBox 19">
             <a:extLst xmlns:a="http://schemas.openxmlformats.org/drawingml/2006/main">
               <a:ext uri="{FF2B5EF4-FFF2-40B4-BE49-F238E27FC236}">
-                <a16:creationId xmlns:a16="http://schemas.microsoft.com/office/drawing/2014/main" id="{910C61FB-76AC-422C-961F-1D6D000EB342}"/>
+                <a16:creationId xmlns:a16="http://schemas.microsoft.com/office/drawing/2014/main" id="{D0C1B830-4F86-42AF-AC98-C14C3FF70D35}"/>
               </a:ext>
             </a:extLst>
           </p:cNvPr>
@@ -12800,7 +12800,7 @@
     </p:spTree>
     <p:extLst>
       <p:ext uri="{BB962C8B-B14F-4D97-AF65-F5344CB8AC3E}">
-        <p14:creationId xmlns:p14="http://schemas.microsoft.com/office/powerpoint/2010/main" val="1430062123"/>
+        <p14:creationId xmlns:p14="http://schemas.microsoft.com/office/powerpoint/2010/main" val="1549987047"/>
       </p:ext>
     </p:extLst>
   </p:cSld>
@@ -12824,7 +12824,7 @@
           <p:cNvPr id="2" name="TextBox 1">
             <a:extLst xmlns:a="http://schemas.openxmlformats.org/drawingml/2006/main">
               <a:ext uri="{FF2B5EF4-FFF2-40B4-BE49-F238E27FC236}">
-                <a16:creationId xmlns:a16="http://schemas.microsoft.com/office/drawing/2014/main" id="{FD217578-01DA-4DE8-8C33-2D283584B851}"/>
+                <a16:creationId xmlns:a16="http://schemas.microsoft.com/office/drawing/2014/main" id="{27F7FEDC-DD36-4AD7-A2AD-3B381B25E9AC}"/>
               </a:ext>
             </a:extLst>
           </p:cNvPr>
@@ -12871,7 +12871,7 @@
           <p:cNvPr id="3" name="TextBox 2">
             <a:extLst xmlns:a="http://schemas.openxmlformats.org/drawingml/2006/main">
               <a:ext uri="{FF2B5EF4-FFF2-40B4-BE49-F238E27FC236}">
-                <a16:creationId xmlns:a16="http://schemas.microsoft.com/office/drawing/2014/main" id="{50ABDEF3-4CD1-4C6D-B5C9-041006B43356}"/>
+                <a16:creationId xmlns:a16="http://schemas.microsoft.com/office/drawing/2014/main" id="{057CECD0-3C42-43A1-AC67-B1ECD7CCD196}"/>
               </a:ext>
             </a:extLst>
           </p:cNvPr>
@@ -12918,7 +12918,7 @@
           <p:cNvPr id="4" name="Rectangle 3">
             <a:extLst xmlns:a="http://schemas.openxmlformats.org/drawingml/2006/main">
               <a:ext uri="{FF2B5EF4-FFF2-40B4-BE49-F238E27FC236}">
-                <a16:creationId xmlns:a16="http://schemas.microsoft.com/office/drawing/2014/main" id="{794D1202-4482-4E7A-BCDF-AB1FFE49BFF8}"/>
+                <a16:creationId xmlns:a16="http://schemas.microsoft.com/office/drawing/2014/main" id="{F545DE4D-D1B6-424E-869C-ADDDFDC6A540}"/>
               </a:ext>
             </a:extLst>
           </p:cNvPr>
@@ -12973,7 +12973,7 @@
           <p:cNvPr id="5" name="Rectangle 4">
             <a:extLst xmlns:a="http://schemas.openxmlformats.org/drawingml/2006/main">
               <a:ext uri="{FF2B5EF4-FFF2-40B4-BE49-F238E27FC236}">
-                <a16:creationId xmlns:a16="http://schemas.microsoft.com/office/drawing/2014/main" id="{44CD4CC4-424E-4495-B4AA-44F2CC52A199}"/>
+                <a16:creationId xmlns:a16="http://schemas.microsoft.com/office/drawing/2014/main" id="{010DD346-14B3-495E-9929-0672536DB067}"/>
               </a:ext>
             </a:extLst>
           </p:cNvPr>
@@ -13028,7 +13028,7 @@
           <p:cNvPr id="6" name="TextBox 5">
             <a:extLst xmlns:a="http://schemas.openxmlformats.org/drawingml/2006/main">
               <a:ext uri="{FF2B5EF4-FFF2-40B4-BE49-F238E27FC236}">
-                <a16:creationId xmlns:a16="http://schemas.microsoft.com/office/drawing/2014/main" id="{F1C91BB2-610C-4C21-A498-3AE2F4C26B88}"/>
+                <a16:creationId xmlns:a16="http://schemas.microsoft.com/office/drawing/2014/main" id="{155EEA72-AAEF-4DFF-A6D3-E2268632A9A6}"/>
               </a:ext>
             </a:extLst>
           </p:cNvPr>
@@ -13065,7 +13065,7 @@
                 <a:ea typeface="Aptos"/>
                 <a:cs typeface="Aptos"/>
               </a:rPr>
-              <a:t>Independent public evidence summary · 2026.07.23-10 · 2026-07-22 · Sources: IMARC; GVR; Fortune</a:t>
+              <a:t>Independent public evidence summary · 2026.07.23-11 · 2026-07-22 · Sources: IMARC; GVR; Fortune</a:t>
             </a:r>
           </a:p>
         </p:txBody>
@@ -13075,7 +13075,7 @@
           <p:cNvPr id="7" name="TextBox 6">
             <a:extLst xmlns:a="http://schemas.openxmlformats.org/drawingml/2006/main">
               <a:ext uri="{FF2B5EF4-FFF2-40B4-BE49-F238E27FC236}">
-                <a16:creationId xmlns:a16="http://schemas.microsoft.com/office/drawing/2014/main" id="{739C2251-77E1-41F1-96D5-E647CAF920BC}"/>
+                <a16:creationId xmlns:a16="http://schemas.microsoft.com/office/drawing/2014/main" id="{4502D44C-2B47-4E02-8A40-44806A6FFE9E}"/>
               </a:ext>
             </a:extLst>
           </p:cNvPr>
@@ -13122,7 +13122,7 @@
           <p:cNvPr id="8" name="Rounded Rectangle 7">
             <a:extLst xmlns:a="http://schemas.openxmlformats.org/drawingml/2006/main">
               <a:ext uri="{FF2B5EF4-FFF2-40B4-BE49-F238E27FC236}">
-                <a16:creationId xmlns:a16="http://schemas.microsoft.com/office/drawing/2014/main" id="{470B9D91-512A-40A7-9D2D-940FFB61BDF8}"/>
+                <a16:creationId xmlns:a16="http://schemas.microsoft.com/office/drawing/2014/main" id="{A803FC8D-3338-42E3-8A25-A5BDD754B173}"/>
               </a:ext>
             </a:extLst>
           </p:cNvPr>
@@ -13179,7 +13179,7 @@
           <p:cNvPr id="9" name="TextBox 8">
             <a:extLst xmlns:a="http://schemas.openxmlformats.org/drawingml/2006/main">
               <a:ext uri="{FF2B5EF4-FFF2-40B4-BE49-F238E27FC236}">
-                <a16:creationId xmlns:a16="http://schemas.microsoft.com/office/drawing/2014/main" id="{E473EE61-65BA-4D6F-9CCC-4063E5E63963}"/>
+                <a16:creationId xmlns:a16="http://schemas.microsoft.com/office/drawing/2014/main" id="{33C8670E-49FF-4EDF-A6D5-40967AD15C88}"/>
               </a:ext>
             </a:extLst>
           </p:cNvPr>
@@ -13226,7 +13226,7 @@
           <p:cNvPr id="10" name="TextBox 9">
             <a:extLst xmlns:a="http://schemas.openxmlformats.org/drawingml/2006/main">
               <a:ext uri="{FF2B5EF4-FFF2-40B4-BE49-F238E27FC236}">
-                <a16:creationId xmlns:a16="http://schemas.microsoft.com/office/drawing/2014/main" id="{D93C8705-2BE4-4B41-8D2D-6C445BBF6C0E}"/>
+                <a16:creationId xmlns:a16="http://schemas.microsoft.com/office/drawing/2014/main" id="{8F3D367C-C735-4F75-9D06-776B3B6CC517}"/>
               </a:ext>
             </a:extLst>
           </p:cNvPr>
@@ -13273,7 +13273,7 @@
           <p:cNvPr id="11" name="Rounded Rectangle 10">
             <a:extLst xmlns:a="http://schemas.openxmlformats.org/drawingml/2006/main">
               <a:ext uri="{FF2B5EF4-FFF2-40B4-BE49-F238E27FC236}">
-                <a16:creationId xmlns:a16="http://schemas.microsoft.com/office/drawing/2014/main" id="{F131B95F-772B-49F8-90F4-CBA5F011397C}"/>
+                <a16:creationId xmlns:a16="http://schemas.microsoft.com/office/drawing/2014/main" id="{054D9A5F-3714-468D-9C1F-6BE2D61CA2FB}"/>
               </a:ext>
             </a:extLst>
           </p:cNvPr>
@@ -13330,7 +13330,7 @@
           <p:cNvPr id="12" name="TextBox 11">
             <a:extLst xmlns:a="http://schemas.openxmlformats.org/drawingml/2006/main">
               <a:ext uri="{FF2B5EF4-FFF2-40B4-BE49-F238E27FC236}">
-                <a16:creationId xmlns:a16="http://schemas.microsoft.com/office/drawing/2014/main" id="{1FFB7506-7E83-4184-8DC0-E3219C8D1F15}"/>
+                <a16:creationId xmlns:a16="http://schemas.microsoft.com/office/drawing/2014/main" id="{76A0138D-A719-4F2A-A82D-F147C53D2ACD}"/>
               </a:ext>
             </a:extLst>
           </p:cNvPr>
@@ -13377,7 +13377,7 @@
           <p:cNvPr id="13" name="TextBox 12">
             <a:extLst xmlns:a="http://schemas.openxmlformats.org/drawingml/2006/main">
               <a:ext uri="{FF2B5EF4-FFF2-40B4-BE49-F238E27FC236}">
-                <a16:creationId xmlns:a16="http://schemas.microsoft.com/office/drawing/2014/main" id="{52A8C069-8589-4907-B994-F8C7FD23B959}"/>
+                <a16:creationId xmlns:a16="http://schemas.microsoft.com/office/drawing/2014/main" id="{B3B61DB6-8422-4E16-87F1-7A4E6F6C70B6}"/>
               </a:ext>
             </a:extLst>
           </p:cNvPr>
@@ -13424,7 +13424,7 @@
           <p:cNvPr id="14" name="Rounded Rectangle 13">
             <a:extLst xmlns:a="http://schemas.openxmlformats.org/drawingml/2006/main">
               <a:ext uri="{FF2B5EF4-FFF2-40B4-BE49-F238E27FC236}">
-                <a16:creationId xmlns:a16="http://schemas.microsoft.com/office/drawing/2014/main" id="{A76AFE75-A97A-46DC-B124-07395D3F678B}"/>
+                <a16:creationId xmlns:a16="http://schemas.microsoft.com/office/drawing/2014/main" id="{78A2B091-B1E9-42DF-9F75-69EE9FD2267B}"/>
               </a:ext>
             </a:extLst>
           </p:cNvPr>
@@ -13481,7 +13481,7 @@
           <p:cNvPr id="15" name="TextBox 14">
             <a:extLst xmlns:a="http://schemas.openxmlformats.org/drawingml/2006/main">
               <a:ext uri="{FF2B5EF4-FFF2-40B4-BE49-F238E27FC236}">
-                <a16:creationId xmlns:a16="http://schemas.microsoft.com/office/drawing/2014/main" id="{96767EF8-6653-4628-B8C3-6829045EDAEF}"/>
+                <a16:creationId xmlns:a16="http://schemas.microsoft.com/office/drawing/2014/main" id="{7E1B754F-03A2-42A6-A94C-5BFC24B75E6F}"/>
               </a:ext>
             </a:extLst>
           </p:cNvPr>
@@ -13528,7 +13528,7 @@
           <p:cNvPr id="16" name="TextBox 15">
             <a:extLst xmlns:a="http://schemas.openxmlformats.org/drawingml/2006/main">
               <a:ext uri="{FF2B5EF4-FFF2-40B4-BE49-F238E27FC236}">
-                <a16:creationId xmlns:a16="http://schemas.microsoft.com/office/drawing/2014/main" id="{C8E0F251-10E6-4041-B9D2-C18D3E4BEED6}"/>
+                <a16:creationId xmlns:a16="http://schemas.microsoft.com/office/drawing/2014/main" id="{DAF39E0E-8325-4E45-937C-B09F3E149E8F}"/>
               </a:ext>
             </a:extLst>
           </p:cNvPr>
@@ -13575,7 +13575,7 @@
           <p:cNvPr id="17" name="TextBox 16">
             <a:extLst xmlns:a="http://schemas.openxmlformats.org/drawingml/2006/main">
               <a:ext uri="{FF2B5EF4-FFF2-40B4-BE49-F238E27FC236}">
-                <a16:creationId xmlns:a16="http://schemas.microsoft.com/office/drawing/2014/main" id="{F5F1C193-8FEB-4CB0-A30C-9B6DE69AAB3A}"/>
+                <a16:creationId xmlns:a16="http://schemas.microsoft.com/office/drawing/2014/main" id="{09D770B4-D99D-48D5-8EDD-B8E62923B0F3}"/>
               </a:ext>
             </a:extLst>
           </p:cNvPr>
@@ -13622,7 +13622,7 @@
           <p:cNvPr id="18" name="Rounded Rectangle 17">
             <a:extLst xmlns:a="http://schemas.openxmlformats.org/drawingml/2006/main">
               <a:ext uri="{FF2B5EF4-FFF2-40B4-BE49-F238E27FC236}">
-                <a16:creationId xmlns:a16="http://schemas.microsoft.com/office/drawing/2014/main" id="{08527326-9664-44DF-8B2F-ED17B458533E}"/>
+                <a16:creationId xmlns:a16="http://schemas.microsoft.com/office/drawing/2014/main" id="{C0662C28-6162-40B1-9899-6BCBB5FFE927}"/>
               </a:ext>
             </a:extLst>
           </p:cNvPr>
@@ -13679,7 +13679,7 @@
           <p:cNvPr id="19" name="TextBox 18">
             <a:extLst xmlns:a="http://schemas.openxmlformats.org/drawingml/2006/main">
               <a:ext uri="{FF2B5EF4-FFF2-40B4-BE49-F238E27FC236}">
-                <a16:creationId xmlns:a16="http://schemas.microsoft.com/office/drawing/2014/main" id="{88A574FC-A8D5-43DA-ADDB-4C6F9C92967F}"/>
+                <a16:creationId xmlns:a16="http://schemas.microsoft.com/office/drawing/2014/main" id="{175BD6A9-22EC-4674-A9DC-403CF40EDE8E}"/>
               </a:ext>
             </a:extLst>
           </p:cNvPr>
@@ -13726,7 +13726,7 @@
           <p:cNvPr id="20" name="TextBox 19">
             <a:extLst xmlns:a="http://schemas.openxmlformats.org/drawingml/2006/main">
               <a:ext uri="{FF2B5EF4-FFF2-40B4-BE49-F238E27FC236}">
-                <a16:creationId xmlns:a16="http://schemas.microsoft.com/office/drawing/2014/main" id="{BA18639B-EE8B-497E-A0D5-ACBA4173CD7C}"/>
+                <a16:creationId xmlns:a16="http://schemas.microsoft.com/office/drawing/2014/main" id="{03C49839-B7A1-4C82-8E30-A13B3BB0ACC4}"/>
               </a:ext>
             </a:extLst>
           </p:cNvPr>
@@ -13771,7 +13771,7 @@
     </p:spTree>
     <p:extLst>
       <p:ext uri="{BB962C8B-B14F-4D97-AF65-F5344CB8AC3E}">
-        <p14:creationId xmlns:p14="http://schemas.microsoft.com/office/powerpoint/2010/main" val="1433827433"/>
+        <p14:creationId xmlns:p14="http://schemas.microsoft.com/office/powerpoint/2010/main" val="1532923370"/>
       </p:ext>
     </p:extLst>
   </p:cSld>
@@ -13795,7 +13795,7 @@
           <p:cNvPr id="2" name="TextBox 1">
             <a:extLst xmlns:a="http://schemas.openxmlformats.org/drawingml/2006/main">
               <a:ext uri="{FF2B5EF4-FFF2-40B4-BE49-F238E27FC236}">
-                <a16:creationId xmlns:a16="http://schemas.microsoft.com/office/drawing/2014/main" id="{6C4BA9EF-103C-4E31-991C-1E52B5DF366B}"/>
+                <a16:creationId xmlns:a16="http://schemas.microsoft.com/office/drawing/2014/main" id="{36010E97-ABBF-430C-9180-4416570D8479}"/>
               </a:ext>
             </a:extLst>
           </p:cNvPr>
@@ -13842,7 +13842,7 @@
           <p:cNvPr id="3" name="TextBox 2">
             <a:extLst xmlns:a="http://schemas.openxmlformats.org/drawingml/2006/main">
               <a:ext uri="{FF2B5EF4-FFF2-40B4-BE49-F238E27FC236}">
-                <a16:creationId xmlns:a16="http://schemas.microsoft.com/office/drawing/2014/main" id="{EB0F104D-F8B5-49E1-9957-CC27123FCBAD}"/>
+                <a16:creationId xmlns:a16="http://schemas.microsoft.com/office/drawing/2014/main" id="{870D72F7-E9E4-4EEF-9FEA-A3885976F991}"/>
               </a:ext>
             </a:extLst>
           </p:cNvPr>
@@ -13889,7 +13889,7 @@
           <p:cNvPr id="4" name="Rectangle 3">
             <a:extLst xmlns:a="http://schemas.openxmlformats.org/drawingml/2006/main">
               <a:ext uri="{FF2B5EF4-FFF2-40B4-BE49-F238E27FC236}">
-                <a16:creationId xmlns:a16="http://schemas.microsoft.com/office/drawing/2014/main" id="{946DCCDC-CBA5-416E-8DDC-CC87CE9B1EA9}"/>
+                <a16:creationId xmlns:a16="http://schemas.microsoft.com/office/drawing/2014/main" id="{CEC935F2-0AFF-40A2-9D58-EE260B13D01F}"/>
               </a:ext>
             </a:extLst>
           </p:cNvPr>
@@ -13944,7 +13944,7 @@
           <p:cNvPr id="5" name="Rectangle 4">
             <a:extLst xmlns:a="http://schemas.openxmlformats.org/drawingml/2006/main">
               <a:ext uri="{FF2B5EF4-FFF2-40B4-BE49-F238E27FC236}">
-                <a16:creationId xmlns:a16="http://schemas.microsoft.com/office/drawing/2014/main" id="{B714FBA5-B69A-45B9-8410-070166C55A94}"/>
+                <a16:creationId xmlns:a16="http://schemas.microsoft.com/office/drawing/2014/main" id="{491F5A3F-6C8F-4CF3-A2C0-76B736736E05}"/>
               </a:ext>
             </a:extLst>
           </p:cNvPr>
@@ -13999,7 +13999,7 @@
           <p:cNvPr id="6" name="TextBox 5">
             <a:extLst xmlns:a="http://schemas.openxmlformats.org/drawingml/2006/main">
               <a:ext uri="{FF2B5EF4-FFF2-40B4-BE49-F238E27FC236}">
-                <a16:creationId xmlns:a16="http://schemas.microsoft.com/office/drawing/2014/main" id="{140472B7-7607-48AE-8B31-D16481EFADC9}"/>
+                <a16:creationId xmlns:a16="http://schemas.microsoft.com/office/drawing/2014/main" id="{06E670F8-0013-4829-82EB-59DB86921EAA}"/>
               </a:ext>
             </a:extLst>
           </p:cNvPr>
@@ -14036,7 +14036,7 @@
                 <a:ea typeface="Aptos"/>
                 <a:cs typeface="Aptos"/>
               </a:rPr>
-              <a:t>Independent public evidence summary · 2026.07.23-10 · 2026-07-22 · Sources: Market-values model; Readiness</a:t>
+              <a:t>Independent public evidence summary · 2026.07.23-11 · 2026-07-22 · Sources: Market-values model; Readiness</a:t>
             </a:r>
           </a:p>
         </p:txBody>
@@ -14046,7 +14046,7 @@
           <p:cNvPr id="7" name="TextBox 6">
             <a:extLst xmlns:a="http://schemas.openxmlformats.org/drawingml/2006/main">
               <a:ext uri="{FF2B5EF4-FFF2-40B4-BE49-F238E27FC236}">
-                <a16:creationId xmlns:a16="http://schemas.microsoft.com/office/drawing/2014/main" id="{30D373F4-E33C-4B49-9730-B559981EB31B}"/>
+                <a16:creationId xmlns:a16="http://schemas.microsoft.com/office/drawing/2014/main" id="{C1DB0E8E-C4B7-4DC1-A246-696D64D5209B}"/>
               </a:ext>
             </a:extLst>
           </p:cNvPr>
@@ -14093,7 +14093,7 @@
           <p:cNvPr id="8" name="TextBox 7">
             <a:extLst xmlns:a="http://schemas.openxmlformats.org/drawingml/2006/main">
               <a:ext uri="{FF2B5EF4-FFF2-40B4-BE49-F238E27FC236}">
-                <a16:creationId xmlns:a16="http://schemas.microsoft.com/office/drawing/2014/main" id="{82EA0CF3-19D1-43EE-9A4E-DF5764CDF7B5}"/>
+                <a16:creationId xmlns:a16="http://schemas.microsoft.com/office/drawing/2014/main" id="{532718D8-AA73-4071-AC5A-69B82EAF490B}"/>
               </a:ext>
             </a:extLst>
           </p:cNvPr>
@@ -14140,7 +14140,7 @@
           <p:cNvPr id="9" name="TextBox 8">
             <a:extLst xmlns:a="http://schemas.openxmlformats.org/drawingml/2006/main">
               <a:ext uri="{FF2B5EF4-FFF2-40B4-BE49-F238E27FC236}">
-                <a16:creationId xmlns:a16="http://schemas.microsoft.com/office/drawing/2014/main" id="{5BC97264-EE73-4ED2-9C7E-DFD89D021994}"/>
+                <a16:creationId xmlns:a16="http://schemas.microsoft.com/office/drawing/2014/main" id="{0A0EE805-D619-4BC0-8484-07497B162478}"/>
               </a:ext>
             </a:extLst>
           </p:cNvPr>
@@ -14237,7 +14237,7 @@
           <p:cNvPr id="10" name="Rounded Rectangle 9">
             <a:extLst xmlns:a="http://schemas.openxmlformats.org/drawingml/2006/main">
               <a:ext uri="{FF2B5EF4-FFF2-40B4-BE49-F238E27FC236}">
-                <a16:creationId xmlns:a16="http://schemas.microsoft.com/office/drawing/2014/main" id="{885825C2-4F03-4E84-ABAE-13959A01456E}"/>
+                <a16:creationId xmlns:a16="http://schemas.microsoft.com/office/drawing/2014/main" id="{514AD6D3-2D9D-4187-A60B-2DAB6E43EE90}"/>
               </a:ext>
             </a:extLst>
           </p:cNvPr>
@@ -14294,7 +14294,7 @@
           <p:cNvPr id="11" name="TextBox 10">
             <a:extLst xmlns:a="http://schemas.openxmlformats.org/drawingml/2006/main">
               <a:ext uri="{FF2B5EF4-FFF2-40B4-BE49-F238E27FC236}">
-                <a16:creationId xmlns:a16="http://schemas.microsoft.com/office/drawing/2014/main" id="{6EF8DCBA-1F4A-4C84-B805-49B12D3DEF60}"/>
+                <a16:creationId xmlns:a16="http://schemas.microsoft.com/office/drawing/2014/main" id="{ECA94DD5-6B56-4063-AC6C-DAE294C7A610}"/>
               </a:ext>
             </a:extLst>
           </p:cNvPr>
@@ -14341,7 +14341,7 @@
           <p:cNvPr id="12" name="TextBox 11">
             <a:extLst xmlns:a="http://schemas.openxmlformats.org/drawingml/2006/main">
               <a:ext uri="{FF2B5EF4-FFF2-40B4-BE49-F238E27FC236}">
-                <a16:creationId xmlns:a16="http://schemas.microsoft.com/office/drawing/2014/main" id="{6F182AFF-4BD3-4CF7-A62A-2DF26FB55273}"/>
+                <a16:creationId xmlns:a16="http://schemas.microsoft.com/office/drawing/2014/main" id="{1F28535E-B8F1-4A47-BD9E-1C7622A80A4A}"/>
               </a:ext>
             </a:extLst>
           </p:cNvPr>
@@ -14386,7 +14386,7 @@
     </p:spTree>
     <p:extLst>
       <p:ext uri="{BB962C8B-B14F-4D97-AF65-F5344CB8AC3E}">
-        <p14:creationId xmlns:p14="http://schemas.microsoft.com/office/powerpoint/2010/main" val="1242436755"/>
+        <p14:creationId xmlns:p14="http://schemas.microsoft.com/office/powerpoint/2010/main" val="324458792"/>
       </p:ext>
     </p:extLst>
   </p:cSld>
@@ -14410,7 +14410,7 @@
           <p:cNvPr id="2" name="TextBox 1">
             <a:extLst xmlns:a="http://schemas.openxmlformats.org/drawingml/2006/main">
               <a:ext uri="{FF2B5EF4-FFF2-40B4-BE49-F238E27FC236}">
-                <a16:creationId xmlns:a16="http://schemas.microsoft.com/office/drawing/2014/main" id="{8F4EBEC0-55CC-4675-B63B-34BAAF0D0EFD}"/>
+                <a16:creationId xmlns:a16="http://schemas.microsoft.com/office/drawing/2014/main" id="{4CCEFDCE-45FC-40B8-9276-B323D5073167}"/>
               </a:ext>
             </a:extLst>
           </p:cNvPr>
@@ -14457,7 +14457,7 @@
           <p:cNvPr id="3" name="TextBox 2">
             <a:extLst xmlns:a="http://schemas.openxmlformats.org/drawingml/2006/main">
               <a:ext uri="{FF2B5EF4-FFF2-40B4-BE49-F238E27FC236}">
-                <a16:creationId xmlns:a16="http://schemas.microsoft.com/office/drawing/2014/main" id="{F18EEF3B-CF7D-4FBD-870F-013E0F6D9489}"/>
+                <a16:creationId xmlns:a16="http://schemas.microsoft.com/office/drawing/2014/main" id="{804AD0D3-7066-445C-9DA8-6EE34B11852E}"/>
               </a:ext>
             </a:extLst>
           </p:cNvPr>
@@ -14504,7 +14504,7 @@
           <p:cNvPr id="4" name="Rectangle 3">
             <a:extLst xmlns:a="http://schemas.openxmlformats.org/drawingml/2006/main">
               <a:ext uri="{FF2B5EF4-FFF2-40B4-BE49-F238E27FC236}">
-                <a16:creationId xmlns:a16="http://schemas.microsoft.com/office/drawing/2014/main" id="{08995396-9A8D-4922-8283-6C7482765D6F}"/>
+                <a16:creationId xmlns:a16="http://schemas.microsoft.com/office/drawing/2014/main" id="{2657DD97-69CC-46FD-AAF3-EFECA78B50B0}"/>
               </a:ext>
             </a:extLst>
           </p:cNvPr>
@@ -14559,7 +14559,7 @@
           <p:cNvPr id="5" name="Rectangle 4">
             <a:extLst xmlns:a="http://schemas.openxmlformats.org/drawingml/2006/main">
               <a:ext uri="{FF2B5EF4-FFF2-40B4-BE49-F238E27FC236}">
-                <a16:creationId xmlns:a16="http://schemas.microsoft.com/office/drawing/2014/main" id="{0756A4A4-F326-4BFD-9C14-6CF1B2330F29}"/>
+                <a16:creationId xmlns:a16="http://schemas.microsoft.com/office/drawing/2014/main" id="{55FA8E63-871E-481B-ADA5-320E5F6E165F}"/>
               </a:ext>
             </a:extLst>
           </p:cNvPr>
@@ -14614,7 +14614,7 @@
           <p:cNvPr id="6" name="TextBox 5">
             <a:extLst xmlns:a="http://schemas.openxmlformats.org/drawingml/2006/main">
               <a:ext uri="{FF2B5EF4-FFF2-40B4-BE49-F238E27FC236}">
-                <a16:creationId xmlns:a16="http://schemas.microsoft.com/office/drawing/2014/main" id="{2767A7B3-C055-4F10-BEB6-A6EA6E25C310}"/>
+                <a16:creationId xmlns:a16="http://schemas.microsoft.com/office/drawing/2014/main" id="{FCC375F0-0ADC-4846-B6E2-E19DF259EAB1}"/>
               </a:ext>
             </a:extLst>
           </p:cNvPr>
@@ -14651,7 +14651,7 @@
                 <a:ea typeface="Aptos"/>
                 <a:cs typeface="Aptos"/>
               </a:rPr>
-              <a:t>Independent public evidence summary · 2026.07.23-10 · 2026-07-22 · Sources: WIPO valuation; Evidence Register</a:t>
+              <a:t>Independent public evidence summary · 2026.07.23-11 · 2026-07-22 · Sources: WIPO valuation; Evidence Register</a:t>
             </a:r>
           </a:p>
         </p:txBody>
@@ -14661,7 +14661,7 @@
           <p:cNvPr id="7" name="TextBox 6">
             <a:extLst xmlns:a="http://schemas.openxmlformats.org/drawingml/2006/main">
               <a:ext uri="{FF2B5EF4-FFF2-40B4-BE49-F238E27FC236}">
-                <a16:creationId xmlns:a16="http://schemas.microsoft.com/office/drawing/2014/main" id="{1EB2D229-CC61-436F-9CBD-168C2AEB57F5}"/>
+                <a16:creationId xmlns:a16="http://schemas.microsoft.com/office/drawing/2014/main" id="{50580B3B-DECA-438E-9576-24170EA3BBFF}"/>
               </a:ext>
             </a:extLst>
           </p:cNvPr>
@@ -15231,7 +15231,7 @@
           <p:cNvPr id="9" name="TextBox 8">
             <a:extLst xmlns:a="http://schemas.openxmlformats.org/drawingml/2006/main">
               <a:ext uri="{FF2B5EF4-FFF2-40B4-BE49-F238E27FC236}">
-                <a16:creationId xmlns:a16="http://schemas.microsoft.com/office/drawing/2014/main" id="{039F17CC-9FF2-4693-8D2A-673C46E161B2}"/>
+                <a16:creationId xmlns:a16="http://schemas.microsoft.com/office/drawing/2014/main" id="{F28BCECF-700D-4A40-98D6-58D8B8D073A1}"/>
               </a:ext>
             </a:extLst>
           </p:cNvPr>
@@ -15276,7 +15276,7 @@
     </p:spTree>
     <p:extLst>
       <p:ext uri="{BB962C8B-B14F-4D97-AF65-F5344CB8AC3E}">
-        <p14:creationId xmlns:p14="http://schemas.microsoft.com/office/powerpoint/2010/main" val="250185763"/>
+        <p14:creationId xmlns:p14="http://schemas.microsoft.com/office/powerpoint/2010/main" val="364355003"/>
       </p:ext>
     </p:extLst>
   </p:cSld>
@@ -15300,7 +15300,7 @@
           <p:cNvPr id="2" name="TextBox 1">
             <a:extLst xmlns:a="http://schemas.openxmlformats.org/drawingml/2006/main">
               <a:ext uri="{FF2B5EF4-FFF2-40B4-BE49-F238E27FC236}">
-                <a16:creationId xmlns:a16="http://schemas.microsoft.com/office/drawing/2014/main" id="{F7C8FF39-751A-4200-9F16-20B0BC90328E}"/>
+                <a16:creationId xmlns:a16="http://schemas.microsoft.com/office/drawing/2014/main" id="{EB80E5C8-4460-4FCC-8C63-1228EAF57F59}"/>
               </a:ext>
             </a:extLst>
           </p:cNvPr>
@@ -15347,7 +15347,7 @@
           <p:cNvPr id="3" name="TextBox 2">
             <a:extLst xmlns:a="http://schemas.openxmlformats.org/drawingml/2006/main">
               <a:ext uri="{FF2B5EF4-FFF2-40B4-BE49-F238E27FC236}">
-                <a16:creationId xmlns:a16="http://schemas.microsoft.com/office/drawing/2014/main" id="{9DA8EA9C-3A11-42CD-B3FC-508113312D87}"/>
+                <a16:creationId xmlns:a16="http://schemas.microsoft.com/office/drawing/2014/main" id="{D8F033F3-DCDF-4F0A-AC89-0647855A3C3E}"/>
               </a:ext>
             </a:extLst>
           </p:cNvPr>
@@ -15394,7 +15394,7 @@
           <p:cNvPr id="4" name="Rectangle 3">
             <a:extLst xmlns:a="http://schemas.openxmlformats.org/drawingml/2006/main">
               <a:ext uri="{FF2B5EF4-FFF2-40B4-BE49-F238E27FC236}">
-                <a16:creationId xmlns:a16="http://schemas.microsoft.com/office/drawing/2014/main" id="{119D40D6-A876-4FE0-85A8-AD7B0834378B}"/>
+                <a16:creationId xmlns:a16="http://schemas.microsoft.com/office/drawing/2014/main" id="{13A612FE-6DF1-4B07-8494-514C33FCBD17}"/>
               </a:ext>
             </a:extLst>
           </p:cNvPr>
@@ -15449,7 +15449,7 @@
           <p:cNvPr id="5" name="Rectangle 4">
             <a:extLst xmlns:a="http://schemas.openxmlformats.org/drawingml/2006/main">
               <a:ext uri="{FF2B5EF4-FFF2-40B4-BE49-F238E27FC236}">
-                <a16:creationId xmlns:a16="http://schemas.microsoft.com/office/drawing/2014/main" id="{E77C1875-5E33-414C-8E75-4066E26F92A4}"/>
+                <a16:creationId xmlns:a16="http://schemas.microsoft.com/office/drawing/2014/main" id="{63DDAE97-41C3-4789-826B-40FEF3741C97}"/>
               </a:ext>
             </a:extLst>
           </p:cNvPr>
@@ -15504,7 +15504,7 @@
           <p:cNvPr id="6" name="TextBox 5">
             <a:extLst xmlns:a="http://schemas.openxmlformats.org/drawingml/2006/main">
               <a:ext uri="{FF2B5EF4-FFF2-40B4-BE49-F238E27FC236}">
-                <a16:creationId xmlns:a16="http://schemas.microsoft.com/office/drawing/2014/main" id="{35BA8125-2460-4189-AF49-9D6BC9F21EBA}"/>
+                <a16:creationId xmlns:a16="http://schemas.microsoft.com/office/drawing/2014/main" id="{DFFDD458-C36F-4F19-8A92-B8311FC7099B}"/>
               </a:ext>
             </a:extLst>
           </p:cNvPr>
@@ -15541,7 +15541,7 @@
                 <a:ea typeface="Aptos"/>
                 <a:cs typeface="Aptos"/>
               </a:rPr>
-              <a:t>Independent public evidence summary · 2026.07.23-10 · 2026-07-22 · Sources: EPO; Germany — official judgments; WIPO</a:t>
+              <a:t>Independent public evidence summary · 2026.07.23-11 · 2026-07-22 · Sources: EPO; Germany — official judgments; WIPO</a:t>
             </a:r>
           </a:p>
         </p:txBody>
@@ -15551,7 +15551,7 @@
           <p:cNvPr id="7" name="TextBox 6">
             <a:extLst xmlns:a="http://schemas.openxmlformats.org/drawingml/2006/main">
               <a:ext uri="{FF2B5EF4-FFF2-40B4-BE49-F238E27FC236}">
-                <a16:creationId xmlns:a16="http://schemas.microsoft.com/office/drawing/2014/main" id="{1AB3C04B-B18A-426A-8D04-F660D7F5C6D5}"/>
+                <a16:creationId xmlns:a16="http://schemas.microsoft.com/office/drawing/2014/main" id="{ED33786C-D7C8-48DD-962E-C0C5740C67B4}"/>
               </a:ext>
             </a:extLst>
           </p:cNvPr>
@@ -15598,7 +15598,7 @@
           <p:cNvPr id="8" name="TextBox 7">
             <a:extLst xmlns:a="http://schemas.openxmlformats.org/drawingml/2006/main">
               <a:ext uri="{FF2B5EF4-FFF2-40B4-BE49-F238E27FC236}">
-                <a16:creationId xmlns:a16="http://schemas.microsoft.com/office/drawing/2014/main" id="{797A5EB9-D2EB-4BFB-B336-463DD496A796}"/>
+                <a16:creationId xmlns:a16="http://schemas.microsoft.com/office/drawing/2014/main" id="{D7C57212-9635-41A1-BB60-FF7B91A4C4B2}"/>
               </a:ext>
             </a:extLst>
           </p:cNvPr>
@@ -15645,7 +15645,7 @@
           <p:cNvPr id="9" name="TextBox 8">
             <a:extLst xmlns:a="http://schemas.openxmlformats.org/drawingml/2006/main">
               <a:ext uri="{FF2B5EF4-FFF2-40B4-BE49-F238E27FC236}">
-                <a16:creationId xmlns:a16="http://schemas.microsoft.com/office/drawing/2014/main" id="{E9F5887E-580F-4DA5-91A5-D59C6B138570}"/>
+                <a16:creationId xmlns:a16="http://schemas.microsoft.com/office/drawing/2014/main" id="{EACE90C8-DB07-41EE-977F-D5B2362D05AC}"/>
               </a:ext>
             </a:extLst>
           </p:cNvPr>
@@ -15742,7 +15742,7 @@
           <p:cNvPr id="10" name="Rounded Rectangle 9">
             <a:extLst xmlns:a="http://schemas.openxmlformats.org/drawingml/2006/main">
               <a:ext uri="{FF2B5EF4-FFF2-40B4-BE49-F238E27FC236}">
-                <a16:creationId xmlns:a16="http://schemas.microsoft.com/office/drawing/2014/main" id="{E40EA0A7-0A11-4F33-8F7D-32FAAE28928F}"/>
+                <a16:creationId xmlns:a16="http://schemas.microsoft.com/office/drawing/2014/main" id="{75EB7DC9-2D13-4932-A0DE-4CFC175D5031}"/>
               </a:ext>
             </a:extLst>
           </p:cNvPr>
@@ -15799,7 +15799,7 @@
           <p:cNvPr id="11" name="TextBox 10">
             <a:extLst xmlns:a="http://schemas.openxmlformats.org/drawingml/2006/main">
               <a:ext uri="{FF2B5EF4-FFF2-40B4-BE49-F238E27FC236}">
-                <a16:creationId xmlns:a16="http://schemas.microsoft.com/office/drawing/2014/main" id="{788B25CA-DD4F-4577-96E3-1F9771818447}"/>
+                <a16:creationId xmlns:a16="http://schemas.microsoft.com/office/drawing/2014/main" id="{8DD87F65-CA2A-461E-ABAF-2FFB13C993FC}"/>
               </a:ext>
             </a:extLst>
           </p:cNvPr>
@@ -15846,7 +15846,7 @@
           <p:cNvPr id="12" name="TextBox 11">
             <a:extLst xmlns:a="http://schemas.openxmlformats.org/drawingml/2006/main">
               <a:ext uri="{FF2B5EF4-FFF2-40B4-BE49-F238E27FC236}">
-                <a16:creationId xmlns:a16="http://schemas.microsoft.com/office/drawing/2014/main" id="{3444F3AF-B0AA-4BAB-A5C0-F858C4F66FE9}"/>
+                <a16:creationId xmlns:a16="http://schemas.microsoft.com/office/drawing/2014/main" id="{01CFCF1F-D39E-47FB-80DC-918FDD8DF221}"/>
               </a:ext>
             </a:extLst>
           </p:cNvPr>
@@ -15891,7 +15891,7 @@
     </p:spTree>
     <p:extLst>
       <p:ext uri="{BB962C8B-B14F-4D97-AF65-F5344CB8AC3E}">
-        <p14:creationId xmlns:p14="http://schemas.microsoft.com/office/powerpoint/2010/main" val="747547884"/>
+        <p14:creationId xmlns:p14="http://schemas.microsoft.com/office/powerpoint/2010/main" val="877846374"/>
       </p:ext>
     </p:extLst>
   </p:cSld>
@@ -15915,7 +15915,7 @@
           <p:cNvPr id="2" name="TextBox 1">
             <a:extLst xmlns:a="http://schemas.openxmlformats.org/drawingml/2006/main">
               <a:ext uri="{FF2B5EF4-FFF2-40B4-BE49-F238E27FC236}">
-                <a16:creationId xmlns:a16="http://schemas.microsoft.com/office/drawing/2014/main" id="{07A2C05D-C3EE-45E7-8365-5DE2A1EF6010}"/>
+                <a16:creationId xmlns:a16="http://schemas.microsoft.com/office/drawing/2014/main" id="{0D918D9A-869B-4625-B200-50600E911BC3}"/>
               </a:ext>
             </a:extLst>
           </p:cNvPr>
@@ -15962,7 +15962,7 @@
           <p:cNvPr id="3" name="TextBox 2">
             <a:extLst xmlns:a="http://schemas.openxmlformats.org/drawingml/2006/main">
               <a:ext uri="{FF2B5EF4-FFF2-40B4-BE49-F238E27FC236}">
-                <a16:creationId xmlns:a16="http://schemas.microsoft.com/office/drawing/2014/main" id="{D3D4D502-F878-4CA1-A23C-260ED1E9098F}"/>
+                <a16:creationId xmlns:a16="http://schemas.microsoft.com/office/drawing/2014/main" id="{01AB1FF8-5AE4-413D-87C4-A31B05438AEE}"/>
               </a:ext>
             </a:extLst>
           </p:cNvPr>
@@ -16009,7 +16009,7 @@
           <p:cNvPr id="4" name="Rectangle 3">
             <a:extLst xmlns:a="http://schemas.openxmlformats.org/drawingml/2006/main">
               <a:ext uri="{FF2B5EF4-FFF2-40B4-BE49-F238E27FC236}">
-                <a16:creationId xmlns:a16="http://schemas.microsoft.com/office/drawing/2014/main" id="{3152E449-4F22-4530-A574-113F42C76211}"/>
+                <a16:creationId xmlns:a16="http://schemas.microsoft.com/office/drawing/2014/main" id="{72521F20-E757-45CC-B2F9-A5F52AD25D15}"/>
               </a:ext>
             </a:extLst>
           </p:cNvPr>
@@ -16064,7 +16064,7 @@
           <p:cNvPr id="5" name="Rectangle 4">
             <a:extLst xmlns:a="http://schemas.openxmlformats.org/drawingml/2006/main">
               <a:ext uri="{FF2B5EF4-FFF2-40B4-BE49-F238E27FC236}">
-                <a16:creationId xmlns:a16="http://schemas.microsoft.com/office/drawing/2014/main" id="{22ACCDD4-9D76-41D8-88B3-2D43521B18B8}"/>
+                <a16:creationId xmlns:a16="http://schemas.microsoft.com/office/drawing/2014/main" id="{8FD2EA95-9EC6-4CFF-A56E-264D1BD439E3}"/>
               </a:ext>
             </a:extLst>
           </p:cNvPr>
@@ -16119,7 +16119,7 @@
           <p:cNvPr id="6" name="TextBox 5">
             <a:extLst xmlns:a="http://schemas.openxmlformats.org/drawingml/2006/main">
               <a:ext uri="{FF2B5EF4-FFF2-40B4-BE49-F238E27FC236}">
-                <a16:creationId xmlns:a16="http://schemas.microsoft.com/office/drawing/2014/main" id="{3839196C-5325-4302-8319-C4793D8E4748}"/>
+                <a16:creationId xmlns:a16="http://schemas.microsoft.com/office/drawing/2014/main" id="{E3B82581-81F1-456B-B023-6EFCCB89F9A7}"/>
               </a:ext>
             </a:extLst>
           </p:cNvPr>
@@ -16156,7 +16156,7 @@
                 <a:ea typeface="Aptos"/>
                 <a:cs typeface="Aptos"/>
               </a:rPr>
-              <a:t>Independent public evidence summary · 2026.07.23-10 · 2026-07-22 · Sources: WIPO licensing; IP Finance</a:t>
+              <a:t>Independent public evidence summary · 2026.07.23-11 · 2026-07-22 · Sources: WIPO licensing; IP Finance</a:t>
             </a:r>
           </a:p>
         </p:txBody>
@@ -16166,7 +16166,7 @@
           <p:cNvPr id="7" name="TextBox 6">
             <a:extLst xmlns:a="http://schemas.openxmlformats.org/drawingml/2006/main">
               <a:ext uri="{FF2B5EF4-FFF2-40B4-BE49-F238E27FC236}">
-                <a16:creationId xmlns:a16="http://schemas.microsoft.com/office/drawing/2014/main" id="{38E14C2D-E997-463D-B76D-9D87CFAD5481}"/>
+                <a16:creationId xmlns:a16="http://schemas.microsoft.com/office/drawing/2014/main" id="{062FAF8A-A6FB-48C8-A2CC-9287F82FD6E6}"/>
               </a:ext>
             </a:extLst>
           </p:cNvPr>
@@ -16213,7 +16213,7 @@
           <p:cNvPr id="8" name="TextBox 7">
             <a:extLst xmlns:a="http://schemas.openxmlformats.org/drawingml/2006/main">
               <a:ext uri="{FF2B5EF4-FFF2-40B4-BE49-F238E27FC236}">
-                <a16:creationId xmlns:a16="http://schemas.microsoft.com/office/drawing/2014/main" id="{CAC157B8-059B-4A0E-95CD-904E5FCE6020}"/>
+                <a16:creationId xmlns:a16="http://schemas.microsoft.com/office/drawing/2014/main" id="{8A317384-E97F-4340-81B8-9F67EB3BBF24}"/>
               </a:ext>
             </a:extLst>
           </p:cNvPr>
@@ -16260,7 +16260,7 @@
           <p:cNvPr id="9" name="TextBox 8">
             <a:extLst xmlns:a="http://schemas.openxmlformats.org/drawingml/2006/main">
               <a:ext uri="{FF2B5EF4-FFF2-40B4-BE49-F238E27FC236}">
-                <a16:creationId xmlns:a16="http://schemas.microsoft.com/office/drawing/2014/main" id="{679B823A-ECFD-4425-8C14-156F04359FDA}"/>
+                <a16:creationId xmlns:a16="http://schemas.microsoft.com/office/drawing/2014/main" id="{084A5E44-6363-4FA3-9919-3E4591399081}"/>
               </a:ext>
             </a:extLst>
           </p:cNvPr>
@@ -16357,7 +16357,7 @@
           <p:cNvPr id="10" name="Rounded Rectangle 9">
             <a:extLst xmlns:a="http://schemas.openxmlformats.org/drawingml/2006/main">
               <a:ext uri="{FF2B5EF4-FFF2-40B4-BE49-F238E27FC236}">
-                <a16:creationId xmlns:a16="http://schemas.microsoft.com/office/drawing/2014/main" id="{96070D32-7C94-422E-86BA-950E0EACA540}"/>
+                <a16:creationId xmlns:a16="http://schemas.microsoft.com/office/drawing/2014/main" id="{EF8584C4-AF91-4513-8E3C-6739BFEC0B8A}"/>
               </a:ext>
             </a:extLst>
           </p:cNvPr>
@@ -16414,7 +16414,7 @@
           <p:cNvPr id="11" name="TextBox 10">
             <a:extLst xmlns:a="http://schemas.openxmlformats.org/drawingml/2006/main">
               <a:ext uri="{FF2B5EF4-FFF2-40B4-BE49-F238E27FC236}">
-                <a16:creationId xmlns:a16="http://schemas.microsoft.com/office/drawing/2014/main" id="{07DC9485-DCD5-4CC6-8894-DF83246778DB}"/>
+                <a16:creationId xmlns:a16="http://schemas.microsoft.com/office/drawing/2014/main" id="{BAFDD4FD-7A43-4C67-BA05-117A9F1AB983}"/>
               </a:ext>
             </a:extLst>
           </p:cNvPr>
@@ -16461,7 +16461,7 @@
           <p:cNvPr id="12" name="TextBox 11">
             <a:extLst xmlns:a="http://schemas.openxmlformats.org/drawingml/2006/main">
               <a:ext uri="{FF2B5EF4-FFF2-40B4-BE49-F238E27FC236}">
-                <a16:creationId xmlns:a16="http://schemas.microsoft.com/office/drawing/2014/main" id="{C806F569-CDFD-4E86-9B34-AC639FB33DF7}"/>
+                <a16:creationId xmlns:a16="http://schemas.microsoft.com/office/drawing/2014/main" id="{3BF8E8E7-F3BF-4329-A1B4-AB5360643BBB}"/>
               </a:ext>
             </a:extLst>
           </p:cNvPr>
@@ -16506,7 +16506,7 @@
     </p:spTree>
     <p:extLst>
       <p:ext uri="{BB962C8B-B14F-4D97-AF65-F5344CB8AC3E}">
-        <p14:creationId xmlns:p14="http://schemas.microsoft.com/office/powerpoint/2010/main" val="340262305"/>
+        <p14:creationId xmlns:p14="http://schemas.microsoft.com/office/powerpoint/2010/main" val="145529628"/>
       </p:ext>
     </p:extLst>
   </p:cSld>
@@ -16530,7 +16530,7 @@
           <p:cNvPr id="2" name="TextBox 1">
             <a:extLst xmlns:a="http://schemas.openxmlformats.org/drawingml/2006/main">
               <a:ext uri="{FF2B5EF4-FFF2-40B4-BE49-F238E27FC236}">
-                <a16:creationId xmlns:a16="http://schemas.microsoft.com/office/drawing/2014/main" id="{9980A7FC-AFB6-499A-B2EE-81ACF6127133}"/>
+                <a16:creationId xmlns:a16="http://schemas.microsoft.com/office/drawing/2014/main" id="{FBABEA17-BEE3-4772-AFDF-71E1BAAFA31D}"/>
               </a:ext>
             </a:extLst>
           </p:cNvPr>
@@ -16577,7 +16577,7 @@
           <p:cNvPr id="3" name="TextBox 2">
             <a:extLst xmlns:a="http://schemas.openxmlformats.org/drawingml/2006/main">
               <a:ext uri="{FF2B5EF4-FFF2-40B4-BE49-F238E27FC236}">
-                <a16:creationId xmlns:a16="http://schemas.microsoft.com/office/drawing/2014/main" id="{9E885DB2-4366-47ED-AC0C-3BC2831E63EF}"/>
+                <a16:creationId xmlns:a16="http://schemas.microsoft.com/office/drawing/2014/main" id="{6D2090E8-20CC-4442-8E67-092F6DB33F3F}"/>
               </a:ext>
             </a:extLst>
           </p:cNvPr>
@@ -16624,7 +16624,7 @@
           <p:cNvPr id="4" name="Rectangle 3">
             <a:extLst xmlns:a="http://schemas.openxmlformats.org/drawingml/2006/main">
               <a:ext uri="{FF2B5EF4-FFF2-40B4-BE49-F238E27FC236}">
-                <a16:creationId xmlns:a16="http://schemas.microsoft.com/office/drawing/2014/main" id="{D2FA1E60-FC1A-42C8-B038-F80520340511}"/>
+                <a16:creationId xmlns:a16="http://schemas.microsoft.com/office/drawing/2014/main" id="{698EDE2B-BB73-4A04-8B2F-9E68079EE24F}"/>
               </a:ext>
             </a:extLst>
           </p:cNvPr>
@@ -16679,7 +16679,7 @@
           <p:cNvPr id="5" name="Rectangle 4">
             <a:extLst xmlns:a="http://schemas.openxmlformats.org/drawingml/2006/main">
               <a:ext uri="{FF2B5EF4-FFF2-40B4-BE49-F238E27FC236}">
-                <a16:creationId xmlns:a16="http://schemas.microsoft.com/office/drawing/2014/main" id="{1894D294-EBCE-4963-95B6-C41EBF848E94}"/>
+                <a16:creationId xmlns:a16="http://schemas.microsoft.com/office/drawing/2014/main" id="{4BCCEB54-0FD0-41C0-8BC1-3D2D1B26AB5E}"/>
               </a:ext>
             </a:extLst>
           </p:cNvPr>
@@ -16734,7 +16734,7 @@
           <p:cNvPr id="6" name="TextBox 5">
             <a:extLst xmlns:a="http://schemas.openxmlformats.org/drawingml/2006/main">
               <a:ext uri="{FF2B5EF4-FFF2-40B4-BE49-F238E27FC236}">
-                <a16:creationId xmlns:a16="http://schemas.microsoft.com/office/drawing/2014/main" id="{01F90638-F82C-45A0-B8A2-8C3466490182}"/>
+                <a16:creationId xmlns:a16="http://schemas.microsoft.com/office/drawing/2014/main" id="{516390B7-B8D6-47AC-8CAE-FC97254CDD73}"/>
               </a:ext>
             </a:extLst>
           </p:cNvPr>
@@ -16771,7 +16771,7 @@
                 <a:ea typeface="Aptos"/>
                 <a:cs typeface="Aptos"/>
               </a:rPr>
-              <a:t>Independent public evidence summary · 2026.07.23-10 · 2026-07-22 · Sources: Evidence Register; EPO</a:t>
+              <a:t>Independent public evidence summary · 2026.07.23-11 · 2026-07-22 · Sources: Evidence Register; EPO</a:t>
             </a:r>
           </a:p>
         </p:txBody>
@@ -16781,7 +16781,7 @@
           <p:cNvPr id="7" name="TextBox 6">
             <a:extLst xmlns:a="http://schemas.openxmlformats.org/drawingml/2006/main">
               <a:ext uri="{FF2B5EF4-FFF2-40B4-BE49-F238E27FC236}">
-                <a16:creationId xmlns:a16="http://schemas.microsoft.com/office/drawing/2014/main" id="{C330DD02-22D6-4CDA-B680-4CE6F7FE15B0}"/>
+                <a16:creationId xmlns:a16="http://schemas.microsoft.com/office/drawing/2014/main" id="{D4E492BE-398F-43D8-9CF9-4457AD58B59C}"/>
               </a:ext>
             </a:extLst>
           </p:cNvPr>
@@ -17268,7 +17268,7 @@
           <p:cNvPr id="9" name="TextBox 8">
             <a:extLst xmlns:a="http://schemas.openxmlformats.org/drawingml/2006/main">
               <a:ext uri="{FF2B5EF4-FFF2-40B4-BE49-F238E27FC236}">
-                <a16:creationId xmlns:a16="http://schemas.microsoft.com/office/drawing/2014/main" id="{542CF62A-A755-4022-BAAB-024BBA495F4B}"/>
+                <a16:creationId xmlns:a16="http://schemas.microsoft.com/office/drawing/2014/main" id="{5A2079AD-DF54-4823-B29C-EA3EFE0B71B9}"/>
               </a:ext>
             </a:extLst>
           </p:cNvPr>
@@ -17313,7 +17313,7 @@
     </p:spTree>
     <p:extLst>
       <p:ext uri="{BB962C8B-B14F-4D97-AF65-F5344CB8AC3E}">
-        <p14:creationId xmlns:p14="http://schemas.microsoft.com/office/powerpoint/2010/main" val="729815906"/>
+        <p14:creationId xmlns:p14="http://schemas.microsoft.com/office/powerpoint/2010/main" val="1892466906"/>
       </p:ext>
     </p:extLst>
   </p:cSld>
@@ -17337,7 +17337,7 @@
           <p:cNvPr id="2" name="TextBox 1">
             <a:extLst xmlns:a="http://schemas.openxmlformats.org/drawingml/2006/main">
               <a:ext uri="{FF2B5EF4-FFF2-40B4-BE49-F238E27FC236}">
-                <a16:creationId xmlns:a16="http://schemas.microsoft.com/office/drawing/2014/main" id="{F211D6FB-AEDC-417F-8C07-0B8FD3C97F8C}"/>
+                <a16:creationId xmlns:a16="http://schemas.microsoft.com/office/drawing/2014/main" id="{4405FE8A-C724-4455-A9BB-C6ABD1E1E13D}"/>
               </a:ext>
             </a:extLst>
           </p:cNvPr>
@@ -17384,7 +17384,7 @@
           <p:cNvPr id="3" name="TextBox 2">
             <a:extLst xmlns:a="http://schemas.openxmlformats.org/drawingml/2006/main">
               <a:ext uri="{FF2B5EF4-FFF2-40B4-BE49-F238E27FC236}">
-                <a16:creationId xmlns:a16="http://schemas.microsoft.com/office/drawing/2014/main" id="{288FB995-2DD6-4117-A2A0-FF5CF5F80574}"/>
+                <a16:creationId xmlns:a16="http://schemas.microsoft.com/office/drawing/2014/main" id="{5AC0631F-903E-46E5-A851-CF7279F30C79}"/>
               </a:ext>
             </a:extLst>
           </p:cNvPr>
@@ -17431,7 +17431,7 @@
           <p:cNvPr id="4" name="Rectangle 3">
             <a:extLst xmlns:a="http://schemas.openxmlformats.org/drawingml/2006/main">
               <a:ext uri="{FF2B5EF4-FFF2-40B4-BE49-F238E27FC236}">
-                <a16:creationId xmlns:a16="http://schemas.microsoft.com/office/drawing/2014/main" id="{CBCEA591-F028-4BA8-B5E9-A4DDD5FDE1E5}"/>
+                <a16:creationId xmlns:a16="http://schemas.microsoft.com/office/drawing/2014/main" id="{CA774E9B-CB8B-4A81-9225-6D19C85CDFCF}"/>
               </a:ext>
             </a:extLst>
           </p:cNvPr>
@@ -17486,7 +17486,7 @@
           <p:cNvPr id="5" name="Rectangle 4">
             <a:extLst xmlns:a="http://schemas.openxmlformats.org/drawingml/2006/main">
               <a:ext uri="{FF2B5EF4-FFF2-40B4-BE49-F238E27FC236}">
-                <a16:creationId xmlns:a16="http://schemas.microsoft.com/office/drawing/2014/main" id="{47D29226-2141-4087-8921-86F3B9D8615C}"/>
+                <a16:creationId xmlns:a16="http://schemas.microsoft.com/office/drawing/2014/main" id="{747AE065-5C86-4629-8FCF-755EE3B46520}"/>
               </a:ext>
             </a:extLst>
           </p:cNvPr>
@@ -17541,7 +17541,7 @@
           <p:cNvPr id="6" name="TextBox 5">
             <a:extLst xmlns:a="http://schemas.openxmlformats.org/drawingml/2006/main">
               <a:ext uri="{FF2B5EF4-FFF2-40B4-BE49-F238E27FC236}">
-                <a16:creationId xmlns:a16="http://schemas.microsoft.com/office/drawing/2014/main" id="{B3E413BF-9D22-455E-AB23-723C4B21B13C}"/>
+                <a16:creationId xmlns:a16="http://schemas.microsoft.com/office/drawing/2014/main" id="{C987F3C0-89CE-4C94-A12A-C21C247E69A7}"/>
               </a:ext>
             </a:extLst>
           </p:cNvPr>
@@ -17578,7 +17578,7 @@
                 <a:ea typeface="Aptos"/>
                 <a:cs typeface="Aptos"/>
               </a:rPr>
-              <a:t>Independent public evidence summary · 2026.07.23-10 · 2026-07-22 · Sources: EP3032975B2; 7 O 3341/24</a:t>
+              <a:t>Independent public evidence summary · 2026.07.23-11 · 2026-07-22 · Sources: EP3032975B2; 7 O 3341/24</a:t>
             </a:r>
           </a:p>
         </p:txBody>
@@ -17588,7 +17588,7 @@
           <p:cNvPr id="7" name="TextBox 6">
             <a:extLst xmlns:a="http://schemas.openxmlformats.org/drawingml/2006/main">
               <a:ext uri="{FF2B5EF4-FFF2-40B4-BE49-F238E27FC236}">
-                <a16:creationId xmlns:a16="http://schemas.microsoft.com/office/drawing/2014/main" id="{EF92FF94-FD40-4922-9233-3D61DACE9B7D}"/>
+                <a16:creationId xmlns:a16="http://schemas.microsoft.com/office/drawing/2014/main" id="{CF481362-F8C8-425D-B2A5-6006B09E9A07}"/>
               </a:ext>
             </a:extLst>
           </p:cNvPr>
@@ -17635,7 +17635,7 @@
           <p:cNvPr id="8" name="Rounded Rectangle 7">
             <a:extLst xmlns:a="http://schemas.openxmlformats.org/drawingml/2006/main">
               <a:ext uri="{FF2B5EF4-FFF2-40B4-BE49-F238E27FC236}">
-                <a16:creationId xmlns:a16="http://schemas.microsoft.com/office/drawing/2014/main" id="{9B914660-52AA-46DE-A118-4B900FFDE37E}"/>
+                <a16:creationId xmlns:a16="http://schemas.microsoft.com/office/drawing/2014/main" id="{086C865D-BA23-4501-8426-2CA291F53E5F}"/>
               </a:ext>
             </a:extLst>
           </p:cNvPr>
@@ -17692,7 +17692,7 @@
           <p:cNvPr id="9" name="TextBox 8">
             <a:extLst xmlns:a="http://schemas.openxmlformats.org/drawingml/2006/main">
               <a:ext uri="{FF2B5EF4-FFF2-40B4-BE49-F238E27FC236}">
-                <a16:creationId xmlns:a16="http://schemas.microsoft.com/office/drawing/2014/main" id="{9D56DB96-49AA-4FFF-9BC0-EF1DEFC428E7}"/>
+                <a16:creationId xmlns:a16="http://schemas.microsoft.com/office/drawing/2014/main" id="{2F93CD18-E8D3-434F-87D6-5C68B1F552A5}"/>
               </a:ext>
             </a:extLst>
           </p:cNvPr>
@@ -17739,7 +17739,7 @@
           <p:cNvPr id="10" name="TextBox 9">
             <a:extLst xmlns:a="http://schemas.openxmlformats.org/drawingml/2006/main">
               <a:ext uri="{FF2B5EF4-FFF2-40B4-BE49-F238E27FC236}">
-                <a16:creationId xmlns:a16="http://schemas.microsoft.com/office/drawing/2014/main" id="{8179FF3E-3A1C-4C34-B0B8-E00EECEB77CB}"/>
+                <a16:creationId xmlns:a16="http://schemas.microsoft.com/office/drawing/2014/main" id="{BDF5D4D9-CF70-40B3-8B22-983142971954}"/>
               </a:ext>
             </a:extLst>
           </p:cNvPr>
@@ -17786,7 +17786,7 @@
           <p:cNvPr id="11" name="TextBox 10">
             <a:extLst xmlns:a="http://schemas.openxmlformats.org/drawingml/2006/main">
               <a:ext uri="{FF2B5EF4-FFF2-40B4-BE49-F238E27FC236}">
-                <a16:creationId xmlns:a16="http://schemas.microsoft.com/office/drawing/2014/main" id="{AE46ED1A-4DDF-40A2-903F-8A17B84725A4}"/>
+                <a16:creationId xmlns:a16="http://schemas.microsoft.com/office/drawing/2014/main" id="{1E9546FC-AC66-4C3B-B58B-F0ADABB13B79}"/>
               </a:ext>
             </a:extLst>
           </p:cNvPr>
@@ -17833,7 +17833,7 @@
           <p:cNvPr id="12" name="Rounded Rectangle 11">
             <a:extLst xmlns:a="http://schemas.openxmlformats.org/drawingml/2006/main">
               <a:ext uri="{FF2B5EF4-FFF2-40B4-BE49-F238E27FC236}">
-                <a16:creationId xmlns:a16="http://schemas.microsoft.com/office/drawing/2014/main" id="{F2448030-76EE-414F-8C86-25A07A09B75C}"/>
+                <a16:creationId xmlns:a16="http://schemas.microsoft.com/office/drawing/2014/main" id="{1A5DA50D-3461-484B-B0A0-051F52AC4314}"/>
               </a:ext>
             </a:extLst>
           </p:cNvPr>
@@ -17890,7 +17890,7 @@
           <p:cNvPr id="13" name="TextBox 12">
             <a:extLst xmlns:a="http://schemas.openxmlformats.org/drawingml/2006/main">
               <a:ext uri="{FF2B5EF4-FFF2-40B4-BE49-F238E27FC236}">
-                <a16:creationId xmlns:a16="http://schemas.microsoft.com/office/drawing/2014/main" id="{62869C3A-2558-408C-BD6B-1D80CAC1F1D0}"/>
+                <a16:creationId xmlns:a16="http://schemas.microsoft.com/office/drawing/2014/main" id="{08E495BB-0704-4C5B-A312-AA686E7191C5}"/>
               </a:ext>
             </a:extLst>
           </p:cNvPr>
@@ -17937,7 +17937,7 @@
           <p:cNvPr id="14" name="TextBox 13">
             <a:extLst xmlns:a="http://schemas.openxmlformats.org/drawingml/2006/main">
               <a:ext uri="{FF2B5EF4-FFF2-40B4-BE49-F238E27FC236}">
-                <a16:creationId xmlns:a16="http://schemas.microsoft.com/office/drawing/2014/main" id="{608D1C0D-7891-468A-B3CF-BD152FF7104F}"/>
+                <a16:creationId xmlns:a16="http://schemas.microsoft.com/office/drawing/2014/main" id="{30B2B55C-4305-4E94-9DBB-959FCE584C65}"/>
               </a:ext>
             </a:extLst>
           </p:cNvPr>
@@ -17984,7 +17984,7 @@
           <p:cNvPr id="15" name="TextBox 14">
             <a:extLst xmlns:a="http://schemas.openxmlformats.org/drawingml/2006/main">
               <a:ext uri="{FF2B5EF4-FFF2-40B4-BE49-F238E27FC236}">
-                <a16:creationId xmlns:a16="http://schemas.microsoft.com/office/drawing/2014/main" id="{9A3A09B7-6088-4468-B821-48C4CF757B70}"/>
+                <a16:creationId xmlns:a16="http://schemas.microsoft.com/office/drawing/2014/main" id="{14C1E4AE-F3B6-46A5-878B-55EAF9E1F579}"/>
               </a:ext>
             </a:extLst>
           </p:cNvPr>
@@ -18031,7 +18031,7 @@
           <p:cNvPr id="16" name="Rounded Rectangle 15">
             <a:extLst xmlns:a="http://schemas.openxmlformats.org/drawingml/2006/main">
               <a:ext uri="{FF2B5EF4-FFF2-40B4-BE49-F238E27FC236}">
-                <a16:creationId xmlns:a16="http://schemas.microsoft.com/office/drawing/2014/main" id="{EDD116F9-824E-4DAE-8A57-50F10E4F2FC4}"/>
+                <a16:creationId xmlns:a16="http://schemas.microsoft.com/office/drawing/2014/main" id="{6FACF75E-2D7F-484E-87D6-740C19A350C6}"/>
               </a:ext>
             </a:extLst>
           </p:cNvPr>
@@ -18088,7 +18088,7 @@
           <p:cNvPr id="17" name="TextBox 16">
             <a:extLst xmlns:a="http://schemas.openxmlformats.org/drawingml/2006/main">
               <a:ext uri="{FF2B5EF4-FFF2-40B4-BE49-F238E27FC236}">
-                <a16:creationId xmlns:a16="http://schemas.microsoft.com/office/drawing/2014/main" id="{454BD2CB-CFFB-4FF0-9E9A-870B696830E4}"/>
+                <a16:creationId xmlns:a16="http://schemas.microsoft.com/office/drawing/2014/main" id="{04DB9590-44C1-4367-8A5C-AFBE49068048}"/>
               </a:ext>
             </a:extLst>
           </p:cNvPr>
@@ -18135,7 +18135,7 @@
           <p:cNvPr id="18" name="TextBox 17">
             <a:extLst xmlns:a="http://schemas.openxmlformats.org/drawingml/2006/main">
               <a:ext uri="{FF2B5EF4-FFF2-40B4-BE49-F238E27FC236}">
-                <a16:creationId xmlns:a16="http://schemas.microsoft.com/office/drawing/2014/main" id="{07FEC64A-9CE7-4294-9D18-966ACD1AB1E3}"/>
+                <a16:creationId xmlns:a16="http://schemas.microsoft.com/office/drawing/2014/main" id="{D85E8ADA-D270-4D49-B45E-0FA23B225E2D}"/>
               </a:ext>
             </a:extLst>
           </p:cNvPr>
@@ -18182,7 +18182,7 @@
           <p:cNvPr id="19" name="TextBox 18">
             <a:extLst xmlns:a="http://schemas.openxmlformats.org/drawingml/2006/main">
               <a:ext uri="{FF2B5EF4-FFF2-40B4-BE49-F238E27FC236}">
-                <a16:creationId xmlns:a16="http://schemas.microsoft.com/office/drawing/2014/main" id="{10171992-BF37-4642-80BF-AD829711EF53}"/>
+                <a16:creationId xmlns:a16="http://schemas.microsoft.com/office/drawing/2014/main" id="{80945F0A-EEF8-4830-ACD8-03453BD0734E}"/>
               </a:ext>
             </a:extLst>
           </p:cNvPr>
@@ -18229,7 +18229,7 @@
           <p:cNvPr id="20" name="Rounded Rectangle 19">
             <a:extLst xmlns:a="http://schemas.openxmlformats.org/drawingml/2006/main">
               <a:ext uri="{FF2B5EF4-FFF2-40B4-BE49-F238E27FC236}">
-                <a16:creationId xmlns:a16="http://schemas.microsoft.com/office/drawing/2014/main" id="{C9370CB4-DD46-415F-A8A6-FCEE4143A35F}"/>
+                <a16:creationId xmlns:a16="http://schemas.microsoft.com/office/drawing/2014/main" id="{5D08EDA8-60BF-4EBC-B09C-C3D5C9F5D914}"/>
               </a:ext>
             </a:extLst>
           </p:cNvPr>
@@ -18286,7 +18286,7 @@
           <p:cNvPr id="21" name="TextBox 20">
             <a:extLst xmlns:a="http://schemas.openxmlformats.org/drawingml/2006/main">
               <a:ext uri="{FF2B5EF4-FFF2-40B4-BE49-F238E27FC236}">
-                <a16:creationId xmlns:a16="http://schemas.microsoft.com/office/drawing/2014/main" id="{1E20B19F-5618-41DF-8BBD-FE01CD94FF48}"/>
+                <a16:creationId xmlns:a16="http://schemas.microsoft.com/office/drawing/2014/main" id="{DAECC3DD-1133-4CF4-AEE0-9E65949F4AA3}"/>
               </a:ext>
             </a:extLst>
           </p:cNvPr>
@@ -18333,7 +18333,7 @@
           <p:cNvPr id="22" name="TextBox 21">
             <a:extLst xmlns:a="http://schemas.openxmlformats.org/drawingml/2006/main">
               <a:ext uri="{FF2B5EF4-FFF2-40B4-BE49-F238E27FC236}">
-                <a16:creationId xmlns:a16="http://schemas.microsoft.com/office/drawing/2014/main" id="{881D8A73-35EF-405F-A065-14B3A183705B}"/>
+                <a16:creationId xmlns:a16="http://schemas.microsoft.com/office/drawing/2014/main" id="{A0B2A25E-EAEC-4A69-9B64-A18E54EB1898}"/>
               </a:ext>
             </a:extLst>
           </p:cNvPr>
@@ -18380,7 +18380,7 @@
           <p:cNvPr id="23" name="TextBox 22">
             <a:extLst xmlns:a="http://schemas.openxmlformats.org/drawingml/2006/main">
               <a:ext uri="{FF2B5EF4-FFF2-40B4-BE49-F238E27FC236}">
-                <a16:creationId xmlns:a16="http://schemas.microsoft.com/office/drawing/2014/main" id="{7ABEBF89-28A0-4B8A-9DF2-B9D2C9D62322}"/>
+                <a16:creationId xmlns:a16="http://schemas.microsoft.com/office/drawing/2014/main" id="{CBE75048-1AEF-4F21-AB31-E24CBC885EF3}"/>
               </a:ext>
             </a:extLst>
           </p:cNvPr>
@@ -18427,7 +18427,7 @@
           <p:cNvPr id="24" name="TextBox 23">
             <a:extLst xmlns:a="http://schemas.openxmlformats.org/drawingml/2006/main">
               <a:ext uri="{FF2B5EF4-FFF2-40B4-BE49-F238E27FC236}">
-                <a16:creationId xmlns:a16="http://schemas.microsoft.com/office/drawing/2014/main" id="{D1A515DC-75CA-44A4-83FA-91C839C79D4A}"/>
+                <a16:creationId xmlns:a16="http://schemas.microsoft.com/office/drawing/2014/main" id="{E86343C4-44CB-48EE-80E4-8EF15DBD04C1}"/>
               </a:ext>
             </a:extLst>
           </p:cNvPr>
@@ -18472,7 +18472,7 @@
     </p:spTree>
     <p:extLst>
       <p:ext uri="{BB962C8B-B14F-4D97-AF65-F5344CB8AC3E}">
-        <p14:creationId xmlns:p14="http://schemas.microsoft.com/office/powerpoint/2010/main" val="917983250"/>
+        <p14:creationId xmlns:p14="http://schemas.microsoft.com/office/powerpoint/2010/main" val="1649455411"/>
       </p:ext>
     </p:extLst>
   </p:cSld>
@@ -18496,7 +18496,7 @@
           <p:cNvPr id="2" name="TextBox 1">
             <a:extLst xmlns:a="http://schemas.openxmlformats.org/drawingml/2006/main">
               <a:ext uri="{FF2B5EF4-FFF2-40B4-BE49-F238E27FC236}">
-                <a16:creationId xmlns:a16="http://schemas.microsoft.com/office/drawing/2014/main" id="{5767BC29-4602-4D16-9A51-F04B1FB3DEF6}"/>
+                <a16:creationId xmlns:a16="http://schemas.microsoft.com/office/drawing/2014/main" id="{A5BF5998-69EC-42BD-9C53-A9E8166BEB94}"/>
               </a:ext>
             </a:extLst>
           </p:cNvPr>
@@ -18543,7 +18543,7 @@
           <p:cNvPr id="3" name="TextBox 2">
             <a:extLst xmlns:a="http://schemas.openxmlformats.org/drawingml/2006/main">
               <a:ext uri="{FF2B5EF4-FFF2-40B4-BE49-F238E27FC236}">
-                <a16:creationId xmlns:a16="http://schemas.microsoft.com/office/drawing/2014/main" id="{13B89AEC-D60D-4E70-8300-A6613FAFC26E}"/>
+                <a16:creationId xmlns:a16="http://schemas.microsoft.com/office/drawing/2014/main" id="{AFFDAB4B-6746-46D0-BC69-31944F6CC57E}"/>
               </a:ext>
             </a:extLst>
           </p:cNvPr>
@@ -18590,7 +18590,7 @@
           <p:cNvPr id="4" name="Rectangle 3">
             <a:extLst xmlns:a="http://schemas.openxmlformats.org/drawingml/2006/main">
               <a:ext uri="{FF2B5EF4-FFF2-40B4-BE49-F238E27FC236}">
-                <a16:creationId xmlns:a16="http://schemas.microsoft.com/office/drawing/2014/main" id="{218AAA1C-F2B6-4CB0-A3ED-1237583BEA0E}"/>
+                <a16:creationId xmlns:a16="http://schemas.microsoft.com/office/drawing/2014/main" id="{A1E7F893-C6A3-4356-9E95-866936AEC2BA}"/>
               </a:ext>
             </a:extLst>
           </p:cNvPr>
@@ -18645,7 +18645,7 @@
           <p:cNvPr id="5" name="Rectangle 4">
             <a:extLst xmlns:a="http://schemas.openxmlformats.org/drawingml/2006/main">
               <a:ext uri="{FF2B5EF4-FFF2-40B4-BE49-F238E27FC236}">
-                <a16:creationId xmlns:a16="http://schemas.microsoft.com/office/drawing/2014/main" id="{D549CF2B-3E7D-41A4-85A8-D48655DBC43A}"/>
+                <a16:creationId xmlns:a16="http://schemas.microsoft.com/office/drawing/2014/main" id="{2E70412B-C134-463D-B50C-2BA465ED265F}"/>
               </a:ext>
             </a:extLst>
           </p:cNvPr>
@@ -18700,7 +18700,7 @@
           <p:cNvPr id="6" name="TextBox 5">
             <a:extLst xmlns:a="http://schemas.openxmlformats.org/drawingml/2006/main">
               <a:ext uri="{FF2B5EF4-FFF2-40B4-BE49-F238E27FC236}">
-                <a16:creationId xmlns:a16="http://schemas.microsoft.com/office/drawing/2014/main" id="{C8CB780B-C0BD-472C-90F3-50FD5766F8D8}"/>
+                <a16:creationId xmlns:a16="http://schemas.microsoft.com/office/drawing/2014/main" id="{93B3F963-45E5-40CF-8803-439BBAEA19BA}"/>
               </a:ext>
             </a:extLst>
           </p:cNvPr>
@@ -18737,7 +18737,7 @@
                 <a:ea typeface="Aptos"/>
                 <a:cs typeface="Aptos"/>
               </a:rPr>
-              <a:t>Independent public evidence summary · 2026.07.23-10 · 2026-07-22 · Sources: WIPO dispute resolution; EPO IPscore</a:t>
+              <a:t>Independent public evidence summary · 2026.07.23-11 · 2026-07-22 · Sources: WIPO dispute resolution; EPO IPscore</a:t>
             </a:r>
           </a:p>
         </p:txBody>
@@ -18747,7 +18747,7 @@
           <p:cNvPr id="7" name="TextBox 6">
             <a:extLst xmlns:a="http://schemas.openxmlformats.org/drawingml/2006/main">
               <a:ext uri="{FF2B5EF4-FFF2-40B4-BE49-F238E27FC236}">
-                <a16:creationId xmlns:a16="http://schemas.microsoft.com/office/drawing/2014/main" id="{D5A566C2-B712-41DE-BB52-F4EC35474259}"/>
+                <a16:creationId xmlns:a16="http://schemas.microsoft.com/office/drawing/2014/main" id="{B2D5AD75-BADA-487D-9F5E-1B8F1CA6AFD3}"/>
               </a:ext>
             </a:extLst>
           </p:cNvPr>
@@ -18794,7 +18794,7 @@
           <p:cNvPr id="8" name="Rounded Rectangle 7">
             <a:extLst xmlns:a="http://schemas.openxmlformats.org/drawingml/2006/main">
               <a:ext uri="{FF2B5EF4-FFF2-40B4-BE49-F238E27FC236}">
-                <a16:creationId xmlns:a16="http://schemas.microsoft.com/office/drawing/2014/main" id="{F00C757F-740D-43DE-9BAF-D639DE606369}"/>
+                <a16:creationId xmlns:a16="http://schemas.microsoft.com/office/drawing/2014/main" id="{8F0FE76D-4C78-415B-AF8F-32CAC05E3E70}"/>
               </a:ext>
             </a:extLst>
           </p:cNvPr>
@@ -18851,7 +18851,7 @@
           <p:cNvPr id="9" name="TextBox 8">
             <a:extLst xmlns:a="http://schemas.openxmlformats.org/drawingml/2006/main">
               <a:ext uri="{FF2B5EF4-FFF2-40B4-BE49-F238E27FC236}">
-                <a16:creationId xmlns:a16="http://schemas.microsoft.com/office/drawing/2014/main" id="{F6E40714-6C6B-4895-B135-18A644D435FA}"/>
+                <a16:creationId xmlns:a16="http://schemas.microsoft.com/office/drawing/2014/main" id="{F3E6ED80-7EE6-49B2-8777-21256A14CE97}"/>
               </a:ext>
             </a:extLst>
           </p:cNvPr>
@@ -18898,7 +18898,7 @@
           <p:cNvPr id="10" name="TextBox 9">
             <a:extLst xmlns:a="http://schemas.openxmlformats.org/drawingml/2006/main">
               <a:ext uri="{FF2B5EF4-FFF2-40B4-BE49-F238E27FC236}">
-                <a16:creationId xmlns:a16="http://schemas.microsoft.com/office/drawing/2014/main" id="{AFFF1FFB-F068-4A5B-BB18-CD9CF8AC91B2}"/>
+                <a16:creationId xmlns:a16="http://schemas.microsoft.com/office/drawing/2014/main" id="{386C0729-F45C-49C1-8808-3202BF2463B6}"/>
               </a:ext>
             </a:extLst>
           </p:cNvPr>
@@ -18945,7 +18945,7 @@
           <p:cNvPr id="11" name="TextBox 10">
             <a:extLst xmlns:a="http://schemas.openxmlformats.org/drawingml/2006/main">
               <a:ext uri="{FF2B5EF4-FFF2-40B4-BE49-F238E27FC236}">
-                <a16:creationId xmlns:a16="http://schemas.microsoft.com/office/drawing/2014/main" id="{C08DDD2D-C31A-44BD-BCAE-D55E4634C6B5}"/>
+                <a16:creationId xmlns:a16="http://schemas.microsoft.com/office/drawing/2014/main" id="{E8922FD6-3820-4D94-9653-F43A5E0808A3}"/>
               </a:ext>
             </a:extLst>
           </p:cNvPr>
@@ -18992,7 +18992,7 @@
           <p:cNvPr id="12" name="Rounded Rectangle 11">
             <a:extLst xmlns:a="http://schemas.openxmlformats.org/drawingml/2006/main">
               <a:ext uri="{FF2B5EF4-FFF2-40B4-BE49-F238E27FC236}">
-                <a16:creationId xmlns:a16="http://schemas.microsoft.com/office/drawing/2014/main" id="{9468DD32-4EF7-4C13-929E-A926F1B7511B}"/>
+                <a16:creationId xmlns:a16="http://schemas.microsoft.com/office/drawing/2014/main" id="{A82C83F7-6610-4C54-95DE-D04B1529C896}"/>
               </a:ext>
             </a:extLst>
           </p:cNvPr>
@@ -19049,7 +19049,7 @@
           <p:cNvPr id="13" name="TextBox 12">
             <a:extLst xmlns:a="http://schemas.openxmlformats.org/drawingml/2006/main">
               <a:ext uri="{FF2B5EF4-FFF2-40B4-BE49-F238E27FC236}">
-                <a16:creationId xmlns:a16="http://schemas.microsoft.com/office/drawing/2014/main" id="{D8A376C3-9FFB-4682-A020-BB13B4555242}"/>
+                <a16:creationId xmlns:a16="http://schemas.microsoft.com/office/drawing/2014/main" id="{258B88D9-39C8-4B84-A37D-326EF456B588}"/>
               </a:ext>
             </a:extLst>
           </p:cNvPr>
@@ -19096,7 +19096,7 @@
           <p:cNvPr id="14" name="TextBox 13">
             <a:extLst xmlns:a="http://schemas.openxmlformats.org/drawingml/2006/main">
               <a:ext uri="{FF2B5EF4-FFF2-40B4-BE49-F238E27FC236}">
-                <a16:creationId xmlns:a16="http://schemas.microsoft.com/office/drawing/2014/main" id="{8CCCBF04-777D-43F7-8203-6E75581A0429}"/>
+                <a16:creationId xmlns:a16="http://schemas.microsoft.com/office/drawing/2014/main" id="{59BD6CFB-0BF2-4149-9AB4-65596259FD74}"/>
               </a:ext>
             </a:extLst>
           </p:cNvPr>
@@ -19143,7 +19143,7 @@
           <p:cNvPr id="15" name="TextBox 14">
             <a:extLst xmlns:a="http://schemas.openxmlformats.org/drawingml/2006/main">
               <a:ext uri="{FF2B5EF4-FFF2-40B4-BE49-F238E27FC236}">
-                <a16:creationId xmlns:a16="http://schemas.microsoft.com/office/drawing/2014/main" id="{00459F79-8175-4ACD-8B24-91E241ED8B12}"/>
+                <a16:creationId xmlns:a16="http://schemas.microsoft.com/office/drawing/2014/main" id="{C58E5FF1-7AAA-469B-91D2-BE8A64637861}"/>
               </a:ext>
             </a:extLst>
           </p:cNvPr>
@@ -19190,7 +19190,7 @@
           <p:cNvPr id="16" name="Rounded Rectangle 15">
             <a:extLst xmlns:a="http://schemas.openxmlformats.org/drawingml/2006/main">
               <a:ext uri="{FF2B5EF4-FFF2-40B4-BE49-F238E27FC236}">
-                <a16:creationId xmlns:a16="http://schemas.microsoft.com/office/drawing/2014/main" id="{394754CA-D8EC-440F-BB89-C9110C9EFF2A}"/>
+                <a16:creationId xmlns:a16="http://schemas.microsoft.com/office/drawing/2014/main" id="{7FDACEDD-FD3F-4A0E-ACE0-14B1BE7088CF}"/>
               </a:ext>
             </a:extLst>
           </p:cNvPr>
@@ -19247,7 +19247,7 @@
           <p:cNvPr id="17" name="TextBox 16">
             <a:extLst xmlns:a="http://schemas.openxmlformats.org/drawingml/2006/main">
               <a:ext uri="{FF2B5EF4-FFF2-40B4-BE49-F238E27FC236}">
-                <a16:creationId xmlns:a16="http://schemas.microsoft.com/office/drawing/2014/main" id="{9F036AFC-547E-48C9-96CC-556E56298DE1}"/>
+                <a16:creationId xmlns:a16="http://schemas.microsoft.com/office/drawing/2014/main" id="{0EC195A9-E388-4365-9D7D-9DDDF9DC8B39}"/>
               </a:ext>
             </a:extLst>
           </p:cNvPr>
@@ -19294,7 +19294,7 @@
           <p:cNvPr id="18" name="TextBox 17">
             <a:extLst xmlns:a="http://schemas.openxmlformats.org/drawingml/2006/main">
               <a:ext uri="{FF2B5EF4-FFF2-40B4-BE49-F238E27FC236}">
-                <a16:creationId xmlns:a16="http://schemas.microsoft.com/office/drawing/2014/main" id="{D676F299-9373-4548-8D9A-8C55B9AEE8C2}"/>
+                <a16:creationId xmlns:a16="http://schemas.microsoft.com/office/drawing/2014/main" id="{8A6493FD-2BE8-4527-8F18-00B016C567F9}"/>
               </a:ext>
             </a:extLst>
           </p:cNvPr>
@@ -19341,7 +19341,7 @@
           <p:cNvPr id="19" name="TextBox 18">
             <a:extLst xmlns:a="http://schemas.openxmlformats.org/drawingml/2006/main">
               <a:ext uri="{FF2B5EF4-FFF2-40B4-BE49-F238E27FC236}">
-                <a16:creationId xmlns:a16="http://schemas.microsoft.com/office/drawing/2014/main" id="{7DB08B5B-8FAB-4482-BFA8-487FBE382697}"/>
+                <a16:creationId xmlns:a16="http://schemas.microsoft.com/office/drawing/2014/main" id="{03BF5AF3-9048-4570-943F-C59A1EF12246}"/>
               </a:ext>
             </a:extLst>
           </p:cNvPr>
@@ -19388,7 +19388,7 @@
           <p:cNvPr id="20" name="Rounded Rectangle 19">
             <a:extLst xmlns:a="http://schemas.openxmlformats.org/drawingml/2006/main">
               <a:ext uri="{FF2B5EF4-FFF2-40B4-BE49-F238E27FC236}">
-                <a16:creationId xmlns:a16="http://schemas.microsoft.com/office/drawing/2014/main" id="{33F3FD50-1ABB-4BCB-B6D6-3D117712676C}"/>
+                <a16:creationId xmlns:a16="http://schemas.microsoft.com/office/drawing/2014/main" id="{6C712A78-2E4A-4066-89DB-60DBBA360966}"/>
               </a:ext>
             </a:extLst>
           </p:cNvPr>
@@ -19445,7 +19445,7 @@
           <p:cNvPr id="21" name="TextBox 20">
             <a:extLst xmlns:a="http://schemas.openxmlformats.org/drawingml/2006/main">
               <a:ext uri="{FF2B5EF4-FFF2-40B4-BE49-F238E27FC236}">
-                <a16:creationId xmlns:a16="http://schemas.microsoft.com/office/drawing/2014/main" id="{384AEB7A-5688-4EDC-BF83-F864B3581923}"/>
+                <a16:creationId xmlns:a16="http://schemas.microsoft.com/office/drawing/2014/main" id="{43232C10-380A-452A-A88A-32A5FD630D15}"/>
               </a:ext>
             </a:extLst>
           </p:cNvPr>
@@ -19492,7 +19492,7 @@
           <p:cNvPr id="22" name="TextBox 21">
             <a:extLst xmlns:a="http://schemas.openxmlformats.org/drawingml/2006/main">
               <a:ext uri="{FF2B5EF4-FFF2-40B4-BE49-F238E27FC236}">
-                <a16:creationId xmlns:a16="http://schemas.microsoft.com/office/drawing/2014/main" id="{099BAFAA-F7D8-43D1-B6A2-6E81555A122F}"/>
+                <a16:creationId xmlns:a16="http://schemas.microsoft.com/office/drawing/2014/main" id="{A850EA52-6233-4FD3-982D-F540FC49A6BD}"/>
               </a:ext>
             </a:extLst>
           </p:cNvPr>
@@ -19539,7 +19539,7 @@
           <p:cNvPr id="23" name="TextBox 22">
             <a:extLst xmlns:a="http://schemas.openxmlformats.org/drawingml/2006/main">
               <a:ext uri="{FF2B5EF4-FFF2-40B4-BE49-F238E27FC236}">
-                <a16:creationId xmlns:a16="http://schemas.microsoft.com/office/drawing/2014/main" id="{EAD9BB6F-D748-4F0B-A855-DD240AA01F48}"/>
+                <a16:creationId xmlns:a16="http://schemas.microsoft.com/office/drawing/2014/main" id="{D57055E5-08AF-45C6-9A13-17E33EC285F9}"/>
               </a:ext>
             </a:extLst>
           </p:cNvPr>
@@ -19586,7 +19586,7 @@
           <p:cNvPr id="24" name="TextBox 23">
             <a:extLst xmlns:a="http://schemas.openxmlformats.org/drawingml/2006/main">
               <a:ext uri="{FF2B5EF4-FFF2-40B4-BE49-F238E27FC236}">
-                <a16:creationId xmlns:a16="http://schemas.microsoft.com/office/drawing/2014/main" id="{DAF44827-F65D-4EFA-B816-B8A698ADB25E}"/>
+                <a16:creationId xmlns:a16="http://schemas.microsoft.com/office/drawing/2014/main" id="{0C091EDB-1F27-4F84-9D17-28117C7C62AD}"/>
               </a:ext>
             </a:extLst>
           </p:cNvPr>
@@ -19631,7 +19631,7 @@
     </p:spTree>
     <p:extLst>
       <p:ext uri="{BB962C8B-B14F-4D97-AF65-F5344CB8AC3E}">
-        <p14:creationId xmlns:p14="http://schemas.microsoft.com/office/powerpoint/2010/main" val="2087689409"/>
+        <p14:creationId xmlns:p14="http://schemas.microsoft.com/office/powerpoint/2010/main" val="1744314089"/>
       </p:ext>
     </p:extLst>
   </p:cSld>
@@ -19655,7 +19655,7 @@
           <p:cNvPr id="2" name="TextBox 1">
             <a:extLst xmlns:a="http://schemas.openxmlformats.org/drawingml/2006/main">
               <a:ext uri="{FF2B5EF4-FFF2-40B4-BE49-F238E27FC236}">
-                <a16:creationId xmlns:a16="http://schemas.microsoft.com/office/drawing/2014/main" id="{6A3401B0-FF00-4EB1-B2DD-16FEE9B7E236}"/>
+                <a16:creationId xmlns:a16="http://schemas.microsoft.com/office/drawing/2014/main" id="{2797708C-94FE-4670-8BF2-5D3D6EA75C9C}"/>
               </a:ext>
             </a:extLst>
           </p:cNvPr>
@@ -19702,7 +19702,7 @@
           <p:cNvPr id="3" name="TextBox 2">
             <a:extLst xmlns:a="http://schemas.openxmlformats.org/drawingml/2006/main">
               <a:ext uri="{FF2B5EF4-FFF2-40B4-BE49-F238E27FC236}">
-                <a16:creationId xmlns:a16="http://schemas.microsoft.com/office/drawing/2014/main" id="{34573C6B-E0DE-4D04-8E97-3DCB860837E5}"/>
+                <a16:creationId xmlns:a16="http://schemas.microsoft.com/office/drawing/2014/main" id="{DA8F015D-22CF-4306-81A0-6900B87601C6}"/>
               </a:ext>
             </a:extLst>
           </p:cNvPr>
@@ -19749,7 +19749,7 @@
           <p:cNvPr id="4" name="Rectangle 3">
             <a:extLst xmlns:a="http://schemas.openxmlformats.org/drawingml/2006/main">
               <a:ext uri="{FF2B5EF4-FFF2-40B4-BE49-F238E27FC236}">
-                <a16:creationId xmlns:a16="http://schemas.microsoft.com/office/drawing/2014/main" id="{4112A014-A753-4D0B-BDC2-A27700528009}"/>
+                <a16:creationId xmlns:a16="http://schemas.microsoft.com/office/drawing/2014/main" id="{1904A954-FA42-4077-97D1-1D287ABB99D3}"/>
               </a:ext>
             </a:extLst>
           </p:cNvPr>
@@ -19804,7 +19804,7 @@
           <p:cNvPr id="5" name="Rectangle 4">
             <a:extLst xmlns:a="http://schemas.openxmlformats.org/drawingml/2006/main">
               <a:ext uri="{FF2B5EF4-FFF2-40B4-BE49-F238E27FC236}">
-                <a16:creationId xmlns:a16="http://schemas.microsoft.com/office/drawing/2014/main" id="{E47336BF-A4CB-4753-92E2-64A64E9FB342}"/>
+                <a16:creationId xmlns:a16="http://schemas.microsoft.com/office/drawing/2014/main" id="{854D26FC-04CD-4F33-A774-EC8B2362EAFA}"/>
               </a:ext>
             </a:extLst>
           </p:cNvPr>
@@ -19859,7 +19859,7 @@
           <p:cNvPr id="6" name="TextBox 5">
             <a:extLst xmlns:a="http://schemas.openxmlformats.org/drawingml/2006/main">
               <a:ext uri="{FF2B5EF4-FFF2-40B4-BE49-F238E27FC236}">
-                <a16:creationId xmlns:a16="http://schemas.microsoft.com/office/drawing/2014/main" id="{6C2907CA-1F51-4D16-8752-D5DD94BB99C3}"/>
+                <a16:creationId xmlns:a16="http://schemas.microsoft.com/office/drawing/2014/main" id="{5860C676-9A68-4BC2-9B0E-CB4D10C9FBD3}"/>
               </a:ext>
             </a:extLst>
           </p:cNvPr>
@@ -19896,7 +19896,7 @@
                 <a:ea typeface="Aptos"/>
                 <a:cs typeface="Aptos"/>
               </a:rPr>
-              <a:t>Independent public evidence summary · 2026.07.23-10 · 2026-07-22 · Sources: WIPO licensing; IP Finance; TPLF mapping</a:t>
+              <a:t>Independent public evidence summary · 2026.07.23-11 · 2026-07-22 · Sources: WIPO licensing; IP Finance; TPLF mapping</a:t>
             </a:r>
           </a:p>
         </p:txBody>
@@ -19906,7 +19906,7 @@
           <p:cNvPr id="7" name="TextBox 6">
             <a:extLst xmlns:a="http://schemas.openxmlformats.org/drawingml/2006/main">
               <a:ext uri="{FF2B5EF4-FFF2-40B4-BE49-F238E27FC236}">
-                <a16:creationId xmlns:a16="http://schemas.microsoft.com/office/drawing/2014/main" id="{81ABA7E3-650D-43BE-8AC5-4B743E47758C}"/>
+                <a16:creationId xmlns:a16="http://schemas.microsoft.com/office/drawing/2014/main" id="{FD7AE657-A59D-43D1-A88E-4E9802213668}"/>
               </a:ext>
             </a:extLst>
           </p:cNvPr>
@@ -20476,7 +20476,7 @@
           <p:cNvPr id="9" name="TextBox 8">
             <a:extLst xmlns:a="http://schemas.openxmlformats.org/drawingml/2006/main">
               <a:ext uri="{FF2B5EF4-FFF2-40B4-BE49-F238E27FC236}">
-                <a16:creationId xmlns:a16="http://schemas.microsoft.com/office/drawing/2014/main" id="{BD9749BA-0425-4F36-B462-F647472C01EE}"/>
+                <a16:creationId xmlns:a16="http://schemas.microsoft.com/office/drawing/2014/main" id="{E183CBA7-6FB9-4B7D-B0CB-3943CD8816C8}"/>
               </a:ext>
             </a:extLst>
           </p:cNvPr>
@@ -20521,7 +20521,7 @@
     </p:spTree>
     <p:extLst>
       <p:ext uri="{BB962C8B-B14F-4D97-AF65-F5344CB8AC3E}">
-        <p14:creationId xmlns:p14="http://schemas.microsoft.com/office/powerpoint/2010/main" val="1055359720"/>
+        <p14:creationId xmlns:p14="http://schemas.microsoft.com/office/powerpoint/2010/main" val="1153751682"/>
       </p:ext>
     </p:extLst>
   </p:cSld>
@@ -20545,7 +20545,7 @@
           <p:cNvPr id="2" name="TextBox 1">
             <a:extLst xmlns:a="http://schemas.openxmlformats.org/drawingml/2006/main">
               <a:ext uri="{FF2B5EF4-FFF2-40B4-BE49-F238E27FC236}">
-                <a16:creationId xmlns:a16="http://schemas.microsoft.com/office/drawing/2014/main" id="{719DFD49-53E7-4A74-BE3A-6D796F6DE2A4}"/>
+                <a16:creationId xmlns:a16="http://schemas.microsoft.com/office/drawing/2014/main" id="{617ED85A-A40A-40BA-9706-43F576690BA9}"/>
               </a:ext>
             </a:extLst>
           </p:cNvPr>
@@ -20592,7 +20592,7 @@
           <p:cNvPr id="3" name="TextBox 2">
             <a:extLst xmlns:a="http://schemas.openxmlformats.org/drawingml/2006/main">
               <a:ext uri="{FF2B5EF4-FFF2-40B4-BE49-F238E27FC236}">
-                <a16:creationId xmlns:a16="http://schemas.microsoft.com/office/drawing/2014/main" id="{0BB451CD-BBC6-4032-B687-7A4DCA4B4058}"/>
+                <a16:creationId xmlns:a16="http://schemas.microsoft.com/office/drawing/2014/main" id="{00383E63-939D-4C0B-B056-B97FD5F528FF}"/>
               </a:ext>
             </a:extLst>
           </p:cNvPr>
@@ -20639,7 +20639,7 @@
           <p:cNvPr id="4" name="Rectangle 3">
             <a:extLst xmlns:a="http://schemas.openxmlformats.org/drawingml/2006/main">
               <a:ext uri="{FF2B5EF4-FFF2-40B4-BE49-F238E27FC236}">
-                <a16:creationId xmlns:a16="http://schemas.microsoft.com/office/drawing/2014/main" id="{81E7987D-513A-4FCB-BD7E-165FFD36DA7F}"/>
+                <a16:creationId xmlns:a16="http://schemas.microsoft.com/office/drawing/2014/main" id="{968B7D54-7165-4E54-8CAA-89445CF8D701}"/>
               </a:ext>
             </a:extLst>
           </p:cNvPr>
@@ -20694,7 +20694,7 @@
           <p:cNvPr id="5" name="Rectangle 4">
             <a:extLst xmlns:a="http://schemas.openxmlformats.org/drawingml/2006/main">
               <a:ext uri="{FF2B5EF4-FFF2-40B4-BE49-F238E27FC236}">
-                <a16:creationId xmlns:a16="http://schemas.microsoft.com/office/drawing/2014/main" id="{A50181CF-28F9-4A21-A74F-65DD492AF1B3}"/>
+                <a16:creationId xmlns:a16="http://schemas.microsoft.com/office/drawing/2014/main" id="{4AB61D7C-8DA7-4488-A87A-1B704239D94A}"/>
               </a:ext>
             </a:extLst>
           </p:cNvPr>
@@ -20749,7 +20749,7 @@
           <p:cNvPr id="6" name="TextBox 5">
             <a:extLst xmlns:a="http://schemas.openxmlformats.org/drawingml/2006/main">
               <a:ext uri="{FF2B5EF4-FFF2-40B4-BE49-F238E27FC236}">
-                <a16:creationId xmlns:a16="http://schemas.microsoft.com/office/drawing/2014/main" id="{FDECAD9F-7859-4A4E-B336-CD11B6697AE0}"/>
+                <a16:creationId xmlns:a16="http://schemas.microsoft.com/office/drawing/2014/main" id="{BBDCCB06-8650-47CE-A5EA-B1266785C064}"/>
               </a:ext>
             </a:extLst>
           </p:cNvPr>
@@ -20786,7 +20786,7 @@
                 <a:ea typeface="Aptos"/>
                 <a:cs typeface="Aptos"/>
               </a:rPr>
-              <a:t>Independent public evidence summary · 2026.07.23-10 · 2026-07-22 · Sources: Evidence Register; WIPO valuation</a:t>
+              <a:t>Independent public evidence summary · 2026.07.23-11 · 2026-07-22 · Sources: Evidence Register; WIPO valuation</a:t>
             </a:r>
           </a:p>
         </p:txBody>
@@ -20796,7 +20796,7 @@
           <p:cNvPr id="7" name="TextBox 6">
             <a:extLst xmlns:a="http://schemas.openxmlformats.org/drawingml/2006/main">
               <a:ext uri="{FF2B5EF4-FFF2-40B4-BE49-F238E27FC236}">
-                <a16:creationId xmlns:a16="http://schemas.microsoft.com/office/drawing/2014/main" id="{ECD341ED-38BC-426E-B698-043DF39C62A0}"/>
+                <a16:creationId xmlns:a16="http://schemas.microsoft.com/office/drawing/2014/main" id="{16F66114-1C3C-41CD-93A8-00DD8F783DC2}"/>
               </a:ext>
             </a:extLst>
           </p:cNvPr>
@@ -21449,7 +21449,7 @@
           <p:cNvPr id="9" name="TextBox 8">
             <a:extLst xmlns:a="http://schemas.openxmlformats.org/drawingml/2006/main">
               <a:ext uri="{FF2B5EF4-FFF2-40B4-BE49-F238E27FC236}">
-                <a16:creationId xmlns:a16="http://schemas.microsoft.com/office/drawing/2014/main" id="{9E6BC743-41B8-4F96-8C2D-C95DF4834913}"/>
+                <a16:creationId xmlns:a16="http://schemas.microsoft.com/office/drawing/2014/main" id="{406795A4-10DF-45E1-ACE8-71A131DEBDDA}"/>
               </a:ext>
             </a:extLst>
           </p:cNvPr>
@@ -21494,7 +21494,7 @@
     </p:spTree>
     <p:extLst>
       <p:ext uri="{BB962C8B-B14F-4D97-AF65-F5344CB8AC3E}">
-        <p14:creationId xmlns:p14="http://schemas.microsoft.com/office/powerpoint/2010/main" val="1178387720"/>
+        <p14:creationId xmlns:p14="http://schemas.microsoft.com/office/powerpoint/2010/main" val="1895016102"/>
       </p:ext>
     </p:extLst>
   </p:cSld>
@@ -21518,7 +21518,7 @@
           <p:cNvPr id="2" name="TextBox 1">
             <a:extLst xmlns:a="http://schemas.openxmlformats.org/drawingml/2006/main">
               <a:ext uri="{FF2B5EF4-FFF2-40B4-BE49-F238E27FC236}">
-                <a16:creationId xmlns:a16="http://schemas.microsoft.com/office/drawing/2014/main" id="{BA0E0014-25AF-4EDD-A86F-8F4158FE753A}"/>
+                <a16:creationId xmlns:a16="http://schemas.microsoft.com/office/drawing/2014/main" id="{8EA5C04F-7DDE-474B-88C8-BCEFFF98C5D6}"/>
               </a:ext>
             </a:extLst>
           </p:cNvPr>
@@ -21565,7 +21565,7 @@
           <p:cNvPr id="3" name="TextBox 2">
             <a:extLst xmlns:a="http://schemas.openxmlformats.org/drawingml/2006/main">
               <a:ext uri="{FF2B5EF4-FFF2-40B4-BE49-F238E27FC236}">
-                <a16:creationId xmlns:a16="http://schemas.microsoft.com/office/drawing/2014/main" id="{B523DA14-1708-48A0-AAF3-C79C19A28BFE}"/>
+                <a16:creationId xmlns:a16="http://schemas.microsoft.com/office/drawing/2014/main" id="{9151A8BF-9F5F-4EDC-8657-A56ECEEEDF3E}"/>
               </a:ext>
             </a:extLst>
           </p:cNvPr>
@@ -21612,7 +21612,7 @@
           <p:cNvPr id="4" name="Rectangle 3">
             <a:extLst xmlns:a="http://schemas.openxmlformats.org/drawingml/2006/main">
               <a:ext uri="{FF2B5EF4-FFF2-40B4-BE49-F238E27FC236}">
-                <a16:creationId xmlns:a16="http://schemas.microsoft.com/office/drawing/2014/main" id="{79C58AD9-952F-4B0D-87A1-037429A31B9F}"/>
+                <a16:creationId xmlns:a16="http://schemas.microsoft.com/office/drawing/2014/main" id="{3EAD722E-65CA-4C61-9E63-42B35314EB48}"/>
               </a:ext>
             </a:extLst>
           </p:cNvPr>
@@ -21667,7 +21667,7 @@
           <p:cNvPr id="5" name="Rectangle 4">
             <a:extLst xmlns:a="http://schemas.openxmlformats.org/drawingml/2006/main">
               <a:ext uri="{FF2B5EF4-FFF2-40B4-BE49-F238E27FC236}">
-                <a16:creationId xmlns:a16="http://schemas.microsoft.com/office/drawing/2014/main" id="{65FE4F14-8E8C-4FAB-B774-DFCA84BD71F2}"/>
+                <a16:creationId xmlns:a16="http://schemas.microsoft.com/office/drawing/2014/main" id="{F871CA43-FAE6-48F5-8AE5-3E562C9E08D9}"/>
               </a:ext>
             </a:extLst>
           </p:cNvPr>
@@ -21722,7 +21722,7 @@
           <p:cNvPr id="6" name="TextBox 5">
             <a:extLst xmlns:a="http://schemas.openxmlformats.org/drawingml/2006/main">
               <a:ext uri="{FF2B5EF4-FFF2-40B4-BE49-F238E27FC236}">
-                <a16:creationId xmlns:a16="http://schemas.microsoft.com/office/drawing/2014/main" id="{98176D4F-6E17-4D73-BC84-FFB85AC8D6CC}"/>
+                <a16:creationId xmlns:a16="http://schemas.microsoft.com/office/drawing/2014/main" id="{5B2A3152-1DFB-48A9-9CF8-F027155D6C5F}"/>
               </a:ext>
             </a:extLst>
           </p:cNvPr>
@@ -21759,7 +21759,7 @@
                 <a:ea typeface="Aptos"/>
                 <a:cs typeface="Aptos"/>
               </a:rPr>
-              <a:t>Independent public evidence summary · 2026.07.23-10 · 2026-07-22 · Sources: WIPO valuation</a:t>
+              <a:t>Independent public evidence summary · 2026.07.23-11 · 2026-07-22 · Sources: WIPO valuation</a:t>
             </a:r>
           </a:p>
         </p:txBody>
@@ -21769,7 +21769,7 @@
           <p:cNvPr id="7" name="TextBox 6">
             <a:extLst xmlns:a="http://schemas.openxmlformats.org/drawingml/2006/main">
               <a:ext uri="{FF2B5EF4-FFF2-40B4-BE49-F238E27FC236}">
-                <a16:creationId xmlns:a16="http://schemas.microsoft.com/office/drawing/2014/main" id="{5DA579D6-1EE1-4D4A-9DF4-59C9FE3289E1}"/>
+                <a16:creationId xmlns:a16="http://schemas.microsoft.com/office/drawing/2014/main" id="{9ED95BE0-160B-44C4-A47E-21FC4700D611}"/>
               </a:ext>
             </a:extLst>
           </p:cNvPr>
@@ -22502,7 +22502,7 @@
           <p:cNvPr id="9" name="TextBox 8">
             <a:extLst xmlns:a="http://schemas.openxmlformats.org/drawingml/2006/main">
               <a:ext uri="{FF2B5EF4-FFF2-40B4-BE49-F238E27FC236}">
-                <a16:creationId xmlns:a16="http://schemas.microsoft.com/office/drawing/2014/main" id="{B42BCE63-1847-45C0-8BE5-F245557E685B}"/>
+                <a16:creationId xmlns:a16="http://schemas.microsoft.com/office/drawing/2014/main" id="{0361DA06-1ADC-4A0F-8A02-00D7732E05C5}"/>
               </a:ext>
             </a:extLst>
           </p:cNvPr>
@@ -22547,7 +22547,7 @@
     </p:spTree>
     <p:extLst>
       <p:ext uri="{BB962C8B-B14F-4D97-AF65-F5344CB8AC3E}">
-        <p14:creationId xmlns:p14="http://schemas.microsoft.com/office/powerpoint/2010/main" val="1405375829"/>
+        <p14:creationId xmlns:p14="http://schemas.microsoft.com/office/powerpoint/2010/main" val="2123521684"/>
       </p:ext>
     </p:extLst>
   </p:cSld>
@@ -22571,7 +22571,7 @@
           <p:cNvPr id="2" name="TextBox 1">
             <a:extLst xmlns:a="http://schemas.openxmlformats.org/drawingml/2006/main">
               <a:ext uri="{FF2B5EF4-FFF2-40B4-BE49-F238E27FC236}">
-                <a16:creationId xmlns:a16="http://schemas.microsoft.com/office/drawing/2014/main" id="{CE739E78-52E5-4251-B279-2881146437B4}"/>
+                <a16:creationId xmlns:a16="http://schemas.microsoft.com/office/drawing/2014/main" id="{05A8E36D-7966-4BA5-AA85-143BC9F55B61}"/>
               </a:ext>
             </a:extLst>
           </p:cNvPr>
@@ -22618,7 +22618,7 @@
           <p:cNvPr id="3" name="TextBox 2">
             <a:extLst xmlns:a="http://schemas.openxmlformats.org/drawingml/2006/main">
               <a:ext uri="{FF2B5EF4-FFF2-40B4-BE49-F238E27FC236}">
-                <a16:creationId xmlns:a16="http://schemas.microsoft.com/office/drawing/2014/main" id="{5C5FD976-EA75-468D-833F-477F5B1AF458}"/>
+                <a16:creationId xmlns:a16="http://schemas.microsoft.com/office/drawing/2014/main" id="{2260F9A8-F408-4A3C-BF6E-42B0D2E4D72C}"/>
               </a:ext>
             </a:extLst>
           </p:cNvPr>
@@ -22665,7 +22665,7 @@
           <p:cNvPr id="4" name="Rectangle 3">
             <a:extLst xmlns:a="http://schemas.openxmlformats.org/drawingml/2006/main">
               <a:ext uri="{FF2B5EF4-FFF2-40B4-BE49-F238E27FC236}">
-                <a16:creationId xmlns:a16="http://schemas.microsoft.com/office/drawing/2014/main" id="{C623E92F-BCCE-4C09-B4BA-064921740286}"/>
+                <a16:creationId xmlns:a16="http://schemas.microsoft.com/office/drawing/2014/main" id="{14936832-AE4E-4C61-9988-B62ED95D99C8}"/>
               </a:ext>
             </a:extLst>
           </p:cNvPr>
@@ -22720,7 +22720,7 @@
           <p:cNvPr id="5" name="Rectangle 4">
             <a:extLst xmlns:a="http://schemas.openxmlformats.org/drawingml/2006/main">
               <a:ext uri="{FF2B5EF4-FFF2-40B4-BE49-F238E27FC236}">
-                <a16:creationId xmlns:a16="http://schemas.microsoft.com/office/drawing/2014/main" id="{0EE6075F-0159-42BD-8FB6-E1ED96D16E00}"/>
+                <a16:creationId xmlns:a16="http://schemas.microsoft.com/office/drawing/2014/main" id="{408A1DAC-FD42-4E9A-8657-B4753BE6484F}"/>
               </a:ext>
             </a:extLst>
           </p:cNvPr>
@@ -22775,7 +22775,7 @@
           <p:cNvPr id="6" name="TextBox 5">
             <a:extLst xmlns:a="http://schemas.openxmlformats.org/drawingml/2006/main">
               <a:ext uri="{FF2B5EF4-FFF2-40B4-BE49-F238E27FC236}">
-                <a16:creationId xmlns:a16="http://schemas.microsoft.com/office/drawing/2014/main" id="{6C2E195D-0BAE-4821-A054-A043CBE4AD7E}"/>
+                <a16:creationId xmlns:a16="http://schemas.microsoft.com/office/drawing/2014/main" id="{FB90259C-A5C9-4D8D-86BC-1A36F0DBBA11}"/>
               </a:ext>
             </a:extLst>
           </p:cNvPr>
@@ -22812,7 +22812,7 @@
                 <a:ea typeface="Aptos"/>
                 <a:cs typeface="Aptos"/>
               </a:rPr>
-              <a:t>Independent public evidence summary · 2026.07.23-10 · 2026-07-22 · Sources: Evidence Register</a:t>
+              <a:t>Independent public evidence summary · 2026.07.23-11 · 2026-07-22 · Sources: Evidence Register</a:t>
             </a:r>
           </a:p>
         </p:txBody>
@@ -22822,7 +22822,7 @@
           <p:cNvPr id="7" name="TextBox 6">
             <a:extLst xmlns:a="http://schemas.openxmlformats.org/drawingml/2006/main">
               <a:ext uri="{FF2B5EF4-FFF2-40B4-BE49-F238E27FC236}">
-                <a16:creationId xmlns:a16="http://schemas.microsoft.com/office/drawing/2014/main" id="{798243D3-46E4-4F6D-B6D0-DDE7AA9E137D}"/>
+                <a16:creationId xmlns:a16="http://schemas.microsoft.com/office/drawing/2014/main" id="{73A052AA-EB64-4C55-B407-2292A4DC13FA}"/>
               </a:ext>
             </a:extLst>
           </p:cNvPr>
@@ -23392,7 +23392,7 @@
           <p:cNvPr id="9" name="TextBox 8">
             <a:extLst xmlns:a="http://schemas.openxmlformats.org/drawingml/2006/main">
               <a:ext uri="{FF2B5EF4-FFF2-40B4-BE49-F238E27FC236}">
-                <a16:creationId xmlns:a16="http://schemas.microsoft.com/office/drawing/2014/main" id="{68AB7D60-A601-41B5-B446-D8E3C23AF0AF}"/>
+                <a16:creationId xmlns:a16="http://schemas.microsoft.com/office/drawing/2014/main" id="{360ED1FA-7D74-47A3-B0BF-B853CD415B36}"/>
               </a:ext>
             </a:extLst>
           </p:cNvPr>
@@ -23437,7 +23437,7 @@
     </p:spTree>
     <p:extLst>
       <p:ext uri="{BB962C8B-B14F-4D97-AF65-F5344CB8AC3E}">
-        <p14:creationId xmlns:p14="http://schemas.microsoft.com/office/powerpoint/2010/main" val="933218628"/>
+        <p14:creationId xmlns:p14="http://schemas.microsoft.com/office/powerpoint/2010/main" val="598218843"/>
       </p:ext>
     </p:extLst>
   </p:cSld>
@@ -23461,7 +23461,7 @@
           <p:cNvPr id="2" name="TextBox 1">
             <a:extLst xmlns:a="http://schemas.openxmlformats.org/drawingml/2006/main">
               <a:ext uri="{FF2B5EF4-FFF2-40B4-BE49-F238E27FC236}">
-                <a16:creationId xmlns:a16="http://schemas.microsoft.com/office/drawing/2014/main" id="{E7B51426-E870-4728-9925-DEB716EE23CA}"/>
+                <a16:creationId xmlns:a16="http://schemas.microsoft.com/office/drawing/2014/main" id="{8194FAA6-CDE9-437A-AD2D-CE53D72F739A}"/>
               </a:ext>
             </a:extLst>
           </p:cNvPr>
@@ -23508,7 +23508,7 @@
           <p:cNvPr id="3" name="TextBox 2">
             <a:extLst xmlns:a="http://schemas.openxmlformats.org/drawingml/2006/main">
               <a:ext uri="{FF2B5EF4-FFF2-40B4-BE49-F238E27FC236}">
-                <a16:creationId xmlns:a16="http://schemas.microsoft.com/office/drawing/2014/main" id="{348C8034-912C-4B35-9751-B9432C2C913B}"/>
+                <a16:creationId xmlns:a16="http://schemas.microsoft.com/office/drawing/2014/main" id="{5E4E969B-48EF-47E8-B3B3-C617465786F8}"/>
               </a:ext>
             </a:extLst>
           </p:cNvPr>
@@ -23555,7 +23555,7 @@
           <p:cNvPr id="4" name="Rectangle 3">
             <a:extLst xmlns:a="http://schemas.openxmlformats.org/drawingml/2006/main">
               <a:ext uri="{FF2B5EF4-FFF2-40B4-BE49-F238E27FC236}">
-                <a16:creationId xmlns:a16="http://schemas.microsoft.com/office/drawing/2014/main" id="{1D9BCD7B-92EB-43DD-B7F4-FE967F5BE907}"/>
+                <a16:creationId xmlns:a16="http://schemas.microsoft.com/office/drawing/2014/main" id="{A19E5853-8C19-4DD2-9201-A54773D5FF4E}"/>
               </a:ext>
             </a:extLst>
           </p:cNvPr>
@@ -23610,7 +23610,7 @@
           <p:cNvPr id="5" name="Rectangle 4">
             <a:extLst xmlns:a="http://schemas.openxmlformats.org/drawingml/2006/main">
               <a:ext uri="{FF2B5EF4-FFF2-40B4-BE49-F238E27FC236}">
-                <a16:creationId xmlns:a16="http://schemas.microsoft.com/office/drawing/2014/main" id="{AF1F63F0-1A48-432D-908D-3CDDEDB2BB76}"/>
+                <a16:creationId xmlns:a16="http://schemas.microsoft.com/office/drawing/2014/main" id="{F4490E17-BFC1-44F7-8A0B-68CAD50762EE}"/>
               </a:ext>
             </a:extLst>
           </p:cNvPr>
@@ -23665,7 +23665,7 @@
           <p:cNvPr id="6" name="TextBox 5">
             <a:extLst xmlns:a="http://schemas.openxmlformats.org/drawingml/2006/main">
               <a:ext uri="{FF2B5EF4-FFF2-40B4-BE49-F238E27FC236}">
-                <a16:creationId xmlns:a16="http://schemas.microsoft.com/office/drawing/2014/main" id="{57C4E468-03ED-4E21-8154-A68DF39E17A9}"/>
+                <a16:creationId xmlns:a16="http://schemas.microsoft.com/office/drawing/2014/main" id="{26ACB488-9851-4B98-8E6F-30BAD92F2C78}"/>
               </a:ext>
             </a:extLst>
           </p:cNvPr>
@@ -23702,7 +23702,7 @@
                 <a:ea typeface="Aptos"/>
                 <a:cs typeface="Aptos"/>
               </a:rPr>
-              <a:t>Independent public evidence summary · 2026.07.23-10 · 2026-07-22 · Sources: Evidence Register</a:t>
+              <a:t>Independent public evidence summary · 2026.07.23-11 · 2026-07-22 · Sources: Evidence Register</a:t>
             </a:r>
           </a:p>
         </p:txBody>
@@ -23712,7 +23712,7 @@
           <p:cNvPr id="7" name="TextBox 6">
             <a:extLst xmlns:a="http://schemas.openxmlformats.org/drawingml/2006/main">
               <a:ext uri="{FF2B5EF4-FFF2-40B4-BE49-F238E27FC236}">
-                <a16:creationId xmlns:a16="http://schemas.microsoft.com/office/drawing/2014/main" id="{F62273F6-877F-4EE8-9F6F-33CA6710AE5E}"/>
+                <a16:creationId xmlns:a16="http://schemas.microsoft.com/office/drawing/2014/main" id="{A63AF13E-BB96-4067-A2C7-D04B8C49BAB7}"/>
               </a:ext>
             </a:extLst>
           </p:cNvPr>
@@ -24365,7 +24365,7 @@
           <p:cNvPr id="9" name="TextBox 8">
             <a:extLst xmlns:a="http://schemas.openxmlformats.org/drawingml/2006/main">
               <a:ext uri="{FF2B5EF4-FFF2-40B4-BE49-F238E27FC236}">
-                <a16:creationId xmlns:a16="http://schemas.microsoft.com/office/drawing/2014/main" id="{6F842D77-9A27-413A-8022-C7DA46E544BA}"/>
+                <a16:creationId xmlns:a16="http://schemas.microsoft.com/office/drawing/2014/main" id="{8D7D8610-6640-4EAB-A08E-0B9DC47C467F}"/>
               </a:ext>
             </a:extLst>
           </p:cNvPr>
@@ -24410,7 +24410,7 @@
     </p:spTree>
     <p:extLst>
       <p:ext uri="{BB962C8B-B14F-4D97-AF65-F5344CB8AC3E}">
-        <p14:creationId xmlns:p14="http://schemas.microsoft.com/office/powerpoint/2010/main" val="761923218"/>
+        <p14:creationId xmlns:p14="http://schemas.microsoft.com/office/powerpoint/2010/main" val="1832772191"/>
       </p:ext>
     </p:extLst>
   </p:cSld>
@@ -24434,7 +24434,7 @@
           <p:cNvPr id="2" name="TextBox 1">
             <a:extLst xmlns:a="http://schemas.openxmlformats.org/drawingml/2006/main">
               <a:ext uri="{FF2B5EF4-FFF2-40B4-BE49-F238E27FC236}">
-                <a16:creationId xmlns:a16="http://schemas.microsoft.com/office/drawing/2014/main" id="{E931539C-865A-4AE2-A2A6-40AECF85EDAD}"/>
+                <a16:creationId xmlns:a16="http://schemas.microsoft.com/office/drawing/2014/main" id="{A59B6270-A65D-4008-86E8-0EE34DBC9704}"/>
               </a:ext>
             </a:extLst>
           </p:cNvPr>
@@ -24481,7 +24481,7 @@
           <p:cNvPr id="3" name="TextBox 2">
             <a:extLst xmlns:a="http://schemas.openxmlformats.org/drawingml/2006/main">
               <a:ext uri="{FF2B5EF4-FFF2-40B4-BE49-F238E27FC236}">
-                <a16:creationId xmlns:a16="http://schemas.microsoft.com/office/drawing/2014/main" id="{EC356DDA-5572-443C-90AE-E7B9F8EFE20C}"/>
+                <a16:creationId xmlns:a16="http://schemas.microsoft.com/office/drawing/2014/main" id="{A80BBAA0-0473-4E5B-A7F9-88F055BD88BA}"/>
               </a:ext>
             </a:extLst>
           </p:cNvPr>
@@ -24528,7 +24528,7 @@
           <p:cNvPr id="4" name="Rectangle 3">
             <a:extLst xmlns:a="http://schemas.openxmlformats.org/drawingml/2006/main">
               <a:ext uri="{FF2B5EF4-FFF2-40B4-BE49-F238E27FC236}">
-                <a16:creationId xmlns:a16="http://schemas.microsoft.com/office/drawing/2014/main" id="{A67D95BA-C8D0-4C0D-8A27-C58AB3305E41}"/>
+                <a16:creationId xmlns:a16="http://schemas.microsoft.com/office/drawing/2014/main" id="{E428E60E-8F56-4445-94B4-F111550B7568}"/>
               </a:ext>
             </a:extLst>
           </p:cNvPr>
@@ -24583,7 +24583,7 @@
           <p:cNvPr id="5" name="Rectangle 4">
             <a:extLst xmlns:a="http://schemas.openxmlformats.org/drawingml/2006/main">
               <a:ext uri="{FF2B5EF4-FFF2-40B4-BE49-F238E27FC236}">
-                <a16:creationId xmlns:a16="http://schemas.microsoft.com/office/drawing/2014/main" id="{17C2568B-5B65-49EB-A10D-0E783A45490A}"/>
+                <a16:creationId xmlns:a16="http://schemas.microsoft.com/office/drawing/2014/main" id="{F2F992AF-41CA-4F3A-A725-C20BB2355090}"/>
               </a:ext>
             </a:extLst>
           </p:cNvPr>
@@ -24638,7 +24638,7 @@
           <p:cNvPr id="6" name="TextBox 5">
             <a:extLst xmlns:a="http://schemas.openxmlformats.org/drawingml/2006/main">
               <a:ext uri="{FF2B5EF4-FFF2-40B4-BE49-F238E27FC236}">
-                <a16:creationId xmlns:a16="http://schemas.microsoft.com/office/drawing/2014/main" id="{61AC46D3-7578-4E6D-88DC-C0B3089CB2FC}"/>
+                <a16:creationId xmlns:a16="http://schemas.microsoft.com/office/drawing/2014/main" id="{B75877EA-B467-4E5C-8409-614ACAD27207}"/>
               </a:ext>
             </a:extLst>
           </p:cNvPr>
@@ -24675,7 +24675,7 @@
                 <a:ea typeface="Aptos"/>
                 <a:cs typeface="Aptos"/>
               </a:rPr>
-              <a:t>Independent public evidence summary · 2026.07.23-10 · 2026-07-22 · Sources: Evidence Register; changelog</a:t>
+              <a:t>Independent public evidence summary · 2026.07.23-11 · 2026-07-22 · Sources: Evidence Register; changelog</a:t>
             </a:r>
           </a:p>
         </p:txBody>
@@ -24685,7 +24685,7 @@
           <p:cNvPr id="7" name="TextBox 6">
             <a:extLst xmlns:a="http://schemas.openxmlformats.org/drawingml/2006/main">
               <a:ext uri="{FF2B5EF4-FFF2-40B4-BE49-F238E27FC236}">
-                <a16:creationId xmlns:a16="http://schemas.microsoft.com/office/drawing/2014/main" id="{A5C754B4-9B99-4E21-BFC1-E3256B11E71B}"/>
+                <a16:creationId xmlns:a16="http://schemas.microsoft.com/office/drawing/2014/main" id="{EF3A7EBF-39EE-40F5-A4E0-5802DD0751F6}"/>
               </a:ext>
             </a:extLst>
           </p:cNvPr>
@@ -24732,7 +24732,7 @@
           <p:cNvPr id="8" name="Rounded Rectangle 7">
             <a:extLst xmlns:a="http://schemas.openxmlformats.org/drawingml/2006/main">
               <a:ext uri="{FF2B5EF4-FFF2-40B4-BE49-F238E27FC236}">
-                <a16:creationId xmlns:a16="http://schemas.microsoft.com/office/drawing/2014/main" id="{77A32934-8478-4732-97FD-3836F3209768}"/>
+                <a16:creationId xmlns:a16="http://schemas.microsoft.com/office/drawing/2014/main" id="{395BD401-6BF7-4DBC-818D-A5515042431F}"/>
               </a:ext>
             </a:extLst>
           </p:cNvPr>
@@ -24789,7 +24789,7 @@
           <p:cNvPr id="9" name="TextBox 8">
             <a:extLst xmlns:a="http://schemas.openxmlformats.org/drawingml/2006/main">
               <a:ext uri="{FF2B5EF4-FFF2-40B4-BE49-F238E27FC236}">
-                <a16:creationId xmlns:a16="http://schemas.microsoft.com/office/drawing/2014/main" id="{9101AB6F-703A-4D5C-90EA-D382780A6FA9}"/>
+                <a16:creationId xmlns:a16="http://schemas.microsoft.com/office/drawing/2014/main" id="{F88DF643-BB1E-458B-9C24-4413EC1EEC71}"/>
               </a:ext>
             </a:extLst>
           </p:cNvPr>
@@ -24836,7 +24836,7 @@
           <p:cNvPr id="10" name="TextBox 9">
             <a:extLst xmlns:a="http://schemas.openxmlformats.org/drawingml/2006/main">
               <a:ext uri="{FF2B5EF4-FFF2-40B4-BE49-F238E27FC236}">
-                <a16:creationId xmlns:a16="http://schemas.microsoft.com/office/drawing/2014/main" id="{910751A1-7DC7-4D08-9084-B4FD379AD980}"/>
+                <a16:creationId xmlns:a16="http://schemas.microsoft.com/office/drawing/2014/main" id="{C62B2C4D-9340-4EEB-9925-9C2A74818109}"/>
               </a:ext>
             </a:extLst>
           </p:cNvPr>
@@ -24883,7 +24883,7 @@
           <p:cNvPr id="11" name="TextBox 10">
             <a:extLst xmlns:a="http://schemas.openxmlformats.org/drawingml/2006/main">
               <a:ext uri="{FF2B5EF4-FFF2-40B4-BE49-F238E27FC236}">
-                <a16:creationId xmlns:a16="http://schemas.microsoft.com/office/drawing/2014/main" id="{DC4282B3-B638-430E-B5B7-06917F72187E}"/>
+                <a16:creationId xmlns:a16="http://schemas.microsoft.com/office/drawing/2014/main" id="{BDC2F6E7-E0F4-4493-88CF-0B16B0716793}"/>
               </a:ext>
             </a:extLst>
           </p:cNvPr>
@@ -24930,7 +24930,7 @@
           <p:cNvPr id="12" name="Rounded Rectangle 11">
             <a:extLst xmlns:a="http://schemas.openxmlformats.org/drawingml/2006/main">
               <a:ext uri="{FF2B5EF4-FFF2-40B4-BE49-F238E27FC236}">
-                <a16:creationId xmlns:a16="http://schemas.microsoft.com/office/drawing/2014/main" id="{0F8F0269-6A2B-42F0-88FA-53F9E9A1A9DD}"/>
+                <a16:creationId xmlns:a16="http://schemas.microsoft.com/office/drawing/2014/main" id="{00315D0B-7D07-4F8D-B5BB-23D9D5FED1AA}"/>
               </a:ext>
             </a:extLst>
           </p:cNvPr>
@@ -24987,7 +24987,7 @@
           <p:cNvPr id="13" name="TextBox 12">
             <a:extLst xmlns:a="http://schemas.openxmlformats.org/drawingml/2006/main">
               <a:ext uri="{FF2B5EF4-FFF2-40B4-BE49-F238E27FC236}">
-                <a16:creationId xmlns:a16="http://schemas.microsoft.com/office/drawing/2014/main" id="{6178299B-6D0B-4500-A379-543E50F107F4}"/>
+                <a16:creationId xmlns:a16="http://schemas.microsoft.com/office/drawing/2014/main" id="{B4597F82-5BA3-4E8F-B84F-DBDDEE6D617F}"/>
               </a:ext>
             </a:extLst>
           </p:cNvPr>
@@ -25034,7 +25034,7 @@
           <p:cNvPr id="14" name="TextBox 13">
             <a:extLst xmlns:a="http://schemas.openxmlformats.org/drawingml/2006/main">
               <a:ext uri="{FF2B5EF4-FFF2-40B4-BE49-F238E27FC236}">
-                <a16:creationId xmlns:a16="http://schemas.microsoft.com/office/drawing/2014/main" id="{399D9A65-C244-4D6C-8DEB-8639133D87FD}"/>
+                <a16:creationId xmlns:a16="http://schemas.microsoft.com/office/drawing/2014/main" id="{3646E6A2-C3AD-48CF-A8E7-62C0B211E182}"/>
               </a:ext>
             </a:extLst>
           </p:cNvPr>
@@ -25081,7 +25081,7 @@
           <p:cNvPr id="15" name="TextBox 14">
             <a:extLst xmlns:a="http://schemas.openxmlformats.org/drawingml/2006/main">
               <a:ext uri="{FF2B5EF4-FFF2-40B4-BE49-F238E27FC236}">
-                <a16:creationId xmlns:a16="http://schemas.microsoft.com/office/drawing/2014/main" id="{F77D1CB0-3153-42F5-81BD-75C9C191E3EA}"/>
+                <a16:creationId xmlns:a16="http://schemas.microsoft.com/office/drawing/2014/main" id="{0B86C2C6-5EA0-4394-9994-68AAE5F73141}"/>
               </a:ext>
             </a:extLst>
           </p:cNvPr>
@@ -25128,7 +25128,7 @@
           <p:cNvPr id="16" name="Rounded Rectangle 15">
             <a:extLst xmlns:a="http://schemas.openxmlformats.org/drawingml/2006/main">
               <a:ext uri="{FF2B5EF4-FFF2-40B4-BE49-F238E27FC236}">
-                <a16:creationId xmlns:a16="http://schemas.microsoft.com/office/drawing/2014/main" id="{449E57A4-AFC9-44E9-9C00-EF0A5DE0E2DB}"/>
+                <a16:creationId xmlns:a16="http://schemas.microsoft.com/office/drawing/2014/main" id="{D3D48DBF-59B0-4145-9566-F0BB7FFFEFEF}"/>
               </a:ext>
             </a:extLst>
           </p:cNvPr>
@@ -25185,7 +25185,7 @@
           <p:cNvPr id="17" name="TextBox 16">
             <a:extLst xmlns:a="http://schemas.openxmlformats.org/drawingml/2006/main">
               <a:ext uri="{FF2B5EF4-FFF2-40B4-BE49-F238E27FC236}">
-                <a16:creationId xmlns:a16="http://schemas.microsoft.com/office/drawing/2014/main" id="{AFC6793B-69A5-46C0-B1C3-518840C7BA36}"/>
+                <a16:creationId xmlns:a16="http://schemas.microsoft.com/office/drawing/2014/main" id="{DD56108B-4AC3-4F2C-8693-F779BC10DBFC}"/>
               </a:ext>
             </a:extLst>
           </p:cNvPr>
@@ -25232,7 +25232,7 @@
           <p:cNvPr id="18" name="TextBox 17">
             <a:extLst xmlns:a="http://schemas.openxmlformats.org/drawingml/2006/main">
               <a:ext uri="{FF2B5EF4-FFF2-40B4-BE49-F238E27FC236}">
-                <a16:creationId xmlns:a16="http://schemas.microsoft.com/office/drawing/2014/main" id="{3369C1C1-76AF-497F-8E2B-68E913E0F6B7}"/>
+                <a16:creationId xmlns:a16="http://schemas.microsoft.com/office/drawing/2014/main" id="{DA17D484-E617-4AFE-938F-EB0DD8AA3A31}"/>
               </a:ext>
             </a:extLst>
           </p:cNvPr>
@@ -25279,7 +25279,7 @@
           <p:cNvPr id="19" name="TextBox 18">
             <a:extLst xmlns:a="http://schemas.openxmlformats.org/drawingml/2006/main">
               <a:ext uri="{FF2B5EF4-FFF2-40B4-BE49-F238E27FC236}">
-                <a16:creationId xmlns:a16="http://schemas.microsoft.com/office/drawing/2014/main" id="{299BBD7E-5DEB-42B9-B730-4F4AA3D453A6}"/>
+                <a16:creationId xmlns:a16="http://schemas.microsoft.com/office/drawing/2014/main" id="{BDEFE6E8-29A4-4C34-9EC6-3B977BB46322}"/>
               </a:ext>
             </a:extLst>
           </p:cNvPr>
@@ -25326,7 +25326,7 @@
           <p:cNvPr id="20" name="Rounded Rectangle 19">
             <a:extLst xmlns:a="http://schemas.openxmlformats.org/drawingml/2006/main">
               <a:ext uri="{FF2B5EF4-FFF2-40B4-BE49-F238E27FC236}">
-                <a16:creationId xmlns:a16="http://schemas.microsoft.com/office/drawing/2014/main" id="{03E5F1DF-ECF4-416E-BADD-E9F18722A223}"/>
+                <a16:creationId xmlns:a16="http://schemas.microsoft.com/office/drawing/2014/main" id="{8CE8FD36-8F64-4C9C-AE1B-020B9D8AAA0D}"/>
               </a:ext>
             </a:extLst>
           </p:cNvPr>
@@ -25383,7 +25383,7 @@
           <p:cNvPr id="21" name="TextBox 20">
             <a:extLst xmlns:a="http://schemas.openxmlformats.org/drawingml/2006/main">
               <a:ext uri="{FF2B5EF4-FFF2-40B4-BE49-F238E27FC236}">
-                <a16:creationId xmlns:a16="http://schemas.microsoft.com/office/drawing/2014/main" id="{ECD7C601-3F12-46C2-8EC9-ABD7CC47B478}"/>
+                <a16:creationId xmlns:a16="http://schemas.microsoft.com/office/drawing/2014/main" id="{D85E8CB7-0949-40C5-940E-AE9DCE9FC6D6}"/>
               </a:ext>
             </a:extLst>
           </p:cNvPr>
@@ -25430,7 +25430,7 @@
           <p:cNvPr id="22" name="TextBox 21">
             <a:extLst xmlns:a="http://schemas.openxmlformats.org/drawingml/2006/main">
               <a:ext uri="{FF2B5EF4-FFF2-40B4-BE49-F238E27FC236}">
-                <a16:creationId xmlns:a16="http://schemas.microsoft.com/office/drawing/2014/main" id="{DEBDE6D6-23C0-4484-BD56-C7E4E4BC25FC}"/>
+                <a16:creationId xmlns:a16="http://schemas.microsoft.com/office/drawing/2014/main" id="{14B56330-1A7E-42FD-BD76-FF9BBE12AF53}"/>
               </a:ext>
             </a:extLst>
           </p:cNvPr>
@@ -25477,7 +25477,7 @@
           <p:cNvPr id="23" name="TextBox 22">
             <a:extLst xmlns:a="http://schemas.openxmlformats.org/drawingml/2006/main">
               <a:ext uri="{FF2B5EF4-FFF2-40B4-BE49-F238E27FC236}">
-                <a16:creationId xmlns:a16="http://schemas.microsoft.com/office/drawing/2014/main" id="{CAB7B1A1-A6B9-430F-AFA8-C2493BD754B6}"/>
+                <a16:creationId xmlns:a16="http://schemas.microsoft.com/office/drawing/2014/main" id="{7183EFBF-514E-41E7-9438-DC8F463BEAF0}"/>
               </a:ext>
             </a:extLst>
           </p:cNvPr>
@@ -25524,7 +25524,7 @@
           <p:cNvPr id="24" name="TextBox 23">
             <a:extLst xmlns:a="http://schemas.openxmlformats.org/drawingml/2006/main">
               <a:ext uri="{FF2B5EF4-FFF2-40B4-BE49-F238E27FC236}">
-                <a16:creationId xmlns:a16="http://schemas.microsoft.com/office/drawing/2014/main" id="{8234CC30-EF4B-4418-A8BE-68CE82B3D4FC}"/>
+                <a16:creationId xmlns:a16="http://schemas.microsoft.com/office/drawing/2014/main" id="{AC74D571-2963-4D2F-B7B2-3165593DAD27}"/>
               </a:ext>
             </a:extLst>
           </p:cNvPr>
@@ -25569,7 +25569,7 @@
     </p:spTree>
     <p:extLst>
       <p:ext uri="{BB962C8B-B14F-4D97-AF65-F5344CB8AC3E}">
-        <p14:creationId xmlns:p14="http://schemas.microsoft.com/office/powerpoint/2010/main" val="1801416930"/>
+        <p14:creationId xmlns:p14="http://schemas.microsoft.com/office/powerpoint/2010/main" val="614676180"/>
       </p:ext>
     </p:extLst>
   </p:cSld>
@@ -25593,7 +25593,7 @@
           <p:cNvPr id="2" name="TextBox 1">
             <a:extLst xmlns:a="http://schemas.openxmlformats.org/drawingml/2006/main">
               <a:ext uri="{FF2B5EF4-FFF2-40B4-BE49-F238E27FC236}">
-                <a16:creationId xmlns:a16="http://schemas.microsoft.com/office/drawing/2014/main" id="{DC39BE08-B519-44DD-A47D-4CA5CAC9A9CA}"/>
+                <a16:creationId xmlns:a16="http://schemas.microsoft.com/office/drawing/2014/main" id="{78760961-E911-4AF3-B277-45EC35685D2B}"/>
               </a:ext>
             </a:extLst>
           </p:cNvPr>
@@ -25640,7 +25640,7 @@
           <p:cNvPr id="3" name="TextBox 2">
             <a:extLst xmlns:a="http://schemas.openxmlformats.org/drawingml/2006/main">
               <a:ext uri="{FF2B5EF4-FFF2-40B4-BE49-F238E27FC236}">
-                <a16:creationId xmlns:a16="http://schemas.microsoft.com/office/drawing/2014/main" id="{E5187957-0F8B-475D-828C-812872F405A4}"/>
+                <a16:creationId xmlns:a16="http://schemas.microsoft.com/office/drawing/2014/main" id="{61D8D4A6-D7AD-42FA-9E0E-59196D5A29B4}"/>
               </a:ext>
             </a:extLst>
           </p:cNvPr>
@@ -25687,7 +25687,7 @@
           <p:cNvPr id="4" name="Rectangle 3">
             <a:extLst xmlns:a="http://schemas.openxmlformats.org/drawingml/2006/main">
               <a:ext uri="{FF2B5EF4-FFF2-40B4-BE49-F238E27FC236}">
-                <a16:creationId xmlns:a16="http://schemas.microsoft.com/office/drawing/2014/main" id="{0CC31C4B-B453-429E-8A24-C588A437E82E}"/>
+                <a16:creationId xmlns:a16="http://schemas.microsoft.com/office/drawing/2014/main" id="{FFE82029-48AC-4598-9EA2-2814FF94B2DA}"/>
               </a:ext>
             </a:extLst>
           </p:cNvPr>
@@ -25742,7 +25742,7 @@
           <p:cNvPr id="5" name="Rectangle 4">
             <a:extLst xmlns:a="http://schemas.openxmlformats.org/drawingml/2006/main">
               <a:ext uri="{FF2B5EF4-FFF2-40B4-BE49-F238E27FC236}">
-                <a16:creationId xmlns:a16="http://schemas.microsoft.com/office/drawing/2014/main" id="{B69B8470-C7A9-433C-9010-4C4B79E30D1E}"/>
+                <a16:creationId xmlns:a16="http://schemas.microsoft.com/office/drawing/2014/main" id="{2F8F74DF-EE62-4A45-81C1-EE80FC9DF169}"/>
               </a:ext>
             </a:extLst>
           </p:cNvPr>
@@ -25797,7 +25797,7 @@
           <p:cNvPr id="6" name="TextBox 5">
             <a:extLst xmlns:a="http://schemas.openxmlformats.org/drawingml/2006/main">
               <a:ext uri="{FF2B5EF4-FFF2-40B4-BE49-F238E27FC236}">
-                <a16:creationId xmlns:a16="http://schemas.microsoft.com/office/drawing/2014/main" id="{C06CCDDB-CB84-4A6D-B3DD-8A05A0E856D4}"/>
+                <a16:creationId xmlns:a16="http://schemas.microsoft.com/office/drawing/2014/main" id="{7004082C-EFED-41E7-B0DF-EA1D0460DE38}"/>
               </a:ext>
             </a:extLst>
           </p:cNvPr>
@@ -25834,7 +25834,7 @@
                 <a:ea typeface="Aptos"/>
                 <a:cs typeface="Aptos"/>
               </a:rPr>
-              <a:t>Independent public evidence summary · 2026.07.23-10 · 2026-07-22 · Sources: EPO; 8 Ni 18/24 (EP); 7 O 3341/24</a:t>
+              <a:t>Independent public evidence summary · 2026.07.23-11 · 2026-07-22 · Sources: EPO; 8 Ni 18/24 (EP); 7 O 3341/24</a:t>
             </a:r>
           </a:p>
         </p:txBody>
@@ -25844,7 +25844,7 @@
           <p:cNvPr id="7" name="TextBox 6">
             <a:extLst xmlns:a="http://schemas.openxmlformats.org/drawingml/2006/main">
               <a:ext uri="{FF2B5EF4-FFF2-40B4-BE49-F238E27FC236}">
-                <a16:creationId xmlns:a16="http://schemas.microsoft.com/office/drawing/2014/main" id="{4192D5BE-BB41-451D-A629-B2996F631506}"/>
+                <a16:creationId xmlns:a16="http://schemas.microsoft.com/office/drawing/2014/main" id="{274F9216-553B-4698-AB29-36700FDB5984}"/>
               </a:ext>
             </a:extLst>
           </p:cNvPr>
@@ -26248,7 +26248,7 @@
           <p:cNvPr id="9" name="TextBox 8">
             <a:extLst xmlns:a="http://schemas.openxmlformats.org/drawingml/2006/main">
               <a:ext uri="{FF2B5EF4-FFF2-40B4-BE49-F238E27FC236}">
-                <a16:creationId xmlns:a16="http://schemas.microsoft.com/office/drawing/2014/main" id="{55944AB8-4A44-4244-85D4-A73FE2CD687B}"/>
+                <a16:creationId xmlns:a16="http://schemas.microsoft.com/office/drawing/2014/main" id="{0787AD0B-87EE-4E2D-99F8-4DAE4388472F}"/>
               </a:ext>
             </a:extLst>
           </p:cNvPr>
@@ -26293,7 +26293,7 @@
     </p:spTree>
     <p:extLst>
       <p:ext uri="{BB962C8B-B14F-4D97-AF65-F5344CB8AC3E}">
-        <p14:creationId xmlns:p14="http://schemas.microsoft.com/office/powerpoint/2010/main" val="784500770"/>
+        <p14:creationId xmlns:p14="http://schemas.microsoft.com/office/powerpoint/2010/main" val="1571552174"/>
       </p:ext>
     </p:extLst>
   </p:cSld>
@@ -26324,7 +26324,7 @@
           <p:cNvPr id="2" name="TextBox 1">
             <a:extLst xmlns:a="http://schemas.openxmlformats.org/drawingml/2006/main">
               <a:ext uri="{FF2B5EF4-FFF2-40B4-BE49-F238E27FC236}">
-                <a16:creationId xmlns:a16="http://schemas.microsoft.com/office/drawing/2014/main" id="{B5B2249B-2272-42D2-BCA8-B652BFB2C205}"/>
+                <a16:creationId xmlns:a16="http://schemas.microsoft.com/office/drawing/2014/main" id="{3A005910-8C16-4E24-AFDF-ED81E1C5CCF9}"/>
               </a:ext>
             </a:extLst>
           </p:cNvPr>
@@ -26371,7 +26371,7 @@
           <p:cNvPr id="3" name="TextBox 2">
             <a:extLst xmlns:a="http://schemas.openxmlformats.org/drawingml/2006/main">
               <a:ext uri="{FF2B5EF4-FFF2-40B4-BE49-F238E27FC236}">
-                <a16:creationId xmlns:a16="http://schemas.microsoft.com/office/drawing/2014/main" id="{CC73BFCA-22C6-4D9C-B837-FDDC18A8E441}"/>
+                <a16:creationId xmlns:a16="http://schemas.microsoft.com/office/drawing/2014/main" id="{209A8C62-2AA7-469C-9940-88570A605096}"/>
               </a:ext>
             </a:extLst>
           </p:cNvPr>
@@ -26418,7 +26418,7 @@
           <p:cNvPr id="4" name="TextBox 3">
             <a:extLst xmlns:a="http://schemas.openxmlformats.org/drawingml/2006/main">
               <a:ext uri="{FF2B5EF4-FFF2-40B4-BE49-F238E27FC236}">
-                <a16:creationId xmlns:a16="http://schemas.microsoft.com/office/drawing/2014/main" id="{2BD646D0-2301-48CC-B199-BEDB02185563}"/>
+                <a16:creationId xmlns:a16="http://schemas.microsoft.com/office/drawing/2014/main" id="{28C98103-4746-4F41-B8CD-076EDA58D87E}"/>
               </a:ext>
             </a:extLst>
           </p:cNvPr>
@@ -26537,7 +26537,7 @@
           <p:cNvPr id="5" name="TextBox 4">
             <a:extLst xmlns:a="http://schemas.openxmlformats.org/drawingml/2006/main">
               <a:ext uri="{FF2B5EF4-FFF2-40B4-BE49-F238E27FC236}">
-                <a16:creationId xmlns:a16="http://schemas.microsoft.com/office/drawing/2014/main" id="{9D441880-4F9A-4B1C-BE63-D0EB9F821E6D}"/>
+                <a16:creationId xmlns:a16="http://schemas.microsoft.com/office/drawing/2014/main" id="{FEE95406-293C-4CBA-A777-AA4551D3EE16}"/>
               </a:ext>
             </a:extLst>
           </p:cNvPr>
@@ -26574,7 +26574,7 @@
                 <a:ea typeface="Aptos"/>
                 <a:cs typeface="Aptos"/>
               </a:rPr>
-              <a:t>Version 2026.07.23-10 · 2026-07-22 · 30 / 30</a:t>
+              <a:t>Version 2026.07.23-11 · 2026-07-22 · 30 / 30</a:t>
             </a:r>
           </a:p>
         </p:txBody>
@@ -26582,7 +26582,7 @@
     </p:spTree>
     <p:extLst>
       <p:ext uri="{BB962C8B-B14F-4D97-AF65-F5344CB8AC3E}">
-        <p14:creationId xmlns:p14="http://schemas.microsoft.com/office/powerpoint/2010/main" val="733978074"/>
+        <p14:creationId xmlns:p14="http://schemas.microsoft.com/office/powerpoint/2010/main" val="422308769"/>
       </p:ext>
     </p:extLst>
   </p:cSld>
@@ -26606,7 +26606,7 @@
           <p:cNvPr id="2" name="TextBox 1">
             <a:extLst xmlns:a="http://schemas.openxmlformats.org/drawingml/2006/main">
               <a:ext uri="{FF2B5EF4-FFF2-40B4-BE49-F238E27FC236}">
-                <a16:creationId xmlns:a16="http://schemas.microsoft.com/office/drawing/2014/main" id="{5FECF78C-1179-40F2-B719-C1D03A470910}"/>
+                <a16:creationId xmlns:a16="http://schemas.microsoft.com/office/drawing/2014/main" id="{4E635081-7A0D-4278-B4B8-70DD0C765518}"/>
               </a:ext>
             </a:extLst>
           </p:cNvPr>
@@ -26653,7 +26653,7 @@
           <p:cNvPr id="3" name="TextBox 2">
             <a:extLst xmlns:a="http://schemas.openxmlformats.org/drawingml/2006/main">
               <a:ext uri="{FF2B5EF4-FFF2-40B4-BE49-F238E27FC236}">
-                <a16:creationId xmlns:a16="http://schemas.microsoft.com/office/drawing/2014/main" id="{6AD31A2B-F6FC-4AE8-A091-9C8AEDDBEFE7}"/>
+                <a16:creationId xmlns:a16="http://schemas.microsoft.com/office/drawing/2014/main" id="{79885DA3-AD3D-4AF5-B7EA-E8BF2A8BE215}"/>
               </a:ext>
             </a:extLst>
           </p:cNvPr>
@@ -26700,7 +26700,7 @@
           <p:cNvPr id="4" name="Rectangle 3">
             <a:extLst xmlns:a="http://schemas.openxmlformats.org/drawingml/2006/main">
               <a:ext uri="{FF2B5EF4-FFF2-40B4-BE49-F238E27FC236}">
-                <a16:creationId xmlns:a16="http://schemas.microsoft.com/office/drawing/2014/main" id="{9A7563BD-49C0-40BE-922B-F42B247E79EF}"/>
+                <a16:creationId xmlns:a16="http://schemas.microsoft.com/office/drawing/2014/main" id="{60CB3F49-F142-4BEB-A24C-89BBD3DFA588}"/>
               </a:ext>
             </a:extLst>
           </p:cNvPr>
@@ -26755,7 +26755,7 @@
           <p:cNvPr id="5" name="Rectangle 4">
             <a:extLst xmlns:a="http://schemas.openxmlformats.org/drawingml/2006/main">
               <a:ext uri="{FF2B5EF4-FFF2-40B4-BE49-F238E27FC236}">
-                <a16:creationId xmlns:a16="http://schemas.microsoft.com/office/drawing/2014/main" id="{53246B55-0A5F-4593-B902-468A597EAB5C}"/>
+                <a16:creationId xmlns:a16="http://schemas.microsoft.com/office/drawing/2014/main" id="{77736D4E-32AF-43E8-901D-7712F41BD953}"/>
               </a:ext>
             </a:extLst>
           </p:cNvPr>
@@ -26810,7 +26810,7 @@
           <p:cNvPr id="6" name="TextBox 5">
             <a:extLst xmlns:a="http://schemas.openxmlformats.org/drawingml/2006/main">
               <a:ext uri="{FF2B5EF4-FFF2-40B4-BE49-F238E27FC236}">
-                <a16:creationId xmlns:a16="http://schemas.microsoft.com/office/drawing/2014/main" id="{75B78308-67CD-494B-B3C3-821875554D8B}"/>
+                <a16:creationId xmlns:a16="http://schemas.microsoft.com/office/drawing/2014/main" id="{5CBFCEA7-2037-4427-8518-14CA945E899C}"/>
               </a:ext>
             </a:extLst>
           </p:cNvPr>
@@ -26847,7 +26847,7 @@
                 <a:ea typeface="Aptos"/>
                 <a:cs typeface="Aptos"/>
               </a:rPr>
-              <a:t>Independent public evidence summary · 2026.07.23-10 · 2026-07-22 · Sources: Evidence Register; WIPO</a:t>
+              <a:t>Independent public evidence summary · 2026.07.23-11 · 2026-07-22 · Sources: Evidence Register; WIPO</a:t>
             </a:r>
           </a:p>
         </p:txBody>
@@ -26857,7 +26857,7 @@
           <p:cNvPr id="7" name="TextBox 6">
             <a:extLst xmlns:a="http://schemas.openxmlformats.org/drawingml/2006/main">
               <a:ext uri="{FF2B5EF4-FFF2-40B4-BE49-F238E27FC236}">
-                <a16:creationId xmlns:a16="http://schemas.microsoft.com/office/drawing/2014/main" id="{493339A3-1E23-495C-B193-D4A359EB7FBF}"/>
+                <a16:creationId xmlns:a16="http://schemas.microsoft.com/office/drawing/2014/main" id="{F59AC8B2-96B7-4ED0-AA3A-614F4EF53471}"/>
               </a:ext>
             </a:extLst>
           </p:cNvPr>
@@ -26904,7 +26904,7 @@
           <p:cNvPr id="8" name="TextBox 7">
             <a:extLst xmlns:a="http://schemas.openxmlformats.org/drawingml/2006/main">
               <a:ext uri="{FF2B5EF4-FFF2-40B4-BE49-F238E27FC236}">
-                <a16:creationId xmlns:a16="http://schemas.microsoft.com/office/drawing/2014/main" id="{495FD5D9-0ABD-451D-8352-F79A243B69AE}"/>
+                <a16:creationId xmlns:a16="http://schemas.microsoft.com/office/drawing/2014/main" id="{C701EE16-8E61-4689-AE89-8D2F9EB5EB2F}"/>
               </a:ext>
             </a:extLst>
           </p:cNvPr>
@@ -26951,7 +26951,7 @@
           <p:cNvPr id="9" name="TextBox 8">
             <a:extLst xmlns:a="http://schemas.openxmlformats.org/drawingml/2006/main">
               <a:ext uri="{FF2B5EF4-FFF2-40B4-BE49-F238E27FC236}">
-                <a16:creationId xmlns:a16="http://schemas.microsoft.com/office/drawing/2014/main" id="{B907D7DC-BB2D-4460-A829-59073B7EE2B7}"/>
+                <a16:creationId xmlns:a16="http://schemas.microsoft.com/office/drawing/2014/main" id="{0E90DFFD-8BA4-43DB-ADDA-1670B74AF69D}"/>
               </a:ext>
             </a:extLst>
           </p:cNvPr>
@@ -27048,7 +27048,7 @@
           <p:cNvPr id="10" name="Rounded Rectangle 9">
             <a:extLst xmlns:a="http://schemas.openxmlformats.org/drawingml/2006/main">
               <a:ext uri="{FF2B5EF4-FFF2-40B4-BE49-F238E27FC236}">
-                <a16:creationId xmlns:a16="http://schemas.microsoft.com/office/drawing/2014/main" id="{4105B759-5F80-4C27-B8D9-18903AAD65EF}"/>
+                <a16:creationId xmlns:a16="http://schemas.microsoft.com/office/drawing/2014/main" id="{1A781E5E-EE71-4772-BBC2-F2FE0F63AA6F}"/>
               </a:ext>
             </a:extLst>
           </p:cNvPr>
@@ -27105,7 +27105,7 @@
           <p:cNvPr id="11" name="TextBox 10">
             <a:extLst xmlns:a="http://schemas.openxmlformats.org/drawingml/2006/main">
               <a:ext uri="{FF2B5EF4-FFF2-40B4-BE49-F238E27FC236}">
-                <a16:creationId xmlns:a16="http://schemas.microsoft.com/office/drawing/2014/main" id="{22725A3C-5159-46E7-A117-676FF2941687}"/>
+                <a16:creationId xmlns:a16="http://schemas.microsoft.com/office/drawing/2014/main" id="{1539F997-4042-4193-AB5F-45999BFDDE3C}"/>
               </a:ext>
             </a:extLst>
           </p:cNvPr>
@@ -27152,7 +27152,7 @@
           <p:cNvPr id="12" name="TextBox 11">
             <a:extLst xmlns:a="http://schemas.openxmlformats.org/drawingml/2006/main">
               <a:ext uri="{FF2B5EF4-FFF2-40B4-BE49-F238E27FC236}">
-                <a16:creationId xmlns:a16="http://schemas.microsoft.com/office/drawing/2014/main" id="{46C060C8-6E84-4A13-BA03-049B4EA4401F}"/>
+                <a16:creationId xmlns:a16="http://schemas.microsoft.com/office/drawing/2014/main" id="{323140A7-4C9A-4282-9626-8327DCD3FE01}"/>
               </a:ext>
             </a:extLst>
           </p:cNvPr>
@@ -27197,7 +27197,7 @@
     </p:spTree>
     <p:extLst>
       <p:ext uri="{BB962C8B-B14F-4D97-AF65-F5344CB8AC3E}">
-        <p14:creationId xmlns:p14="http://schemas.microsoft.com/office/powerpoint/2010/main" val="602478147"/>
+        <p14:creationId xmlns:p14="http://schemas.microsoft.com/office/powerpoint/2010/main" val="998931108"/>
       </p:ext>
     </p:extLst>
   </p:cSld>
@@ -27221,7 +27221,7 @@
           <p:cNvPr id="2" name="TextBox 1">
             <a:extLst xmlns:a="http://schemas.openxmlformats.org/drawingml/2006/main">
               <a:ext uri="{FF2B5EF4-FFF2-40B4-BE49-F238E27FC236}">
-                <a16:creationId xmlns:a16="http://schemas.microsoft.com/office/drawing/2014/main" id="{C5714E1E-0512-44CD-BF26-784B04CFE888}"/>
+                <a16:creationId xmlns:a16="http://schemas.microsoft.com/office/drawing/2014/main" id="{F9953B55-F6D3-4B96-A011-5D965A0BDF64}"/>
               </a:ext>
             </a:extLst>
           </p:cNvPr>
@@ -27268,7 +27268,7 @@
           <p:cNvPr id="3" name="TextBox 2">
             <a:extLst xmlns:a="http://schemas.openxmlformats.org/drawingml/2006/main">
               <a:ext uri="{FF2B5EF4-FFF2-40B4-BE49-F238E27FC236}">
-                <a16:creationId xmlns:a16="http://schemas.microsoft.com/office/drawing/2014/main" id="{63F41A78-85FD-4FE6-8014-CD73FD9A6598}"/>
+                <a16:creationId xmlns:a16="http://schemas.microsoft.com/office/drawing/2014/main" id="{A0D0DF53-06E9-40A7-9F99-76931A5BAC18}"/>
               </a:ext>
             </a:extLst>
           </p:cNvPr>
@@ -27315,7 +27315,7 @@
           <p:cNvPr id="4" name="Rectangle 3">
             <a:extLst xmlns:a="http://schemas.openxmlformats.org/drawingml/2006/main">
               <a:ext uri="{FF2B5EF4-FFF2-40B4-BE49-F238E27FC236}">
-                <a16:creationId xmlns:a16="http://schemas.microsoft.com/office/drawing/2014/main" id="{9B113DC3-B82A-4218-B5F9-D986A39FA302}"/>
+                <a16:creationId xmlns:a16="http://schemas.microsoft.com/office/drawing/2014/main" id="{FC2D1C3F-234D-4A99-95C2-E3C4F5959A4A}"/>
               </a:ext>
             </a:extLst>
           </p:cNvPr>
@@ -27370,7 +27370,7 @@
           <p:cNvPr id="5" name="Rectangle 4">
             <a:extLst xmlns:a="http://schemas.openxmlformats.org/drawingml/2006/main">
               <a:ext uri="{FF2B5EF4-FFF2-40B4-BE49-F238E27FC236}">
-                <a16:creationId xmlns:a16="http://schemas.microsoft.com/office/drawing/2014/main" id="{629F77FC-796F-4D3F-A0CA-84CD24136EBD}"/>
+                <a16:creationId xmlns:a16="http://schemas.microsoft.com/office/drawing/2014/main" id="{2F83EDCA-85FD-43C7-A137-B126B0B59504}"/>
               </a:ext>
             </a:extLst>
           </p:cNvPr>
@@ -27425,7 +27425,7 @@
           <p:cNvPr id="6" name="TextBox 5">
             <a:extLst xmlns:a="http://schemas.openxmlformats.org/drawingml/2006/main">
               <a:ext uri="{FF2B5EF4-FFF2-40B4-BE49-F238E27FC236}">
-                <a16:creationId xmlns:a16="http://schemas.microsoft.com/office/drawing/2014/main" id="{67EE16FD-0BCF-4605-89E6-AF7029E830FE}"/>
+                <a16:creationId xmlns:a16="http://schemas.microsoft.com/office/drawing/2014/main" id="{DE5B65B3-AAD2-44CE-92D8-4A0208C59E5E}"/>
               </a:ext>
             </a:extLst>
           </p:cNvPr>
@@ -27462,7 +27462,7 @@
                 <a:ea typeface="Aptos"/>
                 <a:cs typeface="Aptos"/>
               </a:rPr>
-              <a:t>Independent public evidence summary · 2026.07.23-10 · 2026-07-22 · Sources: EP3032975B2</a:t>
+              <a:t>Independent public evidence summary · 2026.07.23-11 · 2026-07-22 · Sources: EP3032975B2</a:t>
             </a:r>
           </a:p>
         </p:txBody>
@@ -27472,7 +27472,7 @@
           <p:cNvPr id="7" name="TextBox 6">
             <a:extLst xmlns:a="http://schemas.openxmlformats.org/drawingml/2006/main">
               <a:ext uri="{FF2B5EF4-FFF2-40B4-BE49-F238E27FC236}">
-                <a16:creationId xmlns:a16="http://schemas.microsoft.com/office/drawing/2014/main" id="{4296B138-DD66-4603-BD34-779DF6768E95}"/>
+                <a16:creationId xmlns:a16="http://schemas.microsoft.com/office/drawing/2014/main" id="{3911CC5A-6E54-4C9F-B874-099A38AE3278}"/>
               </a:ext>
             </a:extLst>
           </p:cNvPr>
@@ -27519,7 +27519,7 @@
           <p:cNvPr id="8" name="TextBox 7">
             <a:extLst xmlns:a="http://schemas.openxmlformats.org/drawingml/2006/main">
               <a:ext uri="{FF2B5EF4-FFF2-40B4-BE49-F238E27FC236}">
-                <a16:creationId xmlns:a16="http://schemas.microsoft.com/office/drawing/2014/main" id="{EF8D3735-E8F6-44A8-AB31-79B7CD695B9E}"/>
+                <a16:creationId xmlns:a16="http://schemas.microsoft.com/office/drawing/2014/main" id="{FC61DD90-F79B-4549-A1EB-4BDFC46E295D}"/>
               </a:ext>
             </a:extLst>
           </p:cNvPr>
@@ -27566,7 +27566,7 @@
           <p:cNvPr id="9" name="TextBox 8">
             <a:extLst xmlns:a="http://schemas.openxmlformats.org/drawingml/2006/main">
               <a:ext uri="{FF2B5EF4-FFF2-40B4-BE49-F238E27FC236}">
-                <a16:creationId xmlns:a16="http://schemas.microsoft.com/office/drawing/2014/main" id="{E5FAB211-24D3-4590-9A7A-677F0CDFC489}"/>
+                <a16:creationId xmlns:a16="http://schemas.microsoft.com/office/drawing/2014/main" id="{F8F9DC60-FC2B-4C53-B801-810FC1B3BE3F}"/>
               </a:ext>
             </a:extLst>
           </p:cNvPr>
@@ -27663,7 +27663,7 @@
           <p:cNvPr id="10" name="Rounded Rectangle 9">
             <a:extLst xmlns:a="http://schemas.openxmlformats.org/drawingml/2006/main">
               <a:ext uri="{FF2B5EF4-FFF2-40B4-BE49-F238E27FC236}">
-                <a16:creationId xmlns:a16="http://schemas.microsoft.com/office/drawing/2014/main" id="{59E28F05-1A72-47F8-9998-F2FEA83491AB}"/>
+                <a16:creationId xmlns:a16="http://schemas.microsoft.com/office/drawing/2014/main" id="{FA580EC2-97EE-4E70-A08A-62997C713C4B}"/>
               </a:ext>
             </a:extLst>
           </p:cNvPr>
@@ -27720,7 +27720,7 @@
           <p:cNvPr id="11" name="TextBox 10">
             <a:extLst xmlns:a="http://schemas.openxmlformats.org/drawingml/2006/main">
               <a:ext uri="{FF2B5EF4-FFF2-40B4-BE49-F238E27FC236}">
-                <a16:creationId xmlns:a16="http://schemas.microsoft.com/office/drawing/2014/main" id="{7BA7B35C-FC46-4474-B3D7-CA342C2702D6}"/>
+                <a16:creationId xmlns:a16="http://schemas.microsoft.com/office/drawing/2014/main" id="{6B44A0F2-974D-4FBE-BC34-3891760F231A}"/>
               </a:ext>
             </a:extLst>
           </p:cNvPr>
@@ -27767,7 +27767,7 @@
           <p:cNvPr id="12" name="TextBox 11">
             <a:extLst xmlns:a="http://schemas.openxmlformats.org/drawingml/2006/main">
               <a:ext uri="{FF2B5EF4-FFF2-40B4-BE49-F238E27FC236}">
-                <a16:creationId xmlns:a16="http://schemas.microsoft.com/office/drawing/2014/main" id="{E715A0C5-69E8-459D-99AB-7DF1EA734A9C}"/>
+                <a16:creationId xmlns:a16="http://schemas.microsoft.com/office/drawing/2014/main" id="{68327904-7C41-4E63-811C-393B15CFEE99}"/>
               </a:ext>
             </a:extLst>
           </p:cNvPr>
@@ -27812,7 +27812,7 @@
     </p:spTree>
     <p:extLst>
       <p:ext uri="{BB962C8B-B14F-4D97-AF65-F5344CB8AC3E}">
-        <p14:creationId xmlns:p14="http://schemas.microsoft.com/office/powerpoint/2010/main" val="2012476660"/>
+        <p14:creationId xmlns:p14="http://schemas.microsoft.com/office/powerpoint/2010/main" val="1064422834"/>
       </p:ext>
     </p:extLst>
   </p:cSld>
@@ -27836,7 +27836,7 @@
           <p:cNvPr id="2" name="TextBox 1">
             <a:extLst xmlns:a="http://schemas.openxmlformats.org/drawingml/2006/main">
               <a:ext uri="{FF2B5EF4-FFF2-40B4-BE49-F238E27FC236}">
-                <a16:creationId xmlns:a16="http://schemas.microsoft.com/office/drawing/2014/main" id="{F28AB2C8-9ADA-4AA3-9F9C-A5DD17EA28A7}"/>
+                <a16:creationId xmlns:a16="http://schemas.microsoft.com/office/drawing/2014/main" id="{FF8DE4A4-6A5C-4DAD-B56D-1AB1B2FDCF84}"/>
               </a:ext>
             </a:extLst>
           </p:cNvPr>
@@ -27883,7 +27883,7 @@
           <p:cNvPr id="3" name="TextBox 2">
             <a:extLst xmlns:a="http://schemas.openxmlformats.org/drawingml/2006/main">
               <a:ext uri="{FF2B5EF4-FFF2-40B4-BE49-F238E27FC236}">
-                <a16:creationId xmlns:a16="http://schemas.microsoft.com/office/drawing/2014/main" id="{98136BB7-BC91-44C0-9E8C-4AEE74645792}"/>
+                <a16:creationId xmlns:a16="http://schemas.microsoft.com/office/drawing/2014/main" id="{99E642A3-30B6-40CB-A89F-EE69851C0FF2}"/>
               </a:ext>
             </a:extLst>
           </p:cNvPr>
@@ -27930,7 +27930,7 @@
           <p:cNvPr id="4" name="Rectangle 3">
             <a:extLst xmlns:a="http://schemas.openxmlformats.org/drawingml/2006/main">
               <a:ext uri="{FF2B5EF4-FFF2-40B4-BE49-F238E27FC236}">
-                <a16:creationId xmlns:a16="http://schemas.microsoft.com/office/drawing/2014/main" id="{049F2503-33D1-4461-94D1-14B3E64A88AE}"/>
+                <a16:creationId xmlns:a16="http://schemas.microsoft.com/office/drawing/2014/main" id="{DBEF5228-2563-4374-B7C4-A2D8ABF42F0C}"/>
               </a:ext>
             </a:extLst>
           </p:cNvPr>
@@ -27985,7 +27985,7 @@
           <p:cNvPr id="5" name="Rectangle 4">
             <a:extLst xmlns:a="http://schemas.openxmlformats.org/drawingml/2006/main">
               <a:ext uri="{FF2B5EF4-FFF2-40B4-BE49-F238E27FC236}">
-                <a16:creationId xmlns:a16="http://schemas.microsoft.com/office/drawing/2014/main" id="{36FB01EB-5D1F-4DA7-A9BC-B58329654CAA}"/>
+                <a16:creationId xmlns:a16="http://schemas.microsoft.com/office/drawing/2014/main" id="{016B532C-CE90-4171-BBD9-9E25266257D3}"/>
               </a:ext>
             </a:extLst>
           </p:cNvPr>
@@ -28040,7 +28040,7 @@
           <p:cNvPr id="6" name="TextBox 5">
             <a:extLst xmlns:a="http://schemas.openxmlformats.org/drawingml/2006/main">
               <a:ext uri="{FF2B5EF4-FFF2-40B4-BE49-F238E27FC236}">
-                <a16:creationId xmlns:a16="http://schemas.microsoft.com/office/drawing/2014/main" id="{BD522210-83B8-4190-B1AE-BDD27040EA0D}"/>
+                <a16:creationId xmlns:a16="http://schemas.microsoft.com/office/drawing/2014/main" id="{4DCD5D3B-6A90-4E94-B110-0E27019EB763}"/>
               </a:ext>
             </a:extLst>
           </p:cNvPr>
@@ -28077,7 +28077,7 @@
                 <a:ea typeface="Aptos"/>
                 <a:cs typeface="Aptos"/>
               </a:rPr>
-              <a:t>Independent public evidence summary · 2026.07.23-10 · 2026-07-22 · Sources: EP3032975B2</a:t>
+              <a:t>Independent public evidence summary · 2026.07.23-11 · 2026-07-22 · Sources: EP3032975B2</a:t>
             </a:r>
           </a:p>
         </p:txBody>
@@ -28087,7 +28087,7 @@
           <p:cNvPr id="7" name="TextBox 6">
             <a:extLst xmlns:a="http://schemas.openxmlformats.org/drawingml/2006/main">
               <a:ext uri="{FF2B5EF4-FFF2-40B4-BE49-F238E27FC236}">
-                <a16:creationId xmlns:a16="http://schemas.microsoft.com/office/drawing/2014/main" id="{E92DCBAD-BF08-4374-BD8C-43472C6A6C50}"/>
+                <a16:creationId xmlns:a16="http://schemas.microsoft.com/office/drawing/2014/main" id="{BC194073-88F3-4255-A414-AE80BD72B8ED}"/>
               </a:ext>
             </a:extLst>
           </p:cNvPr>
@@ -28657,7 +28657,7 @@
           <p:cNvPr id="9" name="TextBox 8">
             <a:extLst xmlns:a="http://schemas.openxmlformats.org/drawingml/2006/main">
               <a:ext uri="{FF2B5EF4-FFF2-40B4-BE49-F238E27FC236}">
-                <a16:creationId xmlns:a16="http://schemas.microsoft.com/office/drawing/2014/main" id="{4DBE734C-44D9-4BFF-8706-FBBA470B5396}"/>
+                <a16:creationId xmlns:a16="http://schemas.microsoft.com/office/drawing/2014/main" id="{009ACCB1-6B85-44E1-8551-B8604DA78E9C}"/>
               </a:ext>
             </a:extLst>
           </p:cNvPr>
@@ -28702,7 +28702,7 @@
     </p:spTree>
     <p:extLst>
       <p:ext uri="{BB962C8B-B14F-4D97-AF65-F5344CB8AC3E}">
-        <p14:creationId xmlns:p14="http://schemas.microsoft.com/office/powerpoint/2010/main" val="1357717513"/>
+        <p14:creationId xmlns:p14="http://schemas.microsoft.com/office/powerpoint/2010/main" val="1966358754"/>
       </p:ext>
     </p:extLst>
   </p:cSld>
@@ -28726,7 +28726,7 @@
           <p:cNvPr id="2" name="TextBox 1">
             <a:extLst xmlns:a="http://schemas.openxmlformats.org/drawingml/2006/main">
               <a:ext uri="{FF2B5EF4-FFF2-40B4-BE49-F238E27FC236}">
-                <a16:creationId xmlns:a16="http://schemas.microsoft.com/office/drawing/2014/main" id="{C0F255FE-F014-4249-AC27-279019447F69}"/>
+                <a16:creationId xmlns:a16="http://schemas.microsoft.com/office/drawing/2014/main" id="{74F5D165-78B4-4AA2-98DA-E25BE0F3205C}"/>
               </a:ext>
             </a:extLst>
           </p:cNvPr>
@@ -28773,7 +28773,7 @@
           <p:cNvPr id="3" name="TextBox 2">
             <a:extLst xmlns:a="http://schemas.openxmlformats.org/drawingml/2006/main">
               <a:ext uri="{FF2B5EF4-FFF2-40B4-BE49-F238E27FC236}">
-                <a16:creationId xmlns:a16="http://schemas.microsoft.com/office/drawing/2014/main" id="{EF526671-8FE8-4179-B127-455CE2AA95C6}"/>
+                <a16:creationId xmlns:a16="http://schemas.microsoft.com/office/drawing/2014/main" id="{8AF31785-FAA6-41B5-AB58-9FF4D111DD39}"/>
               </a:ext>
             </a:extLst>
           </p:cNvPr>
@@ -28820,7 +28820,7 @@
           <p:cNvPr id="4" name="Rectangle 3">
             <a:extLst xmlns:a="http://schemas.openxmlformats.org/drawingml/2006/main">
               <a:ext uri="{FF2B5EF4-FFF2-40B4-BE49-F238E27FC236}">
-                <a16:creationId xmlns:a16="http://schemas.microsoft.com/office/drawing/2014/main" id="{805F5BCA-46A6-4CB5-A930-4300494441BE}"/>
+                <a16:creationId xmlns:a16="http://schemas.microsoft.com/office/drawing/2014/main" id="{8E444AF5-969E-4B2B-9A56-BC86978AAF2B}"/>
               </a:ext>
             </a:extLst>
           </p:cNvPr>
@@ -28875,7 +28875,7 @@
           <p:cNvPr id="5" name="Rectangle 4">
             <a:extLst xmlns:a="http://schemas.openxmlformats.org/drawingml/2006/main">
               <a:ext uri="{FF2B5EF4-FFF2-40B4-BE49-F238E27FC236}">
-                <a16:creationId xmlns:a16="http://schemas.microsoft.com/office/drawing/2014/main" id="{B9B83AC9-3D2F-4ADE-BBF6-53720778887A}"/>
+                <a16:creationId xmlns:a16="http://schemas.microsoft.com/office/drawing/2014/main" id="{74DA7AC1-C7A5-489E-86EE-0462245711A4}"/>
               </a:ext>
             </a:extLst>
           </p:cNvPr>
@@ -28930,7 +28930,7 @@
           <p:cNvPr id="6" name="TextBox 5">
             <a:extLst xmlns:a="http://schemas.openxmlformats.org/drawingml/2006/main">
               <a:ext uri="{FF2B5EF4-FFF2-40B4-BE49-F238E27FC236}">
-                <a16:creationId xmlns:a16="http://schemas.microsoft.com/office/drawing/2014/main" id="{2545413C-E3CE-4604-A5F2-A78B2E449305}"/>
+                <a16:creationId xmlns:a16="http://schemas.microsoft.com/office/drawing/2014/main" id="{E4097417-F8C3-4631-BDDD-16051017878A}"/>
               </a:ext>
             </a:extLst>
           </p:cNvPr>
@@ -28967,7 +28967,7 @@
                 <a:ea typeface="Aptos"/>
                 <a:cs typeface="Aptos"/>
               </a:rPr>
-              <a:t>Independent public evidence summary · 2026.07.23-10 · 2026-07-22 · Sources: EPO Register; B2</a:t>
+              <a:t>Independent public evidence summary · 2026.07.23-11 · 2026-07-22 · Sources: EPO Register; B2</a:t>
             </a:r>
           </a:p>
         </p:txBody>
@@ -28977,7 +28977,7 @@
           <p:cNvPr id="7" name="TextBox 6">
             <a:extLst xmlns:a="http://schemas.openxmlformats.org/drawingml/2006/main">
               <a:ext uri="{FF2B5EF4-FFF2-40B4-BE49-F238E27FC236}">
-                <a16:creationId xmlns:a16="http://schemas.microsoft.com/office/drawing/2014/main" id="{DEB769A1-C080-466F-BD0B-1D8B114610A4}"/>
+                <a16:creationId xmlns:a16="http://schemas.microsoft.com/office/drawing/2014/main" id="{44F9D945-A07A-46BC-8EAE-F2B521A76483}"/>
               </a:ext>
             </a:extLst>
           </p:cNvPr>
@@ -29024,7 +29024,7 @@
           <p:cNvPr id="8" name="Rounded Rectangle 7">
             <a:extLst xmlns:a="http://schemas.openxmlformats.org/drawingml/2006/main">
               <a:ext uri="{FF2B5EF4-FFF2-40B4-BE49-F238E27FC236}">
-                <a16:creationId xmlns:a16="http://schemas.microsoft.com/office/drawing/2014/main" id="{037AE4D6-D7F2-43B3-9FB7-B772ECE8E052}"/>
+                <a16:creationId xmlns:a16="http://schemas.microsoft.com/office/drawing/2014/main" id="{113CFE3E-F4B3-4E96-8E59-ABA7E60C5438}"/>
               </a:ext>
             </a:extLst>
           </p:cNvPr>
@@ -29081,7 +29081,7 @@
           <p:cNvPr id="9" name="TextBox 8">
             <a:extLst xmlns:a="http://schemas.openxmlformats.org/drawingml/2006/main">
               <a:ext uri="{FF2B5EF4-FFF2-40B4-BE49-F238E27FC236}">
-                <a16:creationId xmlns:a16="http://schemas.microsoft.com/office/drawing/2014/main" id="{12D6807D-D9AA-47AE-9535-A8259A255571}"/>
+                <a16:creationId xmlns:a16="http://schemas.microsoft.com/office/drawing/2014/main" id="{09920181-5623-4541-AEBB-D6556B4F3D68}"/>
               </a:ext>
             </a:extLst>
           </p:cNvPr>
@@ -29128,7 +29128,7 @@
           <p:cNvPr id="10" name="TextBox 9">
             <a:extLst xmlns:a="http://schemas.openxmlformats.org/drawingml/2006/main">
               <a:ext uri="{FF2B5EF4-FFF2-40B4-BE49-F238E27FC236}">
-                <a16:creationId xmlns:a16="http://schemas.microsoft.com/office/drawing/2014/main" id="{B0FDAA0D-0B42-47AA-8DD5-72A9DE8C7C56}"/>
+                <a16:creationId xmlns:a16="http://schemas.microsoft.com/office/drawing/2014/main" id="{17DA4C9E-51A2-488E-9053-96604DB8F04F}"/>
               </a:ext>
             </a:extLst>
           </p:cNvPr>
@@ -29175,7 +29175,7 @@
           <p:cNvPr id="11" name="Rounded Rectangle 10">
             <a:extLst xmlns:a="http://schemas.openxmlformats.org/drawingml/2006/main">
               <a:ext uri="{FF2B5EF4-FFF2-40B4-BE49-F238E27FC236}">
-                <a16:creationId xmlns:a16="http://schemas.microsoft.com/office/drawing/2014/main" id="{48787EE4-349E-4CF5-80DF-9C2393083967}"/>
+                <a16:creationId xmlns:a16="http://schemas.microsoft.com/office/drawing/2014/main" id="{3B91B9B3-7B43-4F69-A830-0CD98E09521E}"/>
               </a:ext>
             </a:extLst>
           </p:cNvPr>
@@ -29232,7 +29232,7 @@
           <p:cNvPr id="12" name="TextBox 11">
             <a:extLst xmlns:a="http://schemas.openxmlformats.org/drawingml/2006/main">
               <a:ext uri="{FF2B5EF4-FFF2-40B4-BE49-F238E27FC236}">
-                <a16:creationId xmlns:a16="http://schemas.microsoft.com/office/drawing/2014/main" id="{EA4C6B9E-DFD0-4451-BA36-B65D00856C8C}"/>
+                <a16:creationId xmlns:a16="http://schemas.microsoft.com/office/drawing/2014/main" id="{2BC17A2A-FEF0-49C9-BF3E-D8E1982306BC}"/>
               </a:ext>
             </a:extLst>
           </p:cNvPr>
@@ -29279,7 +29279,7 @@
           <p:cNvPr id="13" name="TextBox 12">
             <a:extLst xmlns:a="http://schemas.openxmlformats.org/drawingml/2006/main">
               <a:ext uri="{FF2B5EF4-FFF2-40B4-BE49-F238E27FC236}">
-                <a16:creationId xmlns:a16="http://schemas.microsoft.com/office/drawing/2014/main" id="{CBBAA00B-DE80-4F1C-80C8-3F2B7CA7696F}"/>
+                <a16:creationId xmlns:a16="http://schemas.microsoft.com/office/drawing/2014/main" id="{BF85CDAC-4435-4F4D-8144-00C4D4BC28F9}"/>
               </a:ext>
             </a:extLst>
           </p:cNvPr>
@@ -29326,7 +29326,7 @@
           <p:cNvPr id="14" name="Rounded Rectangle 13">
             <a:extLst xmlns:a="http://schemas.openxmlformats.org/drawingml/2006/main">
               <a:ext uri="{FF2B5EF4-FFF2-40B4-BE49-F238E27FC236}">
-                <a16:creationId xmlns:a16="http://schemas.microsoft.com/office/drawing/2014/main" id="{E8970C3E-E2F9-41FE-8671-204838248CC7}"/>
+                <a16:creationId xmlns:a16="http://schemas.microsoft.com/office/drawing/2014/main" id="{A75A60BB-C0C6-4912-A904-12124ABB9524}"/>
               </a:ext>
             </a:extLst>
           </p:cNvPr>
@@ -29383,7 +29383,7 @@
           <p:cNvPr id="15" name="TextBox 14">
             <a:extLst xmlns:a="http://schemas.openxmlformats.org/drawingml/2006/main">
               <a:ext uri="{FF2B5EF4-FFF2-40B4-BE49-F238E27FC236}">
-                <a16:creationId xmlns:a16="http://schemas.microsoft.com/office/drawing/2014/main" id="{322CED65-3765-49B6-9101-9028434F08CA}"/>
+                <a16:creationId xmlns:a16="http://schemas.microsoft.com/office/drawing/2014/main" id="{3E29F868-2711-41D0-A0D6-5FD8EA9B4970}"/>
               </a:ext>
             </a:extLst>
           </p:cNvPr>
@@ -29430,7 +29430,7 @@
           <p:cNvPr id="16" name="TextBox 15">
             <a:extLst xmlns:a="http://schemas.openxmlformats.org/drawingml/2006/main">
               <a:ext uri="{FF2B5EF4-FFF2-40B4-BE49-F238E27FC236}">
-                <a16:creationId xmlns:a16="http://schemas.microsoft.com/office/drawing/2014/main" id="{BCC6A4DB-B63D-4F94-A13C-E87F7B541C33}"/>
+                <a16:creationId xmlns:a16="http://schemas.microsoft.com/office/drawing/2014/main" id="{325BB3C0-92F7-41E9-BCFB-1F3E0BDAAA75}"/>
               </a:ext>
             </a:extLst>
           </p:cNvPr>
@@ -29477,7 +29477,7 @@
           <p:cNvPr id="17" name="TextBox 16">
             <a:extLst xmlns:a="http://schemas.openxmlformats.org/drawingml/2006/main">
               <a:ext uri="{FF2B5EF4-FFF2-40B4-BE49-F238E27FC236}">
-                <a16:creationId xmlns:a16="http://schemas.microsoft.com/office/drawing/2014/main" id="{B6CB91B3-1C5A-4721-AC9D-01850DD30DDF}"/>
+                <a16:creationId xmlns:a16="http://schemas.microsoft.com/office/drawing/2014/main" id="{56EA2B65-AB06-42E0-B1E1-C7AEC58EEAEF}"/>
               </a:ext>
             </a:extLst>
           </p:cNvPr>
@@ -29524,7 +29524,7 @@
           <p:cNvPr id="18" name="Rounded Rectangle 17">
             <a:extLst xmlns:a="http://schemas.openxmlformats.org/drawingml/2006/main">
               <a:ext uri="{FF2B5EF4-FFF2-40B4-BE49-F238E27FC236}">
-                <a16:creationId xmlns:a16="http://schemas.microsoft.com/office/drawing/2014/main" id="{A0C41CE3-8C1F-4B7E-A8E7-A0A6627ABDC8}"/>
+                <a16:creationId xmlns:a16="http://schemas.microsoft.com/office/drawing/2014/main" id="{3DFBCA90-4152-4A46-BF95-8FDF51435BED}"/>
               </a:ext>
             </a:extLst>
           </p:cNvPr>
@@ -29581,7 +29581,7 @@
           <p:cNvPr id="19" name="TextBox 18">
             <a:extLst xmlns:a="http://schemas.openxmlformats.org/drawingml/2006/main">
               <a:ext uri="{FF2B5EF4-FFF2-40B4-BE49-F238E27FC236}">
-                <a16:creationId xmlns:a16="http://schemas.microsoft.com/office/drawing/2014/main" id="{112C3525-E956-4425-B064-B0AC481D914F}"/>
+                <a16:creationId xmlns:a16="http://schemas.microsoft.com/office/drawing/2014/main" id="{A0151705-D54D-4919-B07D-0A2B314D8123}"/>
               </a:ext>
             </a:extLst>
           </p:cNvPr>
@@ -29628,7 +29628,7 @@
           <p:cNvPr id="20" name="TextBox 19">
             <a:extLst xmlns:a="http://schemas.openxmlformats.org/drawingml/2006/main">
               <a:ext uri="{FF2B5EF4-FFF2-40B4-BE49-F238E27FC236}">
-                <a16:creationId xmlns:a16="http://schemas.microsoft.com/office/drawing/2014/main" id="{0E5E9028-5517-4A73-8E1F-73DB3C169A9D}"/>
+                <a16:creationId xmlns:a16="http://schemas.microsoft.com/office/drawing/2014/main" id="{8D95D6F5-905B-4FB0-99A0-63CB195D9301}"/>
               </a:ext>
             </a:extLst>
           </p:cNvPr>
@@ -29673,7 +29673,7 @@
     </p:spTree>
     <p:extLst>
       <p:ext uri="{BB962C8B-B14F-4D97-AF65-F5344CB8AC3E}">
-        <p14:creationId xmlns:p14="http://schemas.microsoft.com/office/powerpoint/2010/main" val="664886785"/>
+        <p14:creationId xmlns:p14="http://schemas.microsoft.com/office/powerpoint/2010/main" val="928223737"/>
       </p:ext>
     </p:extLst>
   </p:cSld>
@@ -29697,7 +29697,7 @@
           <p:cNvPr id="2" name="TextBox 1">
             <a:extLst xmlns:a="http://schemas.openxmlformats.org/drawingml/2006/main">
               <a:ext uri="{FF2B5EF4-FFF2-40B4-BE49-F238E27FC236}">
-                <a16:creationId xmlns:a16="http://schemas.microsoft.com/office/drawing/2014/main" id="{D130B268-7874-432A-B9B8-478389B6B4B9}"/>
+                <a16:creationId xmlns:a16="http://schemas.microsoft.com/office/drawing/2014/main" id="{677A626B-68A9-411D-A9BA-953DB854789F}"/>
               </a:ext>
             </a:extLst>
           </p:cNvPr>
@@ -29744,7 +29744,7 @@
           <p:cNvPr id="3" name="TextBox 2">
             <a:extLst xmlns:a="http://schemas.openxmlformats.org/drawingml/2006/main">
               <a:ext uri="{FF2B5EF4-FFF2-40B4-BE49-F238E27FC236}">
-                <a16:creationId xmlns:a16="http://schemas.microsoft.com/office/drawing/2014/main" id="{4748BDFF-E957-48B8-8811-C62AA0E5C3E4}"/>
+                <a16:creationId xmlns:a16="http://schemas.microsoft.com/office/drawing/2014/main" id="{48E62AE4-9100-46FF-BA5A-A9565432C220}"/>
               </a:ext>
             </a:extLst>
           </p:cNvPr>
@@ -29791,7 +29791,7 @@
           <p:cNvPr id="4" name="Rectangle 3">
             <a:extLst xmlns:a="http://schemas.openxmlformats.org/drawingml/2006/main">
               <a:ext uri="{FF2B5EF4-FFF2-40B4-BE49-F238E27FC236}">
-                <a16:creationId xmlns:a16="http://schemas.microsoft.com/office/drawing/2014/main" id="{3DE5A07B-154A-4BA3-BD48-6C55E6AFBC28}"/>
+                <a16:creationId xmlns:a16="http://schemas.microsoft.com/office/drawing/2014/main" id="{7932A9E7-EC1D-439C-9572-DD3ADCF892EB}"/>
               </a:ext>
             </a:extLst>
           </p:cNvPr>
@@ -29846,7 +29846,7 @@
           <p:cNvPr id="5" name="Rectangle 4">
             <a:extLst xmlns:a="http://schemas.openxmlformats.org/drawingml/2006/main">
               <a:ext uri="{FF2B5EF4-FFF2-40B4-BE49-F238E27FC236}">
-                <a16:creationId xmlns:a16="http://schemas.microsoft.com/office/drawing/2014/main" id="{70E12C48-1C6C-49D2-83A5-74445D4B3E97}"/>
+                <a16:creationId xmlns:a16="http://schemas.microsoft.com/office/drawing/2014/main" id="{10CA9448-13BB-40E3-A35F-F96581C39F9A}"/>
               </a:ext>
             </a:extLst>
           </p:cNvPr>
@@ -29901,7 +29901,7 @@
           <p:cNvPr id="6" name="TextBox 5">
             <a:extLst xmlns:a="http://schemas.openxmlformats.org/drawingml/2006/main">
               <a:ext uri="{FF2B5EF4-FFF2-40B4-BE49-F238E27FC236}">
-                <a16:creationId xmlns:a16="http://schemas.microsoft.com/office/drawing/2014/main" id="{AC2483C3-9A64-4BDC-A229-6D8EA3316D0C}"/>
+                <a16:creationId xmlns:a16="http://schemas.microsoft.com/office/drawing/2014/main" id="{E5431AE0-4E6A-4034-BD0F-985321CB1B52}"/>
               </a:ext>
             </a:extLst>
           </p:cNvPr>
@@ -29938,7 +29938,7 @@
                 <a:ea typeface="Aptos"/>
                 <a:cs typeface="Aptos"/>
               </a:rPr>
-              <a:t>Independent public evidence summary · 2026.07.23-10 · 2026-07-22 · Sources: EPO family; national registers</a:t>
+              <a:t>Independent public evidence summary · 2026.07.23-11 · 2026-07-22 · Sources: EPO family; national registers</a:t>
             </a:r>
           </a:p>
         </p:txBody>
@@ -29948,7 +29948,7 @@
           <p:cNvPr id="7" name="TextBox 6">
             <a:extLst xmlns:a="http://schemas.openxmlformats.org/drawingml/2006/main">
               <a:ext uri="{FF2B5EF4-FFF2-40B4-BE49-F238E27FC236}">
-                <a16:creationId xmlns:a16="http://schemas.microsoft.com/office/drawing/2014/main" id="{E7EC4605-5EB3-4E9F-AE47-9388DE1FD6B5}"/>
+                <a16:creationId xmlns:a16="http://schemas.microsoft.com/office/drawing/2014/main" id="{510BEA92-F7D7-43C2-BE98-7D165FC04A57}"/>
               </a:ext>
             </a:extLst>
           </p:cNvPr>
@@ -29995,7 +29995,7 @@
           <p:cNvPr id="8" name="Rounded Rectangle 7">
             <a:extLst xmlns:a="http://schemas.openxmlformats.org/drawingml/2006/main">
               <a:ext uri="{FF2B5EF4-FFF2-40B4-BE49-F238E27FC236}">
-                <a16:creationId xmlns:a16="http://schemas.microsoft.com/office/drawing/2014/main" id="{3DF2DAE6-6EA5-4179-A4D1-73865299DEAD}"/>
+                <a16:creationId xmlns:a16="http://schemas.microsoft.com/office/drawing/2014/main" id="{8CF93D11-9BA6-436A-A808-350FA2B7C253}"/>
               </a:ext>
             </a:extLst>
           </p:cNvPr>
@@ -30052,7 +30052,7 @@
           <p:cNvPr id="9" name="TextBox 8">
             <a:extLst xmlns:a="http://schemas.openxmlformats.org/drawingml/2006/main">
               <a:ext uri="{FF2B5EF4-FFF2-40B4-BE49-F238E27FC236}">
-                <a16:creationId xmlns:a16="http://schemas.microsoft.com/office/drawing/2014/main" id="{E3543369-E835-405A-B058-090BC42938B1}"/>
+                <a16:creationId xmlns:a16="http://schemas.microsoft.com/office/drawing/2014/main" id="{F071B7D4-8792-4FFD-9135-C0DF38353F39}"/>
               </a:ext>
             </a:extLst>
           </p:cNvPr>
@@ -30099,7 +30099,7 @@
           <p:cNvPr id="10" name="TextBox 9">
             <a:extLst xmlns:a="http://schemas.openxmlformats.org/drawingml/2006/main">
               <a:ext uri="{FF2B5EF4-FFF2-40B4-BE49-F238E27FC236}">
-                <a16:creationId xmlns:a16="http://schemas.microsoft.com/office/drawing/2014/main" id="{8944A267-2CED-4DE8-8EBA-2684F0D44146}"/>
+                <a16:creationId xmlns:a16="http://schemas.microsoft.com/office/drawing/2014/main" id="{3BD29D48-1FD1-4C06-ABEA-C5FCE71E993E}"/>
               </a:ext>
             </a:extLst>
           </p:cNvPr>
@@ -30146,7 +30146,7 @@
           <p:cNvPr id="11" name="Rounded Rectangle 10">
             <a:extLst xmlns:a="http://schemas.openxmlformats.org/drawingml/2006/main">
               <a:ext uri="{FF2B5EF4-FFF2-40B4-BE49-F238E27FC236}">
-                <a16:creationId xmlns:a16="http://schemas.microsoft.com/office/drawing/2014/main" id="{C7ABFE91-7553-471D-90E1-F5BBDB048D7C}"/>
+                <a16:creationId xmlns:a16="http://schemas.microsoft.com/office/drawing/2014/main" id="{3CF4F0E4-6888-4B83-AAC3-212474E5B216}"/>
               </a:ext>
             </a:extLst>
           </p:cNvPr>
@@ -30203,7 +30203,7 @@
           <p:cNvPr id="12" name="TextBox 11">
             <a:extLst xmlns:a="http://schemas.openxmlformats.org/drawingml/2006/main">
               <a:ext uri="{FF2B5EF4-FFF2-40B4-BE49-F238E27FC236}">
-                <a16:creationId xmlns:a16="http://schemas.microsoft.com/office/drawing/2014/main" id="{97A90AF1-6F58-4057-B86A-3ACBC0881572}"/>
+                <a16:creationId xmlns:a16="http://schemas.microsoft.com/office/drawing/2014/main" id="{F38093F4-B427-4A03-BB9D-58296D54B599}"/>
               </a:ext>
             </a:extLst>
           </p:cNvPr>
@@ -30250,7 +30250,7 @@
           <p:cNvPr id="13" name="TextBox 12">
             <a:extLst xmlns:a="http://schemas.openxmlformats.org/drawingml/2006/main">
               <a:ext uri="{FF2B5EF4-FFF2-40B4-BE49-F238E27FC236}">
-                <a16:creationId xmlns:a16="http://schemas.microsoft.com/office/drawing/2014/main" id="{8A376231-3268-4E4E-B8F5-E9768FFB8009}"/>
+                <a16:creationId xmlns:a16="http://schemas.microsoft.com/office/drawing/2014/main" id="{511BDCBB-E9F5-4443-BBFF-617639CB6EC5}"/>
               </a:ext>
             </a:extLst>
           </p:cNvPr>
@@ -30297,7 +30297,7 @@
           <p:cNvPr id="14" name="Rounded Rectangle 13">
             <a:extLst xmlns:a="http://schemas.openxmlformats.org/drawingml/2006/main">
               <a:ext uri="{FF2B5EF4-FFF2-40B4-BE49-F238E27FC236}">
-                <a16:creationId xmlns:a16="http://schemas.microsoft.com/office/drawing/2014/main" id="{9FA7D0A0-2571-489A-B0F7-864CFA759E91}"/>
+                <a16:creationId xmlns:a16="http://schemas.microsoft.com/office/drawing/2014/main" id="{B1C4BEBD-D336-43F9-9291-3ABD18D9933F}"/>
               </a:ext>
             </a:extLst>
           </p:cNvPr>
@@ -30354,7 +30354,7 @@
           <p:cNvPr id="15" name="TextBox 14">
             <a:extLst xmlns:a="http://schemas.openxmlformats.org/drawingml/2006/main">
               <a:ext uri="{FF2B5EF4-FFF2-40B4-BE49-F238E27FC236}">
-                <a16:creationId xmlns:a16="http://schemas.microsoft.com/office/drawing/2014/main" id="{C3E7F8CD-E972-4C9F-92BF-72DEC4E30C18}"/>
+                <a16:creationId xmlns:a16="http://schemas.microsoft.com/office/drawing/2014/main" id="{FD006DF2-96FE-4311-BAF3-F03F8A0D5F2B}"/>
               </a:ext>
             </a:extLst>
           </p:cNvPr>
@@ -30401,7 +30401,7 @@
           <p:cNvPr id="16" name="TextBox 15">
             <a:extLst xmlns:a="http://schemas.openxmlformats.org/drawingml/2006/main">
               <a:ext uri="{FF2B5EF4-FFF2-40B4-BE49-F238E27FC236}">
-                <a16:creationId xmlns:a16="http://schemas.microsoft.com/office/drawing/2014/main" id="{9728CEC8-8AB9-44D3-8518-D4DE63B4ECAE}"/>
+                <a16:creationId xmlns:a16="http://schemas.microsoft.com/office/drawing/2014/main" id="{1C6485DE-F6E8-4751-A764-DFC2598DF6E2}"/>
               </a:ext>
             </a:extLst>
           </p:cNvPr>
@@ -30448,7 +30448,7 @@
           <p:cNvPr id="17" name="Rounded Rectangle 16">
             <a:extLst xmlns:a="http://schemas.openxmlformats.org/drawingml/2006/main">
               <a:ext uri="{FF2B5EF4-FFF2-40B4-BE49-F238E27FC236}">
-                <a16:creationId xmlns:a16="http://schemas.microsoft.com/office/drawing/2014/main" id="{BC9A1E57-ADAB-4EE6-81B4-6DBC70E210B7}"/>
+                <a16:creationId xmlns:a16="http://schemas.microsoft.com/office/drawing/2014/main" id="{082B5444-ED5F-4409-82A8-FD27B0DA1A7A}"/>
               </a:ext>
             </a:extLst>
           </p:cNvPr>
@@ -30505,7 +30505,7 @@
           <p:cNvPr id="18" name="TextBox 17">
             <a:extLst xmlns:a="http://schemas.openxmlformats.org/drawingml/2006/main">
               <a:ext uri="{FF2B5EF4-FFF2-40B4-BE49-F238E27FC236}">
-                <a16:creationId xmlns:a16="http://schemas.microsoft.com/office/drawing/2014/main" id="{87644F90-4C69-4017-9655-1E187BFF6811}"/>
+                <a16:creationId xmlns:a16="http://schemas.microsoft.com/office/drawing/2014/main" id="{B0B2B73E-8FEF-4D4F-821B-80C75B2EEB28}"/>
               </a:ext>
             </a:extLst>
           </p:cNvPr>
@@ -30552,7 +30552,7 @@
           <p:cNvPr id="19" name="TextBox 18">
             <a:extLst xmlns:a="http://schemas.openxmlformats.org/drawingml/2006/main">
               <a:ext uri="{FF2B5EF4-FFF2-40B4-BE49-F238E27FC236}">
-                <a16:creationId xmlns:a16="http://schemas.microsoft.com/office/drawing/2014/main" id="{65C38000-1116-4459-943E-4B8D8B6438DC}"/>
+                <a16:creationId xmlns:a16="http://schemas.microsoft.com/office/drawing/2014/main" id="{89E5C34C-6E74-420D-89E9-1F4F0BED1A0E}"/>
               </a:ext>
             </a:extLst>
           </p:cNvPr>
@@ -30599,7 +30599,7 @@
           <p:cNvPr id="20" name="TextBox 19">
             <a:extLst xmlns:a="http://schemas.openxmlformats.org/drawingml/2006/main">
               <a:ext uri="{FF2B5EF4-FFF2-40B4-BE49-F238E27FC236}">
-                <a16:creationId xmlns:a16="http://schemas.microsoft.com/office/drawing/2014/main" id="{C5B2E74E-7488-4DA7-9012-F0BB59652F46}"/>
+                <a16:creationId xmlns:a16="http://schemas.microsoft.com/office/drawing/2014/main" id="{2B850996-9EC6-47AC-A39C-C4309EC54C14}"/>
               </a:ext>
             </a:extLst>
           </p:cNvPr>
@@ -30646,7 +30646,7 @@
           <p:cNvPr id="21" name="Rounded Rectangle 20">
             <a:extLst xmlns:a="http://schemas.openxmlformats.org/drawingml/2006/main">
               <a:ext uri="{FF2B5EF4-FFF2-40B4-BE49-F238E27FC236}">
-                <a16:creationId xmlns:a16="http://schemas.microsoft.com/office/drawing/2014/main" id="{6310FB59-988A-44AE-B323-973763CBAD1F}"/>
+                <a16:creationId xmlns:a16="http://schemas.microsoft.com/office/drawing/2014/main" id="{93F64C6E-A643-44E9-8E41-D3BF7F5A0C17}"/>
               </a:ext>
             </a:extLst>
           </p:cNvPr>
@@ -30703,7 +30703,7 @@
           <p:cNvPr id="22" name="TextBox 21">
             <a:extLst xmlns:a="http://schemas.openxmlformats.org/drawingml/2006/main">
               <a:ext uri="{FF2B5EF4-FFF2-40B4-BE49-F238E27FC236}">
-                <a16:creationId xmlns:a16="http://schemas.microsoft.com/office/drawing/2014/main" id="{73C96886-655A-435E-93B3-CC1A6E0E89A4}"/>
+                <a16:creationId xmlns:a16="http://schemas.microsoft.com/office/drawing/2014/main" id="{813C075C-AF2F-4B4B-9930-ACB3589EE91F}"/>
               </a:ext>
             </a:extLst>
           </p:cNvPr>
@@ -30750,7 +30750,7 @@
           <p:cNvPr id="23" name="TextBox 22">
             <a:extLst xmlns:a="http://schemas.openxmlformats.org/drawingml/2006/main">
               <a:ext uri="{FF2B5EF4-FFF2-40B4-BE49-F238E27FC236}">
-                <a16:creationId xmlns:a16="http://schemas.microsoft.com/office/drawing/2014/main" id="{F09E23F0-6FE5-4299-B663-5587186FE918}"/>
+                <a16:creationId xmlns:a16="http://schemas.microsoft.com/office/drawing/2014/main" id="{069D99D1-CAC5-4A4A-8679-820DFA6630A6}"/>
               </a:ext>
             </a:extLst>
           </p:cNvPr>
@@ -30795,7 +30795,7 @@
     </p:spTree>
     <p:extLst>
       <p:ext uri="{BB962C8B-B14F-4D97-AF65-F5344CB8AC3E}">
-        <p14:creationId xmlns:p14="http://schemas.microsoft.com/office/powerpoint/2010/main" val="1262548599"/>
+        <p14:creationId xmlns:p14="http://schemas.microsoft.com/office/powerpoint/2010/main" val="877512683"/>
       </p:ext>
     </p:extLst>
   </p:cSld>
@@ -30819,7 +30819,7 @@
           <p:cNvPr id="2" name="TextBox 1">
             <a:extLst xmlns:a="http://schemas.openxmlformats.org/drawingml/2006/main">
               <a:ext uri="{FF2B5EF4-FFF2-40B4-BE49-F238E27FC236}">
-                <a16:creationId xmlns:a16="http://schemas.microsoft.com/office/drawing/2014/main" id="{17928046-A228-4039-BA32-8FA77890F76C}"/>
+                <a16:creationId xmlns:a16="http://schemas.microsoft.com/office/drawing/2014/main" id="{780F40F0-D55E-4AE5-BBC6-CE185DC5D30A}"/>
               </a:ext>
             </a:extLst>
           </p:cNvPr>
@@ -30866,7 +30866,7 @@
           <p:cNvPr id="3" name="TextBox 2">
             <a:extLst xmlns:a="http://schemas.openxmlformats.org/drawingml/2006/main">
               <a:ext uri="{FF2B5EF4-FFF2-40B4-BE49-F238E27FC236}">
-                <a16:creationId xmlns:a16="http://schemas.microsoft.com/office/drawing/2014/main" id="{0759DE54-22C5-49E0-ABE5-58BBC77CA466}"/>
+                <a16:creationId xmlns:a16="http://schemas.microsoft.com/office/drawing/2014/main" id="{70626179-8750-4975-89B0-4E2C57607FA0}"/>
               </a:ext>
             </a:extLst>
           </p:cNvPr>
@@ -30913,7 +30913,7 @@
           <p:cNvPr id="4" name="Rectangle 3">
             <a:extLst xmlns:a="http://schemas.openxmlformats.org/drawingml/2006/main">
               <a:ext uri="{FF2B5EF4-FFF2-40B4-BE49-F238E27FC236}">
-                <a16:creationId xmlns:a16="http://schemas.microsoft.com/office/drawing/2014/main" id="{8C8B38C9-A4FC-4EBD-BAF1-48531484F505}"/>
+                <a16:creationId xmlns:a16="http://schemas.microsoft.com/office/drawing/2014/main" id="{082B59DB-1535-420F-8A5F-06159F805288}"/>
               </a:ext>
             </a:extLst>
           </p:cNvPr>
@@ -30968,7 +30968,7 @@
           <p:cNvPr id="5" name="Rectangle 4">
             <a:extLst xmlns:a="http://schemas.openxmlformats.org/drawingml/2006/main">
               <a:ext uri="{FF2B5EF4-FFF2-40B4-BE49-F238E27FC236}">
-                <a16:creationId xmlns:a16="http://schemas.microsoft.com/office/drawing/2014/main" id="{DC2A18FB-C7F4-49F4-8738-23B3B8805B4F}"/>
+                <a16:creationId xmlns:a16="http://schemas.microsoft.com/office/drawing/2014/main" id="{0AD85DC3-A707-42EA-8C27-D898A7060798}"/>
               </a:ext>
             </a:extLst>
           </p:cNvPr>
@@ -31023,7 +31023,7 @@
           <p:cNvPr id="6" name="TextBox 5">
             <a:extLst xmlns:a="http://schemas.openxmlformats.org/drawingml/2006/main">
               <a:ext uri="{FF2B5EF4-FFF2-40B4-BE49-F238E27FC236}">
-                <a16:creationId xmlns:a16="http://schemas.microsoft.com/office/drawing/2014/main" id="{B0BD5FE0-5A99-4118-AC99-ADACEED5B4E6}"/>
+                <a16:creationId xmlns:a16="http://schemas.microsoft.com/office/drawing/2014/main" id="{D48A2C9F-8BB1-47A5-B9B1-51317746BF3E}"/>
               </a:ext>
             </a:extLst>
           </p:cNvPr>
@@ -31060,7 +31060,7 @@
                 <a:ea typeface="Aptos"/>
                 <a:cs typeface="Aptos"/>
               </a:rPr>
-              <a:t>Independent public evidence summary · 2026.07.23-10 · 2026-07-22 · Sources: Official judgments: 8 Ni 18/24 (EP); 7 O 3341/24</a:t>
+              <a:t>Independent public evidence summary · 2026.07.23-11 · 2026-07-22 · Sources: Official judgments: 8 Ni 18/24 (EP); 7 O 3341/24</a:t>
             </a:r>
           </a:p>
         </p:txBody>
@@ -31070,7 +31070,7 @@
           <p:cNvPr id="7" name="TextBox 6">
             <a:extLst xmlns:a="http://schemas.openxmlformats.org/drawingml/2006/main">
               <a:ext uri="{FF2B5EF4-FFF2-40B4-BE49-F238E27FC236}">
-                <a16:creationId xmlns:a16="http://schemas.microsoft.com/office/drawing/2014/main" id="{77CEAACA-00B6-486A-B429-8A2B215F5660}"/>
+                <a16:creationId xmlns:a16="http://schemas.microsoft.com/office/drawing/2014/main" id="{2818A023-8404-438C-A48F-2A333DB41583}"/>
               </a:ext>
             </a:extLst>
           </p:cNvPr>
@@ -31391,7 +31391,7 @@
           <p:cNvPr id="9" name="TextBox 8">
             <a:extLst xmlns:a="http://schemas.openxmlformats.org/drawingml/2006/main">
               <a:ext uri="{FF2B5EF4-FFF2-40B4-BE49-F238E27FC236}">
-                <a16:creationId xmlns:a16="http://schemas.microsoft.com/office/drawing/2014/main" id="{08BB7F44-71E3-4CDB-8FA9-C9E12C934A70}"/>
+                <a16:creationId xmlns:a16="http://schemas.microsoft.com/office/drawing/2014/main" id="{B904C8E7-DA64-497E-96F1-2E2EC44A7B4A}"/>
               </a:ext>
             </a:extLst>
           </p:cNvPr>
@@ -31436,7 +31436,7 @@
     </p:spTree>
     <p:extLst>
       <p:ext uri="{BB962C8B-B14F-4D97-AF65-F5344CB8AC3E}">
-        <p14:creationId xmlns:p14="http://schemas.microsoft.com/office/powerpoint/2010/main" val="896396466"/>
+        <p14:creationId xmlns:p14="http://schemas.microsoft.com/office/powerpoint/2010/main" val="273613862"/>
       </p:ext>
     </p:extLst>
   </p:cSld>

</xml_diff>

<commit_message>
Publish Canada and vendor outreach status
</commit_message>
<xml_diff>
--- a/site/downloads/pixan-bank-deck-large-en.pptx
+++ b/site/downloads/pixan-bank-deck-large-en.pptx
@@ -2,42 +2,42 @@
 <file path=ppt/presentation.xml><?xml version="1.0" encoding="utf-8"?>
 <p:presentation xmlns:p="http://schemas.openxmlformats.org/presentationml/2006/main">
   <p:sldMasterIdLst>
-    <p:sldMasterId xmlns:r="http://schemas.openxmlformats.org/officeDocument/2006/relationships" id="2147483648" r:id="Re7e2019882044e15"/>
+    <p:sldMasterId xmlns:r="http://schemas.openxmlformats.org/officeDocument/2006/relationships" id="2147483648" r:id="Rd2e224fe3a454244"/>
   </p:sldMasterIdLst>
   <p:notesMasterIdLst>
-    <p:notesMasterId xmlns:r="http://schemas.openxmlformats.org/officeDocument/2006/relationships" r:id="R802a4da9f6b44856"/>
+    <p:notesMasterId xmlns:r="http://schemas.openxmlformats.org/officeDocument/2006/relationships" r:id="Rbb1a95e66067492f"/>
   </p:notesMasterIdLst>
   <p:sldIdLst>
-    <p:sldId xmlns:r="http://schemas.openxmlformats.org/officeDocument/2006/relationships" id="256" r:id="Rdbd15247a94a47c9"/>
-    <p:sldId xmlns:r="http://schemas.openxmlformats.org/officeDocument/2006/relationships" id="257" r:id="R802680e7c5454b62"/>
-    <p:sldId xmlns:r="http://schemas.openxmlformats.org/officeDocument/2006/relationships" id="258" r:id="R6a3b740eaf304d7e"/>
-    <p:sldId xmlns:r="http://schemas.openxmlformats.org/officeDocument/2006/relationships" id="259" r:id="Rf9e6902db2fb4af2"/>
-    <p:sldId xmlns:r="http://schemas.openxmlformats.org/officeDocument/2006/relationships" id="260" r:id="Rf24a7298b3c54671"/>
-    <p:sldId xmlns:r="http://schemas.openxmlformats.org/officeDocument/2006/relationships" id="261" r:id="R8e88cf1d30f94d03"/>
-    <p:sldId xmlns:r="http://schemas.openxmlformats.org/officeDocument/2006/relationships" id="262" r:id="Rdc6bff2d12d843c2"/>
-    <p:sldId xmlns:r="http://schemas.openxmlformats.org/officeDocument/2006/relationships" id="263" r:id="Rf9fc0559d19348b9"/>
-    <p:sldId xmlns:r="http://schemas.openxmlformats.org/officeDocument/2006/relationships" id="264" r:id="R3ab9a4e3a6694c58"/>
-    <p:sldId xmlns:r="http://schemas.openxmlformats.org/officeDocument/2006/relationships" id="265" r:id="R69c792d8e6cf4051"/>
-    <p:sldId xmlns:r="http://schemas.openxmlformats.org/officeDocument/2006/relationships" id="266" r:id="R3d78e3a944a34bfd"/>
-    <p:sldId xmlns:r="http://schemas.openxmlformats.org/officeDocument/2006/relationships" id="267" r:id="R16d05dcf2bda430a"/>
-    <p:sldId xmlns:r="http://schemas.openxmlformats.org/officeDocument/2006/relationships" id="268" r:id="R70c5d9cc9b0a4f9b"/>
-    <p:sldId xmlns:r="http://schemas.openxmlformats.org/officeDocument/2006/relationships" id="269" r:id="Ra951ebbdf946466c"/>
-    <p:sldId xmlns:r="http://schemas.openxmlformats.org/officeDocument/2006/relationships" id="270" r:id="R8dc1785b943e4640"/>
-    <p:sldId xmlns:r="http://schemas.openxmlformats.org/officeDocument/2006/relationships" id="271" r:id="Rde5e759cb18a42b2"/>
-    <p:sldId xmlns:r="http://schemas.openxmlformats.org/officeDocument/2006/relationships" id="272" r:id="R1737235b89ba458a"/>
-    <p:sldId xmlns:r="http://schemas.openxmlformats.org/officeDocument/2006/relationships" id="273" r:id="Ra10f2db6d21b44d5"/>
-    <p:sldId xmlns:r="http://schemas.openxmlformats.org/officeDocument/2006/relationships" id="274" r:id="Rc2ff847a2f634276"/>
-    <p:sldId xmlns:r="http://schemas.openxmlformats.org/officeDocument/2006/relationships" id="275" r:id="R9d4c8068f8e24008"/>
-    <p:sldId xmlns:r="http://schemas.openxmlformats.org/officeDocument/2006/relationships" id="276" r:id="R42003a71fd2449c4"/>
-    <p:sldId xmlns:r="http://schemas.openxmlformats.org/officeDocument/2006/relationships" id="277" r:id="Rcde60cb5432e4778"/>
-    <p:sldId xmlns:r="http://schemas.openxmlformats.org/officeDocument/2006/relationships" id="278" r:id="R89819fbbe5c74fe1"/>
-    <p:sldId xmlns:r="http://schemas.openxmlformats.org/officeDocument/2006/relationships" id="279" r:id="Rf955841f08cb474c"/>
-    <p:sldId xmlns:r="http://schemas.openxmlformats.org/officeDocument/2006/relationships" id="280" r:id="R840335f4bca249a9"/>
-    <p:sldId xmlns:r="http://schemas.openxmlformats.org/officeDocument/2006/relationships" id="281" r:id="Ra1af903b893b4d96"/>
-    <p:sldId xmlns:r="http://schemas.openxmlformats.org/officeDocument/2006/relationships" id="282" r:id="R852c1820c4d44844"/>
-    <p:sldId xmlns:r="http://schemas.openxmlformats.org/officeDocument/2006/relationships" id="283" r:id="R6e40e57a34284278"/>
-    <p:sldId xmlns:r="http://schemas.openxmlformats.org/officeDocument/2006/relationships" id="284" r:id="Rddecc54555734b2f"/>
-    <p:sldId xmlns:r="http://schemas.openxmlformats.org/officeDocument/2006/relationships" id="285" r:id="R8f28f120f45d4582"/>
+    <p:sldId xmlns:r="http://schemas.openxmlformats.org/officeDocument/2006/relationships" id="256" r:id="Ra483134e8296466d"/>
+    <p:sldId xmlns:r="http://schemas.openxmlformats.org/officeDocument/2006/relationships" id="257" r:id="R2ef9fc31563c407a"/>
+    <p:sldId xmlns:r="http://schemas.openxmlformats.org/officeDocument/2006/relationships" id="258" r:id="Rf1f2da0fa10e465f"/>
+    <p:sldId xmlns:r="http://schemas.openxmlformats.org/officeDocument/2006/relationships" id="259" r:id="R84b31a42834f4533"/>
+    <p:sldId xmlns:r="http://schemas.openxmlformats.org/officeDocument/2006/relationships" id="260" r:id="Rfccecb6b1926426a"/>
+    <p:sldId xmlns:r="http://schemas.openxmlformats.org/officeDocument/2006/relationships" id="261" r:id="R5f75e6d5e76c440d"/>
+    <p:sldId xmlns:r="http://schemas.openxmlformats.org/officeDocument/2006/relationships" id="262" r:id="Rc6b0f2e59b714646"/>
+    <p:sldId xmlns:r="http://schemas.openxmlformats.org/officeDocument/2006/relationships" id="263" r:id="Rc80d1822cb404a18"/>
+    <p:sldId xmlns:r="http://schemas.openxmlformats.org/officeDocument/2006/relationships" id="264" r:id="R2053ebffc0de4173"/>
+    <p:sldId xmlns:r="http://schemas.openxmlformats.org/officeDocument/2006/relationships" id="265" r:id="R7e36e56679eb4ad9"/>
+    <p:sldId xmlns:r="http://schemas.openxmlformats.org/officeDocument/2006/relationships" id="266" r:id="R38b3616dbdc3498d"/>
+    <p:sldId xmlns:r="http://schemas.openxmlformats.org/officeDocument/2006/relationships" id="267" r:id="R08d742e9d13444ea"/>
+    <p:sldId xmlns:r="http://schemas.openxmlformats.org/officeDocument/2006/relationships" id="268" r:id="R28322da567d74d2f"/>
+    <p:sldId xmlns:r="http://schemas.openxmlformats.org/officeDocument/2006/relationships" id="269" r:id="Ref11d4629d404c45"/>
+    <p:sldId xmlns:r="http://schemas.openxmlformats.org/officeDocument/2006/relationships" id="270" r:id="R49a4bab82bd24d41"/>
+    <p:sldId xmlns:r="http://schemas.openxmlformats.org/officeDocument/2006/relationships" id="271" r:id="R4f9a341118704480"/>
+    <p:sldId xmlns:r="http://schemas.openxmlformats.org/officeDocument/2006/relationships" id="272" r:id="Rc7aa13dff0d3478d"/>
+    <p:sldId xmlns:r="http://schemas.openxmlformats.org/officeDocument/2006/relationships" id="273" r:id="R9031f97c040743d4"/>
+    <p:sldId xmlns:r="http://schemas.openxmlformats.org/officeDocument/2006/relationships" id="274" r:id="R6d2b9de33383417c"/>
+    <p:sldId xmlns:r="http://schemas.openxmlformats.org/officeDocument/2006/relationships" id="275" r:id="Rc1839c8e24e3439e"/>
+    <p:sldId xmlns:r="http://schemas.openxmlformats.org/officeDocument/2006/relationships" id="276" r:id="R27abceca58a346e5"/>
+    <p:sldId xmlns:r="http://schemas.openxmlformats.org/officeDocument/2006/relationships" id="277" r:id="R74fb0c3918da41fa"/>
+    <p:sldId xmlns:r="http://schemas.openxmlformats.org/officeDocument/2006/relationships" id="278" r:id="R38705f1777d347bb"/>
+    <p:sldId xmlns:r="http://schemas.openxmlformats.org/officeDocument/2006/relationships" id="279" r:id="Ref1ee7d5a61e49a9"/>
+    <p:sldId xmlns:r="http://schemas.openxmlformats.org/officeDocument/2006/relationships" id="280" r:id="Rec8e979fa02a4cb7"/>
+    <p:sldId xmlns:r="http://schemas.openxmlformats.org/officeDocument/2006/relationships" id="281" r:id="R1867cadd94df4f5c"/>
+    <p:sldId xmlns:r="http://schemas.openxmlformats.org/officeDocument/2006/relationships" id="282" r:id="R3f80f991fa4a4433"/>
+    <p:sldId xmlns:r="http://schemas.openxmlformats.org/officeDocument/2006/relationships" id="283" r:id="Rea9a9e5320b84382"/>
+    <p:sldId xmlns:r="http://schemas.openxmlformats.org/officeDocument/2006/relationships" id="284" r:id="R5b52f8a31ae14a4e"/>
+    <p:sldId xmlns:r="http://schemas.openxmlformats.org/officeDocument/2006/relationships" id="285" r:id="Rdf722b25b4544ead"/>
   </p:sldIdLst>
   <p:sldSz cx="12191999" cy="6858000"/>
   <p:notesSz cx="6858000" cy="9144000"/>
@@ -2546,7 +2546,7 @@
           <p:cNvPr id="2" name="Title 1">
             <a:extLst xmlns:a="http://schemas.openxmlformats.org/drawingml/2006/main">
               <a:ext uri="{FF2B5EF4-FFF2-40B4-BE49-F238E27FC236}">
-                <a16:creationId xmlns:a16="http://schemas.microsoft.com/office/drawing/2014/main" id="{F7809EC4-1F78-491A-AF12-7F3FE2CAA5B3}"/>
+                <a16:creationId xmlns:a16="http://schemas.microsoft.com/office/drawing/2014/main" id="{DE9CFF5A-54FC-441F-9668-FB1DBC4CA307}"/>
               </a:ext>
             </a:extLst>
           </p:cNvPr>
@@ -2578,7 +2578,7 @@
           <p:cNvPr id="3" name="Subtitle 2">
             <a:extLst xmlns:a="http://schemas.openxmlformats.org/drawingml/2006/main">
               <a:ext uri="{FF2B5EF4-FFF2-40B4-BE49-F238E27FC236}">
-                <a16:creationId xmlns:a16="http://schemas.microsoft.com/office/drawing/2014/main" id="{CAEF7FD6-62F5-4688-A062-8EB20C9FC22F}"/>
+                <a16:creationId xmlns:a16="http://schemas.microsoft.com/office/drawing/2014/main" id="{B9BCB151-1028-4D47-8CD7-FB6BA387F8EB}"/>
               </a:ext>
             </a:extLst>
           </p:cNvPr>
@@ -2701,7 +2701,7 @@
           <p:cNvPr id="4" name="Date Placeholder 3">
             <a:extLst xmlns:a="http://schemas.openxmlformats.org/drawingml/2006/main">
               <a:ext uri="{FF2B5EF4-FFF2-40B4-BE49-F238E27FC236}">
-                <a16:creationId xmlns:a16="http://schemas.microsoft.com/office/drawing/2014/main" id="{1717D429-BDD1-412D-AD1C-B968E7E4E6D3}"/>
+                <a16:creationId xmlns:a16="http://schemas.microsoft.com/office/drawing/2014/main" id="{656BE47E-0F38-4A4E-B361-1C54B0CBCF6D}"/>
               </a:ext>
             </a:extLst>
           </p:cNvPr>
@@ -2728,7 +2728,7 @@
           <p:cNvPr id="5" name="Footer Placeholder 4">
             <a:extLst xmlns:a="http://schemas.openxmlformats.org/drawingml/2006/main">
               <a:ext uri="{FF2B5EF4-FFF2-40B4-BE49-F238E27FC236}">
-                <a16:creationId xmlns:a16="http://schemas.microsoft.com/office/drawing/2014/main" id="{5C8FEBEC-CD04-4E11-B74D-589655BD46E3}"/>
+                <a16:creationId xmlns:a16="http://schemas.microsoft.com/office/drawing/2014/main" id="{66F49BAD-6DE0-4DEC-9445-FEA00FA365BB}"/>
               </a:ext>
             </a:extLst>
           </p:cNvPr>
@@ -2751,7 +2751,7 @@
           <p:cNvPr id="6" name="Slide Number Placeholder 5">
             <a:extLst xmlns:a="http://schemas.openxmlformats.org/drawingml/2006/main">
               <a:ext uri="{FF2B5EF4-FFF2-40B4-BE49-F238E27FC236}">
-                <a16:creationId xmlns:a16="http://schemas.microsoft.com/office/drawing/2014/main" id="{B617E9FC-5FD3-4A9A-93C5-78E344B8B68A}"/>
+                <a16:creationId xmlns:a16="http://schemas.microsoft.com/office/drawing/2014/main" id="{62A7EE25-A5A5-42CB-B711-3FD73816C11C}"/>
               </a:ext>
             </a:extLst>
           </p:cNvPr>
@@ -2795,7 +2795,7 @@
           <p:cNvPr id="2" name="Title 1">
             <a:extLst xmlns:a="http://schemas.openxmlformats.org/drawingml/2006/main">
               <a:ext uri="{FF2B5EF4-FFF2-40B4-BE49-F238E27FC236}">
-                <a16:creationId xmlns:a16="http://schemas.microsoft.com/office/drawing/2014/main" id="{4F0BE108-02BC-4BE7-B4E8-730C0C756B65}"/>
+                <a16:creationId xmlns:a16="http://schemas.microsoft.com/office/drawing/2014/main" id="{A6DFA2BB-1C27-4C0B-A030-96EED4F6CC5E}"/>
               </a:ext>
             </a:extLst>
           </p:cNvPr>
@@ -2822,7 +2822,7 @@
           <p:cNvPr id="3" name="Vertical Text Placeholder 2">
             <a:extLst xmlns:a="http://schemas.openxmlformats.org/drawingml/2006/main">
               <a:ext uri="{FF2B5EF4-FFF2-40B4-BE49-F238E27FC236}">
-                <a16:creationId xmlns:a16="http://schemas.microsoft.com/office/drawing/2014/main" id="{EE79F35C-3D32-4F47-9FBA-9097CA82CB23}"/>
+                <a16:creationId xmlns:a16="http://schemas.microsoft.com/office/drawing/2014/main" id="{2E464A65-2B46-4918-A1F7-5235EA204002}"/>
               </a:ext>
             </a:extLst>
           </p:cNvPr>
@@ -2884,7 +2884,7 @@
           <p:cNvPr id="4" name="Date Placeholder 3">
             <a:extLst xmlns:a="http://schemas.openxmlformats.org/drawingml/2006/main">
               <a:ext uri="{FF2B5EF4-FFF2-40B4-BE49-F238E27FC236}">
-                <a16:creationId xmlns:a16="http://schemas.microsoft.com/office/drawing/2014/main" id="{5645855B-22BE-4720-AB75-F9E3CB80BDE5}"/>
+                <a16:creationId xmlns:a16="http://schemas.microsoft.com/office/drawing/2014/main" id="{8ED6EC88-9431-4B00-A0A3-CDB9B640D80B}"/>
               </a:ext>
             </a:extLst>
           </p:cNvPr>
@@ -2911,7 +2911,7 @@
           <p:cNvPr id="5" name="Footer Placeholder 4">
             <a:extLst xmlns:a="http://schemas.openxmlformats.org/drawingml/2006/main">
               <a:ext uri="{FF2B5EF4-FFF2-40B4-BE49-F238E27FC236}">
-                <a16:creationId xmlns:a16="http://schemas.microsoft.com/office/drawing/2014/main" id="{612D3F85-D364-40F7-96B2-AA032F16DA5F}"/>
+                <a16:creationId xmlns:a16="http://schemas.microsoft.com/office/drawing/2014/main" id="{53EF5121-CEF9-4811-B878-3F6AFF0F4235}"/>
               </a:ext>
             </a:extLst>
           </p:cNvPr>
@@ -2934,7 +2934,7 @@
           <p:cNvPr id="6" name="Slide Number Placeholder 5">
             <a:extLst xmlns:a="http://schemas.openxmlformats.org/drawingml/2006/main">
               <a:ext uri="{FF2B5EF4-FFF2-40B4-BE49-F238E27FC236}">
-                <a16:creationId xmlns:a16="http://schemas.microsoft.com/office/drawing/2014/main" id="{2494F1CA-EA7B-4905-B1C8-758D7A236FE8}"/>
+                <a16:creationId xmlns:a16="http://schemas.microsoft.com/office/drawing/2014/main" id="{BEBA299E-4885-4D58-8E92-E64E6E67DC9E}"/>
               </a:ext>
             </a:extLst>
           </p:cNvPr>
@@ -2978,7 +2978,7 @@
           <p:cNvPr id="2" name="Vertical Title 1">
             <a:extLst xmlns:a="http://schemas.openxmlformats.org/drawingml/2006/main">
               <a:ext uri="{FF2B5EF4-FFF2-40B4-BE49-F238E27FC236}">
-                <a16:creationId xmlns:a16="http://schemas.microsoft.com/office/drawing/2014/main" id="{D8624403-4E97-4391-8FE0-F217F20E636A}"/>
+                <a16:creationId xmlns:a16="http://schemas.microsoft.com/office/drawing/2014/main" id="{E5B27A54-182B-4412-9876-9A5846BCD946}"/>
               </a:ext>
             </a:extLst>
           </p:cNvPr>
@@ -3010,7 +3010,7 @@
           <p:cNvPr id="3" name="Vertical Text Placeholder 2">
             <a:extLst xmlns:a="http://schemas.openxmlformats.org/drawingml/2006/main">
               <a:ext uri="{FF2B5EF4-FFF2-40B4-BE49-F238E27FC236}">
-                <a16:creationId xmlns:a16="http://schemas.microsoft.com/office/drawing/2014/main" id="{4645BA77-FD9C-4B47-8ECD-8F35F37E42BF}"/>
+                <a16:creationId xmlns:a16="http://schemas.microsoft.com/office/drawing/2014/main" id="{E4BDE4E6-6AC0-4965-B3B5-F69AC680A65E}"/>
               </a:ext>
             </a:extLst>
           </p:cNvPr>
@@ -3077,7 +3077,7 @@
           <p:cNvPr id="4" name="Date Placeholder 3">
             <a:extLst xmlns:a="http://schemas.openxmlformats.org/drawingml/2006/main">
               <a:ext uri="{FF2B5EF4-FFF2-40B4-BE49-F238E27FC236}">
-                <a16:creationId xmlns:a16="http://schemas.microsoft.com/office/drawing/2014/main" id="{A90F3831-201B-48AA-BA53-7B69D200B3C2}"/>
+                <a16:creationId xmlns:a16="http://schemas.microsoft.com/office/drawing/2014/main" id="{35109CCA-D241-4CB2-BA18-D3DD576FF24A}"/>
               </a:ext>
             </a:extLst>
           </p:cNvPr>
@@ -3104,7 +3104,7 @@
           <p:cNvPr id="5" name="Footer Placeholder 4">
             <a:extLst xmlns:a="http://schemas.openxmlformats.org/drawingml/2006/main">
               <a:ext uri="{FF2B5EF4-FFF2-40B4-BE49-F238E27FC236}">
-                <a16:creationId xmlns:a16="http://schemas.microsoft.com/office/drawing/2014/main" id="{A16A7CF0-5011-40CD-BB42-D2E86B51F4CC}"/>
+                <a16:creationId xmlns:a16="http://schemas.microsoft.com/office/drawing/2014/main" id="{1091C4B0-9245-4D19-BF9F-00B250BD5792}"/>
               </a:ext>
             </a:extLst>
           </p:cNvPr>
@@ -3127,7 +3127,7 @@
           <p:cNvPr id="6" name="Slide Number Placeholder 5">
             <a:extLst xmlns:a="http://schemas.openxmlformats.org/drawingml/2006/main">
               <a:ext uri="{FF2B5EF4-FFF2-40B4-BE49-F238E27FC236}">
-                <a16:creationId xmlns:a16="http://schemas.microsoft.com/office/drawing/2014/main" id="{6BC1D610-9494-4800-9188-3D5A9E49A19E}"/>
+                <a16:creationId xmlns:a16="http://schemas.microsoft.com/office/drawing/2014/main" id="{52DCA9A3-4AAE-4A58-9997-D113BA466620}"/>
               </a:ext>
             </a:extLst>
           </p:cNvPr>
@@ -3171,7 +3171,7 @@
           <p:cNvPr id="2" name="Title 1">
             <a:extLst xmlns:a="http://schemas.openxmlformats.org/drawingml/2006/main">
               <a:ext uri="{FF2B5EF4-FFF2-40B4-BE49-F238E27FC236}">
-                <a16:creationId xmlns:a16="http://schemas.microsoft.com/office/drawing/2014/main" id="{E7DD1674-2CC6-4D95-A90D-5058F88EBDF6}"/>
+                <a16:creationId xmlns:a16="http://schemas.microsoft.com/office/drawing/2014/main" id="{F9B00567-7947-4401-9650-1C1F39D9E37F}"/>
               </a:ext>
             </a:extLst>
           </p:cNvPr>
@@ -3198,7 +3198,7 @@
           <p:cNvPr id="3" name="Content Placeholder 2">
             <a:extLst xmlns:a="http://schemas.openxmlformats.org/drawingml/2006/main">
               <a:ext uri="{FF2B5EF4-FFF2-40B4-BE49-F238E27FC236}">
-                <a16:creationId xmlns:a16="http://schemas.microsoft.com/office/drawing/2014/main" id="{FA7AB130-F27B-4213-BCF3-4BF73361BC04}"/>
+                <a16:creationId xmlns:a16="http://schemas.microsoft.com/office/drawing/2014/main" id="{8D28E0C2-83F7-4661-84E0-FC44D0FC2048}"/>
               </a:ext>
             </a:extLst>
           </p:cNvPr>
@@ -3260,7 +3260,7 @@
           <p:cNvPr id="4" name="Date Placeholder 3">
             <a:extLst xmlns:a="http://schemas.openxmlformats.org/drawingml/2006/main">
               <a:ext uri="{FF2B5EF4-FFF2-40B4-BE49-F238E27FC236}">
-                <a16:creationId xmlns:a16="http://schemas.microsoft.com/office/drawing/2014/main" id="{43FCC16E-437D-49CA-9272-EF238AB79849}"/>
+                <a16:creationId xmlns:a16="http://schemas.microsoft.com/office/drawing/2014/main" id="{AD5F40FC-0B66-4A3A-BD13-8EAE97625ADA}"/>
               </a:ext>
             </a:extLst>
           </p:cNvPr>
@@ -3287,7 +3287,7 @@
           <p:cNvPr id="5" name="Footer Placeholder 4">
             <a:extLst xmlns:a="http://schemas.openxmlformats.org/drawingml/2006/main">
               <a:ext uri="{FF2B5EF4-FFF2-40B4-BE49-F238E27FC236}">
-                <a16:creationId xmlns:a16="http://schemas.microsoft.com/office/drawing/2014/main" id="{ED416D9B-4B77-416F-88D8-F2976A2F9DB5}"/>
+                <a16:creationId xmlns:a16="http://schemas.microsoft.com/office/drawing/2014/main" id="{EF3732AE-2455-4934-9264-FEFA0D499AEF}"/>
               </a:ext>
             </a:extLst>
           </p:cNvPr>
@@ -3310,7 +3310,7 @@
           <p:cNvPr id="6" name="Slide Number Placeholder 5">
             <a:extLst xmlns:a="http://schemas.openxmlformats.org/drawingml/2006/main">
               <a:ext uri="{FF2B5EF4-FFF2-40B4-BE49-F238E27FC236}">
-                <a16:creationId xmlns:a16="http://schemas.microsoft.com/office/drawing/2014/main" id="{3EF9937D-A620-4720-BBC6-A2F488E48C1E}"/>
+                <a16:creationId xmlns:a16="http://schemas.microsoft.com/office/drawing/2014/main" id="{9575C7CA-4A93-407E-BDA8-7A477DDA1A4B}"/>
               </a:ext>
             </a:extLst>
           </p:cNvPr>
@@ -3354,7 +3354,7 @@
           <p:cNvPr id="2" name="Title 1">
             <a:extLst xmlns:a="http://schemas.openxmlformats.org/drawingml/2006/main">
               <a:ext uri="{FF2B5EF4-FFF2-40B4-BE49-F238E27FC236}">
-                <a16:creationId xmlns:a16="http://schemas.microsoft.com/office/drawing/2014/main" id="{94E9EF8A-FC8B-46CE-962B-AD19D8581E71}"/>
+                <a16:creationId xmlns:a16="http://schemas.microsoft.com/office/drawing/2014/main" id="{EEF637FB-9536-433C-AB37-9D4112EF0732}"/>
               </a:ext>
             </a:extLst>
           </p:cNvPr>
@@ -3391,7 +3391,7 @@
           <p:cNvPr id="3" name="Text Placeholder 2">
             <a:extLst xmlns:a="http://schemas.openxmlformats.org/drawingml/2006/main">
               <a:ext uri="{FF2B5EF4-FFF2-40B4-BE49-F238E27FC236}">
-                <a16:creationId xmlns:a16="http://schemas.microsoft.com/office/drawing/2014/main" id="{513D9717-1828-49AD-9F8C-4FDAA641A6CC}"/>
+                <a16:creationId xmlns:a16="http://schemas.microsoft.com/office/drawing/2014/main" id="{28B14ED7-E9CB-4334-948C-1C4752FA125A}"/>
               </a:ext>
             </a:extLst>
           </p:cNvPr>
@@ -3517,7 +3517,7 @@
           <p:cNvPr id="4" name="Date Placeholder 3">
             <a:extLst xmlns:a="http://schemas.openxmlformats.org/drawingml/2006/main">
               <a:ext uri="{FF2B5EF4-FFF2-40B4-BE49-F238E27FC236}">
-                <a16:creationId xmlns:a16="http://schemas.microsoft.com/office/drawing/2014/main" id="{B578AB29-2FAD-4ECF-9BB8-99263C16D722}"/>
+                <a16:creationId xmlns:a16="http://schemas.microsoft.com/office/drawing/2014/main" id="{625A9DC9-98F1-4DC3-914A-87F847B1236F}"/>
               </a:ext>
             </a:extLst>
           </p:cNvPr>
@@ -3544,7 +3544,7 @@
           <p:cNvPr id="5" name="Footer Placeholder 4">
             <a:extLst xmlns:a="http://schemas.openxmlformats.org/drawingml/2006/main">
               <a:ext uri="{FF2B5EF4-FFF2-40B4-BE49-F238E27FC236}">
-                <a16:creationId xmlns:a16="http://schemas.microsoft.com/office/drawing/2014/main" id="{9A1760C3-2F0C-4B48-BA15-018AE0FDAF46}"/>
+                <a16:creationId xmlns:a16="http://schemas.microsoft.com/office/drawing/2014/main" id="{31DE74AD-EF91-4647-9552-9BD2B22F4233}"/>
               </a:ext>
             </a:extLst>
           </p:cNvPr>
@@ -3567,7 +3567,7 @@
           <p:cNvPr id="6" name="Slide Number Placeholder 5">
             <a:extLst xmlns:a="http://schemas.openxmlformats.org/drawingml/2006/main">
               <a:ext uri="{FF2B5EF4-FFF2-40B4-BE49-F238E27FC236}">
-                <a16:creationId xmlns:a16="http://schemas.microsoft.com/office/drawing/2014/main" id="{1C85D8CD-FD29-4DC1-86B1-749BF7E81972}"/>
+                <a16:creationId xmlns:a16="http://schemas.microsoft.com/office/drawing/2014/main" id="{95875645-1F33-409D-9625-62B92E7D69DF}"/>
               </a:ext>
             </a:extLst>
           </p:cNvPr>
@@ -3611,7 +3611,7 @@
           <p:cNvPr id="2" name="Title 1">
             <a:extLst xmlns:a="http://schemas.openxmlformats.org/drawingml/2006/main">
               <a:ext uri="{FF2B5EF4-FFF2-40B4-BE49-F238E27FC236}">
-                <a16:creationId xmlns:a16="http://schemas.microsoft.com/office/drawing/2014/main" id="{2BF5DFF3-EC5D-46C6-94AC-C6D84D3B6AAC}"/>
+                <a16:creationId xmlns:a16="http://schemas.microsoft.com/office/drawing/2014/main" id="{52792A39-F1A8-49B7-A4B6-DEF9C887F883}"/>
               </a:ext>
             </a:extLst>
           </p:cNvPr>
@@ -3638,7 +3638,7 @@
           <p:cNvPr id="3" name="Content Placeholder 2">
             <a:extLst xmlns:a="http://schemas.openxmlformats.org/drawingml/2006/main">
               <a:ext uri="{FF2B5EF4-FFF2-40B4-BE49-F238E27FC236}">
-                <a16:creationId xmlns:a16="http://schemas.microsoft.com/office/drawing/2014/main" id="{F01F61E4-4662-4819-B1D1-1C90220B952E}"/>
+                <a16:creationId xmlns:a16="http://schemas.microsoft.com/office/drawing/2014/main" id="{C9D837DB-23B4-4450-9FE5-3CF40D79C091}"/>
               </a:ext>
             </a:extLst>
           </p:cNvPr>
@@ -3742,7 +3742,7 @@
           <p:cNvPr id="4" name="Content Placeholder 3">
             <a:extLst xmlns:a="http://schemas.openxmlformats.org/drawingml/2006/main">
               <a:ext uri="{FF2B5EF4-FFF2-40B4-BE49-F238E27FC236}">
-                <a16:creationId xmlns:a16="http://schemas.microsoft.com/office/drawing/2014/main" id="{2DDF5A29-C6D5-4351-8284-82A93160589D}"/>
+                <a16:creationId xmlns:a16="http://schemas.microsoft.com/office/drawing/2014/main" id="{BE21CE5C-EEDC-4E89-9864-9A9DB80F85A5}"/>
               </a:ext>
             </a:extLst>
           </p:cNvPr>
@@ -3846,7 +3846,7 @@
           <p:cNvPr id="5" name="Date Placeholder 4">
             <a:extLst xmlns:a="http://schemas.openxmlformats.org/drawingml/2006/main">
               <a:ext uri="{FF2B5EF4-FFF2-40B4-BE49-F238E27FC236}">
-                <a16:creationId xmlns:a16="http://schemas.microsoft.com/office/drawing/2014/main" id="{57588AA8-06C6-4FC7-9410-96411EA19D0E}"/>
+                <a16:creationId xmlns:a16="http://schemas.microsoft.com/office/drawing/2014/main" id="{523B3672-6E5F-485A-AC8A-56721F51E1E9}"/>
               </a:ext>
             </a:extLst>
           </p:cNvPr>
@@ -3873,7 +3873,7 @@
           <p:cNvPr id="6" name="Footer Placeholder 5">
             <a:extLst xmlns:a="http://schemas.openxmlformats.org/drawingml/2006/main">
               <a:ext uri="{FF2B5EF4-FFF2-40B4-BE49-F238E27FC236}">
-                <a16:creationId xmlns:a16="http://schemas.microsoft.com/office/drawing/2014/main" id="{A9A066A5-69DE-4CFC-A9BB-A7E6CE5D583A}"/>
+                <a16:creationId xmlns:a16="http://schemas.microsoft.com/office/drawing/2014/main" id="{B8ED130F-5BC9-4340-A408-9D5B69074E23}"/>
               </a:ext>
             </a:extLst>
           </p:cNvPr>
@@ -3896,7 +3896,7 @@
           <p:cNvPr id="7" name="Slide Number Placeholder 6">
             <a:extLst xmlns:a="http://schemas.openxmlformats.org/drawingml/2006/main">
               <a:ext uri="{FF2B5EF4-FFF2-40B4-BE49-F238E27FC236}">
-                <a16:creationId xmlns:a16="http://schemas.microsoft.com/office/drawing/2014/main" id="{75451068-69CD-4064-A47D-4810E6053730}"/>
+                <a16:creationId xmlns:a16="http://schemas.microsoft.com/office/drawing/2014/main" id="{B52D8756-5E29-4364-A93A-4FB27C4121FD}"/>
               </a:ext>
             </a:extLst>
           </p:cNvPr>
@@ -3940,7 +3940,7 @@
           <p:cNvPr id="2" name="Title 1">
             <a:extLst xmlns:a="http://schemas.openxmlformats.org/drawingml/2006/main">
               <a:ext uri="{FF2B5EF4-FFF2-40B4-BE49-F238E27FC236}">
-                <a16:creationId xmlns:a16="http://schemas.microsoft.com/office/drawing/2014/main" id="{157A8D42-2B93-4123-A4FB-9A0B190FAC51}"/>
+                <a16:creationId xmlns:a16="http://schemas.microsoft.com/office/drawing/2014/main" id="{9BDFE8A3-BFFE-4054-983C-0AC5702709A0}"/>
               </a:ext>
             </a:extLst>
           </p:cNvPr>
@@ -3972,7 +3972,7 @@
           <p:cNvPr id="3" name="Text Placeholder 2">
             <a:extLst xmlns:a="http://schemas.openxmlformats.org/drawingml/2006/main">
               <a:ext uri="{FF2B5EF4-FFF2-40B4-BE49-F238E27FC236}">
-                <a16:creationId xmlns:a16="http://schemas.microsoft.com/office/drawing/2014/main" id="{7D634F14-F18B-44CD-892F-41300D9A6374}"/>
+                <a16:creationId xmlns:a16="http://schemas.microsoft.com/office/drawing/2014/main" id="{F94403A3-D6C2-4C47-8644-E85FD494CAE1}"/>
               </a:ext>
             </a:extLst>
           </p:cNvPr>
@@ -4044,7 +4044,7 @@
           <p:cNvPr id="4" name="Content Placeholder 3">
             <a:extLst xmlns:a="http://schemas.openxmlformats.org/drawingml/2006/main">
               <a:ext uri="{FF2B5EF4-FFF2-40B4-BE49-F238E27FC236}">
-                <a16:creationId xmlns:a16="http://schemas.microsoft.com/office/drawing/2014/main" id="{3DA1AC27-890F-488D-9713-513E10D3BB0C}"/>
+                <a16:creationId xmlns:a16="http://schemas.microsoft.com/office/drawing/2014/main" id="{6EFAB9C5-88EC-4D9F-8F82-5CBB48453598}"/>
               </a:ext>
             </a:extLst>
           </p:cNvPr>
@@ -4148,7 +4148,7 @@
           <p:cNvPr id="5" name="Text Placeholder 4">
             <a:extLst xmlns:a="http://schemas.openxmlformats.org/drawingml/2006/main">
               <a:ext uri="{FF2B5EF4-FFF2-40B4-BE49-F238E27FC236}">
-                <a16:creationId xmlns:a16="http://schemas.microsoft.com/office/drawing/2014/main" id="{C590CE0D-1888-408E-B60A-4D4A77DD51C5}"/>
+                <a16:creationId xmlns:a16="http://schemas.microsoft.com/office/drawing/2014/main" id="{EB9EB78F-4158-4040-9B05-51FD8B3AEFF4}"/>
               </a:ext>
             </a:extLst>
           </p:cNvPr>
@@ -4220,7 +4220,7 @@
           <p:cNvPr id="6" name="Content Placeholder 5">
             <a:extLst xmlns:a="http://schemas.openxmlformats.org/drawingml/2006/main">
               <a:ext uri="{FF2B5EF4-FFF2-40B4-BE49-F238E27FC236}">
-                <a16:creationId xmlns:a16="http://schemas.microsoft.com/office/drawing/2014/main" id="{CFA1A617-B61F-4F70-AFBA-FCE3FE3F6604}"/>
+                <a16:creationId xmlns:a16="http://schemas.microsoft.com/office/drawing/2014/main" id="{43C924F6-9D02-405C-86AD-C2CDD42B35FB}"/>
               </a:ext>
             </a:extLst>
           </p:cNvPr>
@@ -4324,7 +4324,7 @@
           <p:cNvPr id="7" name="Date Placeholder 6">
             <a:extLst xmlns:a="http://schemas.openxmlformats.org/drawingml/2006/main">
               <a:ext uri="{FF2B5EF4-FFF2-40B4-BE49-F238E27FC236}">
-                <a16:creationId xmlns:a16="http://schemas.microsoft.com/office/drawing/2014/main" id="{66396BB1-BB12-4001-A4C8-535692CC8404}"/>
+                <a16:creationId xmlns:a16="http://schemas.microsoft.com/office/drawing/2014/main" id="{CBCE8EAC-BB34-4ACD-B4F1-4ED68931C583}"/>
               </a:ext>
             </a:extLst>
           </p:cNvPr>
@@ -4351,7 +4351,7 @@
           <p:cNvPr id="8" name="Footer Placeholder 7">
             <a:extLst xmlns:a="http://schemas.openxmlformats.org/drawingml/2006/main">
               <a:ext uri="{FF2B5EF4-FFF2-40B4-BE49-F238E27FC236}">
-                <a16:creationId xmlns:a16="http://schemas.microsoft.com/office/drawing/2014/main" id="{DC5767B0-0E48-4075-BBE6-EAB46F31812C}"/>
+                <a16:creationId xmlns:a16="http://schemas.microsoft.com/office/drawing/2014/main" id="{89941D0F-E763-4BD4-8EEC-C392D11B73FC}"/>
               </a:ext>
             </a:extLst>
           </p:cNvPr>
@@ -4374,7 +4374,7 @@
           <p:cNvPr id="9" name="Slide Number Placeholder 8">
             <a:extLst xmlns:a="http://schemas.openxmlformats.org/drawingml/2006/main">
               <a:ext uri="{FF2B5EF4-FFF2-40B4-BE49-F238E27FC236}">
-                <a16:creationId xmlns:a16="http://schemas.microsoft.com/office/drawing/2014/main" id="{7D602CE6-EA9D-4C19-B338-AE8A10FE565E}"/>
+                <a16:creationId xmlns:a16="http://schemas.microsoft.com/office/drawing/2014/main" id="{F6FB4DA0-527C-4981-B377-53E596CF03EE}"/>
               </a:ext>
             </a:extLst>
           </p:cNvPr>
@@ -4418,7 +4418,7 @@
           <p:cNvPr id="2" name="Title 1">
             <a:extLst xmlns:a="http://schemas.openxmlformats.org/drawingml/2006/main">
               <a:ext uri="{FF2B5EF4-FFF2-40B4-BE49-F238E27FC236}">
-                <a16:creationId xmlns:a16="http://schemas.microsoft.com/office/drawing/2014/main" id="{59A22DAB-8098-4848-BC18-4081ADAF6FC0}"/>
+                <a16:creationId xmlns:a16="http://schemas.microsoft.com/office/drawing/2014/main" id="{8652F4BF-7D1F-4DAE-9A1D-E708B82592A3}"/>
               </a:ext>
             </a:extLst>
           </p:cNvPr>
@@ -4445,7 +4445,7 @@
           <p:cNvPr id="3" name="Date Placeholder 2">
             <a:extLst xmlns:a="http://schemas.openxmlformats.org/drawingml/2006/main">
               <a:ext uri="{FF2B5EF4-FFF2-40B4-BE49-F238E27FC236}">
-                <a16:creationId xmlns:a16="http://schemas.microsoft.com/office/drawing/2014/main" id="{C11ADB71-6949-4161-8A20-0B8D9C8BB0D0}"/>
+                <a16:creationId xmlns:a16="http://schemas.microsoft.com/office/drawing/2014/main" id="{DEDEBFE4-CC3B-456C-AAE5-C81D6EADC74F}"/>
               </a:ext>
             </a:extLst>
           </p:cNvPr>
@@ -4472,7 +4472,7 @@
           <p:cNvPr id="4" name="Footer Placeholder 3">
             <a:extLst xmlns:a="http://schemas.openxmlformats.org/drawingml/2006/main">
               <a:ext uri="{FF2B5EF4-FFF2-40B4-BE49-F238E27FC236}">
-                <a16:creationId xmlns:a16="http://schemas.microsoft.com/office/drawing/2014/main" id="{87FD76C8-280E-4AF0-8C7E-E82781F8ABC7}"/>
+                <a16:creationId xmlns:a16="http://schemas.microsoft.com/office/drawing/2014/main" id="{4DB508F8-E637-436A-81CA-F5E61A6AE4CF}"/>
               </a:ext>
             </a:extLst>
           </p:cNvPr>
@@ -4495,7 +4495,7 @@
           <p:cNvPr id="5" name="Slide Number Placeholder 4">
             <a:extLst xmlns:a="http://schemas.openxmlformats.org/drawingml/2006/main">
               <a:ext uri="{FF2B5EF4-FFF2-40B4-BE49-F238E27FC236}">
-                <a16:creationId xmlns:a16="http://schemas.microsoft.com/office/drawing/2014/main" id="{1D658A89-06AD-4DA6-AF57-1972911E73AA}"/>
+                <a16:creationId xmlns:a16="http://schemas.microsoft.com/office/drawing/2014/main" id="{DFA8EC41-2B57-4D66-9E93-17EE4FB749DF}"/>
               </a:ext>
             </a:extLst>
           </p:cNvPr>
@@ -4539,7 +4539,7 @@
           <p:cNvPr id="2" name="Date Placeholder 1">
             <a:extLst xmlns:a="http://schemas.openxmlformats.org/drawingml/2006/main">
               <a:ext uri="{FF2B5EF4-FFF2-40B4-BE49-F238E27FC236}">
-                <a16:creationId xmlns:a16="http://schemas.microsoft.com/office/drawing/2014/main" id="{1930CD67-232B-45C9-87CA-2AC9394C1D65}"/>
+                <a16:creationId xmlns:a16="http://schemas.microsoft.com/office/drawing/2014/main" id="{CDCF13CD-5E5C-49B3-8776-EF270E9E59B4}"/>
               </a:ext>
             </a:extLst>
           </p:cNvPr>
@@ -4566,7 +4566,7 @@
           <p:cNvPr id="3" name="Footer Placeholder 2">
             <a:extLst xmlns:a="http://schemas.openxmlformats.org/drawingml/2006/main">
               <a:ext uri="{FF2B5EF4-FFF2-40B4-BE49-F238E27FC236}">
-                <a16:creationId xmlns:a16="http://schemas.microsoft.com/office/drawing/2014/main" id="{5E6CF2FC-3961-412D-AD17-1870A1C81AA9}"/>
+                <a16:creationId xmlns:a16="http://schemas.microsoft.com/office/drawing/2014/main" id="{D2275206-0AC9-49D0-B771-13C6CD520886}"/>
               </a:ext>
             </a:extLst>
           </p:cNvPr>
@@ -4589,7 +4589,7 @@
           <p:cNvPr id="4" name="Slide Number Placeholder 3">
             <a:extLst xmlns:a="http://schemas.openxmlformats.org/drawingml/2006/main">
               <a:ext uri="{FF2B5EF4-FFF2-40B4-BE49-F238E27FC236}">
-                <a16:creationId xmlns:a16="http://schemas.microsoft.com/office/drawing/2014/main" id="{F8BE0EA0-3BF2-474E-ACCD-BF9ADF6BBD2B}"/>
+                <a16:creationId xmlns:a16="http://schemas.microsoft.com/office/drawing/2014/main" id="{2EB342E2-B691-42E6-9F76-4041507DC6C1}"/>
               </a:ext>
             </a:extLst>
           </p:cNvPr>
@@ -4633,7 +4633,7 @@
           <p:cNvPr id="2" name="Title 1">
             <a:extLst xmlns:a="http://schemas.openxmlformats.org/drawingml/2006/main">
               <a:ext uri="{FF2B5EF4-FFF2-40B4-BE49-F238E27FC236}">
-                <a16:creationId xmlns:a16="http://schemas.microsoft.com/office/drawing/2014/main" id="{11D19ECF-07D8-42C5-AF5D-D08A09FCA865}"/>
+                <a16:creationId xmlns:a16="http://schemas.microsoft.com/office/drawing/2014/main" id="{B0D6A0AD-482C-44B3-88F3-BCE778C73ACB}"/>
               </a:ext>
             </a:extLst>
           </p:cNvPr>
@@ -4670,7 +4670,7 @@
           <p:cNvPr id="3" name="Content Placeholder 2">
             <a:extLst xmlns:a="http://schemas.openxmlformats.org/drawingml/2006/main">
               <a:ext uri="{FF2B5EF4-FFF2-40B4-BE49-F238E27FC236}">
-                <a16:creationId xmlns:a16="http://schemas.microsoft.com/office/drawing/2014/main" id="{A8F8DC87-6295-466C-8AA4-6C9AAB2BB42F}"/>
+                <a16:creationId xmlns:a16="http://schemas.microsoft.com/office/drawing/2014/main" id="{408BD542-2A74-48B4-B696-E9E467FFB033}"/>
               </a:ext>
             </a:extLst>
           </p:cNvPr>
@@ -4774,7 +4774,7 @@
           <p:cNvPr id="4" name="Text Placeholder 3">
             <a:extLst xmlns:a="http://schemas.openxmlformats.org/drawingml/2006/main">
               <a:ext uri="{FF2B5EF4-FFF2-40B4-BE49-F238E27FC236}">
-                <a16:creationId xmlns:a16="http://schemas.microsoft.com/office/drawing/2014/main" id="{A3DF6698-2174-4CC6-919E-9D9F3AB10AB8}"/>
+                <a16:creationId xmlns:a16="http://schemas.microsoft.com/office/drawing/2014/main" id="{0D86CBD4-80B7-4E98-B985-A9094315D921}"/>
               </a:ext>
             </a:extLst>
           </p:cNvPr>
@@ -4846,7 +4846,7 @@
           <p:cNvPr id="5" name="Date Placeholder 4">
             <a:extLst xmlns:a="http://schemas.openxmlformats.org/drawingml/2006/main">
               <a:ext uri="{FF2B5EF4-FFF2-40B4-BE49-F238E27FC236}">
-                <a16:creationId xmlns:a16="http://schemas.microsoft.com/office/drawing/2014/main" id="{F8D5C5D3-FE37-42BF-8B11-66C39C4F7EB0}"/>
+                <a16:creationId xmlns:a16="http://schemas.microsoft.com/office/drawing/2014/main" id="{85E766DF-93E0-4A35-9514-D37CEFC41972}"/>
               </a:ext>
             </a:extLst>
           </p:cNvPr>
@@ -4873,7 +4873,7 @@
           <p:cNvPr id="6" name="Footer Placeholder 5">
             <a:extLst xmlns:a="http://schemas.openxmlformats.org/drawingml/2006/main">
               <a:ext uri="{FF2B5EF4-FFF2-40B4-BE49-F238E27FC236}">
-                <a16:creationId xmlns:a16="http://schemas.microsoft.com/office/drawing/2014/main" id="{ACC099E8-7D2C-436C-9756-7F298A354871}"/>
+                <a16:creationId xmlns:a16="http://schemas.microsoft.com/office/drawing/2014/main" id="{35062FE3-77CC-4407-8349-ED21FEA8629E}"/>
               </a:ext>
             </a:extLst>
           </p:cNvPr>
@@ -4896,7 +4896,7 @@
           <p:cNvPr id="7" name="Slide Number Placeholder 6">
             <a:extLst xmlns:a="http://schemas.openxmlformats.org/drawingml/2006/main">
               <a:ext uri="{FF2B5EF4-FFF2-40B4-BE49-F238E27FC236}">
-                <a16:creationId xmlns:a16="http://schemas.microsoft.com/office/drawing/2014/main" id="{275DC1BB-7E9C-4B5E-BEDE-CB063379CCAE}"/>
+                <a16:creationId xmlns:a16="http://schemas.microsoft.com/office/drawing/2014/main" id="{4C3E5E03-3CED-47BC-92BF-9D183B531F1B}"/>
               </a:ext>
             </a:extLst>
           </p:cNvPr>
@@ -4940,7 +4940,7 @@
           <p:cNvPr id="2" name="Title 1">
             <a:extLst xmlns:a="http://schemas.openxmlformats.org/drawingml/2006/main">
               <a:ext uri="{FF2B5EF4-FFF2-40B4-BE49-F238E27FC236}">
-                <a16:creationId xmlns:a16="http://schemas.microsoft.com/office/drawing/2014/main" id="{30D6BAC2-A6EE-445B-867C-BA2E6F059142}"/>
+                <a16:creationId xmlns:a16="http://schemas.microsoft.com/office/drawing/2014/main" id="{B21E1284-005D-4C01-9B8D-DFCFD5834C38}"/>
               </a:ext>
             </a:extLst>
           </p:cNvPr>
@@ -4977,7 +4977,7 @@
           <p:cNvPr id="3" name="Picture Placeholder 2">
             <a:extLst xmlns:a="http://schemas.openxmlformats.org/drawingml/2006/main">
               <a:ext uri="{FF2B5EF4-FFF2-40B4-BE49-F238E27FC236}">
-                <a16:creationId xmlns:a16="http://schemas.microsoft.com/office/drawing/2014/main" id="{7E645AB5-7E6A-4E4B-BB27-476B6408E817}"/>
+                <a16:creationId xmlns:a16="http://schemas.microsoft.com/office/drawing/2014/main" id="{013154CF-D6BB-4FA6-9FF8-0588C89F0967}"/>
               </a:ext>
             </a:extLst>
           </p:cNvPr>
@@ -5042,7 +5042,7 @@
           <p:cNvPr id="4" name="Text Placeholder 3">
             <a:extLst xmlns:a="http://schemas.openxmlformats.org/drawingml/2006/main">
               <a:ext uri="{FF2B5EF4-FFF2-40B4-BE49-F238E27FC236}">
-                <a16:creationId xmlns:a16="http://schemas.microsoft.com/office/drawing/2014/main" id="{241B3D2E-249B-46D8-9A95-3B2CA4FE089F}"/>
+                <a16:creationId xmlns:a16="http://schemas.microsoft.com/office/drawing/2014/main" id="{13606773-D51E-4ED0-A2DE-11EEE1FEB3D6}"/>
               </a:ext>
             </a:extLst>
           </p:cNvPr>
@@ -5114,7 +5114,7 @@
           <p:cNvPr id="5" name="Date Placeholder 4">
             <a:extLst xmlns:a="http://schemas.openxmlformats.org/drawingml/2006/main">
               <a:ext uri="{FF2B5EF4-FFF2-40B4-BE49-F238E27FC236}">
-                <a16:creationId xmlns:a16="http://schemas.microsoft.com/office/drawing/2014/main" id="{9780C79C-7EFA-4EE1-8C81-DF74397ABF66}"/>
+                <a16:creationId xmlns:a16="http://schemas.microsoft.com/office/drawing/2014/main" id="{17F3AAEC-E99B-44D3-BF8C-7A716E220D26}"/>
               </a:ext>
             </a:extLst>
           </p:cNvPr>
@@ -5141,7 +5141,7 @@
           <p:cNvPr id="6" name="Footer Placeholder 5">
             <a:extLst xmlns:a="http://schemas.openxmlformats.org/drawingml/2006/main">
               <a:ext uri="{FF2B5EF4-FFF2-40B4-BE49-F238E27FC236}">
-                <a16:creationId xmlns:a16="http://schemas.microsoft.com/office/drawing/2014/main" id="{D507E20D-4779-48A7-89F0-AAFC7046ACFA}"/>
+                <a16:creationId xmlns:a16="http://schemas.microsoft.com/office/drawing/2014/main" id="{33DBFD80-7C02-444D-8AE4-0A0EFCD8ED45}"/>
               </a:ext>
             </a:extLst>
           </p:cNvPr>
@@ -5164,7 +5164,7 @@
           <p:cNvPr id="7" name="Slide Number Placeholder 6">
             <a:extLst xmlns:a="http://schemas.openxmlformats.org/drawingml/2006/main">
               <a:ext uri="{FF2B5EF4-FFF2-40B4-BE49-F238E27FC236}">
-                <a16:creationId xmlns:a16="http://schemas.microsoft.com/office/drawing/2014/main" id="{359645BD-EC64-4477-A588-1E4DDFED5D2F}"/>
+                <a16:creationId xmlns:a16="http://schemas.microsoft.com/office/drawing/2014/main" id="{662A46D6-6AAA-478B-9CB9-2313146EC5B7}"/>
               </a:ext>
             </a:extLst>
           </p:cNvPr>
@@ -5213,7 +5213,7 @@
           <p:cNvPr id="2" name="Title Placeholder 1">
             <a:extLst xmlns:a="http://schemas.openxmlformats.org/drawingml/2006/main">
               <a:ext uri="{FF2B5EF4-FFF2-40B4-BE49-F238E27FC236}">
-                <a16:creationId xmlns:a16="http://schemas.microsoft.com/office/drawing/2014/main" id="{463CE577-05E8-45FD-BFFA-4F3335D9EE12}"/>
+                <a16:creationId xmlns:a16="http://schemas.microsoft.com/office/drawing/2014/main" id="{9241D5A8-06A4-40AE-B821-AC7ACD6697F3}"/>
               </a:ext>
             </a:extLst>
           </p:cNvPr>
@@ -5250,7 +5250,7 @@
           <p:cNvPr id="3" name="Text Placeholder 2">
             <a:extLst xmlns:a="http://schemas.openxmlformats.org/drawingml/2006/main">
               <a:ext uri="{FF2B5EF4-FFF2-40B4-BE49-F238E27FC236}">
-                <a16:creationId xmlns:a16="http://schemas.microsoft.com/office/drawing/2014/main" id="{06CAC898-4ABF-4288-8A80-FAD724649EAD}"/>
+                <a16:creationId xmlns:a16="http://schemas.microsoft.com/office/drawing/2014/main" id="{3A6AD352-41B2-4114-97D6-54606EF41EC9}"/>
               </a:ext>
             </a:extLst>
           </p:cNvPr>
@@ -5322,7 +5322,7 @@
           <p:cNvPr id="4" name="Date Placeholder 3">
             <a:extLst xmlns:a="http://schemas.openxmlformats.org/drawingml/2006/main">
               <a:ext uri="{FF2B5EF4-FFF2-40B4-BE49-F238E27FC236}">
-                <a16:creationId xmlns:a16="http://schemas.microsoft.com/office/drawing/2014/main" id="{7163F342-25EE-4651-A9CF-678F904BC2CC}"/>
+                <a16:creationId xmlns:a16="http://schemas.microsoft.com/office/drawing/2014/main" id="{46D3AC29-2DFA-44AE-BAEA-EB030332C427}"/>
               </a:ext>
             </a:extLst>
           </p:cNvPr>
@@ -5368,7 +5368,7 @@
           <p:cNvPr id="5" name="Footer Placeholder 4">
             <a:extLst xmlns:a="http://schemas.openxmlformats.org/drawingml/2006/main">
               <a:ext uri="{FF2B5EF4-FFF2-40B4-BE49-F238E27FC236}">
-                <a16:creationId xmlns:a16="http://schemas.microsoft.com/office/drawing/2014/main" id="{4783FBEE-2C4B-4D6C-A02D-958A6C686837}"/>
+                <a16:creationId xmlns:a16="http://schemas.microsoft.com/office/drawing/2014/main" id="{6CEFEC84-38EE-4037-894B-4C1C047CCBFD}"/>
               </a:ext>
             </a:extLst>
           </p:cNvPr>
@@ -5410,7 +5410,7 @@
           <p:cNvPr id="6" name="Slide Number Placeholder 5">
             <a:extLst xmlns:a="http://schemas.openxmlformats.org/drawingml/2006/main">
               <a:ext uri="{FF2B5EF4-FFF2-40B4-BE49-F238E27FC236}">
-                <a16:creationId xmlns:a16="http://schemas.microsoft.com/office/drawing/2014/main" id="{31D2475F-7035-4E82-A172-65A0301E3756}"/>
+                <a16:creationId xmlns:a16="http://schemas.microsoft.com/office/drawing/2014/main" id="{1202F71C-E9DA-47AC-8A69-D4502BA6BF89}"/>
               </a:ext>
             </a:extLst>
           </p:cNvPr>
@@ -5455,17 +5455,17 @@
   </p:cSld>
   <p:clrMap bg1="lt1" tx1="dk1" bg2="lt2" tx2="dk2" accent1="accent1" accent2="accent2" accent3="accent3" accent4="accent4" accent5="accent5" accent6="accent6" hlink="hlink" folHlink="folHlink"/>
   <p:sldLayoutIdLst>
-    <p:sldLayoutId xmlns:r="http://schemas.openxmlformats.org/officeDocument/2006/relationships" id="2147483649" r:id="R5880d5992620492d"/>
-    <p:sldLayoutId xmlns:r="http://schemas.openxmlformats.org/officeDocument/2006/relationships" id="2147483650" r:id="R737bdcc11a1a4615"/>
-    <p:sldLayoutId xmlns:r="http://schemas.openxmlformats.org/officeDocument/2006/relationships" id="2147483651" r:id="R353bed9000a94343"/>
-    <p:sldLayoutId xmlns:r="http://schemas.openxmlformats.org/officeDocument/2006/relationships" id="2147483652" r:id="R65638369637b44a7"/>
-    <p:sldLayoutId xmlns:r="http://schemas.openxmlformats.org/officeDocument/2006/relationships" id="2147483653" r:id="Rf478e7b23b204987"/>
-    <p:sldLayoutId xmlns:r="http://schemas.openxmlformats.org/officeDocument/2006/relationships" id="2147483654" r:id="R2a2119097b6c4f86"/>
-    <p:sldLayoutId xmlns:r="http://schemas.openxmlformats.org/officeDocument/2006/relationships" id="2147483655" r:id="Rdc13873485f24a10"/>
-    <p:sldLayoutId xmlns:r="http://schemas.openxmlformats.org/officeDocument/2006/relationships" id="2147483656" r:id="Rf29e74eb6d9f4fc7"/>
-    <p:sldLayoutId xmlns:r="http://schemas.openxmlformats.org/officeDocument/2006/relationships" id="2147483657" r:id="R75a0c65fadd1467f"/>
-    <p:sldLayoutId xmlns:r="http://schemas.openxmlformats.org/officeDocument/2006/relationships" id="2147483658" r:id="R10caa8a27bde4399"/>
-    <p:sldLayoutId xmlns:r="http://schemas.openxmlformats.org/officeDocument/2006/relationships" id="2147483659" r:id="Rd83ce658582a4167"/>
+    <p:sldLayoutId xmlns:r="http://schemas.openxmlformats.org/officeDocument/2006/relationships" id="2147483649" r:id="Rbed2389782c24c16"/>
+    <p:sldLayoutId xmlns:r="http://schemas.openxmlformats.org/officeDocument/2006/relationships" id="2147483650" r:id="R34be4a391ddf45a6"/>
+    <p:sldLayoutId xmlns:r="http://schemas.openxmlformats.org/officeDocument/2006/relationships" id="2147483651" r:id="R3e282c7de0c54b99"/>
+    <p:sldLayoutId xmlns:r="http://schemas.openxmlformats.org/officeDocument/2006/relationships" id="2147483652" r:id="Rfc5e6302d77f4c27"/>
+    <p:sldLayoutId xmlns:r="http://schemas.openxmlformats.org/officeDocument/2006/relationships" id="2147483653" r:id="R4f78618d8e664d9c"/>
+    <p:sldLayoutId xmlns:r="http://schemas.openxmlformats.org/officeDocument/2006/relationships" id="2147483654" r:id="R0e4a81a31f3a4608"/>
+    <p:sldLayoutId xmlns:r="http://schemas.openxmlformats.org/officeDocument/2006/relationships" id="2147483655" r:id="Rd213e8e4887e43e9"/>
+    <p:sldLayoutId xmlns:r="http://schemas.openxmlformats.org/officeDocument/2006/relationships" id="2147483656" r:id="R4c5aa0d78df64b8c"/>
+    <p:sldLayoutId xmlns:r="http://schemas.openxmlformats.org/officeDocument/2006/relationships" id="2147483657" r:id="R2de9d93609854543"/>
+    <p:sldLayoutId xmlns:r="http://schemas.openxmlformats.org/officeDocument/2006/relationships" id="2147483658" r:id="R316a9008917b4b56"/>
+    <p:sldLayoutId xmlns:r="http://schemas.openxmlformats.org/officeDocument/2006/relationships" id="2147483659" r:id="R292917e93ff84490"/>
   </p:sldLayoutIdLst>
   <p:txStyles>
     <p:titleStyle>
@@ -6018,7 +6018,7 @@
           <p:cNvPr id="2" name="Rectangle 1">
             <a:extLst xmlns:a="http://schemas.openxmlformats.org/drawingml/2006/main">
               <a:ext uri="{FF2B5EF4-FFF2-40B4-BE49-F238E27FC236}">
-                <a16:creationId xmlns:a16="http://schemas.microsoft.com/office/drawing/2014/main" id="{B84B3351-8466-40AA-BC00-83C83F876BC2}"/>
+                <a16:creationId xmlns:a16="http://schemas.microsoft.com/office/drawing/2014/main" id="{DE49B05D-84C6-49EA-BD23-FE0E828021CA}"/>
               </a:ext>
             </a:extLst>
           </p:cNvPr>
@@ -6073,7 +6073,7 @@
           <p:cNvPr id="3" name="TextBox 2">
             <a:extLst xmlns:a="http://schemas.openxmlformats.org/drawingml/2006/main">
               <a:ext uri="{FF2B5EF4-FFF2-40B4-BE49-F238E27FC236}">
-                <a16:creationId xmlns:a16="http://schemas.microsoft.com/office/drawing/2014/main" id="{55186D4C-04D6-426F-9E00-9C2D02DB9EFF}"/>
+                <a16:creationId xmlns:a16="http://schemas.microsoft.com/office/drawing/2014/main" id="{4BF9BAA8-970B-49DB-80AC-CCD3887B2688}"/>
               </a:ext>
             </a:extLst>
           </p:cNvPr>
@@ -6120,7 +6120,7 @@
           <p:cNvPr id="4" name="TextBox 3">
             <a:extLst xmlns:a="http://schemas.openxmlformats.org/drawingml/2006/main">
               <a:ext uri="{FF2B5EF4-FFF2-40B4-BE49-F238E27FC236}">
-                <a16:creationId xmlns:a16="http://schemas.microsoft.com/office/drawing/2014/main" id="{192657B6-E65C-4E41-96D1-2B75C39BFD2F}"/>
+                <a16:creationId xmlns:a16="http://schemas.microsoft.com/office/drawing/2014/main" id="{26FDB0C7-F999-4590-892C-4534FA994C16}"/>
               </a:ext>
             </a:extLst>
           </p:cNvPr>
@@ -6188,7 +6188,7 @@
           <p:cNvPr id="5" name="TextBox 4">
             <a:extLst xmlns:a="http://schemas.openxmlformats.org/drawingml/2006/main">
               <a:ext uri="{FF2B5EF4-FFF2-40B4-BE49-F238E27FC236}">
-                <a16:creationId xmlns:a16="http://schemas.microsoft.com/office/drawing/2014/main" id="{630CD139-E274-413D-8C13-AB803A3DB5AA}"/>
+                <a16:creationId xmlns:a16="http://schemas.microsoft.com/office/drawing/2014/main" id="{61A49200-6824-4523-9777-881BFCF3BE62}"/>
               </a:ext>
             </a:extLst>
           </p:cNvPr>
@@ -6235,7 +6235,7 @@
           <p:cNvPr id="6" name="Rectangle 5">
             <a:extLst xmlns:a="http://schemas.openxmlformats.org/drawingml/2006/main">
               <a:ext uri="{FF2B5EF4-FFF2-40B4-BE49-F238E27FC236}">
-                <a16:creationId xmlns:a16="http://schemas.microsoft.com/office/drawing/2014/main" id="{CDF288AB-4056-4C6F-8D41-06821AEA6953}"/>
+                <a16:creationId xmlns:a16="http://schemas.microsoft.com/office/drawing/2014/main" id="{2C1E84B4-CD7D-4A03-9685-8BD3892B3886}"/>
               </a:ext>
             </a:extLst>
           </p:cNvPr>
@@ -6290,7 +6290,7 @@
           <p:cNvPr id="7" name="TextBox 6">
             <a:extLst xmlns:a="http://schemas.openxmlformats.org/drawingml/2006/main">
               <a:ext uri="{FF2B5EF4-FFF2-40B4-BE49-F238E27FC236}">
-                <a16:creationId xmlns:a16="http://schemas.microsoft.com/office/drawing/2014/main" id="{08184345-7026-4804-A628-186038CBF1B1}"/>
+                <a16:creationId xmlns:a16="http://schemas.microsoft.com/office/drawing/2014/main" id="{BE605A9C-0B8C-4F82-8BE4-FB0C2A4E040B}"/>
               </a:ext>
             </a:extLst>
           </p:cNvPr>
@@ -6337,7 +6337,7 @@
           <p:cNvPr id="8" name="TextBox 7">
             <a:extLst xmlns:a="http://schemas.openxmlformats.org/drawingml/2006/main">
               <a:ext uri="{FF2B5EF4-FFF2-40B4-BE49-F238E27FC236}">
-                <a16:creationId xmlns:a16="http://schemas.microsoft.com/office/drawing/2014/main" id="{E0C3CA0E-6944-45CA-A613-5743844A9B22}"/>
+                <a16:creationId xmlns:a16="http://schemas.microsoft.com/office/drawing/2014/main" id="{AD37B326-F6E9-419D-80B9-75BC861E098D}"/>
               </a:ext>
             </a:extLst>
           </p:cNvPr>
@@ -6374,7 +6374,7 @@
                 <a:ea typeface="Aptos"/>
                 <a:cs typeface="Aptos"/>
               </a:rPr>
-              <a:t>2026.07.23-11</a:t>
+              <a:t>2026.07.23-12</a:t>
             </a:r>
           </a:p>
         </p:txBody>
@@ -6384,7 +6384,7 @@
           <p:cNvPr id="9" name="TextBox 8">
             <a:extLst xmlns:a="http://schemas.openxmlformats.org/drawingml/2006/main">
               <a:ext uri="{FF2B5EF4-FFF2-40B4-BE49-F238E27FC236}">
-                <a16:creationId xmlns:a16="http://schemas.microsoft.com/office/drawing/2014/main" id="{F9E43497-3EA1-4BB5-82B7-76473D2816E3}"/>
+                <a16:creationId xmlns:a16="http://schemas.microsoft.com/office/drawing/2014/main" id="{FDECED31-D187-4E38-8A05-ABD8E7FF7316}"/>
               </a:ext>
             </a:extLst>
           </p:cNvPr>
@@ -6452,7 +6452,7 @@
           <p:cNvPr id="10" name="TextBox 9">
             <a:extLst xmlns:a="http://schemas.openxmlformats.org/drawingml/2006/main">
               <a:ext uri="{FF2B5EF4-FFF2-40B4-BE49-F238E27FC236}">
-                <a16:creationId xmlns:a16="http://schemas.microsoft.com/office/drawing/2014/main" id="{8EC6B138-2AF1-4947-A8CC-2EE04DD23C8D}"/>
+                <a16:creationId xmlns:a16="http://schemas.microsoft.com/office/drawing/2014/main" id="{ABA6AE49-5D2F-4187-820A-5837FC7E54E0}"/>
               </a:ext>
             </a:extLst>
           </p:cNvPr>
@@ -6499,7 +6499,7 @@
           <p:cNvPr id="11" name="TextBox 10">
             <a:extLst xmlns:a="http://schemas.openxmlformats.org/drawingml/2006/main">
               <a:ext uri="{FF2B5EF4-FFF2-40B4-BE49-F238E27FC236}">
-                <a16:creationId xmlns:a16="http://schemas.microsoft.com/office/drawing/2014/main" id="{F63E0A11-901A-46BC-BB76-E155BF0DC3B6}"/>
+                <a16:creationId xmlns:a16="http://schemas.microsoft.com/office/drawing/2014/main" id="{ED104666-685D-4B3E-B140-3781798CF181}"/>
               </a:ext>
             </a:extLst>
           </p:cNvPr>
@@ -6546,7 +6546,7 @@
           <p:cNvPr id="12" name="TextBox 11">
             <a:extLst xmlns:a="http://schemas.openxmlformats.org/drawingml/2006/main">
               <a:ext uri="{FF2B5EF4-FFF2-40B4-BE49-F238E27FC236}">
-                <a16:creationId xmlns:a16="http://schemas.microsoft.com/office/drawing/2014/main" id="{73F29D8C-8AFC-403A-91A7-95C3EB168CF3}"/>
+                <a16:creationId xmlns:a16="http://schemas.microsoft.com/office/drawing/2014/main" id="{0F93C946-D42B-4E33-BABA-9CA4D14AA274}"/>
               </a:ext>
             </a:extLst>
           </p:cNvPr>
@@ -6591,7 +6591,7 @@
     </p:spTree>
     <p:extLst>
       <p:ext uri="{BB962C8B-B14F-4D97-AF65-F5344CB8AC3E}">
-        <p14:creationId xmlns:p14="http://schemas.microsoft.com/office/powerpoint/2010/main" val="1049812690"/>
+        <p14:creationId xmlns:p14="http://schemas.microsoft.com/office/powerpoint/2010/main" val="675495264"/>
       </p:ext>
     </p:extLst>
   </p:cSld>
@@ -6615,7 +6615,7 @@
           <p:cNvPr id="2" name="TextBox 1">
             <a:extLst xmlns:a="http://schemas.openxmlformats.org/drawingml/2006/main">
               <a:ext uri="{FF2B5EF4-FFF2-40B4-BE49-F238E27FC236}">
-                <a16:creationId xmlns:a16="http://schemas.microsoft.com/office/drawing/2014/main" id="{FB9D0F24-EAC5-40F3-8E3C-144A78F8CE2B}"/>
+                <a16:creationId xmlns:a16="http://schemas.microsoft.com/office/drawing/2014/main" id="{15C9DC2F-2A76-4A2E-99BA-A4B647944ED3}"/>
               </a:ext>
             </a:extLst>
           </p:cNvPr>
@@ -6662,7 +6662,7 @@
           <p:cNvPr id="3" name="TextBox 2">
             <a:extLst xmlns:a="http://schemas.openxmlformats.org/drawingml/2006/main">
               <a:ext uri="{FF2B5EF4-FFF2-40B4-BE49-F238E27FC236}">
-                <a16:creationId xmlns:a16="http://schemas.microsoft.com/office/drawing/2014/main" id="{3570924F-5761-47C5-85D2-BAE3F0C1A1C4}"/>
+                <a16:creationId xmlns:a16="http://schemas.microsoft.com/office/drawing/2014/main" id="{9837D2E9-1CB3-4F09-B662-BFE0BE9CEE77}"/>
               </a:ext>
             </a:extLst>
           </p:cNvPr>
@@ -6709,7 +6709,7 @@
           <p:cNvPr id="4" name="Rectangle 3">
             <a:extLst xmlns:a="http://schemas.openxmlformats.org/drawingml/2006/main">
               <a:ext uri="{FF2B5EF4-FFF2-40B4-BE49-F238E27FC236}">
-                <a16:creationId xmlns:a16="http://schemas.microsoft.com/office/drawing/2014/main" id="{747797E3-C501-4B52-9CF0-C58E64A62DE6}"/>
+                <a16:creationId xmlns:a16="http://schemas.microsoft.com/office/drawing/2014/main" id="{0B5B2CD3-C105-48D0-83D0-443E1F36A5C4}"/>
               </a:ext>
             </a:extLst>
           </p:cNvPr>
@@ -6764,7 +6764,7 @@
           <p:cNvPr id="5" name="Rectangle 4">
             <a:extLst xmlns:a="http://schemas.openxmlformats.org/drawingml/2006/main">
               <a:ext uri="{FF2B5EF4-FFF2-40B4-BE49-F238E27FC236}">
-                <a16:creationId xmlns:a16="http://schemas.microsoft.com/office/drawing/2014/main" id="{0C5AEEC3-A75F-4853-919E-7B1B622A3C58}"/>
+                <a16:creationId xmlns:a16="http://schemas.microsoft.com/office/drawing/2014/main" id="{0A1C10DF-9D4B-4770-A27E-C129B7B25109}"/>
               </a:ext>
             </a:extLst>
           </p:cNvPr>
@@ -6819,7 +6819,7 @@
           <p:cNvPr id="6" name="TextBox 5">
             <a:extLst xmlns:a="http://schemas.openxmlformats.org/drawingml/2006/main">
               <a:ext uri="{FF2B5EF4-FFF2-40B4-BE49-F238E27FC236}">
-                <a16:creationId xmlns:a16="http://schemas.microsoft.com/office/drawing/2014/main" id="{E6ECFFE6-0DAC-4AA2-9FD1-79C622D2F6E0}"/>
+                <a16:creationId xmlns:a16="http://schemas.microsoft.com/office/drawing/2014/main" id="{36FB65CD-1B9B-489A-BBBA-221E0165D24D}"/>
               </a:ext>
             </a:extLst>
           </p:cNvPr>
@@ -6856,7 +6856,7 @@
                 <a:ea typeface="Aptos"/>
                 <a:cs typeface="Aptos"/>
               </a:rPr>
-              <a:t>Independent public evidence summary · 2026.07.23-11 · 2026-07-22 · Sources: RPX; CNIPA guidance; EPO family</a:t>
+              <a:t>Independent public evidence summary · 2026.07.23-12 · 2026-07-22 · Sources: RPX; CNIPA guidance; EPO family</a:t>
             </a:r>
           </a:p>
         </p:txBody>
@@ -6866,7 +6866,7 @@
           <p:cNvPr id="7" name="TextBox 6">
             <a:extLst xmlns:a="http://schemas.openxmlformats.org/drawingml/2006/main">
               <a:ext uri="{FF2B5EF4-FFF2-40B4-BE49-F238E27FC236}">
-                <a16:creationId xmlns:a16="http://schemas.microsoft.com/office/drawing/2014/main" id="{ACD52683-BA25-402A-83D5-630DC02AC1F5}"/>
+                <a16:creationId xmlns:a16="http://schemas.microsoft.com/office/drawing/2014/main" id="{A04B91AC-253A-4256-9762-5702A945D6C2}"/>
               </a:ext>
             </a:extLst>
           </p:cNvPr>
@@ -6913,7 +6913,7 @@
           <p:cNvPr id="8" name="TextBox 7">
             <a:extLst xmlns:a="http://schemas.openxmlformats.org/drawingml/2006/main">
               <a:ext uri="{FF2B5EF4-FFF2-40B4-BE49-F238E27FC236}">
-                <a16:creationId xmlns:a16="http://schemas.microsoft.com/office/drawing/2014/main" id="{791A2B7C-5A34-41AC-BCAE-91F1A0C9CA56}"/>
+                <a16:creationId xmlns:a16="http://schemas.microsoft.com/office/drawing/2014/main" id="{DDF8A575-EA5C-4868-B826-3E9CF843C7F3}"/>
               </a:ext>
             </a:extLst>
           </p:cNvPr>
@@ -6960,7 +6960,7 @@
           <p:cNvPr id="9" name="TextBox 8">
             <a:extLst xmlns:a="http://schemas.openxmlformats.org/drawingml/2006/main">
               <a:ext uri="{FF2B5EF4-FFF2-40B4-BE49-F238E27FC236}">
-                <a16:creationId xmlns:a16="http://schemas.microsoft.com/office/drawing/2014/main" id="{D7DA377A-0968-4D6F-B5E6-DCB9346A85D4}"/>
+                <a16:creationId xmlns:a16="http://schemas.microsoft.com/office/drawing/2014/main" id="{A147BB06-5460-44F0-957A-79D459B2D83B}"/>
               </a:ext>
             </a:extLst>
           </p:cNvPr>
@@ -7057,7 +7057,7 @@
           <p:cNvPr id="10" name="Rounded Rectangle 9">
             <a:extLst xmlns:a="http://schemas.openxmlformats.org/drawingml/2006/main">
               <a:ext uri="{FF2B5EF4-FFF2-40B4-BE49-F238E27FC236}">
-                <a16:creationId xmlns:a16="http://schemas.microsoft.com/office/drawing/2014/main" id="{68E3CCC7-7E5A-48A4-88AB-EC1758E85907}"/>
+                <a16:creationId xmlns:a16="http://schemas.microsoft.com/office/drawing/2014/main" id="{9E0313EA-6426-43A7-AAA0-D11C41CE2D79}"/>
               </a:ext>
             </a:extLst>
           </p:cNvPr>
@@ -7114,7 +7114,7 @@
           <p:cNvPr id="11" name="TextBox 10">
             <a:extLst xmlns:a="http://schemas.openxmlformats.org/drawingml/2006/main">
               <a:ext uri="{FF2B5EF4-FFF2-40B4-BE49-F238E27FC236}">
-                <a16:creationId xmlns:a16="http://schemas.microsoft.com/office/drawing/2014/main" id="{C51FB831-FA6B-4073-BF7C-52E82EEE2CE4}"/>
+                <a16:creationId xmlns:a16="http://schemas.microsoft.com/office/drawing/2014/main" id="{88BF3652-75D7-4075-982E-17A40BA5D65E}"/>
               </a:ext>
             </a:extLst>
           </p:cNvPr>
@@ -7161,7 +7161,7 @@
           <p:cNvPr id="12" name="TextBox 11">
             <a:extLst xmlns:a="http://schemas.openxmlformats.org/drawingml/2006/main">
               <a:ext uri="{FF2B5EF4-FFF2-40B4-BE49-F238E27FC236}">
-                <a16:creationId xmlns:a16="http://schemas.microsoft.com/office/drawing/2014/main" id="{2886A989-23DB-45DB-A944-2D76227A000E}"/>
+                <a16:creationId xmlns:a16="http://schemas.microsoft.com/office/drawing/2014/main" id="{2358EB64-5ABF-4AA4-9D45-D18E53221153}"/>
               </a:ext>
             </a:extLst>
           </p:cNvPr>
@@ -7206,7 +7206,7 @@
     </p:spTree>
     <p:extLst>
       <p:ext uri="{BB962C8B-B14F-4D97-AF65-F5344CB8AC3E}">
-        <p14:creationId xmlns:p14="http://schemas.microsoft.com/office/powerpoint/2010/main" val="1283933904"/>
+        <p14:creationId xmlns:p14="http://schemas.microsoft.com/office/powerpoint/2010/main" val="384004384"/>
       </p:ext>
     </p:extLst>
   </p:cSld>
@@ -7230,7 +7230,7 @@
           <p:cNvPr id="2" name="TextBox 1">
             <a:extLst xmlns:a="http://schemas.openxmlformats.org/drawingml/2006/main">
               <a:ext uri="{FF2B5EF4-FFF2-40B4-BE49-F238E27FC236}">
-                <a16:creationId xmlns:a16="http://schemas.microsoft.com/office/drawing/2014/main" id="{6BBE3564-E4A7-4B38-99B0-9A293E727DEF}"/>
+                <a16:creationId xmlns:a16="http://schemas.microsoft.com/office/drawing/2014/main" id="{E1FAFA87-7A41-4342-A951-2766C24E9949}"/>
               </a:ext>
             </a:extLst>
           </p:cNvPr>
@@ -7277,7 +7277,7 @@
           <p:cNvPr id="3" name="TextBox 2">
             <a:extLst xmlns:a="http://schemas.openxmlformats.org/drawingml/2006/main">
               <a:ext uri="{FF2B5EF4-FFF2-40B4-BE49-F238E27FC236}">
-                <a16:creationId xmlns:a16="http://schemas.microsoft.com/office/drawing/2014/main" id="{0875BA64-0119-4842-A492-4AA3B4183D8A}"/>
+                <a16:creationId xmlns:a16="http://schemas.microsoft.com/office/drawing/2014/main" id="{6293DF1B-94A9-443B-9615-E655D7119B72}"/>
               </a:ext>
             </a:extLst>
           </p:cNvPr>
@@ -7324,7 +7324,7 @@
           <p:cNvPr id="4" name="Rectangle 3">
             <a:extLst xmlns:a="http://schemas.openxmlformats.org/drawingml/2006/main">
               <a:ext uri="{FF2B5EF4-FFF2-40B4-BE49-F238E27FC236}">
-                <a16:creationId xmlns:a16="http://schemas.microsoft.com/office/drawing/2014/main" id="{B70C0224-B96E-4BCF-9B60-2C35F06ABD7F}"/>
+                <a16:creationId xmlns:a16="http://schemas.microsoft.com/office/drawing/2014/main" id="{4D31CF89-0D6A-4069-893A-5B59B21A012F}"/>
               </a:ext>
             </a:extLst>
           </p:cNvPr>
@@ -7379,7 +7379,7 @@
           <p:cNvPr id="5" name="Rectangle 4">
             <a:extLst xmlns:a="http://schemas.openxmlformats.org/drawingml/2006/main">
               <a:ext uri="{FF2B5EF4-FFF2-40B4-BE49-F238E27FC236}">
-                <a16:creationId xmlns:a16="http://schemas.microsoft.com/office/drawing/2014/main" id="{C21C2F0A-32AB-43BF-B93D-AD331F4C36C0}"/>
+                <a16:creationId xmlns:a16="http://schemas.microsoft.com/office/drawing/2014/main" id="{E79F0A3C-3DB7-4E0B-8D8E-8ADEB661F57D}"/>
               </a:ext>
             </a:extLst>
           </p:cNvPr>
@@ -7434,7 +7434,7 @@
           <p:cNvPr id="6" name="TextBox 5">
             <a:extLst xmlns:a="http://schemas.openxmlformats.org/drawingml/2006/main">
               <a:ext uri="{FF2B5EF4-FFF2-40B4-BE49-F238E27FC236}">
-                <a16:creationId xmlns:a16="http://schemas.microsoft.com/office/drawing/2014/main" id="{CFCF2316-FF3C-43E7-B080-7C0FA30C0164}"/>
+                <a16:creationId xmlns:a16="http://schemas.microsoft.com/office/drawing/2014/main" id="{5BD7B9F5-F02C-49F0-826F-F0199E5C9759}"/>
               </a:ext>
             </a:extLst>
           </p:cNvPr>
@@ -7471,7 +7471,7 @@
                 <a:ea typeface="Aptos"/>
                 <a:cs typeface="Aptos"/>
               </a:rPr>
-              <a:t>Independent public evidence summary · 2026.07.23-11 · 2026-07-22 · Sources: IP Australia; PRH; EPO; EPO / UPC; USPTO</a:t>
+              <a:t>Independent public evidence summary · 2026.07.23-12 · 2026-07-22 · Sources: IP Australia; PRH; EPO; EPO / UPC; USPTO</a:t>
             </a:r>
           </a:p>
         </p:txBody>
@@ -7481,7 +7481,7 @@
           <p:cNvPr id="7" name="TextBox 6">
             <a:extLst xmlns:a="http://schemas.openxmlformats.org/drawingml/2006/main">
               <a:ext uri="{FF2B5EF4-FFF2-40B4-BE49-F238E27FC236}">
-                <a16:creationId xmlns:a16="http://schemas.microsoft.com/office/drawing/2014/main" id="{EB74F2ED-5D48-4CFF-839D-FE798D95BBB7}"/>
+                <a16:creationId xmlns:a16="http://schemas.microsoft.com/office/drawing/2014/main" id="{D8EF72CB-16F4-47DB-83CD-BB3CDD3F3452}"/>
               </a:ext>
             </a:extLst>
           </p:cNvPr>
@@ -7968,7 +7968,7 @@
           <p:cNvPr id="9" name="TextBox 8">
             <a:extLst xmlns:a="http://schemas.openxmlformats.org/drawingml/2006/main">
               <a:ext uri="{FF2B5EF4-FFF2-40B4-BE49-F238E27FC236}">
-                <a16:creationId xmlns:a16="http://schemas.microsoft.com/office/drawing/2014/main" id="{9ADD5ED6-9731-493F-8AFC-E28D3CF886F4}"/>
+                <a16:creationId xmlns:a16="http://schemas.microsoft.com/office/drawing/2014/main" id="{78106151-9A54-41D9-9775-ACC8048BC217}"/>
               </a:ext>
             </a:extLst>
           </p:cNvPr>
@@ -8013,7 +8013,7 @@
     </p:spTree>
     <p:extLst>
       <p:ext uri="{BB962C8B-B14F-4D97-AF65-F5344CB8AC3E}">
-        <p14:creationId xmlns:p14="http://schemas.microsoft.com/office/powerpoint/2010/main" val="813080793"/>
+        <p14:creationId xmlns:p14="http://schemas.microsoft.com/office/powerpoint/2010/main" val="2007091940"/>
       </p:ext>
     </p:extLst>
   </p:cSld>
@@ -8037,7 +8037,7 @@
           <p:cNvPr id="2" name="TextBox 1">
             <a:extLst xmlns:a="http://schemas.openxmlformats.org/drawingml/2006/main">
               <a:ext uri="{FF2B5EF4-FFF2-40B4-BE49-F238E27FC236}">
-                <a16:creationId xmlns:a16="http://schemas.microsoft.com/office/drawing/2014/main" id="{83E7E9E7-A255-4CD5-A437-8281F8024E6B}"/>
+                <a16:creationId xmlns:a16="http://schemas.microsoft.com/office/drawing/2014/main" id="{7C90A113-52A6-44CD-9283-1CFDE0085091}"/>
               </a:ext>
             </a:extLst>
           </p:cNvPr>
@@ -8084,7 +8084,7 @@
           <p:cNvPr id="3" name="TextBox 2">
             <a:extLst xmlns:a="http://schemas.openxmlformats.org/drawingml/2006/main">
               <a:ext uri="{FF2B5EF4-FFF2-40B4-BE49-F238E27FC236}">
-                <a16:creationId xmlns:a16="http://schemas.microsoft.com/office/drawing/2014/main" id="{0E23D26C-1474-44A9-B037-D7811D8F97C8}"/>
+                <a16:creationId xmlns:a16="http://schemas.microsoft.com/office/drawing/2014/main" id="{E9DA814B-9F18-4E4F-880D-6B1364F8711C}"/>
               </a:ext>
             </a:extLst>
           </p:cNvPr>
@@ -8131,7 +8131,7 @@
           <p:cNvPr id="4" name="Rectangle 3">
             <a:extLst xmlns:a="http://schemas.openxmlformats.org/drawingml/2006/main">
               <a:ext uri="{FF2B5EF4-FFF2-40B4-BE49-F238E27FC236}">
-                <a16:creationId xmlns:a16="http://schemas.microsoft.com/office/drawing/2014/main" id="{ADD958E2-9C75-4F7C-84DF-467870D8B136}"/>
+                <a16:creationId xmlns:a16="http://schemas.microsoft.com/office/drawing/2014/main" id="{AB05DE5D-A12F-4F44-AD76-A81AD5CD3287}"/>
               </a:ext>
             </a:extLst>
           </p:cNvPr>
@@ -8186,7 +8186,7 @@
           <p:cNvPr id="5" name="Rectangle 4">
             <a:extLst xmlns:a="http://schemas.openxmlformats.org/drawingml/2006/main">
               <a:ext uri="{FF2B5EF4-FFF2-40B4-BE49-F238E27FC236}">
-                <a16:creationId xmlns:a16="http://schemas.microsoft.com/office/drawing/2014/main" id="{EFA6400C-107D-4BBC-B295-F5733076AE5F}"/>
+                <a16:creationId xmlns:a16="http://schemas.microsoft.com/office/drawing/2014/main" id="{3FD9B027-2C56-48EE-9C58-391B88FC637B}"/>
               </a:ext>
             </a:extLst>
           </p:cNvPr>
@@ -8241,7 +8241,7 @@
           <p:cNvPr id="6" name="TextBox 5">
             <a:extLst xmlns:a="http://schemas.openxmlformats.org/drawingml/2006/main">
               <a:ext uri="{FF2B5EF4-FFF2-40B4-BE49-F238E27FC236}">
-                <a16:creationId xmlns:a16="http://schemas.microsoft.com/office/drawing/2014/main" id="{D59947B2-BB7D-45EF-869D-837704F9FACE}"/>
+                <a16:creationId xmlns:a16="http://schemas.microsoft.com/office/drawing/2014/main" id="{334C576B-76B6-4824-B326-9493BC0343EA}"/>
               </a:ext>
             </a:extLst>
           </p:cNvPr>
@@ -8278,7 +8278,7 @@
                 <a:ea typeface="Aptos"/>
                 <a:cs typeface="Aptos"/>
               </a:rPr>
-              <a:t>Independent public evidence summary · 2026.07.23-11 · 2026-07-22 · Sources: UN; Atlas</a:t>
+              <a:t>Independent public evidence summary · 2026.07.23-12 · 2026-07-22 · Sources: UN; Atlas</a:t>
             </a:r>
           </a:p>
         </p:txBody>
@@ -8288,7 +8288,7 @@
           <p:cNvPr id="7" name="TextBox 6">
             <a:extLst xmlns:a="http://schemas.openxmlformats.org/drawingml/2006/main">
               <a:ext uri="{FF2B5EF4-FFF2-40B4-BE49-F238E27FC236}">
-                <a16:creationId xmlns:a16="http://schemas.microsoft.com/office/drawing/2014/main" id="{8F247A69-64CD-49A5-B050-C8669BA7A936}"/>
+                <a16:creationId xmlns:a16="http://schemas.microsoft.com/office/drawing/2014/main" id="{BF0B86AB-DD5A-402C-B78A-FFDF3B3D7169}"/>
               </a:ext>
             </a:extLst>
           </p:cNvPr>
@@ -8335,7 +8335,7 @@
           <p:cNvPr id="8" name="Rounded Rectangle 7">
             <a:extLst xmlns:a="http://schemas.openxmlformats.org/drawingml/2006/main">
               <a:ext uri="{FF2B5EF4-FFF2-40B4-BE49-F238E27FC236}">
-                <a16:creationId xmlns:a16="http://schemas.microsoft.com/office/drawing/2014/main" id="{65AD9409-DA7E-4B38-AA14-91314C3413AD}"/>
+                <a16:creationId xmlns:a16="http://schemas.microsoft.com/office/drawing/2014/main" id="{3D59BF14-1209-4A62-A3EE-3911A276488C}"/>
               </a:ext>
             </a:extLst>
           </p:cNvPr>
@@ -8392,7 +8392,7 @@
           <p:cNvPr id="9" name="TextBox 8">
             <a:extLst xmlns:a="http://schemas.openxmlformats.org/drawingml/2006/main">
               <a:ext uri="{FF2B5EF4-FFF2-40B4-BE49-F238E27FC236}">
-                <a16:creationId xmlns:a16="http://schemas.microsoft.com/office/drawing/2014/main" id="{B0275603-FE95-4480-913F-1CBF68E4D129}"/>
+                <a16:creationId xmlns:a16="http://schemas.microsoft.com/office/drawing/2014/main" id="{44D894F2-94A8-464A-A4DF-06BE7279D54B}"/>
               </a:ext>
             </a:extLst>
           </p:cNvPr>
@@ -8439,7 +8439,7 @@
           <p:cNvPr id="10" name="TextBox 9">
             <a:extLst xmlns:a="http://schemas.openxmlformats.org/drawingml/2006/main">
               <a:ext uri="{FF2B5EF4-FFF2-40B4-BE49-F238E27FC236}">
-                <a16:creationId xmlns:a16="http://schemas.microsoft.com/office/drawing/2014/main" id="{34A753AE-92C9-444B-8DF7-F4C30A71106A}"/>
+                <a16:creationId xmlns:a16="http://schemas.microsoft.com/office/drawing/2014/main" id="{23C19D11-5DAD-4023-8E62-27B5017E1D75}"/>
               </a:ext>
             </a:extLst>
           </p:cNvPr>
@@ -8486,7 +8486,7 @@
           <p:cNvPr id="11" name="Rounded Rectangle 10">
             <a:extLst xmlns:a="http://schemas.openxmlformats.org/drawingml/2006/main">
               <a:ext uri="{FF2B5EF4-FFF2-40B4-BE49-F238E27FC236}">
-                <a16:creationId xmlns:a16="http://schemas.microsoft.com/office/drawing/2014/main" id="{7B6CB931-B7DF-4002-B4BF-89415E28BC12}"/>
+                <a16:creationId xmlns:a16="http://schemas.microsoft.com/office/drawing/2014/main" id="{D1303290-7708-4E5E-B511-E649DE6E4574}"/>
               </a:ext>
             </a:extLst>
           </p:cNvPr>
@@ -8543,7 +8543,7 @@
           <p:cNvPr id="12" name="TextBox 11">
             <a:extLst xmlns:a="http://schemas.openxmlformats.org/drawingml/2006/main">
               <a:ext uri="{FF2B5EF4-FFF2-40B4-BE49-F238E27FC236}">
-                <a16:creationId xmlns:a16="http://schemas.microsoft.com/office/drawing/2014/main" id="{EAFB984C-A669-4C7E-B685-7B52C6AB3038}"/>
+                <a16:creationId xmlns:a16="http://schemas.microsoft.com/office/drawing/2014/main" id="{640C2A7E-4CD9-4743-8C49-FC241A8E4415}"/>
               </a:ext>
             </a:extLst>
           </p:cNvPr>
@@ -8590,7 +8590,7 @@
           <p:cNvPr id="13" name="TextBox 12">
             <a:extLst xmlns:a="http://schemas.openxmlformats.org/drawingml/2006/main">
               <a:ext uri="{FF2B5EF4-FFF2-40B4-BE49-F238E27FC236}">
-                <a16:creationId xmlns:a16="http://schemas.microsoft.com/office/drawing/2014/main" id="{80E0438D-7F36-41AC-A2EA-ECC019B098D2}"/>
+                <a16:creationId xmlns:a16="http://schemas.microsoft.com/office/drawing/2014/main" id="{EF798857-53EE-421A-BD17-35190714DD08}"/>
               </a:ext>
             </a:extLst>
           </p:cNvPr>
@@ -8637,7 +8637,7 @@
           <p:cNvPr id="14" name="Rounded Rectangle 13">
             <a:extLst xmlns:a="http://schemas.openxmlformats.org/drawingml/2006/main">
               <a:ext uri="{FF2B5EF4-FFF2-40B4-BE49-F238E27FC236}">
-                <a16:creationId xmlns:a16="http://schemas.microsoft.com/office/drawing/2014/main" id="{18E8B1C0-5E60-4B1D-8B0B-E8CA3840241D}"/>
+                <a16:creationId xmlns:a16="http://schemas.microsoft.com/office/drawing/2014/main" id="{145D7076-A7C8-43EB-8748-39B0A5F5AD09}"/>
               </a:ext>
             </a:extLst>
           </p:cNvPr>
@@ -8694,7 +8694,7 @@
           <p:cNvPr id="15" name="TextBox 14">
             <a:extLst xmlns:a="http://schemas.openxmlformats.org/drawingml/2006/main">
               <a:ext uri="{FF2B5EF4-FFF2-40B4-BE49-F238E27FC236}">
-                <a16:creationId xmlns:a16="http://schemas.microsoft.com/office/drawing/2014/main" id="{073B9E06-E0BC-4071-B5BF-E982053AA5D6}"/>
+                <a16:creationId xmlns:a16="http://schemas.microsoft.com/office/drawing/2014/main" id="{4BE5288B-11AD-4859-955C-8E3AB4E3002E}"/>
               </a:ext>
             </a:extLst>
           </p:cNvPr>
@@ -8741,7 +8741,7 @@
           <p:cNvPr id="16" name="TextBox 15">
             <a:extLst xmlns:a="http://schemas.openxmlformats.org/drawingml/2006/main">
               <a:ext uri="{FF2B5EF4-FFF2-40B4-BE49-F238E27FC236}">
-                <a16:creationId xmlns:a16="http://schemas.microsoft.com/office/drawing/2014/main" id="{883DDB40-15C2-4BC3-8778-C34019F5E519}"/>
+                <a16:creationId xmlns:a16="http://schemas.microsoft.com/office/drawing/2014/main" id="{3273C7EE-C81C-44C7-B716-00A3D856C329}"/>
               </a:ext>
             </a:extLst>
           </p:cNvPr>
@@ -8788,7 +8788,7 @@
           <p:cNvPr id="17" name="Rounded Rectangle 16">
             <a:extLst xmlns:a="http://schemas.openxmlformats.org/drawingml/2006/main">
               <a:ext uri="{FF2B5EF4-FFF2-40B4-BE49-F238E27FC236}">
-                <a16:creationId xmlns:a16="http://schemas.microsoft.com/office/drawing/2014/main" id="{5907A372-E6B0-4424-A49A-9E1401E9E795}"/>
+                <a16:creationId xmlns:a16="http://schemas.microsoft.com/office/drawing/2014/main" id="{43E047F5-83B5-4848-B0EC-163A57E79360}"/>
               </a:ext>
             </a:extLst>
           </p:cNvPr>
@@ -8845,7 +8845,7 @@
           <p:cNvPr id="18" name="TextBox 17">
             <a:extLst xmlns:a="http://schemas.openxmlformats.org/drawingml/2006/main">
               <a:ext uri="{FF2B5EF4-FFF2-40B4-BE49-F238E27FC236}">
-                <a16:creationId xmlns:a16="http://schemas.microsoft.com/office/drawing/2014/main" id="{0F699235-730C-4A63-B615-9B15796D3EB6}"/>
+                <a16:creationId xmlns:a16="http://schemas.microsoft.com/office/drawing/2014/main" id="{2921064E-902C-40EA-902C-58A2A792AF90}"/>
               </a:ext>
             </a:extLst>
           </p:cNvPr>
@@ -8892,7 +8892,7 @@
           <p:cNvPr id="19" name="TextBox 18">
             <a:extLst xmlns:a="http://schemas.openxmlformats.org/drawingml/2006/main">
               <a:ext uri="{FF2B5EF4-FFF2-40B4-BE49-F238E27FC236}">
-                <a16:creationId xmlns:a16="http://schemas.microsoft.com/office/drawing/2014/main" id="{3CD87749-055B-4BE0-B323-60252D4A9525}"/>
+                <a16:creationId xmlns:a16="http://schemas.microsoft.com/office/drawing/2014/main" id="{AAFF7606-7CAC-4D7F-A03A-BBB66BE05DC3}"/>
               </a:ext>
             </a:extLst>
           </p:cNvPr>
@@ -8939,7 +8939,7 @@
           <p:cNvPr id="20" name="TextBox 19">
             <a:extLst xmlns:a="http://schemas.openxmlformats.org/drawingml/2006/main">
               <a:ext uri="{FF2B5EF4-FFF2-40B4-BE49-F238E27FC236}">
-                <a16:creationId xmlns:a16="http://schemas.microsoft.com/office/drawing/2014/main" id="{71D3152D-DE3C-46EC-BD73-D5AA45C414EA}"/>
+                <a16:creationId xmlns:a16="http://schemas.microsoft.com/office/drawing/2014/main" id="{68FC7135-6DCF-49FC-A4FC-D6181C9DAAD6}"/>
               </a:ext>
             </a:extLst>
           </p:cNvPr>
@@ -8986,7 +8986,7 @@
           <p:cNvPr id="21" name="Rounded Rectangle 20">
             <a:extLst xmlns:a="http://schemas.openxmlformats.org/drawingml/2006/main">
               <a:ext uri="{FF2B5EF4-FFF2-40B4-BE49-F238E27FC236}">
-                <a16:creationId xmlns:a16="http://schemas.microsoft.com/office/drawing/2014/main" id="{097FDE0C-8E62-40B6-BD95-5B9F11AAC2B1}"/>
+                <a16:creationId xmlns:a16="http://schemas.microsoft.com/office/drawing/2014/main" id="{79761306-BB7D-4A33-BB70-E577570D61AB}"/>
               </a:ext>
             </a:extLst>
           </p:cNvPr>
@@ -9043,7 +9043,7 @@
           <p:cNvPr id="22" name="TextBox 21">
             <a:extLst xmlns:a="http://schemas.openxmlformats.org/drawingml/2006/main">
               <a:ext uri="{FF2B5EF4-FFF2-40B4-BE49-F238E27FC236}">
-                <a16:creationId xmlns:a16="http://schemas.microsoft.com/office/drawing/2014/main" id="{1CE2088F-C66A-4721-9A8E-6B6DCDCBD71D}"/>
+                <a16:creationId xmlns:a16="http://schemas.microsoft.com/office/drawing/2014/main" id="{EFE9D8F8-7883-446D-83A8-3193A842E28C}"/>
               </a:ext>
             </a:extLst>
           </p:cNvPr>
@@ -9090,7 +9090,7 @@
           <p:cNvPr id="23" name="TextBox 22">
             <a:extLst xmlns:a="http://schemas.openxmlformats.org/drawingml/2006/main">
               <a:ext uri="{FF2B5EF4-FFF2-40B4-BE49-F238E27FC236}">
-                <a16:creationId xmlns:a16="http://schemas.microsoft.com/office/drawing/2014/main" id="{0428FB92-F183-409A-833F-DB035DFF9F45}"/>
+                <a16:creationId xmlns:a16="http://schemas.microsoft.com/office/drawing/2014/main" id="{DE8C8441-9F47-41C0-BD08-7F4E32936094}"/>
               </a:ext>
             </a:extLst>
           </p:cNvPr>
@@ -9135,7 +9135,7 @@
     </p:spTree>
     <p:extLst>
       <p:ext uri="{BB962C8B-B14F-4D97-AF65-F5344CB8AC3E}">
-        <p14:creationId xmlns:p14="http://schemas.microsoft.com/office/powerpoint/2010/main" val="2086873088"/>
+        <p14:creationId xmlns:p14="http://schemas.microsoft.com/office/powerpoint/2010/main" val="1446232686"/>
       </p:ext>
     </p:extLst>
   </p:cSld>
@@ -9159,7 +9159,7 @@
           <p:cNvPr id="2" name="TextBox 1">
             <a:extLst xmlns:a="http://schemas.openxmlformats.org/drawingml/2006/main">
               <a:ext uri="{FF2B5EF4-FFF2-40B4-BE49-F238E27FC236}">
-                <a16:creationId xmlns:a16="http://schemas.microsoft.com/office/drawing/2014/main" id="{B849AB76-DF25-4E77-9C53-6903765B64B6}"/>
+                <a16:creationId xmlns:a16="http://schemas.microsoft.com/office/drawing/2014/main" id="{8E2C5999-A6FD-4CBA-8140-91148C8ABDC1}"/>
               </a:ext>
             </a:extLst>
           </p:cNvPr>
@@ -9206,7 +9206,7 @@
           <p:cNvPr id="3" name="TextBox 2">
             <a:extLst xmlns:a="http://schemas.openxmlformats.org/drawingml/2006/main">
               <a:ext uri="{FF2B5EF4-FFF2-40B4-BE49-F238E27FC236}">
-                <a16:creationId xmlns:a16="http://schemas.microsoft.com/office/drawing/2014/main" id="{069F2A74-3E7C-4A6A-84ED-70809408F1F6}"/>
+                <a16:creationId xmlns:a16="http://schemas.microsoft.com/office/drawing/2014/main" id="{CC150BCD-BD59-4D36-B1A6-EE2F5A23A0B8}"/>
               </a:ext>
             </a:extLst>
           </p:cNvPr>
@@ -9253,7 +9253,7 @@
           <p:cNvPr id="4" name="Rectangle 3">
             <a:extLst xmlns:a="http://schemas.openxmlformats.org/drawingml/2006/main">
               <a:ext uri="{FF2B5EF4-FFF2-40B4-BE49-F238E27FC236}">
-                <a16:creationId xmlns:a16="http://schemas.microsoft.com/office/drawing/2014/main" id="{09F2AA74-AFE8-46F4-A375-D40D8D91A3BC}"/>
+                <a16:creationId xmlns:a16="http://schemas.microsoft.com/office/drawing/2014/main" id="{ED6B07B5-2C2B-4EB2-8E0F-5EFB0420647F}"/>
               </a:ext>
             </a:extLst>
           </p:cNvPr>
@@ -9308,7 +9308,7 @@
           <p:cNvPr id="5" name="Rectangle 4">
             <a:extLst xmlns:a="http://schemas.openxmlformats.org/drawingml/2006/main">
               <a:ext uri="{FF2B5EF4-FFF2-40B4-BE49-F238E27FC236}">
-                <a16:creationId xmlns:a16="http://schemas.microsoft.com/office/drawing/2014/main" id="{663CC336-7886-4105-BF68-1BBCCEB8E58F}"/>
+                <a16:creationId xmlns:a16="http://schemas.microsoft.com/office/drawing/2014/main" id="{CA03FDB6-FDEA-4364-8A21-19303A5FD8AF}"/>
               </a:ext>
             </a:extLst>
           </p:cNvPr>
@@ -9363,7 +9363,7 @@
           <p:cNvPr id="6" name="TextBox 5">
             <a:extLst xmlns:a="http://schemas.openxmlformats.org/drawingml/2006/main">
               <a:ext uri="{FF2B5EF4-FFF2-40B4-BE49-F238E27FC236}">
-                <a16:creationId xmlns:a16="http://schemas.microsoft.com/office/drawing/2014/main" id="{D731022E-18BA-47CB-A341-94085A7D78E2}"/>
+                <a16:creationId xmlns:a16="http://schemas.microsoft.com/office/drawing/2014/main" id="{7EEEE1CA-893B-4B63-9EDE-EA00C0FD8A94}"/>
               </a:ext>
             </a:extLst>
           </p:cNvPr>
@@ -9400,7 +9400,7 @@
                 <a:ea typeface="Aptos"/>
                 <a:cs typeface="Aptos"/>
               </a:rPr>
-              <a:t>Independent public evidence summary · 2026.07.23-11 · 2026-07-22 · Sources: Health Canada; Destatis; Vero; Sejm; Swedish Government</a:t>
+              <a:t>Independent public evidence summary · 2026.07.23-12 · 2026-07-22 · Sources: Health Canada; Destatis; Vero; Sejm; Swedish Government</a:t>
             </a:r>
           </a:p>
         </p:txBody>
@@ -9410,7 +9410,7 @@
           <p:cNvPr id="7" name="TextBox 6">
             <a:extLst xmlns:a="http://schemas.openxmlformats.org/drawingml/2006/main">
               <a:ext uri="{FF2B5EF4-FFF2-40B4-BE49-F238E27FC236}">
-                <a16:creationId xmlns:a16="http://schemas.microsoft.com/office/drawing/2014/main" id="{5F2AE8CA-7B22-4CC2-A887-9E1E564E8E27}"/>
+                <a16:creationId xmlns:a16="http://schemas.microsoft.com/office/drawing/2014/main" id="{81F24B31-8F84-4487-9F2A-9B24CDA63AF3}"/>
               </a:ext>
             </a:extLst>
           </p:cNvPr>
@@ -9980,7 +9980,7 @@
           <p:cNvPr id="9" name="TextBox 8">
             <a:extLst xmlns:a="http://schemas.openxmlformats.org/drawingml/2006/main">
               <a:ext uri="{FF2B5EF4-FFF2-40B4-BE49-F238E27FC236}">
-                <a16:creationId xmlns:a16="http://schemas.microsoft.com/office/drawing/2014/main" id="{94E0904C-1306-4D46-B0DC-DCF02E519293}"/>
+                <a16:creationId xmlns:a16="http://schemas.microsoft.com/office/drawing/2014/main" id="{790585F0-EC56-4637-A93A-B0A1575748D4}"/>
               </a:ext>
             </a:extLst>
           </p:cNvPr>
@@ -10025,7 +10025,7 @@
     </p:spTree>
     <p:extLst>
       <p:ext uri="{BB962C8B-B14F-4D97-AF65-F5344CB8AC3E}">
-        <p14:creationId xmlns:p14="http://schemas.microsoft.com/office/powerpoint/2010/main" val="168174732"/>
+        <p14:creationId xmlns:p14="http://schemas.microsoft.com/office/powerpoint/2010/main" val="781295645"/>
       </p:ext>
     </p:extLst>
   </p:cSld>
@@ -10049,7 +10049,7 @@
           <p:cNvPr id="2" name="TextBox 1">
             <a:extLst xmlns:a="http://schemas.openxmlformats.org/drawingml/2006/main">
               <a:ext uri="{FF2B5EF4-FFF2-40B4-BE49-F238E27FC236}">
-                <a16:creationId xmlns:a16="http://schemas.microsoft.com/office/drawing/2014/main" id="{EC7DC5B3-54F2-495E-AC63-39EB7A3640F0}"/>
+                <a16:creationId xmlns:a16="http://schemas.microsoft.com/office/drawing/2014/main" id="{37BA35AB-382B-49B3-B1D8-C0840A91BD02}"/>
               </a:ext>
             </a:extLst>
           </p:cNvPr>
@@ -10096,7 +10096,7 @@
           <p:cNvPr id="3" name="TextBox 2">
             <a:extLst xmlns:a="http://schemas.openxmlformats.org/drawingml/2006/main">
               <a:ext uri="{FF2B5EF4-FFF2-40B4-BE49-F238E27FC236}">
-                <a16:creationId xmlns:a16="http://schemas.microsoft.com/office/drawing/2014/main" id="{845940B2-6493-4A78-9F91-48A4F0DDB6FF}"/>
+                <a16:creationId xmlns:a16="http://schemas.microsoft.com/office/drawing/2014/main" id="{7F6402E6-0FA2-475E-8246-50A3ABD23FAD}"/>
               </a:ext>
             </a:extLst>
           </p:cNvPr>
@@ -10143,7 +10143,7 @@
           <p:cNvPr id="4" name="Rectangle 3">
             <a:extLst xmlns:a="http://schemas.openxmlformats.org/drawingml/2006/main">
               <a:ext uri="{FF2B5EF4-FFF2-40B4-BE49-F238E27FC236}">
-                <a16:creationId xmlns:a16="http://schemas.microsoft.com/office/drawing/2014/main" id="{105E3BF9-662A-4416-A99D-638867D88CAE}"/>
+                <a16:creationId xmlns:a16="http://schemas.microsoft.com/office/drawing/2014/main" id="{730F0CE7-AECE-428E-A9D5-35BC915E6A88}"/>
               </a:ext>
             </a:extLst>
           </p:cNvPr>
@@ -10198,7 +10198,7 @@
           <p:cNvPr id="5" name="Rectangle 4">
             <a:extLst xmlns:a="http://schemas.openxmlformats.org/drawingml/2006/main">
               <a:ext uri="{FF2B5EF4-FFF2-40B4-BE49-F238E27FC236}">
-                <a16:creationId xmlns:a16="http://schemas.microsoft.com/office/drawing/2014/main" id="{8C9271E5-B4F0-4864-B516-9F3B22B5CAAD}"/>
+                <a16:creationId xmlns:a16="http://schemas.microsoft.com/office/drawing/2014/main" id="{A99F51AC-A67A-4062-83BF-84F7E3207D39}"/>
               </a:ext>
             </a:extLst>
           </p:cNvPr>
@@ -10253,7 +10253,7 @@
           <p:cNvPr id="6" name="TextBox 5">
             <a:extLst xmlns:a="http://schemas.openxmlformats.org/drawingml/2006/main">
               <a:ext uri="{FF2B5EF4-FFF2-40B4-BE49-F238E27FC236}">
-                <a16:creationId xmlns:a16="http://schemas.microsoft.com/office/drawing/2014/main" id="{553CAF99-F7B9-4F00-A44A-C8870FC45F53}"/>
+                <a16:creationId xmlns:a16="http://schemas.microsoft.com/office/drawing/2014/main" id="{9D525425-C36B-4E43-BFE7-8B1D53DACB2E}"/>
               </a:ext>
             </a:extLst>
           </p:cNvPr>
@@ -10290,7 +10290,7 @@
                 <a:ea typeface="Aptos"/>
                 <a:cs typeface="Aptos"/>
               </a:rPr>
-              <a:t>Independent public evidence summary · 2026.07.23-11 · 2026-07-22 · Sources: Health Canada 2024</a:t>
+              <a:t>Independent public evidence summary · 2026.07.23-12 · 2026-07-22 · Sources: Health Canada 2024</a:t>
             </a:r>
           </a:p>
         </p:txBody>
@@ -10300,7 +10300,7 @@
           <p:cNvPr id="7" name="TextBox 6">
             <a:extLst xmlns:a="http://schemas.openxmlformats.org/drawingml/2006/main">
               <a:ext uri="{FF2B5EF4-FFF2-40B4-BE49-F238E27FC236}">
-                <a16:creationId xmlns:a16="http://schemas.microsoft.com/office/drawing/2014/main" id="{6BD1070D-36CA-4F04-8EF6-C51E14F29ADC}"/>
+                <a16:creationId xmlns:a16="http://schemas.microsoft.com/office/drawing/2014/main" id="{B428C0BC-E21B-48BC-86CF-4FC276E5C28F}"/>
               </a:ext>
             </a:extLst>
           </p:cNvPr>
@@ -10347,7 +10347,7 @@
           <p:cNvPr id="8" name="Rounded Rectangle 7">
             <a:extLst xmlns:a="http://schemas.openxmlformats.org/drawingml/2006/main">
               <a:ext uri="{FF2B5EF4-FFF2-40B4-BE49-F238E27FC236}">
-                <a16:creationId xmlns:a16="http://schemas.microsoft.com/office/drawing/2014/main" id="{A3281213-3247-438D-A08C-6F30F13DA0D9}"/>
+                <a16:creationId xmlns:a16="http://schemas.microsoft.com/office/drawing/2014/main" id="{0EC7A6E2-B1BE-4216-B083-FCBE80EFCC26}"/>
               </a:ext>
             </a:extLst>
           </p:cNvPr>
@@ -10404,7 +10404,7 @@
           <p:cNvPr id="9" name="TextBox 8">
             <a:extLst xmlns:a="http://schemas.openxmlformats.org/drawingml/2006/main">
               <a:ext uri="{FF2B5EF4-FFF2-40B4-BE49-F238E27FC236}">
-                <a16:creationId xmlns:a16="http://schemas.microsoft.com/office/drawing/2014/main" id="{BA14D461-DB82-42E4-BDB4-3E3A93E71920}"/>
+                <a16:creationId xmlns:a16="http://schemas.microsoft.com/office/drawing/2014/main" id="{AB48E04D-E212-4008-ACDE-1F76390EDB56}"/>
               </a:ext>
             </a:extLst>
           </p:cNvPr>
@@ -10451,7 +10451,7 @@
           <p:cNvPr id="10" name="TextBox 9">
             <a:extLst xmlns:a="http://schemas.openxmlformats.org/drawingml/2006/main">
               <a:ext uri="{FF2B5EF4-FFF2-40B4-BE49-F238E27FC236}">
-                <a16:creationId xmlns:a16="http://schemas.microsoft.com/office/drawing/2014/main" id="{07B17D0B-ADE8-4EF8-BB70-F9BF3FE9A0A5}"/>
+                <a16:creationId xmlns:a16="http://schemas.microsoft.com/office/drawing/2014/main" id="{4ECD05F5-6BC7-4992-81D3-D1C5F3DDF8E0}"/>
               </a:ext>
             </a:extLst>
           </p:cNvPr>
@@ -10498,7 +10498,7 @@
           <p:cNvPr id="11" name="Rounded Rectangle 10">
             <a:extLst xmlns:a="http://schemas.openxmlformats.org/drawingml/2006/main">
               <a:ext uri="{FF2B5EF4-FFF2-40B4-BE49-F238E27FC236}">
-                <a16:creationId xmlns:a16="http://schemas.microsoft.com/office/drawing/2014/main" id="{3BCB83EF-078F-41EB-970E-78F589035981}"/>
+                <a16:creationId xmlns:a16="http://schemas.microsoft.com/office/drawing/2014/main" id="{186F05F5-DD54-42A1-805E-A8CF9F79B178}"/>
               </a:ext>
             </a:extLst>
           </p:cNvPr>
@@ -10555,7 +10555,7 @@
           <p:cNvPr id="12" name="TextBox 11">
             <a:extLst xmlns:a="http://schemas.openxmlformats.org/drawingml/2006/main">
               <a:ext uri="{FF2B5EF4-FFF2-40B4-BE49-F238E27FC236}">
-                <a16:creationId xmlns:a16="http://schemas.microsoft.com/office/drawing/2014/main" id="{DBC7B415-D97A-468E-96AB-364A6E4DFE7E}"/>
+                <a16:creationId xmlns:a16="http://schemas.microsoft.com/office/drawing/2014/main" id="{D5949BD9-556F-4A31-94A3-521AF430026D}"/>
               </a:ext>
             </a:extLst>
           </p:cNvPr>
@@ -10602,7 +10602,7 @@
           <p:cNvPr id="13" name="TextBox 12">
             <a:extLst xmlns:a="http://schemas.openxmlformats.org/drawingml/2006/main">
               <a:ext uri="{FF2B5EF4-FFF2-40B4-BE49-F238E27FC236}">
-                <a16:creationId xmlns:a16="http://schemas.microsoft.com/office/drawing/2014/main" id="{47BE71CA-EC72-4F3E-8273-DD17AC13EEFB}"/>
+                <a16:creationId xmlns:a16="http://schemas.microsoft.com/office/drawing/2014/main" id="{3E5E735B-5F7E-4DB0-BECB-613F54AB6942}"/>
               </a:ext>
             </a:extLst>
           </p:cNvPr>
@@ -10649,7 +10649,7 @@
           <p:cNvPr id="14" name="Rounded Rectangle 13">
             <a:extLst xmlns:a="http://schemas.openxmlformats.org/drawingml/2006/main">
               <a:ext uri="{FF2B5EF4-FFF2-40B4-BE49-F238E27FC236}">
-                <a16:creationId xmlns:a16="http://schemas.microsoft.com/office/drawing/2014/main" id="{413008A5-9E54-42E6-AF35-C845F2A447C4}"/>
+                <a16:creationId xmlns:a16="http://schemas.microsoft.com/office/drawing/2014/main" id="{7963EB74-6E95-4F4C-B49A-B386E5D85710}"/>
               </a:ext>
             </a:extLst>
           </p:cNvPr>
@@ -10706,7 +10706,7 @@
           <p:cNvPr id="15" name="TextBox 14">
             <a:extLst xmlns:a="http://schemas.openxmlformats.org/drawingml/2006/main">
               <a:ext uri="{FF2B5EF4-FFF2-40B4-BE49-F238E27FC236}">
-                <a16:creationId xmlns:a16="http://schemas.microsoft.com/office/drawing/2014/main" id="{B32DB0A2-FFC2-4354-8C17-B7474202A89B}"/>
+                <a16:creationId xmlns:a16="http://schemas.microsoft.com/office/drawing/2014/main" id="{CF609485-96D2-46C1-99B6-4C52A79E00E1}"/>
               </a:ext>
             </a:extLst>
           </p:cNvPr>
@@ -10753,7 +10753,7 @@
           <p:cNvPr id="16" name="TextBox 15">
             <a:extLst xmlns:a="http://schemas.openxmlformats.org/drawingml/2006/main">
               <a:ext uri="{FF2B5EF4-FFF2-40B4-BE49-F238E27FC236}">
-                <a16:creationId xmlns:a16="http://schemas.microsoft.com/office/drawing/2014/main" id="{6522A2C1-A84F-41CB-9ED5-8CCE9CD0DD74}"/>
+                <a16:creationId xmlns:a16="http://schemas.microsoft.com/office/drawing/2014/main" id="{B605433D-0A27-4111-AA26-FDC156570759}"/>
               </a:ext>
             </a:extLst>
           </p:cNvPr>
@@ -10800,7 +10800,7 @@
           <p:cNvPr id="17" name="TextBox 16">
             <a:extLst xmlns:a="http://schemas.openxmlformats.org/drawingml/2006/main">
               <a:ext uri="{FF2B5EF4-FFF2-40B4-BE49-F238E27FC236}">
-                <a16:creationId xmlns:a16="http://schemas.microsoft.com/office/drawing/2014/main" id="{08B12A30-4ADC-4871-8CAC-CD6CD05EA517}"/>
+                <a16:creationId xmlns:a16="http://schemas.microsoft.com/office/drawing/2014/main" id="{5310F90F-3A70-45F5-BDFD-7374B365C062}"/>
               </a:ext>
             </a:extLst>
           </p:cNvPr>
@@ -10847,7 +10847,7 @@
           <p:cNvPr id="18" name="Rounded Rectangle 17">
             <a:extLst xmlns:a="http://schemas.openxmlformats.org/drawingml/2006/main">
               <a:ext uri="{FF2B5EF4-FFF2-40B4-BE49-F238E27FC236}">
-                <a16:creationId xmlns:a16="http://schemas.microsoft.com/office/drawing/2014/main" id="{6FC55814-8DF0-419E-A0C2-BAE42BA684D9}"/>
+                <a16:creationId xmlns:a16="http://schemas.microsoft.com/office/drawing/2014/main" id="{92E06397-5561-471C-829F-9A2C78963233}"/>
               </a:ext>
             </a:extLst>
           </p:cNvPr>
@@ -10904,7 +10904,7 @@
           <p:cNvPr id="19" name="TextBox 18">
             <a:extLst xmlns:a="http://schemas.openxmlformats.org/drawingml/2006/main">
               <a:ext uri="{FF2B5EF4-FFF2-40B4-BE49-F238E27FC236}">
-                <a16:creationId xmlns:a16="http://schemas.microsoft.com/office/drawing/2014/main" id="{E8A2B5B3-B5B5-475E-8B4E-BD958AD60EEE}"/>
+                <a16:creationId xmlns:a16="http://schemas.microsoft.com/office/drawing/2014/main" id="{04F8A2F1-8AF4-421C-B1B1-7697BAA3F7FC}"/>
               </a:ext>
             </a:extLst>
           </p:cNvPr>
@@ -10951,7 +10951,7 @@
           <p:cNvPr id="20" name="TextBox 19">
             <a:extLst xmlns:a="http://schemas.openxmlformats.org/drawingml/2006/main">
               <a:ext uri="{FF2B5EF4-FFF2-40B4-BE49-F238E27FC236}">
-                <a16:creationId xmlns:a16="http://schemas.microsoft.com/office/drawing/2014/main" id="{FD3B1E4A-7503-4F93-848B-D9C954B1AB3C}"/>
+                <a16:creationId xmlns:a16="http://schemas.microsoft.com/office/drawing/2014/main" id="{EA42CED6-0505-475D-AC56-866FD0FE4060}"/>
               </a:ext>
             </a:extLst>
           </p:cNvPr>
@@ -10996,7 +10996,7 @@
     </p:spTree>
     <p:extLst>
       <p:ext uri="{BB962C8B-B14F-4D97-AF65-F5344CB8AC3E}">
-        <p14:creationId xmlns:p14="http://schemas.microsoft.com/office/powerpoint/2010/main" val="1563846229"/>
+        <p14:creationId xmlns:p14="http://schemas.microsoft.com/office/powerpoint/2010/main" val="237203948"/>
       </p:ext>
     </p:extLst>
   </p:cSld>
@@ -11020,7 +11020,7 @@
           <p:cNvPr id="2" name="TextBox 1">
             <a:extLst xmlns:a="http://schemas.openxmlformats.org/drawingml/2006/main">
               <a:ext uri="{FF2B5EF4-FFF2-40B4-BE49-F238E27FC236}">
-                <a16:creationId xmlns:a16="http://schemas.microsoft.com/office/drawing/2014/main" id="{25ECA68D-04B6-4D01-B053-2FDFF2D4E65F}"/>
+                <a16:creationId xmlns:a16="http://schemas.microsoft.com/office/drawing/2014/main" id="{35EF9102-081D-4631-80F1-2279012C02B2}"/>
               </a:ext>
             </a:extLst>
           </p:cNvPr>
@@ -11067,7 +11067,7 @@
           <p:cNvPr id="3" name="TextBox 2">
             <a:extLst xmlns:a="http://schemas.openxmlformats.org/drawingml/2006/main">
               <a:ext uri="{FF2B5EF4-FFF2-40B4-BE49-F238E27FC236}">
-                <a16:creationId xmlns:a16="http://schemas.microsoft.com/office/drawing/2014/main" id="{262286AE-C1C3-4E05-94E7-5FE48364081C}"/>
+                <a16:creationId xmlns:a16="http://schemas.microsoft.com/office/drawing/2014/main" id="{7BAFB982-1C1A-4F16-9176-64AB97FC1304}"/>
               </a:ext>
             </a:extLst>
           </p:cNvPr>
@@ -11114,7 +11114,7 @@
           <p:cNvPr id="4" name="Rectangle 3">
             <a:extLst xmlns:a="http://schemas.openxmlformats.org/drawingml/2006/main">
               <a:ext uri="{FF2B5EF4-FFF2-40B4-BE49-F238E27FC236}">
-                <a16:creationId xmlns:a16="http://schemas.microsoft.com/office/drawing/2014/main" id="{BFD5CF69-7EE1-467D-B105-243CB36A4E7B}"/>
+                <a16:creationId xmlns:a16="http://schemas.microsoft.com/office/drawing/2014/main" id="{B59B2097-9540-4B5E-8048-03156F29DAB2}"/>
               </a:ext>
             </a:extLst>
           </p:cNvPr>
@@ -11169,7 +11169,7 @@
           <p:cNvPr id="5" name="Rectangle 4">
             <a:extLst xmlns:a="http://schemas.openxmlformats.org/drawingml/2006/main">
               <a:ext uri="{FF2B5EF4-FFF2-40B4-BE49-F238E27FC236}">
-                <a16:creationId xmlns:a16="http://schemas.microsoft.com/office/drawing/2014/main" id="{CCBCEA1D-9FB4-4E69-89CC-FA97F0EE62D7}"/>
+                <a16:creationId xmlns:a16="http://schemas.microsoft.com/office/drawing/2014/main" id="{02FE7E74-EFF0-4CA3-A31B-0CD4281A8921}"/>
               </a:ext>
             </a:extLst>
           </p:cNvPr>
@@ -11224,7 +11224,7 @@
           <p:cNvPr id="6" name="TextBox 5">
             <a:extLst xmlns:a="http://schemas.openxmlformats.org/drawingml/2006/main">
               <a:ext uri="{FF2B5EF4-FFF2-40B4-BE49-F238E27FC236}">
-                <a16:creationId xmlns:a16="http://schemas.microsoft.com/office/drawing/2014/main" id="{20A08FDD-FFCD-4340-84A7-A485FE5AFB45}"/>
+                <a16:creationId xmlns:a16="http://schemas.microsoft.com/office/drawing/2014/main" id="{1D3D4473-6789-440A-BA93-5D887D356C87}"/>
               </a:ext>
             </a:extLst>
           </p:cNvPr>
@@ -11261,7 +11261,7 @@
                 <a:ea typeface="Aptos"/>
                 <a:cs typeface="Aptos"/>
               </a:rPr>
-              <a:t>Independent public evidence summary · 2026.07.23-11 · 2026-07-22 · Sources: Destatis</a:t>
+              <a:t>Independent public evidence summary · 2026.07.23-12 · 2026-07-22 · Sources: Destatis</a:t>
             </a:r>
           </a:p>
         </p:txBody>
@@ -11271,7 +11271,7 @@
           <p:cNvPr id="7" name="TextBox 6">
             <a:extLst xmlns:a="http://schemas.openxmlformats.org/drawingml/2006/main">
               <a:ext uri="{FF2B5EF4-FFF2-40B4-BE49-F238E27FC236}">
-                <a16:creationId xmlns:a16="http://schemas.microsoft.com/office/drawing/2014/main" id="{A1D6F7B9-57CA-4A7C-8C11-29A658A93186}"/>
+                <a16:creationId xmlns:a16="http://schemas.microsoft.com/office/drawing/2014/main" id="{1BC430F2-980B-46F5-A036-126E0F4632DC}"/>
               </a:ext>
             </a:extLst>
           </p:cNvPr>
@@ -11784,7 +11784,7 @@
           <p:cNvPr id="9" name="TextBox 8">
             <a:extLst xmlns:a="http://schemas.openxmlformats.org/drawingml/2006/main">
               <a:ext uri="{FF2B5EF4-FFF2-40B4-BE49-F238E27FC236}">
-                <a16:creationId xmlns:a16="http://schemas.microsoft.com/office/drawing/2014/main" id="{1FDC591A-3A4A-4590-83B7-A920ABFAABF1}"/>
+                <a16:creationId xmlns:a16="http://schemas.microsoft.com/office/drawing/2014/main" id="{06B479E7-A0F9-4677-A6E4-59F3C8B178C5}"/>
               </a:ext>
             </a:extLst>
           </p:cNvPr>
@@ -11829,7 +11829,7 @@
     </p:spTree>
     <p:extLst>
       <p:ext uri="{BB962C8B-B14F-4D97-AF65-F5344CB8AC3E}">
-        <p14:creationId xmlns:p14="http://schemas.microsoft.com/office/powerpoint/2010/main" val="1924246346"/>
+        <p14:creationId xmlns:p14="http://schemas.microsoft.com/office/powerpoint/2010/main" val="269447777"/>
       </p:ext>
     </p:extLst>
   </p:cSld>
@@ -11853,7 +11853,7 @@
           <p:cNvPr id="2" name="TextBox 1">
             <a:extLst xmlns:a="http://schemas.openxmlformats.org/drawingml/2006/main">
               <a:ext uri="{FF2B5EF4-FFF2-40B4-BE49-F238E27FC236}">
-                <a16:creationId xmlns:a16="http://schemas.microsoft.com/office/drawing/2014/main" id="{0C4E630C-F660-4F1E-B66D-D496C2E42377}"/>
+                <a16:creationId xmlns:a16="http://schemas.microsoft.com/office/drawing/2014/main" id="{F475FCDE-CC93-4999-B0EC-8E9E3C6B9AFD}"/>
               </a:ext>
             </a:extLst>
           </p:cNvPr>
@@ -11900,7 +11900,7 @@
           <p:cNvPr id="3" name="TextBox 2">
             <a:extLst xmlns:a="http://schemas.openxmlformats.org/drawingml/2006/main">
               <a:ext uri="{FF2B5EF4-FFF2-40B4-BE49-F238E27FC236}">
-                <a16:creationId xmlns:a16="http://schemas.microsoft.com/office/drawing/2014/main" id="{2D401984-36B9-4291-B6A9-39388383DEE2}"/>
+                <a16:creationId xmlns:a16="http://schemas.microsoft.com/office/drawing/2014/main" id="{6FD8D3EE-72DB-431E-BEE5-88838622EF28}"/>
               </a:ext>
             </a:extLst>
           </p:cNvPr>
@@ -11947,7 +11947,7 @@
           <p:cNvPr id="4" name="Rectangle 3">
             <a:extLst xmlns:a="http://schemas.openxmlformats.org/drawingml/2006/main">
               <a:ext uri="{FF2B5EF4-FFF2-40B4-BE49-F238E27FC236}">
-                <a16:creationId xmlns:a16="http://schemas.microsoft.com/office/drawing/2014/main" id="{DFAB0CDB-2EA2-4846-BD38-C5FBDCE16BC9}"/>
+                <a16:creationId xmlns:a16="http://schemas.microsoft.com/office/drawing/2014/main" id="{7AF374D9-BCF2-4C3D-AAB7-084CCC6295E0}"/>
               </a:ext>
             </a:extLst>
           </p:cNvPr>
@@ -12002,7 +12002,7 @@
           <p:cNvPr id="5" name="Rectangle 4">
             <a:extLst xmlns:a="http://schemas.openxmlformats.org/drawingml/2006/main">
               <a:ext uri="{FF2B5EF4-FFF2-40B4-BE49-F238E27FC236}">
-                <a16:creationId xmlns:a16="http://schemas.microsoft.com/office/drawing/2014/main" id="{3D768825-C38A-4A59-90F4-11152AE86358}"/>
+                <a16:creationId xmlns:a16="http://schemas.microsoft.com/office/drawing/2014/main" id="{27DDD5D5-A4C2-4E57-9A55-E65E3AC26853}"/>
               </a:ext>
             </a:extLst>
           </p:cNvPr>
@@ -12057,7 +12057,7 @@
           <p:cNvPr id="6" name="TextBox 5">
             <a:extLst xmlns:a="http://schemas.openxmlformats.org/drawingml/2006/main">
               <a:ext uri="{FF2B5EF4-FFF2-40B4-BE49-F238E27FC236}">
-                <a16:creationId xmlns:a16="http://schemas.microsoft.com/office/drawing/2014/main" id="{97AC2108-A160-4922-9796-91F5153A4E0E}"/>
+                <a16:creationId xmlns:a16="http://schemas.microsoft.com/office/drawing/2014/main" id="{9C49C8B7-3679-45A6-8944-20CDF9762454}"/>
               </a:ext>
             </a:extLst>
           </p:cNvPr>
@@ -12094,7 +12094,7 @@
                 <a:ea typeface="Aptos"/>
                 <a:cs typeface="Aptos"/>
               </a:rPr>
-              <a:t>Independent public evidence summary · 2026.07.23-11 · 2026-07-22 · Sources: Destatis; inTaste.de</a:t>
+              <a:t>Independent public evidence summary · 2026.07.23-12 · 2026-07-22 · Sources: Destatis; inTaste.de</a:t>
             </a:r>
           </a:p>
         </p:txBody>
@@ -12104,7 +12104,7 @@
           <p:cNvPr id="7" name="TextBox 6">
             <a:extLst xmlns:a="http://schemas.openxmlformats.org/drawingml/2006/main">
               <a:ext uri="{FF2B5EF4-FFF2-40B4-BE49-F238E27FC236}">
-                <a16:creationId xmlns:a16="http://schemas.microsoft.com/office/drawing/2014/main" id="{E6A69BAF-44CB-4DA8-B583-B4EE36F800EB}"/>
+                <a16:creationId xmlns:a16="http://schemas.microsoft.com/office/drawing/2014/main" id="{4C9EF761-F9A1-466F-B32D-1E0AB9884F11}"/>
               </a:ext>
             </a:extLst>
           </p:cNvPr>
@@ -12151,7 +12151,7 @@
           <p:cNvPr id="8" name="Rounded Rectangle 7">
             <a:extLst xmlns:a="http://schemas.openxmlformats.org/drawingml/2006/main">
               <a:ext uri="{FF2B5EF4-FFF2-40B4-BE49-F238E27FC236}">
-                <a16:creationId xmlns:a16="http://schemas.microsoft.com/office/drawing/2014/main" id="{EFD2C8A6-596C-43E8-847C-50607E188F45}"/>
+                <a16:creationId xmlns:a16="http://schemas.microsoft.com/office/drawing/2014/main" id="{7C30D30B-819F-4BB6-AAE7-E24E46C4757E}"/>
               </a:ext>
             </a:extLst>
           </p:cNvPr>
@@ -12208,7 +12208,7 @@
           <p:cNvPr id="9" name="TextBox 8">
             <a:extLst xmlns:a="http://schemas.openxmlformats.org/drawingml/2006/main">
               <a:ext uri="{FF2B5EF4-FFF2-40B4-BE49-F238E27FC236}">
-                <a16:creationId xmlns:a16="http://schemas.microsoft.com/office/drawing/2014/main" id="{61BD2918-5D6F-42F7-91E5-653F4A4F14C9}"/>
+                <a16:creationId xmlns:a16="http://schemas.microsoft.com/office/drawing/2014/main" id="{FBEC8696-CA6D-4B90-B1BC-BEBBEAB5FC4C}"/>
               </a:ext>
             </a:extLst>
           </p:cNvPr>
@@ -12255,7 +12255,7 @@
           <p:cNvPr id="10" name="TextBox 9">
             <a:extLst xmlns:a="http://schemas.openxmlformats.org/drawingml/2006/main">
               <a:ext uri="{FF2B5EF4-FFF2-40B4-BE49-F238E27FC236}">
-                <a16:creationId xmlns:a16="http://schemas.microsoft.com/office/drawing/2014/main" id="{18EC659F-6F22-445E-A4C1-0514F6E1D837}"/>
+                <a16:creationId xmlns:a16="http://schemas.microsoft.com/office/drawing/2014/main" id="{85576A2A-99D9-4391-8817-E21EE0A895AE}"/>
               </a:ext>
             </a:extLst>
           </p:cNvPr>
@@ -12302,7 +12302,7 @@
           <p:cNvPr id="11" name="Rounded Rectangle 10">
             <a:extLst xmlns:a="http://schemas.openxmlformats.org/drawingml/2006/main">
               <a:ext uri="{FF2B5EF4-FFF2-40B4-BE49-F238E27FC236}">
-                <a16:creationId xmlns:a16="http://schemas.microsoft.com/office/drawing/2014/main" id="{DDEFDA4C-65D0-4A03-8C87-E607B84537D3}"/>
+                <a16:creationId xmlns:a16="http://schemas.microsoft.com/office/drawing/2014/main" id="{2E507124-A637-4FBA-886C-3765EA1A95E7}"/>
               </a:ext>
             </a:extLst>
           </p:cNvPr>
@@ -12359,7 +12359,7 @@
           <p:cNvPr id="12" name="TextBox 11">
             <a:extLst xmlns:a="http://schemas.openxmlformats.org/drawingml/2006/main">
               <a:ext uri="{FF2B5EF4-FFF2-40B4-BE49-F238E27FC236}">
-                <a16:creationId xmlns:a16="http://schemas.microsoft.com/office/drawing/2014/main" id="{E4B84C38-2B00-4890-8D8D-27AB957874F7}"/>
+                <a16:creationId xmlns:a16="http://schemas.microsoft.com/office/drawing/2014/main" id="{AD80EA3B-FFE4-4A37-82C1-E7FBA0DD27D0}"/>
               </a:ext>
             </a:extLst>
           </p:cNvPr>
@@ -12406,7 +12406,7 @@
           <p:cNvPr id="13" name="TextBox 12">
             <a:extLst xmlns:a="http://schemas.openxmlformats.org/drawingml/2006/main">
               <a:ext uri="{FF2B5EF4-FFF2-40B4-BE49-F238E27FC236}">
-                <a16:creationId xmlns:a16="http://schemas.microsoft.com/office/drawing/2014/main" id="{C268DD0F-4AE1-470C-9E6C-D5FBABED8942}"/>
+                <a16:creationId xmlns:a16="http://schemas.microsoft.com/office/drawing/2014/main" id="{398FB7CF-7166-4050-A034-6F966BF9EEEE}"/>
               </a:ext>
             </a:extLst>
           </p:cNvPr>
@@ -12453,7 +12453,7 @@
           <p:cNvPr id="14" name="Rounded Rectangle 13">
             <a:extLst xmlns:a="http://schemas.openxmlformats.org/drawingml/2006/main">
               <a:ext uri="{FF2B5EF4-FFF2-40B4-BE49-F238E27FC236}">
-                <a16:creationId xmlns:a16="http://schemas.microsoft.com/office/drawing/2014/main" id="{BE6DA2FB-70B2-4D59-908A-A0B11455EFD3}"/>
+                <a16:creationId xmlns:a16="http://schemas.microsoft.com/office/drawing/2014/main" id="{33B0C949-4E8A-4EB3-8FFD-47D8E81AA080}"/>
               </a:ext>
             </a:extLst>
           </p:cNvPr>
@@ -12510,7 +12510,7 @@
           <p:cNvPr id="15" name="TextBox 14">
             <a:extLst xmlns:a="http://schemas.openxmlformats.org/drawingml/2006/main">
               <a:ext uri="{FF2B5EF4-FFF2-40B4-BE49-F238E27FC236}">
-                <a16:creationId xmlns:a16="http://schemas.microsoft.com/office/drawing/2014/main" id="{1C6C824D-CA56-41F1-BFBB-CE7C790FA608}"/>
+                <a16:creationId xmlns:a16="http://schemas.microsoft.com/office/drawing/2014/main" id="{981AE990-FF6E-4299-8569-704495CDE1AD}"/>
               </a:ext>
             </a:extLst>
           </p:cNvPr>
@@ -12557,7 +12557,7 @@
           <p:cNvPr id="16" name="TextBox 15">
             <a:extLst xmlns:a="http://schemas.openxmlformats.org/drawingml/2006/main">
               <a:ext uri="{FF2B5EF4-FFF2-40B4-BE49-F238E27FC236}">
-                <a16:creationId xmlns:a16="http://schemas.microsoft.com/office/drawing/2014/main" id="{F752A6BA-A10E-4916-8124-9AB0E99306F7}"/>
+                <a16:creationId xmlns:a16="http://schemas.microsoft.com/office/drawing/2014/main" id="{1CDACE80-227C-4FC4-8ED2-DE85C4CFA6A5}"/>
               </a:ext>
             </a:extLst>
           </p:cNvPr>
@@ -12604,7 +12604,7 @@
           <p:cNvPr id="17" name="TextBox 16">
             <a:extLst xmlns:a="http://schemas.openxmlformats.org/drawingml/2006/main">
               <a:ext uri="{FF2B5EF4-FFF2-40B4-BE49-F238E27FC236}">
-                <a16:creationId xmlns:a16="http://schemas.microsoft.com/office/drawing/2014/main" id="{FF22F3EA-88A7-4853-8AEB-AA224ACB921E}"/>
+                <a16:creationId xmlns:a16="http://schemas.microsoft.com/office/drawing/2014/main" id="{E1A61D79-E0F5-46EF-A492-3636DAE6E20F}"/>
               </a:ext>
             </a:extLst>
           </p:cNvPr>
@@ -12651,7 +12651,7 @@
           <p:cNvPr id="18" name="Rounded Rectangle 17">
             <a:extLst xmlns:a="http://schemas.openxmlformats.org/drawingml/2006/main">
               <a:ext uri="{FF2B5EF4-FFF2-40B4-BE49-F238E27FC236}">
-                <a16:creationId xmlns:a16="http://schemas.microsoft.com/office/drawing/2014/main" id="{A89146B7-9B41-45FF-933F-DE66381204D1}"/>
+                <a16:creationId xmlns:a16="http://schemas.microsoft.com/office/drawing/2014/main" id="{BE92DB26-F2B5-4549-971C-8D1AC9EF716E}"/>
               </a:ext>
             </a:extLst>
           </p:cNvPr>
@@ -12708,7 +12708,7 @@
           <p:cNvPr id="19" name="TextBox 18">
             <a:extLst xmlns:a="http://schemas.openxmlformats.org/drawingml/2006/main">
               <a:ext uri="{FF2B5EF4-FFF2-40B4-BE49-F238E27FC236}">
-                <a16:creationId xmlns:a16="http://schemas.microsoft.com/office/drawing/2014/main" id="{3E3723D6-25F3-426B-A522-31C3375A654C}"/>
+                <a16:creationId xmlns:a16="http://schemas.microsoft.com/office/drawing/2014/main" id="{82B88106-95A2-4CEF-AE7C-98572E2A45FC}"/>
               </a:ext>
             </a:extLst>
           </p:cNvPr>
@@ -12755,7 +12755,7 @@
           <p:cNvPr id="20" name="TextBox 19">
             <a:extLst xmlns:a="http://schemas.openxmlformats.org/drawingml/2006/main">
               <a:ext uri="{FF2B5EF4-FFF2-40B4-BE49-F238E27FC236}">
-                <a16:creationId xmlns:a16="http://schemas.microsoft.com/office/drawing/2014/main" id="{D0C1B830-4F86-42AF-AC98-C14C3FF70D35}"/>
+                <a16:creationId xmlns:a16="http://schemas.microsoft.com/office/drawing/2014/main" id="{3F044342-D130-4F73-AE37-F96E953A3678}"/>
               </a:ext>
             </a:extLst>
           </p:cNvPr>
@@ -12800,7 +12800,7 @@
     </p:spTree>
     <p:extLst>
       <p:ext uri="{BB962C8B-B14F-4D97-AF65-F5344CB8AC3E}">
-        <p14:creationId xmlns:p14="http://schemas.microsoft.com/office/powerpoint/2010/main" val="1549987047"/>
+        <p14:creationId xmlns:p14="http://schemas.microsoft.com/office/powerpoint/2010/main" val="1064163650"/>
       </p:ext>
     </p:extLst>
   </p:cSld>
@@ -12824,7 +12824,7 @@
           <p:cNvPr id="2" name="TextBox 1">
             <a:extLst xmlns:a="http://schemas.openxmlformats.org/drawingml/2006/main">
               <a:ext uri="{FF2B5EF4-FFF2-40B4-BE49-F238E27FC236}">
-                <a16:creationId xmlns:a16="http://schemas.microsoft.com/office/drawing/2014/main" id="{27F7FEDC-DD36-4AD7-A2AD-3B381B25E9AC}"/>
+                <a16:creationId xmlns:a16="http://schemas.microsoft.com/office/drawing/2014/main" id="{61DA0A2F-8BF4-457E-81E9-52F1461348B2}"/>
               </a:ext>
             </a:extLst>
           </p:cNvPr>
@@ -12871,7 +12871,7 @@
           <p:cNvPr id="3" name="TextBox 2">
             <a:extLst xmlns:a="http://schemas.openxmlformats.org/drawingml/2006/main">
               <a:ext uri="{FF2B5EF4-FFF2-40B4-BE49-F238E27FC236}">
-                <a16:creationId xmlns:a16="http://schemas.microsoft.com/office/drawing/2014/main" id="{057CECD0-3C42-43A1-AC67-B1ECD7CCD196}"/>
+                <a16:creationId xmlns:a16="http://schemas.microsoft.com/office/drawing/2014/main" id="{C4F2D7FC-427B-41EE-9011-489CB438B9E5}"/>
               </a:ext>
             </a:extLst>
           </p:cNvPr>
@@ -12918,7 +12918,7 @@
           <p:cNvPr id="4" name="Rectangle 3">
             <a:extLst xmlns:a="http://schemas.openxmlformats.org/drawingml/2006/main">
               <a:ext uri="{FF2B5EF4-FFF2-40B4-BE49-F238E27FC236}">
-                <a16:creationId xmlns:a16="http://schemas.microsoft.com/office/drawing/2014/main" id="{F545DE4D-D1B6-424E-869C-ADDDFDC6A540}"/>
+                <a16:creationId xmlns:a16="http://schemas.microsoft.com/office/drawing/2014/main" id="{FAEFED43-289F-4EB9-81F5-AF211A224434}"/>
               </a:ext>
             </a:extLst>
           </p:cNvPr>
@@ -12973,7 +12973,7 @@
           <p:cNvPr id="5" name="Rectangle 4">
             <a:extLst xmlns:a="http://schemas.openxmlformats.org/drawingml/2006/main">
               <a:ext uri="{FF2B5EF4-FFF2-40B4-BE49-F238E27FC236}">
-                <a16:creationId xmlns:a16="http://schemas.microsoft.com/office/drawing/2014/main" id="{010DD346-14B3-495E-9929-0672536DB067}"/>
+                <a16:creationId xmlns:a16="http://schemas.microsoft.com/office/drawing/2014/main" id="{7AFCDE58-8DE9-4BD6-87EA-6437497E2FA9}"/>
               </a:ext>
             </a:extLst>
           </p:cNvPr>
@@ -13028,7 +13028,7 @@
           <p:cNvPr id="6" name="TextBox 5">
             <a:extLst xmlns:a="http://schemas.openxmlformats.org/drawingml/2006/main">
               <a:ext uri="{FF2B5EF4-FFF2-40B4-BE49-F238E27FC236}">
-                <a16:creationId xmlns:a16="http://schemas.microsoft.com/office/drawing/2014/main" id="{155EEA72-AAEF-4DFF-A6D3-E2268632A9A6}"/>
+                <a16:creationId xmlns:a16="http://schemas.microsoft.com/office/drawing/2014/main" id="{83C5D36E-C34D-4F25-86A8-749F1D589BA4}"/>
               </a:ext>
             </a:extLst>
           </p:cNvPr>
@@ -13065,7 +13065,7 @@
                 <a:ea typeface="Aptos"/>
                 <a:cs typeface="Aptos"/>
               </a:rPr>
-              <a:t>Independent public evidence summary · 2026.07.23-11 · 2026-07-22 · Sources: IMARC; GVR; Fortune</a:t>
+              <a:t>Independent public evidence summary · 2026.07.23-12 · 2026-07-22 · Sources: IMARC; GVR; Fortune</a:t>
             </a:r>
           </a:p>
         </p:txBody>
@@ -13075,7 +13075,7 @@
           <p:cNvPr id="7" name="TextBox 6">
             <a:extLst xmlns:a="http://schemas.openxmlformats.org/drawingml/2006/main">
               <a:ext uri="{FF2B5EF4-FFF2-40B4-BE49-F238E27FC236}">
-                <a16:creationId xmlns:a16="http://schemas.microsoft.com/office/drawing/2014/main" id="{4502D44C-2B47-4E02-8A40-44806A6FFE9E}"/>
+                <a16:creationId xmlns:a16="http://schemas.microsoft.com/office/drawing/2014/main" id="{6D189B00-B81E-493B-9B17-DB62CB4EC771}"/>
               </a:ext>
             </a:extLst>
           </p:cNvPr>
@@ -13122,7 +13122,7 @@
           <p:cNvPr id="8" name="Rounded Rectangle 7">
             <a:extLst xmlns:a="http://schemas.openxmlformats.org/drawingml/2006/main">
               <a:ext uri="{FF2B5EF4-FFF2-40B4-BE49-F238E27FC236}">
-                <a16:creationId xmlns:a16="http://schemas.microsoft.com/office/drawing/2014/main" id="{A803FC8D-3338-42E3-8A25-A5BDD754B173}"/>
+                <a16:creationId xmlns:a16="http://schemas.microsoft.com/office/drawing/2014/main" id="{45B33CCC-C874-475D-BC08-EBC128376FD7}"/>
               </a:ext>
             </a:extLst>
           </p:cNvPr>
@@ -13179,7 +13179,7 @@
           <p:cNvPr id="9" name="TextBox 8">
             <a:extLst xmlns:a="http://schemas.openxmlformats.org/drawingml/2006/main">
               <a:ext uri="{FF2B5EF4-FFF2-40B4-BE49-F238E27FC236}">
-                <a16:creationId xmlns:a16="http://schemas.microsoft.com/office/drawing/2014/main" id="{33C8670E-49FF-4EDF-A6D5-40967AD15C88}"/>
+                <a16:creationId xmlns:a16="http://schemas.microsoft.com/office/drawing/2014/main" id="{6845C948-A2C3-49DF-A4A2-197F91641F34}"/>
               </a:ext>
             </a:extLst>
           </p:cNvPr>
@@ -13226,7 +13226,7 @@
           <p:cNvPr id="10" name="TextBox 9">
             <a:extLst xmlns:a="http://schemas.openxmlformats.org/drawingml/2006/main">
               <a:ext uri="{FF2B5EF4-FFF2-40B4-BE49-F238E27FC236}">
-                <a16:creationId xmlns:a16="http://schemas.microsoft.com/office/drawing/2014/main" id="{8F3D367C-C735-4F75-9D06-776B3B6CC517}"/>
+                <a16:creationId xmlns:a16="http://schemas.microsoft.com/office/drawing/2014/main" id="{282C97CD-7559-4387-8180-3C91775D2329}"/>
               </a:ext>
             </a:extLst>
           </p:cNvPr>
@@ -13273,7 +13273,7 @@
           <p:cNvPr id="11" name="Rounded Rectangle 10">
             <a:extLst xmlns:a="http://schemas.openxmlformats.org/drawingml/2006/main">
               <a:ext uri="{FF2B5EF4-FFF2-40B4-BE49-F238E27FC236}">
-                <a16:creationId xmlns:a16="http://schemas.microsoft.com/office/drawing/2014/main" id="{054D9A5F-3714-468D-9C1F-6BE2D61CA2FB}"/>
+                <a16:creationId xmlns:a16="http://schemas.microsoft.com/office/drawing/2014/main" id="{ACBB120E-C24B-472C-B097-34878279B118}"/>
               </a:ext>
             </a:extLst>
           </p:cNvPr>
@@ -13330,7 +13330,7 @@
           <p:cNvPr id="12" name="TextBox 11">
             <a:extLst xmlns:a="http://schemas.openxmlformats.org/drawingml/2006/main">
               <a:ext uri="{FF2B5EF4-FFF2-40B4-BE49-F238E27FC236}">
-                <a16:creationId xmlns:a16="http://schemas.microsoft.com/office/drawing/2014/main" id="{76A0138D-A719-4F2A-A82D-F147C53D2ACD}"/>
+                <a16:creationId xmlns:a16="http://schemas.microsoft.com/office/drawing/2014/main" id="{B58A9728-7116-4225-8025-32A0A3C9FD0A}"/>
               </a:ext>
             </a:extLst>
           </p:cNvPr>
@@ -13377,7 +13377,7 @@
           <p:cNvPr id="13" name="TextBox 12">
             <a:extLst xmlns:a="http://schemas.openxmlformats.org/drawingml/2006/main">
               <a:ext uri="{FF2B5EF4-FFF2-40B4-BE49-F238E27FC236}">
-                <a16:creationId xmlns:a16="http://schemas.microsoft.com/office/drawing/2014/main" id="{B3B61DB6-8422-4E16-87F1-7A4E6F6C70B6}"/>
+                <a16:creationId xmlns:a16="http://schemas.microsoft.com/office/drawing/2014/main" id="{4CBDB883-3703-4B9C-9752-29629B0FAEE8}"/>
               </a:ext>
             </a:extLst>
           </p:cNvPr>
@@ -13424,7 +13424,7 @@
           <p:cNvPr id="14" name="Rounded Rectangle 13">
             <a:extLst xmlns:a="http://schemas.openxmlformats.org/drawingml/2006/main">
               <a:ext uri="{FF2B5EF4-FFF2-40B4-BE49-F238E27FC236}">
-                <a16:creationId xmlns:a16="http://schemas.microsoft.com/office/drawing/2014/main" id="{78A2B091-B1E9-42DF-9F75-69EE9FD2267B}"/>
+                <a16:creationId xmlns:a16="http://schemas.microsoft.com/office/drawing/2014/main" id="{B59D8172-32C6-4F6E-85E4-5BDEE14C0F92}"/>
               </a:ext>
             </a:extLst>
           </p:cNvPr>
@@ -13481,7 +13481,7 @@
           <p:cNvPr id="15" name="TextBox 14">
             <a:extLst xmlns:a="http://schemas.openxmlformats.org/drawingml/2006/main">
               <a:ext uri="{FF2B5EF4-FFF2-40B4-BE49-F238E27FC236}">
-                <a16:creationId xmlns:a16="http://schemas.microsoft.com/office/drawing/2014/main" id="{7E1B754F-03A2-42A6-A94C-5BFC24B75E6F}"/>
+                <a16:creationId xmlns:a16="http://schemas.microsoft.com/office/drawing/2014/main" id="{90343604-96C6-4BBB-ADD1-149F1F1F42A0}"/>
               </a:ext>
             </a:extLst>
           </p:cNvPr>
@@ -13528,7 +13528,7 @@
           <p:cNvPr id="16" name="TextBox 15">
             <a:extLst xmlns:a="http://schemas.openxmlformats.org/drawingml/2006/main">
               <a:ext uri="{FF2B5EF4-FFF2-40B4-BE49-F238E27FC236}">
-                <a16:creationId xmlns:a16="http://schemas.microsoft.com/office/drawing/2014/main" id="{DAF39E0E-8325-4E45-937C-B09F3E149E8F}"/>
+                <a16:creationId xmlns:a16="http://schemas.microsoft.com/office/drawing/2014/main" id="{7B6A126D-40C5-477F-8FF9-D13BE201FBF1}"/>
               </a:ext>
             </a:extLst>
           </p:cNvPr>
@@ -13575,7 +13575,7 @@
           <p:cNvPr id="17" name="TextBox 16">
             <a:extLst xmlns:a="http://schemas.openxmlformats.org/drawingml/2006/main">
               <a:ext uri="{FF2B5EF4-FFF2-40B4-BE49-F238E27FC236}">
-                <a16:creationId xmlns:a16="http://schemas.microsoft.com/office/drawing/2014/main" id="{09D770B4-D99D-48D5-8EDD-B8E62923B0F3}"/>
+                <a16:creationId xmlns:a16="http://schemas.microsoft.com/office/drawing/2014/main" id="{C234465C-811C-4A8A-9CE4-2F1C0F63C819}"/>
               </a:ext>
             </a:extLst>
           </p:cNvPr>
@@ -13622,7 +13622,7 @@
           <p:cNvPr id="18" name="Rounded Rectangle 17">
             <a:extLst xmlns:a="http://schemas.openxmlformats.org/drawingml/2006/main">
               <a:ext uri="{FF2B5EF4-FFF2-40B4-BE49-F238E27FC236}">
-                <a16:creationId xmlns:a16="http://schemas.microsoft.com/office/drawing/2014/main" id="{C0662C28-6162-40B1-9899-6BCBB5FFE927}"/>
+                <a16:creationId xmlns:a16="http://schemas.microsoft.com/office/drawing/2014/main" id="{81120C19-854F-43CD-9156-6D3FFCA98E25}"/>
               </a:ext>
             </a:extLst>
           </p:cNvPr>
@@ -13679,7 +13679,7 @@
           <p:cNvPr id="19" name="TextBox 18">
             <a:extLst xmlns:a="http://schemas.openxmlformats.org/drawingml/2006/main">
               <a:ext uri="{FF2B5EF4-FFF2-40B4-BE49-F238E27FC236}">
-                <a16:creationId xmlns:a16="http://schemas.microsoft.com/office/drawing/2014/main" id="{175BD6A9-22EC-4674-A9DC-403CF40EDE8E}"/>
+                <a16:creationId xmlns:a16="http://schemas.microsoft.com/office/drawing/2014/main" id="{DE8116F1-3B0D-41B0-9889-AF9CD4E64048}"/>
               </a:ext>
             </a:extLst>
           </p:cNvPr>
@@ -13726,7 +13726,7 @@
           <p:cNvPr id="20" name="TextBox 19">
             <a:extLst xmlns:a="http://schemas.openxmlformats.org/drawingml/2006/main">
               <a:ext uri="{FF2B5EF4-FFF2-40B4-BE49-F238E27FC236}">
-                <a16:creationId xmlns:a16="http://schemas.microsoft.com/office/drawing/2014/main" id="{03C49839-B7A1-4C82-8E30-A13B3BB0ACC4}"/>
+                <a16:creationId xmlns:a16="http://schemas.microsoft.com/office/drawing/2014/main" id="{450C90DA-7CAC-45F1-8282-DAA8BE51F754}"/>
               </a:ext>
             </a:extLst>
           </p:cNvPr>
@@ -13771,7 +13771,7 @@
     </p:spTree>
     <p:extLst>
       <p:ext uri="{BB962C8B-B14F-4D97-AF65-F5344CB8AC3E}">
-        <p14:creationId xmlns:p14="http://schemas.microsoft.com/office/powerpoint/2010/main" val="1532923370"/>
+        <p14:creationId xmlns:p14="http://schemas.microsoft.com/office/powerpoint/2010/main" val="1350452989"/>
       </p:ext>
     </p:extLst>
   </p:cSld>
@@ -13795,7 +13795,7 @@
           <p:cNvPr id="2" name="TextBox 1">
             <a:extLst xmlns:a="http://schemas.openxmlformats.org/drawingml/2006/main">
               <a:ext uri="{FF2B5EF4-FFF2-40B4-BE49-F238E27FC236}">
-                <a16:creationId xmlns:a16="http://schemas.microsoft.com/office/drawing/2014/main" id="{36010E97-ABBF-430C-9180-4416570D8479}"/>
+                <a16:creationId xmlns:a16="http://schemas.microsoft.com/office/drawing/2014/main" id="{4B706BAD-34D4-45C7-8931-2E087F9A5CB2}"/>
               </a:ext>
             </a:extLst>
           </p:cNvPr>
@@ -13842,7 +13842,7 @@
           <p:cNvPr id="3" name="TextBox 2">
             <a:extLst xmlns:a="http://schemas.openxmlformats.org/drawingml/2006/main">
               <a:ext uri="{FF2B5EF4-FFF2-40B4-BE49-F238E27FC236}">
-                <a16:creationId xmlns:a16="http://schemas.microsoft.com/office/drawing/2014/main" id="{870D72F7-E9E4-4EEF-9FEA-A3885976F991}"/>
+                <a16:creationId xmlns:a16="http://schemas.microsoft.com/office/drawing/2014/main" id="{1AB87C5F-A658-4F92-8327-03B437B05014}"/>
               </a:ext>
             </a:extLst>
           </p:cNvPr>
@@ -13889,7 +13889,7 @@
           <p:cNvPr id="4" name="Rectangle 3">
             <a:extLst xmlns:a="http://schemas.openxmlformats.org/drawingml/2006/main">
               <a:ext uri="{FF2B5EF4-FFF2-40B4-BE49-F238E27FC236}">
-                <a16:creationId xmlns:a16="http://schemas.microsoft.com/office/drawing/2014/main" id="{CEC935F2-0AFF-40A2-9D58-EE260B13D01F}"/>
+                <a16:creationId xmlns:a16="http://schemas.microsoft.com/office/drawing/2014/main" id="{D7D8C00C-E60C-4852-9154-593B1B99A810}"/>
               </a:ext>
             </a:extLst>
           </p:cNvPr>
@@ -13944,7 +13944,7 @@
           <p:cNvPr id="5" name="Rectangle 4">
             <a:extLst xmlns:a="http://schemas.openxmlformats.org/drawingml/2006/main">
               <a:ext uri="{FF2B5EF4-FFF2-40B4-BE49-F238E27FC236}">
-                <a16:creationId xmlns:a16="http://schemas.microsoft.com/office/drawing/2014/main" id="{491F5A3F-6C8F-4CF3-A2C0-76B736736E05}"/>
+                <a16:creationId xmlns:a16="http://schemas.microsoft.com/office/drawing/2014/main" id="{491CF391-4164-4E67-A9A7-3B97FE2EA227}"/>
               </a:ext>
             </a:extLst>
           </p:cNvPr>
@@ -13999,7 +13999,7 @@
           <p:cNvPr id="6" name="TextBox 5">
             <a:extLst xmlns:a="http://schemas.openxmlformats.org/drawingml/2006/main">
               <a:ext uri="{FF2B5EF4-FFF2-40B4-BE49-F238E27FC236}">
-                <a16:creationId xmlns:a16="http://schemas.microsoft.com/office/drawing/2014/main" id="{06E670F8-0013-4829-82EB-59DB86921EAA}"/>
+                <a16:creationId xmlns:a16="http://schemas.microsoft.com/office/drawing/2014/main" id="{40A68C97-2164-4E64-841E-6BAE93733279}"/>
               </a:ext>
             </a:extLst>
           </p:cNvPr>
@@ -14036,7 +14036,7 @@
                 <a:ea typeface="Aptos"/>
                 <a:cs typeface="Aptos"/>
               </a:rPr>
-              <a:t>Independent public evidence summary · 2026.07.23-11 · 2026-07-22 · Sources: Market-values model; Readiness</a:t>
+              <a:t>Independent public evidence summary · 2026.07.23-12 · 2026-07-22 · Sources: Market-values model; Readiness</a:t>
             </a:r>
           </a:p>
         </p:txBody>
@@ -14046,7 +14046,7 @@
           <p:cNvPr id="7" name="TextBox 6">
             <a:extLst xmlns:a="http://schemas.openxmlformats.org/drawingml/2006/main">
               <a:ext uri="{FF2B5EF4-FFF2-40B4-BE49-F238E27FC236}">
-                <a16:creationId xmlns:a16="http://schemas.microsoft.com/office/drawing/2014/main" id="{C1DB0E8E-C4B7-4DC1-A246-696D64D5209B}"/>
+                <a16:creationId xmlns:a16="http://schemas.microsoft.com/office/drawing/2014/main" id="{D8618B03-956F-4D96-A711-6B81C65556A1}"/>
               </a:ext>
             </a:extLst>
           </p:cNvPr>
@@ -14093,7 +14093,7 @@
           <p:cNvPr id="8" name="TextBox 7">
             <a:extLst xmlns:a="http://schemas.openxmlformats.org/drawingml/2006/main">
               <a:ext uri="{FF2B5EF4-FFF2-40B4-BE49-F238E27FC236}">
-                <a16:creationId xmlns:a16="http://schemas.microsoft.com/office/drawing/2014/main" id="{532718D8-AA73-4071-AC5A-69B82EAF490B}"/>
+                <a16:creationId xmlns:a16="http://schemas.microsoft.com/office/drawing/2014/main" id="{518D2751-FD59-4681-9B25-6337175EEF59}"/>
               </a:ext>
             </a:extLst>
           </p:cNvPr>
@@ -14140,7 +14140,7 @@
           <p:cNvPr id="9" name="TextBox 8">
             <a:extLst xmlns:a="http://schemas.openxmlformats.org/drawingml/2006/main">
               <a:ext uri="{FF2B5EF4-FFF2-40B4-BE49-F238E27FC236}">
-                <a16:creationId xmlns:a16="http://schemas.microsoft.com/office/drawing/2014/main" id="{0A0EE805-D619-4BC0-8484-07497B162478}"/>
+                <a16:creationId xmlns:a16="http://schemas.microsoft.com/office/drawing/2014/main" id="{61588D35-86AA-4C59-A0AC-BC5C8704D669}"/>
               </a:ext>
             </a:extLst>
           </p:cNvPr>
@@ -14237,7 +14237,7 @@
           <p:cNvPr id="10" name="Rounded Rectangle 9">
             <a:extLst xmlns:a="http://schemas.openxmlformats.org/drawingml/2006/main">
               <a:ext uri="{FF2B5EF4-FFF2-40B4-BE49-F238E27FC236}">
-                <a16:creationId xmlns:a16="http://schemas.microsoft.com/office/drawing/2014/main" id="{514AD6D3-2D9D-4187-A60B-2DAB6E43EE90}"/>
+                <a16:creationId xmlns:a16="http://schemas.microsoft.com/office/drawing/2014/main" id="{076411B6-3179-487C-B6CE-A36D8EB6FC9B}"/>
               </a:ext>
             </a:extLst>
           </p:cNvPr>
@@ -14294,7 +14294,7 @@
           <p:cNvPr id="11" name="TextBox 10">
             <a:extLst xmlns:a="http://schemas.openxmlformats.org/drawingml/2006/main">
               <a:ext uri="{FF2B5EF4-FFF2-40B4-BE49-F238E27FC236}">
-                <a16:creationId xmlns:a16="http://schemas.microsoft.com/office/drawing/2014/main" id="{ECA94DD5-6B56-4063-AC6C-DAE294C7A610}"/>
+                <a16:creationId xmlns:a16="http://schemas.microsoft.com/office/drawing/2014/main" id="{67FE6AE9-4810-419E-AB90-13A585F47395}"/>
               </a:ext>
             </a:extLst>
           </p:cNvPr>
@@ -14341,7 +14341,7 @@
           <p:cNvPr id="12" name="TextBox 11">
             <a:extLst xmlns:a="http://schemas.openxmlformats.org/drawingml/2006/main">
               <a:ext uri="{FF2B5EF4-FFF2-40B4-BE49-F238E27FC236}">
-                <a16:creationId xmlns:a16="http://schemas.microsoft.com/office/drawing/2014/main" id="{1F28535E-B8F1-4A47-BD9E-1C7622A80A4A}"/>
+                <a16:creationId xmlns:a16="http://schemas.microsoft.com/office/drawing/2014/main" id="{03B55765-EB69-4144-B113-B164AC44A91C}"/>
               </a:ext>
             </a:extLst>
           </p:cNvPr>
@@ -14386,7 +14386,7 @@
     </p:spTree>
     <p:extLst>
       <p:ext uri="{BB962C8B-B14F-4D97-AF65-F5344CB8AC3E}">
-        <p14:creationId xmlns:p14="http://schemas.microsoft.com/office/powerpoint/2010/main" val="324458792"/>
+        <p14:creationId xmlns:p14="http://schemas.microsoft.com/office/powerpoint/2010/main" val="1638827804"/>
       </p:ext>
     </p:extLst>
   </p:cSld>
@@ -14410,7 +14410,7 @@
           <p:cNvPr id="2" name="TextBox 1">
             <a:extLst xmlns:a="http://schemas.openxmlformats.org/drawingml/2006/main">
               <a:ext uri="{FF2B5EF4-FFF2-40B4-BE49-F238E27FC236}">
-                <a16:creationId xmlns:a16="http://schemas.microsoft.com/office/drawing/2014/main" id="{4CCEFDCE-45FC-40B8-9276-B323D5073167}"/>
+                <a16:creationId xmlns:a16="http://schemas.microsoft.com/office/drawing/2014/main" id="{2CBDD330-0277-4AF3-AF84-93A739F2292B}"/>
               </a:ext>
             </a:extLst>
           </p:cNvPr>
@@ -14457,7 +14457,7 @@
           <p:cNvPr id="3" name="TextBox 2">
             <a:extLst xmlns:a="http://schemas.openxmlformats.org/drawingml/2006/main">
               <a:ext uri="{FF2B5EF4-FFF2-40B4-BE49-F238E27FC236}">
-                <a16:creationId xmlns:a16="http://schemas.microsoft.com/office/drawing/2014/main" id="{804AD0D3-7066-445C-9DA8-6EE34B11852E}"/>
+                <a16:creationId xmlns:a16="http://schemas.microsoft.com/office/drawing/2014/main" id="{B3C1D193-3115-4068-943B-495C7D989F5E}"/>
               </a:ext>
             </a:extLst>
           </p:cNvPr>
@@ -14504,7 +14504,7 @@
           <p:cNvPr id="4" name="Rectangle 3">
             <a:extLst xmlns:a="http://schemas.openxmlformats.org/drawingml/2006/main">
               <a:ext uri="{FF2B5EF4-FFF2-40B4-BE49-F238E27FC236}">
-                <a16:creationId xmlns:a16="http://schemas.microsoft.com/office/drawing/2014/main" id="{2657DD97-69CC-46FD-AAF3-EFECA78B50B0}"/>
+                <a16:creationId xmlns:a16="http://schemas.microsoft.com/office/drawing/2014/main" id="{590FA6A4-AC5E-44C3-B695-F997F0A73B3D}"/>
               </a:ext>
             </a:extLst>
           </p:cNvPr>
@@ -14559,7 +14559,7 @@
           <p:cNvPr id="5" name="Rectangle 4">
             <a:extLst xmlns:a="http://schemas.openxmlformats.org/drawingml/2006/main">
               <a:ext uri="{FF2B5EF4-FFF2-40B4-BE49-F238E27FC236}">
-                <a16:creationId xmlns:a16="http://schemas.microsoft.com/office/drawing/2014/main" id="{55FA8E63-871E-481B-ADA5-320E5F6E165F}"/>
+                <a16:creationId xmlns:a16="http://schemas.microsoft.com/office/drawing/2014/main" id="{6A2CBAB8-00AD-4D3B-A20B-784C3F650374}"/>
               </a:ext>
             </a:extLst>
           </p:cNvPr>
@@ -14614,7 +14614,7 @@
           <p:cNvPr id="6" name="TextBox 5">
             <a:extLst xmlns:a="http://schemas.openxmlformats.org/drawingml/2006/main">
               <a:ext uri="{FF2B5EF4-FFF2-40B4-BE49-F238E27FC236}">
-                <a16:creationId xmlns:a16="http://schemas.microsoft.com/office/drawing/2014/main" id="{FCC375F0-0ADC-4846-B6E2-E19DF259EAB1}"/>
+                <a16:creationId xmlns:a16="http://schemas.microsoft.com/office/drawing/2014/main" id="{5BB772CB-9952-49F1-93F0-AB4AB39851B3}"/>
               </a:ext>
             </a:extLst>
           </p:cNvPr>
@@ -14651,7 +14651,7 @@
                 <a:ea typeface="Aptos"/>
                 <a:cs typeface="Aptos"/>
               </a:rPr>
-              <a:t>Independent public evidence summary · 2026.07.23-11 · 2026-07-22 · Sources: WIPO valuation; Evidence Register</a:t>
+              <a:t>Independent public evidence summary · 2026.07.23-12 · 2026-07-22 · Sources: WIPO valuation; Evidence Register</a:t>
             </a:r>
           </a:p>
         </p:txBody>
@@ -14661,7 +14661,7 @@
           <p:cNvPr id="7" name="TextBox 6">
             <a:extLst xmlns:a="http://schemas.openxmlformats.org/drawingml/2006/main">
               <a:ext uri="{FF2B5EF4-FFF2-40B4-BE49-F238E27FC236}">
-                <a16:creationId xmlns:a16="http://schemas.microsoft.com/office/drawing/2014/main" id="{50580B3B-DECA-438E-9576-24170EA3BBFF}"/>
+                <a16:creationId xmlns:a16="http://schemas.microsoft.com/office/drawing/2014/main" id="{1EDA7A0D-1299-4328-90DF-CE6C33155BBA}"/>
               </a:ext>
             </a:extLst>
           </p:cNvPr>
@@ -15231,7 +15231,7 @@
           <p:cNvPr id="9" name="TextBox 8">
             <a:extLst xmlns:a="http://schemas.openxmlformats.org/drawingml/2006/main">
               <a:ext uri="{FF2B5EF4-FFF2-40B4-BE49-F238E27FC236}">
-                <a16:creationId xmlns:a16="http://schemas.microsoft.com/office/drawing/2014/main" id="{F28BCECF-700D-4A40-98D6-58D8B8D073A1}"/>
+                <a16:creationId xmlns:a16="http://schemas.microsoft.com/office/drawing/2014/main" id="{8C072124-1C4B-4FEA-8022-78B6F4D1BE0C}"/>
               </a:ext>
             </a:extLst>
           </p:cNvPr>
@@ -15276,7 +15276,7 @@
     </p:spTree>
     <p:extLst>
       <p:ext uri="{BB962C8B-B14F-4D97-AF65-F5344CB8AC3E}">
-        <p14:creationId xmlns:p14="http://schemas.microsoft.com/office/powerpoint/2010/main" val="364355003"/>
+        <p14:creationId xmlns:p14="http://schemas.microsoft.com/office/powerpoint/2010/main" val="244496510"/>
       </p:ext>
     </p:extLst>
   </p:cSld>
@@ -15300,7 +15300,7 @@
           <p:cNvPr id="2" name="TextBox 1">
             <a:extLst xmlns:a="http://schemas.openxmlformats.org/drawingml/2006/main">
               <a:ext uri="{FF2B5EF4-FFF2-40B4-BE49-F238E27FC236}">
-                <a16:creationId xmlns:a16="http://schemas.microsoft.com/office/drawing/2014/main" id="{EB80E5C8-4460-4FCC-8C63-1228EAF57F59}"/>
+                <a16:creationId xmlns:a16="http://schemas.microsoft.com/office/drawing/2014/main" id="{2651FA73-5D09-49E3-AD61-17AE17A380BC}"/>
               </a:ext>
             </a:extLst>
           </p:cNvPr>
@@ -15347,7 +15347,7 @@
           <p:cNvPr id="3" name="TextBox 2">
             <a:extLst xmlns:a="http://schemas.openxmlformats.org/drawingml/2006/main">
               <a:ext uri="{FF2B5EF4-FFF2-40B4-BE49-F238E27FC236}">
-                <a16:creationId xmlns:a16="http://schemas.microsoft.com/office/drawing/2014/main" id="{D8F033F3-DCDF-4F0A-AC89-0647855A3C3E}"/>
+                <a16:creationId xmlns:a16="http://schemas.microsoft.com/office/drawing/2014/main" id="{5FAC7F46-CFA1-4508-B5E0-4BE7004D2CFE}"/>
               </a:ext>
             </a:extLst>
           </p:cNvPr>
@@ -15394,7 +15394,7 @@
           <p:cNvPr id="4" name="Rectangle 3">
             <a:extLst xmlns:a="http://schemas.openxmlformats.org/drawingml/2006/main">
               <a:ext uri="{FF2B5EF4-FFF2-40B4-BE49-F238E27FC236}">
-                <a16:creationId xmlns:a16="http://schemas.microsoft.com/office/drawing/2014/main" id="{13A612FE-6DF1-4B07-8494-514C33FCBD17}"/>
+                <a16:creationId xmlns:a16="http://schemas.microsoft.com/office/drawing/2014/main" id="{CCDE451E-9B1C-4AD5-9EA3-5F97EDCBEC29}"/>
               </a:ext>
             </a:extLst>
           </p:cNvPr>
@@ -15449,7 +15449,7 @@
           <p:cNvPr id="5" name="Rectangle 4">
             <a:extLst xmlns:a="http://schemas.openxmlformats.org/drawingml/2006/main">
               <a:ext uri="{FF2B5EF4-FFF2-40B4-BE49-F238E27FC236}">
-                <a16:creationId xmlns:a16="http://schemas.microsoft.com/office/drawing/2014/main" id="{63DDAE97-41C3-4789-826B-40FEF3741C97}"/>
+                <a16:creationId xmlns:a16="http://schemas.microsoft.com/office/drawing/2014/main" id="{A860B8F0-E8A0-48CE-BC81-D6DB5F33D24E}"/>
               </a:ext>
             </a:extLst>
           </p:cNvPr>
@@ -15504,7 +15504,7 @@
           <p:cNvPr id="6" name="TextBox 5">
             <a:extLst xmlns:a="http://schemas.openxmlformats.org/drawingml/2006/main">
               <a:ext uri="{FF2B5EF4-FFF2-40B4-BE49-F238E27FC236}">
-                <a16:creationId xmlns:a16="http://schemas.microsoft.com/office/drawing/2014/main" id="{DFFDD458-C36F-4F19-8A92-B8311FC7099B}"/>
+                <a16:creationId xmlns:a16="http://schemas.microsoft.com/office/drawing/2014/main" id="{9CAFFA86-847E-4AF3-95AA-8523713EF04D}"/>
               </a:ext>
             </a:extLst>
           </p:cNvPr>
@@ -15541,7 +15541,7 @@
                 <a:ea typeface="Aptos"/>
                 <a:cs typeface="Aptos"/>
               </a:rPr>
-              <a:t>Independent public evidence summary · 2026.07.23-11 · 2026-07-22 · Sources: EPO; Germany — official judgments; WIPO</a:t>
+              <a:t>Independent public evidence summary · 2026.07.23-12 · 2026-07-22 · Sources: EPO; Germany — official judgments; WIPO</a:t>
             </a:r>
           </a:p>
         </p:txBody>
@@ -15551,7 +15551,7 @@
           <p:cNvPr id="7" name="TextBox 6">
             <a:extLst xmlns:a="http://schemas.openxmlformats.org/drawingml/2006/main">
               <a:ext uri="{FF2B5EF4-FFF2-40B4-BE49-F238E27FC236}">
-                <a16:creationId xmlns:a16="http://schemas.microsoft.com/office/drawing/2014/main" id="{ED33786C-D7C8-48DD-962E-C0C5740C67B4}"/>
+                <a16:creationId xmlns:a16="http://schemas.microsoft.com/office/drawing/2014/main" id="{D76B29A5-B621-4F2B-8901-EE937559D9C3}"/>
               </a:ext>
             </a:extLst>
           </p:cNvPr>
@@ -15598,7 +15598,7 @@
           <p:cNvPr id="8" name="TextBox 7">
             <a:extLst xmlns:a="http://schemas.openxmlformats.org/drawingml/2006/main">
               <a:ext uri="{FF2B5EF4-FFF2-40B4-BE49-F238E27FC236}">
-                <a16:creationId xmlns:a16="http://schemas.microsoft.com/office/drawing/2014/main" id="{D7C57212-9635-41A1-BB60-FF7B91A4C4B2}"/>
+                <a16:creationId xmlns:a16="http://schemas.microsoft.com/office/drawing/2014/main" id="{012C5057-92BA-4A6D-BCAF-130BE7E166A9}"/>
               </a:ext>
             </a:extLst>
           </p:cNvPr>
@@ -15645,7 +15645,7 @@
           <p:cNvPr id="9" name="TextBox 8">
             <a:extLst xmlns:a="http://schemas.openxmlformats.org/drawingml/2006/main">
               <a:ext uri="{FF2B5EF4-FFF2-40B4-BE49-F238E27FC236}">
-                <a16:creationId xmlns:a16="http://schemas.microsoft.com/office/drawing/2014/main" id="{EACE90C8-DB07-41EE-977F-D5B2362D05AC}"/>
+                <a16:creationId xmlns:a16="http://schemas.microsoft.com/office/drawing/2014/main" id="{A0FF0B60-4C8D-44E1-8DDA-F4B430954C93}"/>
               </a:ext>
             </a:extLst>
           </p:cNvPr>
@@ -15742,7 +15742,7 @@
           <p:cNvPr id="10" name="Rounded Rectangle 9">
             <a:extLst xmlns:a="http://schemas.openxmlformats.org/drawingml/2006/main">
               <a:ext uri="{FF2B5EF4-FFF2-40B4-BE49-F238E27FC236}">
-                <a16:creationId xmlns:a16="http://schemas.microsoft.com/office/drawing/2014/main" id="{75EB7DC9-2D13-4932-A0DE-4CFC175D5031}"/>
+                <a16:creationId xmlns:a16="http://schemas.microsoft.com/office/drawing/2014/main" id="{2BB4CF01-DD5D-497C-9135-C7F28DFC6B05}"/>
               </a:ext>
             </a:extLst>
           </p:cNvPr>
@@ -15799,7 +15799,7 @@
           <p:cNvPr id="11" name="TextBox 10">
             <a:extLst xmlns:a="http://schemas.openxmlformats.org/drawingml/2006/main">
               <a:ext uri="{FF2B5EF4-FFF2-40B4-BE49-F238E27FC236}">
-                <a16:creationId xmlns:a16="http://schemas.microsoft.com/office/drawing/2014/main" id="{8DD87F65-CA2A-461E-ABAF-2FFB13C993FC}"/>
+                <a16:creationId xmlns:a16="http://schemas.microsoft.com/office/drawing/2014/main" id="{A67174AC-1640-44C0-BF3D-D6EA6BFB3948}"/>
               </a:ext>
             </a:extLst>
           </p:cNvPr>
@@ -15846,7 +15846,7 @@
           <p:cNvPr id="12" name="TextBox 11">
             <a:extLst xmlns:a="http://schemas.openxmlformats.org/drawingml/2006/main">
               <a:ext uri="{FF2B5EF4-FFF2-40B4-BE49-F238E27FC236}">
-                <a16:creationId xmlns:a16="http://schemas.microsoft.com/office/drawing/2014/main" id="{01CFCF1F-D39E-47FB-80DC-918FDD8DF221}"/>
+                <a16:creationId xmlns:a16="http://schemas.microsoft.com/office/drawing/2014/main" id="{61F178F5-305E-4F4F-86B7-520EC9C946E9}"/>
               </a:ext>
             </a:extLst>
           </p:cNvPr>
@@ -15891,7 +15891,7 @@
     </p:spTree>
     <p:extLst>
       <p:ext uri="{BB962C8B-B14F-4D97-AF65-F5344CB8AC3E}">
-        <p14:creationId xmlns:p14="http://schemas.microsoft.com/office/powerpoint/2010/main" val="877846374"/>
+        <p14:creationId xmlns:p14="http://schemas.microsoft.com/office/powerpoint/2010/main" val="1065707506"/>
       </p:ext>
     </p:extLst>
   </p:cSld>
@@ -15915,7 +15915,7 @@
           <p:cNvPr id="2" name="TextBox 1">
             <a:extLst xmlns:a="http://schemas.openxmlformats.org/drawingml/2006/main">
               <a:ext uri="{FF2B5EF4-FFF2-40B4-BE49-F238E27FC236}">
-                <a16:creationId xmlns:a16="http://schemas.microsoft.com/office/drawing/2014/main" id="{0D918D9A-869B-4625-B200-50600E911BC3}"/>
+                <a16:creationId xmlns:a16="http://schemas.microsoft.com/office/drawing/2014/main" id="{CCAFE4D0-A13C-4C9F-93F3-D61BC6951F92}"/>
               </a:ext>
             </a:extLst>
           </p:cNvPr>
@@ -15962,7 +15962,7 @@
           <p:cNvPr id="3" name="TextBox 2">
             <a:extLst xmlns:a="http://schemas.openxmlformats.org/drawingml/2006/main">
               <a:ext uri="{FF2B5EF4-FFF2-40B4-BE49-F238E27FC236}">
-                <a16:creationId xmlns:a16="http://schemas.microsoft.com/office/drawing/2014/main" id="{01AB1FF8-5AE4-413D-87C4-A31B05438AEE}"/>
+                <a16:creationId xmlns:a16="http://schemas.microsoft.com/office/drawing/2014/main" id="{D9B9F02B-DF1B-4F0E-BA54-DC89EA16F320}"/>
               </a:ext>
             </a:extLst>
           </p:cNvPr>
@@ -16009,7 +16009,7 @@
           <p:cNvPr id="4" name="Rectangle 3">
             <a:extLst xmlns:a="http://schemas.openxmlformats.org/drawingml/2006/main">
               <a:ext uri="{FF2B5EF4-FFF2-40B4-BE49-F238E27FC236}">
-                <a16:creationId xmlns:a16="http://schemas.microsoft.com/office/drawing/2014/main" id="{72521F20-E757-45CC-B2F9-A5F52AD25D15}"/>
+                <a16:creationId xmlns:a16="http://schemas.microsoft.com/office/drawing/2014/main" id="{2C250012-8DA2-4B1C-9ADD-902A55A17002}"/>
               </a:ext>
             </a:extLst>
           </p:cNvPr>
@@ -16064,7 +16064,7 @@
           <p:cNvPr id="5" name="Rectangle 4">
             <a:extLst xmlns:a="http://schemas.openxmlformats.org/drawingml/2006/main">
               <a:ext uri="{FF2B5EF4-FFF2-40B4-BE49-F238E27FC236}">
-                <a16:creationId xmlns:a16="http://schemas.microsoft.com/office/drawing/2014/main" id="{8FD2EA95-9EC6-4CFF-A56E-264D1BD439E3}"/>
+                <a16:creationId xmlns:a16="http://schemas.microsoft.com/office/drawing/2014/main" id="{17A0EFC8-8AB1-4DD4-9FA3-99772BAAA053}"/>
               </a:ext>
             </a:extLst>
           </p:cNvPr>
@@ -16119,7 +16119,7 @@
           <p:cNvPr id="6" name="TextBox 5">
             <a:extLst xmlns:a="http://schemas.openxmlformats.org/drawingml/2006/main">
               <a:ext uri="{FF2B5EF4-FFF2-40B4-BE49-F238E27FC236}">
-                <a16:creationId xmlns:a16="http://schemas.microsoft.com/office/drawing/2014/main" id="{E3B82581-81F1-456B-B023-6EFCCB89F9A7}"/>
+                <a16:creationId xmlns:a16="http://schemas.microsoft.com/office/drawing/2014/main" id="{63EC61EB-811D-45AB-BAB2-74B55257E798}"/>
               </a:ext>
             </a:extLst>
           </p:cNvPr>
@@ -16156,7 +16156,7 @@
                 <a:ea typeface="Aptos"/>
                 <a:cs typeface="Aptos"/>
               </a:rPr>
-              <a:t>Independent public evidence summary · 2026.07.23-11 · 2026-07-22 · Sources: WIPO licensing; IP Finance</a:t>
+              <a:t>Independent public evidence summary · 2026.07.23-12 · 2026-07-22 · Sources: WIPO licensing; IP Finance</a:t>
             </a:r>
           </a:p>
         </p:txBody>
@@ -16166,7 +16166,7 @@
           <p:cNvPr id="7" name="TextBox 6">
             <a:extLst xmlns:a="http://schemas.openxmlformats.org/drawingml/2006/main">
               <a:ext uri="{FF2B5EF4-FFF2-40B4-BE49-F238E27FC236}">
-                <a16:creationId xmlns:a16="http://schemas.microsoft.com/office/drawing/2014/main" id="{062FAF8A-A6FB-48C8-A2CC-9287F82FD6E6}"/>
+                <a16:creationId xmlns:a16="http://schemas.microsoft.com/office/drawing/2014/main" id="{132B4999-4CE0-411A-ABEB-111435EDEABE}"/>
               </a:ext>
             </a:extLst>
           </p:cNvPr>
@@ -16213,7 +16213,7 @@
           <p:cNvPr id="8" name="TextBox 7">
             <a:extLst xmlns:a="http://schemas.openxmlformats.org/drawingml/2006/main">
               <a:ext uri="{FF2B5EF4-FFF2-40B4-BE49-F238E27FC236}">
-                <a16:creationId xmlns:a16="http://schemas.microsoft.com/office/drawing/2014/main" id="{8A317384-E97F-4340-81B8-9F67EB3BBF24}"/>
+                <a16:creationId xmlns:a16="http://schemas.microsoft.com/office/drawing/2014/main" id="{97699137-D432-4A6D-AD39-C6F3DF5AD963}"/>
               </a:ext>
             </a:extLst>
           </p:cNvPr>
@@ -16260,7 +16260,7 @@
           <p:cNvPr id="9" name="TextBox 8">
             <a:extLst xmlns:a="http://schemas.openxmlformats.org/drawingml/2006/main">
               <a:ext uri="{FF2B5EF4-FFF2-40B4-BE49-F238E27FC236}">
-                <a16:creationId xmlns:a16="http://schemas.microsoft.com/office/drawing/2014/main" id="{084A5E44-6363-4FA3-9919-3E4591399081}"/>
+                <a16:creationId xmlns:a16="http://schemas.microsoft.com/office/drawing/2014/main" id="{BA71C9E5-2569-40E7-A60D-5E0D833703D8}"/>
               </a:ext>
             </a:extLst>
           </p:cNvPr>
@@ -16357,7 +16357,7 @@
           <p:cNvPr id="10" name="Rounded Rectangle 9">
             <a:extLst xmlns:a="http://schemas.openxmlformats.org/drawingml/2006/main">
               <a:ext uri="{FF2B5EF4-FFF2-40B4-BE49-F238E27FC236}">
-                <a16:creationId xmlns:a16="http://schemas.microsoft.com/office/drawing/2014/main" id="{EF8584C4-AF91-4513-8E3C-6739BFEC0B8A}"/>
+                <a16:creationId xmlns:a16="http://schemas.microsoft.com/office/drawing/2014/main" id="{BF7CDC99-E8F9-40B5-9399-48874A3CE833}"/>
               </a:ext>
             </a:extLst>
           </p:cNvPr>
@@ -16414,7 +16414,7 @@
           <p:cNvPr id="11" name="TextBox 10">
             <a:extLst xmlns:a="http://schemas.openxmlformats.org/drawingml/2006/main">
               <a:ext uri="{FF2B5EF4-FFF2-40B4-BE49-F238E27FC236}">
-                <a16:creationId xmlns:a16="http://schemas.microsoft.com/office/drawing/2014/main" id="{BAFDD4FD-7A43-4C67-BA05-117A9F1AB983}"/>
+                <a16:creationId xmlns:a16="http://schemas.microsoft.com/office/drawing/2014/main" id="{9A4F0EA8-C0D5-4E4D-AC27-76EF4DC791CB}"/>
               </a:ext>
             </a:extLst>
           </p:cNvPr>
@@ -16461,7 +16461,7 @@
           <p:cNvPr id="12" name="TextBox 11">
             <a:extLst xmlns:a="http://schemas.openxmlformats.org/drawingml/2006/main">
               <a:ext uri="{FF2B5EF4-FFF2-40B4-BE49-F238E27FC236}">
-                <a16:creationId xmlns:a16="http://schemas.microsoft.com/office/drawing/2014/main" id="{3BF8E8E7-F3BF-4329-A1B4-AB5360643BBB}"/>
+                <a16:creationId xmlns:a16="http://schemas.microsoft.com/office/drawing/2014/main" id="{18E1F523-130F-4457-94DF-6A9195A03EFE}"/>
               </a:ext>
             </a:extLst>
           </p:cNvPr>
@@ -16506,7 +16506,7 @@
     </p:spTree>
     <p:extLst>
       <p:ext uri="{BB962C8B-B14F-4D97-AF65-F5344CB8AC3E}">
-        <p14:creationId xmlns:p14="http://schemas.microsoft.com/office/powerpoint/2010/main" val="145529628"/>
+        <p14:creationId xmlns:p14="http://schemas.microsoft.com/office/powerpoint/2010/main" val="1960259126"/>
       </p:ext>
     </p:extLst>
   </p:cSld>
@@ -16530,7 +16530,7 @@
           <p:cNvPr id="2" name="TextBox 1">
             <a:extLst xmlns:a="http://schemas.openxmlformats.org/drawingml/2006/main">
               <a:ext uri="{FF2B5EF4-FFF2-40B4-BE49-F238E27FC236}">
-                <a16:creationId xmlns:a16="http://schemas.microsoft.com/office/drawing/2014/main" id="{FBABEA17-BEE3-4772-AFDF-71E1BAAFA31D}"/>
+                <a16:creationId xmlns:a16="http://schemas.microsoft.com/office/drawing/2014/main" id="{65003111-C409-485B-BCF9-1C08E234AE9C}"/>
               </a:ext>
             </a:extLst>
           </p:cNvPr>
@@ -16577,7 +16577,7 @@
           <p:cNvPr id="3" name="TextBox 2">
             <a:extLst xmlns:a="http://schemas.openxmlformats.org/drawingml/2006/main">
               <a:ext uri="{FF2B5EF4-FFF2-40B4-BE49-F238E27FC236}">
-                <a16:creationId xmlns:a16="http://schemas.microsoft.com/office/drawing/2014/main" id="{6D2090E8-20CC-4442-8E67-092F6DB33F3F}"/>
+                <a16:creationId xmlns:a16="http://schemas.microsoft.com/office/drawing/2014/main" id="{F9361FA2-3EED-4570-8963-CD5446A11A8B}"/>
               </a:ext>
             </a:extLst>
           </p:cNvPr>
@@ -16624,7 +16624,7 @@
           <p:cNvPr id="4" name="Rectangle 3">
             <a:extLst xmlns:a="http://schemas.openxmlformats.org/drawingml/2006/main">
               <a:ext uri="{FF2B5EF4-FFF2-40B4-BE49-F238E27FC236}">
-                <a16:creationId xmlns:a16="http://schemas.microsoft.com/office/drawing/2014/main" id="{698EDE2B-BB73-4A04-8B2F-9E68079EE24F}"/>
+                <a16:creationId xmlns:a16="http://schemas.microsoft.com/office/drawing/2014/main" id="{2ED3B9B6-BA5B-46B2-89C4-920CFBA70BCB}"/>
               </a:ext>
             </a:extLst>
           </p:cNvPr>
@@ -16679,7 +16679,7 @@
           <p:cNvPr id="5" name="Rectangle 4">
             <a:extLst xmlns:a="http://schemas.openxmlformats.org/drawingml/2006/main">
               <a:ext uri="{FF2B5EF4-FFF2-40B4-BE49-F238E27FC236}">
-                <a16:creationId xmlns:a16="http://schemas.microsoft.com/office/drawing/2014/main" id="{4BCCEB54-0FD0-41C0-8BC1-3D2D1B26AB5E}"/>
+                <a16:creationId xmlns:a16="http://schemas.microsoft.com/office/drawing/2014/main" id="{59C7D383-CEC0-4129-B019-CAB9570D1D72}"/>
               </a:ext>
             </a:extLst>
           </p:cNvPr>
@@ -16734,7 +16734,7 @@
           <p:cNvPr id="6" name="TextBox 5">
             <a:extLst xmlns:a="http://schemas.openxmlformats.org/drawingml/2006/main">
               <a:ext uri="{FF2B5EF4-FFF2-40B4-BE49-F238E27FC236}">
-                <a16:creationId xmlns:a16="http://schemas.microsoft.com/office/drawing/2014/main" id="{516390B7-B8D6-47AC-8CAE-FC97254CDD73}"/>
+                <a16:creationId xmlns:a16="http://schemas.microsoft.com/office/drawing/2014/main" id="{EF19870C-44BC-4C69-BF3D-CB7B2D357021}"/>
               </a:ext>
             </a:extLst>
           </p:cNvPr>
@@ -16771,7 +16771,7 @@
                 <a:ea typeface="Aptos"/>
                 <a:cs typeface="Aptos"/>
               </a:rPr>
-              <a:t>Independent public evidence summary · 2026.07.23-11 · 2026-07-22 · Sources: Evidence Register; EPO</a:t>
+              <a:t>Independent public evidence summary · 2026.07.23-12 · 2026-07-22 · Sources: Evidence Register; EPO</a:t>
             </a:r>
           </a:p>
         </p:txBody>
@@ -16781,7 +16781,7 @@
           <p:cNvPr id="7" name="TextBox 6">
             <a:extLst xmlns:a="http://schemas.openxmlformats.org/drawingml/2006/main">
               <a:ext uri="{FF2B5EF4-FFF2-40B4-BE49-F238E27FC236}">
-                <a16:creationId xmlns:a16="http://schemas.microsoft.com/office/drawing/2014/main" id="{D4E492BE-398F-43D8-9CF9-4457AD58B59C}"/>
+                <a16:creationId xmlns:a16="http://schemas.microsoft.com/office/drawing/2014/main" id="{83D2E492-72DC-4A10-B3AD-1D07B02998C6}"/>
               </a:ext>
             </a:extLst>
           </p:cNvPr>
@@ -17268,7 +17268,7 @@
           <p:cNvPr id="9" name="TextBox 8">
             <a:extLst xmlns:a="http://schemas.openxmlformats.org/drawingml/2006/main">
               <a:ext uri="{FF2B5EF4-FFF2-40B4-BE49-F238E27FC236}">
-                <a16:creationId xmlns:a16="http://schemas.microsoft.com/office/drawing/2014/main" id="{5A2079AD-DF54-4823-B29C-EA3EFE0B71B9}"/>
+                <a16:creationId xmlns:a16="http://schemas.microsoft.com/office/drawing/2014/main" id="{F6F84CF2-4114-49E2-B19F-1321B046E141}"/>
               </a:ext>
             </a:extLst>
           </p:cNvPr>
@@ -17313,7 +17313,7 @@
     </p:spTree>
     <p:extLst>
       <p:ext uri="{BB962C8B-B14F-4D97-AF65-F5344CB8AC3E}">
-        <p14:creationId xmlns:p14="http://schemas.microsoft.com/office/powerpoint/2010/main" val="1892466906"/>
+        <p14:creationId xmlns:p14="http://schemas.microsoft.com/office/powerpoint/2010/main" val="639268024"/>
       </p:ext>
     </p:extLst>
   </p:cSld>
@@ -17337,7 +17337,7 @@
           <p:cNvPr id="2" name="TextBox 1">
             <a:extLst xmlns:a="http://schemas.openxmlformats.org/drawingml/2006/main">
               <a:ext uri="{FF2B5EF4-FFF2-40B4-BE49-F238E27FC236}">
-                <a16:creationId xmlns:a16="http://schemas.microsoft.com/office/drawing/2014/main" id="{4405FE8A-C724-4455-A9BB-C6ABD1E1E13D}"/>
+                <a16:creationId xmlns:a16="http://schemas.microsoft.com/office/drawing/2014/main" id="{CDF93DF6-C37B-45DB-8A4F-06922F80E9C1}"/>
               </a:ext>
             </a:extLst>
           </p:cNvPr>
@@ -17384,7 +17384,7 @@
           <p:cNvPr id="3" name="TextBox 2">
             <a:extLst xmlns:a="http://schemas.openxmlformats.org/drawingml/2006/main">
               <a:ext uri="{FF2B5EF4-FFF2-40B4-BE49-F238E27FC236}">
-                <a16:creationId xmlns:a16="http://schemas.microsoft.com/office/drawing/2014/main" id="{5AC0631F-903E-46E5-A851-CF7279F30C79}"/>
+                <a16:creationId xmlns:a16="http://schemas.microsoft.com/office/drawing/2014/main" id="{4D47D7A0-B97E-4210-AC3A-1386786C9711}"/>
               </a:ext>
             </a:extLst>
           </p:cNvPr>
@@ -17431,7 +17431,7 @@
           <p:cNvPr id="4" name="Rectangle 3">
             <a:extLst xmlns:a="http://schemas.openxmlformats.org/drawingml/2006/main">
               <a:ext uri="{FF2B5EF4-FFF2-40B4-BE49-F238E27FC236}">
-                <a16:creationId xmlns:a16="http://schemas.microsoft.com/office/drawing/2014/main" id="{CA774E9B-CB8B-4A81-9225-6D19C85CDFCF}"/>
+                <a16:creationId xmlns:a16="http://schemas.microsoft.com/office/drawing/2014/main" id="{F350485F-B523-411C-8E36-EE99E449B66C}"/>
               </a:ext>
             </a:extLst>
           </p:cNvPr>
@@ -17486,7 +17486,7 @@
           <p:cNvPr id="5" name="Rectangle 4">
             <a:extLst xmlns:a="http://schemas.openxmlformats.org/drawingml/2006/main">
               <a:ext uri="{FF2B5EF4-FFF2-40B4-BE49-F238E27FC236}">
-                <a16:creationId xmlns:a16="http://schemas.microsoft.com/office/drawing/2014/main" id="{747AE065-5C86-4629-8FCF-755EE3B46520}"/>
+                <a16:creationId xmlns:a16="http://schemas.microsoft.com/office/drawing/2014/main" id="{20C33311-5120-4215-9407-54233469EC2F}"/>
               </a:ext>
             </a:extLst>
           </p:cNvPr>
@@ -17541,7 +17541,7 @@
           <p:cNvPr id="6" name="TextBox 5">
             <a:extLst xmlns:a="http://schemas.openxmlformats.org/drawingml/2006/main">
               <a:ext uri="{FF2B5EF4-FFF2-40B4-BE49-F238E27FC236}">
-                <a16:creationId xmlns:a16="http://schemas.microsoft.com/office/drawing/2014/main" id="{C987F3C0-89CE-4C94-A12A-C21C247E69A7}"/>
+                <a16:creationId xmlns:a16="http://schemas.microsoft.com/office/drawing/2014/main" id="{38439BE2-750F-4E3A-B51E-A0CDC467565B}"/>
               </a:ext>
             </a:extLst>
           </p:cNvPr>
@@ -17578,7 +17578,7 @@
                 <a:ea typeface="Aptos"/>
                 <a:cs typeface="Aptos"/>
               </a:rPr>
-              <a:t>Independent public evidence summary · 2026.07.23-11 · 2026-07-22 · Sources: EP3032975B2; 7 O 3341/24</a:t>
+              <a:t>Independent public evidence summary · 2026.07.23-12 · 2026-07-22 · Sources: EP3032975B2; 7 O 3341/24</a:t>
             </a:r>
           </a:p>
         </p:txBody>
@@ -17588,7 +17588,7 @@
           <p:cNvPr id="7" name="TextBox 6">
             <a:extLst xmlns:a="http://schemas.openxmlformats.org/drawingml/2006/main">
               <a:ext uri="{FF2B5EF4-FFF2-40B4-BE49-F238E27FC236}">
-                <a16:creationId xmlns:a16="http://schemas.microsoft.com/office/drawing/2014/main" id="{CF481362-F8C8-425D-B2A5-6006B09E9A07}"/>
+                <a16:creationId xmlns:a16="http://schemas.microsoft.com/office/drawing/2014/main" id="{23102C0A-4C31-436D-95E0-600D0EBE044D}"/>
               </a:ext>
             </a:extLst>
           </p:cNvPr>
@@ -17635,7 +17635,7 @@
           <p:cNvPr id="8" name="Rounded Rectangle 7">
             <a:extLst xmlns:a="http://schemas.openxmlformats.org/drawingml/2006/main">
               <a:ext uri="{FF2B5EF4-FFF2-40B4-BE49-F238E27FC236}">
-                <a16:creationId xmlns:a16="http://schemas.microsoft.com/office/drawing/2014/main" id="{086C865D-BA23-4501-8426-2CA291F53E5F}"/>
+                <a16:creationId xmlns:a16="http://schemas.microsoft.com/office/drawing/2014/main" id="{CD916AF8-AB79-43AD-A047-8DBC8F5CB553}"/>
               </a:ext>
             </a:extLst>
           </p:cNvPr>
@@ -17692,7 +17692,7 @@
           <p:cNvPr id="9" name="TextBox 8">
             <a:extLst xmlns:a="http://schemas.openxmlformats.org/drawingml/2006/main">
               <a:ext uri="{FF2B5EF4-FFF2-40B4-BE49-F238E27FC236}">
-                <a16:creationId xmlns:a16="http://schemas.microsoft.com/office/drawing/2014/main" id="{2F93CD18-E8D3-434F-87D6-5C68B1F552A5}"/>
+                <a16:creationId xmlns:a16="http://schemas.microsoft.com/office/drawing/2014/main" id="{9AB307EA-1404-498B-8D8D-AB594C440AC7}"/>
               </a:ext>
             </a:extLst>
           </p:cNvPr>
@@ -17739,7 +17739,7 @@
           <p:cNvPr id="10" name="TextBox 9">
             <a:extLst xmlns:a="http://schemas.openxmlformats.org/drawingml/2006/main">
               <a:ext uri="{FF2B5EF4-FFF2-40B4-BE49-F238E27FC236}">
-                <a16:creationId xmlns:a16="http://schemas.microsoft.com/office/drawing/2014/main" id="{BDF5D4D9-CF70-40B3-8B22-983142971954}"/>
+                <a16:creationId xmlns:a16="http://schemas.microsoft.com/office/drawing/2014/main" id="{E79FD6CB-1E42-491E-B4B2-4A2ECAB8FC6B}"/>
               </a:ext>
             </a:extLst>
           </p:cNvPr>
@@ -17786,7 +17786,7 @@
           <p:cNvPr id="11" name="TextBox 10">
             <a:extLst xmlns:a="http://schemas.openxmlformats.org/drawingml/2006/main">
               <a:ext uri="{FF2B5EF4-FFF2-40B4-BE49-F238E27FC236}">
-                <a16:creationId xmlns:a16="http://schemas.microsoft.com/office/drawing/2014/main" id="{1E9546FC-AC66-4C3B-B58B-F0ADABB13B79}"/>
+                <a16:creationId xmlns:a16="http://schemas.microsoft.com/office/drawing/2014/main" id="{04E779CF-1EDC-46AD-8195-24630706AF5F}"/>
               </a:ext>
             </a:extLst>
           </p:cNvPr>
@@ -17833,7 +17833,7 @@
           <p:cNvPr id="12" name="Rounded Rectangle 11">
             <a:extLst xmlns:a="http://schemas.openxmlformats.org/drawingml/2006/main">
               <a:ext uri="{FF2B5EF4-FFF2-40B4-BE49-F238E27FC236}">
-                <a16:creationId xmlns:a16="http://schemas.microsoft.com/office/drawing/2014/main" id="{1A5DA50D-3461-484B-B0A0-051F52AC4314}"/>
+                <a16:creationId xmlns:a16="http://schemas.microsoft.com/office/drawing/2014/main" id="{2579BAC1-E7C5-453E-822C-0560D6655983}"/>
               </a:ext>
             </a:extLst>
           </p:cNvPr>
@@ -17890,7 +17890,7 @@
           <p:cNvPr id="13" name="TextBox 12">
             <a:extLst xmlns:a="http://schemas.openxmlformats.org/drawingml/2006/main">
               <a:ext uri="{FF2B5EF4-FFF2-40B4-BE49-F238E27FC236}">
-                <a16:creationId xmlns:a16="http://schemas.microsoft.com/office/drawing/2014/main" id="{08E495BB-0704-4C5B-A312-AA686E7191C5}"/>
+                <a16:creationId xmlns:a16="http://schemas.microsoft.com/office/drawing/2014/main" id="{4CD1AAA0-E24D-4CEB-B8DA-734ABF7C4956}"/>
               </a:ext>
             </a:extLst>
           </p:cNvPr>
@@ -17937,7 +17937,7 @@
           <p:cNvPr id="14" name="TextBox 13">
             <a:extLst xmlns:a="http://schemas.openxmlformats.org/drawingml/2006/main">
               <a:ext uri="{FF2B5EF4-FFF2-40B4-BE49-F238E27FC236}">
-                <a16:creationId xmlns:a16="http://schemas.microsoft.com/office/drawing/2014/main" id="{30B2B55C-4305-4E94-9DBB-959FCE584C65}"/>
+                <a16:creationId xmlns:a16="http://schemas.microsoft.com/office/drawing/2014/main" id="{B376FA67-1857-432D-ACC8-936EE960F0FB}"/>
               </a:ext>
             </a:extLst>
           </p:cNvPr>
@@ -17984,7 +17984,7 @@
           <p:cNvPr id="15" name="TextBox 14">
             <a:extLst xmlns:a="http://schemas.openxmlformats.org/drawingml/2006/main">
               <a:ext uri="{FF2B5EF4-FFF2-40B4-BE49-F238E27FC236}">
-                <a16:creationId xmlns:a16="http://schemas.microsoft.com/office/drawing/2014/main" id="{14C1E4AE-F3B6-46A5-878B-55EAF9E1F579}"/>
+                <a16:creationId xmlns:a16="http://schemas.microsoft.com/office/drawing/2014/main" id="{7D499321-FA2B-4DCE-ADE3-2065C7BB680B}"/>
               </a:ext>
             </a:extLst>
           </p:cNvPr>
@@ -18031,7 +18031,7 @@
           <p:cNvPr id="16" name="Rounded Rectangle 15">
             <a:extLst xmlns:a="http://schemas.openxmlformats.org/drawingml/2006/main">
               <a:ext uri="{FF2B5EF4-FFF2-40B4-BE49-F238E27FC236}">
-                <a16:creationId xmlns:a16="http://schemas.microsoft.com/office/drawing/2014/main" id="{6FACF75E-2D7F-484E-87D6-740C19A350C6}"/>
+                <a16:creationId xmlns:a16="http://schemas.microsoft.com/office/drawing/2014/main" id="{A8699E44-32A7-4529-B0A6-8E0BC9C43539}"/>
               </a:ext>
             </a:extLst>
           </p:cNvPr>
@@ -18088,7 +18088,7 @@
           <p:cNvPr id="17" name="TextBox 16">
             <a:extLst xmlns:a="http://schemas.openxmlformats.org/drawingml/2006/main">
               <a:ext uri="{FF2B5EF4-FFF2-40B4-BE49-F238E27FC236}">
-                <a16:creationId xmlns:a16="http://schemas.microsoft.com/office/drawing/2014/main" id="{04DB9590-44C1-4367-8A5C-AFBE49068048}"/>
+                <a16:creationId xmlns:a16="http://schemas.microsoft.com/office/drawing/2014/main" id="{5DB910FA-AA57-4370-A581-CD1481DF6191}"/>
               </a:ext>
             </a:extLst>
           </p:cNvPr>
@@ -18135,7 +18135,7 @@
           <p:cNvPr id="18" name="TextBox 17">
             <a:extLst xmlns:a="http://schemas.openxmlformats.org/drawingml/2006/main">
               <a:ext uri="{FF2B5EF4-FFF2-40B4-BE49-F238E27FC236}">
-                <a16:creationId xmlns:a16="http://schemas.microsoft.com/office/drawing/2014/main" id="{D85E8ADA-D270-4D49-B45E-0FA23B225E2D}"/>
+                <a16:creationId xmlns:a16="http://schemas.microsoft.com/office/drawing/2014/main" id="{176DF20C-6F56-4985-9484-8800898C88AF}"/>
               </a:ext>
             </a:extLst>
           </p:cNvPr>
@@ -18182,7 +18182,7 @@
           <p:cNvPr id="19" name="TextBox 18">
             <a:extLst xmlns:a="http://schemas.openxmlformats.org/drawingml/2006/main">
               <a:ext uri="{FF2B5EF4-FFF2-40B4-BE49-F238E27FC236}">
-                <a16:creationId xmlns:a16="http://schemas.microsoft.com/office/drawing/2014/main" id="{80945F0A-EEF8-4830-ACD8-03453BD0734E}"/>
+                <a16:creationId xmlns:a16="http://schemas.microsoft.com/office/drawing/2014/main" id="{764F0B18-FC3D-4FC5-B48E-8654965CDA17}"/>
               </a:ext>
             </a:extLst>
           </p:cNvPr>
@@ -18229,7 +18229,7 @@
           <p:cNvPr id="20" name="Rounded Rectangle 19">
             <a:extLst xmlns:a="http://schemas.openxmlformats.org/drawingml/2006/main">
               <a:ext uri="{FF2B5EF4-FFF2-40B4-BE49-F238E27FC236}">
-                <a16:creationId xmlns:a16="http://schemas.microsoft.com/office/drawing/2014/main" id="{5D08EDA8-60BF-4EBC-B09C-C3D5C9F5D914}"/>
+                <a16:creationId xmlns:a16="http://schemas.microsoft.com/office/drawing/2014/main" id="{CBE86464-093D-4D0C-A4C7-9DCB2D171136}"/>
               </a:ext>
             </a:extLst>
           </p:cNvPr>
@@ -18286,7 +18286,7 @@
           <p:cNvPr id="21" name="TextBox 20">
             <a:extLst xmlns:a="http://schemas.openxmlformats.org/drawingml/2006/main">
               <a:ext uri="{FF2B5EF4-FFF2-40B4-BE49-F238E27FC236}">
-                <a16:creationId xmlns:a16="http://schemas.microsoft.com/office/drawing/2014/main" id="{DAECC3DD-1133-4CF4-AEE0-9E65949F4AA3}"/>
+                <a16:creationId xmlns:a16="http://schemas.microsoft.com/office/drawing/2014/main" id="{AF93A089-B018-4D70-BDC6-B569368DC60F}"/>
               </a:ext>
             </a:extLst>
           </p:cNvPr>
@@ -18333,7 +18333,7 @@
           <p:cNvPr id="22" name="TextBox 21">
             <a:extLst xmlns:a="http://schemas.openxmlformats.org/drawingml/2006/main">
               <a:ext uri="{FF2B5EF4-FFF2-40B4-BE49-F238E27FC236}">
-                <a16:creationId xmlns:a16="http://schemas.microsoft.com/office/drawing/2014/main" id="{A0B2A25E-EAEC-4A69-9B64-A18E54EB1898}"/>
+                <a16:creationId xmlns:a16="http://schemas.microsoft.com/office/drawing/2014/main" id="{054C6445-BB9D-418B-A8FC-D5547D025E9A}"/>
               </a:ext>
             </a:extLst>
           </p:cNvPr>
@@ -18380,7 +18380,7 @@
           <p:cNvPr id="23" name="TextBox 22">
             <a:extLst xmlns:a="http://schemas.openxmlformats.org/drawingml/2006/main">
               <a:ext uri="{FF2B5EF4-FFF2-40B4-BE49-F238E27FC236}">
-                <a16:creationId xmlns:a16="http://schemas.microsoft.com/office/drawing/2014/main" id="{CBE75048-1AEF-4F21-AB31-E24CBC885EF3}"/>
+                <a16:creationId xmlns:a16="http://schemas.microsoft.com/office/drawing/2014/main" id="{3DD56F03-3095-43F6-8C7F-C59B6AEEFE7F}"/>
               </a:ext>
             </a:extLst>
           </p:cNvPr>
@@ -18427,7 +18427,7 @@
           <p:cNvPr id="24" name="TextBox 23">
             <a:extLst xmlns:a="http://schemas.openxmlformats.org/drawingml/2006/main">
               <a:ext uri="{FF2B5EF4-FFF2-40B4-BE49-F238E27FC236}">
-                <a16:creationId xmlns:a16="http://schemas.microsoft.com/office/drawing/2014/main" id="{E86343C4-44CB-48EE-80E4-8EF15DBD04C1}"/>
+                <a16:creationId xmlns:a16="http://schemas.microsoft.com/office/drawing/2014/main" id="{8266854E-13C0-45E8-96F6-141BF39888E9}"/>
               </a:ext>
             </a:extLst>
           </p:cNvPr>
@@ -18472,7 +18472,7 @@
     </p:spTree>
     <p:extLst>
       <p:ext uri="{BB962C8B-B14F-4D97-AF65-F5344CB8AC3E}">
-        <p14:creationId xmlns:p14="http://schemas.microsoft.com/office/powerpoint/2010/main" val="1649455411"/>
+        <p14:creationId xmlns:p14="http://schemas.microsoft.com/office/powerpoint/2010/main" val="1618779236"/>
       </p:ext>
     </p:extLst>
   </p:cSld>
@@ -18496,7 +18496,7 @@
           <p:cNvPr id="2" name="TextBox 1">
             <a:extLst xmlns:a="http://schemas.openxmlformats.org/drawingml/2006/main">
               <a:ext uri="{FF2B5EF4-FFF2-40B4-BE49-F238E27FC236}">
-                <a16:creationId xmlns:a16="http://schemas.microsoft.com/office/drawing/2014/main" id="{A5BF5998-69EC-42BD-9C53-A9E8166BEB94}"/>
+                <a16:creationId xmlns:a16="http://schemas.microsoft.com/office/drawing/2014/main" id="{F3FA05E2-34AC-4120-8789-63211D275110}"/>
               </a:ext>
             </a:extLst>
           </p:cNvPr>
@@ -18543,7 +18543,7 @@
           <p:cNvPr id="3" name="TextBox 2">
             <a:extLst xmlns:a="http://schemas.openxmlformats.org/drawingml/2006/main">
               <a:ext uri="{FF2B5EF4-FFF2-40B4-BE49-F238E27FC236}">
-                <a16:creationId xmlns:a16="http://schemas.microsoft.com/office/drawing/2014/main" id="{AFFDAB4B-6746-46D0-BC69-31944F6CC57E}"/>
+                <a16:creationId xmlns:a16="http://schemas.microsoft.com/office/drawing/2014/main" id="{6728B526-D576-4F85-88FF-A79DA4443155}"/>
               </a:ext>
             </a:extLst>
           </p:cNvPr>
@@ -18590,7 +18590,7 @@
           <p:cNvPr id="4" name="Rectangle 3">
             <a:extLst xmlns:a="http://schemas.openxmlformats.org/drawingml/2006/main">
               <a:ext uri="{FF2B5EF4-FFF2-40B4-BE49-F238E27FC236}">
-                <a16:creationId xmlns:a16="http://schemas.microsoft.com/office/drawing/2014/main" id="{A1E7F893-C6A3-4356-9E95-866936AEC2BA}"/>
+                <a16:creationId xmlns:a16="http://schemas.microsoft.com/office/drawing/2014/main" id="{F5235EAC-BED1-4844-AACB-0A3D01525A5A}"/>
               </a:ext>
             </a:extLst>
           </p:cNvPr>
@@ -18645,7 +18645,7 @@
           <p:cNvPr id="5" name="Rectangle 4">
             <a:extLst xmlns:a="http://schemas.openxmlformats.org/drawingml/2006/main">
               <a:ext uri="{FF2B5EF4-FFF2-40B4-BE49-F238E27FC236}">
-                <a16:creationId xmlns:a16="http://schemas.microsoft.com/office/drawing/2014/main" id="{2E70412B-C134-463D-B50C-2BA465ED265F}"/>
+                <a16:creationId xmlns:a16="http://schemas.microsoft.com/office/drawing/2014/main" id="{A35813C8-2718-4884-98BC-CB085161834E}"/>
               </a:ext>
             </a:extLst>
           </p:cNvPr>
@@ -18700,7 +18700,7 @@
           <p:cNvPr id="6" name="TextBox 5">
             <a:extLst xmlns:a="http://schemas.openxmlformats.org/drawingml/2006/main">
               <a:ext uri="{FF2B5EF4-FFF2-40B4-BE49-F238E27FC236}">
-                <a16:creationId xmlns:a16="http://schemas.microsoft.com/office/drawing/2014/main" id="{93B3F963-45E5-40CF-8803-439BBAEA19BA}"/>
+                <a16:creationId xmlns:a16="http://schemas.microsoft.com/office/drawing/2014/main" id="{D795F483-BD90-41B7-83A8-0A7FD2107DBB}"/>
               </a:ext>
             </a:extLst>
           </p:cNvPr>
@@ -18737,7 +18737,7 @@
                 <a:ea typeface="Aptos"/>
                 <a:cs typeface="Aptos"/>
               </a:rPr>
-              <a:t>Independent public evidence summary · 2026.07.23-11 · 2026-07-22 · Sources: WIPO dispute resolution; EPO IPscore</a:t>
+              <a:t>Independent public evidence summary · 2026.07.23-12 · 2026-07-22 · Sources: WIPO dispute resolution; EPO IPscore</a:t>
             </a:r>
           </a:p>
         </p:txBody>
@@ -18747,7 +18747,7 @@
           <p:cNvPr id="7" name="TextBox 6">
             <a:extLst xmlns:a="http://schemas.openxmlformats.org/drawingml/2006/main">
               <a:ext uri="{FF2B5EF4-FFF2-40B4-BE49-F238E27FC236}">
-                <a16:creationId xmlns:a16="http://schemas.microsoft.com/office/drawing/2014/main" id="{B2D5AD75-BADA-487D-9F5E-1B8F1CA6AFD3}"/>
+                <a16:creationId xmlns:a16="http://schemas.microsoft.com/office/drawing/2014/main" id="{66A7D840-6F6F-4DAF-B29A-C1CA8D934E7F}"/>
               </a:ext>
             </a:extLst>
           </p:cNvPr>
@@ -18794,7 +18794,7 @@
           <p:cNvPr id="8" name="Rounded Rectangle 7">
             <a:extLst xmlns:a="http://schemas.openxmlformats.org/drawingml/2006/main">
               <a:ext uri="{FF2B5EF4-FFF2-40B4-BE49-F238E27FC236}">
-                <a16:creationId xmlns:a16="http://schemas.microsoft.com/office/drawing/2014/main" id="{8F0FE76D-4C78-415B-AF8F-32CAC05E3E70}"/>
+                <a16:creationId xmlns:a16="http://schemas.microsoft.com/office/drawing/2014/main" id="{62876B88-6D3F-4CA7-8252-5371026CCC03}"/>
               </a:ext>
             </a:extLst>
           </p:cNvPr>
@@ -18851,7 +18851,7 @@
           <p:cNvPr id="9" name="TextBox 8">
             <a:extLst xmlns:a="http://schemas.openxmlformats.org/drawingml/2006/main">
               <a:ext uri="{FF2B5EF4-FFF2-40B4-BE49-F238E27FC236}">
-                <a16:creationId xmlns:a16="http://schemas.microsoft.com/office/drawing/2014/main" id="{F3E6ED80-7EE6-49B2-8777-21256A14CE97}"/>
+                <a16:creationId xmlns:a16="http://schemas.microsoft.com/office/drawing/2014/main" id="{89699BA5-5D46-4AAE-8B31-8D2ABD21694E}"/>
               </a:ext>
             </a:extLst>
           </p:cNvPr>
@@ -18898,7 +18898,7 @@
           <p:cNvPr id="10" name="TextBox 9">
             <a:extLst xmlns:a="http://schemas.openxmlformats.org/drawingml/2006/main">
               <a:ext uri="{FF2B5EF4-FFF2-40B4-BE49-F238E27FC236}">
-                <a16:creationId xmlns:a16="http://schemas.microsoft.com/office/drawing/2014/main" id="{386C0729-F45C-49C1-8808-3202BF2463B6}"/>
+                <a16:creationId xmlns:a16="http://schemas.microsoft.com/office/drawing/2014/main" id="{1DCA6FE7-476A-41D5-9F63-DAA99E2DBE83}"/>
               </a:ext>
             </a:extLst>
           </p:cNvPr>
@@ -18945,7 +18945,7 @@
           <p:cNvPr id="11" name="TextBox 10">
             <a:extLst xmlns:a="http://schemas.openxmlformats.org/drawingml/2006/main">
               <a:ext uri="{FF2B5EF4-FFF2-40B4-BE49-F238E27FC236}">
-                <a16:creationId xmlns:a16="http://schemas.microsoft.com/office/drawing/2014/main" id="{E8922FD6-3820-4D94-9653-F43A5E0808A3}"/>
+                <a16:creationId xmlns:a16="http://schemas.microsoft.com/office/drawing/2014/main" id="{21444643-1AFC-4077-B388-5BE902D00052}"/>
               </a:ext>
             </a:extLst>
           </p:cNvPr>
@@ -18992,7 +18992,7 @@
           <p:cNvPr id="12" name="Rounded Rectangle 11">
             <a:extLst xmlns:a="http://schemas.openxmlformats.org/drawingml/2006/main">
               <a:ext uri="{FF2B5EF4-FFF2-40B4-BE49-F238E27FC236}">
-                <a16:creationId xmlns:a16="http://schemas.microsoft.com/office/drawing/2014/main" id="{A82C83F7-6610-4C54-95DE-D04B1529C896}"/>
+                <a16:creationId xmlns:a16="http://schemas.microsoft.com/office/drawing/2014/main" id="{185B4286-A9AE-4580-9355-30D539DF1777}"/>
               </a:ext>
             </a:extLst>
           </p:cNvPr>
@@ -19049,7 +19049,7 @@
           <p:cNvPr id="13" name="TextBox 12">
             <a:extLst xmlns:a="http://schemas.openxmlformats.org/drawingml/2006/main">
               <a:ext uri="{FF2B5EF4-FFF2-40B4-BE49-F238E27FC236}">
-                <a16:creationId xmlns:a16="http://schemas.microsoft.com/office/drawing/2014/main" id="{258B88D9-39C8-4B84-A37D-326EF456B588}"/>
+                <a16:creationId xmlns:a16="http://schemas.microsoft.com/office/drawing/2014/main" id="{6721B431-6BB5-4E4D-B1E7-FEAAFB0250EF}"/>
               </a:ext>
             </a:extLst>
           </p:cNvPr>
@@ -19096,7 +19096,7 @@
           <p:cNvPr id="14" name="TextBox 13">
             <a:extLst xmlns:a="http://schemas.openxmlformats.org/drawingml/2006/main">
               <a:ext uri="{FF2B5EF4-FFF2-40B4-BE49-F238E27FC236}">
-                <a16:creationId xmlns:a16="http://schemas.microsoft.com/office/drawing/2014/main" id="{59BD6CFB-0BF2-4149-9AB4-65596259FD74}"/>
+                <a16:creationId xmlns:a16="http://schemas.microsoft.com/office/drawing/2014/main" id="{38A08721-C9DB-491A-AC5A-CCE4FCA2EF41}"/>
               </a:ext>
             </a:extLst>
           </p:cNvPr>
@@ -19143,7 +19143,7 @@
           <p:cNvPr id="15" name="TextBox 14">
             <a:extLst xmlns:a="http://schemas.openxmlformats.org/drawingml/2006/main">
               <a:ext uri="{FF2B5EF4-FFF2-40B4-BE49-F238E27FC236}">
-                <a16:creationId xmlns:a16="http://schemas.microsoft.com/office/drawing/2014/main" id="{C58E5FF1-7AAA-469B-91D2-BE8A64637861}"/>
+                <a16:creationId xmlns:a16="http://schemas.microsoft.com/office/drawing/2014/main" id="{4BEF2FD2-1841-466D-8B09-2290D0B0C8E3}"/>
               </a:ext>
             </a:extLst>
           </p:cNvPr>
@@ -19190,7 +19190,7 @@
           <p:cNvPr id="16" name="Rounded Rectangle 15">
             <a:extLst xmlns:a="http://schemas.openxmlformats.org/drawingml/2006/main">
               <a:ext uri="{FF2B5EF4-FFF2-40B4-BE49-F238E27FC236}">
-                <a16:creationId xmlns:a16="http://schemas.microsoft.com/office/drawing/2014/main" id="{7FDACEDD-FD3F-4A0E-ACE0-14B1BE7088CF}"/>
+                <a16:creationId xmlns:a16="http://schemas.microsoft.com/office/drawing/2014/main" id="{83BEB343-83B2-4E5B-BBC8-B3A6D4860608}"/>
               </a:ext>
             </a:extLst>
           </p:cNvPr>
@@ -19247,7 +19247,7 @@
           <p:cNvPr id="17" name="TextBox 16">
             <a:extLst xmlns:a="http://schemas.openxmlformats.org/drawingml/2006/main">
               <a:ext uri="{FF2B5EF4-FFF2-40B4-BE49-F238E27FC236}">
-                <a16:creationId xmlns:a16="http://schemas.microsoft.com/office/drawing/2014/main" id="{0EC195A9-E388-4365-9D7D-9DDDF9DC8B39}"/>
+                <a16:creationId xmlns:a16="http://schemas.microsoft.com/office/drawing/2014/main" id="{36EE91EB-4632-496D-AF0D-A7DC78BE8F0F}"/>
               </a:ext>
             </a:extLst>
           </p:cNvPr>
@@ -19294,7 +19294,7 @@
           <p:cNvPr id="18" name="TextBox 17">
             <a:extLst xmlns:a="http://schemas.openxmlformats.org/drawingml/2006/main">
               <a:ext uri="{FF2B5EF4-FFF2-40B4-BE49-F238E27FC236}">
-                <a16:creationId xmlns:a16="http://schemas.microsoft.com/office/drawing/2014/main" id="{8A6493FD-2BE8-4527-8F18-00B016C567F9}"/>
+                <a16:creationId xmlns:a16="http://schemas.microsoft.com/office/drawing/2014/main" id="{2D2E2A82-A2D2-4FDB-92BB-E64F8CAC31B1}"/>
               </a:ext>
             </a:extLst>
           </p:cNvPr>
@@ -19341,7 +19341,7 @@
           <p:cNvPr id="19" name="TextBox 18">
             <a:extLst xmlns:a="http://schemas.openxmlformats.org/drawingml/2006/main">
               <a:ext uri="{FF2B5EF4-FFF2-40B4-BE49-F238E27FC236}">
-                <a16:creationId xmlns:a16="http://schemas.microsoft.com/office/drawing/2014/main" id="{03BF5AF3-9048-4570-943F-C59A1EF12246}"/>
+                <a16:creationId xmlns:a16="http://schemas.microsoft.com/office/drawing/2014/main" id="{2C18D024-1E8F-41EA-9E7F-D1045742BA08}"/>
               </a:ext>
             </a:extLst>
           </p:cNvPr>
@@ -19388,7 +19388,7 @@
           <p:cNvPr id="20" name="Rounded Rectangle 19">
             <a:extLst xmlns:a="http://schemas.openxmlformats.org/drawingml/2006/main">
               <a:ext uri="{FF2B5EF4-FFF2-40B4-BE49-F238E27FC236}">
-                <a16:creationId xmlns:a16="http://schemas.microsoft.com/office/drawing/2014/main" id="{6C712A78-2E4A-4066-89DB-60DBBA360966}"/>
+                <a16:creationId xmlns:a16="http://schemas.microsoft.com/office/drawing/2014/main" id="{370F10F0-73B0-4F88-B5A8-9819586A56E8}"/>
               </a:ext>
             </a:extLst>
           </p:cNvPr>
@@ -19445,7 +19445,7 @@
           <p:cNvPr id="21" name="TextBox 20">
             <a:extLst xmlns:a="http://schemas.openxmlformats.org/drawingml/2006/main">
               <a:ext uri="{FF2B5EF4-FFF2-40B4-BE49-F238E27FC236}">
-                <a16:creationId xmlns:a16="http://schemas.microsoft.com/office/drawing/2014/main" id="{43232C10-380A-452A-A88A-32A5FD630D15}"/>
+                <a16:creationId xmlns:a16="http://schemas.microsoft.com/office/drawing/2014/main" id="{C5C5D78F-38B9-406E-84A0-AFA4593593E0}"/>
               </a:ext>
             </a:extLst>
           </p:cNvPr>
@@ -19492,7 +19492,7 @@
           <p:cNvPr id="22" name="TextBox 21">
             <a:extLst xmlns:a="http://schemas.openxmlformats.org/drawingml/2006/main">
               <a:ext uri="{FF2B5EF4-FFF2-40B4-BE49-F238E27FC236}">
-                <a16:creationId xmlns:a16="http://schemas.microsoft.com/office/drawing/2014/main" id="{A850EA52-6233-4FD3-982D-F540FC49A6BD}"/>
+                <a16:creationId xmlns:a16="http://schemas.microsoft.com/office/drawing/2014/main" id="{909155C0-E258-4FE7-9C95-079EBC2025F0}"/>
               </a:ext>
             </a:extLst>
           </p:cNvPr>
@@ -19539,7 +19539,7 @@
           <p:cNvPr id="23" name="TextBox 22">
             <a:extLst xmlns:a="http://schemas.openxmlformats.org/drawingml/2006/main">
               <a:ext uri="{FF2B5EF4-FFF2-40B4-BE49-F238E27FC236}">
-                <a16:creationId xmlns:a16="http://schemas.microsoft.com/office/drawing/2014/main" id="{D57055E5-08AF-45C6-9A13-17E33EC285F9}"/>
+                <a16:creationId xmlns:a16="http://schemas.microsoft.com/office/drawing/2014/main" id="{165A8A09-80D3-484E-829B-4B536FE0F294}"/>
               </a:ext>
             </a:extLst>
           </p:cNvPr>
@@ -19586,7 +19586,7 @@
           <p:cNvPr id="24" name="TextBox 23">
             <a:extLst xmlns:a="http://schemas.openxmlformats.org/drawingml/2006/main">
               <a:ext uri="{FF2B5EF4-FFF2-40B4-BE49-F238E27FC236}">
-                <a16:creationId xmlns:a16="http://schemas.microsoft.com/office/drawing/2014/main" id="{0C091EDB-1F27-4F84-9D17-28117C7C62AD}"/>
+                <a16:creationId xmlns:a16="http://schemas.microsoft.com/office/drawing/2014/main" id="{2CB18381-6965-4DBB-A78D-A21E8CA11304}"/>
               </a:ext>
             </a:extLst>
           </p:cNvPr>
@@ -19631,7 +19631,7 @@
     </p:spTree>
     <p:extLst>
       <p:ext uri="{BB962C8B-B14F-4D97-AF65-F5344CB8AC3E}">
-        <p14:creationId xmlns:p14="http://schemas.microsoft.com/office/powerpoint/2010/main" val="1744314089"/>
+        <p14:creationId xmlns:p14="http://schemas.microsoft.com/office/powerpoint/2010/main" val="170407320"/>
       </p:ext>
     </p:extLst>
   </p:cSld>
@@ -19655,7 +19655,7 @@
           <p:cNvPr id="2" name="TextBox 1">
             <a:extLst xmlns:a="http://schemas.openxmlformats.org/drawingml/2006/main">
               <a:ext uri="{FF2B5EF4-FFF2-40B4-BE49-F238E27FC236}">
-                <a16:creationId xmlns:a16="http://schemas.microsoft.com/office/drawing/2014/main" id="{2797708C-94FE-4670-8BF2-5D3D6EA75C9C}"/>
+                <a16:creationId xmlns:a16="http://schemas.microsoft.com/office/drawing/2014/main" id="{C9E41D6F-9030-449C-B3A5-27184F5F86FA}"/>
               </a:ext>
             </a:extLst>
           </p:cNvPr>
@@ -19702,7 +19702,7 @@
           <p:cNvPr id="3" name="TextBox 2">
             <a:extLst xmlns:a="http://schemas.openxmlformats.org/drawingml/2006/main">
               <a:ext uri="{FF2B5EF4-FFF2-40B4-BE49-F238E27FC236}">
-                <a16:creationId xmlns:a16="http://schemas.microsoft.com/office/drawing/2014/main" id="{DA8F015D-22CF-4306-81A0-6900B87601C6}"/>
+                <a16:creationId xmlns:a16="http://schemas.microsoft.com/office/drawing/2014/main" id="{148C18CE-544B-4FD8-BCE0-D0B8C0962140}"/>
               </a:ext>
             </a:extLst>
           </p:cNvPr>
@@ -19749,7 +19749,7 @@
           <p:cNvPr id="4" name="Rectangle 3">
             <a:extLst xmlns:a="http://schemas.openxmlformats.org/drawingml/2006/main">
               <a:ext uri="{FF2B5EF4-FFF2-40B4-BE49-F238E27FC236}">
-                <a16:creationId xmlns:a16="http://schemas.microsoft.com/office/drawing/2014/main" id="{1904A954-FA42-4077-97D1-1D287ABB99D3}"/>
+                <a16:creationId xmlns:a16="http://schemas.microsoft.com/office/drawing/2014/main" id="{F6A56ADF-C8C4-4080-B09F-8481964A06CD}"/>
               </a:ext>
             </a:extLst>
           </p:cNvPr>
@@ -19804,7 +19804,7 @@
           <p:cNvPr id="5" name="Rectangle 4">
             <a:extLst xmlns:a="http://schemas.openxmlformats.org/drawingml/2006/main">
               <a:ext uri="{FF2B5EF4-FFF2-40B4-BE49-F238E27FC236}">
-                <a16:creationId xmlns:a16="http://schemas.microsoft.com/office/drawing/2014/main" id="{854D26FC-04CD-4F33-A774-EC8B2362EAFA}"/>
+                <a16:creationId xmlns:a16="http://schemas.microsoft.com/office/drawing/2014/main" id="{3D89AD4D-DADD-41EB-8D5F-C4B000DA2EB2}"/>
               </a:ext>
             </a:extLst>
           </p:cNvPr>
@@ -19859,7 +19859,7 @@
           <p:cNvPr id="6" name="TextBox 5">
             <a:extLst xmlns:a="http://schemas.openxmlformats.org/drawingml/2006/main">
               <a:ext uri="{FF2B5EF4-FFF2-40B4-BE49-F238E27FC236}">
-                <a16:creationId xmlns:a16="http://schemas.microsoft.com/office/drawing/2014/main" id="{5860C676-9A68-4BC2-9B0E-CB4D10C9FBD3}"/>
+                <a16:creationId xmlns:a16="http://schemas.microsoft.com/office/drawing/2014/main" id="{61DA28CF-91A7-422D-B63B-C35833594985}"/>
               </a:ext>
             </a:extLst>
           </p:cNvPr>
@@ -19896,7 +19896,7 @@
                 <a:ea typeface="Aptos"/>
                 <a:cs typeface="Aptos"/>
               </a:rPr>
-              <a:t>Independent public evidence summary · 2026.07.23-11 · 2026-07-22 · Sources: WIPO licensing; IP Finance; TPLF mapping</a:t>
+              <a:t>Independent public evidence summary · 2026.07.23-12 · 2026-07-22 · Sources: WIPO licensing; IP Finance; TPLF mapping</a:t>
             </a:r>
           </a:p>
         </p:txBody>
@@ -19906,7 +19906,7 @@
           <p:cNvPr id="7" name="TextBox 6">
             <a:extLst xmlns:a="http://schemas.openxmlformats.org/drawingml/2006/main">
               <a:ext uri="{FF2B5EF4-FFF2-40B4-BE49-F238E27FC236}">
-                <a16:creationId xmlns:a16="http://schemas.microsoft.com/office/drawing/2014/main" id="{FD7AE657-A59D-43D1-A88E-4E9802213668}"/>
+                <a16:creationId xmlns:a16="http://schemas.microsoft.com/office/drawing/2014/main" id="{3C155A70-66A0-473E-8AD9-5C1BB97E5CE4}"/>
               </a:ext>
             </a:extLst>
           </p:cNvPr>
@@ -20476,7 +20476,7 @@
           <p:cNvPr id="9" name="TextBox 8">
             <a:extLst xmlns:a="http://schemas.openxmlformats.org/drawingml/2006/main">
               <a:ext uri="{FF2B5EF4-FFF2-40B4-BE49-F238E27FC236}">
-                <a16:creationId xmlns:a16="http://schemas.microsoft.com/office/drawing/2014/main" id="{E183CBA7-6FB9-4B7D-B0CB-3943CD8816C8}"/>
+                <a16:creationId xmlns:a16="http://schemas.microsoft.com/office/drawing/2014/main" id="{8CC44935-4557-4037-A0D1-78548C455420}"/>
               </a:ext>
             </a:extLst>
           </p:cNvPr>
@@ -20521,7 +20521,7 @@
     </p:spTree>
     <p:extLst>
       <p:ext uri="{BB962C8B-B14F-4D97-AF65-F5344CB8AC3E}">
-        <p14:creationId xmlns:p14="http://schemas.microsoft.com/office/powerpoint/2010/main" val="1153751682"/>
+        <p14:creationId xmlns:p14="http://schemas.microsoft.com/office/powerpoint/2010/main" val="193986243"/>
       </p:ext>
     </p:extLst>
   </p:cSld>
@@ -20545,7 +20545,7 @@
           <p:cNvPr id="2" name="TextBox 1">
             <a:extLst xmlns:a="http://schemas.openxmlformats.org/drawingml/2006/main">
               <a:ext uri="{FF2B5EF4-FFF2-40B4-BE49-F238E27FC236}">
-                <a16:creationId xmlns:a16="http://schemas.microsoft.com/office/drawing/2014/main" id="{617ED85A-A40A-40BA-9706-43F576690BA9}"/>
+                <a16:creationId xmlns:a16="http://schemas.microsoft.com/office/drawing/2014/main" id="{CFA6AB8D-668B-4BB9-9EE9-FE8F7261A5AD}"/>
               </a:ext>
             </a:extLst>
           </p:cNvPr>
@@ -20592,7 +20592,7 @@
           <p:cNvPr id="3" name="TextBox 2">
             <a:extLst xmlns:a="http://schemas.openxmlformats.org/drawingml/2006/main">
               <a:ext uri="{FF2B5EF4-FFF2-40B4-BE49-F238E27FC236}">
-                <a16:creationId xmlns:a16="http://schemas.microsoft.com/office/drawing/2014/main" id="{00383E63-939D-4C0B-B056-B97FD5F528FF}"/>
+                <a16:creationId xmlns:a16="http://schemas.microsoft.com/office/drawing/2014/main" id="{0496B9AD-2034-41E2-988A-AD3055B866C7}"/>
               </a:ext>
             </a:extLst>
           </p:cNvPr>
@@ -20639,7 +20639,7 @@
           <p:cNvPr id="4" name="Rectangle 3">
             <a:extLst xmlns:a="http://schemas.openxmlformats.org/drawingml/2006/main">
               <a:ext uri="{FF2B5EF4-FFF2-40B4-BE49-F238E27FC236}">
-                <a16:creationId xmlns:a16="http://schemas.microsoft.com/office/drawing/2014/main" id="{968B7D54-7165-4E54-8CAA-89445CF8D701}"/>
+                <a16:creationId xmlns:a16="http://schemas.microsoft.com/office/drawing/2014/main" id="{23BDF581-0838-40C1-804F-13A5CDBD6A12}"/>
               </a:ext>
             </a:extLst>
           </p:cNvPr>
@@ -20694,7 +20694,7 @@
           <p:cNvPr id="5" name="Rectangle 4">
             <a:extLst xmlns:a="http://schemas.openxmlformats.org/drawingml/2006/main">
               <a:ext uri="{FF2B5EF4-FFF2-40B4-BE49-F238E27FC236}">
-                <a16:creationId xmlns:a16="http://schemas.microsoft.com/office/drawing/2014/main" id="{4AB61D7C-8DA7-4488-A87A-1B704239D94A}"/>
+                <a16:creationId xmlns:a16="http://schemas.microsoft.com/office/drawing/2014/main" id="{7310B86D-BBF8-4957-9E19-593CB0501C66}"/>
               </a:ext>
             </a:extLst>
           </p:cNvPr>
@@ -20749,7 +20749,7 @@
           <p:cNvPr id="6" name="TextBox 5">
             <a:extLst xmlns:a="http://schemas.openxmlformats.org/drawingml/2006/main">
               <a:ext uri="{FF2B5EF4-FFF2-40B4-BE49-F238E27FC236}">
-                <a16:creationId xmlns:a16="http://schemas.microsoft.com/office/drawing/2014/main" id="{BBDCCB06-8650-47CE-A5EA-B1266785C064}"/>
+                <a16:creationId xmlns:a16="http://schemas.microsoft.com/office/drawing/2014/main" id="{860A9407-1E61-4192-A55D-C7315570BB72}"/>
               </a:ext>
             </a:extLst>
           </p:cNvPr>
@@ -20786,7 +20786,7 @@
                 <a:ea typeface="Aptos"/>
                 <a:cs typeface="Aptos"/>
               </a:rPr>
-              <a:t>Independent public evidence summary · 2026.07.23-11 · 2026-07-22 · Sources: Evidence Register; WIPO valuation</a:t>
+              <a:t>Independent public evidence summary · 2026.07.23-12 · 2026-07-22 · Sources: Evidence Register; WIPO valuation</a:t>
             </a:r>
           </a:p>
         </p:txBody>
@@ -20796,7 +20796,7 @@
           <p:cNvPr id="7" name="TextBox 6">
             <a:extLst xmlns:a="http://schemas.openxmlformats.org/drawingml/2006/main">
               <a:ext uri="{FF2B5EF4-FFF2-40B4-BE49-F238E27FC236}">
-                <a16:creationId xmlns:a16="http://schemas.microsoft.com/office/drawing/2014/main" id="{16F66114-1C3C-41CD-93A8-00DD8F783DC2}"/>
+                <a16:creationId xmlns:a16="http://schemas.microsoft.com/office/drawing/2014/main" id="{2B99F839-ACDA-4345-92D2-D6C3F5089B42}"/>
               </a:ext>
             </a:extLst>
           </p:cNvPr>
@@ -21449,7 +21449,7 @@
           <p:cNvPr id="9" name="TextBox 8">
             <a:extLst xmlns:a="http://schemas.openxmlformats.org/drawingml/2006/main">
               <a:ext uri="{FF2B5EF4-FFF2-40B4-BE49-F238E27FC236}">
-                <a16:creationId xmlns:a16="http://schemas.microsoft.com/office/drawing/2014/main" id="{406795A4-10DF-45E1-ACE8-71A131DEBDDA}"/>
+                <a16:creationId xmlns:a16="http://schemas.microsoft.com/office/drawing/2014/main" id="{4BF9C665-3AED-4966-AA4B-8DF6E3C9CE0A}"/>
               </a:ext>
             </a:extLst>
           </p:cNvPr>
@@ -21494,7 +21494,7 @@
     </p:spTree>
     <p:extLst>
       <p:ext uri="{BB962C8B-B14F-4D97-AF65-F5344CB8AC3E}">
-        <p14:creationId xmlns:p14="http://schemas.microsoft.com/office/powerpoint/2010/main" val="1895016102"/>
+        <p14:creationId xmlns:p14="http://schemas.microsoft.com/office/powerpoint/2010/main" val="1366395553"/>
       </p:ext>
     </p:extLst>
   </p:cSld>
@@ -21518,7 +21518,7 @@
           <p:cNvPr id="2" name="TextBox 1">
             <a:extLst xmlns:a="http://schemas.openxmlformats.org/drawingml/2006/main">
               <a:ext uri="{FF2B5EF4-FFF2-40B4-BE49-F238E27FC236}">
-                <a16:creationId xmlns:a16="http://schemas.microsoft.com/office/drawing/2014/main" id="{8EA5C04F-7DDE-474B-88C8-BCEFFF98C5D6}"/>
+                <a16:creationId xmlns:a16="http://schemas.microsoft.com/office/drawing/2014/main" id="{B40B6036-92D4-4102-80EA-F775288930C2}"/>
               </a:ext>
             </a:extLst>
           </p:cNvPr>
@@ -21565,7 +21565,7 @@
           <p:cNvPr id="3" name="TextBox 2">
             <a:extLst xmlns:a="http://schemas.openxmlformats.org/drawingml/2006/main">
               <a:ext uri="{FF2B5EF4-FFF2-40B4-BE49-F238E27FC236}">
-                <a16:creationId xmlns:a16="http://schemas.microsoft.com/office/drawing/2014/main" id="{9151A8BF-9F5F-4EDC-8657-A56ECEEEDF3E}"/>
+                <a16:creationId xmlns:a16="http://schemas.microsoft.com/office/drawing/2014/main" id="{BD5391C8-6590-4797-9B96-E6E95443B903}"/>
               </a:ext>
             </a:extLst>
           </p:cNvPr>
@@ -21612,7 +21612,7 @@
           <p:cNvPr id="4" name="Rectangle 3">
             <a:extLst xmlns:a="http://schemas.openxmlformats.org/drawingml/2006/main">
               <a:ext uri="{FF2B5EF4-FFF2-40B4-BE49-F238E27FC236}">
-                <a16:creationId xmlns:a16="http://schemas.microsoft.com/office/drawing/2014/main" id="{3EAD722E-65CA-4C61-9E63-42B35314EB48}"/>
+                <a16:creationId xmlns:a16="http://schemas.microsoft.com/office/drawing/2014/main" id="{EC251119-7C1D-4139-8429-5B45196389F4}"/>
               </a:ext>
             </a:extLst>
           </p:cNvPr>
@@ -21667,7 +21667,7 @@
           <p:cNvPr id="5" name="Rectangle 4">
             <a:extLst xmlns:a="http://schemas.openxmlformats.org/drawingml/2006/main">
               <a:ext uri="{FF2B5EF4-FFF2-40B4-BE49-F238E27FC236}">
-                <a16:creationId xmlns:a16="http://schemas.microsoft.com/office/drawing/2014/main" id="{F871CA43-FAE6-48F5-8AE5-3E562C9E08D9}"/>
+                <a16:creationId xmlns:a16="http://schemas.microsoft.com/office/drawing/2014/main" id="{905CF4C1-6D13-4282-AB65-0D7BDD876D57}"/>
               </a:ext>
             </a:extLst>
           </p:cNvPr>
@@ -21722,7 +21722,7 @@
           <p:cNvPr id="6" name="TextBox 5">
             <a:extLst xmlns:a="http://schemas.openxmlformats.org/drawingml/2006/main">
               <a:ext uri="{FF2B5EF4-FFF2-40B4-BE49-F238E27FC236}">
-                <a16:creationId xmlns:a16="http://schemas.microsoft.com/office/drawing/2014/main" id="{5B2A3152-1DFB-48A9-9CF8-F027155D6C5F}"/>
+                <a16:creationId xmlns:a16="http://schemas.microsoft.com/office/drawing/2014/main" id="{224CEF01-B741-44CF-82D3-6CF10697A23B}"/>
               </a:ext>
             </a:extLst>
           </p:cNvPr>
@@ -21759,7 +21759,7 @@
                 <a:ea typeface="Aptos"/>
                 <a:cs typeface="Aptos"/>
               </a:rPr>
-              <a:t>Independent public evidence summary · 2026.07.23-11 · 2026-07-22 · Sources: WIPO valuation</a:t>
+              <a:t>Independent public evidence summary · 2026.07.23-12 · 2026-07-22 · Sources: WIPO valuation</a:t>
             </a:r>
           </a:p>
         </p:txBody>
@@ -21769,7 +21769,7 @@
           <p:cNvPr id="7" name="TextBox 6">
             <a:extLst xmlns:a="http://schemas.openxmlformats.org/drawingml/2006/main">
               <a:ext uri="{FF2B5EF4-FFF2-40B4-BE49-F238E27FC236}">
-                <a16:creationId xmlns:a16="http://schemas.microsoft.com/office/drawing/2014/main" id="{9ED95BE0-160B-44C4-A47E-21FC4700D611}"/>
+                <a16:creationId xmlns:a16="http://schemas.microsoft.com/office/drawing/2014/main" id="{4845F46E-61D5-4ACA-B4D1-2170617D648D}"/>
               </a:ext>
             </a:extLst>
           </p:cNvPr>
@@ -22502,7 +22502,7 @@
           <p:cNvPr id="9" name="TextBox 8">
             <a:extLst xmlns:a="http://schemas.openxmlformats.org/drawingml/2006/main">
               <a:ext uri="{FF2B5EF4-FFF2-40B4-BE49-F238E27FC236}">
-                <a16:creationId xmlns:a16="http://schemas.microsoft.com/office/drawing/2014/main" id="{0361DA06-1ADC-4A0F-8A02-00D7732E05C5}"/>
+                <a16:creationId xmlns:a16="http://schemas.microsoft.com/office/drawing/2014/main" id="{62C1E2C2-3A73-4434-9095-ED1AE0AEBF99}"/>
               </a:ext>
             </a:extLst>
           </p:cNvPr>
@@ -22547,7 +22547,7 @@
     </p:spTree>
     <p:extLst>
       <p:ext uri="{BB962C8B-B14F-4D97-AF65-F5344CB8AC3E}">
-        <p14:creationId xmlns:p14="http://schemas.microsoft.com/office/powerpoint/2010/main" val="2123521684"/>
+        <p14:creationId xmlns:p14="http://schemas.microsoft.com/office/powerpoint/2010/main" val="1199786298"/>
       </p:ext>
     </p:extLst>
   </p:cSld>
@@ -22571,7 +22571,7 @@
           <p:cNvPr id="2" name="TextBox 1">
             <a:extLst xmlns:a="http://schemas.openxmlformats.org/drawingml/2006/main">
               <a:ext uri="{FF2B5EF4-FFF2-40B4-BE49-F238E27FC236}">
-                <a16:creationId xmlns:a16="http://schemas.microsoft.com/office/drawing/2014/main" id="{05A8E36D-7966-4BA5-AA85-143BC9F55B61}"/>
+                <a16:creationId xmlns:a16="http://schemas.microsoft.com/office/drawing/2014/main" id="{13C8281C-4C11-4D54-8201-FA7B1DA8EDFE}"/>
               </a:ext>
             </a:extLst>
           </p:cNvPr>
@@ -22618,7 +22618,7 @@
           <p:cNvPr id="3" name="TextBox 2">
             <a:extLst xmlns:a="http://schemas.openxmlformats.org/drawingml/2006/main">
               <a:ext uri="{FF2B5EF4-FFF2-40B4-BE49-F238E27FC236}">
-                <a16:creationId xmlns:a16="http://schemas.microsoft.com/office/drawing/2014/main" id="{2260F9A8-F408-4A3C-BF6E-42B0D2E4D72C}"/>
+                <a16:creationId xmlns:a16="http://schemas.microsoft.com/office/drawing/2014/main" id="{DD57748B-87F0-4934-8873-400BD71DBAD2}"/>
               </a:ext>
             </a:extLst>
           </p:cNvPr>
@@ -22665,7 +22665,7 @@
           <p:cNvPr id="4" name="Rectangle 3">
             <a:extLst xmlns:a="http://schemas.openxmlformats.org/drawingml/2006/main">
               <a:ext uri="{FF2B5EF4-FFF2-40B4-BE49-F238E27FC236}">
-                <a16:creationId xmlns:a16="http://schemas.microsoft.com/office/drawing/2014/main" id="{14936832-AE4E-4C61-9988-B62ED95D99C8}"/>
+                <a16:creationId xmlns:a16="http://schemas.microsoft.com/office/drawing/2014/main" id="{7DC2D3F2-9E0D-471D-ABB9-B47FA4E4F2D5}"/>
               </a:ext>
             </a:extLst>
           </p:cNvPr>
@@ -22720,7 +22720,7 @@
           <p:cNvPr id="5" name="Rectangle 4">
             <a:extLst xmlns:a="http://schemas.openxmlformats.org/drawingml/2006/main">
               <a:ext uri="{FF2B5EF4-FFF2-40B4-BE49-F238E27FC236}">
-                <a16:creationId xmlns:a16="http://schemas.microsoft.com/office/drawing/2014/main" id="{408A1DAC-FD42-4E9A-8657-B4753BE6484F}"/>
+                <a16:creationId xmlns:a16="http://schemas.microsoft.com/office/drawing/2014/main" id="{7729C8A2-E66A-424B-A2FA-F3233B0E3618}"/>
               </a:ext>
             </a:extLst>
           </p:cNvPr>
@@ -22775,7 +22775,7 @@
           <p:cNvPr id="6" name="TextBox 5">
             <a:extLst xmlns:a="http://schemas.openxmlformats.org/drawingml/2006/main">
               <a:ext uri="{FF2B5EF4-FFF2-40B4-BE49-F238E27FC236}">
-                <a16:creationId xmlns:a16="http://schemas.microsoft.com/office/drawing/2014/main" id="{FB90259C-A5C9-4D8D-86BC-1A36F0DBBA11}"/>
+                <a16:creationId xmlns:a16="http://schemas.microsoft.com/office/drawing/2014/main" id="{8FFA1D4D-9686-49DB-BA64-4BA77C5965D1}"/>
               </a:ext>
             </a:extLst>
           </p:cNvPr>
@@ -22812,7 +22812,7 @@
                 <a:ea typeface="Aptos"/>
                 <a:cs typeface="Aptos"/>
               </a:rPr>
-              <a:t>Independent public evidence summary · 2026.07.23-11 · 2026-07-22 · Sources: Evidence Register</a:t>
+              <a:t>Independent public evidence summary · 2026.07.23-12 · 2026-07-22 · Sources: Evidence Register</a:t>
             </a:r>
           </a:p>
         </p:txBody>
@@ -22822,7 +22822,7 @@
           <p:cNvPr id="7" name="TextBox 6">
             <a:extLst xmlns:a="http://schemas.openxmlformats.org/drawingml/2006/main">
               <a:ext uri="{FF2B5EF4-FFF2-40B4-BE49-F238E27FC236}">
-                <a16:creationId xmlns:a16="http://schemas.microsoft.com/office/drawing/2014/main" id="{73A052AA-EB64-4C55-B407-2292A4DC13FA}"/>
+                <a16:creationId xmlns:a16="http://schemas.microsoft.com/office/drawing/2014/main" id="{DF252368-E82B-4523-8D94-5E1862D4AFC7}"/>
               </a:ext>
             </a:extLst>
           </p:cNvPr>
@@ -23392,7 +23392,7 @@
           <p:cNvPr id="9" name="TextBox 8">
             <a:extLst xmlns:a="http://schemas.openxmlformats.org/drawingml/2006/main">
               <a:ext uri="{FF2B5EF4-FFF2-40B4-BE49-F238E27FC236}">
-                <a16:creationId xmlns:a16="http://schemas.microsoft.com/office/drawing/2014/main" id="{360ED1FA-7D74-47A3-B0BF-B853CD415B36}"/>
+                <a16:creationId xmlns:a16="http://schemas.microsoft.com/office/drawing/2014/main" id="{F362111B-1ECB-48FD-A1E3-B8B9B740046D}"/>
               </a:ext>
             </a:extLst>
           </p:cNvPr>
@@ -23437,7 +23437,7 @@
     </p:spTree>
     <p:extLst>
       <p:ext uri="{BB962C8B-B14F-4D97-AF65-F5344CB8AC3E}">
-        <p14:creationId xmlns:p14="http://schemas.microsoft.com/office/powerpoint/2010/main" val="598218843"/>
+        <p14:creationId xmlns:p14="http://schemas.microsoft.com/office/powerpoint/2010/main" val="184405048"/>
       </p:ext>
     </p:extLst>
   </p:cSld>
@@ -23461,7 +23461,7 @@
           <p:cNvPr id="2" name="TextBox 1">
             <a:extLst xmlns:a="http://schemas.openxmlformats.org/drawingml/2006/main">
               <a:ext uri="{FF2B5EF4-FFF2-40B4-BE49-F238E27FC236}">
-                <a16:creationId xmlns:a16="http://schemas.microsoft.com/office/drawing/2014/main" id="{8194FAA6-CDE9-437A-AD2D-CE53D72F739A}"/>
+                <a16:creationId xmlns:a16="http://schemas.microsoft.com/office/drawing/2014/main" id="{41915E1A-DBB8-4DAC-8E05-1F53611F2B0D}"/>
               </a:ext>
             </a:extLst>
           </p:cNvPr>
@@ -23508,7 +23508,7 @@
           <p:cNvPr id="3" name="TextBox 2">
             <a:extLst xmlns:a="http://schemas.openxmlformats.org/drawingml/2006/main">
               <a:ext uri="{FF2B5EF4-FFF2-40B4-BE49-F238E27FC236}">
-                <a16:creationId xmlns:a16="http://schemas.microsoft.com/office/drawing/2014/main" id="{5E4E969B-48EF-47E8-B3B3-C617465786F8}"/>
+                <a16:creationId xmlns:a16="http://schemas.microsoft.com/office/drawing/2014/main" id="{F7217DBE-22BD-4E6F-ADBE-3C19A8B168F7}"/>
               </a:ext>
             </a:extLst>
           </p:cNvPr>
@@ -23555,7 +23555,7 @@
           <p:cNvPr id="4" name="Rectangle 3">
             <a:extLst xmlns:a="http://schemas.openxmlformats.org/drawingml/2006/main">
               <a:ext uri="{FF2B5EF4-FFF2-40B4-BE49-F238E27FC236}">
-                <a16:creationId xmlns:a16="http://schemas.microsoft.com/office/drawing/2014/main" id="{A19E5853-8C19-4DD2-9201-A54773D5FF4E}"/>
+                <a16:creationId xmlns:a16="http://schemas.microsoft.com/office/drawing/2014/main" id="{82337E75-A5E0-4EC8-9943-BA4A70C1B8AC}"/>
               </a:ext>
             </a:extLst>
           </p:cNvPr>
@@ -23610,7 +23610,7 @@
           <p:cNvPr id="5" name="Rectangle 4">
             <a:extLst xmlns:a="http://schemas.openxmlformats.org/drawingml/2006/main">
               <a:ext uri="{FF2B5EF4-FFF2-40B4-BE49-F238E27FC236}">
-                <a16:creationId xmlns:a16="http://schemas.microsoft.com/office/drawing/2014/main" id="{F4490E17-BFC1-44F7-8A0B-68CAD50762EE}"/>
+                <a16:creationId xmlns:a16="http://schemas.microsoft.com/office/drawing/2014/main" id="{8668A4FE-FC81-4EAD-9542-327E9D7740AC}"/>
               </a:ext>
             </a:extLst>
           </p:cNvPr>
@@ -23665,7 +23665,7 @@
           <p:cNvPr id="6" name="TextBox 5">
             <a:extLst xmlns:a="http://schemas.openxmlformats.org/drawingml/2006/main">
               <a:ext uri="{FF2B5EF4-FFF2-40B4-BE49-F238E27FC236}">
-                <a16:creationId xmlns:a16="http://schemas.microsoft.com/office/drawing/2014/main" id="{26ACB488-9851-4B98-8E6F-30BAD92F2C78}"/>
+                <a16:creationId xmlns:a16="http://schemas.microsoft.com/office/drawing/2014/main" id="{BB054597-ADE6-4987-A7B0-F0ED7F1B2247}"/>
               </a:ext>
             </a:extLst>
           </p:cNvPr>
@@ -23702,7 +23702,7 @@
                 <a:ea typeface="Aptos"/>
                 <a:cs typeface="Aptos"/>
               </a:rPr>
-              <a:t>Independent public evidence summary · 2026.07.23-11 · 2026-07-22 · Sources: Evidence Register</a:t>
+              <a:t>Independent public evidence summary · 2026.07.23-12 · 2026-07-22 · Sources: Evidence Register</a:t>
             </a:r>
           </a:p>
         </p:txBody>
@@ -23712,7 +23712,7 @@
           <p:cNvPr id="7" name="TextBox 6">
             <a:extLst xmlns:a="http://schemas.openxmlformats.org/drawingml/2006/main">
               <a:ext uri="{FF2B5EF4-FFF2-40B4-BE49-F238E27FC236}">
-                <a16:creationId xmlns:a16="http://schemas.microsoft.com/office/drawing/2014/main" id="{A63AF13E-BB96-4067-A2C7-D04B8C49BAB7}"/>
+                <a16:creationId xmlns:a16="http://schemas.microsoft.com/office/drawing/2014/main" id="{2DAF343E-AB58-47C8-9CA6-AA33482F2608}"/>
               </a:ext>
             </a:extLst>
           </p:cNvPr>
@@ -24365,7 +24365,7 @@
           <p:cNvPr id="9" name="TextBox 8">
             <a:extLst xmlns:a="http://schemas.openxmlformats.org/drawingml/2006/main">
               <a:ext uri="{FF2B5EF4-FFF2-40B4-BE49-F238E27FC236}">
-                <a16:creationId xmlns:a16="http://schemas.microsoft.com/office/drawing/2014/main" id="{8D7D8610-6640-4EAB-A08E-0B9DC47C467F}"/>
+                <a16:creationId xmlns:a16="http://schemas.microsoft.com/office/drawing/2014/main" id="{BCD423B1-A063-4FB0-82D6-F827957DCA8E}"/>
               </a:ext>
             </a:extLst>
           </p:cNvPr>
@@ -24410,7 +24410,7 @@
     </p:spTree>
     <p:extLst>
       <p:ext uri="{BB962C8B-B14F-4D97-AF65-F5344CB8AC3E}">
-        <p14:creationId xmlns:p14="http://schemas.microsoft.com/office/powerpoint/2010/main" val="1832772191"/>
+        <p14:creationId xmlns:p14="http://schemas.microsoft.com/office/powerpoint/2010/main" val="1275388162"/>
       </p:ext>
     </p:extLst>
   </p:cSld>
@@ -24434,7 +24434,7 @@
           <p:cNvPr id="2" name="TextBox 1">
             <a:extLst xmlns:a="http://schemas.openxmlformats.org/drawingml/2006/main">
               <a:ext uri="{FF2B5EF4-FFF2-40B4-BE49-F238E27FC236}">
-                <a16:creationId xmlns:a16="http://schemas.microsoft.com/office/drawing/2014/main" id="{A59B6270-A65D-4008-86E8-0EE34DBC9704}"/>
+                <a16:creationId xmlns:a16="http://schemas.microsoft.com/office/drawing/2014/main" id="{E029EFBD-57BD-464E-9DF1-F1CB50C12D0E}"/>
               </a:ext>
             </a:extLst>
           </p:cNvPr>
@@ -24481,7 +24481,7 @@
           <p:cNvPr id="3" name="TextBox 2">
             <a:extLst xmlns:a="http://schemas.openxmlformats.org/drawingml/2006/main">
               <a:ext uri="{FF2B5EF4-FFF2-40B4-BE49-F238E27FC236}">
-                <a16:creationId xmlns:a16="http://schemas.microsoft.com/office/drawing/2014/main" id="{A80BBAA0-0473-4E5B-A7F9-88F055BD88BA}"/>
+                <a16:creationId xmlns:a16="http://schemas.microsoft.com/office/drawing/2014/main" id="{936F1C02-0C7A-4C38-83E0-6EAF6F98CB9E}"/>
               </a:ext>
             </a:extLst>
           </p:cNvPr>
@@ -24528,7 +24528,7 @@
           <p:cNvPr id="4" name="Rectangle 3">
             <a:extLst xmlns:a="http://schemas.openxmlformats.org/drawingml/2006/main">
               <a:ext uri="{FF2B5EF4-FFF2-40B4-BE49-F238E27FC236}">
-                <a16:creationId xmlns:a16="http://schemas.microsoft.com/office/drawing/2014/main" id="{E428E60E-8F56-4445-94B4-F111550B7568}"/>
+                <a16:creationId xmlns:a16="http://schemas.microsoft.com/office/drawing/2014/main" id="{26D9FDC9-11E6-4A1A-B5B4-1EFBABBFBB21}"/>
               </a:ext>
             </a:extLst>
           </p:cNvPr>
@@ -24583,7 +24583,7 @@
           <p:cNvPr id="5" name="Rectangle 4">
             <a:extLst xmlns:a="http://schemas.openxmlformats.org/drawingml/2006/main">
               <a:ext uri="{FF2B5EF4-FFF2-40B4-BE49-F238E27FC236}">
-                <a16:creationId xmlns:a16="http://schemas.microsoft.com/office/drawing/2014/main" id="{F2F992AF-41CA-4F3A-A725-C20BB2355090}"/>
+                <a16:creationId xmlns:a16="http://schemas.microsoft.com/office/drawing/2014/main" id="{D584DB99-049F-447D-8489-6D3C3E6A930C}"/>
               </a:ext>
             </a:extLst>
           </p:cNvPr>
@@ -24638,7 +24638,7 @@
           <p:cNvPr id="6" name="TextBox 5">
             <a:extLst xmlns:a="http://schemas.openxmlformats.org/drawingml/2006/main">
               <a:ext uri="{FF2B5EF4-FFF2-40B4-BE49-F238E27FC236}">
-                <a16:creationId xmlns:a16="http://schemas.microsoft.com/office/drawing/2014/main" id="{B75877EA-B467-4E5C-8409-614ACAD27207}"/>
+                <a16:creationId xmlns:a16="http://schemas.microsoft.com/office/drawing/2014/main" id="{7246FF7E-9D91-4EA1-A256-F62DD863134C}"/>
               </a:ext>
             </a:extLst>
           </p:cNvPr>
@@ -24675,7 +24675,7 @@
                 <a:ea typeface="Aptos"/>
                 <a:cs typeface="Aptos"/>
               </a:rPr>
-              <a:t>Independent public evidence summary · 2026.07.23-11 · 2026-07-22 · Sources: Evidence Register; changelog</a:t>
+              <a:t>Independent public evidence summary · 2026.07.23-12 · 2026-07-22 · Sources: Evidence Register; changelog</a:t>
             </a:r>
           </a:p>
         </p:txBody>
@@ -24685,7 +24685,7 @@
           <p:cNvPr id="7" name="TextBox 6">
             <a:extLst xmlns:a="http://schemas.openxmlformats.org/drawingml/2006/main">
               <a:ext uri="{FF2B5EF4-FFF2-40B4-BE49-F238E27FC236}">
-                <a16:creationId xmlns:a16="http://schemas.microsoft.com/office/drawing/2014/main" id="{EF3A7EBF-39EE-40F5-A4E0-5802DD0751F6}"/>
+                <a16:creationId xmlns:a16="http://schemas.microsoft.com/office/drawing/2014/main" id="{40A20653-5C19-485D-998D-DA46CCFBD058}"/>
               </a:ext>
             </a:extLst>
           </p:cNvPr>
@@ -24732,7 +24732,7 @@
           <p:cNvPr id="8" name="Rounded Rectangle 7">
             <a:extLst xmlns:a="http://schemas.openxmlformats.org/drawingml/2006/main">
               <a:ext uri="{FF2B5EF4-FFF2-40B4-BE49-F238E27FC236}">
-                <a16:creationId xmlns:a16="http://schemas.microsoft.com/office/drawing/2014/main" id="{395BD401-6BF7-4DBC-818D-A5515042431F}"/>
+                <a16:creationId xmlns:a16="http://schemas.microsoft.com/office/drawing/2014/main" id="{5BC29E40-0191-4C7B-BC36-977992433D17}"/>
               </a:ext>
             </a:extLst>
           </p:cNvPr>
@@ -24789,7 +24789,7 @@
           <p:cNvPr id="9" name="TextBox 8">
             <a:extLst xmlns:a="http://schemas.openxmlformats.org/drawingml/2006/main">
               <a:ext uri="{FF2B5EF4-FFF2-40B4-BE49-F238E27FC236}">
-                <a16:creationId xmlns:a16="http://schemas.microsoft.com/office/drawing/2014/main" id="{F88DF643-BB1E-458B-9C24-4413EC1EEC71}"/>
+                <a16:creationId xmlns:a16="http://schemas.microsoft.com/office/drawing/2014/main" id="{2FD19054-E2CA-45B8-BA53-AF2CE18D527A}"/>
               </a:ext>
             </a:extLst>
           </p:cNvPr>
@@ -24836,7 +24836,7 @@
           <p:cNvPr id="10" name="TextBox 9">
             <a:extLst xmlns:a="http://schemas.openxmlformats.org/drawingml/2006/main">
               <a:ext uri="{FF2B5EF4-FFF2-40B4-BE49-F238E27FC236}">
-                <a16:creationId xmlns:a16="http://schemas.microsoft.com/office/drawing/2014/main" id="{C62B2C4D-9340-4EEB-9925-9C2A74818109}"/>
+                <a16:creationId xmlns:a16="http://schemas.microsoft.com/office/drawing/2014/main" id="{0F2EF49C-570B-45F9-B29E-A62F2E74819E}"/>
               </a:ext>
             </a:extLst>
           </p:cNvPr>
@@ -24883,7 +24883,7 @@
           <p:cNvPr id="11" name="TextBox 10">
             <a:extLst xmlns:a="http://schemas.openxmlformats.org/drawingml/2006/main">
               <a:ext uri="{FF2B5EF4-FFF2-40B4-BE49-F238E27FC236}">
-                <a16:creationId xmlns:a16="http://schemas.microsoft.com/office/drawing/2014/main" id="{BDC2F6E7-E0F4-4493-88CF-0B16B0716793}"/>
+                <a16:creationId xmlns:a16="http://schemas.microsoft.com/office/drawing/2014/main" id="{1A601A18-BE28-48B4-8712-2B97E13AC805}"/>
               </a:ext>
             </a:extLst>
           </p:cNvPr>
@@ -24930,7 +24930,7 @@
           <p:cNvPr id="12" name="Rounded Rectangle 11">
             <a:extLst xmlns:a="http://schemas.openxmlformats.org/drawingml/2006/main">
               <a:ext uri="{FF2B5EF4-FFF2-40B4-BE49-F238E27FC236}">
-                <a16:creationId xmlns:a16="http://schemas.microsoft.com/office/drawing/2014/main" id="{00315D0B-7D07-4F8D-B5BB-23D9D5FED1AA}"/>
+                <a16:creationId xmlns:a16="http://schemas.microsoft.com/office/drawing/2014/main" id="{A7867A77-A788-45BE-93DC-D847973A676E}"/>
               </a:ext>
             </a:extLst>
           </p:cNvPr>
@@ -24987,7 +24987,7 @@
           <p:cNvPr id="13" name="TextBox 12">
             <a:extLst xmlns:a="http://schemas.openxmlformats.org/drawingml/2006/main">
               <a:ext uri="{FF2B5EF4-FFF2-40B4-BE49-F238E27FC236}">
-                <a16:creationId xmlns:a16="http://schemas.microsoft.com/office/drawing/2014/main" id="{B4597F82-5BA3-4E8F-B84F-DBDDEE6D617F}"/>
+                <a16:creationId xmlns:a16="http://schemas.microsoft.com/office/drawing/2014/main" id="{114C5778-EE14-449B-BEEA-D32DEE94F009}"/>
               </a:ext>
             </a:extLst>
           </p:cNvPr>
@@ -25034,7 +25034,7 @@
           <p:cNvPr id="14" name="TextBox 13">
             <a:extLst xmlns:a="http://schemas.openxmlformats.org/drawingml/2006/main">
               <a:ext uri="{FF2B5EF4-FFF2-40B4-BE49-F238E27FC236}">
-                <a16:creationId xmlns:a16="http://schemas.microsoft.com/office/drawing/2014/main" id="{3646E6A2-C3AD-48CF-A8E7-62C0B211E182}"/>
+                <a16:creationId xmlns:a16="http://schemas.microsoft.com/office/drawing/2014/main" id="{CD175EBF-F119-4ACD-B82C-AB9088FEB3B4}"/>
               </a:ext>
             </a:extLst>
           </p:cNvPr>
@@ -25081,7 +25081,7 @@
           <p:cNvPr id="15" name="TextBox 14">
             <a:extLst xmlns:a="http://schemas.openxmlformats.org/drawingml/2006/main">
               <a:ext uri="{FF2B5EF4-FFF2-40B4-BE49-F238E27FC236}">
-                <a16:creationId xmlns:a16="http://schemas.microsoft.com/office/drawing/2014/main" id="{0B86C2C6-5EA0-4394-9994-68AAE5F73141}"/>
+                <a16:creationId xmlns:a16="http://schemas.microsoft.com/office/drawing/2014/main" id="{CA7E4D0D-E8B6-45B7-A8C0-173B4811B3DA}"/>
               </a:ext>
             </a:extLst>
           </p:cNvPr>
@@ -25128,7 +25128,7 @@
           <p:cNvPr id="16" name="Rounded Rectangle 15">
             <a:extLst xmlns:a="http://schemas.openxmlformats.org/drawingml/2006/main">
               <a:ext uri="{FF2B5EF4-FFF2-40B4-BE49-F238E27FC236}">
-                <a16:creationId xmlns:a16="http://schemas.microsoft.com/office/drawing/2014/main" id="{D3D48DBF-59B0-4145-9566-F0BB7FFFEFEF}"/>
+                <a16:creationId xmlns:a16="http://schemas.microsoft.com/office/drawing/2014/main" id="{57D32403-1490-4590-B570-DECE2B7DFABD}"/>
               </a:ext>
             </a:extLst>
           </p:cNvPr>
@@ -25185,7 +25185,7 @@
           <p:cNvPr id="17" name="TextBox 16">
             <a:extLst xmlns:a="http://schemas.openxmlformats.org/drawingml/2006/main">
               <a:ext uri="{FF2B5EF4-FFF2-40B4-BE49-F238E27FC236}">
-                <a16:creationId xmlns:a16="http://schemas.microsoft.com/office/drawing/2014/main" id="{DD56108B-4AC3-4F2C-8693-F779BC10DBFC}"/>
+                <a16:creationId xmlns:a16="http://schemas.microsoft.com/office/drawing/2014/main" id="{D7A8F07C-A65D-4BD3-AFC5-D1A2DE288565}"/>
               </a:ext>
             </a:extLst>
           </p:cNvPr>
@@ -25232,7 +25232,7 @@
           <p:cNvPr id="18" name="TextBox 17">
             <a:extLst xmlns:a="http://schemas.openxmlformats.org/drawingml/2006/main">
               <a:ext uri="{FF2B5EF4-FFF2-40B4-BE49-F238E27FC236}">
-                <a16:creationId xmlns:a16="http://schemas.microsoft.com/office/drawing/2014/main" id="{DA17D484-E617-4AFE-938F-EB0DD8AA3A31}"/>
+                <a16:creationId xmlns:a16="http://schemas.microsoft.com/office/drawing/2014/main" id="{8AD4FED9-D076-4145-8B47-AE72394739C4}"/>
               </a:ext>
             </a:extLst>
           </p:cNvPr>
@@ -25279,7 +25279,7 @@
           <p:cNvPr id="19" name="TextBox 18">
             <a:extLst xmlns:a="http://schemas.openxmlformats.org/drawingml/2006/main">
               <a:ext uri="{FF2B5EF4-FFF2-40B4-BE49-F238E27FC236}">
-                <a16:creationId xmlns:a16="http://schemas.microsoft.com/office/drawing/2014/main" id="{BDEFE6E8-29A4-4C34-9EC6-3B977BB46322}"/>
+                <a16:creationId xmlns:a16="http://schemas.microsoft.com/office/drawing/2014/main" id="{99A0F72F-AA6A-4B06-9081-306065A921CC}"/>
               </a:ext>
             </a:extLst>
           </p:cNvPr>
@@ -25326,7 +25326,7 @@
           <p:cNvPr id="20" name="Rounded Rectangle 19">
             <a:extLst xmlns:a="http://schemas.openxmlformats.org/drawingml/2006/main">
               <a:ext uri="{FF2B5EF4-FFF2-40B4-BE49-F238E27FC236}">
-                <a16:creationId xmlns:a16="http://schemas.microsoft.com/office/drawing/2014/main" id="{8CE8FD36-8F64-4C9C-AE1B-020B9D8AAA0D}"/>
+                <a16:creationId xmlns:a16="http://schemas.microsoft.com/office/drawing/2014/main" id="{CECD132F-6E1A-41E4-9847-622524CA0ABF}"/>
               </a:ext>
             </a:extLst>
           </p:cNvPr>
@@ -25383,7 +25383,7 @@
           <p:cNvPr id="21" name="TextBox 20">
             <a:extLst xmlns:a="http://schemas.openxmlformats.org/drawingml/2006/main">
               <a:ext uri="{FF2B5EF4-FFF2-40B4-BE49-F238E27FC236}">
-                <a16:creationId xmlns:a16="http://schemas.microsoft.com/office/drawing/2014/main" id="{D85E8CB7-0949-40C5-940E-AE9DCE9FC6D6}"/>
+                <a16:creationId xmlns:a16="http://schemas.microsoft.com/office/drawing/2014/main" id="{A6F7B3B8-6583-41B2-9849-8EA68DD3C248}"/>
               </a:ext>
             </a:extLst>
           </p:cNvPr>
@@ -25430,7 +25430,7 @@
           <p:cNvPr id="22" name="TextBox 21">
             <a:extLst xmlns:a="http://schemas.openxmlformats.org/drawingml/2006/main">
               <a:ext uri="{FF2B5EF4-FFF2-40B4-BE49-F238E27FC236}">
-                <a16:creationId xmlns:a16="http://schemas.microsoft.com/office/drawing/2014/main" id="{14B56330-1A7E-42FD-BD76-FF9BBE12AF53}"/>
+                <a16:creationId xmlns:a16="http://schemas.microsoft.com/office/drawing/2014/main" id="{66F6F93C-B989-4AB7-8BDD-6A17E84A5561}"/>
               </a:ext>
             </a:extLst>
           </p:cNvPr>
@@ -25477,7 +25477,7 @@
           <p:cNvPr id="23" name="TextBox 22">
             <a:extLst xmlns:a="http://schemas.openxmlformats.org/drawingml/2006/main">
               <a:ext uri="{FF2B5EF4-FFF2-40B4-BE49-F238E27FC236}">
-                <a16:creationId xmlns:a16="http://schemas.microsoft.com/office/drawing/2014/main" id="{7183EFBF-514E-41E7-9438-DC8F463BEAF0}"/>
+                <a16:creationId xmlns:a16="http://schemas.microsoft.com/office/drawing/2014/main" id="{E8CC6C31-4138-439F-B7D7-9B329FCB0F04}"/>
               </a:ext>
             </a:extLst>
           </p:cNvPr>
@@ -25524,7 +25524,7 @@
           <p:cNvPr id="24" name="TextBox 23">
             <a:extLst xmlns:a="http://schemas.openxmlformats.org/drawingml/2006/main">
               <a:ext uri="{FF2B5EF4-FFF2-40B4-BE49-F238E27FC236}">
-                <a16:creationId xmlns:a16="http://schemas.microsoft.com/office/drawing/2014/main" id="{AC74D571-2963-4D2F-B7B2-3165593DAD27}"/>
+                <a16:creationId xmlns:a16="http://schemas.microsoft.com/office/drawing/2014/main" id="{191B7668-0003-4268-95DF-A7DED462ED72}"/>
               </a:ext>
             </a:extLst>
           </p:cNvPr>
@@ -25569,7 +25569,7 @@
     </p:spTree>
     <p:extLst>
       <p:ext uri="{BB962C8B-B14F-4D97-AF65-F5344CB8AC3E}">
-        <p14:creationId xmlns:p14="http://schemas.microsoft.com/office/powerpoint/2010/main" val="614676180"/>
+        <p14:creationId xmlns:p14="http://schemas.microsoft.com/office/powerpoint/2010/main" val="1793769815"/>
       </p:ext>
     </p:extLst>
   </p:cSld>
@@ -25593,7 +25593,7 @@
           <p:cNvPr id="2" name="TextBox 1">
             <a:extLst xmlns:a="http://schemas.openxmlformats.org/drawingml/2006/main">
               <a:ext uri="{FF2B5EF4-FFF2-40B4-BE49-F238E27FC236}">
-                <a16:creationId xmlns:a16="http://schemas.microsoft.com/office/drawing/2014/main" id="{78760961-E911-4AF3-B277-45EC35685D2B}"/>
+                <a16:creationId xmlns:a16="http://schemas.microsoft.com/office/drawing/2014/main" id="{BC909E00-B0A6-4324-BA6A-9F628E580988}"/>
               </a:ext>
             </a:extLst>
           </p:cNvPr>
@@ -25640,7 +25640,7 @@
           <p:cNvPr id="3" name="TextBox 2">
             <a:extLst xmlns:a="http://schemas.openxmlformats.org/drawingml/2006/main">
               <a:ext uri="{FF2B5EF4-FFF2-40B4-BE49-F238E27FC236}">
-                <a16:creationId xmlns:a16="http://schemas.microsoft.com/office/drawing/2014/main" id="{61D8D4A6-D7AD-42FA-9E0E-59196D5A29B4}"/>
+                <a16:creationId xmlns:a16="http://schemas.microsoft.com/office/drawing/2014/main" id="{0FDE2F91-72FD-4437-BD56-1E3DD66A9B05}"/>
               </a:ext>
             </a:extLst>
           </p:cNvPr>
@@ -25687,7 +25687,7 @@
           <p:cNvPr id="4" name="Rectangle 3">
             <a:extLst xmlns:a="http://schemas.openxmlformats.org/drawingml/2006/main">
               <a:ext uri="{FF2B5EF4-FFF2-40B4-BE49-F238E27FC236}">
-                <a16:creationId xmlns:a16="http://schemas.microsoft.com/office/drawing/2014/main" id="{FFE82029-48AC-4598-9EA2-2814FF94B2DA}"/>
+                <a16:creationId xmlns:a16="http://schemas.microsoft.com/office/drawing/2014/main" id="{80724439-6D8F-4524-8926-AB3755E0B37C}"/>
               </a:ext>
             </a:extLst>
           </p:cNvPr>
@@ -25742,7 +25742,7 @@
           <p:cNvPr id="5" name="Rectangle 4">
             <a:extLst xmlns:a="http://schemas.openxmlformats.org/drawingml/2006/main">
               <a:ext uri="{FF2B5EF4-FFF2-40B4-BE49-F238E27FC236}">
-                <a16:creationId xmlns:a16="http://schemas.microsoft.com/office/drawing/2014/main" id="{2F8F74DF-EE62-4A45-81C1-EE80FC9DF169}"/>
+                <a16:creationId xmlns:a16="http://schemas.microsoft.com/office/drawing/2014/main" id="{171FC370-3C2A-4AFD-86F1-DFCBA5FDDADF}"/>
               </a:ext>
             </a:extLst>
           </p:cNvPr>
@@ -25797,7 +25797,7 @@
           <p:cNvPr id="6" name="TextBox 5">
             <a:extLst xmlns:a="http://schemas.openxmlformats.org/drawingml/2006/main">
               <a:ext uri="{FF2B5EF4-FFF2-40B4-BE49-F238E27FC236}">
-                <a16:creationId xmlns:a16="http://schemas.microsoft.com/office/drawing/2014/main" id="{7004082C-EFED-41E7-B0DF-EA1D0460DE38}"/>
+                <a16:creationId xmlns:a16="http://schemas.microsoft.com/office/drawing/2014/main" id="{DF900256-F058-4A15-8695-FA520F0EB903}"/>
               </a:ext>
             </a:extLst>
           </p:cNvPr>
@@ -25834,7 +25834,7 @@
                 <a:ea typeface="Aptos"/>
                 <a:cs typeface="Aptos"/>
               </a:rPr>
-              <a:t>Independent public evidence summary · 2026.07.23-11 · 2026-07-22 · Sources: EPO; 8 Ni 18/24 (EP); 7 O 3341/24</a:t>
+              <a:t>Independent public evidence summary · 2026.07.23-12 · 2026-07-22 · Sources: EPO; 8 Ni 18/24 (EP); 7 O 3341/24</a:t>
             </a:r>
           </a:p>
         </p:txBody>
@@ -25844,7 +25844,7 @@
           <p:cNvPr id="7" name="TextBox 6">
             <a:extLst xmlns:a="http://schemas.openxmlformats.org/drawingml/2006/main">
               <a:ext uri="{FF2B5EF4-FFF2-40B4-BE49-F238E27FC236}">
-                <a16:creationId xmlns:a16="http://schemas.microsoft.com/office/drawing/2014/main" id="{274F9216-553B-4698-AB29-36700FDB5984}"/>
+                <a16:creationId xmlns:a16="http://schemas.microsoft.com/office/drawing/2014/main" id="{6ACFF603-A09B-43F8-8DE1-799ACDC6FD2C}"/>
               </a:ext>
             </a:extLst>
           </p:cNvPr>
@@ -26248,7 +26248,7 @@
           <p:cNvPr id="9" name="TextBox 8">
             <a:extLst xmlns:a="http://schemas.openxmlformats.org/drawingml/2006/main">
               <a:ext uri="{FF2B5EF4-FFF2-40B4-BE49-F238E27FC236}">
-                <a16:creationId xmlns:a16="http://schemas.microsoft.com/office/drawing/2014/main" id="{0787AD0B-87EE-4E2D-99F8-4DAE4388472F}"/>
+                <a16:creationId xmlns:a16="http://schemas.microsoft.com/office/drawing/2014/main" id="{99E2B904-2722-4C1D-A7A8-64DA63CFFCD1}"/>
               </a:ext>
             </a:extLst>
           </p:cNvPr>
@@ -26293,7 +26293,7 @@
     </p:spTree>
     <p:extLst>
       <p:ext uri="{BB962C8B-B14F-4D97-AF65-F5344CB8AC3E}">
-        <p14:creationId xmlns:p14="http://schemas.microsoft.com/office/powerpoint/2010/main" val="1571552174"/>
+        <p14:creationId xmlns:p14="http://schemas.microsoft.com/office/powerpoint/2010/main" val="1530264729"/>
       </p:ext>
     </p:extLst>
   </p:cSld>
@@ -26324,7 +26324,7 @@
           <p:cNvPr id="2" name="TextBox 1">
             <a:extLst xmlns:a="http://schemas.openxmlformats.org/drawingml/2006/main">
               <a:ext uri="{FF2B5EF4-FFF2-40B4-BE49-F238E27FC236}">
-                <a16:creationId xmlns:a16="http://schemas.microsoft.com/office/drawing/2014/main" id="{3A005910-8C16-4E24-AFDF-ED81E1C5CCF9}"/>
+                <a16:creationId xmlns:a16="http://schemas.microsoft.com/office/drawing/2014/main" id="{AD0E2F19-B4FB-40CD-A0C9-3FB742DC96F7}"/>
               </a:ext>
             </a:extLst>
           </p:cNvPr>
@@ -26371,7 +26371,7 @@
           <p:cNvPr id="3" name="TextBox 2">
             <a:extLst xmlns:a="http://schemas.openxmlformats.org/drawingml/2006/main">
               <a:ext uri="{FF2B5EF4-FFF2-40B4-BE49-F238E27FC236}">
-                <a16:creationId xmlns:a16="http://schemas.microsoft.com/office/drawing/2014/main" id="{209A8C62-2AA7-469C-9940-88570A605096}"/>
+                <a16:creationId xmlns:a16="http://schemas.microsoft.com/office/drawing/2014/main" id="{CE25A6AE-87FB-447C-962B-80B69344D4EF}"/>
               </a:ext>
             </a:extLst>
           </p:cNvPr>
@@ -26418,7 +26418,7 @@
           <p:cNvPr id="4" name="TextBox 3">
             <a:extLst xmlns:a="http://schemas.openxmlformats.org/drawingml/2006/main">
               <a:ext uri="{FF2B5EF4-FFF2-40B4-BE49-F238E27FC236}">
-                <a16:creationId xmlns:a16="http://schemas.microsoft.com/office/drawing/2014/main" id="{28C98103-4746-4F41-B8CD-076EDA58D87E}"/>
+                <a16:creationId xmlns:a16="http://schemas.microsoft.com/office/drawing/2014/main" id="{E45CEA02-A101-4356-86DB-00F26B5FB24F}"/>
               </a:ext>
             </a:extLst>
           </p:cNvPr>
@@ -26537,7 +26537,7 @@
           <p:cNvPr id="5" name="TextBox 4">
             <a:extLst xmlns:a="http://schemas.openxmlformats.org/drawingml/2006/main">
               <a:ext uri="{FF2B5EF4-FFF2-40B4-BE49-F238E27FC236}">
-                <a16:creationId xmlns:a16="http://schemas.microsoft.com/office/drawing/2014/main" id="{FEE95406-293C-4CBA-A777-AA4551D3EE16}"/>
+                <a16:creationId xmlns:a16="http://schemas.microsoft.com/office/drawing/2014/main" id="{D8F38668-4194-4C03-8AA5-8E9900D1C78E}"/>
               </a:ext>
             </a:extLst>
           </p:cNvPr>
@@ -26574,7 +26574,7 @@
                 <a:ea typeface="Aptos"/>
                 <a:cs typeface="Aptos"/>
               </a:rPr>
-              <a:t>Version 2026.07.23-11 · 2026-07-22 · 30 / 30</a:t>
+              <a:t>Version 2026.07.23-12 · 2026-07-22 · 30 / 30</a:t>
             </a:r>
           </a:p>
         </p:txBody>
@@ -26582,7 +26582,7 @@
     </p:spTree>
     <p:extLst>
       <p:ext uri="{BB962C8B-B14F-4D97-AF65-F5344CB8AC3E}">
-        <p14:creationId xmlns:p14="http://schemas.microsoft.com/office/powerpoint/2010/main" val="422308769"/>
+        <p14:creationId xmlns:p14="http://schemas.microsoft.com/office/powerpoint/2010/main" val="512281456"/>
       </p:ext>
     </p:extLst>
   </p:cSld>
@@ -26606,7 +26606,7 @@
           <p:cNvPr id="2" name="TextBox 1">
             <a:extLst xmlns:a="http://schemas.openxmlformats.org/drawingml/2006/main">
               <a:ext uri="{FF2B5EF4-FFF2-40B4-BE49-F238E27FC236}">
-                <a16:creationId xmlns:a16="http://schemas.microsoft.com/office/drawing/2014/main" id="{4E635081-7A0D-4278-B4B8-70DD0C765518}"/>
+                <a16:creationId xmlns:a16="http://schemas.microsoft.com/office/drawing/2014/main" id="{91783EE8-D44E-4516-B0B5-48BE4D8D8004}"/>
               </a:ext>
             </a:extLst>
           </p:cNvPr>
@@ -26653,7 +26653,7 @@
           <p:cNvPr id="3" name="TextBox 2">
             <a:extLst xmlns:a="http://schemas.openxmlformats.org/drawingml/2006/main">
               <a:ext uri="{FF2B5EF4-FFF2-40B4-BE49-F238E27FC236}">
-                <a16:creationId xmlns:a16="http://schemas.microsoft.com/office/drawing/2014/main" id="{79885DA3-AD3D-4AF5-B7EA-E8BF2A8BE215}"/>
+                <a16:creationId xmlns:a16="http://schemas.microsoft.com/office/drawing/2014/main" id="{92720D15-7846-4FC1-AADB-E239575D1E32}"/>
               </a:ext>
             </a:extLst>
           </p:cNvPr>
@@ -26700,7 +26700,7 @@
           <p:cNvPr id="4" name="Rectangle 3">
             <a:extLst xmlns:a="http://schemas.openxmlformats.org/drawingml/2006/main">
               <a:ext uri="{FF2B5EF4-FFF2-40B4-BE49-F238E27FC236}">
-                <a16:creationId xmlns:a16="http://schemas.microsoft.com/office/drawing/2014/main" id="{60CB3F49-F142-4BEB-A24C-89BBD3DFA588}"/>
+                <a16:creationId xmlns:a16="http://schemas.microsoft.com/office/drawing/2014/main" id="{C4166E60-E209-4305-AF06-081AD299F655}"/>
               </a:ext>
             </a:extLst>
           </p:cNvPr>
@@ -26755,7 +26755,7 @@
           <p:cNvPr id="5" name="Rectangle 4">
             <a:extLst xmlns:a="http://schemas.openxmlformats.org/drawingml/2006/main">
               <a:ext uri="{FF2B5EF4-FFF2-40B4-BE49-F238E27FC236}">
-                <a16:creationId xmlns:a16="http://schemas.microsoft.com/office/drawing/2014/main" id="{77736D4E-32AF-43E8-901D-7712F41BD953}"/>
+                <a16:creationId xmlns:a16="http://schemas.microsoft.com/office/drawing/2014/main" id="{96582BD4-7598-41DB-A205-F26F9D5DCAC8}"/>
               </a:ext>
             </a:extLst>
           </p:cNvPr>
@@ -26810,7 +26810,7 @@
           <p:cNvPr id="6" name="TextBox 5">
             <a:extLst xmlns:a="http://schemas.openxmlformats.org/drawingml/2006/main">
               <a:ext uri="{FF2B5EF4-FFF2-40B4-BE49-F238E27FC236}">
-                <a16:creationId xmlns:a16="http://schemas.microsoft.com/office/drawing/2014/main" id="{5CBFCEA7-2037-4427-8518-14CA945E899C}"/>
+                <a16:creationId xmlns:a16="http://schemas.microsoft.com/office/drawing/2014/main" id="{F1BFBFB0-725B-43D1-997C-30A21E92E268}"/>
               </a:ext>
             </a:extLst>
           </p:cNvPr>
@@ -26847,7 +26847,7 @@
                 <a:ea typeface="Aptos"/>
                 <a:cs typeface="Aptos"/>
               </a:rPr>
-              <a:t>Independent public evidence summary · 2026.07.23-11 · 2026-07-22 · Sources: Evidence Register; WIPO</a:t>
+              <a:t>Independent public evidence summary · 2026.07.23-12 · 2026-07-22 · Sources: Evidence Register; WIPO</a:t>
             </a:r>
           </a:p>
         </p:txBody>
@@ -26857,7 +26857,7 @@
           <p:cNvPr id="7" name="TextBox 6">
             <a:extLst xmlns:a="http://schemas.openxmlformats.org/drawingml/2006/main">
               <a:ext uri="{FF2B5EF4-FFF2-40B4-BE49-F238E27FC236}">
-                <a16:creationId xmlns:a16="http://schemas.microsoft.com/office/drawing/2014/main" id="{F59AC8B2-96B7-4ED0-AA3A-614F4EF53471}"/>
+                <a16:creationId xmlns:a16="http://schemas.microsoft.com/office/drawing/2014/main" id="{0EE67602-EC3A-461B-AFD9-EE824C4092C5}"/>
               </a:ext>
             </a:extLst>
           </p:cNvPr>
@@ -26904,7 +26904,7 @@
           <p:cNvPr id="8" name="TextBox 7">
             <a:extLst xmlns:a="http://schemas.openxmlformats.org/drawingml/2006/main">
               <a:ext uri="{FF2B5EF4-FFF2-40B4-BE49-F238E27FC236}">
-                <a16:creationId xmlns:a16="http://schemas.microsoft.com/office/drawing/2014/main" id="{C701EE16-8E61-4689-AE89-8D2F9EB5EB2F}"/>
+                <a16:creationId xmlns:a16="http://schemas.microsoft.com/office/drawing/2014/main" id="{70E157BA-419E-49B7-994F-DEF6C13E1467}"/>
               </a:ext>
             </a:extLst>
           </p:cNvPr>
@@ -26951,7 +26951,7 @@
           <p:cNvPr id="9" name="TextBox 8">
             <a:extLst xmlns:a="http://schemas.openxmlformats.org/drawingml/2006/main">
               <a:ext uri="{FF2B5EF4-FFF2-40B4-BE49-F238E27FC236}">
-                <a16:creationId xmlns:a16="http://schemas.microsoft.com/office/drawing/2014/main" id="{0E90DFFD-8BA4-43DB-ADDA-1670B74AF69D}"/>
+                <a16:creationId xmlns:a16="http://schemas.microsoft.com/office/drawing/2014/main" id="{84260A1D-304A-4C74-AA85-82014890B9FE}"/>
               </a:ext>
             </a:extLst>
           </p:cNvPr>
@@ -27048,7 +27048,7 @@
           <p:cNvPr id="10" name="Rounded Rectangle 9">
             <a:extLst xmlns:a="http://schemas.openxmlformats.org/drawingml/2006/main">
               <a:ext uri="{FF2B5EF4-FFF2-40B4-BE49-F238E27FC236}">
-                <a16:creationId xmlns:a16="http://schemas.microsoft.com/office/drawing/2014/main" id="{1A781E5E-EE71-4772-BBC2-F2FE0F63AA6F}"/>
+                <a16:creationId xmlns:a16="http://schemas.microsoft.com/office/drawing/2014/main" id="{40B8B34D-FD5D-4E19-88AC-CB6727D4CB37}"/>
               </a:ext>
             </a:extLst>
           </p:cNvPr>
@@ -27105,7 +27105,7 @@
           <p:cNvPr id="11" name="TextBox 10">
             <a:extLst xmlns:a="http://schemas.openxmlformats.org/drawingml/2006/main">
               <a:ext uri="{FF2B5EF4-FFF2-40B4-BE49-F238E27FC236}">
-                <a16:creationId xmlns:a16="http://schemas.microsoft.com/office/drawing/2014/main" id="{1539F997-4042-4193-AB5F-45999BFDDE3C}"/>
+                <a16:creationId xmlns:a16="http://schemas.microsoft.com/office/drawing/2014/main" id="{19BFECC1-B5E9-4D55-95F5-E43B60D8E35B}"/>
               </a:ext>
             </a:extLst>
           </p:cNvPr>
@@ -27152,7 +27152,7 @@
           <p:cNvPr id="12" name="TextBox 11">
             <a:extLst xmlns:a="http://schemas.openxmlformats.org/drawingml/2006/main">
               <a:ext uri="{FF2B5EF4-FFF2-40B4-BE49-F238E27FC236}">
-                <a16:creationId xmlns:a16="http://schemas.microsoft.com/office/drawing/2014/main" id="{323140A7-4C9A-4282-9626-8327DCD3FE01}"/>
+                <a16:creationId xmlns:a16="http://schemas.microsoft.com/office/drawing/2014/main" id="{F5935AE3-E013-4491-8B23-A957948DEC83}"/>
               </a:ext>
             </a:extLst>
           </p:cNvPr>
@@ -27197,7 +27197,7 @@
     </p:spTree>
     <p:extLst>
       <p:ext uri="{BB962C8B-B14F-4D97-AF65-F5344CB8AC3E}">
-        <p14:creationId xmlns:p14="http://schemas.microsoft.com/office/powerpoint/2010/main" val="998931108"/>
+        <p14:creationId xmlns:p14="http://schemas.microsoft.com/office/powerpoint/2010/main" val="159504858"/>
       </p:ext>
     </p:extLst>
   </p:cSld>
@@ -27221,7 +27221,7 @@
           <p:cNvPr id="2" name="TextBox 1">
             <a:extLst xmlns:a="http://schemas.openxmlformats.org/drawingml/2006/main">
               <a:ext uri="{FF2B5EF4-FFF2-40B4-BE49-F238E27FC236}">
-                <a16:creationId xmlns:a16="http://schemas.microsoft.com/office/drawing/2014/main" id="{F9953B55-F6D3-4B96-A011-5D965A0BDF64}"/>
+                <a16:creationId xmlns:a16="http://schemas.microsoft.com/office/drawing/2014/main" id="{8CB57FBB-0E69-4830-B920-4A6AEF527AA4}"/>
               </a:ext>
             </a:extLst>
           </p:cNvPr>
@@ -27268,7 +27268,7 @@
           <p:cNvPr id="3" name="TextBox 2">
             <a:extLst xmlns:a="http://schemas.openxmlformats.org/drawingml/2006/main">
               <a:ext uri="{FF2B5EF4-FFF2-40B4-BE49-F238E27FC236}">
-                <a16:creationId xmlns:a16="http://schemas.microsoft.com/office/drawing/2014/main" id="{A0D0DF53-06E9-40A7-9F99-76931A5BAC18}"/>
+                <a16:creationId xmlns:a16="http://schemas.microsoft.com/office/drawing/2014/main" id="{287BF8EF-602D-4DD4-928A-7A083F4C4891}"/>
               </a:ext>
             </a:extLst>
           </p:cNvPr>
@@ -27315,7 +27315,7 @@
           <p:cNvPr id="4" name="Rectangle 3">
             <a:extLst xmlns:a="http://schemas.openxmlformats.org/drawingml/2006/main">
               <a:ext uri="{FF2B5EF4-FFF2-40B4-BE49-F238E27FC236}">
-                <a16:creationId xmlns:a16="http://schemas.microsoft.com/office/drawing/2014/main" id="{FC2D1C3F-234D-4A99-95C2-E3C4F5959A4A}"/>
+                <a16:creationId xmlns:a16="http://schemas.microsoft.com/office/drawing/2014/main" id="{8D88E304-6206-4989-9A0F-1AF601C5E9EC}"/>
               </a:ext>
             </a:extLst>
           </p:cNvPr>
@@ -27370,7 +27370,7 @@
           <p:cNvPr id="5" name="Rectangle 4">
             <a:extLst xmlns:a="http://schemas.openxmlformats.org/drawingml/2006/main">
               <a:ext uri="{FF2B5EF4-FFF2-40B4-BE49-F238E27FC236}">
-                <a16:creationId xmlns:a16="http://schemas.microsoft.com/office/drawing/2014/main" id="{2F83EDCA-85FD-43C7-A137-B126B0B59504}"/>
+                <a16:creationId xmlns:a16="http://schemas.microsoft.com/office/drawing/2014/main" id="{3770668F-02BB-4428-A809-2101C0BF1DFB}"/>
               </a:ext>
             </a:extLst>
           </p:cNvPr>
@@ -27425,7 +27425,7 @@
           <p:cNvPr id="6" name="TextBox 5">
             <a:extLst xmlns:a="http://schemas.openxmlformats.org/drawingml/2006/main">
               <a:ext uri="{FF2B5EF4-FFF2-40B4-BE49-F238E27FC236}">
-                <a16:creationId xmlns:a16="http://schemas.microsoft.com/office/drawing/2014/main" id="{DE5B65B3-AAD2-44CE-92D8-4A0208C59E5E}"/>
+                <a16:creationId xmlns:a16="http://schemas.microsoft.com/office/drawing/2014/main" id="{2D597CEF-F491-4CC3-807A-227EB0766211}"/>
               </a:ext>
             </a:extLst>
           </p:cNvPr>
@@ -27462,7 +27462,7 @@
                 <a:ea typeface="Aptos"/>
                 <a:cs typeface="Aptos"/>
               </a:rPr>
-              <a:t>Independent public evidence summary · 2026.07.23-11 · 2026-07-22 · Sources: EP3032975B2</a:t>
+              <a:t>Independent public evidence summary · 2026.07.23-12 · 2026-07-22 · Sources: EP3032975B2</a:t>
             </a:r>
           </a:p>
         </p:txBody>
@@ -27472,7 +27472,7 @@
           <p:cNvPr id="7" name="TextBox 6">
             <a:extLst xmlns:a="http://schemas.openxmlformats.org/drawingml/2006/main">
               <a:ext uri="{FF2B5EF4-FFF2-40B4-BE49-F238E27FC236}">
-                <a16:creationId xmlns:a16="http://schemas.microsoft.com/office/drawing/2014/main" id="{3911CC5A-6E54-4C9F-B874-099A38AE3278}"/>
+                <a16:creationId xmlns:a16="http://schemas.microsoft.com/office/drawing/2014/main" id="{A158AB8F-270C-4DB5-A6B6-FFD751617C69}"/>
               </a:ext>
             </a:extLst>
           </p:cNvPr>
@@ -27519,7 +27519,7 @@
           <p:cNvPr id="8" name="TextBox 7">
             <a:extLst xmlns:a="http://schemas.openxmlformats.org/drawingml/2006/main">
               <a:ext uri="{FF2B5EF4-FFF2-40B4-BE49-F238E27FC236}">
-                <a16:creationId xmlns:a16="http://schemas.microsoft.com/office/drawing/2014/main" id="{FC61DD90-F79B-4549-A1EB-4BDFC46E295D}"/>
+                <a16:creationId xmlns:a16="http://schemas.microsoft.com/office/drawing/2014/main" id="{AC3045CB-C42A-4115-8805-0DAFDAB4A0E9}"/>
               </a:ext>
             </a:extLst>
           </p:cNvPr>
@@ -27566,7 +27566,7 @@
           <p:cNvPr id="9" name="TextBox 8">
             <a:extLst xmlns:a="http://schemas.openxmlformats.org/drawingml/2006/main">
               <a:ext uri="{FF2B5EF4-FFF2-40B4-BE49-F238E27FC236}">
-                <a16:creationId xmlns:a16="http://schemas.microsoft.com/office/drawing/2014/main" id="{F8F9DC60-FC2B-4C53-B801-810FC1B3BE3F}"/>
+                <a16:creationId xmlns:a16="http://schemas.microsoft.com/office/drawing/2014/main" id="{FB8F783B-D3A0-4DAA-9FFA-A7B95A7D0845}"/>
               </a:ext>
             </a:extLst>
           </p:cNvPr>
@@ -27663,7 +27663,7 @@
           <p:cNvPr id="10" name="Rounded Rectangle 9">
             <a:extLst xmlns:a="http://schemas.openxmlformats.org/drawingml/2006/main">
               <a:ext uri="{FF2B5EF4-FFF2-40B4-BE49-F238E27FC236}">
-                <a16:creationId xmlns:a16="http://schemas.microsoft.com/office/drawing/2014/main" id="{FA580EC2-97EE-4E70-A08A-62997C713C4B}"/>
+                <a16:creationId xmlns:a16="http://schemas.microsoft.com/office/drawing/2014/main" id="{1D2D9360-BF21-434E-87FE-4DE53AFE42B3}"/>
               </a:ext>
             </a:extLst>
           </p:cNvPr>
@@ -27720,7 +27720,7 @@
           <p:cNvPr id="11" name="TextBox 10">
             <a:extLst xmlns:a="http://schemas.openxmlformats.org/drawingml/2006/main">
               <a:ext uri="{FF2B5EF4-FFF2-40B4-BE49-F238E27FC236}">
-                <a16:creationId xmlns:a16="http://schemas.microsoft.com/office/drawing/2014/main" id="{6B44A0F2-974D-4FBE-BC34-3891760F231A}"/>
+                <a16:creationId xmlns:a16="http://schemas.microsoft.com/office/drawing/2014/main" id="{FF07E2DF-5C20-48A5-9BD6-B79E626D8563}"/>
               </a:ext>
             </a:extLst>
           </p:cNvPr>
@@ -27767,7 +27767,7 @@
           <p:cNvPr id="12" name="TextBox 11">
             <a:extLst xmlns:a="http://schemas.openxmlformats.org/drawingml/2006/main">
               <a:ext uri="{FF2B5EF4-FFF2-40B4-BE49-F238E27FC236}">
-                <a16:creationId xmlns:a16="http://schemas.microsoft.com/office/drawing/2014/main" id="{68327904-7C41-4E63-811C-393B15CFEE99}"/>
+                <a16:creationId xmlns:a16="http://schemas.microsoft.com/office/drawing/2014/main" id="{A17DF37E-06F1-41EA-8FB5-42BCC3FADE6B}"/>
               </a:ext>
             </a:extLst>
           </p:cNvPr>
@@ -27812,7 +27812,7 @@
     </p:spTree>
     <p:extLst>
       <p:ext uri="{BB962C8B-B14F-4D97-AF65-F5344CB8AC3E}">
-        <p14:creationId xmlns:p14="http://schemas.microsoft.com/office/powerpoint/2010/main" val="1064422834"/>
+        <p14:creationId xmlns:p14="http://schemas.microsoft.com/office/powerpoint/2010/main" val="851094719"/>
       </p:ext>
     </p:extLst>
   </p:cSld>
@@ -27836,7 +27836,7 @@
           <p:cNvPr id="2" name="TextBox 1">
             <a:extLst xmlns:a="http://schemas.openxmlformats.org/drawingml/2006/main">
               <a:ext uri="{FF2B5EF4-FFF2-40B4-BE49-F238E27FC236}">
-                <a16:creationId xmlns:a16="http://schemas.microsoft.com/office/drawing/2014/main" id="{FF8DE4A4-6A5C-4DAD-B56D-1AB1B2FDCF84}"/>
+                <a16:creationId xmlns:a16="http://schemas.microsoft.com/office/drawing/2014/main" id="{2E7FC015-72D5-4714-AC66-6E78438351CE}"/>
               </a:ext>
             </a:extLst>
           </p:cNvPr>
@@ -27883,7 +27883,7 @@
           <p:cNvPr id="3" name="TextBox 2">
             <a:extLst xmlns:a="http://schemas.openxmlformats.org/drawingml/2006/main">
               <a:ext uri="{FF2B5EF4-FFF2-40B4-BE49-F238E27FC236}">
-                <a16:creationId xmlns:a16="http://schemas.microsoft.com/office/drawing/2014/main" id="{99E642A3-30B6-40CB-A89F-EE69851C0FF2}"/>
+                <a16:creationId xmlns:a16="http://schemas.microsoft.com/office/drawing/2014/main" id="{A962FA0B-B00D-447F-9F3B-3C52DCDF23B1}"/>
               </a:ext>
             </a:extLst>
           </p:cNvPr>
@@ -27930,7 +27930,7 @@
           <p:cNvPr id="4" name="Rectangle 3">
             <a:extLst xmlns:a="http://schemas.openxmlformats.org/drawingml/2006/main">
               <a:ext uri="{FF2B5EF4-FFF2-40B4-BE49-F238E27FC236}">
-                <a16:creationId xmlns:a16="http://schemas.microsoft.com/office/drawing/2014/main" id="{DBEF5228-2563-4374-B7C4-A2D8ABF42F0C}"/>
+                <a16:creationId xmlns:a16="http://schemas.microsoft.com/office/drawing/2014/main" id="{A6400827-5BF5-4D33-BA09-25AC0A0210A2}"/>
               </a:ext>
             </a:extLst>
           </p:cNvPr>
@@ -27985,7 +27985,7 @@
           <p:cNvPr id="5" name="Rectangle 4">
             <a:extLst xmlns:a="http://schemas.openxmlformats.org/drawingml/2006/main">
               <a:ext uri="{FF2B5EF4-FFF2-40B4-BE49-F238E27FC236}">
-                <a16:creationId xmlns:a16="http://schemas.microsoft.com/office/drawing/2014/main" id="{016B532C-CE90-4171-BBD9-9E25266257D3}"/>
+                <a16:creationId xmlns:a16="http://schemas.microsoft.com/office/drawing/2014/main" id="{33BE30B5-CB65-42E8-8137-6E28E1E1FF91}"/>
               </a:ext>
             </a:extLst>
           </p:cNvPr>
@@ -28040,7 +28040,7 @@
           <p:cNvPr id="6" name="TextBox 5">
             <a:extLst xmlns:a="http://schemas.openxmlformats.org/drawingml/2006/main">
               <a:ext uri="{FF2B5EF4-FFF2-40B4-BE49-F238E27FC236}">
-                <a16:creationId xmlns:a16="http://schemas.microsoft.com/office/drawing/2014/main" id="{4DCD5D3B-6A90-4E94-B110-0E27019EB763}"/>
+                <a16:creationId xmlns:a16="http://schemas.microsoft.com/office/drawing/2014/main" id="{2D4672D3-8247-4618-906B-AC1889FA8E49}"/>
               </a:ext>
             </a:extLst>
           </p:cNvPr>
@@ -28077,7 +28077,7 @@
                 <a:ea typeface="Aptos"/>
                 <a:cs typeface="Aptos"/>
               </a:rPr>
-              <a:t>Independent public evidence summary · 2026.07.23-11 · 2026-07-22 · Sources: EP3032975B2</a:t>
+              <a:t>Independent public evidence summary · 2026.07.23-12 · 2026-07-22 · Sources: EP3032975B2</a:t>
             </a:r>
           </a:p>
         </p:txBody>
@@ -28087,7 +28087,7 @@
           <p:cNvPr id="7" name="TextBox 6">
             <a:extLst xmlns:a="http://schemas.openxmlformats.org/drawingml/2006/main">
               <a:ext uri="{FF2B5EF4-FFF2-40B4-BE49-F238E27FC236}">
-                <a16:creationId xmlns:a16="http://schemas.microsoft.com/office/drawing/2014/main" id="{BC194073-88F3-4255-A414-AE80BD72B8ED}"/>
+                <a16:creationId xmlns:a16="http://schemas.microsoft.com/office/drawing/2014/main" id="{65C37FDC-1B06-42FC-8E77-62651A5710E6}"/>
               </a:ext>
             </a:extLst>
           </p:cNvPr>
@@ -28657,7 +28657,7 @@
           <p:cNvPr id="9" name="TextBox 8">
             <a:extLst xmlns:a="http://schemas.openxmlformats.org/drawingml/2006/main">
               <a:ext uri="{FF2B5EF4-FFF2-40B4-BE49-F238E27FC236}">
-                <a16:creationId xmlns:a16="http://schemas.microsoft.com/office/drawing/2014/main" id="{009ACCB1-6B85-44E1-8551-B8604DA78E9C}"/>
+                <a16:creationId xmlns:a16="http://schemas.microsoft.com/office/drawing/2014/main" id="{AA34ADC4-7DE0-4147-B5D6-535D0127A89B}"/>
               </a:ext>
             </a:extLst>
           </p:cNvPr>
@@ -28702,7 +28702,7 @@
     </p:spTree>
     <p:extLst>
       <p:ext uri="{BB962C8B-B14F-4D97-AF65-F5344CB8AC3E}">
-        <p14:creationId xmlns:p14="http://schemas.microsoft.com/office/powerpoint/2010/main" val="1966358754"/>
+        <p14:creationId xmlns:p14="http://schemas.microsoft.com/office/powerpoint/2010/main" val="1275727853"/>
       </p:ext>
     </p:extLst>
   </p:cSld>
@@ -28726,7 +28726,7 @@
           <p:cNvPr id="2" name="TextBox 1">
             <a:extLst xmlns:a="http://schemas.openxmlformats.org/drawingml/2006/main">
               <a:ext uri="{FF2B5EF4-FFF2-40B4-BE49-F238E27FC236}">
-                <a16:creationId xmlns:a16="http://schemas.microsoft.com/office/drawing/2014/main" id="{74F5D165-78B4-4AA2-98DA-E25BE0F3205C}"/>
+                <a16:creationId xmlns:a16="http://schemas.microsoft.com/office/drawing/2014/main" id="{71B9AF21-0835-439B-9B8E-860FD478A0C6}"/>
               </a:ext>
             </a:extLst>
           </p:cNvPr>
@@ -28773,7 +28773,7 @@
           <p:cNvPr id="3" name="TextBox 2">
             <a:extLst xmlns:a="http://schemas.openxmlformats.org/drawingml/2006/main">
               <a:ext uri="{FF2B5EF4-FFF2-40B4-BE49-F238E27FC236}">
-                <a16:creationId xmlns:a16="http://schemas.microsoft.com/office/drawing/2014/main" id="{8AF31785-FAA6-41B5-AB58-9FF4D111DD39}"/>
+                <a16:creationId xmlns:a16="http://schemas.microsoft.com/office/drawing/2014/main" id="{45124C53-E805-4B81-942E-02CB24FF3E5A}"/>
               </a:ext>
             </a:extLst>
           </p:cNvPr>
@@ -28820,7 +28820,7 @@
           <p:cNvPr id="4" name="Rectangle 3">
             <a:extLst xmlns:a="http://schemas.openxmlformats.org/drawingml/2006/main">
               <a:ext uri="{FF2B5EF4-FFF2-40B4-BE49-F238E27FC236}">
-                <a16:creationId xmlns:a16="http://schemas.microsoft.com/office/drawing/2014/main" id="{8E444AF5-969E-4B2B-9A56-BC86978AAF2B}"/>
+                <a16:creationId xmlns:a16="http://schemas.microsoft.com/office/drawing/2014/main" id="{B238E8AD-26F1-4E5C-98D6-D16AEF45A745}"/>
               </a:ext>
             </a:extLst>
           </p:cNvPr>
@@ -28875,7 +28875,7 @@
           <p:cNvPr id="5" name="Rectangle 4">
             <a:extLst xmlns:a="http://schemas.openxmlformats.org/drawingml/2006/main">
               <a:ext uri="{FF2B5EF4-FFF2-40B4-BE49-F238E27FC236}">
-                <a16:creationId xmlns:a16="http://schemas.microsoft.com/office/drawing/2014/main" id="{74DA7AC1-C7A5-489E-86EE-0462245711A4}"/>
+                <a16:creationId xmlns:a16="http://schemas.microsoft.com/office/drawing/2014/main" id="{FBCCBACC-547F-4144-9B93-6C45A777E873}"/>
               </a:ext>
             </a:extLst>
           </p:cNvPr>
@@ -28930,7 +28930,7 @@
           <p:cNvPr id="6" name="TextBox 5">
             <a:extLst xmlns:a="http://schemas.openxmlformats.org/drawingml/2006/main">
               <a:ext uri="{FF2B5EF4-FFF2-40B4-BE49-F238E27FC236}">
-                <a16:creationId xmlns:a16="http://schemas.microsoft.com/office/drawing/2014/main" id="{E4097417-F8C3-4631-BDDD-16051017878A}"/>
+                <a16:creationId xmlns:a16="http://schemas.microsoft.com/office/drawing/2014/main" id="{C3A4695D-31DD-48C0-A633-32758EA3EF31}"/>
               </a:ext>
             </a:extLst>
           </p:cNvPr>
@@ -28967,7 +28967,7 @@
                 <a:ea typeface="Aptos"/>
                 <a:cs typeface="Aptos"/>
               </a:rPr>
-              <a:t>Independent public evidence summary · 2026.07.23-11 · 2026-07-22 · Sources: EPO Register; B2</a:t>
+              <a:t>Independent public evidence summary · 2026.07.23-12 · 2026-07-22 · Sources: EPO Register; B2</a:t>
             </a:r>
           </a:p>
         </p:txBody>
@@ -28977,7 +28977,7 @@
           <p:cNvPr id="7" name="TextBox 6">
             <a:extLst xmlns:a="http://schemas.openxmlformats.org/drawingml/2006/main">
               <a:ext uri="{FF2B5EF4-FFF2-40B4-BE49-F238E27FC236}">
-                <a16:creationId xmlns:a16="http://schemas.microsoft.com/office/drawing/2014/main" id="{44F9D945-A07A-46BC-8EAE-F2B521A76483}"/>
+                <a16:creationId xmlns:a16="http://schemas.microsoft.com/office/drawing/2014/main" id="{D7A884D4-CB4F-426A-9C04-43AD0BDAD917}"/>
               </a:ext>
             </a:extLst>
           </p:cNvPr>
@@ -29024,7 +29024,7 @@
           <p:cNvPr id="8" name="Rounded Rectangle 7">
             <a:extLst xmlns:a="http://schemas.openxmlformats.org/drawingml/2006/main">
               <a:ext uri="{FF2B5EF4-FFF2-40B4-BE49-F238E27FC236}">
-                <a16:creationId xmlns:a16="http://schemas.microsoft.com/office/drawing/2014/main" id="{113CFE3E-F4B3-4E96-8E59-ABA7E60C5438}"/>
+                <a16:creationId xmlns:a16="http://schemas.microsoft.com/office/drawing/2014/main" id="{DBBEF106-1D73-46D6-82A1-1C2846F94FF7}"/>
               </a:ext>
             </a:extLst>
           </p:cNvPr>
@@ -29081,7 +29081,7 @@
           <p:cNvPr id="9" name="TextBox 8">
             <a:extLst xmlns:a="http://schemas.openxmlformats.org/drawingml/2006/main">
               <a:ext uri="{FF2B5EF4-FFF2-40B4-BE49-F238E27FC236}">
-                <a16:creationId xmlns:a16="http://schemas.microsoft.com/office/drawing/2014/main" id="{09920181-5623-4541-AEBB-D6556B4F3D68}"/>
+                <a16:creationId xmlns:a16="http://schemas.microsoft.com/office/drawing/2014/main" id="{C10CCE86-8646-4867-A496-3B5E5E88C021}"/>
               </a:ext>
             </a:extLst>
           </p:cNvPr>
@@ -29128,7 +29128,7 @@
           <p:cNvPr id="10" name="TextBox 9">
             <a:extLst xmlns:a="http://schemas.openxmlformats.org/drawingml/2006/main">
               <a:ext uri="{FF2B5EF4-FFF2-40B4-BE49-F238E27FC236}">
-                <a16:creationId xmlns:a16="http://schemas.microsoft.com/office/drawing/2014/main" id="{17DA4C9E-51A2-488E-9053-96604DB8F04F}"/>
+                <a16:creationId xmlns:a16="http://schemas.microsoft.com/office/drawing/2014/main" id="{C47A6BDE-1990-43D2-A95D-3FAFA69C95BF}"/>
               </a:ext>
             </a:extLst>
           </p:cNvPr>
@@ -29175,7 +29175,7 @@
           <p:cNvPr id="11" name="Rounded Rectangle 10">
             <a:extLst xmlns:a="http://schemas.openxmlformats.org/drawingml/2006/main">
               <a:ext uri="{FF2B5EF4-FFF2-40B4-BE49-F238E27FC236}">
-                <a16:creationId xmlns:a16="http://schemas.microsoft.com/office/drawing/2014/main" id="{3B91B9B3-7B43-4F69-A830-0CD98E09521E}"/>
+                <a16:creationId xmlns:a16="http://schemas.microsoft.com/office/drawing/2014/main" id="{DA8671DD-450D-43FC-89B9-BB2F0045F6F3}"/>
               </a:ext>
             </a:extLst>
           </p:cNvPr>
@@ -29232,7 +29232,7 @@
           <p:cNvPr id="12" name="TextBox 11">
             <a:extLst xmlns:a="http://schemas.openxmlformats.org/drawingml/2006/main">
               <a:ext uri="{FF2B5EF4-FFF2-40B4-BE49-F238E27FC236}">
-                <a16:creationId xmlns:a16="http://schemas.microsoft.com/office/drawing/2014/main" id="{2BC17A2A-FEF0-49C9-BF3E-D8E1982306BC}"/>
+                <a16:creationId xmlns:a16="http://schemas.microsoft.com/office/drawing/2014/main" id="{FA3458CF-AACE-40CE-B470-46691AC23BDF}"/>
               </a:ext>
             </a:extLst>
           </p:cNvPr>
@@ -29279,7 +29279,7 @@
           <p:cNvPr id="13" name="TextBox 12">
             <a:extLst xmlns:a="http://schemas.openxmlformats.org/drawingml/2006/main">
               <a:ext uri="{FF2B5EF4-FFF2-40B4-BE49-F238E27FC236}">
-                <a16:creationId xmlns:a16="http://schemas.microsoft.com/office/drawing/2014/main" id="{BF85CDAC-4435-4F4D-8144-00C4D4BC28F9}"/>
+                <a16:creationId xmlns:a16="http://schemas.microsoft.com/office/drawing/2014/main" id="{9601FB94-3086-4D0D-8A3B-0A542647161D}"/>
               </a:ext>
             </a:extLst>
           </p:cNvPr>
@@ -29326,7 +29326,7 @@
           <p:cNvPr id="14" name="Rounded Rectangle 13">
             <a:extLst xmlns:a="http://schemas.openxmlformats.org/drawingml/2006/main">
               <a:ext uri="{FF2B5EF4-FFF2-40B4-BE49-F238E27FC236}">
-                <a16:creationId xmlns:a16="http://schemas.microsoft.com/office/drawing/2014/main" id="{A75A60BB-C0C6-4912-A904-12124ABB9524}"/>
+                <a16:creationId xmlns:a16="http://schemas.microsoft.com/office/drawing/2014/main" id="{6385ACC5-F434-4809-A7AC-6F1F8D6DC17F}"/>
               </a:ext>
             </a:extLst>
           </p:cNvPr>
@@ -29383,7 +29383,7 @@
           <p:cNvPr id="15" name="TextBox 14">
             <a:extLst xmlns:a="http://schemas.openxmlformats.org/drawingml/2006/main">
               <a:ext uri="{FF2B5EF4-FFF2-40B4-BE49-F238E27FC236}">
-                <a16:creationId xmlns:a16="http://schemas.microsoft.com/office/drawing/2014/main" id="{3E29F868-2711-41D0-A0D6-5FD8EA9B4970}"/>
+                <a16:creationId xmlns:a16="http://schemas.microsoft.com/office/drawing/2014/main" id="{B485C49C-4F31-44BB-8D71-DB6E6C0B155C}"/>
               </a:ext>
             </a:extLst>
           </p:cNvPr>
@@ -29430,7 +29430,7 @@
           <p:cNvPr id="16" name="TextBox 15">
             <a:extLst xmlns:a="http://schemas.openxmlformats.org/drawingml/2006/main">
               <a:ext uri="{FF2B5EF4-FFF2-40B4-BE49-F238E27FC236}">
-                <a16:creationId xmlns:a16="http://schemas.microsoft.com/office/drawing/2014/main" id="{325BB3C0-92F7-41E9-BCFB-1F3E0BDAAA75}"/>
+                <a16:creationId xmlns:a16="http://schemas.microsoft.com/office/drawing/2014/main" id="{E8FE9C22-98E8-49B9-BED4-558734269DA3}"/>
               </a:ext>
             </a:extLst>
           </p:cNvPr>
@@ -29477,7 +29477,7 @@
           <p:cNvPr id="17" name="TextBox 16">
             <a:extLst xmlns:a="http://schemas.openxmlformats.org/drawingml/2006/main">
               <a:ext uri="{FF2B5EF4-FFF2-40B4-BE49-F238E27FC236}">
-                <a16:creationId xmlns:a16="http://schemas.microsoft.com/office/drawing/2014/main" id="{56EA2B65-AB06-42E0-B1E1-C7AEC58EEAEF}"/>
+                <a16:creationId xmlns:a16="http://schemas.microsoft.com/office/drawing/2014/main" id="{AED967F5-66A0-4CB3-A861-06D1B11DD8B1}"/>
               </a:ext>
             </a:extLst>
           </p:cNvPr>
@@ -29524,7 +29524,7 @@
           <p:cNvPr id="18" name="Rounded Rectangle 17">
             <a:extLst xmlns:a="http://schemas.openxmlformats.org/drawingml/2006/main">
               <a:ext uri="{FF2B5EF4-FFF2-40B4-BE49-F238E27FC236}">
-                <a16:creationId xmlns:a16="http://schemas.microsoft.com/office/drawing/2014/main" id="{3DFBCA90-4152-4A46-BF95-8FDF51435BED}"/>
+                <a16:creationId xmlns:a16="http://schemas.microsoft.com/office/drawing/2014/main" id="{6A41995F-24EA-48A2-B38D-7A87DDFB1CA0}"/>
               </a:ext>
             </a:extLst>
           </p:cNvPr>
@@ -29581,7 +29581,7 @@
           <p:cNvPr id="19" name="TextBox 18">
             <a:extLst xmlns:a="http://schemas.openxmlformats.org/drawingml/2006/main">
               <a:ext uri="{FF2B5EF4-FFF2-40B4-BE49-F238E27FC236}">
-                <a16:creationId xmlns:a16="http://schemas.microsoft.com/office/drawing/2014/main" id="{A0151705-D54D-4919-B07D-0A2B314D8123}"/>
+                <a16:creationId xmlns:a16="http://schemas.microsoft.com/office/drawing/2014/main" id="{731ED684-82D8-4E4A-9FC9-97E3A964C2E5}"/>
               </a:ext>
             </a:extLst>
           </p:cNvPr>
@@ -29628,7 +29628,7 @@
           <p:cNvPr id="20" name="TextBox 19">
             <a:extLst xmlns:a="http://schemas.openxmlformats.org/drawingml/2006/main">
               <a:ext uri="{FF2B5EF4-FFF2-40B4-BE49-F238E27FC236}">
-                <a16:creationId xmlns:a16="http://schemas.microsoft.com/office/drawing/2014/main" id="{8D95D6F5-905B-4FB0-99A0-63CB195D9301}"/>
+                <a16:creationId xmlns:a16="http://schemas.microsoft.com/office/drawing/2014/main" id="{827BBAA5-A217-4303-B9C8-E6A01174DE6D}"/>
               </a:ext>
             </a:extLst>
           </p:cNvPr>
@@ -29673,7 +29673,7 @@
     </p:spTree>
     <p:extLst>
       <p:ext uri="{BB962C8B-B14F-4D97-AF65-F5344CB8AC3E}">
-        <p14:creationId xmlns:p14="http://schemas.microsoft.com/office/powerpoint/2010/main" val="928223737"/>
+        <p14:creationId xmlns:p14="http://schemas.microsoft.com/office/powerpoint/2010/main" val="1272210282"/>
       </p:ext>
     </p:extLst>
   </p:cSld>
@@ -29697,7 +29697,7 @@
           <p:cNvPr id="2" name="TextBox 1">
             <a:extLst xmlns:a="http://schemas.openxmlformats.org/drawingml/2006/main">
               <a:ext uri="{FF2B5EF4-FFF2-40B4-BE49-F238E27FC236}">
-                <a16:creationId xmlns:a16="http://schemas.microsoft.com/office/drawing/2014/main" id="{677A626B-68A9-411D-A9BA-953DB854789F}"/>
+                <a16:creationId xmlns:a16="http://schemas.microsoft.com/office/drawing/2014/main" id="{312E1CF8-5CC5-4D55-A0F4-97874B808DDE}"/>
               </a:ext>
             </a:extLst>
           </p:cNvPr>
@@ -29744,7 +29744,7 @@
           <p:cNvPr id="3" name="TextBox 2">
             <a:extLst xmlns:a="http://schemas.openxmlformats.org/drawingml/2006/main">
               <a:ext uri="{FF2B5EF4-FFF2-40B4-BE49-F238E27FC236}">
-                <a16:creationId xmlns:a16="http://schemas.microsoft.com/office/drawing/2014/main" id="{48E62AE4-9100-46FF-BA5A-A9565432C220}"/>
+                <a16:creationId xmlns:a16="http://schemas.microsoft.com/office/drawing/2014/main" id="{2EA16945-CEE0-4015-9DA9-65FE82318BCD}"/>
               </a:ext>
             </a:extLst>
           </p:cNvPr>
@@ -29791,7 +29791,7 @@
           <p:cNvPr id="4" name="Rectangle 3">
             <a:extLst xmlns:a="http://schemas.openxmlformats.org/drawingml/2006/main">
               <a:ext uri="{FF2B5EF4-FFF2-40B4-BE49-F238E27FC236}">
-                <a16:creationId xmlns:a16="http://schemas.microsoft.com/office/drawing/2014/main" id="{7932A9E7-EC1D-439C-9572-DD3ADCF892EB}"/>
+                <a16:creationId xmlns:a16="http://schemas.microsoft.com/office/drawing/2014/main" id="{7E5C43D6-3983-454F-B113-DCAAB16C9D1D}"/>
               </a:ext>
             </a:extLst>
           </p:cNvPr>
@@ -29846,7 +29846,7 @@
           <p:cNvPr id="5" name="Rectangle 4">
             <a:extLst xmlns:a="http://schemas.openxmlformats.org/drawingml/2006/main">
               <a:ext uri="{FF2B5EF4-FFF2-40B4-BE49-F238E27FC236}">
-                <a16:creationId xmlns:a16="http://schemas.microsoft.com/office/drawing/2014/main" id="{10CA9448-13BB-40E3-A35F-F96581C39F9A}"/>
+                <a16:creationId xmlns:a16="http://schemas.microsoft.com/office/drawing/2014/main" id="{45CA5238-CFEF-4EC3-BFEB-E1DB3006AC00}"/>
               </a:ext>
             </a:extLst>
           </p:cNvPr>
@@ -29901,7 +29901,7 @@
           <p:cNvPr id="6" name="TextBox 5">
             <a:extLst xmlns:a="http://schemas.openxmlformats.org/drawingml/2006/main">
               <a:ext uri="{FF2B5EF4-FFF2-40B4-BE49-F238E27FC236}">
-                <a16:creationId xmlns:a16="http://schemas.microsoft.com/office/drawing/2014/main" id="{E5431AE0-4E6A-4034-BD0F-985321CB1B52}"/>
+                <a16:creationId xmlns:a16="http://schemas.microsoft.com/office/drawing/2014/main" id="{1D4051DB-9C17-4EF8-91F1-5EDDD4ABDDBC}"/>
               </a:ext>
             </a:extLst>
           </p:cNvPr>
@@ -29938,7 +29938,7 @@
                 <a:ea typeface="Aptos"/>
                 <a:cs typeface="Aptos"/>
               </a:rPr>
-              <a:t>Independent public evidence summary · 2026.07.23-11 · 2026-07-22 · Sources: EPO family; national registers</a:t>
+              <a:t>Independent public evidence summary · 2026.07.23-12 · 2026-07-22 · Sources: EPO family; national registers</a:t>
             </a:r>
           </a:p>
         </p:txBody>
@@ -29948,7 +29948,7 @@
           <p:cNvPr id="7" name="TextBox 6">
             <a:extLst xmlns:a="http://schemas.openxmlformats.org/drawingml/2006/main">
               <a:ext uri="{FF2B5EF4-FFF2-40B4-BE49-F238E27FC236}">
-                <a16:creationId xmlns:a16="http://schemas.microsoft.com/office/drawing/2014/main" id="{510BEA92-F7D7-43C2-BE98-7D165FC04A57}"/>
+                <a16:creationId xmlns:a16="http://schemas.microsoft.com/office/drawing/2014/main" id="{097BAFDB-2722-4974-968D-75D0A770FB73}"/>
               </a:ext>
             </a:extLst>
           </p:cNvPr>
@@ -29995,7 +29995,7 @@
           <p:cNvPr id="8" name="Rounded Rectangle 7">
             <a:extLst xmlns:a="http://schemas.openxmlformats.org/drawingml/2006/main">
               <a:ext uri="{FF2B5EF4-FFF2-40B4-BE49-F238E27FC236}">
-                <a16:creationId xmlns:a16="http://schemas.microsoft.com/office/drawing/2014/main" id="{8CF93D11-9BA6-436A-A808-350FA2B7C253}"/>
+                <a16:creationId xmlns:a16="http://schemas.microsoft.com/office/drawing/2014/main" id="{C68ABCCB-B361-4233-B9B6-82AFF928CFE1}"/>
               </a:ext>
             </a:extLst>
           </p:cNvPr>
@@ -30052,7 +30052,7 @@
           <p:cNvPr id="9" name="TextBox 8">
             <a:extLst xmlns:a="http://schemas.openxmlformats.org/drawingml/2006/main">
               <a:ext uri="{FF2B5EF4-FFF2-40B4-BE49-F238E27FC236}">
-                <a16:creationId xmlns:a16="http://schemas.microsoft.com/office/drawing/2014/main" id="{F071B7D4-8792-4FFD-9135-C0DF38353F39}"/>
+                <a16:creationId xmlns:a16="http://schemas.microsoft.com/office/drawing/2014/main" id="{0BAF9EEC-1B8A-48B0-A165-09AE35FD4134}"/>
               </a:ext>
             </a:extLst>
           </p:cNvPr>
@@ -30099,7 +30099,7 @@
           <p:cNvPr id="10" name="TextBox 9">
             <a:extLst xmlns:a="http://schemas.openxmlformats.org/drawingml/2006/main">
               <a:ext uri="{FF2B5EF4-FFF2-40B4-BE49-F238E27FC236}">
-                <a16:creationId xmlns:a16="http://schemas.microsoft.com/office/drawing/2014/main" id="{3BD29D48-1FD1-4C06-ABEA-C5FCE71E993E}"/>
+                <a16:creationId xmlns:a16="http://schemas.microsoft.com/office/drawing/2014/main" id="{D59269AC-90B0-4B61-89CE-223C706A0DAE}"/>
               </a:ext>
             </a:extLst>
           </p:cNvPr>
@@ -30146,7 +30146,7 @@
           <p:cNvPr id="11" name="Rounded Rectangle 10">
             <a:extLst xmlns:a="http://schemas.openxmlformats.org/drawingml/2006/main">
               <a:ext uri="{FF2B5EF4-FFF2-40B4-BE49-F238E27FC236}">
-                <a16:creationId xmlns:a16="http://schemas.microsoft.com/office/drawing/2014/main" id="{3CF4F0E4-6888-4B83-AAC3-212474E5B216}"/>
+                <a16:creationId xmlns:a16="http://schemas.microsoft.com/office/drawing/2014/main" id="{5C77A466-D8FE-4533-B8EB-23FE4AC6DCE3}"/>
               </a:ext>
             </a:extLst>
           </p:cNvPr>
@@ -30203,7 +30203,7 @@
           <p:cNvPr id="12" name="TextBox 11">
             <a:extLst xmlns:a="http://schemas.openxmlformats.org/drawingml/2006/main">
               <a:ext uri="{FF2B5EF4-FFF2-40B4-BE49-F238E27FC236}">
-                <a16:creationId xmlns:a16="http://schemas.microsoft.com/office/drawing/2014/main" id="{F38093F4-B427-4A03-BB9D-58296D54B599}"/>
+                <a16:creationId xmlns:a16="http://schemas.microsoft.com/office/drawing/2014/main" id="{F8C3A6CA-3670-447F-A47B-458D2B4D8A02}"/>
               </a:ext>
             </a:extLst>
           </p:cNvPr>
@@ -30250,7 +30250,7 @@
           <p:cNvPr id="13" name="TextBox 12">
             <a:extLst xmlns:a="http://schemas.openxmlformats.org/drawingml/2006/main">
               <a:ext uri="{FF2B5EF4-FFF2-40B4-BE49-F238E27FC236}">
-                <a16:creationId xmlns:a16="http://schemas.microsoft.com/office/drawing/2014/main" id="{511BDCBB-E9F5-4443-BBFF-617639CB6EC5}"/>
+                <a16:creationId xmlns:a16="http://schemas.microsoft.com/office/drawing/2014/main" id="{8E617221-3ACB-44FB-B193-CB80FA2B8180}"/>
               </a:ext>
             </a:extLst>
           </p:cNvPr>
@@ -30297,7 +30297,7 @@
           <p:cNvPr id="14" name="Rounded Rectangle 13">
             <a:extLst xmlns:a="http://schemas.openxmlformats.org/drawingml/2006/main">
               <a:ext uri="{FF2B5EF4-FFF2-40B4-BE49-F238E27FC236}">
-                <a16:creationId xmlns:a16="http://schemas.microsoft.com/office/drawing/2014/main" id="{B1C4BEBD-D336-43F9-9291-3ABD18D9933F}"/>
+                <a16:creationId xmlns:a16="http://schemas.microsoft.com/office/drawing/2014/main" id="{F0402745-79B1-47CF-A8C0-EADC4F3FF715}"/>
               </a:ext>
             </a:extLst>
           </p:cNvPr>
@@ -30354,7 +30354,7 @@
           <p:cNvPr id="15" name="TextBox 14">
             <a:extLst xmlns:a="http://schemas.openxmlformats.org/drawingml/2006/main">
               <a:ext uri="{FF2B5EF4-FFF2-40B4-BE49-F238E27FC236}">
-                <a16:creationId xmlns:a16="http://schemas.microsoft.com/office/drawing/2014/main" id="{FD006DF2-96FE-4311-BAF3-F03F8A0D5F2B}"/>
+                <a16:creationId xmlns:a16="http://schemas.microsoft.com/office/drawing/2014/main" id="{E0FAFD96-4132-4A77-BADB-4D34370829DA}"/>
               </a:ext>
             </a:extLst>
           </p:cNvPr>
@@ -30401,7 +30401,7 @@
           <p:cNvPr id="16" name="TextBox 15">
             <a:extLst xmlns:a="http://schemas.openxmlformats.org/drawingml/2006/main">
               <a:ext uri="{FF2B5EF4-FFF2-40B4-BE49-F238E27FC236}">
-                <a16:creationId xmlns:a16="http://schemas.microsoft.com/office/drawing/2014/main" id="{1C6485DE-F6E8-4751-A764-DFC2598DF6E2}"/>
+                <a16:creationId xmlns:a16="http://schemas.microsoft.com/office/drawing/2014/main" id="{9F086C17-B132-4A5E-82BD-0A07910D0F75}"/>
               </a:ext>
             </a:extLst>
           </p:cNvPr>
@@ -30448,7 +30448,7 @@
           <p:cNvPr id="17" name="Rounded Rectangle 16">
             <a:extLst xmlns:a="http://schemas.openxmlformats.org/drawingml/2006/main">
               <a:ext uri="{FF2B5EF4-FFF2-40B4-BE49-F238E27FC236}">
-                <a16:creationId xmlns:a16="http://schemas.microsoft.com/office/drawing/2014/main" id="{082B5444-ED5F-4409-82A8-FD27B0DA1A7A}"/>
+                <a16:creationId xmlns:a16="http://schemas.microsoft.com/office/drawing/2014/main" id="{D7E1BE68-E25E-49BB-AA4A-664AFBD8652F}"/>
               </a:ext>
             </a:extLst>
           </p:cNvPr>
@@ -30505,7 +30505,7 @@
           <p:cNvPr id="18" name="TextBox 17">
             <a:extLst xmlns:a="http://schemas.openxmlformats.org/drawingml/2006/main">
               <a:ext uri="{FF2B5EF4-FFF2-40B4-BE49-F238E27FC236}">
-                <a16:creationId xmlns:a16="http://schemas.microsoft.com/office/drawing/2014/main" id="{B0B2B73E-8FEF-4D4F-821B-80C75B2EEB28}"/>
+                <a16:creationId xmlns:a16="http://schemas.microsoft.com/office/drawing/2014/main" id="{0B1575DA-EA48-478E-A4DD-CD8514202537}"/>
               </a:ext>
             </a:extLst>
           </p:cNvPr>
@@ -30552,7 +30552,7 @@
           <p:cNvPr id="19" name="TextBox 18">
             <a:extLst xmlns:a="http://schemas.openxmlformats.org/drawingml/2006/main">
               <a:ext uri="{FF2B5EF4-FFF2-40B4-BE49-F238E27FC236}">
-                <a16:creationId xmlns:a16="http://schemas.microsoft.com/office/drawing/2014/main" id="{89E5C34C-6E74-420D-89E9-1F4F0BED1A0E}"/>
+                <a16:creationId xmlns:a16="http://schemas.microsoft.com/office/drawing/2014/main" id="{163C0B06-090F-42F4-85D0-E0B663A0B667}"/>
               </a:ext>
             </a:extLst>
           </p:cNvPr>
@@ -30599,7 +30599,7 @@
           <p:cNvPr id="20" name="TextBox 19">
             <a:extLst xmlns:a="http://schemas.openxmlformats.org/drawingml/2006/main">
               <a:ext uri="{FF2B5EF4-FFF2-40B4-BE49-F238E27FC236}">
-                <a16:creationId xmlns:a16="http://schemas.microsoft.com/office/drawing/2014/main" id="{2B850996-9EC6-47AC-A39C-C4309EC54C14}"/>
+                <a16:creationId xmlns:a16="http://schemas.microsoft.com/office/drawing/2014/main" id="{EF7908C7-57CF-439F-A6C1-4A9F35AD6A84}"/>
               </a:ext>
             </a:extLst>
           </p:cNvPr>
@@ -30646,7 +30646,7 @@
           <p:cNvPr id="21" name="Rounded Rectangle 20">
             <a:extLst xmlns:a="http://schemas.openxmlformats.org/drawingml/2006/main">
               <a:ext uri="{FF2B5EF4-FFF2-40B4-BE49-F238E27FC236}">
-                <a16:creationId xmlns:a16="http://schemas.microsoft.com/office/drawing/2014/main" id="{93F64C6E-A643-44E9-8E41-D3BF7F5A0C17}"/>
+                <a16:creationId xmlns:a16="http://schemas.microsoft.com/office/drawing/2014/main" id="{798FBAF3-6B96-4C9A-A8A6-06D78F43DB03}"/>
               </a:ext>
             </a:extLst>
           </p:cNvPr>
@@ -30703,7 +30703,7 @@
           <p:cNvPr id="22" name="TextBox 21">
             <a:extLst xmlns:a="http://schemas.openxmlformats.org/drawingml/2006/main">
               <a:ext uri="{FF2B5EF4-FFF2-40B4-BE49-F238E27FC236}">
-                <a16:creationId xmlns:a16="http://schemas.microsoft.com/office/drawing/2014/main" id="{813C075C-AF2F-4B4B-9930-ACB3589EE91F}"/>
+                <a16:creationId xmlns:a16="http://schemas.microsoft.com/office/drawing/2014/main" id="{683104F0-A8E8-4EEE-821C-E1CF66E3C0B2}"/>
               </a:ext>
             </a:extLst>
           </p:cNvPr>
@@ -30750,7 +30750,7 @@
           <p:cNvPr id="23" name="TextBox 22">
             <a:extLst xmlns:a="http://schemas.openxmlformats.org/drawingml/2006/main">
               <a:ext uri="{FF2B5EF4-FFF2-40B4-BE49-F238E27FC236}">
-                <a16:creationId xmlns:a16="http://schemas.microsoft.com/office/drawing/2014/main" id="{069D99D1-CAC5-4A4A-8679-820DFA6630A6}"/>
+                <a16:creationId xmlns:a16="http://schemas.microsoft.com/office/drawing/2014/main" id="{9B636DDA-DA24-45EF-A9C0-44642899EA61}"/>
               </a:ext>
             </a:extLst>
           </p:cNvPr>
@@ -30795,7 +30795,7 @@
     </p:spTree>
     <p:extLst>
       <p:ext uri="{BB962C8B-B14F-4D97-AF65-F5344CB8AC3E}">
-        <p14:creationId xmlns:p14="http://schemas.microsoft.com/office/powerpoint/2010/main" val="877512683"/>
+        <p14:creationId xmlns:p14="http://schemas.microsoft.com/office/powerpoint/2010/main" val="361366820"/>
       </p:ext>
     </p:extLst>
   </p:cSld>
@@ -30819,7 +30819,7 @@
           <p:cNvPr id="2" name="TextBox 1">
             <a:extLst xmlns:a="http://schemas.openxmlformats.org/drawingml/2006/main">
               <a:ext uri="{FF2B5EF4-FFF2-40B4-BE49-F238E27FC236}">
-                <a16:creationId xmlns:a16="http://schemas.microsoft.com/office/drawing/2014/main" id="{780F40F0-D55E-4AE5-BBC6-CE185DC5D30A}"/>
+                <a16:creationId xmlns:a16="http://schemas.microsoft.com/office/drawing/2014/main" id="{9B25CA04-9F79-4389-BAC3-811F0DC34ECA}"/>
               </a:ext>
             </a:extLst>
           </p:cNvPr>
@@ -30866,7 +30866,7 @@
           <p:cNvPr id="3" name="TextBox 2">
             <a:extLst xmlns:a="http://schemas.openxmlformats.org/drawingml/2006/main">
               <a:ext uri="{FF2B5EF4-FFF2-40B4-BE49-F238E27FC236}">
-                <a16:creationId xmlns:a16="http://schemas.microsoft.com/office/drawing/2014/main" id="{70626179-8750-4975-89B0-4E2C57607FA0}"/>
+                <a16:creationId xmlns:a16="http://schemas.microsoft.com/office/drawing/2014/main" id="{AD62B9E4-4BA3-4FB2-883B-90A5C6442543}"/>
               </a:ext>
             </a:extLst>
           </p:cNvPr>
@@ -30913,7 +30913,7 @@
           <p:cNvPr id="4" name="Rectangle 3">
             <a:extLst xmlns:a="http://schemas.openxmlformats.org/drawingml/2006/main">
               <a:ext uri="{FF2B5EF4-FFF2-40B4-BE49-F238E27FC236}">
-                <a16:creationId xmlns:a16="http://schemas.microsoft.com/office/drawing/2014/main" id="{082B59DB-1535-420F-8A5F-06159F805288}"/>
+                <a16:creationId xmlns:a16="http://schemas.microsoft.com/office/drawing/2014/main" id="{6C650611-1834-4E27-897B-0A79EAB151D3}"/>
               </a:ext>
             </a:extLst>
           </p:cNvPr>
@@ -30968,7 +30968,7 @@
           <p:cNvPr id="5" name="Rectangle 4">
             <a:extLst xmlns:a="http://schemas.openxmlformats.org/drawingml/2006/main">
               <a:ext uri="{FF2B5EF4-FFF2-40B4-BE49-F238E27FC236}">
-                <a16:creationId xmlns:a16="http://schemas.microsoft.com/office/drawing/2014/main" id="{0AD85DC3-A707-42EA-8C27-D898A7060798}"/>
+                <a16:creationId xmlns:a16="http://schemas.microsoft.com/office/drawing/2014/main" id="{23B47504-3982-4DF2-A222-E208C397D0B7}"/>
               </a:ext>
             </a:extLst>
           </p:cNvPr>
@@ -31023,7 +31023,7 @@
           <p:cNvPr id="6" name="TextBox 5">
             <a:extLst xmlns:a="http://schemas.openxmlformats.org/drawingml/2006/main">
               <a:ext uri="{FF2B5EF4-FFF2-40B4-BE49-F238E27FC236}">
-                <a16:creationId xmlns:a16="http://schemas.microsoft.com/office/drawing/2014/main" id="{D48A2C9F-8BB1-47A5-B9B1-51317746BF3E}"/>
+                <a16:creationId xmlns:a16="http://schemas.microsoft.com/office/drawing/2014/main" id="{4419CF96-3761-474D-B8D6-2E7137C7F53A}"/>
               </a:ext>
             </a:extLst>
           </p:cNvPr>
@@ -31060,7 +31060,7 @@
                 <a:ea typeface="Aptos"/>
                 <a:cs typeface="Aptos"/>
               </a:rPr>
-              <a:t>Independent public evidence summary · 2026.07.23-11 · 2026-07-22 · Sources: Official judgments: 8 Ni 18/24 (EP); 7 O 3341/24</a:t>
+              <a:t>Independent public evidence summary · 2026.07.23-12 · 2026-07-22 · Sources: Official judgments: 8 Ni 18/24 (EP); 7 O 3341/24</a:t>
             </a:r>
           </a:p>
         </p:txBody>
@@ -31070,7 +31070,7 @@
           <p:cNvPr id="7" name="TextBox 6">
             <a:extLst xmlns:a="http://schemas.openxmlformats.org/drawingml/2006/main">
               <a:ext uri="{FF2B5EF4-FFF2-40B4-BE49-F238E27FC236}">
-                <a16:creationId xmlns:a16="http://schemas.microsoft.com/office/drawing/2014/main" id="{2818A023-8404-438C-A48F-2A333DB41583}"/>
+                <a16:creationId xmlns:a16="http://schemas.microsoft.com/office/drawing/2014/main" id="{7134C264-BE89-43FF-913F-96B4E00DBAA0}"/>
               </a:ext>
             </a:extLst>
           </p:cNvPr>
@@ -31391,7 +31391,7 @@
           <p:cNvPr id="9" name="TextBox 8">
             <a:extLst xmlns:a="http://schemas.openxmlformats.org/drawingml/2006/main">
               <a:ext uri="{FF2B5EF4-FFF2-40B4-BE49-F238E27FC236}">
-                <a16:creationId xmlns:a16="http://schemas.microsoft.com/office/drawing/2014/main" id="{B904C8E7-DA64-497E-96F1-2E2EC44A7B4A}"/>
+                <a16:creationId xmlns:a16="http://schemas.microsoft.com/office/drawing/2014/main" id="{127FDBB8-D214-43C1-8CEA-26141004C229}"/>
               </a:ext>
             </a:extLst>
           </p:cNvPr>
@@ -31436,7 +31436,7 @@
     </p:spTree>
     <p:extLst>
       <p:ext uri="{BB962C8B-B14F-4D97-AF65-F5344CB8AC3E}">
-        <p14:creationId xmlns:p14="http://schemas.microsoft.com/office/powerpoint/2010/main" val="273613862"/>
+        <p14:creationId xmlns:p14="http://schemas.microsoft.com/office/powerpoint/2010/main" val="335127963"/>
       </p:ext>
     </p:extLst>
   </p:cSld>

</xml_diff>

<commit_message>
Publish Canada and vendor outreach status (#10)
Publish the privacy-safe Canada dispatch and commercial outreach states, refresh the bilingual v12 evidence package, and keep all no-response and no-purchase boundaries explicit.
</commit_message>
<xml_diff>
--- a/site/downloads/pixan-bank-deck-large-en.pptx
+++ b/site/downloads/pixan-bank-deck-large-en.pptx
@@ -2,42 +2,42 @@
 <file path=ppt/presentation.xml><?xml version="1.0" encoding="utf-8"?>
 <p:presentation xmlns:p="http://schemas.openxmlformats.org/presentationml/2006/main">
   <p:sldMasterIdLst>
-    <p:sldMasterId xmlns:r="http://schemas.openxmlformats.org/officeDocument/2006/relationships" id="2147483648" r:id="Re7e2019882044e15"/>
+    <p:sldMasterId xmlns:r="http://schemas.openxmlformats.org/officeDocument/2006/relationships" id="2147483648" r:id="Rd2e224fe3a454244"/>
   </p:sldMasterIdLst>
   <p:notesMasterIdLst>
-    <p:notesMasterId xmlns:r="http://schemas.openxmlformats.org/officeDocument/2006/relationships" r:id="R802a4da9f6b44856"/>
+    <p:notesMasterId xmlns:r="http://schemas.openxmlformats.org/officeDocument/2006/relationships" r:id="Rbb1a95e66067492f"/>
   </p:notesMasterIdLst>
   <p:sldIdLst>
-    <p:sldId xmlns:r="http://schemas.openxmlformats.org/officeDocument/2006/relationships" id="256" r:id="Rdbd15247a94a47c9"/>
-    <p:sldId xmlns:r="http://schemas.openxmlformats.org/officeDocument/2006/relationships" id="257" r:id="R802680e7c5454b62"/>
-    <p:sldId xmlns:r="http://schemas.openxmlformats.org/officeDocument/2006/relationships" id="258" r:id="R6a3b740eaf304d7e"/>
-    <p:sldId xmlns:r="http://schemas.openxmlformats.org/officeDocument/2006/relationships" id="259" r:id="Rf9e6902db2fb4af2"/>
-    <p:sldId xmlns:r="http://schemas.openxmlformats.org/officeDocument/2006/relationships" id="260" r:id="Rf24a7298b3c54671"/>
-    <p:sldId xmlns:r="http://schemas.openxmlformats.org/officeDocument/2006/relationships" id="261" r:id="R8e88cf1d30f94d03"/>
-    <p:sldId xmlns:r="http://schemas.openxmlformats.org/officeDocument/2006/relationships" id="262" r:id="Rdc6bff2d12d843c2"/>
-    <p:sldId xmlns:r="http://schemas.openxmlformats.org/officeDocument/2006/relationships" id="263" r:id="Rf9fc0559d19348b9"/>
-    <p:sldId xmlns:r="http://schemas.openxmlformats.org/officeDocument/2006/relationships" id="264" r:id="R3ab9a4e3a6694c58"/>
-    <p:sldId xmlns:r="http://schemas.openxmlformats.org/officeDocument/2006/relationships" id="265" r:id="R69c792d8e6cf4051"/>
-    <p:sldId xmlns:r="http://schemas.openxmlformats.org/officeDocument/2006/relationships" id="266" r:id="R3d78e3a944a34bfd"/>
-    <p:sldId xmlns:r="http://schemas.openxmlformats.org/officeDocument/2006/relationships" id="267" r:id="R16d05dcf2bda430a"/>
-    <p:sldId xmlns:r="http://schemas.openxmlformats.org/officeDocument/2006/relationships" id="268" r:id="R70c5d9cc9b0a4f9b"/>
-    <p:sldId xmlns:r="http://schemas.openxmlformats.org/officeDocument/2006/relationships" id="269" r:id="Ra951ebbdf946466c"/>
-    <p:sldId xmlns:r="http://schemas.openxmlformats.org/officeDocument/2006/relationships" id="270" r:id="R8dc1785b943e4640"/>
-    <p:sldId xmlns:r="http://schemas.openxmlformats.org/officeDocument/2006/relationships" id="271" r:id="Rde5e759cb18a42b2"/>
-    <p:sldId xmlns:r="http://schemas.openxmlformats.org/officeDocument/2006/relationships" id="272" r:id="R1737235b89ba458a"/>
-    <p:sldId xmlns:r="http://schemas.openxmlformats.org/officeDocument/2006/relationships" id="273" r:id="Ra10f2db6d21b44d5"/>
-    <p:sldId xmlns:r="http://schemas.openxmlformats.org/officeDocument/2006/relationships" id="274" r:id="Rc2ff847a2f634276"/>
-    <p:sldId xmlns:r="http://schemas.openxmlformats.org/officeDocument/2006/relationships" id="275" r:id="R9d4c8068f8e24008"/>
-    <p:sldId xmlns:r="http://schemas.openxmlformats.org/officeDocument/2006/relationships" id="276" r:id="R42003a71fd2449c4"/>
-    <p:sldId xmlns:r="http://schemas.openxmlformats.org/officeDocument/2006/relationships" id="277" r:id="Rcde60cb5432e4778"/>
-    <p:sldId xmlns:r="http://schemas.openxmlformats.org/officeDocument/2006/relationships" id="278" r:id="R89819fbbe5c74fe1"/>
-    <p:sldId xmlns:r="http://schemas.openxmlformats.org/officeDocument/2006/relationships" id="279" r:id="Rf955841f08cb474c"/>
-    <p:sldId xmlns:r="http://schemas.openxmlformats.org/officeDocument/2006/relationships" id="280" r:id="R840335f4bca249a9"/>
-    <p:sldId xmlns:r="http://schemas.openxmlformats.org/officeDocument/2006/relationships" id="281" r:id="Ra1af903b893b4d96"/>
-    <p:sldId xmlns:r="http://schemas.openxmlformats.org/officeDocument/2006/relationships" id="282" r:id="R852c1820c4d44844"/>
-    <p:sldId xmlns:r="http://schemas.openxmlformats.org/officeDocument/2006/relationships" id="283" r:id="R6e40e57a34284278"/>
-    <p:sldId xmlns:r="http://schemas.openxmlformats.org/officeDocument/2006/relationships" id="284" r:id="Rddecc54555734b2f"/>
-    <p:sldId xmlns:r="http://schemas.openxmlformats.org/officeDocument/2006/relationships" id="285" r:id="R8f28f120f45d4582"/>
+    <p:sldId xmlns:r="http://schemas.openxmlformats.org/officeDocument/2006/relationships" id="256" r:id="Ra483134e8296466d"/>
+    <p:sldId xmlns:r="http://schemas.openxmlformats.org/officeDocument/2006/relationships" id="257" r:id="R2ef9fc31563c407a"/>
+    <p:sldId xmlns:r="http://schemas.openxmlformats.org/officeDocument/2006/relationships" id="258" r:id="Rf1f2da0fa10e465f"/>
+    <p:sldId xmlns:r="http://schemas.openxmlformats.org/officeDocument/2006/relationships" id="259" r:id="R84b31a42834f4533"/>
+    <p:sldId xmlns:r="http://schemas.openxmlformats.org/officeDocument/2006/relationships" id="260" r:id="Rfccecb6b1926426a"/>
+    <p:sldId xmlns:r="http://schemas.openxmlformats.org/officeDocument/2006/relationships" id="261" r:id="R5f75e6d5e76c440d"/>
+    <p:sldId xmlns:r="http://schemas.openxmlformats.org/officeDocument/2006/relationships" id="262" r:id="Rc6b0f2e59b714646"/>
+    <p:sldId xmlns:r="http://schemas.openxmlformats.org/officeDocument/2006/relationships" id="263" r:id="Rc80d1822cb404a18"/>
+    <p:sldId xmlns:r="http://schemas.openxmlformats.org/officeDocument/2006/relationships" id="264" r:id="R2053ebffc0de4173"/>
+    <p:sldId xmlns:r="http://schemas.openxmlformats.org/officeDocument/2006/relationships" id="265" r:id="R7e36e56679eb4ad9"/>
+    <p:sldId xmlns:r="http://schemas.openxmlformats.org/officeDocument/2006/relationships" id="266" r:id="R38b3616dbdc3498d"/>
+    <p:sldId xmlns:r="http://schemas.openxmlformats.org/officeDocument/2006/relationships" id="267" r:id="R08d742e9d13444ea"/>
+    <p:sldId xmlns:r="http://schemas.openxmlformats.org/officeDocument/2006/relationships" id="268" r:id="R28322da567d74d2f"/>
+    <p:sldId xmlns:r="http://schemas.openxmlformats.org/officeDocument/2006/relationships" id="269" r:id="Ref11d4629d404c45"/>
+    <p:sldId xmlns:r="http://schemas.openxmlformats.org/officeDocument/2006/relationships" id="270" r:id="R49a4bab82bd24d41"/>
+    <p:sldId xmlns:r="http://schemas.openxmlformats.org/officeDocument/2006/relationships" id="271" r:id="R4f9a341118704480"/>
+    <p:sldId xmlns:r="http://schemas.openxmlformats.org/officeDocument/2006/relationships" id="272" r:id="Rc7aa13dff0d3478d"/>
+    <p:sldId xmlns:r="http://schemas.openxmlformats.org/officeDocument/2006/relationships" id="273" r:id="R9031f97c040743d4"/>
+    <p:sldId xmlns:r="http://schemas.openxmlformats.org/officeDocument/2006/relationships" id="274" r:id="R6d2b9de33383417c"/>
+    <p:sldId xmlns:r="http://schemas.openxmlformats.org/officeDocument/2006/relationships" id="275" r:id="Rc1839c8e24e3439e"/>
+    <p:sldId xmlns:r="http://schemas.openxmlformats.org/officeDocument/2006/relationships" id="276" r:id="R27abceca58a346e5"/>
+    <p:sldId xmlns:r="http://schemas.openxmlformats.org/officeDocument/2006/relationships" id="277" r:id="R74fb0c3918da41fa"/>
+    <p:sldId xmlns:r="http://schemas.openxmlformats.org/officeDocument/2006/relationships" id="278" r:id="R38705f1777d347bb"/>
+    <p:sldId xmlns:r="http://schemas.openxmlformats.org/officeDocument/2006/relationships" id="279" r:id="Ref1ee7d5a61e49a9"/>
+    <p:sldId xmlns:r="http://schemas.openxmlformats.org/officeDocument/2006/relationships" id="280" r:id="Rec8e979fa02a4cb7"/>
+    <p:sldId xmlns:r="http://schemas.openxmlformats.org/officeDocument/2006/relationships" id="281" r:id="R1867cadd94df4f5c"/>
+    <p:sldId xmlns:r="http://schemas.openxmlformats.org/officeDocument/2006/relationships" id="282" r:id="R3f80f991fa4a4433"/>
+    <p:sldId xmlns:r="http://schemas.openxmlformats.org/officeDocument/2006/relationships" id="283" r:id="Rea9a9e5320b84382"/>
+    <p:sldId xmlns:r="http://schemas.openxmlformats.org/officeDocument/2006/relationships" id="284" r:id="R5b52f8a31ae14a4e"/>
+    <p:sldId xmlns:r="http://schemas.openxmlformats.org/officeDocument/2006/relationships" id="285" r:id="Rdf722b25b4544ead"/>
   </p:sldIdLst>
   <p:sldSz cx="12191999" cy="6858000"/>
   <p:notesSz cx="6858000" cy="9144000"/>
@@ -2546,7 +2546,7 @@
           <p:cNvPr id="2" name="Title 1">
             <a:extLst xmlns:a="http://schemas.openxmlformats.org/drawingml/2006/main">
               <a:ext uri="{FF2B5EF4-FFF2-40B4-BE49-F238E27FC236}">
-                <a16:creationId xmlns:a16="http://schemas.microsoft.com/office/drawing/2014/main" id="{F7809EC4-1F78-491A-AF12-7F3FE2CAA5B3}"/>
+                <a16:creationId xmlns:a16="http://schemas.microsoft.com/office/drawing/2014/main" id="{DE9CFF5A-54FC-441F-9668-FB1DBC4CA307}"/>
               </a:ext>
             </a:extLst>
           </p:cNvPr>
@@ -2578,7 +2578,7 @@
           <p:cNvPr id="3" name="Subtitle 2">
             <a:extLst xmlns:a="http://schemas.openxmlformats.org/drawingml/2006/main">
               <a:ext uri="{FF2B5EF4-FFF2-40B4-BE49-F238E27FC236}">
-                <a16:creationId xmlns:a16="http://schemas.microsoft.com/office/drawing/2014/main" id="{CAEF7FD6-62F5-4688-A062-8EB20C9FC22F}"/>
+                <a16:creationId xmlns:a16="http://schemas.microsoft.com/office/drawing/2014/main" id="{B9BCB151-1028-4D47-8CD7-FB6BA387F8EB}"/>
               </a:ext>
             </a:extLst>
           </p:cNvPr>
@@ -2701,7 +2701,7 @@
           <p:cNvPr id="4" name="Date Placeholder 3">
             <a:extLst xmlns:a="http://schemas.openxmlformats.org/drawingml/2006/main">
               <a:ext uri="{FF2B5EF4-FFF2-40B4-BE49-F238E27FC236}">
-                <a16:creationId xmlns:a16="http://schemas.microsoft.com/office/drawing/2014/main" id="{1717D429-BDD1-412D-AD1C-B968E7E4E6D3}"/>
+                <a16:creationId xmlns:a16="http://schemas.microsoft.com/office/drawing/2014/main" id="{656BE47E-0F38-4A4E-B361-1C54B0CBCF6D}"/>
               </a:ext>
             </a:extLst>
           </p:cNvPr>
@@ -2728,7 +2728,7 @@
           <p:cNvPr id="5" name="Footer Placeholder 4">
             <a:extLst xmlns:a="http://schemas.openxmlformats.org/drawingml/2006/main">
               <a:ext uri="{FF2B5EF4-FFF2-40B4-BE49-F238E27FC236}">
-                <a16:creationId xmlns:a16="http://schemas.microsoft.com/office/drawing/2014/main" id="{5C8FEBEC-CD04-4E11-B74D-589655BD46E3}"/>
+                <a16:creationId xmlns:a16="http://schemas.microsoft.com/office/drawing/2014/main" id="{66F49BAD-6DE0-4DEC-9445-FEA00FA365BB}"/>
               </a:ext>
             </a:extLst>
           </p:cNvPr>
@@ -2751,7 +2751,7 @@
           <p:cNvPr id="6" name="Slide Number Placeholder 5">
             <a:extLst xmlns:a="http://schemas.openxmlformats.org/drawingml/2006/main">
               <a:ext uri="{FF2B5EF4-FFF2-40B4-BE49-F238E27FC236}">
-                <a16:creationId xmlns:a16="http://schemas.microsoft.com/office/drawing/2014/main" id="{B617E9FC-5FD3-4A9A-93C5-78E344B8B68A}"/>
+                <a16:creationId xmlns:a16="http://schemas.microsoft.com/office/drawing/2014/main" id="{62A7EE25-A5A5-42CB-B711-3FD73816C11C}"/>
               </a:ext>
             </a:extLst>
           </p:cNvPr>
@@ -2795,7 +2795,7 @@
           <p:cNvPr id="2" name="Title 1">
             <a:extLst xmlns:a="http://schemas.openxmlformats.org/drawingml/2006/main">
               <a:ext uri="{FF2B5EF4-FFF2-40B4-BE49-F238E27FC236}">
-                <a16:creationId xmlns:a16="http://schemas.microsoft.com/office/drawing/2014/main" id="{4F0BE108-02BC-4BE7-B4E8-730C0C756B65}"/>
+                <a16:creationId xmlns:a16="http://schemas.microsoft.com/office/drawing/2014/main" id="{A6DFA2BB-1C27-4C0B-A030-96EED4F6CC5E}"/>
               </a:ext>
             </a:extLst>
           </p:cNvPr>
@@ -2822,7 +2822,7 @@
           <p:cNvPr id="3" name="Vertical Text Placeholder 2">
             <a:extLst xmlns:a="http://schemas.openxmlformats.org/drawingml/2006/main">
               <a:ext uri="{FF2B5EF4-FFF2-40B4-BE49-F238E27FC236}">
-                <a16:creationId xmlns:a16="http://schemas.microsoft.com/office/drawing/2014/main" id="{EE79F35C-3D32-4F47-9FBA-9097CA82CB23}"/>
+                <a16:creationId xmlns:a16="http://schemas.microsoft.com/office/drawing/2014/main" id="{2E464A65-2B46-4918-A1F7-5235EA204002}"/>
               </a:ext>
             </a:extLst>
           </p:cNvPr>
@@ -2884,7 +2884,7 @@
           <p:cNvPr id="4" name="Date Placeholder 3">
             <a:extLst xmlns:a="http://schemas.openxmlformats.org/drawingml/2006/main">
               <a:ext uri="{FF2B5EF4-FFF2-40B4-BE49-F238E27FC236}">
-                <a16:creationId xmlns:a16="http://schemas.microsoft.com/office/drawing/2014/main" id="{5645855B-22BE-4720-AB75-F9E3CB80BDE5}"/>
+                <a16:creationId xmlns:a16="http://schemas.microsoft.com/office/drawing/2014/main" id="{8ED6EC88-9431-4B00-A0A3-CDB9B640D80B}"/>
               </a:ext>
             </a:extLst>
           </p:cNvPr>
@@ -2911,7 +2911,7 @@
           <p:cNvPr id="5" name="Footer Placeholder 4">
             <a:extLst xmlns:a="http://schemas.openxmlformats.org/drawingml/2006/main">
               <a:ext uri="{FF2B5EF4-FFF2-40B4-BE49-F238E27FC236}">
-                <a16:creationId xmlns:a16="http://schemas.microsoft.com/office/drawing/2014/main" id="{612D3F85-D364-40F7-96B2-AA032F16DA5F}"/>
+                <a16:creationId xmlns:a16="http://schemas.microsoft.com/office/drawing/2014/main" id="{53EF5121-CEF9-4811-B878-3F6AFF0F4235}"/>
               </a:ext>
             </a:extLst>
           </p:cNvPr>
@@ -2934,7 +2934,7 @@
           <p:cNvPr id="6" name="Slide Number Placeholder 5">
             <a:extLst xmlns:a="http://schemas.openxmlformats.org/drawingml/2006/main">
               <a:ext uri="{FF2B5EF4-FFF2-40B4-BE49-F238E27FC236}">
-                <a16:creationId xmlns:a16="http://schemas.microsoft.com/office/drawing/2014/main" id="{2494F1CA-EA7B-4905-B1C8-758D7A236FE8}"/>
+                <a16:creationId xmlns:a16="http://schemas.microsoft.com/office/drawing/2014/main" id="{BEBA299E-4885-4D58-8E92-E64E6E67DC9E}"/>
               </a:ext>
             </a:extLst>
           </p:cNvPr>
@@ -2978,7 +2978,7 @@
           <p:cNvPr id="2" name="Vertical Title 1">
             <a:extLst xmlns:a="http://schemas.openxmlformats.org/drawingml/2006/main">
               <a:ext uri="{FF2B5EF4-FFF2-40B4-BE49-F238E27FC236}">
-                <a16:creationId xmlns:a16="http://schemas.microsoft.com/office/drawing/2014/main" id="{D8624403-4E97-4391-8FE0-F217F20E636A}"/>
+                <a16:creationId xmlns:a16="http://schemas.microsoft.com/office/drawing/2014/main" id="{E5B27A54-182B-4412-9876-9A5846BCD946}"/>
               </a:ext>
             </a:extLst>
           </p:cNvPr>
@@ -3010,7 +3010,7 @@
           <p:cNvPr id="3" name="Vertical Text Placeholder 2">
             <a:extLst xmlns:a="http://schemas.openxmlformats.org/drawingml/2006/main">
               <a:ext uri="{FF2B5EF4-FFF2-40B4-BE49-F238E27FC236}">
-                <a16:creationId xmlns:a16="http://schemas.microsoft.com/office/drawing/2014/main" id="{4645BA77-FD9C-4B47-8ECD-8F35F37E42BF}"/>
+                <a16:creationId xmlns:a16="http://schemas.microsoft.com/office/drawing/2014/main" id="{E4BDE4E6-6AC0-4965-B3B5-F69AC680A65E}"/>
               </a:ext>
             </a:extLst>
           </p:cNvPr>
@@ -3077,7 +3077,7 @@
           <p:cNvPr id="4" name="Date Placeholder 3">
             <a:extLst xmlns:a="http://schemas.openxmlformats.org/drawingml/2006/main">
               <a:ext uri="{FF2B5EF4-FFF2-40B4-BE49-F238E27FC236}">
-                <a16:creationId xmlns:a16="http://schemas.microsoft.com/office/drawing/2014/main" id="{A90F3831-201B-48AA-BA53-7B69D200B3C2}"/>
+                <a16:creationId xmlns:a16="http://schemas.microsoft.com/office/drawing/2014/main" id="{35109CCA-D241-4CB2-BA18-D3DD576FF24A}"/>
               </a:ext>
             </a:extLst>
           </p:cNvPr>
@@ -3104,7 +3104,7 @@
           <p:cNvPr id="5" name="Footer Placeholder 4">
             <a:extLst xmlns:a="http://schemas.openxmlformats.org/drawingml/2006/main">
               <a:ext uri="{FF2B5EF4-FFF2-40B4-BE49-F238E27FC236}">
-                <a16:creationId xmlns:a16="http://schemas.microsoft.com/office/drawing/2014/main" id="{A16A7CF0-5011-40CD-BB42-D2E86B51F4CC}"/>
+                <a16:creationId xmlns:a16="http://schemas.microsoft.com/office/drawing/2014/main" id="{1091C4B0-9245-4D19-BF9F-00B250BD5792}"/>
               </a:ext>
             </a:extLst>
           </p:cNvPr>
@@ -3127,7 +3127,7 @@
           <p:cNvPr id="6" name="Slide Number Placeholder 5">
             <a:extLst xmlns:a="http://schemas.openxmlformats.org/drawingml/2006/main">
               <a:ext uri="{FF2B5EF4-FFF2-40B4-BE49-F238E27FC236}">
-                <a16:creationId xmlns:a16="http://schemas.microsoft.com/office/drawing/2014/main" id="{6BC1D610-9494-4800-9188-3D5A9E49A19E}"/>
+                <a16:creationId xmlns:a16="http://schemas.microsoft.com/office/drawing/2014/main" id="{52DCA9A3-4AAE-4A58-9997-D113BA466620}"/>
               </a:ext>
             </a:extLst>
           </p:cNvPr>
@@ -3171,7 +3171,7 @@
           <p:cNvPr id="2" name="Title 1">
             <a:extLst xmlns:a="http://schemas.openxmlformats.org/drawingml/2006/main">
               <a:ext uri="{FF2B5EF4-FFF2-40B4-BE49-F238E27FC236}">
-                <a16:creationId xmlns:a16="http://schemas.microsoft.com/office/drawing/2014/main" id="{E7DD1674-2CC6-4D95-A90D-5058F88EBDF6}"/>
+                <a16:creationId xmlns:a16="http://schemas.microsoft.com/office/drawing/2014/main" id="{F9B00567-7947-4401-9650-1C1F39D9E37F}"/>
               </a:ext>
             </a:extLst>
           </p:cNvPr>
@@ -3198,7 +3198,7 @@
           <p:cNvPr id="3" name="Content Placeholder 2">
             <a:extLst xmlns:a="http://schemas.openxmlformats.org/drawingml/2006/main">
               <a:ext uri="{FF2B5EF4-FFF2-40B4-BE49-F238E27FC236}">
-                <a16:creationId xmlns:a16="http://schemas.microsoft.com/office/drawing/2014/main" id="{FA7AB130-F27B-4213-BCF3-4BF73361BC04}"/>
+                <a16:creationId xmlns:a16="http://schemas.microsoft.com/office/drawing/2014/main" id="{8D28E0C2-83F7-4661-84E0-FC44D0FC2048}"/>
               </a:ext>
             </a:extLst>
           </p:cNvPr>
@@ -3260,7 +3260,7 @@
           <p:cNvPr id="4" name="Date Placeholder 3">
             <a:extLst xmlns:a="http://schemas.openxmlformats.org/drawingml/2006/main">
               <a:ext uri="{FF2B5EF4-FFF2-40B4-BE49-F238E27FC236}">
-                <a16:creationId xmlns:a16="http://schemas.microsoft.com/office/drawing/2014/main" id="{43FCC16E-437D-49CA-9272-EF238AB79849}"/>
+                <a16:creationId xmlns:a16="http://schemas.microsoft.com/office/drawing/2014/main" id="{AD5F40FC-0B66-4A3A-BD13-8EAE97625ADA}"/>
               </a:ext>
             </a:extLst>
           </p:cNvPr>
@@ -3287,7 +3287,7 @@
           <p:cNvPr id="5" name="Footer Placeholder 4">
             <a:extLst xmlns:a="http://schemas.openxmlformats.org/drawingml/2006/main">
               <a:ext uri="{FF2B5EF4-FFF2-40B4-BE49-F238E27FC236}">
-                <a16:creationId xmlns:a16="http://schemas.microsoft.com/office/drawing/2014/main" id="{ED416D9B-4B77-416F-88D8-F2976A2F9DB5}"/>
+                <a16:creationId xmlns:a16="http://schemas.microsoft.com/office/drawing/2014/main" id="{EF3732AE-2455-4934-9264-FEFA0D499AEF}"/>
               </a:ext>
             </a:extLst>
           </p:cNvPr>
@@ -3310,7 +3310,7 @@
           <p:cNvPr id="6" name="Slide Number Placeholder 5">
             <a:extLst xmlns:a="http://schemas.openxmlformats.org/drawingml/2006/main">
               <a:ext uri="{FF2B5EF4-FFF2-40B4-BE49-F238E27FC236}">
-                <a16:creationId xmlns:a16="http://schemas.microsoft.com/office/drawing/2014/main" id="{3EF9937D-A620-4720-BBC6-A2F488E48C1E}"/>
+                <a16:creationId xmlns:a16="http://schemas.microsoft.com/office/drawing/2014/main" id="{9575C7CA-4A93-407E-BDA8-7A477DDA1A4B}"/>
               </a:ext>
             </a:extLst>
           </p:cNvPr>
@@ -3354,7 +3354,7 @@
           <p:cNvPr id="2" name="Title 1">
             <a:extLst xmlns:a="http://schemas.openxmlformats.org/drawingml/2006/main">
               <a:ext uri="{FF2B5EF4-FFF2-40B4-BE49-F238E27FC236}">
-                <a16:creationId xmlns:a16="http://schemas.microsoft.com/office/drawing/2014/main" id="{94E9EF8A-FC8B-46CE-962B-AD19D8581E71}"/>
+                <a16:creationId xmlns:a16="http://schemas.microsoft.com/office/drawing/2014/main" id="{EEF637FB-9536-433C-AB37-9D4112EF0732}"/>
               </a:ext>
             </a:extLst>
           </p:cNvPr>
@@ -3391,7 +3391,7 @@
           <p:cNvPr id="3" name="Text Placeholder 2">
             <a:extLst xmlns:a="http://schemas.openxmlformats.org/drawingml/2006/main">
               <a:ext uri="{FF2B5EF4-FFF2-40B4-BE49-F238E27FC236}">
-                <a16:creationId xmlns:a16="http://schemas.microsoft.com/office/drawing/2014/main" id="{513D9717-1828-49AD-9F8C-4FDAA641A6CC}"/>
+                <a16:creationId xmlns:a16="http://schemas.microsoft.com/office/drawing/2014/main" id="{28B14ED7-E9CB-4334-948C-1C4752FA125A}"/>
               </a:ext>
             </a:extLst>
           </p:cNvPr>
@@ -3517,7 +3517,7 @@
           <p:cNvPr id="4" name="Date Placeholder 3">
             <a:extLst xmlns:a="http://schemas.openxmlformats.org/drawingml/2006/main">
               <a:ext uri="{FF2B5EF4-FFF2-40B4-BE49-F238E27FC236}">
-                <a16:creationId xmlns:a16="http://schemas.microsoft.com/office/drawing/2014/main" id="{B578AB29-2FAD-4ECF-9BB8-99263C16D722}"/>
+                <a16:creationId xmlns:a16="http://schemas.microsoft.com/office/drawing/2014/main" id="{625A9DC9-98F1-4DC3-914A-87F847B1236F}"/>
               </a:ext>
             </a:extLst>
           </p:cNvPr>
@@ -3544,7 +3544,7 @@
           <p:cNvPr id="5" name="Footer Placeholder 4">
             <a:extLst xmlns:a="http://schemas.openxmlformats.org/drawingml/2006/main">
               <a:ext uri="{FF2B5EF4-FFF2-40B4-BE49-F238E27FC236}">
-                <a16:creationId xmlns:a16="http://schemas.microsoft.com/office/drawing/2014/main" id="{9A1760C3-2F0C-4B48-BA15-018AE0FDAF46}"/>
+                <a16:creationId xmlns:a16="http://schemas.microsoft.com/office/drawing/2014/main" id="{31DE74AD-EF91-4647-9552-9BD2B22F4233}"/>
               </a:ext>
             </a:extLst>
           </p:cNvPr>
@@ -3567,7 +3567,7 @@
           <p:cNvPr id="6" name="Slide Number Placeholder 5">
             <a:extLst xmlns:a="http://schemas.openxmlformats.org/drawingml/2006/main">
               <a:ext uri="{FF2B5EF4-FFF2-40B4-BE49-F238E27FC236}">
-                <a16:creationId xmlns:a16="http://schemas.microsoft.com/office/drawing/2014/main" id="{1C85D8CD-FD29-4DC1-86B1-749BF7E81972}"/>
+                <a16:creationId xmlns:a16="http://schemas.microsoft.com/office/drawing/2014/main" id="{95875645-1F33-409D-9625-62B92E7D69DF}"/>
               </a:ext>
             </a:extLst>
           </p:cNvPr>
@@ -3611,7 +3611,7 @@
           <p:cNvPr id="2" name="Title 1">
             <a:extLst xmlns:a="http://schemas.openxmlformats.org/drawingml/2006/main">
               <a:ext uri="{FF2B5EF4-FFF2-40B4-BE49-F238E27FC236}">
-                <a16:creationId xmlns:a16="http://schemas.microsoft.com/office/drawing/2014/main" id="{2BF5DFF3-EC5D-46C6-94AC-C6D84D3B6AAC}"/>
+                <a16:creationId xmlns:a16="http://schemas.microsoft.com/office/drawing/2014/main" id="{52792A39-F1A8-49B7-A4B6-DEF9C887F883}"/>
               </a:ext>
             </a:extLst>
           </p:cNvPr>
@@ -3638,7 +3638,7 @@
           <p:cNvPr id="3" name="Content Placeholder 2">
             <a:extLst xmlns:a="http://schemas.openxmlformats.org/drawingml/2006/main">
               <a:ext uri="{FF2B5EF4-FFF2-40B4-BE49-F238E27FC236}">
-                <a16:creationId xmlns:a16="http://schemas.microsoft.com/office/drawing/2014/main" id="{F01F61E4-4662-4819-B1D1-1C90220B952E}"/>
+                <a16:creationId xmlns:a16="http://schemas.microsoft.com/office/drawing/2014/main" id="{C9D837DB-23B4-4450-9FE5-3CF40D79C091}"/>
               </a:ext>
             </a:extLst>
           </p:cNvPr>
@@ -3742,7 +3742,7 @@
           <p:cNvPr id="4" name="Content Placeholder 3">
             <a:extLst xmlns:a="http://schemas.openxmlformats.org/drawingml/2006/main">
               <a:ext uri="{FF2B5EF4-FFF2-40B4-BE49-F238E27FC236}">
-                <a16:creationId xmlns:a16="http://schemas.microsoft.com/office/drawing/2014/main" id="{2DDF5A29-C6D5-4351-8284-82A93160589D}"/>
+                <a16:creationId xmlns:a16="http://schemas.microsoft.com/office/drawing/2014/main" id="{BE21CE5C-EEDC-4E89-9864-9A9DB80F85A5}"/>
               </a:ext>
             </a:extLst>
           </p:cNvPr>
@@ -3846,7 +3846,7 @@
           <p:cNvPr id="5" name="Date Placeholder 4">
             <a:extLst xmlns:a="http://schemas.openxmlformats.org/drawingml/2006/main">
               <a:ext uri="{FF2B5EF4-FFF2-40B4-BE49-F238E27FC236}">
-                <a16:creationId xmlns:a16="http://schemas.microsoft.com/office/drawing/2014/main" id="{57588AA8-06C6-4FC7-9410-96411EA19D0E}"/>
+                <a16:creationId xmlns:a16="http://schemas.microsoft.com/office/drawing/2014/main" id="{523B3672-6E5F-485A-AC8A-56721F51E1E9}"/>
               </a:ext>
             </a:extLst>
           </p:cNvPr>
@@ -3873,7 +3873,7 @@
           <p:cNvPr id="6" name="Footer Placeholder 5">
             <a:extLst xmlns:a="http://schemas.openxmlformats.org/drawingml/2006/main">
               <a:ext uri="{FF2B5EF4-FFF2-40B4-BE49-F238E27FC236}">
-                <a16:creationId xmlns:a16="http://schemas.microsoft.com/office/drawing/2014/main" id="{A9A066A5-69DE-4CFC-A9BB-A7E6CE5D583A}"/>
+                <a16:creationId xmlns:a16="http://schemas.microsoft.com/office/drawing/2014/main" id="{B8ED130F-5BC9-4340-A408-9D5B69074E23}"/>
               </a:ext>
             </a:extLst>
           </p:cNvPr>
@@ -3896,7 +3896,7 @@
           <p:cNvPr id="7" name="Slide Number Placeholder 6">
             <a:extLst xmlns:a="http://schemas.openxmlformats.org/drawingml/2006/main">
               <a:ext uri="{FF2B5EF4-FFF2-40B4-BE49-F238E27FC236}">
-                <a16:creationId xmlns:a16="http://schemas.microsoft.com/office/drawing/2014/main" id="{75451068-69CD-4064-A47D-4810E6053730}"/>
+                <a16:creationId xmlns:a16="http://schemas.microsoft.com/office/drawing/2014/main" id="{B52D8756-5E29-4364-A93A-4FB27C4121FD}"/>
               </a:ext>
             </a:extLst>
           </p:cNvPr>
@@ -3940,7 +3940,7 @@
           <p:cNvPr id="2" name="Title 1">
             <a:extLst xmlns:a="http://schemas.openxmlformats.org/drawingml/2006/main">
               <a:ext uri="{FF2B5EF4-FFF2-40B4-BE49-F238E27FC236}">
-                <a16:creationId xmlns:a16="http://schemas.microsoft.com/office/drawing/2014/main" id="{157A8D42-2B93-4123-A4FB-9A0B190FAC51}"/>
+                <a16:creationId xmlns:a16="http://schemas.microsoft.com/office/drawing/2014/main" id="{9BDFE8A3-BFFE-4054-983C-0AC5702709A0}"/>
               </a:ext>
             </a:extLst>
           </p:cNvPr>
@@ -3972,7 +3972,7 @@
           <p:cNvPr id="3" name="Text Placeholder 2">
             <a:extLst xmlns:a="http://schemas.openxmlformats.org/drawingml/2006/main">
               <a:ext uri="{FF2B5EF4-FFF2-40B4-BE49-F238E27FC236}">
-                <a16:creationId xmlns:a16="http://schemas.microsoft.com/office/drawing/2014/main" id="{7D634F14-F18B-44CD-892F-41300D9A6374}"/>
+                <a16:creationId xmlns:a16="http://schemas.microsoft.com/office/drawing/2014/main" id="{F94403A3-D6C2-4C47-8644-E85FD494CAE1}"/>
               </a:ext>
             </a:extLst>
           </p:cNvPr>
@@ -4044,7 +4044,7 @@
           <p:cNvPr id="4" name="Content Placeholder 3">
             <a:extLst xmlns:a="http://schemas.openxmlformats.org/drawingml/2006/main">
               <a:ext uri="{FF2B5EF4-FFF2-40B4-BE49-F238E27FC236}">
-                <a16:creationId xmlns:a16="http://schemas.microsoft.com/office/drawing/2014/main" id="{3DA1AC27-890F-488D-9713-513E10D3BB0C}"/>
+                <a16:creationId xmlns:a16="http://schemas.microsoft.com/office/drawing/2014/main" id="{6EFAB9C5-88EC-4D9F-8F82-5CBB48453598}"/>
               </a:ext>
             </a:extLst>
           </p:cNvPr>
@@ -4148,7 +4148,7 @@
           <p:cNvPr id="5" name="Text Placeholder 4">
             <a:extLst xmlns:a="http://schemas.openxmlformats.org/drawingml/2006/main">
               <a:ext uri="{FF2B5EF4-FFF2-40B4-BE49-F238E27FC236}">
-                <a16:creationId xmlns:a16="http://schemas.microsoft.com/office/drawing/2014/main" id="{C590CE0D-1888-408E-B60A-4D4A77DD51C5}"/>
+                <a16:creationId xmlns:a16="http://schemas.microsoft.com/office/drawing/2014/main" id="{EB9EB78F-4158-4040-9B05-51FD8B3AEFF4}"/>
               </a:ext>
             </a:extLst>
           </p:cNvPr>
@@ -4220,7 +4220,7 @@
           <p:cNvPr id="6" name="Content Placeholder 5">
             <a:extLst xmlns:a="http://schemas.openxmlformats.org/drawingml/2006/main">
               <a:ext uri="{FF2B5EF4-FFF2-40B4-BE49-F238E27FC236}">
-                <a16:creationId xmlns:a16="http://schemas.microsoft.com/office/drawing/2014/main" id="{CFA1A617-B61F-4F70-AFBA-FCE3FE3F6604}"/>
+                <a16:creationId xmlns:a16="http://schemas.microsoft.com/office/drawing/2014/main" id="{43C924F6-9D02-405C-86AD-C2CDD42B35FB}"/>
               </a:ext>
             </a:extLst>
           </p:cNvPr>
@@ -4324,7 +4324,7 @@
           <p:cNvPr id="7" name="Date Placeholder 6">
             <a:extLst xmlns:a="http://schemas.openxmlformats.org/drawingml/2006/main">
               <a:ext uri="{FF2B5EF4-FFF2-40B4-BE49-F238E27FC236}">
-                <a16:creationId xmlns:a16="http://schemas.microsoft.com/office/drawing/2014/main" id="{66396BB1-BB12-4001-A4C8-535692CC8404}"/>
+                <a16:creationId xmlns:a16="http://schemas.microsoft.com/office/drawing/2014/main" id="{CBCE8EAC-BB34-4ACD-B4F1-4ED68931C583}"/>
               </a:ext>
             </a:extLst>
           </p:cNvPr>
@@ -4351,7 +4351,7 @@
           <p:cNvPr id="8" name="Footer Placeholder 7">
             <a:extLst xmlns:a="http://schemas.openxmlformats.org/drawingml/2006/main">
               <a:ext uri="{FF2B5EF4-FFF2-40B4-BE49-F238E27FC236}">
-                <a16:creationId xmlns:a16="http://schemas.microsoft.com/office/drawing/2014/main" id="{DC5767B0-0E48-4075-BBE6-EAB46F31812C}"/>
+                <a16:creationId xmlns:a16="http://schemas.microsoft.com/office/drawing/2014/main" id="{89941D0F-E763-4BD4-8EEC-C392D11B73FC}"/>
               </a:ext>
             </a:extLst>
           </p:cNvPr>
@@ -4374,7 +4374,7 @@
           <p:cNvPr id="9" name="Slide Number Placeholder 8">
             <a:extLst xmlns:a="http://schemas.openxmlformats.org/drawingml/2006/main">
               <a:ext uri="{FF2B5EF4-FFF2-40B4-BE49-F238E27FC236}">
-                <a16:creationId xmlns:a16="http://schemas.microsoft.com/office/drawing/2014/main" id="{7D602CE6-EA9D-4C19-B338-AE8A10FE565E}"/>
+                <a16:creationId xmlns:a16="http://schemas.microsoft.com/office/drawing/2014/main" id="{F6FB4DA0-527C-4981-B377-53E596CF03EE}"/>
               </a:ext>
             </a:extLst>
           </p:cNvPr>
@@ -4418,7 +4418,7 @@
           <p:cNvPr id="2" name="Title 1">
             <a:extLst xmlns:a="http://schemas.openxmlformats.org/drawingml/2006/main">
               <a:ext uri="{FF2B5EF4-FFF2-40B4-BE49-F238E27FC236}">
-                <a16:creationId xmlns:a16="http://schemas.microsoft.com/office/drawing/2014/main" id="{59A22DAB-8098-4848-BC18-4081ADAF6FC0}"/>
+                <a16:creationId xmlns:a16="http://schemas.microsoft.com/office/drawing/2014/main" id="{8652F4BF-7D1F-4DAE-9A1D-E708B82592A3}"/>
               </a:ext>
             </a:extLst>
           </p:cNvPr>
@@ -4445,7 +4445,7 @@
           <p:cNvPr id="3" name="Date Placeholder 2">
             <a:extLst xmlns:a="http://schemas.openxmlformats.org/drawingml/2006/main">
               <a:ext uri="{FF2B5EF4-FFF2-40B4-BE49-F238E27FC236}">
-                <a16:creationId xmlns:a16="http://schemas.microsoft.com/office/drawing/2014/main" id="{C11ADB71-6949-4161-8A20-0B8D9C8BB0D0}"/>
+                <a16:creationId xmlns:a16="http://schemas.microsoft.com/office/drawing/2014/main" id="{DEDEBFE4-CC3B-456C-AAE5-C81D6EADC74F}"/>
               </a:ext>
             </a:extLst>
           </p:cNvPr>
@@ -4472,7 +4472,7 @@
           <p:cNvPr id="4" name="Footer Placeholder 3">
             <a:extLst xmlns:a="http://schemas.openxmlformats.org/drawingml/2006/main">
               <a:ext uri="{FF2B5EF4-FFF2-40B4-BE49-F238E27FC236}">
-                <a16:creationId xmlns:a16="http://schemas.microsoft.com/office/drawing/2014/main" id="{87FD76C8-280E-4AF0-8C7E-E82781F8ABC7}"/>
+                <a16:creationId xmlns:a16="http://schemas.microsoft.com/office/drawing/2014/main" id="{4DB508F8-E637-436A-81CA-F5E61A6AE4CF}"/>
               </a:ext>
             </a:extLst>
           </p:cNvPr>
@@ -4495,7 +4495,7 @@
           <p:cNvPr id="5" name="Slide Number Placeholder 4">
             <a:extLst xmlns:a="http://schemas.openxmlformats.org/drawingml/2006/main">
               <a:ext uri="{FF2B5EF4-FFF2-40B4-BE49-F238E27FC236}">
-                <a16:creationId xmlns:a16="http://schemas.microsoft.com/office/drawing/2014/main" id="{1D658A89-06AD-4DA6-AF57-1972911E73AA}"/>
+                <a16:creationId xmlns:a16="http://schemas.microsoft.com/office/drawing/2014/main" id="{DFA8EC41-2B57-4D66-9E93-17EE4FB749DF}"/>
               </a:ext>
             </a:extLst>
           </p:cNvPr>
@@ -4539,7 +4539,7 @@
           <p:cNvPr id="2" name="Date Placeholder 1">
             <a:extLst xmlns:a="http://schemas.openxmlformats.org/drawingml/2006/main">
               <a:ext uri="{FF2B5EF4-FFF2-40B4-BE49-F238E27FC236}">
-                <a16:creationId xmlns:a16="http://schemas.microsoft.com/office/drawing/2014/main" id="{1930CD67-232B-45C9-87CA-2AC9394C1D65}"/>
+                <a16:creationId xmlns:a16="http://schemas.microsoft.com/office/drawing/2014/main" id="{CDCF13CD-5E5C-49B3-8776-EF270E9E59B4}"/>
               </a:ext>
             </a:extLst>
           </p:cNvPr>
@@ -4566,7 +4566,7 @@
           <p:cNvPr id="3" name="Footer Placeholder 2">
             <a:extLst xmlns:a="http://schemas.openxmlformats.org/drawingml/2006/main">
               <a:ext uri="{FF2B5EF4-FFF2-40B4-BE49-F238E27FC236}">
-                <a16:creationId xmlns:a16="http://schemas.microsoft.com/office/drawing/2014/main" id="{5E6CF2FC-3961-412D-AD17-1870A1C81AA9}"/>
+                <a16:creationId xmlns:a16="http://schemas.microsoft.com/office/drawing/2014/main" id="{D2275206-0AC9-49D0-B771-13C6CD520886}"/>
               </a:ext>
             </a:extLst>
           </p:cNvPr>
@@ -4589,7 +4589,7 @@
           <p:cNvPr id="4" name="Slide Number Placeholder 3">
             <a:extLst xmlns:a="http://schemas.openxmlformats.org/drawingml/2006/main">
               <a:ext uri="{FF2B5EF4-FFF2-40B4-BE49-F238E27FC236}">
-                <a16:creationId xmlns:a16="http://schemas.microsoft.com/office/drawing/2014/main" id="{F8BE0EA0-3BF2-474E-ACCD-BF9ADF6BBD2B}"/>
+                <a16:creationId xmlns:a16="http://schemas.microsoft.com/office/drawing/2014/main" id="{2EB342E2-B691-42E6-9F76-4041507DC6C1}"/>
               </a:ext>
             </a:extLst>
           </p:cNvPr>
@@ -4633,7 +4633,7 @@
           <p:cNvPr id="2" name="Title 1">
             <a:extLst xmlns:a="http://schemas.openxmlformats.org/drawingml/2006/main">
               <a:ext uri="{FF2B5EF4-FFF2-40B4-BE49-F238E27FC236}">
-                <a16:creationId xmlns:a16="http://schemas.microsoft.com/office/drawing/2014/main" id="{11D19ECF-07D8-42C5-AF5D-D08A09FCA865}"/>
+                <a16:creationId xmlns:a16="http://schemas.microsoft.com/office/drawing/2014/main" id="{B0D6A0AD-482C-44B3-88F3-BCE778C73ACB}"/>
               </a:ext>
             </a:extLst>
           </p:cNvPr>
@@ -4670,7 +4670,7 @@
           <p:cNvPr id="3" name="Content Placeholder 2">
             <a:extLst xmlns:a="http://schemas.openxmlformats.org/drawingml/2006/main">
               <a:ext uri="{FF2B5EF4-FFF2-40B4-BE49-F238E27FC236}">
-                <a16:creationId xmlns:a16="http://schemas.microsoft.com/office/drawing/2014/main" id="{A8F8DC87-6295-466C-8AA4-6C9AAB2BB42F}"/>
+                <a16:creationId xmlns:a16="http://schemas.microsoft.com/office/drawing/2014/main" id="{408BD542-2A74-48B4-B696-E9E467FFB033}"/>
               </a:ext>
             </a:extLst>
           </p:cNvPr>
@@ -4774,7 +4774,7 @@
           <p:cNvPr id="4" name="Text Placeholder 3">
             <a:extLst xmlns:a="http://schemas.openxmlformats.org/drawingml/2006/main">
               <a:ext uri="{FF2B5EF4-FFF2-40B4-BE49-F238E27FC236}">
-                <a16:creationId xmlns:a16="http://schemas.microsoft.com/office/drawing/2014/main" id="{A3DF6698-2174-4CC6-919E-9D9F3AB10AB8}"/>
+                <a16:creationId xmlns:a16="http://schemas.microsoft.com/office/drawing/2014/main" id="{0D86CBD4-80B7-4E98-B985-A9094315D921}"/>
               </a:ext>
             </a:extLst>
           </p:cNvPr>
@@ -4846,7 +4846,7 @@
           <p:cNvPr id="5" name="Date Placeholder 4">
             <a:extLst xmlns:a="http://schemas.openxmlformats.org/drawingml/2006/main">
               <a:ext uri="{FF2B5EF4-FFF2-40B4-BE49-F238E27FC236}">
-                <a16:creationId xmlns:a16="http://schemas.microsoft.com/office/drawing/2014/main" id="{F8D5C5D3-FE37-42BF-8B11-66C39C4F7EB0}"/>
+                <a16:creationId xmlns:a16="http://schemas.microsoft.com/office/drawing/2014/main" id="{85E766DF-93E0-4A35-9514-D37CEFC41972}"/>
               </a:ext>
             </a:extLst>
           </p:cNvPr>
@@ -4873,7 +4873,7 @@
           <p:cNvPr id="6" name="Footer Placeholder 5">
             <a:extLst xmlns:a="http://schemas.openxmlformats.org/drawingml/2006/main">
               <a:ext uri="{FF2B5EF4-FFF2-40B4-BE49-F238E27FC236}">
-                <a16:creationId xmlns:a16="http://schemas.microsoft.com/office/drawing/2014/main" id="{ACC099E8-7D2C-436C-9756-7F298A354871}"/>
+                <a16:creationId xmlns:a16="http://schemas.microsoft.com/office/drawing/2014/main" id="{35062FE3-77CC-4407-8349-ED21FEA8629E}"/>
               </a:ext>
             </a:extLst>
           </p:cNvPr>
@@ -4896,7 +4896,7 @@
           <p:cNvPr id="7" name="Slide Number Placeholder 6">
             <a:extLst xmlns:a="http://schemas.openxmlformats.org/drawingml/2006/main">
               <a:ext uri="{FF2B5EF4-FFF2-40B4-BE49-F238E27FC236}">
-                <a16:creationId xmlns:a16="http://schemas.microsoft.com/office/drawing/2014/main" id="{275DC1BB-7E9C-4B5E-BEDE-CB063379CCAE}"/>
+                <a16:creationId xmlns:a16="http://schemas.microsoft.com/office/drawing/2014/main" id="{4C3E5E03-3CED-47BC-92BF-9D183B531F1B}"/>
               </a:ext>
             </a:extLst>
           </p:cNvPr>
@@ -4940,7 +4940,7 @@
           <p:cNvPr id="2" name="Title 1">
             <a:extLst xmlns:a="http://schemas.openxmlformats.org/drawingml/2006/main">
               <a:ext uri="{FF2B5EF4-FFF2-40B4-BE49-F238E27FC236}">
-                <a16:creationId xmlns:a16="http://schemas.microsoft.com/office/drawing/2014/main" id="{30D6BAC2-A6EE-445B-867C-BA2E6F059142}"/>
+                <a16:creationId xmlns:a16="http://schemas.microsoft.com/office/drawing/2014/main" id="{B21E1284-005D-4C01-9B8D-DFCFD5834C38}"/>
               </a:ext>
             </a:extLst>
           </p:cNvPr>
@@ -4977,7 +4977,7 @@
           <p:cNvPr id="3" name="Picture Placeholder 2">
             <a:extLst xmlns:a="http://schemas.openxmlformats.org/drawingml/2006/main">
               <a:ext uri="{FF2B5EF4-FFF2-40B4-BE49-F238E27FC236}">
-                <a16:creationId xmlns:a16="http://schemas.microsoft.com/office/drawing/2014/main" id="{7E645AB5-7E6A-4E4B-BB27-476B6408E817}"/>
+                <a16:creationId xmlns:a16="http://schemas.microsoft.com/office/drawing/2014/main" id="{013154CF-D6BB-4FA6-9FF8-0588C89F0967}"/>
               </a:ext>
             </a:extLst>
           </p:cNvPr>
@@ -5042,7 +5042,7 @@
           <p:cNvPr id="4" name="Text Placeholder 3">
             <a:extLst xmlns:a="http://schemas.openxmlformats.org/drawingml/2006/main">
               <a:ext uri="{FF2B5EF4-FFF2-40B4-BE49-F238E27FC236}">
-                <a16:creationId xmlns:a16="http://schemas.microsoft.com/office/drawing/2014/main" id="{241B3D2E-249B-46D8-9A95-3B2CA4FE089F}"/>
+                <a16:creationId xmlns:a16="http://schemas.microsoft.com/office/drawing/2014/main" id="{13606773-D51E-4ED0-A2DE-11EEE1FEB3D6}"/>
               </a:ext>
             </a:extLst>
           </p:cNvPr>
@@ -5114,7 +5114,7 @@
           <p:cNvPr id="5" name="Date Placeholder 4">
             <a:extLst xmlns:a="http://schemas.openxmlformats.org/drawingml/2006/main">
               <a:ext uri="{FF2B5EF4-FFF2-40B4-BE49-F238E27FC236}">
-                <a16:creationId xmlns:a16="http://schemas.microsoft.com/office/drawing/2014/main" id="{9780C79C-7EFA-4EE1-8C81-DF74397ABF66}"/>
+                <a16:creationId xmlns:a16="http://schemas.microsoft.com/office/drawing/2014/main" id="{17F3AAEC-E99B-44D3-BF8C-7A716E220D26}"/>
               </a:ext>
             </a:extLst>
           </p:cNvPr>
@@ -5141,7 +5141,7 @@
           <p:cNvPr id="6" name="Footer Placeholder 5">
             <a:extLst xmlns:a="http://schemas.openxmlformats.org/drawingml/2006/main">
               <a:ext uri="{FF2B5EF4-FFF2-40B4-BE49-F238E27FC236}">
-                <a16:creationId xmlns:a16="http://schemas.microsoft.com/office/drawing/2014/main" id="{D507E20D-4779-48A7-89F0-AAFC7046ACFA}"/>
+                <a16:creationId xmlns:a16="http://schemas.microsoft.com/office/drawing/2014/main" id="{33DBFD80-7C02-444D-8AE4-0A0EFCD8ED45}"/>
               </a:ext>
             </a:extLst>
           </p:cNvPr>
@@ -5164,7 +5164,7 @@
           <p:cNvPr id="7" name="Slide Number Placeholder 6">
             <a:extLst xmlns:a="http://schemas.openxmlformats.org/drawingml/2006/main">
               <a:ext uri="{FF2B5EF4-FFF2-40B4-BE49-F238E27FC236}">
-                <a16:creationId xmlns:a16="http://schemas.microsoft.com/office/drawing/2014/main" id="{359645BD-EC64-4477-A588-1E4DDFED5D2F}"/>
+                <a16:creationId xmlns:a16="http://schemas.microsoft.com/office/drawing/2014/main" id="{662A46D6-6AAA-478B-9CB9-2313146EC5B7}"/>
               </a:ext>
             </a:extLst>
           </p:cNvPr>
@@ -5213,7 +5213,7 @@
           <p:cNvPr id="2" name="Title Placeholder 1">
             <a:extLst xmlns:a="http://schemas.openxmlformats.org/drawingml/2006/main">
               <a:ext uri="{FF2B5EF4-FFF2-40B4-BE49-F238E27FC236}">
-                <a16:creationId xmlns:a16="http://schemas.microsoft.com/office/drawing/2014/main" id="{463CE577-05E8-45FD-BFFA-4F3335D9EE12}"/>
+                <a16:creationId xmlns:a16="http://schemas.microsoft.com/office/drawing/2014/main" id="{9241D5A8-06A4-40AE-B821-AC7ACD6697F3}"/>
               </a:ext>
             </a:extLst>
           </p:cNvPr>
@@ -5250,7 +5250,7 @@
           <p:cNvPr id="3" name="Text Placeholder 2">
             <a:extLst xmlns:a="http://schemas.openxmlformats.org/drawingml/2006/main">
               <a:ext uri="{FF2B5EF4-FFF2-40B4-BE49-F238E27FC236}">
-                <a16:creationId xmlns:a16="http://schemas.microsoft.com/office/drawing/2014/main" id="{06CAC898-4ABF-4288-8A80-FAD724649EAD}"/>
+                <a16:creationId xmlns:a16="http://schemas.microsoft.com/office/drawing/2014/main" id="{3A6AD352-41B2-4114-97D6-54606EF41EC9}"/>
               </a:ext>
             </a:extLst>
           </p:cNvPr>
@@ -5322,7 +5322,7 @@
           <p:cNvPr id="4" name="Date Placeholder 3">
             <a:extLst xmlns:a="http://schemas.openxmlformats.org/drawingml/2006/main">
               <a:ext uri="{FF2B5EF4-FFF2-40B4-BE49-F238E27FC236}">
-                <a16:creationId xmlns:a16="http://schemas.microsoft.com/office/drawing/2014/main" id="{7163F342-25EE-4651-A9CF-678F904BC2CC}"/>
+                <a16:creationId xmlns:a16="http://schemas.microsoft.com/office/drawing/2014/main" id="{46D3AC29-2DFA-44AE-BAEA-EB030332C427}"/>
               </a:ext>
             </a:extLst>
           </p:cNvPr>
@@ -5368,7 +5368,7 @@
           <p:cNvPr id="5" name="Footer Placeholder 4">
             <a:extLst xmlns:a="http://schemas.openxmlformats.org/drawingml/2006/main">
               <a:ext uri="{FF2B5EF4-FFF2-40B4-BE49-F238E27FC236}">
-                <a16:creationId xmlns:a16="http://schemas.microsoft.com/office/drawing/2014/main" id="{4783FBEE-2C4B-4D6C-A02D-958A6C686837}"/>
+                <a16:creationId xmlns:a16="http://schemas.microsoft.com/office/drawing/2014/main" id="{6CEFEC84-38EE-4037-894B-4C1C047CCBFD}"/>
               </a:ext>
             </a:extLst>
           </p:cNvPr>
@@ -5410,7 +5410,7 @@
           <p:cNvPr id="6" name="Slide Number Placeholder 5">
             <a:extLst xmlns:a="http://schemas.openxmlformats.org/drawingml/2006/main">
               <a:ext uri="{FF2B5EF4-FFF2-40B4-BE49-F238E27FC236}">
-                <a16:creationId xmlns:a16="http://schemas.microsoft.com/office/drawing/2014/main" id="{31D2475F-7035-4E82-A172-65A0301E3756}"/>
+                <a16:creationId xmlns:a16="http://schemas.microsoft.com/office/drawing/2014/main" id="{1202F71C-E9DA-47AC-8A69-D4502BA6BF89}"/>
               </a:ext>
             </a:extLst>
           </p:cNvPr>
@@ -5455,17 +5455,17 @@
   </p:cSld>
   <p:clrMap bg1="lt1" tx1="dk1" bg2="lt2" tx2="dk2" accent1="accent1" accent2="accent2" accent3="accent3" accent4="accent4" accent5="accent5" accent6="accent6" hlink="hlink" folHlink="folHlink"/>
   <p:sldLayoutIdLst>
-    <p:sldLayoutId xmlns:r="http://schemas.openxmlformats.org/officeDocument/2006/relationships" id="2147483649" r:id="R5880d5992620492d"/>
-    <p:sldLayoutId xmlns:r="http://schemas.openxmlformats.org/officeDocument/2006/relationships" id="2147483650" r:id="R737bdcc11a1a4615"/>
-    <p:sldLayoutId xmlns:r="http://schemas.openxmlformats.org/officeDocument/2006/relationships" id="2147483651" r:id="R353bed9000a94343"/>
-    <p:sldLayoutId xmlns:r="http://schemas.openxmlformats.org/officeDocument/2006/relationships" id="2147483652" r:id="R65638369637b44a7"/>
-    <p:sldLayoutId xmlns:r="http://schemas.openxmlformats.org/officeDocument/2006/relationships" id="2147483653" r:id="Rf478e7b23b204987"/>
-    <p:sldLayoutId xmlns:r="http://schemas.openxmlformats.org/officeDocument/2006/relationships" id="2147483654" r:id="R2a2119097b6c4f86"/>
-    <p:sldLayoutId xmlns:r="http://schemas.openxmlformats.org/officeDocument/2006/relationships" id="2147483655" r:id="Rdc13873485f24a10"/>
-    <p:sldLayoutId xmlns:r="http://schemas.openxmlformats.org/officeDocument/2006/relationships" id="2147483656" r:id="Rf29e74eb6d9f4fc7"/>
-    <p:sldLayoutId xmlns:r="http://schemas.openxmlformats.org/officeDocument/2006/relationships" id="2147483657" r:id="R75a0c65fadd1467f"/>
-    <p:sldLayoutId xmlns:r="http://schemas.openxmlformats.org/officeDocument/2006/relationships" id="2147483658" r:id="R10caa8a27bde4399"/>
-    <p:sldLayoutId xmlns:r="http://schemas.openxmlformats.org/officeDocument/2006/relationships" id="2147483659" r:id="Rd83ce658582a4167"/>
+    <p:sldLayoutId xmlns:r="http://schemas.openxmlformats.org/officeDocument/2006/relationships" id="2147483649" r:id="Rbed2389782c24c16"/>
+    <p:sldLayoutId xmlns:r="http://schemas.openxmlformats.org/officeDocument/2006/relationships" id="2147483650" r:id="R34be4a391ddf45a6"/>
+    <p:sldLayoutId xmlns:r="http://schemas.openxmlformats.org/officeDocument/2006/relationships" id="2147483651" r:id="R3e282c7de0c54b99"/>
+    <p:sldLayoutId xmlns:r="http://schemas.openxmlformats.org/officeDocument/2006/relationships" id="2147483652" r:id="Rfc5e6302d77f4c27"/>
+    <p:sldLayoutId xmlns:r="http://schemas.openxmlformats.org/officeDocument/2006/relationships" id="2147483653" r:id="R4f78618d8e664d9c"/>
+    <p:sldLayoutId xmlns:r="http://schemas.openxmlformats.org/officeDocument/2006/relationships" id="2147483654" r:id="R0e4a81a31f3a4608"/>
+    <p:sldLayoutId xmlns:r="http://schemas.openxmlformats.org/officeDocument/2006/relationships" id="2147483655" r:id="Rd213e8e4887e43e9"/>
+    <p:sldLayoutId xmlns:r="http://schemas.openxmlformats.org/officeDocument/2006/relationships" id="2147483656" r:id="R4c5aa0d78df64b8c"/>
+    <p:sldLayoutId xmlns:r="http://schemas.openxmlformats.org/officeDocument/2006/relationships" id="2147483657" r:id="R2de9d93609854543"/>
+    <p:sldLayoutId xmlns:r="http://schemas.openxmlformats.org/officeDocument/2006/relationships" id="2147483658" r:id="R316a9008917b4b56"/>
+    <p:sldLayoutId xmlns:r="http://schemas.openxmlformats.org/officeDocument/2006/relationships" id="2147483659" r:id="R292917e93ff84490"/>
   </p:sldLayoutIdLst>
   <p:txStyles>
     <p:titleStyle>
@@ -6018,7 +6018,7 @@
           <p:cNvPr id="2" name="Rectangle 1">
             <a:extLst xmlns:a="http://schemas.openxmlformats.org/drawingml/2006/main">
               <a:ext uri="{FF2B5EF4-FFF2-40B4-BE49-F238E27FC236}">
-                <a16:creationId xmlns:a16="http://schemas.microsoft.com/office/drawing/2014/main" id="{B84B3351-8466-40AA-BC00-83C83F876BC2}"/>
+                <a16:creationId xmlns:a16="http://schemas.microsoft.com/office/drawing/2014/main" id="{DE49B05D-84C6-49EA-BD23-FE0E828021CA}"/>
               </a:ext>
             </a:extLst>
           </p:cNvPr>
@@ -6073,7 +6073,7 @@
           <p:cNvPr id="3" name="TextBox 2">
             <a:extLst xmlns:a="http://schemas.openxmlformats.org/drawingml/2006/main">
               <a:ext uri="{FF2B5EF4-FFF2-40B4-BE49-F238E27FC236}">
-                <a16:creationId xmlns:a16="http://schemas.microsoft.com/office/drawing/2014/main" id="{55186D4C-04D6-426F-9E00-9C2D02DB9EFF}"/>
+                <a16:creationId xmlns:a16="http://schemas.microsoft.com/office/drawing/2014/main" id="{4BF9BAA8-970B-49DB-80AC-CCD3887B2688}"/>
               </a:ext>
             </a:extLst>
           </p:cNvPr>
@@ -6120,7 +6120,7 @@
           <p:cNvPr id="4" name="TextBox 3">
             <a:extLst xmlns:a="http://schemas.openxmlformats.org/drawingml/2006/main">
               <a:ext uri="{FF2B5EF4-FFF2-40B4-BE49-F238E27FC236}">
-                <a16:creationId xmlns:a16="http://schemas.microsoft.com/office/drawing/2014/main" id="{192657B6-E65C-4E41-96D1-2B75C39BFD2F}"/>
+                <a16:creationId xmlns:a16="http://schemas.microsoft.com/office/drawing/2014/main" id="{26FDB0C7-F999-4590-892C-4534FA994C16}"/>
               </a:ext>
             </a:extLst>
           </p:cNvPr>
@@ -6188,7 +6188,7 @@
           <p:cNvPr id="5" name="TextBox 4">
             <a:extLst xmlns:a="http://schemas.openxmlformats.org/drawingml/2006/main">
               <a:ext uri="{FF2B5EF4-FFF2-40B4-BE49-F238E27FC236}">
-                <a16:creationId xmlns:a16="http://schemas.microsoft.com/office/drawing/2014/main" id="{630CD139-E274-413D-8C13-AB803A3DB5AA}"/>
+                <a16:creationId xmlns:a16="http://schemas.microsoft.com/office/drawing/2014/main" id="{61A49200-6824-4523-9777-881BFCF3BE62}"/>
               </a:ext>
             </a:extLst>
           </p:cNvPr>
@@ -6235,7 +6235,7 @@
           <p:cNvPr id="6" name="Rectangle 5">
             <a:extLst xmlns:a="http://schemas.openxmlformats.org/drawingml/2006/main">
               <a:ext uri="{FF2B5EF4-FFF2-40B4-BE49-F238E27FC236}">
-                <a16:creationId xmlns:a16="http://schemas.microsoft.com/office/drawing/2014/main" id="{CDF288AB-4056-4C6F-8D41-06821AEA6953}"/>
+                <a16:creationId xmlns:a16="http://schemas.microsoft.com/office/drawing/2014/main" id="{2C1E84B4-CD7D-4A03-9685-8BD3892B3886}"/>
               </a:ext>
             </a:extLst>
           </p:cNvPr>
@@ -6290,7 +6290,7 @@
           <p:cNvPr id="7" name="TextBox 6">
             <a:extLst xmlns:a="http://schemas.openxmlformats.org/drawingml/2006/main">
               <a:ext uri="{FF2B5EF4-FFF2-40B4-BE49-F238E27FC236}">
-                <a16:creationId xmlns:a16="http://schemas.microsoft.com/office/drawing/2014/main" id="{08184345-7026-4804-A628-186038CBF1B1}"/>
+                <a16:creationId xmlns:a16="http://schemas.microsoft.com/office/drawing/2014/main" id="{BE605A9C-0B8C-4F82-8BE4-FB0C2A4E040B}"/>
               </a:ext>
             </a:extLst>
           </p:cNvPr>
@@ -6337,7 +6337,7 @@
           <p:cNvPr id="8" name="TextBox 7">
             <a:extLst xmlns:a="http://schemas.openxmlformats.org/drawingml/2006/main">
               <a:ext uri="{FF2B5EF4-FFF2-40B4-BE49-F238E27FC236}">
-                <a16:creationId xmlns:a16="http://schemas.microsoft.com/office/drawing/2014/main" id="{E0C3CA0E-6944-45CA-A613-5743844A9B22}"/>
+                <a16:creationId xmlns:a16="http://schemas.microsoft.com/office/drawing/2014/main" id="{AD37B326-F6E9-419D-80B9-75BC861E098D}"/>
               </a:ext>
             </a:extLst>
           </p:cNvPr>
@@ -6374,7 +6374,7 @@
                 <a:ea typeface="Aptos"/>
                 <a:cs typeface="Aptos"/>
               </a:rPr>
-              <a:t>2026.07.23-11</a:t>
+              <a:t>2026.07.23-12</a:t>
             </a:r>
           </a:p>
         </p:txBody>
@@ -6384,7 +6384,7 @@
           <p:cNvPr id="9" name="TextBox 8">
             <a:extLst xmlns:a="http://schemas.openxmlformats.org/drawingml/2006/main">
               <a:ext uri="{FF2B5EF4-FFF2-40B4-BE49-F238E27FC236}">
-                <a16:creationId xmlns:a16="http://schemas.microsoft.com/office/drawing/2014/main" id="{F9E43497-3EA1-4BB5-82B7-76473D2816E3}"/>
+                <a16:creationId xmlns:a16="http://schemas.microsoft.com/office/drawing/2014/main" id="{FDECED31-D187-4E38-8A05-ABD8E7FF7316}"/>
               </a:ext>
             </a:extLst>
           </p:cNvPr>
@@ -6452,7 +6452,7 @@
           <p:cNvPr id="10" name="TextBox 9">
             <a:extLst xmlns:a="http://schemas.openxmlformats.org/drawingml/2006/main">
               <a:ext uri="{FF2B5EF4-FFF2-40B4-BE49-F238E27FC236}">
-                <a16:creationId xmlns:a16="http://schemas.microsoft.com/office/drawing/2014/main" id="{8EC6B138-2AF1-4947-A8CC-2EE04DD23C8D}"/>
+                <a16:creationId xmlns:a16="http://schemas.microsoft.com/office/drawing/2014/main" id="{ABA6AE49-5D2F-4187-820A-5837FC7E54E0}"/>
               </a:ext>
             </a:extLst>
           </p:cNvPr>
@@ -6499,7 +6499,7 @@
           <p:cNvPr id="11" name="TextBox 10">
             <a:extLst xmlns:a="http://schemas.openxmlformats.org/drawingml/2006/main">
               <a:ext uri="{FF2B5EF4-FFF2-40B4-BE49-F238E27FC236}">
-                <a16:creationId xmlns:a16="http://schemas.microsoft.com/office/drawing/2014/main" id="{F63E0A11-901A-46BC-BB76-E155BF0DC3B6}"/>
+                <a16:creationId xmlns:a16="http://schemas.microsoft.com/office/drawing/2014/main" id="{ED104666-685D-4B3E-B140-3781798CF181}"/>
               </a:ext>
             </a:extLst>
           </p:cNvPr>
@@ -6546,7 +6546,7 @@
           <p:cNvPr id="12" name="TextBox 11">
             <a:extLst xmlns:a="http://schemas.openxmlformats.org/drawingml/2006/main">
               <a:ext uri="{FF2B5EF4-FFF2-40B4-BE49-F238E27FC236}">
-                <a16:creationId xmlns:a16="http://schemas.microsoft.com/office/drawing/2014/main" id="{73F29D8C-8AFC-403A-91A7-95C3EB168CF3}"/>
+                <a16:creationId xmlns:a16="http://schemas.microsoft.com/office/drawing/2014/main" id="{0F93C946-D42B-4E33-BABA-9CA4D14AA274}"/>
               </a:ext>
             </a:extLst>
           </p:cNvPr>
@@ -6591,7 +6591,7 @@
     </p:spTree>
     <p:extLst>
       <p:ext uri="{BB962C8B-B14F-4D97-AF65-F5344CB8AC3E}">
-        <p14:creationId xmlns:p14="http://schemas.microsoft.com/office/powerpoint/2010/main" val="1049812690"/>
+        <p14:creationId xmlns:p14="http://schemas.microsoft.com/office/powerpoint/2010/main" val="675495264"/>
       </p:ext>
     </p:extLst>
   </p:cSld>
@@ -6615,7 +6615,7 @@
           <p:cNvPr id="2" name="TextBox 1">
             <a:extLst xmlns:a="http://schemas.openxmlformats.org/drawingml/2006/main">
               <a:ext uri="{FF2B5EF4-FFF2-40B4-BE49-F238E27FC236}">
-                <a16:creationId xmlns:a16="http://schemas.microsoft.com/office/drawing/2014/main" id="{FB9D0F24-EAC5-40F3-8E3C-144A78F8CE2B}"/>
+                <a16:creationId xmlns:a16="http://schemas.microsoft.com/office/drawing/2014/main" id="{15C9DC2F-2A76-4A2E-99BA-A4B647944ED3}"/>
               </a:ext>
             </a:extLst>
           </p:cNvPr>
@@ -6662,7 +6662,7 @@
           <p:cNvPr id="3" name="TextBox 2">
             <a:extLst xmlns:a="http://schemas.openxmlformats.org/drawingml/2006/main">
               <a:ext uri="{FF2B5EF4-FFF2-40B4-BE49-F238E27FC236}">
-                <a16:creationId xmlns:a16="http://schemas.microsoft.com/office/drawing/2014/main" id="{3570924F-5761-47C5-85D2-BAE3F0C1A1C4}"/>
+                <a16:creationId xmlns:a16="http://schemas.microsoft.com/office/drawing/2014/main" id="{9837D2E9-1CB3-4F09-B662-BFE0BE9CEE77}"/>
               </a:ext>
             </a:extLst>
           </p:cNvPr>
@@ -6709,7 +6709,7 @@
           <p:cNvPr id="4" name="Rectangle 3">
             <a:extLst xmlns:a="http://schemas.openxmlformats.org/drawingml/2006/main">
               <a:ext uri="{FF2B5EF4-FFF2-40B4-BE49-F238E27FC236}">
-                <a16:creationId xmlns:a16="http://schemas.microsoft.com/office/drawing/2014/main" id="{747797E3-C501-4B52-9CF0-C58E64A62DE6}"/>
+                <a16:creationId xmlns:a16="http://schemas.microsoft.com/office/drawing/2014/main" id="{0B5B2CD3-C105-48D0-83D0-443E1F36A5C4}"/>
               </a:ext>
             </a:extLst>
           </p:cNvPr>
@@ -6764,7 +6764,7 @@
           <p:cNvPr id="5" name="Rectangle 4">
             <a:extLst xmlns:a="http://schemas.openxmlformats.org/drawingml/2006/main">
               <a:ext uri="{FF2B5EF4-FFF2-40B4-BE49-F238E27FC236}">
-                <a16:creationId xmlns:a16="http://schemas.microsoft.com/office/drawing/2014/main" id="{0C5AEEC3-A75F-4853-919E-7B1B622A3C58}"/>
+                <a16:creationId xmlns:a16="http://schemas.microsoft.com/office/drawing/2014/main" id="{0A1C10DF-9D4B-4770-A27E-C129B7B25109}"/>
               </a:ext>
             </a:extLst>
           </p:cNvPr>
@@ -6819,7 +6819,7 @@
           <p:cNvPr id="6" name="TextBox 5">
             <a:extLst xmlns:a="http://schemas.openxmlformats.org/drawingml/2006/main">
               <a:ext uri="{FF2B5EF4-FFF2-40B4-BE49-F238E27FC236}">
-                <a16:creationId xmlns:a16="http://schemas.microsoft.com/office/drawing/2014/main" id="{E6ECFFE6-0DAC-4AA2-9FD1-79C622D2F6E0}"/>
+                <a16:creationId xmlns:a16="http://schemas.microsoft.com/office/drawing/2014/main" id="{36FB65CD-1B9B-489A-BBBA-221E0165D24D}"/>
               </a:ext>
             </a:extLst>
           </p:cNvPr>
@@ -6856,7 +6856,7 @@
                 <a:ea typeface="Aptos"/>
                 <a:cs typeface="Aptos"/>
               </a:rPr>
-              <a:t>Independent public evidence summary · 2026.07.23-11 · 2026-07-22 · Sources: RPX; CNIPA guidance; EPO family</a:t>
+              <a:t>Independent public evidence summary · 2026.07.23-12 · 2026-07-22 · Sources: RPX; CNIPA guidance; EPO family</a:t>
             </a:r>
           </a:p>
         </p:txBody>
@@ -6866,7 +6866,7 @@
           <p:cNvPr id="7" name="TextBox 6">
             <a:extLst xmlns:a="http://schemas.openxmlformats.org/drawingml/2006/main">
               <a:ext uri="{FF2B5EF4-FFF2-40B4-BE49-F238E27FC236}">
-                <a16:creationId xmlns:a16="http://schemas.microsoft.com/office/drawing/2014/main" id="{ACD52683-BA25-402A-83D5-630DC02AC1F5}"/>
+                <a16:creationId xmlns:a16="http://schemas.microsoft.com/office/drawing/2014/main" id="{A04B91AC-253A-4256-9762-5702A945D6C2}"/>
               </a:ext>
             </a:extLst>
           </p:cNvPr>
@@ -6913,7 +6913,7 @@
           <p:cNvPr id="8" name="TextBox 7">
             <a:extLst xmlns:a="http://schemas.openxmlformats.org/drawingml/2006/main">
               <a:ext uri="{FF2B5EF4-FFF2-40B4-BE49-F238E27FC236}">
-                <a16:creationId xmlns:a16="http://schemas.microsoft.com/office/drawing/2014/main" id="{791A2B7C-5A34-41AC-BCAE-91F1A0C9CA56}"/>
+                <a16:creationId xmlns:a16="http://schemas.microsoft.com/office/drawing/2014/main" id="{DDF8A575-EA5C-4868-B826-3E9CF843C7F3}"/>
               </a:ext>
             </a:extLst>
           </p:cNvPr>
@@ -6960,7 +6960,7 @@
           <p:cNvPr id="9" name="TextBox 8">
             <a:extLst xmlns:a="http://schemas.openxmlformats.org/drawingml/2006/main">
               <a:ext uri="{FF2B5EF4-FFF2-40B4-BE49-F238E27FC236}">
-                <a16:creationId xmlns:a16="http://schemas.microsoft.com/office/drawing/2014/main" id="{D7DA377A-0968-4D6F-B5E6-DCB9346A85D4}"/>
+                <a16:creationId xmlns:a16="http://schemas.microsoft.com/office/drawing/2014/main" id="{A147BB06-5460-44F0-957A-79D459B2D83B}"/>
               </a:ext>
             </a:extLst>
           </p:cNvPr>
@@ -7057,7 +7057,7 @@
           <p:cNvPr id="10" name="Rounded Rectangle 9">
             <a:extLst xmlns:a="http://schemas.openxmlformats.org/drawingml/2006/main">
               <a:ext uri="{FF2B5EF4-FFF2-40B4-BE49-F238E27FC236}">
-                <a16:creationId xmlns:a16="http://schemas.microsoft.com/office/drawing/2014/main" id="{68E3CCC7-7E5A-48A4-88AB-EC1758E85907}"/>
+                <a16:creationId xmlns:a16="http://schemas.microsoft.com/office/drawing/2014/main" id="{9E0313EA-6426-43A7-AAA0-D11C41CE2D79}"/>
               </a:ext>
             </a:extLst>
           </p:cNvPr>
@@ -7114,7 +7114,7 @@
           <p:cNvPr id="11" name="TextBox 10">
             <a:extLst xmlns:a="http://schemas.openxmlformats.org/drawingml/2006/main">
               <a:ext uri="{FF2B5EF4-FFF2-40B4-BE49-F238E27FC236}">
-                <a16:creationId xmlns:a16="http://schemas.microsoft.com/office/drawing/2014/main" id="{C51FB831-FA6B-4073-BF7C-52E82EEE2CE4}"/>
+                <a16:creationId xmlns:a16="http://schemas.microsoft.com/office/drawing/2014/main" id="{88BF3652-75D7-4075-982E-17A40BA5D65E}"/>
               </a:ext>
             </a:extLst>
           </p:cNvPr>
@@ -7161,7 +7161,7 @@
           <p:cNvPr id="12" name="TextBox 11">
             <a:extLst xmlns:a="http://schemas.openxmlformats.org/drawingml/2006/main">
               <a:ext uri="{FF2B5EF4-FFF2-40B4-BE49-F238E27FC236}">
-                <a16:creationId xmlns:a16="http://schemas.microsoft.com/office/drawing/2014/main" id="{2886A989-23DB-45DB-A944-2D76227A000E}"/>
+                <a16:creationId xmlns:a16="http://schemas.microsoft.com/office/drawing/2014/main" id="{2358EB64-5ABF-4AA4-9D45-D18E53221153}"/>
               </a:ext>
             </a:extLst>
           </p:cNvPr>
@@ -7206,7 +7206,7 @@
     </p:spTree>
     <p:extLst>
       <p:ext uri="{BB962C8B-B14F-4D97-AF65-F5344CB8AC3E}">
-        <p14:creationId xmlns:p14="http://schemas.microsoft.com/office/powerpoint/2010/main" val="1283933904"/>
+        <p14:creationId xmlns:p14="http://schemas.microsoft.com/office/powerpoint/2010/main" val="384004384"/>
       </p:ext>
     </p:extLst>
   </p:cSld>
@@ -7230,7 +7230,7 @@
           <p:cNvPr id="2" name="TextBox 1">
             <a:extLst xmlns:a="http://schemas.openxmlformats.org/drawingml/2006/main">
               <a:ext uri="{FF2B5EF4-FFF2-40B4-BE49-F238E27FC236}">
-                <a16:creationId xmlns:a16="http://schemas.microsoft.com/office/drawing/2014/main" id="{6BBE3564-E4A7-4B38-99B0-9A293E727DEF}"/>
+                <a16:creationId xmlns:a16="http://schemas.microsoft.com/office/drawing/2014/main" id="{E1FAFA87-7A41-4342-A951-2766C24E9949}"/>
               </a:ext>
             </a:extLst>
           </p:cNvPr>
@@ -7277,7 +7277,7 @@
           <p:cNvPr id="3" name="TextBox 2">
             <a:extLst xmlns:a="http://schemas.openxmlformats.org/drawingml/2006/main">
               <a:ext uri="{FF2B5EF4-FFF2-40B4-BE49-F238E27FC236}">
-                <a16:creationId xmlns:a16="http://schemas.microsoft.com/office/drawing/2014/main" id="{0875BA64-0119-4842-A492-4AA3B4183D8A}"/>
+                <a16:creationId xmlns:a16="http://schemas.microsoft.com/office/drawing/2014/main" id="{6293DF1B-94A9-443B-9615-E655D7119B72}"/>
               </a:ext>
             </a:extLst>
           </p:cNvPr>
@@ -7324,7 +7324,7 @@
           <p:cNvPr id="4" name="Rectangle 3">
             <a:extLst xmlns:a="http://schemas.openxmlformats.org/drawingml/2006/main">
               <a:ext uri="{FF2B5EF4-FFF2-40B4-BE49-F238E27FC236}">
-                <a16:creationId xmlns:a16="http://schemas.microsoft.com/office/drawing/2014/main" id="{B70C0224-B96E-4BCF-9B60-2C35F06ABD7F}"/>
+                <a16:creationId xmlns:a16="http://schemas.microsoft.com/office/drawing/2014/main" id="{4D31CF89-0D6A-4069-893A-5B59B21A012F}"/>
               </a:ext>
             </a:extLst>
           </p:cNvPr>
@@ -7379,7 +7379,7 @@
           <p:cNvPr id="5" name="Rectangle 4">
             <a:extLst xmlns:a="http://schemas.openxmlformats.org/drawingml/2006/main">
               <a:ext uri="{FF2B5EF4-FFF2-40B4-BE49-F238E27FC236}">
-                <a16:creationId xmlns:a16="http://schemas.microsoft.com/office/drawing/2014/main" id="{C21C2F0A-32AB-43BF-B93D-AD331F4C36C0}"/>
+                <a16:creationId xmlns:a16="http://schemas.microsoft.com/office/drawing/2014/main" id="{E79F0A3C-3DB7-4E0B-8D8E-8ADEB661F57D}"/>
               </a:ext>
             </a:extLst>
           </p:cNvPr>
@@ -7434,7 +7434,7 @@
           <p:cNvPr id="6" name="TextBox 5">
             <a:extLst xmlns:a="http://schemas.openxmlformats.org/drawingml/2006/main">
               <a:ext uri="{FF2B5EF4-FFF2-40B4-BE49-F238E27FC236}">
-                <a16:creationId xmlns:a16="http://schemas.microsoft.com/office/drawing/2014/main" id="{CFCF2316-FF3C-43E7-B080-7C0FA30C0164}"/>
+                <a16:creationId xmlns:a16="http://schemas.microsoft.com/office/drawing/2014/main" id="{5BD7B9F5-F02C-49F0-826F-F0199E5C9759}"/>
               </a:ext>
             </a:extLst>
           </p:cNvPr>
@@ -7471,7 +7471,7 @@
                 <a:ea typeface="Aptos"/>
                 <a:cs typeface="Aptos"/>
               </a:rPr>
-              <a:t>Independent public evidence summary · 2026.07.23-11 · 2026-07-22 · Sources: IP Australia; PRH; EPO; EPO / UPC; USPTO</a:t>
+              <a:t>Independent public evidence summary · 2026.07.23-12 · 2026-07-22 · Sources: IP Australia; PRH; EPO; EPO / UPC; USPTO</a:t>
             </a:r>
           </a:p>
         </p:txBody>
@@ -7481,7 +7481,7 @@
           <p:cNvPr id="7" name="TextBox 6">
             <a:extLst xmlns:a="http://schemas.openxmlformats.org/drawingml/2006/main">
               <a:ext uri="{FF2B5EF4-FFF2-40B4-BE49-F238E27FC236}">
-                <a16:creationId xmlns:a16="http://schemas.microsoft.com/office/drawing/2014/main" id="{EB74F2ED-5D48-4CFF-839D-FE798D95BBB7}"/>
+                <a16:creationId xmlns:a16="http://schemas.microsoft.com/office/drawing/2014/main" id="{D8EF72CB-16F4-47DB-83CD-BB3CDD3F3452}"/>
               </a:ext>
             </a:extLst>
           </p:cNvPr>
@@ -7968,7 +7968,7 @@
           <p:cNvPr id="9" name="TextBox 8">
             <a:extLst xmlns:a="http://schemas.openxmlformats.org/drawingml/2006/main">
               <a:ext uri="{FF2B5EF4-FFF2-40B4-BE49-F238E27FC236}">
-                <a16:creationId xmlns:a16="http://schemas.microsoft.com/office/drawing/2014/main" id="{9ADD5ED6-9731-493F-8AFC-E28D3CF886F4}"/>
+                <a16:creationId xmlns:a16="http://schemas.microsoft.com/office/drawing/2014/main" id="{78106151-9A54-41D9-9775-ACC8048BC217}"/>
               </a:ext>
             </a:extLst>
           </p:cNvPr>
@@ -8013,7 +8013,7 @@
     </p:spTree>
     <p:extLst>
       <p:ext uri="{BB962C8B-B14F-4D97-AF65-F5344CB8AC3E}">
-        <p14:creationId xmlns:p14="http://schemas.microsoft.com/office/powerpoint/2010/main" val="813080793"/>
+        <p14:creationId xmlns:p14="http://schemas.microsoft.com/office/powerpoint/2010/main" val="2007091940"/>
       </p:ext>
     </p:extLst>
   </p:cSld>
@@ -8037,7 +8037,7 @@
           <p:cNvPr id="2" name="TextBox 1">
             <a:extLst xmlns:a="http://schemas.openxmlformats.org/drawingml/2006/main">
               <a:ext uri="{FF2B5EF4-FFF2-40B4-BE49-F238E27FC236}">
-                <a16:creationId xmlns:a16="http://schemas.microsoft.com/office/drawing/2014/main" id="{83E7E9E7-A255-4CD5-A437-8281F8024E6B}"/>
+                <a16:creationId xmlns:a16="http://schemas.microsoft.com/office/drawing/2014/main" id="{7C90A113-52A6-44CD-9283-1CFDE0085091}"/>
               </a:ext>
             </a:extLst>
           </p:cNvPr>
@@ -8084,7 +8084,7 @@
           <p:cNvPr id="3" name="TextBox 2">
             <a:extLst xmlns:a="http://schemas.openxmlformats.org/drawingml/2006/main">
               <a:ext uri="{FF2B5EF4-FFF2-40B4-BE49-F238E27FC236}">
-                <a16:creationId xmlns:a16="http://schemas.microsoft.com/office/drawing/2014/main" id="{0E23D26C-1474-44A9-B037-D7811D8F97C8}"/>
+                <a16:creationId xmlns:a16="http://schemas.microsoft.com/office/drawing/2014/main" id="{E9DA814B-9F18-4E4F-880D-6B1364F8711C}"/>
               </a:ext>
             </a:extLst>
           </p:cNvPr>
@@ -8131,7 +8131,7 @@
           <p:cNvPr id="4" name="Rectangle 3">
             <a:extLst xmlns:a="http://schemas.openxmlformats.org/drawingml/2006/main">
               <a:ext uri="{FF2B5EF4-FFF2-40B4-BE49-F238E27FC236}">
-                <a16:creationId xmlns:a16="http://schemas.microsoft.com/office/drawing/2014/main" id="{ADD958E2-9C75-4F7C-84DF-467870D8B136}"/>
+                <a16:creationId xmlns:a16="http://schemas.microsoft.com/office/drawing/2014/main" id="{AB05DE5D-A12F-4F44-AD76-A81AD5CD3287}"/>
               </a:ext>
             </a:extLst>
           </p:cNvPr>
@@ -8186,7 +8186,7 @@
           <p:cNvPr id="5" name="Rectangle 4">
             <a:extLst xmlns:a="http://schemas.openxmlformats.org/drawingml/2006/main">
               <a:ext uri="{FF2B5EF4-FFF2-40B4-BE49-F238E27FC236}">
-                <a16:creationId xmlns:a16="http://schemas.microsoft.com/office/drawing/2014/main" id="{EFA6400C-107D-4BBC-B295-F5733076AE5F}"/>
+                <a16:creationId xmlns:a16="http://schemas.microsoft.com/office/drawing/2014/main" id="{3FD9B027-2C56-48EE-9C58-391B88FC637B}"/>
               </a:ext>
             </a:extLst>
           </p:cNvPr>
@@ -8241,7 +8241,7 @@
           <p:cNvPr id="6" name="TextBox 5">
             <a:extLst xmlns:a="http://schemas.openxmlformats.org/drawingml/2006/main">
               <a:ext uri="{FF2B5EF4-FFF2-40B4-BE49-F238E27FC236}">
-                <a16:creationId xmlns:a16="http://schemas.microsoft.com/office/drawing/2014/main" id="{D59947B2-BB7D-45EF-869D-837704F9FACE}"/>
+                <a16:creationId xmlns:a16="http://schemas.microsoft.com/office/drawing/2014/main" id="{334C576B-76B6-4824-B326-9493BC0343EA}"/>
               </a:ext>
             </a:extLst>
           </p:cNvPr>
@@ -8278,7 +8278,7 @@
                 <a:ea typeface="Aptos"/>
                 <a:cs typeface="Aptos"/>
               </a:rPr>
-              <a:t>Independent public evidence summary · 2026.07.23-11 · 2026-07-22 · Sources: UN; Atlas</a:t>
+              <a:t>Independent public evidence summary · 2026.07.23-12 · 2026-07-22 · Sources: UN; Atlas</a:t>
             </a:r>
           </a:p>
         </p:txBody>
@@ -8288,7 +8288,7 @@
           <p:cNvPr id="7" name="TextBox 6">
             <a:extLst xmlns:a="http://schemas.openxmlformats.org/drawingml/2006/main">
               <a:ext uri="{FF2B5EF4-FFF2-40B4-BE49-F238E27FC236}">
-                <a16:creationId xmlns:a16="http://schemas.microsoft.com/office/drawing/2014/main" id="{8F247A69-64CD-49A5-B050-C8669BA7A936}"/>
+                <a16:creationId xmlns:a16="http://schemas.microsoft.com/office/drawing/2014/main" id="{BF0B86AB-DD5A-402C-B78A-FFDF3B3D7169}"/>
               </a:ext>
             </a:extLst>
           </p:cNvPr>
@@ -8335,7 +8335,7 @@
           <p:cNvPr id="8" name="Rounded Rectangle 7">
             <a:extLst xmlns:a="http://schemas.openxmlformats.org/drawingml/2006/main">
               <a:ext uri="{FF2B5EF4-FFF2-40B4-BE49-F238E27FC236}">
-                <a16:creationId xmlns:a16="http://schemas.microsoft.com/office/drawing/2014/main" id="{65AD9409-DA7E-4B38-AA14-91314C3413AD}"/>
+                <a16:creationId xmlns:a16="http://schemas.microsoft.com/office/drawing/2014/main" id="{3D59BF14-1209-4A62-A3EE-3911A276488C}"/>
               </a:ext>
             </a:extLst>
           </p:cNvPr>
@@ -8392,7 +8392,7 @@
           <p:cNvPr id="9" name="TextBox 8">
             <a:extLst xmlns:a="http://schemas.openxmlformats.org/drawingml/2006/main">
               <a:ext uri="{FF2B5EF4-FFF2-40B4-BE49-F238E27FC236}">
-                <a16:creationId xmlns:a16="http://schemas.microsoft.com/office/drawing/2014/main" id="{B0275603-FE95-4480-913F-1CBF68E4D129}"/>
+                <a16:creationId xmlns:a16="http://schemas.microsoft.com/office/drawing/2014/main" id="{44D894F2-94A8-464A-A4DF-06BE7279D54B}"/>
               </a:ext>
             </a:extLst>
           </p:cNvPr>
@@ -8439,7 +8439,7 @@
           <p:cNvPr id="10" name="TextBox 9">
             <a:extLst xmlns:a="http://schemas.openxmlformats.org/drawingml/2006/main">
               <a:ext uri="{FF2B5EF4-FFF2-40B4-BE49-F238E27FC236}">
-                <a16:creationId xmlns:a16="http://schemas.microsoft.com/office/drawing/2014/main" id="{34A753AE-92C9-444B-8DF7-F4C30A71106A}"/>
+                <a16:creationId xmlns:a16="http://schemas.microsoft.com/office/drawing/2014/main" id="{23C19D11-5DAD-4023-8E62-27B5017E1D75}"/>
               </a:ext>
             </a:extLst>
           </p:cNvPr>
@@ -8486,7 +8486,7 @@
           <p:cNvPr id="11" name="Rounded Rectangle 10">
             <a:extLst xmlns:a="http://schemas.openxmlformats.org/drawingml/2006/main">
               <a:ext uri="{FF2B5EF4-FFF2-40B4-BE49-F238E27FC236}">
-                <a16:creationId xmlns:a16="http://schemas.microsoft.com/office/drawing/2014/main" id="{7B6CB931-B7DF-4002-B4BF-89415E28BC12}"/>
+                <a16:creationId xmlns:a16="http://schemas.microsoft.com/office/drawing/2014/main" id="{D1303290-7708-4E5E-B511-E649DE6E4574}"/>
               </a:ext>
             </a:extLst>
           </p:cNvPr>
@@ -8543,7 +8543,7 @@
           <p:cNvPr id="12" name="TextBox 11">
             <a:extLst xmlns:a="http://schemas.openxmlformats.org/drawingml/2006/main">
               <a:ext uri="{FF2B5EF4-FFF2-40B4-BE49-F238E27FC236}">
-                <a16:creationId xmlns:a16="http://schemas.microsoft.com/office/drawing/2014/main" id="{EAFB984C-A669-4C7E-B685-7B52C6AB3038}"/>
+                <a16:creationId xmlns:a16="http://schemas.microsoft.com/office/drawing/2014/main" id="{640C2A7E-4CD9-4743-8C49-FC241A8E4415}"/>
               </a:ext>
             </a:extLst>
           </p:cNvPr>
@@ -8590,7 +8590,7 @@
           <p:cNvPr id="13" name="TextBox 12">
             <a:extLst xmlns:a="http://schemas.openxmlformats.org/drawingml/2006/main">
               <a:ext uri="{FF2B5EF4-FFF2-40B4-BE49-F238E27FC236}">
-                <a16:creationId xmlns:a16="http://schemas.microsoft.com/office/drawing/2014/main" id="{80E0438D-7F36-41AC-A2EA-ECC019B098D2}"/>
+                <a16:creationId xmlns:a16="http://schemas.microsoft.com/office/drawing/2014/main" id="{EF798857-53EE-421A-BD17-35190714DD08}"/>
               </a:ext>
             </a:extLst>
           </p:cNvPr>
@@ -8637,7 +8637,7 @@
           <p:cNvPr id="14" name="Rounded Rectangle 13">
             <a:extLst xmlns:a="http://schemas.openxmlformats.org/drawingml/2006/main">
               <a:ext uri="{FF2B5EF4-FFF2-40B4-BE49-F238E27FC236}">
-                <a16:creationId xmlns:a16="http://schemas.microsoft.com/office/drawing/2014/main" id="{18E8B1C0-5E60-4B1D-8B0B-E8CA3840241D}"/>
+                <a16:creationId xmlns:a16="http://schemas.microsoft.com/office/drawing/2014/main" id="{145D7076-A7C8-43EB-8748-39B0A5F5AD09}"/>
               </a:ext>
             </a:extLst>
           </p:cNvPr>
@@ -8694,7 +8694,7 @@
           <p:cNvPr id="15" name="TextBox 14">
             <a:extLst xmlns:a="http://schemas.openxmlformats.org/drawingml/2006/main">
               <a:ext uri="{FF2B5EF4-FFF2-40B4-BE49-F238E27FC236}">
-                <a16:creationId xmlns:a16="http://schemas.microsoft.com/office/drawing/2014/main" id="{073B9E06-E0BC-4071-B5BF-E982053AA5D6}"/>
+                <a16:creationId xmlns:a16="http://schemas.microsoft.com/office/drawing/2014/main" id="{4BE5288B-11AD-4859-955C-8E3AB4E3002E}"/>
               </a:ext>
             </a:extLst>
           </p:cNvPr>
@@ -8741,7 +8741,7 @@
           <p:cNvPr id="16" name="TextBox 15">
             <a:extLst xmlns:a="http://schemas.openxmlformats.org/drawingml/2006/main">
               <a:ext uri="{FF2B5EF4-FFF2-40B4-BE49-F238E27FC236}">
-                <a16:creationId xmlns:a16="http://schemas.microsoft.com/office/drawing/2014/main" id="{883DDB40-15C2-4BC3-8778-C34019F5E519}"/>
+                <a16:creationId xmlns:a16="http://schemas.microsoft.com/office/drawing/2014/main" id="{3273C7EE-C81C-44C7-B716-00A3D856C329}"/>
               </a:ext>
             </a:extLst>
           </p:cNvPr>
@@ -8788,7 +8788,7 @@
           <p:cNvPr id="17" name="Rounded Rectangle 16">
             <a:extLst xmlns:a="http://schemas.openxmlformats.org/drawingml/2006/main">
               <a:ext uri="{FF2B5EF4-FFF2-40B4-BE49-F238E27FC236}">
-                <a16:creationId xmlns:a16="http://schemas.microsoft.com/office/drawing/2014/main" id="{5907A372-E6B0-4424-A49A-9E1401E9E795}"/>
+                <a16:creationId xmlns:a16="http://schemas.microsoft.com/office/drawing/2014/main" id="{43E047F5-83B5-4848-B0EC-163A57E79360}"/>
               </a:ext>
             </a:extLst>
           </p:cNvPr>
@@ -8845,7 +8845,7 @@
           <p:cNvPr id="18" name="TextBox 17">
             <a:extLst xmlns:a="http://schemas.openxmlformats.org/drawingml/2006/main">
               <a:ext uri="{FF2B5EF4-FFF2-40B4-BE49-F238E27FC236}">
-                <a16:creationId xmlns:a16="http://schemas.microsoft.com/office/drawing/2014/main" id="{0F699235-730C-4A63-B615-9B15796D3EB6}"/>
+                <a16:creationId xmlns:a16="http://schemas.microsoft.com/office/drawing/2014/main" id="{2921064E-902C-40EA-902C-58A2A792AF90}"/>
               </a:ext>
             </a:extLst>
           </p:cNvPr>
@@ -8892,7 +8892,7 @@
           <p:cNvPr id="19" name="TextBox 18">
             <a:extLst xmlns:a="http://schemas.openxmlformats.org/drawingml/2006/main">
               <a:ext uri="{FF2B5EF4-FFF2-40B4-BE49-F238E27FC236}">
-                <a16:creationId xmlns:a16="http://schemas.microsoft.com/office/drawing/2014/main" id="{3CD87749-055B-4BE0-B323-60252D4A9525}"/>
+                <a16:creationId xmlns:a16="http://schemas.microsoft.com/office/drawing/2014/main" id="{AAFF7606-7CAC-4D7F-A03A-BBB66BE05DC3}"/>
               </a:ext>
             </a:extLst>
           </p:cNvPr>
@@ -8939,7 +8939,7 @@
           <p:cNvPr id="20" name="TextBox 19">
             <a:extLst xmlns:a="http://schemas.openxmlformats.org/drawingml/2006/main">
               <a:ext uri="{FF2B5EF4-FFF2-40B4-BE49-F238E27FC236}">
-                <a16:creationId xmlns:a16="http://schemas.microsoft.com/office/drawing/2014/main" id="{71D3152D-DE3C-46EC-BD73-D5AA45C414EA}"/>
+                <a16:creationId xmlns:a16="http://schemas.microsoft.com/office/drawing/2014/main" id="{68FC7135-6DCF-49FC-A4FC-D6181C9DAAD6}"/>
               </a:ext>
             </a:extLst>
           </p:cNvPr>
@@ -8986,7 +8986,7 @@
           <p:cNvPr id="21" name="Rounded Rectangle 20">
             <a:extLst xmlns:a="http://schemas.openxmlformats.org/drawingml/2006/main">
               <a:ext uri="{FF2B5EF4-FFF2-40B4-BE49-F238E27FC236}">
-                <a16:creationId xmlns:a16="http://schemas.microsoft.com/office/drawing/2014/main" id="{097FDE0C-8E62-40B6-BD95-5B9F11AAC2B1}"/>
+                <a16:creationId xmlns:a16="http://schemas.microsoft.com/office/drawing/2014/main" id="{79761306-BB7D-4A33-BB70-E577570D61AB}"/>
               </a:ext>
             </a:extLst>
           </p:cNvPr>
@@ -9043,7 +9043,7 @@
           <p:cNvPr id="22" name="TextBox 21">
             <a:extLst xmlns:a="http://schemas.openxmlformats.org/drawingml/2006/main">
               <a:ext uri="{FF2B5EF4-FFF2-40B4-BE49-F238E27FC236}">
-                <a16:creationId xmlns:a16="http://schemas.microsoft.com/office/drawing/2014/main" id="{1CE2088F-C66A-4721-9A8E-6B6DCDCBD71D}"/>
+                <a16:creationId xmlns:a16="http://schemas.microsoft.com/office/drawing/2014/main" id="{EFE9D8F8-7883-446D-83A8-3193A842E28C}"/>
               </a:ext>
             </a:extLst>
           </p:cNvPr>
@@ -9090,7 +9090,7 @@
           <p:cNvPr id="23" name="TextBox 22">
             <a:extLst xmlns:a="http://schemas.openxmlformats.org/drawingml/2006/main">
               <a:ext uri="{FF2B5EF4-FFF2-40B4-BE49-F238E27FC236}">
-                <a16:creationId xmlns:a16="http://schemas.microsoft.com/office/drawing/2014/main" id="{0428FB92-F183-409A-833F-DB035DFF9F45}"/>
+                <a16:creationId xmlns:a16="http://schemas.microsoft.com/office/drawing/2014/main" id="{DE8C8441-9F47-41C0-BD08-7F4E32936094}"/>
               </a:ext>
             </a:extLst>
           </p:cNvPr>
@@ -9135,7 +9135,7 @@
     </p:spTree>
     <p:extLst>
       <p:ext uri="{BB962C8B-B14F-4D97-AF65-F5344CB8AC3E}">
-        <p14:creationId xmlns:p14="http://schemas.microsoft.com/office/powerpoint/2010/main" val="2086873088"/>
+        <p14:creationId xmlns:p14="http://schemas.microsoft.com/office/powerpoint/2010/main" val="1446232686"/>
       </p:ext>
     </p:extLst>
   </p:cSld>
@@ -9159,7 +9159,7 @@
           <p:cNvPr id="2" name="TextBox 1">
             <a:extLst xmlns:a="http://schemas.openxmlformats.org/drawingml/2006/main">
               <a:ext uri="{FF2B5EF4-FFF2-40B4-BE49-F238E27FC236}">
-                <a16:creationId xmlns:a16="http://schemas.microsoft.com/office/drawing/2014/main" id="{B849AB76-DF25-4E77-9C53-6903765B64B6}"/>
+                <a16:creationId xmlns:a16="http://schemas.microsoft.com/office/drawing/2014/main" id="{8E2C5999-A6FD-4CBA-8140-91148C8ABDC1}"/>
               </a:ext>
             </a:extLst>
           </p:cNvPr>
@@ -9206,7 +9206,7 @@
           <p:cNvPr id="3" name="TextBox 2">
             <a:extLst xmlns:a="http://schemas.openxmlformats.org/drawingml/2006/main">
               <a:ext uri="{FF2B5EF4-FFF2-40B4-BE49-F238E27FC236}">
-                <a16:creationId xmlns:a16="http://schemas.microsoft.com/office/drawing/2014/main" id="{069F2A74-3E7C-4A6A-84ED-70809408F1F6}"/>
+                <a16:creationId xmlns:a16="http://schemas.microsoft.com/office/drawing/2014/main" id="{CC150BCD-BD59-4D36-B1A6-EE2F5A23A0B8}"/>
               </a:ext>
             </a:extLst>
           </p:cNvPr>
@@ -9253,7 +9253,7 @@
           <p:cNvPr id="4" name="Rectangle 3">
             <a:extLst xmlns:a="http://schemas.openxmlformats.org/drawingml/2006/main">
               <a:ext uri="{FF2B5EF4-FFF2-40B4-BE49-F238E27FC236}">
-                <a16:creationId xmlns:a16="http://schemas.microsoft.com/office/drawing/2014/main" id="{09F2AA74-AFE8-46F4-A375-D40D8D91A3BC}"/>
+                <a16:creationId xmlns:a16="http://schemas.microsoft.com/office/drawing/2014/main" id="{ED6B07B5-2C2B-4EB2-8E0F-5EFB0420647F}"/>
               </a:ext>
             </a:extLst>
           </p:cNvPr>
@@ -9308,7 +9308,7 @@
           <p:cNvPr id="5" name="Rectangle 4">
             <a:extLst xmlns:a="http://schemas.openxmlformats.org/drawingml/2006/main">
               <a:ext uri="{FF2B5EF4-FFF2-40B4-BE49-F238E27FC236}">
-                <a16:creationId xmlns:a16="http://schemas.microsoft.com/office/drawing/2014/main" id="{663CC336-7886-4105-BF68-1BBCCEB8E58F}"/>
+                <a16:creationId xmlns:a16="http://schemas.microsoft.com/office/drawing/2014/main" id="{CA03FDB6-FDEA-4364-8A21-19303A5FD8AF}"/>
               </a:ext>
             </a:extLst>
           </p:cNvPr>
@@ -9363,7 +9363,7 @@
           <p:cNvPr id="6" name="TextBox 5">
             <a:extLst xmlns:a="http://schemas.openxmlformats.org/drawingml/2006/main">
               <a:ext uri="{FF2B5EF4-FFF2-40B4-BE49-F238E27FC236}">
-                <a16:creationId xmlns:a16="http://schemas.microsoft.com/office/drawing/2014/main" id="{D731022E-18BA-47CB-A341-94085A7D78E2}"/>
+                <a16:creationId xmlns:a16="http://schemas.microsoft.com/office/drawing/2014/main" id="{7EEEE1CA-893B-4B63-9EDE-EA00C0FD8A94}"/>
               </a:ext>
             </a:extLst>
           </p:cNvPr>
@@ -9400,7 +9400,7 @@
                 <a:ea typeface="Aptos"/>
                 <a:cs typeface="Aptos"/>
               </a:rPr>
-              <a:t>Independent public evidence summary · 2026.07.23-11 · 2026-07-22 · Sources: Health Canada; Destatis; Vero; Sejm; Swedish Government</a:t>
+              <a:t>Independent public evidence summary · 2026.07.23-12 · 2026-07-22 · Sources: Health Canada; Destatis; Vero; Sejm; Swedish Government</a:t>
             </a:r>
           </a:p>
         </p:txBody>
@@ -9410,7 +9410,7 @@
           <p:cNvPr id="7" name="TextBox 6">
             <a:extLst xmlns:a="http://schemas.openxmlformats.org/drawingml/2006/main">
               <a:ext uri="{FF2B5EF4-FFF2-40B4-BE49-F238E27FC236}">
-                <a16:creationId xmlns:a16="http://schemas.microsoft.com/office/drawing/2014/main" id="{5F2AE8CA-7B22-4CC2-A887-9E1E564E8E27}"/>
+                <a16:creationId xmlns:a16="http://schemas.microsoft.com/office/drawing/2014/main" id="{81F24B31-8F84-4487-9F2A-9B24CDA63AF3}"/>
               </a:ext>
             </a:extLst>
           </p:cNvPr>
@@ -9980,7 +9980,7 @@
           <p:cNvPr id="9" name="TextBox 8">
             <a:extLst xmlns:a="http://schemas.openxmlformats.org/drawingml/2006/main">
               <a:ext uri="{FF2B5EF4-FFF2-40B4-BE49-F238E27FC236}">
-                <a16:creationId xmlns:a16="http://schemas.microsoft.com/office/drawing/2014/main" id="{94E0904C-1306-4D46-B0DC-DCF02E519293}"/>
+                <a16:creationId xmlns:a16="http://schemas.microsoft.com/office/drawing/2014/main" id="{790585F0-EC56-4637-A93A-B0A1575748D4}"/>
               </a:ext>
             </a:extLst>
           </p:cNvPr>
@@ -10025,7 +10025,7 @@
     </p:spTree>
     <p:extLst>
       <p:ext uri="{BB962C8B-B14F-4D97-AF65-F5344CB8AC3E}">
-        <p14:creationId xmlns:p14="http://schemas.microsoft.com/office/powerpoint/2010/main" val="168174732"/>
+        <p14:creationId xmlns:p14="http://schemas.microsoft.com/office/powerpoint/2010/main" val="781295645"/>
       </p:ext>
     </p:extLst>
   </p:cSld>
@@ -10049,7 +10049,7 @@
           <p:cNvPr id="2" name="TextBox 1">
             <a:extLst xmlns:a="http://schemas.openxmlformats.org/drawingml/2006/main">
               <a:ext uri="{FF2B5EF4-FFF2-40B4-BE49-F238E27FC236}">
-                <a16:creationId xmlns:a16="http://schemas.microsoft.com/office/drawing/2014/main" id="{EC7DC5B3-54F2-495E-AC63-39EB7A3640F0}"/>
+                <a16:creationId xmlns:a16="http://schemas.microsoft.com/office/drawing/2014/main" id="{37BA35AB-382B-49B3-B1D8-C0840A91BD02}"/>
               </a:ext>
             </a:extLst>
           </p:cNvPr>
@@ -10096,7 +10096,7 @@
           <p:cNvPr id="3" name="TextBox 2">
             <a:extLst xmlns:a="http://schemas.openxmlformats.org/drawingml/2006/main">
               <a:ext uri="{FF2B5EF4-FFF2-40B4-BE49-F238E27FC236}">
-                <a16:creationId xmlns:a16="http://schemas.microsoft.com/office/drawing/2014/main" id="{845940B2-6493-4A78-9F91-48A4F0DDB6FF}"/>
+                <a16:creationId xmlns:a16="http://schemas.microsoft.com/office/drawing/2014/main" id="{7F6402E6-0FA2-475E-8246-50A3ABD23FAD}"/>
               </a:ext>
             </a:extLst>
           </p:cNvPr>
@@ -10143,7 +10143,7 @@
           <p:cNvPr id="4" name="Rectangle 3">
             <a:extLst xmlns:a="http://schemas.openxmlformats.org/drawingml/2006/main">
               <a:ext uri="{FF2B5EF4-FFF2-40B4-BE49-F238E27FC236}">
-                <a16:creationId xmlns:a16="http://schemas.microsoft.com/office/drawing/2014/main" id="{105E3BF9-662A-4416-A99D-638867D88CAE}"/>
+                <a16:creationId xmlns:a16="http://schemas.microsoft.com/office/drawing/2014/main" id="{730F0CE7-AECE-428E-A9D5-35BC915E6A88}"/>
               </a:ext>
             </a:extLst>
           </p:cNvPr>
@@ -10198,7 +10198,7 @@
           <p:cNvPr id="5" name="Rectangle 4">
             <a:extLst xmlns:a="http://schemas.openxmlformats.org/drawingml/2006/main">
               <a:ext uri="{FF2B5EF4-FFF2-40B4-BE49-F238E27FC236}">
-                <a16:creationId xmlns:a16="http://schemas.microsoft.com/office/drawing/2014/main" id="{8C9271E5-B4F0-4864-B516-9F3B22B5CAAD}"/>
+                <a16:creationId xmlns:a16="http://schemas.microsoft.com/office/drawing/2014/main" id="{A99F51AC-A67A-4062-83BF-84F7E3207D39}"/>
               </a:ext>
             </a:extLst>
           </p:cNvPr>
@@ -10253,7 +10253,7 @@
           <p:cNvPr id="6" name="TextBox 5">
             <a:extLst xmlns:a="http://schemas.openxmlformats.org/drawingml/2006/main">
               <a:ext uri="{FF2B5EF4-FFF2-40B4-BE49-F238E27FC236}">
-                <a16:creationId xmlns:a16="http://schemas.microsoft.com/office/drawing/2014/main" id="{553CAF99-F7B9-4F00-A44A-C8870FC45F53}"/>
+                <a16:creationId xmlns:a16="http://schemas.microsoft.com/office/drawing/2014/main" id="{9D525425-C36B-4E43-BFE7-8B1D53DACB2E}"/>
               </a:ext>
             </a:extLst>
           </p:cNvPr>
@@ -10290,7 +10290,7 @@
                 <a:ea typeface="Aptos"/>
                 <a:cs typeface="Aptos"/>
               </a:rPr>
-              <a:t>Independent public evidence summary · 2026.07.23-11 · 2026-07-22 · Sources: Health Canada 2024</a:t>
+              <a:t>Independent public evidence summary · 2026.07.23-12 · 2026-07-22 · Sources: Health Canada 2024</a:t>
             </a:r>
           </a:p>
         </p:txBody>
@@ -10300,7 +10300,7 @@
           <p:cNvPr id="7" name="TextBox 6">
             <a:extLst xmlns:a="http://schemas.openxmlformats.org/drawingml/2006/main">
               <a:ext uri="{FF2B5EF4-FFF2-40B4-BE49-F238E27FC236}">
-                <a16:creationId xmlns:a16="http://schemas.microsoft.com/office/drawing/2014/main" id="{6BD1070D-36CA-4F04-8EF6-C51E14F29ADC}"/>
+                <a16:creationId xmlns:a16="http://schemas.microsoft.com/office/drawing/2014/main" id="{B428C0BC-E21B-48BC-86CF-4FC276E5C28F}"/>
               </a:ext>
             </a:extLst>
           </p:cNvPr>
@@ -10347,7 +10347,7 @@
           <p:cNvPr id="8" name="Rounded Rectangle 7">
             <a:extLst xmlns:a="http://schemas.openxmlformats.org/drawingml/2006/main">
               <a:ext uri="{FF2B5EF4-FFF2-40B4-BE49-F238E27FC236}">
-                <a16:creationId xmlns:a16="http://schemas.microsoft.com/office/drawing/2014/main" id="{A3281213-3247-438D-A08C-6F30F13DA0D9}"/>
+                <a16:creationId xmlns:a16="http://schemas.microsoft.com/office/drawing/2014/main" id="{0EC7A6E2-B1BE-4216-B083-FCBE80EFCC26}"/>
               </a:ext>
             </a:extLst>
           </p:cNvPr>
@@ -10404,7 +10404,7 @@
           <p:cNvPr id="9" name="TextBox 8">
             <a:extLst xmlns:a="http://schemas.openxmlformats.org/drawingml/2006/main">
               <a:ext uri="{FF2B5EF4-FFF2-40B4-BE49-F238E27FC236}">
-                <a16:creationId xmlns:a16="http://schemas.microsoft.com/office/drawing/2014/main" id="{BA14D461-DB82-42E4-BDB4-3E3A93E71920}"/>
+                <a16:creationId xmlns:a16="http://schemas.microsoft.com/office/drawing/2014/main" id="{AB48E04D-E212-4008-ACDE-1F76390EDB56}"/>
               </a:ext>
             </a:extLst>
           </p:cNvPr>
@@ -10451,7 +10451,7 @@
           <p:cNvPr id="10" name="TextBox 9">
             <a:extLst xmlns:a="http://schemas.openxmlformats.org/drawingml/2006/main">
               <a:ext uri="{FF2B5EF4-FFF2-40B4-BE49-F238E27FC236}">
-                <a16:creationId xmlns:a16="http://schemas.microsoft.com/office/drawing/2014/main" id="{07B17D0B-ADE8-4EF8-BB70-F9BF3FE9A0A5}"/>
+                <a16:creationId xmlns:a16="http://schemas.microsoft.com/office/drawing/2014/main" id="{4ECD05F5-6BC7-4992-81D3-D1C5F3DDF8E0}"/>
               </a:ext>
             </a:extLst>
           </p:cNvPr>
@@ -10498,7 +10498,7 @@
           <p:cNvPr id="11" name="Rounded Rectangle 10">
             <a:extLst xmlns:a="http://schemas.openxmlformats.org/drawingml/2006/main">
               <a:ext uri="{FF2B5EF4-FFF2-40B4-BE49-F238E27FC236}">
-                <a16:creationId xmlns:a16="http://schemas.microsoft.com/office/drawing/2014/main" id="{3BCB83EF-078F-41EB-970E-78F589035981}"/>
+                <a16:creationId xmlns:a16="http://schemas.microsoft.com/office/drawing/2014/main" id="{186F05F5-DD54-42A1-805E-A8CF9F79B178}"/>
               </a:ext>
             </a:extLst>
           </p:cNvPr>
@@ -10555,7 +10555,7 @@
           <p:cNvPr id="12" name="TextBox 11">
             <a:extLst xmlns:a="http://schemas.openxmlformats.org/drawingml/2006/main">
               <a:ext uri="{FF2B5EF4-FFF2-40B4-BE49-F238E27FC236}">
-                <a16:creationId xmlns:a16="http://schemas.microsoft.com/office/drawing/2014/main" id="{DBC7B415-D97A-468E-96AB-364A6E4DFE7E}"/>
+                <a16:creationId xmlns:a16="http://schemas.microsoft.com/office/drawing/2014/main" id="{D5949BD9-556F-4A31-94A3-521AF430026D}"/>
               </a:ext>
             </a:extLst>
           </p:cNvPr>
@@ -10602,7 +10602,7 @@
           <p:cNvPr id="13" name="TextBox 12">
             <a:extLst xmlns:a="http://schemas.openxmlformats.org/drawingml/2006/main">
               <a:ext uri="{FF2B5EF4-FFF2-40B4-BE49-F238E27FC236}">
-                <a16:creationId xmlns:a16="http://schemas.microsoft.com/office/drawing/2014/main" id="{47BE71CA-EC72-4F3E-8273-DD17AC13EEFB}"/>
+                <a16:creationId xmlns:a16="http://schemas.microsoft.com/office/drawing/2014/main" id="{3E5E735B-5F7E-4DB0-BECB-613F54AB6942}"/>
               </a:ext>
             </a:extLst>
           </p:cNvPr>
@@ -10649,7 +10649,7 @@
           <p:cNvPr id="14" name="Rounded Rectangle 13">
             <a:extLst xmlns:a="http://schemas.openxmlformats.org/drawingml/2006/main">
               <a:ext uri="{FF2B5EF4-FFF2-40B4-BE49-F238E27FC236}">
-                <a16:creationId xmlns:a16="http://schemas.microsoft.com/office/drawing/2014/main" id="{413008A5-9E54-42E6-AF35-C845F2A447C4}"/>
+                <a16:creationId xmlns:a16="http://schemas.microsoft.com/office/drawing/2014/main" id="{7963EB74-6E95-4F4C-B49A-B386E5D85710}"/>
               </a:ext>
             </a:extLst>
           </p:cNvPr>
@@ -10706,7 +10706,7 @@
           <p:cNvPr id="15" name="TextBox 14">
             <a:extLst xmlns:a="http://schemas.openxmlformats.org/drawingml/2006/main">
               <a:ext uri="{FF2B5EF4-FFF2-40B4-BE49-F238E27FC236}">
-                <a16:creationId xmlns:a16="http://schemas.microsoft.com/office/drawing/2014/main" id="{B32DB0A2-FFC2-4354-8C17-B7474202A89B}"/>
+                <a16:creationId xmlns:a16="http://schemas.microsoft.com/office/drawing/2014/main" id="{CF609485-96D2-46C1-99B6-4C52A79E00E1}"/>
               </a:ext>
             </a:extLst>
           </p:cNvPr>
@@ -10753,7 +10753,7 @@
           <p:cNvPr id="16" name="TextBox 15">
             <a:extLst xmlns:a="http://schemas.openxmlformats.org/drawingml/2006/main">
               <a:ext uri="{FF2B5EF4-FFF2-40B4-BE49-F238E27FC236}">
-                <a16:creationId xmlns:a16="http://schemas.microsoft.com/office/drawing/2014/main" id="{6522A2C1-A84F-41CB-9ED5-8CCE9CD0DD74}"/>
+                <a16:creationId xmlns:a16="http://schemas.microsoft.com/office/drawing/2014/main" id="{B605433D-0A27-4111-AA26-FDC156570759}"/>
               </a:ext>
             </a:extLst>
           </p:cNvPr>
@@ -10800,7 +10800,7 @@
           <p:cNvPr id="17" name="TextBox 16">
             <a:extLst xmlns:a="http://schemas.openxmlformats.org/drawingml/2006/main">
               <a:ext uri="{FF2B5EF4-FFF2-40B4-BE49-F238E27FC236}">
-                <a16:creationId xmlns:a16="http://schemas.microsoft.com/office/drawing/2014/main" id="{08B12A30-4ADC-4871-8CAC-CD6CD05EA517}"/>
+                <a16:creationId xmlns:a16="http://schemas.microsoft.com/office/drawing/2014/main" id="{5310F90F-3A70-45F5-BDFD-7374B365C062}"/>
               </a:ext>
             </a:extLst>
           </p:cNvPr>
@@ -10847,7 +10847,7 @@
           <p:cNvPr id="18" name="Rounded Rectangle 17">
             <a:extLst xmlns:a="http://schemas.openxmlformats.org/drawingml/2006/main">
               <a:ext uri="{FF2B5EF4-FFF2-40B4-BE49-F238E27FC236}">
-                <a16:creationId xmlns:a16="http://schemas.microsoft.com/office/drawing/2014/main" id="{6FC55814-8DF0-419E-A0C2-BAE42BA684D9}"/>
+                <a16:creationId xmlns:a16="http://schemas.microsoft.com/office/drawing/2014/main" id="{92E06397-5561-471C-829F-9A2C78963233}"/>
               </a:ext>
             </a:extLst>
           </p:cNvPr>
@@ -10904,7 +10904,7 @@
           <p:cNvPr id="19" name="TextBox 18">
             <a:extLst xmlns:a="http://schemas.openxmlformats.org/drawingml/2006/main">
               <a:ext uri="{FF2B5EF4-FFF2-40B4-BE49-F238E27FC236}">
-                <a16:creationId xmlns:a16="http://schemas.microsoft.com/office/drawing/2014/main" id="{E8A2B5B3-B5B5-475E-8B4E-BD958AD60EEE}"/>
+                <a16:creationId xmlns:a16="http://schemas.microsoft.com/office/drawing/2014/main" id="{04F8A2F1-8AF4-421C-B1B1-7697BAA3F7FC}"/>
               </a:ext>
             </a:extLst>
           </p:cNvPr>
@@ -10951,7 +10951,7 @@
           <p:cNvPr id="20" name="TextBox 19">
             <a:extLst xmlns:a="http://schemas.openxmlformats.org/drawingml/2006/main">
               <a:ext uri="{FF2B5EF4-FFF2-40B4-BE49-F238E27FC236}">
-                <a16:creationId xmlns:a16="http://schemas.microsoft.com/office/drawing/2014/main" id="{FD3B1E4A-7503-4F93-848B-D9C954B1AB3C}"/>
+                <a16:creationId xmlns:a16="http://schemas.microsoft.com/office/drawing/2014/main" id="{EA42CED6-0505-475D-AC56-866FD0FE4060}"/>
               </a:ext>
             </a:extLst>
           </p:cNvPr>
@@ -10996,7 +10996,7 @@
     </p:spTree>
     <p:extLst>
       <p:ext uri="{BB962C8B-B14F-4D97-AF65-F5344CB8AC3E}">
-        <p14:creationId xmlns:p14="http://schemas.microsoft.com/office/powerpoint/2010/main" val="1563846229"/>
+        <p14:creationId xmlns:p14="http://schemas.microsoft.com/office/powerpoint/2010/main" val="237203948"/>
       </p:ext>
     </p:extLst>
   </p:cSld>
@@ -11020,7 +11020,7 @@
           <p:cNvPr id="2" name="TextBox 1">
             <a:extLst xmlns:a="http://schemas.openxmlformats.org/drawingml/2006/main">
               <a:ext uri="{FF2B5EF4-FFF2-40B4-BE49-F238E27FC236}">
-                <a16:creationId xmlns:a16="http://schemas.microsoft.com/office/drawing/2014/main" id="{25ECA68D-04B6-4D01-B053-2FDFF2D4E65F}"/>
+                <a16:creationId xmlns:a16="http://schemas.microsoft.com/office/drawing/2014/main" id="{35EF9102-081D-4631-80F1-2279012C02B2}"/>
               </a:ext>
             </a:extLst>
           </p:cNvPr>
@@ -11067,7 +11067,7 @@
           <p:cNvPr id="3" name="TextBox 2">
             <a:extLst xmlns:a="http://schemas.openxmlformats.org/drawingml/2006/main">
               <a:ext uri="{FF2B5EF4-FFF2-40B4-BE49-F238E27FC236}">
-                <a16:creationId xmlns:a16="http://schemas.microsoft.com/office/drawing/2014/main" id="{262286AE-C1C3-4E05-94E7-5FE48364081C}"/>
+                <a16:creationId xmlns:a16="http://schemas.microsoft.com/office/drawing/2014/main" id="{7BAFB982-1C1A-4F16-9176-64AB97FC1304}"/>
               </a:ext>
             </a:extLst>
           </p:cNvPr>
@@ -11114,7 +11114,7 @@
           <p:cNvPr id="4" name="Rectangle 3">
             <a:extLst xmlns:a="http://schemas.openxmlformats.org/drawingml/2006/main">
               <a:ext uri="{FF2B5EF4-FFF2-40B4-BE49-F238E27FC236}">
-                <a16:creationId xmlns:a16="http://schemas.microsoft.com/office/drawing/2014/main" id="{BFD5CF69-7EE1-467D-B105-243CB36A4E7B}"/>
+                <a16:creationId xmlns:a16="http://schemas.microsoft.com/office/drawing/2014/main" id="{B59B2097-9540-4B5E-8048-03156F29DAB2}"/>
               </a:ext>
             </a:extLst>
           </p:cNvPr>
@@ -11169,7 +11169,7 @@
           <p:cNvPr id="5" name="Rectangle 4">
             <a:extLst xmlns:a="http://schemas.openxmlformats.org/drawingml/2006/main">
               <a:ext uri="{FF2B5EF4-FFF2-40B4-BE49-F238E27FC236}">
-                <a16:creationId xmlns:a16="http://schemas.microsoft.com/office/drawing/2014/main" id="{CCBCEA1D-9FB4-4E69-89CC-FA97F0EE62D7}"/>
+                <a16:creationId xmlns:a16="http://schemas.microsoft.com/office/drawing/2014/main" id="{02FE7E74-EFF0-4CA3-A31B-0CD4281A8921}"/>
               </a:ext>
             </a:extLst>
           </p:cNvPr>
@@ -11224,7 +11224,7 @@
           <p:cNvPr id="6" name="TextBox 5">
             <a:extLst xmlns:a="http://schemas.openxmlformats.org/drawingml/2006/main">
               <a:ext uri="{FF2B5EF4-FFF2-40B4-BE49-F238E27FC236}">
-                <a16:creationId xmlns:a16="http://schemas.microsoft.com/office/drawing/2014/main" id="{20A08FDD-FFCD-4340-84A7-A485FE5AFB45}"/>
+                <a16:creationId xmlns:a16="http://schemas.microsoft.com/office/drawing/2014/main" id="{1D3D4473-6789-440A-BA93-5D887D356C87}"/>
               </a:ext>
             </a:extLst>
           </p:cNvPr>
@@ -11261,7 +11261,7 @@
                 <a:ea typeface="Aptos"/>
                 <a:cs typeface="Aptos"/>
               </a:rPr>
-              <a:t>Independent public evidence summary · 2026.07.23-11 · 2026-07-22 · Sources: Destatis</a:t>
+              <a:t>Independent public evidence summary · 2026.07.23-12 · 2026-07-22 · Sources: Destatis</a:t>
             </a:r>
           </a:p>
         </p:txBody>
@@ -11271,7 +11271,7 @@
           <p:cNvPr id="7" name="TextBox 6">
             <a:extLst xmlns:a="http://schemas.openxmlformats.org/drawingml/2006/main">
               <a:ext uri="{FF2B5EF4-FFF2-40B4-BE49-F238E27FC236}">
-                <a16:creationId xmlns:a16="http://schemas.microsoft.com/office/drawing/2014/main" id="{A1D6F7B9-57CA-4A7C-8C11-29A658A93186}"/>
+                <a16:creationId xmlns:a16="http://schemas.microsoft.com/office/drawing/2014/main" id="{1BC430F2-980B-46F5-A036-126E0F4632DC}"/>
               </a:ext>
             </a:extLst>
           </p:cNvPr>
@@ -11784,7 +11784,7 @@
           <p:cNvPr id="9" name="TextBox 8">
             <a:extLst xmlns:a="http://schemas.openxmlformats.org/drawingml/2006/main">
               <a:ext uri="{FF2B5EF4-FFF2-40B4-BE49-F238E27FC236}">
-                <a16:creationId xmlns:a16="http://schemas.microsoft.com/office/drawing/2014/main" id="{1FDC591A-3A4A-4590-83B7-A920ABFAABF1}"/>
+                <a16:creationId xmlns:a16="http://schemas.microsoft.com/office/drawing/2014/main" id="{06B479E7-A0F9-4677-A6E4-59F3C8B178C5}"/>
               </a:ext>
             </a:extLst>
           </p:cNvPr>
@@ -11829,7 +11829,7 @@
     </p:spTree>
     <p:extLst>
       <p:ext uri="{BB962C8B-B14F-4D97-AF65-F5344CB8AC3E}">
-        <p14:creationId xmlns:p14="http://schemas.microsoft.com/office/powerpoint/2010/main" val="1924246346"/>
+        <p14:creationId xmlns:p14="http://schemas.microsoft.com/office/powerpoint/2010/main" val="269447777"/>
       </p:ext>
     </p:extLst>
   </p:cSld>
@@ -11853,7 +11853,7 @@
           <p:cNvPr id="2" name="TextBox 1">
             <a:extLst xmlns:a="http://schemas.openxmlformats.org/drawingml/2006/main">
               <a:ext uri="{FF2B5EF4-FFF2-40B4-BE49-F238E27FC236}">
-                <a16:creationId xmlns:a16="http://schemas.microsoft.com/office/drawing/2014/main" id="{0C4E630C-F660-4F1E-B66D-D496C2E42377}"/>
+                <a16:creationId xmlns:a16="http://schemas.microsoft.com/office/drawing/2014/main" id="{F475FCDE-CC93-4999-B0EC-8E9E3C6B9AFD}"/>
               </a:ext>
             </a:extLst>
           </p:cNvPr>
@@ -11900,7 +11900,7 @@
           <p:cNvPr id="3" name="TextBox 2">
             <a:extLst xmlns:a="http://schemas.openxmlformats.org/drawingml/2006/main">
               <a:ext uri="{FF2B5EF4-FFF2-40B4-BE49-F238E27FC236}">
-                <a16:creationId xmlns:a16="http://schemas.microsoft.com/office/drawing/2014/main" id="{2D401984-36B9-4291-B6A9-39388383DEE2}"/>
+                <a16:creationId xmlns:a16="http://schemas.microsoft.com/office/drawing/2014/main" id="{6FD8D3EE-72DB-431E-BEE5-88838622EF28}"/>
               </a:ext>
             </a:extLst>
           </p:cNvPr>
@@ -11947,7 +11947,7 @@
           <p:cNvPr id="4" name="Rectangle 3">
             <a:extLst xmlns:a="http://schemas.openxmlformats.org/drawingml/2006/main">
               <a:ext uri="{FF2B5EF4-FFF2-40B4-BE49-F238E27FC236}">
-                <a16:creationId xmlns:a16="http://schemas.microsoft.com/office/drawing/2014/main" id="{DFAB0CDB-2EA2-4846-BD38-C5FBDCE16BC9}"/>
+                <a16:creationId xmlns:a16="http://schemas.microsoft.com/office/drawing/2014/main" id="{7AF374D9-BCF2-4C3D-AAB7-084CCC6295E0}"/>
               </a:ext>
             </a:extLst>
           </p:cNvPr>
@@ -12002,7 +12002,7 @@
           <p:cNvPr id="5" name="Rectangle 4">
             <a:extLst xmlns:a="http://schemas.openxmlformats.org/drawingml/2006/main">
               <a:ext uri="{FF2B5EF4-FFF2-40B4-BE49-F238E27FC236}">
-                <a16:creationId xmlns:a16="http://schemas.microsoft.com/office/drawing/2014/main" id="{3D768825-C38A-4A59-90F4-11152AE86358}"/>
+                <a16:creationId xmlns:a16="http://schemas.microsoft.com/office/drawing/2014/main" id="{27DDD5D5-A4C2-4E57-9A55-E65E3AC26853}"/>
               </a:ext>
             </a:extLst>
           </p:cNvPr>
@@ -12057,7 +12057,7 @@
           <p:cNvPr id="6" name="TextBox 5">
             <a:extLst xmlns:a="http://schemas.openxmlformats.org/drawingml/2006/main">
               <a:ext uri="{FF2B5EF4-FFF2-40B4-BE49-F238E27FC236}">
-                <a16:creationId xmlns:a16="http://schemas.microsoft.com/office/drawing/2014/main" id="{97AC2108-A160-4922-9796-91F5153A4E0E}"/>
+                <a16:creationId xmlns:a16="http://schemas.microsoft.com/office/drawing/2014/main" id="{9C49C8B7-3679-45A6-8944-20CDF9762454}"/>
               </a:ext>
             </a:extLst>
           </p:cNvPr>
@@ -12094,7 +12094,7 @@
                 <a:ea typeface="Aptos"/>
                 <a:cs typeface="Aptos"/>
               </a:rPr>
-              <a:t>Independent public evidence summary · 2026.07.23-11 · 2026-07-22 · Sources: Destatis; inTaste.de</a:t>
+              <a:t>Independent public evidence summary · 2026.07.23-12 · 2026-07-22 · Sources: Destatis; inTaste.de</a:t>
             </a:r>
           </a:p>
         </p:txBody>
@@ -12104,7 +12104,7 @@
           <p:cNvPr id="7" name="TextBox 6">
             <a:extLst xmlns:a="http://schemas.openxmlformats.org/drawingml/2006/main">
               <a:ext uri="{FF2B5EF4-FFF2-40B4-BE49-F238E27FC236}">
-                <a16:creationId xmlns:a16="http://schemas.microsoft.com/office/drawing/2014/main" id="{E6A69BAF-44CB-4DA8-B583-B4EE36F800EB}"/>
+                <a16:creationId xmlns:a16="http://schemas.microsoft.com/office/drawing/2014/main" id="{4C9EF761-F9A1-466F-B32D-1E0AB9884F11}"/>
               </a:ext>
             </a:extLst>
           </p:cNvPr>
@@ -12151,7 +12151,7 @@
           <p:cNvPr id="8" name="Rounded Rectangle 7">
             <a:extLst xmlns:a="http://schemas.openxmlformats.org/drawingml/2006/main">
               <a:ext uri="{FF2B5EF4-FFF2-40B4-BE49-F238E27FC236}">
-                <a16:creationId xmlns:a16="http://schemas.microsoft.com/office/drawing/2014/main" id="{EFD2C8A6-596C-43E8-847C-50607E188F45}"/>
+                <a16:creationId xmlns:a16="http://schemas.microsoft.com/office/drawing/2014/main" id="{7C30D30B-819F-4BB6-AAE7-E24E46C4757E}"/>
               </a:ext>
             </a:extLst>
           </p:cNvPr>
@@ -12208,7 +12208,7 @@
           <p:cNvPr id="9" name="TextBox 8">
             <a:extLst xmlns:a="http://schemas.openxmlformats.org/drawingml/2006/main">
               <a:ext uri="{FF2B5EF4-FFF2-40B4-BE49-F238E27FC236}">
-                <a16:creationId xmlns:a16="http://schemas.microsoft.com/office/drawing/2014/main" id="{61BD2918-5D6F-42F7-91E5-653F4A4F14C9}"/>
+                <a16:creationId xmlns:a16="http://schemas.microsoft.com/office/drawing/2014/main" id="{FBEC8696-CA6D-4B90-B1BC-BEBBEAB5FC4C}"/>
               </a:ext>
             </a:extLst>
           </p:cNvPr>
@@ -12255,7 +12255,7 @@
           <p:cNvPr id="10" name="TextBox 9">
             <a:extLst xmlns:a="http://schemas.openxmlformats.org/drawingml/2006/main">
               <a:ext uri="{FF2B5EF4-FFF2-40B4-BE49-F238E27FC236}">
-                <a16:creationId xmlns:a16="http://schemas.microsoft.com/office/drawing/2014/main" id="{18EC659F-6F22-445E-A4C1-0514F6E1D837}"/>
+                <a16:creationId xmlns:a16="http://schemas.microsoft.com/office/drawing/2014/main" id="{85576A2A-99D9-4391-8817-E21EE0A895AE}"/>
               </a:ext>
             </a:extLst>
           </p:cNvPr>
@@ -12302,7 +12302,7 @@
           <p:cNvPr id="11" name="Rounded Rectangle 10">
             <a:extLst xmlns:a="http://schemas.openxmlformats.org/drawingml/2006/main">
               <a:ext uri="{FF2B5EF4-FFF2-40B4-BE49-F238E27FC236}">
-                <a16:creationId xmlns:a16="http://schemas.microsoft.com/office/drawing/2014/main" id="{DDEFDA4C-65D0-4A03-8C87-E607B84537D3}"/>
+                <a16:creationId xmlns:a16="http://schemas.microsoft.com/office/drawing/2014/main" id="{2E507124-A637-4FBA-886C-3765EA1A95E7}"/>
               </a:ext>
             </a:extLst>
           </p:cNvPr>
@@ -12359,7 +12359,7 @@
           <p:cNvPr id="12" name="TextBox 11">
             <a:extLst xmlns:a="http://schemas.openxmlformats.org/drawingml/2006/main">
               <a:ext uri="{FF2B5EF4-FFF2-40B4-BE49-F238E27FC236}">
-                <a16:creationId xmlns:a16="http://schemas.microsoft.com/office/drawing/2014/main" id="{E4B84C38-2B00-4890-8D8D-27AB957874F7}"/>
+                <a16:creationId xmlns:a16="http://schemas.microsoft.com/office/drawing/2014/main" id="{AD80EA3B-FFE4-4A37-82C1-E7FBA0DD27D0}"/>
               </a:ext>
             </a:extLst>
           </p:cNvPr>
@@ -12406,7 +12406,7 @@
           <p:cNvPr id="13" name="TextBox 12">
             <a:extLst xmlns:a="http://schemas.openxmlformats.org/drawingml/2006/main">
               <a:ext uri="{FF2B5EF4-FFF2-40B4-BE49-F238E27FC236}">
-                <a16:creationId xmlns:a16="http://schemas.microsoft.com/office/drawing/2014/main" id="{C268DD0F-4AE1-470C-9E6C-D5FBABED8942}"/>
+                <a16:creationId xmlns:a16="http://schemas.microsoft.com/office/drawing/2014/main" id="{398FB7CF-7166-4050-A034-6F966BF9EEEE}"/>
               </a:ext>
             </a:extLst>
           </p:cNvPr>
@@ -12453,7 +12453,7 @@
           <p:cNvPr id="14" name="Rounded Rectangle 13">
             <a:extLst xmlns:a="http://schemas.openxmlformats.org/drawingml/2006/main">
               <a:ext uri="{FF2B5EF4-FFF2-40B4-BE49-F238E27FC236}">
-                <a16:creationId xmlns:a16="http://schemas.microsoft.com/office/drawing/2014/main" id="{BE6DA2FB-70B2-4D59-908A-A0B11455EFD3}"/>
+                <a16:creationId xmlns:a16="http://schemas.microsoft.com/office/drawing/2014/main" id="{33B0C949-4E8A-4EB3-8FFD-47D8E81AA080}"/>
               </a:ext>
             </a:extLst>
           </p:cNvPr>
@@ -12510,7 +12510,7 @@
           <p:cNvPr id="15" name="TextBox 14">
             <a:extLst xmlns:a="http://schemas.openxmlformats.org/drawingml/2006/main">
               <a:ext uri="{FF2B5EF4-FFF2-40B4-BE49-F238E27FC236}">
-                <a16:creationId xmlns:a16="http://schemas.microsoft.com/office/drawing/2014/main" id="{1C6C824D-CA56-41F1-BFBB-CE7C790FA608}"/>
+                <a16:creationId xmlns:a16="http://schemas.microsoft.com/office/drawing/2014/main" id="{981AE990-FF6E-4299-8569-704495CDE1AD}"/>
               </a:ext>
             </a:extLst>
           </p:cNvPr>
@@ -12557,7 +12557,7 @@
           <p:cNvPr id="16" name="TextBox 15">
             <a:extLst xmlns:a="http://schemas.openxmlformats.org/drawingml/2006/main">
               <a:ext uri="{FF2B5EF4-FFF2-40B4-BE49-F238E27FC236}">
-                <a16:creationId xmlns:a16="http://schemas.microsoft.com/office/drawing/2014/main" id="{F752A6BA-A10E-4916-8124-9AB0E99306F7}"/>
+                <a16:creationId xmlns:a16="http://schemas.microsoft.com/office/drawing/2014/main" id="{1CDACE80-227C-4FC4-8ED2-DE85C4CFA6A5}"/>
               </a:ext>
             </a:extLst>
           </p:cNvPr>
@@ -12604,7 +12604,7 @@
           <p:cNvPr id="17" name="TextBox 16">
             <a:extLst xmlns:a="http://schemas.openxmlformats.org/drawingml/2006/main">
               <a:ext uri="{FF2B5EF4-FFF2-40B4-BE49-F238E27FC236}">
-                <a16:creationId xmlns:a16="http://schemas.microsoft.com/office/drawing/2014/main" id="{FF22F3EA-88A7-4853-8AEB-AA224ACB921E}"/>
+                <a16:creationId xmlns:a16="http://schemas.microsoft.com/office/drawing/2014/main" id="{E1A61D79-E0F5-46EF-A492-3636DAE6E20F}"/>
               </a:ext>
             </a:extLst>
           </p:cNvPr>
@@ -12651,7 +12651,7 @@
           <p:cNvPr id="18" name="Rounded Rectangle 17">
             <a:extLst xmlns:a="http://schemas.openxmlformats.org/drawingml/2006/main">
               <a:ext uri="{FF2B5EF4-FFF2-40B4-BE49-F238E27FC236}">
-                <a16:creationId xmlns:a16="http://schemas.microsoft.com/office/drawing/2014/main" id="{A89146B7-9B41-45FF-933F-DE66381204D1}"/>
+                <a16:creationId xmlns:a16="http://schemas.microsoft.com/office/drawing/2014/main" id="{BE92DB26-F2B5-4549-971C-8D1AC9EF716E}"/>
               </a:ext>
             </a:extLst>
           </p:cNvPr>
@@ -12708,7 +12708,7 @@
           <p:cNvPr id="19" name="TextBox 18">
             <a:extLst xmlns:a="http://schemas.openxmlformats.org/drawingml/2006/main">
               <a:ext uri="{FF2B5EF4-FFF2-40B4-BE49-F238E27FC236}">
-                <a16:creationId xmlns:a16="http://schemas.microsoft.com/office/drawing/2014/main" id="{3E3723D6-25F3-426B-A522-31C3375A654C}"/>
+                <a16:creationId xmlns:a16="http://schemas.microsoft.com/office/drawing/2014/main" id="{82B88106-95A2-4CEF-AE7C-98572E2A45FC}"/>
               </a:ext>
             </a:extLst>
           </p:cNvPr>
@@ -12755,7 +12755,7 @@
           <p:cNvPr id="20" name="TextBox 19">
             <a:extLst xmlns:a="http://schemas.openxmlformats.org/drawingml/2006/main">
               <a:ext uri="{FF2B5EF4-FFF2-40B4-BE49-F238E27FC236}">
-                <a16:creationId xmlns:a16="http://schemas.microsoft.com/office/drawing/2014/main" id="{D0C1B830-4F86-42AF-AC98-C14C3FF70D35}"/>
+                <a16:creationId xmlns:a16="http://schemas.microsoft.com/office/drawing/2014/main" id="{3F044342-D130-4F73-AE37-F96E953A3678}"/>
               </a:ext>
             </a:extLst>
           </p:cNvPr>
@@ -12800,7 +12800,7 @@
     </p:spTree>
     <p:extLst>
       <p:ext uri="{BB962C8B-B14F-4D97-AF65-F5344CB8AC3E}">
-        <p14:creationId xmlns:p14="http://schemas.microsoft.com/office/powerpoint/2010/main" val="1549987047"/>
+        <p14:creationId xmlns:p14="http://schemas.microsoft.com/office/powerpoint/2010/main" val="1064163650"/>
       </p:ext>
     </p:extLst>
   </p:cSld>
@@ -12824,7 +12824,7 @@
           <p:cNvPr id="2" name="TextBox 1">
             <a:extLst xmlns:a="http://schemas.openxmlformats.org/drawingml/2006/main">
               <a:ext uri="{FF2B5EF4-FFF2-40B4-BE49-F238E27FC236}">
-                <a16:creationId xmlns:a16="http://schemas.microsoft.com/office/drawing/2014/main" id="{27F7FEDC-DD36-4AD7-A2AD-3B381B25E9AC}"/>
+                <a16:creationId xmlns:a16="http://schemas.microsoft.com/office/drawing/2014/main" id="{61DA0A2F-8BF4-457E-81E9-52F1461348B2}"/>
               </a:ext>
             </a:extLst>
           </p:cNvPr>
@@ -12871,7 +12871,7 @@
           <p:cNvPr id="3" name="TextBox 2">
             <a:extLst xmlns:a="http://schemas.openxmlformats.org/drawingml/2006/main">
               <a:ext uri="{FF2B5EF4-FFF2-40B4-BE49-F238E27FC236}">
-                <a16:creationId xmlns:a16="http://schemas.microsoft.com/office/drawing/2014/main" id="{057CECD0-3C42-43A1-AC67-B1ECD7CCD196}"/>
+                <a16:creationId xmlns:a16="http://schemas.microsoft.com/office/drawing/2014/main" id="{C4F2D7FC-427B-41EE-9011-489CB438B9E5}"/>
               </a:ext>
             </a:extLst>
           </p:cNvPr>
@@ -12918,7 +12918,7 @@
           <p:cNvPr id="4" name="Rectangle 3">
             <a:extLst xmlns:a="http://schemas.openxmlformats.org/drawingml/2006/main">
               <a:ext uri="{FF2B5EF4-FFF2-40B4-BE49-F238E27FC236}">
-                <a16:creationId xmlns:a16="http://schemas.microsoft.com/office/drawing/2014/main" id="{F545DE4D-D1B6-424E-869C-ADDDFDC6A540}"/>
+                <a16:creationId xmlns:a16="http://schemas.microsoft.com/office/drawing/2014/main" id="{FAEFED43-289F-4EB9-81F5-AF211A224434}"/>
               </a:ext>
             </a:extLst>
           </p:cNvPr>
@@ -12973,7 +12973,7 @@
           <p:cNvPr id="5" name="Rectangle 4">
             <a:extLst xmlns:a="http://schemas.openxmlformats.org/drawingml/2006/main">
               <a:ext uri="{FF2B5EF4-FFF2-40B4-BE49-F238E27FC236}">
-                <a16:creationId xmlns:a16="http://schemas.microsoft.com/office/drawing/2014/main" id="{010DD346-14B3-495E-9929-0672536DB067}"/>
+                <a16:creationId xmlns:a16="http://schemas.microsoft.com/office/drawing/2014/main" id="{7AFCDE58-8DE9-4BD6-87EA-6437497E2FA9}"/>
               </a:ext>
             </a:extLst>
           </p:cNvPr>
@@ -13028,7 +13028,7 @@
           <p:cNvPr id="6" name="TextBox 5">
             <a:extLst xmlns:a="http://schemas.openxmlformats.org/drawingml/2006/main">
               <a:ext uri="{FF2B5EF4-FFF2-40B4-BE49-F238E27FC236}">
-                <a16:creationId xmlns:a16="http://schemas.microsoft.com/office/drawing/2014/main" id="{155EEA72-AAEF-4DFF-A6D3-E2268632A9A6}"/>
+                <a16:creationId xmlns:a16="http://schemas.microsoft.com/office/drawing/2014/main" id="{83C5D36E-C34D-4F25-86A8-749F1D589BA4}"/>
               </a:ext>
             </a:extLst>
           </p:cNvPr>
@@ -13065,7 +13065,7 @@
                 <a:ea typeface="Aptos"/>
                 <a:cs typeface="Aptos"/>
               </a:rPr>
-              <a:t>Independent public evidence summary · 2026.07.23-11 · 2026-07-22 · Sources: IMARC; GVR; Fortune</a:t>
+              <a:t>Independent public evidence summary · 2026.07.23-12 · 2026-07-22 · Sources: IMARC; GVR; Fortune</a:t>
             </a:r>
           </a:p>
         </p:txBody>
@@ -13075,7 +13075,7 @@
           <p:cNvPr id="7" name="TextBox 6">
             <a:extLst xmlns:a="http://schemas.openxmlformats.org/drawingml/2006/main">
               <a:ext uri="{FF2B5EF4-FFF2-40B4-BE49-F238E27FC236}">
-                <a16:creationId xmlns:a16="http://schemas.microsoft.com/office/drawing/2014/main" id="{4502D44C-2B47-4E02-8A40-44806A6FFE9E}"/>
+                <a16:creationId xmlns:a16="http://schemas.microsoft.com/office/drawing/2014/main" id="{6D189B00-B81E-493B-9B17-DB62CB4EC771}"/>
               </a:ext>
             </a:extLst>
           </p:cNvPr>
@@ -13122,7 +13122,7 @@
           <p:cNvPr id="8" name="Rounded Rectangle 7">
             <a:extLst xmlns:a="http://schemas.openxmlformats.org/drawingml/2006/main">
               <a:ext uri="{FF2B5EF4-FFF2-40B4-BE49-F238E27FC236}">
-                <a16:creationId xmlns:a16="http://schemas.microsoft.com/office/drawing/2014/main" id="{A803FC8D-3338-42E3-8A25-A5BDD754B173}"/>
+                <a16:creationId xmlns:a16="http://schemas.microsoft.com/office/drawing/2014/main" id="{45B33CCC-C874-475D-BC08-EBC128376FD7}"/>
               </a:ext>
             </a:extLst>
           </p:cNvPr>
@@ -13179,7 +13179,7 @@
           <p:cNvPr id="9" name="TextBox 8">
             <a:extLst xmlns:a="http://schemas.openxmlformats.org/drawingml/2006/main">
               <a:ext uri="{FF2B5EF4-FFF2-40B4-BE49-F238E27FC236}">
-                <a16:creationId xmlns:a16="http://schemas.microsoft.com/office/drawing/2014/main" id="{33C8670E-49FF-4EDF-A6D5-40967AD15C88}"/>
+                <a16:creationId xmlns:a16="http://schemas.microsoft.com/office/drawing/2014/main" id="{6845C948-A2C3-49DF-A4A2-197F91641F34}"/>
               </a:ext>
             </a:extLst>
           </p:cNvPr>
@@ -13226,7 +13226,7 @@
           <p:cNvPr id="10" name="TextBox 9">
             <a:extLst xmlns:a="http://schemas.openxmlformats.org/drawingml/2006/main">
               <a:ext uri="{FF2B5EF4-FFF2-40B4-BE49-F238E27FC236}">
-                <a16:creationId xmlns:a16="http://schemas.microsoft.com/office/drawing/2014/main" id="{8F3D367C-C735-4F75-9D06-776B3B6CC517}"/>
+                <a16:creationId xmlns:a16="http://schemas.microsoft.com/office/drawing/2014/main" id="{282C97CD-7559-4387-8180-3C91775D2329}"/>
               </a:ext>
             </a:extLst>
           </p:cNvPr>
@@ -13273,7 +13273,7 @@
           <p:cNvPr id="11" name="Rounded Rectangle 10">
             <a:extLst xmlns:a="http://schemas.openxmlformats.org/drawingml/2006/main">
               <a:ext uri="{FF2B5EF4-FFF2-40B4-BE49-F238E27FC236}">
-                <a16:creationId xmlns:a16="http://schemas.microsoft.com/office/drawing/2014/main" id="{054D9A5F-3714-468D-9C1F-6BE2D61CA2FB}"/>
+                <a16:creationId xmlns:a16="http://schemas.microsoft.com/office/drawing/2014/main" id="{ACBB120E-C24B-472C-B097-34878279B118}"/>
               </a:ext>
             </a:extLst>
           </p:cNvPr>
@@ -13330,7 +13330,7 @@
           <p:cNvPr id="12" name="TextBox 11">
             <a:extLst xmlns:a="http://schemas.openxmlformats.org/drawingml/2006/main">
               <a:ext uri="{FF2B5EF4-FFF2-40B4-BE49-F238E27FC236}">
-                <a16:creationId xmlns:a16="http://schemas.microsoft.com/office/drawing/2014/main" id="{76A0138D-A719-4F2A-A82D-F147C53D2ACD}"/>
+                <a16:creationId xmlns:a16="http://schemas.microsoft.com/office/drawing/2014/main" id="{B58A9728-7116-4225-8025-32A0A3C9FD0A}"/>
               </a:ext>
             </a:extLst>
           </p:cNvPr>
@@ -13377,7 +13377,7 @@
           <p:cNvPr id="13" name="TextBox 12">
             <a:extLst xmlns:a="http://schemas.openxmlformats.org/drawingml/2006/main">
               <a:ext uri="{FF2B5EF4-FFF2-40B4-BE49-F238E27FC236}">
-                <a16:creationId xmlns:a16="http://schemas.microsoft.com/office/drawing/2014/main" id="{B3B61DB6-8422-4E16-87F1-7A4E6F6C70B6}"/>
+                <a16:creationId xmlns:a16="http://schemas.microsoft.com/office/drawing/2014/main" id="{4CBDB883-3703-4B9C-9752-29629B0FAEE8}"/>
               </a:ext>
             </a:extLst>
           </p:cNvPr>
@@ -13424,7 +13424,7 @@
           <p:cNvPr id="14" name="Rounded Rectangle 13">
             <a:extLst xmlns:a="http://schemas.openxmlformats.org/drawingml/2006/main">
               <a:ext uri="{FF2B5EF4-FFF2-40B4-BE49-F238E27FC236}">
-                <a16:creationId xmlns:a16="http://schemas.microsoft.com/office/drawing/2014/main" id="{78A2B091-B1E9-42DF-9F75-69EE9FD2267B}"/>
+                <a16:creationId xmlns:a16="http://schemas.microsoft.com/office/drawing/2014/main" id="{B59D8172-32C6-4F6E-85E4-5BDEE14C0F92}"/>
               </a:ext>
             </a:extLst>
           </p:cNvPr>
@@ -13481,7 +13481,7 @@
           <p:cNvPr id="15" name="TextBox 14">
             <a:extLst xmlns:a="http://schemas.openxmlformats.org/drawingml/2006/main">
               <a:ext uri="{FF2B5EF4-FFF2-40B4-BE49-F238E27FC236}">
-                <a16:creationId xmlns:a16="http://schemas.microsoft.com/office/drawing/2014/main" id="{7E1B754F-03A2-42A6-A94C-5BFC24B75E6F}"/>
+                <a16:creationId xmlns:a16="http://schemas.microsoft.com/office/drawing/2014/main" id="{90343604-96C6-4BBB-ADD1-149F1F1F42A0}"/>
               </a:ext>
             </a:extLst>
           </p:cNvPr>
@@ -13528,7 +13528,7 @@
           <p:cNvPr id="16" name="TextBox 15">
             <a:extLst xmlns:a="http://schemas.openxmlformats.org/drawingml/2006/main">
               <a:ext uri="{FF2B5EF4-FFF2-40B4-BE49-F238E27FC236}">
-                <a16:creationId xmlns:a16="http://schemas.microsoft.com/office/drawing/2014/main" id="{DAF39E0E-8325-4E45-937C-B09F3E149E8F}"/>
+                <a16:creationId xmlns:a16="http://schemas.microsoft.com/office/drawing/2014/main" id="{7B6A126D-40C5-477F-8FF9-D13BE201FBF1}"/>
               </a:ext>
             </a:extLst>
           </p:cNvPr>
@@ -13575,7 +13575,7 @@
           <p:cNvPr id="17" name="TextBox 16">
             <a:extLst xmlns:a="http://schemas.openxmlformats.org/drawingml/2006/main">
               <a:ext uri="{FF2B5EF4-FFF2-40B4-BE49-F238E27FC236}">
-                <a16:creationId xmlns:a16="http://schemas.microsoft.com/office/drawing/2014/main" id="{09D770B4-D99D-48D5-8EDD-B8E62923B0F3}"/>
+                <a16:creationId xmlns:a16="http://schemas.microsoft.com/office/drawing/2014/main" id="{C234465C-811C-4A8A-9CE4-2F1C0F63C819}"/>
               </a:ext>
             </a:extLst>
           </p:cNvPr>
@@ -13622,7 +13622,7 @@
           <p:cNvPr id="18" name="Rounded Rectangle 17">
             <a:extLst xmlns:a="http://schemas.openxmlformats.org/drawingml/2006/main">
               <a:ext uri="{FF2B5EF4-FFF2-40B4-BE49-F238E27FC236}">
-                <a16:creationId xmlns:a16="http://schemas.microsoft.com/office/drawing/2014/main" id="{C0662C28-6162-40B1-9899-6BCBB5FFE927}"/>
+                <a16:creationId xmlns:a16="http://schemas.microsoft.com/office/drawing/2014/main" id="{81120C19-854F-43CD-9156-6D3FFCA98E25}"/>
               </a:ext>
             </a:extLst>
           </p:cNvPr>
@@ -13679,7 +13679,7 @@
           <p:cNvPr id="19" name="TextBox 18">
             <a:extLst xmlns:a="http://schemas.openxmlformats.org/drawingml/2006/main">
               <a:ext uri="{FF2B5EF4-FFF2-40B4-BE49-F238E27FC236}">
-                <a16:creationId xmlns:a16="http://schemas.microsoft.com/office/drawing/2014/main" id="{175BD6A9-22EC-4674-A9DC-403CF40EDE8E}"/>
+                <a16:creationId xmlns:a16="http://schemas.microsoft.com/office/drawing/2014/main" id="{DE8116F1-3B0D-41B0-9889-AF9CD4E64048}"/>
               </a:ext>
             </a:extLst>
           </p:cNvPr>
@@ -13726,7 +13726,7 @@
           <p:cNvPr id="20" name="TextBox 19">
             <a:extLst xmlns:a="http://schemas.openxmlformats.org/drawingml/2006/main">
               <a:ext uri="{FF2B5EF4-FFF2-40B4-BE49-F238E27FC236}">
-                <a16:creationId xmlns:a16="http://schemas.microsoft.com/office/drawing/2014/main" id="{03C49839-B7A1-4C82-8E30-A13B3BB0ACC4}"/>
+                <a16:creationId xmlns:a16="http://schemas.microsoft.com/office/drawing/2014/main" id="{450C90DA-7CAC-45F1-8282-DAA8BE51F754}"/>
               </a:ext>
             </a:extLst>
           </p:cNvPr>
@@ -13771,7 +13771,7 @@
     </p:spTree>
     <p:extLst>
       <p:ext uri="{BB962C8B-B14F-4D97-AF65-F5344CB8AC3E}">
-        <p14:creationId xmlns:p14="http://schemas.microsoft.com/office/powerpoint/2010/main" val="1532923370"/>
+        <p14:creationId xmlns:p14="http://schemas.microsoft.com/office/powerpoint/2010/main" val="1350452989"/>
       </p:ext>
     </p:extLst>
   </p:cSld>
@@ -13795,7 +13795,7 @@
           <p:cNvPr id="2" name="TextBox 1">
             <a:extLst xmlns:a="http://schemas.openxmlformats.org/drawingml/2006/main">
               <a:ext uri="{FF2B5EF4-FFF2-40B4-BE49-F238E27FC236}">
-                <a16:creationId xmlns:a16="http://schemas.microsoft.com/office/drawing/2014/main" id="{36010E97-ABBF-430C-9180-4416570D8479}"/>
+                <a16:creationId xmlns:a16="http://schemas.microsoft.com/office/drawing/2014/main" id="{4B706BAD-34D4-45C7-8931-2E087F9A5CB2}"/>
               </a:ext>
             </a:extLst>
           </p:cNvPr>
@@ -13842,7 +13842,7 @@
           <p:cNvPr id="3" name="TextBox 2">
             <a:extLst xmlns:a="http://schemas.openxmlformats.org/drawingml/2006/main">
               <a:ext uri="{FF2B5EF4-FFF2-40B4-BE49-F238E27FC236}">
-                <a16:creationId xmlns:a16="http://schemas.microsoft.com/office/drawing/2014/main" id="{870D72F7-E9E4-4EEF-9FEA-A3885976F991}"/>
+                <a16:creationId xmlns:a16="http://schemas.microsoft.com/office/drawing/2014/main" id="{1AB87C5F-A658-4F92-8327-03B437B05014}"/>
               </a:ext>
             </a:extLst>
           </p:cNvPr>
@@ -13889,7 +13889,7 @@
           <p:cNvPr id="4" name="Rectangle 3">
             <a:extLst xmlns:a="http://schemas.openxmlformats.org/drawingml/2006/main">
               <a:ext uri="{FF2B5EF4-FFF2-40B4-BE49-F238E27FC236}">
-                <a16:creationId xmlns:a16="http://schemas.microsoft.com/office/drawing/2014/main" id="{CEC935F2-0AFF-40A2-9D58-EE260B13D01F}"/>
+                <a16:creationId xmlns:a16="http://schemas.microsoft.com/office/drawing/2014/main" id="{D7D8C00C-E60C-4852-9154-593B1B99A810}"/>
               </a:ext>
             </a:extLst>
           </p:cNvPr>
@@ -13944,7 +13944,7 @@
           <p:cNvPr id="5" name="Rectangle 4">
             <a:extLst xmlns:a="http://schemas.openxmlformats.org/drawingml/2006/main">
               <a:ext uri="{FF2B5EF4-FFF2-40B4-BE49-F238E27FC236}">
-                <a16:creationId xmlns:a16="http://schemas.microsoft.com/office/drawing/2014/main" id="{491F5A3F-6C8F-4CF3-A2C0-76B736736E05}"/>
+                <a16:creationId xmlns:a16="http://schemas.microsoft.com/office/drawing/2014/main" id="{491CF391-4164-4E67-A9A7-3B97FE2EA227}"/>
               </a:ext>
             </a:extLst>
           </p:cNvPr>
@@ -13999,7 +13999,7 @@
           <p:cNvPr id="6" name="TextBox 5">
             <a:extLst xmlns:a="http://schemas.openxmlformats.org/drawingml/2006/main">
               <a:ext uri="{FF2B5EF4-FFF2-40B4-BE49-F238E27FC236}">
-                <a16:creationId xmlns:a16="http://schemas.microsoft.com/office/drawing/2014/main" id="{06E670F8-0013-4829-82EB-59DB86921EAA}"/>
+                <a16:creationId xmlns:a16="http://schemas.microsoft.com/office/drawing/2014/main" id="{40A68C97-2164-4E64-841E-6BAE93733279}"/>
               </a:ext>
             </a:extLst>
           </p:cNvPr>
@@ -14036,7 +14036,7 @@
                 <a:ea typeface="Aptos"/>
                 <a:cs typeface="Aptos"/>
               </a:rPr>
-              <a:t>Independent public evidence summary · 2026.07.23-11 · 2026-07-22 · Sources: Market-values model; Readiness</a:t>
+              <a:t>Independent public evidence summary · 2026.07.23-12 · 2026-07-22 · Sources: Market-values model; Readiness</a:t>
             </a:r>
           </a:p>
         </p:txBody>
@@ -14046,7 +14046,7 @@
           <p:cNvPr id="7" name="TextBox 6">
             <a:extLst xmlns:a="http://schemas.openxmlformats.org/drawingml/2006/main">
               <a:ext uri="{FF2B5EF4-FFF2-40B4-BE49-F238E27FC236}">
-                <a16:creationId xmlns:a16="http://schemas.microsoft.com/office/drawing/2014/main" id="{C1DB0E8E-C4B7-4DC1-A246-696D64D5209B}"/>
+                <a16:creationId xmlns:a16="http://schemas.microsoft.com/office/drawing/2014/main" id="{D8618B03-956F-4D96-A711-6B81C65556A1}"/>
               </a:ext>
             </a:extLst>
           </p:cNvPr>
@@ -14093,7 +14093,7 @@
           <p:cNvPr id="8" name="TextBox 7">
             <a:extLst xmlns:a="http://schemas.openxmlformats.org/drawingml/2006/main">
               <a:ext uri="{FF2B5EF4-FFF2-40B4-BE49-F238E27FC236}">
-                <a16:creationId xmlns:a16="http://schemas.microsoft.com/office/drawing/2014/main" id="{532718D8-AA73-4071-AC5A-69B82EAF490B}"/>
+                <a16:creationId xmlns:a16="http://schemas.microsoft.com/office/drawing/2014/main" id="{518D2751-FD59-4681-9B25-6337175EEF59}"/>
               </a:ext>
             </a:extLst>
           </p:cNvPr>
@@ -14140,7 +14140,7 @@
           <p:cNvPr id="9" name="TextBox 8">
             <a:extLst xmlns:a="http://schemas.openxmlformats.org/drawingml/2006/main">
               <a:ext uri="{FF2B5EF4-FFF2-40B4-BE49-F238E27FC236}">
-                <a16:creationId xmlns:a16="http://schemas.microsoft.com/office/drawing/2014/main" id="{0A0EE805-D619-4BC0-8484-07497B162478}"/>
+                <a16:creationId xmlns:a16="http://schemas.microsoft.com/office/drawing/2014/main" id="{61588D35-86AA-4C59-A0AC-BC5C8704D669}"/>
               </a:ext>
             </a:extLst>
           </p:cNvPr>
@@ -14237,7 +14237,7 @@
           <p:cNvPr id="10" name="Rounded Rectangle 9">
             <a:extLst xmlns:a="http://schemas.openxmlformats.org/drawingml/2006/main">
               <a:ext uri="{FF2B5EF4-FFF2-40B4-BE49-F238E27FC236}">
-                <a16:creationId xmlns:a16="http://schemas.microsoft.com/office/drawing/2014/main" id="{514AD6D3-2D9D-4187-A60B-2DAB6E43EE90}"/>
+                <a16:creationId xmlns:a16="http://schemas.microsoft.com/office/drawing/2014/main" id="{076411B6-3179-487C-B6CE-A36D8EB6FC9B}"/>
               </a:ext>
             </a:extLst>
           </p:cNvPr>
@@ -14294,7 +14294,7 @@
           <p:cNvPr id="11" name="TextBox 10">
             <a:extLst xmlns:a="http://schemas.openxmlformats.org/drawingml/2006/main">
               <a:ext uri="{FF2B5EF4-FFF2-40B4-BE49-F238E27FC236}">
-                <a16:creationId xmlns:a16="http://schemas.microsoft.com/office/drawing/2014/main" id="{ECA94DD5-6B56-4063-AC6C-DAE294C7A610}"/>
+                <a16:creationId xmlns:a16="http://schemas.microsoft.com/office/drawing/2014/main" id="{67FE6AE9-4810-419E-AB90-13A585F47395}"/>
               </a:ext>
             </a:extLst>
           </p:cNvPr>
@@ -14341,7 +14341,7 @@
           <p:cNvPr id="12" name="TextBox 11">
             <a:extLst xmlns:a="http://schemas.openxmlformats.org/drawingml/2006/main">
               <a:ext uri="{FF2B5EF4-FFF2-40B4-BE49-F238E27FC236}">
-                <a16:creationId xmlns:a16="http://schemas.microsoft.com/office/drawing/2014/main" id="{1F28535E-B8F1-4A47-BD9E-1C7622A80A4A}"/>
+                <a16:creationId xmlns:a16="http://schemas.microsoft.com/office/drawing/2014/main" id="{03B55765-EB69-4144-B113-B164AC44A91C}"/>
               </a:ext>
             </a:extLst>
           </p:cNvPr>
@@ -14386,7 +14386,7 @@
     </p:spTree>
     <p:extLst>
       <p:ext uri="{BB962C8B-B14F-4D97-AF65-F5344CB8AC3E}">
-        <p14:creationId xmlns:p14="http://schemas.microsoft.com/office/powerpoint/2010/main" val="324458792"/>
+        <p14:creationId xmlns:p14="http://schemas.microsoft.com/office/powerpoint/2010/main" val="1638827804"/>
       </p:ext>
     </p:extLst>
   </p:cSld>
@@ -14410,7 +14410,7 @@
           <p:cNvPr id="2" name="TextBox 1">
             <a:extLst xmlns:a="http://schemas.openxmlformats.org/drawingml/2006/main">
               <a:ext uri="{FF2B5EF4-FFF2-40B4-BE49-F238E27FC236}">
-                <a16:creationId xmlns:a16="http://schemas.microsoft.com/office/drawing/2014/main" id="{4CCEFDCE-45FC-40B8-9276-B323D5073167}"/>
+                <a16:creationId xmlns:a16="http://schemas.microsoft.com/office/drawing/2014/main" id="{2CBDD330-0277-4AF3-AF84-93A739F2292B}"/>
               </a:ext>
             </a:extLst>
           </p:cNvPr>
@@ -14457,7 +14457,7 @@
           <p:cNvPr id="3" name="TextBox 2">
             <a:extLst xmlns:a="http://schemas.openxmlformats.org/drawingml/2006/main">
               <a:ext uri="{FF2B5EF4-FFF2-40B4-BE49-F238E27FC236}">
-                <a16:creationId xmlns:a16="http://schemas.microsoft.com/office/drawing/2014/main" id="{804AD0D3-7066-445C-9DA8-6EE34B11852E}"/>
+                <a16:creationId xmlns:a16="http://schemas.microsoft.com/office/drawing/2014/main" id="{B3C1D193-3115-4068-943B-495C7D989F5E}"/>
               </a:ext>
             </a:extLst>
           </p:cNvPr>
@@ -14504,7 +14504,7 @@
           <p:cNvPr id="4" name="Rectangle 3">
             <a:extLst xmlns:a="http://schemas.openxmlformats.org/drawingml/2006/main">
               <a:ext uri="{FF2B5EF4-FFF2-40B4-BE49-F238E27FC236}">
-                <a16:creationId xmlns:a16="http://schemas.microsoft.com/office/drawing/2014/main" id="{2657DD97-69CC-46FD-AAF3-EFECA78B50B0}"/>
+                <a16:creationId xmlns:a16="http://schemas.microsoft.com/office/drawing/2014/main" id="{590FA6A4-AC5E-44C3-B695-F997F0A73B3D}"/>
               </a:ext>
             </a:extLst>
           </p:cNvPr>
@@ -14559,7 +14559,7 @@
           <p:cNvPr id="5" name="Rectangle 4">
             <a:extLst xmlns:a="http://schemas.openxmlformats.org/drawingml/2006/main">
               <a:ext uri="{FF2B5EF4-FFF2-40B4-BE49-F238E27FC236}">
-                <a16:creationId xmlns:a16="http://schemas.microsoft.com/office/drawing/2014/main" id="{55FA8E63-871E-481B-ADA5-320E5F6E165F}"/>
+                <a16:creationId xmlns:a16="http://schemas.microsoft.com/office/drawing/2014/main" id="{6A2CBAB8-00AD-4D3B-A20B-784C3F650374}"/>
               </a:ext>
             </a:extLst>
           </p:cNvPr>
@@ -14614,7 +14614,7 @@
           <p:cNvPr id="6" name="TextBox 5">
             <a:extLst xmlns:a="http://schemas.openxmlformats.org/drawingml/2006/main">
               <a:ext uri="{FF2B5EF4-FFF2-40B4-BE49-F238E27FC236}">
-                <a16:creationId xmlns:a16="http://schemas.microsoft.com/office/drawing/2014/main" id="{FCC375F0-0ADC-4846-B6E2-E19DF259EAB1}"/>
+                <a16:creationId xmlns:a16="http://schemas.microsoft.com/office/drawing/2014/main" id="{5BB772CB-9952-49F1-93F0-AB4AB39851B3}"/>
               </a:ext>
             </a:extLst>
           </p:cNvPr>
@@ -14651,7 +14651,7 @@
                 <a:ea typeface="Aptos"/>
                 <a:cs typeface="Aptos"/>
               </a:rPr>
-              <a:t>Independent public evidence summary · 2026.07.23-11 · 2026-07-22 · Sources: WIPO valuation; Evidence Register</a:t>
+              <a:t>Independent public evidence summary · 2026.07.23-12 · 2026-07-22 · Sources: WIPO valuation; Evidence Register</a:t>
             </a:r>
           </a:p>
         </p:txBody>
@@ -14661,7 +14661,7 @@
           <p:cNvPr id="7" name="TextBox 6">
             <a:extLst xmlns:a="http://schemas.openxmlformats.org/drawingml/2006/main">
               <a:ext uri="{FF2B5EF4-FFF2-40B4-BE49-F238E27FC236}">
-                <a16:creationId xmlns:a16="http://schemas.microsoft.com/office/drawing/2014/main" id="{50580B3B-DECA-438E-9576-24170EA3BBFF}"/>
+                <a16:creationId xmlns:a16="http://schemas.microsoft.com/office/drawing/2014/main" id="{1EDA7A0D-1299-4328-90DF-CE6C33155BBA}"/>
               </a:ext>
             </a:extLst>
           </p:cNvPr>
@@ -15231,7 +15231,7 @@
           <p:cNvPr id="9" name="TextBox 8">
             <a:extLst xmlns:a="http://schemas.openxmlformats.org/drawingml/2006/main">
               <a:ext uri="{FF2B5EF4-FFF2-40B4-BE49-F238E27FC236}">
-                <a16:creationId xmlns:a16="http://schemas.microsoft.com/office/drawing/2014/main" id="{F28BCECF-700D-4A40-98D6-58D8B8D073A1}"/>
+                <a16:creationId xmlns:a16="http://schemas.microsoft.com/office/drawing/2014/main" id="{8C072124-1C4B-4FEA-8022-78B6F4D1BE0C}"/>
               </a:ext>
             </a:extLst>
           </p:cNvPr>
@@ -15276,7 +15276,7 @@
     </p:spTree>
     <p:extLst>
       <p:ext uri="{BB962C8B-B14F-4D97-AF65-F5344CB8AC3E}">
-        <p14:creationId xmlns:p14="http://schemas.microsoft.com/office/powerpoint/2010/main" val="364355003"/>
+        <p14:creationId xmlns:p14="http://schemas.microsoft.com/office/powerpoint/2010/main" val="244496510"/>
       </p:ext>
     </p:extLst>
   </p:cSld>
@@ -15300,7 +15300,7 @@
           <p:cNvPr id="2" name="TextBox 1">
             <a:extLst xmlns:a="http://schemas.openxmlformats.org/drawingml/2006/main">
               <a:ext uri="{FF2B5EF4-FFF2-40B4-BE49-F238E27FC236}">
-                <a16:creationId xmlns:a16="http://schemas.microsoft.com/office/drawing/2014/main" id="{EB80E5C8-4460-4FCC-8C63-1228EAF57F59}"/>
+                <a16:creationId xmlns:a16="http://schemas.microsoft.com/office/drawing/2014/main" id="{2651FA73-5D09-49E3-AD61-17AE17A380BC}"/>
               </a:ext>
             </a:extLst>
           </p:cNvPr>
@@ -15347,7 +15347,7 @@
           <p:cNvPr id="3" name="TextBox 2">
             <a:extLst xmlns:a="http://schemas.openxmlformats.org/drawingml/2006/main">
               <a:ext uri="{FF2B5EF4-FFF2-40B4-BE49-F238E27FC236}">
-                <a16:creationId xmlns:a16="http://schemas.microsoft.com/office/drawing/2014/main" id="{D8F033F3-DCDF-4F0A-AC89-0647855A3C3E}"/>
+                <a16:creationId xmlns:a16="http://schemas.microsoft.com/office/drawing/2014/main" id="{5FAC7F46-CFA1-4508-B5E0-4BE7004D2CFE}"/>
               </a:ext>
             </a:extLst>
           </p:cNvPr>
@@ -15394,7 +15394,7 @@
           <p:cNvPr id="4" name="Rectangle 3">
             <a:extLst xmlns:a="http://schemas.openxmlformats.org/drawingml/2006/main">
               <a:ext uri="{FF2B5EF4-FFF2-40B4-BE49-F238E27FC236}">
-                <a16:creationId xmlns:a16="http://schemas.microsoft.com/office/drawing/2014/main" id="{13A612FE-6DF1-4B07-8494-514C33FCBD17}"/>
+                <a16:creationId xmlns:a16="http://schemas.microsoft.com/office/drawing/2014/main" id="{CCDE451E-9B1C-4AD5-9EA3-5F97EDCBEC29}"/>
               </a:ext>
             </a:extLst>
           </p:cNvPr>
@@ -15449,7 +15449,7 @@
           <p:cNvPr id="5" name="Rectangle 4">
             <a:extLst xmlns:a="http://schemas.openxmlformats.org/drawingml/2006/main">
               <a:ext uri="{FF2B5EF4-FFF2-40B4-BE49-F238E27FC236}">
-                <a16:creationId xmlns:a16="http://schemas.microsoft.com/office/drawing/2014/main" id="{63DDAE97-41C3-4789-826B-40FEF3741C97}"/>
+                <a16:creationId xmlns:a16="http://schemas.microsoft.com/office/drawing/2014/main" id="{A860B8F0-E8A0-48CE-BC81-D6DB5F33D24E}"/>
               </a:ext>
             </a:extLst>
           </p:cNvPr>
@@ -15504,7 +15504,7 @@
           <p:cNvPr id="6" name="TextBox 5">
             <a:extLst xmlns:a="http://schemas.openxmlformats.org/drawingml/2006/main">
               <a:ext uri="{FF2B5EF4-FFF2-40B4-BE49-F238E27FC236}">
-                <a16:creationId xmlns:a16="http://schemas.microsoft.com/office/drawing/2014/main" id="{DFFDD458-C36F-4F19-8A92-B8311FC7099B}"/>
+                <a16:creationId xmlns:a16="http://schemas.microsoft.com/office/drawing/2014/main" id="{9CAFFA86-847E-4AF3-95AA-8523713EF04D}"/>
               </a:ext>
             </a:extLst>
           </p:cNvPr>
@@ -15541,7 +15541,7 @@
                 <a:ea typeface="Aptos"/>
                 <a:cs typeface="Aptos"/>
               </a:rPr>
-              <a:t>Independent public evidence summary · 2026.07.23-11 · 2026-07-22 · Sources: EPO; Germany — official judgments; WIPO</a:t>
+              <a:t>Independent public evidence summary · 2026.07.23-12 · 2026-07-22 · Sources: EPO; Germany — official judgments; WIPO</a:t>
             </a:r>
           </a:p>
         </p:txBody>
@@ -15551,7 +15551,7 @@
           <p:cNvPr id="7" name="TextBox 6">
             <a:extLst xmlns:a="http://schemas.openxmlformats.org/drawingml/2006/main">
               <a:ext uri="{FF2B5EF4-FFF2-40B4-BE49-F238E27FC236}">
-                <a16:creationId xmlns:a16="http://schemas.microsoft.com/office/drawing/2014/main" id="{ED33786C-D7C8-48DD-962E-C0C5740C67B4}"/>
+                <a16:creationId xmlns:a16="http://schemas.microsoft.com/office/drawing/2014/main" id="{D76B29A5-B621-4F2B-8901-EE937559D9C3}"/>
               </a:ext>
             </a:extLst>
           </p:cNvPr>
@@ -15598,7 +15598,7 @@
           <p:cNvPr id="8" name="TextBox 7">
             <a:extLst xmlns:a="http://schemas.openxmlformats.org/drawingml/2006/main">
               <a:ext uri="{FF2B5EF4-FFF2-40B4-BE49-F238E27FC236}">
-                <a16:creationId xmlns:a16="http://schemas.microsoft.com/office/drawing/2014/main" id="{D7C57212-9635-41A1-BB60-FF7B91A4C4B2}"/>
+                <a16:creationId xmlns:a16="http://schemas.microsoft.com/office/drawing/2014/main" id="{012C5057-92BA-4A6D-BCAF-130BE7E166A9}"/>
               </a:ext>
             </a:extLst>
           </p:cNvPr>
@@ -15645,7 +15645,7 @@
           <p:cNvPr id="9" name="TextBox 8">
             <a:extLst xmlns:a="http://schemas.openxmlformats.org/drawingml/2006/main">
               <a:ext uri="{FF2B5EF4-FFF2-40B4-BE49-F238E27FC236}">
-                <a16:creationId xmlns:a16="http://schemas.microsoft.com/office/drawing/2014/main" id="{EACE90C8-DB07-41EE-977F-D5B2362D05AC}"/>
+                <a16:creationId xmlns:a16="http://schemas.microsoft.com/office/drawing/2014/main" id="{A0FF0B60-4C8D-44E1-8DDA-F4B430954C93}"/>
               </a:ext>
             </a:extLst>
           </p:cNvPr>
@@ -15742,7 +15742,7 @@
           <p:cNvPr id="10" name="Rounded Rectangle 9">
             <a:extLst xmlns:a="http://schemas.openxmlformats.org/drawingml/2006/main">
               <a:ext uri="{FF2B5EF4-FFF2-40B4-BE49-F238E27FC236}">
-                <a16:creationId xmlns:a16="http://schemas.microsoft.com/office/drawing/2014/main" id="{75EB7DC9-2D13-4932-A0DE-4CFC175D5031}"/>
+                <a16:creationId xmlns:a16="http://schemas.microsoft.com/office/drawing/2014/main" id="{2BB4CF01-DD5D-497C-9135-C7F28DFC6B05}"/>
               </a:ext>
             </a:extLst>
           </p:cNvPr>
@@ -15799,7 +15799,7 @@
           <p:cNvPr id="11" name="TextBox 10">
             <a:extLst xmlns:a="http://schemas.openxmlformats.org/drawingml/2006/main">
               <a:ext uri="{FF2B5EF4-FFF2-40B4-BE49-F238E27FC236}">
-                <a16:creationId xmlns:a16="http://schemas.microsoft.com/office/drawing/2014/main" id="{8DD87F65-CA2A-461E-ABAF-2FFB13C993FC}"/>
+                <a16:creationId xmlns:a16="http://schemas.microsoft.com/office/drawing/2014/main" id="{A67174AC-1640-44C0-BF3D-D6EA6BFB3948}"/>
               </a:ext>
             </a:extLst>
           </p:cNvPr>
@@ -15846,7 +15846,7 @@
           <p:cNvPr id="12" name="TextBox 11">
             <a:extLst xmlns:a="http://schemas.openxmlformats.org/drawingml/2006/main">
               <a:ext uri="{FF2B5EF4-FFF2-40B4-BE49-F238E27FC236}">
-                <a16:creationId xmlns:a16="http://schemas.microsoft.com/office/drawing/2014/main" id="{01CFCF1F-D39E-47FB-80DC-918FDD8DF221}"/>
+                <a16:creationId xmlns:a16="http://schemas.microsoft.com/office/drawing/2014/main" id="{61F178F5-305E-4F4F-86B7-520EC9C946E9}"/>
               </a:ext>
             </a:extLst>
           </p:cNvPr>
@@ -15891,7 +15891,7 @@
     </p:spTree>
     <p:extLst>
       <p:ext uri="{BB962C8B-B14F-4D97-AF65-F5344CB8AC3E}">
-        <p14:creationId xmlns:p14="http://schemas.microsoft.com/office/powerpoint/2010/main" val="877846374"/>
+        <p14:creationId xmlns:p14="http://schemas.microsoft.com/office/powerpoint/2010/main" val="1065707506"/>
       </p:ext>
     </p:extLst>
   </p:cSld>
@@ -15915,7 +15915,7 @@
           <p:cNvPr id="2" name="TextBox 1">
             <a:extLst xmlns:a="http://schemas.openxmlformats.org/drawingml/2006/main">
               <a:ext uri="{FF2B5EF4-FFF2-40B4-BE49-F238E27FC236}">
-                <a16:creationId xmlns:a16="http://schemas.microsoft.com/office/drawing/2014/main" id="{0D918D9A-869B-4625-B200-50600E911BC3}"/>
+                <a16:creationId xmlns:a16="http://schemas.microsoft.com/office/drawing/2014/main" id="{CCAFE4D0-A13C-4C9F-93F3-D61BC6951F92}"/>
               </a:ext>
             </a:extLst>
           </p:cNvPr>
@@ -15962,7 +15962,7 @@
           <p:cNvPr id="3" name="TextBox 2">
             <a:extLst xmlns:a="http://schemas.openxmlformats.org/drawingml/2006/main">
               <a:ext uri="{FF2B5EF4-FFF2-40B4-BE49-F238E27FC236}">
-                <a16:creationId xmlns:a16="http://schemas.microsoft.com/office/drawing/2014/main" id="{01AB1FF8-5AE4-413D-87C4-A31B05438AEE}"/>
+                <a16:creationId xmlns:a16="http://schemas.microsoft.com/office/drawing/2014/main" id="{D9B9F02B-DF1B-4F0E-BA54-DC89EA16F320}"/>
               </a:ext>
             </a:extLst>
           </p:cNvPr>
@@ -16009,7 +16009,7 @@
           <p:cNvPr id="4" name="Rectangle 3">
             <a:extLst xmlns:a="http://schemas.openxmlformats.org/drawingml/2006/main">
               <a:ext uri="{FF2B5EF4-FFF2-40B4-BE49-F238E27FC236}">
-                <a16:creationId xmlns:a16="http://schemas.microsoft.com/office/drawing/2014/main" id="{72521F20-E757-45CC-B2F9-A5F52AD25D15}"/>
+                <a16:creationId xmlns:a16="http://schemas.microsoft.com/office/drawing/2014/main" id="{2C250012-8DA2-4B1C-9ADD-902A55A17002}"/>
               </a:ext>
             </a:extLst>
           </p:cNvPr>
@@ -16064,7 +16064,7 @@
           <p:cNvPr id="5" name="Rectangle 4">
             <a:extLst xmlns:a="http://schemas.openxmlformats.org/drawingml/2006/main">
               <a:ext uri="{FF2B5EF4-FFF2-40B4-BE49-F238E27FC236}">
-                <a16:creationId xmlns:a16="http://schemas.microsoft.com/office/drawing/2014/main" id="{8FD2EA95-9EC6-4CFF-A56E-264D1BD439E3}"/>
+                <a16:creationId xmlns:a16="http://schemas.microsoft.com/office/drawing/2014/main" id="{17A0EFC8-8AB1-4DD4-9FA3-99772BAAA053}"/>
               </a:ext>
             </a:extLst>
           </p:cNvPr>
@@ -16119,7 +16119,7 @@
           <p:cNvPr id="6" name="TextBox 5">
             <a:extLst xmlns:a="http://schemas.openxmlformats.org/drawingml/2006/main">
               <a:ext uri="{FF2B5EF4-FFF2-40B4-BE49-F238E27FC236}">
-                <a16:creationId xmlns:a16="http://schemas.microsoft.com/office/drawing/2014/main" id="{E3B82581-81F1-456B-B023-6EFCCB89F9A7}"/>
+                <a16:creationId xmlns:a16="http://schemas.microsoft.com/office/drawing/2014/main" id="{63EC61EB-811D-45AB-BAB2-74B55257E798}"/>
               </a:ext>
             </a:extLst>
           </p:cNvPr>
@@ -16156,7 +16156,7 @@
                 <a:ea typeface="Aptos"/>
                 <a:cs typeface="Aptos"/>
               </a:rPr>
-              <a:t>Independent public evidence summary · 2026.07.23-11 · 2026-07-22 · Sources: WIPO licensing; IP Finance</a:t>
+              <a:t>Independent public evidence summary · 2026.07.23-12 · 2026-07-22 · Sources: WIPO licensing; IP Finance</a:t>
             </a:r>
           </a:p>
         </p:txBody>
@@ -16166,7 +16166,7 @@
           <p:cNvPr id="7" name="TextBox 6">
             <a:extLst xmlns:a="http://schemas.openxmlformats.org/drawingml/2006/main">
               <a:ext uri="{FF2B5EF4-FFF2-40B4-BE49-F238E27FC236}">
-                <a16:creationId xmlns:a16="http://schemas.microsoft.com/office/drawing/2014/main" id="{062FAF8A-A6FB-48C8-A2CC-9287F82FD6E6}"/>
+                <a16:creationId xmlns:a16="http://schemas.microsoft.com/office/drawing/2014/main" id="{132B4999-4CE0-411A-ABEB-111435EDEABE}"/>
               </a:ext>
             </a:extLst>
           </p:cNvPr>
@@ -16213,7 +16213,7 @@
           <p:cNvPr id="8" name="TextBox 7">
             <a:extLst xmlns:a="http://schemas.openxmlformats.org/drawingml/2006/main">
               <a:ext uri="{FF2B5EF4-FFF2-40B4-BE49-F238E27FC236}">
-                <a16:creationId xmlns:a16="http://schemas.microsoft.com/office/drawing/2014/main" id="{8A317384-E97F-4340-81B8-9F67EB3BBF24}"/>
+                <a16:creationId xmlns:a16="http://schemas.microsoft.com/office/drawing/2014/main" id="{97699137-D432-4A6D-AD39-C6F3DF5AD963}"/>
               </a:ext>
             </a:extLst>
           </p:cNvPr>
@@ -16260,7 +16260,7 @@
           <p:cNvPr id="9" name="TextBox 8">
             <a:extLst xmlns:a="http://schemas.openxmlformats.org/drawingml/2006/main">
               <a:ext uri="{FF2B5EF4-FFF2-40B4-BE49-F238E27FC236}">
-                <a16:creationId xmlns:a16="http://schemas.microsoft.com/office/drawing/2014/main" id="{084A5E44-6363-4FA3-9919-3E4591399081}"/>
+                <a16:creationId xmlns:a16="http://schemas.microsoft.com/office/drawing/2014/main" id="{BA71C9E5-2569-40E7-A60D-5E0D833703D8}"/>
               </a:ext>
             </a:extLst>
           </p:cNvPr>
@@ -16357,7 +16357,7 @@
           <p:cNvPr id="10" name="Rounded Rectangle 9">
             <a:extLst xmlns:a="http://schemas.openxmlformats.org/drawingml/2006/main">
               <a:ext uri="{FF2B5EF4-FFF2-40B4-BE49-F238E27FC236}">
-                <a16:creationId xmlns:a16="http://schemas.microsoft.com/office/drawing/2014/main" id="{EF8584C4-AF91-4513-8E3C-6739BFEC0B8A}"/>
+                <a16:creationId xmlns:a16="http://schemas.microsoft.com/office/drawing/2014/main" id="{BF7CDC99-E8F9-40B5-9399-48874A3CE833}"/>
               </a:ext>
             </a:extLst>
           </p:cNvPr>
@@ -16414,7 +16414,7 @@
           <p:cNvPr id="11" name="TextBox 10">
             <a:extLst xmlns:a="http://schemas.openxmlformats.org/drawingml/2006/main">
               <a:ext uri="{FF2B5EF4-FFF2-40B4-BE49-F238E27FC236}">
-                <a16:creationId xmlns:a16="http://schemas.microsoft.com/office/drawing/2014/main" id="{BAFDD4FD-7A43-4C67-BA05-117A9F1AB983}"/>
+                <a16:creationId xmlns:a16="http://schemas.microsoft.com/office/drawing/2014/main" id="{9A4F0EA8-C0D5-4E4D-AC27-76EF4DC791CB}"/>
               </a:ext>
             </a:extLst>
           </p:cNvPr>
@@ -16461,7 +16461,7 @@
           <p:cNvPr id="12" name="TextBox 11">
             <a:extLst xmlns:a="http://schemas.openxmlformats.org/drawingml/2006/main">
               <a:ext uri="{FF2B5EF4-FFF2-40B4-BE49-F238E27FC236}">
-                <a16:creationId xmlns:a16="http://schemas.microsoft.com/office/drawing/2014/main" id="{3BF8E8E7-F3BF-4329-A1B4-AB5360643BBB}"/>
+                <a16:creationId xmlns:a16="http://schemas.microsoft.com/office/drawing/2014/main" id="{18E1F523-130F-4457-94DF-6A9195A03EFE}"/>
               </a:ext>
             </a:extLst>
           </p:cNvPr>
@@ -16506,7 +16506,7 @@
     </p:spTree>
     <p:extLst>
       <p:ext uri="{BB962C8B-B14F-4D97-AF65-F5344CB8AC3E}">
-        <p14:creationId xmlns:p14="http://schemas.microsoft.com/office/powerpoint/2010/main" val="145529628"/>
+        <p14:creationId xmlns:p14="http://schemas.microsoft.com/office/powerpoint/2010/main" val="1960259126"/>
       </p:ext>
     </p:extLst>
   </p:cSld>
@@ -16530,7 +16530,7 @@
           <p:cNvPr id="2" name="TextBox 1">
             <a:extLst xmlns:a="http://schemas.openxmlformats.org/drawingml/2006/main">
               <a:ext uri="{FF2B5EF4-FFF2-40B4-BE49-F238E27FC236}">
-                <a16:creationId xmlns:a16="http://schemas.microsoft.com/office/drawing/2014/main" id="{FBABEA17-BEE3-4772-AFDF-71E1BAAFA31D}"/>
+                <a16:creationId xmlns:a16="http://schemas.microsoft.com/office/drawing/2014/main" id="{65003111-C409-485B-BCF9-1C08E234AE9C}"/>
               </a:ext>
             </a:extLst>
           </p:cNvPr>
@@ -16577,7 +16577,7 @@
           <p:cNvPr id="3" name="TextBox 2">
             <a:extLst xmlns:a="http://schemas.openxmlformats.org/drawingml/2006/main">
               <a:ext uri="{FF2B5EF4-FFF2-40B4-BE49-F238E27FC236}">
-                <a16:creationId xmlns:a16="http://schemas.microsoft.com/office/drawing/2014/main" id="{6D2090E8-20CC-4442-8E67-092F6DB33F3F}"/>
+                <a16:creationId xmlns:a16="http://schemas.microsoft.com/office/drawing/2014/main" id="{F9361FA2-3EED-4570-8963-CD5446A11A8B}"/>
               </a:ext>
             </a:extLst>
           </p:cNvPr>
@@ -16624,7 +16624,7 @@
           <p:cNvPr id="4" name="Rectangle 3">
             <a:extLst xmlns:a="http://schemas.openxmlformats.org/drawingml/2006/main">
               <a:ext uri="{FF2B5EF4-FFF2-40B4-BE49-F238E27FC236}">
-                <a16:creationId xmlns:a16="http://schemas.microsoft.com/office/drawing/2014/main" id="{698EDE2B-BB73-4A04-8B2F-9E68079EE24F}"/>
+                <a16:creationId xmlns:a16="http://schemas.microsoft.com/office/drawing/2014/main" id="{2ED3B9B6-BA5B-46B2-89C4-920CFBA70BCB}"/>
               </a:ext>
             </a:extLst>
           </p:cNvPr>
@@ -16679,7 +16679,7 @@
           <p:cNvPr id="5" name="Rectangle 4">
             <a:extLst xmlns:a="http://schemas.openxmlformats.org/drawingml/2006/main">
               <a:ext uri="{FF2B5EF4-FFF2-40B4-BE49-F238E27FC236}">
-                <a16:creationId xmlns:a16="http://schemas.microsoft.com/office/drawing/2014/main" id="{4BCCEB54-0FD0-41C0-8BC1-3D2D1B26AB5E}"/>
+                <a16:creationId xmlns:a16="http://schemas.microsoft.com/office/drawing/2014/main" id="{59C7D383-CEC0-4129-B019-CAB9570D1D72}"/>
               </a:ext>
             </a:extLst>
           </p:cNvPr>
@@ -16734,7 +16734,7 @@
           <p:cNvPr id="6" name="TextBox 5">
             <a:extLst xmlns:a="http://schemas.openxmlformats.org/drawingml/2006/main">
               <a:ext uri="{FF2B5EF4-FFF2-40B4-BE49-F238E27FC236}">
-                <a16:creationId xmlns:a16="http://schemas.microsoft.com/office/drawing/2014/main" id="{516390B7-B8D6-47AC-8CAE-FC97254CDD73}"/>
+                <a16:creationId xmlns:a16="http://schemas.microsoft.com/office/drawing/2014/main" id="{EF19870C-44BC-4C69-BF3D-CB7B2D357021}"/>
               </a:ext>
             </a:extLst>
           </p:cNvPr>
@@ -16771,7 +16771,7 @@
                 <a:ea typeface="Aptos"/>
                 <a:cs typeface="Aptos"/>
               </a:rPr>
-              <a:t>Independent public evidence summary · 2026.07.23-11 · 2026-07-22 · Sources: Evidence Register; EPO</a:t>
+              <a:t>Independent public evidence summary · 2026.07.23-12 · 2026-07-22 · Sources: Evidence Register; EPO</a:t>
             </a:r>
           </a:p>
         </p:txBody>
@@ -16781,7 +16781,7 @@
           <p:cNvPr id="7" name="TextBox 6">
             <a:extLst xmlns:a="http://schemas.openxmlformats.org/drawingml/2006/main">
               <a:ext uri="{FF2B5EF4-FFF2-40B4-BE49-F238E27FC236}">
-                <a16:creationId xmlns:a16="http://schemas.microsoft.com/office/drawing/2014/main" id="{D4E492BE-398F-43D8-9CF9-4457AD58B59C}"/>
+                <a16:creationId xmlns:a16="http://schemas.microsoft.com/office/drawing/2014/main" id="{83D2E492-72DC-4A10-B3AD-1D07B02998C6}"/>
               </a:ext>
             </a:extLst>
           </p:cNvPr>
@@ -17268,7 +17268,7 @@
           <p:cNvPr id="9" name="TextBox 8">
             <a:extLst xmlns:a="http://schemas.openxmlformats.org/drawingml/2006/main">
               <a:ext uri="{FF2B5EF4-FFF2-40B4-BE49-F238E27FC236}">
-                <a16:creationId xmlns:a16="http://schemas.microsoft.com/office/drawing/2014/main" id="{5A2079AD-DF54-4823-B29C-EA3EFE0B71B9}"/>
+                <a16:creationId xmlns:a16="http://schemas.microsoft.com/office/drawing/2014/main" id="{F6F84CF2-4114-49E2-B19F-1321B046E141}"/>
               </a:ext>
             </a:extLst>
           </p:cNvPr>
@@ -17313,7 +17313,7 @@
     </p:spTree>
     <p:extLst>
       <p:ext uri="{BB962C8B-B14F-4D97-AF65-F5344CB8AC3E}">
-        <p14:creationId xmlns:p14="http://schemas.microsoft.com/office/powerpoint/2010/main" val="1892466906"/>
+        <p14:creationId xmlns:p14="http://schemas.microsoft.com/office/powerpoint/2010/main" val="639268024"/>
       </p:ext>
     </p:extLst>
   </p:cSld>
@@ -17337,7 +17337,7 @@
           <p:cNvPr id="2" name="TextBox 1">
             <a:extLst xmlns:a="http://schemas.openxmlformats.org/drawingml/2006/main">
               <a:ext uri="{FF2B5EF4-FFF2-40B4-BE49-F238E27FC236}">
-                <a16:creationId xmlns:a16="http://schemas.microsoft.com/office/drawing/2014/main" id="{4405FE8A-C724-4455-A9BB-C6ABD1E1E13D}"/>
+                <a16:creationId xmlns:a16="http://schemas.microsoft.com/office/drawing/2014/main" id="{CDF93DF6-C37B-45DB-8A4F-06922F80E9C1}"/>
               </a:ext>
             </a:extLst>
           </p:cNvPr>
@@ -17384,7 +17384,7 @@
           <p:cNvPr id="3" name="TextBox 2">
             <a:extLst xmlns:a="http://schemas.openxmlformats.org/drawingml/2006/main">
               <a:ext uri="{FF2B5EF4-FFF2-40B4-BE49-F238E27FC236}">
-                <a16:creationId xmlns:a16="http://schemas.microsoft.com/office/drawing/2014/main" id="{5AC0631F-903E-46E5-A851-CF7279F30C79}"/>
+                <a16:creationId xmlns:a16="http://schemas.microsoft.com/office/drawing/2014/main" id="{4D47D7A0-B97E-4210-AC3A-1386786C9711}"/>
               </a:ext>
             </a:extLst>
           </p:cNvPr>
@@ -17431,7 +17431,7 @@
           <p:cNvPr id="4" name="Rectangle 3">
             <a:extLst xmlns:a="http://schemas.openxmlformats.org/drawingml/2006/main">
               <a:ext uri="{FF2B5EF4-FFF2-40B4-BE49-F238E27FC236}">
-                <a16:creationId xmlns:a16="http://schemas.microsoft.com/office/drawing/2014/main" id="{CA774E9B-CB8B-4A81-9225-6D19C85CDFCF}"/>
+                <a16:creationId xmlns:a16="http://schemas.microsoft.com/office/drawing/2014/main" id="{F350485F-B523-411C-8E36-EE99E449B66C}"/>
               </a:ext>
             </a:extLst>
           </p:cNvPr>
@@ -17486,7 +17486,7 @@
           <p:cNvPr id="5" name="Rectangle 4">
             <a:extLst xmlns:a="http://schemas.openxmlformats.org/drawingml/2006/main">
               <a:ext uri="{FF2B5EF4-FFF2-40B4-BE49-F238E27FC236}">
-                <a16:creationId xmlns:a16="http://schemas.microsoft.com/office/drawing/2014/main" id="{747AE065-5C86-4629-8FCF-755EE3B46520}"/>
+                <a16:creationId xmlns:a16="http://schemas.microsoft.com/office/drawing/2014/main" id="{20C33311-5120-4215-9407-54233469EC2F}"/>
               </a:ext>
             </a:extLst>
           </p:cNvPr>
@@ -17541,7 +17541,7 @@
           <p:cNvPr id="6" name="TextBox 5">
             <a:extLst xmlns:a="http://schemas.openxmlformats.org/drawingml/2006/main">
               <a:ext uri="{FF2B5EF4-FFF2-40B4-BE49-F238E27FC236}">
-                <a16:creationId xmlns:a16="http://schemas.microsoft.com/office/drawing/2014/main" id="{C987F3C0-89CE-4C94-A12A-C21C247E69A7}"/>
+                <a16:creationId xmlns:a16="http://schemas.microsoft.com/office/drawing/2014/main" id="{38439BE2-750F-4E3A-B51E-A0CDC467565B}"/>
               </a:ext>
             </a:extLst>
           </p:cNvPr>
@@ -17578,7 +17578,7 @@
                 <a:ea typeface="Aptos"/>
                 <a:cs typeface="Aptos"/>
               </a:rPr>
-              <a:t>Independent public evidence summary · 2026.07.23-11 · 2026-07-22 · Sources: EP3032975B2; 7 O 3341/24</a:t>
+              <a:t>Independent public evidence summary · 2026.07.23-12 · 2026-07-22 · Sources: EP3032975B2; 7 O 3341/24</a:t>
             </a:r>
           </a:p>
         </p:txBody>
@@ -17588,7 +17588,7 @@
           <p:cNvPr id="7" name="TextBox 6">
             <a:extLst xmlns:a="http://schemas.openxmlformats.org/drawingml/2006/main">
               <a:ext uri="{FF2B5EF4-FFF2-40B4-BE49-F238E27FC236}">
-                <a16:creationId xmlns:a16="http://schemas.microsoft.com/office/drawing/2014/main" id="{CF481362-F8C8-425D-B2A5-6006B09E9A07}"/>
+                <a16:creationId xmlns:a16="http://schemas.microsoft.com/office/drawing/2014/main" id="{23102C0A-4C31-436D-95E0-600D0EBE044D}"/>
               </a:ext>
             </a:extLst>
           </p:cNvPr>
@@ -17635,7 +17635,7 @@
           <p:cNvPr id="8" name="Rounded Rectangle 7">
             <a:extLst xmlns:a="http://schemas.openxmlformats.org/drawingml/2006/main">
               <a:ext uri="{FF2B5EF4-FFF2-40B4-BE49-F238E27FC236}">
-                <a16:creationId xmlns:a16="http://schemas.microsoft.com/office/drawing/2014/main" id="{086C865D-BA23-4501-8426-2CA291F53E5F}"/>
+                <a16:creationId xmlns:a16="http://schemas.microsoft.com/office/drawing/2014/main" id="{CD916AF8-AB79-43AD-A047-8DBC8F5CB553}"/>
               </a:ext>
             </a:extLst>
           </p:cNvPr>
@@ -17692,7 +17692,7 @@
           <p:cNvPr id="9" name="TextBox 8">
             <a:extLst xmlns:a="http://schemas.openxmlformats.org/drawingml/2006/main">
               <a:ext uri="{FF2B5EF4-FFF2-40B4-BE49-F238E27FC236}">
-                <a16:creationId xmlns:a16="http://schemas.microsoft.com/office/drawing/2014/main" id="{2F93CD18-E8D3-434F-87D6-5C68B1F552A5}"/>
+                <a16:creationId xmlns:a16="http://schemas.microsoft.com/office/drawing/2014/main" id="{9AB307EA-1404-498B-8D8D-AB594C440AC7}"/>
               </a:ext>
             </a:extLst>
           </p:cNvPr>
@@ -17739,7 +17739,7 @@
           <p:cNvPr id="10" name="TextBox 9">
             <a:extLst xmlns:a="http://schemas.openxmlformats.org/drawingml/2006/main">
               <a:ext uri="{FF2B5EF4-FFF2-40B4-BE49-F238E27FC236}">
-                <a16:creationId xmlns:a16="http://schemas.microsoft.com/office/drawing/2014/main" id="{BDF5D4D9-CF70-40B3-8B22-983142971954}"/>
+                <a16:creationId xmlns:a16="http://schemas.microsoft.com/office/drawing/2014/main" id="{E79FD6CB-1E42-491E-B4B2-4A2ECAB8FC6B}"/>
               </a:ext>
             </a:extLst>
           </p:cNvPr>
@@ -17786,7 +17786,7 @@
           <p:cNvPr id="11" name="TextBox 10">
             <a:extLst xmlns:a="http://schemas.openxmlformats.org/drawingml/2006/main">
               <a:ext uri="{FF2B5EF4-FFF2-40B4-BE49-F238E27FC236}">
-                <a16:creationId xmlns:a16="http://schemas.microsoft.com/office/drawing/2014/main" id="{1E9546FC-AC66-4C3B-B58B-F0ADABB13B79}"/>
+                <a16:creationId xmlns:a16="http://schemas.microsoft.com/office/drawing/2014/main" id="{04E779CF-1EDC-46AD-8195-24630706AF5F}"/>
               </a:ext>
             </a:extLst>
           </p:cNvPr>
@@ -17833,7 +17833,7 @@
           <p:cNvPr id="12" name="Rounded Rectangle 11">
             <a:extLst xmlns:a="http://schemas.openxmlformats.org/drawingml/2006/main">
               <a:ext uri="{FF2B5EF4-FFF2-40B4-BE49-F238E27FC236}">
-                <a16:creationId xmlns:a16="http://schemas.microsoft.com/office/drawing/2014/main" id="{1A5DA50D-3461-484B-B0A0-051F52AC4314}"/>
+                <a16:creationId xmlns:a16="http://schemas.microsoft.com/office/drawing/2014/main" id="{2579BAC1-E7C5-453E-822C-0560D6655983}"/>
               </a:ext>
             </a:extLst>
           </p:cNvPr>
@@ -17890,7 +17890,7 @@
           <p:cNvPr id="13" name="TextBox 12">
             <a:extLst xmlns:a="http://schemas.openxmlformats.org/drawingml/2006/main">
               <a:ext uri="{FF2B5EF4-FFF2-40B4-BE49-F238E27FC236}">
-                <a16:creationId xmlns:a16="http://schemas.microsoft.com/office/drawing/2014/main" id="{08E495BB-0704-4C5B-A312-AA686E7191C5}"/>
+                <a16:creationId xmlns:a16="http://schemas.microsoft.com/office/drawing/2014/main" id="{4CD1AAA0-E24D-4CEB-B8DA-734ABF7C4956}"/>
               </a:ext>
             </a:extLst>
           </p:cNvPr>
@@ -17937,7 +17937,7 @@
           <p:cNvPr id="14" name="TextBox 13">
             <a:extLst xmlns:a="http://schemas.openxmlformats.org/drawingml/2006/main">
               <a:ext uri="{FF2B5EF4-FFF2-40B4-BE49-F238E27FC236}">
-                <a16:creationId xmlns:a16="http://schemas.microsoft.com/office/drawing/2014/main" id="{30B2B55C-4305-4E94-9DBB-959FCE584C65}"/>
+                <a16:creationId xmlns:a16="http://schemas.microsoft.com/office/drawing/2014/main" id="{B376FA67-1857-432D-ACC8-936EE960F0FB}"/>
               </a:ext>
             </a:extLst>
           </p:cNvPr>
@@ -17984,7 +17984,7 @@
           <p:cNvPr id="15" name="TextBox 14">
             <a:extLst xmlns:a="http://schemas.openxmlformats.org/drawingml/2006/main">
               <a:ext uri="{FF2B5EF4-FFF2-40B4-BE49-F238E27FC236}">
-                <a16:creationId xmlns:a16="http://schemas.microsoft.com/office/drawing/2014/main" id="{14C1E4AE-F3B6-46A5-878B-55EAF9E1F579}"/>
+                <a16:creationId xmlns:a16="http://schemas.microsoft.com/office/drawing/2014/main" id="{7D499321-FA2B-4DCE-ADE3-2065C7BB680B}"/>
               </a:ext>
             </a:extLst>
           </p:cNvPr>
@@ -18031,7 +18031,7 @@
           <p:cNvPr id="16" name="Rounded Rectangle 15">
             <a:extLst xmlns:a="http://schemas.openxmlformats.org/drawingml/2006/main">
               <a:ext uri="{FF2B5EF4-FFF2-40B4-BE49-F238E27FC236}">
-                <a16:creationId xmlns:a16="http://schemas.microsoft.com/office/drawing/2014/main" id="{6FACF75E-2D7F-484E-87D6-740C19A350C6}"/>
+                <a16:creationId xmlns:a16="http://schemas.microsoft.com/office/drawing/2014/main" id="{A8699E44-32A7-4529-B0A6-8E0BC9C43539}"/>
               </a:ext>
             </a:extLst>
           </p:cNvPr>
@@ -18088,7 +18088,7 @@
           <p:cNvPr id="17" name="TextBox 16">
             <a:extLst xmlns:a="http://schemas.openxmlformats.org/drawingml/2006/main">
               <a:ext uri="{FF2B5EF4-FFF2-40B4-BE49-F238E27FC236}">
-                <a16:creationId xmlns:a16="http://schemas.microsoft.com/office/drawing/2014/main" id="{04DB9590-44C1-4367-8A5C-AFBE49068048}"/>
+                <a16:creationId xmlns:a16="http://schemas.microsoft.com/office/drawing/2014/main" id="{5DB910FA-AA57-4370-A581-CD1481DF6191}"/>
               </a:ext>
             </a:extLst>
           </p:cNvPr>
@@ -18135,7 +18135,7 @@
           <p:cNvPr id="18" name="TextBox 17">
             <a:extLst xmlns:a="http://schemas.openxmlformats.org/drawingml/2006/main">
               <a:ext uri="{FF2B5EF4-FFF2-40B4-BE49-F238E27FC236}">
-                <a16:creationId xmlns:a16="http://schemas.microsoft.com/office/drawing/2014/main" id="{D85E8ADA-D270-4D49-B45E-0FA23B225E2D}"/>
+                <a16:creationId xmlns:a16="http://schemas.microsoft.com/office/drawing/2014/main" id="{176DF20C-6F56-4985-9484-8800898C88AF}"/>
               </a:ext>
             </a:extLst>
           </p:cNvPr>
@@ -18182,7 +18182,7 @@
           <p:cNvPr id="19" name="TextBox 18">
             <a:extLst xmlns:a="http://schemas.openxmlformats.org/drawingml/2006/main">
               <a:ext uri="{FF2B5EF4-FFF2-40B4-BE49-F238E27FC236}">
-                <a16:creationId xmlns:a16="http://schemas.microsoft.com/office/drawing/2014/main" id="{80945F0A-EEF8-4830-ACD8-03453BD0734E}"/>
+                <a16:creationId xmlns:a16="http://schemas.microsoft.com/office/drawing/2014/main" id="{764F0B18-FC3D-4FC5-B48E-8654965CDA17}"/>
               </a:ext>
             </a:extLst>
           </p:cNvPr>
@@ -18229,7 +18229,7 @@
           <p:cNvPr id="20" name="Rounded Rectangle 19">
             <a:extLst xmlns:a="http://schemas.openxmlformats.org/drawingml/2006/main">
               <a:ext uri="{FF2B5EF4-FFF2-40B4-BE49-F238E27FC236}">
-                <a16:creationId xmlns:a16="http://schemas.microsoft.com/office/drawing/2014/main" id="{5D08EDA8-60BF-4EBC-B09C-C3D5C9F5D914}"/>
+                <a16:creationId xmlns:a16="http://schemas.microsoft.com/office/drawing/2014/main" id="{CBE86464-093D-4D0C-A4C7-9DCB2D171136}"/>
               </a:ext>
             </a:extLst>
           </p:cNvPr>
@@ -18286,7 +18286,7 @@
           <p:cNvPr id="21" name="TextBox 20">
             <a:extLst xmlns:a="http://schemas.openxmlformats.org/drawingml/2006/main">
               <a:ext uri="{FF2B5EF4-FFF2-40B4-BE49-F238E27FC236}">
-                <a16:creationId xmlns:a16="http://schemas.microsoft.com/office/drawing/2014/main" id="{DAECC3DD-1133-4CF4-AEE0-9E65949F4AA3}"/>
+                <a16:creationId xmlns:a16="http://schemas.microsoft.com/office/drawing/2014/main" id="{AF93A089-B018-4D70-BDC6-B569368DC60F}"/>
               </a:ext>
             </a:extLst>
           </p:cNvPr>
@@ -18333,7 +18333,7 @@
           <p:cNvPr id="22" name="TextBox 21">
             <a:extLst xmlns:a="http://schemas.openxmlformats.org/drawingml/2006/main">
               <a:ext uri="{FF2B5EF4-FFF2-40B4-BE49-F238E27FC236}">
-                <a16:creationId xmlns:a16="http://schemas.microsoft.com/office/drawing/2014/main" id="{A0B2A25E-EAEC-4A69-9B64-A18E54EB1898}"/>
+                <a16:creationId xmlns:a16="http://schemas.microsoft.com/office/drawing/2014/main" id="{054C6445-BB9D-418B-A8FC-D5547D025E9A}"/>
               </a:ext>
             </a:extLst>
           </p:cNvPr>
@@ -18380,7 +18380,7 @@
           <p:cNvPr id="23" name="TextBox 22">
             <a:extLst xmlns:a="http://schemas.openxmlformats.org/drawingml/2006/main">
               <a:ext uri="{FF2B5EF4-FFF2-40B4-BE49-F238E27FC236}">
-                <a16:creationId xmlns:a16="http://schemas.microsoft.com/office/drawing/2014/main" id="{CBE75048-1AEF-4F21-AB31-E24CBC885EF3}"/>
+                <a16:creationId xmlns:a16="http://schemas.microsoft.com/office/drawing/2014/main" id="{3DD56F03-3095-43F6-8C7F-C59B6AEEFE7F}"/>
               </a:ext>
             </a:extLst>
           </p:cNvPr>
@@ -18427,7 +18427,7 @@
           <p:cNvPr id="24" name="TextBox 23">
             <a:extLst xmlns:a="http://schemas.openxmlformats.org/drawingml/2006/main">
               <a:ext uri="{FF2B5EF4-FFF2-40B4-BE49-F238E27FC236}">
-                <a16:creationId xmlns:a16="http://schemas.microsoft.com/office/drawing/2014/main" id="{E86343C4-44CB-48EE-80E4-8EF15DBD04C1}"/>
+                <a16:creationId xmlns:a16="http://schemas.microsoft.com/office/drawing/2014/main" id="{8266854E-13C0-45E8-96F6-141BF39888E9}"/>
               </a:ext>
             </a:extLst>
           </p:cNvPr>
@@ -18472,7 +18472,7 @@
     </p:spTree>
     <p:extLst>
       <p:ext uri="{BB962C8B-B14F-4D97-AF65-F5344CB8AC3E}">
-        <p14:creationId xmlns:p14="http://schemas.microsoft.com/office/powerpoint/2010/main" val="1649455411"/>
+        <p14:creationId xmlns:p14="http://schemas.microsoft.com/office/powerpoint/2010/main" val="1618779236"/>
       </p:ext>
     </p:extLst>
   </p:cSld>
@@ -18496,7 +18496,7 @@
           <p:cNvPr id="2" name="TextBox 1">
             <a:extLst xmlns:a="http://schemas.openxmlformats.org/drawingml/2006/main">
               <a:ext uri="{FF2B5EF4-FFF2-40B4-BE49-F238E27FC236}">
-                <a16:creationId xmlns:a16="http://schemas.microsoft.com/office/drawing/2014/main" id="{A5BF5998-69EC-42BD-9C53-A9E8166BEB94}"/>
+                <a16:creationId xmlns:a16="http://schemas.microsoft.com/office/drawing/2014/main" id="{F3FA05E2-34AC-4120-8789-63211D275110}"/>
               </a:ext>
             </a:extLst>
           </p:cNvPr>
@@ -18543,7 +18543,7 @@
           <p:cNvPr id="3" name="TextBox 2">
             <a:extLst xmlns:a="http://schemas.openxmlformats.org/drawingml/2006/main">
               <a:ext uri="{FF2B5EF4-FFF2-40B4-BE49-F238E27FC236}">
-                <a16:creationId xmlns:a16="http://schemas.microsoft.com/office/drawing/2014/main" id="{AFFDAB4B-6746-46D0-BC69-31944F6CC57E}"/>
+                <a16:creationId xmlns:a16="http://schemas.microsoft.com/office/drawing/2014/main" id="{6728B526-D576-4F85-88FF-A79DA4443155}"/>
               </a:ext>
             </a:extLst>
           </p:cNvPr>
@@ -18590,7 +18590,7 @@
           <p:cNvPr id="4" name="Rectangle 3">
             <a:extLst xmlns:a="http://schemas.openxmlformats.org/drawingml/2006/main">
               <a:ext uri="{FF2B5EF4-FFF2-40B4-BE49-F238E27FC236}">
-                <a16:creationId xmlns:a16="http://schemas.microsoft.com/office/drawing/2014/main" id="{A1E7F893-C6A3-4356-9E95-866936AEC2BA}"/>
+                <a16:creationId xmlns:a16="http://schemas.microsoft.com/office/drawing/2014/main" id="{F5235EAC-BED1-4844-AACB-0A3D01525A5A}"/>
               </a:ext>
             </a:extLst>
           </p:cNvPr>
@@ -18645,7 +18645,7 @@
           <p:cNvPr id="5" name="Rectangle 4">
             <a:extLst xmlns:a="http://schemas.openxmlformats.org/drawingml/2006/main">
               <a:ext uri="{FF2B5EF4-FFF2-40B4-BE49-F238E27FC236}">
-                <a16:creationId xmlns:a16="http://schemas.microsoft.com/office/drawing/2014/main" id="{2E70412B-C134-463D-B50C-2BA465ED265F}"/>
+                <a16:creationId xmlns:a16="http://schemas.microsoft.com/office/drawing/2014/main" id="{A35813C8-2718-4884-98BC-CB085161834E}"/>
               </a:ext>
             </a:extLst>
           </p:cNvPr>
@@ -18700,7 +18700,7 @@
           <p:cNvPr id="6" name="TextBox 5">
             <a:extLst xmlns:a="http://schemas.openxmlformats.org/drawingml/2006/main">
               <a:ext uri="{FF2B5EF4-FFF2-40B4-BE49-F238E27FC236}">
-                <a16:creationId xmlns:a16="http://schemas.microsoft.com/office/drawing/2014/main" id="{93B3F963-45E5-40CF-8803-439BBAEA19BA}"/>
+                <a16:creationId xmlns:a16="http://schemas.microsoft.com/office/drawing/2014/main" id="{D795F483-BD90-41B7-83A8-0A7FD2107DBB}"/>
               </a:ext>
             </a:extLst>
           </p:cNvPr>
@@ -18737,7 +18737,7 @@
                 <a:ea typeface="Aptos"/>
                 <a:cs typeface="Aptos"/>
               </a:rPr>
-              <a:t>Independent public evidence summary · 2026.07.23-11 · 2026-07-22 · Sources: WIPO dispute resolution; EPO IPscore</a:t>
+              <a:t>Independent public evidence summary · 2026.07.23-12 · 2026-07-22 · Sources: WIPO dispute resolution; EPO IPscore</a:t>
             </a:r>
           </a:p>
         </p:txBody>
@@ -18747,7 +18747,7 @@
           <p:cNvPr id="7" name="TextBox 6">
             <a:extLst xmlns:a="http://schemas.openxmlformats.org/drawingml/2006/main">
               <a:ext uri="{FF2B5EF4-FFF2-40B4-BE49-F238E27FC236}">
-                <a16:creationId xmlns:a16="http://schemas.microsoft.com/office/drawing/2014/main" id="{B2D5AD75-BADA-487D-9F5E-1B8F1CA6AFD3}"/>
+                <a16:creationId xmlns:a16="http://schemas.microsoft.com/office/drawing/2014/main" id="{66A7D840-6F6F-4DAF-B29A-C1CA8D934E7F}"/>
               </a:ext>
             </a:extLst>
           </p:cNvPr>
@@ -18794,7 +18794,7 @@
           <p:cNvPr id="8" name="Rounded Rectangle 7">
             <a:extLst xmlns:a="http://schemas.openxmlformats.org/drawingml/2006/main">
               <a:ext uri="{FF2B5EF4-FFF2-40B4-BE49-F238E27FC236}">
-                <a16:creationId xmlns:a16="http://schemas.microsoft.com/office/drawing/2014/main" id="{8F0FE76D-4C78-415B-AF8F-32CAC05E3E70}"/>
+                <a16:creationId xmlns:a16="http://schemas.microsoft.com/office/drawing/2014/main" id="{62876B88-6D3F-4CA7-8252-5371026CCC03}"/>
               </a:ext>
             </a:extLst>
           </p:cNvPr>
@@ -18851,7 +18851,7 @@
           <p:cNvPr id="9" name="TextBox 8">
             <a:extLst xmlns:a="http://schemas.openxmlformats.org/drawingml/2006/main">
               <a:ext uri="{FF2B5EF4-FFF2-40B4-BE49-F238E27FC236}">
-                <a16:creationId xmlns:a16="http://schemas.microsoft.com/office/drawing/2014/main" id="{F3E6ED80-7EE6-49B2-8777-21256A14CE97}"/>
+                <a16:creationId xmlns:a16="http://schemas.microsoft.com/office/drawing/2014/main" id="{89699BA5-5D46-4AAE-8B31-8D2ABD21694E}"/>
               </a:ext>
             </a:extLst>
           </p:cNvPr>
@@ -18898,7 +18898,7 @@
           <p:cNvPr id="10" name="TextBox 9">
             <a:extLst xmlns:a="http://schemas.openxmlformats.org/drawingml/2006/main">
               <a:ext uri="{FF2B5EF4-FFF2-40B4-BE49-F238E27FC236}">
-                <a16:creationId xmlns:a16="http://schemas.microsoft.com/office/drawing/2014/main" id="{386C0729-F45C-49C1-8808-3202BF2463B6}"/>
+                <a16:creationId xmlns:a16="http://schemas.microsoft.com/office/drawing/2014/main" id="{1DCA6FE7-476A-41D5-9F63-DAA99E2DBE83}"/>
               </a:ext>
             </a:extLst>
           </p:cNvPr>
@@ -18945,7 +18945,7 @@
           <p:cNvPr id="11" name="TextBox 10">
             <a:extLst xmlns:a="http://schemas.openxmlformats.org/drawingml/2006/main">
               <a:ext uri="{FF2B5EF4-FFF2-40B4-BE49-F238E27FC236}">
-                <a16:creationId xmlns:a16="http://schemas.microsoft.com/office/drawing/2014/main" id="{E8922FD6-3820-4D94-9653-F43A5E0808A3}"/>
+                <a16:creationId xmlns:a16="http://schemas.microsoft.com/office/drawing/2014/main" id="{21444643-1AFC-4077-B388-5BE902D00052}"/>
               </a:ext>
             </a:extLst>
           </p:cNvPr>
@@ -18992,7 +18992,7 @@
           <p:cNvPr id="12" name="Rounded Rectangle 11">
             <a:extLst xmlns:a="http://schemas.openxmlformats.org/drawingml/2006/main">
               <a:ext uri="{FF2B5EF4-FFF2-40B4-BE49-F238E27FC236}">
-                <a16:creationId xmlns:a16="http://schemas.microsoft.com/office/drawing/2014/main" id="{A82C83F7-6610-4C54-95DE-D04B1529C896}"/>
+                <a16:creationId xmlns:a16="http://schemas.microsoft.com/office/drawing/2014/main" id="{185B4286-A9AE-4580-9355-30D539DF1777}"/>
               </a:ext>
             </a:extLst>
           </p:cNvPr>
@@ -19049,7 +19049,7 @@
           <p:cNvPr id="13" name="TextBox 12">
             <a:extLst xmlns:a="http://schemas.openxmlformats.org/drawingml/2006/main">
               <a:ext uri="{FF2B5EF4-FFF2-40B4-BE49-F238E27FC236}">
-                <a16:creationId xmlns:a16="http://schemas.microsoft.com/office/drawing/2014/main" id="{258B88D9-39C8-4B84-A37D-326EF456B588}"/>
+                <a16:creationId xmlns:a16="http://schemas.microsoft.com/office/drawing/2014/main" id="{6721B431-6BB5-4E4D-B1E7-FEAAFB0250EF}"/>
               </a:ext>
             </a:extLst>
           </p:cNvPr>
@@ -19096,7 +19096,7 @@
           <p:cNvPr id="14" name="TextBox 13">
             <a:extLst xmlns:a="http://schemas.openxmlformats.org/drawingml/2006/main">
               <a:ext uri="{FF2B5EF4-FFF2-40B4-BE49-F238E27FC236}">
-                <a16:creationId xmlns:a16="http://schemas.microsoft.com/office/drawing/2014/main" id="{59BD6CFB-0BF2-4149-9AB4-65596259FD74}"/>
+                <a16:creationId xmlns:a16="http://schemas.microsoft.com/office/drawing/2014/main" id="{38A08721-C9DB-491A-AC5A-CCE4FCA2EF41}"/>
               </a:ext>
             </a:extLst>
           </p:cNvPr>
@@ -19143,7 +19143,7 @@
           <p:cNvPr id="15" name="TextBox 14">
             <a:extLst xmlns:a="http://schemas.openxmlformats.org/drawingml/2006/main">
               <a:ext uri="{FF2B5EF4-FFF2-40B4-BE49-F238E27FC236}">
-                <a16:creationId xmlns:a16="http://schemas.microsoft.com/office/drawing/2014/main" id="{C58E5FF1-7AAA-469B-91D2-BE8A64637861}"/>
+                <a16:creationId xmlns:a16="http://schemas.microsoft.com/office/drawing/2014/main" id="{4BEF2FD2-1841-466D-8B09-2290D0B0C8E3}"/>
               </a:ext>
             </a:extLst>
           </p:cNvPr>
@@ -19190,7 +19190,7 @@
           <p:cNvPr id="16" name="Rounded Rectangle 15">
             <a:extLst xmlns:a="http://schemas.openxmlformats.org/drawingml/2006/main">
               <a:ext uri="{FF2B5EF4-FFF2-40B4-BE49-F238E27FC236}">
-                <a16:creationId xmlns:a16="http://schemas.microsoft.com/office/drawing/2014/main" id="{7FDACEDD-FD3F-4A0E-ACE0-14B1BE7088CF}"/>
+                <a16:creationId xmlns:a16="http://schemas.microsoft.com/office/drawing/2014/main" id="{83BEB343-83B2-4E5B-BBC8-B3A6D4860608}"/>
               </a:ext>
             </a:extLst>
           </p:cNvPr>
@@ -19247,7 +19247,7 @@
           <p:cNvPr id="17" name="TextBox 16">
             <a:extLst xmlns:a="http://schemas.openxmlformats.org/drawingml/2006/main">
               <a:ext uri="{FF2B5EF4-FFF2-40B4-BE49-F238E27FC236}">
-                <a16:creationId xmlns:a16="http://schemas.microsoft.com/office/drawing/2014/main" id="{0EC195A9-E388-4365-9D7D-9DDDF9DC8B39}"/>
+                <a16:creationId xmlns:a16="http://schemas.microsoft.com/office/drawing/2014/main" id="{36EE91EB-4632-496D-AF0D-A7DC78BE8F0F}"/>
               </a:ext>
             </a:extLst>
           </p:cNvPr>
@@ -19294,7 +19294,7 @@
           <p:cNvPr id="18" name="TextBox 17">
             <a:extLst xmlns:a="http://schemas.openxmlformats.org/drawingml/2006/main">
               <a:ext uri="{FF2B5EF4-FFF2-40B4-BE49-F238E27FC236}">
-                <a16:creationId xmlns:a16="http://schemas.microsoft.com/office/drawing/2014/main" id="{8A6493FD-2BE8-4527-8F18-00B016C567F9}"/>
+                <a16:creationId xmlns:a16="http://schemas.microsoft.com/office/drawing/2014/main" id="{2D2E2A82-A2D2-4FDB-92BB-E64F8CAC31B1}"/>
               </a:ext>
             </a:extLst>
           </p:cNvPr>
@@ -19341,7 +19341,7 @@
           <p:cNvPr id="19" name="TextBox 18">
             <a:extLst xmlns:a="http://schemas.openxmlformats.org/drawingml/2006/main">
               <a:ext uri="{FF2B5EF4-FFF2-40B4-BE49-F238E27FC236}">
-                <a16:creationId xmlns:a16="http://schemas.microsoft.com/office/drawing/2014/main" id="{03BF5AF3-9048-4570-943F-C59A1EF12246}"/>
+                <a16:creationId xmlns:a16="http://schemas.microsoft.com/office/drawing/2014/main" id="{2C18D024-1E8F-41EA-9E7F-D1045742BA08}"/>
               </a:ext>
             </a:extLst>
           </p:cNvPr>
@@ -19388,7 +19388,7 @@
           <p:cNvPr id="20" name="Rounded Rectangle 19">
             <a:extLst xmlns:a="http://schemas.openxmlformats.org/drawingml/2006/main">
               <a:ext uri="{FF2B5EF4-FFF2-40B4-BE49-F238E27FC236}">
-                <a16:creationId xmlns:a16="http://schemas.microsoft.com/office/drawing/2014/main" id="{6C712A78-2E4A-4066-89DB-60DBBA360966}"/>
+                <a16:creationId xmlns:a16="http://schemas.microsoft.com/office/drawing/2014/main" id="{370F10F0-73B0-4F88-B5A8-9819586A56E8}"/>
               </a:ext>
             </a:extLst>
           </p:cNvPr>
@@ -19445,7 +19445,7 @@
           <p:cNvPr id="21" name="TextBox 20">
             <a:extLst xmlns:a="http://schemas.openxmlformats.org/drawingml/2006/main">
               <a:ext uri="{FF2B5EF4-FFF2-40B4-BE49-F238E27FC236}">
-                <a16:creationId xmlns:a16="http://schemas.microsoft.com/office/drawing/2014/main" id="{43232C10-380A-452A-A88A-32A5FD630D15}"/>
+                <a16:creationId xmlns:a16="http://schemas.microsoft.com/office/drawing/2014/main" id="{C5C5D78F-38B9-406E-84A0-AFA4593593E0}"/>
               </a:ext>
             </a:extLst>
           </p:cNvPr>
@@ -19492,7 +19492,7 @@
           <p:cNvPr id="22" name="TextBox 21">
             <a:extLst xmlns:a="http://schemas.openxmlformats.org/drawingml/2006/main">
               <a:ext uri="{FF2B5EF4-FFF2-40B4-BE49-F238E27FC236}">
-                <a16:creationId xmlns:a16="http://schemas.microsoft.com/office/drawing/2014/main" id="{A850EA52-6233-4FD3-982D-F540FC49A6BD}"/>
+                <a16:creationId xmlns:a16="http://schemas.microsoft.com/office/drawing/2014/main" id="{909155C0-E258-4FE7-9C95-079EBC2025F0}"/>
               </a:ext>
             </a:extLst>
           </p:cNvPr>
@@ -19539,7 +19539,7 @@
           <p:cNvPr id="23" name="TextBox 22">
             <a:extLst xmlns:a="http://schemas.openxmlformats.org/drawingml/2006/main">
               <a:ext uri="{FF2B5EF4-FFF2-40B4-BE49-F238E27FC236}">
-                <a16:creationId xmlns:a16="http://schemas.microsoft.com/office/drawing/2014/main" id="{D57055E5-08AF-45C6-9A13-17E33EC285F9}"/>
+                <a16:creationId xmlns:a16="http://schemas.microsoft.com/office/drawing/2014/main" id="{165A8A09-80D3-484E-829B-4B536FE0F294}"/>
               </a:ext>
             </a:extLst>
           </p:cNvPr>
@@ -19586,7 +19586,7 @@
           <p:cNvPr id="24" name="TextBox 23">
             <a:extLst xmlns:a="http://schemas.openxmlformats.org/drawingml/2006/main">
               <a:ext uri="{FF2B5EF4-FFF2-40B4-BE49-F238E27FC236}">
-                <a16:creationId xmlns:a16="http://schemas.microsoft.com/office/drawing/2014/main" id="{0C091EDB-1F27-4F84-9D17-28117C7C62AD}"/>
+                <a16:creationId xmlns:a16="http://schemas.microsoft.com/office/drawing/2014/main" id="{2CB18381-6965-4DBB-A78D-A21E8CA11304}"/>
               </a:ext>
             </a:extLst>
           </p:cNvPr>
@@ -19631,7 +19631,7 @@
     </p:spTree>
     <p:extLst>
       <p:ext uri="{BB962C8B-B14F-4D97-AF65-F5344CB8AC3E}">
-        <p14:creationId xmlns:p14="http://schemas.microsoft.com/office/powerpoint/2010/main" val="1744314089"/>
+        <p14:creationId xmlns:p14="http://schemas.microsoft.com/office/powerpoint/2010/main" val="170407320"/>
       </p:ext>
     </p:extLst>
   </p:cSld>
@@ -19655,7 +19655,7 @@
           <p:cNvPr id="2" name="TextBox 1">
             <a:extLst xmlns:a="http://schemas.openxmlformats.org/drawingml/2006/main">
               <a:ext uri="{FF2B5EF4-FFF2-40B4-BE49-F238E27FC236}">
-                <a16:creationId xmlns:a16="http://schemas.microsoft.com/office/drawing/2014/main" id="{2797708C-94FE-4670-8BF2-5D3D6EA75C9C}"/>
+                <a16:creationId xmlns:a16="http://schemas.microsoft.com/office/drawing/2014/main" id="{C9E41D6F-9030-449C-B3A5-27184F5F86FA}"/>
               </a:ext>
             </a:extLst>
           </p:cNvPr>
@@ -19702,7 +19702,7 @@
           <p:cNvPr id="3" name="TextBox 2">
             <a:extLst xmlns:a="http://schemas.openxmlformats.org/drawingml/2006/main">
               <a:ext uri="{FF2B5EF4-FFF2-40B4-BE49-F238E27FC236}">
-                <a16:creationId xmlns:a16="http://schemas.microsoft.com/office/drawing/2014/main" id="{DA8F015D-22CF-4306-81A0-6900B87601C6}"/>
+                <a16:creationId xmlns:a16="http://schemas.microsoft.com/office/drawing/2014/main" id="{148C18CE-544B-4FD8-BCE0-D0B8C0962140}"/>
               </a:ext>
             </a:extLst>
           </p:cNvPr>
@@ -19749,7 +19749,7 @@
           <p:cNvPr id="4" name="Rectangle 3">
             <a:extLst xmlns:a="http://schemas.openxmlformats.org/drawingml/2006/main">
               <a:ext uri="{FF2B5EF4-FFF2-40B4-BE49-F238E27FC236}">
-                <a16:creationId xmlns:a16="http://schemas.microsoft.com/office/drawing/2014/main" id="{1904A954-FA42-4077-97D1-1D287ABB99D3}"/>
+                <a16:creationId xmlns:a16="http://schemas.microsoft.com/office/drawing/2014/main" id="{F6A56ADF-C8C4-4080-B09F-8481964A06CD}"/>
               </a:ext>
             </a:extLst>
           </p:cNvPr>
@@ -19804,7 +19804,7 @@
           <p:cNvPr id="5" name="Rectangle 4">
             <a:extLst xmlns:a="http://schemas.openxmlformats.org/drawingml/2006/main">
               <a:ext uri="{FF2B5EF4-FFF2-40B4-BE49-F238E27FC236}">
-                <a16:creationId xmlns:a16="http://schemas.microsoft.com/office/drawing/2014/main" id="{854D26FC-04CD-4F33-A774-EC8B2362EAFA}"/>
+                <a16:creationId xmlns:a16="http://schemas.microsoft.com/office/drawing/2014/main" id="{3D89AD4D-DADD-41EB-8D5F-C4B000DA2EB2}"/>
               </a:ext>
             </a:extLst>
           </p:cNvPr>
@@ -19859,7 +19859,7 @@
           <p:cNvPr id="6" name="TextBox 5">
             <a:extLst xmlns:a="http://schemas.openxmlformats.org/drawingml/2006/main">
               <a:ext uri="{FF2B5EF4-FFF2-40B4-BE49-F238E27FC236}">
-                <a16:creationId xmlns:a16="http://schemas.microsoft.com/office/drawing/2014/main" id="{5860C676-9A68-4BC2-9B0E-CB4D10C9FBD3}"/>
+                <a16:creationId xmlns:a16="http://schemas.microsoft.com/office/drawing/2014/main" id="{61DA28CF-91A7-422D-B63B-C35833594985}"/>
               </a:ext>
             </a:extLst>
           </p:cNvPr>
@@ -19896,7 +19896,7 @@
                 <a:ea typeface="Aptos"/>
                 <a:cs typeface="Aptos"/>
               </a:rPr>
-              <a:t>Independent public evidence summary · 2026.07.23-11 · 2026-07-22 · Sources: WIPO licensing; IP Finance; TPLF mapping</a:t>
+              <a:t>Independent public evidence summary · 2026.07.23-12 · 2026-07-22 · Sources: WIPO licensing; IP Finance; TPLF mapping</a:t>
             </a:r>
           </a:p>
         </p:txBody>
@@ -19906,7 +19906,7 @@
           <p:cNvPr id="7" name="TextBox 6">
             <a:extLst xmlns:a="http://schemas.openxmlformats.org/drawingml/2006/main">
               <a:ext uri="{FF2B5EF4-FFF2-40B4-BE49-F238E27FC236}">
-                <a16:creationId xmlns:a16="http://schemas.microsoft.com/office/drawing/2014/main" id="{FD7AE657-A59D-43D1-A88E-4E9802213668}"/>
+                <a16:creationId xmlns:a16="http://schemas.microsoft.com/office/drawing/2014/main" id="{3C155A70-66A0-473E-8AD9-5C1BB97E5CE4}"/>
               </a:ext>
             </a:extLst>
           </p:cNvPr>
@@ -20476,7 +20476,7 @@
           <p:cNvPr id="9" name="TextBox 8">
             <a:extLst xmlns:a="http://schemas.openxmlformats.org/drawingml/2006/main">
               <a:ext uri="{FF2B5EF4-FFF2-40B4-BE49-F238E27FC236}">
-                <a16:creationId xmlns:a16="http://schemas.microsoft.com/office/drawing/2014/main" id="{E183CBA7-6FB9-4B7D-B0CB-3943CD8816C8}"/>
+                <a16:creationId xmlns:a16="http://schemas.microsoft.com/office/drawing/2014/main" id="{8CC44935-4557-4037-A0D1-78548C455420}"/>
               </a:ext>
             </a:extLst>
           </p:cNvPr>
@@ -20521,7 +20521,7 @@
     </p:spTree>
     <p:extLst>
       <p:ext uri="{BB962C8B-B14F-4D97-AF65-F5344CB8AC3E}">
-        <p14:creationId xmlns:p14="http://schemas.microsoft.com/office/powerpoint/2010/main" val="1153751682"/>
+        <p14:creationId xmlns:p14="http://schemas.microsoft.com/office/powerpoint/2010/main" val="193986243"/>
       </p:ext>
     </p:extLst>
   </p:cSld>
@@ -20545,7 +20545,7 @@
           <p:cNvPr id="2" name="TextBox 1">
             <a:extLst xmlns:a="http://schemas.openxmlformats.org/drawingml/2006/main">
               <a:ext uri="{FF2B5EF4-FFF2-40B4-BE49-F238E27FC236}">
-                <a16:creationId xmlns:a16="http://schemas.microsoft.com/office/drawing/2014/main" id="{617ED85A-A40A-40BA-9706-43F576690BA9}"/>
+                <a16:creationId xmlns:a16="http://schemas.microsoft.com/office/drawing/2014/main" id="{CFA6AB8D-668B-4BB9-9EE9-FE8F7261A5AD}"/>
               </a:ext>
             </a:extLst>
           </p:cNvPr>
@@ -20592,7 +20592,7 @@
           <p:cNvPr id="3" name="TextBox 2">
             <a:extLst xmlns:a="http://schemas.openxmlformats.org/drawingml/2006/main">
               <a:ext uri="{FF2B5EF4-FFF2-40B4-BE49-F238E27FC236}">
-                <a16:creationId xmlns:a16="http://schemas.microsoft.com/office/drawing/2014/main" id="{00383E63-939D-4C0B-B056-B97FD5F528FF}"/>
+                <a16:creationId xmlns:a16="http://schemas.microsoft.com/office/drawing/2014/main" id="{0496B9AD-2034-41E2-988A-AD3055B866C7}"/>
               </a:ext>
             </a:extLst>
           </p:cNvPr>
@@ -20639,7 +20639,7 @@
           <p:cNvPr id="4" name="Rectangle 3">
             <a:extLst xmlns:a="http://schemas.openxmlformats.org/drawingml/2006/main">
               <a:ext uri="{FF2B5EF4-FFF2-40B4-BE49-F238E27FC236}">
-                <a16:creationId xmlns:a16="http://schemas.microsoft.com/office/drawing/2014/main" id="{968B7D54-7165-4E54-8CAA-89445CF8D701}"/>
+                <a16:creationId xmlns:a16="http://schemas.microsoft.com/office/drawing/2014/main" id="{23BDF581-0838-40C1-804F-13A5CDBD6A12}"/>
               </a:ext>
             </a:extLst>
           </p:cNvPr>
@@ -20694,7 +20694,7 @@
           <p:cNvPr id="5" name="Rectangle 4">
             <a:extLst xmlns:a="http://schemas.openxmlformats.org/drawingml/2006/main">
               <a:ext uri="{FF2B5EF4-FFF2-40B4-BE49-F238E27FC236}">
-                <a16:creationId xmlns:a16="http://schemas.microsoft.com/office/drawing/2014/main" id="{4AB61D7C-8DA7-4488-A87A-1B704239D94A}"/>
+                <a16:creationId xmlns:a16="http://schemas.microsoft.com/office/drawing/2014/main" id="{7310B86D-BBF8-4957-9E19-593CB0501C66}"/>
               </a:ext>
             </a:extLst>
           </p:cNvPr>
@@ -20749,7 +20749,7 @@
           <p:cNvPr id="6" name="TextBox 5">
             <a:extLst xmlns:a="http://schemas.openxmlformats.org/drawingml/2006/main">
               <a:ext uri="{FF2B5EF4-FFF2-40B4-BE49-F238E27FC236}">
-                <a16:creationId xmlns:a16="http://schemas.microsoft.com/office/drawing/2014/main" id="{BBDCCB06-8650-47CE-A5EA-B1266785C064}"/>
+                <a16:creationId xmlns:a16="http://schemas.microsoft.com/office/drawing/2014/main" id="{860A9407-1E61-4192-A55D-C7315570BB72}"/>
               </a:ext>
             </a:extLst>
           </p:cNvPr>
@@ -20786,7 +20786,7 @@
                 <a:ea typeface="Aptos"/>
                 <a:cs typeface="Aptos"/>
               </a:rPr>
-              <a:t>Independent public evidence summary · 2026.07.23-11 · 2026-07-22 · Sources: Evidence Register; WIPO valuation</a:t>
+              <a:t>Independent public evidence summary · 2026.07.23-12 · 2026-07-22 · Sources: Evidence Register; WIPO valuation</a:t>
             </a:r>
           </a:p>
         </p:txBody>
@@ -20796,7 +20796,7 @@
           <p:cNvPr id="7" name="TextBox 6">
             <a:extLst xmlns:a="http://schemas.openxmlformats.org/drawingml/2006/main">
               <a:ext uri="{FF2B5EF4-FFF2-40B4-BE49-F238E27FC236}">
-                <a16:creationId xmlns:a16="http://schemas.microsoft.com/office/drawing/2014/main" id="{16F66114-1C3C-41CD-93A8-00DD8F783DC2}"/>
+                <a16:creationId xmlns:a16="http://schemas.microsoft.com/office/drawing/2014/main" id="{2B99F839-ACDA-4345-92D2-D6C3F5089B42}"/>
               </a:ext>
             </a:extLst>
           </p:cNvPr>
@@ -21449,7 +21449,7 @@
           <p:cNvPr id="9" name="TextBox 8">
             <a:extLst xmlns:a="http://schemas.openxmlformats.org/drawingml/2006/main">
               <a:ext uri="{FF2B5EF4-FFF2-40B4-BE49-F238E27FC236}">
-                <a16:creationId xmlns:a16="http://schemas.microsoft.com/office/drawing/2014/main" id="{406795A4-10DF-45E1-ACE8-71A131DEBDDA}"/>
+                <a16:creationId xmlns:a16="http://schemas.microsoft.com/office/drawing/2014/main" id="{4BF9C665-3AED-4966-AA4B-8DF6E3C9CE0A}"/>
               </a:ext>
             </a:extLst>
           </p:cNvPr>
@@ -21494,7 +21494,7 @@
     </p:spTree>
     <p:extLst>
       <p:ext uri="{BB962C8B-B14F-4D97-AF65-F5344CB8AC3E}">
-        <p14:creationId xmlns:p14="http://schemas.microsoft.com/office/powerpoint/2010/main" val="1895016102"/>
+        <p14:creationId xmlns:p14="http://schemas.microsoft.com/office/powerpoint/2010/main" val="1366395553"/>
       </p:ext>
     </p:extLst>
   </p:cSld>
@@ -21518,7 +21518,7 @@
           <p:cNvPr id="2" name="TextBox 1">
             <a:extLst xmlns:a="http://schemas.openxmlformats.org/drawingml/2006/main">
               <a:ext uri="{FF2B5EF4-FFF2-40B4-BE49-F238E27FC236}">
-                <a16:creationId xmlns:a16="http://schemas.microsoft.com/office/drawing/2014/main" id="{8EA5C04F-7DDE-474B-88C8-BCEFFF98C5D6}"/>
+                <a16:creationId xmlns:a16="http://schemas.microsoft.com/office/drawing/2014/main" id="{B40B6036-92D4-4102-80EA-F775288930C2}"/>
               </a:ext>
             </a:extLst>
           </p:cNvPr>
@@ -21565,7 +21565,7 @@
           <p:cNvPr id="3" name="TextBox 2">
             <a:extLst xmlns:a="http://schemas.openxmlformats.org/drawingml/2006/main">
               <a:ext uri="{FF2B5EF4-FFF2-40B4-BE49-F238E27FC236}">
-                <a16:creationId xmlns:a16="http://schemas.microsoft.com/office/drawing/2014/main" id="{9151A8BF-9F5F-4EDC-8657-A56ECEEEDF3E}"/>
+                <a16:creationId xmlns:a16="http://schemas.microsoft.com/office/drawing/2014/main" id="{BD5391C8-6590-4797-9B96-E6E95443B903}"/>
               </a:ext>
             </a:extLst>
           </p:cNvPr>
@@ -21612,7 +21612,7 @@
           <p:cNvPr id="4" name="Rectangle 3">
             <a:extLst xmlns:a="http://schemas.openxmlformats.org/drawingml/2006/main">
               <a:ext uri="{FF2B5EF4-FFF2-40B4-BE49-F238E27FC236}">
-                <a16:creationId xmlns:a16="http://schemas.microsoft.com/office/drawing/2014/main" id="{3EAD722E-65CA-4C61-9E63-42B35314EB48}"/>
+                <a16:creationId xmlns:a16="http://schemas.microsoft.com/office/drawing/2014/main" id="{EC251119-7C1D-4139-8429-5B45196389F4}"/>
               </a:ext>
             </a:extLst>
           </p:cNvPr>
@@ -21667,7 +21667,7 @@
           <p:cNvPr id="5" name="Rectangle 4">
             <a:extLst xmlns:a="http://schemas.openxmlformats.org/drawingml/2006/main">
               <a:ext uri="{FF2B5EF4-FFF2-40B4-BE49-F238E27FC236}">
-                <a16:creationId xmlns:a16="http://schemas.microsoft.com/office/drawing/2014/main" id="{F871CA43-FAE6-48F5-8AE5-3E562C9E08D9}"/>
+                <a16:creationId xmlns:a16="http://schemas.microsoft.com/office/drawing/2014/main" id="{905CF4C1-6D13-4282-AB65-0D7BDD876D57}"/>
               </a:ext>
             </a:extLst>
           </p:cNvPr>
@@ -21722,7 +21722,7 @@
           <p:cNvPr id="6" name="TextBox 5">
             <a:extLst xmlns:a="http://schemas.openxmlformats.org/drawingml/2006/main">
               <a:ext uri="{FF2B5EF4-FFF2-40B4-BE49-F238E27FC236}">
-                <a16:creationId xmlns:a16="http://schemas.microsoft.com/office/drawing/2014/main" id="{5B2A3152-1DFB-48A9-9CF8-F027155D6C5F}"/>
+                <a16:creationId xmlns:a16="http://schemas.microsoft.com/office/drawing/2014/main" id="{224CEF01-B741-44CF-82D3-6CF10697A23B}"/>
               </a:ext>
             </a:extLst>
           </p:cNvPr>
@@ -21759,7 +21759,7 @@
                 <a:ea typeface="Aptos"/>
                 <a:cs typeface="Aptos"/>
               </a:rPr>
-              <a:t>Independent public evidence summary · 2026.07.23-11 · 2026-07-22 · Sources: WIPO valuation</a:t>
+              <a:t>Independent public evidence summary · 2026.07.23-12 · 2026-07-22 · Sources: WIPO valuation</a:t>
             </a:r>
           </a:p>
         </p:txBody>
@@ -21769,7 +21769,7 @@
           <p:cNvPr id="7" name="TextBox 6">
             <a:extLst xmlns:a="http://schemas.openxmlformats.org/drawingml/2006/main">
               <a:ext uri="{FF2B5EF4-FFF2-40B4-BE49-F238E27FC236}">
-                <a16:creationId xmlns:a16="http://schemas.microsoft.com/office/drawing/2014/main" id="{9ED95BE0-160B-44C4-A47E-21FC4700D611}"/>
+                <a16:creationId xmlns:a16="http://schemas.microsoft.com/office/drawing/2014/main" id="{4845F46E-61D5-4ACA-B4D1-2170617D648D}"/>
               </a:ext>
             </a:extLst>
           </p:cNvPr>
@@ -22502,7 +22502,7 @@
           <p:cNvPr id="9" name="TextBox 8">
             <a:extLst xmlns:a="http://schemas.openxmlformats.org/drawingml/2006/main">
               <a:ext uri="{FF2B5EF4-FFF2-40B4-BE49-F238E27FC236}">
-                <a16:creationId xmlns:a16="http://schemas.microsoft.com/office/drawing/2014/main" id="{0361DA06-1ADC-4A0F-8A02-00D7732E05C5}"/>
+                <a16:creationId xmlns:a16="http://schemas.microsoft.com/office/drawing/2014/main" id="{62C1E2C2-3A73-4434-9095-ED1AE0AEBF99}"/>
               </a:ext>
             </a:extLst>
           </p:cNvPr>
@@ -22547,7 +22547,7 @@
     </p:spTree>
     <p:extLst>
       <p:ext uri="{BB962C8B-B14F-4D97-AF65-F5344CB8AC3E}">
-        <p14:creationId xmlns:p14="http://schemas.microsoft.com/office/powerpoint/2010/main" val="2123521684"/>
+        <p14:creationId xmlns:p14="http://schemas.microsoft.com/office/powerpoint/2010/main" val="1199786298"/>
       </p:ext>
     </p:extLst>
   </p:cSld>
@@ -22571,7 +22571,7 @@
           <p:cNvPr id="2" name="TextBox 1">
             <a:extLst xmlns:a="http://schemas.openxmlformats.org/drawingml/2006/main">
               <a:ext uri="{FF2B5EF4-FFF2-40B4-BE49-F238E27FC236}">
-                <a16:creationId xmlns:a16="http://schemas.microsoft.com/office/drawing/2014/main" id="{05A8E36D-7966-4BA5-AA85-143BC9F55B61}"/>
+                <a16:creationId xmlns:a16="http://schemas.microsoft.com/office/drawing/2014/main" id="{13C8281C-4C11-4D54-8201-FA7B1DA8EDFE}"/>
               </a:ext>
             </a:extLst>
           </p:cNvPr>
@@ -22618,7 +22618,7 @@
           <p:cNvPr id="3" name="TextBox 2">
             <a:extLst xmlns:a="http://schemas.openxmlformats.org/drawingml/2006/main">
               <a:ext uri="{FF2B5EF4-FFF2-40B4-BE49-F238E27FC236}">
-                <a16:creationId xmlns:a16="http://schemas.microsoft.com/office/drawing/2014/main" id="{2260F9A8-F408-4A3C-BF6E-42B0D2E4D72C}"/>
+                <a16:creationId xmlns:a16="http://schemas.microsoft.com/office/drawing/2014/main" id="{DD57748B-87F0-4934-8873-400BD71DBAD2}"/>
               </a:ext>
             </a:extLst>
           </p:cNvPr>
@@ -22665,7 +22665,7 @@
           <p:cNvPr id="4" name="Rectangle 3">
             <a:extLst xmlns:a="http://schemas.openxmlformats.org/drawingml/2006/main">
               <a:ext uri="{FF2B5EF4-FFF2-40B4-BE49-F238E27FC236}">
-                <a16:creationId xmlns:a16="http://schemas.microsoft.com/office/drawing/2014/main" id="{14936832-AE4E-4C61-9988-B62ED95D99C8}"/>
+                <a16:creationId xmlns:a16="http://schemas.microsoft.com/office/drawing/2014/main" id="{7DC2D3F2-9E0D-471D-ABB9-B47FA4E4F2D5}"/>
               </a:ext>
             </a:extLst>
           </p:cNvPr>
@@ -22720,7 +22720,7 @@
           <p:cNvPr id="5" name="Rectangle 4">
             <a:extLst xmlns:a="http://schemas.openxmlformats.org/drawingml/2006/main">
               <a:ext uri="{FF2B5EF4-FFF2-40B4-BE49-F238E27FC236}">
-                <a16:creationId xmlns:a16="http://schemas.microsoft.com/office/drawing/2014/main" id="{408A1DAC-FD42-4E9A-8657-B4753BE6484F}"/>
+                <a16:creationId xmlns:a16="http://schemas.microsoft.com/office/drawing/2014/main" id="{7729C8A2-E66A-424B-A2FA-F3233B0E3618}"/>
               </a:ext>
             </a:extLst>
           </p:cNvPr>
@@ -22775,7 +22775,7 @@
           <p:cNvPr id="6" name="TextBox 5">
             <a:extLst xmlns:a="http://schemas.openxmlformats.org/drawingml/2006/main">
               <a:ext uri="{FF2B5EF4-FFF2-40B4-BE49-F238E27FC236}">
-                <a16:creationId xmlns:a16="http://schemas.microsoft.com/office/drawing/2014/main" id="{FB90259C-A5C9-4D8D-86BC-1A36F0DBBA11}"/>
+                <a16:creationId xmlns:a16="http://schemas.microsoft.com/office/drawing/2014/main" id="{8FFA1D4D-9686-49DB-BA64-4BA77C5965D1}"/>
               </a:ext>
             </a:extLst>
           </p:cNvPr>
@@ -22812,7 +22812,7 @@
                 <a:ea typeface="Aptos"/>
                 <a:cs typeface="Aptos"/>
               </a:rPr>
-              <a:t>Independent public evidence summary · 2026.07.23-11 · 2026-07-22 · Sources: Evidence Register</a:t>
+              <a:t>Independent public evidence summary · 2026.07.23-12 · 2026-07-22 · Sources: Evidence Register</a:t>
             </a:r>
           </a:p>
         </p:txBody>
@@ -22822,7 +22822,7 @@
           <p:cNvPr id="7" name="TextBox 6">
             <a:extLst xmlns:a="http://schemas.openxmlformats.org/drawingml/2006/main">
               <a:ext uri="{FF2B5EF4-FFF2-40B4-BE49-F238E27FC236}">
-                <a16:creationId xmlns:a16="http://schemas.microsoft.com/office/drawing/2014/main" id="{73A052AA-EB64-4C55-B407-2292A4DC13FA}"/>
+                <a16:creationId xmlns:a16="http://schemas.microsoft.com/office/drawing/2014/main" id="{DF252368-E82B-4523-8D94-5E1862D4AFC7}"/>
               </a:ext>
             </a:extLst>
           </p:cNvPr>
@@ -23392,7 +23392,7 @@
           <p:cNvPr id="9" name="TextBox 8">
             <a:extLst xmlns:a="http://schemas.openxmlformats.org/drawingml/2006/main">
               <a:ext uri="{FF2B5EF4-FFF2-40B4-BE49-F238E27FC236}">
-                <a16:creationId xmlns:a16="http://schemas.microsoft.com/office/drawing/2014/main" id="{360ED1FA-7D74-47A3-B0BF-B853CD415B36}"/>
+                <a16:creationId xmlns:a16="http://schemas.microsoft.com/office/drawing/2014/main" id="{F362111B-1ECB-48FD-A1E3-B8B9B740046D}"/>
               </a:ext>
             </a:extLst>
           </p:cNvPr>
@@ -23437,7 +23437,7 @@
     </p:spTree>
     <p:extLst>
       <p:ext uri="{BB962C8B-B14F-4D97-AF65-F5344CB8AC3E}">
-        <p14:creationId xmlns:p14="http://schemas.microsoft.com/office/powerpoint/2010/main" val="598218843"/>
+        <p14:creationId xmlns:p14="http://schemas.microsoft.com/office/powerpoint/2010/main" val="184405048"/>
       </p:ext>
     </p:extLst>
   </p:cSld>
@@ -23461,7 +23461,7 @@
           <p:cNvPr id="2" name="TextBox 1">
             <a:extLst xmlns:a="http://schemas.openxmlformats.org/drawingml/2006/main">
               <a:ext uri="{FF2B5EF4-FFF2-40B4-BE49-F238E27FC236}">
-                <a16:creationId xmlns:a16="http://schemas.microsoft.com/office/drawing/2014/main" id="{8194FAA6-CDE9-437A-AD2D-CE53D72F739A}"/>
+                <a16:creationId xmlns:a16="http://schemas.microsoft.com/office/drawing/2014/main" id="{41915E1A-DBB8-4DAC-8E05-1F53611F2B0D}"/>
               </a:ext>
             </a:extLst>
           </p:cNvPr>
@@ -23508,7 +23508,7 @@
           <p:cNvPr id="3" name="TextBox 2">
             <a:extLst xmlns:a="http://schemas.openxmlformats.org/drawingml/2006/main">
               <a:ext uri="{FF2B5EF4-FFF2-40B4-BE49-F238E27FC236}">
-                <a16:creationId xmlns:a16="http://schemas.microsoft.com/office/drawing/2014/main" id="{5E4E969B-48EF-47E8-B3B3-C617465786F8}"/>
+                <a16:creationId xmlns:a16="http://schemas.microsoft.com/office/drawing/2014/main" id="{F7217DBE-22BD-4E6F-ADBE-3C19A8B168F7}"/>
               </a:ext>
             </a:extLst>
           </p:cNvPr>
@@ -23555,7 +23555,7 @@
           <p:cNvPr id="4" name="Rectangle 3">
             <a:extLst xmlns:a="http://schemas.openxmlformats.org/drawingml/2006/main">
               <a:ext uri="{FF2B5EF4-FFF2-40B4-BE49-F238E27FC236}">
-                <a16:creationId xmlns:a16="http://schemas.microsoft.com/office/drawing/2014/main" id="{A19E5853-8C19-4DD2-9201-A54773D5FF4E}"/>
+                <a16:creationId xmlns:a16="http://schemas.microsoft.com/office/drawing/2014/main" id="{82337E75-A5E0-4EC8-9943-BA4A70C1B8AC}"/>
               </a:ext>
             </a:extLst>
           </p:cNvPr>
@@ -23610,7 +23610,7 @@
           <p:cNvPr id="5" name="Rectangle 4">
             <a:extLst xmlns:a="http://schemas.openxmlformats.org/drawingml/2006/main">
               <a:ext uri="{FF2B5EF4-FFF2-40B4-BE49-F238E27FC236}">
-                <a16:creationId xmlns:a16="http://schemas.microsoft.com/office/drawing/2014/main" id="{F4490E17-BFC1-44F7-8A0B-68CAD50762EE}"/>
+                <a16:creationId xmlns:a16="http://schemas.microsoft.com/office/drawing/2014/main" id="{8668A4FE-FC81-4EAD-9542-327E9D7740AC}"/>
               </a:ext>
             </a:extLst>
           </p:cNvPr>
@@ -23665,7 +23665,7 @@
           <p:cNvPr id="6" name="TextBox 5">
             <a:extLst xmlns:a="http://schemas.openxmlformats.org/drawingml/2006/main">
               <a:ext uri="{FF2B5EF4-FFF2-40B4-BE49-F238E27FC236}">
-                <a16:creationId xmlns:a16="http://schemas.microsoft.com/office/drawing/2014/main" id="{26ACB488-9851-4B98-8E6F-30BAD92F2C78}"/>
+                <a16:creationId xmlns:a16="http://schemas.microsoft.com/office/drawing/2014/main" id="{BB054597-ADE6-4987-A7B0-F0ED7F1B2247}"/>
               </a:ext>
             </a:extLst>
           </p:cNvPr>
@@ -23702,7 +23702,7 @@
                 <a:ea typeface="Aptos"/>
                 <a:cs typeface="Aptos"/>
               </a:rPr>
-              <a:t>Independent public evidence summary · 2026.07.23-11 · 2026-07-22 · Sources: Evidence Register</a:t>
+              <a:t>Independent public evidence summary · 2026.07.23-12 · 2026-07-22 · Sources: Evidence Register</a:t>
             </a:r>
           </a:p>
         </p:txBody>
@@ -23712,7 +23712,7 @@
           <p:cNvPr id="7" name="TextBox 6">
             <a:extLst xmlns:a="http://schemas.openxmlformats.org/drawingml/2006/main">
               <a:ext uri="{FF2B5EF4-FFF2-40B4-BE49-F238E27FC236}">
-                <a16:creationId xmlns:a16="http://schemas.microsoft.com/office/drawing/2014/main" id="{A63AF13E-BB96-4067-A2C7-D04B8C49BAB7}"/>
+                <a16:creationId xmlns:a16="http://schemas.microsoft.com/office/drawing/2014/main" id="{2DAF343E-AB58-47C8-9CA6-AA33482F2608}"/>
               </a:ext>
             </a:extLst>
           </p:cNvPr>
@@ -24365,7 +24365,7 @@
           <p:cNvPr id="9" name="TextBox 8">
             <a:extLst xmlns:a="http://schemas.openxmlformats.org/drawingml/2006/main">
               <a:ext uri="{FF2B5EF4-FFF2-40B4-BE49-F238E27FC236}">
-                <a16:creationId xmlns:a16="http://schemas.microsoft.com/office/drawing/2014/main" id="{8D7D8610-6640-4EAB-A08E-0B9DC47C467F}"/>
+                <a16:creationId xmlns:a16="http://schemas.microsoft.com/office/drawing/2014/main" id="{BCD423B1-A063-4FB0-82D6-F827957DCA8E}"/>
               </a:ext>
             </a:extLst>
           </p:cNvPr>
@@ -24410,7 +24410,7 @@
     </p:spTree>
     <p:extLst>
       <p:ext uri="{BB962C8B-B14F-4D97-AF65-F5344CB8AC3E}">
-        <p14:creationId xmlns:p14="http://schemas.microsoft.com/office/powerpoint/2010/main" val="1832772191"/>
+        <p14:creationId xmlns:p14="http://schemas.microsoft.com/office/powerpoint/2010/main" val="1275388162"/>
       </p:ext>
     </p:extLst>
   </p:cSld>
@@ -24434,7 +24434,7 @@
           <p:cNvPr id="2" name="TextBox 1">
             <a:extLst xmlns:a="http://schemas.openxmlformats.org/drawingml/2006/main">
               <a:ext uri="{FF2B5EF4-FFF2-40B4-BE49-F238E27FC236}">
-                <a16:creationId xmlns:a16="http://schemas.microsoft.com/office/drawing/2014/main" id="{A59B6270-A65D-4008-86E8-0EE34DBC9704}"/>
+                <a16:creationId xmlns:a16="http://schemas.microsoft.com/office/drawing/2014/main" id="{E029EFBD-57BD-464E-9DF1-F1CB50C12D0E}"/>
               </a:ext>
             </a:extLst>
           </p:cNvPr>
@@ -24481,7 +24481,7 @@
           <p:cNvPr id="3" name="TextBox 2">
             <a:extLst xmlns:a="http://schemas.openxmlformats.org/drawingml/2006/main">
               <a:ext uri="{FF2B5EF4-FFF2-40B4-BE49-F238E27FC236}">
-                <a16:creationId xmlns:a16="http://schemas.microsoft.com/office/drawing/2014/main" id="{A80BBAA0-0473-4E5B-A7F9-88F055BD88BA}"/>
+                <a16:creationId xmlns:a16="http://schemas.microsoft.com/office/drawing/2014/main" id="{936F1C02-0C7A-4C38-83E0-6EAF6F98CB9E}"/>
               </a:ext>
             </a:extLst>
           </p:cNvPr>
@@ -24528,7 +24528,7 @@
           <p:cNvPr id="4" name="Rectangle 3">
             <a:extLst xmlns:a="http://schemas.openxmlformats.org/drawingml/2006/main">
               <a:ext uri="{FF2B5EF4-FFF2-40B4-BE49-F238E27FC236}">
-                <a16:creationId xmlns:a16="http://schemas.microsoft.com/office/drawing/2014/main" id="{E428E60E-8F56-4445-94B4-F111550B7568}"/>
+                <a16:creationId xmlns:a16="http://schemas.microsoft.com/office/drawing/2014/main" id="{26D9FDC9-11E6-4A1A-B5B4-1EFBABBFBB21}"/>
               </a:ext>
             </a:extLst>
           </p:cNvPr>
@@ -24583,7 +24583,7 @@
           <p:cNvPr id="5" name="Rectangle 4">
             <a:extLst xmlns:a="http://schemas.openxmlformats.org/drawingml/2006/main">
               <a:ext uri="{FF2B5EF4-FFF2-40B4-BE49-F238E27FC236}">
-                <a16:creationId xmlns:a16="http://schemas.microsoft.com/office/drawing/2014/main" id="{F2F992AF-41CA-4F3A-A725-C20BB2355090}"/>
+                <a16:creationId xmlns:a16="http://schemas.microsoft.com/office/drawing/2014/main" id="{D584DB99-049F-447D-8489-6D3C3E6A930C}"/>
               </a:ext>
             </a:extLst>
           </p:cNvPr>
@@ -24638,7 +24638,7 @@
           <p:cNvPr id="6" name="TextBox 5">
             <a:extLst xmlns:a="http://schemas.openxmlformats.org/drawingml/2006/main">
               <a:ext uri="{FF2B5EF4-FFF2-40B4-BE49-F238E27FC236}">
-                <a16:creationId xmlns:a16="http://schemas.microsoft.com/office/drawing/2014/main" id="{B75877EA-B467-4E5C-8409-614ACAD27207}"/>
+                <a16:creationId xmlns:a16="http://schemas.microsoft.com/office/drawing/2014/main" id="{7246FF7E-9D91-4EA1-A256-F62DD863134C}"/>
               </a:ext>
             </a:extLst>
           </p:cNvPr>
@@ -24675,7 +24675,7 @@
                 <a:ea typeface="Aptos"/>
                 <a:cs typeface="Aptos"/>
               </a:rPr>
-              <a:t>Independent public evidence summary · 2026.07.23-11 · 2026-07-22 · Sources: Evidence Register; changelog</a:t>
+              <a:t>Independent public evidence summary · 2026.07.23-12 · 2026-07-22 · Sources: Evidence Register; changelog</a:t>
             </a:r>
           </a:p>
         </p:txBody>
@@ -24685,7 +24685,7 @@
           <p:cNvPr id="7" name="TextBox 6">
             <a:extLst xmlns:a="http://schemas.openxmlformats.org/drawingml/2006/main">
               <a:ext uri="{FF2B5EF4-FFF2-40B4-BE49-F238E27FC236}">
-                <a16:creationId xmlns:a16="http://schemas.microsoft.com/office/drawing/2014/main" id="{EF3A7EBF-39EE-40F5-A4E0-5802DD0751F6}"/>
+                <a16:creationId xmlns:a16="http://schemas.microsoft.com/office/drawing/2014/main" id="{40A20653-5C19-485D-998D-DA46CCFBD058}"/>
               </a:ext>
             </a:extLst>
           </p:cNvPr>
@@ -24732,7 +24732,7 @@
           <p:cNvPr id="8" name="Rounded Rectangle 7">
             <a:extLst xmlns:a="http://schemas.openxmlformats.org/drawingml/2006/main">
               <a:ext uri="{FF2B5EF4-FFF2-40B4-BE49-F238E27FC236}">
-                <a16:creationId xmlns:a16="http://schemas.microsoft.com/office/drawing/2014/main" id="{395BD401-6BF7-4DBC-818D-A5515042431F}"/>
+                <a16:creationId xmlns:a16="http://schemas.microsoft.com/office/drawing/2014/main" id="{5BC29E40-0191-4C7B-BC36-977992433D17}"/>
               </a:ext>
             </a:extLst>
           </p:cNvPr>
@@ -24789,7 +24789,7 @@
           <p:cNvPr id="9" name="TextBox 8">
             <a:extLst xmlns:a="http://schemas.openxmlformats.org/drawingml/2006/main">
               <a:ext uri="{FF2B5EF4-FFF2-40B4-BE49-F238E27FC236}">
-                <a16:creationId xmlns:a16="http://schemas.microsoft.com/office/drawing/2014/main" id="{F88DF643-BB1E-458B-9C24-4413EC1EEC71}"/>
+                <a16:creationId xmlns:a16="http://schemas.microsoft.com/office/drawing/2014/main" id="{2FD19054-E2CA-45B8-BA53-AF2CE18D527A}"/>
               </a:ext>
             </a:extLst>
           </p:cNvPr>
@@ -24836,7 +24836,7 @@
           <p:cNvPr id="10" name="TextBox 9">
             <a:extLst xmlns:a="http://schemas.openxmlformats.org/drawingml/2006/main">
               <a:ext uri="{FF2B5EF4-FFF2-40B4-BE49-F238E27FC236}">
-                <a16:creationId xmlns:a16="http://schemas.microsoft.com/office/drawing/2014/main" id="{C62B2C4D-9340-4EEB-9925-9C2A74818109}"/>
+                <a16:creationId xmlns:a16="http://schemas.microsoft.com/office/drawing/2014/main" id="{0F2EF49C-570B-45F9-B29E-A62F2E74819E}"/>
               </a:ext>
             </a:extLst>
           </p:cNvPr>
@@ -24883,7 +24883,7 @@
           <p:cNvPr id="11" name="TextBox 10">
             <a:extLst xmlns:a="http://schemas.openxmlformats.org/drawingml/2006/main">
               <a:ext uri="{FF2B5EF4-FFF2-40B4-BE49-F238E27FC236}">
-                <a16:creationId xmlns:a16="http://schemas.microsoft.com/office/drawing/2014/main" id="{BDC2F6E7-E0F4-4493-88CF-0B16B0716793}"/>
+                <a16:creationId xmlns:a16="http://schemas.microsoft.com/office/drawing/2014/main" id="{1A601A18-BE28-48B4-8712-2B97E13AC805}"/>
               </a:ext>
             </a:extLst>
           </p:cNvPr>
@@ -24930,7 +24930,7 @@
           <p:cNvPr id="12" name="Rounded Rectangle 11">
             <a:extLst xmlns:a="http://schemas.openxmlformats.org/drawingml/2006/main">
               <a:ext uri="{FF2B5EF4-FFF2-40B4-BE49-F238E27FC236}">
-                <a16:creationId xmlns:a16="http://schemas.microsoft.com/office/drawing/2014/main" id="{00315D0B-7D07-4F8D-B5BB-23D9D5FED1AA}"/>
+                <a16:creationId xmlns:a16="http://schemas.microsoft.com/office/drawing/2014/main" id="{A7867A77-A788-45BE-93DC-D847973A676E}"/>
               </a:ext>
             </a:extLst>
           </p:cNvPr>
@@ -24987,7 +24987,7 @@
           <p:cNvPr id="13" name="TextBox 12">
             <a:extLst xmlns:a="http://schemas.openxmlformats.org/drawingml/2006/main">
               <a:ext uri="{FF2B5EF4-FFF2-40B4-BE49-F238E27FC236}">
-                <a16:creationId xmlns:a16="http://schemas.microsoft.com/office/drawing/2014/main" id="{B4597F82-5BA3-4E8F-B84F-DBDDEE6D617F}"/>
+                <a16:creationId xmlns:a16="http://schemas.microsoft.com/office/drawing/2014/main" id="{114C5778-EE14-449B-BEEA-D32DEE94F009}"/>
               </a:ext>
             </a:extLst>
           </p:cNvPr>
@@ -25034,7 +25034,7 @@
           <p:cNvPr id="14" name="TextBox 13">
             <a:extLst xmlns:a="http://schemas.openxmlformats.org/drawingml/2006/main">
               <a:ext uri="{FF2B5EF4-FFF2-40B4-BE49-F238E27FC236}">
-                <a16:creationId xmlns:a16="http://schemas.microsoft.com/office/drawing/2014/main" id="{3646E6A2-C3AD-48CF-A8E7-62C0B211E182}"/>
+                <a16:creationId xmlns:a16="http://schemas.microsoft.com/office/drawing/2014/main" id="{CD175EBF-F119-4ACD-B82C-AB9088FEB3B4}"/>
               </a:ext>
             </a:extLst>
           </p:cNvPr>
@@ -25081,7 +25081,7 @@
           <p:cNvPr id="15" name="TextBox 14">
             <a:extLst xmlns:a="http://schemas.openxmlformats.org/drawingml/2006/main">
               <a:ext uri="{FF2B5EF4-FFF2-40B4-BE49-F238E27FC236}">
-                <a16:creationId xmlns:a16="http://schemas.microsoft.com/office/drawing/2014/main" id="{0B86C2C6-5EA0-4394-9994-68AAE5F73141}"/>
+                <a16:creationId xmlns:a16="http://schemas.microsoft.com/office/drawing/2014/main" id="{CA7E4D0D-E8B6-45B7-A8C0-173B4811B3DA}"/>
               </a:ext>
             </a:extLst>
           </p:cNvPr>
@@ -25128,7 +25128,7 @@
           <p:cNvPr id="16" name="Rounded Rectangle 15">
             <a:extLst xmlns:a="http://schemas.openxmlformats.org/drawingml/2006/main">
               <a:ext uri="{FF2B5EF4-FFF2-40B4-BE49-F238E27FC236}">
-                <a16:creationId xmlns:a16="http://schemas.microsoft.com/office/drawing/2014/main" id="{D3D48DBF-59B0-4145-9566-F0BB7FFFEFEF}"/>
+                <a16:creationId xmlns:a16="http://schemas.microsoft.com/office/drawing/2014/main" id="{57D32403-1490-4590-B570-DECE2B7DFABD}"/>
               </a:ext>
             </a:extLst>
           </p:cNvPr>
@@ -25185,7 +25185,7 @@
           <p:cNvPr id="17" name="TextBox 16">
             <a:extLst xmlns:a="http://schemas.openxmlformats.org/drawingml/2006/main">
               <a:ext uri="{FF2B5EF4-FFF2-40B4-BE49-F238E27FC236}">
-                <a16:creationId xmlns:a16="http://schemas.microsoft.com/office/drawing/2014/main" id="{DD56108B-4AC3-4F2C-8693-F779BC10DBFC}"/>
+                <a16:creationId xmlns:a16="http://schemas.microsoft.com/office/drawing/2014/main" id="{D7A8F07C-A65D-4BD3-AFC5-D1A2DE288565}"/>
               </a:ext>
             </a:extLst>
           </p:cNvPr>
@@ -25232,7 +25232,7 @@
           <p:cNvPr id="18" name="TextBox 17">
             <a:extLst xmlns:a="http://schemas.openxmlformats.org/drawingml/2006/main">
               <a:ext uri="{FF2B5EF4-FFF2-40B4-BE49-F238E27FC236}">
-                <a16:creationId xmlns:a16="http://schemas.microsoft.com/office/drawing/2014/main" id="{DA17D484-E617-4AFE-938F-EB0DD8AA3A31}"/>
+                <a16:creationId xmlns:a16="http://schemas.microsoft.com/office/drawing/2014/main" id="{8AD4FED9-D076-4145-8B47-AE72394739C4}"/>
               </a:ext>
             </a:extLst>
           </p:cNvPr>
@@ -25279,7 +25279,7 @@
           <p:cNvPr id="19" name="TextBox 18">
             <a:extLst xmlns:a="http://schemas.openxmlformats.org/drawingml/2006/main">
               <a:ext uri="{FF2B5EF4-FFF2-40B4-BE49-F238E27FC236}">
-                <a16:creationId xmlns:a16="http://schemas.microsoft.com/office/drawing/2014/main" id="{BDEFE6E8-29A4-4C34-9EC6-3B977BB46322}"/>
+                <a16:creationId xmlns:a16="http://schemas.microsoft.com/office/drawing/2014/main" id="{99A0F72F-AA6A-4B06-9081-306065A921CC}"/>
               </a:ext>
             </a:extLst>
           </p:cNvPr>
@@ -25326,7 +25326,7 @@
           <p:cNvPr id="20" name="Rounded Rectangle 19">
             <a:extLst xmlns:a="http://schemas.openxmlformats.org/drawingml/2006/main">
               <a:ext uri="{FF2B5EF4-FFF2-40B4-BE49-F238E27FC236}">
-                <a16:creationId xmlns:a16="http://schemas.microsoft.com/office/drawing/2014/main" id="{8CE8FD36-8F64-4C9C-AE1B-020B9D8AAA0D}"/>
+                <a16:creationId xmlns:a16="http://schemas.microsoft.com/office/drawing/2014/main" id="{CECD132F-6E1A-41E4-9847-622524CA0ABF}"/>
               </a:ext>
             </a:extLst>
           </p:cNvPr>
@@ -25383,7 +25383,7 @@
           <p:cNvPr id="21" name="TextBox 20">
             <a:extLst xmlns:a="http://schemas.openxmlformats.org/drawingml/2006/main">
               <a:ext uri="{FF2B5EF4-FFF2-40B4-BE49-F238E27FC236}">
-                <a16:creationId xmlns:a16="http://schemas.microsoft.com/office/drawing/2014/main" id="{D85E8CB7-0949-40C5-940E-AE9DCE9FC6D6}"/>
+                <a16:creationId xmlns:a16="http://schemas.microsoft.com/office/drawing/2014/main" id="{A6F7B3B8-6583-41B2-9849-8EA68DD3C248}"/>
               </a:ext>
             </a:extLst>
           </p:cNvPr>
@@ -25430,7 +25430,7 @@
           <p:cNvPr id="22" name="TextBox 21">
             <a:extLst xmlns:a="http://schemas.openxmlformats.org/drawingml/2006/main">
               <a:ext uri="{FF2B5EF4-FFF2-40B4-BE49-F238E27FC236}">
-                <a16:creationId xmlns:a16="http://schemas.microsoft.com/office/drawing/2014/main" id="{14B56330-1A7E-42FD-BD76-FF9BBE12AF53}"/>
+                <a16:creationId xmlns:a16="http://schemas.microsoft.com/office/drawing/2014/main" id="{66F6F93C-B989-4AB7-8BDD-6A17E84A5561}"/>
               </a:ext>
             </a:extLst>
           </p:cNvPr>
@@ -25477,7 +25477,7 @@
           <p:cNvPr id="23" name="TextBox 22">
             <a:extLst xmlns:a="http://schemas.openxmlformats.org/drawingml/2006/main">
               <a:ext uri="{FF2B5EF4-FFF2-40B4-BE49-F238E27FC236}">
-                <a16:creationId xmlns:a16="http://schemas.microsoft.com/office/drawing/2014/main" id="{7183EFBF-514E-41E7-9438-DC8F463BEAF0}"/>
+                <a16:creationId xmlns:a16="http://schemas.microsoft.com/office/drawing/2014/main" id="{E8CC6C31-4138-439F-B7D7-9B329FCB0F04}"/>
               </a:ext>
             </a:extLst>
           </p:cNvPr>
@@ -25524,7 +25524,7 @@
           <p:cNvPr id="24" name="TextBox 23">
             <a:extLst xmlns:a="http://schemas.openxmlformats.org/drawingml/2006/main">
               <a:ext uri="{FF2B5EF4-FFF2-40B4-BE49-F238E27FC236}">
-                <a16:creationId xmlns:a16="http://schemas.microsoft.com/office/drawing/2014/main" id="{AC74D571-2963-4D2F-B7B2-3165593DAD27}"/>
+                <a16:creationId xmlns:a16="http://schemas.microsoft.com/office/drawing/2014/main" id="{191B7668-0003-4268-95DF-A7DED462ED72}"/>
               </a:ext>
             </a:extLst>
           </p:cNvPr>
@@ -25569,7 +25569,7 @@
     </p:spTree>
     <p:extLst>
       <p:ext uri="{BB962C8B-B14F-4D97-AF65-F5344CB8AC3E}">
-        <p14:creationId xmlns:p14="http://schemas.microsoft.com/office/powerpoint/2010/main" val="614676180"/>
+        <p14:creationId xmlns:p14="http://schemas.microsoft.com/office/powerpoint/2010/main" val="1793769815"/>
       </p:ext>
     </p:extLst>
   </p:cSld>
@@ -25593,7 +25593,7 @@
           <p:cNvPr id="2" name="TextBox 1">
             <a:extLst xmlns:a="http://schemas.openxmlformats.org/drawingml/2006/main">
               <a:ext uri="{FF2B5EF4-FFF2-40B4-BE49-F238E27FC236}">
-                <a16:creationId xmlns:a16="http://schemas.microsoft.com/office/drawing/2014/main" id="{78760961-E911-4AF3-B277-45EC35685D2B}"/>
+                <a16:creationId xmlns:a16="http://schemas.microsoft.com/office/drawing/2014/main" id="{BC909E00-B0A6-4324-BA6A-9F628E580988}"/>
               </a:ext>
             </a:extLst>
           </p:cNvPr>
@@ -25640,7 +25640,7 @@
           <p:cNvPr id="3" name="TextBox 2">
             <a:extLst xmlns:a="http://schemas.openxmlformats.org/drawingml/2006/main">
               <a:ext uri="{FF2B5EF4-FFF2-40B4-BE49-F238E27FC236}">
-                <a16:creationId xmlns:a16="http://schemas.microsoft.com/office/drawing/2014/main" id="{61D8D4A6-D7AD-42FA-9E0E-59196D5A29B4}"/>
+                <a16:creationId xmlns:a16="http://schemas.microsoft.com/office/drawing/2014/main" id="{0FDE2F91-72FD-4437-BD56-1E3DD66A9B05}"/>
               </a:ext>
             </a:extLst>
           </p:cNvPr>
@@ -25687,7 +25687,7 @@
           <p:cNvPr id="4" name="Rectangle 3">
             <a:extLst xmlns:a="http://schemas.openxmlformats.org/drawingml/2006/main">
               <a:ext uri="{FF2B5EF4-FFF2-40B4-BE49-F238E27FC236}">
-                <a16:creationId xmlns:a16="http://schemas.microsoft.com/office/drawing/2014/main" id="{FFE82029-48AC-4598-9EA2-2814FF94B2DA}"/>
+                <a16:creationId xmlns:a16="http://schemas.microsoft.com/office/drawing/2014/main" id="{80724439-6D8F-4524-8926-AB3755E0B37C}"/>
               </a:ext>
             </a:extLst>
           </p:cNvPr>
@@ -25742,7 +25742,7 @@
           <p:cNvPr id="5" name="Rectangle 4">
             <a:extLst xmlns:a="http://schemas.openxmlformats.org/drawingml/2006/main">
               <a:ext uri="{FF2B5EF4-FFF2-40B4-BE49-F238E27FC236}">
-                <a16:creationId xmlns:a16="http://schemas.microsoft.com/office/drawing/2014/main" id="{2F8F74DF-EE62-4A45-81C1-EE80FC9DF169}"/>
+                <a16:creationId xmlns:a16="http://schemas.microsoft.com/office/drawing/2014/main" id="{171FC370-3C2A-4AFD-86F1-DFCBA5FDDADF}"/>
               </a:ext>
             </a:extLst>
           </p:cNvPr>
@@ -25797,7 +25797,7 @@
           <p:cNvPr id="6" name="TextBox 5">
             <a:extLst xmlns:a="http://schemas.openxmlformats.org/drawingml/2006/main">
               <a:ext uri="{FF2B5EF4-FFF2-40B4-BE49-F238E27FC236}">
-                <a16:creationId xmlns:a16="http://schemas.microsoft.com/office/drawing/2014/main" id="{7004082C-EFED-41E7-B0DF-EA1D0460DE38}"/>
+                <a16:creationId xmlns:a16="http://schemas.microsoft.com/office/drawing/2014/main" id="{DF900256-F058-4A15-8695-FA520F0EB903}"/>
               </a:ext>
             </a:extLst>
           </p:cNvPr>
@@ -25834,7 +25834,7 @@
                 <a:ea typeface="Aptos"/>
                 <a:cs typeface="Aptos"/>
               </a:rPr>
-              <a:t>Independent public evidence summary · 2026.07.23-11 · 2026-07-22 · Sources: EPO; 8 Ni 18/24 (EP); 7 O 3341/24</a:t>
+              <a:t>Independent public evidence summary · 2026.07.23-12 · 2026-07-22 · Sources: EPO; 8 Ni 18/24 (EP); 7 O 3341/24</a:t>
             </a:r>
           </a:p>
         </p:txBody>
@@ -25844,7 +25844,7 @@
           <p:cNvPr id="7" name="TextBox 6">
             <a:extLst xmlns:a="http://schemas.openxmlformats.org/drawingml/2006/main">
               <a:ext uri="{FF2B5EF4-FFF2-40B4-BE49-F238E27FC236}">
-                <a16:creationId xmlns:a16="http://schemas.microsoft.com/office/drawing/2014/main" id="{274F9216-553B-4698-AB29-36700FDB5984}"/>
+                <a16:creationId xmlns:a16="http://schemas.microsoft.com/office/drawing/2014/main" id="{6ACFF603-A09B-43F8-8DE1-799ACDC6FD2C}"/>
               </a:ext>
             </a:extLst>
           </p:cNvPr>
@@ -26248,7 +26248,7 @@
           <p:cNvPr id="9" name="TextBox 8">
             <a:extLst xmlns:a="http://schemas.openxmlformats.org/drawingml/2006/main">
               <a:ext uri="{FF2B5EF4-FFF2-40B4-BE49-F238E27FC236}">
-                <a16:creationId xmlns:a16="http://schemas.microsoft.com/office/drawing/2014/main" id="{0787AD0B-87EE-4E2D-99F8-4DAE4388472F}"/>
+                <a16:creationId xmlns:a16="http://schemas.microsoft.com/office/drawing/2014/main" id="{99E2B904-2722-4C1D-A7A8-64DA63CFFCD1}"/>
               </a:ext>
             </a:extLst>
           </p:cNvPr>
@@ -26293,7 +26293,7 @@
     </p:spTree>
     <p:extLst>
       <p:ext uri="{BB962C8B-B14F-4D97-AF65-F5344CB8AC3E}">
-        <p14:creationId xmlns:p14="http://schemas.microsoft.com/office/powerpoint/2010/main" val="1571552174"/>
+        <p14:creationId xmlns:p14="http://schemas.microsoft.com/office/powerpoint/2010/main" val="1530264729"/>
       </p:ext>
     </p:extLst>
   </p:cSld>
@@ -26324,7 +26324,7 @@
           <p:cNvPr id="2" name="TextBox 1">
             <a:extLst xmlns:a="http://schemas.openxmlformats.org/drawingml/2006/main">
               <a:ext uri="{FF2B5EF4-FFF2-40B4-BE49-F238E27FC236}">
-                <a16:creationId xmlns:a16="http://schemas.microsoft.com/office/drawing/2014/main" id="{3A005910-8C16-4E24-AFDF-ED81E1C5CCF9}"/>
+                <a16:creationId xmlns:a16="http://schemas.microsoft.com/office/drawing/2014/main" id="{AD0E2F19-B4FB-40CD-A0C9-3FB742DC96F7}"/>
               </a:ext>
             </a:extLst>
           </p:cNvPr>
@@ -26371,7 +26371,7 @@
           <p:cNvPr id="3" name="TextBox 2">
             <a:extLst xmlns:a="http://schemas.openxmlformats.org/drawingml/2006/main">
               <a:ext uri="{FF2B5EF4-FFF2-40B4-BE49-F238E27FC236}">
-                <a16:creationId xmlns:a16="http://schemas.microsoft.com/office/drawing/2014/main" id="{209A8C62-2AA7-469C-9940-88570A605096}"/>
+                <a16:creationId xmlns:a16="http://schemas.microsoft.com/office/drawing/2014/main" id="{CE25A6AE-87FB-447C-962B-80B69344D4EF}"/>
               </a:ext>
             </a:extLst>
           </p:cNvPr>
@@ -26418,7 +26418,7 @@
           <p:cNvPr id="4" name="TextBox 3">
             <a:extLst xmlns:a="http://schemas.openxmlformats.org/drawingml/2006/main">
               <a:ext uri="{FF2B5EF4-FFF2-40B4-BE49-F238E27FC236}">
-                <a16:creationId xmlns:a16="http://schemas.microsoft.com/office/drawing/2014/main" id="{28C98103-4746-4F41-B8CD-076EDA58D87E}"/>
+                <a16:creationId xmlns:a16="http://schemas.microsoft.com/office/drawing/2014/main" id="{E45CEA02-A101-4356-86DB-00F26B5FB24F}"/>
               </a:ext>
             </a:extLst>
           </p:cNvPr>
@@ -26537,7 +26537,7 @@
           <p:cNvPr id="5" name="TextBox 4">
             <a:extLst xmlns:a="http://schemas.openxmlformats.org/drawingml/2006/main">
               <a:ext uri="{FF2B5EF4-FFF2-40B4-BE49-F238E27FC236}">
-                <a16:creationId xmlns:a16="http://schemas.microsoft.com/office/drawing/2014/main" id="{FEE95406-293C-4CBA-A777-AA4551D3EE16}"/>
+                <a16:creationId xmlns:a16="http://schemas.microsoft.com/office/drawing/2014/main" id="{D8F38668-4194-4C03-8AA5-8E9900D1C78E}"/>
               </a:ext>
             </a:extLst>
           </p:cNvPr>
@@ -26574,7 +26574,7 @@
                 <a:ea typeface="Aptos"/>
                 <a:cs typeface="Aptos"/>
               </a:rPr>
-              <a:t>Version 2026.07.23-11 · 2026-07-22 · 30 / 30</a:t>
+              <a:t>Version 2026.07.23-12 · 2026-07-22 · 30 / 30</a:t>
             </a:r>
           </a:p>
         </p:txBody>
@@ -26582,7 +26582,7 @@
     </p:spTree>
     <p:extLst>
       <p:ext uri="{BB962C8B-B14F-4D97-AF65-F5344CB8AC3E}">
-        <p14:creationId xmlns:p14="http://schemas.microsoft.com/office/powerpoint/2010/main" val="422308769"/>
+        <p14:creationId xmlns:p14="http://schemas.microsoft.com/office/powerpoint/2010/main" val="512281456"/>
       </p:ext>
     </p:extLst>
   </p:cSld>
@@ -26606,7 +26606,7 @@
           <p:cNvPr id="2" name="TextBox 1">
             <a:extLst xmlns:a="http://schemas.openxmlformats.org/drawingml/2006/main">
               <a:ext uri="{FF2B5EF4-FFF2-40B4-BE49-F238E27FC236}">
-                <a16:creationId xmlns:a16="http://schemas.microsoft.com/office/drawing/2014/main" id="{4E635081-7A0D-4278-B4B8-70DD0C765518}"/>
+                <a16:creationId xmlns:a16="http://schemas.microsoft.com/office/drawing/2014/main" id="{91783EE8-D44E-4516-B0B5-48BE4D8D8004}"/>
               </a:ext>
             </a:extLst>
           </p:cNvPr>
@@ -26653,7 +26653,7 @@
           <p:cNvPr id="3" name="TextBox 2">
             <a:extLst xmlns:a="http://schemas.openxmlformats.org/drawingml/2006/main">
               <a:ext uri="{FF2B5EF4-FFF2-40B4-BE49-F238E27FC236}">
-                <a16:creationId xmlns:a16="http://schemas.microsoft.com/office/drawing/2014/main" id="{79885DA3-AD3D-4AF5-B7EA-E8BF2A8BE215}"/>
+                <a16:creationId xmlns:a16="http://schemas.microsoft.com/office/drawing/2014/main" id="{92720D15-7846-4FC1-AADB-E239575D1E32}"/>
               </a:ext>
             </a:extLst>
           </p:cNvPr>
@@ -26700,7 +26700,7 @@
           <p:cNvPr id="4" name="Rectangle 3">
             <a:extLst xmlns:a="http://schemas.openxmlformats.org/drawingml/2006/main">
               <a:ext uri="{FF2B5EF4-FFF2-40B4-BE49-F238E27FC236}">
-                <a16:creationId xmlns:a16="http://schemas.microsoft.com/office/drawing/2014/main" id="{60CB3F49-F142-4BEB-A24C-89BBD3DFA588}"/>
+                <a16:creationId xmlns:a16="http://schemas.microsoft.com/office/drawing/2014/main" id="{C4166E60-E209-4305-AF06-081AD299F655}"/>
               </a:ext>
             </a:extLst>
           </p:cNvPr>
@@ -26755,7 +26755,7 @@
           <p:cNvPr id="5" name="Rectangle 4">
             <a:extLst xmlns:a="http://schemas.openxmlformats.org/drawingml/2006/main">
               <a:ext uri="{FF2B5EF4-FFF2-40B4-BE49-F238E27FC236}">
-                <a16:creationId xmlns:a16="http://schemas.microsoft.com/office/drawing/2014/main" id="{77736D4E-32AF-43E8-901D-7712F41BD953}"/>
+                <a16:creationId xmlns:a16="http://schemas.microsoft.com/office/drawing/2014/main" id="{96582BD4-7598-41DB-A205-F26F9D5DCAC8}"/>
               </a:ext>
             </a:extLst>
           </p:cNvPr>
@@ -26810,7 +26810,7 @@
           <p:cNvPr id="6" name="TextBox 5">
             <a:extLst xmlns:a="http://schemas.openxmlformats.org/drawingml/2006/main">
               <a:ext uri="{FF2B5EF4-FFF2-40B4-BE49-F238E27FC236}">
-                <a16:creationId xmlns:a16="http://schemas.microsoft.com/office/drawing/2014/main" id="{5CBFCEA7-2037-4427-8518-14CA945E899C}"/>
+                <a16:creationId xmlns:a16="http://schemas.microsoft.com/office/drawing/2014/main" id="{F1BFBFB0-725B-43D1-997C-30A21E92E268}"/>
               </a:ext>
             </a:extLst>
           </p:cNvPr>
@@ -26847,7 +26847,7 @@
                 <a:ea typeface="Aptos"/>
                 <a:cs typeface="Aptos"/>
               </a:rPr>
-              <a:t>Independent public evidence summary · 2026.07.23-11 · 2026-07-22 · Sources: Evidence Register; WIPO</a:t>
+              <a:t>Independent public evidence summary · 2026.07.23-12 · 2026-07-22 · Sources: Evidence Register; WIPO</a:t>
             </a:r>
           </a:p>
         </p:txBody>
@@ -26857,7 +26857,7 @@
           <p:cNvPr id="7" name="TextBox 6">
             <a:extLst xmlns:a="http://schemas.openxmlformats.org/drawingml/2006/main">
               <a:ext uri="{FF2B5EF4-FFF2-40B4-BE49-F238E27FC236}">
-                <a16:creationId xmlns:a16="http://schemas.microsoft.com/office/drawing/2014/main" id="{F59AC8B2-96B7-4ED0-AA3A-614F4EF53471}"/>
+                <a16:creationId xmlns:a16="http://schemas.microsoft.com/office/drawing/2014/main" id="{0EE67602-EC3A-461B-AFD9-EE824C4092C5}"/>
               </a:ext>
             </a:extLst>
           </p:cNvPr>
@@ -26904,7 +26904,7 @@
           <p:cNvPr id="8" name="TextBox 7">
             <a:extLst xmlns:a="http://schemas.openxmlformats.org/drawingml/2006/main">
               <a:ext uri="{FF2B5EF4-FFF2-40B4-BE49-F238E27FC236}">
-                <a16:creationId xmlns:a16="http://schemas.microsoft.com/office/drawing/2014/main" id="{C701EE16-8E61-4689-AE89-8D2F9EB5EB2F}"/>
+                <a16:creationId xmlns:a16="http://schemas.microsoft.com/office/drawing/2014/main" id="{70E157BA-419E-49B7-994F-DEF6C13E1467}"/>
               </a:ext>
             </a:extLst>
           </p:cNvPr>
@@ -26951,7 +26951,7 @@
           <p:cNvPr id="9" name="TextBox 8">
             <a:extLst xmlns:a="http://schemas.openxmlformats.org/drawingml/2006/main">
               <a:ext uri="{FF2B5EF4-FFF2-40B4-BE49-F238E27FC236}">
-                <a16:creationId xmlns:a16="http://schemas.microsoft.com/office/drawing/2014/main" id="{0E90DFFD-8BA4-43DB-ADDA-1670B74AF69D}"/>
+                <a16:creationId xmlns:a16="http://schemas.microsoft.com/office/drawing/2014/main" id="{84260A1D-304A-4C74-AA85-82014890B9FE}"/>
               </a:ext>
             </a:extLst>
           </p:cNvPr>
@@ -27048,7 +27048,7 @@
           <p:cNvPr id="10" name="Rounded Rectangle 9">
             <a:extLst xmlns:a="http://schemas.openxmlformats.org/drawingml/2006/main">
               <a:ext uri="{FF2B5EF4-FFF2-40B4-BE49-F238E27FC236}">
-                <a16:creationId xmlns:a16="http://schemas.microsoft.com/office/drawing/2014/main" id="{1A781E5E-EE71-4772-BBC2-F2FE0F63AA6F}"/>
+                <a16:creationId xmlns:a16="http://schemas.microsoft.com/office/drawing/2014/main" id="{40B8B34D-FD5D-4E19-88AC-CB6727D4CB37}"/>
               </a:ext>
             </a:extLst>
           </p:cNvPr>
@@ -27105,7 +27105,7 @@
           <p:cNvPr id="11" name="TextBox 10">
             <a:extLst xmlns:a="http://schemas.openxmlformats.org/drawingml/2006/main">
               <a:ext uri="{FF2B5EF4-FFF2-40B4-BE49-F238E27FC236}">
-                <a16:creationId xmlns:a16="http://schemas.microsoft.com/office/drawing/2014/main" id="{1539F997-4042-4193-AB5F-45999BFDDE3C}"/>
+                <a16:creationId xmlns:a16="http://schemas.microsoft.com/office/drawing/2014/main" id="{19BFECC1-B5E9-4D55-95F5-E43B60D8E35B}"/>
               </a:ext>
             </a:extLst>
           </p:cNvPr>
@@ -27152,7 +27152,7 @@
           <p:cNvPr id="12" name="TextBox 11">
             <a:extLst xmlns:a="http://schemas.openxmlformats.org/drawingml/2006/main">
               <a:ext uri="{FF2B5EF4-FFF2-40B4-BE49-F238E27FC236}">
-                <a16:creationId xmlns:a16="http://schemas.microsoft.com/office/drawing/2014/main" id="{323140A7-4C9A-4282-9626-8327DCD3FE01}"/>
+                <a16:creationId xmlns:a16="http://schemas.microsoft.com/office/drawing/2014/main" id="{F5935AE3-E013-4491-8B23-A957948DEC83}"/>
               </a:ext>
             </a:extLst>
           </p:cNvPr>
@@ -27197,7 +27197,7 @@
     </p:spTree>
     <p:extLst>
       <p:ext uri="{BB962C8B-B14F-4D97-AF65-F5344CB8AC3E}">
-        <p14:creationId xmlns:p14="http://schemas.microsoft.com/office/powerpoint/2010/main" val="998931108"/>
+        <p14:creationId xmlns:p14="http://schemas.microsoft.com/office/powerpoint/2010/main" val="159504858"/>
       </p:ext>
     </p:extLst>
   </p:cSld>
@@ -27221,7 +27221,7 @@
           <p:cNvPr id="2" name="TextBox 1">
             <a:extLst xmlns:a="http://schemas.openxmlformats.org/drawingml/2006/main">
               <a:ext uri="{FF2B5EF4-FFF2-40B4-BE49-F238E27FC236}">
-                <a16:creationId xmlns:a16="http://schemas.microsoft.com/office/drawing/2014/main" id="{F9953B55-F6D3-4B96-A011-5D965A0BDF64}"/>
+                <a16:creationId xmlns:a16="http://schemas.microsoft.com/office/drawing/2014/main" id="{8CB57FBB-0E69-4830-B920-4A6AEF527AA4}"/>
               </a:ext>
             </a:extLst>
           </p:cNvPr>
@@ -27268,7 +27268,7 @@
           <p:cNvPr id="3" name="TextBox 2">
             <a:extLst xmlns:a="http://schemas.openxmlformats.org/drawingml/2006/main">
               <a:ext uri="{FF2B5EF4-FFF2-40B4-BE49-F238E27FC236}">
-                <a16:creationId xmlns:a16="http://schemas.microsoft.com/office/drawing/2014/main" id="{A0D0DF53-06E9-40A7-9F99-76931A5BAC18}"/>
+                <a16:creationId xmlns:a16="http://schemas.microsoft.com/office/drawing/2014/main" id="{287BF8EF-602D-4DD4-928A-7A083F4C4891}"/>
               </a:ext>
             </a:extLst>
           </p:cNvPr>
@@ -27315,7 +27315,7 @@
           <p:cNvPr id="4" name="Rectangle 3">
             <a:extLst xmlns:a="http://schemas.openxmlformats.org/drawingml/2006/main">
               <a:ext uri="{FF2B5EF4-FFF2-40B4-BE49-F238E27FC236}">
-                <a16:creationId xmlns:a16="http://schemas.microsoft.com/office/drawing/2014/main" id="{FC2D1C3F-234D-4A99-95C2-E3C4F5959A4A}"/>
+                <a16:creationId xmlns:a16="http://schemas.microsoft.com/office/drawing/2014/main" id="{8D88E304-6206-4989-9A0F-1AF601C5E9EC}"/>
               </a:ext>
             </a:extLst>
           </p:cNvPr>
@@ -27370,7 +27370,7 @@
           <p:cNvPr id="5" name="Rectangle 4">
             <a:extLst xmlns:a="http://schemas.openxmlformats.org/drawingml/2006/main">
               <a:ext uri="{FF2B5EF4-FFF2-40B4-BE49-F238E27FC236}">
-                <a16:creationId xmlns:a16="http://schemas.microsoft.com/office/drawing/2014/main" id="{2F83EDCA-85FD-43C7-A137-B126B0B59504}"/>
+                <a16:creationId xmlns:a16="http://schemas.microsoft.com/office/drawing/2014/main" id="{3770668F-02BB-4428-A809-2101C0BF1DFB}"/>
               </a:ext>
             </a:extLst>
           </p:cNvPr>
@@ -27425,7 +27425,7 @@
           <p:cNvPr id="6" name="TextBox 5">
             <a:extLst xmlns:a="http://schemas.openxmlformats.org/drawingml/2006/main">
               <a:ext uri="{FF2B5EF4-FFF2-40B4-BE49-F238E27FC236}">
-                <a16:creationId xmlns:a16="http://schemas.microsoft.com/office/drawing/2014/main" id="{DE5B65B3-AAD2-44CE-92D8-4A0208C59E5E}"/>
+                <a16:creationId xmlns:a16="http://schemas.microsoft.com/office/drawing/2014/main" id="{2D597CEF-F491-4CC3-807A-227EB0766211}"/>
               </a:ext>
             </a:extLst>
           </p:cNvPr>
@@ -27462,7 +27462,7 @@
                 <a:ea typeface="Aptos"/>
                 <a:cs typeface="Aptos"/>
               </a:rPr>
-              <a:t>Independent public evidence summary · 2026.07.23-11 · 2026-07-22 · Sources: EP3032975B2</a:t>
+              <a:t>Independent public evidence summary · 2026.07.23-12 · 2026-07-22 · Sources: EP3032975B2</a:t>
             </a:r>
           </a:p>
         </p:txBody>
@@ -27472,7 +27472,7 @@
           <p:cNvPr id="7" name="TextBox 6">
             <a:extLst xmlns:a="http://schemas.openxmlformats.org/drawingml/2006/main">
               <a:ext uri="{FF2B5EF4-FFF2-40B4-BE49-F238E27FC236}">
-                <a16:creationId xmlns:a16="http://schemas.microsoft.com/office/drawing/2014/main" id="{3911CC5A-6E54-4C9F-B874-099A38AE3278}"/>
+                <a16:creationId xmlns:a16="http://schemas.microsoft.com/office/drawing/2014/main" id="{A158AB8F-270C-4DB5-A6B6-FFD751617C69}"/>
               </a:ext>
             </a:extLst>
           </p:cNvPr>
@@ -27519,7 +27519,7 @@
           <p:cNvPr id="8" name="TextBox 7">
             <a:extLst xmlns:a="http://schemas.openxmlformats.org/drawingml/2006/main">
               <a:ext uri="{FF2B5EF4-FFF2-40B4-BE49-F238E27FC236}">
-                <a16:creationId xmlns:a16="http://schemas.microsoft.com/office/drawing/2014/main" id="{FC61DD90-F79B-4549-A1EB-4BDFC46E295D}"/>
+                <a16:creationId xmlns:a16="http://schemas.microsoft.com/office/drawing/2014/main" id="{AC3045CB-C42A-4115-8805-0DAFDAB4A0E9}"/>
               </a:ext>
             </a:extLst>
           </p:cNvPr>
@@ -27566,7 +27566,7 @@
           <p:cNvPr id="9" name="TextBox 8">
             <a:extLst xmlns:a="http://schemas.openxmlformats.org/drawingml/2006/main">
               <a:ext uri="{FF2B5EF4-FFF2-40B4-BE49-F238E27FC236}">
-                <a16:creationId xmlns:a16="http://schemas.microsoft.com/office/drawing/2014/main" id="{F8F9DC60-FC2B-4C53-B801-810FC1B3BE3F}"/>
+                <a16:creationId xmlns:a16="http://schemas.microsoft.com/office/drawing/2014/main" id="{FB8F783B-D3A0-4DAA-9FFA-A7B95A7D0845}"/>
               </a:ext>
             </a:extLst>
           </p:cNvPr>
@@ -27663,7 +27663,7 @@
           <p:cNvPr id="10" name="Rounded Rectangle 9">
             <a:extLst xmlns:a="http://schemas.openxmlformats.org/drawingml/2006/main">
               <a:ext uri="{FF2B5EF4-FFF2-40B4-BE49-F238E27FC236}">
-                <a16:creationId xmlns:a16="http://schemas.microsoft.com/office/drawing/2014/main" id="{FA580EC2-97EE-4E70-A08A-62997C713C4B}"/>
+                <a16:creationId xmlns:a16="http://schemas.microsoft.com/office/drawing/2014/main" id="{1D2D9360-BF21-434E-87FE-4DE53AFE42B3}"/>
               </a:ext>
             </a:extLst>
           </p:cNvPr>
@@ -27720,7 +27720,7 @@
           <p:cNvPr id="11" name="TextBox 10">
             <a:extLst xmlns:a="http://schemas.openxmlformats.org/drawingml/2006/main">
               <a:ext uri="{FF2B5EF4-FFF2-40B4-BE49-F238E27FC236}">
-                <a16:creationId xmlns:a16="http://schemas.microsoft.com/office/drawing/2014/main" id="{6B44A0F2-974D-4FBE-BC34-3891760F231A}"/>
+                <a16:creationId xmlns:a16="http://schemas.microsoft.com/office/drawing/2014/main" id="{FF07E2DF-5C20-48A5-9BD6-B79E626D8563}"/>
               </a:ext>
             </a:extLst>
           </p:cNvPr>
@@ -27767,7 +27767,7 @@
           <p:cNvPr id="12" name="TextBox 11">
             <a:extLst xmlns:a="http://schemas.openxmlformats.org/drawingml/2006/main">
               <a:ext uri="{FF2B5EF4-FFF2-40B4-BE49-F238E27FC236}">
-                <a16:creationId xmlns:a16="http://schemas.microsoft.com/office/drawing/2014/main" id="{68327904-7C41-4E63-811C-393B15CFEE99}"/>
+                <a16:creationId xmlns:a16="http://schemas.microsoft.com/office/drawing/2014/main" id="{A17DF37E-06F1-41EA-8FB5-42BCC3FADE6B}"/>
               </a:ext>
             </a:extLst>
           </p:cNvPr>
@@ -27812,7 +27812,7 @@
     </p:spTree>
     <p:extLst>
       <p:ext uri="{BB962C8B-B14F-4D97-AF65-F5344CB8AC3E}">
-        <p14:creationId xmlns:p14="http://schemas.microsoft.com/office/powerpoint/2010/main" val="1064422834"/>
+        <p14:creationId xmlns:p14="http://schemas.microsoft.com/office/powerpoint/2010/main" val="851094719"/>
       </p:ext>
     </p:extLst>
   </p:cSld>
@@ -27836,7 +27836,7 @@
           <p:cNvPr id="2" name="TextBox 1">
             <a:extLst xmlns:a="http://schemas.openxmlformats.org/drawingml/2006/main">
               <a:ext uri="{FF2B5EF4-FFF2-40B4-BE49-F238E27FC236}">
-                <a16:creationId xmlns:a16="http://schemas.microsoft.com/office/drawing/2014/main" id="{FF8DE4A4-6A5C-4DAD-B56D-1AB1B2FDCF84}"/>
+                <a16:creationId xmlns:a16="http://schemas.microsoft.com/office/drawing/2014/main" id="{2E7FC015-72D5-4714-AC66-6E78438351CE}"/>
               </a:ext>
             </a:extLst>
           </p:cNvPr>
@@ -27883,7 +27883,7 @@
           <p:cNvPr id="3" name="TextBox 2">
             <a:extLst xmlns:a="http://schemas.openxmlformats.org/drawingml/2006/main">
               <a:ext uri="{FF2B5EF4-FFF2-40B4-BE49-F238E27FC236}">
-                <a16:creationId xmlns:a16="http://schemas.microsoft.com/office/drawing/2014/main" id="{99E642A3-30B6-40CB-A89F-EE69851C0FF2}"/>
+                <a16:creationId xmlns:a16="http://schemas.microsoft.com/office/drawing/2014/main" id="{A962FA0B-B00D-447F-9F3B-3C52DCDF23B1}"/>
               </a:ext>
             </a:extLst>
           </p:cNvPr>
@@ -27930,7 +27930,7 @@
           <p:cNvPr id="4" name="Rectangle 3">
             <a:extLst xmlns:a="http://schemas.openxmlformats.org/drawingml/2006/main">
               <a:ext uri="{FF2B5EF4-FFF2-40B4-BE49-F238E27FC236}">
-                <a16:creationId xmlns:a16="http://schemas.microsoft.com/office/drawing/2014/main" id="{DBEF5228-2563-4374-B7C4-A2D8ABF42F0C}"/>
+                <a16:creationId xmlns:a16="http://schemas.microsoft.com/office/drawing/2014/main" id="{A6400827-5BF5-4D33-BA09-25AC0A0210A2}"/>
               </a:ext>
             </a:extLst>
           </p:cNvPr>
@@ -27985,7 +27985,7 @@
           <p:cNvPr id="5" name="Rectangle 4">
             <a:extLst xmlns:a="http://schemas.openxmlformats.org/drawingml/2006/main">
               <a:ext uri="{FF2B5EF4-FFF2-40B4-BE49-F238E27FC236}">
-                <a16:creationId xmlns:a16="http://schemas.microsoft.com/office/drawing/2014/main" id="{016B532C-CE90-4171-BBD9-9E25266257D3}"/>
+                <a16:creationId xmlns:a16="http://schemas.microsoft.com/office/drawing/2014/main" id="{33BE30B5-CB65-42E8-8137-6E28E1E1FF91}"/>
               </a:ext>
             </a:extLst>
           </p:cNvPr>
@@ -28040,7 +28040,7 @@
           <p:cNvPr id="6" name="TextBox 5">
             <a:extLst xmlns:a="http://schemas.openxmlformats.org/drawingml/2006/main">
               <a:ext uri="{FF2B5EF4-FFF2-40B4-BE49-F238E27FC236}">
-                <a16:creationId xmlns:a16="http://schemas.microsoft.com/office/drawing/2014/main" id="{4DCD5D3B-6A90-4E94-B110-0E27019EB763}"/>
+                <a16:creationId xmlns:a16="http://schemas.microsoft.com/office/drawing/2014/main" id="{2D4672D3-8247-4618-906B-AC1889FA8E49}"/>
               </a:ext>
             </a:extLst>
           </p:cNvPr>
@@ -28077,7 +28077,7 @@
                 <a:ea typeface="Aptos"/>
                 <a:cs typeface="Aptos"/>
               </a:rPr>
-              <a:t>Independent public evidence summary · 2026.07.23-11 · 2026-07-22 · Sources: EP3032975B2</a:t>
+              <a:t>Independent public evidence summary · 2026.07.23-12 · 2026-07-22 · Sources: EP3032975B2</a:t>
             </a:r>
           </a:p>
         </p:txBody>
@@ -28087,7 +28087,7 @@
           <p:cNvPr id="7" name="TextBox 6">
             <a:extLst xmlns:a="http://schemas.openxmlformats.org/drawingml/2006/main">
               <a:ext uri="{FF2B5EF4-FFF2-40B4-BE49-F238E27FC236}">
-                <a16:creationId xmlns:a16="http://schemas.microsoft.com/office/drawing/2014/main" id="{BC194073-88F3-4255-A414-AE80BD72B8ED}"/>
+                <a16:creationId xmlns:a16="http://schemas.microsoft.com/office/drawing/2014/main" id="{65C37FDC-1B06-42FC-8E77-62651A5710E6}"/>
               </a:ext>
             </a:extLst>
           </p:cNvPr>
@@ -28657,7 +28657,7 @@
           <p:cNvPr id="9" name="TextBox 8">
             <a:extLst xmlns:a="http://schemas.openxmlformats.org/drawingml/2006/main">
               <a:ext uri="{FF2B5EF4-FFF2-40B4-BE49-F238E27FC236}">
-                <a16:creationId xmlns:a16="http://schemas.microsoft.com/office/drawing/2014/main" id="{009ACCB1-6B85-44E1-8551-B8604DA78E9C}"/>
+                <a16:creationId xmlns:a16="http://schemas.microsoft.com/office/drawing/2014/main" id="{AA34ADC4-7DE0-4147-B5D6-535D0127A89B}"/>
               </a:ext>
             </a:extLst>
           </p:cNvPr>
@@ -28702,7 +28702,7 @@
     </p:spTree>
     <p:extLst>
       <p:ext uri="{BB962C8B-B14F-4D97-AF65-F5344CB8AC3E}">
-        <p14:creationId xmlns:p14="http://schemas.microsoft.com/office/powerpoint/2010/main" val="1966358754"/>
+        <p14:creationId xmlns:p14="http://schemas.microsoft.com/office/powerpoint/2010/main" val="1275727853"/>
       </p:ext>
     </p:extLst>
   </p:cSld>
@@ -28726,7 +28726,7 @@
           <p:cNvPr id="2" name="TextBox 1">
             <a:extLst xmlns:a="http://schemas.openxmlformats.org/drawingml/2006/main">
               <a:ext uri="{FF2B5EF4-FFF2-40B4-BE49-F238E27FC236}">
-                <a16:creationId xmlns:a16="http://schemas.microsoft.com/office/drawing/2014/main" id="{74F5D165-78B4-4AA2-98DA-E25BE0F3205C}"/>
+                <a16:creationId xmlns:a16="http://schemas.microsoft.com/office/drawing/2014/main" id="{71B9AF21-0835-439B-9B8E-860FD478A0C6}"/>
               </a:ext>
             </a:extLst>
           </p:cNvPr>
@@ -28773,7 +28773,7 @@
           <p:cNvPr id="3" name="TextBox 2">
             <a:extLst xmlns:a="http://schemas.openxmlformats.org/drawingml/2006/main">
               <a:ext uri="{FF2B5EF4-FFF2-40B4-BE49-F238E27FC236}">
-                <a16:creationId xmlns:a16="http://schemas.microsoft.com/office/drawing/2014/main" id="{8AF31785-FAA6-41B5-AB58-9FF4D111DD39}"/>
+                <a16:creationId xmlns:a16="http://schemas.microsoft.com/office/drawing/2014/main" id="{45124C53-E805-4B81-942E-02CB24FF3E5A}"/>
               </a:ext>
             </a:extLst>
           </p:cNvPr>
@@ -28820,7 +28820,7 @@
           <p:cNvPr id="4" name="Rectangle 3">
             <a:extLst xmlns:a="http://schemas.openxmlformats.org/drawingml/2006/main">
               <a:ext uri="{FF2B5EF4-FFF2-40B4-BE49-F238E27FC236}">
-                <a16:creationId xmlns:a16="http://schemas.microsoft.com/office/drawing/2014/main" id="{8E444AF5-969E-4B2B-9A56-BC86978AAF2B}"/>
+                <a16:creationId xmlns:a16="http://schemas.microsoft.com/office/drawing/2014/main" id="{B238E8AD-26F1-4E5C-98D6-D16AEF45A745}"/>
               </a:ext>
             </a:extLst>
           </p:cNvPr>
@@ -28875,7 +28875,7 @@
           <p:cNvPr id="5" name="Rectangle 4">
             <a:extLst xmlns:a="http://schemas.openxmlformats.org/drawingml/2006/main">
               <a:ext uri="{FF2B5EF4-FFF2-40B4-BE49-F238E27FC236}">
-                <a16:creationId xmlns:a16="http://schemas.microsoft.com/office/drawing/2014/main" id="{74DA7AC1-C7A5-489E-86EE-0462245711A4}"/>
+                <a16:creationId xmlns:a16="http://schemas.microsoft.com/office/drawing/2014/main" id="{FBCCBACC-547F-4144-9B93-6C45A777E873}"/>
               </a:ext>
             </a:extLst>
           </p:cNvPr>
@@ -28930,7 +28930,7 @@
           <p:cNvPr id="6" name="TextBox 5">
             <a:extLst xmlns:a="http://schemas.openxmlformats.org/drawingml/2006/main">
               <a:ext uri="{FF2B5EF4-FFF2-40B4-BE49-F238E27FC236}">
-                <a16:creationId xmlns:a16="http://schemas.microsoft.com/office/drawing/2014/main" id="{E4097417-F8C3-4631-BDDD-16051017878A}"/>
+                <a16:creationId xmlns:a16="http://schemas.microsoft.com/office/drawing/2014/main" id="{C3A4695D-31DD-48C0-A633-32758EA3EF31}"/>
               </a:ext>
             </a:extLst>
           </p:cNvPr>
@@ -28967,7 +28967,7 @@
                 <a:ea typeface="Aptos"/>
                 <a:cs typeface="Aptos"/>
               </a:rPr>
-              <a:t>Independent public evidence summary · 2026.07.23-11 · 2026-07-22 · Sources: EPO Register; B2</a:t>
+              <a:t>Independent public evidence summary · 2026.07.23-12 · 2026-07-22 · Sources: EPO Register; B2</a:t>
             </a:r>
           </a:p>
         </p:txBody>
@@ -28977,7 +28977,7 @@
           <p:cNvPr id="7" name="TextBox 6">
             <a:extLst xmlns:a="http://schemas.openxmlformats.org/drawingml/2006/main">
               <a:ext uri="{FF2B5EF4-FFF2-40B4-BE49-F238E27FC236}">
-                <a16:creationId xmlns:a16="http://schemas.microsoft.com/office/drawing/2014/main" id="{44F9D945-A07A-46BC-8EAE-F2B521A76483}"/>
+                <a16:creationId xmlns:a16="http://schemas.microsoft.com/office/drawing/2014/main" id="{D7A884D4-CB4F-426A-9C04-43AD0BDAD917}"/>
               </a:ext>
             </a:extLst>
           </p:cNvPr>
@@ -29024,7 +29024,7 @@
           <p:cNvPr id="8" name="Rounded Rectangle 7">
             <a:extLst xmlns:a="http://schemas.openxmlformats.org/drawingml/2006/main">
               <a:ext uri="{FF2B5EF4-FFF2-40B4-BE49-F238E27FC236}">
-                <a16:creationId xmlns:a16="http://schemas.microsoft.com/office/drawing/2014/main" id="{113CFE3E-F4B3-4E96-8E59-ABA7E60C5438}"/>
+                <a16:creationId xmlns:a16="http://schemas.microsoft.com/office/drawing/2014/main" id="{DBBEF106-1D73-46D6-82A1-1C2846F94FF7}"/>
               </a:ext>
             </a:extLst>
           </p:cNvPr>
@@ -29081,7 +29081,7 @@
           <p:cNvPr id="9" name="TextBox 8">
             <a:extLst xmlns:a="http://schemas.openxmlformats.org/drawingml/2006/main">
               <a:ext uri="{FF2B5EF4-FFF2-40B4-BE49-F238E27FC236}">
-                <a16:creationId xmlns:a16="http://schemas.microsoft.com/office/drawing/2014/main" id="{09920181-5623-4541-AEBB-D6556B4F3D68}"/>
+                <a16:creationId xmlns:a16="http://schemas.microsoft.com/office/drawing/2014/main" id="{C10CCE86-8646-4867-A496-3B5E5E88C021}"/>
               </a:ext>
             </a:extLst>
           </p:cNvPr>
@@ -29128,7 +29128,7 @@
           <p:cNvPr id="10" name="TextBox 9">
             <a:extLst xmlns:a="http://schemas.openxmlformats.org/drawingml/2006/main">
               <a:ext uri="{FF2B5EF4-FFF2-40B4-BE49-F238E27FC236}">
-                <a16:creationId xmlns:a16="http://schemas.microsoft.com/office/drawing/2014/main" id="{17DA4C9E-51A2-488E-9053-96604DB8F04F}"/>
+                <a16:creationId xmlns:a16="http://schemas.microsoft.com/office/drawing/2014/main" id="{C47A6BDE-1990-43D2-A95D-3FAFA69C95BF}"/>
               </a:ext>
             </a:extLst>
           </p:cNvPr>
@@ -29175,7 +29175,7 @@
           <p:cNvPr id="11" name="Rounded Rectangle 10">
             <a:extLst xmlns:a="http://schemas.openxmlformats.org/drawingml/2006/main">
               <a:ext uri="{FF2B5EF4-FFF2-40B4-BE49-F238E27FC236}">
-                <a16:creationId xmlns:a16="http://schemas.microsoft.com/office/drawing/2014/main" id="{3B91B9B3-7B43-4F69-A830-0CD98E09521E}"/>
+                <a16:creationId xmlns:a16="http://schemas.microsoft.com/office/drawing/2014/main" id="{DA8671DD-450D-43FC-89B9-BB2F0045F6F3}"/>
               </a:ext>
             </a:extLst>
           </p:cNvPr>
@@ -29232,7 +29232,7 @@
           <p:cNvPr id="12" name="TextBox 11">
             <a:extLst xmlns:a="http://schemas.openxmlformats.org/drawingml/2006/main">
               <a:ext uri="{FF2B5EF4-FFF2-40B4-BE49-F238E27FC236}">
-                <a16:creationId xmlns:a16="http://schemas.microsoft.com/office/drawing/2014/main" id="{2BC17A2A-FEF0-49C9-BF3E-D8E1982306BC}"/>
+                <a16:creationId xmlns:a16="http://schemas.microsoft.com/office/drawing/2014/main" id="{FA3458CF-AACE-40CE-B470-46691AC23BDF}"/>
               </a:ext>
             </a:extLst>
           </p:cNvPr>
@@ -29279,7 +29279,7 @@
           <p:cNvPr id="13" name="TextBox 12">
             <a:extLst xmlns:a="http://schemas.openxmlformats.org/drawingml/2006/main">
               <a:ext uri="{FF2B5EF4-FFF2-40B4-BE49-F238E27FC236}">
-                <a16:creationId xmlns:a16="http://schemas.microsoft.com/office/drawing/2014/main" id="{BF85CDAC-4435-4F4D-8144-00C4D4BC28F9}"/>
+                <a16:creationId xmlns:a16="http://schemas.microsoft.com/office/drawing/2014/main" id="{9601FB94-3086-4D0D-8A3B-0A542647161D}"/>
               </a:ext>
             </a:extLst>
           </p:cNvPr>
@@ -29326,7 +29326,7 @@
           <p:cNvPr id="14" name="Rounded Rectangle 13">
             <a:extLst xmlns:a="http://schemas.openxmlformats.org/drawingml/2006/main">
               <a:ext uri="{FF2B5EF4-FFF2-40B4-BE49-F238E27FC236}">
-                <a16:creationId xmlns:a16="http://schemas.microsoft.com/office/drawing/2014/main" id="{A75A60BB-C0C6-4912-A904-12124ABB9524}"/>
+                <a16:creationId xmlns:a16="http://schemas.microsoft.com/office/drawing/2014/main" id="{6385ACC5-F434-4809-A7AC-6F1F8D6DC17F}"/>
               </a:ext>
             </a:extLst>
           </p:cNvPr>
@@ -29383,7 +29383,7 @@
           <p:cNvPr id="15" name="TextBox 14">
             <a:extLst xmlns:a="http://schemas.openxmlformats.org/drawingml/2006/main">
               <a:ext uri="{FF2B5EF4-FFF2-40B4-BE49-F238E27FC236}">
-                <a16:creationId xmlns:a16="http://schemas.microsoft.com/office/drawing/2014/main" id="{3E29F868-2711-41D0-A0D6-5FD8EA9B4970}"/>
+                <a16:creationId xmlns:a16="http://schemas.microsoft.com/office/drawing/2014/main" id="{B485C49C-4F31-44BB-8D71-DB6E6C0B155C}"/>
               </a:ext>
             </a:extLst>
           </p:cNvPr>
@@ -29430,7 +29430,7 @@
           <p:cNvPr id="16" name="TextBox 15">
             <a:extLst xmlns:a="http://schemas.openxmlformats.org/drawingml/2006/main">
               <a:ext uri="{FF2B5EF4-FFF2-40B4-BE49-F238E27FC236}">
-                <a16:creationId xmlns:a16="http://schemas.microsoft.com/office/drawing/2014/main" id="{325BB3C0-92F7-41E9-BCFB-1F3E0BDAAA75}"/>
+                <a16:creationId xmlns:a16="http://schemas.microsoft.com/office/drawing/2014/main" id="{E8FE9C22-98E8-49B9-BED4-558734269DA3}"/>
               </a:ext>
             </a:extLst>
           </p:cNvPr>
@@ -29477,7 +29477,7 @@
           <p:cNvPr id="17" name="TextBox 16">
             <a:extLst xmlns:a="http://schemas.openxmlformats.org/drawingml/2006/main">
               <a:ext uri="{FF2B5EF4-FFF2-40B4-BE49-F238E27FC236}">
-                <a16:creationId xmlns:a16="http://schemas.microsoft.com/office/drawing/2014/main" id="{56EA2B65-AB06-42E0-B1E1-C7AEC58EEAEF}"/>
+                <a16:creationId xmlns:a16="http://schemas.microsoft.com/office/drawing/2014/main" id="{AED967F5-66A0-4CB3-A861-06D1B11DD8B1}"/>
               </a:ext>
             </a:extLst>
           </p:cNvPr>
@@ -29524,7 +29524,7 @@
           <p:cNvPr id="18" name="Rounded Rectangle 17">
             <a:extLst xmlns:a="http://schemas.openxmlformats.org/drawingml/2006/main">
               <a:ext uri="{FF2B5EF4-FFF2-40B4-BE49-F238E27FC236}">
-                <a16:creationId xmlns:a16="http://schemas.microsoft.com/office/drawing/2014/main" id="{3DFBCA90-4152-4A46-BF95-8FDF51435BED}"/>
+                <a16:creationId xmlns:a16="http://schemas.microsoft.com/office/drawing/2014/main" id="{6A41995F-24EA-48A2-B38D-7A87DDFB1CA0}"/>
               </a:ext>
             </a:extLst>
           </p:cNvPr>
@@ -29581,7 +29581,7 @@
           <p:cNvPr id="19" name="TextBox 18">
             <a:extLst xmlns:a="http://schemas.openxmlformats.org/drawingml/2006/main">
               <a:ext uri="{FF2B5EF4-FFF2-40B4-BE49-F238E27FC236}">
-                <a16:creationId xmlns:a16="http://schemas.microsoft.com/office/drawing/2014/main" id="{A0151705-D54D-4919-B07D-0A2B314D8123}"/>
+                <a16:creationId xmlns:a16="http://schemas.microsoft.com/office/drawing/2014/main" id="{731ED684-82D8-4E4A-9FC9-97E3A964C2E5}"/>
               </a:ext>
             </a:extLst>
           </p:cNvPr>
@@ -29628,7 +29628,7 @@
           <p:cNvPr id="20" name="TextBox 19">
             <a:extLst xmlns:a="http://schemas.openxmlformats.org/drawingml/2006/main">
               <a:ext uri="{FF2B5EF4-FFF2-40B4-BE49-F238E27FC236}">
-                <a16:creationId xmlns:a16="http://schemas.microsoft.com/office/drawing/2014/main" id="{8D95D6F5-905B-4FB0-99A0-63CB195D9301}"/>
+                <a16:creationId xmlns:a16="http://schemas.microsoft.com/office/drawing/2014/main" id="{827BBAA5-A217-4303-B9C8-E6A01174DE6D}"/>
               </a:ext>
             </a:extLst>
           </p:cNvPr>
@@ -29673,7 +29673,7 @@
     </p:spTree>
     <p:extLst>
       <p:ext uri="{BB962C8B-B14F-4D97-AF65-F5344CB8AC3E}">
-        <p14:creationId xmlns:p14="http://schemas.microsoft.com/office/powerpoint/2010/main" val="928223737"/>
+        <p14:creationId xmlns:p14="http://schemas.microsoft.com/office/powerpoint/2010/main" val="1272210282"/>
       </p:ext>
     </p:extLst>
   </p:cSld>
@@ -29697,7 +29697,7 @@
           <p:cNvPr id="2" name="TextBox 1">
             <a:extLst xmlns:a="http://schemas.openxmlformats.org/drawingml/2006/main">
               <a:ext uri="{FF2B5EF4-FFF2-40B4-BE49-F238E27FC236}">
-                <a16:creationId xmlns:a16="http://schemas.microsoft.com/office/drawing/2014/main" id="{677A626B-68A9-411D-A9BA-953DB854789F}"/>
+                <a16:creationId xmlns:a16="http://schemas.microsoft.com/office/drawing/2014/main" id="{312E1CF8-5CC5-4D55-A0F4-97874B808DDE}"/>
               </a:ext>
             </a:extLst>
           </p:cNvPr>
@@ -29744,7 +29744,7 @@
           <p:cNvPr id="3" name="TextBox 2">
             <a:extLst xmlns:a="http://schemas.openxmlformats.org/drawingml/2006/main">
               <a:ext uri="{FF2B5EF4-FFF2-40B4-BE49-F238E27FC236}">
-                <a16:creationId xmlns:a16="http://schemas.microsoft.com/office/drawing/2014/main" id="{48E62AE4-9100-46FF-BA5A-A9565432C220}"/>
+                <a16:creationId xmlns:a16="http://schemas.microsoft.com/office/drawing/2014/main" id="{2EA16945-CEE0-4015-9DA9-65FE82318BCD}"/>
               </a:ext>
             </a:extLst>
           </p:cNvPr>
@@ -29791,7 +29791,7 @@
           <p:cNvPr id="4" name="Rectangle 3">
             <a:extLst xmlns:a="http://schemas.openxmlformats.org/drawingml/2006/main">
               <a:ext uri="{FF2B5EF4-FFF2-40B4-BE49-F238E27FC236}">
-                <a16:creationId xmlns:a16="http://schemas.microsoft.com/office/drawing/2014/main" id="{7932A9E7-EC1D-439C-9572-DD3ADCF892EB}"/>
+                <a16:creationId xmlns:a16="http://schemas.microsoft.com/office/drawing/2014/main" id="{7E5C43D6-3983-454F-B113-DCAAB16C9D1D}"/>
               </a:ext>
             </a:extLst>
           </p:cNvPr>
@@ -29846,7 +29846,7 @@
           <p:cNvPr id="5" name="Rectangle 4">
             <a:extLst xmlns:a="http://schemas.openxmlformats.org/drawingml/2006/main">
               <a:ext uri="{FF2B5EF4-FFF2-40B4-BE49-F238E27FC236}">
-                <a16:creationId xmlns:a16="http://schemas.microsoft.com/office/drawing/2014/main" id="{10CA9448-13BB-40E3-A35F-F96581C39F9A}"/>
+                <a16:creationId xmlns:a16="http://schemas.microsoft.com/office/drawing/2014/main" id="{45CA5238-CFEF-4EC3-BFEB-E1DB3006AC00}"/>
               </a:ext>
             </a:extLst>
           </p:cNvPr>
@@ -29901,7 +29901,7 @@
           <p:cNvPr id="6" name="TextBox 5">
             <a:extLst xmlns:a="http://schemas.openxmlformats.org/drawingml/2006/main">
               <a:ext uri="{FF2B5EF4-FFF2-40B4-BE49-F238E27FC236}">
-                <a16:creationId xmlns:a16="http://schemas.microsoft.com/office/drawing/2014/main" id="{E5431AE0-4E6A-4034-BD0F-985321CB1B52}"/>
+                <a16:creationId xmlns:a16="http://schemas.microsoft.com/office/drawing/2014/main" id="{1D4051DB-9C17-4EF8-91F1-5EDDD4ABDDBC}"/>
               </a:ext>
             </a:extLst>
           </p:cNvPr>
@@ -29938,7 +29938,7 @@
                 <a:ea typeface="Aptos"/>
                 <a:cs typeface="Aptos"/>
               </a:rPr>
-              <a:t>Independent public evidence summary · 2026.07.23-11 · 2026-07-22 · Sources: EPO family; national registers</a:t>
+              <a:t>Independent public evidence summary · 2026.07.23-12 · 2026-07-22 · Sources: EPO family; national registers</a:t>
             </a:r>
           </a:p>
         </p:txBody>
@@ -29948,7 +29948,7 @@
           <p:cNvPr id="7" name="TextBox 6">
             <a:extLst xmlns:a="http://schemas.openxmlformats.org/drawingml/2006/main">
               <a:ext uri="{FF2B5EF4-FFF2-40B4-BE49-F238E27FC236}">
-                <a16:creationId xmlns:a16="http://schemas.microsoft.com/office/drawing/2014/main" id="{510BEA92-F7D7-43C2-BE98-7D165FC04A57}"/>
+                <a16:creationId xmlns:a16="http://schemas.microsoft.com/office/drawing/2014/main" id="{097BAFDB-2722-4974-968D-75D0A770FB73}"/>
               </a:ext>
             </a:extLst>
           </p:cNvPr>
@@ -29995,7 +29995,7 @@
           <p:cNvPr id="8" name="Rounded Rectangle 7">
             <a:extLst xmlns:a="http://schemas.openxmlformats.org/drawingml/2006/main">
               <a:ext uri="{FF2B5EF4-FFF2-40B4-BE49-F238E27FC236}">
-                <a16:creationId xmlns:a16="http://schemas.microsoft.com/office/drawing/2014/main" id="{8CF93D11-9BA6-436A-A808-350FA2B7C253}"/>
+                <a16:creationId xmlns:a16="http://schemas.microsoft.com/office/drawing/2014/main" id="{C68ABCCB-B361-4233-B9B6-82AFF928CFE1}"/>
               </a:ext>
             </a:extLst>
           </p:cNvPr>
@@ -30052,7 +30052,7 @@
           <p:cNvPr id="9" name="TextBox 8">
             <a:extLst xmlns:a="http://schemas.openxmlformats.org/drawingml/2006/main">
               <a:ext uri="{FF2B5EF4-FFF2-40B4-BE49-F238E27FC236}">
-                <a16:creationId xmlns:a16="http://schemas.microsoft.com/office/drawing/2014/main" id="{F071B7D4-8792-4FFD-9135-C0DF38353F39}"/>
+                <a16:creationId xmlns:a16="http://schemas.microsoft.com/office/drawing/2014/main" id="{0BAF9EEC-1B8A-48B0-A165-09AE35FD4134}"/>
               </a:ext>
             </a:extLst>
           </p:cNvPr>
@@ -30099,7 +30099,7 @@
           <p:cNvPr id="10" name="TextBox 9">
             <a:extLst xmlns:a="http://schemas.openxmlformats.org/drawingml/2006/main">
               <a:ext uri="{FF2B5EF4-FFF2-40B4-BE49-F238E27FC236}">
-                <a16:creationId xmlns:a16="http://schemas.microsoft.com/office/drawing/2014/main" id="{3BD29D48-1FD1-4C06-ABEA-C5FCE71E993E}"/>
+                <a16:creationId xmlns:a16="http://schemas.microsoft.com/office/drawing/2014/main" id="{D59269AC-90B0-4B61-89CE-223C706A0DAE}"/>
               </a:ext>
             </a:extLst>
           </p:cNvPr>
@@ -30146,7 +30146,7 @@
           <p:cNvPr id="11" name="Rounded Rectangle 10">
             <a:extLst xmlns:a="http://schemas.openxmlformats.org/drawingml/2006/main">
               <a:ext uri="{FF2B5EF4-FFF2-40B4-BE49-F238E27FC236}">
-                <a16:creationId xmlns:a16="http://schemas.microsoft.com/office/drawing/2014/main" id="{3CF4F0E4-6888-4B83-AAC3-212474E5B216}"/>
+                <a16:creationId xmlns:a16="http://schemas.microsoft.com/office/drawing/2014/main" id="{5C77A466-D8FE-4533-B8EB-23FE4AC6DCE3}"/>
               </a:ext>
             </a:extLst>
           </p:cNvPr>
@@ -30203,7 +30203,7 @@
           <p:cNvPr id="12" name="TextBox 11">
             <a:extLst xmlns:a="http://schemas.openxmlformats.org/drawingml/2006/main">
               <a:ext uri="{FF2B5EF4-FFF2-40B4-BE49-F238E27FC236}">
-                <a16:creationId xmlns:a16="http://schemas.microsoft.com/office/drawing/2014/main" id="{F38093F4-B427-4A03-BB9D-58296D54B599}"/>
+                <a16:creationId xmlns:a16="http://schemas.microsoft.com/office/drawing/2014/main" id="{F8C3A6CA-3670-447F-A47B-458D2B4D8A02}"/>
               </a:ext>
             </a:extLst>
           </p:cNvPr>
@@ -30250,7 +30250,7 @@
           <p:cNvPr id="13" name="TextBox 12">
             <a:extLst xmlns:a="http://schemas.openxmlformats.org/drawingml/2006/main">
               <a:ext uri="{FF2B5EF4-FFF2-40B4-BE49-F238E27FC236}">
-                <a16:creationId xmlns:a16="http://schemas.microsoft.com/office/drawing/2014/main" id="{511BDCBB-E9F5-4443-BBFF-617639CB6EC5}"/>
+                <a16:creationId xmlns:a16="http://schemas.microsoft.com/office/drawing/2014/main" id="{8E617221-3ACB-44FB-B193-CB80FA2B8180}"/>
               </a:ext>
             </a:extLst>
           </p:cNvPr>
@@ -30297,7 +30297,7 @@
           <p:cNvPr id="14" name="Rounded Rectangle 13">
             <a:extLst xmlns:a="http://schemas.openxmlformats.org/drawingml/2006/main">
               <a:ext uri="{FF2B5EF4-FFF2-40B4-BE49-F238E27FC236}">
-                <a16:creationId xmlns:a16="http://schemas.microsoft.com/office/drawing/2014/main" id="{B1C4BEBD-D336-43F9-9291-3ABD18D9933F}"/>
+                <a16:creationId xmlns:a16="http://schemas.microsoft.com/office/drawing/2014/main" id="{F0402745-79B1-47CF-A8C0-EADC4F3FF715}"/>
               </a:ext>
             </a:extLst>
           </p:cNvPr>
@@ -30354,7 +30354,7 @@
           <p:cNvPr id="15" name="TextBox 14">
             <a:extLst xmlns:a="http://schemas.openxmlformats.org/drawingml/2006/main">
               <a:ext uri="{FF2B5EF4-FFF2-40B4-BE49-F238E27FC236}">
-                <a16:creationId xmlns:a16="http://schemas.microsoft.com/office/drawing/2014/main" id="{FD006DF2-96FE-4311-BAF3-F03F8A0D5F2B}"/>
+                <a16:creationId xmlns:a16="http://schemas.microsoft.com/office/drawing/2014/main" id="{E0FAFD96-4132-4A77-BADB-4D34370829DA}"/>
               </a:ext>
             </a:extLst>
           </p:cNvPr>
@@ -30401,7 +30401,7 @@
           <p:cNvPr id="16" name="TextBox 15">
             <a:extLst xmlns:a="http://schemas.openxmlformats.org/drawingml/2006/main">
               <a:ext uri="{FF2B5EF4-FFF2-40B4-BE49-F238E27FC236}">
-                <a16:creationId xmlns:a16="http://schemas.microsoft.com/office/drawing/2014/main" id="{1C6485DE-F6E8-4751-A764-DFC2598DF6E2}"/>
+                <a16:creationId xmlns:a16="http://schemas.microsoft.com/office/drawing/2014/main" id="{9F086C17-B132-4A5E-82BD-0A07910D0F75}"/>
               </a:ext>
             </a:extLst>
           </p:cNvPr>
@@ -30448,7 +30448,7 @@
           <p:cNvPr id="17" name="Rounded Rectangle 16">
             <a:extLst xmlns:a="http://schemas.openxmlformats.org/drawingml/2006/main">
               <a:ext uri="{FF2B5EF4-FFF2-40B4-BE49-F238E27FC236}">
-                <a16:creationId xmlns:a16="http://schemas.microsoft.com/office/drawing/2014/main" id="{082B5444-ED5F-4409-82A8-FD27B0DA1A7A}"/>
+                <a16:creationId xmlns:a16="http://schemas.microsoft.com/office/drawing/2014/main" id="{D7E1BE68-E25E-49BB-AA4A-664AFBD8652F}"/>
               </a:ext>
             </a:extLst>
           </p:cNvPr>
@@ -30505,7 +30505,7 @@
           <p:cNvPr id="18" name="TextBox 17">
             <a:extLst xmlns:a="http://schemas.openxmlformats.org/drawingml/2006/main">
               <a:ext uri="{FF2B5EF4-FFF2-40B4-BE49-F238E27FC236}">
-                <a16:creationId xmlns:a16="http://schemas.microsoft.com/office/drawing/2014/main" id="{B0B2B73E-8FEF-4D4F-821B-80C75B2EEB28}"/>
+                <a16:creationId xmlns:a16="http://schemas.microsoft.com/office/drawing/2014/main" id="{0B1575DA-EA48-478E-A4DD-CD8514202537}"/>
               </a:ext>
             </a:extLst>
           </p:cNvPr>
@@ -30552,7 +30552,7 @@
           <p:cNvPr id="19" name="TextBox 18">
             <a:extLst xmlns:a="http://schemas.openxmlformats.org/drawingml/2006/main">
               <a:ext uri="{FF2B5EF4-FFF2-40B4-BE49-F238E27FC236}">
-                <a16:creationId xmlns:a16="http://schemas.microsoft.com/office/drawing/2014/main" id="{89E5C34C-6E74-420D-89E9-1F4F0BED1A0E}"/>
+                <a16:creationId xmlns:a16="http://schemas.microsoft.com/office/drawing/2014/main" id="{163C0B06-090F-42F4-85D0-E0B663A0B667}"/>
               </a:ext>
             </a:extLst>
           </p:cNvPr>
@@ -30599,7 +30599,7 @@
           <p:cNvPr id="20" name="TextBox 19">
             <a:extLst xmlns:a="http://schemas.openxmlformats.org/drawingml/2006/main">
               <a:ext uri="{FF2B5EF4-FFF2-40B4-BE49-F238E27FC236}">